<commit_message>
Got gc somewhat working (#888)
</commit_message>
<xml_diff>
--- a/php-zigar/doc/object-ownership.pptx
+++ b/php-zigar/doc/object-ownership.pptx
@@ -237,7 +237,7 @@
             <a:spLocks noGrp="1" noChangeArrowheads="1"/>
             <a:extLst>
               <a:ext uri="smNativeData">
-                <pr:smNativeData xmlns:pr="smNativeData" xmlns="smNativeData" val="SMDATA_15_AnHWaRMAAAAlAAAAZAAAAA8BAAAAkAAAAEgAAACQAAAASAAAAAAAAAABAAAAAAAAAAEAAABQAAAAAAAAAAAA4D8AAAAAAADgPwAAAAAAAOA/AAAAAAAA4D8AAAAAAADgPwAAAAAAAOA/AAAAAAAA4D8AAAAAAADgPwAAAAAAAOA/AAAAAAAA4D8CAAAAjAAAAAAAAAAAAAAAu+DjDP///wgAAAAAAAAAAAAAAAAAAAAAAAAAAAAAAAAAAAAAZAAAAAEAAABAAAAAAAAAAAAAAAAAAAAAAAAAAAAAAAAAAAAAAAAAAAAAAAAAAAAAAAAAAAAAAAAAAAAAAAAAAAAAAAAAAAAAAAAAAAAAAAAAAAAAAAAAAAAAAAAAAAAAFAAAADwAAAAAAAAAAAAAAAAAAAkUAAAAAQAAABQAAAAUAAAAFAAAAAEAAAAAAAAAZAAAAGQAAAAAAAAAZAAAAGQAAAAVAAAAYAAAAAAAAAAAAAAADwAAACADAAAAAAAAAAAAAAEAAACgMgAAVgcAAKr4//8BAAAAf39/AAEAAABkAAAAAAAAABQAAABAHwAAAAAAACYAAAAAAAAAwOD//wAAAAAmAAAAZAAAABYAAABMAAAAAAAAAAAAAAAEAAAAAAAAAAEAAACAgIAKAAAAACgAAAAoAAAAZAAAAGQAAAAAAAAAzMzMAAAAAABQAAAAUAAAAGQAAABkAAAAAAAAABcAAAAUAAAAAAAAAAAAAAD/fwAA/38AAAAAAAAJAAAABAAAAAAAAAAeAAAAaAAAAAAAAAAAAAAAAAAAAAAAAAAAAAAAECcAABAnAAAAAAAAAAAAAAAAAAAAAAAAAAAAAAAAAAAAAAAAAAAAABQAAAAAAAAAwMD/AAAAAABkAAAAMgAAAAAAAABkAAAAAAAAAH9/fwAKAAAAIgAAABgAAAAAAAAAAAAAAAAAAAAAAAAAAAAAAAAAAAAkAAAAJAAAAAAAAAAHAAAAAAAAAAAAAAAAAAAAAAAAAAAAAAAAAAAAf39/ACUAAABYAAAAAAAAAAAAAAAAAAAAAAAAAAAAAAAAAAAAAAAAAAAAAAAAAAAAAAAAAAAAAAA/AAAAAAAAAKCGAQAAAAAAAAAAAAAAAAAMAAAAAQAAAAAAAAAAAAAAAAAAAB8AAABUAAAAAAAABQAAAAEAAAAAAAAAAAAAAAAAAAAAAAAAAAAAAAAAAAAAAAAAAAAAAAJ/f38AAAAAA8zMzADAwP8Af39/AAAAAAAAAAAAAAAAAAAAAAAAAAAAIQAAABgAAAAUAAAAoAUAABoNAABgRQAAJhYAABAAAAAmAAAACAAAAAEAAAAAAAAA"/>
+                <pr:smNativeData xmlns:pr="smNativeData" xmlns="smNativeData" val="SMDATA_15_7aDWaRMAAAAlAAAAZAAAAA8BAAAAkAAAAEgAAACQAAAASAAAAAAAAAABAAAAAAAAAAEAAABQAAAAAAAAAAAA4D8AAAAAAADgPwAAAAAAAOA/AAAAAAAA4D8AAAAAAADgPwAAAAAAAOA/AAAAAAAA4D8AAAAAAADgPwAAAAAAAOA/AAAAAAAA4D8CAAAAjAAAAAAAAAAAAAAAu+DjDP///wgAAAAAAAAAAAAAAAAAAAAAAAAAAAAAAAAAAAAAZAAAAAEAAABAAAAAAAAAAAAAAAAAAAAAAAAAAAAAAAAAAAAAAAAAAAAAAAAAAAAAAAAAAAAAAAAAAAAAAAAAAAAAAAAAAAAAAAAAAAAAAAAAAAAAAAAAAAAAAAAAAAAAFAAAADwAAAAAAAAAAAAAAAAAAAkUAAAAAQAAABQAAAAUAAAAFAAAAAEAAAAAAAAAZAAAAGQAAAAAAAAAZAAAAGQAAAAVAAAAYAAAAAAAAAAAAAAADwAAACADAAAAAAAAAAAAAAEAAACgMgAAVgcAAKr4//8BAAAAf39/AAEAAABkAAAAAAAAABQAAABAHwAAAAAAACYAAAAAAAAAwOD//wAAAAAmAAAAZAAAABYAAABMAAAAAAAAAAAAAAAEAAAAAAAAAAEAAACAgIAKAAAAACgAAAAoAAAAZAAAAGQAAAAAAAAAzMzMAAAAAABQAAAAUAAAAGQAAABkAAAAAAAAABcAAAAUAAAAAAAAAAAAAAD/fwAA/38AAAAAAAAJAAAABAAAAAAAAAAeAAAAaAAAAAAAAAAAAAAAAAAAAAAAAAAAAAAAECcAABAnAAAAAAAAAAAAAAAAAAAAAAAAAAAAAAAAAAAAAAAAAAAAABQAAAAAAAAAwMD/AAAAAABkAAAAMgAAAAAAAABkAAAAAAAAAH9/fwAKAAAAIgAAABgAAAAAAAAAAAAAAAAAAAAAAAAAAAAAAAAAAAAkAAAAJAAAAAAAAAAHAAAAAAAAAAAAAAAAAAAAAAAAAAAAAAAAAAAAf39/ACUAAABYAAAAAAAAAAAAAAAAAAAAAAAAAAAAAAAAAAAAAAAAAAAAAAAAAAAAAAAAAAAAAAA/AAAAAAAAAKCGAQAAAAAAAAAAAAAAAAAMAAAAAQAAAAAAAAAAAAAAAAAAAB8AAABUAAAAAAAABQAAAAEAAAAAAAAAAAAAAAAAAAAAAAAAAAAAAAAAAAAAAAAAAAAAAAJ/f38AAAAAA8zMzADAwP8Af39/AAAAAAAAAAAAAAAAAAAAAAAAAAAAIQAAABgAAAAUAAAAoAUAABoNAABgRQAAJhYAABAAAAAmAAAACAAAAAEAAAAAAAAA"/>
               </a:ext>
             </a:extLst>
           </p:cNvSpPr>
@@ -269,7 +269,7 @@
             <a:spLocks noGrp="1" noChangeArrowheads="1"/>
             <a:extLst>
               <a:ext uri="smNativeData">
-                <pr:smNativeData xmlns:pr="smNativeData" xmlns="smNativeData" val="SMDATA_15_AnHWaRMAAAAlAAAAZAAAAA8BAAAAkAAAAEgAAACQAAAASAAAAAAAAAAAAAAAAAAAAAEAAABQAAAAAAAAAAAA4D8AAAAAAADgPwAAAAAAAOA/AAAAAAAA4D8AAAAAAADgPwAAAAAAAOA/AAAAAAAA4D8AAAAAAADgPwAAAAAAAOA/AAAAAAAA4D8CAAAAjAAAAAAAAAAAAAAAu+DjDP///wgAAAAAAAAAAAAAAAAAAAAAAAAAAAAAAAAAAAAAZAAAAAEAAABAAAAAAAAAAAAAAAAAAAAAAAAAAAAAAAAAAAAAAAAAAAAAAAAAAAAAAAAAAAAAAAAAAAAAAAAAAAAAAAAAAAAAAAAAAAAAAAAAAAAAAAAAAAAAAAAAAAAAFAAAADwAAAAAAAAAAAAAAAAAAAkUAAAAAQAAABQAAAAUAAAAFAAAAAEAAAAAAAAAZAAAAGQAAAAAAAAAZAAAAGQAAAAVAAAAYAAAAAAAAAAAAAAADwAAACADAAAAAAAAAAAAAAEAAACgMgAAVgcAAKr4//8BAAAAf39/AAEAAABkAAAAAAAAABQAAABAHwAAAAAAACYAAAAAAAAAwOD//wAAAAAmAAAAZAAAABYAAABMAAAAAAAAAAAAAAAEAAAAAAAAAAEAAACAgIAKAAAAACgAAAAoAAAAZAAAAGQAAAAAAAAAzMzMAAAAAABQAAAAUAAAAGQAAABkAAAAAAAAABcAAAAUAAAAAAAAAAAAAAD/fwAA/38AAAAAAAAJAAAABAAAAAAAAAAeAAAAaAAAAAAAAAAAAAAAAAAAAAAAAAAAAAAAECcAABAnAAAAAAAAAAAAAAAAAAAAAAAAAAAAAAAAAAAAAAAAAAAAABQAAAAAAAAAwMD/AAAAAABkAAAAMgAAAAAAAABkAAAAAAAAAH9/fwAKAAAAIgAAABgAAAAAAAAAAAAAAAAAAAAAAAAAAAAAAAAAAAAkAAAAJAAAAAAAAAAHAAAAAAAAAAAAAAAAAAAAAAAAAAAAAAAAAAAAf39/ACUAAABYAAAAAAAAAAAAAAAAAAAAAAAAAAAAAAAAAAAAAAAAAAAAAAAAAAAAAAAAAAAAAAA/AAAAAAAAAKCGAQAAAAAAAAAAAAAAAAAMAAAAAQAAAAAAAAAAAAAAAAAAAB8AAABUAAAAAAAABQAAAAEAAAAAAAAAAAAAAAAAAAAAAAAAAAAAAAAAAAAAAAAAAAAAAAJ/f38AAAAAA8zMzADAwP8Af39/AAAAAAAAAAAAAAAAAAAAAAAAAAAAIQAAABgAAAAUAAAAQAsAAOgXAADAPwAAsCIAABAAAAAmAAAACAAAAAGAAAAAAAAA"/>
+                <pr:smNativeData xmlns:pr="smNativeData" xmlns="smNativeData" val="SMDATA_15_7aDWaRMAAAAlAAAAZAAAAA8BAAAAkAAAAEgAAACQAAAASAAAAAAAAAAAAAAAAAAAAAEAAABQAAAAAAAAAAAA4D8AAAAAAADgPwAAAAAAAOA/AAAAAAAA4D8AAAAAAADgPwAAAAAAAOA/AAAAAAAA4D8AAAAAAADgPwAAAAAAAOA/AAAAAAAA4D8CAAAAjAAAAAAAAAAAAAAAu+DjDP///wgAAAAAAAAAAAAAAAAAAAAAAAAAAAAAAAAAAAAAZAAAAAEAAABAAAAAAAAAAAAAAAAAAAAAAAAAAAAAAAAAAAAAAAAAAAAAAAAAAAAAAAAAAAAAAAAAAAAAAAAAAAAAAAAAAAAAAAAAAAAAAAAAAAAAAAAAAAAAAAAAAAAAFAAAADwAAAAAAAAAAAAAAAAAAAkUAAAAAQAAABQAAAAUAAAAFAAAAAEAAAAAAAAAZAAAAGQAAAAAAAAAZAAAAGQAAAAVAAAAYAAAAAAAAAAAAAAADwAAACADAAAAAAAAAAAAAAEAAACgMgAAVgcAAKr4//8BAAAAf39/AAEAAABkAAAAAAAAABQAAABAHwAAAAAAACYAAAAAAAAAwOD//wAAAAAmAAAAZAAAABYAAABMAAAAAAAAAAAAAAAEAAAAAAAAAAEAAACAgIAKAAAAACgAAAAoAAAAZAAAAGQAAAAAAAAAzMzMAAAAAABQAAAAUAAAAGQAAABkAAAAAAAAABcAAAAUAAAAAAAAAAAAAAD/fwAA/38AAAAAAAAJAAAABAAAAAAAAAAeAAAAaAAAAAAAAAAAAAAAAAAAAAAAAAAAAAAAECcAABAnAAAAAAAAAAAAAAAAAAAAAAAAAAAAAAAAAAAAAAAAAAAAABQAAAAAAAAAwMD/AAAAAABkAAAAMgAAAAAAAABkAAAAAAAAAH9/fwAKAAAAIgAAABgAAAAAAAAAAAAAAAAAAAAAAAAAAAAAAAAAAAAkAAAAJAAAAAAAAAAHAAAAAAAAAAAAAAAAAAAAAAAAAAAAAAAAAAAAf39/ACUAAABYAAAAAAAAAAAAAAAAAAAAAAAAAAAAAAAAAAAAAAAAAAAAAAAAAAAAAAAAAAAAAAA/AAAAAAAAAKCGAQAAAAAAAAAAAAAAAAAMAAAAAQAAAAAAAAAAAAAAAAAAAB8AAABUAAAAAAAABQAAAAEAAAAAAAAAAAAAAAAAAAAAAAAAAAAAAAAAAAAAAAAAAAAAAAJ/f38AAAAAA8zMzADAwP8Af39/AAAAAAAAAAAAAAAAAAAAAAAAAAAAIQAAABgAAAAUAAAAQAsAAOgXAADAPwAAsCIAABAAAAAmAAAACAAAAAGAAAAAAAAA"/>
               </a:ext>
             </a:extLst>
           </p:cNvSpPr>
@@ -329,7 +329,7 @@
             <a:spLocks noGrp="1" noChangeArrowheads="1"/>
             <a:extLst>
               <a:ext uri="smNativeData">
-                <pr:smNativeData xmlns:pr="smNativeData" xmlns="smNativeData" val="SMDATA_15_AnHWaRMAAAAlAAAAZAAAAA8BAAAAkAAAAEgAAACQAAAASAAAAAAAAAABAAAAAAAAAAEAAABQAAAAAAAAAAAA4D8AAAAAAADgPwAAAAAAAOA/AAAAAAAA4D8AAAAAAADgPwAAAAAAAOA/AAAAAAAA4D8AAAAAAADgPwAAAAAAAOA/AAAAAAAA4D8CAAAAjAAAAAAAAAAAAAAAu+DjDP///wgAAAAAAAAAAAAAAAAAAAAAAAAAAAAAAAAAAAAAZAAAAAEAAABAAAAAAAAAAAAAAAAAAAAAAAAAAAAAAAAAAAAAAAAAAAAAAAAAAAAAAAAAAAAAAAAAAAAAAAAAAAAAAAAAAAAAAAAAAAAAAAAAAAAAAAAAAAAAAAAAAAAAFAAAADwAAAAAAAAAAAAAAAAAAAkUAAAAAQAAABQAAAAUAAAAFAAAAAEAAAAAAAAAZAAAAGQAAAAAAAAAZAAAAGQAAAAVAAAAYAAAAAAAAAAAAAAADwAAACADAAAAAAAAAAAAAAEAAACgMgAAVgcAAKr4//8BAAAAf39/AAEAAABkAAAAAAAAABQAAABAHwAAAAAAACYAAAAAAAAAwOD//wAAAAAmAAAAZAAAABYAAABMAAAAAAAAAAAAAAAEAAAAAAAAAAEAAACAgIAKAAAAACgAAAAoAAAAZAAAAGQAAAAAAAAAzMzMAAAAAABQAAAAUAAAAGQAAABkAAAAAAAAABcAAAAUAAAAAAAAAAAAAAD/fwAA/38AAAAAAAAJAAAABAAAAAAAAAAeAAAAaAAAAAAAAAAAAAAAAAAAAAAAAAAAAAAAECcAABAnAAAAAAAAAAAAAAAAAAAAAAAAAAAAAAAAAAAAAAAAAAAAABQAAAAAAAAAwMD/AAAAAABkAAAAMgAAAAAAAABkAAAAAAAAAH9/fwAKAAAAIgAAABgAAAAAAAAAAAAAAAAAAAAAAAAAAAAAAAAAAAAkAAAAJAAAAAAAAAAHAAAAAAAAAAAAAAAAAAAAAAAAAAAAAAAAAAAAf39/ACUAAABYAAAAAAAAAAAAAAAAAAAAAAAAAAAAAAAAAAAAAAAAAAAAAAAAAAAAAAAAAAAAAAA/AAAAAAAAAKCGAQAAAAAAAAAAAAAAAAAMAAAAAQAAAAAAAAAAAAAAAAAAAB8AAABUAAAAAAAABQAAAAEAAAAAAAAAAAAAAAAAAAAAAAAAAAAAAAAAAAAAAAAAAAAAAAJ/f38AAAAAA8zMzADAwP8Af39/AAAAAAAAAAAAAAAAAAAAAAAAAAAAIQAAABgAAAAUAAAAwAMAABsnAAA/FQAAWSkAABAAAAAmAAAACAAAAAAAAAAAAAAA"/>
+                <pr:smNativeData xmlns:pr="smNativeData" xmlns="smNativeData" val="SMDATA_15_7aDWaRMAAAAlAAAAZAAAAA8BAAAAkAAAAEgAAACQAAAASAAAAAAAAAABAAAAAAAAAAEAAABQAAAAAAAAAAAA4D8AAAAAAADgPwAAAAAAAOA/AAAAAAAA4D8AAAAAAADgPwAAAAAAAOA/AAAAAAAA4D8AAAAAAADgPwAAAAAAAOA/AAAAAAAA4D8CAAAAjAAAAAAAAAAAAAAAu+DjDP///wgAAAAAAAAAAAAAAAAAAAAAAAAAAAAAAAAAAAAAZAAAAAEAAABAAAAAAAAAAAAAAAAAAAAAAAAAAAAAAAAAAAAAAAAAAAAAAAAAAAAAAAAAAAAAAAAAAAAAAAAAAAAAAAAAAAAAAAAAAAAAAAAAAAAAAAAAAAAAAAAAAAAAFAAAADwAAAAAAAAAAAAAAAAAAAkUAAAAAQAAABQAAAAUAAAAFAAAAAEAAAAAAAAAZAAAAGQAAAAAAAAAZAAAAGQAAAAVAAAAYAAAAAAAAAAAAAAADwAAACADAAAAAAAAAAAAAAEAAACgMgAAVgcAAKr4//8BAAAAf39/AAEAAABkAAAAAAAAABQAAABAHwAAAAAAACYAAAAAAAAAwOD//wAAAAAmAAAAZAAAABYAAABMAAAAAAAAAAAAAAAEAAAAAAAAAAEAAACAgIAKAAAAACgAAAAoAAAAZAAAAGQAAAAAAAAAzMzMAAAAAABQAAAAUAAAAGQAAABkAAAAAAAAABcAAAAUAAAAAAAAAAAAAAD/fwAA/38AAAAAAAAJAAAABAAAAAAAAAAeAAAAaAAAAAAAAAAAAAAAAAAAAAAAAAAAAAAAECcAABAnAAAAAAAAAAAAAAAAAAAAAAAAAAAAAAAAAAAAAAAAAAAAABQAAAAAAAAAwMD/AAAAAABkAAAAMgAAAAAAAABkAAAAAAAAAH9/fwAKAAAAIgAAABgAAAAAAAAAAAAAAAAAAAAAAAAAAAAAAAAAAAAkAAAAJAAAAAAAAAAHAAAAAAAAAAAAAAAAAAAAAAAAAAAAAAAAAAAAf39/ACUAAABYAAAAAAAAAAAAAAAAAAAAAAAAAAAAAAAAAAAAAAAAAAAAAAAAAAAAAAAAAAAAAAA/AAAAAAAAAKCGAQAAAAAAAAAAAAAAAAAMAAAAAQAAAAAAAAAAAAAAAAAAAB8AAABUAAAAAAAABQAAAAEAAAAAAAAAAAAAAAAAAAAAAAAAAAAAAAAAAAAAAAAAAAAAAAJ/f38AAAAAA8zMzADAwP8Af39/AAAAAAAAAAAAAAAAAAAAAAAAAAAAIQAAABgAAAAUAAAAwAMAABsnAAA/FQAAWSkAABAAAAAmAAAACAAAAAAAAAAAAAAA"/>
               </a:ext>
             </a:extLst>
           </p:cNvSpPr>
@@ -343,7 +343,7 @@
           <a:lstStyle/>
           <a:p>
             <a:pPr/>
-            <a:fld id="{0D9656C1-8FE0-C3A0-AE2E-79F51860582C}" type="datetime1">
+            <a:fld id="{4FF01712-5CA2-A5E1-EC48-AAB459061AFF}" type="datetime1">
               <a:t/>
             </a:fld>
           </a:p>
@@ -356,7 +356,7 @@
             <a:spLocks noGrp="1" noChangeArrowheads="1"/>
             <a:extLst>
               <a:ext uri="smNativeData">
-                <pr:smNativeData xmlns:pr="smNativeData" xmlns="smNativeData" val="SMDATA_15_AnHWaRMAAAAlAAAAZAAAAA8BAAAAkAAAAEgAAACQAAAASAAAAAAAAAABAAAAAAAAAAEAAABQAAAAAAAAAAAA4D8AAAAAAADgPwAAAAAAAOA/AAAAAAAA4D8AAAAAAADgPwAAAAAAAOA/AAAAAAAA4D8AAAAAAADgPwAAAAAAAOA/AAAAAAAA4D8CAAAAjAAAAAAAAAAAAAAAu+DjDP///wgAAAAAAAAAAAAAAAAAAAAAAAAAAAAAAAAAAAAAZAAAAAEAAABAAAAAAAAAAAAAAAAAAAAAAAAAAAAAAAAAAAAAAAAAAAAAAAAAAAAAAAAAAAAAAAAAAAAAAAAAAAAAAAAAAAAAAAAAAAAAAAAAAAAAAAAAAAAAAAAAAAAAFAAAADwAAAAAAAAAAAAAAAAAAAkUAAAAAQAAABQAAAAUAAAAFAAAAAEAAAAAAAAAZAAAAGQAAAAAAAAAZAAAAGQAAAAVAAAAYAAAAAAAAAAAAAAADwAAACADAAAAAAAAAAAAAAEAAACgMgAAVgcAAKr4//8BAAAAf39/AAEAAABkAAAAAAAAABQAAABAHwAAAAAAACYAAAAAAAAAwOD//wAAAAAmAAAAZAAAABYAAABMAAAAAAAAAAAAAAAEAAAAAAAAAAEAAACAgIAKAAAAACgAAAAoAAAAZAAAAGQAAAAAAAAAzMzMAAAAAABQAAAAUAAAAGQAAABkAAAAAAAAABcAAAAUAAAAAAAAAAAAAAD/fwAA/38AAAAAAAAJAAAABAAAAAAAAAAeAAAAaAAAAAAAAAAAAAAAAAAAAAAAAAAAAAAAECcAABAnAAAAAAAAAAAAAAAAAAAAAAAAAAAAAAAAAAAAAAAAAAAAABQAAAAAAAAAwMD/AAAAAABkAAAAMgAAAAAAAABkAAAAAAAAAH9/fwAKAAAAIgAAABgAAAAAAAAAAAAAAAAAAAAAAAAAAAAAAAAAAAAkAAAAJAAAAAAAAAAHAAAAAAAAAAAAAAAAAAAAAAAAAAAAAAAAAAAAf39/ACUAAABYAAAAAAAAAAAAAAAAAAAAAAAAAAAAAAAAAAAAAAAAAAAAAAAAAAAAAAAAAAAAAAA/AAAAAAAAAKCGAQAAAAAAAAAAAAAAAAAMAAAAAQAAAAAAAAAAAAAAAAAAAB8AAABUAAAAAAAABQAAAAEAAAAAAAAAAAAAAAAAAAAAAAAAAAAAAAAAAAAAAAAAAAAAAAJ/f38AAAAAA8zMzADAwP8Af39/AAAAAAAAAAAAAAAAAAAAAAAAAAAAIQAAABgAAAAUAAAAoRkAABsnAABfMQAAWSkAABAAAAAmAAAACAAAAAAAAAAAAAAA"/>
+                <pr:smNativeData xmlns:pr="smNativeData" xmlns="smNativeData" val="SMDATA_15_7aDWaRMAAAAlAAAAZAAAAA8BAAAAkAAAAEgAAACQAAAASAAAAAAAAAABAAAAAAAAAAEAAABQAAAAAAAAAAAA4D8AAAAAAADgPwAAAAAAAOA/AAAAAAAA4D8AAAAAAADgPwAAAAAAAOA/AAAAAAAA4D8AAAAAAADgPwAAAAAAAOA/AAAAAAAA4D8CAAAAjAAAAAAAAAAAAAAAu+DjDP///wgAAAAAAAAAAAAAAAAAAAAAAAAAAAAAAAAAAAAAZAAAAAEAAABAAAAAAAAAAAAAAAAAAAAAAAAAAAAAAAAAAAAAAAAAAAAAAAAAAAAAAAAAAAAAAAAAAAAAAAAAAAAAAAAAAAAAAAAAAAAAAAAAAAAAAAAAAAAAAAAAAAAAFAAAADwAAAAAAAAAAAAAAAAAAAkUAAAAAQAAABQAAAAUAAAAFAAAAAEAAAAAAAAAZAAAAGQAAAAAAAAAZAAAAGQAAAAVAAAAYAAAAAAAAAAAAAAADwAAACADAAAAAAAAAAAAAAEAAACgMgAAVgcAAKr4//8BAAAAf39/AAEAAABkAAAAAAAAABQAAABAHwAAAAAAACYAAAAAAAAAwOD//wAAAAAmAAAAZAAAABYAAABMAAAAAAAAAAAAAAAEAAAAAAAAAAEAAACAgIAKAAAAACgAAAAoAAAAZAAAAGQAAAAAAAAAzMzMAAAAAABQAAAAUAAAAGQAAABkAAAAAAAAABcAAAAUAAAAAAAAAAAAAAD/fwAA/38AAAAAAAAJAAAABAAAAAAAAAAeAAAAaAAAAAAAAAAAAAAAAAAAAAAAAAAAAAAAECcAABAnAAAAAAAAAAAAAAAAAAAAAAAAAAAAAAAAAAAAAAAAAAAAABQAAAAAAAAAwMD/AAAAAABkAAAAMgAAAAAAAABkAAAAAAAAAH9/fwAKAAAAIgAAABgAAAAAAAAAAAAAAAAAAAAAAAAAAAAAAAAAAAAkAAAAJAAAAAAAAAAHAAAAAAAAAAAAAAAAAAAAAAAAAAAAAAAAAAAAf39/ACUAAABYAAAAAAAAAAAAAAAAAAAAAAAAAAAAAAAAAAAAAAAAAAAAAAAAAAAAAAAAAAAAAAA/AAAAAAAAAKCGAQAAAAAAAAAAAAAAAAAMAAAAAQAAAAAAAAAAAAAAAAAAAB8AAABUAAAAAAAABQAAAAEAAAAAAAAAAAAAAAAAAAAAAAAAAAAAAAAAAAAAAAAAAAAAAAJ/f38AAAAAA8zMzADAwP8Af39/AAAAAAAAAAAAAAAAAAAAAAAAAAAAIQAAABgAAAAUAAAAoRkAABsnAABfMQAAWSkAABAAAAAmAAAACAAAAAAAAAAAAAAA"/>
               </a:ext>
             </a:extLst>
           </p:cNvSpPr>
@@ -370,9 +370,6 @@
           <a:lstStyle/>
           <a:p>
             <a:pPr/>
-            <a:r>
-              <a:t/>
-            </a:r>
           </a:p>
         </p:txBody>
       </p:sp>
@@ -383,7 +380,7 @@
             <a:spLocks noGrp="1" noChangeArrowheads="1"/>
             <a:extLst>
               <a:ext uri="smNativeData">
-                <pr:smNativeData xmlns:pr="smNativeData" xmlns="smNativeData" val="SMDATA_15_AnHWaRMAAAAlAAAAZAAAAA8BAAAAkAAAAEgAAACQAAAASAAAAAAAAAABAAAAAAAAAAEAAABQAAAAAAAAAAAA4D8AAAAAAADgPwAAAAAAAOA/AAAAAAAA4D8AAAAAAADgPwAAAAAAAOA/AAAAAAAA4D8AAAAAAADgPwAAAAAAAOA/AAAAAAAA4D8CAAAAjAAAAAAAAAAAAAAAu+DjDP///wgAAAAAAAAAAAAAAAAAAAAAAAAAAAAAAAAAAAAAZAAAAAEAAABAAAAAAAAAAAAAAAAAAAAAAAAAAAAAAAAAAAAAAAAAAAAAAAAAAAAAAAAAAAAAAAAAAAAAAAAAAAAAAAAAAAAAAAAAAAAAAAAAAAAAAAAAAAAAAAAAAAAAFAAAADwAAAAAAAAAAAAAAAAAAAkUAAAAAQAAABQAAAAUAAAAFAAAAAEAAAAAAAAAZAAAAGQAAAAAAAAAZAAAAGQAAAAVAAAAYAAAAAAAAAAAAAAADwAAACADAAAAAAAAAAAAAAEAAACgMgAAVgcAAKr4//8BAAAAf39/AAEAAABkAAAAAAAAABQAAABAHwAAAAAAACYAAAAAAAAAwOD//wAAAAAmAAAAZAAAABYAAABMAAAAAAAAAAAAAAAEAAAAAAAAAAEAAACAgIAKAAAAACgAAAAoAAAAZAAAAGQAAAAAAAAAzMzMAAAAAABQAAAAUAAAAGQAAABkAAAAAAAAABcAAAAUAAAAAAAAAAAAAAD/fwAA/38AAAAAAAAJAAAABAAAAHsAfAAeAAAAaAAAAAAAAAAAAAAAAAAAAAAAAAAAAAAAECcAABAnAAAAAAAAAAAAAAAAAAAAAAAAAAAAAAAAAAAAAAAAAAAAABQAAAAAAAAAwMD/AAAAAABkAAAAMgAAAAAAAABkAAAAAAAAAH9/fwAKAAAAIgAAABgAAAAAAAAAAAAAAAAAAAAAAAAAAAAAAAAAAAAkAAAAJAAAAAAAAAAHAAAAAAAAAAAAAAAAAAAAAAAAAAAAAAAAAAAAf39/ACUAAABYAAAAAAAAAAAAAAAAAAAAAAAAAAAAAAAAAAAAAAAAAAAAAAAAAAAAAAAAAAAAAAA/AAAAAAAAAKCGAQAAAAAAAAAAAAAAAAAMAAAAAQAAAAAAAAAAAAAAAAAAAB8AAABUAAAAAAAABQAAAAEAAAAAAAAAAAAAAAAAAAAAAAAAAAAAAAAAAAAAAAAAAAAAAAJ/f38AAAAAA8zMzADAwP8Af39/AAAAAAAAAAAAAAAAAAAAAAAAAAAAIQAAABgAAAAUAAAAwTUAABsnAABARwAAWSkAABAAAAAmAAAACAAAAAAAAAAAAAAA"/>
+                <pr:smNativeData xmlns:pr="smNativeData" xmlns="smNativeData" val="SMDATA_15_7aDWaRMAAAAlAAAAZAAAAA8BAAAAkAAAAEgAAACQAAAASAAAAAAAAAABAAAAAAAAAAEAAABQAAAAAAAAAAAA4D8AAAAAAADgPwAAAAAAAOA/AAAAAAAA4D8AAAAAAADgPwAAAAAAAOA/AAAAAAAA4D8AAAAAAADgPwAAAAAAAOA/AAAAAAAA4D8CAAAAjAAAAAAAAAAAAAAAu+DjDP///wgAAAAAAAAAAAAAAAAAAAAAAAAAAAAAAAAAAAAAZAAAAAEAAABAAAAAAAAAAAAAAAAAAAAAAAAAAAAAAAAAAAAAAAAAAAAAAAAAAAAAAAAAAAAAAAAAAAAAAAAAAAAAAAAAAAAAAAAAAAAAAAAAAAAAAAAAAAAAAAAAAAAAFAAAADwAAAAAAAAAAAAAAAAAAAkUAAAAAQAAABQAAAAUAAAAFAAAAAEAAAAAAAAAZAAAAGQAAAAAAAAAZAAAAGQAAAAVAAAAYAAAAAAAAAAAAAAADwAAACADAAAAAAAAAAAAAAEAAACgMgAAVgcAAKr4//8BAAAAf39/AAEAAABkAAAAAAAAABQAAABAHwAAAAAAACYAAAAAAAAAwOD//wAAAAAmAAAAZAAAABYAAABMAAAAAAAAAAAAAAAEAAAAAAAAAAEAAACAgIAKAAAAACgAAAAoAAAAZAAAAGQAAAAAAAAAzMzMAAAAAABQAAAAUAAAAGQAAABkAAAAAAAAABcAAAAUAAAAAAAAAAAAAAD/fwAA/38AAAAAAAAJAAAABAAAAHsAfAAeAAAAaAAAAAAAAAAAAAAAAAAAAAAAAAAAAAAAECcAABAnAAAAAAAAAAAAAAAAAAAAAAAAAAAAAAAAAAAAAAAAAAAAABQAAAAAAAAAwMD/AAAAAABkAAAAMgAAAAAAAABkAAAAAAAAAH9/fwAKAAAAIgAAABgAAAAAAAAAAAAAAAAAAAAAAAAAAAAAAAAAAAAkAAAAJAAAAAAAAAAHAAAAAAAAAAAAAAAAAAAAAAAAAAAAAAAAAAAAf39/ACUAAABYAAAAAAAAAAAAAAAAAAAAAAAAAAAAAAAAAAAAAAAAAAAAAAAAAAAAAAAAAAAAAAA/AAAAAAAAAKCGAQAAAAAAAAAAAAAAAAAMAAAAAQAAAAAAAAAAAAAAAAAAAB8AAABUAAAAAAAABQAAAAEAAAAAAAAAAAAAAAAAAAAAAAAAAAAAAAAAAAAAAAAAAAAAAAJ/f38AAAAAA8zMzADAwP8Af39/AAAAAAAAAAAAAAAAAAAAAAAAAAAAIQAAABgAAAAUAAAAwTUAABsnAABARwAAWSkAABAAAAAmAAAACAAAAAAAAAAAAAAA"/>
               </a:ext>
             </a:extLst>
           </p:cNvSpPr>
@@ -397,7 +394,7 @@
           <a:lstStyle/>
           <a:p>
             <a:pPr/>
-            <a:fld id="{71BF9B4F-019C-EA6D-D207-F738D54924A2}" type="slidenum">
+            <a:fld id="{65A3423A-7488-F6B4-C61B-82E10C5530D7}" type="slidenum">
               <a:t/>
             </a:fld>
           </a:p>
@@ -408,6 +405,7 @@
   <p:clrMapOvr>
     <a:masterClrMapping/>
   </p:clrMapOvr>
+  <p:hf hdr="0" ftr="0"/>
 </p:sldLayout>
 </file>
 
@@ -435,7 +433,7 @@
             <a:spLocks noGrp="1" noChangeArrowheads="1"/>
             <a:extLst>
               <a:ext uri="smNativeData">
-                <pr:smNativeData xmlns:pr="smNativeData" xmlns="smNativeData" val="SMDATA_15_AnHWaRMAAAAlAAAAZAAAAA8BAAAAkAAAAEgAAACQAAAASAAAAAAAAAABAAAAAAAAAAEAAABQAAAAAAAAAAAA4D8AAAAAAADgPwAAAAAAAOA/AAAAAAAA4D8AAAAAAADgPwAAAAAAAOA/AAAAAAAA4D8AAAAAAADgPwAAAAAAAOA/AAAAAAAA4D8CAAAAjAAAAAAAAAAAAAAAu+DjDP///wgAAAAAAAAAAAAAAAAAAAAAAAAAAAAAAAAAAAAAZAAAAAEAAABAAAAAAAAAAAAAAAAAAAAAAAAAAAAAAAAAAAAAAAAAAAAAAAAAAAAAAAAAAAAAAAAAAAAAAAAAAAAAAAAAAAAAAAAAAAAAAAAAAAAAAAAAAAAAAAAAAAAAFAAAADwAAAAAAAAAAAAAAAAAAAkUAAAAAQAAABQAAAAUAAAAFAAAAAEAAAAAAAAAZAAAAGQAAAAAAAAAZAAAAGQAAAAVAAAAYAAAAAAAAAAAAAAADwAAACADAAAAAAAAAAAAAAEAAACgMgAAVgcAAKr4//8BAAAAf39/AAEAAABkAAAAAAAAABQAAABAHwAAAAAAACYAAAAAAAAAwOD//wAAAAAmAAAAZAAAABYAAABMAAAAAAAAAAAAAAAEAAAAAAAAAAEAAACAgIAKAAAAACgAAAAoAAAAZAAAAGQAAAAAAAAAzMzMAAAAAABQAAAAUAAAAGQAAABkAAAAAAAAABcAAAAUAAAAAAAAAAAAAAD/fwAA/38AAAAAAAAJAAAABAAAAG49IjEeAAAAaAAAAAAAAAAAAAAAAAAAAAAAAAAAAAAAECcAABAnAAAAAAAAAAAAAAAAAAAAAAAAAAAAAAAAAAAAAAAAAAAAABQAAAAAAAAAwMD/AAAAAABkAAAAMgAAAAAAAABkAAAAAAAAAH9/fwAKAAAAIgAAABgAAAAAAAAAAAAAAAAAAAAAAAAAAAAAAAAAAAAkAAAAJAAAAAAAAAAHAAAAAAAAAAAAAAAAAAAAAAAAAAAAAAAAAAAAf39/ACUAAABYAAAAAAAAAAAAAAAAAAAAAAAAAAAAAAAAAAAAAAAAAAAAAAAAAAAAAAAAAAAAAAA/AAAAAAAAAKCGAQAAAAAAAAAAAAAAAAAMAAAAAQAAAAAAAAAAAAAAAAAAAB8AAABUAAAAAAAABQAAAAEAAAAAAAAAAAAAAAAAAAAAAAAAAAAAAAAAAAAAAAAAAAAAAAJ/f38AAAAAA8zMzADAwP8Af39/AAAAAAAAAAAAAAAAAAAAAAAAAAAAIQAAABgAAAAUAAAAwAMAALABAABARwAAuAgAABAAAAAmAAAACAAAAAAAAAAAAAAA"/>
+                <pr:smNativeData xmlns:pr="smNativeData" xmlns="smNativeData" val="SMDATA_15_7aDWaRMAAAAlAAAAZAAAAA8BAAAAkAAAAEgAAACQAAAASAAAAAAAAAABAAAAAAAAAAEAAABQAAAAAAAAAAAA4D8AAAAAAADgPwAAAAAAAOA/AAAAAAAA4D8AAAAAAADgPwAAAAAAAOA/AAAAAAAA4D8AAAAAAADgPwAAAAAAAOA/AAAAAAAA4D8CAAAAjAAAAAAAAAAAAAAAu+DjDP///wgAAAAAAAAAAAAAAAAAAAAAAAAAAAAAAAAAAAAAZAAAAAEAAABAAAAAAAAAAAAAAAAAAAAAAAAAAAAAAAAAAAAAAAAAAAAAAAAAAAAAAAAAAAAAAAAAAAAAAAAAAAAAAAAAAAAAAAAAAAAAAAAAAAAAAAAAAAAAAAAAAAAAFAAAADwAAAAAAAAAAAAAAAAAAAkUAAAAAQAAABQAAAAUAAAAFAAAAAEAAAAAAAAAZAAAAGQAAAAAAAAAZAAAAGQAAAAVAAAAYAAAAAAAAAAAAAAADwAAACADAAAAAAAAAAAAAAEAAACgMgAAVgcAAKr4//8BAAAAf39/AAEAAABkAAAAAAAAABQAAABAHwAAAAAAACYAAAAAAAAAwOD//wAAAAAmAAAAZAAAABYAAABMAAAAAAAAAAAAAAAEAAAAAAAAAAEAAACAgIAKAAAAACgAAAAoAAAAZAAAAGQAAAAAAAAAzMzMAAAAAABQAAAAUAAAAGQAAABkAAAAAAAAABcAAAAUAAAAAAAAAAAAAAD/fwAA/38AAAAAAAAJAAAABAAAAG49IjEeAAAAaAAAAAAAAAAAAAAAAAAAAAAAAAAAAAAAECcAABAnAAAAAAAAAAAAAAAAAAAAAAAAAAAAAAAAAAAAAAAAAAAAABQAAAAAAAAAwMD/AAAAAABkAAAAMgAAAAAAAABkAAAAAAAAAH9/fwAKAAAAIgAAABgAAAAAAAAAAAAAAAAAAAAAAAAAAAAAAAAAAAAkAAAAJAAAAAAAAAAHAAAAAAAAAAAAAAAAAAAAAAAAAAAAAAAAAAAAf39/ACUAAABYAAAAAAAAAAAAAAAAAAAAAAAAAAAAAAAAAAAAAAAAAAAAAAAAAAAAAAAAAAAAAAA/AAAAAAAAAKCGAQAAAAAAAAAAAAAAAAAMAAAAAQAAAAAAAAAAAAAAAAAAAB8AAABUAAAAAAAABQAAAAEAAAAAAAAAAAAAAAAAAAAAAAAAAAAAAAAAAAAAAAAAAAAAAAJ/f38AAAAAA8zMzADAwP8Af39/AAAAAAAAAAAAAAAAAAAAAAAAAAAAIQAAABgAAAAUAAAAwAMAALABAABARwAAuAgAABAAAAAmAAAACAAAAAAAAAAAAAAA"/>
               </a:ext>
             </a:extLst>
           </p:cNvSpPr>
@@ -462,7 +460,7 @@
             <a:spLocks noGrp="1" noChangeArrowheads="1"/>
             <a:extLst>
               <a:ext uri="smNativeData">
-                <pr:smNativeData xmlns:pr="smNativeData" xmlns="smNativeData" val="SMDATA_15_AnHWaRMAAAAlAAAAZAAAAA8BAAAAkAAAAEgAAACQAAAASAAAAAAAAAAAAAAAAQAAAAEAAABQAAAAAAAAAAAA4D8AAAAAAADgPwAAAAAAAOA/AAAAAAAA4D8AAAAAAADgPwAAAAAAAOA/AAAAAAAA4D8AAAAAAADgPwAAAAAAAOA/AAAAAAAA4D8CAAAAjAAAAAAAAAAAAAAAu+DjDP///wgAAAAAAAAAAAAAAAAAAAAAAAAAAAAAAAAAAAAAZAAAAAEAAABAAAAAAAAAAAAAAAAAAAAAAAAAAAAAAAAAAAAAAAAAAAAAAAAAAAAAAAAAAAAAAAAAAAAAAAAAAAAAAAAAAAAAAAAAAAAAAAAAAAAAAAAAAAAAAAAAAAAAFAAAADwAAAAAAAAAAAAAAAAAAAkUAAAAAQAAABQAAAAUAAAAFAAAAAEAAAAAAAAAZAAAAGQAAAAAAAAAZAAAAGQAAAAVAAAAYAAAAAAAAAAAAAAADwAAACADAAAAAAAAAAAAAAEAAACgMgAAVgcAAKr4//8BAAAAf39/AAEAAABkAAAAAAAAABQAAABAHwAAAAAAACYAAAAAAAAAwOD//wAAAAAmAAAAZAAAABYAAABMAAAAAAAAAAAAAAAEAAAAAAAAAAEAAACAgIAKAAAAACgAAAAoAAAAZAAAAGQAAAAAAAAAzMzMAAAAAABQAAAAUAAAAGQAAABkAAAAAAAAABcAAAAUAAAAAAAAAAAAAAD/fwAA/38AAAAAAAAJAAAABAAAAAAAAAAeAAAAaAAAAAAAAAAAAAAAAAAAAAAAAAAAAAAAECcAABAnAAAAAAAAAAAAAAAAAAAAAAAAAAAAAAAAAAAAAAAAAAAAABQAAAAAAAAAwMD/AAAAAABkAAAAMgAAAAAAAABkAAAAAAAAAH9/fwAKAAAAIgAAABgAAAAAAAAAAAAAAAAAAAAAAAAAAAAAAAAAAAAkAAAAJAAAAAAAAAAHAAAAAAAAAAAAAAAAAAAAAAAAAAAAAAAAAAAAf39/ACUAAABYAAAAAAAAAAAAAAAAAAAAAAAAAAAAAAAAAAAAAAAAAAAAAAAAAAAAAAAAAAAAAAA/AAAAAAAAAKCGAQAAAAAAAAAAAAAAAAAMAAAAAQAAAAAAAAAAAAAAAAAAAB8AAABUAAAAAAAABQAAAAEAAAAAAAAAAAAAAAAAAAAAAAAAAAAAAAAAAAAAAAAAAAAAAAJ/f38AAAAAA8zMzADAwP8Af39/AAAAAAAAAAAAAAAAAAAAAAAAAAAAIQAAABgAAAAUAAAAwAMAANgJAABARwAAsCUAABAAAAAmAAAACAAAAAIAAAAAAAAA"/>
+                <pr:smNativeData xmlns:pr="smNativeData" xmlns="smNativeData" val="SMDATA_15_7aDWaRMAAAAlAAAAZAAAAA8BAAAAkAAAAEgAAACQAAAASAAAAAAAAAAAAAAAAQAAAAEAAABQAAAAAAAAAAAA4D8AAAAAAADgPwAAAAAAAOA/AAAAAAAA4D8AAAAAAADgPwAAAAAAAOA/AAAAAAAA4D8AAAAAAADgPwAAAAAAAOA/AAAAAAAA4D8CAAAAjAAAAAAAAAAAAAAAu+DjDP///wgAAAAAAAAAAAAAAAAAAAAAAAAAAAAAAAAAAAAAZAAAAAEAAABAAAAAAAAAAAAAAAAAAAAAAAAAAAAAAAAAAAAAAAAAAAAAAAAAAAAAAAAAAAAAAAAAAAAAAAAAAAAAAAAAAAAAAAAAAAAAAAAAAAAAAAAAAAAAAAAAAAAAFAAAADwAAAAAAAAAAAAAAAAAAAkUAAAAAQAAABQAAAAUAAAAFAAAAAEAAAAAAAAAZAAAAGQAAAAAAAAAZAAAAGQAAAAVAAAAYAAAAAAAAAAAAAAADwAAACADAAAAAAAAAAAAAAEAAACgMgAAVgcAAKr4//8BAAAAf39/AAEAAABkAAAAAAAAABQAAABAHwAAAAAAACYAAAAAAAAAwOD//wAAAAAmAAAAZAAAABYAAABMAAAAAAAAAAAAAAAEAAAAAAAAAAEAAACAgIAKAAAAACgAAAAoAAAAZAAAAGQAAAAAAAAAzMzMAAAAAABQAAAAUAAAAGQAAABkAAAAAAAAABcAAAAUAAAAAAAAAAAAAAD/fwAA/38AAAAAAAAJAAAABAAAAAAAAAAeAAAAaAAAAAAAAAAAAAAAAAAAAAAAAAAAAAAAECcAABAnAAAAAAAAAAAAAAAAAAAAAAAAAAAAAAAAAAAAAAAAAAAAABQAAAAAAAAAwMD/AAAAAABkAAAAMgAAAAAAAABkAAAAAAAAAH9/fwAKAAAAIgAAABgAAAAAAAAAAAAAAAAAAAAAAAAAAAAAAAAAAAAkAAAAJAAAAAAAAAAHAAAAAAAAAAAAAAAAAAAAAAAAAAAAAAAAAAAAf39/ACUAAABYAAAAAAAAAAAAAAAAAAAAAAAAAAAAAAAAAAAAAAAAAAAAAAAAAAAAAAAAAAAAAAA/AAAAAAAAAKCGAQAAAAAAAAAAAAAAAAAMAAAAAQAAAAAAAAAAAAAAAAAAAB8AAABUAAAAAAAABQAAAAEAAAAAAAAAAAAAAAAAAAAAAAAAAAAAAAAAAAAAAAAAAAAAAAJ/f38AAAAAA8zMzADAwP8Af39/AAAAAAAAAAAAAAAAAAAAAAAAAAAAIQAAABgAAAAUAAAAwAMAANgJAABARwAAsCUAABAAAAAmAAAACAAAAAIAAAAAAAAA"/>
               </a:ext>
             </a:extLst>
           </p:cNvSpPr>
@@ -517,7 +515,7 @@
             <a:spLocks noGrp="1" noChangeArrowheads="1"/>
             <a:extLst>
               <a:ext uri="smNativeData">
-                <pr:smNativeData xmlns:pr="smNativeData" xmlns="smNativeData" val="SMDATA_15_AnHWaRMAAAAlAAAAZAAAAA8BAAAAkAAAAEgAAACQAAAASAAAAAAAAAABAAAAAAAAAAEAAABQAAAAAAAAAAAA4D8AAAAAAADgPwAAAAAAAOA/AAAAAAAA4D8AAAAAAADgPwAAAAAAAOA/AAAAAAAA4D8AAAAAAADgPwAAAAAAAOA/AAAAAAAA4D8CAAAAjAAAAAAAAAAAAAAAu+DjDP///wgAAAAAAAAAAAAAAAAAAAAAAAAAAAAAAAAAAAAAZAAAAAEAAABAAAAAAAAAAAAAAAAAAAAAAAAAAAAAAAAAAAAAAAAAAAAAAAAAAAAAAAAAAAAAAAAAAAAAAAAAAAAAAAAAAAAAAAAAAAAAAAAAAAAAAAAAAAAAAAAAAAAAFAAAADwAAAAAAAAAAAAAAAAAAAkUAAAAAQAAABQAAAAUAAAAFAAAAAEAAAAAAAAAZAAAAGQAAAAAAAAAZAAAAGQAAAAVAAAAYAAAAAAAAAAAAAAADwAAACADAAAAAAAAAAAAAAEAAACgMgAAVgcAAKr4//8BAAAAf39/AAEAAABkAAAAAAAAABQAAABAHwAAAAAAACYAAAAAAAAAwOD//wAAAAAmAAAAZAAAABYAAABMAAAAAAAAAAAAAAAEAAAAAAAAAAEAAACAgIAKAAAAACgAAAAoAAAAZAAAAGQAAAAAAAAAzMzMAAAAAABQAAAAUAAAAGQAAABkAAAAAAAAABcAAAAUAAAAAAAAAAAAAAD/fwAA/38AAAAAAAAJAAAABAAAAAAAAAAeAAAAaAAAAAAAAAAAAAAAAAAAAAAAAAAAAAAAECcAABAnAAAAAAAAAAAAAAAAAAAAAAAAAAAAAAAAAAAAAAAAAAAAABQAAAAAAAAAwMD/AAAAAABkAAAAMgAAAAAAAABkAAAAAAAAAH9/fwAKAAAAIgAAABgAAAAAAAAAAAAAAAAAAAAAAAAAAAAAAAAAAAAkAAAAJAAAAAAAAAAHAAAAAAAAAAAAAAAAAAAAAAAAAAAAAAAAAAAAf39/ACUAAABYAAAAAAAAAAAAAAAAAAAAAAAAAAAAAAAAAAAAAAAAAAAAAAAAAAAAAAAAAAAAAAA/AAAAAAAAAKCGAQAAAAAAAAAAAAAAAAAMAAAAAQAAAAAAAAAAAAAAAAAAAB8AAABUAAAAAAAABQAAAAEAAAAAAAAAAAAAAAAAAAAAAAAAAAAAAAAAAAAAAAAAAAAAAAJ/f38AAAAAA8zMzADAwP8Af39/AAAAAAAAAAAAAAAAAAAAAAAAAAAAIQAAABgAAAAUAAAAwAMAABsnAAA/FQAAWSkAABAAAAAmAAAACAAAAAAAAAAAAAAA"/>
+                <pr:smNativeData xmlns:pr="smNativeData" xmlns="smNativeData" val="SMDATA_15_7aDWaRMAAAAlAAAAZAAAAA8BAAAAkAAAAEgAAACQAAAASAAAAAAAAAABAAAAAAAAAAEAAABQAAAAAAAAAAAA4D8AAAAAAADgPwAAAAAAAOA/AAAAAAAA4D8AAAAAAADgPwAAAAAAAOA/AAAAAAAA4D8AAAAAAADgPwAAAAAAAOA/AAAAAAAA4D8CAAAAjAAAAAAAAAAAAAAAu+DjDP///wgAAAAAAAAAAAAAAAAAAAAAAAAAAAAAAAAAAAAAZAAAAAEAAABAAAAAAAAAAAAAAAAAAAAAAAAAAAAAAAAAAAAAAAAAAAAAAAAAAAAAAAAAAAAAAAAAAAAAAAAAAAAAAAAAAAAAAAAAAAAAAAAAAAAAAAAAAAAAAAAAAAAAFAAAADwAAAAAAAAAAAAAAAAAAAkUAAAAAQAAABQAAAAUAAAAFAAAAAEAAAAAAAAAZAAAAGQAAAAAAAAAZAAAAGQAAAAVAAAAYAAAAAAAAAAAAAAADwAAACADAAAAAAAAAAAAAAEAAACgMgAAVgcAAKr4//8BAAAAf39/AAEAAABkAAAAAAAAABQAAABAHwAAAAAAACYAAAAAAAAAwOD//wAAAAAmAAAAZAAAABYAAABMAAAAAAAAAAAAAAAEAAAAAAAAAAEAAACAgIAKAAAAACgAAAAoAAAAZAAAAGQAAAAAAAAAzMzMAAAAAABQAAAAUAAAAGQAAABkAAAAAAAAABcAAAAUAAAAAAAAAAAAAAD/fwAA/38AAAAAAAAJAAAABAAAAAAAAAAeAAAAaAAAAAAAAAAAAAAAAAAAAAAAAAAAAAAAECcAABAnAAAAAAAAAAAAAAAAAAAAAAAAAAAAAAAAAAAAAAAAAAAAABQAAAAAAAAAwMD/AAAAAABkAAAAMgAAAAAAAABkAAAAAAAAAH9/fwAKAAAAIgAAABgAAAAAAAAAAAAAAAAAAAAAAAAAAAAAAAAAAAAkAAAAJAAAAAAAAAAHAAAAAAAAAAAAAAAAAAAAAAAAAAAAAAAAAAAAf39/ACUAAABYAAAAAAAAAAAAAAAAAAAAAAAAAAAAAAAAAAAAAAAAAAAAAAAAAAAAAAAAAAAAAAA/AAAAAAAAAKCGAQAAAAAAAAAAAAAAAAAMAAAAAQAAAAAAAAAAAAAAAAAAAB8AAABUAAAAAAAABQAAAAEAAAAAAAAAAAAAAAAAAAAAAAAAAAAAAAAAAAAAAAAAAAAAAAJ/f38AAAAAA8zMzADAwP8Af39/AAAAAAAAAAAAAAAAAAAAAAAAAAAAIQAAABgAAAAUAAAAwAMAABsnAAA/FQAAWSkAABAAAAAmAAAACAAAAAAAAAAAAAAA"/>
               </a:ext>
             </a:extLst>
           </p:cNvSpPr>
@@ -531,7 +529,7 @@
           <a:lstStyle/>
           <a:p>
             <a:pPr/>
-            <a:fld id="{706D4201-4F9D-38B4-D3D5-B9E10C9B25EC}" type="datetime1">
+            <a:fld id="{426D1226-68AF-38E4-E1D5-9EB15C9B17CB}" type="datetime1">
               <a:t/>
             </a:fld>
           </a:p>
@@ -544,7 +542,7 @@
             <a:spLocks noGrp="1" noChangeArrowheads="1"/>
             <a:extLst>
               <a:ext uri="smNativeData">
-                <pr:smNativeData xmlns:pr="smNativeData" xmlns="smNativeData" val="SMDATA_15_AnHWaRMAAAAlAAAAZAAAAA8BAAAAkAAAAEgAAACQAAAASAAAAAAAAAABAAAAAAAAAAEAAABQAAAAAAAAAAAA4D8AAAAAAADgPwAAAAAAAOA/AAAAAAAA4D8AAAAAAADgPwAAAAAAAOA/AAAAAAAA4D8AAAAAAADgPwAAAAAAAOA/AAAAAAAA4D8CAAAAjAAAAAAAAAAAAAAAu+DjDP///wgAAAAAAAAAAAAAAAAAAAAAAAAAAAAAAAAAAAAAZAAAAAEAAABAAAAAAAAAAAAAAAAAAAAAAAAAAAAAAAAAAAAAAAAAAAAAAAAAAAAAAAAAAAAAAAAAAAAAAAAAAAAAAAAAAAAAAAAAAAAAAAAAAAAAAAAAAAAAAAAAAAAAFAAAADwAAAAAAAAAAAAAAAAAAAkUAAAAAQAAABQAAAAUAAAAFAAAAAEAAAAAAAAAZAAAAGQAAAAAAAAAZAAAAGQAAAAVAAAAYAAAAAAAAAAAAAAADwAAACADAAAAAAAAAAAAAAEAAACgMgAAVgcAAKr4//8BAAAAf39/AAEAAABkAAAAAAAAABQAAABAHwAAAAAAACYAAAAAAAAAwOD//wAAAAAmAAAAZAAAABYAAABMAAAAAAAAAAAAAAAEAAAAAAAAAAEAAACAgIAKAAAAACgAAAAoAAAAZAAAAGQAAAAAAAAAzMzMAAAAAABQAAAAUAAAAGQAAABkAAAAAAAAABcAAAAUAAAAAAAAAAAAAAD/fwAA/38AAAAAAAAJAAAABAAAAGE6c3AeAAAAaAAAAAAAAAAAAAAAAAAAAAAAAAAAAAAAECcAABAnAAAAAAAAAAAAAAAAAAAAAAAAAAAAAAAAAAAAAAAAAAAAABQAAAAAAAAAwMD/AAAAAABkAAAAMgAAAAAAAABkAAAAAAAAAH9/fwAKAAAAIgAAABgAAAAAAAAAAAAAAAAAAAAAAAAAAAAAAAAAAAAkAAAAJAAAAAAAAAAHAAAAAAAAAAAAAAAAAAAAAAAAAAAAAAAAAAAAf39/ACUAAABYAAAAAAAAAAAAAAAAAAAAAAAAAAAAAAAAAAAAAAAAAAAAAAAAAAAAAAAAAAAAAAA/AAAAAAAAAKCGAQAAAAAAAAAAAAAAAAAMAAAAAQAAAAAAAAAAAAAAAAAAAB8AAABUAAAAAAAABQAAAAEAAAAAAAAAAAAAAAAAAAAAAAAAAAAAAAAAAAAAAAAAAAAAAAJ/f38AAAAAA8zMzADAwP8Af39/AAAAAAAAAAAAAAAAAAAAAAAAAAAAIQAAABgAAAAUAAAAoRkAABsnAABfMQAAWSkAABAAAAAmAAAACAAAAAAAAAAAAAAA"/>
+                <pr:smNativeData xmlns:pr="smNativeData" xmlns="smNativeData" val="SMDATA_15_7aDWaRMAAAAlAAAAZAAAAA8BAAAAkAAAAEgAAACQAAAASAAAAAAAAAABAAAAAAAAAAEAAABQAAAAAAAAAAAA4D8AAAAAAADgPwAAAAAAAOA/AAAAAAAA4D8AAAAAAADgPwAAAAAAAOA/AAAAAAAA4D8AAAAAAADgPwAAAAAAAOA/AAAAAAAA4D8CAAAAjAAAAAAAAAAAAAAAu+DjDP///wgAAAAAAAAAAAAAAAAAAAAAAAAAAAAAAAAAAAAAZAAAAAEAAABAAAAAAAAAAAAAAAAAAAAAAAAAAAAAAAAAAAAAAAAAAAAAAAAAAAAAAAAAAAAAAAAAAAAAAAAAAAAAAAAAAAAAAAAAAAAAAAAAAAAAAAAAAAAAAAAAAAAAFAAAADwAAAAAAAAAAAAAAAAAAAkUAAAAAQAAABQAAAAUAAAAFAAAAAEAAAAAAAAAZAAAAGQAAAAAAAAAZAAAAGQAAAAVAAAAYAAAAAAAAAAAAAAADwAAACADAAAAAAAAAAAAAAEAAACgMgAAVgcAAKr4//8BAAAAf39/AAEAAABkAAAAAAAAABQAAABAHwAAAAAAACYAAAAAAAAAwOD//wAAAAAmAAAAZAAAABYAAABMAAAAAAAAAAAAAAAEAAAAAAAAAAEAAACAgIAKAAAAACgAAAAoAAAAZAAAAGQAAAAAAAAAzMzMAAAAAABQAAAAUAAAAGQAAABkAAAAAAAAABcAAAAUAAAAAAAAAAAAAAD/fwAA/38AAAAAAAAJAAAABAAAAGE6c3AeAAAAaAAAAAAAAAAAAAAAAAAAAAAAAAAAAAAAECcAABAnAAAAAAAAAAAAAAAAAAAAAAAAAAAAAAAAAAAAAAAAAAAAABQAAAAAAAAAwMD/AAAAAABkAAAAMgAAAAAAAABkAAAAAAAAAH9/fwAKAAAAIgAAABgAAAAAAAAAAAAAAAAAAAAAAAAAAAAAAAAAAAAkAAAAJAAAAAAAAAAHAAAAAAAAAAAAAAAAAAAAAAAAAAAAAAAAAAAAf39/ACUAAABYAAAAAAAAAAAAAAAAAAAAAAAAAAAAAAAAAAAAAAAAAAAAAAAAAAAAAAAAAAAAAAA/AAAAAAAAAKCGAQAAAAAAAAAAAAAAAAAMAAAAAQAAAAAAAAAAAAAAAAAAAB8AAABUAAAAAAAABQAAAAEAAAAAAAAAAAAAAAAAAAAAAAAAAAAAAAAAAAAAAAAAAAAAAAJ/f38AAAAAA8zMzADAwP8Af39/AAAAAAAAAAAAAAAAAAAAAAAAAAAAIQAAABgAAAAUAAAAoRkAABsnAABfMQAAWSkAABAAAAAmAAAACAAAAAAAAAAAAAAA"/>
               </a:ext>
             </a:extLst>
           </p:cNvSpPr>
@@ -558,9 +556,6 @@
           <a:lstStyle/>
           <a:p>
             <a:pPr/>
-            <a:r>
-              <a:t/>
-            </a:r>
           </a:p>
         </p:txBody>
       </p:sp>
@@ -571,7 +566,7 @@
             <a:spLocks noGrp="1" noChangeArrowheads="1"/>
             <a:extLst>
               <a:ext uri="smNativeData">
-                <pr:smNativeData xmlns:pr="smNativeData" xmlns="smNativeData" val="SMDATA_15_AnHWaRMAAAAlAAAAZAAAAA8BAAAAkAAAAEgAAACQAAAASAAAAAAAAAABAAAAAAAAAAEAAABQAAAAAAAAAAAA4D8AAAAAAADgPwAAAAAAAOA/AAAAAAAA4D8AAAAAAADgPwAAAAAAAOA/AAAAAAAA4D8AAAAAAADgPwAAAAAAAOA/AAAAAAAA4D8CAAAAjAAAAAAAAAAAAAAAu+DjDP///wgAAAAAAAAAAAAAAAAAAAAAAAAAAAAAAAAAAAAAZAAAAAEAAABAAAAAAAAAAAAAAAAAAAAAAAAAAAAAAAAAAAAAAAAAAAAAAAAAAAAAAAAAAAAAAAAAAAAAAAAAAAAAAAAAAAAAAAAAAAAAAAAAAAAAAAAAAAAAAAAAAAAAFAAAADwAAAAAAAAAAAAAAAAAAAkUAAAAAQAAABQAAAAUAAAAFAAAAAEAAAAAAAAAZAAAAGQAAAAAAAAAZAAAAGQAAAAVAAAAYAAAAAAAAAAAAAAADwAAACADAAAAAAAAAAAAAAEAAACgMgAAVgcAAKr4//8BAAAAf39/AAEAAABkAAAAAAAAABQAAABAHwAAAAAAACYAAAAAAAAAwOD//wAAAAAmAAAAZAAAABYAAABMAAAAAAAAAAAAAAAEAAAAAAAAAAEAAACAgIAKAAAAACgAAAAoAAAAZAAAAGQAAAAAAAAAzMzMAAAAAABQAAAAUAAAAGQAAABkAAAAAAAAABcAAAAUAAAAAAAAAAAAAAD/fwAA/38AAAAAAAAJAAAABAAAAAAAAAAeAAAAaAAAAAAAAAAAAAAAAAAAAAAAAAAAAAAAECcAABAnAAAAAAAAAAAAAAAAAAAAAAAAAAAAAAAAAAAAAAAAAAAAABQAAAAAAAAAwMD/AAAAAABkAAAAMgAAAAAAAABkAAAAAAAAAH9/fwAKAAAAIgAAABgAAAAAAAAAAAAAAAAAAAAAAAAAAAAAAAAAAAAkAAAAJAAAAAAAAAAHAAAAAAAAAAAAAAAAAAAAAAAAAAAAAAAAAAAAf39/ACUAAABYAAAAAAAAAAAAAAAAAAAAAAAAAAAAAAAAAAAAAAAAAAAAAAAAAAAAAAAAAAAAAAA/AAAAAAAAAKCGAQAAAAAAAAAAAAAAAAAMAAAAAQAAAAAAAAAAAAAAAAAAAB8AAABUAAAAAAAABQAAAAEAAAAAAAAAAAAAAAAAAAAAAAAAAAAAAAAAAAAAAAAAAAAAAAJ/f38AAAAAA8zMzADAwP8Af39/AAAAAAAAAAAAAAAAAAAAAAAAAAAAIQAAABgAAAAUAAAAwTUAABsnAABARwAAWSkAABAAAAAmAAAACAAAAAAAAAAAAAAA"/>
+                <pr:smNativeData xmlns:pr="smNativeData" xmlns="smNativeData" val="SMDATA_15_7aDWaRMAAAAlAAAAZAAAAA8BAAAAkAAAAEgAAACQAAAASAAAAAAAAAABAAAAAAAAAAEAAABQAAAAAAAAAAAA4D8AAAAAAADgPwAAAAAAAOA/AAAAAAAA4D8AAAAAAADgPwAAAAAAAOA/AAAAAAAA4D8AAAAAAADgPwAAAAAAAOA/AAAAAAAA4D8CAAAAjAAAAAAAAAAAAAAAu+DjDP///wgAAAAAAAAAAAAAAAAAAAAAAAAAAAAAAAAAAAAAZAAAAAEAAABAAAAAAAAAAAAAAAAAAAAAAAAAAAAAAAAAAAAAAAAAAAAAAAAAAAAAAAAAAAAAAAAAAAAAAAAAAAAAAAAAAAAAAAAAAAAAAAAAAAAAAAAAAAAAAAAAAAAAFAAAADwAAAAAAAAAAAAAAAAAAAkUAAAAAQAAABQAAAAUAAAAFAAAAAEAAAAAAAAAZAAAAGQAAAAAAAAAZAAAAGQAAAAVAAAAYAAAAAAAAAAAAAAADwAAACADAAAAAAAAAAAAAAEAAACgMgAAVgcAAKr4//8BAAAAf39/AAEAAABkAAAAAAAAABQAAABAHwAAAAAAACYAAAAAAAAAwOD//wAAAAAmAAAAZAAAABYAAABMAAAAAAAAAAAAAAAEAAAAAAAAAAEAAACAgIAKAAAAACgAAAAoAAAAZAAAAGQAAAAAAAAAzMzMAAAAAABQAAAAUAAAAGQAAABkAAAAAAAAABcAAAAUAAAAAAAAAAAAAAD/fwAA/38AAAAAAAAJAAAABAAAAAAAAAAeAAAAaAAAAAAAAAAAAAAAAAAAAAAAAAAAAAAAECcAABAnAAAAAAAAAAAAAAAAAAAAAAAAAAAAAAAAAAAAAAAAAAAAABQAAAAAAAAAwMD/AAAAAABkAAAAMgAAAAAAAABkAAAAAAAAAH9/fwAKAAAAIgAAABgAAAAAAAAAAAAAAAAAAAAAAAAAAAAAAAAAAAAkAAAAJAAAAAAAAAAHAAAAAAAAAAAAAAAAAAAAAAAAAAAAAAAAAAAAf39/ACUAAABYAAAAAAAAAAAAAAAAAAAAAAAAAAAAAAAAAAAAAAAAAAAAAAAAAAAAAAAAAAAAAAA/AAAAAAAAAKCGAQAAAAAAAAAAAAAAAAAMAAAAAQAAAAAAAAAAAAAAAAAAAB8AAABUAAAAAAAABQAAAAEAAAAAAAAAAAAAAAAAAAAAAAAAAAAAAAAAAAAAAAAAAAAAAAJ/f38AAAAAA8zMzADAwP8Af39/AAAAAAAAAAAAAAAAAAAAAAAAAAAAIQAAABgAAAAUAAAAwTUAABsnAABARwAAWSkAABAAAAAmAAAACAAAAAAAAAAAAAAA"/>
               </a:ext>
             </a:extLst>
           </p:cNvSpPr>
@@ -585,7 +580,7 @@
           <a:lstStyle/>
           <a:p>
             <a:pPr/>
-            <a:fld id="{511B0FC8-86BC-4EF9-F2A3-70AC41ED0425}" type="slidenum">
+            <a:fld id="{62202A29-678F-75DC-C198-918964D637C4}" type="slidenum">
               <a:t/>
             </a:fld>
           </a:p>
@@ -596,6 +591,7 @@
   <p:clrMapOvr>
     <a:masterClrMapping/>
   </p:clrMapOvr>
+  <p:hf hdr="0" ftr="0"/>
 </p:sldLayout>
 </file>
 
@@ -623,7 +619,7 @@
             <a:spLocks noGrp="1" noChangeArrowheads="1"/>
             <a:extLst>
               <a:ext uri="smNativeData">
-                <pr:smNativeData xmlns:pr="smNativeData" xmlns="smNativeData" val="SMDATA_15_AnHWaRMAAAAlAAAAZAAAAA8BAAAAkAAAAEgAAACQAAAASAAAAAAAAAACAAAAAQAAAAEAAABQAAAAAAAAAAAA4D8AAAAAAADgPwAAAAAAAOA/AAAAAAAA4D8AAAAAAADgPwAAAAAAAOA/AAAAAAAA4D8AAAAAAADgPwAAAAAAAOA/AAAAAAAA4D8CAAAAjAAAAAAAAAAAAAAAu+DjDP///wgAAAAAAAAAAAAAAAAAAAAAAAAAAAAAAAAAAAAAZAAAAAEAAABAAAAAAAAAAAAAAAAAAAAAAAAAAAAAAAAAAAAAAAAAAAAAAAAAAAAAAAAAAAAAAAAAAAAAAAAAAAAAAAAAAAAAAAAAAAAAAAAAAAAAAAAAAAAAAAAAAAAAFAAAADwAAAAAAAAAAAAAAAAAAAkUAAAAAQAAABQAAAAUAAAAFAAAAAEAAAAAAAAAZAAAAGQAAAAAAAAAZAAAAGQAAAAVAAAAYAAAAAAAAAAAAAAADwAAACADAAAAAAAAAAAAAAEAAACgMgAAVgcAAKr4//8BAAAAf39/AAEAAABkAAAAAAAAABQAAABAHwAAAAAAACYAAAAAAAAAwOD//wAAAAAmAAAAZAAAABYAAABMAAAAAAAAAAAAAAAEAAAAAAAAAAEAAACAgIAKAAAAACgAAAAoAAAAZAAAAGQAAAAAAAAAzMzMAAAAAABQAAAAUAAAAGQAAABkAAAAAAAAABcAAAAUAAAAAAAAAAAAAAD/fwAA/38AAAAAAAAJAAAABAAAAAAAAAAeAAAAaAAAAAAAAAAAAAAAAAAAAAAAAAAAAAAAECcAABAnAAAAAAAAAAAAAAAAAAAAAAAAAAAAAAAAAAAAAAAAAAAAABQAAAAAAAAAwMD/AAAAAABkAAAAMgAAAAAAAABkAAAAAAAAAH9/fwAKAAAAIgAAABgAAAAAAAAAAAAAAAAAAAAAAAAAAAAAAAAAAAAkAAAAJAAAAAAAAAAHAAAAAAAAAAAAAAAAAAAAAAAAAAAAAAAAAAAAf39/ACUAAABYAAAAAAAAAAAAAAAAAAAAAAAAAAAAAAAAAAAAAAAAAAAAAAAAAAAAAAAAAAAAAAA/AAAAAAAAAKCGAQAAAAAAAAAAAAAAAAAMAAAAAQAAAAAAAAAAAAAAAAAAAB8AAABUAAAAAAAABQAAAAEAAAAAAAAAAAAAAAAAAAAAAAAAAAAAAAAAAAAAAAAAAAAAAAJ/f38AAAAAA8zMzADAwP8Af39/AAAAAAAAAAAAAAAAAAAAAAAAAAAAIQAAABgAAAAUAAAAYDYAALABAABARwAAsCUAABAAAAAmAAAACAAAAIMAAAAAAAAA"/>
+                <pr:smNativeData xmlns:pr="smNativeData" xmlns="smNativeData" val="SMDATA_15_7aDWaRMAAAAlAAAAZAAAAA8BAAAAkAAAAEgAAACQAAAASAAAAAAAAAACAAAAAQAAAAEAAABQAAAAAAAAAAAA4D8AAAAAAADgPwAAAAAAAOA/AAAAAAAA4D8AAAAAAADgPwAAAAAAAOA/AAAAAAAA4D8AAAAAAADgPwAAAAAAAOA/AAAAAAAA4D8CAAAAjAAAAAAAAAAAAAAAu+DjDP///wgAAAAAAAAAAAAAAAAAAAAAAAAAAAAAAAAAAAAAZAAAAAEAAABAAAAAAAAAAAAAAAAAAAAAAAAAAAAAAAAAAAAAAAAAAAAAAAAAAAAAAAAAAAAAAAAAAAAAAAAAAAAAAAAAAAAAAAAAAAAAAAAAAAAAAAAAAAAAAAAAAAAAFAAAADwAAAAAAAAAAAAAAAAAAAkUAAAAAQAAABQAAAAUAAAAFAAAAAEAAAAAAAAAZAAAAGQAAAAAAAAAZAAAAGQAAAAVAAAAYAAAAAAAAAAAAAAADwAAACADAAAAAAAAAAAAAAEAAACgMgAAVgcAAKr4//8BAAAAf39/AAEAAABkAAAAAAAAABQAAABAHwAAAAAAACYAAAAAAAAAwOD//wAAAAAmAAAAZAAAABYAAABMAAAAAAAAAAAAAAAEAAAAAAAAAAEAAACAgIAKAAAAACgAAAAoAAAAZAAAAGQAAAAAAAAAzMzMAAAAAABQAAAAUAAAAGQAAABkAAAAAAAAABcAAAAUAAAAAAAAAAAAAAD/fwAA/38AAAAAAAAJAAAABAAAAAAAAAAeAAAAaAAAAAAAAAAAAAAAAAAAAAAAAAAAAAAAECcAABAnAAAAAAAAAAAAAAAAAAAAAAAAAAAAAAAAAAAAAAAAAAAAABQAAAAAAAAAwMD/AAAAAABkAAAAMgAAAAAAAABkAAAAAAAAAH9/fwAKAAAAIgAAABgAAAAAAAAAAAAAAAAAAAAAAAAAAAAAAAAAAAAkAAAAJAAAAAAAAAAHAAAAAAAAAAAAAAAAAAAAAAAAAAAAAAAAAAAAf39/ACUAAABYAAAAAAAAAAAAAAAAAAAAAAAAAAAAAAAAAAAAAAAAAAAAAAAAAAAAAAAAAAAAAAA/AAAAAAAAAKCGAQAAAAAAAAAAAAAAAAAMAAAAAQAAAAAAAAAAAAAAAAAAAB8AAABUAAAAAAAABQAAAAEAAAAAAAAAAAAAAAAAAAAAAAAAAAAAAAAAAAAAAAAAAAAAAAJ/f38AAAAAA8zMzADAwP8Af39/AAAAAAAAAAAAAAAAAAAAAAAAAAAAIQAAABgAAAAUAAAAYDYAALABAABARwAAsCUAABAAAAAmAAAACAAAAIMAAAAAAAAA"/>
               </a:ext>
             </a:extLst>
           </p:cNvSpPr>
@@ -659,7 +655,7 @@
             <a:spLocks noGrp="1" noChangeArrowheads="1"/>
             <a:extLst>
               <a:ext uri="smNativeData">
-                <pr:smNativeData xmlns:pr="smNativeData" xmlns="smNativeData" val="SMDATA_15_AnHWaRMAAAAlAAAAZAAAAA8BAAAAkAAAAEgAAACQAAAASAAAAAAAAAAAAAAAAQAAAAEAAABQAAAAAAAAAAAA4D8AAAAAAADgPwAAAAAAAOA/AAAAAAAA4D8AAAAAAADgPwAAAAAAAOA/AAAAAAAA4D8AAAAAAADgPwAAAAAAAOA/AAAAAAAA4D8CAAAAjAAAAAAAAAAAAAAAu+DjDP///wgAAAAAAAAAAAAAAAAAAAAAAAAAAAAAAAAAAAAAZAAAAAEAAABAAAAAAAAAAAAAAAAAAAAAAAAAAAAAAAAAAAAAAAAAAAAAAAAAAAAAAAAAAAAAAAAAAAAAAAAAAAAAAAAAAAAAAAAAAAAAAAAAAAAAAAAAAAAAAAAAAAAAFAAAADwAAAAAAAAAAAAAAAAAAAkUAAAAAQAAABQAAAAUAAAAFAAAAAEAAAAAAAAAZAAAAGQAAAAAAAAAZAAAAGQAAAAVAAAAYAAAAAAAAAAAAAAADwAAACADAAAAAAAAAAAAAAEAAACgMgAAVgcAAKr4//8BAAAAf39/AAEAAABkAAAAAAAAABQAAABAHwAAAAAAACYAAAAAAAAAwOD//wAAAAAmAAAAZAAAABYAAABMAAAAAAAAAAAAAAAEAAAAAAAAAAEAAACAgIAKAAAAACgAAAAoAAAAZAAAAGQAAAAAAAAAzMzMAAAAAABQAAAAUAAAAGQAAABkAAAAAAAAABcAAAAUAAAAAAAAAAAAAAD/fwAA/38AAAAAAAAJAAAABAAAAAAAAAAeAAAAaAAAAAAAAAAAAAAAAAAAAAAAAAAAAAAAECcAABAnAAAAAAAAAAAAAAAAAAAAAAAAAAAAAAAAAAAAAAAAAAAAABQAAAAAAAAAwMD/AAAAAABkAAAAMgAAAAAAAABkAAAAAAAAAH9/fwAKAAAAIgAAABgAAAAAAAAAAAAAAAAAAAAAAAAAAAAAAAAAAAAkAAAAJAAAAAAAAAAHAAAAAAAAAAAAAAAAAAAAAAAAAAAAAAAAAAAAf39/ACUAAABYAAAAAAAAAAAAAAAAAAAAAAAAAAAAAAAAAAAAAAAAAAAAAAAAAAAAAAAAAAAAAAA/AAAAAAAAAKCGAQAAAAAAAAAAAAAAAAAMAAAAAQAAAAAAAAAAAAAAAAAAAB8AAABUAAAAAAAABQAAAAEAAAAAAAAAAAAAAAAAAAAAAAAAAAAAAAAAAAAAAAAAAAAAAAJ/f38AAAAAA8zMzADAwP8Af39/AAAAAAAAAAAAAAAAAAAAAAAAAAAAIQAAABgAAAAUAAAAwAMAALABAAAfNQAAsCUAABAAAAAmAAAACAAAAAMAAAAAAAAA"/>
+                <pr:smNativeData xmlns:pr="smNativeData" xmlns="smNativeData" val="SMDATA_15_7aDWaRMAAAAlAAAAZAAAAA8BAAAAkAAAAEgAAACQAAAASAAAAAAAAAAAAAAAAQAAAAEAAABQAAAAAAAAAAAA4D8AAAAAAADgPwAAAAAAAOA/AAAAAAAA4D8AAAAAAADgPwAAAAAAAOA/AAAAAAAA4D8AAAAAAADgPwAAAAAAAOA/AAAAAAAA4D8CAAAAjAAAAAAAAAAAAAAAu+DjDP///wgAAAAAAAAAAAAAAAAAAAAAAAAAAAAAAAAAAAAAZAAAAAEAAABAAAAAAAAAAAAAAAAAAAAAAAAAAAAAAAAAAAAAAAAAAAAAAAAAAAAAAAAAAAAAAAAAAAAAAAAAAAAAAAAAAAAAAAAAAAAAAAAAAAAAAAAAAAAAAAAAAAAAFAAAADwAAAAAAAAAAAAAAAAAAAkUAAAAAQAAABQAAAAUAAAAFAAAAAEAAAAAAAAAZAAAAGQAAAAAAAAAZAAAAGQAAAAVAAAAYAAAAAAAAAAAAAAADwAAACADAAAAAAAAAAAAAAEAAACgMgAAVgcAAKr4//8BAAAAf39/AAEAAABkAAAAAAAAABQAAABAHwAAAAAAACYAAAAAAAAAwOD//wAAAAAmAAAAZAAAABYAAABMAAAAAAAAAAAAAAAEAAAAAAAAAAEAAACAgIAKAAAAACgAAAAoAAAAZAAAAGQAAAAAAAAAzMzMAAAAAABQAAAAUAAAAGQAAABkAAAAAAAAABcAAAAUAAAAAAAAAAAAAAD/fwAA/38AAAAAAAAJAAAABAAAAAAAAAAeAAAAaAAAAAAAAAAAAAAAAAAAAAAAAAAAAAAAECcAABAnAAAAAAAAAAAAAAAAAAAAAAAAAAAAAAAAAAAAAAAAAAAAABQAAAAAAAAAwMD/AAAAAABkAAAAMgAAAAAAAABkAAAAAAAAAH9/fwAKAAAAIgAAABgAAAAAAAAAAAAAAAAAAAAAAAAAAAAAAAAAAAAkAAAAJAAAAAAAAAAHAAAAAAAAAAAAAAAAAAAAAAAAAAAAAAAAAAAAf39/ACUAAABYAAAAAAAAAAAAAAAAAAAAAAAAAAAAAAAAAAAAAAAAAAAAAAAAAAAAAAAAAAAAAAA/AAAAAAAAAKCGAQAAAAAAAAAAAAAAAAAMAAAAAQAAAAAAAAAAAAAAAAAAAB8AAABUAAAAAAAABQAAAAEAAAAAAAAAAAAAAAAAAAAAAAAAAAAAAAAAAAAAAAAAAAAAAAJ/f38AAAAAA8zMzADAwP8Af39/AAAAAAAAAAAAAAAAAAAAAAAAAAAAIQAAABgAAAAUAAAAwAMAALABAAAfNQAAsCUAABAAAAAmAAAACAAAAAMAAAAAAAAA"/>
               </a:ext>
             </a:extLst>
           </p:cNvSpPr>
@@ -719,7 +715,7 @@
             <a:spLocks noGrp="1" noChangeArrowheads="1"/>
             <a:extLst>
               <a:ext uri="smNativeData">
-                <pr:smNativeData xmlns:pr="smNativeData" xmlns="smNativeData" val="SMDATA_15_AnHWaRMAAAAlAAAAZAAAAA8BAAAAkAAAAEgAAACQAAAASAAAAAAAAAABAAAAAAAAAAEAAABQAAAAAAAAAAAA4D8AAAAAAADgPwAAAAAAAOA/AAAAAAAA4D8AAAAAAADgPwAAAAAAAOA/AAAAAAAA4D8AAAAAAADgPwAAAAAAAOA/AAAAAAAA4D8CAAAAjAAAAAAAAAAAAAAAu+DjDP///wgAAAAAAAAAAAAAAAAAAAAAAAAAAAAAAAAAAAAAZAAAAAEAAABAAAAAAAAAAAAAAAAAAAAAAAAAAAAAAAAAAAAAAAAAAAAAAAAAAAAAAAAAAAAAAAAAAAAAAAAAAAAAAAAAAAAAAAAAAAAAAAAAAAAAAAAAAAAAAAAAAAAAFAAAADwAAAAAAAAAAAAAAAAAAAkUAAAAAQAAABQAAAAUAAAAFAAAAAEAAAAAAAAAZAAAAGQAAAAAAAAAZAAAAGQAAAAVAAAAYAAAAAAAAAAAAAAADwAAACADAAAAAAAAAAAAAAEAAACgMgAAVgcAAKr4//8BAAAAf39/AAEAAABkAAAAAAAAABQAAABAHwAAAAAAACYAAAAAAAAAwOD//wAAAAAmAAAAZAAAABYAAABMAAAAAAAAAAAAAAAEAAAAAAAAAAEAAACAgIAKAAAAACgAAAAoAAAAZAAAAGQAAAAAAAAAzMzMAAAAAABQAAAAUAAAAGQAAABkAAAAAAAAABcAAAAUAAAAAAAAAAAAAAD/fwAA/38AAAAAAAAJAAAABAAAAAAAAAAeAAAAaAAAAAAAAAAAAAAAAAAAAAAAAAAAAAAAECcAABAnAAAAAAAAAAAAAAAAAAAAAAAAAAAAAAAAAAAAAAAAAAAAABQAAAAAAAAAwMD/AAAAAABkAAAAMgAAAAAAAABkAAAAAAAAAH9/fwAKAAAAIgAAABgAAAAAAAAAAAAAAAAAAAAAAAAAAAAAAAAAAAAkAAAAJAAAAAAAAAAHAAAAAAAAAAAAAAAAAAAAAAAAAAAAAAAAAAAAf39/ACUAAABYAAAAAAAAAAAAAAAAAAAAAAAAAAAAAAAAAAAAAAAAAAAAAAAAAAAAAAAAAAAAAAA/AAAAAAAAAKCGAQAAAAAAAAAAAAAAAAAMAAAAAQAAAAAAAAAAAAAAAAAAAB8AAABUAAAAAAAABQAAAAEAAAAAAAAAAAAAAAAAAAAAAAAAAAAAAAAAAAAAAAAAAAAAAAJ/f38AAAAAA8zMzADAwP8Af39/AAAAAAAAAAAAAAAAAAAAAAAAAAAAIQAAABgAAAAUAAAAwAMAABsnAAA/FQAAWSkAABAAAAAmAAAACAAAAAAAAAAAAAAA"/>
+                <pr:smNativeData xmlns:pr="smNativeData" xmlns="smNativeData" val="SMDATA_15_7aDWaRMAAAAlAAAAZAAAAA8BAAAAkAAAAEgAAACQAAAASAAAAAAAAAABAAAAAAAAAAEAAABQAAAAAAAAAAAA4D8AAAAAAADgPwAAAAAAAOA/AAAAAAAA4D8AAAAAAADgPwAAAAAAAOA/AAAAAAAA4D8AAAAAAADgPwAAAAAAAOA/AAAAAAAA4D8CAAAAjAAAAAAAAAAAAAAAu+DjDP///wgAAAAAAAAAAAAAAAAAAAAAAAAAAAAAAAAAAAAAZAAAAAEAAABAAAAAAAAAAAAAAAAAAAAAAAAAAAAAAAAAAAAAAAAAAAAAAAAAAAAAAAAAAAAAAAAAAAAAAAAAAAAAAAAAAAAAAAAAAAAAAAAAAAAAAAAAAAAAAAAAAAAAFAAAADwAAAAAAAAAAAAAAAAAAAkUAAAAAQAAABQAAAAUAAAAFAAAAAEAAAAAAAAAZAAAAGQAAAAAAAAAZAAAAGQAAAAVAAAAYAAAAAAAAAAAAAAADwAAACADAAAAAAAAAAAAAAEAAACgMgAAVgcAAKr4//8BAAAAf39/AAEAAABkAAAAAAAAABQAAABAHwAAAAAAACYAAAAAAAAAwOD//wAAAAAmAAAAZAAAABYAAABMAAAAAAAAAAAAAAAEAAAAAAAAAAEAAACAgIAKAAAAACgAAAAoAAAAZAAAAGQAAAAAAAAAzMzMAAAAAABQAAAAUAAAAGQAAABkAAAAAAAAABcAAAAUAAAAAAAAAAAAAAD/fwAA/38AAAAAAAAJAAAABAAAAAAAAAAeAAAAaAAAAAAAAAAAAAAAAAAAAAAAAAAAAAAAECcAABAnAAAAAAAAAAAAAAAAAAAAAAAAAAAAAAAAAAAAAAAAAAAAABQAAAAAAAAAwMD/AAAAAABkAAAAMgAAAAAAAABkAAAAAAAAAH9/fwAKAAAAIgAAABgAAAAAAAAAAAAAAAAAAAAAAAAAAAAAAAAAAAAkAAAAJAAAAAAAAAAHAAAAAAAAAAAAAAAAAAAAAAAAAAAAAAAAAAAAf39/ACUAAABYAAAAAAAAAAAAAAAAAAAAAAAAAAAAAAAAAAAAAAAAAAAAAAAAAAAAAAAAAAAAAAA/AAAAAAAAAKCGAQAAAAAAAAAAAAAAAAAMAAAAAQAAAAAAAAAAAAAAAAAAAB8AAABUAAAAAAAABQAAAAEAAAAAAAAAAAAAAAAAAAAAAAAAAAAAAAAAAAAAAAAAAAAAAAJ/f38AAAAAA8zMzADAwP8Af39/AAAAAAAAAAAAAAAAAAAAAAAAAAAAIQAAABgAAAAUAAAAwAMAABsnAAA/FQAAWSkAABAAAAAmAAAACAAAAAAAAAAAAAAA"/>
               </a:ext>
             </a:extLst>
           </p:cNvSpPr>
@@ -733,7 +729,7 @@
           <a:lstStyle/>
           <a:p>
             <a:pPr/>
-            <a:fld id="{3437F13C-72D9-6207-978F-8452BFC161D1}" type="datetime1">
+            <a:fld id="{2FA06291-DFC2-F594-8C18-29C12C567A7C}" type="datetime1">
               <a:t/>
             </a:fld>
           </a:p>
@@ -746,7 +742,7 @@
             <a:spLocks noGrp="1" noChangeArrowheads="1"/>
             <a:extLst>
               <a:ext uri="smNativeData">
-                <pr:smNativeData xmlns:pr="smNativeData" xmlns="smNativeData" val="SMDATA_15_AnHWaRMAAAAlAAAAZAAAAA8BAAAAkAAAAEgAAACQAAAASAAAAAAAAAABAAAAAAAAAAEAAABQAAAAAAAAAAAA4D8AAAAAAADgPwAAAAAAAOA/AAAAAAAA4D8AAAAAAADgPwAAAAAAAOA/AAAAAAAA4D8AAAAAAADgPwAAAAAAAOA/AAAAAAAA4D8CAAAAjAAAAAAAAAAAAAAAu+DjDP///wgAAAAAAAAAAAAAAAAAAAAAAAAAAAAAAAAAAAAAZAAAAAEAAABAAAAAAAAAAAAAAAAAAAAAAAAAAAAAAAAAAAAAAAAAAAAAAAAAAAAAAAAAAAAAAAAAAAAAAAAAAAAAAAAAAAAAAAAAAAAAAAAAAAAAAAAAAAAAAAAAAAAAFAAAADwAAAAAAAAAAAAAAAAAAAkUAAAAAQAAABQAAAAUAAAAFAAAAAEAAAAAAAAAZAAAAGQAAAAAAAAAZAAAAGQAAAAVAAAAYAAAAAAAAAAAAAAADwAAACADAAAAAAAAAAAAAAEAAACgMgAAVgcAAKr4//8BAAAAf39/AAEAAABkAAAAAAAAABQAAABAHwAAAAAAACYAAAAAAAAAwOD//wAAAAAmAAAAZAAAABYAAABMAAAAAAAAAAAAAAAEAAAAAAAAAAEAAACAgIAKAAAAACgAAAAoAAAAZAAAAGQAAAAAAAAAzMzMAAAAAABQAAAAUAAAAGQAAABkAAAAAAAAABcAAAAUAAAAAAAAAAAAAAD/fwAA/38AAAAAAAAJAAAABAAAAAAAAAAeAAAAaAAAAAAAAAAAAAAAAAAAAAAAAAAAAAAAECcAABAnAAAAAAAAAAAAAAAAAAAAAAAAAAAAAAAAAAAAAAAAAAAAABQAAAAAAAAAwMD/AAAAAABkAAAAMgAAAAAAAABkAAAAAAAAAH9/fwAKAAAAIgAAABgAAAAAAAAAAAAAAAAAAAAAAAAAAAAAAAAAAAAkAAAAJAAAAAAAAAAHAAAAAAAAAAAAAAAAAAAAAAAAAAAAAAAAAAAAf39/ACUAAABYAAAAAAAAAAAAAAAAAAAAAAAAAAAAAAAAAAAAAAAAAAAAAAAAAAAAAAAAAAAAAAA/AAAAAAAAAKCGAQAAAAAAAAAAAAAAAAAMAAAAAQAAAAAAAAAAAAAAAAAAAB8AAABUAAAAAAAABQAAAAEAAAAAAAAAAAAAAAAAAAAAAAAAAAAAAAAAAAAAAAAAAAAAAAJ/f38AAAAAA8zMzADAwP8Af39/AAAAAAAAAAAAAAAAAAAAAAAAAAAAIQAAABgAAAAUAAAAoRkAABsnAABfMQAAWSkAABAAAAAmAAAACAAAAAAAAAAAAAAA"/>
+                <pr:smNativeData xmlns:pr="smNativeData" xmlns="smNativeData" val="SMDATA_15_7aDWaRMAAAAlAAAAZAAAAA8BAAAAkAAAAEgAAACQAAAASAAAAAAAAAABAAAAAAAAAAEAAABQAAAAAAAAAAAA4D8AAAAAAADgPwAAAAAAAOA/AAAAAAAA4D8AAAAAAADgPwAAAAAAAOA/AAAAAAAA4D8AAAAAAADgPwAAAAAAAOA/AAAAAAAA4D8CAAAAjAAAAAAAAAAAAAAAu+DjDP///wgAAAAAAAAAAAAAAAAAAAAAAAAAAAAAAAAAAAAAZAAAAAEAAABAAAAAAAAAAAAAAAAAAAAAAAAAAAAAAAAAAAAAAAAAAAAAAAAAAAAAAAAAAAAAAAAAAAAAAAAAAAAAAAAAAAAAAAAAAAAAAAAAAAAAAAAAAAAAAAAAAAAAFAAAADwAAAAAAAAAAAAAAAAAAAkUAAAAAQAAABQAAAAUAAAAFAAAAAEAAAAAAAAAZAAAAGQAAAAAAAAAZAAAAGQAAAAVAAAAYAAAAAAAAAAAAAAADwAAACADAAAAAAAAAAAAAAEAAACgMgAAVgcAAKr4//8BAAAAf39/AAEAAABkAAAAAAAAABQAAABAHwAAAAAAACYAAAAAAAAAwOD//wAAAAAmAAAAZAAAABYAAABMAAAAAAAAAAAAAAAEAAAAAAAAAAEAAACAgIAKAAAAACgAAAAoAAAAZAAAAGQAAAAAAAAAzMzMAAAAAABQAAAAUAAAAGQAAABkAAAAAAAAABcAAAAUAAAAAAAAAAAAAAD/fwAA/38AAAAAAAAJAAAABAAAAAAAAAAeAAAAaAAAAAAAAAAAAAAAAAAAAAAAAAAAAAAAECcAABAnAAAAAAAAAAAAAAAAAAAAAAAAAAAAAAAAAAAAAAAAAAAAABQAAAAAAAAAwMD/AAAAAABkAAAAMgAAAAAAAABkAAAAAAAAAH9/fwAKAAAAIgAAABgAAAAAAAAAAAAAAAAAAAAAAAAAAAAAAAAAAAAkAAAAJAAAAAAAAAAHAAAAAAAAAAAAAAAAAAAAAAAAAAAAAAAAAAAAf39/ACUAAABYAAAAAAAAAAAAAAAAAAAAAAAAAAAAAAAAAAAAAAAAAAAAAAAAAAAAAAAAAAAAAAA/AAAAAAAAAKCGAQAAAAAAAAAAAAAAAAAMAAAAAQAAAAAAAAAAAAAAAAAAAB8AAABUAAAAAAAABQAAAAEAAAAAAAAAAAAAAAAAAAAAAAAAAAAAAAAAAAAAAAAAAAAAAAJ/f38AAAAAA8zMzADAwP8Af39/AAAAAAAAAAAAAAAAAAAAAAAAAAAAIQAAABgAAAAUAAAAoRkAABsnAABfMQAAWSkAABAAAAAmAAAACAAAAAAAAAAAAAAA"/>
               </a:ext>
             </a:extLst>
           </p:cNvSpPr>
@@ -760,9 +756,6 @@
           <a:lstStyle/>
           <a:p>
             <a:pPr/>
-            <a:r>
-              <a:t/>
-            </a:r>
           </a:p>
         </p:txBody>
       </p:sp>
@@ -773,7 +766,7 @@
             <a:spLocks noGrp="1" noChangeArrowheads="1"/>
             <a:extLst>
               <a:ext uri="smNativeData">
-                <pr:smNativeData xmlns:pr="smNativeData" xmlns="smNativeData" val="SMDATA_15_AnHWaRMAAAAlAAAAZAAAAA8BAAAAkAAAAEgAAACQAAAASAAAAAAAAAABAAAAAAAAAAEAAABQAAAAAAAAAAAA4D8AAAAAAADgPwAAAAAAAOA/AAAAAAAA4D8AAAAAAADgPwAAAAAAAOA/AAAAAAAA4D8AAAAAAADgPwAAAAAAAOA/AAAAAAAA4D8CAAAAjAAAAAAAAAAAAAAAu+DjDP///wgAAAAAAAAAAAAAAAAAAAAAAAAAAAAAAAAAAAAAZAAAAAEAAABAAAAAAAAAAAAAAAAAAAAAAAAAAAAAAAAAAAAAAAAAAAAAAAAAAAAAAAAAAAAAAAAAAAAAAAAAAAAAAAAAAAAAAAAAAAAAAAAAAAAAAAAAAAAAAAAAAAAAFAAAADwAAAAAAAAAAAAAAAAAAAkUAAAAAQAAABQAAAAUAAAAFAAAAAEAAAAAAAAAZAAAAGQAAAAAAAAAZAAAAGQAAAAVAAAAYAAAAAAAAAAAAAAADwAAACADAAAAAAAAAAAAAAEAAACgMgAAVgcAAKr4//8BAAAAf39/AAEAAABkAAAAAAAAABQAAABAHwAAAAAAACYAAAAAAAAAwOD//wAAAAAmAAAAZAAAABYAAABMAAAAAAAAAAAAAAAEAAAAAAAAAAEAAACAgIAKAAAAACgAAAAoAAAAZAAAAGQAAAAAAAAAzMzMAAAAAABQAAAAUAAAAGQAAABkAAAAAAAAABcAAAAUAAAAAAAAAAAAAAD/fwAA/38AAAAAAAAJAAAABAAAAAAAAAAeAAAAaAAAAAAAAAAAAAAAAAAAAAAAAAAAAAAAECcAABAnAAAAAAAAAAAAAAAAAAAAAAAAAAAAAAAAAAAAAAAAAAAAABQAAAAAAAAAwMD/AAAAAABkAAAAMgAAAAAAAABkAAAAAAAAAH9/fwAKAAAAIgAAABgAAAAAAAAAAAAAAAAAAAAAAAAAAAAAAAAAAAAkAAAAJAAAAAAAAAAHAAAAAAAAAAAAAAAAAAAAAAAAAAAAAAAAAAAAf39/ACUAAABYAAAAAAAAAAAAAAAAAAAAAAAAAAAAAAAAAAAAAAAAAAAAAAAAAAAAAAAAAAAAAAA/AAAAAAAAAKCGAQAAAAAAAAAAAAAAAAAMAAAAAQAAAAAAAAAAAAAAAAAAAB8AAABUAAAAAAAABQAAAAEAAAAAAAAAAAAAAAAAAAAAAAAAAAAAAAAAAAAAAAAAAAAAAAJ/f38AAAAAA8zMzADAwP8Af39/AAAAAAAAAAAAAAAAAAAAAAAAAAAAIQAAABgAAAAUAAAAwTUAABsnAABARwAAWSkAABAAAAAmAAAACAAAAAAAAAAAAAAA"/>
+                <pr:smNativeData xmlns:pr="smNativeData" xmlns="smNativeData" val="SMDATA_15_7aDWaRMAAAAlAAAAZAAAAA8BAAAAkAAAAEgAAACQAAAASAAAAAAAAAABAAAAAAAAAAEAAABQAAAAAAAAAAAA4D8AAAAAAADgPwAAAAAAAOA/AAAAAAAA4D8AAAAAAADgPwAAAAAAAOA/AAAAAAAA4D8AAAAAAADgPwAAAAAAAOA/AAAAAAAA4D8CAAAAjAAAAAAAAAAAAAAAu+DjDP///wgAAAAAAAAAAAAAAAAAAAAAAAAAAAAAAAAAAAAAZAAAAAEAAABAAAAAAAAAAAAAAAAAAAAAAAAAAAAAAAAAAAAAAAAAAAAAAAAAAAAAAAAAAAAAAAAAAAAAAAAAAAAAAAAAAAAAAAAAAAAAAAAAAAAAAAAAAAAAAAAAAAAAFAAAADwAAAAAAAAAAAAAAAAAAAkUAAAAAQAAABQAAAAUAAAAFAAAAAEAAAAAAAAAZAAAAGQAAAAAAAAAZAAAAGQAAAAVAAAAYAAAAAAAAAAAAAAADwAAACADAAAAAAAAAAAAAAEAAACgMgAAVgcAAKr4//8BAAAAf39/AAEAAABkAAAAAAAAABQAAABAHwAAAAAAACYAAAAAAAAAwOD//wAAAAAmAAAAZAAAABYAAABMAAAAAAAAAAAAAAAEAAAAAAAAAAEAAACAgIAKAAAAACgAAAAoAAAAZAAAAGQAAAAAAAAAzMzMAAAAAABQAAAAUAAAAGQAAABkAAAAAAAAABcAAAAUAAAAAAAAAAAAAAD/fwAA/38AAAAAAAAJAAAABAAAAAAAAAAeAAAAaAAAAAAAAAAAAAAAAAAAAAAAAAAAAAAAECcAABAnAAAAAAAAAAAAAAAAAAAAAAAAAAAAAAAAAAAAAAAAAAAAABQAAAAAAAAAwMD/AAAAAABkAAAAMgAAAAAAAABkAAAAAAAAAH9/fwAKAAAAIgAAABgAAAAAAAAAAAAAAAAAAAAAAAAAAAAAAAAAAAAkAAAAJAAAAAAAAAAHAAAAAAAAAAAAAAAAAAAAAAAAAAAAAAAAAAAAf39/ACUAAABYAAAAAAAAAAAAAAAAAAAAAAAAAAAAAAAAAAAAAAAAAAAAAAAAAAAAAAAAAAAAAAA/AAAAAAAAAKCGAQAAAAAAAAAAAAAAAAAMAAAAAQAAAAAAAAAAAAAAAAAAAB8AAABUAAAAAAAABQAAAAEAAAAAAAAAAAAAAAAAAAAAAAAAAAAAAAAAAAAAAAAAAAAAAAJ/f38AAAAAA8zMzADAwP8Af39/AAAAAAAAAAAAAAAAAAAAAAAAAAAAIQAAABgAAAAUAAAAwTUAABsnAABARwAAWSkAABAAAAAmAAAACAAAAAAAAAAAAAAA"/>
               </a:ext>
             </a:extLst>
           </p:cNvSpPr>
@@ -787,7 +780,7 @@
           <a:lstStyle/>
           <a:p>
             <a:pPr/>
-            <a:fld id="{4F5F3D26-68A2-0ACB-ECE7-9E9E73A91ACB}" type="slidenum">
+            <a:fld id="{3F1875E0-AED2-4D83-9CA0-58D63BEE6A0D}" type="slidenum">
               <a:t/>
             </a:fld>
           </a:p>
@@ -798,6 +791,7 @@
   <p:clrMapOvr>
     <a:masterClrMapping/>
   </p:clrMapOvr>
+  <p:hf hdr="0" ftr="0"/>
 </p:sldLayout>
 </file>
 
@@ -825,7 +819,7 @@
             <a:spLocks noGrp="1" noChangeArrowheads="1"/>
             <a:extLst>
               <a:ext uri="smNativeData">
-                <pr:smNativeData xmlns:pr="smNativeData" xmlns="smNativeData" val="SMDATA_15_AnHWaRMAAAAlAAAAZAAAAA8BAAAAkAAAAEgAAACQAAAASAAAAAAAAAABAAAAAAAAAAEAAABQAAAAAAAAAAAA4D8AAAAAAADgPwAAAAAAAOA/AAAAAAAA4D8AAAAAAADgPwAAAAAAAOA/AAAAAAAA4D8AAAAAAADgPwAAAAAAAOA/AAAAAAAA4D8CAAAAjAAAAAAAAAAAAAAAu+DjDP///wgAAAAAAAAAAAAAAAAAAAAAAAAAAAAAAAAAAAAAZAAAAAEAAABAAAAAAAAAAAAAAAAAAAAAAAAAAAAAAAAAAAAAAAAAAAAAAAAAAAAAAAAAAAAAAAAAAAAAAAAAAAAAAAAAAAAAAAAAAAAAAAAAAAAAAAAAAAAAAAAAAAAAFAAAADwAAAAAAAAAAAAAAAAAAAkUAAAAAQAAABQAAAAUAAAAFAAAAAEAAAAAAAAAZAAAAGQAAAAAAAAAZAAAAGQAAAAVAAAAYAAAAAAAAAAAAAAADwAAACADAAAAAAAAAAAAAAEAAACgMgAAVgcAAKr4//8BAAAAf39/AAEAAABkAAAAAAAAABQAAABAHwAAAAAAACYAAAAAAAAAwOD//wAAAAAmAAAAZAAAABYAAABMAAAAAAAAAAAAAAAEAAAAAAAAAAEAAACAgIAKAAAAACgAAAAoAAAAZAAAAGQAAAAAAAAAzMzMAAAAAABQAAAAUAAAAGQAAABkAAAAAAAAABcAAAAUAAAAAAAAAAAAAAD/fwAA/38AAAAAAAAJAAAABAAAAAAAAAAeAAAAaAAAAAAAAAAAAAAAAAAAAAAAAAAAAAAAECcAABAnAAAAAAAAAAAAAAAAAAAAAAAAAAAAAAAAAAAAAAAAAAAAABQAAAAAAAAAwMD/AAAAAABkAAAAMgAAAAAAAABkAAAAAAAAAH9/fwAKAAAAIgAAABgAAAAAAAAAAAAAAAAAAAAAAAAAAAAAAAAAAAAkAAAAJAAAAAAAAAAHAAAAAAAAAAAAAAAAAAAAAAAAAAAAAAAAAAAAf39/ACUAAABYAAAAAAAAAAAAAAAAAAAAAAAAAAAAAAAAAAAAAAAAAAAAAAAAAAAAAAAAAAAAAAA/AAAAAAAAAKCGAQAAAAAAAAAAAAAAAAAMAAAAAQAAAAAAAAAAAAAAAAAAAB8AAABUAAAAAAAABQAAAAEAAAAAAAAAAAAAAAAAAAAAAAAAAAAAAAAAAAAAAAAAAAAAAAJ/f38AAAAAA8zMzADAwP8Af39/AAAAAAAAAAAAAAAAAAAAAAAAAAAAIQAAABgAAAAUAAAAwAMAALABAABARwAAuAgAABAAAAAmAAAACAAAAAAAAAAAAAAA"/>
+                <pr:smNativeData xmlns:pr="smNativeData" xmlns="smNativeData" val="SMDATA_15_7aDWaRMAAAAlAAAAZAAAAA8BAAAAkAAAAEgAAACQAAAASAAAAAAAAAABAAAAAAAAAAEAAABQAAAAAAAAAAAA4D8AAAAAAADgPwAAAAAAAOA/AAAAAAAA4D8AAAAAAADgPwAAAAAAAOA/AAAAAAAA4D8AAAAAAADgPwAAAAAAAOA/AAAAAAAA4D8CAAAAjAAAAAAAAAAAAAAAu+DjDP///wgAAAAAAAAAAAAAAAAAAAAAAAAAAAAAAAAAAAAAZAAAAAEAAABAAAAAAAAAAAAAAAAAAAAAAAAAAAAAAAAAAAAAAAAAAAAAAAAAAAAAAAAAAAAAAAAAAAAAAAAAAAAAAAAAAAAAAAAAAAAAAAAAAAAAAAAAAAAAAAAAAAAAFAAAADwAAAAAAAAAAAAAAAAAAAkUAAAAAQAAABQAAAAUAAAAFAAAAAEAAAAAAAAAZAAAAGQAAAAAAAAAZAAAAGQAAAAVAAAAYAAAAAAAAAAAAAAADwAAACADAAAAAAAAAAAAAAEAAACgMgAAVgcAAKr4//8BAAAAf39/AAEAAABkAAAAAAAAABQAAABAHwAAAAAAACYAAAAAAAAAwOD//wAAAAAmAAAAZAAAABYAAABMAAAAAAAAAAAAAAAEAAAAAAAAAAEAAACAgIAKAAAAACgAAAAoAAAAZAAAAGQAAAAAAAAAzMzMAAAAAABQAAAAUAAAAGQAAABkAAAAAAAAABcAAAAUAAAAAAAAAAAAAAD/fwAA/38AAAAAAAAJAAAABAAAAAAAAAAeAAAAaAAAAAAAAAAAAAAAAAAAAAAAAAAAAAAAECcAABAnAAAAAAAAAAAAAAAAAAAAAAAAAAAAAAAAAAAAAAAAAAAAABQAAAAAAAAAwMD/AAAAAABkAAAAMgAAAAAAAABkAAAAAAAAAH9/fwAKAAAAIgAAABgAAAAAAAAAAAAAAAAAAAAAAAAAAAAAAAAAAAAkAAAAJAAAAAAAAAAHAAAAAAAAAAAAAAAAAAAAAAAAAAAAAAAAAAAAf39/ACUAAABYAAAAAAAAAAAAAAAAAAAAAAAAAAAAAAAAAAAAAAAAAAAAAAAAAAAAAAAAAAAAAAA/AAAAAAAAAKCGAQAAAAAAAAAAAAAAAAAMAAAAAQAAAAAAAAAAAAAAAAAAAB8AAABUAAAAAAAABQAAAAEAAAAAAAAAAAAAAAAAAAAAAAAAAAAAAAAAAAAAAAAAAAAAAAJ/f38AAAAAA8zMzADAwP8Af39/AAAAAAAAAAAAAAAAAAAAAAAAAAAAIQAAABgAAAAUAAAAwAMAALABAABARwAAuAgAABAAAAAmAAAACAAAAAAAAAAAAAAA"/>
               </a:ext>
             </a:extLst>
           </p:cNvSpPr>
@@ -852,7 +846,7 @@
             <a:spLocks noGrp="1" noChangeArrowheads="1"/>
             <a:extLst>
               <a:ext uri="smNativeData">
-                <pr:smNativeData xmlns:pr="smNativeData" xmlns="smNativeData" val="SMDATA_15_AnHWaRMAAAAlAAAAZAAAAA8BAAAAkAAAAEgAAACQAAAASAAAAAAAAAAAAAAAAAAAAAEAAABQAAAAAAAAAAAA4D8AAAAAAADgPwAAAAAAAOA/AAAAAAAA4D8AAAAAAADgPwAAAAAAAOA/AAAAAAAA4D8AAAAAAADgPwAAAAAAAOA/AAAAAAAA4D8CAAAAjAAAAAAAAAAAAAAAu+DjDP///wgAAAAAAAAAAAAAAAAAAAAAAAAAAAAAAAAAAAAAZAAAAAEAAABAAAAAAAAAAAAAAAAAAAAAAAAAAAAAAAAAAAAAAAAAAAAAAAAAAAAAAAAAAAAAAAAAAAAAAAAAAAAAAAAAAAAAAAAAAAAAAAAAAAAAAAAAAAAAAAAAAAAAFAAAADwAAAAAAAAAAAAAAAAAAAkUAAAAAQAAABQAAAAUAAAAFAAAAAEAAAAAAAAAZAAAAGQAAAAAAAAAZAAAAGQAAAAVAAAAYAAAAAAAAAAAAAAADwAAACADAAAAAAAAAAAAAAEAAACgMgAAVgcAAKr4//8BAAAAf39/AAEAAABkAAAAAAAAABQAAABAHwAAAAAAACYAAAAAAAAAwOD//wAAAAAmAAAAZAAAABYAAABMAAAAAAAAAAAAAAAEAAAAAAAAAAEAAACAgIAKAAAAACgAAAAoAAAAZAAAAGQAAAAAAAAAzMzMAAAAAABQAAAAUAAAAGQAAABkAAAAAAAAABcAAAAUAAAAAAAAAAAAAAD/fwAA/38AAAAAAAAJAAAABAAAAAAAAAAeAAAAaAAAAAAAAAAAAAAAAAAAAAAAAAAAAAAAECcAABAnAAAAAAAAAAAAAAAAAAAAAAAAAAAAAAAAAAAAAAAAAAAAABQAAAAAAAAAwMD/AAAAAABkAAAAMgAAAAAAAABkAAAAAAAAAH9/fwAKAAAAIgAAABgAAAAAAAAAAAAAAAAAAAAAAAAAAAAAAAAAAAAkAAAAJAAAAAAAAAAHAAAAAAAAAAAAAAAAAAAAAAAAAAAAAAAAAAAAf39/ACUAAABYAAAAAAAAAAAAAAAAAAAAAAAAAAAAAAAAAAAAAAAAAAAAAAAAAAAAAAAAAAAAAAA/AAAAAAAAAKCGAQAAAAAAAAAAAAAAAAAMAAAAAQAAAAAAAAAAAAAAAAAAAB8AAABUAAAAAAAABQAAAAEAAAAAAAAAAAAAAAAAAAAAAAAAAAAAAAAAAAAAAAAAAAAAAAJ/f38AAAAAA8zMzADAwP8Af39/AAAAAAAAAAAAAAAAAAAAAAAAAAAAIQAAABgAAAAUAAAAwAMAANgJAABARwAAsCUAABAAAAAmAAAACAAAAAAAAAAAAAAA"/>
+                <pr:smNativeData xmlns:pr="smNativeData" xmlns="smNativeData" val="SMDATA_15_7aDWaRMAAAAlAAAAZAAAAA8BAAAAkAAAAEgAAACQAAAASAAAAAAAAAAAAAAAAAAAAAEAAABQAAAAAAAAAAAA4D8AAAAAAADgPwAAAAAAAOA/AAAAAAAA4D8AAAAAAADgPwAAAAAAAOA/AAAAAAAA4D8AAAAAAADgPwAAAAAAAOA/AAAAAAAA4D8CAAAAjAAAAAAAAAAAAAAAu+DjDP///wgAAAAAAAAAAAAAAAAAAAAAAAAAAAAAAAAAAAAAZAAAAAEAAABAAAAAAAAAAAAAAAAAAAAAAAAAAAAAAAAAAAAAAAAAAAAAAAAAAAAAAAAAAAAAAAAAAAAAAAAAAAAAAAAAAAAAAAAAAAAAAAAAAAAAAAAAAAAAAAAAAAAAFAAAADwAAAAAAAAAAAAAAAAAAAkUAAAAAQAAABQAAAAUAAAAFAAAAAEAAAAAAAAAZAAAAGQAAAAAAAAAZAAAAGQAAAAVAAAAYAAAAAAAAAAAAAAADwAAACADAAAAAAAAAAAAAAEAAACgMgAAVgcAAKr4//8BAAAAf39/AAEAAABkAAAAAAAAABQAAABAHwAAAAAAACYAAAAAAAAAwOD//wAAAAAmAAAAZAAAABYAAABMAAAAAAAAAAAAAAAEAAAAAAAAAAEAAACAgIAKAAAAACgAAAAoAAAAZAAAAGQAAAAAAAAAzMzMAAAAAABQAAAAUAAAAGQAAABkAAAAAAAAABcAAAAUAAAAAAAAAAAAAAD/fwAA/38AAAAAAAAJAAAABAAAAAAAAAAeAAAAaAAAAAAAAAAAAAAAAAAAAAAAAAAAAAAAECcAABAnAAAAAAAAAAAAAAAAAAAAAAAAAAAAAAAAAAAAAAAAAAAAABQAAAAAAAAAwMD/AAAAAABkAAAAMgAAAAAAAABkAAAAAAAAAH9/fwAKAAAAIgAAABgAAAAAAAAAAAAAAAAAAAAAAAAAAAAAAAAAAAAkAAAAJAAAAAAAAAAHAAAAAAAAAAAAAAAAAAAAAAAAAAAAAAAAAAAAf39/ACUAAABYAAAAAAAAAAAAAAAAAAAAAAAAAAAAAAAAAAAAAAAAAAAAAAAAAAAAAAAAAAAAAAA/AAAAAAAAAKCGAQAAAAAAAAAAAAAAAAAMAAAAAQAAAAAAAAAAAAAAAAAAAB8AAABUAAAAAAAABQAAAAEAAAAAAAAAAAAAAAAAAAAAAAAAAAAAAAAAAAAAAAAAAAAAAAJ/f38AAAAAA8zMzADAwP8Af39/AAAAAAAAAAAAAAAAAAAAAAAAAAAAIQAAABgAAAAUAAAAwAMAANgJAABARwAAsCUAABAAAAAmAAAACAAAAAAAAAAAAAAA"/>
               </a:ext>
             </a:extLst>
           </p:cNvSpPr>
@@ -903,7 +897,7 @@
             <a:spLocks noGrp="1" noChangeArrowheads="1"/>
             <a:extLst>
               <a:ext uri="smNativeData">
-                <pr:smNativeData xmlns:pr="smNativeData" xmlns="smNativeData" val="SMDATA_15_AnHWaRMAAAAlAAAAZAAAAA8BAAAAkAAAAEgAAACQAAAASAAAAAAAAAABAAAAAAAAAAEAAABQAAAAAAAAAAAA4D8AAAAAAADgPwAAAAAAAOA/AAAAAAAA4D8AAAAAAADgPwAAAAAAAOA/AAAAAAAA4D8AAAAAAADgPwAAAAAAAOA/AAAAAAAA4D8CAAAAjAAAAAAAAAAAAAAAu+DjDP///wgAAAAAAAAAAAAAAAAAAAAAAAAAAAAAAAAAAAAAZAAAAAEAAABAAAAAAAAAAAAAAAAAAAAAAAAAAAAAAAAAAAAAAAAAAAAAAAAAAAAAAAAAAAAAAAAAAAAAAAAAAAAAAAAAAAAAAAAAAAAAAAAAAAAAAAAAAAAAAAAAAAAAFAAAADwAAAAAAAAAAAAAAAAAAAkUAAAAAQAAABQAAAAUAAAAFAAAAAEAAAAAAAAAZAAAAGQAAAAAAAAAZAAAAGQAAAAVAAAAYAAAAAAAAAAAAAAADwAAACADAAAAAAAAAAAAAAEAAACgMgAAVgcAAKr4//8BAAAAf39/AAEAAABkAAAAAAAAABQAAABAHwAAAAAAACYAAAAAAAAAwOD//wAAAAAmAAAAZAAAABYAAABMAAAAAAAAAAAAAAAEAAAAAAAAAAEAAACAgIAKAAAAACgAAAAoAAAAZAAAAGQAAAAAAAAAzMzMAAAAAABQAAAAUAAAAGQAAABkAAAAAAAAABcAAAAUAAAAAAAAAAAAAAD/fwAA/38AAAAAAAAJAAAABAAAANw7IAEeAAAAaAAAAAAAAAAAAAAAAAAAAAAAAAAAAAAAECcAABAnAAAAAAAAAAAAAAAAAAAAAAAAAAAAAAAAAAAAAAAAAAAAABQAAAAAAAAAwMD/AAAAAABkAAAAMgAAAAAAAABkAAAAAAAAAH9/fwAKAAAAIgAAABgAAAAAAAAAAAAAAAAAAAAAAAAAAAAAAAAAAAAkAAAAJAAAAAAAAAAHAAAAAAAAAAAAAAAAAAAAAAAAAAAAAAAAAAAAf39/ACUAAABYAAAAAAAAAAAAAAAAAAAAAAAAAAAAAAAAAAAAAAAAAAAAAAAAAAAAAAAAAAAAAAA/AAAAAAAAAKCGAQAAAAAAAAAAAAAAAAAMAAAAAQAAAAAAAAAAAAAAAAAAAB8AAABUAAAAAAAABQAAAAEAAAAAAAAAAAAAAAAAAAAAAAAAAAAAAAAAAAAAAAAAAAAAAAJ/f38AAAAAA8zMzADAwP8Af39/AAAAAAAAAAAAAAAAAAAAAAAAAAAAIQAAABgAAAAUAAAAwAMAABsnAAA/FQAAWSkAABAAAAAmAAAACAAAAAAAAAAAAAAA"/>
+                <pr:smNativeData xmlns:pr="smNativeData" xmlns="smNativeData" val="SMDATA_15_7aDWaRMAAAAlAAAAZAAAAA8BAAAAkAAAAEgAAACQAAAASAAAAAAAAAABAAAAAAAAAAEAAABQAAAAAAAAAAAA4D8AAAAAAADgPwAAAAAAAOA/AAAAAAAA4D8AAAAAAADgPwAAAAAAAOA/AAAAAAAA4D8AAAAAAADgPwAAAAAAAOA/AAAAAAAA4D8CAAAAjAAAAAAAAAAAAAAAu+DjDP///wgAAAAAAAAAAAAAAAAAAAAAAAAAAAAAAAAAAAAAZAAAAAEAAABAAAAAAAAAAAAAAAAAAAAAAAAAAAAAAAAAAAAAAAAAAAAAAAAAAAAAAAAAAAAAAAAAAAAAAAAAAAAAAAAAAAAAAAAAAAAAAAAAAAAAAAAAAAAAAAAAAAAAFAAAADwAAAAAAAAAAAAAAAAAAAkUAAAAAQAAABQAAAAUAAAAFAAAAAEAAAAAAAAAZAAAAGQAAAAAAAAAZAAAAGQAAAAVAAAAYAAAAAAAAAAAAAAADwAAACADAAAAAAAAAAAAAAEAAACgMgAAVgcAAKr4//8BAAAAf39/AAEAAABkAAAAAAAAABQAAABAHwAAAAAAACYAAAAAAAAAwOD//wAAAAAmAAAAZAAAABYAAABMAAAAAAAAAAAAAAAEAAAAAAAAAAEAAACAgIAKAAAAACgAAAAoAAAAZAAAAGQAAAAAAAAAzMzMAAAAAABQAAAAUAAAAGQAAABkAAAAAAAAABcAAAAUAAAAAAAAAAAAAAD/fwAA/38AAAAAAAAJAAAABAAAANw7IAEeAAAAaAAAAAAAAAAAAAAAAAAAAAAAAAAAAAAAECcAABAnAAAAAAAAAAAAAAAAAAAAAAAAAAAAAAAAAAAAAAAAAAAAABQAAAAAAAAAwMD/AAAAAABkAAAAMgAAAAAAAABkAAAAAAAAAH9/fwAKAAAAIgAAABgAAAAAAAAAAAAAAAAAAAAAAAAAAAAAAAAAAAAkAAAAJAAAAAAAAAAHAAAAAAAAAAAAAAAAAAAAAAAAAAAAAAAAAAAAf39/ACUAAABYAAAAAAAAAAAAAAAAAAAAAAAAAAAAAAAAAAAAAAAAAAAAAAAAAAAAAAAAAAAAAAA/AAAAAAAAAKCGAQAAAAAAAAAAAAAAAAAMAAAAAQAAAAAAAAAAAAAAAAAAAB8AAABUAAAAAAAABQAAAAEAAAAAAAAAAAAAAAAAAAAAAAAAAAAAAAAAAAAAAAAAAAAAAAJ/f38AAAAAA8zMzADAwP8Af39/AAAAAAAAAAAAAAAAAAAAAAAAAAAAIQAAABgAAAAUAAAAwAMAABsnAAA/FQAAWSkAABAAAAAmAAAACAAAAAAAAAAAAAAA"/>
               </a:ext>
             </a:extLst>
           </p:cNvSpPr>
@@ -917,7 +911,7 @@
           <a:lstStyle/>
           <a:p>
             <a:pPr/>
-            <a:fld id="{329B34A5-EBDF-CEC2-9123-1D977A6D6748}" type="datetime1">
+            <a:fld id="{69BDC9B9-F784-E83F-CA05-016A874B3C54}" type="datetime1">
               <a:t/>
             </a:fld>
           </a:p>
@@ -930,7 +924,7 @@
             <a:spLocks noGrp="1" noChangeArrowheads="1"/>
             <a:extLst>
               <a:ext uri="smNativeData">
-                <pr:smNativeData xmlns:pr="smNativeData" xmlns="smNativeData" val="SMDATA_15_AnHWaRMAAAAlAAAAZAAAAA8BAAAAkAAAAEgAAACQAAAASAAAAAAAAAABAAAAAAAAAAEAAABQAAAAAAAAAAAA4D8AAAAAAADgPwAAAAAAAOA/AAAAAAAA4D8AAAAAAADgPwAAAAAAAOA/AAAAAAAA4D8AAAAAAADgPwAAAAAAAOA/AAAAAAAA4D8CAAAAjAAAAAAAAAAAAAAAu+DjDP///wgAAAAAAAAAAAAAAAAAAAAAAAAAAAAAAAAAAAAAZAAAAAEAAABAAAAAAAAAAAAAAAAAAAAAAAAAAAAAAAAAAAAAAAAAAAAAAAAAAAAAAAAAAAAAAAAAAAAAAAAAAAAAAAAAAAAAAAAAAAAAAAAAAAAAAAAAAAAAAAAAAAAAFAAAADwAAAAAAAAAAAAAAAAAAAkUAAAAAQAAABQAAAAUAAAAFAAAAAEAAAAAAAAAZAAAAGQAAAAAAAAAZAAAAGQAAAAVAAAAYAAAAAAAAAAAAAAADwAAACADAAAAAAAAAAAAAAEAAACgMgAAVgcAAKr4//8BAAAAf39/AAEAAABkAAAAAAAAABQAAABAHwAAAAAAACYAAAAAAAAAwOD//wAAAAAmAAAAZAAAABYAAABMAAAAAAAAAAAAAAAEAAAAAAAAAAEAAACAgIAKAAAAACgAAAAoAAAAZAAAAGQAAAAAAAAAzMzMAAAAAABQAAAAUAAAAGQAAABkAAAAAAAAABcAAAAUAAAAAAAAAAAAAAD/fwAA/38AAAAAAAAJAAAABAAAANw7IAEeAAAAaAAAAAAAAAAAAAAAAAAAAAAAAAAAAAAAECcAABAnAAAAAAAAAAAAAAAAAAAAAAAAAAAAAAAAAAAAAAAAAAAAABQAAAAAAAAAwMD/AAAAAABkAAAAMgAAAAAAAABkAAAAAAAAAH9/fwAKAAAAIgAAABgAAAAAAAAAAAAAAAAAAAAAAAAAAAAAAAAAAAAkAAAAJAAAAAAAAAAHAAAAAAAAAAAAAAAAAAAAAAAAAAAAAAAAAAAAf39/ACUAAABYAAAAAAAAAAAAAAAAAAAAAAAAAAAAAAAAAAAAAAAAAAAAAAAAAAAAAAAAAAAAAAA/AAAAAAAAAKCGAQAAAAAAAAAAAAAAAAAMAAAAAQAAAAAAAAAAAAAAAAAAAB8AAABUAAAAAAAABQAAAAEAAAAAAAAAAAAAAAAAAAAAAAAAAAAAAAAAAAAAAAAAAAAAAAJ/f38AAAAAA8zMzADAwP8Af39/AAAAAAAAAAAAAAAAAAAAAAAAAAAAIQAAABgAAAAUAAAAoRkAABsnAABfMQAAWSkAABAAAAAmAAAACAAAAAAAAAAAAAAA"/>
+                <pr:smNativeData xmlns:pr="smNativeData" xmlns="smNativeData" val="SMDATA_15_7aDWaRMAAAAlAAAAZAAAAA8BAAAAkAAAAEgAAACQAAAASAAAAAAAAAABAAAAAAAAAAEAAABQAAAAAAAAAAAA4D8AAAAAAADgPwAAAAAAAOA/AAAAAAAA4D8AAAAAAADgPwAAAAAAAOA/AAAAAAAA4D8AAAAAAADgPwAAAAAAAOA/AAAAAAAA4D8CAAAAjAAAAAAAAAAAAAAAu+DjDP///wgAAAAAAAAAAAAAAAAAAAAAAAAAAAAAAAAAAAAAZAAAAAEAAABAAAAAAAAAAAAAAAAAAAAAAAAAAAAAAAAAAAAAAAAAAAAAAAAAAAAAAAAAAAAAAAAAAAAAAAAAAAAAAAAAAAAAAAAAAAAAAAAAAAAAAAAAAAAAAAAAAAAAFAAAADwAAAAAAAAAAAAAAAAAAAkUAAAAAQAAABQAAAAUAAAAFAAAAAEAAAAAAAAAZAAAAGQAAAAAAAAAZAAAAGQAAAAVAAAAYAAAAAAAAAAAAAAADwAAACADAAAAAAAAAAAAAAEAAACgMgAAVgcAAKr4//8BAAAAf39/AAEAAABkAAAAAAAAABQAAABAHwAAAAAAACYAAAAAAAAAwOD//wAAAAAmAAAAZAAAABYAAABMAAAAAAAAAAAAAAAEAAAAAAAAAAEAAACAgIAKAAAAACgAAAAoAAAAZAAAAGQAAAAAAAAAzMzMAAAAAABQAAAAUAAAAGQAAABkAAAAAAAAABcAAAAUAAAAAAAAAAAAAAD/fwAA/38AAAAAAAAJAAAABAAAANw7IAEeAAAAaAAAAAAAAAAAAAAAAAAAAAAAAAAAAAAAECcAABAnAAAAAAAAAAAAAAAAAAAAAAAAAAAAAAAAAAAAAAAAAAAAABQAAAAAAAAAwMD/AAAAAABkAAAAMgAAAAAAAABkAAAAAAAAAH9/fwAKAAAAIgAAABgAAAAAAAAAAAAAAAAAAAAAAAAAAAAAAAAAAAAkAAAAJAAAAAAAAAAHAAAAAAAAAAAAAAAAAAAAAAAAAAAAAAAAAAAAf39/ACUAAABYAAAAAAAAAAAAAAAAAAAAAAAAAAAAAAAAAAAAAAAAAAAAAAAAAAAAAAAAAAAAAAA/AAAAAAAAAKCGAQAAAAAAAAAAAAAAAAAMAAAAAQAAAAAAAAAAAAAAAAAAAB8AAABUAAAAAAAABQAAAAEAAAAAAAAAAAAAAAAAAAAAAAAAAAAAAAAAAAAAAAAAAAAAAAJ/f38AAAAAA8zMzADAwP8Af39/AAAAAAAAAAAAAAAAAAAAAAAAAAAAIQAAABgAAAAUAAAAoRkAABsnAABfMQAAWSkAABAAAAAmAAAACAAAAAAAAAAAAAAA"/>
               </a:ext>
             </a:extLst>
           </p:cNvSpPr>
@@ -944,9 +938,6 @@
           <a:lstStyle/>
           <a:p>
             <a:pPr/>
-            <a:r>
-              <a:t/>
-            </a:r>
           </a:p>
         </p:txBody>
       </p:sp>
@@ -957,7 +948,7 @@
             <a:spLocks noGrp="1" noChangeArrowheads="1"/>
             <a:extLst>
               <a:ext uri="smNativeData">
-                <pr:smNativeData xmlns:pr="smNativeData" xmlns="smNativeData" val="SMDATA_15_AnHWaRMAAAAlAAAAZAAAAA8BAAAAkAAAAEgAAACQAAAASAAAAAAAAAABAAAAAAAAAAEAAABQAAAAAAAAAAAA4D8AAAAAAADgPwAAAAAAAOA/AAAAAAAA4D8AAAAAAADgPwAAAAAAAOA/AAAAAAAA4D8AAAAAAADgPwAAAAAAAOA/AAAAAAAA4D8CAAAAjAAAAAAAAAAAAAAAu+DjDP///wgAAAAAAAAAAAAAAAAAAAAAAAAAAAAAAAAAAAAAZAAAAAEAAABAAAAAAAAAAAAAAAAAAAAAAAAAAAAAAAAAAAAAAAAAAAAAAAAAAAAAAAAAAAAAAAAAAAAAAAAAAAAAAAAAAAAAAAAAAAAAAAAAAAAAAAAAAAAAAAAAAAAAFAAAADwAAAAAAAAAAAAAAAAAAAkUAAAAAQAAABQAAAAUAAAAFAAAAAEAAAAAAAAAZAAAAGQAAAAAAAAAZAAAAGQAAAAVAAAAYAAAAAAAAAAAAAAADwAAACADAAAAAAAAAAAAAAEAAACgMgAAVgcAAKr4//8BAAAAf39/AAEAAABkAAAAAAAAABQAAABAHwAAAAAAACYAAAAAAAAAwOD//wAAAAAmAAAAZAAAABYAAABMAAAAAAAAAAAAAAAEAAAAAAAAAAEAAACAgIAKAAAAACgAAAAoAAAAZAAAAGQAAAAAAAAAzMzMAAAAAABQAAAAUAAAAGQAAABkAAAAAAAAABcAAAAUAAAAAAAAAAAAAAD/fwAA/38AAAAAAAAJAAAABAAAAAAAAAAeAAAAaAAAAAAAAAAAAAAAAAAAAAAAAAAAAAAAECcAABAnAAAAAAAAAAAAAAAAAAAAAAAAAAAAAAAAAAAAAAAAAAAAABQAAAAAAAAAwMD/AAAAAABkAAAAMgAAAAAAAABkAAAAAAAAAH9/fwAKAAAAIgAAABgAAAAAAAAAAAAAAAAAAAAAAAAAAAAAAAAAAAAkAAAAJAAAAAAAAAAHAAAAAAAAAAAAAAAAAAAAAAAAAAAAAAAAAAAAf39/ACUAAABYAAAAAAAAAAAAAAAAAAAAAAAAAAAAAAAAAAAAAAAAAAAAAAAAAAAAAAAAAAAAAAA/AAAAAAAAAKCGAQAAAAAAAAAAAAAAAAAMAAAAAQAAAAAAAAAAAAAAAAAAAB8AAABUAAAAAAAABQAAAAEAAAAAAAAAAAAAAAAAAAAAAAAAAAAAAAAAAAAAAAAAAAAAAAJ/f38AAAAAA8zMzADAwP8Af39/AAAAAAAAAAAAAAAAAAAAAAAAAAAAIQAAABgAAAAUAAAAwTUAABsnAABARwAAWSkAABAAAAAmAAAACAAAAAAAAAAAAAAA"/>
+                <pr:smNativeData xmlns:pr="smNativeData" xmlns="smNativeData" val="SMDATA_15_7aDWaRMAAAAlAAAAZAAAAA8BAAAAkAAAAEgAAACQAAAASAAAAAAAAAABAAAAAAAAAAEAAABQAAAAAAAAAAAA4D8AAAAAAADgPwAAAAAAAOA/AAAAAAAA4D8AAAAAAADgPwAAAAAAAOA/AAAAAAAA4D8AAAAAAADgPwAAAAAAAOA/AAAAAAAA4D8CAAAAjAAAAAAAAAAAAAAAu+DjDP///wgAAAAAAAAAAAAAAAAAAAAAAAAAAAAAAAAAAAAAZAAAAAEAAABAAAAAAAAAAAAAAAAAAAAAAAAAAAAAAAAAAAAAAAAAAAAAAAAAAAAAAAAAAAAAAAAAAAAAAAAAAAAAAAAAAAAAAAAAAAAAAAAAAAAAAAAAAAAAAAAAAAAAFAAAADwAAAAAAAAAAAAAAAAAAAkUAAAAAQAAABQAAAAUAAAAFAAAAAEAAAAAAAAAZAAAAGQAAAAAAAAAZAAAAGQAAAAVAAAAYAAAAAAAAAAAAAAADwAAACADAAAAAAAAAAAAAAEAAACgMgAAVgcAAKr4//8BAAAAf39/AAEAAABkAAAAAAAAABQAAABAHwAAAAAAACYAAAAAAAAAwOD//wAAAAAmAAAAZAAAABYAAABMAAAAAAAAAAAAAAAEAAAAAAAAAAEAAACAgIAKAAAAACgAAAAoAAAAZAAAAGQAAAAAAAAAzMzMAAAAAABQAAAAUAAAAGQAAABkAAAAAAAAABcAAAAUAAAAAAAAAAAAAAD/fwAA/38AAAAAAAAJAAAABAAAAAAAAAAeAAAAaAAAAAAAAAAAAAAAAAAAAAAAAAAAAAAAECcAABAnAAAAAAAAAAAAAAAAAAAAAAAAAAAAAAAAAAAAAAAAAAAAABQAAAAAAAAAwMD/AAAAAABkAAAAMgAAAAAAAABkAAAAAAAAAH9/fwAKAAAAIgAAABgAAAAAAAAAAAAAAAAAAAAAAAAAAAAAAAAAAAAkAAAAJAAAAAAAAAAHAAAAAAAAAAAAAAAAAAAAAAAAAAAAAAAAAAAAf39/ACUAAABYAAAAAAAAAAAAAAAAAAAAAAAAAAAAAAAAAAAAAAAAAAAAAAAAAAAAAAAAAAAAAAA/AAAAAAAAAKCGAQAAAAAAAAAAAAAAAAAMAAAAAQAAAAAAAAAAAAAAAAAAAB8AAABUAAAAAAAABQAAAAEAAAAAAAAAAAAAAAAAAAAAAAAAAAAAAAAAAAAAAAAAAAAAAAJ/f38AAAAAA8zMzADAwP8Af39/AAAAAAAAAAAAAAAAAAAAAAAAAAAAIQAAABgAAAAUAAAAwTUAABsnAABARwAAWSkAABAAAAAmAAAACAAAAAAAAAAAAAAA"/>
               </a:ext>
             </a:extLst>
           </p:cNvSpPr>
@@ -971,7 +962,7 @@
           <a:lstStyle/>
           <a:p>
             <a:pPr/>
-            <a:fld id="{6ED503B6-F883-80F5-CD6D-0EA04D233B5B}" type="slidenum">
+            <a:fld id="{1C000438-76F1-55F2-BFB8-80A74AF649D5}" type="slidenum">
               <a:t/>
             </a:fld>
           </a:p>
@@ -982,6 +973,7 @@
   <p:clrMapOvr>
     <a:masterClrMapping/>
   </p:clrMapOvr>
+  <p:hf hdr="0" ftr="0"/>
 </p:sldLayout>
 </file>
 
@@ -1009,7 +1001,7 @@
             <a:spLocks noGrp="1" noChangeArrowheads="1"/>
             <a:extLst>
               <a:ext uri="smNativeData">
-                <pr:smNativeData xmlns:pr="smNativeData" xmlns="smNativeData" val="SMDATA_15_AnHWaRMAAAAlAAAAZAAAAA8BAAAAkAAAAEgAAACQAAAASAAAAAAAAAAAAAAAAAAAAAEAAABQAAAAAAAAAAAA4D8AAAAAAADgPwAAAAAAAOA/AAAAAAAA4D8AAAAAAADgPwAAAAAAAOA/AAAAAAAA4D8AAAAAAADgPwAAAAAAAOA/AAAAAAAA4D8CAAAAjAAAAAAAAAAAAAAAu+DjDP///wgAAAAAAAAAAAAAAAAAAAAAAAAAAAAAAAAAAAAAZAAAAAEAAABAAAAAAAAAAAAAAAAAAAAAAAAAAAAAAAAAAAAAAAAAAAAAAAAAAAAAAAAAAAAAAAAAAAAAAAAAAAAAAAAAAAAAAAAAAAAAAAAAAAAAAAAAAAAAAAAAAAAAFAAAADwAAAAAAAAAAAAAAAAAAAkUAAAAAQAAABQAAAAUAAAAFAAAAAEAAAAAAAAAZAAAAGQAAAAAAAAAZAAAAGQAAAAVAAAAYAAAAAAAAAAAAAAADwAAACADAAAAAAAAAAAAAAEAAACgMgAAVgcAAKr4//8BAAAAf39/AAEAAABkAAAAAAAAABQAAABAHwAAAAAAACYAAAAAAAAAwOD//wAAAAAmAAAAZAAAABYAAABMAAAAAAAAAAAAAAAEAAAAAAAAAAEAAACAgIAKAAAAACgAAAAoAAAAZAAAAGQAAAAAAAAAzMzMAAAAAABQAAAAUAAAAGQAAABkAAAAAAAAABcAAAAUAAAAAAAAAAAAAAD/fwAA/38AAAAAAAAJAAAABAAAANw7IAEeAAAAaAAAAAAAAAAAAAAAAAAAAAAAAAAAAAAAECcAABAnAAAAAAAAAAAAAAAAAAAAAAAAAAAAAAAAAAAAAAAAAAAAABQAAAAAAAAAwMD/AAAAAABkAAAAMgAAAAAAAABkAAAAAAAAAH9/fwAKAAAAIgAAABgAAAAAAAAAAAAAAAAAAAAAAAAAAAAAAAAAAAAkAAAAJAAAAAAAAAAHAAAAAAAAAAAAAAAAAAAAAAAAAAAAAAAAAAAAf39/ACUAAABYAAAAAAAAAAAAAAAAAAAAAAAAAAAAAAAAAAAAAAAAAAAAAAAAAAAAAAAAAAAAAAA/AAAAAAAAAKCGAQAAAAAAAAAAAAAAAAAMAAAAAQAAAAAAAAAAAAAAAAAAAB8AAABUAAAAAAAABQAAAAEAAAAAAAAAAAAAAAAAAAAAAAAAAAAAAAAAAAAAAAAAAAAAAAJ/f38AAAAAA8zMzADAwP8Af39/AAAAAAAAAAAAAAAAAAAAAAAAAAAAIQAAABgAAAAUAAAA7QUAABwbAACtRQAAfSMAABAAAAAmAAAACAAAAIGAAAAAAAAA"/>
+                <pr:smNativeData xmlns:pr="smNativeData" xmlns="smNativeData" val="SMDATA_15_7aDWaRMAAAAlAAAAZAAAAA8BAAAAkAAAAEgAAACQAAAASAAAAAAAAAAAAAAAAAAAAAEAAABQAAAAAAAAAAAA4D8AAAAAAADgPwAAAAAAAOA/AAAAAAAA4D8AAAAAAADgPwAAAAAAAOA/AAAAAAAA4D8AAAAAAADgPwAAAAAAAOA/AAAAAAAA4D8CAAAAjAAAAAAAAAAAAAAAu+DjDP///wgAAAAAAAAAAAAAAAAAAAAAAAAAAAAAAAAAAAAAZAAAAAEAAABAAAAAAAAAAAAAAAAAAAAAAAAAAAAAAAAAAAAAAAAAAAAAAAAAAAAAAAAAAAAAAAAAAAAAAAAAAAAAAAAAAAAAAAAAAAAAAAAAAAAAAAAAAAAAAAAAAAAAFAAAADwAAAAAAAAAAAAAAAAAAAkUAAAAAQAAABQAAAAUAAAAFAAAAAEAAAAAAAAAZAAAAGQAAAAAAAAAZAAAAGQAAAAVAAAAYAAAAAAAAAAAAAAADwAAACADAAAAAAAAAAAAAAEAAACgMgAAVgcAAKr4//8BAAAAf39/AAEAAABkAAAAAAAAABQAAABAHwAAAAAAACYAAAAAAAAAwOD//wAAAAAmAAAAZAAAABYAAABMAAAAAAAAAAAAAAAEAAAAAAAAAAEAAACAgIAKAAAAACgAAAAoAAAAZAAAAGQAAAAAAAAAzMzMAAAAAABQAAAAUAAAAGQAAABkAAAAAAAAABcAAAAUAAAAAAAAAAAAAAD/fwAA/38AAAAAAAAJAAAABAAAANw7IAEeAAAAaAAAAAAAAAAAAAAAAAAAAAAAAAAAAAAAECcAABAnAAAAAAAAAAAAAAAAAAAAAAAAAAAAAAAAAAAAAAAAAAAAABQAAAAAAAAAwMD/AAAAAABkAAAAMgAAAAAAAABkAAAAAAAAAH9/fwAKAAAAIgAAABgAAAAAAAAAAAAAAAAAAAAAAAAAAAAAAAAAAAAkAAAAJAAAAAAAAAAHAAAAAAAAAAAAAAAAAAAAAAAAAAAAAAAAAAAAf39/ACUAAABYAAAAAAAAAAAAAAAAAAAAAAAAAAAAAAAAAAAAAAAAAAAAAAAAAAAAAAAAAAAAAAA/AAAAAAAAAKCGAQAAAAAAAAAAAAAAAAAMAAAAAQAAAAAAAAAAAAAAAAAAAB8AAABUAAAAAAAABQAAAAEAAAAAAAAAAAAAAAAAAAAAAAAAAAAAAAAAAAAAAAAAAAAAAAJ/f38AAAAAA8zMzADAwP8Af39/AAAAAAAAAAAAAAAAAAAAAAAAAAAAIQAAABgAAAAUAAAA7QUAABwbAACtRQAAfSMAABAAAAAmAAAACAAAAIGAAAAAAAAA"/>
               </a:ext>
             </a:extLst>
           </p:cNvSpPr>
@@ -1049,7 +1041,7 @@
             <a:spLocks noGrp="1" noChangeArrowheads="1"/>
             <a:extLst>
               <a:ext uri="smNativeData">
-                <pr:smNativeData xmlns:pr="smNativeData" xmlns="smNativeData" val="SMDATA_15_AnHWaRMAAAAlAAAAZAAAAA8BAAAAkAAAAEgAAACQAAAASAAAAAAAAAACAAAAAAAAAAEAAABQAAAAAAAAAAAA4D8AAAAAAADgPwAAAAAAAOA/AAAAAAAA4D8AAAAAAADgPwAAAAAAAOA/AAAAAAAA4D8AAAAAAADgPwAAAAAAAOA/AAAAAAAA4D8CAAAAjAAAAAAAAAAAAAAAu+DjDP///wgAAAAAAAAAAAAAAAAAAAAAAAAAAAAAAAAAAAAAZAAAAAEAAABAAAAAAAAAAAAAAAAAAAAAAAAAAAAAAAAAAAAAAAAAAAAAAAAAAAAAAAAAAAAAAAAAAAAAAAAAAAAAAAAAAAAAAAAAAAAAAAAAAAAAAAAAAAAAAAAAAAAAFAAAADwAAAAAAAAAAAAAAAAAAAkUAAAAAQAAABQAAAAUAAAAFAAAAAEAAAAAAAAAZAAAAGQAAAAAAAAAZAAAAGQAAAAVAAAAYAAAAAAAAAAAAAAADwAAACADAAAAAAAAAAAAAAEAAACgMgAAVgcAAKr4//8BAAAAf39/AAEAAABkAAAAAAAAABQAAABAHwAAAAAAACYAAAAAAAAAwOD//wAAAAAmAAAAZAAAABYAAABMAAAAAAAAAAAAAAAEAAAAAAAAAAEAAACAgIAKAAAAACgAAAAoAAAAZAAAAGQAAAAAAAAAzMzMAAAAAABQAAAAUAAAAGQAAABkAAAAAAAAABcAAAAUAAAAAAAAAAAAAAD/fwAA/38AAAAAAAAJAAAABAAAANw7IAEeAAAAaAAAAAAAAAAAAAAAAAAAAAAAAAAAAAAAECcAABAnAAAAAAAAAAAAAAAAAAAAAAAAAAAAAAAAAAAAAAAAAAAAABQAAAAAAAAAwMD/AAAAAABkAAAAMgAAAAAAAABkAAAAAAAAAH9/fwAKAAAAIgAAABgAAAAAAAAAAAAAAAAAAAAAAAAAAAAAAAAAAAAkAAAAJAAAAAAAAAAHAAAAAAAAAAAAAAAAAAAAAAAAAAAAAAAAAAAAf39/ACUAAABYAAAAAAAAAAAAAAAAAAAAAAAAAAAAAAAAAAAAAAAAAAAAAAAAAAAAAAAAAAAAAAA/AAAAAAAAAKCGAQAAAAAAAAAAAAAAAAAMAAAAAQAAAAAAAAAAAAAAAAAAAB8AAABUAAAAAAAABQAAAAEAAAAAAAAAAAAAAAAAAAAAAAAAAAAAAAAAAAAAAAAAAAAAAAJ/f38AAAAAA8zMzADAwP8Af39/AAAAAAAAAAAAAAAAAAAAAAAAAAAAIQAAABgAAAAUAAAA7QUAAOERAACtRQAAHBsAABAAAAAmAAAACAAAAIGAAAAAAAAA"/>
+                <pr:smNativeData xmlns:pr="smNativeData" xmlns="smNativeData" val="SMDATA_15_7aDWaRMAAAAlAAAAZAAAAA8BAAAAkAAAAEgAAACQAAAASAAAAAAAAAACAAAAAAAAAAEAAABQAAAAAAAAAAAA4D8AAAAAAADgPwAAAAAAAOA/AAAAAAAA4D8AAAAAAADgPwAAAAAAAOA/AAAAAAAA4D8AAAAAAADgPwAAAAAAAOA/AAAAAAAA4D8CAAAAjAAAAAAAAAAAAAAAu+DjDP///wgAAAAAAAAAAAAAAAAAAAAAAAAAAAAAAAAAAAAAZAAAAAEAAABAAAAAAAAAAAAAAAAAAAAAAAAAAAAAAAAAAAAAAAAAAAAAAAAAAAAAAAAAAAAAAAAAAAAAAAAAAAAAAAAAAAAAAAAAAAAAAAAAAAAAAAAAAAAAAAAAAAAAFAAAADwAAAAAAAAAAAAAAAAAAAkUAAAAAQAAABQAAAAUAAAAFAAAAAEAAAAAAAAAZAAAAGQAAAAAAAAAZAAAAGQAAAAVAAAAYAAAAAAAAAAAAAAADwAAACADAAAAAAAAAAAAAAEAAACgMgAAVgcAAKr4//8BAAAAf39/AAEAAABkAAAAAAAAABQAAABAHwAAAAAAACYAAAAAAAAAwOD//wAAAAAmAAAAZAAAABYAAABMAAAAAAAAAAAAAAAEAAAAAAAAAAEAAACAgIAKAAAAACgAAAAoAAAAZAAAAGQAAAAAAAAAzMzMAAAAAABQAAAAUAAAAGQAAABkAAAAAAAAABcAAAAUAAAAAAAAAAAAAAD/fwAA/38AAAAAAAAJAAAABAAAANw7IAEeAAAAaAAAAAAAAAAAAAAAAAAAAAAAAAAAAAAAECcAABAnAAAAAAAAAAAAAAAAAAAAAAAAAAAAAAAAAAAAAAAAAAAAABQAAAAAAAAAwMD/AAAAAABkAAAAMgAAAAAAAABkAAAAAAAAAH9/fwAKAAAAIgAAABgAAAAAAAAAAAAAAAAAAAAAAAAAAAAAAAAAAAAkAAAAJAAAAAAAAAAHAAAAAAAAAAAAAAAAAAAAAAAAAAAAAAAAAAAAf39/ACUAAABYAAAAAAAAAAAAAAAAAAAAAAAAAAAAAAAAAAAAAAAAAAAAAAAAAAAAAAAAAAAAAAA/AAAAAAAAAKCGAQAAAAAAAAAAAAAAAAAMAAAAAQAAAAAAAAAAAAAAAAAAAB8AAABUAAAAAAAABQAAAAEAAAAAAAAAAAAAAAAAAAAAAAAAAAAAAAAAAAAAAAAAAAAAAAJ/f38AAAAAA8zMzADAwP8Af39/AAAAAAAAAAAAAAAAAAAAAAAAAAAAIQAAABgAAAAUAAAA7QUAAOERAACtRQAAHBsAABAAAAAmAAAACAAAAIGAAAAAAAAA"/>
               </a:ext>
             </a:extLst>
           </p:cNvSpPr>
@@ -1122,7 +1114,7 @@
             <a:spLocks noGrp="1" noChangeArrowheads="1"/>
             <a:extLst>
               <a:ext uri="smNativeData">
-                <pr:smNativeData xmlns:pr="smNativeData" xmlns="smNativeData" val="SMDATA_15_AnHWaRMAAAAlAAAAZAAAAA8BAAAAkAAAAEgAAACQAAAASAAAAAAAAAABAAAAAAAAAAEAAABQAAAAAAAAAAAA4D8AAAAAAADgPwAAAAAAAOA/AAAAAAAA4D8AAAAAAADgPwAAAAAAAOA/AAAAAAAA4D8AAAAAAADgPwAAAAAAAOA/AAAAAAAA4D8CAAAAjAAAAAAAAAAAAAAAu+DjDP///wgAAAAAAAAAAAAAAAAAAAAAAAAAAAAAAAAAAAAAZAAAAAEAAABAAAAAAAAAAAAAAAAAAAAAAAAAAAAAAAAAAAAAAAAAAAAAAAAAAAAAAAAAAAAAAAAAAAAAAAAAAAAAAAAAAAAAAAAAAAAAAAAAAAAAAAAAAAAAAAAAAAAAFAAAADwAAAAAAAAAAAAAAAAAAAkUAAAAAQAAABQAAAAUAAAAFAAAAAEAAAAAAAAAZAAAAGQAAAAAAAAAZAAAAGQAAAAVAAAAYAAAAAAAAAAAAAAADwAAACADAAAAAAAAAAAAAAEAAACgMgAAVgcAAKr4//8BAAAAf39/AAEAAABkAAAAAAAAABQAAABAHwAAAAAAACYAAAAAAAAAwOD//wAAAAAmAAAAZAAAABYAAABMAAAAAAAAAAAAAAAEAAAAAAAAAAEAAACAgIAKAAAAACgAAAAoAAAAZAAAAGQAAAAAAAAAzMzMAAAAAABQAAAAUAAAAGQAAABkAAAAAAAAABcAAAAUAAAAAAAAAAAAAAD/fwAA/38AAAAAAAAJAAAABAAAAAAAAAAeAAAAaAAAAAAAAAAAAAAAAAAAAAAAAAAAAAAAECcAABAnAAAAAAAAAAAAAAAAAAAAAAAAAAAAAAAAAAAAAAAAAAAAABQAAAAAAAAAwMD/AAAAAABkAAAAMgAAAAAAAABkAAAAAAAAAH9/fwAKAAAAIgAAABgAAAAAAAAAAAAAAAAAAAAAAAAAAAAAAAAAAAAkAAAAJAAAAAAAAAAHAAAAAAAAAAAAAAAAAAAAAAAAAAAAAAAAAAAAf39/ACUAAABYAAAAAAAAAAAAAAAAAAAAAAAAAAAAAAAAAAAAAAAAAAAAAAAAAAAAAAAAAAAAAAA/AAAAAAAAAKCGAQAAAAAAAAAAAAAAAAAMAAAAAQAAAAAAAAAAAAAAAAAAAB8AAABUAAAAAAAABQAAAAEAAAAAAAAAAAAAAAAAAAAAAAAAAAAAAAAAAAAAAAAAAAAAAAJ/f38AAAAAA8zMzADAwP8Af39/AAAAAAAAAAAAAAAAAAAAAAAAAAAAIQAAABgAAAAUAAAAwAMAABsnAAA/FQAAWSkAABAAAAAmAAAACAAAAAAAAAAAAAAA"/>
+                <pr:smNativeData xmlns:pr="smNativeData" xmlns="smNativeData" val="SMDATA_15_7aDWaRMAAAAlAAAAZAAAAA8BAAAAkAAAAEgAAACQAAAASAAAAAAAAAABAAAAAAAAAAEAAABQAAAAAAAAAAAA4D8AAAAAAADgPwAAAAAAAOA/AAAAAAAA4D8AAAAAAADgPwAAAAAAAOA/AAAAAAAA4D8AAAAAAADgPwAAAAAAAOA/AAAAAAAA4D8CAAAAjAAAAAAAAAAAAAAAu+DjDP///wgAAAAAAAAAAAAAAAAAAAAAAAAAAAAAAAAAAAAAZAAAAAEAAABAAAAAAAAAAAAAAAAAAAAAAAAAAAAAAAAAAAAAAAAAAAAAAAAAAAAAAAAAAAAAAAAAAAAAAAAAAAAAAAAAAAAAAAAAAAAAAAAAAAAAAAAAAAAAAAAAAAAAFAAAADwAAAAAAAAAAAAAAAAAAAkUAAAAAQAAABQAAAAUAAAAFAAAAAEAAAAAAAAAZAAAAGQAAAAAAAAAZAAAAGQAAAAVAAAAYAAAAAAAAAAAAAAADwAAACADAAAAAAAAAAAAAAEAAACgMgAAVgcAAKr4//8BAAAAf39/AAEAAABkAAAAAAAAABQAAABAHwAAAAAAACYAAAAAAAAAwOD//wAAAAAmAAAAZAAAABYAAABMAAAAAAAAAAAAAAAEAAAAAAAAAAEAAACAgIAKAAAAACgAAAAoAAAAZAAAAGQAAAAAAAAAzMzMAAAAAABQAAAAUAAAAGQAAABkAAAAAAAAABcAAAAUAAAAAAAAAAAAAAD/fwAA/38AAAAAAAAJAAAABAAAAAAAAAAeAAAAaAAAAAAAAAAAAAAAAAAAAAAAAAAAAAAAECcAABAnAAAAAAAAAAAAAAAAAAAAAAAAAAAAAAAAAAAAAAAAAAAAABQAAAAAAAAAwMD/AAAAAABkAAAAMgAAAAAAAABkAAAAAAAAAH9/fwAKAAAAIgAAABgAAAAAAAAAAAAAAAAAAAAAAAAAAAAAAAAAAAAkAAAAJAAAAAAAAAAHAAAAAAAAAAAAAAAAAAAAAAAAAAAAAAAAAAAAf39/ACUAAABYAAAAAAAAAAAAAAAAAAAAAAAAAAAAAAAAAAAAAAAAAAAAAAAAAAAAAAAAAAAAAAA/AAAAAAAAAKCGAQAAAAAAAAAAAAAAAAAMAAAAAQAAAAAAAAAAAAAAAAAAAB8AAABUAAAAAAAABQAAAAEAAAAAAAAAAAAAAAAAAAAAAAAAAAAAAAAAAAAAAAAAAAAAAAJ/f38AAAAAA8zMzADAwP8Af39/AAAAAAAAAAAAAAAAAAAAAAAAAAAAIQAAABgAAAAUAAAAwAMAABsnAAA/FQAAWSkAABAAAAAmAAAACAAAAAAAAAAAAAAA"/>
               </a:ext>
             </a:extLst>
           </p:cNvSpPr>
@@ -1136,7 +1128,7 @@
           <a:lstStyle/>
           <a:p>
             <a:pPr/>
-            <a:fld id="{16A5C343-0DFB-F035-B51D-FB608D5343AE}" type="datetime1">
+            <a:fld id="{1F3FF9B4-FAF2-6A0F-BC87-0C5AB7C94A59}" type="datetime1">
               <a:t/>
             </a:fld>
           </a:p>
@@ -1149,7 +1141,7 @@
             <a:spLocks noGrp="1" noChangeArrowheads="1"/>
             <a:extLst>
               <a:ext uri="smNativeData">
-                <pr:smNativeData xmlns:pr="smNativeData" xmlns="smNativeData" val="SMDATA_15_AnHWaRMAAAAlAAAAZAAAAA8BAAAAkAAAAEgAAACQAAAASAAAAAAAAAABAAAAAAAAAAEAAABQAAAAAAAAAAAA4D8AAAAAAADgPwAAAAAAAOA/AAAAAAAA4D8AAAAAAADgPwAAAAAAAOA/AAAAAAAA4D8AAAAAAADgPwAAAAAAAOA/AAAAAAAA4D8CAAAAjAAAAAAAAAAAAAAAu+DjDP///wgAAAAAAAAAAAAAAAAAAAAAAAAAAAAAAAAAAAAAZAAAAAEAAABAAAAAAAAAAAAAAAAAAAAAAAAAAAAAAAAAAAAAAAAAAAAAAAAAAAAAAAAAAAAAAAAAAAAAAAAAAAAAAAAAAAAAAAAAAAAAAAAAAAAAAAAAAAAAAAAAAAAAFAAAADwAAAAAAAAAAAAAAAAAAAkUAAAAAQAAABQAAAAUAAAAFAAAAAEAAAAAAAAAZAAAAGQAAAAAAAAAZAAAAGQAAAAVAAAAYAAAAAAAAAAAAAAADwAAACADAAAAAAAAAAAAAAEAAACgMgAAVgcAAKr4//8BAAAAf39/AAEAAABkAAAAAAAAABQAAABAHwAAAAAAACYAAAAAAAAAwOD//wAAAAAmAAAAZAAAABYAAABMAAAAAAAAAAAAAAAEAAAAAAAAAAEAAACAgIAKAAAAACgAAAAoAAAAZAAAAGQAAAAAAAAAzMzMAAAAAABQAAAAUAAAAGQAAABkAAAAAAAAABcAAAAUAAAAAAAAAAAAAAD/fwAA/38AAAAAAAAJAAAABAAAANw7IAEeAAAAaAAAAAAAAAAAAAAAAAAAAAAAAAAAAAAAECcAABAnAAAAAAAAAAAAAAAAAAAAAAAAAAAAAAAAAAAAAAAAAAAAABQAAAAAAAAAwMD/AAAAAABkAAAAMgAAAAAAAABkAAAAAAAAAH9/fwAKAAAAIgAAABgAAAAAAAAAAAAAAAAAAAAAAAAAAAAAAAAAAAAkAAAAJAAAAAAAAAAHAAAAAAAAAAAAAAAAAAAAAAAAAAAAAAAAAAAAf39/ACUAAABYAAAAAAAAAAAAAAAAAAAAAAAAAAAAAAAAAAAAAAAAAAAAAAAAAAAAAAAAAAAAAAA/AAAAAAAAAKCGAQAAAAAAAAAAAAAAAAAMAAAAAQAAAAAAAAAAAAAAAAAAAB8AAABUAAAAAAAABQAAAAEAAAAAAAAAAAAAAAAAAAAAAAAAAAAAAAAAAAAAAAAAAAAAAAJ/f38AAAAAA8zMzADAwP8Af39/AAAAAAAAAAAAAAAAAAAAAAAAAAAAIQAAABgAAAAUAAAAoRkAABsnAABfMQAAWSkAABAAAAAmAAAACAAAAAAAAAAAAAAA"/>
+                <pr:smNativeData xmlns:pr="smNativeData" xmlns="smNativeData" val="SMDATA_15_7aDWaRMAAAAlAAAAZAAAAA8BAAAAkAAAAEgAAACQAAAASAAAAAAAAAABAAAAAAAAAAEAAABQAAAAAAAAAAAA4D8AAAAAAADgPwAAAAAAAOA/AAAAAAAA4D8AAAAAAADgPwAAAAAAAOA/AAAAAAAA4D8AAAAAAADgPwAAAAAAAOA/AAAAAAAA4D8CAAAAjAAAAAAAAAAAAAAAu+DjDP///wgAAAAAAAAAAAAAAAAAAAAAAAAAAAAAAAAAAAAAZAAAAAEAAABAAAAAAAAAAAAAAAAAAAAAAAAAAAAAAAAAAAAAAAAAAAAAAAAAAAAAAAAAAAAAAAAAAAAAAAAAAAAAAAAAAAAAAAAAAAAAAAAAAAAAAAAAAAAAAAAAAAAAFAAAADwAAAAAAAAAAAAAAAAAAAkUAAAAAQAAABQAAAAUAAAAFAAAAAEAAAAAAAAAZAAAAGQAAAAAAAAAZAAAAGQAAAAVAAAAYAAAAAAAAAAAAAAADwAAACADAAAAAAAAAAAAAAEAAACgMgAAVgcAAKr4//8BAAAAf39/AAEAAABkAAAAAAAAABQAAABAHwAAAAAAACYAAAAAAAAAwOD//wAAAAAmAAAAZAAAABYAAABMAAAAAAAAAAAAAAAEAAAAAAAAAAEAAACAgIAKAAAAACgAAAAoAAAAZAAAAGQAAAAAAAAAzMzMAAAAAABQAAAAUAAAAGQAAABkAAAAAAAAABcAAAAUAAAAAAAAAAAAAAD/fwAA/38AAAAAAAAJAAAABAAAANw7IAEeAAAAaAAAAAAAAAAAAAAAAAAAAAAAAAAAAAAAECcAABAnAAAAAAAAAAAAAAAAAAAAAAAAAAAAAAAAAAAAAAAAAAAAABQAAAAAAAAAwMD/AAAAAABkAAAAMgAAAAAAAABkAAAAAAAAAH9/fwAKAAAAIgAAABgAAAAAAAAAAAAAAAAAAAAAAAAAAAAAAAAAAAAkAAAAJAAAAAAAAAAHAAAAAAAAAAAAAAAAAAAAAAAAAAAAAAAAAAAAf39/ACUAAABYAAAAAAAAAAAAAAAAAAAAAAAAAAAAAAAAAAAAAAAAAAAAAAAAAAAAAAAAAAAAAAA/AAAAAAAAAKCGAQAAAAAAAAAAAAAAAAAMAAAAAQAAAAAAAAAAAAAAAAAAAB8AAABUAAAAAAAABQAAAAEAAAAAAAAAAAAAAAAAAAAAAAAAAAAAAAAAAAAAAAAAAAAAAAJ/f38AAAAAA8zMzADAwP8Af39/AAAAAAAAAAAAAAAAAAAAAAAAAAAAIQAAABgAAAAUAAAAoRkAABsnAABfMQAAWSkAABAAAAAmAAAACAAAAAAAAAAAAAAA"/>
               </a:ext>
             </a:extLst>
           </p:cNvSpPr>
@@ -1163,9 +1155,6 @@
           <a:lstStyle/>
           <a:p>
             <a:pPr/>
-            <a:r>
-              <a:t/>
-            </a:r>
           </a:p>
         </p:txBody>
       </p:sp>
@@ -1176,7 +1165,7 @@
             <a:spLocks noGrp="1" noChangeArrowheads="1"/>
             <a:extLst>
               <a:ext uri="smNativeData">
-                <pr:smNativeData xmlns:pr="smNativeData" xmlns="smNativeData" val="SMDATA_15_AnHWaRMAAAAlAAAAZAAAAA8BAAAAkAAAAEgAAACQAAAASAAAAAAAAAABAAAAAAAAAAEAAABQAAAAAAAAAAAA4D8AAAAAAADgPwAAAAAAAOA/AAAAAAAA4D8AAAAAAADgPwAAAAAAAOA/AAAAAAAA4D8AAAAAAADgPwAAAAAAAOA/AAAAAAAA4D8CAAAAjAAAAAAAAAAAAAAAu+DjDP///wgAAAAAAAAAAAAAAAAAAAAAAAAAAAAAAAAAAAAAZAAAAAEAAABAAAAAAAAAAAAAAAAAAAAAAAAAAAAAAAAAAAAAAAAAAAAAAAAAAAAAAAAAAAAAAAAAAAAAAAAAAAAAAAAAAAAAAAAAAAAAAAAAAAAAAAAAAAAAAAAAAAAAFAAAADwAAAAAAAAAAAAAAAAAAAkUAAAAAQAAABQAAAAUAAAAFAAAAAEAAAAAAAAAZAAAAGQAAAAAAAAAZAAAAGQAAAAVAAAAYAAAAAAAAAAAAAAADwAAACADAAAAAAAAAAAAAAEAAACgMgAAVgcAAKr4//8BAAAAf39/AAEAAABkAAAAAAAAABQAAABAHwAAAAAAACYAAAAAAAAAwOD//wAAAAAmAAAAZAAAABYAAABMAAAAAAAAAAAAAAAEAAAAAAAAAAEAAACAgIAKAAAAACgAAAAoAAAAZAAAAGQAAAAAAAAAzMzMAAAAAABQAAAAUAAAAGQAAABkAAAAAAAAABcAAAAUAAAAAAAAAAAAAAD/fwAA/38AAAAAAAAJAAAABAAAANw7IAEeAAAAaAAAAAAAAAAAAAAAAAAAAAAAAAAAAAAAECcAABAnAAAAAAAAAAAAAAAAAAAAAAAAAAAAAAAAAAAAAAAAAAAAABQAAAAAAAAAwMD/AAAAAABkAAAAMgAAAAAAAABkAAAAAAAAAH9/fwAKAAAAIgAAABgAAAAAAAAAAAAAAAAAAAAAAAAAAAAAAAAAAAAkAAAAJAAAAAAAAAAHAAAAAAAAAAAAAAAAAAAAAAAAAAAAAAAAAAAAf39/ACUAAABYAAAAAAAAAAAAAAAAAAAAAAAAAAAAAAAAAAAAAAAAAAAAAAAAAAAAAAAAAAAAAAA/AAAAAAAAAKCGAQAAAAAAAAAAAAAAAAAMAAAAAQAAAAAAAAAAAAAAAAAAAB8AAABUAAAAAAAABQAAAAEAAAAAAAAAAAAAAAAAAAAAAAAAAAAAAAAAAAAAAAAAAAAAAAJ/f38AAAAAA8zMzADAwP8Af39/AAAAAAAAAAAAAAAAAAAAAAAAAAAAIQAAABgAAAAUAAAAwTUAABsnAABARwAAWSkAABAAAAAmAAAACAAAAAAAAAAAAAAA"/>
+                <pr:smNativeData xmlns:pr="smNativeData" xmlns="smNativeData" val="SMDATA_15_7aDWaRMAAAAlAAAAZAAAAA8BAAAAkAAAAEgAAACQAAAASAAAAAAAAAABAAAAAAAAAAEAAABQAAAAAAAAAAAA4D8AAAAAAADgPwAAAAAAAOA/AAAAAAAA4D8AAAAAAADgPwAAAAAAAOA/AAAAAAAA4D8AAAAAAADgPwAAAAAAAOA/AAAAAAAA4D8CAAAAjAAAAAAAAAAAAAAAu+DjDP///wgAAAAAAAAAAAAAAAAAAAAAAAAAAAAAAAAAAAAAZAAAAAEAAABAAAAAAAAAAAAAAAAAAAAAAAAAAAAAAAAAAAAAAAAAAAAAAAAAAAAAAAAAAAAAAAAAAAAAAAAAAAAAAAAAAAAAAAAAAAAAAAAAAAAAAAAAAAAAAAAAAAAAFAAAADwAAAAAAAAAAAAAAAAAAAkUAAAAAQAAABQAAAAUAAAAFAAAAAEAAAAAAAAAZAAAAGQAAAAAAAAAZAAAAGQAAAAVAAAAYAAAAAAAAAAAAAAADwAAACADAAAAAAAAAAAAAAEAAACgMgAAVgcAAKr4//8BAAAAf39/AAEAAABkAAAAAAAAABQAAABAHwAAAAAAACYAAAAAAAAAwOD//wAAAAAmAAAAZAAAABYAAABMAAAAAAAAAAAAAAAEAAAAAAAAAAEAAACAgIAKAAAAACgAAAAoAAAAZAAAAGQAAAAAAAAAzMzMAAAAAABQAAAAUAAAAGQAAABkAAAAAAAAABcAAAAUAAAAAAAAAAAAAAD/fwAA/38AAAAAAAAJAAAABAAAANw7IAEeAAAAaAAAAAAAAAAAAAAAAAAAAAAAAAAAAAAAECcAABAnAAAAAAAAAAAAAAAAAAAAAAAAAAAAAAAAAAAAAAAAAAAAABQAAAAAAAAAwMD/AAAAAABkAAAAMgAAAAAAAABkAAAAAAAAAH9/fwAKAAAAIgAAABgAAAAAAAAAAAAAAAAAAAAAAAAAAAAAAAAAAAAkAAAAJAAAAAAAAAAHAAAAAAAAAAAAAAAAAAAAAAAAAAAAAAAAAAAAf39/ACUAAABYAAAAAAAAAAAAAAAAAAAAAAAAAAAAAAAAAAAAAAAAAAAAAAAAAAAAAAAAAAAAAAA/AAAAAAAAAKCGAQAAAAAAAAAAAAAAAAAMAAAAAQAAAAAAAAAAAAAAAAAAAB8AAABUAAAAAAAABQAAAAEAAAAAAAAAAAAAAAAAAAAAAAAAAAAAAAAAAAAAAAAAAAAAAAJ/f38AAAAAA8zMzADAwP8Af39/AAAAAAAAAAAAAAAAAAAAAAAAAAAAIQAAABgAAAAUAAAAwTUAABsnAABARwAAWSkAABAAAAAmAAAACAAAAAAAAAAAAAAA"/>
               </a:ext>
             </a:extLst>
           </p:cNvSpPr>
@@ -1190,7 +1179,7 @@
           <a:lstStyle/>
           <a:p>
             <a:pPr/>
-            <a:fld id="{38ED9FAB-E5D5-B869-9B55-133CD11B6D46}" type="slidenum">
+            <a:fld id="{5A1F8A31-7FB7-4A7C-F9A7-8929C4E90FDC}" type="slidenum">
               <a:t/>
             </a:fld>
           </a:p>
@@ -1201,6 +1190,7 @@
   <p:clrMapOvr>
     <a:masterClrMapping/>
   </p:clrMapOvr>
+  <p:hf hdr="0" ftr="0"/>
 </p:sldLayout>
 </file>
 
@@ -1228,7 +1218,7 @@
             <a:spLocks noGrp="1" noChangeArrowheads="1"/>
             <a:extLst>
               <a:ext uri="smNativeData">
-                <pr:smNativeData xmlns:pr="smNativeData" xmlns="smNativeData" val="SMDATA_15_AnHWaRMAAAAlAAAAZAAAAA8BAAAAkAAAAEgAAACQAAAASAAAAAAAAAABAAAAAAAAAAEAAABQAAAAAAAAAAAA4D8AAAAAAADgPwAAAAAAAOA/AAAAAAAA4D8AAAAAAADgPwAAAAAAAOA/AAAAAAAA4D8AAAAAAADgPwAAAAAAAOA/AAAAAAAA4D8CAAAAjAAAAAAAAAAAAAAAu+DjDP///wgAAAAAAAAAAAAAAAAAAAAAAAAAAAAAAAAAAAAAZAAAAAEAAABAAAAAAAAAAAAAAAAAAAAAAAAAAAAAAAAAAAAAAAAAAAAAAAAAAAAAAAAAAAAAAAAAAAAAAAAAAAAAAAAAAAAAAAAAAAAAAAAAAAAAAAAAAAAAAAAAAAAAFAAAADwAAAAAAAAAAAAAAAAAAAkUAAAAAQAAABQAAAAUAAAAFAAAAAEAAAAAAAAAZAAAAGQAAAAAAAAAZAAAAGQAAAAVAAAAYAAAAAAAAAAAAAAADwAAACADAAAAAAAAAAAAAAEAAACgMgAAVgcAAKr4//8BAAAAf39/AAEAAABkAAAAAAAAABQAAABAHwAAAAAAACYAAAAAAAAAwOD//wAAAAAmAAAAZAAAABYAAABMAAAAAAAAAAAAAAAEAAAAAAAAAAEAAACAgIAKAAAAACgAAAAoAAAAZAAAAGQAAAAAAAAAzMzMAAAAAABQAAAAUAAAAGQAAABkAAAAAAAAABcAAAAUAAAAAAAAAAAAAAD/fwAA/38AAAAAAAAJAAAABAAAANw7IAEeAAAAaAAAAAAAAAAAAAAAAAAAAAAAAAAAAAAAECcAABAnAAAAAAAAAAAAAAAAAAAAAAAAAAAAAAAAAAAAAAAAAAAAABQAAAAAAAAAwMD/AAAAAABkAAAAMgAAAAAAAABkAAAAAAAAAH9/fwAKAAAAIgAAABgAAAAAAAAAAAAAAAAAAAAAAAAAAAAAAAAAAAAkAAAAJAAAAAAAAAAHAAAAAAAAAAAAAAAAAAAAAAAAAAAAAAAAAAAAf39/ACUAAABYAAAAAAAAAAAAAAAAAAAAAAAAAAAAAAAAAAAAAAAAAAAAAAAAAAAAAAAAAAAAAAA/AAAAAAAAAKCGAQAAAAAAAAAAAAAAAAAMAAAAAQAAAAAAAAAAAAAAAAAAAB8AAABUAAAAAAAABQAAAAEAAAAAAAAAAAAAAAAAAAAAAAAAAAAAAAAAAAAAAAAAAAAAAAJ/f38AAAAAA8zMzADAwP8Af39/AAAAAAAAAAAAAAAAAAAAAAAAAAAAIQAAABgAAAAUAAAAwAMAALABAABARwAAuAgAABAAAAAmAAAACAAAAAAAAAAAAAAA"/>
+                <pr:smNativeData xmlns:pr="smNativeData" xmlns="smNativeData" val="SMDATA_15_7aDWaRMAAAAlAAAAZAAAAA8BAAAAkAAAAEgAAACQAAAASAAAAAAAAAABAAAAAAAAAAEAAABQAAAAAAAAAAAA4D8AAAAAAADgPwAAAAAAAOA/AAAAAAAA4D8AAAAAAADgPwAAAAAAAOA/AAAAAAAA4D8AAAAAAADgPwAAAAAAAOA/AAAAAAAA4D8CAAAAjAAAAAAAAAAAAAAAu+DjDP///wgAAAAAAAAAAAAAAAAAAAAAAAAAAAAAAAAAAAAAZAAAAAEAAABAAAAAAAAAAAAAAAAAAAAAAAAAAAAAAAAAAAAAAAAAAAAAAAAAAAAAAAAAAAAAAAAAAAAAAAAAAAAAAAAAAAAAAAAAAAAAAAAAAAAAAAAAAAAAAAAAAAAAFAAAADwAAAAAAAAAAAAAAAAAAAkUAAAAAQAAABQAAAAUAAAAFAAAAAEAAAAAAAAAZAAAAGQAAAAAAAAAZAAAAGQAAAAVAAAAYAAAAAAAAAAAAAAADwAAACADAAAAAAAAAAAAAAEAAACgMgAAVgcAAKr4//8BAAAAf39/AAEAAABkAAAAAAAAABQAAABAHwAAAAAAACYAAAAAAAAAwOD//wAAAAAmAAAAZAAAABYAAABMAAAAAAAAAAAAAAAEAAAAAAAAAAEAAACAgIAKAAAAACgAAAAoAAAAZAAAAGQAAAAAAAAAzMzMAAAAAABQAAAAUAAAAGQAAABkAAAAAAAAABcAAAAUAAAAAAAAAAAAAAD/fwAA/38AAAAAAAAJAAAABAAAANw7IAEeAAAAaAAAAAAAAAAAAAAAAAAAAAAAAAAAAAAAECcAABAnAAAAAAAAAAAAAAAAAAAAAAAAAAAAAAAAAAAAAAAAAAAAABQAAAAAAAAAwMD/AAAAAABkAAAAMgAAAAAAAABkAAAAAAAAAH9/fwAKAAAAIgAAABgAAAAAAAAAAAAAAAAAAAAAAAAAAAAAAAAAAAAkAAAAJAAAAAAAAAAHAAAAAAAAAAAAAAAAAAAAAAAAAAAAAAAAAAAAf39/ACUAAABYAAAAAAAAAAAAAAAAAAAAAAAAAAAAAAAAAAAAAAAAAAAAAAAAAAAAAAAAAAAAAAA/AAAAAAAAAKCGAQAAAAAAAAAAAAAAAAAMAAAAAQAAAAAAAAAAAAAAAAAAAB8AAABUAAAAAAAABQAAAAEAAAAAAAAAAAAAAAAAAAAAAAAAAAAAAAAAAAAAAAAAAAAAAAJ/f38AAAAAA8zMzADAwP8Af39/AAAAAAAAAAAAAAAAAAAAAAAAAAAAIQAAABgAAAAUAAAAwAMAALABAABARwAAuAgAABAAAAAmAAAACAAAAAAAAAAAAAAA"/>
               </a:ext>
             </a:extLst>
           </p:cNvSpPr>
@@ -1255,7 +1245,7 @@
             <a:spLocks noGrp="1" noChangeArrowheads="1"/>
             <a:extLst>
               <a:ext uri="smNativeData">
-                <pr:smNativeData xmlns:pr="smNativeData" xmlns="smNativeData" val="SMDATA_15_AnHWaRMAAAAlAAAAZAAAAA8BAAAAkAAAAEgAAACQAAAASAAAAAAAAAAAAAAAAAAAAAEAAABQAAAAAAAAAAAA4D8AAAAAAADgPwAAAAAAAOA/AAAAAAAA4D8AAAAAAADgPwAAAAAAAOA/AAAAAAAA4D8AAAAAAADgPwAAAAAAAOA/AAAAAAAA4D8CAAAAjAAAAAAAAAAAAAAAu+DjDP///wgAAAAAAAAAAAAAAAAAAAAAAAAAAAAAAAAAAAAAZAAAAAEAAABAAAAAAAAAAAAAAAAAAAAAAAAAAAAAAAAAAAAAAAAAAAAAAAAAAAAAAAAAAAAAAAAAAAAAAAAAAAAAAAAAAAAAAAAAAAAAAAAAAAAAAAAAAAAAAAAAAAAAFAAAADwAAAAAAAAAAAAAAAAAAAkUAAAAAQAAABQAAAAUAAAAFAAAAAEAAAAAAAAAZAAAAGQAAAAAAAAAZAAAAGQAAAAVAAAAYAAAAAAAAAAAAAAADwAAACADAAAAAAAAAAAAAAEAAACgMgAAVgcAAKr4//8BAAAAf39/AAEAAABkAAAAAAAAABQAAABAHwAAAAAAACYAAAAAAAAAwOD//wAAAAAmAAAAZAAAABYAAABMAAAAAAAAAAAAAAAEAAAAAAAAAAEAAACAgIAKAAAAACgAAAAoAAAAZAAAAGQAAAAAAAAAzMzMAAAAAABQAAAAUAAAAGQAAABkAAAAAAAAABcAAAAUAAAAAAAAAAAAAAD/fwAA/38AAAAAAAAJAAAABAAAANw7IAEeAAAAaAAAAAAAAAAAAAAAAAAAAAAAAAAAAAAAECcAABAnAAAAAAAAAAAAAAAAAAAAAAAAAAAAAAAAAAAAAAAAAAAAABQAAAAAAAAAwMD/AAAAAABkAAAAMgAAAAAAAABkAAAAAAAAAH9/fwAKAAAAIgAAABgAAAAAAAAAAAAAAAAAAAAAAAAAAAAAAAAAAAAkAAAAJAAAAAAAAAAHAAAAAAAAAAAAAAAAAAAAAAAAAAAAAAAAAAAAf39/ACUAAABYAAAAAAAAAAAAAAAAAAAAAAAAAAAAAAAAAAAAAAAAAAAAAAAAAAAAAAAAAAAAAAA/AAAAAAAAAKCGAQAAAAAAAAAAAAAAAAAMAAAAAQAAAAAAAAAAAAAAAAAAAB8AAABUAAAAAAAABQAAAAEAAAAAAAAAAAAAAAAAAAAAAAAAAAAAAAAAAAAAAAAAAAAAAAJ/f38AAAAAA8zMzADAwP8Af39/AAAAAAAAAAAAAAAAAAAAAAAAAAAAIQAAABgAAAAUAAAAwAMAANgJAADhJAAAsCUAABAAAAAmAAAACAAAAAGAAAAAAAAA"/>
+                <pr:smNativeData xmlns:pr="smNativeData" xmlns="smNativeData" val="SMDATA_15_7aDWaRMAAAAlAAAAZAAAAA8BAAAAkAAAAEgAAACQAAAASAAAAAAAAAAAAAAAAAAAAAEAAABQAAAAAAAAAAAA4D8AAAAAAADgPwAAAAAAAOA/AAAAAAAA4D8AAAAAAADgPwAAAAAAAOA/AAAAAAAA4D8AAAAAAADgPwAAAAAAAOA/AAAAAAAA4D8CAAAAjAAAAAAAAAAAAAAAu+DjDP///wgAAAAAAAAAAAAAAAAAAAAAAAAAAAAAAAAAAAAAZAAAAAEAAABAAAAAAAAAAAAAAAAAAAAAAAAAAAAAAAAAAAAAAAAAAAAAAAAAAAAAAAAAAAAAAAAAAAAAAAAAAAAAAAAAAAAAAAAAAAAAAAAAAAAAAAAAAAAAAAAAAAAAFAAAADwAAAAAAAAAAAAAAAAAAAkUAAAAAQAAABQAAAAUAAAAFAAAAAEAAAAAAAAAZAAAAGQAAAAAAAAAZAAAAGQAAAAVAAAAYAAAAAAAAAAAAAAADwAAACADAAAAAAAAAAAAAAEAAACgMgAAVgcAAKr4//8BAAAAf39/AAEAAABkAAAAAAAAABQAAABAHwAAAAAAACYAAAAAAAAAwOD//wAAAAAmAAAAZAAAABYAAABMAAAAAAAAAAAAAAAEAAAAAAAAAAEAAACAgIAKAAAAACgAAAAoAAAAZAAAAGQAAAAAAAAAzMzMAAAAAABQAAAAUAAAAGQAAABkAAAAAAAAABcAAAAUAAAAAAAAAAAAAAD/fwAA/38AAAAAAAAJAAAABAAAANw7IAEeAAAAaAAAAAAAAAAAAAAAAAAAAAAAAAAAAAAAECcAABAnAAAAAAAAAAAAAAAAAAAAAAAAAAAAAAAAAAAAAAAAAAAAABQAAAAAAAAAwMD/AAAAAABkAAAAMgAAAAAAAABkAAAAAAAAAH9/fwAKAAAAIgAAABgAAAAAAAAAAAAAAAAAAAAAAAAAAAAAAAAAAAAkAAAAJAAAAAAAAAAHAAAAAAAAAAAAAAAAAAAAAAAAAAAAAAAAAAAAf39/ACUAAABYAAAAAAAAAAAAAAAAAAAAAAAAAAAAAAAAAAAAAAAAAAAAAAAAAAAAAAAAAAAAAAA/AAAAAAAAAKCGAQAAAAAAAAAAAAAAAAAMAAAAAQAAAAAAAAAAAAAAAAAAAB8AAABUAAAAAAAABQAAAAEAAAAAAAAAAAAAAAAAAAAAAAAAAAAAAAAAAAAAAAAAAAAAAAJ/f38AAAAAA8zMzADAwP8Af39/AAAAAAAAAAAAAAAAAAAAAAAAAAAAIQAAABgAAAAUAAAAwAMAANgJAADhJAAAsCUAABAAAAAmAAAACAAAAAGAAAAAAAAA"/>
               </a:ext>
             </a:extLst>
           </p:cNvSpPr>
@@ -1339,7 +1329,7 @@
             <a:spLocks noGrp="1" noChangeArrowheads="1"/>
             <a:extLst>
               <a:ext uri="smNativeData">
-                <pr:smNativeData xmlns:pr="smNativeData" xmlns="smNativeData" val="SMDATA_15_AnHWaRMAAAAlAAAAZAAAAA8BAAAAkAAAAEgAAACQAAAASAAAAAAAAAAAAAAAAAAAAAEAAABQAAAAAAAAAAAA4D8AAAAAAADgPwAAAAAAAOA/AAAAAAAA4D8AAAAAAADgPwAAAAAAAOA/AAAAAAAA4D8AAAAAAADgPwAAAAAAAOA/AAAAAAAA4D8CAAAAjAAAAAAAAAAAAAAAu+DjDP///wgAAAAAAAAAAAAAAAAAAAAAAAAAAAAAAAAAAAAAZAAAAAEAAABAAAAAAAAAAAAAAAAAAAAAAAAAAAAAAAAAAAAAAAAAAAAAAAAAAAAAAAAAAAAAAAAAAAAAAAAAAAAAAAAAAAAAAAAAAAAAAAAAAAAAAAAAAAAAAAAAAAAAFAAAADwAAAAAAAAAAAAAAAAAAAkUAAAAAQAAABQAAAAUAAAAFAAAAAEAAAAAAAAAZAAAAGQAAAAAAAAAZAAAAGQAAAAVAAAAYAAAAAAAAAAAAAAADwAAACADAAAAAAAAAAAAAAEAAACgMgAAVgcAAKr4//8BAAAAf39/AAEAAABkAAAAAAAAABQAAABAHwAAAAAAACYAAAAAAAAAwOD//wAAAAAmAAAAZAAAABYAAABMAAAAAAAAAAAAAAAEAAAAAAAAAAEAAACAgIAKAAAAACgAAAAoAAAAZAAAAGQAAAAAAAAAzMzMAAAAAABQAAAAUAAAAGQAAABkAAAAAAAAABcAAAAUAAAAAAAAAAAAAAD/fwAA/38AAAAAAAAJAAAABAAAANw7IAEeAAAAaAAAAAAAAAAAAAAAAAAAAAAAAAAAAAAAECcAABAnAAAAAAAAAAAAAAAAAAAAAAAAAAAAAAAAAAAAAAAAAAAAABQAAAAAAAAAwMD/AAAAAABkAAAAMgAAAAAAAABkAAAAAAAAAH9/fwAKAAAAIgAAABgAAAAAAAAAAAAAAAAAAAAAAAAAAAAAAAAAAAAkAAAAJAAAAAAAAAAHAAAAAAAAAAAAAAAAAAAAAAAAAAAAAAAAAAAAf39/ACUAAABYAAAAAAAAAAAAAAAAAAAAAAAAAAAAAAAAAAAAAAAAAAAAAAAAAAAAAAAAAAAAAAA/AAAAAAAAAKCGAQAAAAAAAAAAAAAAAAAMAAAAAQAAAAAAAAAAAAAAAAAAAB8AAABUAAAAAAAABQAAAAEAAAAAAAAAAAAAAAAAAAAAAAAAAAAAAAAAAAAAAAAAAAAAAAJ/f38AAAAAA8zMzADAwP8Af39/AAAAAAAAAAAAAAAAAAAAAAAAAAAAIQAAABgAAAAUAAAAHyYAANgJAABARwAAsCUAABAAAAAmAAAACAAAAAGAAAAAAAAA"/>
+                <pr:smNativeData xmlns:pr="smNativeData" xmlns="smNativeData" val="SMDATA_15_7aDWaRMAAAAlAAAAZAAAAA8BAAAAkAAAAEgAAACQAAAASAAAAAAAAAAAAAAAAAAAAAEAAABQAAAAAAAAAAAA4D8AAAAAAADgPwAAAAAAAOA/AAAAAAAA4D8AAAAAAADgPwAAAAAAAOA/AAAAAAAA4D8AAAAAAADgPwAAAAAAAOA/AAAAAAAA4D8CAAAAjAAAAAAAAAAAAAAAu+DjDP///wgAAAAAAAAAAAAAAAAAAAAAAAAAAAAAAAAAAAAAZAAAAAEAAABAAAAAAAAAAAAAAAAAAAAAAAAAAAAAAAAAAAAAAAAAAAAAAAAAAAAAAAAAAAAAAAAAAAAAAAAAAAAAAAAAAAAAAAAAAAAAAAAAAAAAAAAAAAAAAAAAAAAAFAAAADwAAAAAAAAAAAAAAAAAAAkUAAAAAQAAABQAAAAUAAAAFAAAAAEAAAAAAAAAZAAAAGQAAAAAAAAAZAAAAGQAAAAVAAAAYAAAAAAAAAAAAAAADwAAACADAAAAAAAAAAAAAAEAAACgMgAAVgcAAKr4//8BAAAAf39/AAEAAABkAAAAAAAAABQAAABAHwAAAAAAACYAAAAAAAAAwOD//wAAAAAmAAAAZAAAABYAAABMAAAAAAAAAAAAAAAEAAAAAAAAAAEAAACAgIAKAAAAACgAAAAoAAAAZAAAAGQAAAAAAAAAzMzMAAAAAABQAAAAUAAAAGQAAABkAAAAAAAAABcAAAAUAAAAAAAAAAAAAAD/fwAA/38AAAAAAAAJAAAABAAAANw7IAEeAAAAaAAAAAAAAAAAAAAAAAAAAAAAAAAAAAAAECcAABAnAAAAAAAAAAAAAAAAAAAAAAAAAAAAAAAAAAAAAAAAAAAAABQAAAAAAAAAwMD/AAAAAABkAAAAMgAAAAAAAABkAAAAAAAAAH9/fwAKAAAAIgAAABgAAAAAAAAAAAAAAAAAAAAAAAAAAAAAAAAAAAAkAAAAJAAAAAAAAAAHAAAAAAAAAAAAAAAAAAAAAAAAAAAAAAAAAAAAf39/ACUAAABYAAAAAAAAAAAAAAAAAAAAAAAAAAAAAAAAAAAAAAAAAAAAAAAAAAAAAAAAAAAAAAA/AAAAAAAAAKCGAQAAAAAAAAAAAAAAAAAMAAAAAQAAAAAAAAAAAAAAAAAAAB8AAABUAAAAAAAABQAAAAEAAAAAAAAAAAAAAAAAAAAAAAAAAAAAAAAAAAAAAAAAAAAAAAJ/f38AAAAAA8zMzADAwP8Af39/AAAAAAAAAAAAAAAAAAAAAAAAAAAAIQAAABgAAAAUAAAAHyYAANgJAABARwAAsCUAABAAAAAmAAAACAAAAAGAAAAAAAAA"/>
               </a:ext>
             </a:extLst>
           </p:cNvSpPr>
@@ -1423,7 +1413,7 @@
             <a:spLocks noGrp="1" noChangeArrowheads="1"/>
             <a:extLst>
               <a:ext uri="smNativeData">
-                <pr:smNativeData xmlns:pr="smNativeData" xmlns="smNativeData" val="SMDATA_15_AnHWaRMAAAAlAAAAZAAAAA8BAAAAkAAAAEgAAACQAAAASAAAAAAAAAABAAAAAAAAAAEAAABQAAAAAAAAAAAA4D8AAAAAAADgPwAAAAAAAOA/AAAAAAAA4D8AAAAAAADgPwAAAAAAAOA/AAAAAAAA4D8AAAAAAADgPwAAAAAAAOA/AAAAAAAA4D8CAAAAjAAAAAAAAAAAAAAAu+DjDP///wgAAAAAAAAAAAAAAAAAAAAAAAAAAAAAAAAAAAAAZAAAAAEAAABAAAAAAAAAAAAAAAAAAAAAAAAAAAAAAAAAAAAAAAAAAAAAAAAAAAAAAAAAAAAAAAAAAAAAAAAAAAAAAAAAAAAAAAAAAAAAAAAAAAAAAAAAAAAAAAAAAAAAFAAAADwAAAAAAAAAAAAAAAAAAAkUAAAAAQAAABQAAAAUAAAAFAAAAAEAAAAAAAAAZAAAAGQAAAAAAAAAZAAAAGQAAAAVAAAAYAAAAAAAAAAAAAAADwAAACADAAAAAAAAAAAAAAEAAACgMgAAVgcAAKr4//8BAAAAf39/AAEAAABkAAAAAAAAABQAAABAHwAAAAAAACYAAAAAAAAAwOD//wAAAAAmAAAAZAAAABYAAABMAAAAAAAAAAAAAAAEAAAAAAAAAAEAAACAgIAKAAAAACgAAAAoAAAAZAAAAGQAAAAAAAAAzMzMAAAAAABQAAAAUAAAAGQAAABkAAAAAAAAABcAAAAUAAAAAAAAAAAAAAD/fwAA/38AAAAAAAAJAAAABAAAANw7IAEeAAAAaAAAAAAAAAAAAAAAAAAAAAAAAAAAAAAAECcAABAnAAAAAAAAAAAAAAAAAAAAAAAAAAAAAAAAAAAAAAAAAAAAABQAAAAAAAAAwMD/AAAAAABkAAAAMgAAAAAAAABkAAAAAAAAAH9/fwAKAAAAIgAAABgAAAAAAAAAAAAAAAAAAAAAAAAAAAAAAAAAAAAkAAAAJAAAAAAAAAAHAAAAAAAAAAAAAAAAAAAAAAAAAAAAAAAAAAAAf39/ACUAAABYAAAAAAAAAAAAAAAAAAAAAAAAAAAAAAAAAAAAAAAAAAAAAAAAAAAAAAAAAAAAAAA/AAAAAAAAAKCGAQAAAAAAAAAAAAAAAAAMAAAAAQAAAAAAAAAAAAAAAAAAAB8AAABUAAAAAAAABQAAAAEAAAAAAAAAAAAAAAAAAAAAAAAAAAAAAAAAAAAAAAAAAAAAAAJ/f38AAAAAA8zMzADAwP8Af39/AAAAAAAAAAAAAAAAAAAAAAAAAAAAIQAAABgAAAAUAAAAwAMAABsnAAA/FQAAWSkAABAAAAAmAAAACAAAAAAAAAAAAAAA"/>
+                <pr:smNativeData xmlns:pr="smNativeData" xmlns="smNativeData" val="SMDATA_15_7aDWaRMAAAAlAAAAZAAAAA8BAAAAkAAAAEgAAACQAAAASAAAAAAAAAABAAAAAAAAAAEAAABQAAAAAAAAAAAA4D8AAAAAAADgPwAAAAAAAOA/AAAAAAAA4D8AAAAAAADgPwAAAAAAAOA/AAAAAAAA4D8AAAAAAADgPwAAAAAAAOA/AAAAAAAA4D8CAAAAjAAAAAAAAAAAAAAAu+DjDP///wgAAAAAAAAAAAAAAAAAAAAAAAAAAAAAAAAAAAAAZAAAAAEAAABAAAAAAAAAAAAAAAAAAAAAAAAAAAAAAAAAAAAAAAAAAAAAAAAAAAAAAAAAAAAAAAAAAAAAAAAAAAAAAAAAAAAAAAAAAAAAAAAAAAAAAAAAAAAAAAAAAAAAFAAAADwAAAAAAAAAAAAAAAAAAAkUAAAAAQAAABQAAAAUAAAAFAAAAAEAAAAAAAAAZAAAAGQAAAAAAAAAZAAAAGQAAAAVAAAAYAAAAAAAAAAAAAAADwAAACADAAAAAAAAAAAAAAEAAACgMgAAVgcAAKr4//8BAAAAf39/AAEAAABkAAAAAAAAABQAAABAHwAAAAAAACYAAAAAAAAAwOD//wAAAAAmAAAAZAAAABYAAABMAAAAAAAAAAAAAAAEAAAAAAAAAAEAAACAgIAKAAAAACgAAAAoAAAAZAAAAGQAAAAAAAAAzMzMAAAAAABQAAAAUAAAAGQAAABkAAAAAAAAABcAAAAUAAAAAAAAAAAAAAD/fwAA/38AAAAAAAAJAAAABAAAANw7IAEeAAAAaAAAAAAAAAAAAAAAAAAAAAAAAAAAAAAAECcAABAnAAAAAAAAAAAAAAAAAAAAAAAAAAAAAAAAAAAAAAAAAAAAABQAAAAAAAAAwMD/AAAAAABkAAAAMgAAAAAAAABkAAAAAAAAAH9/fwAKAAAAIgAAABgAAAAAAAAAAAAAAAAAAAAAAAAAAAAAAAAAAAAkAAAAJAAAAAAAAAAHAAAAAAAAAAAAAAAAAAAAAAAAAAAAAAAAAAAAf39/ACUAAABYAAAAAAAAAAAAAAAAAAAAAAAAAAAAAAAAAAAAAAAAAAAAAAAAAAAAAAAAAAAAAAA/AAAAAAAAAKCGAQAAAAAAAAAAAAAAAAAMAAAAAQAAAAAAAAAAAAAAAAAAAB8AAABUAAAAAAAABQAAAAEAAAAAAAAAAAAAAAAAAAAAAAAAAAAAAAAAAAAAAAAAAAAAAAJ/f38AAAAAA8zMzADAwP8Af39/AAAAAAAAAAAAAAAAAAAAAAAAAAAAIQAAABgAAAAUAAAAwAMAABsnAAA/FQAAWSkAABAAAAAmAAAACAAAAAAAAAAAAAAA"/>
               </a:ext>
             </a:extLst>
           </p:cNvSpPr>
@@ -1437,7 +1427,7 @@
           <a:lstStyle/>
           <a:p>
             <a:pPr/>
-            <a:fld id="{5F8980A9-E7B2-DC76-FC31-1123CE7F0A44}" type="datetime1">
+            <a:fld id="{490CEAED-A3A4-591C-EAB4-5549A4FA1C00}" type="datetime1">
               <a:t/>
             </a:fld>
           </a:p>
@@ -1450,7 +1440,7 @@
             <a:spLocks noGrp="1" noChangeArrowheads="1"/>
             <a:extLst>
               <a:ext uri="smNativeData">
-                <pr:smNativeData xmlns:pr="smNativeData" xmlns="smNativeData" val="SMDATA_15_AnHWaRMAAAAlAAAAZAAAAA8BAAAAkAAAAEgAAACQAAAASAAAAAAAAAABAAAAAAAAAAEAAABQAAAAAAAAAAAA4D8AAAAAAADgPwAAAAAAAOA/AAAAAAAA4D8AAAAAAADgPwAAAAAAAOA/AAAAAAAA4D8AAAAAAADgPwAAAAAAAOA/AAAAAAAA4D8CAAAAjAAAAAAAAAAAAAAAu+DjDP///wgAAAAAAAAAAAAAAAAAAAAAAAAAAAAAAAAAAAAAZAAAAAEAAABAAAAAAAAAAAAAAAAAAAAAAAAAAAAAAAAAAAAAAAAAAAAAAAAAAAAAAAAAAAAAAAAAAAAAAAAAAAAAAAAAAAAAAAAAAAAAAAAAAAAAAAAAAAAAAAAAAAAAFAAAADwAAAAAAAAAAAAAAAAAAAkUAAAAAQAAABQAAAAUAAAAFAAAAAEAAAAAAAAAZAAAAGQAAAAAAAAAZAAAAGQAAAAVAAAAYAAAAAAAAAAAAAAADwAAACADAAAAAAAAAAAAAAEAAACgMgAAVgcAAKr4//8BAAAAf39/AAEAAABkAAAAAAAAABQAAABAHwAAAAAAACYAAAAAAAAAwOD//wAAAAAmAAAAZAAAABYAAABMAAAAAAAAAAAAAAAEAAAAAAAAAAEAAACAgIAKAAAAACgAAAAoAAAAZAAAAGQAAAAAAAAAzMzMAAAAAABQAAAAUAAAAGQAAABkAAAAAAAAABcAAAAUAAAAAAAAAAAAAAD/fwAA/38AAAAAAAAJAAAABAAAANw7IAEeAAAAaAAAAAAAAAAAAAAAAAAAAAAAAAAAAAAAECcAABAnAAAAAAAAAAAAAAAAAAAAAAAAAAAAAAAAAAAAAAAAAAAAABQAAAAAAAAAwMD/AAAAAABkAAAAMgAAAAAAAABkAAAAAAAAAH9/fwAKAAAAIgAAABgAAAAAAAAAAAAAAAAAAAAAAAAAAAAAAAAAAAAkAAAAJAAAAAAAAAAHAAAAAAAAAAAAAAAAAAAAAAAAAAAAAAAAAAAAf39/ACUAAABYAAAAAAAAAAAAAAAAAAAAAAAAAAAAAAAAAAAAAAAAAAAAAAAAAAAAAAAAAAAAAAA/AAAAAAAAAKCGAQAAAAAAAAAAAAAAAAAMAAAAAQAAAAAAAAAAAAAAAAAAAB8AAABUAAAAAAAABQAAAAEAAAAAAAAAAAAAAAAAAAAAAAAAAAAAAAAAAAAAAAAAAAAAAAJ/f38AAAAAA8zMzADAwP8Af39/AAAAAAAAAAAAAAAAAAAAAAAAAAAAIQAAABgAAAAUAAAAoRkAABsnAABfMQAAWSkAABAAAAAmAAAACAAAAAAAAAAAAAAA"/>
+                <pr:smNativeData xmlns:pr="smNativeData" xmlns="smNativeData" val="SMDATA_15_7aDWaRMAAAAlAAAAZAAAAA8BAAAAkAAAAEgAAACQAAAASAAAAAAAAAABAAAAAAAAAAEAAABQAAAAAAAAAAAA4D8AAAAAAADgPwAAAAAAAOA/AAAAAAAA4D8AAAAAAADgPwAAAAAAAOA/AAAAAAAA4D8AAAAAAADgPwAAAAAAAOA/AAAAAAAA4D8CAAAAjAAAAAAAAAAAAAAAu+DjDP///wgAAAAAAAAAAAAAAAAAAAAAAAAAAAAAAAAAAAAAZAAAAAEAAABAAAAAAAAAAAAAAAAAAAAAAAAAAAAAAAAAAAAAAAAAAAAAAAAAAAAAAAAAAAAAAAAAAAAAAAAAAAAAAAAAAAAAAAAAAAAAAAAAAAAAAAAAAAAAAAAAAAAAFAAAADwAAAAAAAAAAAAAAAAAAAkUAAAAAQAAABQAAAAUAAAAFAAAAAEAAAAAAAAAZAAAAGQAAAAAAAAAZAAAAGQAAAAVAAAAYAAAAAAAAAAAAAAADwAAACADAAAAAAAAAAAAAAEAAACgMgAAVgcAAKr4//8BAAAAf39/AAEAAABkAAAAAAAAABQAAABAHwAAAAAAACYAAAAAAAAAwOD//wAAAAAmAAAAZAAAABYAAABMAAAAAAAAAAAAAAAEAAAAAAAAAAEAAACAgIAKAAAAACgAAAAoAAAAZAAAAGQAAAAAAAAAzMzMAAAAAABQAAAAUAAAAGQAAABkAAAAAAAAABcAAAAUAAAAAAAAAAAAAAD/fwAA/38AAAAAAAAJAAAABAAAANw7IAEeAAAAaAAAAAAAAAAAAAAAAAAAAAAAAAAAAAAAECcAABAnAAAAAAAAAAAAAAAAAAAAAAAAAAAAAAAAAAAAAAAAAAAAABQAAAAAAAAAwMD/AAAAAABkAAAAMgAAAAAAAABkAAAAAAAAAH9/fwAKAAAAIgAAABgAAAAAAAAAAAAAAAAAAAAAAAAAAAAAAAAAAAAkAAAAJAAAAAAAAAAHAAAAAAAAAAAAAAAAAAAAAAAAAAAAAAAAAAAAf39/ACUAAABYAAAAAAAAAAAAAAAAAAAAAAAAAAAAAAAAAAAAAAAAAAAAAAAAAAAAAAAAAAAAAAA/AAAAAAAAAKCGAQAAAAAAAAAAAAAAAAAMAAAAAQAAAAAAAAAAAAAAAAAAAB8AAABUAAAAAAAABQAAAAEAAAAAAAAAAAAAAAAAAAAAAAAAAAAAAAAAAAAAAAAAAAAAAAJ/f38AAAAAA8zMzADAwP8Af39/AAAAAAAAAAAAAAAAAAAAAAAAAAAAIQAAABgAAAAUAAAAoRkAABsnAABfMQAAWSkAABAAAAAmAAAACAAAAAAAAAAAAAAA"/>
               </a:ext>
             </a:extLst>
           </p:cNvSpPr>
@@ -1464,9 +1454,6 @@
           <a:lstStyle/>
           <a:p>
             <a:pPr/>
-            <a:r>
-              <a:t/>
-            </a:r>
           </a:p>
         </p:txBody>
       </p:sp>
@@ -1477,7 +1464,7 @@
             <a:spLocks noGrp="1" noChangeArrowheads="1"/>
             <a:extLst>
               <a:ext uri="smNativeData">
-                <pr:smNativeData xmlns:pr="smNativeData" xmlns="smNativeData" val="SMDATA_15_AnHWaRMAAAAlAAAAZAAAAA8BAAAAkAAAAEgAAACQAAAASAAAAAAAAAABAAAAAAAAAAEAAABQAAAAAAAAAAAA4D8AAAAAAADgPwAAAAAAAOA/AAAAAAAA4D8AAAAAAADgPwAAAAAAAOA/AAAAAAAA4D8AAAAAAADgPwAAAAAAAOA/AAAAAAAA4D8CAAAAjAAAAAAAAAAAAAAAu+DjDP///wgAAAAAAAAAAAAAAAAAAAAAAAAAAAAAAAAAAAAAZAAAAAEAAABAAAAAAAAAAAAAAAAAAAAAAAAAAAAAAAAAAAAAAAAAAAAAAAAAAAAAAAAAAAAAAAAAAAAAAAAAAAAAAAAAAAAAAAAAAAAAAAAAAAAAAAAAAAAAAAAAAAAAFAAAADwAAAAAAAAAAAAAAAAAAAkUAAAAAQAAABQAAAAUAAAAFAAAAAEAAAAAAAAAZAAAAGQAAAAAAAAAZAAAAGQAAAAVAAAAYAAAAAAAAAAAAAAADwAAACADAAAAAAAAAAAAAAEAAACgMgAAVgcAAKr4//8BAAAAf39/AAEAAABkAAAAAAAAABQAAABAHwAAAAAAACYAAAAAAAAAwOD//wAAAAAmAAAAZAAAABYAAABMAAAAAAAAAAAAAAAEAAAAAAAAAAEAAACAgIAKAAAAACgAAAAoAAAAZAAAAGQAAAAAAAAAzMzMAAAAAABQAAAAUAAAAGQAAABkAAAAAAAAABcAAAAUAAAAAAAAAAAAAAD/fwAA/38AAAAAAAAJAAAABAAAANw7IAEeAAAAaAAAAAAAAAAAAAAAAAAAAAAAAAAAAAAAECcAABAnAAAAAAAAAAAAAAAAAAAAAAAAAAAAAAAAAAAAAAAAAAAAABQAAAAAAAAAwMD/AAAAAABkAAAAMgAAAAAAAABkAAAAAAAAAH9/fwAKAAAAIgAAABgAAAAAAAAAAAAAAAAAAAAAAAAAAAAAAAAAAAAkAAAAJAAAAAAAAAAHAAAAAAAAAAAAAAAAAAAAAAAAAAAAAAAAAAAAf39/ACUAAABYAAAAAAAAAAAAAAAAAAAAAAAAAAAAAAAAAAAAAAAAAAAAAAAAAAAAAAAAAAAAAAA/AAAAAAAAAKCGAQAAAAAAAAAAAAAAAAAMAAAAAQAAAAAAAAAAAAAAAAAAAB8AAABUAAAAAAAABQAAAAEAAAAAAAAAAAAAAAAAAAAAAAAAAAAAAAAAAAAAAAAAAAAAAAJ/f38AAAAAA8zMzADAwP8Af39/AAAAAAAAAAAAAAAAAAAAAAAAAAAAIQAAABgAAAAUAAAAwTUAABsnAABARwAAWSkAABAAAAAmAAAACAAAAAAAAAAAAAAA"/>
+                <pr:smNativeData xmlns:pr="smNativeData" xmlns="smNativeData" val="SMDATA_15_7aDWaRMAAAAlAAAAZAAAAA8BAAAAkAAAAEgAAACQAAAASAAAAAAAAAABAAAAAAAAAAEAAABQAAAAAAAAAAAA4D8AAAAAAADgPwAAAAAAAOA/AAAAAAAA4D8AAAAAAADgPwAAAAAAAOA/AAAAAAAA4D8AAAAAAADgPwAAAAAAAOA/AAAAAAAA4D8CAAAAjAAAAAAAAAAAAAAAu+DjDP///wgAAAAAAAAAAAAAAAAAAAAAAAAAAAAAAAAAAAAAZAAAAAEAAABAAAAAAAAAAAAAAAAAAAAAAAAAAAAAAAAAAAAAAAAAAAAAAAAAAAAAAAAAAAAAAAAAAAAAAAAAAAAAAAAAAAAAAAAAAAAAAAAAAAAAAAAAAAAAAAAAAAAAFAAAADwAAAAAAAAAAAAAAAAAAAkUAAAAAQAAABQAAAAUAAAAFAAAAAEAAAAAAAAAZAAAAGQAAAAAAAAAZAAAAGQAAAAVAAAAYAAAAAAAAAAAAAAADwAAACADAAAAAAAAAAAAAAEAAACgMgAAVgcAAKr4//8BAAAAf39/AAEAAABkAAAAAAAAABQAAABAHwAAAAAAACYAAAAAAAAAwOD//wAAAAAmAAAAZAAAABYAAABMAAAAAAAAAAAAAAAEAAAAAAAAAAEAAACAgIAKAAAAACgAAAAoAAAAZAAAAGQAAAAAAAAAzMzMAAAAAABQAAAAUAAAAGQAAABkAAAAAAAAABcAAAAUAAAAAAAAAAAAAAD/fwAA/38AAAAAAAAJAAAABAAAANw7IAEeAAAAaAAAAAAAAAAAAAAAAAAAAAAAAAAAAAAAECcAABAnAAAAAAAAAAAAAAAAAAAAAAAAAAAAAAAAAAAAAAAAAAAAABQAAAAAAAAAwMD/AAAAAABkAAAAMgAAAAAAAABkAAAAAAAAAH9/fwAKAAAAIgAAABgAAAAAAAAAAAAAAAAAAAAAAAAAAAAAAAAAAAAkAAAAJAAAAAAAAAAHAAAAAAAAAAAAAAAAAAAAAAAAAAAAAAAAAAAAf39/ACUAAABYAAAAAAAAAAAAAAAAAAAAAAAAAAAAAAAAAAAAAAAAAAAAAAAAAAAAAAAAAAAAAAA/AAAAAAAAAKCGAQAAAAAAAAAAAAAAAAAMAAAAAQAAAAAAAAAAAAAAAAAAAB8AAABUAAAAAAAABQAAAAEAAAAAAAAAAAAAAAAAAAAAAAAAAAAAAAAAAAAAAAAAAAAAAAJ/f38AAAAAA8zMzADAwP8Af39/AAAAAAAAAAAAAAAAAAAAAAAAAAAAIQAAABgAAAAUAAAAwTUAABsnAABARwAAWSkAABAAAAAmAAAACAAAAAAAAAAAAAAA"/>
               </a:ext>
             </a:extLst>
           </p:cNvSpPr>
@@ -1491,7 +1478,7 @@
           <a:lstStyle/>
           <a:p>
             <a:pPr/>
-            <a:fld id="{453CED28-66A8-691B-E684-904EA3CA10C5}" type="slidenum">
+            <a:fld id="{3C7D8877-39D1-287E-9FC5-CF2BC68B699A}" type="slidenum">
               <a:t/>
             </a:fld>
           </a:p>
@@ -1502,6 +1489,7 @@
   <p:clrMapOvr>
     <a:masterClrMapping/>
   </p:clrMapOvr>
+  <p:hf hdr="0" ftr="0"/>
 </p:sldLayout>
 </file>
 
@@ -1529,7 +1517,7 @@
             <a:spLocks noGrp="1" noChangeArrowheads="1"/>
             <a:extLst>
               <a:ext uri="smNativeData">
-                <pr:smNativeData xmlns:pr="smNativeData" xmlns="smNativeData" val="SMDATA_15_AnHWaRMAAAAlAAAAZAAAAA8BAAAAkAAAAEgAAACQAAAASAAAAAAAAAABAAAAAAAAAAEAAABQAAAAAAAAAAAA4D8AAAAAAADgPwAAAAAAAOA/AAAAAAAA4D8AAAAAAADgPwAAAAAAAOA/AAAAAAAA4D8AAAAAAADgPwAAAAAAAOA/AAAAAAAA4D8CAAAAjAAAAAAAAAAAAAAAu+DjDP///wgAAAAAAAAAAAAAAAAAAAAAAAAAAAAAAAAAAAAAZAAAAAEAAABAAAAAAAAAAAAAAAAAAAAAAAAAAAAAAAAAAAAAAAAAAAAAAAAAAAAAAAAAAAAAAAAAAAAAAAAAAAAAAAAAAAAAAAAAAAAAAAAAAAAAAAAAAAAAAAAAAAAAFAAAADwAAAAAAAAAAAAAAAAAAAkUAAAAAQAAABQAAAAUAAAAFAAAAAEAAAAAAAAAZAAAAGQAAAAAAAAAZAAAAGQAAAAVAAAAYAAAAAAAAAAAAAAADwAAACADAAAAAAAAAAAAAAEAAACgMgAAVgcAAKr4//8BAAAAf39/AAEAAABkAAAAAAAAABQAAABAHwAAAAAAACYAAAAAAAAAwOD//wAAAAAmAAAAZAAAABYAAABMAAAAAAAAAAAAAAAEAAAAAAAAAAEAAACAgIAKAAAAACgAAAAoAAAAZAAAAGQAAAAAAAAAzMzMAAAAAABQAAAAUAAAAGQAAABkAAAAAAAAABcAAAAUAAAAAAAAAAAAAAD/fwAA/38AAAAAAAAJAAAABAAAANw7IAEeAAAAaAAAAAAAAAAAAAAAAAAAAAAAAAAAAAAAECcAABAnAAAAAAAAAAAAAAAAAAAAAAAAAAAAAAAAAAAAAAAAAAAAABQAAAAAAAAAwMD/AAAAAABkAAAAMgAAAAAAAABkAAAAAAAAAH9/fwAKAAAAIgAAABgAAAAAAAAAAAAAAAAAAAAAAAAAAAAAAAAAAAAkAAAAJAAAAAAAAAAHAAAAAAAAAAAAAAAAAAAAAAAAAAAAAAAAAAAAf39/ACUAAABYAAAAAAAAAAAAAAAAAAAAAAAAAAAAAAAAAAAAAAAAAAAAAAAAAAAAAAAAAAAAAAA/AAAAAAAAAKCGAQAAAAAAAAAAAAAAAAAMAAAAAQAAAAAAAAAAAAAAAAAAAB8AAABUAAAAAAAABQAAAAEAAAAAAAAAAAAAAAAAAAAAAAAAAAAAAAAAAAAAAAAAAAAAAAJ/f38AAAAAA8zMzADAwP8Af39/AAAAAAAAAAAAAAAAAAAAAAAAAAAAIQAAABgAAAAUAAAAwAMAALABAABARwAAuAgAABAAAAAmAAAACAAAAAAAAAAAAAAA"/>
+                <pr:smNativeData xmlns:pr="smNativeData" xmlns="smNativeData" val="SMDATA_15_7aDWaRMAAAAlAAAAZAAAAA8BAAAAkAAAAEgAAACQAAAASAAAAAAAAAABAAAAAAAAAAEAAABQAAAAAAAAAAAA4D8AAAAAAADgPwAAAAAAAOA/AAAAAAAA4D8AAAAAAADgPwAAAAAAAOA/AAAAAAAA4D8AAAAAAADgPwAAAAAAAOA/AAAAAAAA4D8CAAAAjAAAAAAAAAAAAAAAu+DjDP///wgAAAAAAAAAAAAAAAAAAAAAAAAAAAAAAAAAAAAAZAAAAAEAAABAAAAAAAAAAAAAAAAAAAAAAAAAAAAAAAAAAAAAAAAAAAAAAAAAAAAAAAAAAAAAAAAAAAAAAAAAAAAAAAAAAAAAAAAAAAAAAAAAAAAAAAAAAAAAAAAAAAAAFAAAADwAAAAAAAAAAAAAAAAAAAkUAAAAAQAAABQAAAAUAAAAFAAAAAEAAAAAAAAAZAAAAGQAAAAAAAAAZAAAAGQAAAAVAAAAYAAAAAAAAAAAAAAADwAAACADAAAAAAAAAAAAAAEAAACgMgAAVgcAAKr4//8BAAAAf39/AAEAAABkAAAAAAAAABQAAABAHwAAAAAAACYAAAAAAAAAwOD//wAAAAAmAAAAZAAAABYAAABMAAAAAAAAAAAAAAAEAAAAAAAAAAEAAACAgIAKAAAAACgAAAAoAAAAZAAAAGQAAAAAAAAAzMzMAAAAAABQAAAAUAAAAGQAAABkAAAAAAAAABcAAAAUAAAAAAAAAAAAAAD/fwAA/38AAAAAAAAJAAAABAAAANw7IAEeAAAAaAAAAAAAAAAAAAAAAAAAAAAAAAAAAAAAECcAABAnAAAAAAAAAAAAAAAAAAAAAAAAAAAAAAAAAAAAAAAAAAAAABQAAAAAAAAAwMD/AAAAAABkAAAAMgAAAAAAAABkAAAAAAAAAH9/fwAKAAAAIgAAABgAAAAAAAAAAAAAAAAAAAAAAAAAAAAAAAAAAAAkAAAAJAAAAAAAAAAHAAAAAAAAAAAAAAAAAAAAAAAAAAAAAAAAAAAAf39/ACUAAABYAAAAAAAAAAAAAAAAAAAAAAAAAAAAAAAAAAAAAAAAAAAAAAAAAAAAAAAAAAAAAAA/AAAAAAAAAKCGAQAAAAAAAAAAAAAAAAAMAAAAAQAAAAAAAAAAAAAAAAAAAB8AAABUAAAAAAAABQAAAAEAAAAAAAAAAAAAAAAAAAAAAAAAAAAAAAAAAAAAAAAAAAAAAAJ/f38AAAAAA8zMzADAwP8Af39/AAAAAAAAAAAAAAAAAAAAAAAAAAAAIQAAABgAAAAUAAAAwAMAALABAABARwAAuAgAABAAAAAmAAAACAAAAAAAAAAAAAAA"/>
               </a:ext>
             </a:extLst>
           </p:cNvSpPr>
@@ -1556,7 +1544,7 @@
             <a:spLocks noGrp="1" noChangeArrowheads="1"/>
             <a:extLst>
               <a:ext uri="smNativeData">
-                <pr:smNativeData xmlns:pr="smNativeData" xmlns="smNativeData" val="SMDATA_15_AnHWaRMAAAAlAAAAZAAAAA8BAAAAkAAAAEgAAACQAAAASAAAAAAAAAACAAAAAAAAAAEAAABQAAAAAAAAAAAA4D8AAAAAAADgPwAAAAAAAOA/AAAAAAAA4D8AAAAAAADgPwAAAAAAAOA/AAAAAAAA4D8AAAAAAADgPwAAAAAAAOA/AAAAAAAA4D8CAAAAjAAAAAAAAAAAAAAAu+DjDP///wgAAAAAAAAAAAAAAAAAAAAAAAAAAAAAAAAAAAAAZAAAAAEAAABAAAAAAAAAAAAAAAAAAAAAAAAAAAAAAAAAAAAAAAAAAAAAAAAAAAAAAAAAAAAAAAAAAAAAAAAAAAAAAAAAAAAAAAAAAAAAAAAAAAAAAAAAAAAAAAAAAAAAFAAAADwAAAAAAAAAAAAAAAAAAAkUAAAAAQAAABQAAAAUAAAAFAAAAAEAAAAAAAAAZAAAAGQAAAAAAAAAZAAAAGQAAAAVAAAAYAAAAAAAAAAAAAAADwAAACADAAAAAAAAAAAAAAEAAACgMgAAVgcAAKr4//8BAAAAf39/AAEAAABkAAAAAAAAABQAAABAHwAAAAAAACYAAAAAAAAAwOD//wAAAAAmAAAAZAAAABYAAABMAAAAAAAAAAAAAAAEAAAAAAAAAAEAAACAgIAKAAAAACgAAAAoAAAAZAAAAGQAAAAAAAAAzMzMAAAAAABQAAAAUAAAAGQAAABkAAAAAAAAABcAAAAUAAAAAAAAAAAAAAD/fwAA/38AAAAAAAAJAAAABAAAANw7IAEeAAAAaAAAAAAAAAAAAAAAAAAAAAAAAAAAAAAAECcAABAnAAAAAAAAAAAAAAAAAAAAAAAAAAAAAAAAAAAAAAAAAAAAABQAAAAAAAAAwMD/AAAAAABkAAAAMgAAAAAAAABkAAAAAAAAAH9/fwAKAAAAIgAAABgAAAAAAAAAAAAAAAAAAAAAAAAAAAAAAAAAAAAkAAAAJAAAAAAAAAAHAAAAAAAAAAAAAAAAAAAAAAAAAAAAAAAAAAAAf39/ACUAAABYAAAAAAAAAAAAAAAAAAAAAAAAAAAAAAAAAAAAAAAAAAAAAAAAAAAAAAAAAAAAAAA/AAAAAAAAAKCGAQAAAAAAAAAAAAAAAAAMAAAAAQAAAAAAAAAAAAAAAAAAAB8AAABUAAAAAAAABQAAAAEAAAAAAAAAAAAAAAAAAAAAAAAAAAAAAAAAAAAAAAAAAAAAAAJ/f38AAAAAA8zMzADAwP8Af39/AAAAAAAAAAAAAAAAAAAAAAAAAAAAIQAAABgAAAAUAAAAwAMAAHEJAADjJAAAYQ0AABAAAAAmAAAACAAAAIGAAAAAAAAA"/>
+                <pr:smNativeData xmlns:pr="smNativeData" xmlns="smNativeData" val="SMDATA_15_7aDWaRMAAAAlAAAAZAAAAA8BAAAAkAAAAEgAAACQAAAASAAAAAAAAAACAAAAAAAAAAEAAABQAAAAAAAAAAAA4D8AAAAAAADgPwAAAAAAAOA/AAAAAAAA4D8AAAAAAADgPwAAAAAAAOA/AAAAAAAA4D8AAAAAAADgPwAAAAAAAOA/AAAAAAAA4D8CAAAAjAAAAAAAAAAAAAAAu+DjDP///wgAAAAAAAAAAAAAAAAAAAAAAAAAAAAAAAAAAAAAZAAAAAEAAABAAAAAAAAAAAAAAAAAAAAAAAAAAAAAAAAAAAAAAAAAAAAAAAAAAAAAAAAAAAAAAAAAAAAAAAAAAAAAAAAAAAAAAAAAAAAAAAAAAAAAAAAAAAAAAAAAAAAAFAAAADwAAAAAAAAAAAAAAAAAAAkUAAAAAQAAABQAAAAUAAAAFAAAAAEAAAAAAAAAZAAAAGQAAAAAAAAAZAAAAGQAAAAVAAAAYAAAAAAAAAAAAAAADwAAACADAAAAAAAAAAAAAAEAAACgMgAAVgcAAKr4//8BAAAAf39/AAEAAABkAAAAAAAAABQAAABAHwAAAAAAACYAAAAAAAAAwOD//wAAAAAmAAAAZAAAABYAAABMAAAAAAAAAAAAAAAEAAAAAAAAAAEAAACAgIAKAAAAACgAAAAoAAAAZAAAAGQAAAAAAAAAzMzMAAAAAABQAAAAUAAAAGQAAABkAAAAAAAAABcAAAAUAAAAAAAAAAAAAAD/fwAA/38AAAAAAAAJAAAABAAAANw7IAEeAAAAaAAAAAAAAAAAAAAAAAAAAAAAAAAAAAAAECcAABAnAAAAAAAAAAAAAAAAAAAAAAAAAAAAAAAAAAAAAAAAAAAAABQAAAAAAAAAwMD/AAAAAABkAAAAMgAAAAAAAABkAAAAAAAAAH9/fwAKAAAAIgAAABgAAAAAAAAAAAAAAAAAAAAAAAAAAAAAAAAAAAAkAAAAJAAAAAAAAAAHAAAAAAAAAAAAAAAAAAAAAAAAAAAAAAAAAAAAf39/ACUAAABYAAAAAAAAAAAAAAAAAAAAAAAAAAAAAAAAAAAAAAAAAAAAAAAAAAAAAAAAAAAAAAA/AAAAAAAAAKCGAQAAAAAAAAAAAAAAAAAMAAAAAQAAAAAAAAAAAAAAAAAAAB8AAABUAAAAAAAABQAAAAEAAAAAAAAAAAAAAAAAAAAAAAAAAAAAAAAAAAAAAAAAAAAAAAJ/f38AAAAAA8zMzADAwP8Af39/AAAAAAAAAAAAAAAAAAAAAAAAAAAAIQAAABgAAAAUAAAAwAMAAHEJAADjJAAAYQ0AABAAAAAmAAAACAAAAIGAAAAAAAAA"/>
               </a:ext>
             </a:extLst>
           </p:cNvSpPr>
@@ -1629,7 +1617,7 @@
             <a:spLocks noGrp="1" noChangeArrowheads="1"/>
             <a:extLst>
               <a:ext uri="smNativeData">
-                <pr:smNativeData xmlns:pr="smNativeData" xmlns="smNativeData" val="SMDATA_15_AnHWaRMAAAAlAAAAZAAAAA8BAAAAkAAAAEgAAACQAAAASAAAAAAAAAAAAAAAAAAAAAEAAABQAAAAAAAAAAAA4D8AAAAAAADgPwAAAAAAAOA/AAAAAAAA4D8AAAAAAADgPwAAAAAAAOA/AAAAAAAA4D8AAAAAAADgPwAAAAAAAOA/AAAAAAAA4D8CAAAAjAAAAAAAAAAAAAAAu+DjDP///wgAAAAAAAAAAAAAAAAAAAAAAAAAAAAAAAAAAAAAZAAAAAEAAABAAAAAAAAAAAAAAAAAAAAAAAAAAAAAAAAAAAAAAAAAAAAAAAAAAAAAAAAAAAAAAAAAAAAAAAAAAAAAAAAAAAAAAAAAAAAAAAAAAAAAAAAAAAAAAAAAAAAAFAAAADwAAAAAAAAAAAAAAAAAAAkUAAAAAQAAABQAAAAUAAAAFAAAAAEAAAAAAAAAZAAAAGQAAAAAAAAAZAAAAGQAAAAVAAAAYAAAAAAAAAAAAAAADwAAACADAAAAAAAAAAAAAAEAAACgMgAAVgcAAKr4//8BAAAAf39/AAEAAABkAAAAAAAAABQAAABAHwAAAAAAACYAAAAAAAAAwOD//wAAAAAmAAAAZAAAABYAAABMAAAAAAAAAAAAAAAEAAAAAAAAAAEAAACAgIAKAAAAACgAAAAoAAAAZAAAAGQAAAAAAAAAzMzMAAAAAABQAAAAUAAAAGQAAABkAAAAAAAAABcAAAAUAAAAAAAAAAAAAAD/fwAA/38AAAAAAAAJAAAABAAAANw7IAEeAAAAaAAAAAAAAAAAAAAAAAAAAAAAAAAAAAAAECcAABAnAAAAAAAAAAAAAAAAAAAAAAAAAAAAAAAAAAAAAAAAAAAAABQAAAAAAAAAwMD/AAAAAABkAAAAMgAAAAAAAABkAAAAAAAAAH9/fwAKAAAAIgAAABgAAAAAAAAAAAAAAAAAAAAAAAAAAAAAAAAAAAAkAAAAJAAAAAAAAAAHAAAAAAAAAAAAAAAAAAAAAAAAAAAAAAAAAAAAf39/ACUAAABYAAAAAAAAAAAAAAAAAAAAAAAAAAAAAAAAAAAAAAAAAAAAAAAAAAAAAAAAAAAAAAA/AAAAAAAAAKCGAQAAAAAAAAAAAAAAAAAMAAAAAQAAAAAAAAAAAAAAAAAAAB8AAABUAAAAAAAABQAAAAEAAAAAAAAAAAAAAAAAAAAAAAAAAAAAAAAAAAAAAAAAAAAAAAJ/f38AAAAAA8zMzADAwP8Af39/AAAAAAAAAAAAAAAAAAAAAAAAAAAAIQAAABgAAAAUAAAAwAMAAGENAADjJAAAsCUAABAAAAAmAAAACAAAAAGAAAAAAAAA"/>
+                <pr:smNativeData xmlns:pr="smNativeData" xmlns="smNativeData" val="SMDATA_15_7aDWaRMAAAAlAAAAZAAAAA8BAAAAkAAAAEgAAACQAAAASAAAAAAAAAAAAAAAAAAAAAEAAABQAAAAAAAAAAAA4D8AAAAAAADgPwAAAAAAAOA/AAAAAAAA4D8AAAAAAADgPwAAAAAAAOA/AAAAAAAA4D8AAAAAAADgPwAAAAAAAOA/AAAAAAAA4D8CAAAAjAAAAAAAAAAAAAAAu+DjDP///wgAAAAAAAAAAAAAAAAAAAAAAAAAAAAAAAAAAAAAZAAAAAEAAABAAAAAAAAAAAAAAAAAAAAAAAAAAAAAAAAAAAAAAAAAAAAAAAAAAAAAAAAAAAAAAAAAAAAAAAAAAAAAAAAAAAAAAAAAAAAAAAAAAAAAAAAAAAAAAAAAAAAAFAAAADwAAAAAAAAAAAAAAAAAAAkUAAAAAQAAABQAAAAUAAAAFAAAAAEAAAAAAAAAZAAAAGQAAAAAAAAAZAAAAGQAAAAVAAAAYAAAAAAAAAAAAAAADwAAACADAAAAAAAAAAAAAAEAAACgMgAAVgcAAKr4//8BAAAAf39/AAEAAABkAAAAAAAAABQAAABAHwAAAAAAACYAAAAAAAAAwOD//wAAAAAmAAAAZAAAABYAAABMAAAAAAAAAAAAAAAEAAAAAAAAAAEAAACAgIAKAAAAACgAAAAoAAAAZAAAAGQAAAAAAAAAzMzMAAAAAABQAAAAUAAAAGQAAABkAAAAAAAAABcAAAAUAAAAAAAAAAAAAAD/fwAA/38AAAAAAAAJAAAABAAAANw7IAEeAAAAaAAAAAAAAAAAAAAAAAAAAAAAAAAAAAAAECcAABAnAAAAAAAAAAAAAAAAAAAAAAAAAAAAAAAAAAAAAAAAAAAAABQAAAAAAAAAwMD/AAAAAABkAAAAMgAAAAAAAABkAAAAAAAAAH9/fwAKAAAAIgAAABgAAAAAAAAAAAAAAAAAAAAAAAAAAAAAAAAAAAAkAAAAJAAAAAAAAAAHAAAAAAAAAAAAAAAAAAAAAAAAAAAAAAAAAAAAf39/ACUAAABYAAAAAAAAAAAAAAAAAAAAAAAAAAAAAAAAAAAAAAAAAAAAAAAAAAAAAAAAAAAAAAA/AAAAAAAAAKCGAQAAAAAAAAAAAAAAAAAMAAAAAQAAAAAAAAAAAAAAAAAAAB8AAABUAAAAAAAABQAAAAEAAAAAAAAAAAAAAAAAAAAAAAAAAAAAAAAAAAAAAAAAAAAAAAJ/f38AAAAAA8zMzADAwP8Af39/AAAAAAAAAAAAAAAAAAAAAAAAAAAAIQAAABgAAAAUAAAAwAMAAGENAADjJAAAsCUAABAAAAAmAAAACAAAAAGAAAAAAAAA"/>
               </a:ext>
             </a:extLst>
           </p:cNvSpPr>
@@ -1713,7 +1701,7 @@
             <a:spLocks noGrp="1" noChangeArrowheads="1"/>
             <a:extLst>
               <a:ext uri="smNativeData">
-                <pr:smNativeData xmlns:pr="smNativeData" xmlns="smNativeData" val="SMDATA_15_AnHWaRMAAAAlAAAAZAAAAA8BAAAAkAAAAEgAAACQAAAASAAAAAAAAAACAAAAAAAAAAEAAABQAAAAAAAAAAAA4D8AAAAAAADgPwAAAAAAAOA/AAAAAAAA4D8AAAAAAADgPwAAAAAAAOA/AAAAAAAA4D8AAAAAAADgPwAAAAAAAOA/AAAAAAAA4D8CAAAAjAAAAAAAAAAAAAAAu+DjDP///wgAAAAAAAAAAAAAAAAAAAAAAAAAAAAAAAAAAAAAZAAAAAEAAABAAAAAAAAAAAAAAAAAAAAAAAAAAAAAAAAAAAAAAAAAAAAAAAAAAAAAAAAAAAAAAAAAAAAAAAAAAAAAAAAAAAAAAAAAAAAAAAAAAAAAAAAAAAAAAAAAAAAAFAAAADwAAAAAAAAAAAAAAAAAAAkUAAAAAQAAABQAAAAUAAAAFAAAAAEAAAAAAAAAZAAAAGQAAAAAAAAAZAAAAGQAAAAVAAAAYAAAAAAAAAAAAAAADwAAACADAAAAAAAAAAAAAAEAAACgMgAAVgcAAKr4//8BAAAAf39/AAEAAABkAAAAAAAAABQAAABAHwAAAAAAACYAAAAAAAAAwOD//wAAAAAmAAAAZAAAABYAAABMAAAAAAAAAAAAAAAEAAAAAAAAAAEAAACAgIAKAAAAACgAAAAoAAAAZAAAAGQAAAAAAAAAzMzMAAAAAABQAAAAUAAAAGQAAABkAAAAAAAAABcAAAAUAAAAAAAAAAAAAAD/fwAA/38AAAAAAAAJAAAABAAAANw7IAEeAAAAaAAAAAAAAAAAAAAAAAAAAAAAAAAAAAAAECcAABAnAAAAAAAAAAAAAAAAAAAAAAAAAAAAAAAAAAAAAAAAAAAAABQAAAAAAAAAwMD/AAAAAABkAAAAMgAAAAAAAABkAAAAAAAAAH9/fwAKAAAAIgAAABgAAAAAAAAAAAAAAAAAAAAAAAAAAAAAAAAAAAAkAAAAJAAAAAAAAAAHAAAAAAAAAAAAAAAAAAAAAAAAAAAAAAAAAAAAf39/ACUAAABYAAAAAAAAAAAAAAAAAAAAAAAAAAAAAAAAAAAAAAAAAAAAAAAAAAAAAAAAAAAAAAA/AAAAAAAAAKCGAQAAAAAAAAAAAAAAAAAMAAAAAQAAAAAAAAAAAAAAAAAAAB8AAABUAAAAAAAABQAAAAEAAAAAAAAAAAAAAAAAAAAAAAAAAAAAAAAAAAAAAAAAAAAAAAJ/f38AAAAAA8zMzADAwP8Af39/AAAAAAAAAAAAAAAAAAAAAAAAAAAAIQAAABgAAAAUAAAAHSYAAHEJAABARwAAYQ0AABAAAAAmAAAACAAAAIGAAAAAAAAA"/>
+                <pr:smNativeData xmlns:pr="smNativeData" xmlns="smNativeData" val="SMDATA_15_7aDWaRMAAAAlAAAAZAAAAA8BAAAAkAAAAEgAAACQAAAASAAAAAAAAAACAAAAAAAAAAEAAABQAAAAAAAAAAAA4D8AAAAAAADgPwAAAAAAAOA/AAAAAAAA4D8AAAAAAADgPwAAAAAAAOA/AAAAAAAA4D8AAAAAAADgPwAAAAAAAOA/AAAAAAAA4D8CAAAAjAAAAAAAAAAAAAAAu+DjDP///wgAAAAAAAAAAAAAAAAAAAAAAAAAAAAAAAAAAAAAZAAAAAEAAABAAAAAAAAAAAAAAAAAAAAAAAAAAAAAAAAAAAAAAAAAAAAAAAAAAAAAAAAAAAAAAAAAAAAAAAAAAAAAAAAAAAAAAAAAAAAAAAAAAAAAAAAAAAAAAAAAAAAAFAAAADwAAAAAAAAAAAAAAAAAAAkUAAAAAQAAABQAAAAUAAAAFAAAAAEAAAAAAAAAZAAAAGQAAAAAAAAAZAAAAGQAAAAVAAAAYAAAAAAAAAAAAAAADwAAACADAAAAAAAAAAAAAAEAAACgMgAAVgcAAKr4//8BAAAAf39/AAEAAABkAAAAAAAAABQAAABAHwAAAAAAACYAAAAAAAAAwOD//wAAAAAmAAAAZAAAABYAAABMAAAAAAAAAAAAAAAEAAAAAAAAAAEAAACAgIAKAAAAACgAAAAoAAAAZAAAAGQAAAAAAAAAzMzMAAAAAABQAAAAUAAAAGQAAABkAAAAAAAAABcAAAAUAAAAAAAAAAAAAAD/fwAA/38AAAAAAAAJAAAABAAAANw7IAEeAAAAaAAAAAAAAAAAAAAAAAAAAAAAAAAAAAAAECcAABAnAAAAAAAAAAAAAAAAAAAAAAAAAAAAAAAAAAAAAAAAAAAAABQAAAAAAAAAwMD/AAAAAABkAAAAMgAAAAAAAABkAAAAAAAAAH9/fwAKAAAAIgAAABgAAAAAAAAAAAAAAAAAAAAAAAAAAAAAAAAAAAAkAAAAJAAAAAAAAAAHAAAAAAAAAAAAAAAAAAAAAAAAAAAAAAAAAAAAf39/ACUAAABYAAAAAAAAAAAAAAAAAAAAAAAAAAAAAAAAAAAAAAAAAAAAAAAAAAAAAAAAAAAAAAA/AAAAAAAAAKCGAQAAAAAAAAAAAAAAAAAMAAAAAQAAAAAAAAAAAAAAAAAAAB8AAABUAAAAAAAABQAAAAEAAAAAAAAAAAAAAAAAAAAAAAAAAAAAAAAAAAAAAAAAAAAAAAJ/f38AAAAAA8zMzADAwP8Af39/AAAAAAAAAAAAAAAAAAAAAAAAAAAAIQAAABgAAAAUAAAAHSYAAHEJAABARwAAYQ0AABAAAAAmAAAACAAAAIGAAAAAAAAA"/>
               </a:ext>
             </a:extLst>
           </p:cNvSpPr>
@@ -1786,7 +1774,7 @@
             <a:spLocks noGrp="1" noChangeArrowheads="1"/>
             <a:extLst>
               <a:ext uri="smNativeData">
-                <pr:smNativeData xmlns:pr="smNativeData" xmlns="smNativeData" val="SMDATA_15_AnHWaRMAAAAlAAAAZAAAAA8BAAAAkAAAAEgAAACQAAAASAAAAAAAAAAAAAAAAAAAAAEAAABQAAAAAAAAAAAA4D8AAAAAAADgPwAAAAAAAOA/AAAAAAAA4D8AAAAAAADgPwAAAAAAAOA/AAAAAAAA4D8AAAAAAADgPwAAAAAAAOA/AAAAAAAA4D8CAAAAjAAAAAAAAAAAAAAAu+DjDP///wgAAAAAAAAAAAAAAAAAAAAAAAAAAAAAAAAAAAAAZAAAAAEAAABAAAAAAAAAAAAAAAAAAAAAAAAAAAAAAAAAAAAAAAAAAAAAAAAAAAAAAAAAAAAAAAAAAAAAAAAAAAAAAAAAAAAAAAAAAAAAAAAAAAAAAAAAAAAAAAAAAAAAFAAAADwAAAAAAAAAAAAAAAAAAAkUAAAAAQAAABQAAAAUAAAAFAAAAAEAAAAAAAAAZAAAAGQAAAAAAAAAZAAAAGQAAAAVAAAAYAAAAAAAAAAAAAAADwAAACADAAAAAAAAAAAAAAEAAACgMgAAVgcAAKr4//8BAAAAf39/AAEAAABkAAAAAAAAABQAAABAHwAAAAAAACYAAAAAAAAAwOD//wAAAAAmAAAAZAAAABYAAABMAAAAAAAAAAAAAAAEAAAAAAAAAAEAAACAgIAKAAAAACgAAAAoAAAAZAAAAGQAAAAAAAAAzMzMAAAAAABQAAAAUAAAAGQAAABkAAAAAAAAABcAAAAUAAAAAAAAAAAAAAD/fwAA/38AAAAAAAAJAAAABAAAANw7IAEeAAAAaAAAAAAAAAAAAAAAAAAAAAAAAAAAAAAAECcAABAnAAAAAAAAAAAAAAAAAAAAAAAAAAAAAAAAAAAAAAAAAAAAABQAAAAAAAAAwMD/AAAAAABkAAAAMgAAAAAAAABkAAAAAAAAAH9/fwAKAAAAIgAAABgAAAAAAAAAAAAAAAAAAAAAAAAAAAAAAAAAAAAkAAAAJAAAAAAAAAAHAAAAAAAAAAAAAAAAAAAAAAAAAAAAAAAAAAAAf39/ACUAAABYAAAAAAAAAAAAAAAAAAAAAAAAAAAAAAAAAAAAAAAAAAAAAAAAAAAAAAAAAAAAAAA/AAAAAAAAAKCGAQAAAAAAAAAAAAAAAAAMAAAAAQAAAAAAAAAAAAAAAAAAAB8AAABUAAAAAAAABQAAAAEAAAAAAAAAAAAAAAAAAAAAAAAAAAAAAAAAAAAAAAAAAAAAAAJ/f38AAAAAA8zMzADAwP8Af39/AAAAAAAAAAAAAAAAAAAAAAAAAAAAIQAAABgAAAAUAAAAHSYAAGENAABARwAAsCUAABAAAAAmAAAACAAAAAGAAAAAAAAA"/>
+                <pr:smNativeData xmlns:pr="smNativeData" xmlns="smNativeData" val="SMDATA_15_7aDWaRMAAAAlAAAAZAAAAA8BAAAAkAAAAEgAAACQAAAASAAAAAAAAAAAAAAAAAAAAAEAAABQAAAAAAAAAAAA4D8AAAAAAADgPwAAAAAAAOA/AAAAAAAA4D8AAAAAAADgPwAAAAAAAOA/AAAAAAAA4D8AAAAAAADgPwAAAAAAAOA/AAAAAAAA4D8CAAAAjAAAAAAAAAAAAAAAu+DjDP///wgAAAAAAAAAAAAAAAAAAAAAAAAAAAAAAAAAAAAAZAAAAAEAAABAAAAAAAAAAAAAAAAAAAAAAAAAAAAAAAAAAAAAAAAAAAAAAAAAAAAAAAAAAAAAAAAAAAAAAAAAAAAAAAAAAAAAAAAAAAAAAAAAAAAAAAAAAAAAAAAAAAAAFAAAADwAAAAAAAAAAAAAAAAAAAkUAAAAAQAAABQAAAAUAAAAFAAAAAEAAAAAAAAAZAAAAGQAAAAAAAAAZAAAAGQAAAAVAAAAYAAAAAAAAAAAAAAADwAAACADAAAAAAAAAAAAAAEAAACgMgAAVgcAAKr4//8BAAAAf39/AAEAAABkAAAAAAAAABQAAABAHwAAAAAAACYAAAAAAAAAwOD//wAAAAAmAAAAZAAAABYAAABMAAAAAAAAAAAAAAAEAAAAAAAAAAEAAACAgIAKAAAAACgAAAAoAAAAZAAAAGQAAAAAAAAAzMzMAAAAAABQAAAAUAAAAGQAAABkAAAAAAAAABcAAAAUAAAAAAAAAAAAAAD/fwAA/38AAAAAAAAJAAAABAAAANw7IAEeAAAAaAAAAAAAAAAAAAAAAAAAAAAAAAAAAAAAECcAABAnAAAAAAAAAAAAAAAAAAAAAAAAAAAAAAAAAAAAAAAAAAAAABQAAAAAAAAAwMD/AAAAAABkAAAAMgAAAAAAAABkAAAAAAAAAH9/fwAKAAAAIgAAABgAAAAAAAAAAAAAAAAAAAAAAAAAAAAAAAAAAAAkAAAAJAAAAAAAAAAHAAAAAAAAAAAAAAAAAAAAAAAAAAAAAAAAAAAAf39/ACUAAABYAAAAAAAAAAAAAAAAAAAAAAAAAAAAAAAAAAAAAAAAAAAAAAAAAAAAAAAAAAAAAAA/AAAAAAAAAKCGAQAAAAAAAAAAAAAAAAAMAAAAAQAAAAAAAAAAAAAAAAAAAB8AAABUAAAAAAAABQAAAAEAAAAAAAAAAAAAAAAAAAAAAAAAAAAAAAAAAAAAAAAAAAAAAAJ/f38AAAAAA8zMzADAwP8Af39/AAAAAAAAAAAAAAAAAAAAAAAAAAAAIQAAABgAAAAUAAAAHSYAAGENAABARwAAsCUAABAAAAAmAAAACAAAAAGAAAAAAAAA"/>
               </a:ext>
             </a:extLst>
           </p:cNvSpPr>
@@ -1870,7 +1858,7 @@
             <a:spLocks noGrp="1" noChangeArrowheads="1"/>
             <a:extLst>
               <a:ext uri="smNativeData">
-                <pr:smNativeData xmlns:pr="smNativeData" xmlns="smNativeData" val="SMDATA_15_AnHWaRMAAAAlAAAAZAAAAA8BAAAAkAAAAEgAAACQAAAASAAAAAAAAAABAAAAAAAAAAEAAABQAAAAAAAAAAAA4D8AAAAAAADgPwAAAAAAAOA/AAAAAAAA4D8AAAAAAADgPwAAAAAAAOA/AAAAAAAA4D8AAAAAAADgPwAAAAAAAOA/AAAAAAAA4D8CAAAAjAAAAAAAAAAAAAAAu+DjDP///wgAAAAAAAAAAAAAAAAAAAAAAAAAAAAAAAAAAAAAZAAAAAEAAABAAAAAAAAAAAAAAAAAAAAAAAAAAAAAAAAAAAAAAAAAAAAAAAAAAAAAAAAAAAAAAAAAAAAAAAAAAAAAAAAAAAAAAAAAAAAAAAAAAAAAAAAAAAAAAAAAAAAAFAAAADwAAAAAAAAAAAAAAAAAAAkUAAAAAQAAABQAAAAUAAAAFAAAAAEAAAAAAAAAZAAAAGQAAAAAAAAAZAAAAGQAAAAVAAAAYAAAAAAAAAAAAAAADwAAACADAAAAAAAAAAAAAAEAAACgMgAAVgcAAKr4//8BAAAAf39/AAEAAABkAAAAAAAAABQAAABAHwAAAAAAACYAAAAAAAAAwOD//wAAAAAmAAAAZAAAABYAAABMAAAAAAAAAAAAAAAEAAAAAAAAAAEAAACAgIAKAAAAACgAAAAoAAAAZAAAAGQAAAAAAAAAzMzMAAAAAABQAAAAUAAAAGQAAABkAAAAAAAAABcAAAAUAAAAAAAAAAAAAAD/fwAA/38AAAAAAAAJAAAABAAAANw7IAEeAAAAaAAAAAAAAAAAAAAAAAAAAAAAAAAAAAAAECcAABAnAAAAAAAAAAAAAAAAAAAAAAAAAAAAAAAAAAAAAAAAAAAAABQAAAAAAAAAwMD/AAAAAABkAAAAMgAAAAAAAABkAAAAAAAAAH9/fwAKAAAAIgAAABgAAAAAAAAAAAAAAAAAAAAAAAAAAAAAAAAAAAAkAAAAJAAAAAAAAAAHAAAAAAAAAAAAAAAAAAAAAAAAAAAAAAAAAAAAf39/ACUAAABYAAAAAAAAAAAAAAAAAAAAAAAAAAAAAAAAAAAAAAAAAAAAAAAAAAAAAAAAAAAAAAA/AAAAAAAAAKCGAQAAAAAAAAAAAAAAAAAMAAAAAQAAAAAAAAAAAAAAAAAAAB8AAABUAAAAAAAABQAAAAEAAAAAAAAAAAAAAAAAAAAAAAAAAAAAAAAAAAAAAAAAAAAAAAJ/f38AAAAAA8zMzADAwP8Af39/AAAAAAAAAAAAAAAAAAAAAAAAAAAAIQAAABgAAAAUAAAAwAMAABsnAAA/FQAAWSkAABAAAAAmAAAACAAAAAAAAAAAAAAA"/>
+                <pr:smNativeData xmlns:pr="smNativeData" xmlns="smNativeData" val="SMDATA_15_7aDWaRMAAAAlAAAAZAAAAA8BAAAAkAAAAEgAAACQAAAASAAAAAAAAAABAAAAAAAAAAEAAABQAAAAAAAAAAAA4D8AAAAAAADgPwAAAAAAAOA/AAAAAAAA4D8AAAAAAADgPwAAAAAAAOA/AAAAAAAA4D8AAAAAAADgPwAAAAAAAOA/AAAAAAAA4D8CAAAAjAAAAAAAAAAAAAAAu+DjDP///wgAAAAAAAAAAAAAAAAAAAAAAAAAAAAAAAAAAAAAZAAAAAEAAABAAAAAAAAAAAAAAAAAAAAAAAAAAAAAAAAAAAAAAAAAAAAAAAAAAAAAAAAAAAAAAAAAAAAAAAAAAAAAAAAAAAAAAAAAAAAAAAAAAAAAAAAAAAAAAAAAAAAAFAAAADwAAAAAAAAAAAAAAAAAAAkUAAAAAQAAABQAAAAUAAAAFAAAAAEAAAAAAAAAZAAAAGQAAAAAAAAAZAAAAGQAAAAVAAAAYAAAAAAAAAAAAAAADwAAACADAAAAAAAAAAAAAAEAAACgMgAAVgcAAKr4//8BAAAAf39/AAEAAABkAAAAAAAAABQAAABAHwAAAAAAACYAAAAAAAAAwOD//wAAAAAmAAAAZAAAABYAAABMAAAAAAAAAAAAAAAEAAAAAAAAAAEAAACAgIAKAAAAACgAAAAoAAAAZAAAAGQAAAAAAAAAzMzMAAAAAABQAAAAUAAAAGQAAABkAAAAAAAAABcAAAAUAAAAAAAAAAAAAAD/fwAA/38AAAAAAAAJAAAABAAAANw7IAEeAAAAaAAAAAAAAAAAAAAAAAAAAAAAAAAAAAAAECcAABAnAAAAAAAAAAAAAAAAAAAAAAAAAAAAAAAAAAAAAAAAAAAAABQAAAAAAAAAwMD/AAAAAABkAAAAMgAAAAAAAABkAAAAAAAAAH9/fwAKAAAAIgAAABgAAAAAAAAAAAAAAAAAAAAAAAAAAAAAAAAAAAAkAAAAJAAAAAAAAAAHAAAAAAAAAAAAAAAAAAAAAAAAAAAAAAAAAAAAf39/ACUAAABYAAAAAAAAAAAAAAAAAAAAAAAAAAAAAAAAAAAAAAAAAAAAAAAAAAAAAAAAAAAAAAA/AAAAAAAAAKCGAQAAAAAAAAAAAAAAAAAMAAAAAQAAAAAAAAAAAAAAAAAAAB8AAABUAAAAAAAABQAAAAEAAAAAAAAAAAAAAAAAAAAAAAAAAAAAAAAAAAAAAAAAAAAAAAJ/f38AAAAAA8zMzADAwP8Af39/AAAAAAAAAAAAAAAAAAAAAAAAAAAAIQAAABgAAAAUAAAAwAMAABsnAAA/FQAAWSkAABAAAAAmAAAACAAAAAAAAAAAAAAA"/>
               </a:ext>
             </a:extLst>
           </p:cNvSpPr>
@@ -1884,7 +1872,7 @@
           <a:lstStyle/>
           <a:p>
             <a:pPr/>
-            <a:fld id="{331F68BF-F1DE-4A9E-90A7-07CB26E96652}" type="datetime1">
+            <a:fld id="{2D80004B-05C0-D5F6-8E38-F3A34E7678A6}" type="datetime1">
               <a:t/>
             </a:fld>
           </a:p>
@@ -1897,7 +1885,7 @@
             <a:spLocks noGrp="1" noChangeArrowheads="1"/>
             <a:extLst>
               <a:ext uri="smNativeData">
-                <pr:smNativeData xmlns:pr="smNativeData" xmlns="smNativeData" val="SMDATA_15_AnHWaRMAAAAlAAAAZAAAAA8BAAAAkAAAAEgAAACQAAAASAAAAAAAAAABAAAAAAAAAAEAAABQAAAAAAAAAAAA4D8AAAAAAADgPwAAAAAAAOA/AAAAAAAA4D8AAAAAAADgPwAAAAAAAOA/AAAAAAAA4D8AAAAAAADgPwAAAAAAAOA/AAAAAAAA4D8CAAAAjAAAAAAAAAAAAAAAu+DjDP///wgAAAAAAAAAAAAAAAAAAAAAAAAAAAAAAAAAAAAAZAAAAAEAAABAAAAAAAAAAAAAAAAAAAAAAAAAAAAAAAAAAAAAAAAAAAAAAAAAAAAAAAAAAAAAAAAAAAAAAAAAAAAAAAAAAAAAAAAAAAAAAAAAAAAAAAAAAAAAAAAAAAAAFAAAADwAAAAAAAAAAAAAAAAAAAkUAAAAAQAAABQAAAAUAAAAFAAAAAEAAAAAAAAAZAAAAGQAAAAAAAAAZAAAAGQAAAAVAAAAYAAAAAAAAAAAAAAADwAAACADAAAAAAAAAAAAAAEAAACgMgAAVgcAAKr4//8BAAAAf39/AAEAAABkAAAAAAAAABQAAABAHwAAAAAAACYAAAAAAAAAwOD//wAAAAAmAAAAZAAAABYAAABMAAAAAAAAAAAAAAAEAAAAAAAAAAEAAACAgIAKAAAAACgAAAAoAAAAZAAAAGQAAAAAAAAAzMzMAAAAAABQAAAAUAAAAGQAAABkAAAAAAAAABcAAAAUAAAAAAAAAAAAAAD/fwAA/38AAAAAAAAJAAAABAAAANw7IAEeAAAAaAAAAAAAAAAAAAAAAAAAAAAAAAAAAAAAECcAABAnAAAAAAAAAAAAAAAAAAAAAAAAAAAAAAAAAAAAAAAAAAAAABQAAAAAAAAAwMD/AAAAAABkAAAAMgAAAAAAAABkAAAAAAAAAH9/fwAKAAAAIgAAABgAAAAAAAAAAAAAAAAAAAAAAAAAAAAAAAAAAAAkAAAAJAAAAAAAAAAHAAAAAAAAAAAAAAAAAAAAAAAAAAAAAAAAAAAAf39/ACUAAABYAAAAAAAAAAAAAAAAAAAAAAAAAAAAAAAAAAAAAAAAAAAAAAAAAAAAAAAAAAAAAAA/AAAAAAAAAKCGAQAAAAAAAAAAAAAAAAAMAAAAAQAAAAAAAAAAAAAAAAAAAB8AAABUAAAAAAAABQAAAAEAAAAAAAAAAAAAAAAAAAAAAAAAAAAAAAAAAAAAAAAAAAAAAAJ/f38AAAAAA8zMzADAwP8Af39/AAAAAAAAAAAAAAAAAAAAAAAAAAAAIQAAABgAAAAUAAAAoRkAABsnAABfMQAAWSkAABAAAAAmAAAACAAAAAAAAAAAAAAA"/>
+                <pr:smNativeData xmlns:pr="smNativeData" xmlns="smNativeData" val="SMDATA_15_7aDWaRMAAAAlAAAAZAAAAA8BAAAAkAAAAEgAAACQAAAASAAAAAAAAAABAAAAAAAAAAEAAABQAAAAAAAAAAAA4D8AAAAAAADgPwAAAAAAAOA/AAAAAAAA4D8AAAAAAADgPwAAAAAAAOA/AAAAAAAA4D8AAAAAAADgPwAAAAAAAOA/AAAAAAAA4D8CAAAAjAAAAAAAAAAAAAAAu+DjDP///wgAAAAAAAAAAAAAAAAAAAAAAAAAAAAAAAAAAAAAZAAAAAEAAABAAAAAAAAAAAAAAAAAAAAAAAAAAAAAAAAAAAAAAAAAAAAAAAAAAAAAAAAAAAAAAAAAAAAAAAAAAAAAAAAAAAAAAAAAAAAAAAAAAAAAAAAAAAAAAAAAAAAAFAAAADwAAAAAAAAAAAAAAAAAAAkUAAAAAQAAABQAAAAUAAAAFAAAAAEAAAAAAAAAZAAAAGQAAAAAAAAAZAAAAGQAAAAVAAAAYAAAAAAAAAAAAAAADwAAACADAAAAAAAAAAAAAAEAAACgMgAAVgcAAKr4//8BAAAAf39/AAEAAABkAAAAAAAAABQAAABAHwAAAAAAACYAAAAAAAAAwOD//wAAAAAmAAAAZAAAABYAAABMAAAAAAAAAAAAAAAEAAAAAAAAAAEAAACAgIAKAAAAACgAAAAoAAAAZAAAAGQAAAAAAAAAzMzMAAAAAABQAAAAUAAAAGQAAABkAAAAAAAAABcAAAAUAAAAAAAAAAAAAAD/fwAA/38AAAAAAAAJAAAABAAAANw7IAEeAAAAaAAAAAAAAAAAAAAAAAAAAAAAAAAAAAAAECcAABAnAAAAAAAAAAAAAAAAAAAAAAAAAAAAAAAAAAAAAAAAAAAAABQAAAAAAAAAwMD/AAAAAABkAAAAMgAAAAAAAABkAAAAAAAAAH9/fwAKAAAAIgAAABgAAAAAAAAAAAAAAAAAAAAAAAAAAAAAAAAAAAAkAAAAJAAAAAAAAAAHAAAAAAAAAAAAAAAAAAAAAAAAAAAAAAAAAAAAf39/ACUAAABYAAAAAAAAAAAAAAAAAAAAAAAAAAAAAAAAAAAAAAAAAAAAAAAAAAAAAAAAAAAAAAA/AAAAAAAAAKCGAQAAAAAAAAAAAAAAAAAMAAAAAQAAAAAAAAAAAAAAAAAAAB8AAABUAAAAAAAABQAAAAEAAAAAAAAAAAAAAAAAAAAAAAAAAAAAAAAAAAAAAAAAAAAAAAJ/f38AAAAAA8zMzADAwP8Af39/AAAAAAAAAAAAAAAAAAAAAAAAAAAAIQAAABgAAAAUAAAAoRkAABsnAABfMQAAWSkAABAAAAAmAAAACAAAAAAAAAAAAAAA"/>
               </a:ext>
             </a:extLst>
           </p:cNvSpPr>
@@ -1911,9 +1899,6 @@
           <a:lstStyle/>
           <a:p>
             <a:pPr/>
-            <a:r>
-              <a:t/>
-            </a:r>
           </a:p>
         </p:txBody>
       </p:sp>
@@ -1924,7 +1909,7 @@
             <a:spLocks noGrp="1" noChangeArrowheads="1"/>
             <a:extLst>
               <a:ext uri="smNativeData">
-                <pr:smNativeData xmlns:pr="smNativeData" xmlns="smNativeData" val="SMDATA_15_AnHWaRMAAAAlAAAAZAAAAA8BAAAAkAAAAEgAAACQAAAASAAAAAAAAAABAAAAAAAAAAEAAABQAAAAAAAAAAAA4D8AAAAAAADgPwAAAAAAAOA/AAAAAAAA4D8AAAAAAADgPwAAAAAAAOA/AAAAAAAA4D8AAAAAAADgPwAAAAAAAOA/AAAAAAAA4D8CAAAAjAAAAAAAAAAAAAAAu+DjDP///wgAAAAAAAAAAAAAAAAAAAAAAAAAAAAAAAAAAAAAZAAAAAEAAABAAAAAAAAAAAAAAAAAAAAAAAAAAAAAAAAAAAAAAAAAAAAAAAAAAAAAAAAAAAAAAAAAAAAAAAAAAAAAAAAAAAAAAAAAAAAAAAAAAAAAAAAAAAAAAAAAAAAAFAAAADwAAAAAAAAAAAAAAAAAAAkUAAAAAQAAABQAAAAUAAAAFAAAAAEAAAAAAAAAZAAAAGQAAAAAAAAAZAAAAGQAAAAVAAAAYAAAAAAAAAAAAAAADwAAACADAAAAAAAAAAAAAAEAAACgMgAAVgcAAKr4//8BAAAAf39/AAEAAABkAAAAAAAAABQAAABAHwAAAAAAACYAAAAAAAAAwOD//wAAAAAmAAAAZAAAABYAAABMAAAAAAAAAAAAAAAEAAAAAAAAAAEAAACAgIAKAAAAACgAAAAoAAAAZAAAAGQAAAAAAAAAzMzMAAAAAABQAAAAUAAAAGQAAABkAAAAAAAAABcAAAAUAAAAAAAAAAAAAAD/fwAA/38AAAAAAAAJAAAABAAAANw7IAEeAAAAaAAAAAAAAAAAAAAAAAAAAAAAAAAAAAAAECcAABAnAAAAAAAAAAAAAAAAAAAAAAAAAAAAAAAAAAAAAAAAAAAAABQAAAAAAAAAwMD/AAAAAABkAAAAMgAAAAAAAABkAAAAAAAAAH9/fwAKAAAAIgAAABgAAAAAAAAAAAAAAAAAAAAAAAAAAAAAAAAAAAAkAAAAJAAAAAAAAAAHAAAAAAAAAAAAAAAAAAAAAAAAAAAAAAAAAAAAf39/ACUAAABYAAAAAAAAAAAAAAAAAAAAAAAAAAAAAAAAAAAAAAAAAAAAAAAAAAAAAAAAAAAAAAA/AAAAAAAAAKCGAQAAAAAAAAAAAAAAAAAMAAAAAQAAAAAAAAAAAAAAAAAAAB8AAABUAAAAAAAABQAAAAEAAAAAAAAAAAAAAAAAAAAAAAAAAAAAAAAAAAAAAAAAAAAAAAJ/f38AAAAAA8zMzADAwP8Af39/AAAAAAAAAAAAAAAAAAAAAAAAAAAAIQAAABgAAAAUAAAAwTUAABsnAABARwAAWSkAABAAAAAmAAAACAAAAAAAAAAAAAAA"/>
+                <pr:smNativeData xmlns:pr="smNativeData" xmlns="smNativeData" val="SMDATA_15_7aDWaRMAAAAlAAAAZAAAAA8BAAAAkAAAAEgAAACQAAAASAAAAAAAAAABAAAAAAAAAAEAAABQAAAAAAAAAAAA4D8AAAAAAADgPwAAAAAAAOA/AAAAAAAA4D8AAAAAAADgPwAAAAAAAOA/AAAAAAAA4D8AAAAAAADgPwAAAAAAAOA/AAAAAAAA4D8CAAAAjAAAAAAAAAAAAAAAu+DjDP///wgAAAAAAAAAAAAAAAAAAAAAAAAAAAAAAAAAAAAAZAAAAAEAAABAAAAAAAAAAAAAAAAAAAAAAAAAAAAAAAAAAAAAAAAAAAAAAAAAAAAAAAAAAAAAAAAAAAAAAAAAAAAAAAAAAAAAAAAAAAAAAAAAAAAAAAAAAAAAAAAAAAAAFAAAADwAAAAAAAAAAAAAAAAAAAkUAAAAAQAAABQAAAAUAAAAFAAAAAEAAAAAAAAAZAAAAGQAAAAAAAAAZAAAAGQAAAAVAAAAYAAAAAAAAAAAAAAADwAAACADAAAAAAAAAAAAAAEAAACgMgAAVgcAAKr4//8BAAAAf39/AAEAAABkAAAAAAAAABQAAABAHwAAAAAAACYAAAAAAAAAwOD//wAAAAAmAAAAZAAAABYAAABMAAAAAAAAAAAAAAAEAAAAAAAAAAEAAACAgIAKAAAAACgAAAAoAAAAZAAAAGQAAAAAAAAAzMzMAAAAAABQAAAAUAAAAGQAAABkAAAAAAAAABcAAAAUAAAAAAAAAAAAAAD/fwAA/38AAAAAAAAJAAAABAAAANw7IAEeAAAAaAAAAAAAAAAAAAAAAAAAAAAAAAAAAAAAECcAABAnAAAAAAAAAAAAAAAAAAAAAAAAAAAAAAAAAAAAAAAAAAAAABQAAAAAAAAAwMD/AAAAAABkAAAAMgAAAAAAAABkAAAAAAAAAH9/fwAKAAAAIgAAABgAAAAAAAAAAAAAAAAAAAAAAAAAAAAAAAAAAAAkAAAAJAAAAAAAAAAHAAAAAAAAAAAAAAAAAAAAAAAAAAAAAAAAAAAAf39/ACUAAABYAAAAAAAAAAAAAAAAAAAAAAAAAAAAAAAAAAAAAAAAAAAAAAAAAAAAAAAAAAAAAAA/AAAAAAAAAKCGAQAAAAAAAAAAAAAAAAAMAAAAAQAAAAAAAAAAAAAAAAAAAB8AAABUAAAAAAAABQAAAAEAAAAAAAAAAAAAAAAAAAAAAAAAAAAAAAAAAAAAAAAAAAAAAAJ/f38AAAAAA8zMzADAwP8Af39/AAAAAAAAAAAAAAAAAAAAAAAAAAAAIQAAABgAAAAUAAAAwTUAABsnAABARwAAWSkAABAAAAAmAAAACAAAAAAAAAAAAAAA"/>
               </a:ext>
             </a:extLst>
           </p:cNvSpPr>
@@ -1938,7 +1923,7 @@
           <a:lstStyle/>
           <a:p>
             <a:pPr/>
-            <a:fld id="{14BB2CB8-F6F9-EEDA-B703-008F624D4155}" type="slidenum">
+            <a:fld id="{7D363FCC-8290-63C9-DE8E-749C71C02821}" type="slidenum">
               <a:t/>
             </a:fld>
           </a:p>
@@ -1949,6 +1934,7 @@
   <p:clrMapOvr>
     <a:masterClrMapping/>
   </p:clrMapOvr>
+  <p:hf hdr="0" ftr="0"/>
 </p:sldLayout>
 </file>
 
@@ -1976,7 +1962,7 @@
             <a:spLocks noGrp="1" noChangeArrowheads="1"/>
             <a:extLst>
               <a:ext uri="smNativeData">
-                <pr:smNativeData xmlns:pr="smNativeData" xmlns="smNativeData" val="SMDATA_15_AnHWaRMAAAAlAAAAZAAAAA8BAAAAkAAAAEgAAACQAAAASAAAAAAAAAABAAAAAAAAAAEAAABQAAAAAAAAAAAA4D8AAAAAAADgPwAAAAAAAOA/AAAAAAAA4D8AAAAAAADgPwAAAAAAAOA/AAAAAAAA4D8AAAAAAADgPwAAAAAAAOA/AAAAAAAA4D8CAAAAjAAAAAAAAAAAAAAAu+DjDP///wgAAAAAAAAAAAAAAAAAAAAAAAAAAAAAAAAAAAAAZAAAAAEAAABAAAAAAAAAAAAAAAAAAAAAAAAAAAAAAAAAAAAAAAAAAAAAAAAAAAAAAAAAAAAAAAAAAAAAAAAAAAAAAAAAAAAAAAAAAAAAAAAAAAAAAAAAAAAAAAAAAAAAFAAAADwAAAAAAAAAAAAAAAAAAAkUAAAAAQAAABQAAAAUAAAAFAAAAAEAAAAAAAAAZAAAAGQAAAAAAAAAZAAAAGQAAAAVAAAAYAAAAAAAAAAAAAAADwAAACADAAAAAAAAAAAAAAEAAACgMgAAVgcAAKr4//8BAAAAf39/AAEAAABkAAAAAAAAABQAAABAHwAAAAAAACYAAAAAAAAAwOD//wAAAAAmAAAAZAAAABYAAABMAAAAAAAAAAAAAAAEAAAAAAAAAAEAAACAgIAKAAAAACgAAAAoAAAAZAAAAGQAAAAAAAAAzMzMAAAAAABQAAAAUAAAAGQAAABkAAAAAAAAABcAAAAUAAAAAAAAAAAAAAD/fwAA/38AAAAAAAAJAAAABAAAANw7IAEeAAAAaAAAAAAAAAAAAAAAAAAAAAAAAAAAAAAAECcAABAnAAAAAAAAAAAAAAAAAAAAAAAAAAAAAAAAAAAAAAAAAAAAABQAAAAAAAAAwMD/AAAAAABkAAAAMgAAAAAAAABkAAAAAAAAAH9/fwAKAAAAIgAAABgAAAAAAAAAAAAAAAAAAAAAAAAAAAAAAAAAAAAkAAAAJAAAAAAAAAAHAAAAAAAAAAAAAAAAAAAAAAAAAAAAAAAAAAAAf39/ACUAAABYAAAAAAAAAAAAAAAAAAAAAAAAAAAAAAAAAAAAAAAAAAAAAAAAAAAAAAAAAAAAAAA/AAAAAAAAAKCGAQAAAAAAAAAAAAAAAAAMAAAAAQAAAAAAAAAAAAAAAAAAAB8AAABUAAAAAAAABQAAAAEAAAAAAAAAAAAAAAAAAAAAAAAAAAAAAAAAAAAAAAAAAAAAAAJ/f38AAAAAA8zMzADAwP8Af39/AAAAAAAAAAAAAAAAAAAAAAAAAAAAIQAAABgAAAAUAAAAwAMAALABAABARwAAuAgAABAAAAAmAAAACAAAAAAAAAAAAAAA"/>
+                <pr:smNativeData xmlns:pr="smNativeData" xmlns="smNativeData" val="SMDATA_15_7aDWaRMAAAAlAAAAZAAAAA8BAAAAkAAAAEgAAACQAAAASAAAAAAAAAABAAAAAAAAAAEAAABQAAAAAAAAAAAA4D8AAAAAAADgPwAAAAAAAOA/AAAAAAAA4D8AAAAAAADgPwAAAAAAAOA/AAAAAAAA4D8AAAAAAADgPwAAAAAAAOA/AAAAAAAA4D8CAAAAjAAAAAAAAAAAAAAAu+DjDP///wgAAAAAAAAAAAAAAAAAAAAAAAAAAAAAAAAAAAAAZAAAAAEAAABAAAAAAAAAAAAAAAAAAAAAAAAAAAAAAAAAAAAAAAAAAAAAAAAAAAAAAAAAAAAAAAAAAAAAAAAAAAAAAAAAAAAAAAAAAAAAAAAAAAAAAAAAAAAAAAAAAAAAFAAAADwAAAAAAAAAAAAAAAAAAAkUAAAAAQAAABQAAAAUAAAAFAAAAAEAAAAAAAAAZAAAAGQAAAAAAAAAZAAAAGQAAAAVAAAAYAAAAAAAAAAAAAAADwAAACADAAAAAAAAAAAAAAEAAACgMgAAVgcAAKr4//8BAAAAf39/AAEAAABkAAAAAAAAABQAAABAHwAAAAAAACYAAAAAAAAAwOD//wAAAAAmAAAAZAAAABYAAABMAAAAAAAAAAAAAAAEAAAAAAAAAAEAAACAgIAKAAAAACgAAAAoAAAAZAAAAGQAAAAAAAAAzMzMAAAAAABQAAAAUAAAAGQAAABkAAAAAAAAABcAAAAUAAAAAAAAAAAAAAD/fwAA/38AAAAAAAAJAAAABAAAANw7IAEeAAAAaAAAAAAAAAAAAAAAAAAAAAAAAAAAAAAAECcAABAnAAAAAAAAAAAAAAAAAAAAAAAAAAAAAAAAAAAAAAAAAAAAABQAAAAAAAAAwMD/AAAAAABkAAAAMgAAAAAAAABkAAAAAAAAAH9/fwAKAAAAIgAAABgAAAAAAAAAAAAAAAAAAAAAAAAAAAAAAAAAAAAkAAAAJAAAAAAAAAAHAAAAAAAAAAAAAAAAAAAAAAAAAAAAAAAAAAAAf39/ACUAAABYAAAAAAAAAAAAAAAAAAAAAAAAAAAAAAAAAAAAAAAAAAAAAAAAAAAAAAAAAAAAAAA/AAAAAAAAAKCGAQAAAAAAAAAAAAAAAAAMAAAAAQAAAAAAAAAAAAAAAAAAAB8AAABUAAAAAAAABQAAAAEAAAAAAAAAAAAAAAAAAAAAAAAAAAAAAAAAAAAAAAAAAAAAAAJ/f38AAAAAA8zMzADAwP8Af39/AAAAAAAAAAAAAAAAAAAAAAAAAAAAIQAAABgAAAAUAAAAwAMAALABAABARwAAuAgAABAAAAAmAAAACAAAAAAAAAAAAAAA"/>
               </a:ext>
             </a:extLst>
           </p:cNvSpPr>
@@ -2003,7 +1989,7 @@
             <a:spLocks noGrp="1" noChangeArrowheads="1"/>
             <a:extLst>
               <a:ext uri="smNativeData">
-                <pr:smNativeData xmlns:pr="smNativeData" xmlns="smNativeData" val="SMDATA_15_AnHWaRMAAAAlAAAAZAAAAA8BAAAAkAAAAEgAAACQAAAASAAAAAAAAAABAAAAAAAAAAEAAABQAAAAAAAAAAAA4D8AAAAAAADgPwAAAAAAAOA/AAAAAAAA4D8AAAAAAADgPwAAAAAAAOA/AAAAAAAA4D8AAAAAAADgPwAAAAAAAOA/AAAAAAAA4D8CAAAAjAAAAAAAAAAAAAAAu+DjDP///wgAAAAAAAAAAAAAAAAAAAAAAAAAAAAAAAAAAAAAZAAAAAEAAABAAAAAAAAAAAAAAAAAAAAAAAAAAAAAAAAAAAAAAAAAAAAAAAAAAAAAAAAAAAAAAAAAAAAAAAAAAAAAAAAAAAAAAAAAAAAAAAAAAAAAAAAAAAAAAAAAAAAAFAAAADwAAAAAAAAAAAAAAAAAAAkUAAAAAQAAABQAAAAUAAAAFAAAAAEAAAAAAAAAZAAAAGQAAAAAAAAAZAAAAGQAAAAVAAAAYAAAAAAAAAAAAAAADwAAACADAAAAAAAAAAAAAAEAAACgMgAAVgcAAKr4//8BAAAAf39/AAEAAABkAAAAAAAAABQAAABAHwAAAAAAACYAAAAAAAAAwOD//wAAAAAmAAAAZAAAABYAAABMAAAAAAAAAAAAAAAEAAAAAAAAAAEAAACAgIAKAAAAACgAAAAoAAAAZAAAAGQAAAAAAAAAzMzMAAAAAABQAAAAUAAAAGQAAABkAAAAAAAAABcAAAAUAAAAAAAAAAAAAAD/fwAA/38AAAAAAAAJAAAABAAAANw7IAEeAAAAaAAAAAAAAAAAAAAAAAAAAAAAAAAAAAAAECcAABAnAAAAAAAAAAAAAAAAAAAAAAAAAAAAAAAAAAAAAAAAAAAAABQAAAAAAAAAwMD/AAAAAABkAAAAMgAAAAAAAABkAAAAAAAAAH9/fwAKAAAAIgAAABgAAAAAAAAAAAAAAAAAAAAAAAAAAAAAAAAAAAAkAAAAJAAAAAAAAAAHAAAAAAAAAAAAAAAAAAAAAAAAAAAAAAAAAAAAf39/ACUAAABYAAAAAAAAAAAAAAAAAAAAAAAAAAAAAAAAAAAAAAAAAAAAAAAAAAAAAAAAAAAAAAA/AAAAAAAAAKCGAQAAAAAAAAAAAAAAAAAMAAAAAQAAAAAAAAAAAAAAAAAAAB8AAABUAAAAAAAABQAAAAEAAAAAAAAAAAAAAAAAAAAAAAAAAAAAAAAAAAAAAAAAAAAAAAJ/f38AAAAAA8zMzADAwP8Af39/AAAAAAAAAAAAAAAAAAAAAAAAAAAAIQAAABgAAAAUAAAAwAMAABsnAAA/FQAAWSkAABAAAAAmAAAACAAAAAAAAAAAAAAA"/>
+                <pr:smNativeData xmlns:pr="smNativeData" xmlns="smNativeData" val="SMDATA_15_7aDWaRMAAAAlAAAAZAAAAA8BAAAAkAAAAEgAAACQAAAASAAAAAAAAAABAAAAAAAAAAEAAABQAAAAAAAAAAAA4D8AAAAAAADgPwAAAAAAAOA/AAAAAAAA4D8AAAAAAADgPwAAAAAAAOA/AAAAAAAA4D8AAAAAAADgPwAAAAAAAOA/AAAAAAAA4D8CAAAAjAAAAAAAAAAAAAAAu+DjDP///wgAAAAAAAAAAAAAAAAAAAAAAAAAAAAAAAAAAAAAZAAAAAEAAABAAAAAAAAAAAAAAAAAAAAAAAAAAAAAAAAAAAAAAAAAAAAAAAAAAAAAAAAAAAAAAAAAAAAAAAAAAAAAAAAAAAAAAAAAAAAAAAAAAAAAAAAAAAAAAAAAAAAAFAAAADwAAAAAAAAAAAAAAAAAAAkUAAAAAQAAABQAAAAUAAAAFAAAAAEAAAAAAAAAZAAAAGQAAAAAAAAAZAAAAGQAAAAVAAAAYAAAAAAAAAAAAAAADwAAACADAAAAAAAAAAAAAAEAAACgMgAAVgcAAKr4//8BAAAAf39/AAEAAABkAAAAAAAAABQAAABAHwAAAAAAACYAAAAAAAAAwOD//wAAAAAmAAAAZAAAABYAAABMAAAAAAAAAAAAAAAEAAAAAAAAAAEAAACAgIAKAAAAACgAAAAoAAAAZAAAAGQAAAAAAAAAzMzMAAAAAABQAAAAUAAAAGQAAABkAAAAAAAAABcAAAAUAAAAAAAAAAAAAAD/fwAA/38AAAAAAAAJAAAABAAAANw7IAEeAAAAaAAAAAAAAAAAAAAAAAAAAAAAAAAAAAAAECcAABAnAAAAAAAAAAAAAAAAAAAAAAAAAAAAAAAAAAAAAAAAAAAAABQAAAAAAAAAwMD/AAAAAABkAAAAMgAAAAAAAABkAAAAAAAAAH9/fwAKAAAAIgAAABgAAAAAAAAAAAAAAAAAAAAAAAAAAAAAAAAAAAAkAAAAJAAAAAAAAAAHAAAAAAAAAAAAAAAAAAAAAAAAAAAAAAAAAAAAf39/ACUAAABYAAAAAAAAAAAAAAAAAAAAAAAAAAAAAAAAAAAAAAAAAAAAAAAAAAAAAAAAAAAAAAA/AAAAAAAAAKCGAQAAAAAAAAAAAAAAAAAMAAAAAQAAAAAAAAAAAAAAAAAAAB8AAABUAAAAAAAABQAAAAEAAAAAAAAAAAAAAAAAAAAAAAAAAAAAAAAAAAAAAAAAAAAAAAJ/f38AAAAAA8zMzADAwP8Af39/AAAAAAAAAAAAAAAAAAAAAAAAAAAAIQAAABgAAAAUAAAAwAMAABsnAAA/FQAAWSkAABAAAAAmAAAACAAAAAAAAAAAAAAA"/>
               </a:ext>
             </a:extLst>
           </p:cNvSpPr>
@@ -2017,7 +2003,7 @@
           <a:lstStyle/>
           <a:p>
             <a:pPr/>
-            <a:fld id="{68FADAED-A385-AF2C-CB42-5579940C3D00}" type="datetime1">
+            <a:fld id="{0DA4810B-45E0-F177-AE1C-B322CF5258E6}" type="datetime1">
               <a:t/>
             </a:fld>
           </a:p>
@@ -2030,7 +2016,7 @@
             <a:spLocks noGrp="1" noChangeArrowheads="1"/>
             <a:extLst>
               <a:ext uri="smNativeData">
-                <pr:smNativeData xmlns:pr="smNativeData" xmlns="smNativeData" val="SMDATA_15_AnHWaRMAAAAlAAAAZAAAAA8BAAAAkAAAAEgAAACQAAAASAAAAAAAAAABAAAAAAAAAAEAAABQAAAAAAAAAAAA4D8AAAAAAADgPwAAAAAAAOA/AAAAAAAA4D8AAAAAAADgPwAAAAAAAOA/AAAAAAAA4D8AAAAAAADgPwAAAAAAAOA/AAAAAAAA4D8CAAAAjAAAAAAAAAAAAAAAu+DjDP///wgAAAAAAAAAAAAAAAAAAAAAAAAAAAAAAAAAAAAAZAAAAAEAAABAAAAAAAAAAAAAAAAAAAAAAAAAAAAAAAAAAAAAAAAAAAAAAAAAAAAAAAAAAAAAAAAAAAAAAAAAAAAAAAAAAAAAAAAAAAAAAAAAAAAAAAAAAAAAAAAAAAAAFAAAADwAAAAAAAAAAAAAAAAAAAkUAAAAAQAAABQAAAAUAAAAFAAAAAEAAAAAAAAAZAAAAGQAAAAAAAAAZAAAAGQAAAAVAAAAYAAAAAAAAAAAAAAADwAAACADAAAAAAAAAAAAAAEAAACgMgAAVgcAAKr4//8BAAAAf39/AAEAAABkAAAAAAAAABQAAABAHwAAAAAAACYAAAAAAAAAwOD//wAAAAAmAAAAZAAAABYAAABMAAAAAAAAAAAAAAAEAAAAAAAAAAEAAACAgIAKAAAAACgAAAAoAAAAZAAAAGQAAAAAAAAAzMzMAAAAAABQAAAAUAAAAGQAAABkAAAAAAAAABcAAAAUAAAAAAAAAAAAAAD/fwAA/38AAAAAAAAJAAAABAAAANw7IAEeAAAAaAAAAAAAAAAAAAAAAAAAAAAAAAAAAAAAECcAABAnAAAAAAAAAAAAAAAAAAAAAAAAAAAAAAAAAAAAAAAAAAAAABQAAAAAAAAAwMD/AAAAAABkAAAAMgAAAAAAAABkAAAAAAAAAH9/fwAKAAAAIgAAABgAAAAAAAAAAAAAAAAAAAAAAAAAAAAAAAAAAAAkAAAAJAAAAAAAAAAHAAAAAAAAAAAAAAAAAAAAAAAAAAAAAAAAAAAAf39/ACUAAABYAAAAAAAAAAAAAAAAAAAAAAAAAAAAAAAAAAAAAAAAAAAAAAAAAAAAAAAAAAAAAAA/AAAAAAAAAKCGAQAAAAAAAAAAAAAAAAAMAAAAAQAAAAAAAAAAAAAAAAAAAB8AAABUAAAAAAAABQAAAAEAAAAAAAAAAAAAAAAAAAAAAAAAAAAAAAAAAAAAAAAAAAAAAAJ/f38AAAAAA8zMzADAwP8Af39/AAAAAAAAAAAAAAAAAAAAAAAAAAAAIQAAABgAAAAUAAAAoRkAABsnAABfMQAAWSkAABAAAAAmAAAACAAAAAAAAAAAAAAA"/>
+                <pr:smNativeData xmlns:pr="smNativeData" xmlns="smNativeData" val="SMDATA_15_7aDWaRMAAAAlAAAAZAAAAA8BAAAAkAAAAEgAAACQAAAASAAAAAAAAAABAAAAAAAAAAEAAABQAAAAAAAAAAAA4D8AAAAAAADgPwAAAAAAAOA/AAAAAAAA4D8AAAAAAADgPwAAAAAAAOA/AAAAAAAA4D8AAAAAAADgPwAAAAAAAOA/AAAAAAAA4D8CAAAAjAAAAAAAAAAAAAAAu+DjDP///wgAAAAAAAAAAAAAAAAAAAAAAAAAAAAAAAAAAAAAZAAAAAEAAABAAAAAAAAAAAAAAAAAAAAAAAAAAAAAAAAAAAAAAAAAAAAAAAAAAAAAAAAAAAAAAAAAAAAAAAAAAAAAAAAAAAAAAAAAAAAAAAAAAAAAAAAAAAAAAAAAAAAAFAAAADwAAAAAAAAAAAAAAAAAAAkUAAAAAQAAABQAAAAUAAAAFAAAAAEAAAAAAAAAZAAAAGQAAAAAAAAAZAAAAGQAAAAVAAAAYAAAAAAAAAAAAAAADwAAACADAAAAAAAAAAAAAAEAAACgMgAAVgcAAKr4//8BAAAAf39/AAEAAABkAAAAAAAAABQAAABAHwAAAAAAACYAAAAAAAAAwOD//wAAAAAmAAAAZAAAABYAAABMAAAAAAAAAAAAAAAEAAAAAAAAAAEAAACAgIAKAAAAACgAAAAoAAAAZAAAAGQAAAAAAAAAzMzMAAAAAABQAAAAUAAAAGQAAABkAAAAAAAAABcAAAAUAAAAAAAAAAAAAAD/fwAA/38AAAAAAAAJAAAABAAAANw7IAEeAAAAaAAAAAAAAAAAAAAAAAAAAAAAAAAAAAAAECcAABAnAAAAAAAAAAAAAAAAAAAAAAAAAAAAAAAAAAAAAAAAAAAAABQAAAAAAAAAwMD/AAAAAABkAAAAMgAAAAAAAABkAAAAAAAAAH9/fwAKAAAAIgAAABgAAAAAAAAAAAAAAAAAAAAAAAAAAAAAAAAAAAAkAAAAJAAAAAAAAAAHAAAAAAAAAAAAAAAAAAAAAAAAAAAAAAAAAAAAf39/ACUAAABYAAAAAAAAAAAAAAAAAAAAAAAAAAAAAAAAAAAAAAAAAAAAAAAAAAAAAAAAAAAAAAA/AAAAAAAAAKCGAQAAAAAAAAAAAAAAAAAMAAAAAQAAAAAAAAAAAAAAAAAAAB8AAABUAAAAAAAABQAAAAEAAAAAAAAAAAAAAAAAAAAAAAAAAAAAAAAAAAAAAAAAAAAAAAJ/f38AAAAAA8zMzADAwP8Af39/AAAAAAAAAAAAAAAAAAAAAAAAAAAAIQAAABgAAAAUAAAAoRkAABsnAABfMQAAWSkAABAAAAAmAAAACAAAAAAAAAAAAAAA"/>
               </a:ext>
             </a:extLst>
           </p:cNvSpPr>
@@ -2044,9 +2030,6 @@
           <a:lstStyle/>
           <a:p>
             <a:pPr/>
-            <a:r>
-              <a:t/>
-            </a:r>
           </a:p>
         </p:txBody>
       </p:sp>
@@ -2057,7 +2040,7 @@
             <a:spLocks noGrp="1" noChangeArrowheads="1"/>
             <a:extLst>
               <a:ext uri="smNativeData">
-                <pr:smNativeData xmlns:pr="smNativeData" xmlns="smNativeData" val="SMDATA_15_AnHWaRMAAAAlAAAAZAAAAA8BAAAAkAAAAEgAAACQAAAASAAAAAAAAAABAAAAAAAAAAEAAABQAAAAAAAAAAAA4D8AAAAAAADgPwAAAAAAAOA/AAAAAAAA4D8AAAAAAADgPwAAAAAAAOA/AAAAAAAA4D8AAAAAAADgPwAAAAAAAOA/AAAAAAAA4D8CAAAAjAAAAAAAAAAAAAAAu+DjDP///wgAAAAAAAAAAAAAAAAAAAAAAAAAAAAAAAAAAAAAZAAAAAEAAABAAAAAAAAAAAAAAAAAAAAAAAAAAAAAAAAAAAAAAAAAAAAAAAAAAAAAAAAAAAAAAAAAAAAAAAAAAAAAAAAAAAAAAAAAAAAAAAAAAAAAAAAAAAAAAAAAAAAAFAAAADwAAAAAAAAAAAAAAAAAAAkUAAAAAQAAABQAAAAUAAAAFAAAAAEAAAAAAAAAZAAAAGQAAAAAAAAAZAAAAGQAAAAVAAAAYAAAAAAAAAAAAAAADwAAACADAAAAAAAAAAAAAAEAAACgMgAAVgcAAKr4//8BAAAAf39/AAEAAABkAAAAAAAAABQAAABAHwAAAAAAACYAAAAAAAAAwOD//wAAAAAmAAAAZAAAABYAAABMAAAAAAAAAAAAAAAEAAAAAAAAAAEAAACAgIAKAAAAACgAAAAoAAAAZAAAAGQAAAAAAAAAzMzMAAAAAABQAAAAUAAAAGQAAABkAAAAAAAAABcAAAAUAAAAAAAAAAAAAAD/fwAA/38AAAAAAAAJAAAABAAAANw7IAEeAAAAaAAAAAAAAAAAAAAAAAAAAAAAAAAAAAAAECcAABAnAAAAAAAAAAAAAAAAAAAAAAAAAAAAAAAAAAAAAAAAAAAAABQAAAAAAAAAwMD/AAAAAABkAAAAMgAAAAAAAABkAAAAAAAAAH9/fwAKAAAAIgAAABgAAAAAAAAAAAAAAAAAAAAAAAAAAAAAAAAAAAAkAAAAJAAAAAAAAAAHAAAAAAAAAAAAAAAAAAAAAAAAAAAAAAAAAAAAf39/ACUAAABYAAAAAAAAAAAAAAAAAAAAAAAAAAAAAAAAAAAAAAAAAAAAAAAAAAAAAAAAAAAAAAA/AAAAAAAAAKCGAQAAAAAAAAAAAAAAAAAMAAAAAQAAAAAAAAAAAAAAAAAAAB8AAABUAAAAAAAABQAAAAEAAAAAAAAAAAAAAAAAAAAAAAAAAAAAAAAAAAAAAAAAAAAAAAJ/f38AAAAAA8zMzADAwP8Af39/AAAAAAAAAAAAAAAAAAAAAAAAAAAAIQAAABgAAAAUAAAAwTUAABsnAABARwAAWSkAABAAAAAmAAAACAAAAAAAAAAAAAAA"/>
+                <pr:smNativeData xmlns:pr="smNativeData" xmlns="smNativeData" val="SMDATA_15_7aDWaRMAAAAlAAAAZAAAAA8BAAAAkAAAAEgAAACQAAAASAAAAAAAAAABAAAAAAAAAAEAAABQAAAAAAAAAAAA4D8AAAAAAADgPwAAAAAAAOA/AAAAAAAA4D8AAAAAAADgPwAAAAAAAOA/AAAAAAAA4D8AAAAAAADgPwAAAAAAAOA/AAAAAAAA4D8CAAAAjAAAAAAAAAAAAAAAu+DjDP///wgAAAAAAAAAAAAAAAAAAAAAAAAAAAAAAAAAAAAAZAAAAAEAAABAAAAAAAAAAAAAAAAAAAAAAAAAAAAAAAAAAAAAAAAAAAAAAAAAAAAAAAAAAAAAAAAAAAAAAAAAAAAAAAAAAAAAAAAAAAAAAAAAAAAAAAAAAAAAAAAAAAAAFAAAADwAAAAAAAAAAAAAAAAAAAkUAAAAAQAAABQAAAAUAAAAFAAAAAEAAAAAAAAAZAAAAGQAAAAAAAAAZAAAAGQAAAAVAAAAYAAAAAAAAAAAAAAADwAAACADAAAAAAAAAAAAAAEAAACgMgAAVgcAAKr4//8BAAAAf39/AAEAAABkAAAAAAAAABQAAABAHwAAAAAAACYAAAAAAAAAwOD//wAAAAAmAAAAZAAAABYAAABMAAAAAAAAAAAAAAAEAAAAAAAAAAEAAACAgIAKAAAAACgAAAAoAAAAZAAAAGQAAAAAAAAAzMzMAAAAAABQAAAAUAAAAGQAAABkAAAAAAAAABcAAAAUAAAAAAAAAAAAAAD/fwAA/38AAAAAAAAJAAAABAAAANw7IAEeAAAAaAAAAAAAAAAAAAAAAAAAAAAAAAAAAAAAECcAABAnAAAAAAAAAAAAAAAAAAAAAAAAAAAAAAAAAAAAAAAAAAAAABQAAAAAAAAAwMD/AAAAAABkAAAAMgAAAAAAAABkAAAAAAAAAH9/fwAKAAAAIgAAABgAAAAAAAAAAAAAAAAAAAAAAAAAAAAAAAAAAAAkAAAAJAAAAAAAAAAHAAAAAAAAAAAAAAAAAAAAAAAAAAAAAAAAAAAAf39/ACUAAABYAAAAAAAAAAAAAAAAAAAAAAAAAAAAAAAAAAAAAAAAAAAAAAAAAAAAAAAAAAAAAAA/AAAAAAAAAKCGAQAAAAAAAAAAAAAAAAAMAAAAAQAAAAAAAAAAAAAAAAAAAB8AAABUAAAAAAAABQAAAAEAAAAAAAAAAAAAAAAAAAAAAAAAAAAAAAAAAAAAAAAAAAAAAAJ/f38AAAAAA8zMzADAwP8Af39/AAAAAAAAAAAAAAAAAAAAAAAAAAAAIQAAABgAAAAUAAAAwTUAABsnAABARwAAWSkAABAAAAAmAAAACAAAAAAAAAAAAAAA"/>
               </a:ext>
             </a:extLst>
           </p:cNvSpPr>
@@ -2071,7 +2054,7 @@
           <a:lstStyle/>
           <a:p>
             <a:pPr/>
-            <a:fld id="{5C764BCA-84B1-23BD-FFCE-72E805800927}" type="slidenum">
+            <a:fld id="{31996BDC-92DC-CC9D-9221-64C8256F6431}" type="slidenum">
               <a:t/>
             </a:fld>
           </a:p>
@@ -2082,6 +2065,7 @@
   <p:clrMapOvr>
     <a:masterClrMapping/>
   </p:clrMapOvr>
+  <p:hf hdr="0" ftr="0"/>
 </p:sldLayout>
 </file>
 
@@ -2109,7 +2093,7 @@
             <a:spLocks noGrp="1" noChangeArrowheads="1"/>
             <a:extLst>
               <a:ext uri="smNativeData">
-                <pr:smNativeData xmlns:pr="smNativeData" xmlns="smNativeData" val="SMDATA_15_AnHWaRMAAAAlAAAAZAAAAA8BAAAAkAAAAEgAAACQAAAASAAAAAAAAAABAAAAAAAAAAEAAABQAAAAAAAAAAAA4D8AAAAAAADgPwAAAAAAAOA/AAAAAAAA4D8AAAAAAADgPwAAAAAAAOA/AAAAAAAA4D8AAAAAAADgPwAAAAAAAOA/AAAAAAAA4D8CAAAAjAAAAAAAAAAAAAAAu+DjDP///wgAAAAAAAAAAAAAAAAAAAAAAAAAAAAAAAAAAAAAZAAAAAEAAABAAAAAAAAAAAAAAAAAAAAAAAAAAAAAAAAAAAAAAAAAAAAAAAAAAAAAAAAAAAAAAAAAAAAAAAAAAAAAAAAAAAAAAAAAAAAAAAAAAAAAAAAAAAAAAAAAAAAAFAAAADwAAAAAAAAAAAAAAAAAAAkUAAAAAQAAABQAAAAUAAAAFAAAAAEAAAAAAAAAZAAAAGQAAAAAAAAAZAAAAGQAAAAVAAAAYAAAAAAAAAAAAAAADwAAACADAAAAAAAAAAAAAAEAAACgMgAAVgcAAKr4//8BAAAAf39/AAEAAABkAAAAAAAAABQAAABAHwAAAAAAACYAAAAAAAAAwOD//wAAAAAmAAAAZAAAABYAAABMAAAAAAAAAAAAAAAEAAAAAAAAAAEAAACAgIAKAAAAACgAAAAoAAAAZAAAAGQAAAAAAAAAzMzMAAAAAABQAAAAUAAAAGQAAABkAAAAAAAAABcAAAAUAAAAAAAAAAAAAAD/fwAA/38AAAAAAAAJAAAABAAAANw7IAEeAAAAaAAAAAAAAAAAAAAAAAAAAAAAAAAAAAAAECcAABAnAAAAAAAAAAAAAAAAAAAAAAAAAAAAAAAAAAAAAAAAAAAAABQAAAAAAAAAwMD/AAAAAABkAAAAMgAAAAAAAABkAAAAAAAAAH9/fwAKAAAAIgAAABgAAAAAAAAAAAAAAAAAAAAAAAAAAAAAAAAAAAAkAAAAJAAAAAAAAAAHAAAAAAAAAAAAAAAAAAAAAAAAAAAAAAAAAAAAf39/ACUAAABYAAAAAAAAAAAAAAAAAAAAAAAAAAAAAAAAAAAAAAAAAAAAAAAAAAAAAAAAAAAAAAA/AAAAAAAAAKCGAQAAAAAAAAAAAAAAAAAMAAAAAQAAAAAAAAAAAAAAAAAAAB8AAABUAAAAAAAABQAAAAEAAAAAAAAAAAAAAAAAAAAAAAAAAAAAAAAAAAAAAAAAAAAAAAJ/f38AAAAAA8zMzADAwP8Af39/AAAAAAAAAAAAAAAAAAAAAAAAAAAAIQAAABgAAAAUAAAAwAMAABsnAAA/FQAAWSkAABAAAAAmAAAACAAAAAAAAAAAAAAA"/>
+                <pr:smNativeData xmlns:pr="smNativeData" xmlns="smNativeData" val="SMDATA_15_7aDWaRMAAAAlAAAAZAAAAA8BAAAAkAAAAEgAAACQAAAASAAAAAAAAAABAAAAAAAAAAEAAABQAAAAAAAAAAAA4D8AAAAAAADgPwAAAAAAAOA/AAAAAAAA4D8AAAAAAADgPwAAAAAAAOA/AAAAAAAA4D8AAAAAAADgPwAAAAAAAOA/AAAAAAAA4D8CAAAAjAAAAAAAAAAAAAAAu+DjDP///wgAAAAAAAAAAAAAAAAAAAAAAAAAAAAAAAAAAAAAZAAAAAEAAABAAAAAAAAAAAAAAAAAAAAAAAAAAAAAAAAAAAAAAAAAAAAAAAAAAAAAAAAAAAAAAAAAAAAAAAAAAAAAAAAAAAAAAAAAAAAAAAAAAAAAAAAAAAAAAAAAAAAAFAAAADwAAAAAAAAAAAAAAAAAAAkUAAAAAQAAABQAAAAUAAAAFAAAAAEAAAAAAAAAZAAAAGQAAAAAAAAAZAAAAGQAAAAVAAAAYAAAAAAAAAAAAAAADwAAACADAAAAAAAAAAAAAAEAAACgMgAAVgcAAKr4//8BAAAAf39/AAEAAABkAAAAAAAAABQAAABAHwAAAAAAACYAAAAAAAAAwOD//wAAAAAmAAAAZAAAABYAAABMAAAAAAAAAAAAAAAEAAAAAAAAAAEAAACAgIAKAAAAACgAAAAoAAAAZAAAAGQAAAAAAAAAzMzMAAAAAABQAAAAUAAAAGQAAABkAAAAAAAAABcAAAAUAAAAAAAAAAAAAAD/fwAA/38AAAAAAAAJAAAABAAAANw7IAEeAAAAaAAAAAAAAAAAAAAAAAAAAAAAAAAAAAAAECcAABAnAAAAAAAAAAAAAAAAAAAAAAAAAAAAAAAAAAAAAAAAAAAAABQAAAAAAAAAwMD/AAAAAABkAAAAMgAAAAAAAABkAAAAAAAAAH9/fwAKAAAAIgAAABgAAAAAAAAAAAAAAAAAAAAAAAAAAAAAAAAAAAAkAAAAJAAAAAAAAAAHAAAAAAAAAAAAAAAAAAAAAAAAAAAAAAAAAAAAf39/ACUAAABYAAAAAAAAAAAAAAAAAAAAAAAAAAAAAAAAAAAAAAAAAAAAAAAAAAAAAAAAAAAAAAA/AAAAAAAAAKCGAQAAAAAAAAAAAAAAAAAMAAAAAQAAAAAAAAAAAAAAAAAAAB8AAABUAAAAAAAABQAAAAEAAAAAAAAAAAAAAAAAAAAAAAAAAAAAAAAAAAAAAAAAAAAAAAJ/f38AAAAAA8zMzADAwP8Af39/AAAAAAAAAAAAAAAAAAAAAAAAAAAAIQAAABgAAAAUAAAAwAMAABsnAAA/FQAAWSkAABAAAAAmAAAACAAAAAAAAAAAAAAA"/>
               </a:ext>
             </a:extLst>
           </p:cNvSpPr>
@@ -2123,7 +2107,7 @@
           <a:lstStyle/>
           <a:p>
             <a:pPr/>
-            <a:fld id="{5A9DAEBC-F2B7-C858-F925-040DE06B0F51}" type="datetime1">
+            <a:fld id="{63B8F16D-238E-ED07-C000-D552BF4E3680}" type="datetime1">
               <a:t/>
             </a:fld>
           </a:p>
@@ -2136,7 +2120,7 @@
             <a:spLocks noGrp="1" noChangeArrowheads="1"/>
             <a:extLst>
               <a:ext uri="smNativeData">
-                <pr:smNativeData xmlns:pr="smNativeData" xmlns="smNativeData" val="SMDATA_15_AnHWaRMAAAAlAAAAZAAAAA8BAAAAkAAAAEgAAACQAAAASAAAAAAAAAABAAAAAAAAAAEAAABQAAAAAAAAAAAA4D8AAAAAAADgPwAAAAAAAOA/AAAAAAAA4D8AAAAAAADgPwAAAAAAAOA/AAAAAAAA4D8AAAAAAADgPwAAAAAAAOA/AAAAAAAA4D8CAAAAjAAAAAAAAAAAAAAAu+DjDP///wgAAAAAAAAAAAAAAAAAAAAAAAAAAAAAAAAAAAAAZAAAAAEAAABAAAAAAAAAAAAAAAAAAAAAAAAAAAAAAAAAAAAAAAAAAAAAAAAAAAAAAAAAAAAAAAAAAAAAAAAAAAAAAAAAAAAAAAAAAAAAAAAAAAAAAAAAAAAAAAAAAAAAFAAAADwAAAAAAAAAAAAAAAAAAAkUAAAAAQAAABQAAAAUAAAAFAAAAAEAAAAAAAAAZAAAAGQAAAAAAAAAZAAAAGQAAAAVAAAAYAAAAAAAAAAAAAAADwAAACADAAAAAAAAAAAAAAEAAACgMgAAVgcAAKr4//8BAAAAf39/AAEAAABkAAAAAAAAABQAAABAHwAAAAAAACYAAAAAAAAAwOD//wAAAAAmAAAAZAAAABYAAABMAAAAAAAAAAAAAAAEAAAAAAAAAAEAAACAgIAKAAAAACgAAAAoAAAAZAAAAGQAAAAAAAAAzMzMAAAAAABQAAAAUAAAAGQAAABkAAAAAAAAABcAAAAUAAAAAAAAAAAAAAD/fwAA/38AAAAAAAAJAAAABAAAAAAAAAAeAAAAaAAAAAAAAAAAAAAAAAAAAAAAAAAAAAAAECcAABAnAAAAAAAAAAAAAAAAAAAAAAAAAAAAAAAAAAAAAAAAAAAAABQAAAAAAAAAwMD/AAAAAABkAAAAMgAAAAAAAABkAAAAAAAAAH9/fwAKAAAAIgAAABgAAAAAAAAAAAAAAAAAAAAAAAAAAAAAAAAAAAAkAAAAJAAAAAAAAAAHAAAAAAAAAAAAAAAAAAAAAAAAAAAAAAAAAAAAf39/ACUAAABYAAAAAAAAAAAAAAAAAAAAAAAAAAAAAAAAAAAAAAAAAAAAAAAAAAAAAAAAAAAAAAA/AAAAAAAAAKCGAQAAAAAAAAAAAAAAAAAMAAAAAQAAAAAAAAAAAAAAAAAAAB8AAABUAAAAAAAABQAAAAEAAAAAAAAAAAAAAAAAAAAAAAAAAAAAAAAAAAAAAAAAAAAAAAJ/f38AAAAAA8zMzADAwP8Af39/AAAAAAAAAAAAAAAAAAAAAAAAAAAAIQAAABgAAAAUAAAAoRkAABsnAABfMQAAWSkAABAAAAAmAAAACAAAAAAAAAAAAAAA"/>
+                <pr:smNativeData xmlns:pr="smNativeData" xmlns="smNativeData" val="SMDATA_15_7aDWaRMAAAAlAAAAZAAAAA8BAAAAkAAAAEgAAACQAAAASAAAAAAAAAABAAAAAAAAAAEAAABQAAAAAAAAAAAA4D8AAAAAAADgPwAAAAAAAOA/AAAAAAAA4D8AAAAAAADgPwAAAAAAAOA/AAAAAAAA4D8AAAAAAADgPwAAAAAAAOA/AAAAAAAA4D8CAAAAjAAAAAAAAAAAAAAAu+DjDP///wgAAAAAAAAAAAAAAAAAAAAAAAAAAAAAAAAAAAAAZAAAAAEAAABAAAAAAAAAAAAAAAAAAAAAAAAAAAAAAAAAAAAAAAAAAAAAAAAAAAAAAAAAAAAAAAAAAAAAAAAAAAAAAAAAAAAAAAAAAAAAAAAAAAAAAAAAAAAAAAAAAAAAFAAAADwAAAAAAAAAAAAAAAAAAAkUAAAAAQAAABQAAAAUAAAAFAAAAAEAAAAAAAAAZAAAAGQAAAAAAAAAZAAAAGQAAAAVAAAAYAAAAAAAAAAAAAAADwAAACADAAAAAAAAAAAAAAEAAACgMgAAVgcAAKr4//8BAAAAf39/AAEAAABkAAAAAAAAABQAAABAHwAAAAAAACYAAAAAAAAAwOD//wAAAAAmAAAAZAAAABYAAABMAAAAAAAAAAAAAAAEAAAAAAAAAAEAAACAgIAKAAAAACgAAAAoAAAAZAAAAGQAAAAAAAAAzMzMAAAAAABQAAAAUAAAAGQAAABkAAAAAAAAABcAAAAUAAAAAAAAAAAAAAD/fwAA/38AAAAAAAAJAAAABAAAAAAAAAAeAAAAaAAAAAAAAAAAAAAAAAAAAAAAAAAAAAAAECcAABAnAAAAAAAAAAAAAAAAAAAAAAAAAAAAAAAAAAAAAAAAAAAAABQAAAAAAAAAwMD/AAAAAABkAAAAMgAAAAAAAABkAAAAAAAAAH9/fwAKAAAAIgAAABgAAAAAAAAAAAAAAAAAAAAAAAAAAAAAAAAAAAAkAAAAJAAAAAAAAAAHAAAAAAAAAAAAAAAAAAAAAAAAAAAAAAAAAAAAf39/ACUAAABYAAAAAAAAAAAAAAAAAAAAAAAAAAAAAAAAAAAAAAAAAAAAAAAAAAAAAAAAAAAAAAA/AAAAAAAAAKCGAQAAAAAAAAAAAAAAAAAMAAAAAQAAAAAAAAAAAAAAAAAAAB8AAABUAAAAAAAABQAAAAEAAAAAAAAAAAAAAAAAAAAAAAAAAAAAAAAAAAAAAAAAAAAAAAJ/f38AAAAAA8zMzADAwP8Af39/AAAAAAAAAAAAAAAAAAAAAAAAAAAAIQAAABgAAAAUAAAAoRkAABsnAABfMQAAWSkAABAAAAAmAAAACAAAAAAAAAAAAAAA"/>
               </a:ext>
             </a:extLst>
           </p:cNvSpPr>
@@ -2150,9 +2134,6 @@
           <a:lstStyle/>
           <a:p>
             <a:pPr/>
-            <a:r>
-              <a:t/>
-            </a:r>
           </a:p>
         </p:txBody>
       </p:sp>
@@ -2163,7 +2144,7 @@
             <a:spLocks noGrp="1" noChangeArrowheads="1"/>
             <a:extLst>
               <a:ext uri="smNativeData">
-                <pr:smNativeData xmlns:pr="smNativeData" xmlns="smNativeData" val="SMDATA_15_AnHWaRMAAAAlAAAAZAAAAA8BAAAAkAAAAEgAAACQAAAASAAAAAAAAAABAAAAAAAAAAEAAABQAAAAAAAAAAAA4D8AAAAAAADgPwAAAAAAAOA/AAAAAAAA4D8AAAAAAADgPwAAAAAAAOA/AAAAAAAA4D8AAAAAAADgPwAAAAAAAOA/AAAAAAAA4D8CAAAAjAAAAAAAAAAAAAAAu+DjDP///wgAAAAAAAAAAAAAAAAAAAAAAAAAAAAAAAAAAAAAZAAAAAEAAABAAAAAAAAAAAAAAAAAAAAAAAAAAAAAAAAAAAAAAAAAAAAAAAAAAAAAAAAAAAAAAAAAAAAAAAAAAAAAAAAAAAAAAAAAAAAAAAAAAAAAAAAAAAAAAAAAAAAAFAAAADwAAAAAAAAAAAAAAAAAAAkUAAAAAQAAABQAAAAUAAAAFAAAAAEAAAAAAAAAZAAAAGQAAAAAAAAAZAAAAGQAAAAVAAAAYAAAAAAAAAAAAAAADwAAACADAAAAAAAAAAAAAAEAAACgMgAAVgcAAKr4//8BAAAAf39/AAEAAABkAAAAAAAAABQAAABAHwAAAAAAACYAAAAAAAAAwOD//wAAAAAmAAAAZAAAABYAAABMAAAAAAAAAAAAAAAEAAAAAAAAAAEAAACAgIAKAAAAACgAAAAoAAAAZAAAAGQAAAAAAAAAzMzMAAAAAABQAAAAUAAAAGQAAABkAAAAAAAAABcAAAAUAAAAAAAAAAAAAAD/fwAA/38AAAAAAAAJAAAABAAAAAAAAAAeAAAAaAAAAAAAAAAAAAAAAAAAAAAAAAAAAAAAECcAABAnAAAAAAAAAAAAAAAAAAAAAAAAAAAAAAAAAAAAAAAAAAAAABQAAAAAAAAAwMD/AAAAAABkAAAAMgAAAAAAAABkAAAAAAAAAH9/fwAKAAAAIgAAABgAAAAAAAAAAAAAAAAAAAAAAAAAAAAAAAAAAAAkAAAAJAAAAAAAAAAHAAAAAAAAAAAAAAAAAAAAAAAAAAAAAAAAAAAAf39/ACUAAABYAAAAAAAAAAAAAAAAAAAAAAAAAAAAAAAAAAAAAAAAAAAAAAAAAAAAAAAAAAAAAAA/AAAAAAAAAKCGAQAAAAAAAAAAAAAAAAAMAAAAAQAAAAAAAAAAAAAAAAAAAB8AAABUAAAAAAAABQAAAAEAAAAAAAAAAAAAAAAAAAAAAAAAAAAAAAAAAAAAAAAAAAAAAAJ/f38AAAAAA8zMzADAwP8Af39/AAAAAAAAAAAAAAAAAAAAAAAAAAAAIQAAABgAAAAUAAAAwTUAABsnAABARwAAWSkAABAAAAAmAAAACAAAAAAAAAAAAAAA"/>
+                <pr:smNativeData xmlns:pr="smNativeData" xmlns="smNativeData" val="SMDATA_15_7aDWaRMAAAAlAAAAZAAAAA8BAAAAkAAAAEgAAACQAAAASAAAAAAAAAABAAAAAAAAAAEAAABQAAAAAAAAAAAA4D8AAAAAAADgPwAAAAAAAOA/AAAAAAAA4D8AAAAAAADgPwAAAAAAAOA/AAAAAAAA4D8AAAAAAADgPwAAAAAAAOA/AAAAAAAA4D8CAAAAjAAAAAAAAAAAAAAAu+DjDP///wgAAAAAAAAAAAAAAAAAAAAAAAAAAAAAAAAAAAAAZAAAAAEAAABAAAAAAAAAAAAAAAAAAAAAAAAAAAAAAAAAAAAAAAAAAAAAAAAAAAAAAAAAAAAAAAAAAAAAAAAAAAAAAAAAAAAAAAAAAAAAAAAAAAAAAAAAAAAAAAAAAAAAFAAAADwAAAAAAAAAAAAAAAAAAAkUAAAAAQAAABQAAAAUAAAAFAAAAAEAAAAAAAAAZAAAAGQAAAAAAAAAZAAAAGQAAAAVAAAAYAAAAAAAAAAAAAAADwAAACADAAAAAAAAAAAAAAEAAACgMgAAVgcAAKr4//8BAAAAf39/AAEAAABkAAAAAAAAABQAAABAHwAAAAAAACYAAAAAAAAAwOD//wAAAAAmAAAAZAAAABYAAABMAAAAAAAAAAAAAAAEAAAAAAAAAAEAAACAgIAKAAAAACgAAAAoAAAAZAAAAGQAAAAAAAAAzMzMAAAAAABQAAAAUAAAAGQAAABkAAAAAAAAABcAAAAUAAAAAAAAAAAAAAD/fwAA/38AAAAAAAAJAAAABAAAAAAAAAAeAAAAaAAAAAAAAAAAAAAAAAAAAAAAAAAAAAAAECcAABAnAAAAAAAAAAAAAAAAAAAAAAAAAAAAAAAAAAAAAAAAAAAAABQAAAAAAAAAwMD/AAAAAABkAAAAMgAAAAAAAABkAAAAAAAAAH9/fwAKAAAAIgAAABgAAAAAAAAAAAAAAAAAAAAAAAAAAAAAAAAAAAAkAAAAJAAAAAAAAAAHAAAAAAAAAAAAAAAAAAAAAAAAAAAAAAAAAAAAf39/ACUAAABYAAAAAAAAAAAAAAAAAAAAAAAAAAAAAAAAAAAAAAAAAAAAAAAAAAAAAAAAAAAAAAA/AAAAAAAAAKCGAQAAAAAAAAAAAAAAAAAMAAAAAQAAAAAAAAAAAAAAAAAAAB8AAABUAAAAAAAABQAAAAEAAAAAAAAAAAAAAAAAAAAAAAAAAAAAAAAAAAAAAAAAAAAAAAJ/f38AAAAAA8zMzADAwP8Af39/AAAAAAAAAAAAAAAAAAAAAAAAAAAAIQAAABgAAAAUAAAAwTUAABsnAABARwAAWSkAABAAAAAmAAAACAAAAAAAAAAAAAAA"/>
               </a:ext>
             </a:extLst>
           </p:cNvSpPr>
@@ -2177,7 +2158,7 @@
           <a:lstStyle/>
           <a:p>
             <a:pPr/>
-            <a:fld id="{43A18BC0-8EAE-F47D-E019-7828C557162D}" type="slidenum">
+            <a:fld id="{528B5113-5DBF-DEA7-F133-ABF21F7D07FE}" type="slidenum">
               <a:t/>
             </a:fld>
           </a:p>
@@ -2188,6 +2169,7 @@
   <p:clrMapOvr>
     <a:masterClrMapping/>
   </p:clrMapOvr>
+  <p:hf hdr="0" ftr="0"/>
 </p:sldLayout>
 </file>
 
@@ -2215,7 +2197,7 @@
             <a:spLocks noGrp="1" noChangeArrowheads="1"/>
             <a:extLst>
               <a:ext uri="smNativeData">
-                <pr:smNativeData xmlns:pr="smNativeData" xmlns="smNativeData" val="SMDATA_15_AnHWaRMAAAAlAAAAZAAAAA8BAAAAkAAAAEgAAACQAAAASAAAAAAAAAACAAAAAAAAAAEAAABQAAAAAAAAAAAA4D8AAAAAAADgPwAAAAAAAOA/AAAAAAAA4D8AAAAAAADgPwAAAAAAAOA/AAAAAAAA4D8AAAAAAADgPwAAAAAAAOA/AAAAAAAA4D8CAAAAjAAAAAAAAAAAAAAAu+DjDP///wgAAAAAAAAAAAAAAAAAAAAAAAAAAAAAAAAAAAAAZAAAAAEAAABAAAAAAAAAAAAAAAAAAAAAAAAAAAAAAAAAAAAAAAAAAAAAAAAAAAAAAAAAAAAAAAAAAAAAAAAAAAAAAAAAAAAAAAAAAAAAAAAAAAAAAAAAAAAAAAAAAAAAFAAAADwAAAAAAAAAAAAAAAAAAAkUAAAAAQAAABQAAAAUAAAAFAAAAAEAAAAAAAAAZAAAAGQAAAAAAAAAZAAAAGQAAAAVAAAAYAAAAAAAAAAAAAAADwAAACADAAAAAAAAAAAAAAEAAACgMgAAVgcAAKr4//8BAAAAf39/AAEAAABkAAAAAAAAABQAAABAHwAAAAAAACYAAAAAAAAAwOD//wAAAAAmAAAAZAAAABYAAABMAAAAAAAAAAAAAAAEAAAAAAAAAAEAAACAgIAKAAAAACgAAAAoAAAAZAAAAGQAAAAAAAAAzMzMAAAAAABQAAAAUAAAAGQAAABkAAAAAAAAABcAAAAUAAAAAAAAAAAAAAD/fwAA/38AAAAAAAAJAAAABAAAAAAAAAAeAAAAaAAAAAAAAAAAAAAAAAAAAAAAAAAAAAAAECcAABAnAAAAAAAAAAAAAAAAAAAAAAAAAAAAAAAAAAAAAAAAAAAAABQAAAAAAAAAwMD/AAAAAABkAAAAMgAAAAAAAABkAAAAAAAAAH9/fwAKAAAAIgAAABgAAAAAAAAAAAAAAAAAAAAAAAAAAAAAAAAAAAAkAAAAJAAAAAAAAAAHAAAAAAAAAAAAAAAAAAAAAAAAAAAAAAAAAAAAf39/ACUAAABYAAAAAAAAAAAAAAAAAAAAAAAAAAAAAAAAAAAAAAAAAAAAAAAAAAAAAAAAAAAAAAA/AAAAAAAAAKCGAQAAAAAAAAAAAAAAAAAMAAAAAQAAAAAAAAAAAAAAAAAAAB8AAABUAAAAAAAABQAAAAEAAAAAAAAAAAAAAAAAAAAAAAAAAAAAAAAAAAAAAAAAAAAAAAJ/f38AAAAAA8zMzADAwP8Af39/AAAAAAAAAAAAAAAAAAAAAAAAAAAAIQAAABgAAAAUAAAAwAMAAK4BAABtHAAA1AgAABAAAAAmAAAACAAAAIGAAAAAAAAA"/>
+                <pr:smNativeData xmlns:pr="smNativeData" xmlns="smNativeData" val="SMDATA_15_7aDWaRMAAAAlAAAAZAAAAA8BAAAAkAAAAEgAAACQAAAASAAAAAAAAAACAAAAAAAAAAEAAABQAAAAAAAAAAAA4D8AAAAAAADgPwAAAAAAAOA/AAAAAAAA4D8AAAAAAADgPwAAAAAAAOA/AAAAAAAA4D8AAAAAAADgPwAAAAAAAOA/AAAAAAAA4D8CAAAAjAAAAAAAAAAAAAAAu+DjDP///wgAAAAAAAAAAAAAAAAAAAAAAAAAAAAAAAAAAAAAZAAAAAEAAABAAAAAAAAAAAAAAAAAAAAAAAAAAAAAAAAAAAAAAAAAAAAAAAAAAAAAAAAAAAAAAAAAAAAAAAAAAAAAAAAAAAAAAAAAAAAAAAAAAAAAAAAAAAAAAAAAAAAAFAAAADwAAAAAAAAAAAAAAAAAAAkUAAAAAQAAABQAAAAUAAAAFAAAAAEAAAAAAAAAZAAAAGQAAAAAAAAAZAAAAGQAAAAVAAAAYAAAAAAAAAAAAAAADwAAACADAAAAAAAAAAAAAAEAAACgMgAAVgcAAKr4//8BAAAAf39/AAEAAABkAAAAAAAAABQAAABAHwAAAAAAACYAAAAAAAAAwOD//wAAAAAmAAAAZAAAABYAAABMAAAAAAAAAAAAAAAEAAAAAAAAAAEAAACAgIAKAAAAACgAAAAoAAAAZAAAAGQAAAAAAAAAzMzMAAAAAABQAAAAUAAAAGQAAABkAAAAAAAAABcAAAAUAAAAAAAAAAAAAAD/fwAA/38AAAAAAAAJAAAABAAAAAAAAAAeAAAAaAAAAAAAAAAAAAAAAAAAAAAAAAAAAAAAECcAABAnAAAAAAAAAAAAAAAAAAAAAAAAAAAAAAAAAAAAAAAAAAAAABQAAAAAAAAAwMD/AAAAAABkAAAAMgAAAAAAAABkAAAAAAAAAH9/fwAKAAAAIgAAABgAAAAAAAAAAAAAAAAAAAAAAAAAAAAAAAAAAAAkAAAAJAAAAAAAAAAHAAAAAAAAAAAAAAAAAAAAAAAAAAAAAAAAAAAAf39/ACUAAABYAAAAAAAAAAAAAAAAAAAAAAAAAAAAAAAAAAAAAAAAAAAAAAAAAAAAAAAAAAAAAAA/AAAAAAAAAKCGAQAAAAAAAAAAAAAAAAAMAAAAAQAAAAAAAAAAAAAAAAAAAB8AAABUAAAAAAAABQAAAAEAAAAAAAAAAAAAAAAAAAAAAAAAAAAAAAAAAAAAAAAAAAAAAAJ/f38AAAAAA8zMzADAwP8Af39/AAAAAAAAAAAAAAAAAAAAAAAAAAAAIQAAABgAAAAUAAAAwAMAAK4BAABtHAAA1AgAABAAAAAmAAAACAAAAIGAAAAAAAAA"/>
               </a:ext>
             </a:extLst>
           </p:cNvSpPr>
@@ -2255,7 +2237,7 @@
             <a:spLocks noGrp="1" noChangeArrowheads="1"/>
             <a:extLst>
               <a:ext uri="smNativeData">
-                <pr:smNativeData xmlns:pr="smNativeData" xmlns="smNativeData" val="SMDATA_15_AnHWaRMAAAAlAAAAZAAAAA8BAAAAkAAAAEgAAACQAAAASAAAAAAAAAAAAAAAAAAAAAEAAABQAAAAAAAAAAAA4D8AAAAAAADgPwAAAAAAAOA/AAAAAAAA4D8AAAAAAADgPwAAAAAAAOA/AAAAAAAA4D8AAAAAAADgPwAAAAAAAOA/AAAAAAAA4D8CAAAAjAAAAAAAAAAAAAAAu+DjDP///wgAAAAAAAAAAAAAAAAAAAAAAAAAAAAAAAAAAAAAZAAAAAEAAABAAAAAAAAAAAAAAAAAAAAAAAAAAAAAAAAAAAAAAAAAAAAAAAAAAAAAAAAAAAAAAAAAAAAAAAAAAAAAAAAAAAAAAAAAAAAAAAAAAAAAAAAAAAAAAAAAAAAAFAAAADwAAAAAAAAAAAAAAAAAAAkUAAAAAQAAABQAAAAUAAAAFAAAAAEAAAAAAAAAZAAAAGQAAAAAAAAAZAAAAGQAAAAVAAAAYAAAAAAAAAAAAAAADwAAACADAAAAAAAAAAAAAAEAAACgMgAAVgcAAKr4//8BAAAAf39/AAEAAABkAAAAAAAAABQAAABAHwAAAAAAACYAAAAAAAAAwOD//wAAAAAmAAAAZAAAABYAAABMAAAAAAAAAAAAAAAEAAAAAAAAAAEAAACAgIAKAAAAACgAAAAoAAAAZAAAAGQAAAAAAAAAzMzMAAAAAABQAAAAUAAAAGQAAABkAAAAAAAAABcAAAAUAAAAAAAAAAAAAAD/fwAA/38AAAAAAAAJAAAABAAAAAAAAAAeAAAAaAAAAAAAAAAAAAAAAAAAAAAAAAAAAAAAECcAABAnAAAAAAAAAAAAAAAAAAAAAAAAAAAAAAAAAAAAAAAAAAAAABQAAAAAAAAAwMD/AAAAAABkAAAAMgAAAAAAAABkAAAAAAAAAH9/fwAKAAAAIgAAABgAAAAAAAAAAAAAAAAAAAAAAAAAAAAAAAAAAAAkAAAAJAAAAAAAAAAHAAAAAAAAAAAAAAAAAAAAAAAAAAAAAAAAAAAAf39/ACUAAABYAAAAAAAAAAAAAAAAAAAAAAAAAAAAAAAAAAAAAAAAAAAAAAAAAAAAAAAAAAAAAAA/AAAAAAAAAKCGAQAAAAAAAAAAAAAAAAAMAAAAAQAAAAAAAAAAAAAAAAAAAB8AAABUAAAAAAAABQAAAAEAAAAAAAAAAAAAAAAAAAAAAAAAAAAAAAAAAAAAAAAAAAAAAAJ/f38AAAAAA8zMzADAwP8Af39/AAAAAAAAAAAAAAAAAAAAAAAAAAAAIQAAABgAAAAUAAAAUx0AAK4BAABARwAAsCUAABAAAAAmAAAACAAAAAGAAAAAAAAA"/>
+                <pr:smNativeData xmlns:pr="smNativeData" xmlns="smNativeData" val="SMDATA_15_7aDWaRMAAAAlAAAAZAAAAA8BAAAAkAAAAEgAAACQAAAASAAAAAAAAAAAAAAAAAAAAAEAAABQAAAAAAAAAAAA4D8AAAAAAADgPwAAAAAAAOA/AAAAAAAA4D8AAAAAAADgPwAAAAAAAOA/AAAAAAAA4D8AAAAAAADgPwAAAAAAAOA/AAAAAAAA4D8CAAAAjAAAAAAAAAAAAAAAu+DjDP///wgAAAAAAAAAAAAAAAAAAAAAAAAAAAAAAAAAAAAAZAAAAAEAAABAAAAAAAAAAAAAAAAAAAAAAAAAAAAAAAAAAAAAAAAAAAAAAAAAAAAAAAAAAAAAAAAAAAAAAAAAAAAAAAAAAAAAAAAAAAAAAAAAAAAAAAAAAAAAAAAAAAAAFAAAADwAAAAAAAAAAAAAAAAAAAkUAAAAAQAAABQAAAAUAAAAFAAAAAEAAAAAAAAAZAAAAGQAAAAAAAAAZAAAAGQAAAAVAAAAYAAAAAAAAAAAAAAADwAAACADAAAAAAAAAAAAAAEAAACgMgAAVgcAAKr4//8BAAAAf39/AAEAAABkAAAAAAAAABQAAABAHwAAAAAAACYAAAAAAAAAwOD//wAAAAAmAAAAZAAAABYAAABMAAAAAAAAAAAAAAAEAAAAAAAAAAEAAACAgIAKAAAAACgAAAAoAAAAZAAAAGQAAAAAAAAAzMzMAAAAAABQAAAAUAAAAGQAAABkAAAAAAAAABcAAAAUAAAAAAAAAAAAAAD/fwAA/38AAAAAAAAJAAAABAAAAAAAAAAeAAAAaAAAAAAAAAAAAAAAAAAAAAAAAAAAAAAAECcAABAnAAAAAAAAAAAAAAAAAAAAAAAAAAAAAAAAAAAAAAAAAAAAABQAAAAAAAAAwMD/AAAAAABkAAAAMgAAAAAAAABkAAAAAAAAAH9/fwAKAAAAIgAAABgAAAAAAAAAAAAAAAAAAAAAAAAAAAAAAAAAAAAkAAAAJAAAAAAAAAAHAAAAAAAAAAAAAAAAAAAAAAAAAAAAAAAAAAAAf39/ACUAAABYAAAAAAAAAAAAAAAAAAAAAAAAAAAAAAAAAAAAAAAAAAAAAAAAAAAAAAAAAAAAAAA/AAAAAAAAAKCGAQAAAAAAAAAAAAAAAAAMAAAAAQAAAAAAAAAAAAAAAAAAAB8AAABUAAAAAAAABQAAAAEAAAAAAAAAAAAAAAAAAAAAAAAAAAAAAAAAAAAAAAAAAAAAAAJ/f38AAAAAA8zMzADAwP8Af39/AAAAAAAAAAAAAAAAAAAAAAAAAAAAIQAAABgAAAAUAAAAUx0AAK4BAABARwAAsCUAABAAAAAmAAAACAAAAAGAAAAAAAAA"/>
               </a:ext>
             </a:extLst>
           </p:cNvSpPr>
@@ -2339,7 +2321,7 @@
             <a:spLocks noGrp="1" noChangeArrowheads="1"/>
             <a:extLst>
               <a:ext uri="smNativeData">
-                <pr:smNativeData xmlns:pr="smNativeData" xmlns="smNativeData" val="SMDATA_15_AnHWaRMAAAAlAAAAZAAAAA8BAAAAkAAAAEgAAACQAAAASAAAAAAAAAAAAAAAAAAAAAEAAABQAAAAAAAAAAAA4D8AAAAAAADgPwAAAAAAAOA/AAAAAAAA4D8AAAAAAADgPwAAAAAAAOA/AAAAAAAA4D8AAAAAAADgPwAAAAAAAOA/AAAAAAAA4D8CAAAAjAAAAAAAAAAAAAAAu+DjDP///wgAAAAAAAAAAAAAAAAAAAAAAAAAAAAAAAAAAAAAZAAAAAEAAABAAAAAAAAAAAAAAAAAAAAAAAAAAAAAAAAAAAAAAAAAAAAAAAAAAAAAAAAAAAAAAAAAAAAAAAAAAAAAAAAAAAAAAAAAAAAAAAAAAAAAAAAAAAAAAAAAAAAAFAAAADwAAAAAAAAAAAAAAAAAAAkUAAAAAQAAABQAAAAUAAAAFAAAAAEAAAAAAAAAZAAAAGQAAAAAAAAAZAAAAGQAAAAVAAAAYAAAAAAAAAAAAAAADwAAACADAAAAAAAAAAAAAAEAAACgMgAAVgcAAKr4//8BAAAAf39/AAEAAABkAAAAAAAAABQAAABAHwAAAAAAACYAAAAAAAAAwOD//wAAAAAmAAAAZAAAABYAAABMAAAAAAAAAAAAAAAEAAAAAAAAAAEAAACAgIAKAAAAACgAAAAoAAAAZAAAAGQAAAAAAAAAzMzMAAAAAABQAAAAUAAAAGQAAABkAAAAAAAAABcAAAAUAAAAAAAAAAAAAAD/fwAA/38AAAAAAAAJAAAABAAAAAAAAAAeAAAAaAAAAAAAAAAAAAAAAAAAAAAAAAAAAAAAECcAABAnAAAAAAAAAAAAAAAAAAAAAAAAAAAAAAAAAAAAAAAAAAAAABQAAAAAAAAAwMD/AAAAAABkAAAAMgAAAAAAAABkAAAAAAAAAH9/fwAKAAAAIgAAABgAAAAAAAAAAAAAAAAAAAAAAAAAAAAAAAAAAAAkAAAAJAAAAAAAAAAHAAAAAAAAAAAAAAAAAAAAAAAAAAAAAAAAAAAAf39/ACUAAABYAAAAAAAAAAAAAAAAAAAAAAAAAAAAAAAAAAAAAAAAAAAAAAAAAAAAAAAAAAAAAAA/AAAAAAAAAKCGAQAAAAAAAAAAAAAAAAAMAAAAAQAAAAAAAAAAAAAAAAAAAB8AAABUAAAAAAAABQAAAAEAAAAAAAAAAAAAAAAAAAAAAAAAAAAAAAAAAAAAAAAAAAAAAAJ/f38AAAAAA8zMzADAwP8Af39/AAAAAAAAAAAAAAAAAAAAAAAAAAAAIQAAABgAAAAUAAAAwAMAANQIAABtHAAAsCUAABAAAAAmAAAACAAAAAGAAAAAAAAA"/>
+                <pr:smNativeData xmlns:pr="smNativeData" xmlns="smNativeData" val="SMDATA_15_7aDWaRMAAAAlAAAAZAAAAA8BAAAAkAAAAEgAAACQAAAASAAAAAAAAAAAAAAAAAAAAAEAAABQAAAAAAAAAAAA4D8AAAAAAADgPwAAAAAAAOA/AAAAAAAA4D8AAAAAAADgPwAAAAAAAOA/AAAAAAAA4D8AAAAAAADgPwAAAAAAAOA/AAAAAAAA4D8CAAAAjAAAAAAAAAAAAAAAu+DjDP///wgAAAAAAAAAAAAAAAAAAAAAAAAAAAAAAAAAAAAAZAAAAAEAAABAAAAAAAAAAAAAAAAAAAAAAAAAAAAAAAAAAAAAAAAAAAAAAAAAAAAAAAAAAAAAAAAAAAAAAAAAAAAAAAAAAAAAAAAAAAAAAAAAAAAAAAAAAAAAAAAAAAAAFAAAADwAAAAAAAAAAAAAAAAAAAkUAAAAAQAAABQAAAAUAAAAFAAAAAEAAAAAAAAAZAAAAGQAAAAAAAAAZAAAAGQAAAAVAAAAYAAAAAAAAAAAAAAADwAAACADAAAAAAAAAAAAAAEAAACgMgAAVgcAAKr4//8BAAAAf39/AAEAAABkAAAAAAAAABQAAABAHwAAAAAAACYAAAAAAAAAwOD//wAAAAAmAAAAZAAAABYAAABMAAAAAAAAAAAAAAAEAAAAAAAAAAEAAACAgIAKAAAAACgAAAAoAAAAZAAAAGQAAAAAAAAAzMzMAAAAAABQAAAAUAAAAGQAAABkAAAAAAAAABcAAAAUAAAAAAAAAAAAAAD/fwAA/38AAAAAAAAJAAAABAAAAAAAAAAeAAAAaAAAAAAAAAAAAAAAAAAAAAAAAAAAAAAAECcAABAnAAAAAAAAAAAAAAAAAAAAAAAAAAAAAAAAAAAAAAAAAAAAABQAAAAAAAAAwMD/AAAAAABkAAAAMgAAAAAAAABkAAAAAAAAAH9/fwAKAAAAIgAAABgAAAAAAAAAAAAAAAAAAAAAAAAAAAAAAAAAAAAkAAAAJAAAAAAAAAAHAAAAAAAAAAAAAAAAAAAAAAAAAAAAAAAAAAAAf39/ACUAAABYAAAAAAAAAAAAAAAAAAAAAAAAAAAAAAAAAAAAAAAAAAAAAAAAAAAAAAAAAAAAAAA/AAAAAAAAAKCGAQAAAAAAAAAAAAAAAAAMAAAAAQAAAAAAAAAAAAAAAAAAAB8AAABUAAAAAAAABQAAAAEAAAAAAAAAAAAAAAAAAAAAAAAAAAAAAAAAAAAAAAAAAAAAAAJ/f38AAAAAA8zMzADAwP8Af39/AAAAAAAAAAAAAAAAAAAAAAAAAAAAIQAAABgAAAAUAAAAwAMAANQIAABtHAAAsCUAABAAAAAmAAAACAAAAAGAAAAAAAAA"/>
               </a:ext>
             </a:extLst>
           </p:cNvSpPr>
@@ -2408,7 +2390,7 @@
             <a:spLocks noGrp="1" noChangeArrowheads="1"/>
             <a:extLst>
               <a:ext uri="smNativeData">
-                <pr:smNativeData xmlns:pr="smNativeData" xmlns="smNativeData" val="SMDATA_15_AnHWaRMAAAAlAAAAZAAAAA8BAAAAkAAAAEgAAACQAAAASAAAAAAAAAABAAAAAAAAAAEAAABQAAAAAAAAAAAA4D8AAAAAAADgPwAAAAAAAOA/AAAAAAAA4D8AAAAAAADgPwAAAAAAAOA/AAAAAAAA4D8AAAAAAADgPwAAAAAAAOA/AAAAAAAA4D8CAAAAjAAAAAAAAAAAAAAAu+DjDP///wgAAAAAAAAAAAAAAAAAAAAAAAAAAAAAAAAAAAAAZAAAAAEAAABAAAAAAAAAAAAAAAAAAAAAAAAAAAAAAAAAAAAAAAAAAAAAAAAAAAAAAAAAAAAAAAAAAAAAAAAAAAAAAAAAAAAAAAAAAAAAAAAAAAAAAAAAAAAAAAAAAAAAFAAAADwAAAAAAAAAAAAAAAAAAAkUAAAAAQAAABQAAAAUAAAAFAAAAAEAAAAAAAAAZAAAAGQAAAAAAAAAZAAAAGQAAAAVAAAAYAAAAAAAAAAAAAAADwAAACADAAAAAAAAAAAAAAEAAACgMgAAVgcAAKr4//8BAAAAf39/AAEAAABkAAAAAAAAABQAAABAHwAAAAAAACYAAAAAAAAAwOD//wAAAAAmAAAAZAAAABYAAABMAAAAAAAAAAAAAAAEAAAAAAAAAAEAAACAgIAKAAAAACgAAAAoAAAAZAAAAGQAAAAAAAAAzMzMAAAAAABQAAAAUAAAAGQAAABkAAAAAAAAABcAAAAUAAAAAAAAAAAAAAD/fwAA/38AAAAAAAAJAAAABAAAAAAAAAAeAAAAaAAAAAAAAAAAAAAAAAAAAAAAAAAAAAAAECcAABAnAAAAAAAAAAAAAAAAAAAAAAAAAAAAAAAAAAAAAAAAAAAAABQAAAAAAAAAwMD/AAAAAABkAAAAMgAAAAAAAABkAAAAAAAAAH9/fwAKAAAAIgAAABgAAAAAAAAAAAAAAAAAAAAAAAAAAAAAAAAAAAAkAAAAJAAAAAAAAAAHAAAAAAAAAAAAAAAAAAAAAAAAAAAAAAAAAAAAf39/ACUAAABYAAAAAAAAAAAAAAAAAAAAAAAAAAAAAAAAAAAAAAAAAAAAAAAAAAAAAAAAAAAAAAA/AAAAAAAAAKCGAQAAAAAAAAAAAAAAAAAMAAAAAQAAAAAAAAAAAAAAAAAAAB8AAABUAAAAAAAABQAAAAEAAAAAAAAAAAAAAAAAAAAAAAAAAAAAAAAAAAAAAAAAAAAAAAJ/f38AAAAAA8zMzADAwP8Af39/AAAAAAAAAAAAAAAAAAAAAAAAAAAAIQAAABgAAAAUAAAAwAMAABsnAAA/FQAAWSkAABAAAAAmAAAACAAAAAAAAAAAAAAA"/>
+                <pr:smNativeData xmlns:pr="smNativeData" xmlns="smNativeData" val="SMDATA_15_7aDWaRMAAAAlAAAAZAAAAA8BAAAAkAAAAEgAAACQAAAASAAAAAAAAAABAAAAAAAAAAEAAABQAAAAAAAAAAAA4D8AAAAAAADgPwAAAAAAAOA/AAAAAAAA4D8AAAAAAADgPwAAAAAAAOA/AAAAAAAA4D8AAAAAAADgPwAAAAAAAOA/AAAAAAAA4D8CAAAAjAAAAAAAAAAAAAAAu+DjDP///wgAAAAAAAAAAAAAAAAAAAAAAAAAAAAAAAAAAAAAZAAAAAEAAABAAAAAAAAAAAAAAAAAAAAAAAAAAAAAAAAAAAAAAAAAAAAAAAAAAAAAAAAAAAAAAAAAAAAAAAAAAAAAAAAAAAAAAAAAAAAAAAAAAAAAAAAAAAAAAAAAAAAAFAAAADwAAAAAAAAAAAAAAAAAAAkUAAAAAQAAABQAAAAUAAAAFAAAAAEAAAAAAAAAZAAAAGQAAAAAAAAAZAAAAGQAAAAVAAAAYAAAAAAAAAAAAAAADwAAACADAAAAAAAAAAAAAAEAAACgMgAAVgcAAKr4//8BAAAAf39/AAEAAABkAAAAAAAAABQAAABAHwAAAAAAACYAAAAAAAAAwOD//wAAAAAmAAAAZAAAABYAAABMAAAAAAAAAAAAAAAEAAAAAAAAAAEAAACAgIAKAAAAACgAAAAoAAAAZAAAAGQAAAAAAAAAzMzMAAAAAABQAAAAUAAAAGQAAABkAAAAAAAAABcAAAAUAAAAAAAAAAAAAAD/fwAA/38AAAAAAAAJAAAABAAAAAAAAAAeAAAAaAAAAAAAAAAAAAAAAAAAAAAAAAAAAAAAECcAABAnAAAAAAAAAAAAAAAAAAAAAAAAAAAAAAAAAAAAAAAAAAAAABQAAAAAAAAAwMD/AAAAAABkAAAAMgAAAAAAAABkAAAAAAAAAH9/fwAKAAAAIgAAABgAAAAAAAAAAAAAAAAAAAAAAAAAAAAAAAAAAAAkAAAAJAAAAAAAAAAHAAAAAAAAAAAAAAAAAAAAAAAAAAAAAAAAAAAAf39/ACUAAABYAAAAAAAAAAAAAAAAAAAAAAAAAAAAAAAAAAAAAAAAAAAAAAAAAAAAAAAAAAAAAAA/AAAAAAAAAKCGAQAAAAAAAAAAAAAAAAAMAAAAAQAAAAAAAAAAAAAAAAAAAB8AAABUAAAAAAAABQAAAAEAAAAAAAAAAAAAAAAAAAAAAAAAAAAAAAAAAAAAAAAAAAAAAAJ/f38AAAAAA8zMzADAwP8Af39/AAAAAAAAAAAAAAAAAAAAAAAAAAAAIQAAABgAAAAUAAAAwAMAABsnAAA/FQAAWSkAABAAAAAmAAAACAAAAAAAAAAAAAAA"/>
               </a:ext>
             </a:extLst>
           </p:cNvSpPr>
@@ -2422,7 +2404,7 @@
           <a:lstStyle/>
           <a:p>
             <a:pPr/>
-            <a:fld id="{674C3A1E-508A-19CC-C4F4-A69974BA32F3}" type="datetime1">
+            <a:fld id="{21C0AF25-6BCC-9559-8278-9D0CE13674C8}" type="datetime1">
               <a:t/>
             </a:fld>
           </a:p>
@@ -2435,7 +2417,7 @@
             <a:spLocks noGrp="1" noChangeArrowheads="1"/>
             <a:extLst>
               <a:ext uri="smNativeData">
-                <pr:smNativeData xmlns:pr="smNativeData" xmlns="smNativeData" val="SMDATA_15_AnHWaRMAAAAlAAAAZAAAAA8BAAAAkAAAAEgAAACQAAAASAAAAAAAAAABAAAAAAAAAAEAAABQAAAAAAAAAAAA4D8AAAAAAADgPwAAAAAAAOA/AAAAAAAA4D8AAAAAAADgPwAAAAAAAOA/AAAAAAAA4D8AAAAAAADgPwAAAAAAAOA/AAAAAAAA4D8CAAAAjAAAAAAAAAAAAAAAu+DjDP///wgAAAAAAAAAAAAAAAAAAAAAAAAAAAAAAAAAAAAAZAAAAAEAAABAAAAAAAAAAAAAAAAAAAAAAAAAAAAAAAAAAAAAAAAAAAAAAAAAAAAAAAAAAAAAAAAAAAAAAAAAAAAAAAAAAAAAAAAAAAAAAAAAAAAAAAAAAAAAAAAAAAAAFAAAADwAAAAAAAAAAAAAAAAAAAkUAAAAAQAAABQAAAAUAAAAFAAAAAEAAAAAAAAAZAAAAGQAAAAAAAAAZAAAAGQAAAAVAAAAYAAAAAAAAAAAAAAADwAAACADAAAAAAAAAAAAAAEAAACgMgAAVgcAAKr4//8BAAAAf39/AAEAAABkAAAAAAAAABQAAABAHwAAAAAAACYAAAAAAAAAwOD//wAAAAAmAAAAZAAAABYAAABMAAAAAAAAAAAAAAAEAAAAAAAAAAEAAACAgIAKAAAAACgAAAAoAAAAZAAAAGQAAAAAAAAAzMzMAAAAAABQAAAAUAAAAGQAAABkAAAAAAAAABcAAAAUAAAAAAAAAAAAAAD/fwAA/38AAAAAAAAJAAAABAAAAHNwY0IeAAAAaAAAAAAAAAAAAAAAAAAAAAAAAAAAAAAAECcAABAnAAAAAAAAAAAAAAAAAAAAAAAAAAAAAAAAAAAAAAAAAAAAABQAAAAAAAAAwMD/AAAAAABkAAAAMgAAAAAAAABkAAAAAAAAAH9/fwAKAAAAIgAAABgAAAAAAAAAAAAAAAAAAAAAAAAAAAAAAAAAAAAkAAAAJAAAAAAAAAAHAAAAAAAAAAAAAAAAAAAAAAAAAAAAAAAAAAAAf39/ACUAAABYAAAAAAAAAAAAAAAAAAAAAAAAAAAAAAAAAAAAAAAAAAAAAAAAAAAAAAAAAAAAAAA/AAAAAAAAAKCGAQAAAAAAAAAAAAAAAAAMAAAAAQAAAAAAAAAAAAAAAAAAAB8AAABUAAAAAAAABQAAAAEAAAAAAAAAAAAAAAAAAAAAAAAAAAAAAAAAAAAAAAAAAAAAAAJ/f38AAAAAA8zMzADAwP8Af39/AAAAAAAAAAAAAAAAAAAAAAAAAAAAIQAAABgAAAAUAAAAoRkAABsnAABfMQAAWSkAABAAAAAmAAAACAAAAAAAAAAAAAAA"/>
+                <pr:smNativeData xmlns:pr="smNativeData" xmlns="smNativeData" val="SMDATA_15_7aDWaRMAAAAlAAAAZAAAAA8BAAAAkAAAAEgAAACQAAAASAAAAAAAAAABAAAAAAAAAAEAAABQAAAAAAAAAAAA4D8AAAAAAADgPwAAAAAAAOA/AAAAAAAA4D8AAAAAAADgPwAAAAAAAOA/AAAAAAAA4D8AAAAAAADgPwAAAAAAAOA/AAAAAAAA4D8CAAAAjAAAAAAAAAAAAAAAu+DjDP///wgAAAAAAAAAAAAAAAAAAAAAAAAAAAAAAAAAAAAAZAAAAAEAAABAAAAAAAAAAAAAAAAAAAAAAAAAAAAAAAAAAAAAAAAAAAAAAAAAAAAAAAAAAAAAAAAAAAAAAAAAAAAAAAAAAAAAAAAAAAAAAAAAAAAAAAAAAAAAAAAAAAAAFAAAADwAAAAAAAAAAAAAAAAAAAkUAAAAAQAAABQAAAAUAAAAFAAAAAEAAAAAAAAAZAAAAGQAAAAAAAAAZAAAAGQAAAAVAAAAYAAAAAAAAAAAAAAADwAAACADAAAAAAAAAAAAAAEAAACgMgAAVgcAAKr4//8BAAAAf39/AAEAAABkAAAAAAAAABQAAABAHwAAAAAAACYAAAAAAAAAwOD//wAAAAAmAAAAZAAAABYAAABMAAAAAAAAAAAAAAAEAAAAAAAAAAEAAACAgIAKAAAAACgAAAAoAAAAZAAAAGQAAAAAAAAAzMzMAAAAAABQAAAAUAAAAGQAAABkAAAAAAAAABcAAAAUAAAAAAAAAAAAAAD/fwAA/38AAAAAAAAJAAAABAAAAHNwY0IeAAAAaAAAAAAAAAAAAAAAAAAAAAAAAAAAAAAAECcAABAnAAAAAAAAAAAAAAAAAAAAAAAAAAAAAAAAAAAAAAAAAAAAABQAAAAAAAAAwMD/AAAAAABkAAAAMgAAAAAAAABkAAAAAAAAAH9/fwAKAAAAIgAAABgAAAAAAAAAAAAAAAAAAAAAAAAAAAAAAAAAAAAkAAAAJAAAAAAAAAAHAAAAAAAAAAAAAAAAAAAAAAAAAAAAAAAAAAAAf39/ACUAAABYAAAAAAAAAAAAAAAAAAAAAAAAAAAAAAAAAAAAAAAAAAAAAAAAAAAAAAAAAAAAAAA/AAAAAAAAAKCGAQAAAAAAAAAAAAAAAAAMAAAAAQAAAAAAAAAAAAAAAAAAAB8AAABUAAAAAAAABQAAAAEAAAAAAAAAAAAAAAAAAAAAAAAAAAAAAAAAAAAAAAAAAAAAAAJ/f38AAAAAA8zMzADAwP8Af39/AAAAAAAAAAAAAAAAAAAAAAAAAAAAIQAAABgAAAAUAAAAoRkAABsnAABfMQAAWSkAABAAAAAmAAAACAAAAAAAAAAAAAAA"/>
               </a:ext>
             </a:extLst>
           </p:cNvSpPr>
@@ -2449,9 +2431,6 @@
           <a:lstStyle/>
           <a:p>
             <a:pPr/>
-            <a:r>
-              <a:t/>
-            </a:r>
           </a:p>
         </p:txBody>
       </p:sp>
@@ -2462,7 +2441,7 @@
             <a:spLocks noGrp="1" noChangeArrowheads="1"/>
             <a:extLst>
               <a:ext uri="smNativeData">
-                <pr:smNativeData xmlns:pr="smNativeData" xmlns="smNativeData" val="SMDATA_15_AnHWaRMAAAAlAAAAZAAAAA8BAAAAkAAAAEgAAACQAAAASAAAAAAAAAABAAAAAAAAAAEAAABQAAAAAAAAAAAA4D8AAAAAAADgPwAAAAAAAOA/AAAAAAAA4D8AAAAAAADgPwAAAAAAAOA/AAAAAAAA4D8AAAAAAADgPwAAAAAAAOA/AAAAAAAA4D8CAAAAjAAAAAAAAAAAAAAAu+DjDP///wgAAAAAAAAAAAAAAAAAAAAAAAAAAAAAAAAAAAAAZAAAAAEAAABAAAAAAAAAAAAAAAAAAAAAAAAAAAAAAAAAAAAAAAAAAAAAAAAAAAAAAAAAAAAAAAAAAAAAAAAAAAAAAAAAAAAAAAAAAAAAAAAAAAAAAAAAAAAAAAAAAAAAFAAAADwAAAAAAAAAAAAAAAAAAAkUAAAAAQAAABQAAAAUAAAAFAAAAAEAAAAAAAAAZAAAAGQAAAAAAAAAZAAAAGQAAAAVAAAAYAAAAAAAAAAAAAAADwAAACADAAAAAAAAAAAAAAEAAACgMgAAVgcAAKr4//8BAAAAf39/AAEAAABkAAAAAAAAABQAAABAHwAAAAAAACYAAAAAAAAAwOD//wAAAAAmAAAAZAAAABYAAABMAAAAAAAAAAAAAAAEAAAAAAAAAAEAAACAgIAKAAAAACgAAAAoAAAAZAAAAGQAAAAAAAAAzMzMAAAAAABQAAAAUAAAAGQAAABkAAAAAAAAABcAAAAUAAAAAAAAAAAAAAD/fwAA/38AAAAAAAAJAAAABAAAAAAAAAAeAAAAaAAAAAAAAAAAAAAAAAAAAAAAAAAAAAAAECcAABAnAAAAAAAAAAAAAAAAAAAAAAAAAAAAAAAAAAAAAAAAAAAAABQAAAAAAAAAwMD/AAAAAABkAAAAMgAAAAAAAABkAAAAAAAAAH9/fwAKAAAAIgAAABgAAAAAAAAAAAAAAAAAAAAAAAAAAAAAAAAAAAAkAAAAJAAAAAAAAAAHAAAAAAAAAAAAAAAAAAAAAAAAAAAAAAAAAAAAf39/ACUAAABYAAAAAAAAAAAAAAAAAAAAAAAAAAAAAAAAAAAAAAAAAAAAAAAAAAAAAAAAAAAAAAA/AAAAAAAAAKCGAQAAAAAAAAAAAAAAAAAMAAAAAQAAAAAAAAAAAAAAAAAAAB8AAABUAAAAAAAABQAAAAEAAAAAAAAAAAAAAAAAAAAAAAAAAAAAAAAAAAAAAAAAAAAAAAJ/f38AAAAAA8zMzADAwP8Af39/AAAAAAAAAAAAAAAAAAAAAAAAAAAAIQAAABgAAAAUAAAAwTUAABsnAABARwAAWSkAABAAAAAmAAAACAAAAAAAAAAAAAAA"/>
+                <pr:smNativeData xmlns:pr="smNativeData" xmlns="smNativeData" val="SMDATA_15_7aDWaRMAAAAlAAAAZAAAAA8BAAAAkAAAAEgAAACQAAAASAAAAAAAAAABAAAAAAAAAAEAAABQAAAAAAAAAAAA4D8AAAAAAADgPwAAAAAAAOA/AAAAAAAA4D8AAAAAAADgPwAAAAAAAOA/AAAAAAAA4D8AAAAAAADgPwAAAAAAAOA/AAAAAAAA4D8CAAAAjAAAAAAAAAAAAAAAu+DjDP///wgAAAAAAAAAAAAAAAAAAAAAAAAAAAAAAAAAAAAAZAAAAAEAAABAAAAAAAAAAAAAAAAAAAAAAAAAAAAAAAAAAAAAAAAAAAAAAAAAAAAAAAAAAAAAAAAAAAAAAAAAAAAAAAAAAAAAAAAAAAAAAAAAAAAAAAAAAAAAAAAAAAAAFAAAADwAAAAAAAAAAAAAAAAAAAkUAAAAAQAAABQAAAAUAAAAFAAAAAEAAAAAAAAAZAAAAGQAAAAAAAAAZAAAAGQAAAAVAAAAYAAAAAAAAAAAAAAADwAAACADAAAAAAAAAAAAAAEAAACgMgAAVgcAAKr4//8BAAAAf39/AAEAAABkAAAAAAAAABQAAABAHwAAAAAAACYAAAAAAAAAwOD//wAAAAAmAAAAZAAAABYAAABMAAAAAAAAAAAAAAAEAAAAAAAAAAEAAACAgIAKAAAAACgAAAAoAAAAZAAAAGQAAAAAAAAAzMzMAAAAAABQAAAAUAAAAGQAAABkAAAAAAAAABcAAAAUAAAAAAAAAAAAAAD/fwAA/38AAAAAAAAJAAAABAAAAAAAAAAeAAAAaAAAAAAAAAAAAAAAAAAAAAAAAAAAAAAAECcAABAnAAAAAAAAAAAAAAAAAAAAAAAAAAAAAAAAAAAAAAAAAAAAABQAAAAAAAAAwMD/AAAAAABkAAAAMgAAAAAAAABkAAAAAAAAAH9/fwAKAAAAIgAAABgAAAAAAAAAAAAAAAAAAAAAAAAAAAAAAAAAAAAkAAAAJAAAAAAAAAAHAAAAAAAAAAAAAAAAAAAAAAAAAAAAAAAAAAAAf39/ACUAAABYAAAAAAAAAAAAAAAAAAAAAAAAAAAAAAAAAAAAAAAAAAAAAAAAAAAAAAAAAAAAAAA/AAAAAAAAAKCGAQAAAAAAAAAAAAAAAAAMAAAAAQAAAAAAAAAAAAAAAAAAAB8AAABUAAAAAAAABQAAAAEAAAAAAAAAAAAAAAAAAAAAAAAAAAAAAAAAAAAAAAAAAAAAAAJ/f38AAAAAA8zMzADAwP8Af39/AAAAAAAAAAAAAAAAAAAAAAAAAAAAIQAAABgAAAAUAAAAwTUAABsnAABARwAAWSkAABAAAAAmAAAACAAAAAAAAAAAAAAA"/>
               </a:ext>
             </a:extLst>
           </p:cNvSpPr>
@@ -2476,7 +2455,7 @@
           <a:lstStyle/>
           <a:p>
             <a:pPr/>
-            <a:fld id="{4B449BBD-F3A6-116D-E8FC-0538D5B21E50}" type="slidenum">
+            <a:fld id="{65B799D9-9788-E26F-C60F-613AD7413034}" type="slidenum">
               <a:t/>
             </a:fld>
           </a:p>
@@ -2487,6 +2466,7 @@
   <p:clrMapOvr>
     <a:masterClrMapping/>
   </p:clrMapOvr>
+  <p:hf hdr="0" ftr="0"/>
 </p:sldLayout>
 </file>
 
@@ -2514,7 +2494,7 @@
             <a:spLocks noGrp="1" noChangeArrowheads="1"/>
             <a:extLst>
               <a:ext uri="smNativeData">
-                <pr:smNativeData xmlns:pr="smNativeData" xmlns="smNativeData" val="SMDATA_15_AnHWaRMAAAAlAAAAZAAAAA8BAAAAkAAAAEgAAACQAAAASAAAAAAAAAACAAAAAAAAAAEAAABQAAAAAAAAAAAA4D8AAAAAAADgPwAAAAAAAOA/AAAAAAAA4D8AAAAAAADgPwAAAAAAAOA/AAAAAAAA4D8AAAAAAADgPwAAAAAAAOA/AAAAAAAA4D8CAAAAjAAAAAAAAAAAAAAAu+DjDP///wgAAAAAAAAAAAAAAAAAAAAAAAAAAAAAAAAAAAAAZAAAAAEAAABAAAAAAAAAAAAAAAAAAAAAAAAAAAAAAAAAAAAAAAAAAAAAAAAAAAAAAAAAAAAAAAAAAAAAAAAAAAAAAAAAAAAAAAAAAAAAAAAAAAAAAAAAAAAAAAAAAAAAFAAAADwAAAAAAAAAAAAAAAAAAAkUAAAAAQAAABQAAAAUAAAAFAAAAAEAAAAAAAAAZAAAAGQAAAAAAAAAZAAAAGQAAAAVAAAAYAAAAAAAAAAAAAAADwAAACADAAAAAAAAAAAAAAEAAACgMgAAVgcAAKr4//8BAAAAf39/AAEAAABkAAAAAAAAABQAAABAHwAAAAAAACYAAAAAAAAAwOD//wAAAAAmAAAAZAAAABYAAABMAAAAAAAAAAAAAAAEAAAAAAAAAAEAAACAgIAKAAAAACgAAAAoAAAAZAAAAGQAAAAAAAAAzMzMAAAAAABQAAAAUAAAAGQAAABkAAAAAAAAABcAAAAUAAAAAAAAAAAAAAD/fwAA/38AAAAAAAAJAAAABAAAAAAAAAAeAAAAaAAAAAAAAAAAAAAAAAAAAAAAAAAAAAAAECcAABAnAAAAAAAAAAAAAAAAAAAAAAAAAAAAAAAAAAAAAAAAAAAAABQAAAAAAAAAwMD/AAAAAABkAAAAMgAAAAAAAABkAAAAAAAAAH9/fwAKAAAAIgAAABgAAAAAAAAAAAAAAAAAAAAAAAAAAAAAAAAAAAAkAAAAJAAAAAAAAAAHAAAAAAAAAAAAAAAAAAAAAAAAAAAAAAAAAAAAf39/ACUAAABYAAAAAAAAAAAAAAAAAAAAAAAAAAAAAAAAAAAAAAAAAAAAAAAAAAAAAAAAAAAAAAA/AAAAAAAAAKCGAQAAAAAAAAAAAAAAAAAMAAAAAQAAAAAAAAAAAAAAAAAAAB8AAABUAAAAAAAABQAAAAEAAAAAAAAAAAAAAAAAAAAAAAAAAAAAAAAAAAAAAAAAAAAAAAJ/f38AAAAAA8zMzADAwP8Af39/AAAAAAAAAAAAAAAAAAAAAAAAAAAAIQAAABgAAAAUAAAAsw4AAIgdAACzOwAABCEAABAAAAAmAAAACAAAAIGAAAAAAAAA"/>
+                <pr:smNativeData xmlns:pr="smNativeData" xmlns="smNativeData" val="SMDATA_15_7aDWaRMAAAAlAAAAZAAAAA8BAAAAkAAAAEgAAACQAAAASAAAAAAAAAACAAAAAAAAAAEAAABQAAAAAAAAAAAA4D8AAAAAAADgPwAAAAAAAOA/AAAAAAAA4D8AAAAAAADgPwAAAAAAAOA/AAAAAAAA4D8AAAAAAADgPwAAAAAAAOA/AAAAAAAA4D8CAAAAjAAAAAAAAAAAAAAAu+DjDP///wgAAAAAAAAAAAAAAAAAAAAAAAAAAAAAAAAAAAAAZAAAAAEAAABAAAAAAAAAAAAAAAAAAAAAAAAAAAAAAAAAAAAAAAAAAAAAAAAAAAAAAAAAAAAAAAAAAAAAAAAAAAAAAAAAAAAAAAAAAAAAAAAAAAAAAAAAAAAAAAAAAAAAFAAAADwAAAAAAAAAAAAAAAAAAAkUAAAAAQAAABQAAAAUAAAAFAAAAAEAAAAAAAAAZAAAAGQAAAAAAAAAZAAAAGQAAAAVAAAAYAAAAAAAAAAAAAAADwAAACADAAAAAAAAAAAAAAEAAACgMgAAVgcAAKr4//8BAAAAf39/AAEAAABkAAAAAAAAABQAAABAHwAAAAAAACYAAAAAAAAAwOD//wAAAAAmAAAAZAAAABYAAABMAAAAAAAAAAAAAAAEAAAAAAAAAAEAAACAgIAKAAAAACgAAAAoAAAAZAAAAGQAAAAAAAAAzMzMAAAAAABQAAAAUAAAAGQAAABkAAAAAAAAABcAAAAUAAAAAAAAAAAAAAD/fwAA/38AAAAAAAAJAAAABAAAAAAAAAAeAAAAaAAAAAAAAAAAAAAAAAAAAAAAAAAAAAAAECcAABAnAAAAAAAAAAAAAAAAAAAAAAAAAAAAAAAAAAAAAAAAAAAAABQAAAAAAAAAwMD/AAAAAABkAAAAMgAAAAAAAABkAAAAAAAAAH9/fwAKAAAAIgAAABgAAAAAAAAAAAAAAAAAAAAAAAAAAAAAAAAAAAAkAAAAJAAAAAAAAAAHAAAAAAAAAAAAAAAAAAAAAAAAAAAAAAAAAAAAf39/ACUAAABYAAAAAAAAAAAAAAAAAAAAAAAAAAAAAAAAAAAAAAAAAAAAAAAAAAAAAAAAAAAAAAA/AAAAAAAAAKCGAQAAAAAAAAAAAAAAAAAMAAAAAQAAAAAAAAAAAAAAAAAAAB8AAABUAAAAAAAABQAAAAEAAAAAAAAAAAAAAAAAAAAAAAAAAAAAAAAAAAAAAAAAAAAAAAJ/f38AAAAAA8zMzADAwP8Af39/AAAAAAAAAAAAAAAAAAAAAAAAAAAAIQAAABgAAAAUAAAAsw4AAIgdAACzOwAABCEAABAAAAAmAAAACAAAAIGAAAAAAAAA"/>
               </a:ext>
             </a:extLst>
           </p:cNvSpPr>
@@ -2554,7 +2534,7 @@
             <a:spLocks noGrp="1" noChangeArrowheads="1"/>
             <a:extLst>
               <a:ext uri="smNativeData">
-                <pr:smNativeData xmlns:pr="smNativeData" xmlns="smNativeData" val="SMDATA_15_AnHWaRMAAAAlAAAAZAAAAA8BAAAAkAAAAEgAAACQAAAASAAAAAAAAAAAAAAAAAAAAAEAAABQAAAAAAAAAAAA4D8AAAAAAADgPwAAAAAAAOA/AAAAAAAA4D8AAAAAAADgPwAAAAAAAOA/AAAAAAAA4D8AAAAAAADgPwAAAAAAAOA/AAAAAAAA4D8CAAAAjAAAAAAAAAAAAAAAu+DjDP///wgAAAAAAAAAAAAAAAAAAAAAAAAAAAAAAAAAAAAAZAAAAAEAAABAAAAAAAAAAAAAAAAAAAAAAAAAAAAAAAAAAAAAAAAAAAAAAAAAAAAAAAAAAAAAAAAAAAAAAAAAAAAAAAAAAAAAAAAAAAAAAAAAAAAAAAAAAAAAAAAAAAAAFAAAADwAAAAAAAAAAAAAAAAAAAkUAAAAAQAAABQAAAAUAAAAFAAAAAEAAAAAAAAAZAAAAGQAAAAAAAAAZAAAAGQAAAAVAAAAYAAAAAAAAAAAAAAADwAAACADAAAAAAAAAAAAAAEAAACgMgAAVgcAAKr4//8BAAAAf39/AAEAAABkAAAAAAAAABQAAABAHwAAAAAAACYAAAAAAAAAwOD//wAAAAAmAAAAZAAAABYAAABMAAAAAAAAAAAAAAAEAAAAAAAAAAEAAACAgIAKAAAAACgAAAAoAAAAZAAAAGQAAAAAAAAAzMzMAAAAAABQAAAAUAAAAGQAAABkAAAAAAAAABcAAAAUAAAAAAAAAAAAAAD/fwAA/38AAAAAAAAJAAAABAAAAAAAAAAeAAAAaAAAAAAAAAAAAAAAAAAAAAAAAAAAAAAAECcAABAnAAAAAAAAAAAAAAAAAAAAAAAAAAAAAAAAAAAAAAAAAAAAABQAAAAAAAAAwMD/AAAAAABkAAAAMgAAAAAAAABkAAAAAAAAAH9/fwAKAAAAIgAAABgAAAAAAAAAAAAAAAAAAAAAAAAAAAAAAAAAAAAkAAAAJAAAAAAAAAAHAAAAAAAAAAAAAAAAAAAAAAAAAAAAAAAAAAAAf39/ACUAAABYAAAAAAAAAAAAAAAAAAAAAAAAAAAAAAAAAAAAAAAAAAAAAAAAAAAAAAAAAAAAAAA/AAAAAAAAAKCGAQAAAAAAAAAAAAAAAAAMAAAAAQAAAAAAAAAAAAAAAAAAAB8AAABUAAAAAAAABQAAAAEAAAAAAAAAAAAAAAAAAAAAAAAAAAAAAAAAAAAAAAAAAAAAAAJ/f38AAAAAA8zMzADAwP8Af39/AAAAAAAAAAAAAAAAAAAAAAAAAAAAIQAAABgAAAAUAAAAsw4AAMYDAACzOwAAFh0AABAAAAAmAAAACAAAAAGAAAAAAAAA"/>
+                <pr:smNativeData xmlns:pr="smNativeData" xmlns="smNativeData" val="SMDATA_15_7aDWaRMAAAAlAAAAZAAAAA8BAAAAkAAAAEgAAACQAAAASAAAAAAAAAAAAAAAAAAAAAEAAABQAAAAAAAAAAAA4D8AAAAAAADgPwAAAAAAAOA/AAAAAAAA4D8AAAAAAADgPwAAAAAAAOA/AAAAAAAA4D8AAAAAAADgPwAAAAAAAOA/AAAAAAAA4D8CAAAAjAAAAAAAAAAAAAAAu+DjDP///wgAAAAAAAAAAAAAAAAAAAAAAAAAAAAAAAAAAAAAZAAAAAEAAABAAAAAAAAAAAAAAAAAAAAAAAAAAAAAAAAAAAAAAAAAAAAAAAAAAAAAAAAAAAAAAAAAAAAAAAAAAAAAAAAAAAAAAAAAAAAAAAAAAAAAAAAAAAAAAAAAAAAAFAAAADwAAAAAAAAAAAAAAAAAAAkUAAAAAQAAABQAAAAUAAAAFAAAAAEAAAAAAAAAZAAAAGQAAAAAAAAAZAAAAGQAAAAVAAAAYAAAAAAAAAAAAAAADwAAACADAAAAAAAAAAAAAAEAAACgMgAAVgcAAKr4//8BAAAAf39/AAEAAABkAAAAAAAAABQAAABAHwAAAAAAACYAAAAAAAAAwOD//wAAAAAmAAAAZAAAABYAAABMAAAAAAAAAAAAAAAEAAAAAAAAAAEAAACAgIAKAAAAACgAAAAoAAAAZAAAAGQAAAAAAAAAzMzMAAAAAABQAAAAUAAAAGQAAABkAAAAAAAAABcAAAAUAAAAAAAAAAAAAAD/fwAA/38AAAAAAAAJAAAABAAAAAAAAAAeAAAAaAAAAAAAAAAAAAAAAAAAAAAAAAAAAAAAECcAABAnAAAAAAAAAAAAAAAAAAAAAAAAAAAAAAAAAAAAAAAAAAAAABQAAAAAAAAAwMD/AAAAAABkAAAAMgAAAAAAAABkAAAAAAAAAH9/fwAKAAAAIgAAABgAAAAAAAAAAAAAAAAAAAAAAAAAAAAAAAAAAAAkAAAAJAAAAAAAAAAHAAAAAAAAAAAAAAAAAAAAAAAAAAAAAAAAAAAAf39/ACUAAABYAAAAAAAAAAAAAAAAAAAAAAAAAAAAAAAAAAAAAAAAAAAAAAAAAAAAAAAAAAAAAAA/AAAAAAAAAKCGAQAAAAAAAAAAAAAAAAAMAAAAAQAAAAAAAAAAAAAAAAAAAB8AAABUAAAAAAAABQAAAAEAAAAAAAAAAAAAAAAAAAAAAAAAAAAAAAAAAAAAAAAAAAAAAAJ/f38AAAAAA8zMzADAwP8Af39/AAAAAAAAAAAAAAAAAAAAAAAAAAAAIQAAABgAAAAUAAAAsw4AAMYDAACzOwAAFh0AABAAAAAmAAAACAAAAAGAAAAAAAAA"/>
               </a:ext>
             </a:extLst>
           </p:cNvSpPr>
@@ -2623,7 +2603,7 @@
             <a:spLocks noGrp="1" noChangeArrowheads="1"/>
             <a:extLst>
               <a:ext uri="smNativeData">
-                <pr:smNativeData xmlns:pr="smNativeData" xmlns="smNativeData" val="SMDATA_15_AnHWaRMAAAAlAAAAZAAAAA8BAAAAkAAAAEgAAACQAAAASAAAAAAAAAAAAAAAAAAAAAEAAABQAAAAAAAAAAAA4D8AAAAAAADgPwAAAAAAAOA/AAAAAAAA4D8AAAAAAADgPwAAAAAAAOA/AAAAAAAA4D8AAAAAAADgPwAAAAAAAOA/AAAAAAAA4D8CAAAAjAAAAAAAAAAAAAAAu+DjDP///wgAAAAAAAAAAAAAAAAAAAAAAAAAAAAAAAAAAAAAZAAAAAEAAABAAAAAAAAAAAAAAAAAAAAAAAAAAAAAAAAAAAAAAAAAAAAAAAAAAAAAAAAAAAAAAAAAAAAAAAAAAAAAAAAAAAAAAAAAAAAAAAAAAAAAAAAAAAAAAAAAAAAAFAAAADwAAAAAAAAAAAAAAAAAAAkUAAAAAQAAABQAAAAUAAAAFAAAAAEAAAAAAAAAZAAAAGQAAAAAAAAAZAAAAGQAAAAVAAAAYAAAAAAAAAAAAAAADwAAACADAAAAAAAAAAAAAAEAAACgMgAAVgcAAKr4//8BAAAAf39/AAEAAABkAAAAAAAAABQAAABAHwAAAAAAACYAAAAAAAAAwOD//wAAAAAmAAAAZAAAABYAAABMAAAAAAAAAAAAAAAEAAAAAAAAAAEAAACAgIAKAAAAACgAAAAoAAAAZAAAAGQAAAAAAAAAzMzMAAAAAABQAAAAUAAAAGQAAABkAAAAAAAAABcAAAAUAAAAAAAAAAAAAAD/fwAA/38AAAAAAAAJAAAABAAAAAAAAAAeAAAAaAAAAAAAAAAAAAAAAAAAAAAAAAAAAAAAECcAABAnAAAAAAAAAAAAAAAAAAAAAAAAAAAAAAAAAAAAAAAAAAAAABQAAAAAAAAAwMD/AAAAAABkAAAAMgAAAAAAAABkAAAAAAAAAH9/fwAKAAAAIgAAABgAAAAAAAAAAAAAAAAAAAAAAAAAAAAAAAAAAAAkAAAAJAAAAAAAAAAHAAAAAAAAAAAAAAAAAAAAAAAAAAAAAAAAAAAAf39/ACUAAABYAAAAAAAAAAAAAAAAAAAAAAAAAAAAAAAAAAAAAAAAAAAAAAAAAAAAAAAAAAAAAAA/AAAAAAAAAKCGAQAAAAAAAAAAAAAAAAAMAAAAAQAAAAAAAAAAAAAAAAAAAB8AAABUAAAAAAAABQAAAAEAAAAAAAAAAAAAAAAAAAAAAAAAAAAAAAAAAAAAAAAAAAAAAAJ/f38AAAAAA8zMzADAwP8Af39/AAAAAAAAAAAAAAAAAAAAAAAAAAAAIQAAABgAAAAUAAAAsw4AAAQhAACzOwAA+CUAABAAAAAmAAAACAAAAAGAAAAAAAAA"/>
+                <pr:smNativeData xmlns:pr="smNativeData" xmlns="smNativeData" val="SMDATA_15_7aDWaRMAAAAlAAAAZAAAAA8BAAAAkAAAAEgAAACQAAAASAAAAAAAAAAAAAAAAAAAAAEAAABQAAAAAAAAAAAA4D8AAAAAAADgPwAAAAAAAOA/AAAAAAAA4D8AAAAAAADgPwAAAAAAAOA/AAAAAAAA4D8AAAAAAADgPwAAAAAAAOA/AAAAAAAA4D8CAAAAjAAAAAAAAAAAAAAAu+DjDP///wgAAAAAAAAAAAAAAAAAAAAAAAAAAAAAAAAAAAAAZAAAAAEAAABAAAAAAAAAAAAAAAAAAAAAAAAAAAAAAAAAAAAAAAAAAAAAAAAAAAAAAAAAAAAAAAAAAAAAAAAAAAAAAAAAAAAAAAAAAAAAAAAAAAAAAAAAAAAAAAAAAAAAFAAAADwAAAAAAAAAAAAAAAAAAAkUAAAAAQAAABQAAAAUAAAAFAAAAAEAAAAAAAAAZAAAAGQAAAAAAAAAZAAAAGQAAAAVAAAAYAAAAAAAAAAAAAAADwAAACADAAAAAAAAAAAAAAEAAACgMgAAVgcAAKr4//8BAAAAf39/AAEAAABkAAAAAAAAABQAAABAHwAAAAAAACYAAAAAAAAAwOD//wAAAAAmAAAAZAAAABYAAABMAAAAAAAAAAAAAAAEAAAAAAAAAAEAAACAgIAKAAAAACgAAAAoAAAAZAAAAGQAAAAAAAAAzMzMAAAAAABQAAAAUAAAAGQAAABkAAAAAAAAABcAAAAUAAAAAAAAAAAAAAD/fwAA/38AAAAAAAAJAAAABAAAAAAAAAAeAAAAaAAAAAAAAAAAAAAAAAAAAAAAAAAAAAAAECcAABAnAAAAAAAAAAAAAAAAAAAAAAAAAAAAAAAAAAAAAAAAAAAAABQAAAAAAAAAwMD/AAAAAABkAAAAMgAAAAAAAABkAAAAAAAAAH9/fwAKAAAAIgAAABgAAAAAAAAAAAAAAAAAAAAAAAAAAAAAAAAAAAAkAAAAJAAAAAAAAAAHAAAAAAAAAAAAAAAAAAAAAAAAAAAAAAAAAAAAf39/ACUAAABYAAAAAAAAAAAAAAAAAAAAAAAAAAAAAAAAAAAAAAAAAAAAAAAAAAAAAAAAAAAAAAA/AAAAAAAAAKCGAQAAAAAAAAAAAAAAAAAMAAAAAQAAAAAAAAAAAAAAAAAAAB8AAABUAAAAAAAABQAAAAEAAAAAAAAAAAAAAAAAAAAAAAAAAAAAAAAAAAAAAAAAAAAAAAJ/f38AAAAAA8zMzADAwP8Af39/AAAAAAAAAAAAAAAAAAAAAAAAAAAAIQAAABgAAAAUAAAAsw4AAAQhAACzOwAA+CUAABAAAAAmAAAACAAAAAGAAAAAAAAA"/>
               </a:ext>
             </a:extLst>
           </p:cNvSpPr>
@@ -2692,7 +2672,7 @@
             <a:spLocks noGrp="1" noChangeArrowheads="1"/>
             <a:extLst>
               <a:ext uri="smNativeData">
-                <pr:smNativeData xmlns:pr="smNativeData" xmlns="smNativeData" val="SMDATA_15_AnHWaRMAAAAlAAAAZAAAAA8BAAAAkAAAAEgAAACQAAAASAAAAAAAAAABAAAAAAAAAAEAAABQAAAAAAAAAAAA4D8AAAAAAADgPwAAAAAAAOA/AAAAAAAA4D8AAAAAAADgPwAAAAAAAOA/AAAAAAAA4D8AAAAAAADgPwAAAAAAAOA/AAAAAAAA4D8CAAAAjAAAAAAAAAAAAAAAu+DjDP///wgAAAAAAAAAAAAAAAAAAAAAAAAAAAAAAAAAAAAAZAAAAAEAAABAAAAAAAAAAAAAAAAAAAAAAAAAAAAAAAAAAAAAAAAAAAAAAAAAAAAAAAAAAAAAAAAAAAAAAAAAAAAAAAAAAAAAAAAAAAAAAAAAAAAAAAAAAAAAAAAAAAAAFAAAADwAAAAAAAAAAAAAAAAAAAkUAAAAAQAAABQAAAAUAAAAFAAAAAEAAAAAAAAAZAAAAGQAAAAAAAAAZAAAAGQAAAAVAAAAYAAAAAAAAAAAAAAADwAAACADAAAAAAAAAAAAAAEAAACgMgAAVgcAAKr4//8BAAAAf39/AAEAAABkAAAAAAAAABQAAABAHwAAAAAAACYAAAAAAAAAwOD//wAAAAAmAAAAZAAAABYAAABMAAAAAAAAAAAAAAAEAAAAAAAAAAEAAACAgIAKAAAAACgAAAAoAAAAZAAAAGQAAAAAAAAAzMzMAAAAAABQAAAAUAAAAGQAAABkAAAAAAAAABcAAAAUAAAAAAAAAAAAAAD/fwAA/38AAAAAAAAJAAAABAAAAAAAAAAeAAAAaAAAAAAAAAAAAAAAAAAAAAAAAAAAAAAAECcAABAnAAAAAAAAAAAAAAAAAAAAAAAAAAAAAAAAAAAAAAAAAAAAABQAAAAAAAAAwMD/AAAAAABkAAAAMgAAAAAAAABkAAAAAAAAAH9/fwAKAAAAIgAAABgAAAAAAAAAAAAAAAAAAAAAAAAAAAAAAAAAAAAkAAAAJAAAAAAAAAAHAAAAAAAAAAAAAAAAAAAAAAAAAAAAAAAAAAAAf39/ACUAAABYAAAAAAAAAAAAAAAAAAAAAAAAAAAAAAAAAAAAAAAAAAAAAAAAAAAAAAAAAAAAAAA/AAAAAAAAAKCGAQAAAAAAAAAAAAAAAAAMAAAAAQAAAAAAAAAAAAAAAAAAAB8AAABUAAAAAAAABQAAAAEAAAAAAAAAAAAAAAAAAAAAAAAAAAAAAAAAAAAAAAAAAAAAAAJ/f38AAAAAA8zMzADAwP8Af39/AAAAAAAAAAAAAAAAAAAAAAAAAAAAIQAAABgAAAAUAAAAwAMAABsnAAA/FQAAWSkAABAAAAAmAAAACAAAAAAAAAAAAAAA"/>
+                <pr:smNativeData xmlns:pr="smNativeData" xmlns="smNativeData" val="SMDATA_15_7aDWaRMAAAAlAAAAZAAAAA8BAAAAkAAAAEgAAACQAAAASAAAAAAAAAABAAAAAAAAAAEAAABQAAAAAAAAAAAA4D8AAAAAAADgPwAAAAAAAOA/AAAAAAAA4D8AAAAAAADgPwAAAAAAAOA/AAAAAAAA4D8AAAAAAADgPwAAAAAAAOA/AAAAAAAA4D8CAAAAjAAAAAAAAAAAAAAAu+DjDP///wgAAAAAAAAAAAAAAAAAAAAAAAAAAAAAAAAAAAAAZAAAAAEAAABAAAAAAAAAAAAAAAAAAAAAAAAAAAAAAAAAAAAAAAAAAAAAAAAAAAAAAAAAAAAAAAAAAAAAAAAAAAAAAAAAAAAAAAAAAAAAAAAAAAAAAAAAAAAAAAAAAAAAFAAAADwAAAAAAAAAAAAAAAAAAAkUAAAAAQAAABQAAAAUAAAAFAAAAAEAAAAAAAAAZAAAAGQAAAAAAAAAZAAAAGQAAAAVAAAAYAAAAAAAAAAAAAAADwAAACADAAAAAAAAAAAAAAEAAACgMgAAVgcAAKr4//8BAAAAf39/AAEAAABkAAAAAAAAABQAAABAHwAAAAAAACYAAAAAAAAAwOD//wAAAAAmAAAAZAAAABYAAABMAAAAAAAAAAAAAAAEAAAAAAAAAAEAAACAgIAKAAAAACgAAAAoAAAAZAAAAGQAAAAAAAAAzMzMAAAAAABQAAAAUAAAAGQAAABkAAAAAAAAABcAAAAUAAAAAAAAAAAAAAD/fwAA/38AAAAAAAAJAAAABAAAAAAAAAAeAAAAaAAAAAAAAAAAAAAAAAAAAAAAAAAAAAAAECcAABAnAAAAAAAAAAAAAAAAAAAAAAAAAAAAAAAAAAAAAAAAAAAAABQAAAAAAAAAwMD/AAAAAABkAAAAMgAAAAAAAABkAAAAAAAAAH9/fwAKAAAAIgAAABgAAAAAAAAAAAAAAAAAAAAAAAAAAAAAAAAAAAAkAAAAJAAAAAAAAAAHAAAAAAAAAAAAAAAAAAAAAAAAAAAAAAAAAAAAf39/ACUAAABYAAAAAAAAAAAAAAAAAAAAAAAAAAAAAAAAAAAAAAAAAAAAAAAAAAAAAAAAAAAAAAA/AAAAAAAAAKCGAQAAAAAAAAAAAAAAAAAMAAAAAQAAAAAAAAAAAAAAAAAAAB8AAABUAAAAAAAABQAAAAEAAAAAAAAAAAAAAAAAAAAAAAAAAAAAAAAAAAAAAAAAAAAAAAJ/f38AAAAAA8zMzADAwP8Af39/AAAAAAAAAAAAAAAAAAAAAAAAAAAAIQAAABgAAAAUAAAAwAMAABsnAAA/FQAAWSkAABAAAAAmAAAACAAAAAAAAAAAAAAA"/>
               </a:ext>
             </a:extLst>
           </p:cNvSpPr>
@@ -2706,7 +2686,7 @@
           <a:lstStyle/>
           <a:p>
             <a:pPr/>
-            <a:fld id="{343AF323-6DD9-6F05-9782-9B50BDCC61CE}" type="datetime1">
+            <a:fld id="{08843BDD-93E5-D1CD-AB3C-659875725D30}" type="datetime1">
               <a:t/>
             </a:fld>
           </a:p>
@@ -2719,7 +2699,7 @@
             <a:spLocks noGrp="1" noChangeArrowheads="1"/>
             <a:extLst>
               <a:ext uri="smNativeData">
-                <pr:smNativeData xmlns:pr="smNativeData" xmlns="smNativeData" val="SMDATA_15_AnHWaRMAAAAlAAAAZAAAAA8BAAAAkAAAAEgAAACQAAAASAAAAAAAAAABAAAAAAAAAAEAAABQAAAAAAAAAAAA4D8AAAAAAADgPwAAAAAAAOA/AAAAAAAA4D8AAAAAAADgPwAAAAAAAOA/AAAAAAAA4D8AAAAAAADgPwAAAAAAAOA/AAAAAAAA4D8CAAAAjAAAAAAAAAAAAAAAu+DjDP///wgAAAAAAAAAAAAAAAAAAAAAAAAAAAAAAAAAAAAAZAAAAAEAAABAAAAAAAAAAAAAAAAAAAAAAAAAAAAAAAAAAAAAAAAAAAAAAAAAAAAAAAAAAAAAAAAAAAAAAAAAAAAAAAAAAAAAAAAAAAAAAAAAAAAAAAAAAAAAAAAAAAAAFAAAADwAAAAAAAAAAAAAAAAAAAkUAAAAAQAAABQAAAAUAAAAFAAAAAEAAAAAAAAAZAAAAGQAAAAAAAAAZAAAAGQAAAAVAAAAYAAAAAAAAAAAAAAADwAAACADAAAAAAAAAAAAAAEAAACgMgAAVgcAAKr4//8BAAAAf39/AAEAAABkAAAAAAAAABQAAABAHwAAAAAAACYAAAAAAAAAwOD//wAAAAAmAAAAZAAAABYAAABMAAAAAAAAAAAAAAAEAAAAAAAAAAEAAACAgIAKAAAAACgAAAAoAAAAZAAAAGQAAAAAAAAAzMzMAAAAAABQAAAAUAAAAGQAAABkAAAAAAAAABcAAAAUAAAAAAAAAAAAAAD/fwAA/38AAAAAAAAJAAAABAAAAAAAAAAeAAAAaAAAAAAAAAAAAAAAAAAAAAAAAAAAAAAAECcAABAnAAAAAAAAAAAAAAAAAAAAAAAAAAAAAAAAAAAAAAAAAAAAABQAAAAAAAAAwMD/AAAAAABkAAAAMgAAAAAAAABkAAAAAAAAAH9/fwAKAAAAIgAAABgAAAAAAAAAAAAAAAAAAAAAAAAAAAAAAAAAAAAkAAAAJAAAAAAAAAAHAAAAAAAAAAAAAAAAAAAAAAAAAAAAAAAAAAAAf39/ACUAAABYAAAAAAAAAAAAAAAAAAAAAAAAAAAAAAAAAAAAAAAAAAAAAAAAAAAAAAAAAAAAAAA/AAAAAAAAAKCGAQAAAAAAAAAAAAAAAAAMAAAAAQAAAAAAAAAAAAAAAAAAAB8AAABUAAAAAAAABQAAAAEAAAAAAAAAAAAAAAAAAAAAAAAAAAAAAAAAAAAAAAAAAAAAAAJ/f38AAAAAA8zMzADAwP8Af39/AAAAAAAAAAAAAAAAAAAAAAAAAAAAIQAAABgAAAAUAAAAoRkAABsnAABfMQAAWSkAABAAAAAmAAAACAAAAAAAAAAAAAAA"/>
+                <pr:smNativeData xmlns:pr="smNativeData" xmlns="smNativeData" val="SMDATA_15_7aDWaRMAAAAlAAAAZAAAAA8BAAAAkAAAAEgAAACQAAAASAAAAAAAAAABAAAAAAAAAAEAAABQAAAAAAAAAAAA4D8AAAAAAADgPwAAAAAAAOA/AAAAAAAA4D8AAAAAAADgPwAAAAAAAOA/AAAAAAAA4D8AAAAAAADgPwAAAAAAAOA/AAAAAAAA4D8CAAAAjAAAAAAAAAAAAAAAu+DjDP///wgAAAAAAAAAAAAAAAAAAAAAAAAAAAAAAAAAAAAAZAAAAAEAAABAAAAAAAAAAAAAAAAAAAAAAAAAAAAAAAAAAAAAAAAAAAAAAAAAAAAAAAAAAAAAAAAAAAAAAAAAAAAAAAAAAAAAAAAAAAAAAAAAAAAAAAAAAAAAAAAAAAAAFAAAADwAAAAAAAAAAAAAAAAAAAkUAAAAAQAAABQAAAAUAAAAFAAAAAEAAAAAAAAAZAAAAGQAAAAAAAAAZAAAAGQAAAAVAAAAYAAAAAAAAAAAAAAADwAAACADAAAAAAAAAAAAAAEAAACgMgAAVgcAAKr4//8BAAAAf39/AAEAAABkAAAAAAAAABQAAABAHwAAAAAAACYAAAAAAAAAwOD//wAAAAAmAAAAZAAAABYAAABMAAAAAAAAAAAAAAAEAAAAAAAAAAEAAACAgIAKAAAAACgAAAAoAAAAZAAAAGQAAAAAAAAAzMzMAAAAAABQAAAAUAAAAGQAAABkAAAAAAAAABcAAAAUAAAAAAAAAAAAAAD/fwAA/38AAAAAAAAJAAAABAAAAAAAAAAeAAAAaAAAAAAAAAAAAAAAAAAAAAAAAAAAAAAAECcAABAnAAAAAAAAAAAAAAAAAAAAAAAAAAAAAAAAAAAAAAAAAAAAABQAAAAAAAAAwMD/AAAAAABkAAAAMgAAAAAAAABkAAAAAAAAAH9/fwAKAAAAIgAAABgAAAAAAAAAAAAAAAAAAAAAAAAAAAAAAAAAAAAkAAAAJAAAAAAAAAAHAAAAAAAAAAAAAAAAAAAAAAAAAAAAAAAAAAAAf39/ACUAAABYAAAAAAAAAAAAAAAAAAAAAAAAAAAAAAAAAAAAAAAAAAAAAAAAAAAAAAAAAAAAAAA/AAAAAAAAAKCGAQAAAAAAAAAAAAAAAAAMAAAAAQAAAAAAAAAAAAAAAAAAAB8AAABUAAAAAAAABQAAAAEAAAAAAAAAAAAAAAAAAAAAAAAAAAAAAAAAAAAAAAAAAAAAAAJ/f38AAAAAA8zMzADAwP8Af39/AAAAAAAAAAAAAAAAAAAAAAAAAAAAIQAAABgAAAAUAAAAoRkAABsnAABfMQAAWSkAABAAAAAmAAAACAAAAAAAAAAAAAAA"/>
               </a:ext>
             </a:extLst>
           </p:cNvSpPr>
@@ -2733,9 +2713,6 @@
           <a:lstStyle/>
           <a:p>
             <a:pPr/>
-            <a:r>
-              <a:t/>
-            </a:r>
           </a:p>
         </p:txBody>
       </p:sp>
@@ -2746,7 +2723,7 @@
             <a:spLocks noGrp="1" noChangeArrowheads="1"/>
             <a:extLst>
               <a:ext uri="smNativeData">
-                <pr:smNativeData xmlns:pr="smNativeData" xmlns="smNativeData" val="SMDATA_15_AnHWaRMAAAAlAAAAZAAAAA8BAAAAkAAAAEgAAACQAAAASAAAAAAAAAABAAAAAAAAAAEAAABQAAAAAAAAAAAA4D8AAAAAAADgPwAAAAAAAOA/AAAAAAAA4D8AAAAAAADgPwAAAAAAAOA/AAAAAAAA4D8AAAAAAADgPwAAAAAAAOA/AAAAAAAA4D8CAAAAjAAAAAAAAAAAAAAAu+DjDP///wgAAAAAAAAAAAAAAAAAAAAAAAAAAAAAAAAAAAAAZAAAAAEAAABAAAAAAAAAAAAAAAAAAAAAAAAAAAAAAAAAAAAAAAAAAAAAAAAAAAAAAAAAAAAAAAAAAAAAAAAAAAAAAAAAAAAAAAAAAAAAAAAAAAAAAAAAAAAAAAAAAAAAFAAAADwAAAAAAAAAAAAAAAAAAAkUAAAAAQAAABQAAAAUAAAAFAAAAAEAAAAAAAAAZAAAAGQAAAAAAAAAZAAAAGQAAAAVAAAAYAAAAAAAAAAAAAAADwAAACADAAAAAAAAAAAAAAEAAACgMgAAVgcAAKr4//8BAAAAf39/AAEAAABkAAAAAAAAABQAAABAHwAAAAAAACYAAAAAAAAAwOD//wAAAAAmAAAAZAAAABYAAABMAAAAAAAAAAAAAAAEAAAAAAAAAAEAAACAgIAKAAAAACgAAAAoAAAAZAAAAGQAAAAAAAAAzMzMAAAAAABQAAAAUAAAAGQAAABkAAAAAAAAABcAAAAUAAAAAAAAAAAAAAD/fwAA/38AAAAAAAAJAAAABAAAAAAAAAAeAAAAaAAAAAAAAAAAAAAAAAAAAAAAAAAAAAAAECcAABAnAAAAAAAAAAAAAAAAAAAAAAAAAAAAAAAAAAAAAAAAAAAAABQAAAAAAAAAwMD/AAAAAABkAAAAMgAAAAAAAABkAAAAAAAAAH9/fwAKAAAAIgAAABgAAAAAAAAAAAAAAAAAAAAAAAAAAAAAAAAAAAAkAAAAJAAAAAAAAAAHAAAAAAAAAAAAAAAAAAAAAAAAAAAAAAAAAAAAf39/ACUAAABYAAAAAAAAAAAAAAAAAAAAAAAAAAAAAAAAAAAAAAAAAAAAAAAAAAAAAAAAAAAAAAA/AAAAAAAAAKCGAQAAAAAAAAAAAAAAAAAMAAAAAQAAAAAAAAAAAAAAAAAAAB8AAABUAAAAAAAABQAAAAEAAAAAAAAAAAAAAAAAAAAAAAAAAAAAAAAAAAAAAAAAAAAAAAJ/f38AAAAAA8zMzADAwP8Af39/AAAAAAAAAAAAAAAAAAAAAAAAAAAAIQAAABgAAAAUAAAAwTUAABsnAABARwAAWSkAABAAAAAmAAAACAAAAAAAAAAAAAAA"/>
+                <pr:smNativeData xmlns:pr="smNativeData" xmlns="smNativeData" val="SMDATA_15_7aDWaRMAAAAlAAAAZAAAAA8BAAAAkAAAAEgAAACQAAAASAAAAAAAAAABAAAAAAAAAAEAAABQAAAAAAAAAAAA4D8AAAAAAADgPwAAAAAAAOA/AAAAAAAA4D8AAAAAAADgPwAAAAAAAOA/AAAAAAAA4D8AAAAAAADgPwAAAAAAAOA/AAAAAAAA4D8CAAAAjAAAAAAAAAAAAAAAu+DjDP///wgAAAAAAAAAAAAAAAAAAAAAAAAAAAAAAAAAAAAAZAAAAAEAAABAAAAAAAAAAAAAAAAAAAAAAAAAAAAAAAAAAAAAAAAAAAAAAAAAAAAAAAAAAAAAAAAAAAAAAAAAAAAAAAAAAAAAAAAAAAAAAAAAAAAAAAAAAAAAAAAAAAAAFAAAADwAAAAAAAAAAAAAAAAAAAkUAAAAAQAAABQAAAAUAAAAFAAAAAEAAAAAAAAAZAAAAGQAAAAAAAAAZAAAAGQAAAAVAAAAYAAAAAAAAAAAAAAADwAAACADAAAAAAAAAAAAAAEAAACgMgAAVgcAAKr4//8BAAAAf39/AAEAAABkAAAAAAAAABQAAABAHwAAAAAAACYAAAAAAAAAwOD//wAAAAAmAAAAZAAAABYAAABMAAAAAAAAAAAAAAAEAAAAAAAAAAEAAACAgIAKAAAAACgAAAAoAAAAZAAAAGQAAAAAAAAAzMzMAAAAAABQAAAAUAAAAGQAAABkAAAAAAAAABcAAAAUAAAAAAAAAAAAAAD/fwAA/38AAAAAAAAJAAAABAAAAAAAAAAeAAAAaAAAAAAAAAAAAAAAAAAAAAAAAAAAAAAAECcAABAnAAAAAAAAAAAAAAAAAAAAAAAAAAAAAAAAAAAAAAAAAAAAABQAAAAAAAAAwMD/AAAAAABkAAAAMgAAAAAAAABkAAAAAAAAAH9/fwAKAAAAIgAAABgAAAAAAAAAAAAAAAAAAAAAAAAAAAAAAAAAAAAkAAAAJAAAAAAAAAAHAAAAAAAAAAAAAAAAAAAAAAAAAAAAAAAAAAAAf39/ACUAAABYAAAAAAAAAAAAAAAAAAAAAAAAAAAAAAAAAAAAAAAAAAAAAAAAAAAAAAAAAAAAAAA/AAAAAAAAAKCGAQAAAAAAAAAAAAAAAAAMAAAAAQAAAAAAAAAAAAAAAAAAAB8AAABUAAAAAAAABQAAAAEAAAAAAAAAAAAAAAAAAAAAAAAAAAAAAAAAAAAAAAAAAAAAAAJ/f38AAAAAA8zMzADAwP8Af39/AAAAAAAAAAAAAAAAAAAAAAAAAAAAIQAAABgAAAAUAAAAwTUAABsnAABARwAAWSkAABAAAAAmAAAACAAAAAAAAAAAAAAA"/>
               </a:ext>
             </a:extLst>
           </p:cNvSpPr>
@@ -2760,7 +2737,7 @@
           <a:lstStyle/>
           <a:p>
             <a:pPr/>
-            <a:fld id="{4F365610-5EA2-63A0-EC8E-A8F518C01AFD}" type="slidenum">
+            <a:fld id="{743B99ED-A399-6E6F-D783-553AD7CD2100}" type="slidenum">
               <a:t/>
             </a:fld>
           </a:p>
@@ -2771,6 +2748,7 @@
   <p:clrMapOvr>
     <a:masterClrMapping/>
   </p:clrMapOvr>
+  <p:hf hdr="0" ftr="0"/>
 </p:sldLayout>
 </file>
 
@@ -2806,7 +2784,7 @@
             <a:spLocks noGrp="1" noChangeArrowheads="1"/>
             <a:extLst>
               <a:ext uri="smNativeData">
-                <pr:smNativeData xmlns:pr="smNativeData" xmlns="smNativeData" val="SMDATA_15_AnHWaRMAAAAlAAAAZAAAAA8BAAAAkAAAAEgAAACQAAAASAAAAAAAAAABAAAAAAAAAAEAAABQAAAAAAAAAAAA4D8AAAAAAADgPwAAAAAAAOA/AAAAAAAA4D8AAAAAAADgPwAAAAAAAOA/AAAAAAAA4D8AAAAAAADgPwAAAAAAAOA/AAAAAAAA4D8CAAAAjAAAAAAAAAAAAAAAu+DjDP///wgAAAAAAAAAAAAAAAAAAAAAAAAAAAAAAAAAAAAAZAAAAAEAAABAAAAAAAAAAAAAAAAAAAAAAAAAAAAAAAAAAAAAAAAAAAAAAAAAAAAAAAAAAAAAAAAAAAAAAAAAAAAAAAAAAAAAAAAAAAAAAAAAAAAAAAAAAAAAAAAAAAAAFAAAADwAAAAAAAAAAAAAAAAAAAkUAAAAAQAAABQAAAAUAAAAFAAAAAEAAAAAAAAAZAAAAGQAAAAAAAAAZAAAAGQAAAAVAAAAYAAAAAAAAAAAAAAADwAAACADAAAAAAAAAAAAAAEAAACgMgAAVgcAAKr4//8BAAAAf39/AAEAAABkAAAAAAAAABQAAABAHwAAAAAAACYAAAAAAAAAwOD//wAAAAAmAAAAZAAAABYAAABMAAAAAAAAAAAAAAAEAAAAAAAAAAEAAACAgIAKAAAAACgAAAAoAAAAZAAAAGQAAAAAAAAAzMzMAAAAAABQAAAAUAAAAGQAAABkAAAAAAAAABcAAAAUAAAAAAAAAAAAAAD/fwAA/38AAAAAAAAJAAAABAAAAHsAfAAeAAAAaAAAAAAAAAAAAAAAAAAAAAAAAAAAAAAAECcAABAnAAAAAAAAAAAAAAAAAAAAAAAAAAAAAAAAAAAAAAAAAAAAABQAAAAAAAAAwMD/AAAAAABkAAAAMgAAAAAAAABkAAAAAAAAAH9/fwAKAAAAIgAAABgAAAAAAAAAAAAAAAAAAAAAAAAAAAAAAAAAAAAkAAAAJAAAAAAAAAAHAAAAAAAAAAAAAAAAAAAAAAAAAAAAAAAAAAAAf39/ACUAAABYAAAAAAAAAAAAAAAAAAAAAAAAAAAAAAAAAAAAAAAAAAAAAAAAAAAAAAAAAAAAAAA/AAAAAAAAAKCGAQAAAAAAAAAAAAAAAAAMAAAAAQAAAAAAAAAAAAAAAAAAAB8AAABUAAAAAAAABQAAAAEAAAAAAAAAAAAAAAAAAAAAAAAAAAAAAAAAAAAAAAAAAAAAAAJ/f38AAAAAA8zMzADAwP8Af39/AAAAAAAAAAAAAAAAAAAAAAAAAAAAIQAAABgAAAAUAAAAwAMAALABAABARwAAuAgAABAAAAAmAAAACAAAAP//////////"/>
+                <pr:smNativeData xmlns:pr="smNativeData" xmlns="smNativeData" val="SMDATA_15_7aDWaRMAAAAlAAAAZAAAAA8BAAAAkAAAAEgAAACQAAAASAAAAAAAAAABAAAAAAAAAAEAAABQAAAAAAAAAAAA4D8AAAAAAADgPwAAAAAAAOA/AAAAAAAA4D8AAAAAAADgPwAAAAAAAOA/AAAAAAAA4D8AAAAAAADgPwAAAAAAAOA/AAAAAAAA4D8CAAAAjAAAAAAAAAAAAAAAu+DjDP///wgAAAAAAAAAAAAAAAAAAAAAAAAAAAAAAAAAAAAAZAAAAAEAAABAAAAAAAAAAAAAAAAAAAAAAAAAAAAAAAAAAAAAAAAAAAAAAAAAAAAAAAAAAAAAAAAAAAAAAAAAAAAAAAAAAAAAAAAAAAAAAAAAAAAAAAAAAAAAAAAAAAAAFAAAADwAAAAAAAAAAAAAAAAAAAkUAAAAAQAAABQAAAAUAAAAFAAAAAEAAAAAAAAAZAAAAGQAAAAAAAAAZAAAAGQAAAAVAAAAYAAAAAAAAAAAAAAADwAAACADAAAAAAAAAAAAAAEAAACgMgAAVgcAAKr4//8BAAAAf39/AAEAAABkAAAAAAAAABQAAABAHwAAAAAAACYAAAAAAAAAwOD//wAAAAAmAAAAZAAAABYAAABMAAAAAAAAAAAAAAAEAAAAAAAAAAEAAACAgIAKAAAAACgAAAAoAAAAZAAAAGQAAAAAAAAAzMzMAAAAAABQAAAAUAAAAGQAAABkAAAAAAAAABcAAAAUAAAAAAAAAAAAAAD/fwAA/38AAAAAAAAJAAAABAAAAHsAfAAeAAAAaAAAAAAAAAAAAAAAAAAAAAAAAAAAAAAAECcAABAnAAAAAAAAAAAAAAAAAAAAAAAAAAAAAAAAAAAAAAAAAAAAABQAAAAAAAAAwMD/AAAAAABkAAAAMgAAAAAAAABkAAAAAAAAAH9/fwAKAAAAIgAAABgAAAAAAAAAAAAAAAAAAAAAAAAAAAAAAAAAAAAkAAAAJAAAAAAAAAAHAAAAAAAAAAAAAAAAAAAAAAAAAAAAAAAAAAAAf39/ACUAAABYAAAAAAAAAAAAAAAAAAAAAAAAAAAAAAAAAAAAAAAAAAAAAAAAAAAAAAAAAAAAAAA/AAAAAAAAAKCGAQAAAAAAAAAAAAAAAAAMAAAAAQAAAAAAAAAAAAAAAAAAAB8AAABUAAAAAAAABQAAAAEAAAAAAAAAAAAAAAAAAAAAAAAAAAAAAAAAAAAAAAAAAAAAAAJ/f38AAAAAA8zMzADAwP8Af39/AAAAAAAAAAAAAAAAAAAAAAAAAAAAIQAAABgAAAAUAAAAwAMAALABAABARwAAuAgAABAAAAAmAAAACAAAAP//////////"/>
               </a:ext>
             </a:extLst>
           </p:cNvSpPr>
@@ -2850,7 +2828,7 @@
             <a:spLocks noGrp="1" noChangeArrowheads="1"/>
             <a:extLst>
               <a:ext uri="smNativeData">
-                <pr:smNativeData xmlns:pr="smNativeData" xmlns="smNativeData" val="SMDATA_15_AnHWaRMAAAAlAAAAZAAAAA8BAAAAkAAAAEgAAACQAAAASAAAAAAAAAAAAAAAAAAAAAEAAABQAAAAAAAAAAAA4D8AAAAAAADgPwAAAAAAAOA/AAAAAAAA4D8AAAAAAADgPwAAAAAAAOA/AAAAAAAA4D8AAAAAAADgPwAAAAAAAOA/AAAAAAAA4D8CAAAAjAAAAAAAAAAAAAAAu+DjDP///wgAAAAAAAAAAAAAAAAAAAAAAAAAAAAAAAAAAAAAZAAAAAEAAABAAAAAAAAAAAAAAAAAAAAAAAAAAAAAAAAAAAAAAAAAAAAAAAAAAAAAAAAAAAAAAAAAAAAAAAAAAAAAAAAAAAAAAAAAAAAAAAAAAAAAAAAAAAAAAAAAAAAAFAAAADwAAAAAAAAAAAAAAAAAAAkUAAAAAQAAABQAAAAUAAAAFAAAAAEAAAAAAAAAZAAAAGQAAAAAAAAAZAAAAGQAAAAVAAAAYAAAAAAAAAAAAAAADwAAACADAAAAAAAAAAAAAAEAAACgMgAAVgcAAKr4//8BAAAAf39/AAEAAABkAAAAAAAAABQAAABAHwAAAAAAACYAAAAAAAAAwOD//wAAAAAmAAAAZAAAABYAAABMAAAAAAAAAAAAAAAEAAAAAAAAAAEAAACAgIAKAAAAACgAAAAoAAAAZAAAAGQAAAAAAAAAzMzMAAAAAABQAAAAUAAAAGQAAABkAAAAAAAAABcAAAAUAAAAAAAAAAAAAAD/fwAA/38AAAAAAAAJAAAABAAAAHsAfAAeAAAAaAAAAAAAAAAAAAAAAAAAAAAAAAAAAAAAECcAABAnAAAAAAAAAAAAAAAAAAAAAAAAAAAAAAAAAAAAAAAAAAAAABQAAAAAAAAAwMD/AAAAAABkAAAAMgAAAAAAAABkAAAAAAAAAH9/fwAKAAAAIgAAABgAAAAAAAAAAAAAAAAAAAAAAAAAAAAAAAAAAAAkAAAAJAAAAAAAAAAHAAAAAAAAAAAAAAAAAAAAAAAAAAAAAAAAAAAAf39/ACUAAABYAAAAAAAAAAAAAAAAAAAAAAAAAAAAAAAAAAAAAAAAAAAAAAAAAAAAAAAAAAAAAAA/AAAAAAAAAKCGAQAAAAAAAAAAAAAAAAAMAAAAAQAAAAAAAAAAAAAAAAAAAB8AAABUAAAAAAAABQAAAAEAAAAAAAAAAAAAAAAAAAAAAAAAAAAAAAAAAAAAAAAAAAAAAAJ/f38AAAAAA8zMzADAwP8Af39/AAAAAAAAAAAAAAAAAAAAAAAAAAAAIQAAABgAAAAUAAAAwAMAANgJAABARwAAsCUAABAAAAAmAAAACAAAAP//////////"/>
+                <pr:smNativeData xmlns:pr="smNativeData" xmlns="smNativeData" val="SMDATA_15_7aDWaRMAAAAlAAAAZAAAAA8BAAAAkAAAAEgAAACQAAAASAAAAAAAAAAAAAAAAAAAAAEAAABQAAAAAAAAAAAA4D8AAAAAAADgPwAAAAAAAOA/AAAAAAAA4D8AAAAAAADgPwAAAAAAAOA/AAAAAAAA4D8AAAAAAADgPwAAAAAAAOA/AAAAAAAA4D8CAAAAjAAAAAAAAAAAAAAAu+DjDP///wgAAAAAAAAAAAAAAAAAAAAAAAAAAAAAAAAAAAAAZAAAAAEAAABAAAAAAAAAAAAAAAAAAAAAAAAAAAAAAAAAAAAAAAAAAAAAAAAAAAAAAAAAAAAAAAAAAAAAAAAAAAAAAAAAAAAAAAAAAAAAAAAAAAAAAAAAAAAAAAAAAAAAFAAAADwAAAAAAAAAAAAAAAAAAAkUAAAAAQAAABQAAAAUAAAAFAAAAAEAAAAAAAAAZAAAAGQAAAAAAAAAZAAAAGQAAAAVAAAAYAAAAAAAAAAAAAAADwAAACADAAAAAAAAAAAAAAEAAACgMgAAVgcAAKr4//8BAAAAf39/AAEAAABkAAAAAAAAABQAAABAHwAAAAAAACYAAAAAAAAAwOD//wAAAAAmAAAAZAAAABYAAABMAAAAAAAAAAAAAAAEAAAAAAAAAAEAAACAgIAKAAAAACgAAAAoAAAAZAAAAGQAAAAAAAAAzMzMAAAAAABQAAAAUAAAAGQAAABkAAAAAAAAABcAAAAUAAAAAAAAAAAAAAD/fwAA/38AAAAAAAAJAAAABAAAAHsAfAAeAAAAaAAAAAAAAAAAAAAAAAAAAAAAAAAAAAAAECcAABAnAAAAAAAAAAAAAAAAAAAAAAAAAAAAAAAAAAAAAAAAAAAAABQAAAAAAAAAwMD/AAAAAABkAAAAMgAAAAAAAABkAAAAAAAAAH9/fwAKAAAAIgAAABgAAAAAAAAAAAAAAAAAAAAAAAAAAAAAAAAAAAAkAAAAJAAAAAAAAAAHAAAAAAAAAAAAAAAAAAAAAAAAAAAAAAAAAAAAf39/ACUAAABYAAAAAAAAAAAAAAAAAAAAAAAAAAAAAAAAAAAAAAAAAAAAAAAAAAAAAAAAAAAAAAA/AAAAAAAAAKCGAQAAAAAAAAAAAAAAAAAMAAAAAQAAAAAAAAAAAAAAAAAAAB8AAABUAAAAAAAABQAAAAEAAAAAAAAAAAAAAAAAAAAAAAAAAAAAAAAAAAAAAAAAAAAAAAJ/f38AAAAAA8zMzADAwP8Af39/AAAAAAAAAAAAAAAAAAAAAAAAAAAAIQAAABgAAAAUAAAAwAMAANgJAABARwAAsCUAABAAAAAmAAAACAAAAP//////////"/>
               </a:ext>
             </a:extLst>
           </p:cNvSpPr>
@@ -2918,7 +2896,7 @@
             <a:spLocks noGrp="1" noChangeArrowheads="1"/>
             <a:extLst>
               <a:ext uri="smNativeData">
-                <pr:smNativeData xmlns:pr="smNativeData" xmlns="smNativeData" val="SMDATA_15_AnHWaRMAAAAlAAAAZAAAAA8BAAAAkAAAAEgAAACQAAAASAAAAAAAAAABAAAAAAAAAAEAAABQAAAAAAAAAAAA4D8AAAAAAADgPwAAAAAAAOA/AAAAAAAA4D8AAAAAAADgPwAAAAAAAOA/AAAAAAAA4D8AAAAAAADgPwAAAAAAAOA/AAAAAAAA4D8CAAAAjAAAAAAAAAAAAAAAu+DjDP///wgAAAAAAAAAAAAAAAAAAAAAAAAAAAAAAAAAAAAAZAAAAAEAAABAAAAAAAAAAAAAAAAAAAAAAAAAAAAAAAAAAAAAAAAAAAAAAAAAAAAAAAAAAAAAAAAAAAAAAAAAAAAAAAAAAAAAAAAAAAAAAAAAAAAAAAAAAAAAAAAAAAAAFAAAADwAAAAAAAAAAAAAAAAAAAkUAAAAAQAAABQAAAAUAAAAFAAAAAEAAAAAAAAAZAAAAGQAAAAAAAAAZAAAAGQAAAAVAAAAYAAAAAAAAAAAAAAADwAAACADAAAAAAAAAAAAAAEAAACgMgAAVgcAAKr4//8BAAAAf39/AAEAAABkAAAAAAAAABQAAABAHwAAAAAAACYAAAAAAAAAwOD//wAAAAAmAAAAZAAAABYAAABMAAAAAAAAAAAAAAAEAAAAAAAAAAEAAACAgIAKAAAAACgAAAAoAAAAZAAAAGQAAAAAAAAAzMzMAAAAAABQAAAAUAAAAGQAAABkAAAAAAAAABcAAAAUAAAAAAAAAAAAAAD/fwAA/38AAAAAAAAJAAAABAAAAHsAfAAeAAAAaAAAAAAAAAAAAAAAAAAAAAAAAAAAAAAAECcAABAnAAAAAAAAAAAAAAAAAAAAAAAAAAAAAAAAAAAAAAAAAAAAABQAAAAAAAAAwMD/AAAAAABkAAAAMgAAAAAAAABkAAAAAAAAAH9/fwAKAAAAIgAAABgAAAAAAAAAAAAAAAAAAAAAAAAAAAAAAAAAAAAkAAAAJAAAAAAAAAAHAAAAAAAAAAAAAAAAAAAAAAAAAAAAAAAAAAAAf39/ACUAAABYAAAAAAAAAAAAAAAAAAAAAAAAAAAAAAAAAAAAAAAAAAAAAAAAAAAAAAAAAAAAAAA/AAAAAAAAAKCGAQAAAAAAAAAAAAAAAAAMAAAAAQAAAAAAAAAAAAAAAAAAAB8AAABUAAAAAAAABQAAAAEAAAAAAAAAAAAAAAAAAAAAAAAAAAAAAAAAAAAAAAAAAAAAAAJ/f38AAAAAA8zMzADAwP8Af39/AAAAAAAAAAAAAAAAAAAAAAAAAAAAIQAAABgAAAAUAAAAwAMAABsnAAA/FQAAWSkAABAAAAAmAAAACAAAAP//////////"/>
+                <pr:smNativeData xmlns:pr="smNativeData" xmlns="smNativeData" val="SMDATA_15_7aDWaRMAAAAlAAAAZAAAAA8BAAAAkAAAAEgAAACQAAAASAAAAAAAAAABAAAAAAAAAAEAAABQAAAAAAAAAAAA4D8AAAAAAADgPwAAAAAAAOA/AAAAAAAA4D8AAAAAAADgPwAAAAAAAOA/AAAAAAAA4D8AAAAAAADgPwAAAAAAAOA/AAAAAAAA4D8CAAAAjAAAAAAAAAAAAAAAu+DjDP///wgAAAAAAAAAAAAAAAAAAAAAAAAAAAAAAAAAAAAAZAAAAAEAAABAAAAAAAAAAAAAAAAAAAAAAAAAAAAAAAAAAAAAAAAAAAAAAAAAAAAAAAAAAAAAAAAAAAAAAAAAAAAAAAAAAAAAAAAAAAAAAAAAAAAAAAAAAAAAAAAAAAAAFAAAADwAAAAAAAAAAAAAAAAAAAkUAAAAAQAAABQAAAAUAAAAFAAAAAEAAAAAAAAAZAAAAGQAAAAAAAAAZAAAAGQAAAAVAAAAYAAAAAAAAAAAAAAADwAAACADAAAAAAAAAAAAAAEAAACgMgAAVgcAAKr4//8BAAAAf39/AAEAAABkAAAAAAAAABQAAABAHwAAAAAAACYAAAAAAAAAwOD//wAAAAAmAAAAZAAAABYAAABMAAAAAAAAAAAAAAAEAAAAAAAAAAEAAACAgIAKAAAAACgAAAAoAAAAZAAAAGQAAAAAAAAAzMzMAAAAAABQAAAAUAAAAGQAAABkAAAAAAAAABcAAAAUAAAAAAAAAAAAAAD/fwAA/38AAAAAAAAJAAAABAAAAHsAfAAeAAAAaAAAAAAAAAAAAAAAAAAAAAAAAAAAAAAAECcAABAnAAAAAAAAAAAAAAAAAAAAAAAAAAAAAAAAAAAAAAAAAAAAABQAAAAAAAAAwMD/AAAAAABkAAAAMgAAAAAAAABkAAAAAAAAAH9/fwAKAAAAIgAAABgAAAAAAAAAAAAAAAAAAAAAAAAAAAAAAAAAAAAkAAAAJAAAAAAAAAAHAAAAAAAAAAAAAAAAAAAAAAAAAAAAAAAAAAAAf39/ACUAAABYAAAAAAAAAAAAAAAAAAAAAAAAAAAAAAAAAAAAAAAAAAAAAAAAAAAAAAAAAAAAAAA/AAAAAAAAAKCGAQAAAAAAAAAAAAAAAAAMAAAAAQAAAAAAAAAAAAAAAAAAAB8AAABUAAAAAAAABQAAAAEAAAAAAAAAAAAAAAAAAAAAAAAAAAAAAAAAAAAAAAAAAAAAAAJ/f38AAAAAA8zMzADAwP8Af39/AAAAAAAAAAAAAAAAAAAAAAAAAAAAIQAAABgAAAAUAAAAwAMAABsnAAA/FQAAWSkAABAAAAAmAAAACAAAAP//////////"/>
               </a:ext>
             </a:extLst>
           </p:cNvSpPr>
@@ -2953,7 +2931,7 @@
           </a:lstStyle>
           <a:p>
             <a:pPr/>
-            <a:fld id="{600A0496-D88D-5FF2-C3B2-2EA74AFC357B}" type="datetime1">
+            <a:fld id="{06D32DB8-F6EB-86DB-A56B-008E63255355}" type="datetime1">
               <a:t/>
             </a:fld>
           </a:p>
@@ -2966,7 +2944,7 @@
             <a:spLocks noGrp="1" noChangeArrowheads="1"/>
             <a:extLst>
               <a:ext uri="smNativeData">
-                <pr:smNativeData xmlns:pr="smNativeData" xmlns="smNativeData" val="SMDATA_15_AnHWaRMAAAAlAAAAZAAAAA8BAAAAkAAAAEgAAACQAAAASAAAAAAAAAABAAAAAAAAAAEAAABQAAAAAAAAAAAA4D8AAAAAAADgPwAAAAAAAOA/AAAAAAAA4D8AAAAAAADgPwAAAAAAAOA/AAAAAAAA4D8AAAAAAADgPwAAAAAAAOA/AAAAAAAA4D8CAAAAjAAAAAAAAAAAAAAAu+DjDP///wgAAAAAAAAAAAAAAAAAAAAAAAAAAAAAAAAAAAAAZAAAAAEAAABAAAAAAAAAAAAAAAAAAAAAAAAAAAAAAAAAAAAAAAAAAAAAAAAAAAAAAAAAAAAAAAAAAAAAAAAAAAAAAAAAAAAAAAAAAAAAAAAAAAAAAAAAAAAAAAAAAAAAFAAAADwAAAAAAAAAAAAAAAAAAAkUAAAAAQAAABQAAAAUAAAAFAAAAAEAAAAAAAAAZAAAAGQAAAAAAAAAZAAAAGQAAAAVAAAAYAAAAAAAAAAAAAAADwAAACADAAAAAAAAAAAAAAEAAACgMgAAVgcAAKr4//8BAAAAf39/AAEAAABkAAAAAAAAABQAAABAHwAAAAAAACYAAAAAAAAAwOD//wAAAAAmAAAAZAAAABYAAABMAAAAAAAAAAAAAAAEAAAAAAAAAAEAAACAgIAKAAAAACgAAAAoAAAAZAAAAGQAAAAAAAAAzMzMAAAAAABQAAAAUAAAAGQAAABkAAAAAAAAABcAAAAUAAAAAAAAAAAAAAD/fwAA/38AAAAAAAAJAAAABAAAAAAAAAAeAAAAaAAAAAAAAAAAAAAAAAAAAAAAAAAAAAAAECcAABAnAAAAAAAAAAAAAAAAAAAAAAAAAAAAAAAAAAAAAAAAAAAAABQAAAAAAAAAwMD/AAAAAABkAAAAMgAAAAAAAABkAAAAAAAAAH9/fwAKAAAAIgAAABgAAAAAAAAAAAAAAAAAAAAAAAAAAAAAAAAAAAAkAAAAJAAAAAAAAAAHAAAAAAAAAAAAAAAAAAAAAAAAAAAAAAAAAAAAf39/ACUAAABYAAAAAAAAAAAAAAAAAAAAAAAAAAAAAAAAAAAAAAAAAAAAAAAAAAAAAAAAAAAAAAA/AAAAAAAAAKCGAQAAAAAAAAAAAAAAAAAMAAAAAQAAAAAAAAAAAAAAAAAAAB8AAABUAAAAAAAABQAAAAEAAAAAAAAAAAAAAAAAAAAAAAAAAAAAAAAAAAAAAAAAAAAAAAJ/f38AAAAAA8zMzADAwP8Af39/AAAAAAAAAAAAAAAAAAAAAAAAAAAAIQAAABgAAAAUAAAAoRkAABsnAABfMQAAWSkAABAAAAAmAAAACAAAAP//////////"/>
+                <pr:smNativeData xmlns:pr="smNativeData" xmlns="smNativeData" val="SMDATA_15_7aDWaRMAAAAlAAAAZAAAAA8BAAAAkAAAAEgAAACQAAAASAAAAAAAAAABAAAAAAAAAAEAAABQAAAAAAAAAAAA4D8AAAAAAADgPwAAAAAAAOA/AAAAAAAA4D8AAAAAAADgPwAAAAAAAOA/AAAAAAAA4D8AAAAAAADgPwAAAAAAAOA/AAAAAAAA4D8CAAAAjAAAAAAAAAAAAAAAu+DjDP///wgAAAAAAAAAAAAAAAAAAAAAAAAAAAAAAAAAAAAAZAAAAAEAAABAAAAAAAAAAAAAAAAAAAAAAAAAAAAAAAAAAAAAAAAAAAAAAAAAAAAAAAAAAAAAAAAAAAAAAAAAAAAAAAAAAAAAAAAAAAAAAAAAAAAAAAAAAAAAAAAAAAAAFAAAADwAAAAAAAAAAAAAAAAAAAkUAAAAAQAAABQAAAAUAAAAFAAAAAEAAAAAAAAAZAAAAGQAAAAAAAAAZAAAAGQAAAAVAAAAYAAAAAAAAAAAAAAADwAAACADAAAAAAAAAAAAAAEAAACgMgAAVgcAAKr4//8BAAAAf39/AAEAAABkAAAAAAAAABQAAABAHwAAAAAAACYAAAAAAAAAwOD//wAAAAAmAAAAZAAAABYAAABMAAAAAAAAAAAAAAAEAAAAAAAAAAEAAACAgIAKAAAAACgAAAAoAAAAZAAAAGQAAAAAAAAAzMzMAAAAAABQAAAAUAAAAGQAAABkAAAAAAAAABcAAAAUAAAAAAAAAAAAAAD/fwAA/38AAAAAAAAJAAAABAAAAAAAAAAeAAAAaAAAAAAAAAAAAAAAAAAAAAAAAAAAAAAAECcAABAnAAAAAAAAAAAAAAAAAAAAAAAAAAAAAAAAAAAAAAAAAAAAABQAAAAAAAAAwMD/AAAAAABkAAAAMgAAAAAAAABkAAAAAAAAAH9/fwAKAAAAIgAAABgAAAAAAAAAAAAAAAAAAAAAAAAAAAAAAAAAAAAkAAAAJAAAAAAAAAAHAAAAAAAAAAAAAAAAAAAAAAAAAAAAAAAAAAAAf39/ACUAAABYAAAAAAAAAAAAAAAAAAAAAAAAAAAAAAAAAAAAAAAAAAAAAAAAAAAAAAAAAAAAAAA/AAAAAAAAAKCGAQAAAAAAAAAAAAAAAAAMAAAAAQAAAAAAAAAAAAAAAAAAAB8AAABUAAAAAAAABQAAAAEAAAAAAAAAAAAAAAAAAAAAAAAAAAAAAAAAAAAAAAAAAAAAAAJ/f38AAAAAA8zMzADAwP8Af39/AAAAAAAAAAAAAAAAAAAAAAAAAAAAIQAAABgAAAAUAAAAoRkAABsnAABfMQAAWSkAABAAAAAmAAAACAAAAP//////////"/>
               </a:ext>
             </a:extLst>
           </p:cNvSpPr>
@@ -3001,9 +2979,6 @@
           </a:lstStyle>
           <a:p>
             <a:pPr/>
-            <a:r>
-              <a:t/>
-            </a:r>
           </a:p>
         </p:txBody>
       </p:sp>
@@ -3014,7 +2989,7 @@
             <a:spLocks noGrp="1" noChangeArrowheads="1"/>
             <a:extLst>
               <a:ext uri="smNativeData">
-                <pr:smNativeData xmlns:pr="smNativeData" xmlns="smNativeData" val="SMDATA_15_AnHWaRMAAAAlAAAAZAAAAA8BAAAAkAAAAEgAAACQAAAASAAAAAAAAAABAAAAAAAAAAEAAABQAAAAAAAAAAAA4D8AAAAAAADgPwAAAAAAAOA/AAAAAAAA4D8AAAAAAADgPwAAAAAAAOA/AAAAAAAA4D8AAAAAAADgPwAAAAAAAOA/AAAAAAAA4D8CAAAAjAAAAAAAAAAAAAAAu+DjDP///wgAAAAAAAAAAAAAAAAAAAAAAAAAAAAAAAAAAAAAZAAAAAEAAABAAAAAAAAAAAAAAAAAAAAAAAAAAAAAAAAAAAAAAAAAAAAAAAAAAAAAAAAAAAAAAAAAAAAAAAAAAAAAAAAAAAAAAAAAAAAAAAAAAAAAAAAAAAAAAAAAAAAAFAAAADwAAAAAAAAAAAAAAAAAAAkUAAAAAQAAABQAAAAUAAAAFAAAAAEAAAAAAAAAZAAAAGQAAAAAAAAAZAAAAGQAAAAVAAAAYAAAAAAAAAAAAAAADwAAACADAAAAAAAAAAAAAAEAAACgMgAAVgcAAKr4//8BAAAAf39/AAEAAABkAAAAAAAAABQAAABAHwAAAAAAACYAAAAAAAAAwOD//wAAAAAmAAAAZAAAABYAAABMAAAAAAAAAAAAAAAEAAAAAAAAAAEAAACAgIAKAAAAACgAAAAoAAAAZAAAAGQAAAAAAAAAzMzMAAAAAABQAAAAUAAAAGQAAABkAAAAAAAAABcAAAAUAAAAAAAAAAAAAAD/fwAA/38AAAAAAAAJAAAABAAAAP////8eAAAAaAAAAAAAAAAAAAAAAAAAAAAAAAAAAAAAECcAABAnAAAAAAAAAAAAAAAAAAAAAAAAAAAAAAAAAAAAAAAAAAAAABQAAAAAAAAAwMD/AAAAAABkAAAAMgAAAAAAAABkAAAAAAAAAH9/fwAKAAAAIgAAABgAAAAAAAAAAAAAAAAAAAAAAAAAAAAAAAAAAAAkAAAAJAAAAAAAAAAHAAAAAAAAAAAAAAAAAAAAAAAAAAAAAAAAAAAAf39/ACUAAABYAAAAAAAAAAAAAAAAAAAAAAAAAAAAAAAAAAAAAAAAAAAAAAAAAAAAAAAAAAAAAAA/AAAAAAAAAKCGAQAAAAAAAAAAAAAAAAAMAAAAAQAAAAAAAAAAAAAAAAAAAB8AAABUAAAAAAAABQAAAAEAAAAAAAAAAAAAAAAAAAAAAAAAAAAAAAAAAAAAAAAAAAAAAAJ/f38AAAAAA8zMzADAwP8Af39/AAAAAAAAAAAAAAAAAAAAAAAAAAAAIQAAABgAAAAUAAAAwTUAABsnAABARwAAWSkAABAAAAAmAAAACAAAAP//////////"/>
+                <pr:smNativeData xmlns:pr="smNativeData" xmlns="smNativeData" val="SMDATA_15_7aDWaRMAAAAlAAAAZAAAAA8BAAAAkAAAAEgAAACQAAAASAAAAAAAAAABAAAAAAAAAAEAAABQAAAAAAAAAAAA4D8AAAAAAADgPwAAAAAAAOA/AAAAAAAA4D8AAAAAAADgPwAAAAAAAOA/AAAAAAAA4D8AAAAAAADgPwAAAAAAAOA/AAAAAAAA4D8CAAAAjAAAAAAAAAAAAAAAu+DjDP///wgAAAAAAAAAAAAAAAAAAAAAAAAAAAAAAAAAAAAAZAAAAAEAAABAAAAAAAAAAAAAAAAAAAAAAAAAAAAAAAAAAAAAAAAAAAAAAAAAAAAAAAAAAAAAAAAAAAAAAAAAAAAAAAAAAAAAAAAAAAAAAAAAAAAAAAAAAAAAAAAAAAAAFAAAADwAAAAAAAAAAAAAAAAAAAkUAAAAAQAAABQAAAAUAAAAFAAAAAEAAAAAAAAAZAAAAGQAAAAAAAAAZAAAAGQAAAAVAAAAYAAAAAAAAAAAAAAADwAAACADAAAAAAAAAAAAAAEAAACgMgAAVgcAAKr4//8BAAAAf39/AAEAAABkAAAAAAAAABQAAABAHwAAAAAAACYAAAAAAAAAwOD//wAAAAAmAAAAZAAAABYAAABMAAAAAAAAAAAAAAAEAAAAAAAAAAEAAACAgIAKAAAAACgAAAAoAAAAZAAAAGQAAAAAAAAAzMzMAAAAAABQAAAAUAAAAGQAAABkAAAAAAAAABcAAAAUAAAAAAAAAAAAAAD/fwAA/38AAAAAAAAJAAAABAAAAP////8eAAAAaAAAAAAAAAAAAAAAAAAAAAAAAAAAAAAAECcAABAnAAAAAAAAAAAAAAAAAAAAAAAAAAAAAAAAAAAAAAAAAAAAABQAAAAAAAAAwMD/AAAAAABkAAAAMgAAAAAAAABkAAAAAAAAAH9/fwAKAAAAIgAAABgAAAAAAAAAAAAAAAAAAAAAAAAAAAAAAAAAAAAkAAAAJAAAAAAAAAAHAAAAAAAAAAAAAAAAAAAAAAAAAAAAAAAAAAAAf39/ACUAAABYAAAAAAAAAAAAAAAAAAAAAAAAAAAAAAAAAAAAAAAAAAAAAAAAAAAAAAAAAAAAAAA/AAAAAAAAAKCGAQAAAAAAAAAAAAAAAAAMAAAAAQAAAAAAAAAAAAAAAAAAAB8AAABUAAAAAAAABQAAAAEAAAAAAAAAAAAAAAAAAAAAAAAAAAAAAAAAAAAAAAAAAAAAAAJ/f38AAAAAA8zMzADAwP8Af39/AAAAAAAAAAAAAAAAAAAAAAAAAAAAIQAAABgAAAAUAAAAwTUAABsnAABARwAAWSkAABAAAAAmAAAACAAAAP//////////"/>
               </a:ext>
             </a:extLst>
           </p:cNvSpPr>
@@ -3049,7 +3024,7 @@
           </a:lstStyle>
           <a:p>
             <a:pPr/>
-            <a:fld id="{789602D5-9B95-C3F4-DB2E-6DA14C602D38}" type="slidenum">
+            <a:fld id="{2850A038-76C5-0556-8BE8-8003EEA67DD5}" type="slidenum">
               <a:t/>
             </a:fld>
           </a:p>
@@ -3721,276 +3696,213 @@
           <a:chExt cx="0" cy="0"/>
         </a:xfrm>
       </p:grpSpPr>
-      <p:grpSp>
-        <p:nvGrpSpPr>
-          <p:cNvPr id="2" name="Group2"/>
-          <p:cNvGrpSpPr>
-            <a:extLst>
-              <a:ext uri="smNativeData">
-                <pr:smNativeData xmlns:pr="smNativeData" xmlns="smNativeData" val="SMDATA_6_AnHWaRMAAAAlAAAAAQAAAC8BAAAAkAAAAEgAAACQAAAASAAAAAAAAAAAAAAAAAAAABcAAAAUAAAAAAAAAAAAAAD/fwAA/38AAAAAAAAJAAAABAAAAAUAAAAfAAAAVAAAAAAAAAAAAAAAAAAAAAAAAAAAAAAAAAAAAAAAAAAAAAAAAAAAAAAAAAAAAAAAAAAAAAAAAAAAAAAAAAAAAAAAAAAAAAAAAAAAAAAAAAAAAAAAAAAAACEAAAAYAAAAFAAAAN0TAAA1DQAAaTUAAHUPAAAAAAAAJgAAAAgAAAD/////AAAAAA=="/>
-              </a:ext>
-            </a:extLst>
-          </p:cNvGrpSpPr>
+      <p:sp>
+        <p:nvSpPr>
+          <p:cNvPr id="2" name="Textbox1"/>
+          <p:cNvSpPr txBox="1">
+            <a:extLst>
+              <a:ext uri="smNativeData">
+                <pr:smNativeData xmlns:pr="smNativeData" xmlns="smNativeData" val="SMDATA_15_7aDWaRMAAAAlAAAAEgAAAE8BAAAAkAAAAEgAAACQAAAASAAAAAAAAAAAAAAAAAAAAAEAAABQAAAAAAAAAAAA4D8AAAAAAADgPwAAAAAAAOA/AAAAAAAA4D8AAAAAAADgPwAAAAAAAOA/AAAAAAAA4D8AAAAAAADgPwAAAAAAAOA/AAAAAAAA4D8CAAAAjAAAAAAAAAAAAAAAu+DjDP///wgAAAAAAAAAAAAAAAAAAAAAAAAAAAAAAAAAAAAAZAAAAAEAAABAAAAAAAAAAAAAAAAAAAAAAAAAAAAAAAAAAAAAAAAAAAAAAAAAAAAAAAAAAAAAAAAAAAAAAAAAAAAAAAAAAAAAAAAAAAAAAAAAAAAAAAAAAAAAAAAAAAAAFAAAADwAAAAAAAAAAAAAAAAAAAkUAAAAAQAAABQAAAAUAAAAFAAAAAEAAAAAAAAAZAAAAGQAAAAAAAAAZAAAAGQAAAAVAAAAYAAAAAAAAAAAAAAADwAAACADAAAAAAAAAAAAAAEAAACgMgAAVgcAAKr4//8BAAAAf39/AAEAAABkAAAAAAAAABQAAABAHwAAAAAAACYAAAAAAAAAwOD//wAAAAAmAAAAZAAAABYAAABMAAAAAAAAAAAAAAAEAAAAAAAAAAEAAACAgIAKAAAAACgAAAAoAAAAZAAAAGQAAAAAAAAAzMzMAAAAAABQAAAAUAAAAGQAAABkAAAAAAAAABcAAAAUAAAAAAAAANwIAAD/fwAA/38AAAAAAAAJAAAABAAAACMAAAAeAAAAaAAAAAAAAAAAAAAAAAAAAAAAAAAAAAAAECcAABAnAAAAAAAAAAAAAAAAAAAAAAAAAAAAAAAAAAAAAAAAAAAAABQAAAAAAAAAwMD/AAAAAABkAAAAMgAAAAAAAABkAAAAAAAAAH9/fwAKAAAAIgAAABgAAAAAAAAAAAAAAAAAAAAAAAAAAAAAAAAAAAAkAAAAJAAAAAAAAAAHAAAAAAAAAAAAAAAAAAAAAAAAAAAAAAAAAAAAf39/ACUAAABYAAAAAAAAAAAAAAAAAAAAAAAAAAAAAAAAAAAAAAAAAAAAAAAAAAAAAAAAAAAAAAA/AAAAAAAAAKCGAQAAAAAAAAAAAAAAAAAMAAAAAQAAAAAAAAAAAAAAAAAAAB8AAABUAAAAu+DjBf///wEAAAAAAAAAAAAAAAAAAAAAAAAAAAAAAAAAAAAAAAAAAAAAAAJ/f38AgICAA8zMzADAwP8Af39/AAAAAAAAAAAAAAAAAAAAAAAAAAAAIQAAABgAAAAUAAAA3yIAADUNAABpNQAAdQ8AAAAgAAAmAAAACAAAAP//////////"/>
+              </a:ext>
+            </a:extLst>
+          </p:cNvSpPr>
           <p:nvPr/>
-        </p:nvGrpSpPr>
-        <p:grpSpPr>
+        </p:nvSpPr>
+        <p:spPr>
           <a:xfrm>
-            <a:off x="3228975" y="2146935"/>
-            <a:ext cx="5453380" cy="365760"/>
-            <a:chOff x="3228975" y="2146935"/>
-            <a:chExt cx="5453380" cy="365760"/>
-          </a:xfrm>
-        </p:grpSpPr>
-        <p:cxnSp>
-          <p:nvCxnSpPr>
-            <p:cNvPr id="4" name="Connector1"/>
-            <p:cNvCxnSpPr>
-              <a:extLst>
-                <a:ext uri="smNativeData">
-                  <pr:smNativeData xmlns:pr="smNativeData" xmlns="smNativeData" val="SMDATA_15_AnHWaRMAAAAlAAAADQAAAA8BAAAAkAAAAEgAAACQAAAASAAAAAAAAAAAAAAAAAAAAAEAAABQAAAAAAAAAAAA4D8AAAAAAADgPwAAAAAAAOA/AAAAAAAA4D8AAAAAAADgPwAAAAAAAOA/AAAAAAAA4D8AAAAAAADgPwAAAAAAAOA/AAAAAAAA4D8CAAAAjAAAAAAAAAAAAAAAu+DjDP///wgAAAAAAAAAAAAAAAAAAAAAAAAAAAAAAAAAAAAAZAAAAAEAAABAAAAAAAAAAAAAAAAAAAAAAAAAAAAAAAAAAAAAAAAAAAAAAAAAAAAAAAAAAAAAAAAAAAAAAAAAAAAAAAAAAAAAAAAAAAAAAAAAAAAAAAAAAAAAAAAAAAAAFAAAADwAAAABAAAAAAAAAAAAAAlkAAAAAQAAABQAAAAUAAAAFAAAAAEAAAAAAAAAZAAAAGQAAAABAAAAlgAAAJYAAAAVAAAAYAAAAAAAAAAAAAAADwAAACADAAAAAAAAAAAAAAEAAACgMgAAVgcAAKr4//8BAAAAf39/AAEAAABkAAAAAAAAABQAAABAHwAAAAAAACYAAAAAAAAAwOD//wAAAAAmAAAAZAAAABYAAABMAAAAAAAAAAAAAAAEAAAAAAAAAAEAAACAgIAKAAAAACgAAAAoAAAAZAAAAGQAAAAAAAAAzMzMAAAAAABQAAAAUAAAAGQAAABkAAAAAAAAABcAAAAUAAAAAAAAAAAAAAD/fwAA/38AAAAAAAAJAAAABAAAAAAAAQAeAAAAaAAAAAAAAAAAAAAAAAAAAAAAAAAAAAAAECcAABAnAAAAAAAAAAAAAAAAAAAAAAAAAAAAAAAAAAAAAAAAAAAAABQAAAAAAAAAwMD/AAAAAABkAAAAMgAAAAAAAABkAAAAAAAAAH9/fwAKAAAAIgAAABgAAAAAAAAAAAAAAAAAAAAAAAAAAAAAAAAAAAAkAAAAJAAAAAAAAAAHAAAAAAAAAAAAAAAAAAAAAAAAAAAAAAAAAAAAf39/ACUAAABYAAAAAAAAAAAAAAAAAAAAAAAAAAAAAAAAAAAAAAAAAAAAAAAAAAAAAAAAAAAAAAA/AAAAAAAAAKCGAQAAAAAAAAAAAAAAAAAMAAAAAQAAAAAAAAAAAAAAAAAAAB8AAABUAAAAu+DjBf///wEAAAAAAAAAAAAAAAAAAAAAAAAAAAAAAAAAAAAAAAAAAAAAAAJ/f38AgICAA8zMzADAwP8Af39/AAAAAAAAAAAAAAAAAAAAAAAAAAAAIQAAABgAAAAUAAAA3RMAABcOAACqIAAAFw4AAAAAAAAmAAAACAAAAP//////////"/>
-                </a:ext>
-              </a:extLst>
-            </p:cNvCxnSpPr>
-            <p:nvPr/>
-          </p:nvCxnSpPr>
-          <p:spPr>
-            <a:xfrm flipH="1">
-              <a:off x="4269105" y="1250315"/>
-              <a:ext cx="0" cy="2080895"/>
-            </a:xfrm>
-            <a:prstGeom prst="straightConnector1">
-              <a:avLst/>
-            </a:prstGeom>
+            <a:off x="5668645" y="2146935"/>
+            <a:ext cx="3013710" cy="365760"/>
+          </a:xfrm>
+          <a:prstGeom prst="rect">
+            <a:avLst/>
+          </a:prstGeom>
+          <a:noFill/>
+          <a:ln>
             <a:noFill/>
-            <a:ln w="63500" cap="flat" cmpd="sng" algn="ctr">
-              <a:solidFill>
-                <a:schemeClr val="tx1"/>
-              </a:solidFill>
-              <a:prstDash val="solid"/>
-              <a:headEnd type="none"/>
-              <a:tailEnd type="stealth" w="lg" len="lg"/>
-            </a:ln>
-            <a:effectLst/>
-          </p:spPr>
-        </p:cxnSp>
-        <p:sp>
-          <p:nvSpPr>
-            <p:cNvPr id="3" name="Textbox1"/>
-            <p:cNvSpPr txBox="1">
-              <a:extLst>
-                <a:ext uri="smNativeData">
-                  <pr:smNativeData xmlns:pr="smNativeData" xmlns="smNativeData" val="SMDATA_15_AnHWaRMAAAAlAAAAEgAAAE8BAAAAkAAAAEgAAACQAAAASAAAAAAAAAAAAAAAAAAAAAEAAABQAAAAAAAAAAAA4D8AAAAAAADgPwAAAAAAAOA/AAAAAAAA4D8AAAAAAADgPwAAAAAAAOA/AAAAAAAA4D8AAAAAAADgPwAAAAAAAOA/AAAAAAAA4D8CAAAAjAAAAAAAAAAAAAAAu+DjDP///wgAAAAAAAAAAAAAAAAAAAAAAAAAAAAAAAAAAAAAZAAAAAEAAABAAAAAAAAAAAAAAAAAAAAAAAAAAAAAAAAAAAAAAAAAAAAAAAAAAAAAAAAAAAAAAAAAAAAAAAAAAAAAAAAAAAAAAAAAAAAAAAAAAAAAAAAAAAAAAAAAAAAAFAAAADwAAAAAAAAAAAAAAAAAAAkUAAAAAQAAABQAAAAUAAAAFAAAAAEAAAAAAAAAZAAAAGQAAAAAAAAAZAAAAGQAAAAVAAAAYAAAAAAAAAAAAAAADwAAACADAAAAAAAAAAAAAAEAAACgMgAAVgcAAKr4//8BAAAAf39/AAEAAABkAAAAAAAAABQAAABAHwAAAAAAACYAAAAAAAAAwOD//wAAAAAmAAAAZAAAABYAAABMAAAAAAAAAAAAAAAEAAAAAAAAAAEAAACAgIAKAAAAACgAAAAoAAAAZAAAAGQAAAAAAAAAzMzMAAAAAABQAAAAUAAAAGQAAABkAAAAAAAAABcAAAAUAAAAAAAAANwIAAD/fwAA/38AAAAAAAAJAAAABAAAACMAAAAeAAAAaAAAAAAAAAAAAAAAAAAAAAAAAAAAAAAAECcAABAnAAAAAAAAAAAAAAAAAAAAAAAAAAAAAAAAAAAAAAAAAAAAABQAAAAAAAAAwMD/AAAAAABkAAAAMgAAAAAAAABkAAAAAAAAAH9/fwAKAAAAIgAAABgAAAAAAAAAAAAAAAAAAAAAAAAAAAAAAAAAAAAkAAAAJAAAAAAAAAAHAAAAAAAAAAAAAAAAAAAAAAAAAAAAAAAAAAAAf39/ACUAAABYAAAAAAAAAAAAAAAAAAAAAAAAAAAAAAAAAAAAAAAAAAAAAAAAAAAAAAAAAAAAAAA/AAAAAAAAAKCGAQAAAAAAAAAAAAAAAAAMAAAAAQAAAAAAAAAAAAAAAAAAAB8AAABUAAAAu+DjBf///wEAAAAAAAAAAAAAAAAAAAAAAAAAAAAAAAAAAAAAAAAAAAAAAAJ/f38AgICAA8zMzADAwP8Af39/AAAAAAAAAAAAAAAAAAAAAAAAAAAAIQAAABgAAAAUAAAA3yIAADUNAABpNQAAdQ8AAAAgAAAmAAAACAAAAP//////////"/>
-                </a:ext>
-              </a:extLst>
-            </p:cNvSpPr>
-            <p:nvPr/>
-          </p:nvSpPr>
-          <p:spPr>
-            <a:xfrm>
-              <a:off x="5668645" y="2146935"/>
-              <a:ext cx="3013710" cy="365760"/>
-            </a:xfrm>
-            <a:prstGeom prst="rect">
-              <a:avLst/>
-            </a:prstGeom>
+          </a:ln>
+          <a:effectLst/>
+        </p:spPr>
+        <p:txBody>
+          <a:bodyPr vert="horz" wrap="square" numCol="1" spcCol="215900" anchor="t"/>
+          <a:lstStyle/>
+          <a:p>
+            <a:pPr/>
+            <a:r>
+              <a:t>Strong reference (ownership)</a:t>
+            </a:r>
+          </a:p>
+        </p:txBody>
+      </p:sp>
+      <p:sp>
+        <p:nvSpPr>
+          <p:cNvPr id="3" name="Textbox2"/>
+          <p:cNvSpPr txBox="1">
+            <a:extLst>
+              <a:ext uri="smNativeData">
+                <pr:smNativeData xmlns:pr="smNativeData" xmlns="smNativeData" val="SMDATA_15_7aDWaRMAAAAlAAAAEgAAAE8BAAAAkAAAAEgAAACQAAAASAAAAAAAAAAAAAAAAAAAAAEAAABQAAAAAAAAAAAA4D8AAAAAAADgPwAAAAAAAOA/AAAAAAAA4D8AAAAAAADgPwAAAAAAAOA/AAAAAAAA4D8AAAAAAADgPwAAAAAAAOA/AAAAAAAA4D8CAAAAjAAAAAAAAAAAAAAAu+DjDP///wgAAAAAAAAAAAAAAAAAAAAAAAAAAAAAAAAAAAAAZAAAAAEAAABAAAAAAAAAAAAAAAAAAAAAAAAAAAAAAAAAAAAAAAAAAAAAAAAAAAAAAAAAAAAAAAAAAAAAAAAAAAAAAAAAAAAAAAAAAAAAAAAAAAAAAAAAAAAAAAAAAAAAFAAAADwAAAAAAAAAAAAAAAAAAAkUAAAAAQAAABQAAAAUAAAAFAAAAAEAAAAAAAAAZAAAAGQAAAAAAAAAZAAAAGQAAAAVAAAAYAAAAAAAAAAAAAAADwAAACADAAAAAAAAAAAAAAEAAACgMgAAVgcAAKr4//8BAAAAf39/AAEAAABkAAAAAAAAABQAAABAHwAAAAAAACYAAAAAAAAAwOD//wAAAAAmAAAAZAAAABYAAABMAAAAAAAAAAAAAAAEAAAAAAAAAAEAAACAgIAKAAAAACgAAAAoAAAAZAAAAGQAAAAAAAAAzMzMAAAAAABQAAAAUAAAAGQAAABkAAAAAAAAABcAAAAUAAAAAAAAANwIAAD/fwAA/38AAAAAAAAJAAAABAAAAEkAAAAeAAAAaAAAAAAAAAAAAAAAAAAAAAAAAAAAAAAAECcAABAnAAAAAAAAAAAAAAAAAAAAAAAAAAAAAAAAAAAAAAAAAAAAABQAAAAAAAAAwMD/AAAAAABkAAAAMgAAAAAAAABkAAAAAAAAAH9/fwAKAAAAIgAAABgAAAAAAAAAAAAAAAAAAAAAAAAAAAAAAAAAAAAkAAAAJAAAAAAAAAAHAAAAAAAAAAAAAAAAAAAAAAAAAAAAAAAAAAAAf39/ACUAAABYAAAAAAAAAAAAAAAAAAAAAAAAAAAAAAAAAAAAAAAAAAAAAAAAAAAAAAAAAAAAAAA/AAAAAAAAAKCGAQAAAAAAAAAAAAAAAAAMAAAAAQAAAAAAAAAAAAAAAAAAAB8AAABUAAAAu+DjBf///wEAAAAAAAAAAAAAAAAAAAAAAAAAAAAAAAAAAAAAAAAAAAAAAAJ/f38AgICAA8zMzADAwP8Af39/AAAAAAAAAAAAAAAAAAAAAAAAAAAAIQAAABgAAAAUAAAA3yIAAO4QAABpNQAALhMAAAAgAAAmAAAACAAAAP//////////"/>
+              </a:ext>
+            </a:extLst>
+          </p:cNvSpPr>
+          <p:nvPr/>
+        </p:nvSpPr>
+        <p:spPr>
+          <a:xfrm>
+            <a:off x="5668645" y="2752090"/>
+            <a:ext cx="3013710" cy="365760"/>
+          </a:xfrm>
+          <a:prstGeom prst="rect">
+            <a:avLst/>
+          </a:prstGeom>
+          <a:noFill/>
+          <a:ln>
             <a:noFill/>
-            <a:ln>
-              <a:noFill/>
-            </a:ln>
-            <a:effectLst/>
-          </p:spPr>
-          <p:txBody>
-            <a:bodyPr vert="horz" wrap="square" numCol="1" spcCol="215900" anchor="t"/>
-            <a:lstStyle/>
-            <a:p>
-              <a:pPr/>
-              <a:r>
-                <a:t>Strong reference (ownership)</a:t>
-              </a:r>
-            </a:p>
-          </p:txBody>
-        </p:sp>
-      </p:grpSp>
-      <p:grpSp>
-        <p:nvGrpSpPr>
-          <p:cNvPr id="5" name="Group1"/>
-          <p:cNvGrpSpPr>
-            <a:extLst>
-              <a:ext uri="smNativeData">
-                <pr:smNativeData xmlns:pr="smNativeData" xmlns="smNativeData" val="SMDATA_6_AnHWaRMAAAAlAAAAAQAAAC8BAAAAkAAAAEgAAACQAAAASAAAAAAAAAAAAAAAAAAAABcAAAAUAAAAAAAAAAAAAAD/fwAA/38AAAAAAAAJAAAABAAAAAUAAAAfAAAAVAAAAAAAAAAAAAAAAAAAAAAAAAAAAAAAAAAAAAAAAAAAAAAAAAAAAAAAAAAAAAAAAAAAAAAAAAAAAAAAAAAAAAAAAAAAAAAAAAAAAAAAAAAAAAAAAAAAACEAAAAYAAAAFAAAAN0TAADuEAAAaTUAAC4TAAAAAAAAJgAAAAgAAAD/////AAAAAA=="/>
-              </a:ext>
-            </a:extLst>
-          </p:cNvGrpSpPr>
+          </a:ln>
+          <a:effectLst/>
+        </p:spPr>
+        <p:txBody>
+          <a:bodyPr vert="horz" wrap="square" numCol="1" spcCol="215900" anchor="t"/>
+          <a:lstStyle/>
+          <a:p>
+            <a:pPr/>
+            <a:r>
+              <a:t>Weak reference</a:t>
+            </a:r>
+          </a:p>
+        </p:txBody>
+      </p:sp>
+      <p:sp>
+        <p:nvSpPr>
+          <p:cNvPr id="4" name="Textbox3"/>
+          <p:cNvSpPr txBox="1">
+            <a:extLst>
+              <a:ext uri="smNativeData">
+                <pr:smNativeData xmlns:pr="smNativeData" xmlns="smNativeData" val="SMDATA_15_7aDWaRMAAAAlAAAAEgAAAE8BAAAAkAAAAEgAAACQAAAASAAAAAAAAAAAAAAAAAAAAAEAAABQAAAAAAAAAAAA4D8AAAAAAADgPwAAAAAAAOA/AAAAAAAA4D8AAAAAAADgPwAAAAAAAOA/AAAAAAAA4D8AAAAAAADgPwAAAAAAAOA/AAAAAAAA4D8CAAAAjAAAAAAAAAAAAAAAu+DjDP///wgAAAAAAAAAAAAAAAAAAAAAAAAAAAAAAAAAAAAAZAAAAAEAAABAAAAAAAAAAAAAAAAAAAAAAAAAAAAAAAAAAAAAAAAAAAAAAAAAAAAAAAAAAAAAAAAAAAAAAAAAAAAAAAAAAAAAAAAAAAAAAAAAAAAAAAAAAAAAAAAAAAAAFAAAADwAAAAAAAAAAAAAAAAAAAkUAAAAAQAAABQAAAAUAAAAFAAAAAEAAAAAAAAAZAAAAGQAAAAAAAAAZAAAAGQAAAAVAAAAYAAAAAAAAAAAAAAADwAAACADAAAAAAAAAAAAAAEAAACgMgAAVgcAAKr4//8BAAAAf39/AAEAAABkAAAAAAAAABQAAABAHwAAAAAAACYAAAAAAAAAwOD//wAAAAAmAAAAZAAAABYAAABMAAAAAAAAAAAAAAAEAAAAAAAAAAEAAACAgIAKAAAAACgAAAAoAAAAZAAAAGQAAAAAAAAAzMzMAAAAAABQAAAAUAAAAGQAAABkAAAAAAAAABcAAAAUAAAAAAAAANwIAAD/fwAA/38AAAAAAAAJAAAABAAAAAAAAQAeAAAAaAAAAAAAAAAAAAAAAAAAAAAAAAAAAAAAECcAABAnAAAAAAAAAAAAAAAAAAAAAAAAAAAAAAAAAAAAAAAAAAAAABQAAAAAAAAAwMD/AAAAAABkAAAAMgAAAAAAAABkAAAAAAAAAH9/fwAKAAAAIgAAABgAAAAAAAAAAAAAAAAAAAAAAAAAAAAAAAAAAAAkAAAAJAAAAAAAAAAHAAAAAAAAAAAAAAAAAAAAAAAAAAAAAAAAAAAAf39/ACUAAABYAAAAAAAAAAAAAAAAAAAAAAAAAAAAAAAAAAAAAAAAAAAAAAAAAAAAAAAAAAAAAAA/AAAAAAAAAKCGAQAAAAAAAAAAAAAAAAAMAAAAAQAAAAAAAAAAAAAAAAAAAB8AAABUAAAAu+DjBf///wEAAAAAAAAAAAAAAAAAAAAAAAAAAAAAAAAAAAAAAAAAAAAAAAJ/f38AgICAA8zMzADAwP8Af39/AAAAAAAAAAAAAAAAAAAAAAAAAAAAIQAAABgAAAAUAAAA3yIAAKcUAABpNQAA5xYAAAAgAAAmAAAACAAAAP//////////"/>
+              </a:ext>
+            </a:extLst>
+          </p:cNvSpPr>
           <p:nvPr/>
-        </p:nvGrpSpPr>
-        <p:grpSpPr>
+        </p:nvSpPr>
+        <p:spPr>
           <a:xfrm>
-            <a:off x="3228975" y="2752090"/>
-            <a:ext cx="5453380" cy="365760"/>
-            <a:chOff x="3228975" y="2752090"/>
-            <a:chExt cx="5453380" cy="365760"/>
-          </a:xfrm>
-        </p:grpSpPr>
-        <p:cxnSp>
-          <p:nvCxnSpPr>
-            <p:cNvPr id="7" name="Connector2"/>
-            <p:cNvCxnSpPr>
-              <a:extLst>
-                <a:ext uri="smNativeData">
-                  <pr:smNativeData xmlns:pr="smNativeData" xmlns="smNativeData" val="SMDATA_15_AnHWaRMAAAAlAAAADQAAAA8BAAAAkAAAAEgAAACQAAAASAAAAAAAAAAAAAAAAAAAAAEAAABQAAAAAAAAAAAA4D8AAAAAAADgPwAAAAAAAOA/AAAAAAAA4D8AAAAAAADgPwAAAAAAAOA/AAAAAAAA4D8AAAAAAADgPwAAAAAAAOA/AAAAAAAA4D8CAAAAjAAAAAAAAAAAAAAAu+DjDP///wgAAAAAAAAAAAAAAAAAAAAAAAAAAAAAAAAAAAAAZAAAAAEAAABAAAAAAAAAAAAAAAAAAAAAAAAAAAAAAAAAAAAAAAAAAAAAAAAAAAAAAAAAAAAAAAAAAAAAAAAAAAAAAAAAAAAAAAAAAAAAAAAAAAAAAAAAAAAAAAAAAAAAFAAAADwAAAABAAAAAQAAAAAAAAlkAAAAAQAAABQAAAAUAAAAFAAAAAEAAAAAAAAAZAAAAGQAAAABAAAAlgAAAJYAAAAVAAAAYAAAAAAAAAAAAAAADwAAACADAAAAAAAAAAAAAAEAAACgMgAAVgcAAKr4//8BAAAAf39/AAEAAABkAAAAAAAAABQAAABAHwAAAAAAACYAAAAAAAAAwOD//wAAAAAmAAAAZAAAABYAAABMAAAAAAAAAAAAAAAEAAAAAAAAAAEAAACAgIAKAAAAACgAAAAoAAAAZAAAAGQAAAAAAAAAzMzMAAAAAABQAAAAUAAAAGQAAABkAAAAAAAAABcAAAAUAAAAAAAAAAAAAAD/fwAA/38AAAAAAAAJAAAABAAAAAAAAQAeAAAAaAAAAAAAAAAAAAAAAAAAAAAAAAAAAAAAECcAABAnAAAAAAAAAAAAAAAAAAAAAAAAAAAAAAAAAAAAAAAAAAAAABQAAAAAAAAAwMD/AAAAAABkAAAAMgAAAAAAAABkAAAAAAAAAH9/fwAKAAAAIgAAABgAAAAAAAAAAAAAAAAAAAAAAAAAAAAAAAAAAAAkAAAAJAAAAAAAAAAHAAAAAAAAAAAAAAAAAAAAAAAAAAAAAAAAAAAAf39/ACUAAABYAAAAAAAAAAAAAAAAAAAAAAAAAAAAAAAAAAAAAAAAAAAAAAAAAAAAAAAAAAAAAAA/AAAAAAAAAKCGAQAAAAAAAAAAAAAAAAAMAAAAAQAAAAAAAAAAAAAAAAAAAB8AAABUAAAAu+DjBf///wEAAAAAAAAAAAAAAAAAAAAAAAAAAAAAAAAAAAAAAAAAAAAAAAJ/f38AgICAA8zMzADAwP8Af39/AAAAAAAAAAAAAAAAAAAAAAAAAAAAIQAAABgAAAAUAAAA3RMAANARAACqIAAA0BEAAAAAAAAmAAAACAAAAP//////////"/>
-                </a:ext>
-              </a:extLst>
-            </p:cNvCxnSpPr>
-            <p:nvPr/>
-          </p:nvCxnSpPr>
-          <p:spPr>
-            <a:xfrm flipH="1">
-              <a:off x="4269105" y="1855470"/>
-              <a:ext cx="0" cy="2080895"/>
-            </a:xfrm>
-            <a:prstGeom prst="straightConnector1">
-              <a:avLst/>
-            </a:prstGeom>
+            <a:off x="5668645" y="3357245"/>
+            <a:ext cx="3013710" cy="365760"/>
+          </a:xfrm>
+          <a:prstGeom prst="rect">
+            <a:avLst/>
+          </a:prstGeom>
+          <a:noFill/>
+          <a:ln>
             <a:noFill/>
-            <a:ln w="63500" cap="flat" cmpd="sng" algn="ctr">
-              <a:solidFill>
-                <a:schemeClr val="tx1"/>
-              </a:solidFill>
-              <a:prstDash val="sysDot"/>
-              <a:headEnd type="none"/>
-              <a:tailEnd type="stealth" w="lg" len="lg"/>
-            </a:ln>
-            <a:effectLst/>
-          </p:spPr>
-        </p:cxnSp>
-        <p:sp>
-          <p:nvSpPr>
-            <p:cNvPr id="6" name="Textbox2"/>
-            <p:cNvSpPr txBox="1">
-              <a:extLst>
-                <a:ext uri="smNativeData">
-                  <pr:smNativeData xmlns:pr="smNativeData" xmlns="smNativeData" val="SMDATA_15_AnHWaRMAAAAlAAAAEgAAAE8BAAAAkAAAAEgAAACQAAAASAAAAAAAAAAAAAAAAAAAAAEAAABQAAAAAAAAAAAA4D8AAAAAAADgPwAAAAAAAOA/AAAAAAAA4D8AAAAAAADgPwAAAAAAAOA/AAAAAAAA4D8AAAAAAADgPwAAAAAAAOA/AAAAAAAA4D8CAAAAjAAAAAAAAAAAAAAAu+DjDP///wgAAAAAAAAAAAAAAAAAAAAAAAAAAAAAAAAAAAAAZAAAAAEAAABAAAAAAAAAAAAAAAAAAAAAAAAAAAAAAAAAAAAAAAAAAAAAAAAAAAAAAAAAAAAAAAAAAAAAAAAAAAAAAAAAAAAAAAAAAAAAAAAAAAAAAAAAAAAAAAAAAAAAFAAAADwAAAAAAAAAAAAAAAAAAAkUAAAAAQAAABQAAAAUAAAAFAAAAAEAAAAAAAAAZAAAAGQAAAAAAAAAZAAAAGQAAAAVAAAAYAAAAAAAAAAAAAAADwAAACADAAAAAAAAAAAAAAEAAACgMgAAVgcAAKr4//8BAAAAf39/AAEAAABkAAAAAAAAABQAAABAHwAAAAAAACYAAAAAAAAAwOD//wAAAAAmAAAAZAAAABYAAABMAAAAAAAAAAAAAAAEAAAAAAAAAAEAAACAgIAKAAAAACgAAAAoAAAAZAAAAGQAAAAAAAAAzMzMAAAAAABQAAAAUAAAAGQAAABkAAAAAAAAABcAAAAUAAAAAAAAANwIAAD/fwAA/38AAAAAAAAJAAAABAAAAEkAAAAeAAAAaAAAAAAAAAAAAAAAAAAAAAAAAAAAAAAAECcAABAnAAAAAAAAAAAAAAAAAAAAAAAAAAAAAAAAAAAAAAAAAAAAABQAAAAAAAAAwMD/AAAAAABkAAAAMgAAAAAAAABkAAAAAAAAAH9/fwAKAAAAIgAAABgAAAAAAAAAAAAAAAAAAAAAAAAAAAAAAAAAAAAkAAAAJAAAAAAAAAAHAAAAAAAAAAAAAAAAAAAAAAAAAAAAAAAAAAAAf39/ACUAAABYAAAAAAAAAAAAAAAAAAAAAAAAAAAAAAAAAAAAAAAAAAAAAAAAAAAAAAAAAAAAAAA/AAAAAAAAAKCGAQAAAAAAAAAAAAAAAAAMAAAAAQAAAAAAAAAAAAAAAAAAAB8AAABUAAAAu+DjBf///wEAAAAAAAAAAAAAAAAAAAAAAAAAAAAAAAAAAAAAAAAAAAAAAAJ/f38AgICAA8zMzADAwP8Af39/AAAAAAAAAAAAAAAAAAAAAAAAAAAAIQAAABgAAAAUAAAA3yIAAO4QAABpNQAALhMAAAAgAAAmAAAACAAAAP//////////"/>
-                </a:ext>
-              </a:extLst>
-            </p:cNvSpPr>
-            <p:nvPr/>
-          </p:nvSpPr>
-          <p:spPr>
-            <a:xfrm>
-              <a:off x="5668645" y="2752090"/>
-              <a:ext cx="3013710" cy="365760"/>
-            </a:xfrm>
-            <a:prstGeom prst="rect">
-              <a:avLst/>
-            </a:prstGeom>
-            <a:noFill/>
-            <a:ln>
-              <a:noFill/>
-            </a:ln>
-            <a:effectLst/>
-          </p:spPr>
-          <p:txBody>
-            <a:bodyPr vert="horz" wrap="square" numCol="1" spcCol="215900" anchor="t"/>
-            <a:lstStyle/>
-            <a:p>
-              <a:pPr/>
-              <a:r>
-                <a:t>Weak reference</a:t>
-              </a:r>
-            </a:p>
-          </p:txBody>
-        </p:sp>
-      </p:grpSp>
-      <p:grpSp>
-        <p:nvGrpSpPr>
-          <p:cNvPr id="8" name="Group3"/>
-          <p:cNvGrpSpPr>
-            <a:extLst>
-              <a:ext uri="smNativeData">
-                <pr:smNativeData xmlns:pr="smNativeData" xmlns="smNativeData" val="SMDATA_6_AnHWaRMAAAAlAAAAAQAAAC8BAAAAkAAAAEgAAACQAAAASAAAAAAAAAAAAAAAAAAAABcAAAAUAAAAAAAAAAAAAAD/fwAA/38AAAAAAAAJAAAABAAAAAUAAAAfAAAAVAAAAAAAAAAAAAAAAAAAAAAAAAAAAAAAAAAAAAAAAAAAAAAAAAAAAAAAAAAAAAAAAAAAAAAAAAAAAAAAAAAAAAAAAAAAAAAAAAAAAAAAAAAAAAAAAAAAACEAAAAYAAAAFAAAAN0TAACnFAAAaTUAAOcWAAAAAAAAJgAAAAgAAAD/////AAAAAA=="/>
-              </a:ext>
-            </a:extLst>
-          </p:cNvGrpSpPr>
+          </a:ln>
+          <a:effectLst/>
+        </p:spPr>
+        <p:txBody>
+          <a:bodyPr vert="horz" wrap="square" numCol="1" spcCol="215900" anchor="t"/>
+          <a:lstStyle/>
+          <a:p>
+            <a:pPr/>
+            <a:r>
+              <a:t>Garbage collection reporting</a:t>
+            </a:r>
+          </a:p>
+        </p:txBody>
+      </p:sp>
+      <p:sp>
+        <p:nvSpPr>
+          <p:cNvPr id="5" name="Line1"/>
+          <p:cNvSpPr>
+            <a:extLst>
+              <a:ext uri="smNativeData">
+                <pr:smNativeData xmlns:pr="smNativeData" xmlns="smNativeData" val="SMDATA_15_7aDWaRMAAAAlAAAACgAAAA8BAAAAkAAAAEgAAACQAAAASAAAAAAAAAAAAAAAAAAAAAEAAABQAAAAAAAAAAAA4D8AAAAAAADgPwAAAAAAAOA/AAAAAAAA4D8AAAAAAADgPwAAAAAAAOA/AAAAAAAA4D8AAAAAAADgPwAAAAAAAOA/AAAAAAAA4D8CAAAAjAAAAAAAAAAAAAAAu+DjDP///wgAAAAAAAAAAAAAAAAAAAAAAAAAAAAAAAAAAAAAZAAAAAEAAABAAAAAAAAAAAAAAAAAAAAAAAAAAAAAAAAAAAAAAAAAAAAAAAAAAAAAAAAAAAAAAAAAAAAAAAAAAAAAAAAAAAAAAAAAAAAAAAAAAAAAAAAAAAAAAAAAAAAAFAAAADwAAAABAAAAAAAAAAAAAAlkAAAAAQAAABQAAAAUAAAAFAAAAAEAAAAAAAAAZAAAAGQAAAABAAAAlgAAAJYAAAAVAAAAYAAAAAAAAAAAAAAADwAAACADAAAAAAAAAAAAAAEAAACgMgAAVgcAAKr4//8BAAAAf39/AAEAAABkAAAAAAAAABQAAABAHwAAAAAAACYAAAAAAAAAwOD//wAAAAAmAAAAZAAAABYAAABMAAAAAAAAAAAAAAAEAAAAAAAAAAEAAACAgIAKAAAAACgAAAAoAAAAZAAAAGQAAAAAAAAAzMzMAAAAAABQAAAAUAAAAGQAAABkAAAAAAAAABcAAAAUAAAAAAAAAAAAAAD/fwAA/38AAAAAAAAJAAAABAAAAAAAAAAeAAAAaAAAAAAAAAAAAAAAAAAAAAAAAAAAAAAAECcAABAnAAAAAAAAAAAAAAAAAAAAAAAAAAAAAAAAAAAAAAAAAAAAABQAAAAAAAAAwMD/AAAAAABkAAAAMgAAAAAAAABkAAAAAAAAAH9/fwAKAAAAIgAAABgAAAAAAAAAAAAAAAAAAAAAAAAAAAAAAAAAAAAkAAAAJAAAAAAAAAAHAAAAAAAAAAAAAAAAAAAAAAAAAAAAAAAAAAAAf39/ACUAAABYAAAAAAAAAAAAAAAAAAAAAAAAAAAAAAAAAAAAAAAAAAAAAAAAAAAAAAAAAAAAAAA/AAAAAAAAAKCGAQAAAAAAAAAAAAAAAAAMAAAAAQAAAAAAAAAAAAAAAAAAAB8AAABUAAAAu+DjBf///wEAAAAAAAAAAAAAAAAAAAAAAAAAAAAAAAAAAAAAAAAAAAAAAAJ/f38AgICAA8zMzADAwP8Af39/AAAAAAAAAAAAAAAAAAAAAAAAAAAAIQAAABgAAAAUAAAAMBUAAI8OAACqIAAAkQ4AAAAAAAAmAAAACAAAAP//////////"/>
+              </a:ext>
+            </a:extLst>
+          </p:cNvSpPr>
           <p:nvPr/>
-        </p:nvGrpSpPr>
-        <p:grpSpPr>
+        </p:nvSpPr>
+        <p:spPr>
           <a:xfrm>
-            <a:off x="3228975" y="3357245"/>
-            <a:ext cx="5453380" cy="365760"/>
-            <a:chOff x="3228975" y="3357245"/>
-            <a:chExt cx="5453380" cy="365760"/>
-          </a:xfrm>
-        </p:grpSpPr>
-        <p:cxnSp>
-          <p:nvCxnSpPr>
-            <p:cNvPr id="10" name="Connector3"/>
-            <p:cNvCxnSpPr>
-              <a:extLst>
-                <a:ext uri="smNativeData">
-                  <pr:smNativeData xmlns:pr="smNativeData" xmlns="smNativeData" val="SMDATA_15_AnHWaRMAAAAlAAAADQAAAA8BAAAAkAAAAEgAAACQAAAASAAAAAAAAAAAAAAAAAAAAAEAAABQAAAAAAAAAAAA4D8AAAAAAADgPwAAAAAAAOA/AAAAAAAA4D8AAAAAAADgPwAAAAAAAOA/AAAAAAAA4D8AAAAAAADgPwAAAAAAAOA/AAAAAAAA4D8CAAAAjAAAAAAAAAAAAAAAu+DjDP///wgAAAAAAAAAAAAAAAAAAAAAAAAAAAAAAAAAAAAAZAAAAAEAAABAAAAAAAAAAAAAAAAAAAAAAAAAAAAAAAAAAAAAAAAAAAAAAAAAAAAAAAAAAAAAAAAAAAAAAAAAAAAAAAAAAAAAAAAAAAAAAAAAAAAAAAAAAAAAAAAAAAAAFAAAADwAAAABAAAAAgAAAAAAAAlkAAAAAQAAABQAAAAUAAAAFAAAAAEAAAAAAAAAZAAAAGQAAAABAAAAlgAAAJYAAAAVAAAAYAAAAAAAAAAAAAAADwAAACADAAAAAAAAAAAAAAEAAACgMgAAVgcAAKr4//8BAAAAf39/AAEAAABkAAAAAAAAABQAAABAHwAAAAAAACYAAAAAAAAAwOD//wAAAAAmAAAAZAAAABYAAABMAAAAAAAAAAAAAAAEAAAAAAAAAAEAAACAgIAKAAAAACgAAAAoAAAAZAAAAGQAAAAAAAAAzMzMAAAAAABQAAAAUAAAAGQAAABkAAAAAAAAABcAAAAUAAAAAAAAAAAAAAD/fwAA/38AAAAAAAAJAAAABAAAAAAAAQAeAAAAaAAAAAAAAAAAAAAAAAAAAAAAAAAAAAAAECcAABAnAAAAAAAAAAAAAAAAAAAAAAAAAAAAAAAAAAAAAAAAAAAAABQAAAAAAAAAwMD/AAAAAABkAAAAMgAAAAAAAABkAAAAAAAAAH9/fwAKAAAAIgAAABgAAAAAAAAAAAAAAAAAAAAAAAAAAAAAAAAAAAAkAAAAJAAAAAAAAAAHAAAAAAAAAAAAAAAAAAAAAAAAAAAAAAAAAAAAf39/ACUAAABYAAAAAAAAAAAAAAAAAAAAAAAAAAAAAAAAAAAAAAAAAAAAAAAAAAAAAAAAAAAAAAA/AAAAAAAAAKCGAQAAAAAAAAAAAAAAAAAMAAAAAQAAAAAAAAAAAAAAAAAAAB8AAABUAAAAu+DjBf///wEAAAAAAAAAAAAAAAAAAAAAAAAAAAAAAAAAAAAAAAAAAAAAAAJ/f38AgICAA8zMzADAwP8Af39/AAAAAAAAAAAAAAAAAAAAAAAAAAAAIQAAABgAAAAUAAAA3RMAAIkVAACqIAAAiRUAAAAAAAAmAAAACAAAAP//////////"/>
-                </a:ext>
-              </a:extLst>
-            </p:cNvCxnSpPr>
-            <p:nvPr/>
-          </p:nvCxnSpPr>
-          <p:spPr>
-            <a:xfrm flipH="1">
-              <a:off x="4269105" y="2460625"/>
-              <a:ext cx="0" cy="2080895"/>
-            </a:xfrm>
-            <a:prstGeom prst="straightConnector1">
-              <a:avLst/>
-            </a:prstGeom>
-            <a:noFill/>
-            <a:ln w="63500" cap="flat" cmpd="sng" algn="ctr">
-              <a:solidFill>
-                <a:schemeClr val="tx1"/>
-              </a:solidFill>
-              <a:prstDash val="sysDash"/>
-              <a:headEnd type="none"/>
-              <a:tailEnd type="stealth" w="lg" len="lg"/>
-            </a:ln>
-            <a:effectLst/>
-          </p:spPr>
-        </p:cxnSp>
-        <p:sp>
-          <p:nvSpPr>
-            <p:cNvPr id="9" name="Textbox3"/>
-            <p:cNvSpPr txBox="1">
-              <a:extLst>
-                <a:ext uri="smNativeData">
-                  <pr:smNativeData xmlns:pr="smNativeData" xmlns="smNativeData" val="SMDATA_15_AnHWaRMAAAAlAAAAEgAAAE8BAAAAkAAAAEgAAACQAAAASAAAAAAAAAAAAAAAAAAAAAEAAABQAAAAAAAAAAAA4D8AAAAAAADgPwAAAAAAAOA/AAAAAAAA4D8AAAAAAADgPwAAAAAAAOA/AAAAAAAA4D8AAAAAAADgPwAAAAAAAOA/AAAAAAAA4D8CAAAAjAAAAAAAAAAAAAAAu+DjDP///wgAAAAAAAAAAAAAAAAAAAAAAAAAAAAAAAAAAAAAZAAAAAEAAABAAAAAAAAAAAAAAAAAAAAAAAAAAAAAAAAAAAAAAAAAAAAAAAAAAAAAAAAAAAAAAAAAAAAAAAAAAAAAAAAAAAAAAAAAAAAAAAAAAAAAAAAAAAAAAAAAAAAAFAAAADwAAAAAAAAAAAAAAAAAAAkUAAAAAQAAABQAAAAUAAAAFAAAAAEAAAAAAAAAZAAAAGQAAAAAAAAAZAAAAGQAAAAVAAAAYAAAAAAAAAAAAAAADwAAACADAAAAAAAAAAAAAAEAAACgMgAAVgcAAKr4//8BAAAAf39/AAEAAABkAAAAAAAAABQAAABAHwAAAAAAACYAAAAAAAAAwOD//wAAAAAmAAAAZAAAABYAAABMAAAAAAAAAAAAAAAEAAAAAAAAAAEAAACAgIAKAAAAACgAAAAoAAAAZAAAAGQAAAAAAAAAzMzMAAAAAABQAAAAUAAAAGQAAABkAAAAAAAAABcAAAAUAAAAAAAAANwIAAD/fwAA/38AAAAAAAAJAAAABAAAAAAAAQAeAAAAaAAAAAAAAAAAAAAAAAAAAAAAAAAAAAAAECcAABAnAAAAAAAAAAAAAAAAAAAAAAAAAAAAAAAAAAAAAAAAAAAAABQAAAAAAAAAwMD/AAAAAABkAAAAMgAAAAAAAABkAAAAAAAAAH9/fwAKAAAAIgAAABgAAAAAAAAAAAAAAAAAAAAAAAAAAAAAAAAAAAAkAAAAJAAAAAAAAAAHAAAAAAAAAAAAAAAAAAAAAAAAAAAAAAAAAAAAf39/ACUAAABYAAAAAAAAAAAAAAAAAAAAAAAAAAAAAAAAAAAAAAAAAAAAAAAAAAAAAAAAAAAAAAA/AAAAAAAAAKCGAQAAAAAAAAAAAAAAAAAMAAAAAQAAAAAAAAAAAAAAAAAAAB8AAABUAAAAu+DjBf///wEAAAAAAAAAAAAAAAAAAAAAAAAAAAAAAAAAAAAAAAAAAAAAAAJ/f38AgICAA8zMzADAwP8Af39/AAAAAAAAAAAAAAAAAAAAAAAAAAAAIQAAABgAAAAUAAAA3yIAAKcUAABpNQAA5xYAAAAgAAAmAAAACAAAAP//////////"/>
-                </a:ext>
-              </a:extLst>
-            </p:cNvSpPr>
-            <p:nvPr/>
-          </p:nvSpPr>
-          <p:spPr>
-            <a:xfrm>
-              <a:off x="5668645" y="3357245"/>
-              <a:ext cx="3013710" cy="365760"/>
-            </a:xfrm>
-            <a:prstGeom prst="rect">
-              <a:avLst/>
-            </a:prstGeom>
-            <a:noFill/>
-            <a:ln>
-              <a:noFill/>
-            </a:ln>
-            <a:effectLst/>
-          </p:spPr>
-          <p:txBody>
-            <a:bodyPr vert="horz" wrap="square" numCol="1" spcCol="215900" anchor="t"/>
-            <a:lstStyle/>
-            <a:p>
-              <a:pPr/>
-              <a:r>
-                <a:t>Garbage collection reporting</a:t>
-              </a:r>
-            </a:p>
-          </p:txBody>
-        </p:sp>
-      </p:grpSp>
+            <a:off x="3444240" y="2366645"/>
+            <a:ext cx="1865630" cy="1270"/>
+          </a:xfrm>
+          <a:prstGeom prst="line">
+            <a:avLst/>
+          </a:prstGeom>
+          <a:noFill/>
+          <a:ln w="63500" cap="flat" cmpd="sng" algn="ctr">
+            <a:solidFill>
+              <a:schemeClr val="tx1"/>
+            </a:solidFill>
+            <a:prstDash val="solid"/>
+            <a:headEnd type="none"/>
+            <a:tailEnd type="stealth" w="lg" len="lg"/>
+          </a:ln>
+          <a:effectLst/>
+        </p:spPr>
+      </p:sp>
+      <p:sp>
+        <p:nvSpPr>
+          <p:cNvPr id="6" name="Line2"/>
+          <p:cNvSpPr>
+            <a:extLst>
+              <a:ext uri="smNativeData">
+                <pr:smNativeData xmlns:pr="smNativeData" xmlns="smNativeData" val="SMDATA_15_7aDWaRMAAAAlAAAACgAAAA8BAAAAkAAAAEgAAACQAAAASAAAAAAAAAAAAAAAAAAAAAEAAABQAAAAAAAAAAAA4D8AAAAAAADgPwAAAAAAAOA/AAAAAAAA4D8AAAAAAADgPwAAAAAAAOA/AAAAAAAA4D8AAAAAAADgPwAAAAAAAOA/AAAAAAAA4D8CAAAAjAAAAAAAAAAAAAAAu+DjDP///wgAAAAAAAAAAAAAAAAAAAAAAAAAAAAAAAAAAAAAZAAAAAEAAABAAAAAAAAAAAAAAAAAAAAAAAAAAAAAAAAAAAAAAAAAAAAAAAAAAAAAAAAAAAAAAAAAAAAAAAAAAAAAAAAAAAAAAAAAAAAAAAAAAAAAAAAAAAAAAAAAAAAAFAAAADwAAAABAAAAAQAAAAAAAAlkAAAAAQAAABQAAAAUAAAAFAAAAAEAAAAAAAAAZAAAAGQAAAABAAAAlgAAAJYAAAAVAAAAYAAAAAAAAAAAAAAADwAAACADAAAAAAAAAAAAAAEAAACgMgAAVgcAAKr4//8BAAAAf39/AAEAAABkAAAAAAAAABQAAABAHwAAAAAAACYAAAAAAAAAwOD//wAAAAAmAAAAZAAAABYAAABMAAAAAAAAAAAAAAAEAAAAAAAAAAEAAACAgIAKAAAAACgAAAAoAAAAZAAAAGQAAAAAAAAAzMzMAAAAAABQAAAAUAAAAGQAAABkAAAAAAAAABcAAAAUAAAAAAAAAAAAAAD/fwAA/38AAAAAAAAJAAAABAAAAEC5/SQeAAAAaAAAAAAAAAAAAAAAAAAAAAAAAAAAAAAAECcAABAnAAAAAAAAAAAAAAAAAAAAAAAAAAAAAAAAAAAAAAAAAAAAABQAAAAAAAAAwMD/AAAAAABkAAAAMgAAAAAAAABkAAAAAAAAAH9/fwAKAAAAIgAAABgAAAAAAAAAAAAAAAAAAAAAAAAAAAAAAAAAAAAkAAAAJAAAAAAAAAAHAAAAAAAAAAAAAAAAAAAAAAAAAAAAAAAAAAAAf39/ACUAAABYAAAAAAAAAAAAAAAAAAAAAAAAAAAAAAAAAAAAAAAAAAAAAAAAAAAAAAAAAAAAAAA/AAAAAAAAAKCGAQAAAAAAAAAAAAAAAAAMAAAAAQAAAAAAAAAAAAAAAAAAAB8AAABUAAAAu+DjBf///wEAAAAAAAAAAAAAAAAAAAAAAAAAAAAAAAAAAAAAAAAAAAAAAAJ/f38AgICAA8zMzADAwP8Af39/AAAAAAAAAAAAAAAAAAAAAAAAAAAAIQAAABgAAAAUAAAAMBUAABkSAACqIAAAGxIAAAAAAAAmAAAACAAAAP//////////"/>
+              </a:ext>
+            </a:extLst>
+          </p:cNvSpPr>
+          <p:nvPr/>
+        </p:nvSpPr>
+        <p:spPr>
+          <a:xfrm>
+            <a:off x="3444240" y="2941955"/>
+            <a:ext cx="1865630" cy="1270"/>
+          </a:xfrm>
+          <a:prstGeom prst="line">
+            <a:avLst/>
+          </a:prstGeom>
+          <a:noFill/>
+          <a:ln w="63500" cap="flat" cmpd="sng" algn="ctr">
+            <a:solidFill>
+              <a:schemeClr val="tx1"/>
+            </a:solidFill>
+            <a:prstDash val="sysDot"/>
+            <a:headEnd type="none"/>
+            <a:tailEnd type="stealth" w="lg" len="lg"/>
+          </a:ln>
+          <a:effectLst/>
+        </p:spPr>
+      </p:sp>
+      <p:sp>
+        <p:nvSpPr>
+          <p:cNvPr id="7" name="Line3"/>
+          <p:cNvSpPr>
+            <a:extLst>
+              <a:ext uri="smNativeData">
+                <pr:smNativeData xmlns:pr="smNativeData" xmlns="smNativeData" val="SMDATA_15_7aDWaRMAAAAlAAAACgAAAA8BAAAAkAAAAEgAAACQAAAASAAAAAAAAAAAAAAAAAAAAAEAAABQAAAAAAAAAAAA4D8AAAAAAADgPwAAAAAAAOA/AAAAAAAA4D8AAAAAAADgPwAAAAAAAOA/AAAAAAAA4D8AAAAAAADgPwAAAAAAAOA/AAAAAAAA4D8CAAAAjAAAAAAAAAAAAAAAu+DjDP///wgAAAAAAAAAAAAAAAAAAAAAAAAAAAAAAAAAAAAAZAAAAAEAAABAAAAAAAAAAAAAAAAAAAAAAAAAAAAAAAAAAAAAAAAAAAAAAAAAAAAAAAAAAAAAAAAAAAAAAAAAAAAAAAAAAAAAAAAAAAAAAAAAAAAAAAAAAAAAAAAAAAAAFAAAADwAAAABAAAAAgAAAAAAAAlkAAAAAQAAABQAAAAUAAAAFAAAAAEAAAAAAAAAZAAAAGQAAAABAAAAlgAAAJYAAAAVAAAAYAAAAAAAAAAAAAAADwAAACADAAAAAAAAAAAAAAEAAACgMgAAVgcAAKr4//8BAAAAf39/AAEAAABkAAAAAAAAABQAAABAHwAAAAAAACYAAAAAAAAAwOD//wAAAAAmAAAAZAAAABYAAABMAAAAAAAAAAAAAAAEAAAAAAAAAAEAAACAgIAKAAAAACgAAAAoAAAAZAAAAGQAAAAAAAAAzMzMAAAAAABQAAAAUAAAAGQAAABkAAAAAAAAABcAAAAUAAAAAAAAAAAAAAD/fwAA/38AAAAAAAAJAAAABAAAAADB/SQeAAAAaAAAAAAAAAAAAAAAAAAAAAAAAAAAAAAAECcAABAnAAAAAAAAAAAAAAAAAAAAAAAAAAAAAAAAAAAAAAAAAAAAABQAAAAAAAAAwMD/AAAAAABkAAAAMgAAAAAAAABkAAAAAAAAAH9/fwAKAAAAIgAAABgAAAAAAAAAAAAAAAAAAAAAAAAAAAAAAAAAAAAkAAAAJAAAAAAAAAAHAAAAAAAAAAAAAAAAAAAAAAAAAAAAAAAAAAAAf39/ACUAAABYAAAAAAAAAAAAAAAAAAAAAAAAAAAAAAAAAAAAAAAAAAAAAAAAAAAAAAAAAAAAAAA/AAAAAAAAAKCGAQAAAAAAAAAAAAAAAAAMAAAAAQAAAAAAAAAAAAAAAAAAAB8AAABUAAAAu+DjBf///wEAAAAAAAAAAAAAAAAAAAAAAAAAAAAAAAAAAAAAAAAAAAAAAAJ/f38AgICAA8zMzADAwP8Af39/AAAAAAAAAAAAAAAAAAAAAAAAAAAAIQAAABgAAAAUAAAAMBUAABAWAACqIAAAEhYAAAAAAAAmAAAACAAAAP//////////"/>
+              </a:ext>
+            </a:extLst>
+          </p:cNvSpPr>
+          <p:nvPr/>
+        </p:nvSpPr>
+        <p:spPr>
+          <a:xfrm>
+            <a:off x="3444240" y="3586480"/>
+            <a:ext cx="1865630" cy="1270"/>
+          </a:xfrm>
+          <a:prstGeom prst="line">
+            <a:avLst/>
+          </a:prstGeom>
+          <a:noFill/>
+          <a:ln w="63500" cap="flat" cmpd="sng" algn="ctr">
+            <a:solidFill>
+              <a:schemeClr val="tx1"/>
+            </a:solidFill>
+            <a:prstDash val="sysDash"/>
+            <a:headEnd type="none"/>
+            <a:tailEnd type="stealth" w="lg" len="lg"/>
+          </a:ln>
+          <a:effectLst/>
+        </p:spPr>
+      </p:sp>
     </p:spTree>
   </p:cSld>
   <p:clrMapOvr>
@@ -4029,7 +3941,7 @@
           <p:cNvSpPr txBox="1">
             <a:extLst>
               <a:ext uri="smNativeData">
-                <pr:smNativeData xmlns:pr="smNativeData" xmlns="smNativeData" val="SMDATA_15_AnHWaRMAAAAlAAAAEgAAAA8BAAAAkAAAAEgAAACQAAAASAAAAAAAAAABAAAAAAAAAAEAAABQAAAAAAAAAAAA4D8AAAAAAADgPwAAAAAAAOA/AAAAAAAA4D8AAAAAAADgPwAAAAAAAOA/AAAAAAAA4D8AAAAAAADgPwAAAAAAAOA/AAAAAAAA4D8CAAAAjAAAAAEAAAAAAAAAAP8AAP///wgAAAAAAAAAAAAAAAAAAAAAAAAAAAAAAAAAAAAAZAAAAAEAAABAAAAAAAAAAAAAAAAAAAAAAAAAAAAAAAAAAAAAAAAAAAAAAAAAAAAAAAAAAAAAAAAAAAAAAAAAAAAAAAAAAAAAAAAAAAAAAAAAAAAAAAAAAAAAAAAAAAAAFAAAADwAAAABAAAAAAAAAAAAAAkUAAAAAQAAABQAAAAUAAAAFAAAAAEAAAAAAAAAZAAAAGQAAAAAAAAAZAAAAGQAAAAVAAAAYAAAAAAAAAAAAAAADwAAACADAAAAAAAAAAAAAAEAAACgMgAAVgcAAKr4//8BAAAAf39/AAEAAABkAAAAAAAAABQAAABAHwAAAAAAACYAAAAAAAAAwOD//wAAAAAmAAAAZAAAABYAAABMAAAAAAAAAAAAAAAEAAAAAAAAAAEAAACAgIAKAAAAACgAAAAoAAAAZAAAAGQAAAAAAAAAzMzMAAAAAABQAAAAUAAAAGQAAABkAAAAAAAAABcAAAAUAAAAAAAAAIEHAAD/fwAA/38AAAAAAAAJAAAABAAAAAsAAAAeAAAAaAAAAAAAAAAAAAAAAAAAAAAAAAAAAAAAECcAABAnAAAAAAAAAAAAAAAAAAAAAAAAAAAAAAAAAAAAAAAAAAAAABQAAAAAAAAAwMD/AAAAAABkAAAAMgAAAAAAAABkAAAAAAAAAH9/fwAKAAAAIgAAABgAAAAAAAAAAAAAAAAAAAAAAAAAAAAAAAAAAAAkAAAAJAAAAAAAAAAHAAAAAAAAAAAAAAAAAAAAAAAAAAAAAAAAAAAAf39/ACUAAABYAAAAAAAAAAAAAAAAAAAAAAAAAAAAAAAAAAAAAAAAAAAAAAAAAAAAAAAAAAAAAAA/AAAAAAAAAKCGAQAAAAAAAAAAAAAAAAAMAAAAAQAAAAAAAAAAAAAAAAAAAB8AAABUAAAAAP8AAP///wEAAAAAAAAAAAAAAAAAAAAAAAAAAAAAAAAAAAAAAAAAAAAAAAJ/f38AgICAA8zMzADAwP8Af39/AAAAAAAAAAAAAAAAAAAAAAAAAAAAIQAAABgAAAAUAAAADyAAAP0MAAD6KwAA9hAAAAAAAAAmAAAACAAAAP//////////"/>
+                <pr:smNativeData xmlns:pr="smNativeData" xmlns="smNativeData" val="SMDATA_15_7aDWaRMAAAAlAAAAEgAAAA8BAAAAkAAAAEgAAACQAAAASAAAAAAAAAABAAAAAAAAAAEAAABQAAAAAAAAAAAA4D8AAAAAAADgPwAAAAAAAOA/AAAAAAAA4D8AAAAAAADgPwAAAAAAAOA/AAAAAAAA4D8AAAAAAADgPwAAAAAAAOA/AAAAAAAA4D8CAAAAjAAAAAEAAAAAAAAAAP8AAP///wgAAAAAAAAAAAAAAAAAAAAAAAAAAAAAAAAAAAAAZAAAAAEAAABAAAAAAAAAAAAAAAAAAAAAAAAAAAAAAAAAAAAAAAAAAAAAAAAAAAAAAAAAAAAAAAAAAAAAAAAAAAAAAAAAAAAAAAAAAAAAAAAAAAAAAAAAAAAAAAAAAAAAFAAAADwAAAABAAAAAAAAAAAAAAkUAAAAAQAAABQAAAAUAAAAFAAAAAEAAAAAAAAAZAAAAGQAAAAAAAAAZAAAAGQAAAAVAAAAYAAAAAAAAAAAAAAADwAAACADAAAAAAAAAAAAAAEAAACgMgAAVgcAAKr4//8BAAAAf39/AAEAAABkAAAAAAAAABQAAABAHwAAAAAAACYAAAAAAAAAwOD//wAAAAAmAAAAZAAAABYAAABMAAAAAAAAAAAAAAAEAAAAAAAAAAEAAACAgIAKAAAAACgAAAAoAAAAZAAAAGQAAAAAAAAAzMzMAAAAAABQAAAAUAAAAGQAAABkAAAAAAAAABcAAAAUAAAAAAAAAIEHAAD/fwAA/38AAAAAAAAJAAAABAAAAAsAAAAeAAAAaAAAAAAAAAAAAAAAAAAAAAAAAAAAAAAAECcAABAnAAAAAAAAAAAAAAAAAAAAAAAAAAAAAAAAAAAAAAAAAAAAABQAAAAAAAAAwMD/AAAAAABkAAAAMgAAAAAAAABkAAAAAAAAAH9/fwAKAAAAIgAAABgAAAAAAAAAAAAAAAAAAAAAAAAAAAAAAAAAAAAkAAAAJAAAAAAAAAAHAAAAAAAAAAAAAAAAAAAAAAAAAAAAAAAAAAAAf39/ACUAAABYAAAAAAAAAAAAAAAAAAAAAAAAAAAAAAAAAAAAAAAAAAAAAAAAAAAAAAAAAAAAAAA/AAAAAAAAAKCGAQAAAAAAAAAAAAAAAAAMAAAAAQAAAAAAAAAAAAAAAAAAAB8AAABUAAAAAP8AAP///wEAAAAAAAAAAAAAAAAAAAAAAAAAAAAAAAAAAAAAAAAAAAAAAAJ/f38AgICAA8zMzADAwP8Af39/AAAAAAAAAAAAAAAAAAAAAAAAAAAAIQAAABgAAAAUAAAADyAAAP0MAAD6KwAA9hAAABAAAAAmAAAACAAAAP//////////"/>
               </a:ext>
             </a:extLst>
           </p:cNvSpPr>
@@ -4081,7 +3993,7 @@
           <p:cNvSpPr txBox="1">
             <a:extLst>
               <a:ext uri="smNativeData">
-                <pr:smNativeData xmlns:pr="smNativeData" xmlns="smNativeData" val="SMDATA_15_AnHWaRMAAAAlAAAAEgAAAA8BAAAAkAAAAEgAAACQAAAASAAAAAAAAAABAAAAAAAAAAEAAABQAAAAAAAAAAAA4D8AAAAAAADgPwAAAAAAAOA/AAAAAAAA4D8AAAAAAADgPwAAAAAAAOA/AAAAAAAA4D8AAAAAAADgPwAAAAAAAOA/AAAAAAAA4D8CAAAAjAAAAAEAAAAAAAAAAP8AAP///wgAAAAAAAAAAAAAAAAAAAAAAAAAAAAAAAAAAAAAZAAAAAEAAABAAAAAAAAAAAAAAAAAAAAAAAAAAAAAAAAAAAAAAAAAAAAAAAAAAAAAAAAAAAAAAAAAAAAAAAAAAAAAAAAAAAAAAAAAAAAAAAAAAAAAAAAAAAAAAAAAAAAAFAAAADwAAAABAAAAAAAAAAAAAAkUAAAAAQAAABQAAAAUAAAAFAAAAAEAAAAAAAAAZAAAAGQAAAAAAAAAZAAAAGQAAAAVAAAAYAAAAAAAAAAAAAAADwAAACADAAAAAAAAAAAAAAEAAACgMgAAVgcAAKr4//8BAAAAf39/AAEAAABkAAAAAAAAABQAAABAHwAAAAAAACYAAAAAAAAAwOD//wAAAAAmAAAAZAAAABYAAABMAAAAAAAAAAAAAAAEAAAAAAAAAAEAAACAgIAKAAAAACgAAAAoAAAAZAAAAGQAAAAAAAAAzMzMAAAAAABQAAAAUAAAAGQAAABkAAAAAAAAABcAAAAUAAAAAAAAAIgDAAD/fwAA/38AAAAAAAAJAAAABAAAAA4AAAAeAAAAaAAAAAAAAAAAAAAAAAAAAAAAAAAAAAAAECcAABAnAAAAAAAAAAAAAAAAAAAAAAAAAAAAAAAAAAAAAAAAAAAAABQAAAAAAAAAwMD/AAAAAABkAAAAMgAAAAAAAABkAAAAAAAAAH9/fwAKAAAAIgAAABgAAAAAAAAAAAAAAAAAAAAAAAAAAAAAAAAAAAAkAAAAJAAAAAAAAAAHAAAAAAAAAAAAAAAAAAAAAAAAAAAAAAAAAAAAf39/ACUAAABYAAAAAAAAAAAAAAAAAAAAAAAAAAAAAAAAAAAAAAAAAAAAAAAAAAAAAAAAAAAAAAA/AAAAAAAAAKCGAQAAAAAAAAAAAAAAAAAMAAAAAQAAAAAAAAAAAAAAAAAAAB8AAABUAAAAAP8AAP///wEAAAAAAAAAAAAAAAAAAAAAAAAAAAAAAAAAAAAAAAAAAAAAAAJ/f38AgICAA8zMzADAwP8Af39/AAAAAAAAAAAAAAAAAAAAAAAAAAAAIQAAABgAAAAUAAAAJBQAAAENAACHHAAA+hAAAAAAAAAmAAAACAAAAP//////////"/>
+                <pr:smNativeData xmlns:pr="smNativeData" xmlns="smNativeData" val="SMDATA_15_7aDWaRMAAAAlAAAAEgAAAA8BAAAAkAAAAEgAAACQAAAASAAAAAAAAAABAAAAAAAAAAEAAABQAAAAAAAAAAAA4D8AAAAAAADgPwAAAAAAAOA/AAAAAAAA4D8AAAAAAADgPwAAAAAAAOA/AAAAAAAA4D8AAAAAAADgPwAAAAAAAOA/AAAAAAAA4D8CAAAAjAAAAAEAAAAAAAAAAP8AAP///wgAAAAAAAAAAAAAAAAAAAAAAAAAAAAAAAAAAAAAZAAAAAEAAABAAAAAAAAAAAAAAAAAAAAAAAAAAAAAAAAAAAAAAAAAAAAAAAAAAAAAAAAAAAAAAAAAAAAAAAAAAAAAAAAAAAAAAAAAAAAAAAAAAAAAAAAAAAAAAAAAAAAAFAAAADwAAAABAAAAAAAAAAAAAAkUAAAAAQAAABQAAAAUAAAAFAAAAAEAAAAAAAAAZAAAAGQAAAAAAAAAZAAAAGQAAAAVAAAAYAAAAAAAAAAAAAAADwAAACADAAAAAAAAAAAAAAEAAACgMgAAVgcAAKr4//8BAAAAf39/AAEAAABkAAAAAAAAABQAAABAHwAAAAAAACYAAAAAAAAAwOD//wAAAAAmAAAAZAAAABYAAABMAAAAAAAAAAAAAAAEAAAAAAAAAAEAAACAgIAKAAAAACgAAAAoAAAAZAAAAGQAAAAAAAAAzMzMAAAAAABQAAAAUAAAAGQAAABkAAAAAAAAABcAAAAUAAAAAAAAAIgDAAD/fwAA/38AAAAAAAAJAAAABAAAAA4AAAAeAAAAaAAAAAAAAAAAAAAAAAAAAAAAAAAAAAAAECcAABAnAAAAAAAAAAAAAAAAAAAAAAAAAAAAAAAAAAAAAAAAAAAAABQAAAAAAAAAwMD/AAAAAABkAAAAMgAAAAAAAABkAAAAAAAAAH9/fwAKAAAAIgAAABgAAAAAAAAAAAAAAAAAAAAAAAAAAAAAAAAAAAAkAAAAJAAAAAAAAAAHAAAAAAAAAAAAAAAAAAAAAAAAAAAAAAAAAAAAf39/ACUAAABYAAAAAAAAAAAAAAAAAAAAAAAAAAAAAAAAAAAAAAAAAAAAAAAAAAAAAAAAAAAAAAA/AAAAAAAAAKCGAQAAAAAAAAAAAAAAAAAMAAAAAQAAAAAAAAAAAAAAAAAAAB8AAABUAAAAAP8AAP///wEAAAAAAAAAAAAAAAAAAAAAAAAAAAAAAAAAAAAAAAAAAAAAAAJ/f38AgICAA8zMzADAwP8Af39/AAAAAAAAAAAAAAAAAAAAAAAAAAAAIQAAABgAAAAUAAAAJBQAAAENAACHHAAA+hAAABAAAAAmAAAACAAAAP//////////"/>
               </a:ext>
             </a:extLst>
           </p:cNvSpPr>
@@ -4133,7 +4045,7 @@
           <p:cNvSpPr txBox="1">
             <a:extLst>
               <a:ext uri="smNativeData">
-                <pr:smNativeData xmlns:pr="smNativeData" xmlns="smNativeData" val="SMDATA_15_AnHWaRMAAAAlAAAAEgAAAA8BAAAAkAAAAEgAAACQAAAASAAAAAAAAAABAAAAAAAAAAEAAABQAAAAAAAAAAAA4D8AAAAAAADgPwAAAAAAAOA/AAAAAAAA4D8AAAAAAADgPwAAAAAAAOA/AAAAAAAA4D8AAAAAAADgPwAAAAAAAOA/AAAAAAAA4D8CAAAAjAAAAAEAAAAAAAAAAP8AAP///wgAAAAAAAAAAAAAAAAAAAAAAAAAAAAAAAAAAAAAZAAAAAEAAABAAAAAAAAAAAAAAAAAAAAAAAAAAAAAAAAAAAAAAAAAAAAAAAAAAAAAAAAAAAAAAAAAAAAAAAAAAAAAAAAAAAAAAAAAAAAAAAAAAAAAAAAAAAAAAAAAAAAAFAAAADwAAAABAAAAAAAAAAAAAAkUAAAAAQAAABQAAAAUAAAAFAAAAAEAAAAAAAAAZAAAAGQAAAAAAAAAZAAAAGQAAAAVAAAAYAAAAAAAAAAAAAAADwAAACADAAAAAAAAAAAAAAEAAACgMgAAVgcAAKr4//8BAAAAf39/AAEAAABkAAAAAAAAABQAAABAHwAAAAAAACYAAAAAAAAAwOD//wAAAAAmAAAAZAAAABYAAABMAAAAAAAAAAAAAAAEAAAAAAAAAAEAAACAgIAKAAAAACgAAAAoAAAAZAAAAGQAAAAAAAAAzMzMAAAAAABQAAAAUAAAAGQAAABkAAAAAAAAABcAAAAUAAAAAAAAAIgDAAD/fwAA/38AAAAAAAAJAAAABAAAACMAAAAeAAAAaAAAAAAAAAAAAAAAAAAAAAAAAAAAAAAAECcAABAnAAAAAAAAAAAAAAAAAAAAAAAAAAAAAAAAAAAAAAAAAAAAABQAAAAAAAAAwMD/AAAAAABkAAAAMgAAAAAAAABkAAAAAAAAAH9/fwAKAAAAIgAAABgAAAAAAAAAAAAAAAAAAAAAAAAAAAAAAAAAAAAkAAAAJAAAAAAAAAAHAAAAAAAAAAAAAAAAAAAAAAAAAAAAAAAAAAAAf39/ACUAAABYAAAAAAAAAAAAAAAAAAAAAAAAAAAAAAAAAAAAAAAAAAAAAAAAAAAAAAAAAAAAAAA/AAAAAAAAAKCGAQAAAAAAAAAAAAAAAAAMAAAAAQAAAAAAAAAAAAAAAAAAAB8AAABUAAAAAP8AAP///wEAAAAAAAAAAAAAAAAAAAAAAAAAAAAAAAAAAAAAAAAAAAAAAAJ/f38AgICAA8zMzADAwP8Af39/AAAAAAAAAAAAAAAAAAAAAAAAAAAAIQAAABgAAAAUAAAAOxUAAJIGAABpGwAAiwoAAAAAAAAmAAAACAAAAP//////////"/>
+                <pr:smNativeData xmlns:pr="smNativeData" xmlns="smNativeData" val="SMDATA_15_7aDWaRMAAAAlAAAAEgAAAA8BAAAAkAAAAEgAAACQAAAASAAAAAAAAAABAAAAAAAAAAEAAABQAAAAAAAAAAAA4D8AAAAAAADgPwAAAAAAAOA/AAAAAAAA4D8AAAAAAADgPwAAAAAAAOA/AAAAAAAA4D8AAAAAAADgPwAAAAAAAOA/AAAAAAAA4D8CAAAAjAAAAAEAAAAAAAAAAP8AAP///wgAAAAAAAAAAAAAAAAAAAAAAAAAAAAAAAAAAAAAZAAAAAEAAABAAAAAAAAAAAAAAAAAAAAAAAAAAAAAAAAAAAAAAAAAAAAAAAAAAAAAAAAAAAAAAAAAAAAAAAAAAAAAAAAAAAAAAAAAAAAAAAAAAAAAAAAAAAAAAAAAAAAAFAAAADwAAAABAAAAAAAAAAAAAAkUAAAAAQAAABQAAAAUAAAAFAAAAAEAAAAAAAAAZAAAAGQAAAAAAAAAZAAAAGQAAAAVAAAAYAAAAAAAAAAAAAAADwAAACADAAAAAAAAAAAAAAEAAACgMgAAVgcAAKr4//8BAAAAf39/AAEAAABkAAAAAAAAABQAAABAHwAAAAAAACYAAAAAAAAAwOD//wAAAAAmAAAAZAAAABYAAABMAAAAAAAAAAAAAAAEAAAAAAAAAAEAAACAgIAKAAAAACgAAAAoAAAAZAAAAGQAAAAAAAAAzMzMAAAAAABQAAAAUAAAAGQAAABkAAAAAAAAABcAAAAUAAAAAAAAAIgDAAD/fwAA/38AAAAAAAAJAAAABAAAACMAAAAeAAAAaAAAAAAAAAAAAAAAAAAAAAAAAAAAAAAAECcAABAnAAAAAAAAAAAAAAAAAAAAAAAAAAAAAAAAAAAAAAAAAAAAABQAAAAAAAAAwMD/AAAAAABkAAAAMgAAAAAAAABkAAAAAAAAAH9/fwAKAAAAIgAAABgAAAAAAAAAAAAAAAAAAAAAAAAAAAAAAAAAAAAkAAAAJAAAAAAAAAAHAAAAAAAAAAAAAAAAAAAAAAAAAAAAAAAAAAAAf39/ACUAAABYAAAAAAAAAAAAAAAAAAAAAAAAAAAAAAAAAAAAAAAAAAAAAAAAAAAAAAAAAAAAAAA/AAAAAAAAAKCGAQAAAAAAAAAAAAAAAAAMAAAAAQAAAAAAAAAAAAAAAAAAAB8AAABUAAAAAP8AAP///wEAAAAAAAAAAAAAAAAAAAAAAAAAAAAAAAAAAAAAAAAAAAAAAAJ/f38AgICAA8zMzADAwP8Af39/AAAAAAAAAAAAAAAAAAAAAAAAAAAAIQAAABgAAAAUAAAAOxUAAJIGAABpGwAAiwoAABAAAAAmAAAACAAAAP//////////"/>
               </a:ext>
             </a:extLst>
           </p:cNvSpPr>
@@ -4185,7 +4097,7 @@
           <p:cNvSpPr txBox="1">
             <a:extLst>
               <a:ext uri="smNativeData">
-                <pr:smNativeData xmlns:pr="smNativeData" xmlns="smNativeData" val="SMDATA_15_AnHWaRMAAAAlAAAAEgAAAA8BAAAAkAAAAEgAAACQAAAASAAAAAAAAAABAAAAAAAAAAEAAABQAAAAAAAAAAAA4D8AAAAAAADgPwAAAAAAAOA/AAAAAAAA4D8AAAAAAADgPwAAAAAAAOA/AAAAAAAA4D8AAAAAAADgPwAAAAAAAOA/AAAAAAAA4D8CAAAAjAAAAAEAAAAAAAAA//8AAP///wgAAAAAAAAAAAAAAAAAAAAAAAAAAAAAAAAAAAAAZAAAAAEAAABAAAAAAAAAAAAAAAAAAAAAAAAAAAAAAAAAAAAAAAAAAAAAAAAAAAAAAAAAAAAAAAAAAAAAAAAAAAAAAAAAAAAAAAAAAAAAAAAAAAAAAAAAAAAAAAAAAAAAFAAAADwAAAABAAAAAAAAAAAAAAkUAAAAAQAAABQAAAAUAAAAFAAAAAEAAAAAAAAAZAAAAGQAAAAAAAAAZAAAAGQAAAAVAAAAYAAAAAAAAAAAAAAADwAAACADAAAAAAAAAAAAAAEAAACgMgAAVgcAAKr4//8BAAAAf39/AAEAAABkAAAAAAAAABQAAABAHwAAAAAAACYAAAAAAAAAwOD//wAAAAAmAAAAZAAAABYAAABMAAAAAAAAAAAAAAAEAAAAAAAAAAEAAACAgIAKAAAAACgAAAAoAAAAZAAAAGQAAAAAAAAAzMzMAAAAAABQAAAAUAAAAGQAAABkAAAAAAAAABcAAAAUAAAAAAAAAIgDAAD/fwAA/38AAAAAAAAJAAAABAAAAAEBAQEeAAAAaAAAAAAAAAAAAAAAAAAAAAAAAAAAAAAAECcAABAnAAAAAAAAAAAAAAAAAAAAAAAAAAAAAAAAAAAAAAAAAAAAABQAAAAAAAAAwMD/AAAAAABkAAAAMgAAAAAAAABkAAAAAAAAAH9/fwAKAAAAIgAAABgAAAAAAAAAAAAAAAAAAAAAAAAAAAAAAAAAAAAkAAAAJAAAAAAAAAAHAAAAAAAAAAAAAAAAAAAAAAAAAAAAAAAAAAAAf39/ACUAAABYAAAAAAAAAAAAAAAAAAAAAAAAAAAAAAAAAAAAAAAAAAAAAAAAAAAAAAAAAAAAAAA/AAAAAAAAAKCGAQAAAAAAAAAAAAAAAAAMAAAAAQAAAAAAAAAAAAAAAAAAAB8AAABUAAAA//8AAP///wEAAAAAAAAAAAAAAAAAAAAAAAAAAAAAAAAAAAAAAAAAAAAAAAJ/f38AgICAA8zMzADAwP8Af39/AAAAAAAAAAAAAAAAAAAAAAAAAAAAIQAAABgAAAAUAAAAwQsAAIgNAADvEQAAehAAAAAAAAAmAAAACAAAAP//////////"/>
+                <pr:smNativeData xmlns:pr="smNativeData" xmlns="smNativeData" val="SMDATA_15_7aDWaRMAAAAlAAAAEgAAAA8BAAAAkAAAAEgAAACQAAAASAAAAAAAAAABAAAAAAAAAAEAAABQAAAAAAAAAAAA4D8AAAAAAADgPwAAAAAAAOA/AAAAAAAA4D8AAAAAAADgPwAAAAAAAOA/AAAAAAAA4D8AAAAAAADgPwAAAAAAAOA/AAAAAAAA4D8CAAAAjAAAAAEAAAAAAAAA//8AAP///wgAAAAAAAAAAAAAAAAAAAAAAAAAAAAAAAAAAAAAZAAAAAEAAABAAAAAAAAAAAAAAAAAAAAAAAAAAAAAAAAAAAAAAAAAAAAAAAAAAAAAAAAAAAAAAAAAAAAAAAAAAAAAAAAAAAAAAAAAAAAAAAAAAAAAAAAAAAAAAAAAAAAAFAAAADwAAAABAAAAAAAAAAAAAAkUAAAAAQAAABQAAAAUAAAAFAAAAAEAAAAAAAAAZAAAAGQAAAAAAAAAZAAAAGQAAAAVAAAAYAAAAAAAAAAAAAAADwAAACADAAAAAAAAAAAAAAEAAACgMgAAVgcAAKr4//8BAAAAf39/AAEAAABkAAAAAAAAABQAAABAHwAAAAAAACYAAAAAAAAAwOD//wAAAAAmAAAAZAAAABYAAABMAAAAAAAAAAAAAAAEAAAAAAAAAAEAAACAgIAKAAAAACgAAAAoAAAAZAAAAGQAAAAAAAAAzMzMAAAAAABQAAAAUAAAAGQAAABkAAAAAAAAABcAAAAUAAAAAAAAAIgDAAD/fwAA/38AAAAAAAAJAAAABAAAAAEBAQEeAAAAaAAAAAAAAAAAAAAAAAAAAAAAAAAAAAAAECcAABAnAAAAAAAAAAAAAAAAAAAAAAAAAAAAAAAAAAAAAAAAAAAAABQAAAAAAAAAwMD/AAAAAABkAAAAMgAAAAAAAABkAAAAAAAAAH9/fwAKAAAAIgAAABgAAAAAAAAAAAAAAAAAAAAAAAAAAAAAAAAAAAAkAAAAJAAAAAAAAAAHAAAAAAAAAAAAAAAAAAAAAAAAAAAAAAAAAAAAf39/ACUAAABYAAAAAAAAAAAAAAAAAAAAAAAAAAAAAAAAAAAAAAAAAAAAAAAAAAAAAAAAAAAAAAA/AAAAAAAAAKCGAQAAAAAAAAAAAAAAAAAMAAAAAQAAAAAAAAAAAAAAAAAAAB8AAABUAAAA//8AAP///wEAAAAAAAAAAAAAAAAAAAAAAAAAAAAAAAAAAAAAAAAAAAAAAAJ/f38AgICAA8zMzADAwP8Af39/AAAAAAAAAAAAAAAAAAAAAAAAAAAAIQAAABgAAAAUAAAAwQsAAIgNAADvEQAAehAAABAAAAAmAAAACAAAAP//////////"/>
               </a:ext>
             </a:extLst>
           </p:cNvSpPr>
@@ -4229,7 +4141,7 @@
           <p:cNvSpPr txBox="1">
             <a:extLst>
               <a:ext uri="smNativeData">
-                <pr:smNativeData xmlns:pr="smNativeData" xmlns="smNativeData" val="SMDATA_15_AnHWaRMAAAAlAAAAEgAAAA8BAAAAkAAAAEgAAACQAAAASAAAAAAAAAABAAAAAAAAAAEAAABQAAAAAAAAAAAA4D8AAAAAAADgPwAAAAAAAOA/AAAAAAAA4D8AAAAAAADgPwAAAAAAAOA/AAAAAAAA4D8AAAAAAADgPwAAAAAAAOA/AAAAAAAA4D8CAAAAjAAAAAEAAAAAAAAAAP8AAP///wgAAAAAAAAAAAAAAAAAAAAAAAAAAAAAAAAAAAAAZAAAAAEAAABAAAAAAAAAAAAAAAAAAAAAAAAAAAAAAAAAAAAAAAAAAAAAAAAAAAAAAAAAAAAAAAAAAAAAAAAAAAAAAAAAAAAAAAAAAAAAAAAAAAAAAAAAAAAAAAAAAAAAFAAAADwAAAABAAAAAAAAAAAAAAkUAAAAAQAAABQAAAAUAAAAFAAAAAEAAAAAAAAAZAAAAGQAAAAAAAAAZAAAAGQAAAAVAAAAYAAAAAAAAAAAAAAADwAAACADAAAAAAAAAAAAAAEAAACgMgAAVgcAAKr4//8BAAAAf39/AAEAAABkAAAAAAAAABQAAABAHwAAAAAAACYAAAAAAAAAwOD//wAAAAAmAAAAZAAAABYAAABMAAAAAAAAAAAAAAAEAAAAAAAAAAEAAACAgIAKAAAAACgAAAAoAAAAZAAAAGQAAAAAAAAAzMzMAAAAAABQAAAAUAAAAGQAAABkAAAAAAAAABcAAAAUAAAAAAAAAIgDAAD/fwAA/38AAAAAAAAJAAAABAAAACMAAAAeAAAAaAAAAAAAAAAAAAAAAAAAAAAAAAAAAAAAECcAABAnAAAAAAAAAAAAAAAAAAAAAAAAAAAAAAAAAAAAAAAAAAAAABQAAAAAAAAAwMD/AAAAAABkAAAAMgAAAAAAAABkAAAAAAAAAH9/fwAKAAAAIgAAABgAAAAAAAAAAAAAAAAAAAAAAAAAAAAAAAAAAAAkAAAAJAAAAAAAAAAHAAAAAAAAAAAAAAAAAAAAAAAAAAAAAAAAAAAAf39/ACUAAABYAAAAAAAAAAAAAAAAAAAAAAAAAAAAAAAAAAAAAAAAAAAAAAAAAAAAAAAAAAAAAAA/AAAAAAAAAKCGAQAAAAAAAAAAAAAAAAAMAAAAAQAAAAAAAAAAAAAAAAAAAB8AAABUAAAAAP8AAP///wEAAAAAAAAAAAAAAAAAAAAAAAAAAAAAAAAAAAAAAAAAAAAAAAJ/f38AgICAA8zMzADAwP8Af39/AAAAAAAAAAAAAAAAAAAAAAAAAAAAIQAAABgAAAAUAAAAfiIAAHgGAACOKQAAcQoAAAAAAAAmAAAACAAAAP//////////"/>
+                <pr:smNativeData xmlns:pr="smNativeData" xmlns="smNativeData" val="SMDATA_15_7aDWaRMAAAAlAAAAEgAAAA8BAAAAkAAAAEgAAACQAAAASAAAAAAAAAABAAAAAAAAAAEAAABQAAAAAAAAAAAA4D8AAAAAAADgPwAAAAAAAOA/AAAAAAAA4D8AAAAAAADgPwAAAAAAAOA/AAAAAAAA4D8AAAAAAADgPwAAAAAAAOA/AAAAAAAA4D8CAAAAjAAAAAEAAAAAAAAAAP8AAP///wgAAAAAAAAAAAAAAAAAAAAAAAAAAAAAAAAAAAAAZAAAAAEAAABAAAAAAAAAAAAAAAAAAAAAAAAAAAAAAAAAAAAAAAAAAAAAAAAAAAAAAAAAAAAAAAAAAAAAAAAAAAAAAAAAAAAAAAAAAAAAAAAAAAAAAAAAAAAAAAAAAAAAFAAAADwAAAABAAAAAAAAAAAAAAkUAAAAAQAAABQAAAAUAAAAFAAAAAEAAAAAAAAAZAAAAGQAAAAAAAAAZAAAAGQAAAAVAAAAYAAAAAAAAAAAAAAADwAAACADAAAAAAAAAAAAAAEAAACgMgAAVgcAAKr4//8BAAAAf39/AAEAAABkAAAAAAAAABQAAABAHwAAAAAAACYAAAAAAAAAwOD//wAAAAAmAAAAZAAAABYAAABMAAAAAAAAAAAAAAAEAAAAAAAAAAEAAACAgIAKAAAAACgAAAAoAAAAZAAAAGQAAAAAAAAAzMzMAAAAAABQAAAAUAAAAGQAAABkAAAAAAAAABcAAAAUAAAAAAAAAIgDAAD/fwAA/38AAAAAAAAJAAAABAAAACMAAAAeAAAAaAAAAAAAAAAAAAAAAAAAAAAAAAAAAAAAECcAABAnAAAAAAAAAAAAAAAAAAAAAAAAAAAAAAAAAAAAAAAAAAAAABQAAAAAAAAAwMD/AAAAAABkAAAAMgAAAAAAAABkAAAAAAAAAH9/fwAKAAAAIgAAABgAAAAAAAAAAAAAAAAAAAAAAAAAAAAAAAAAAAAkAAAAJAAAAAAAAAAHAAAAAAAAAAAAAAAAAAAAAAAAAAAAAAAAAAAAf39/ACUAAABYAAAAAAAAAAAAAAAAAAAAAAAAAAAAAAAAAAAAAAAAAAAAAAAAAAAAAAAAAAAAAAA/AAAAAAAAAKCGAQAAAAAAAAAAAAAAAAAMAAAAAQAAAAAAAAAAAAAAAAAAAB8AAABUAAAAAP8AAP///wEAAAAAAAAAAAAAAAAAAAAAAAAAAAAAAAAAAAAAAAAAAAAAAAJ/f38AgICAA8zMzADAwP8Af39/AAAAAAAAAAAAAAAAAAAAAAAAAAAAIQAAABgAAAAUAAAAfiIAAHgGAACOKQAAcQoAABAAAAAmAAAACAAAAP//////////"/>
               </a:ext>
             </a:extLst>
           </p:cNvSpPr>
@@ -4281,7 +4193,7 @@
           <p:cNvSpPr txBox="1">
             <a:extLst>
               <a:ext uri="smNativeData">
-                <pr:smNativeData xmlns:pr="smNativeData" xmlns="smNativeData" val="SMDATA_15_AnHWaRMAAAAlAAAAEgAAAA8BAAAAkAAAAEgAAACQAAAASAAAAAAAAAABAAAAAAAAAAEAAABQAAAAAAAAAAAA4D8AAAAAAADgPwAAAAAAAOA/AAAAAAAA4D8AAAAAAADgPwAAAAAAAOA/AAAAAAAA4D8AAAAAAADgPwAAAAAAAOA/AAAAAAAA4D8CAAAAjAAAAAEAAAAAAAAA//8AAP///wgAAAAAAAAAAAAAAAAAAAAAAAAAAAAAAAAAAAAAZAAAAAEAAABAAAAAAAAAAAAAAAAAAAAAAAAAAAAAAAAAAAAAAAAAAAAAAAAAAAAAAAAAAAAAAAAAAAAAAAAAAAAAAAAAAAAAAAAAAAAAAAAAAAAAAAAAAAAAAAAAAAAAFAAAADwAAAABAAAAAAAAAAAAAAkUAAAAAQAAABQAAAAUAAAAFAAAAAEAAAAAAAAAZAAAAGQAAAAAAAAAZAAAAGQAAAAVAAAAYAAAAAAAAAAAAAAADwAAACADAAAAAAAAAAAAAAEAAACgMgAAVgcAAKr4//8BAAAAf39/AAEAAABkAAAAAAAAABQAAABAHwAAAAAAACYAAAAAAAAAwOD//wAAAAAmAAAAZAAAABYAAABMAAAAAAAAAAAAAAAEAAAAAAAAAAEAAACAgIAKAAAAACgAAAAoAAAAZAAAAGQAAAAAAAAAzMzMAAAAAABQAAAAUAAAAGQAAABkAAAAAAAAABcAAAAUAAAAAAAAAIEHAAD/fwAA/38AAAAAAAAJAAAABAAAACMAAAAeAAAAaAAAAAAAAAAAAAAAAAAAAAAAAAAAAAAAECcAABAnAAAAAAAAAAAAAAAAAAAAAAAAAAAAAAAAAAAAAAAAAAAAABQAAAAAAAAAwMD/AAAAAABkAAAAMgAAAAAAAABkAAAAAAAAAH9/fwAKAAAAIgAAABgAAAAAAAAAAAAAAAAAAAAAAAAAAAAAAAAAAAAkAAAAJAAAAAAAAAAHAAAAAAAAAAAAAAAAAAAAAAAAAAAAAAAAAAAAf39/ACUAAABYAAAAAAAAAAAAAAAAAAAAAAAAAAAAAAAAAAAAAAAAAAAAAAAAAAAAAAAAAAAAAAA/AAAAAAAAAKCGAQAAAAAAAAAAAAAAAAAMAAAAAQAAAAAAAAAAAAAAAAAAAB8AAABUAAAA//8AAP///wEAAAAAAAAAAAAAAAAAAAAAAAAAAAAAAAAAAAAAAAAAAAAAAAJ/f38AgICAA8zMzADAwP8Af39/AAAAAAAAAAAAAAAAAAAAAAAAAAAAIQAAABgAAAAUAAAA8SAAAFsUAAAYKwAAVBgAAAAAAAAmAAAACAAAAP//////////"/>
+                <pr:smNativeData xmlns:pr="smNativeData" xmlns="smNativeData" val="SMDATA_15_7aDWaRMAAAAlAAAAEgAAAA8BAAAAkAAAAEgAAACQAAAASAAAAAAAAAABAAAAAAAAAAEAAABQAAAAAAAAAAAA4D8AAAAAAADgPwAAAAAAAOA/AAAAAAAA4D8AAAAAAADgPwAAAAAAAOA/AAAAAAAA4D8AAAAAAADgPwAAAAAAAOA/AAAAAAAA4D8CAAAAjAAAAAEAAAAAAAAA//8AAP///wgAAAAAAAAAAAAAAAAAAAAAAAAAAAAAAAAAAAAAZAAAAAEAAABAAAAAAAAAAAAAAAAAAAAAAAAAAAAAAAAAAAAAAAAAAAAAAAAAAAAAAAAAAAAAAAAAAAAAAAAAAAAAAAAAAAAAAAAAAAAAAAAAAAAAAAAAAAAAAAAAAAAAFAAAADwAAAABAAAAAAAAAAAAAAkUAAAAAQAAABQAAAAUAAAAFAAAAAEAAAAAAAAAZAAAAGQAAAAAAAAAZAAAAGQAAAAVAAAAYAAAAAAAAAAAAAAADwAAACADAAAAAAAAAAAAAAEAAACgMgAAVgcAAKr4//8BAAAAf39/AAEAAABkAAAAAAAAABQAAABAHwAAAAAAACYAAAAAAAAAwOD//wAAAAAmAAAAZAAAABYAAABMAAAAAAAAAAAAAAAEAAAAAAAAAAEAAACAgIAKAAAAACgAAAAoAAAAZAAAAGQAAAAAAAAAzMzMAAAAAABQAAAAUAAAAGQAAABkAAAAAAAAABcAAAAUAAAAAAAAAIEHAAD/fwAA/38AAAAAAAAJAAAABAAAACMAAAAeAAAAaAAAAAAAAAAAAAAAAAAAAAAAAAAAAAAAECcAABAnAAAAAAAAAAAAAAAAAAAAAAAAAAAAAAAAAAAAAAAAAAAAABQAAAAAAAAAwMD/AAAAAABkAAAAMgAAAAAAAABkAAAAAAAAAH9/fwAKAAAAIgAAABgAAAAAAAAAAAAAAAAAAAAAAAAAAAAAAAAAAAAkAAAAJAAAAAAAAAAHAAAAAAAAAAAAAAAAAAAAAAAAAAAAAAAAAAAAf39/ACUAAABYAAAAAAAAAAAAAAAAAAAAAAAAAAAAAAAAAAAAAAAAAAAAAAAAAAAAAAAAAAAAAAA/AAAAAAAAAKCGAQAAAAAAAAAAAAAAAAAMAAAAAQAAAAAAAAAAAAAAAAAAAB8AAABUAAAA//8AAP///wEAAAAAAAAAAAAAAAAAAAAAAAAAAAAAAAAAAAAAAAAAAAAAAAJ/f38AgICAA8zMzADAwP8Af39/AAAAAAAAAAAAAAAAAAAAAAAAAAAAIQAAABgAAAAUAAAA8SAAAFsUAAAYKwAAVBgAABAAAAAmAAAACAAAAP//////////"/>
               </a:ext>
             </a:extLst>
           </p:cNvSpPr>
@@ -4333,7 +4245,7 @@
           <p:cNvSpPr txBox="1">
             <a:extLst>
               <a:ext uri="smNativeData">
-                <pr:smNativeData xmlns:pr="smNativeData" xmlns="smNativeData" val="SMDATA_15_AnHWaRMAAAAlAAAAEgAAAA8BAAAAkAAAAEgAAACQAAAASAAAAAAAAAABAAAAAAAAAAEAAABQAAAAAAAAAAAA4D8AAAAAAADgPwAAAAAAAOA/AAAAAAAA4D8AAAAAAADgPwAAAAAAAOA/AAAAAAAA4D8AAAAAAADgPwAAAAAAAOA/AAAAAAAA4D8CAAAAjAAAAAEAAAAAAAAA//8AAP///wgAAAAAAAAAAAAAAAAAAAAAAAAAAAAAAAAAAAAAZAAAAAEAAABAAAAAAAAAAAAAAAAAAAAAAAAAAAAAAAAAAAAAAAAAAAAAAAAAAAAAAAAAAAAAAAAAAAAAAAAAAAAAAAAAAAAAAAAAAAAAAAAAAAAAAAAAAAAAAAAAAAAAFAAAADwAAAABAAAAAAAAAAAAAAkUAAAAAQAAABQAAAAUAAAAFAAAAAEAAAAAAAAAZAAAAGQAAAAAAAAAZAAAAGQAAAAVAAAAYAAAAAAAAAAAAAAADwAAACADAAAAAAAAAAAAAAEAAACgMgAAVgcAAKr4//8BAAAAf39/AAEAAABkAAAAAAAAABQAAABAHwAAAAAAACYAAAAAAAAAwOD//wAAAAAmAAAAZAAAABYAAABMAAAAAAAAAAAAAAAEAAAAAAAAAAEAAACAgIAKAAAAACgAAAAoAAAAZAAAAGQAAAAAAAAAzMzMAAAAAABQAAAAUAAAAGQAAABkAAAAAAAAABcAAAAUAAAAAAAAAIgDAAD/fwAA/38AAAAAAAAJAAAABAAAACMAAAAeAAAAaAAAAAAAAAAAAAAAAAAAAAAAAAAAAAAAECcAABAnAAAAAAAAAAAAAAAAAAAAAAAAAAAAAAAAAAAAAAAAAAAAABQAAAAAAAAAwMD/AAAAAABkAAAAMgAAAAAAAABkAAAAAAAAAH9/fwAKAAAAIgAAABgAAAAAAAAAAAAAAAAAAAAAAAAAAAAAAAAAAAAkAAAAJAAAAAAAAAAHAAAAAAAAAAAAAAAAAAAAAAAAAAAAAAAAAAAAf39/ACUAAABYAAAAAAAAAAAAAAAAAAAAAAAAAAAAAAAAAAAAAAAAAAAAAAAAAAAAAAAAAAAAAAA/AAAAAAAAAKCGAQAAAAAAAAAAAAAAAAAMAAAAAQAAAAAAAAAAAAAAAAAAAB8AAABUAAAA//8AAP///wEAAAAAAAAAAAAAAAAAAAAAAAAAAAAAAAAAAAAAAAAAAAAAAAJ/f38AgICAA8zMzADAwP8Af39/AAAAAAAAAAAAAAAAAAAAAAAAAAAAIQAAABgAAAAUAAAAgTIAAOUHAADkOgAA/AoAAAAAAAAmAAAACAAAAP//////////"/>
+                <pr:smNativeData xmlns:pr="smNativeData" xmlns="smNativeData" val="SMDATA_15_7aDWaRMAAAAlAAAAEgAAAA8BAAAAkAAAAEgAAACQAAAASAAAAAAAAAABAAAAAAAAAAEAAABQAAAAAAAAAAAA4D8AAAAAAADgPwAAAAAAAOA/AAAAAAAA4D8AAAAAAADgPwAAAAAAAOA/AAAAAAAA4D8AAAAAAADgPwAAAAAAAOA/AAAAAAAA4D8CAAAAjAAAAAEAAAAAAAAA//8AAP///wgAAAAAAAAAAAAAAAAAAAAAAAAAAAAAAAAAAAAAZAAAAAEAAABAAAAAAAAAAAAAAAAAAAAAAAAAAAAAAAAAAAAAAAAAAAAAAAAAAAAAAAAAAAAAAAAAAAAAAAAAAAAAAAAAAAAAAAAAAAAAAAAAAAAAAAAAAAAAAAAAAAAAFAAAADwAAAABAAAAAAAAAAAAAAkUAAAAAQAAABQAAAAUAAAAFAAAAAEAAAAAAAAAZAAAAGQAAAAAAAAAZAAAAGQAAAAVAAAAYAAAAAAAAAAAAAAADwAAACADAAAAAAAAAAAAAAEAAACgMgAAVgcAAKr4//8BAAAAf39/AAEAAABkAAAAAAAAABQAAABAHwAAAAAAACYAAAAAAAAAwOD//wAAAAAmAAAAZAAAABYAAABMAAAAAAAAAAAAAAAEAAAAAAAAAAEAAACAgIAKAAAAACgAAAAoAAAAZAAAAGQAAAAAAAAAzMzMAAAAAABQAAAAUAAAAGQAAABkAAAAAAAAABcAAAAUAAAAAAAAAIgDAAD/fwAA/38AAAAAAAAJAAAABAAAACMAAAAeAAAAaAAAAAAAAAAAAAAAAAAAAAAAAAAAAAAAECcAABAnAAAAAAAAAAAAAAAAAAAAAAAAAAAAAAAAAAAAAAAAAAAAABQAAAAAAAAAwMD/AAAAAABkAAAAMgAAAAAAAABkAAAAAAAAAH9/fwAKAAAAIgAAABgAAAAAAAAAAAAAAAAAAAAAAAAAAAAAAAAAAAAkAAAAJAAAAAAAAAAHAAAAAAAAAAAAAAAAAAAAAAAAAAAAAAAAAAAAf39/ACUAAABYAAAAAAAAAAAAAAAAAAAAAAAAAAAAAAAAAAAAAAAAAAAAAAAAAAAAAAAAAAAAAAA/AAAAAAAAAKCGAQAAAAAAAAAAAAAAAAAMAAAAAQAAAAAAAAAAAAAAAAAAAB8AAABUAAAA//8AAP///wEAAAAAAAAAAAAAAAAAAAAAAAAAAAAAAAAAAAAAAAAAAAAAAAJ/f38AgICAA8zMzADAwP8Af39/AAAAAAAAAAAAAAAAAAAAAAAAAAAAIQAAABgAAAAUAAAAgTIAAOUHAADkOgAA/AoAABAAAAAmAAAACAAAAP//////////"/>
               </a:ext>
             </a:extLst>
           </p:cNvSpPr>
@@ -4377,7 +4289,7 @@
           <p:cNvSpPr txBox="1">
             <a:extLst>
               <a:ext uri="smNativeData">
-                <pr:smNativeData xmlns:pr="smNativeData" xmlns="smNativeData" val="SMDATA_15_AnHWaRMAAAAlAAAAEgAAAA8BAAAAkAAAAEgAAACQAAAASAAAAAAAAAABAAAAAAAAAAEAAABQAAAAAAAAAAAA4D8AAAAAAADgPwAAAAAAAOA/AAAAAAAA4D8AAAAAAADgPwAAAAAAAOA/AAAAAAAA4D8AAAAAAADgPwAAAAAAAOA/AAAAAAAA4D8CAAAAjAAAAAEAAAAAAAAAAP8AAP///wgAAAAAAAAAAAAAAAAAAAAAAAAAAAAAAAAAAAAAZAAAAAEAAABAAAAAAAAAAAAAAAAAAAAAAAAAAAAAAAAAAAAAAAAAAAAAAAAAAAAAAAAAAAAAAAAAAAAAAAAAAAAAAAAAAAAAAAAAAAAAAAAAAAAAAAAAAAAAAAAAAAAAFAAAADwAAAABAAAAAAAAAAAAAAkUAAAAAQAAABQAAAAUAAAAFAAAAAEAAAAAAAAAZAAAAGQAAAAAAAAAZAAAAGQAAAAVAAAAYAAAAAAAAAAAAAAADwAAACADAAAAAAAAAAAAAAEAAACgMgAAVgcAAKr4//8BAAAAf39/AAEAAABkAAAAAAAAABQAAABAHwAAAAAAACYAAAAAAAAAwOD//wAAAAAmAAAAZAAAABYAAABMAAAAAAAAAAAAAAAEAAAAAAAAAAEAAACAgIAKAAAAACgAAAAoAAAAZAAAAGQAAAAAAAAAzMzMAAAAAABQAAAAUAAAAGQAAABkAAAAAAAAABcAAAAUAAAAAAAAAIgDAAD/fwAA/38AAAAAAAAJAAAABAAAACMAAAAeAAAAaAAAAAAAAAAAAAAAAAAAAAAAAAAAAAAAECcAABAnAAAAAAAAAAAAAAAAAAAAAAAAAAAAAAAAAAAAAAAAAAAAABQAAAAAAAAAwMD/AAAAAABkAAAAMgAAAAAAAABkAAAAAAAAAH9/fwAKAAAAIgAAABgAAAAAAAAAAAAAAAAAAAAAAAAAAAAAAAAAAAAkAAAAJAAAAAAAAAAHAAAAAAAAAAAAAAAAAAAAAAAAAAAAAAAAAAAAf39/ACUAAABYAAAAAAAAAAAAAAAAAAAAAAAAAAAAAAAAAAAAAAAAAAAAAAAAAAAAAAAAAAAAAAA/AAAAAAAAAKCGAQAAAAAAAAAAAAAAAAAMAAAAAQAAAAAAAAAAAAAAAAAAAB8AAABUAAAAAP8AAP///wEAAAAAAAAAAAAAAAAAAAAAAAAAAAAAAAAAAAAAAAAAAAAAAAJ/f38AgICAA8zMzADAwP8Af39/AAAAAAAAAAAAAAAAAAAAAAAAAAAAIQAAABgAAAAUAAAALDEAAH8CAAA1PAAAlgUAAAAAAAAmAAAACAAAAP//////////"/>
+                <pr:smNativeData xmlns:pr="smNativeData" xmlns="smNativeData" val="SMDATA_15_7aDWaRMAAAAlAAAAEgAAAA8BAAAAkAAAAEgAAACQAAAASAAAAAAAAAABAAAAAAAAAAEAAABQAAAAAAAAAAAA4D8AAAAAAADgPwAAAAAAAOA/AAAAAAAA4D8AAAAAAADgPwAAAAAAAOA/AAAAAAAA4D8AAAAAAADgPwAAAAAAAOA/AAAAAAAA4D8CAAAAjAAAAAEAAAAAAAAAAP8AAP///wgAAAAAAAAAAAAAAAAAAAAAAAAAAAAAAAAAAAAAZAAAAAEAAABAAAAAAAAAAAAAAAAAAAAAAAAAAAAAAAAAAAAAAAAAAAAAAAAAAAAAAAAAAAAAAAAAAAAAAAAAAAAAAAAAAAAAAAAAAAAAAAAAAAAAAAAAAAAAAAAAAAAAFAAAADwAAAABAAAAAAAAAAAAAAkUAAAAAQAAABQAAAAUAAAAFAAAAAEAAAAAAAAAZAAAAGQAAAAAAAAAZAAAAGQAAAAVAAAAYAAAAAAAAAAAAAAADwAAACADAAAAAAAAAAAAAAEAAACgMgAAVgcAAKr4//8BAAAAf39/AAEAAABkAAAAAAAAABQAAABAHwAAAAAAACYAAAAAAAAAwOD//wAAAAAmAAAAZAAAABYAAABMAAAAAAAAAAAAAAAEAAAAAAAAAAEAAACAgIAKAAAAACgAAAAoAAAAZAAAAGQAAAAAAAAAzMzMAAAAAABQAAAAUAAAAGQAAABkAAAAAAAAABcAAAAUAAAAAAAAAIgDAAD/fwAA/38AAAAAAAAJAAAABAAAACMAAAAeAAAAaAAAAAAAAAAAAAAAAAAAAAAAAAAAAAAAECcAABAnAAAAAAAAAAAAAAAAAAAAAAAAAAAAAAAAAAAAAAAAAAAAABQAAAAAAAAAwMD/AAAAAABkAAAAMgAAAAAAAABkAAAAAAAAAH9/fwAKAAAAIgAAABgAAAAAAAAAAAAAAAAAAAAAAAAAAAAAAAAAAAAkAAAAJAAAAAAAAAAHAAAAAAAAAAAAAAAAAAAAAAAAAAAAAAAAAAAAf39/ACUAAABYAAAAAAAAAAAAAAAAAAAAAAAAAAAAAAAAAAAAAAAAAAAAAAAAAAAAAAAAAAAAAAA/AAAAAAAAAKCGAQAAAAAAAAAAAAAAAAAMAAAAAQAAAAAAAAAAAAAAAAAAAB8AAABUAAAAAP8AAP///wEAAAAAAAAAAAAAAAAAAAAAAAAAAAAAAAAAAAAAAAAAAAAAAAJ/f38AgICAA8zMzADAwP8Af39/AAAAAAAAAAAAAAAAAAAAAAAAAAAAIQAAABgAAAAUAAAALDEAAH8CAAA1PAAAlgUAABAAAAAmAAAACAAAAP//////////"/>
               </a:ext>
             </a:extLst>
           </p:cNvSpPr>
@@ -4421,7 +4333,7 @@
           <p:cNvSpPr txBox="1">
             <a:extLst>
               <a:ext uri="smNativeData">
-                <pr:smNativeData xmlns:pr="smNativeData" xmlns="smNativeData" val="SMDATA_15_AnHWaRMAAAAlAAAAEgAAAA8BAAAAkAAAAEgAAACQAAAASAAAAAAAAAABAAAAAAAAAAEAAABQAAAAAAAAAAAA4D8AAAAAAADgPwAAAAAAAOA/AAAAAAAA4D8AAAAAAADgPwAAAAAAAOA/AAAAAAAA4D8AAAAAAADgPwAAAAAAAOA/AAAAAAAA4D8CAAAAjAAAAAEAAAAAAAAA//8AAP///wgAAAAAAAAAAAAAAAAAAAAAAAAAAAAAAAAAAAAAZAAAAAEAAABAAAAAAAAAAAAAAAAAAAAAAAAAAAAAAAAAAAAAAAAAAAAAAAAAAAAAAAAAAAAAAAAAAAAAAAAAAAAAAAAAAAAAAAAAAAAAAAAAAAAAAAAAAAAAAAAAAAAAFAAAADwAAAABAAAAAAAAAAAAAAkUAAAAAQAAABQAAAAUAAAAFAAAAAEAAAAAAAAAZAAAAGQAAAAAAAAAZAAAAGQAAAAVAAAAYAAAAAAAAAAAAAAADwAAACADAAAAAAAAAAAAAAEAAACgMgAAVgcAAKr4//8BAAAAf39/AAEAAABkAAAAAAAAABQAAABAHwAAAAAAACYAAAAAAAAAwOD//wAAAAAmAAAAZAAAABYAAABMAAAAAAAAAAAAAAAEAAAAAAAAAAEAAACAgIAKAAAAACgAAAAoAAAAZAAAAGQAAAAAAAAAzMzMAAAAAABQAAAAUAAAAGQAAABkAAAAAAAAABcAAAAUAAAAAAAAAIEHAAD/fwAA/38AAAAAAAAJAAAABAAAACMAAAAeAAAAaAAAAAAAAAAAAAAAAAAAAAAAAAAAAAAAECcAABAnAAAAAAAAAAAAAAAAAAAAAAAAAAAAAAAAAAAAAAAAAAAAABQAAAAAAAAAwMD/AAAAAABkAAAAMgAAAAAAAABkAAAAAAAAAH9/fwAKAAAAIgAAABgAAAAAAAAAAAAAAAAAAAAAAAAAAAAAAAAAAAAkAAAAJAAAAAAAAAAHAAAAAAAAAAAAAAAAAAAAAAAAAAAAAAAAAAAAf39/ACUAAABYAAAAAAAAAAAAAAAAAAAAAAAAAAAAAAAAAAAAAAAAAAAAAAAAAAAAAAAAAAAAAAA/AAAAAAAAAKCGAQAAAAAAAAAAAAAAAAAMAAAAAQAAAAAAAAAAAAAAAAAAAB8AAABUAAAA//8AAP///wEAAAAAAAAAAAAAAAAAAAAAAAAAAAAAAAAAAAAAAAAAAAAAAAJ/f38AgICAA8zMzADAwP8Af39/AAAAAAAAAAAAAAAAAAAAAAAAAAAAIQAAABgAAAAUAAAAgDIAABMOAACnPAAADBIAAAAAAAAmAAAACAAAAP//////////"/>
+                <pr:smNativeData xmlns:pr="smNativeData" xmlns="smNativeData" val="SMDATA_15_7aDWaRMAAAAlAAAAEgAAAA8BAAAAkAAAAEgAAACQAAAASAAAAAAAAAABAAAAAAAAAAEAAABQAAAAAAAAAAAA4D8AAAAAAADgPwAAAAAAAOA/AAAAAAAA4D8AAAAAAADgPwAAAAAAAOA/AAAAAAAA4D8AAAAAAADgPwAAAAAAAOA/AAAAAAAA4D8CAAAAjAAAAAEAAAAAAAAA//8AAP///wgAAAAAAAAAAAAAAAAAAAAAAAAAAAAAAAAAAAAAZAAAAAEAAABAAAAAAAAAAAAAAAAAAAAAAAAAAAAAAAAAAAAAAAAAAAAAAAAAAAAAAAAAAAAAAAAAAAAAAAAAAAAAAAAAAAAAAAAAAAAAAAAAAAAAAAAAAAAAAAAAAAAAFAAAADwAAAABAAAAAAAAAAAAAAkUAAAAAQAAABQAAAAUAAAAFAAAAAEAAAAAAAAAZAAAAGQAAAAAAAAAZAAAAGQAAAAVAAAAYAAAAAAAAAAAAAAADwAAACADAAAAAAAAAAAAAAEAAACgMgAAVgcAAKr4//8BAAAAf39/AAEAAABkAAAAAAAAABQAAABAHwAAAAAAACYAAAAAAAAAwOD//wAAAAAmAAAAZAAAABYAAABMAAAAAAAAAAAAAAAEAAAAAAAAAAEAAACAgIAKAAAAACgAAAAoAAAAZAAAAGQAAAAAAAAAzMzMAAAAAABQAAAAUAAAAGQAAABkAAAAAAAAABcAAAAUAAAAAAAAAIEHAAD/fwAA/38AAAAAAAAJAAAABAAAACMAAAAeAAAAaAAAAAAAAAAAAAAAAAAAAAAAAAAAAAAAECcAABAnAAAAAAAAAAAAAAAAAAAAAAAAAAAAAAAAAAAAAAAAAAAAABQAAAAAAAAAwMD/AAAAAABkAAAAMgAAAAAAAABkAAAAAAAAAH9/fwAKAAAAIgAAABgAAAAAAAAAAAAAAAAAAAAAAAAAAAAAAAAAAAAkAAAAJAAAAAAAAAAHAAAAAAAAAAAAAAAAAAAAAAAAAAAAAAAAAAAAf39/ACUAAABYAAAAAAAAAAAAAAAAAAAAAAAAAAAAAAAAAAAAAAAAAAAAAAAAAAAAAAAAAAAAAAA/AAAAAAAAAKCGAQAAAAAAAAAAAAAAAAAMAAAAAQAAAAAAAAAAAAAAAAAAAB8AAABUAAAA//8AAP///wEAAAAAAAAAAAAAAAAAAAAAAAAAAAAAAAAAAAAAAAAAAAAAAAJ/f38AgICAA8zMzADAwP8Af39/AAAAAAAAAAAAAAAAAAAAAAAAAAAAIQAAABgAAAAUAAAAgDIAABMOAACnPAAADBIAABAAAAAmAAAACAAAAP//////////"/>
               </a:ext>
             </a:extLst>
           </p:cNvSpPr>
@@ -4473,7 +4385,7 @@
           <p:cNvSpPr txBox="1">
             <a:extLst>
               <a:ext uri="smNativeData">
-                <pr:smNativeData xmlns:pr="smNativeData" xmlns="smNativeData" val="SMDATA_15_AnHWaRMAAAAlAAAAEgAAAA8BAAAAkAAAAEgAAACQAAAASAAAAAAAAAABAAAAAAAAAAEAAABQAAAAAAAAAAAA4D8AAAAAAADgPwAAAAAAAOA/AAAAAAAA4D8AAAAAAADgPwAAAAAAAOA/AAAAAAAA4D8AAAAAAADgPwAAAAAAAOA/AAAAAAAA4D8CAAAAjAAAAAEAAAAAAAAA//8AAP///wgAAAAAAAAAAAAAAAAAAAAAAAAAAAAAAAAAAAAAZAAAAAEAAABAAAAAAAAAAAAAAAAAAAAAAAAAAAAAAAAAAAAAAAAAAAAAAAAAAAAAAAAAAAAAAAAAAAAAAAAAAAAAAAAAAAAAAAAAAAAAAAAAAAAAAAAAAAAAAAAAAAAAFAAAADwAAAABAAAAAAAAAAAAAAkUAAAAAQAAABQAAAAUAAAAFAAAAAEAAAAAAAAAZAAAAGQAAAAAAAAAZAAAAGQAAAAVAAAAYAAAAAAAAAAAAAAADwAAACADAAAAAAAAAAAAAAEAAACgMgAAVgcAAKr4//8BAAAAf39/AAEAAABkAAAAAAAAABQAAABAHwAAAAAAACYAAAAAAAAAwOD//wAAAAAmAAAAZAAAABYAAABMAAAAAAAAAAAAAAAEAAAAAAAAAAEAAACAgIAKAAAAACgAAAAoAAAAZAAAAGQAAAAAAAAAzMzMAAAAAABQAAAAUAAAAGQAAABkAAAAAAAAABcAAAAUAAAAAAAAAIEHAAD/fwAA/38AAAAAAAAJAAAABAAAAJCbpzEeAAAAaAAAAAAAAAAAAAAAAAAAAAAAAAAAAAAAECcAABAnAAAAAAAAAAAAAAAAAAAAAAAAAAAAAAAAAAAAAAAAAAAAABQAAAAAAAAAwMD/AAAAAABkAAAAMgAAAAAAAABkAAAAAAAAAH9/fwAKAAAAIgAAABgAAAAAAAAAAAAAAAAAAAAAAAAAAAAAAAAAAAAkAAAAJAAAAAAAAAAHAAAAAAAAAAAAAAAAAAAAAAAAAAAAAAAAAAAAf39/ACUAAABYAAAAAAAAAAAAAAAAAAAAAAAAAAAAAAAAAAAAAAAAAAAAAAAAAAAAAAAAAAAAAAA/AAAAAAAAAKCGAQAAAAAAAAAAAAAAAAAMAAAAAQAAAAAAAAAAAAAAAAAAAB8AAABUAAAA//8AAP///wEAAAAAAAAAAAAAAAAAAAAAAAAAAAAAAAAAAAAAAAAAAAAAAAJ/f38AgICAA8zMzADAwP8Af39/AAAAAAAAAAAAAAAAAAAAAAAAAAAAIQAAABgAAAAUAAAARjEAAFsUAACSNgAAVBgAAAAAAAAmAAAACAAAAP//////////"/>
+                <pr:smNativeData xmlns:pr="smNativeData" xmlns="smNativeData" val="SMDATA_15_7aDWaRMAAAAlAAAAEgAAAA8BAAAAkAAAAEgAAACQAAAASAAAAAAAAAABAAAAAAAAAAEAAABQAAAAAAAAAAAA4D8AAAAAAADgPwAAAAAAAOA/AAAAAAAA4D8AAAAAAADgPwAAAAAAAOA/AAAAAAAA4D8AAAAAAADgPwAAAAAAAOA/AAAAAAAA4D8CAAAAjAAAAAEAAAAAAAAA//8AAP///wgAAAAAAAAAAAAAAAAAAAAAAAAAAAAAAAAAAAAAZAAAAAEAAABAAAAAAAAAAAAAAAAAAAAAAAAAAAAAAAAAAAAAAAAAAAAAAAAAAAAAAAAAAAAAAAAAAAAAAAAAAAAAAAAAAAAAAAAAAAAAAAAAAAAAAAAAAAAAAAAAAAAAFAAAADwAAAABAAAAAAAAAAAAAAkUAAAAAQAAABQAAAAUAAAAFAAAAAEAAAAAAAAAZAAAAGQAAAAAAAAAZAAAAGQAAAAVAAAAYAAAAAAAAAAAAAAADwAAACADAAAAAAAAAAAAAAEAAACgMgAAVgcAAKr4//8BAAAAf39/AAEAAABkAAAAAAAAABQAAABAHwAAAAAAACYAAAAAAAAAwOD//wAAAAAmAAAAZAAAABYAAABMAAAAAAAAAAAAAAAEAAAAAAAAAAEAAACAgIAKAAAAACgAAAAoAAAAZAAAAGQAAAAAAAAAzMzMAAAAAABQAAAAUAAAAGQAAABkAAAAAAAAABcAAAAUAAAAAAAAAIEHAAD/fwAA/38AAAAAAAAJAAAABAAAAJCbpzEeAAAAaAAAAAAAAAAAAAAAAAAAAAAAAAAAAAAAECcAABAnAAAAAAAAAAAAAAAAAAAAAAAAAAAAAAAAAAAAAAAAAAAAABQAAAAAAAAAwMD/AAAAAABkAAAAMgAAAAAAAABkAAAAAAAAAH9/fwAKAAAAIgAAABgAAAAAAAAAAAAAAAAAAAAAAAAAAAAAAAAAAAAkAAAAJAAAAAAAAAAHAAAAAAAAAAAAAAAAAAAAAAAAAAAAAAAAAAAAf39/ACUAAABYAAAAAAAAAAAAAAAAAAAAAAAAAAAAAAAAAAAAAAAAAAAAAAAAAAAAAAAAAAAAAAA/AAAAAAAAAKCGAQAAAAAAAAAAAAAAAAAMAAAAAQAAAAAAAAAAAAAAAAAAAB8AAABUAAAA//8AAP///wEAAAAAAAAAAAAAAAAAAAAAAAAAAAAAAAAAAAAAAAAAAAAAAAJ/f38AgICAA8zMzADAwP8Af39/AAAAAAAAAAAAAAAAAAAAAAAAAAAAIQAAABgAAAAUAAAARjEAAFsUAACSNgAAVBgAABAAAAAmAAAACAAAAP//////////"/>
               </a:ext>
             </a:extLst>
           </p:cNvSpPr>
@@ -4525,7 +4437,7 @@
           <p:cNvGrpSpPr>
             <a:extLst>
               <a:ext uri="smNativeData">
-                <pr:smNativeData xmlns:pr="smNativeData" xmlns="smNativeData" val="SMDATA_6_AnHWaRMAAAAlAAAAAQAAAC8BAAAAkAAAAEgAAACQAAAASAAAAAAAAAAAAAAAAAAAABcAAAAUAAAAAAAAAAAAAAD/fwAA/38AAAAAAAAJAAAABAAAAA8AAAAfAAAAVAAAAAAAAAAAAAAAAAAAAAAAAAAAAAAAAAAAAAAAAAAAAAAAAAAAAAAAAAAAAAAAAAAAAAAAAAAAAAAAAAAAAAAAAAAAAAAAAAAAAAAAAAAAAAAAAAAAACEAAAAYAAAAFAAAAKkoAADFGwAATDAAAP4eAAAAAAAAJgAAAAgAAAD/////AAAAAA=="/>
+                <pr:smNativeData xmlns:pr="smNativeData" xmlns="smNativeData" val="SMDATA_6_7aDWaRMAAAAlAAAAAQAAAA8BAAAAkAAAAEgAAACQAAAASAAAAAAAAAAAAAAAAAAAABcAAAAUAAAAAAAAAAAAAAD/fwAA/38AAAAAAAAJAAAABAAAAN4aAAAfAAAAVAAAAAAAAAAAAAAAAAAAAAAAAAAAAAAAAAAAAAAAAAAAAAAAAAAAAAAAAAAAAAAAAAAAAAAAAAAAAAAAAAAAAAAAAAAAAAAAAAAAAAAAAAAAAAAAAAAAACEAAAAYAAAAFAAAAKkoAADFGwAATDAAAP4eAAAQAAAAJgAAAAgAAAD/////AAAAAA=="/>
               </a:ext>
             </a:extLst>
           </p:cNvGrpSpPr>
@@ -4545,7 +4457,7 @@
             <p:cNvSpPr txBox="1">
               <a:extLst>
                 <a:ext uri="smNativeData">
-                  <pr:smNativeData xmlns:pr="smNativeData" xmlns="smNativeData" val="SMDATA_15_AnHWaRMAAAAlAAAAEgAAAA8BAAAAkAAAAEgAAACQAAAASAAAAAAAAAABAAAAAAAAAAEAAABQAAAAAAAAAAAA4D8AAAAAAADgPwAAAAAAAOA/AAAAAAAA4D8AAAAAAADgPwAAAAAAAOA/AAAAAAAA4D8AAAAAAADgPwAAAAAAAOA/AAAAAAAA4D8CAAAAjAAAAAEAAAAAAAAA//8AAP///wgAAAAAAAAAAAAAAAAAAAAAAAAAAAAAAAAAAAAAZAAAAAEAAABAAAAAAAAAAAAAAAAAAAAAAAAAAAAAAAAAAAAAAAAAAAAAAAAAAAAAAAAAAAAAAAAAAAAAAAAAAAAAAAAAAAAAAAAAAAAAAAAAAAAAAAAAAAAAAAAAAAAAFAAAADwAAAABAAAAAAAAAAAAAAkUAAAAAQAAABQAAAAUAAAAFAAAAAEAAAAAAAAAZAAAAGQAAAAAAAAAZAAAAGQAAAAVAAAAYAAAAAAAAAAAAAAADwAAACADAAAAAAAAAAAAAAEAAACgMgAAVgcAAKr4//8BAAAAf39/AAEAAABkAAAAAAAAABQAAABAHwAAAAAAACYAAAAAAAAAwOD//wAAAAAmAAAAZAAAABYAAABMAAAAAAAAAAAAAAAEAAAAAAAAAAEAAACAgIAKAAAAACgAAAAoAAAAZAAAAGQAAAAAAAAAzMzMAAAAAABQAAAAUAAAAGQAAABkAAAAAAAAABcAAAAUAAAAAAAAAIgDAAD/fwAA/38AAAAAAAAJAAAABAAAACMAAAAeAAAAaAAAAAAAAAAAAAAAAAAAAAAAAAAAAAAAECcAABAnAAAAAAAAAAAAAAAAAAAAAAAAAAAAAAAAAAAAAAAAAAAAABQAAAAAAAAAwMD/AAAAAABkAAAAMgAAAAAAAABkAAAAAAAAAH9/fwAKAAAAIgAAABgAAAAAAAAAAAAAAAAAAAAAAAAAAAAAAAAAAAAkAAAAJAAAAAAAAAAHAAAAAAAAAAAAAAAAAAAAAAAAAAAAAAAAAAAAf39/ACUAAABYAAAAAAAAAAAAAAAAAAAAAAAAAAAAAAAAAAAAAAAAAAAAAAAAAAAAAAAAAAAAAAA/AAAAAAAAAKCGAQAAAAAAAAAAAAAAAAAMAAAAAQAAAAAAAAAAAAAAAAAAAB8AAABUAAAA//8AAP///wEAAAAAAAAAAAAAAAAAAAAAAAAAAAAAAAAAAAAAAAAAAAAAAAJ/f38AgICAA8zMzADAwP8Af39/AAAAAAAAAAAAAAAAAAAAAAAAAAAAIQAAABgAAAAUAAAADSkAACkcAABMMAAA/h4AAAAAAAAmAAAACAAAAP//////////"/>
+                  <pr:smNativeData xmlns:pr="smNativeData" xmlns="smNativeData" val="SMDATA_15_7aDWaRMAAAAlAAAAEgAAAA8BAAAAkAAAAEgAAACQAAAASAAAAAAAAAABAAAAAAAAAAEAAABQAAAAAAAAAAAA4D8AAAAAAADgPwAAAAAAAOA/AAAAAAAA4D8AAAAAAADgPwAAAAAAAOA/AAAAAAAA4D8AAAAAAADgPwAAAAAAAOA/AAAAAAAA4D8CAAAAjAAAAAEAAAAAAAAA//8AAP///wgAAAAAAAAAAAAAAAAAAAAAAAAAAAAAAAAAAAAAZAAAAAEAAABAAAAAAAAAAAAAAAAAAAAAAAAAAAAAAAAAAAAAAAAAAAAAAAAAAAAAAAAAAAAAAAAAAAAAAAAAAAAAAAAAAAAAAAAAAAAAAAAAAAAAAAAAAAAAAAAAAAAAFAAAADwAAAABAAAAAAAAAAAAAAkUAAAAAQAAABQAAAAUAAAAFAAAAAEAAAAAAAAAZAAAAGQAAAAAAAAAZAAAAGQAAAAVAAAAYAAAAAAAAAAAAAAADwAAACADAAAAAAAAAAAAAAEAAACgMgAAVgcAAKr4//8BAAAAf39/AAEAAABkAAAAAAAAABQAAABAHwAAAAAAACYAAAAAAAAAwOD//wAAAAAmAAAAZAAAABYAAABMAAAAAAAAAAAAAAAEAAAAAAAAAAEAAACAgIAKAAAAACgAAAAoAAAAZAAAAGQAAAAAAAAAzMzMAAAAAABQAAAAUAAAAGQAAABkAAAAAAAAABcAAAAUAAAAAAAAAIgDAAD/fwAA/38AAAAAAAAJAAAABAAAACMAAAAeAAAAaAAAAAAAAAAAAAAAAAAAAAAAAAAAAAAAECcAABAnAAAAAAAAAAAAAAAAAAAAAAAAAAAAAAAAAAAAAAAAAAAAABQAAAAAAAAAwMD/AAAAAABkAAAAMgAAAAAAAABkAAAAAAAAAH9/fwAKAAAAIgAAABgAAAAAAAAAAAAAAAAAAAAAAAAAAAAAAAAAAAAkAAAAJAAAAAAAAAAHAAAAAAAAAAAAAAAAAAAAAAAAAAAAAAAAAAAAf39/ACUAAABYAAAAAAAAAAAAAAAAAAAAAAAAAAAAAAAAAAAAAAAAAAAAAAAAAAAAAAAAAAAAAAA/AAAAAAAAAKCGAQAAAAAAAAAAAAAAAAAMAAAAAQAAAAAAAAAAAAAAAAAAAB8AAABUAAAA//8AAP///wEAAAAAAAAAAAAAAAAAAAAAAAAAAAAAAAAAAAAAAAAAAAAAAAJ/f38AgICAA8zMzADAwP8Af39/AAAAAAAAAAAAAAAAAAAAAAAAAAAAIQAAABgAAAAUAAAADSkAACkcAABMMAAA/h4AAAAAAAAmAAAACAAAAP//////////"/>
                 </a:ext>
               </a:extLst>
             </p:cNvSpPr>
@@ -4589,7 +4501,7 @@
             <p:cNvSpPr txBox="1">
               <a:extLst>
                 <a:ext uri="smNativeData">
-                  <pr:smNativeData xmlns:pr="smNativeData" xmlns="smNativeData" val="SMDATA_15_AnHWaRMAAAAlAAAAEgAAAA8BAAAAkAAAAEgAAACQAAAASAAAAAAAAAABAAAAAAAAAAEAAABQAAAAAAAAAAAA4D8AAAAAAADgPwAAAAAAAOA/AAAAAAAA4D8AAAAAAADgPwAAAAAAAOA/AAAAAAAA4D8AAAAAAADgPwAAAAAAAOA/AAAAAAAA4D8CAAAAjAAAAAEAAAAAAAAA//8AAP///wgAAAAAAAAAAAAAAAAAAAAAAAAAAAAAAAAAAAAAZAAAAAEAAABAAAAAAAAAAAAAAAAAAAAAAAAAAAAAAAAAAAAAAAAAAAAAAAAAAAAAAAAAAAAAAAAAAAAAAAAAAAAAAAAAAAAAAAAAAAAAAAAAAAAAAAAAAAAAAAAAAAAAFAAAADwAAAABAAAAAAAAAAAAAAkUAAAAAQAAABQAAAAUAAAAFAAAAAEAAAAAAAAAZAAAAGQAAAAAAAAAZAAAAGQAAAAVAAAAYAAAAAAAAAAAAAAADwAAACADAAAAAAAAAAAAAAEAAACgMgAAVgcAAKr4//8BAAAAf39/AAEAAABkAAAAAAAAABQAAABAHwAAAAAAACYAAAAAAAAAwOD//wAAAAAmAAAAZAAAABYAAABMAAAAAAAAAAAAAAAEAAAAAAAAAAEAAACAgIAKAAAAACgAAAAoAAAAZAAAAGQAAAAAAAAAzMzMAAAAAABQAAAAUAAAAGQAAABkAAAAAAAAABcAAAAUAAAAAAAAAIgDAAD/fwAA/38AAAAAAAAJAAAABAAAAID8+zAeAAAAaAAAAAAAAAAAAAAAAAAAAAAAAAAAAAAAECcAABAnAAAAAAAAAAAAAAAAAAAAAAAAAAAAAAAAAAAAAAAAAAAAABQAAAAAAAAAwMD/AAAAAABkAAAAMgAAAAAAAABkAAAAAAAAAH9/fwAKAAAAIgAAABgAAAAAAAAAAAAAAAAAAAAAAAAAAAAAAAAAAAAkAAAAJAAAAAAAAAAHAAAAAAAAAAAAAAAAAAAAAAAAAAAAAAAAAAAAf39/ACUAAABYAAAAAAAAAAAAAAAAAAAAAAAAAAAAAAAAAAAAAAAAAAAAAAAAAAAAAAAAAAAAAAA/AAAAAAAAAKCGAQAAAAAAAAAAAAAAAAAMAAAAAQAAAAAAAAAAAAAAAAAAAB8AAABUAAAA//8AAP///wEAAAAAAAAAAAAAAAAAAAAAAAAAAAAAAAAAAAAAAAAAAAAAAAJ/f38AgICAA8zMzADAwP8Af39/AAAAAAAAAAAAAAAAAAAAAAAAAAAAIQAAABgAAAAUAAAAqSgAAMUbAADoLwAAmh4AAAAAAAAmAAAACAAAAP//////////"/>
+                  <pr:smNativeData xmlns:pr="smNativeData" xmlns="smNativeData" val="SMDATA_15_7aDWaRMAAAAlAAAAEgAAAA8BAAAAkAAAAEgAAACQAAAASAAAAAAAAAABAAAAAAAAAAEAAABQAAAAAAAAAAAA4D8AAAAAAADgPwAAAAAAAOA/AAAAAAAA4D8AAAAAAADgPwAAAAAAAOA/AAAAAAAA4D8AAAAAAADgPwAAAAAAAOA/AAAAAAAA4D8CAAAAjAAAAAEAAAAAAAAA//8AAP///wgAAAAAAAAAAAAAAAAAAAAAAAAAAAAAAAAAAAAAZAAAAAEAAABAAAAAAAAAAAAAAAAAAAAAAAAAAAAAAAAAAAAAAAAAAAAAAAAAAAAAAAAAAAAAAAAAAAAAAAAAAAAAAAAAAAAAAAAAAAAAAAAAAAAAAAAAAAAAAAAAAAAAFAAAADwAAAABAAAAAAAAAAAAAAkUAAAAAQAAABQAAAAUAAAAFAAAAAEAAAAAAAAAZAAAAGQAAAAAAAAAZAAAAGQAAAAVAAAAYAAAAAAAAAAAAAAADwAAACADAAAAAAAAAAAAAAEAAACgMgAAVgcAAKr4//8BAAAAf39/AAEAAABkAAAAAAAAABQAAABAHwAAAAAAACYAAAAAAAAAwOD//wAAAAAmAAAAZAAAABYAAABMAAAAAAAAAAAAAAAEAAAAAAAAAAEAAACAgIAKAAAAACgAAAAoAAAAZAAAAGQAAAAAAAAAzMzMAAAAAABQAAAAUAAAAGQAAABkAAAAAAAAABcAAAAUAAAAAAAAAIgDAAD/fwAA/38AAAAAAAAJAAAABAAAAID8+zAeAAAAaAAAAAAAAAAAAAAAAAAAAAAAAAAAAAAAECcAABAnAAAAAAAAAAAAAAAAAAAAAAAAAAAAAAAAAAAAAAAAAAAAABQAAAAAAAAAwMD/AAAAAABkAAAAMgAAAAAAAABkAAAAAAAAAH9/fwAKAAAAIgAAABgAAAAAAAAAAAAAAAAAAAAAAAAAAAAAAAAAAAAkAAAAJAAAAAAAAAAHAAAAAAAAAAAAAAAAAAAAAAAAAAAAAAAAAAAAf39/ACUAAABYAAAAAAAAAAAAAAAAAAAAAAAAAAAAAAAAAAAAAAAAAAAAAAAAAAAAAAAAAAAAAAA/AAAAAAAAAKCGAQAAAAAAAAAAAAAAAAAMAAAAAQAAAAAAAAAAAAAAAAAAAB8AAABUAAAA//8AAP///wEAAAAAAAAAAAAAAAAAAAAAAAAAAAAAAAAAAAAAAAAAAAAAAAJ/f38AgICAA8zMzADAwP8Af39/AAAAAAAAAAAAAAAAAAAAAAAAAAAAIQAAABgAAAAUAAAAqSgAAMUbAADoLwAAmh4AAAAAAAAmAAAACAAAAP//////////"/>
                 </a:ext>
               </a:extLst>
             </p:cNvSpPr>
@@ -4634,7 +4546,7 @@
           <p:cNvSpPr txBox="1">
             <a:extLst>
               <a:ext uri="smNativeData">
-                <pr:smNativeData xmlns:pr="smNativeData" xmlns="smNativeData" val="SMDATA_15_AnHWaRMAAAAlAAAAEgAAAA8BAAAAkAAAAEgAAACQAAAASAAAAAAAAAABAAAAAAAAAAEAAABQAAAAAAAAAAAA4D8AAAAAAADgPwAAAAAAAOA/AAAAAAAA4D8AAAAAAADgPwAAAAAAAOA/AAAAAAAA4D8AAAAAAADgPwAAAAAAAOA/AAAAAAAA4D8CAAAAjAAAAAEAAAAAAAAA//8AAP///wgAAAAAAAAAAAAAAAAAAAAAAAAAAAAAAAAAAAAAZAAAAAEAAABAAAAAAAAAAAAAAAAAAAAAAAAAAAAAAAAAAAAAAAAAAAAAAAAAAAAAAAAAAAAAAAAAAAAAAAAAAAAAAAAAAAAAAAAAAAAAAAAAAAAAAAAAAAAAAAAAAAAAFAAAADwAAAABAAAAAAAAAAAAAAkUAAAAAQAAABQAAAAUAAAAFAAAAAEAAAAAAAAAZAAAAGQAAAAAAAAAZAAAAGQAAAAVAAAAYAAAAAAAAAAAAAAADwAAACADAAAAAAAAAAAAAAEAAACgMgAAVgcAAKr4//8BAAAAf39/AAEAAABkAAAAAAAAABQAAABAHwAAAAAAACYAAAAAAAAAwOD//wAAAAAmAAAAZAAAABYAAABMAAAAAAAAAAAAAAAEAAAAAAAAAAEAAACAgIAKAAAAACgAAAAoAAAAZAAAAGQAAAAAAAAAzMzMAAAAAABQAAAAUAAAAGQAAABkAAAAAAAAABcAAAAUAAAAAAAAAIgDAAD/fwAA/38AAAAAAAAJAAAABAAAACMAAAAeAAAAaAAAAAAAAAAAAAAAAAAAAAAAAAAAAAAAECcAABAnAAAAAAAAAAAAAAAAAAAAAAAAAAAAAAAAAAAAAAAAAAAAABQAAAAAAAAAwMD/AAAAAABkAAAAMgAAAAAAAABkAAAAAAAAAH9/fwAKAAAAIgAAABgAAAAAAAAAAAAAAAAAAAAAAAAAAAAAAAAAAAAkAAAAJAAAAAAAAAAHAAAAAAAAAAAAAAAAAAAAAAAAAAAAAAAAAAAAf39/ACUAAABYAAAAAAAAAAAAAAAAAAAAAAAAAAAAAAAAAAAAAAAAAAAAAAAAAAAAAAAAAAAAAAA/AAAAAAAAAKCGAQAAAAAAAAAAAAAAAAAMAAAAAQAAAAAAAAAAAAAAAAAAAB8AAABUAAAA//8AAP///wEAAAAAAAAAAAAAAAAAAAAAAAAAAAAAAAAAAAAAAAAAAAAAAAJ/f38AgICAA8zMzADAwP8Af39/AAAAAAAAAAAAAAAAAAAAAAAAAAAAIQAAABgAAAAUAAAAAzgAANEbAABCPwAAph4AAAAAAAAmAAAACAAAAP//////////"/>
+                <pr:smNativeData xmlns:pr="smNativeData" xmlns="smNativeData" val="SMDATA_15_7aDWaRMAAAAlAAAAEgAAAA8BAAAAkAAAAEgAAACQAAAASAAAAAAAAAABAAAAAAAAAAEAAABQAAAAAAAAAAAA4D8AAAAAAADgPwAAAAAAAOA/AAAAAAAA4D8AAAAAAADgPwAAAAAAAOA/AAAAAAAA4D8AAAAAAADgPwAAAAAAAOA/AAAAAAAA4D8CAAAAjAAAAAEAAAAAAAAA//8AAP///wgAAAAAAAAAAAAAAAAAAAAAAAAAAAAAAAAAAAAAZAAAAAEAAABAAAAAAAAAAAAAAAAAAAAAAAAAAAAAAAAAAAAAAAAAAAAAAAAAAAAAAAAAAAAAAAAAAAAAAAAAAAAAAAAAAAAAAAAAAAAAAAAAAAAAAAAAAAAAAAAAAAAAFAAAADwAAAABAAAAAAAAAAAAAAkUAAAAAQAAABQAAAAUAAAAFAAAAAEAAAAAAAAAZAAAAGQAAAAAAAAAZAAAAGQAAAAVAAAAYAAAAAAAAAAAAAAADwAAACADAAAAAAAAAAAAAAEAAACgMgAAVgcAAKr4//8BAAAAf39/AAEAAABkAAAAAAAAABQAAABAHwAAAAAAACYAAAAAAAAAwOD//wAAAAAmAAAAZAAAABYAAABMAAAAAAAAAAAAAAAEAAAAAAAAAAEAAACAgIAKAAAAACgAAAAoAAAAZAAAAGQAAAAAAAAAzMzMAAAAAABQAAAAUAAAAGQAAABkAAAAAAAAABcAAAAUAAAAAAAAAIgDAAD/fwAA/38AAAAAAAAJAAAABAAAACMAAAAeAAAAaAAAAAAAAAAAAAAAAAAAAAAAAAAAAAAAECcAABAnAAAAAAAAAAAAAAAAAAAAAAAAAAAAAAAAAAAAAAAAAAAAABQAAAAAAAAAwMD/AAAAAABkAAAAMgAAAAAAAABkAAAAAAAAAH9/fwAKAAAAIgAAABgAAAAAAAAAAAAAAAAAAAAAAAAAAAAAAAAAAAAkAAAAJAAAAAAAAAAHAAAAAAAAAAAAAAAAAAAAAAAAAAAAAAAAAAAAf39/ACUAAABYAAAAAAAAAAAAAAAAAAAAAAAAAAAAAAAAAAAAAAAAAAAAAAAAAAAAAAAAAAAAAAA/AAAAAAAAAKCGAQAAAAAAAAAAAAAAAAAMAAAAAQAAAAAAAAAAAAAAAAAAAB8AAABUAAAA//8AAP///wEAAAAAAAAAAAAAAAAAAAAAAAAAAAAAAAAAAAAAAAAAAAAAAAJ/f38AgICAA8zMzADAwP8Af39/AAAAAAAAAAAAAAAAAAAAAAAAAAAAIQAAABgAAAAUAAAAAzgAANEbAABCPwAAph4AABAAAAAmAAAACAAAAP//////////"/>
               </a:ext>
             </a:extLst>
           </p:cNvSpPr>
@@ -4678,7 +4590,7 @@
           <p:cNvSpPr txBox="1">
             <a:extLst>
               <a:ext uri="smNativeData">
-                <pr:smNativeData xmlns:pr="smNativeData" xmlns="smNativeData" val="SMDATA_15_AnHWaRMAAAAlAAAAEgAAAA8BAAAAkAAAAEgAAACQAAAASAAAAAAAAAABAAAAAAAAAAEAAABQAAAAAAAAAAAA4D8AAAAAAADgPwAAAAAAAOA/AAAAAAAA4D8AAAAAAADgPwAAAAAAAOA/AAAAAAAA4D8AAAAAAADgPwAAAAAAAOA/AAAAAAAA4D8CAAAAjAAAAAEAAAAAAAAAAP8AAP///wgAAAAAAAAAAAAAAAAAAAAAAAAAAAAAAAAAAAAAZAAAAAEAAABAAAAAAAAAAAAAAAAAAAAAAAAAAAAAAAAAAAAAAAAAAAAAAAAAAAAAAAAAAAAAAAAAAAAAAAAAAAAAAAAAAAAAAAAAAAAAAAAAAAAAAAAAAAAAAAAAAAAAFAAAADwAAAABAAAAAAAAAAAAAAkUAAAAAQAAABQAAAAUAAAAFAAAAAEAAAAAAAAAZAAAAGQAAAAAAAAAZAAAAGQAAAAVAAAAYAAAAAAAAAAAAAAADwAAACADAAAAAAAAAAAAAAEAAACgMgAAVgcAAKr4//8BAAAAf39/AAEAAABkAAAAAAAAABQAAABAHwAAAAAAACYAAAAAAAAAwOD//wAAAAAmAAAAZAAAABYAAABMAAAAAAAAAAAAAAAEAAAAAAAAAAEAAACAgIAKAAAAACgAAAAoAAAAZAAAAGQAAAAAAAAAzMzMAAAAAABQAAAAUAAAAGQAAABkAAAAAAAAABcAAAAUAAAAAAAAAIgDAAD/fwAA/38AAAAAAAAJAAAABAAAACMAAAAeAAAAaAAAAAAAAAAAAAAAAAAAAAAAAAAAAAAAECcAABAnAAAAAAAAAAAAAAAAAAAAAAAAAAAAAAAAAAAAAAAAAAAAABQAAAAAAAAAwMD/AAAAAABkAAAAMgAAAAAAAABkAAAAAAAAAH9/fwAKAAAAIgAAABgAAAAAAAAAAAAAAAAAAAAAAAAAAAAAAAAAAAAkAAAAJAAAAAAAAAAHAAAAAAAAAAAAAAAAAAAAAAAAAAAAAAAAAAAAf39/ACUAAABYAAAAAAAAAAAAAAAAAAAAAAAAAAAAAAAAAAAAAAAAAAAAAAAAAAAAAAAAAAAAAAA/AAAAAAAAAKCGAQAAAAAAAAAAAAAAAAAMAAAAAQAAAAAAAAAAAAAAAAAAAB8AAABUAAAAAP8AAP///wEAAAAAAAAAAAAAAAAAAAAAAAAAAAAAAAAAAAAAAAAAAAAAAAJ/f38AgICAA8zMzADAwP8Af39/AAAAAAAAAAAAAAAAAAAAAAAAAAAAIQAAABgAAAAUAAAANTkAAHwgAAAQPgAAUSMAAAAAAAAmAAAACAAAAP//////////"/>
+                <pr:smNativeData xmlns:pr="smNativeData" xmlns="smNativeData" val="SMDATA_15_7aDWaRMAAAAlAAAAEgAAAA8BAAAAkAAAAEgAAACQAAAASAAAAAAAAAABAAAAAAAAAAEAAABQAAAAAAAAAAAA4D8AAAAAAADgPwAAAAAAAOA/AAAAAAAA4D8AAAAAAADgPwAAAAAAAOA/AAAAAAAA4D8AAAAAAADgPwAAAAAAAOA/AAAAAAAA4D8CAAAAjAAAAAEAAAAAAAAAAP8AAP///wgAAAAAAAAAAAAAAAAAAAAAAAAAAAAAAAAAAAAAZAAAAAEAAABAAAAAAAAAAAAAAAAAAAAAAAAAAAAAAAAAAAAAAAAAAAAAAAAAAAAAAAAAAAAAAAAAAAAAAAAAAAAAAAAAAAAAAAAAAAAAAAAAAAAAAAAAAAAAAAAAAAAAFAAAADwAAAABAAAAAAAAAAAAAAkUAAAAAQAAABQAAAAUAAAAFAAAAAEAAAAAAAAAZAAAAGQAAAAAAAAAZAAAAGQAAAAVAAAAYAAAAAAAAAAAAAAADwAAACADAAAAAAAAAAAAAAEAAACgMgAAVgcAAKr4//8BAAAAf39/AAEAAABkAAAAAAAAABQAAABAHwAAAAAAACYAAAAAAAAAwOD//wAAAAAmAAAAZAAAABYAAABMAAAAAAAAAAAAAAAEAAAAAAAAAAEAAACAgIAKAAAAACgAAAAoAAAAZAAAAGQAAAAAAAAAzMzMAAAAAABQAAAAUAAAAGQAAABkAAAAAAAAABcAAAAUAAAAAAAAAIgDAAD/fwAA/38AAAAAAAAJAAAABAAAACMAAAAeAAAAaAAAAAAAAAAAAAAAAAAAAAAAAAAAAAAAECcAABAnAAAAAAAAAAAAAAAAAAAAAAAAAAAAAAAAAAAAAAAAAAAAABQAAAAAAAAAwMD/AAAAAABkAAAAMgAAAAAAAABkAAAAAAAAAH9/fwAKAAAAIgAAABgAAAAAAAAAAAAAAAAAAAAAAAAAAAAAAAAAAAAkAAAAJAAAAAAAAAAHAAAAAAAAAAAAAAAAAAAAAAAAAAAAAAAAAAAAf39/ACUAAABYAAAAAAAAAAAAAAAAAAAAAAAAAAAAAAAAAAAAAAAAAAAAAAAAAAAAAAAAAAAAAAA/AAAAAAAAAKCGAQAAAAAAAAAAAAAAAAAMAAAAAQAAAAAAAAAAAAAAAAAAAB8AAABUAAAAAP8AAP///wEAAAAAAAAAAAAAAAAAAAAAAAAAAAAAAAAAAAAAAAAAAAAAAAJ/f38AgICAA8zMzADAwP8Af39/AAAAAAAAAAAAAAAAAAAAAAAAAAAAIQAAABgAAAAUAAAANTkAAHwgAAAQPgAAUSMAABAAAAAmAAAACAAAAP//////////"/>
               </a:ext>
             </a:extLst>
           </p:cNvSpPr>
@@ -4722,7 +4634,7 @@
           <p:cNvSpPr txBox="1">
             <a:extLst>
               <a:ext uri="smNativeData">
-                <pr:smNativeData xmlns:pr="smNativeData" xmlns="smNativeData" val="SMDATA_15_AnHWaRMAAAAlAAAAEgAAAA8BAAAAkAAAAEgAAACQAAAASAAAAAAAAAABAAAAAAAAAAEAAABQAAAAAAAAAAAA4D8AAAAAAADgPwAAAAAAAOA/AAAAAAAA4D8AAAAAAADgPwAAAAAAAOA/AAAAAAAA4D8AAAAAAADgPwAAAAAAAOA/AAAAAAAA4D8CAAAAjAAAAAEAAAAAAAAA//8AAP///wgAAAAAAAAAAAAAAAAAAAAAAAAAAAAAAAAAAAAAZAAAAAEAAABAAAAAAAAAAAAAAAAAAAAAAAAAAAAAAAAAAAAAAAAAAAAAAAAAAAAAAAAAAAAAAAAAAAAAAAAAAAAAAAAAAAAAAAAAAAAAAAAAAAAAAAAAAAAAAAAAAAAAFAAAADwAAAABAAAAAAAAAAAAAAkUAAAAAQAAABQAAAAUAAAAFAAAAAEAAAAAAAAAZAAAAGQAAAAAAAAAZAAAAGQAAAAVAAAAYAAAAAAAAAAAAAAADwAAACADAAAAAAAAAAAAAAEAAACgMgAAVgcAAKr4//8BAAAAf39/AAEAAABkAAAAAAAAABQAAABAHwAAAAAAACYAAAAAAAAAwOD//wAAAAAmAAAAZAAAABYAAABMAAAAAAAAAAAAAAAEAAAAAAAAAAEAAACAgIAKAAAAACgAAAAoAAAAZAAAAGQAAAAAAAAAzMzMAAAAAABQAAAAUAAAAGQAAABkAAAAAAAAABcAAAAUAAAAAAAAAIEHAAD/fwAA/38AAAAAAAAJAAAABAAAACJIYW4eAAAAaAAAAAAAAAAAAAAAAAAAAAAAAAAAAAAAECcAABAnAAAAAAAAAAAAAAAAAAAAAAAAAAAAAAAAAAAAAAAAAAAAABQAAAAAAAAAwMD/AAAAAABkAAAAMgAAAAAAAABkAAAAAAAAAH9/fwAKAAAAIgAAABgAAAAAAAAAAAAAAAAAAAAAAAAAAAAAAAAAAAAkAAAAJAAAAAAAAAAHAAAAAAAAAAAAAAAAAAAAAAAAAAAAAAAAAAAAf39/ACUAAABYAAAAAAAAAAAAAAAAAAAAAAAAAAAAAAAAAAAAAAAAAAAAAAAAAAAAAAAAAAAAAAA/AAAAAAAAAKCGAQAAAAAAAAAAAAAAAAAMAAAAAQAAAAAAAAAAAAAAAAAAAB8AAABUAAAA//8AAP///wEAAAAAAAAAAAAAAAAAAAAAAAAAAAAAAAAAAAAAAAAAAAAAAAJ/f38AgICAA8zMzADAwP8Af39/AAAAAAAAAAAAAAAAAAAAAAAAAAAAIQAAABgAAAAUAAAAahQAAFsUAAC2GQAAVBgAAAAAAAAmAAAACAAAAP//////////"/>
+                <pr:smNativeData xmlns:pr="smNativeData" xmlns="smNativeData" val="SMDATA_15_7aDWaRMAAAAlAAAAEgAAAA8BAAAAkAAAAEgAAACQAAAASAAAAAAAAAABAAAAAAAAAAEAAABQAAAAAAAAAAAA4D8AAAAAAADgPwAAAAAAAOA/AAAAAAAA4D8AAAAAAADgPwAAAAAAAOA/AAAAAAAA4D8AAAAAAADgPwAAAAAAAOA/AAAAAAAA4D8CAAAAjAAAAAEAAAAAAAAA//8AAP///wgAAAAAAAAAAAAAAAAAAAAAAAAAAAAAAAAAAAAAZAAAAAEAAABAAAAAAAAAAAAAAAAAAAAAAAAAAAAAAAAAAAAAAAAAAAAAAAAAAAAAAAAAAAAAAAAAAAAAAAAAAAAAAAAAAAAAAAAAAAAAAAAAAAAAAAAAAAAAAAAAAAAAFAAAADwAAAABAAAAAAAAAAAAAAkUAAAAAQAAABQAAAAUAAAAFAAAAAEAAAAAAAAAZAAAAGQAAAAAAAAAZAAAAGQAAAAVAAAAYAAAAAAAAAAAAAAADwAAACADAAAAAAAAAAAAAAEAAACgMgAAVgcAAKr4//8BAAAAf39/AAEAAABkAAAAAAAAABQAAABAHwAAAAAAACYAAAAAAAAAwOD//wAAAAAmAAAAZAAAABYAAABMAAAAAAAAAAAAAAAEAAAAAAAAAAEAAACAgIAKAAAAACgAAAAoAAAAZAAAAGQAAAAAAAAAzMzMAAAAAABQAAAAUAAAAGQAAABkAAAAAAAAABcAAAAUAAAAAAAAAIEHAAD/fwAA/38AAAAAAAAJAAAABAAAACJIYW4eAAAAaAAAAAAAAAAAAAAAAAAAAAAAAAAAAAAAECcAABAnAAAAAAAAAAAAAAAAAAAAAAAAAAAAAAAAAAAAAAAAAAAAABQAAAAAAAAAwMD/AAAAAABkAAAAMgAAAAAAAABkAAAAAAAAAH9/fwAKAAAAIgAAABgAAAAAAAAAAAAAAAAAAAAAAAAAAAAAAAAAAAAkAAAAJAAAAAAAAAAHAAAAAAAAAAAAAAAAAAAAAAAAAAAAAAAAAAAAf39/ACUAAABYAAAAAAAAAAAAAAAAAAAAAAAAAAAAAAAAAAAAAAAAAAAAAAAAAAAAAAAAAAAAAAA/AAAAAAAAAKCGAQAAAAAAAAAAAAAAAAAMAAAAAQAAAAAAAAAAAAAAAAAAAB8AAABUAAAA//8AAP///wEAAAAAAAAAAAAAAAAAAAAAAAAAAAAAAAAAAAAAAAAAAAAAAAJ/f38AgICAA8zMzADAwP8Af39/AAAAAAAAAAAAAAAAAAAAAAAAAAAAIQAAABgAAAAUAAAAahQAAFsUAAC2GQAAVBgAABAAAAAmAAAACAAAAP//////////"/>
               </a:ext>
             </a:extLst>
           </p:cNvSpPr>
@@ -4774,7 +4686,7 @@
           <p:cNvSpPr txBox="1">
             <a:extLst>
               <a:ext uri="smNativeData">
-                <pr:smNativeData xmlns:pr="smNativeData" xmlns="smNativeData" val="SMDATA_15_AnHWaRMAAAAlAAAAEgAAAA8BAAAAkAAAAEgAAACQAAAASAAAAAAAAAABAAAAAAAAAAEAAABQAAAAAAAAAAAA4D8AAAAAAADgPwAAAAAAAOA/AAAAAAAA4D8AAAAAAADgPwAAAAAAAOA/AAAAAAAA4D8AAAAAAADgPwAAAAAAAOA/AAAAAAAA4D8CAAAAjAAAAAEAAAAAAAAA//8AAP///wgAAAAAAAAAAAAAAAAAAAAAAAAAAAAAAAAAAAAAZAAAAAEAAABAAAAAAAAAAAAAAAAAAAAAAAAAAAAAAAAAAAAAAAAAAAAAAAAAAAAAAAAAAAAAAAAAAAAAAAAAAAAAAAAAAAAAAAAAAAAAAAAAAAAAAAAAAAAAAAAAAAAAFAAAADwAAAABAAAAAAAAAAAAAAkUAAAAAQAAABQAAAAUAAAAFAAAAAEAAAAAAAAAZAAAAGQAAAAAAAAAZAAAAGQAAAAVAAAAYAAAAAAAAAAAAAAADwAAACADAAAAAAAAAAAAAAEAAACgMgAAVgcAAKr4//8BAAAAf39/AAEAAABkAAAAAAAAABQAAABAHwAAAAAAACYAAAAAAAAAwOD//wAAAAAmAAAAZAAAABYAAABMAAAAAAAAAAAAAAAEAAAAAAAAAAEAAACAgIAKAAAAACgAAAAoAAAAZAAAAGQAAAAAAAAAzMzMAAAAAABQAAAAUAAAAGQAAABkAAAAAAAAABcAAAAUAAAAAAAAAIgDAAD/fwAA/38AAAAAAAAJAAAABAAAACMAAAAeAAAAaAAAAAAAAAAAAAAAAAAAAAAAAAAAAAAAECcAABAnAAAAAAAAAAAAAAAAAAAAAAAAAAAAAAAAAAAAAAAAAAAAABQAAAAAAAAAwMD/AAAAAABkAAAAMgAAAAAAAABkAAAAAAAAAH9/fwAKAAAAIgAAABgAAAAAAAAAAAAAAAAAAAAAAAAAAAAAAAAAAAAkAAAAJAAAAAAAAAAHAAAAAAAAAAAAAAAAAAAAAAAAAAAAAAAAAAAAf39/ACUAAABYAAAAAAAAAAAAAAAAAAAAAAAAAAAAAAAAAAAAAAAAAAAAAAAAAAAAAAAAAAAAAAA/AAAAAAAAAKCGAQAAAAAAAAAAAAAAAAAMAAAAAQAAAAAAAAAAAAAAAAAAAB8AAABUAAAA//8AAP///wEAAAAAAAAAAAAAAAAAAAAAAAAAAAAAAAAAAAAAAAAAAAAAAAJ/f38AgICAA8zMzADAwP8Af39/AAAAAAAAAAAAAAAAAAAAAAAAAAAAIQAAABgAAAAUAAAAsRsAAJAbAADwIgAAZR4AAAAAAAAmAAAACAAAAP//////////"/>
+                <pr:smNativeData xmlns:pr="smNativeData" xmlns="smNativeData" val="SMDATA_15_7aDWaRMAAAAlAAAAEgAAAA8BAAAAkAAAAEgAAACQAAAASAAAAAAAAAABAAAAAAAAAAEAAABQAAAAAAAAAAAA4D8AAAAAAADgPwAAAAAAAOA/AAAAAAAA4D8AAAAAAADgPwAAAAAAAOA/AAAAAAAA4D8AAAAAAADgPwAAAAAAAOA/AAAAAAAA4D8CAAAAjAAAAAEAAAAAAAAA//8AAP///wgAAAAAAAAAAAAAAAAAAAAAAAAAAAAAAAAAAAAAZAAAAAEAAABAAAAAAAAAAAAAAAAAAAAAAAAAAAAAAAAAAAAAAAAAAAAAAAAAAAAAAAAAAAAAAAAAAAAAAAAAAAAAAAAAAAAAAAAAAAAAAAAAAAAAAAAAAAAAAAAAAAAAFAAAADwAAAABAAAAAAAAAAAAAAkUAAAAAQAAABQAAAAUAAAAFAAAAAEAAAAAAAAAZAAAAGQAAAAAAAAAZAAAAGQAAAAVAAAAYAAAAAAAAAAAAAAADwAAACADAAAAAAAAAAAAAAEAAACgMgAAVgcAAKr4//8BAAAAf39/AAEAAABkAAAAAAAAABQAAABAHwAAAAAAACYAAAAAAAAAwOD//wAAAAAmAAAAZAAAABYAAABMAAAAAAAAAAAAAAAEAAAAAAAAAAEAAACAgIAKAAAAACgAAAAoAAAAZAAAAGQAAAAAAAAAzMzMAAAAAABQAAAAUAAAAGQAAABkAAAAAAAAABcAAAAUAAAAAAAAAIgDAAD/fwAA/38AAAAAAAAJAAAABAAAACMAAAAeAAAAaAAAAAAAAAAAAAAAAAAAAAAAAAAAAAAAECcAABAnAAAAAAAAAAAAAAAAAAAAAAAAAAAAAAAAAAAAAAAAAAAAABQAAAAAAAAAwMD/AAAAAABkAAAAMgAAAAAAAABkAAAAAAAAAH9/fwAKAAAAIgAAABgAAAAAAAAAAAAAAAAAAAAAAAAAAAAAAAAAAAAkAAAAJAAAAAAAAAAHAAAAAAAAAAAAAAAAAAAAAAAAAAAAAAAAAAAAf39/ACUAAABYAAAAAAAAAAAAAAAAAAAAAAAAAAAAAAAAAAAAAAAAAAAAAAAAAAAAAAAAAAAAAAA/AAAAAAAAAKCGAQAAAAAAAAAAAAAAAAAMAAAAAQAAAAAAAAAAAAAAAAAAAB8AAABUAAAA//8AAP///wEAAAAAAAAAAAAAAAAAAAAAAAAAAAAAAAAAAAAAAAAAAAAAAAJ/f38AgICAA8zMzADAwP8Af39/AAAAAAAAAAAAAAAAAAAAAAAAAAAAIQAAABgAAAAUAAAAsRsAAJAbAADwIgAAZR4AABAAAAAmAAAACAAAAP//////////"/>
               </a:ext>
             </a:extLst>
           </p:cNvSpPr>
@@ -4818,7 +4730,7 @@
           <p:cNvSpPr txBox="1">
             <a:extLst>
               <a:ext uri="smNativeData">
-                <pr:smNativeData xmlns:pr="smNativeData" xmlns="smNativeData" val="SMDATA_15_AnHWaRMAAAAlAAAAEgAAAA8BAAAAkAAAAEgAAACQAAAASAAAAAAAAAABAAAAAAAAAAEAAABQAAAAAAAAAAAA4D8AAAAAAADgPwAAAAAAAOA/AAAAAAAA4D8AAAAAAADgPwAAAAAAAOA/AAAAAAAA4D8AAAAAAADgPwAAAAAAAOA/AAAAAAAA4D8CAAAAjAAAAAEAAAAAAAAAAP8AAP///wgAAAAAAAAAAAAAAAAAAAAAAAAAAAAAAAAAAAAAZAAAAAEAAABAAAAAAAAAAAAAAAAAAAAAAAAAAAAAAAAAAAAAAAAAAAAAAAAAAAAAAAAAAAAAAAAAAAAAAAAAAAAAAAAAAAAAAAAAAAAAAAAAAAAAAAAAAAAAAAAAAAAAFAAAADwAAAABAAAAAAAAAAAAAAkUAAAAAQAAABQAAAAUAAAAFAAAAAEAAAAAAAAAZAAAAGQAAAAAAAAAZAAAAGQAAAAVAAAAYAAAAAAAAAAAAAAADwAAACADAAAAAAAAAAAAAAEAAACgMgAAVgcAAKr4//8BAAAAf39/AAEAAABkAAAAAAAAABQAAABAHwAAAAAAACYAAAAAAAAAwOD//wAAAAAmAAAAZAAAABYAAABMAAAAAAAAAAAAAAAEAAAAAAAAAAEAAACAgIAKAAAAACgAAAAoAAAAZAAAAGQAAAAAAAAAzMzMAAAAAABQAAAAUAAAAGQAAABkAAAAAAAAABcAAAAUAAAAAAAAAIgDAAD/fwAA/38AAAAAAAAJAAAABAAAAAAAAAAeAAAAaAAAAAAAAAAAAAAAAAAAAAAAAAAAAAAAECcAABAnAAAAAAAAAAAAAAAAAAAAAAAAAAAAAAAAAAAAAAAAAAAAABQAAAAAAAAAwMD/AAAAAABkAAAAMgAAAAAAAABkAAAAAAAAAH9/fwAKAAAAIgAAABgAAAAAAAAAAAAAAAAAAAAAAAAAAAAAAAAAAAAkAAAAJAAAAAAAAAAHAAAAAAAAAAAAAAAAAAAAAAAAAAAAAAAAAAAAf39/ACUAAABYAAAAAAAAAAAAAAAAAAAAAAAAAAAAAAAAAAAAAAAAAAAAAAAAAAAAAAAAAAAAAAA/AAAAAAAAAKCGAQAAAAAAAAAAAAAAAAAMAAAAAQAAAAAAAAAAAAAAAAAAAB8AAABUAAAAAP8AAP///wEAAAAAAAAAAAAAAAAAAAAAAAAAAAAAAAAAAAAAAAAAAAAAAAJ/f38AgICAA8zMzADAwP8Af39/AAAAAAAAAAAAAAAAAAAAAAAAAAAAIQAAABgAAAAUAAAA4xwAAGsgAAC+IQAAQCMAAAAAAAAmAAAACAAAAP//////////"/>
+                <pr:smNativeData xmlns:pr="smNativeData" xmlns="smNativeData" val="SMDATA_15_7aDWaRMAAAAlAAAAEgAAAA8BAAAAkAAAAEgAAACQAAAASAAAAAAAAAABAAAAAAAAAAEAAABQAAAAAAAAAAAA4D8AAAAAAADgPwAAAAAAAOA/AAAAAAAA4D8AAAAAAADgPwAAAAAAAOA/AAAAAAAA4D8AAAAAAADgPwAAAAAAAOA/AAAAAAAA4D8CAAAAjAAAAAEAAAAAAAAAAP8AAP///wgAAAAAAAAAAAAAAAAAAAAAAAAAAAAAAAAAAAAAZAAAAAEAAABAAAAAAAAAAAAAAAAAAAAAAAAAAAAAAAAAAAAAAAAAAAAAAAAAAAAAAAAAAAAAAAAAAAAAAAAAAAAAAAAAAAAAAAAAAAAAAAAAAAAAAAAAAAAAAAAAAAAAFAAAADwAAAABAAAAAAAAAAAAAAkUAAAAAQAAABQAAAAUAAAAFAAAAAEAAAAAAAAAZAAAAGQAAAAAAAAAZAAAAGQAAAAVAAAAYAAAAAAAAAAAAAAADwAAACADAAAAAAAAAAAAAAEAAACgMgAAVgcAAKr4//8BAAAAf39/AAEAAABkAAAAAAAAABQAAABAHwAAAAAAACYAAAAAAAAAwOD//wAAAAAmAAAAZAAAABYAAABMAAAAAAAAAAAAAAAEAAAAAAAAAAEAAACAgIAKAAAAACgAAAAoAAAAZAAAAGQAAAAAAAAAzMzMAAAAAABQAAAAUAAAAGQAAABkAAAAAAAAABcAAAAUAAAAAAAAAIgDAAD/fwAA/38AAAAAAAAJAAAABAAAAAAAAAAeAAAAaAAAAAAAAAAAAAAAAAAAAAAAAAAAAAAAECcAABAnAAAAAAAAAAAAAAAAAAAAAAAAAAAAAAAAAAAAAAAAAAAAABQAAAAAAAAAwMD/AAAAAABkAAAAMgAAAAAAAABkAAAAAAAAAH9/fwAKAAAAIgAAABgAAAAAAAAAAAAAAAAAAAAAAAAAAAAAAAAAAAAkAAAAJAAAAAAAAAAHAAAAAAAAAAAAAAAAAAAAAAAAAAAAAAAAAAAAf39/ACUAAABYAAAAAAAAAAAAAAAAAAAAAAAAAAAAAAAAAAAAAAAAAAAAAAAAAAAAAAAAAAAAAAA/AAAAAAAAAKCGAQAAAAAAAAAAAAAAAAAMAAAAAQAAAAAAAAAAAAAAAAAAAB8AAABUAAAAAP8AAP///wEAAAAAAAAAAAAAAAAAAAAAAAAAAAAAAAAAAAAAAAAAAAAAAAJ/f38AgICAA8zMzADAwP8Af39/AAAAAAAAAAAAAAAAAAAAAAAAAAAAIQAAABgAAAAUAAAA4xwAAGsgAAC+IQAAQCMAABAAAAAmAAAACAAAAP//////////"/>
               </a:ext>
             </a:extLst>
           </p:cNvSpPr>
@@ -4862,7 +4774,7 @@
           <p:cNvGrpSpPr>
             <a:extLst>
               <a:ext uri="smNativeData">
-                <pr:smNativeData xmlns:pr="smNativeData" xmlns="smNativeData" val="SMDATA_6_AnHWaRMAAAAlAAAAAQAAAC8BAAAAkAAAAEgAAACQAAAASAAAAAAAAAAAAAAAAAAAABcAAAAUAAAAAAAAAAAAAAD/fwAA/38AAAAAAAAJAAAABAAAAA8AAAAfAAAAVAAAAAAAAAAAAAAAAAAAAAAAAAAAAAAAAAAAAAAAAAAAAAAAAAAAAAAAAAAAAAAAAAAAAAAAAAAAAAAAAAAAAAAAAAAAAAAAAAAAAAAAAAAAAAAAAAAAACEAAAAYAAAAFAAAAAgOAACcGwAAqxUAANUeAAAAAAAAJgAAAAgAAAD/////AAAAAA=="/>
+                <pr:smNativeData xmlns:pr="smNativeData" xmlns="smNativeData" val="SMDATA_6_7aDWaRMAAAAlAAAAAQAAAA8BAAAAkAAAAEgAAACQAAAASAAAAAAAAAAAAAAAAAAAABcAAAAUAAAAAAAAAAAAAAD/fwAA/38AAAAAAAAJAAAABAAAAF0AAAAfAAAAVAAAAAAAAAAAAAAAAAAAAAAAAAAAAAAAAAAAAAAAAAAAAAAAAAAAAAAAAAAAAAAAAAAAAAAAAAAAAAAAAAAAAAAAAAAAAAAAAAAAAAAAAAAAAAAAAAAAACEAAAAYAAAAFAAAAAgOAACcGwAAqxUAANUeAAAQAAAAJgAAAAgAAAD/////AAAAAA=="/>
               </a:ext>
             </a:extLst>
           </p:cNvGrpSpPr>
@@ -4882,7 +4794,7 @@
             <p:cNvSpPr txBox="1">
               <a:extLst>
                 <a:ext uri="smNativeData">
-                  <pr:smNativeData xmlns:pr="smNativeData" xmlns="smNativeData" val="SMDATA_15_AnHWaRMAAAAlAAAAEgAAAA8BAAAAkAAAAEgAAACQAAAASAAAAAAAAAABAAAAAAAAAAEAAABQAAAAAAAAAAAA4D8AAAAAAADgPwAAAAAAAOA/AAAAAAAA4D8AAAAAAADgPwAAAAAAAOA/AAAAAAAA4D8AAAAAAADgPwAAAAAAAOA/AAAAAAAA4D8CAAAAjAAAAAEAAAAAAAAA//8AAP///wgAAAAAAAAAAAAAAAAAAAAAAAAAAAAAAAAAAAAAZAAAAAEAAABAAAAAAAAAAAAAAAAAAAAAAAAAAAAAAAAAAAAAAAAAAAAAAAAAAAAAAAAAAAAAAAAAAAAAAAAAAAAAAAAAAAAAAAAAAAAAAAAAAAAAAAAAAAAAAAAAAAAAFAAAADwAAAABAAAAAAAAAAAAAAkUAAAAAQAAABQAAAAUAAAAFAAAAAEAAAAAAAAAZAAAAGQAAAAAAAAAZAAAAGQAAAAVAAAAYAAAAAAAAAAAAAAADwAAACADAAAAAAAAAAAAAAEAAACgMgAAVgcAAKr4//8BAAAAf39/AAEAAABkAAAAAAAAABQAAABAHwAAAAAAACYAAAAAAAAAwOD//wAAAAAmAAAAZAAAABYAAABMAAAAAAAAAAAAAAAEAAAAAAAAAAEAAACAgIAKAAAAACgAAAAoAAAAZAAAAGQAAAAAAAAAzMzMAAAAAABQAAAAUAAAAGQAAABkAAAAAAAAABcAAAAUAAAAAAAAAIgDAAD/fwAA/38AAAAAAAAJAAAABAAAAJD3rDEeAAAAaAAAAAAAAAAAAAAAAAAAAAAAAAAAAAAAECcAABAnAAAAAAAAAAAAAAAAAAAAAAAAAAAAAAAAAAAAAAAAAAAAABQAAAAAAAAAwMD/AAAAAABkAAAAMgAAAAAAAABkAAAAAAAAAH9/fwAKAAAAIgAAABgAAAAAAAAAAAAAAAAAAAAAAAAAAAAAAAAAAAAkAAAAJAAAAAAAAAAHAAAAAAAAAAAAAAAAAAAAAAAAAAAAAAAAAAAAf39/ACUAAABYAAAAAAAAAAAAAAAAAAAAAAAAAAAAAAAAAAAAAAAAAAAAAAAAAAAAAAAAAAAAAAA/AAAAAAAAAKCGAQAAAAAAAAAAAAAAAAAMAAAAAQAAAAAAAAAAAAAAAAAAAB8AAABUAAAA//8AAP///wEAAAAAAAAAAAAAAAAAAAAAAAAAAAAAAAAAAAAAAAAAAAAAAAJ/f38AgICAA8zMzADAwP8Af39/AAAAAAAAAAAAAAAAAAAAAAAAAAAAIQAAABgAAAAUAAAAbA4AAAAcAACrFQAA1R4AAAAAAAAmAAAACAAAAP//////////"/>
+                  <pr:smNativeData xmlns:pr="smNativeData" xmlns="smNativeData" val="SMDATA_15_7aDWaRMAAAAlAAAAEgAAAA8BAAAAkAAAAEgAAACQAAAASAAAAAAAAAABAAAAAAAAAAEAAABQAAAAAAAAAAAA4D8AAAAAAADgPwAAAAAAAOA/AAAAAAAA4D8AAAAAAADgPwAAAAAAAOA/AAAAAAAA4D8AAAAAAADgPwAAAAAAAOA/AAAAAAAA4D8CAAAAjAAAAAEAAAAAAAAA//8AAP///wgAAAAAAAAAAAAAAAAAAAAAAAAAAAAAAAAAAAAAZAAAAAEAAABAAAAAAAAAAAAAAAAAAAAAAAAAAAAAAAAAAAAAAAAAAAAAAAAAAAAAAAAAAAAAAAAAAAAAAAAAAAAAAAAAAAAAAAAAAAAAAAAAAAAAAAAAAAAAAAAAAAAAFAAAADwAAAABAAAAAAAAAAAAAAkUAAAAAQAAABQAAAAUAAAAFAAAAAEAAAAAAAAAZAAAAGQAAAAAAAAAZAAAAGQAAAAVAAAAYAAAAAAAAAAAAAAADwAAACADAAAAAAAAAAAAAAEAAACgMgAAVgcAAKr4//8BAAAAf39/AAEAAABkAAAAAAAAABQAAABAHwAAAAAAACYAAAAAAAAAwOD//wAAAAAmAAAAZAAAABYAAABMAAAAAAAAAAAAAAAEAAAAAAAAAAEAAACAgIAKAAAAACgAAAAoAAAAZAAAAGQAAAAAAAAAzMzMAAAAAABQAAAAUAAAAGQAAABkAAAAAAAAABcAAAAUAAAAAAAAAIgDAAD/fwAA/38AAAAAAAAJAAAABAAAAJD3rDEeAAAAaAAAAAAAAAAAAAAAAAAAAAAAAAAAAAAAECcAABAnAAAAAAAAAAAAAAAAAAAAAAAAAAAAAAAAAAAAAAAAAAAAABQAAAAAAAAAwMD/AAAAAABkAAAAMgAAAAAAAABkAAAAAAAAAH9/fwAKAAAAIgAAABgAAAAAAAAAAAAAAAAAAAAAAAAAAAAAAAAAAAAkAAAAJAAAAAAAAAAHAAAAAAAAAAAAAAAAAAAAAAAAAAAAAAAAAAAAf39/ACUAAABYAAAAAAAAAAAAAAAAAAAAAAAAAAAAAAAAAAAAAAAAAAAAAAAAAAAAAAAAAAAAAAA/AAAAAAAAAKCGAQAAAAAAAAAAAAAAAAAMAAAAAQAAAAAAAAAAAAAAAAAAAB8AAABUAAAA//8AAP///wEAAAAAAAAAAAAAAAAAAAAAAAAAAAAAAAAAAAAAAAAAAAAAAAJ/f38AgICAA8zMzADAwP8Af39/AAAAAAAAAAAAAAAAAAAAAAAAAAAAIQAAABgAAAAUAAAAbA4AAAAcAACrFQAA1R4AAAAAAAAmAAAACAAAAP//////////"/>
                 </a:ext>
               </a:extLst>
             </p:cNvSpPr>
@@ -4926,7 +4838,7 @@
             <p:cNvSpPr txBox="1">
               <a:extLst>
                 <a:ext uri="smNativeData">
-                  <pr:smNativeData xmlns:pr="smNativeData" xmlns="smNativeData" val="SMDATA_15_AnHWaRMAAAAlAAAAEgAAAA8BAAAAkAAAAEgAAACQAAAASAAAAAAAAAABAAAAAAAAAAEAAABQAAAAAAAAAAAA4D8AAAAAAADgPwAAAAAAAOA/AAAAAAAA4D8AAAAAAADgPwAAAAAAAOA/AAAAAAAA4D8AAAAAAADgPwAAAAAAAOA/AAAAAAAA4D8CAAAAjAAAAAEAAAAAAAAA//8AAP///wgAAAAAAAAAAAAAAAAAAAAAAAAAAAAAAAAAAAAAZAAAAAEAAABAAAAAAAAAAAAAAAAAAAAAAAAAAAAAAAAAAAAAAAAAAAAAAAAAAAAAAAAAAAAAAAAAAAAAAAAAAAAAAAAAAAAAAAAAAAAAAAAAAAAAAAAAAAAAAAAAAAAAFAAAADwAAAABAAAAAAAAAAAAAAkUAAAAAQAAABQAAAAUAAAAFAAAAAEAAAAAAAAAZAAAAGQAAAAAAAAAZAAAAGQAAAAVAAAAYAAAAAAAAAAAAAAADwAAACADAAAAAAAAAAAAAAEAAACgMgAAVgcAAKr4//8BAAAAf39/AAEAAABkAAAAAAAAABQAAABAHwAAAAAAACYAAAAAAAAAwOD//wAAAAAmAAAAZAAAABYAAABMAAAAAAAAAAAAAAAEAAAAAAAAAAEAAACAgIAKAAAAACgAAAAoAAAAZAAAAGQAAAAAAAAAzMzMAAAAAABQAAAAUAAAAGQAAABkAAAAAAAAABcAAAAUAAAAAAAAAIgDAAD/fwAA/38AAAAAAAAJAAAABAAAACMAAAAeAAAAaAAAAAAAAAAAAAAAAAAAAAAAAAAAAAAAECcAABAnAAAAAAAAAAAAAAAAAAAAAAAAAAAAAAAAAAAAAAAAAAAAABQAAAAAAAAAwMD/AAAAAABkAAAAMgAAAAAAAABkAAAAAAAAAH9/fwAKAAAAIgAAABgAAAAAAAAAAAAAAAAAAAAAAAAAAAAAAAAAAAAkAAAAJAAAAAAAAAAHAAAAAAAAAAAAAAAAAAAAAAAAAAAAAAAAAAAAf39/ACUAAABYAAAAAAAAAAAAAAAAAAAAAAAAAAAAAAAAAAAAAAAAAAAAAAAAAAAAAAAAAAAAAAA/AAAAAAAAAKCGAQAAAAAAAAAAAAAAAAAMAAAAAQAAAAAAAAAAAAAAAAAAAB8AAABUAAAA//8AAP///wEAAAAAAAAAAAAAAAAAAAAAAAAAAAAAAAAAAAAAAAAAAAAAAAJ/f38AgICAA8zMzADAwP8Af39/AAAAAAAAAAAAAAAAAAAAAAAAAAAAIQAAABgAAAAUAAAACA4AAJwbAABHFQAAcR4AAAAAAAAmAAAACAAAAP//////////"/>
+                  <pr:smNativeData xmlns:pr="smNativeData" xmlns="smNativeData" val="SMDATA_15_7aDWaRMAAAAlAAAAEgAAAA8BAAAAkAAAAEgAAACQAAAASAAAAAAAAAABAAAAAAAAAAEAAABQAAAAAAAAAAAA4D8AAAAAAADgPwAAAAAAAOA/AAAAAAAA4D8AAAAAAADgPwAAAAAAAOA/AAAAAAAA4D8AAAAAAADgPwAAAAAAAOA/AAAAAAAA4D8CAAAAjAAAAAEAAAAAAAAA//8AAP///wgAAAAAAAAAAAAAAAAAAAAAAAAAAAAAAAAAAAAAZAAAAAEAAABAAAAAAAAAAAAAAAAAAAAAAAAAAAAAAAAAAAAAAAAAAAAAAAAAAAAAAAAAAAAAAAAAAAAAAAAAAAAAAAAAAAAAAAAAAAAAAAAAAAAAAAAAAAAAAAAAAAAAFAAAADwAAAABAAAAAAAAAAAAAAkUAAAAAQAAABQAAAAUAAAAFAAAAAEAAAAAAAAAZAAAAGQAAAAAAAAAZAAAAGQAAAAVAAAAYAAAAAAAAAAAAAAADwAAACADAAAAAAAAAAAAAAEAAACgMgAAVgcAAKr4//8BAAAAf39/AAEAAABkAAAAAAAAABQAAABAHwAAAAAAACYAAAAAAAAAwOD//wAAAAAmAAAAZAAAABYAAABMAAAAAAAAAAAAAAAEAAAAAAAAAAEAAACAgIAKAAAAACgAAAAoAAAAZAAAAGQAAAAAAAAAzMzMAAAAAABQAAAAUAAAAGQAAABkAAAAAAAAABcAAAAUAAAAAAAAAIgDAAD/fwAA/38AAAAAAAAJAAAABAAAACMAAAAeAAAAaAAAAAAAAAAAAAAAAAAAAAAAAAAAAAAAECcAABAnAAAAAAAAAAAAAAAAAAAAAAAAAAAAAAAAAAAAAAAAAAAAABQAAAAAAAAAwMD/AAAAAABkAAAAMgAAAAAAAABkAAAAAAAAAH9/fwAKAAAAIgAAABgAAAAAAAAAAAAAAAAAAAAAAAAAAAAAAAAAAAAkAAAAJAAAAAAAAAAHAAAAAAAAAAAAAAAAAAAAAAAAAAAAAAAAAAAAf39/ACUAAABYAAAAAAAAAAAAAAAAAAAAAAAAAAAAAAAAAAAAAAAAAAAAAAAAAAAAAAAAAAAAAAA/AAAAAAAAAKCGAQAAAAAAAAAAAAAAAAAMAAAAAQAAAAAAAAAAAAAAAAAAAB8AAABUAAAA//8AAP///wEAAAAAAAAAAAAAAAAAAAAAAAAAAAAAAAAAAAAAAAAAAAAAAAJ/f38AgICAA8zMzADAwP8Af39/AAAAAAAAAAAAAAAAAAAAAAAAAAAAIQAAABgAAAAUAAAACA4AAJwbAABHFQAAcR4AAAAAAAAmAAAACAAAAP//////////"/>
                 </a:ext>
               </a:extLst>
             </p:cNvSpPr>
@@ -4971,7 +4883,7 @@
           <p:cNvGrpSpPr>
             <a:extLst>
               <a:ext uri="smNativeData">
-                <pr:smNativeData xmlns:pr="smNativeData" xmlns="smNativeData" val="SMDATA_6_AnHWaRMAAAAlAAAAAQAAAC8BAAAAkAAAAEgAAACQAAAASAAAAAAAAAAAAAAAAAAAABcAAAAUAAAAAAAAAAAAAAD/fwAA/38AAAAAAAAJAAAABAAAANDl5DEfAAAAVAAAAAAAAAAAAAAAAAAAAAAAAAAAAAAAAAAAAAAAAAAAAAAAAAAAAAAAAAAAAAAAAAAAAAAAAAAAAAAAAAAAAAAAAAAAAAAAAAAAAAAAAAAAAAAAAAAAACEAAAAYAAAAFAAAADMNAACoJAAAaBYAAN4nAAAAAAAAJgAAAAgAAAD/////AAAAAA=="/>
+                <pr:smNativeData xmlns:pr="smNativeData" xmlns="smNativeData" val="SMDATA_6_7aDWaRMAAAAlAAAAAQAAAA8BAAAAkAAAAEgAAACQAAAASAAAAAAAAAAAAAAAAAAAABcAAAAUAAAAAAAAAAAAAAD/fwAA/38AAAAAAAAJAAAABAAAABQeAjMfAAAAVAAAAAAAAAAAAAAAAAAAAAAAAAAAAAAAAAAAAAAAAAAAAAAAAAAAAAAAAAAAAAAAAAAAAAAAAAAAAAAAAAAAAAAAAAAAAAAAAAAAAAAAAAAAAAAAAAAAACEAAAAYAAAAFAAAADMNAACoJAAAaBYAAN4nAAAQAAAAJgAAAAgAAAD/////AAAAAA=="/>
               </a:ext>
             </a:extLst>
           </p:cNvGrpSpPr>
@@ -4991,7 +4903,7 @@
             <p:cNvSpPr txBox="1">
               <a:extLst>
                 <a:ext uri="smNativeData">
-                  <pr:smNativeData xmlns:pr="smNativeData" xmlns="smNativeData" val="SMDATA_15_AnHWaRMAAAAlAAAAEgAAAA8BAAAAkAAAAEgAAACQAAAASAAAAAAAAAABAAAAAAAAAAEAAABQAAAAAAAAAAAA4D8AAAAAAADgPwAAAAAAAOA/AAAAAAAA4D8AAAAAAADgPwAAAAAAAOA/AAAAAAAA4D8AAAAAAADgPwAAAAAAAOA/AAAAAAAA4D8CAAAAjAAAAAEAAAAAAAAA//8AAP///wgAAAAAAAAAAAAAAAAAAAAAAAAAAAAAAAAAAAAAZAAAAAEAAABAAAAAAAAAAAAAAAAAAAAAAAAAAAAAAAAAAAAAAAAAAAAAAAAAAAAAAAAAAAAAAAAAAAAAAAAAAAAAAAAAAAAAAAAAAAAAAAAAAAAAAAAAAAAAAAAAAAAAFAAAADwAAAABAAAAAAAAAAAAAAkUAAAAAQAAABQAAAAUAAAAFAAAAAEAAAAAAAAAZAAAAGQAAAAAAAAAZAAAAGQAAAAVAAAAYAAAAAAAAAAAAAAADwAAACADAAAAAAAAAAAAAAEAAACgMgAAVgcAAKr4//8BAAAAf39/AAEAAABkAAAAAAAAABQAAABAHwAAAAAAACYAAAAAAAAAwOD//wAAAAAmAAAAZAAAABYAAABMAAAAAAAAAAAAAAAEAAAAAAAAAAEAAACAgIAKAAAAACgAAAAoAAAAZAAAAGQAAAAAAAAAzMzMAAAAAABQAAAAUAAAAGQAAABkAAAAAAAAABcAAAAUAAAAAAAAAIgDAAD/fwAA/38AAAAAAAAJAAAABAAAAAAAAAAeAAAAaAAAAAAAAAAAAAAAAAAAAAAAAAAAAAAAECcAABAnAAAAAAAAAAAAAAAAAAAAAAAAAAAAAAAAAAAAAAAAAAAAABQAAAAAAAAAwMD/AAAAAABkAAAAMgAAAAAAAABkAAAAAAAAAH9/fwAKAAAAIgAAABgAAAAAAAAAAAAAAAAAAAAAAAAAAAAAAAAAAAAkAAAAJAAAAAAAAAAHAAAAAAAAAAAAAAAAAAAAAAAAAAAAAAAAAAAAf39/ACUAAABYAAAAAAAAAAAAAAAAAAAAAAAAAAAAAAAAAAAAAAAAAAAAAAAAAAAAAAAAAAAAAAA/AAAAAAAAAKCGAQAAAAAAAAAAAAAAAAAMAAAAAQAAAAAAAAAAAAAAAAAAAB8AAABUAAAA//8AAP///wEAAAAAAAAAAAAAAAAAAAAAAAAAAAAAAAAAAAAAAAAAAAAAAAJ/f38AgICAA8zMzADAwP8Af39/AAAAAAAAAAAAAAAAAAAAAAAAAAAAIQAAABgAAAAUAAAAlA0AAAklAABoFgAA3icAAAAAAAAmAAAACAAAAP//////////"/>
+                  <pr:smNativeData xmlns:pr="smNativeData" xmlns="smNativeData" val="SMDATA_15_7aDWaRMAAAAlAAAAEgAAAA8BAAAAkAAAAEgAAACQAAAASAAAAAAAAAABAAAAAAAAAAEAAABQAAAAAAAAAAAA4D8AAAAAAADgPwAAAAAAAOA/AAAAAAAA4D8AAAAAAADgPwAAAAAAAOA/AAAAAAAA4D8AAAAAAADgPwAAAAAAAOA/AAAAAAAA4D8CAAAAjAAAAAEAAAAAAAAA//8AAP///wgAAAAAAAAAAAAAAAAAAAAAAAAAAAAAAAAAAAAAZAAAAAEAAABAAAAAAAAAAAAAAAAAAAAAAAAAAAAAAAAAAAAAAAAAAAAAAAAAAAAAAAAAAAAAAAAAAAAAAAAAAAAAAAAAAAAAAAAAAAAAAAAAAAAAAAAAAAAAAAAAAAAAFAAAADwAAAABAAAAAAAAAAAAAAkUAAAAAQAAABQAAAAUAAAAFAAAAAEAAAAAAAAAZAAAAGQAAAAAAAAAZAAAAGQAAAAVAAAAYAAAAAAAAAAAAAAADwAAACADAAAAAAAAAAAAAAEAAACgMgAAVgcAAKr4//8BAAAAf39/AAEAAABkAAAAAAAAABQAAABAHwAAAAAAACYAAAAAAAAAwOD//wAAAAAmAAAAZAAAABYAAABMAAAAAAAAAAAAAAAEAAAAAAAAAAEAAACAgIAKAAAAACgAAAAoAAAAZAAAAGQAAAAAAAAAzMzMAAAAAABQAAAAUAAAAGQAAABkAAAAAAAAABcAAAAUAAAAAAAAAIgDAAD/fwAA/38AAAAAAAAJAAAABAAAAAAAAAAeAAAAaAAAAAAAAAAAAAAAAAAAAAAAAAAAAAAAECcAABAnAAAAAAAAAAAAAAAAAAAAAAAAAAAAAAAAAAAAAAAAAAAAABQAAAAAAAAAwMD/AAAAAABkAAAAMgAAAAAAAABkAAAAAAAAAH9/fwAKAAAAIgAAABgAAAAAAAAAAAAAAAAAAAAAAAAAAAAAAAAAAAAkAAAAJAAAAAAAAAAHAAAAAAAAAAAAAAAAAAAAAAAAAAAAAAAAAAAAf39/ACUAAABYAAAAAAAAAAAAAAAAAAAAAAAAAAAAAAAAAAAAAAAAAAAAAAAAAAAAAAAAAAAAAAA/AAAAAAAAAKCGAQAAAAAAAAAAAAAAAAAMAAAAAQAAAAAAAAAAAAAAAAAAAB8AAABUAAAA//8AAP///wEAAAAAAAAAAAAAAAAAAAAAAAAAAAAAAAAAAAAAAAAAAAAAAAJ/f38AgICAA8zMzADAwP8Af39/AAAAAAAAAAAAAAAAAAAAAAAAAAAAIQAAABgAAAAUAAAAlA0AAAklAABoFgAA3icAAAAAAAAmAAAACAAAAP//////////"/>
                 </a:ext>
               </a:extLst>
             </p:cNvSpPr>
@@ -5035,7 +4947,7 @@
             <p:cNvSpPr txBox="1">
               <a:extLst>
                 <a:ext uri="smNativeData">
-                  <pr:smNativeData xmlns:pr="smNativeData" xmlns="smNativeData" val="SMDATA_15_AnHWaRMAAAAlAAAAEgAAAA8BAAAAkAAAAEgAAACQAAAASAAAAAAAAAABAAAAAAAAAAEAAABQAAAAAAAAAAAA4D8AAAAAAADgPwAAAAAAAOA/AAAAAAAA4D8AAAAAAADgPwAAAAAAAOA/AAAAAAAA4D8AAAAAAADgPwAAAAAAAOA/AAAAAAAA4D8CAAAAjAAAAAEAAAAAAAAA//8AAP///wgAAAAAAAAAAAAAAAAAAAAAAAAAAAAAAAAAAAAAZAAAAAEAAABAAAAAAAAAAAAAAAAAAAAAAAAAAAAAAAAAAAAAAAAAAAAAAAAAAAAAAAAAAAAAAAAAAAAAAAAAAAAAAAAAAAAAAAAAAAAAAAAAAAAAAAAAAAAAAAAAAAAAFAAAADwAAAABAAAAAAAAAAAAAAkUAAAAAQAAABQAAAAUAAAAFAAAAAEAAAAAAAAAZAAAAGQAAAAAAAAAZAAAAGQAAAAVAAAAYAAAAAAAAAAAAAAADwAAACADAAAAAAAAAAAAAAEAAACgMgAAVgcAAKr4//8BAAAAf39/AAEAAABkAAAAAAAAABQAAABAHwAAAAAAACYAAAAAAAAAwOD//wAAAAAmAAAAZAAAABYAAABMAAAAAAAAAAAAAAAEAAAAAAAAAAEAAACAgIAKAAAAACgAAAAoAAAAZAAAAGQAAAAAAAAAzMzMAAAAAABQAAAAUAAAAGQAAABkAAAAAAAAABcAAAAUAAAAAAAAAIgDAAD/fwAA/38AAAAAAAAJAAAABAAAAA+Qx/8eAAAAaAAAAAAAAAAAAAAAAAAAAAAAAAAAAAAAECcAABAnAAAAAAAAAAAAAAAAAAAAAAAAAAAAAAAAAAAAAAAAAAAAABQAAAAAAAAAwMD/AAAAAABkAAAAMgAAAAAAAABkAAAAAAAAAH9/fwAKAAAAIgAAABgAAAAAAAAAAAAAAAAAAAAAAAAAAAAAAAAAAAAkAAAAJAAAAAAAAAAHAAAAAAAAAAAAAAAAAAAAAAAAAAAAAAAAAAAAf39/ACUAAABYAAAAAAAAAAAAAAAAAAAAAAAAAAAAAAAAAAAAAAAAAAAAAAAAAAAAAAAAAAAAAAA/AAAAAAAAAKCGAQAAAAAAAAAAAAAAAAAMAAAAAQAAAAAAAAAAAAAAAAAAAB8AAABUAAAA//8AAP///wEAAAAAAAAAAAAAAAAAAAAAAAAAAAAAAAAAAAAAAAAAAAAAAAJ/f38AgICAA8zMzADAwP8Af39/AAAAAAAAAAAAAAAAAAAAAAAAAAAAIQAAABgAAAAUAAAAMw0AAKgkAAAHFgAAfScAAAAAAAAmAAAACAAAAP//////////"/>
+                  <pr:smNativeData xmlns:pr="smNativeData" xmlns="smNativeData" val="SMDATA_15_7aDWaRMAAAAlAAAAEgAAAA8BAAAAkAAAAEgAAACQAAAASAAAAAAAAAABAAAAAAAAAAEAAABQAAAAAAAAAAAA4D8AAAAAAADgPwAAAAAAAOA/AAAAAAAA4D8AAAAAAADgPwAAAAAAAOA/AAAAAAAA4D8AAAAAAADgPwAAAAAAAOA/AAAAAAAA4D8CAAAAjAAAAAEAAAAAAAAA//8AAP///wgAAAAAAAAAAAAAAAAAAAAAAAAAAAAAAAAAAAAAZAAAAAEAAABAAAAAAAAAAAAAAAAAAAAAAAAAAAAAAAAAAAAAAAAAAAAAAAAAAAAAAAAAAAAAAAAAAAAAAAAAAAAAAAAAAAAAAAAAAAAAAAAAAAAAAAAAAAAAAAAAAAAAFAAAADwAAAABAAAAAAAAAAAAAAkUAAAAAQAAABQAAAAUAAAAFAAAAAEAAAAAAAAAZAAAAGQAAAAAAAAAZAAAAGQAAAAVAAAAYAAAAAAAAAAAAAAADwAAACADAAAAAAAAAAAAAAEAAACgMgAAVgcAAKr4//8BAAAAf39/AAEAAABkAAAAAAAAABQAAABAHwAAAAAAACYAAAAAAAAAwOD//wAAAAAmAAAAZAAAABYAAABMAAAAAAAAAAAAAAAEAAAAAAAAAAEAAACAgIAKAAAAACgAAAAoAAAAZAAAAGQAAAAAAAAAzMzMAAAAAABQAAAAUAAAAGQAAABkAAAAAAAAABcAAAAUAAAAAAAAAIgDAAD/fwAA/38AAAAAAAAJAAAABAAAAA+Qx/8eAAAAaAAAAAAAAAAAAAAAAAAAAAAAAAAAAAAAECcAABAnAAAAAAAAAAAAAAAAAAAAAAAAAAAAAAAAAAAAAAAAAAAAABQAAAAAAAAAwMD/AAAAAABkAAAAMgAAAAAAAABkAAAAAAAAAH9/fwAKAAAAIgAAABgAAAAAAAAAAAAAAAAAAAAAAAAAAAAAAAAAAAAkAAAAJAAAAAAAAAAHAAAAAAAAAAAAAAAAAAAAAAAAAAAAAAAAAAAAf39/ACUAAABYAAAAAAAAAAAAAAAAAAAAAAAAAAAAAAAAAAAAAAAAAAAAAAAAAAAAAAAAAAAAAAA/AAAAAAAAAKCGAQAAAAAAAAAAAAAAAAAMAAAAAQAAAAAAAAAAAAAAAAAAAB8AAABUAAAA//8AAP///wEAAAAAAAAAAAAAAAAAAAAAAAAAAAAAAAAAAAAAAAAAAAAAAAJ/f38AgICAA8zMzADAwP8Af39/AAAAAAAAAAAAAAAAAAAAAAAAAAAAIQAAABgAAAAUAAAAMw0AAKgkAAAHFgAAfScAAAAAAAAmAAAACAAAAP//////////"/>
                 </a:ext>
               </a:extLst>
             </p:cNvSpPr>
@@ -5080,7 +4992,7 @@
           <p:cNvGrpSpPr>
             <a:extLst>
               <a:ext uri="smNativeData">
-                <pr:smNativeData xmlns:pr="smNativeData" xmlns="smNativeData" val="SMDATA_6_AnHWaRMAAAAlAAAAAQAAAC8BAAAAkAAAAEgAAACQAAAASAAAAAAAAAAAAAAAAAAAABcAAAAUAAAAAAAAAAAAAAD/fwAA/38AAAAAAAAJAAAABAAAAA8AAAAfAAAAVAAAAAAAAAAAAAAAAAAAAAAAAAAAAAAAAAAAAAAAAAAAAAAAAAAAAAAAAAAAAAAAAAAAAAAAAAAAAAAAAAAAAAAAAAAAAAAAAAAAAAAAAAAAAAAAAAAAACEAAAAYAAAAFAAAAGoNAABqIAAAMRYAAHQjAAAAAAAAJgAAAAgAAAD/////AAAAAA=="/>
+                <pr:smNativeData xmlns:pr="smNativeData" xmlns="smNativeData" val="SMDATA_6_7aDWaRMAAAAlAAAAAQAAAA8BAAAAkAAAAEgAAACQAAAASAAAAAAAAAAAAAAAAAAAABcAAAAUAAAAAAAAAAAAAAD/fwAA/38AAAAAAAAJAAAABAAAAHIGAAAfAAAAVAAAAAAAAAAAAAAAAAAAAAAAAAAAAAAAAAAAAAAAAAAAAAAAAAAAAAAAAAAAAAAAAAAAAAAAAAAAAAAAAAAAAAAAAAAAAAAAAAAAAAAAAAAAAAAAAAAAACEAAAAYAAAAFAAAAGoNAABqIAAAMRYAAHQjAAAQAAAAJgAAAAgAAAD/////AAAAAA=="/>
               </a:ext>
             </a:extLst>
           </p:cNvGrpSpPr>
@@ -5100,7 +5012,7 @@
             <p:cNvSpPr txBox="1">
               <a:extLst>
                 <a:ext uri="smNativeData">
-                  <pr:smNativeData xmlns:pr="smNativeData" xmlns="smNativeData" val="SMDATA_15_AnHWaRMAAAAlAAAAEgAAAA8BAAAAkAAAAEgAAACQAAAASAAAAAAAAAABAAAAAAAAAAEAAABQAAAAAAAAAAAA4D8AAAAAAADgPwAAAAAAAOA/AAAAAAAA4D8AAAAAAADgPwAAAAAAAOA/AAAAAAAA4D8AAAAAAADgPwAAAAAAAOA/AAAAAAAA4D8CAAAAjAAAAAEAAAAAAAAAAP8AAP///wgAAAAAAAAAAAAAAAAAAAAAAAAAAAAAAAAAAAAAZAAAAAEAAABAAAAAAAAAAAAAAAAAAAAAAAAAAAAAAAAAAAAAAAAAAAAAAAAAAAAAAAAAAAAAAAAAAAAAAAAAAAAAAAAAAAAAAAAAAAAAAAAAAAAAAAAAAAAAAAAAAAAAFAAAADwAAAABAAAAAAAAAAAAAAkUAAAAAQAAABQAAAAUAAAAFAAAAAEAAAAAAAAAZAAAAGQAAAAAAAAAZAAAAGQAAAAVAAAAYAAAAAAAAAAAAAAADwAAACADAAAAAAAAAAAAAAEAAACgMgAAVgcAAKr4//8BAAAAf39/AAEAAABkAAAAAAAAABQAAABAHwAAAAAAACYAAAAAAAAAwOD//wAAAAAmAAAAZAAAABYAAABMAAAAAAAAAAAAAAAEAAAAAAAAAAEAAACAgIAKAAAAACgAAAAoAAAAZAAAAGQAAAAAAAAAzMzMAAAAAABQAAAAUAAAAGQAAABkAAAAAAAAABcAAAAUAAAAAAAAAIgDAAD/fwAA/38AAAAAAAAJAAAABAAAACMAAAAeAAAAaAAAAAAAAAAAAAAAAAAAAAAAAAAAAAAAECcAABAnAAAAAAAAAAAAAAAAAAAAAAAAAAAAAAAAAAAAAAAAAAAAABQAAAAAAAAAwMD/AAAAAABkAAAAMgAAAAAAAABkAAAAAAAAAH9/fwAKAAAAIgAAABgAAAAAAAAAAAAAAAAAAAAAAAAAAAAAAAAAAAAkAAAAJAAAAAAAAAAHAAAAAAAAAAAAAAAAAAAAAAAAAAAAAAAAAAAAf39/ACUAAABYAAAAAAAAAAAAAAAAAAAAAAAAAAAAAAAAAAAAAAAAAAAAAAAAAAAAAAAAAAAAAAA/AAAAAAAAAKCGAQAAAAAAAAAAAAAAAAAMAAAAAQAAAAAAAAAAAAAAAAAAAB8AAABUAAAAAP8AAP///wEAAAAAAAAAAAAAAAAAAAAAAAAAAAAAAAAAAAAAAAAAAAAAAAJ/f38AgICAA8zMzADAwP8Af39/AAAAAAAAAAAAAAAAAAAAAAAAAAAAIQAAABgAAAAUAAAAzg0AAM4gAAAxFgAAdCMAAAAAAAAmAAAACAAAAP//////////"/>
+                  <pr:smNativeData xmlns:pr="smNativeData" xmlns="smNativeData" val="SMDATA_15_7aDWaRMAAAAlAAAAEgAAAA8BAAAAkAAAAEgAAACQAAAASAAAAAAAAAABAAAAAAAAAAEAAABQAAAAAAAAAAAA4D8AAAAAAADgPwAAAAAAAOA/AAAAAAAA4D8AAAAAAADgPwAAAAAAAOA/AAAAAAAA4D8AAAAAAADgPwAAAAAAAOA/AAAAAAAA4D8CAAAAjAAAAAEAAAAAAAAAAP8AAP///wgAAAAAAAAAAAAAAAAAAAAAAAAAAAAAAAAAAAAAZAAAAAEAAABAAAAAAAAAAAAAAAAAAAAAAAAAAAAAAAAAAAAAAAAAAAAAAAAAAAAAAAAAAAAAAAAAAAAAAAAAAAAAAAAAAAAAAAAAAAAAAAAAAAAAAAAAAAAAAAAAAAAAFAAAADwAAAABAAAAAAAAAAAAAAkUAAAAAQAAABQAAAAUAAAAFAAAAAEAAAAAAAAAZAAAAGQAAAAAAAAAZAAAAGQAAAAVAAAAYAAAAAAAAAAAAAAADwAAACADAAAAAAAAAAAAAAEAAACgMgAAVgcAAKr4//8BAAAAf39/AAEAAABkAAAAAAAAABQAAABAHwAAAAAAACYAAAAAAAAAwOD//wAAAAAmAAAAZAAAABYAAABMAAAAAAAAAAAAAAAEAAAAAAAAAAEAAACAgIAKAAAAACgAAAAoAAAAZAAAAGQAAAAAAAAAzMzMAAAAAABQAAAAUAAAAGQAAABkAAAAAAAAABcAAAAUAAAAAAAAAIgDAAD/fwAA/38AAAAAAAAJAAAABAAAACMAAAAeAAAAaAAAAAAAAAAAAAAAAAAAAAAAAAAAAAAAECcAABAnAAAAAAAAAAAAAAAAAAAAAAAAAAAAAAAAAAAAAAAAAAAAABQAAAAAAAAAwMD/AAAAAABkAAAAMgAAAAAAAABkAAAAAAAAAH9/fwAKAAAAIgAAABgAAAAAAAAAAAAAAAAAAAAAAAAAAAAAAAAAAAAkAAAAJAAAAAAAAAAHAAAAAAAAAAAAAAAAAAAAAAAAAAAAAAAAAAAAf39/ACUAAABYAAAAAAAAAAAAAAAAAAAAAAAAAAAAAAAAAAAAAAAAAAAAAAAAAAAAAAAAAAAAAAA/AAAAAAAAAKCGAQAAAAAAAAAAAAAAAAAMAAAAAQAAAAAAAAAAAAAAAAAAAB8AAABUAAAAAP8AAP///wEAAAAAAAAAAAAAAAAAAAAAAAAAAAAAAAAAAAAAAAAAAAAAAAJ/f38AgICAA8zMzADAwP8Af39/AAAAAAAAAAAAAAAAAAAAAAAAAAAAIQAAABgAAAAUAAAAzg0AAM4gAAAxFgAAdCMAAAAAAAAmAAAACAAAAP//////////"/>
                 </a:ext>
               </a:extLst>
             </p:cNvSpPr>
@@ -5144,7 +5056,7 @@
             <p:cNvSpPr txBox="1">
               <a:extLst>
                 <a:ext uri="smNativeData">
-                  <pr:smNativeData xmlns:pr="smNativeData" xmlns="smNativeData" val="SMDATA_15_AnHWaRMAAAAlAAAAEgAAAA8BAAAAkAAAAEgAAACQAAAASAAAAAAAAAABAAAAAAAAAAEAAABQAAAAAAAAAAAA4D8AAAAAAADgPwAAAAAAAOA/AAAAAAAA4D8AAAAAAADgPwAAAAAAAOA/AAAAAAAA4D8AAAAAAADgPwAAAAAAAOA/AAAAAAAA4D8CAAAAjAAAAAEAAAAAAAAAAP8AAP///wgAAAAAAAAAAAAAAAAAAAAAAAAAAAAAAAAAAAAAZAAAAAEAAABAAAAAAAAAAAAAAAAAAAAAAAAAAAAAAAAAAAAAAAAAAAAAAAAAAAAAAAAAAAAAAAAAAAAAAAAAAAAAAAAAAAAAAAAAAAAAAAAAAAAAAAAAAAAAAAAAAAAAFAAAADwAAAABAAAAAAAAAAAAAAkUAAAAAQAAABQAAAAUAAAAFAAAAAEAAAAAAAAAZAAAAGQAAAAAAAAAZAAAAGQAAAAVAAAAYAAAAAAAAAAAAAAADwAAACADAAAAAAAAAAAAAAEAAACgMgAAVgcAAKr4//8BAAAAf39/AAEAAABkAAAAAAAAABQAAABAHwAAAAAAACYAAAAAAAAAwOD//wAAAAAmAAAAZAAAABYAAABMAAAAAAAAAAAAAAAEAAAAAAAAAAEAAACAgIAKAAAAACgAAAAoAAAAZAAAAGQAAAAAAAAAzMzMAAAAAABQAAAAUAAAAGQAAABkAAAAAAAAABcAAAAUAAAAAAAAAIgDAAD/fwAA/38AAAAAAAAJAAAABAAAACMAAAAeAAAAaAAAAAAAAAAAAAAAAAAAAAAAAAAAAAAAECcAABAnAAAAAAAAAAAAAAAAAAAAAAAAAAAAAAAAAAAAAAAAAAAAABQAAAAAAAAAwMD/AAAAAABkAAAAMgAAAAAAAABkAAAAAAAAAH9/fwAKAAAAIgAAABgAAAAAAAAAAAAAAAAAAAAAAAAAAAAAAAAAAAAkAAAAJAAAAAAAAAAHAAAAAAAAAAAAAAAAAAAAAAAAAAAAAAAAAAAAf39/ACUAAABYAAAAAAAAAAAAAAAAAAAAAAAAAAAAAAAAAAAAAAAAAAAAAAAAAAAAAAAAAAAAAAA/AAAAAAAAAKCGAQAAAAAAAAAAAAAAAAAMAAAAAQAAAAAAAAAAAAAAAAAAAB8AAABUAAAAAP8AAP///wEAAAAAAAAAAAAAAAAAAAAAAAAAAAAAAAAAAAAAAAAAAAAAAAJ/f38AgICAA8zMzADAwP8Af39/AAAAAAAAAAAAAAAAAAAAAAAAAAAAIQAAABgAAAAUAAAAag0AAGogAADNFQAAECMAAAAAAAAmAAAACAAAAP//////////"/>
+                  <pr:smNativeData xmlns:pr="smNativeData" xmlns="smNativeData" val="SMDATA_15_7aDWaRMAAAAlAAAAEgAAAA8BAAAAkAAAAEgAAACQAAAASAAAAAAAAAABAAAAAAAAAAEAAABQAAAAAAAAAAAA4D8AAAAAAADgPwAAAAAAAOA/AAAAAAAA4D8AAAAAAADgPwAAAAAAAOA/AAAAAAAA4D8AAAAAAADgPwAAAAAAAOA/AAAAAAAA4D8CAAAAjAAAAAEAAAAAAAAAAP8AAP///wgAAAAAAAAAAAAAAAAAAAAAAAAAAAAAAAAAAAAAZAAAAAEAAABAAAAAAAAAAAAAAAAAAAAAAAAAAAAAAAAAAAAAAAAAAAAAAAAAAAAAAAAAAAAAAAAAAAAAAAAAAAAAAAAAAAAAAAAAAAAAAAAAAAAAAAAAAAAAAAAAAAAAFAAAADwAAAABAAAAAAAAAAAAAAkUAAAAAQAAABQAAAAUAAAAFAAAAAEAAAAAAAAAZAAAAGQAAAAAAAAAZAAAAGQAAAAVAAAAYAAAAAAAAAAAAAAADwAAACADAAAAAAAAAAAAAAEAAACgMgAAVgcAAKr4//8BAAAAf39/AAEAAABkAAAAAAAAABQAAABAHwAAAAAAACYAAAAAAAAAwOD//wAAAAAmAAAAZAAAABYAAABMAAAAAAAAAAAAAAAEAAAAAAAAAAEAAACAgIAKAAAAACgAAAAoAAAAZAAAAGQAAAAAAAAAzMzMAAAAAABQAAAAUAAAAGQAAABkAAAAAAAAABcAAAAUAAAAAAAAAIgDAAD/fwAA/38AAAAAAAAJAAAABAAAACMAAAAeAAAAaAAAAAAAAAAAAAAAAAAAAAAAAAAAAAAAECcAABAnAAAAAAAAAAAAAAAAAAAAAAAAAAAAAAAAAAAAAAAAAAAAABQAAAAAAAAAwMD/AAAAAABkAAAAMgAAAAAAAABkAAAAAAAAAH9/fwAKAAAAIgAAABgAAAAAAAAAAAAAAAAAAAAAAAAAAAAAAAAAAAAkAAAAJAAAAAAAAAAHAAAAAAAAAAAAAAAAAAAAAAAAAAAAAAAAAAAAf39/ACUAAABYAAAAAAAAAAAAAAAAAAAAAAAAAAAAAAAAAAAAAAAAAAAAAAAAAAAAAAAAAAAAAAA/AAAAAAAAAKCGAQAAAAAAAAAAAAAAAAAMAAAAAQAAAAAAAAAAAAAAAAAAAB8AAABUAAAAAP8AAP///wEAAAAAAAAAAAAAAAAAAAAAAAAAAAAAAAAAAAAAAAAAAAAAAAJ/f38AgICAA8zMzADAwP8Af39/AAAAAAAAAAAAAAAAAAAAAAAAAAAAIQAAABgAAAAUAAAAag0AAGogAADNFQAAECMAAAAAAAAmAAAACAAAAP//////////"/>
                 </a:ext>
               </a:extLst>
             </p:cNvSpPr>
@@ -5191,7 +5103,7 @@
             <a:endCxn id="19" idx="0"/>
             <a:extLst>
               <a:ext uri="smNativeData">
-                <pr:smNativeData xmlns:pr="smNativeData" xmlns="smNativeData" val="SMDATA_15_AnHWaRMAAAAlAAAADgAAAA8BAAAAkAAAAEgAAACQAAAASAAAAAAAAAAAAAAAAAAAAAEAAABQAAAAVObRwNBxAbwAAAAAAADgPwAAAAAAAOA/AAAAAAAA4D8AAAAAAADgPwAAAAAAAOA/AAAAAAAA4D8AAAAAAADgPwAAAAAAAOA/AAAAAAAA4D8CAAAAjAAAAAAAAAAAAAAAu+DjDP///wgAAAAAAAAAAAAAAAAAAAAAAAAAAAAAAAAAAAAAZAAAAAEAAABAAAAAAAAAAAAAAAAAAAAAAAAAAAAAAAAAAAAAAAAAAAAAAAAAAAAAAAAAAAAAAAAAAAAAAAAAAAAAAAAAAAAAAAAAAAAAAAAAAAAAAAAAAAAAAAAAAAAAFAAAADwAAAABAAAAAAAAAAAAAAkUAAAAAQAAABQAAAAUAAAAFAAAAAEAAAAAAAAAZAAAAGQAAAABAAAAlgAAAJYAAAAVAAAAYAAAAAAAAAAAAAAADwAAACADAAAAAAAAAAAAAAEAAACgMgAAVgcAAKr4//8BAAAAf39/AAEAAABkAAAAAAAAABQAAABAHwAAAAAAACYAAAAAAAAAwOD//wAAAAAmAAAAZAAAABYAAABMAAAAAAAAAAAAAAAEAAAAAAAAAAEAAACAgIAKAAAAACgAAAAoAAAAZAAAAGQAAAAAAAAAzMzMAAAAAABQAAAAUAAAAGQAAABkAAAAAAAAABcAAAAUAAAAAAAAAAAAAAD/fwAA/38AAAAAAAAJAAAABAAAAAIAAAAeAAAAaAAAAAAAAAAAAAAAAAAAAAAAAAAAAAAAECcAABAnAAAAAAAAAAAAAAAAAAAAAAAAAAAAAAAAAAAAAAAAAAAAABQAAAAAAAAAwMD/AAAAAABkAAAAMgAAAAAAAABkAAAAAAAAAH9/fwAKAAAAIgAAABgAAAAAAAAAAAAAAAAAAAAAAAAAAAAAAAAAAAAkAAAAJAAAAAAAAAAHAAAAAAAAAAAAAAAAAAAAAAAAAAAAAAAAAAAAf39/ACUAAABYAAAAAAAAAAAAAAAAAAAAAAAAAAAAAAAAAAAAAAAAAAAAAAAAAAAAAAAAAAAAAAA/AAAAAAAAAKCGAQAAAAAAAAAAAAAAAAAMAAAAAQAAAAAAAAAAAAAAAAAAAB8AAABUAAAAu+DjBf///wEAAAAAAAAAAAAAAAAAAAAAAAAAAAAAAAAAAAAAAAAAAAAAAAJ/f38AgICAA8zMzADAwP8Af39/AAAAAAAAAAAAAAAAAAAAAAAAAAAAIQAAABgAAAAUAAAAUR8AAGUeAABRHwAAayAAAAAAAAAmAAAACAAAAP//////////"/>
+                <pr:smNativeData xmlns:pr="smNativeData" xmlns="smNativeData" val="SMDATA_15_7aDWaRMAAAAlAAAADgAAAA8BAAAAkAAAAEgAAACQAAAASAAAAAAAAAAAAAAAAAAAAAEAAABQAAAAVObRwNBxAbwAAAAAAADgPwAAAAAAAOA/AAAAAAAA4D8AAAAAAADgPwAAAAAAAOA/AAAAAAAA4D8AAAAAAADgPwAAAAAAAOA/AAAAAAAA4D8CAAAAjAAAAAAAAAAAAAAAu+DjDP///wgAAAAAAAAAAAAAAAAAAAAAAAAAAAAAAAAAAAAAZAAAAAEAAABAAAAAAAAAAAAAAAAAAAAAAAAAAAAAAAAAAAAAAAAAAAAAAAAAAAAAAAAAAAAAAAAAAAAAAAAAAAAAAAAAAAAAAAAAAAAAAAAAAAAAAAAAAAAAAAAAAAAAFAAAADwAAAABAAAAAAAAAAAAAAkUAAAAAQAAABQAAAAUAAAAFAAAAAEAAAAAAAAAZAAAAGQAAAABAAAAlgAAAJYAAAAVAAAAYAAAAAAAAAAAAAAADwAAACADAAAAAAAAAAAAAAEAAACgMgAAVgcAAKr4//8BAAAAf39/AAEAAABkAAAAAAAAABQAAABAHwAAAAAAACYAAAAAAAAAwOD//wAAAAAmAAAAZAAAABYAAABMAAAAAAAAAAAAAAAEAAAAAAAAAAEAAACAgIAKAAAAACgAAAAoAAAAZAAAAGQAAAAAAAAAzMzMAAAAAABQAAAAUAAAAGQAAABkAAAAAAAAABcAAAAUAAAAAAAAAAAAAAD/fwAA/38AAAAAAAAJAAAABAAAAAIAAAAeAAAAaAAAAAAAAAAAAAAAAAAAAAAAAAAAAAAAECcAABAnAAAAAAAAAAAAAAAAAAAAAAAAAAAAAAAAAAAAAAAAAAAAABQAAAAAAAAAwMD/AAAAAABkAAAAMgAAAAAAAABkAAAAAAAAAH9/fwAKAAAAIgAAABgAAAAAAAAAAAAAAAAAAAAAAAAAAAAAAAAAAAAkAAAAJAAAAAAAAAAHAAAAAAAAAAAAAAAAAAAAAAAAAAAAAAAAAAAAf39/ACUAAABYAAAAAAAAAAAAAAAAAAAAAAAAAAAAAAAAAAAAAAAAAAAAAAAAAAAAAAAAAAAAAAA/AAAAAAAAAKCGAQAAAAAAAAAAAAAAAAAMAAAAAQAAAAAAAAAAAAAAAAAAAB8AAABUAAAAu+DjBf///wEAAAAAAAAAAAAAAAAAAAAAAAAAAAAAAAAAAAAAAAAAAAAAAAJ/f38AgICAA8zMzADAwP8Af39/AAAAAAAAAAAAAAAAAAAAAAAAAAAAIQAAABgAAAAUAAAAUR8AAGUeAABRHwAAayAAABAAAAAmAAAACAAAAP//////////"/>
               </a:ext>
             </a:extLst>
           </p:cNvCxnSpPr>
@@ -5224,7 +5136,7 @@
             <a:stCxn id="17" idx="2"/>
             <a:extLst>
               <a:ext uri="smNativeData">
-                <pr:smNativeData xmlns:pr="smNativeData" xmlns="smNativeData" val="SMDATA_15_AnHWaRMAAAAlAAAADgAAAA8BAAAAkAAAAEgAAACQAAAASAAAAAAAAAAAAAAAAAAAAAEAAABQAAAAAAAAAAAAAAAAAAAAAADgPwAAAAAAAOA/AAAAAAAA4D8AAAAAAADgPwAAAAAAAOA/AAAAAAAA4D8AAAAAAADgPwAAAAAAAOA/AAAAAAAA4D8CAAAAjAAAAAAAAAAAAAAAu+DjDP///wgAAAAAAAAAAAAAAAAAAAAAAAAAAAAAAAAAAAAAZAAAAAEAAABAAAAAAAAAAAAAAAAAAAAAAAAAAAAAAAAAAAAAAAAAAAAAAAAAAAAAAAAAAAAAAAAAAAAAAAAAAAAAAAAAAAAAAAAAAAAAAAAAAAAAAAAAAAAAAAAAAAAAFAAAADwAAAABAAAAAAAAAAAAAAkUAAAAAQAAABQAAAAUAAAAFAAAAAEAAAAAAAAAZAAAAGQAAAABAAAAlgAAAJYAAAAVAAAAYAAAAAAAAAAAAAAADwAAACADAAAAAAAAAAAAAAEAAACgMgAAVgcAAKr4//8BAAAAf39/AAEAAABkAAAAAAAAABQAAABAHwAAAAAAACYAAAAAAAAAwOD//wAAAAAmAAAAZAAAABYAAABMAAAAAAAAAAAAAAAEAAAAAAAAAAEAAACAgIAKAAAAACgAAAAoAAAAZAAAAGQAAAAAAAAAzMzMAAAAAABQAAAAUAAAAGQAAABkAAAAAAAAABcAAAAUAAAAAAAAAAAAAAD/fwAA/38AAAAAAAAJAAAABAAAAAAAAAAeAAAAaAAAAAAAAAAAAAAAAAAAAAAAAAAAAAAAECcAABAnAAAAAAAAAAAAAAAAAAAAAAAAAAAAAAAAAAAAAAAAAAAAABQAAAAAAAAAwMD/AAAAAABkAAAAMgAAAAAAAABkAAAAAAAAAH9/fwAKAAAAIgAAABgAAAAAAAAAAAAAAAAAAAAAAAAAAAAAAAAAAAAkAAAAJAAAAAAAAAAHAAAAAAAAAAAAAAAAAAAAAAAAAAAAAAAAAAAAf39/ACUAAABYAAAAAAAAAAAAAAAAAAAAAAAAAAAAAAAAAAAAAAAAAAAAAAAAAAAAAAAAAAAAAAA/AAAAAAAAAKCGAQAAAAAAAAAAAAAAAAAMAAAAAQAAAAAAAAAAAAAAAAAAAB8AAABUAAAAu+DjBf///wEAAAAAAAAAAAAAAAAAAAAAAAAAAAAAAAAAAAAAAAAAAAAAAAJ/f38AgICAA8zMzADAwP8Af39/AAAAAAAAAAAAAAAAAAAAAAAAAAAAIQAAABgAAAAUAAAA1hEAAFQYAAAQFwAAkBsAAAAAAAAmAAAACAAAAP//////////"/>
+                <pr:smNativeData xmlns:pr="smNativeData" xmlns="smNativeData" val="SMDATA_15_7aDWaRMAAAAlAAAADgAAAA8BAAAAkAAAAEgAAACQAAAASAAAAAAAAAAAAAAAAAAAAAEAAABQAAAAAAAAAAAAAAAAAAAAAADgPwAAAAAAAOA/AAAAAAAA4D8AAAAAAADgPwAAAAAAAOA/AAAAAAAA4D8AAAAAAADgPwAAAAAAAOA/AAAAAAAA4D8CAAAAjAAAAAAAAAAAAAAAu+DjDP///wgAAAAAAAAAAAAAAAAAAAAAAAAAAAAAAAAAAAAAZAAAAAEAAABAAAAAAAAAAAAAAAAAAAAAAAAAAAAAAAAAAAAAAAAAAAAAAAAAAAAAAAAAAAAAAAAAAAAAAAAAAAAAAAAAAAAAAAAAAAAAAAAAAAAAAAAAAAAAAAAAAAAAFAAAADwAAAABAAAAAAAAAAAAAAkUAAAAAQAAABQAAAAUAAAAFAAAAAEAAAAAAAAAZAAAAGQAAAABAAAAlgAAAJYAAAAVAAAAYAAAAAAAAAAAAAAADwAAACADAAAAAAAAAAAAAAEAAACgMgAAVgcAAKr4//8BAAAAf39/AAEAAABkAAAAAAAAABQAAABAHwAAAAAAACYAAAAAAAAAwOD//wAAAAAmAAAAZAAAABYAAABMAAAAAAAAAAAAAAAEAAAAAAAAAAEAAACAgIAKAAAAACgAAAAoAAAAZAAAAGQAAAAAAAAAzMzMAAAAAABQAAAAUAAAAGQAAABkAAAAAAAAABcAAAAUAAAAAAAAAAAAAAD/fwAA/38AAAAAAAAJAAAABAAAAAAAAAAeAAAAaAAAAAAAAAAAAAAAAAAAAAAAAAAAAAAAECcAABAnAAAAAAAAAAAAAAAAAAAAAAAAAAAAAAAAAAAAAAAAAAAAABQAAAAAAAAAwMD/AAAAAABkAAAAMgAAAAAAAABkAAAAAAAAAH9/fwAKAAAAIgAAABgAAAAAAAAAAAAAAAAAAAAAAAAAAAAAAAAAAAAkAAAAJAAAAAAAAAAHAAAAAAAAAAAAAAAAAAAAAAAAAAAAAAAAAAAAf39/ACUAAABYAAAAAAAAAAAAAAAAAAAAAAAAAAAAAAAAAAAAAAAAAAAAAAAAAAAAAAAAAAAAAAA/AAAAAAAAAKCGAQAAAAAAAAAAAAAAAAAMAAAAAQAAAAAAAAAAAAAAAAAAAB8AAABUAAAAu+DjBf///wEAAAAAAAAAAAAAAAAAAAAAAAAAAAAAAAAAAAAAAAAAAAAAAAJ/f38AgICAA8zMzADAwP8Af39/AAAAAAAAAAAAAAAAAAAAAAAAAAAAIQAAABgAAAAUAAAA1hEAAFQYAAAQFwAAkBsAABAAAAAmAAAACAAAAP//////////"/>
               </a:ext>
             </a:extLst>
           </p:cNvCxnSpPr>
@@ -5260,7 +5172,7 @@
             <a:endCxn id="18" idx="0"/>
             <a:extLst>
               <a:ext uri="smNativeData">
-                <pr:smNativeData xmlns:pr="smNativeData" xmlns="smNativeData" val="SMDATA_15_AnHWaRMAAAAlAAAADgAAAA8BAAAAkAAAAEgAAACQAAAASAAAAAAAAAAAAAAAAAAAAAEAAABQAAAAKgs9ranT9TsAAAAAAADgPwAAAAAAAOA/AAAAAAAA4D8AAAAAAADgPwAAAAAAAOA/AAAAAAAA4D8AAAAAAADgPwAAAAAAAOA/AAAAAAAA4D8CAAAAjAAAAAAAAAAAAAAAu+DjDP///wgAAAAAAAAAAAAAAAAAAAAAAAAAAAAAAAAAAAAAZAAAAAEAAABAAAAAAAAAAAAAAAAAAAAAAAAAAAAAAAAAAAAAAAAAAAAAAAAAAAAAAAAAAAAAAAAAAAAAAAAAAAAAAAAAAAAAAAAAAAAAAAAAAAAAAAAAAAAAAAAAAAAAFAAAADwAAAABAAAAAAAAAAAAAAkUAAAAAQAAABQAAAAUAAAAFAAAAAEAAAAAAAAAZAAAAGQAAAABAAAAlgAAAJYAAAAVAAAAYAAAAAAAAAAAAAAADwAAACADAAAAAAAAAAAAAAEAAACgMgAAVgcAAKr4//8BAAAAf39/AAEAAABkAAAAAAAAABQAAABAHwAAAAAAACYAAAAAAAAAwOD//wAAAAAmAAAAZAAAABYAAABMAAAAAAAAAAAAAAAEAAAAAAAAAAEAAACAgIAKAAAAACgAAAAoAAAAZAAAAGQAAAAAAAAAzMzMAAAAAABQAAAAUAAAAGQAAABkAAAAAAAAABcAAAAUAAAAAAAAAAAAAAD/fwAA/38AAAAAAAAJAAAABAAAAAAAAAAeAAAAaAAAAAAAAAAAAAAAAAAAAAAAAAAAAAAAECcAABAnAAAAAAAAAAAAAAAAAAAAAAAAAAAAAAAAAAAAAAAAAAAAABQAAAAAAAAAwMD/AAAAAABkAAAAMgAAAAAAAABkAAAAAAAAAH9/fwAKAAAAIgAAABgAAAAAAAAAAAAAAAAAAAAAAAAAAAAAAAAAAAAkAAAAJAAAAAAAAAAHAAAAAAAAAAAAAAAAAAAAAAAAAAAAAAAAAAAAf39/ACUAAABYAAAAAAAAAAAAAAAAAAAAAAAAAAAAAAAAAAAAAAAAAAAAAAAAAAAAAAAAAAAAAAA/AAAAAAAAAKCGAQAAAAAAAAAAAAAAAAAMAAAAAQAAAAAAAAAAAAAAAAAAAB8AAABUAAAAu+DjBf///wEAAAAAAAAAAAAAAAAAAAAAAAAAAAAAAAAAAAAAAAAAAAAAAAJ/f38AgICAA8zMzADAwP8Af39/AAAAAAAAAAAAAAAAAAAAAAAAAAAAIQAAABgAAAAUAAAAEBcAAFQYAABRHwAAkBsAAAAAAAAmAAAACAAAAP//////////"/>
+                <pr:smNativeData xmlns:pr="smNativeData" xmlns="smNativeData" val="SMDATA_15_7aDWaRMAAAAlAAAADgAAAA8BAAAAkAAAAEgAAACQAAAASAAAAAAAAAAAAAAAAAAAAAEAAABQAAAAKgs9ranT9TsAAAAAAADgPwAAAAAAAOA/AAAAAAAA4D8AAAAAAADgPwAAAAAAAOA/AAAAAAAA4D8AAAAAAADgPwAAAAAAAOA/AAAAAAAA4D8CAAAAjAAAAAAAAAAAAAAAu+DjDP///wgAAAAAAAAAAAAAAAAAAAAAAAAAAAAAAAAAAAAAZAAAAAEAAABAAAAAAAAAAAAAAAAAAAAAAAAAAAAAAAAAAAAAAAAAAAAAAAAAAAAAAAAAAAAAAAAAAAAAAAAAAAAAAAAAAAAAAAAAAAAAAAAAAAAAAAAAAAAAAAAAAAAAFAAAADwAAAABAAAAAAAAAAAAAAkUAAAAAQAAABQAAAAUAAAAFAAAAAEAAAAAAAAAZAAAAGQAAAABAAAAlgAAAJYAAAAVAAAAYAAAAAAAAAAAAAAADwAAACADAAAAAAAAAAAAAAEAAACgMgAAVgcAAKr4//8BAAAAf39/AAEAAABkAAAAAAAAABQAAABAHwAAAAAAACYAAAAAAAAAwOD//wAAAAAmAAAAZAAAABYAAABMAAAAAAAAAAAAAAAEAAAAAAAAAAEAAACAgIAKAAAAACgAAAAoAAAAZAAAAGQAAAAAAAAAzMzMAAAAAABQAAAAUAAAAGQAAABkAAAAAAAAABcAAAAUAAAAAAAAAAAAAAD/fwAA/38AAAAAAAAJAAAABAAAAAAAAAAeAAAAaAAAAAAAAAAAAAAAAAAAAAAAAAAAAAAAECcAABAnAAAAAAAAAAAAAAAAAAAAAAAAAAAAAAAAAAAAAAAAAAAAABQAAAAAAAAAwMD/AAAAAABkAAAAMgAAAAAAAABkAAAAAAAAAH9/fwAKAAAAIgAAABgAAAAAAAAAAAAAAAAAAAAAAAAAAAAAAAAAAAAkAAAAJAAAAAAAAAAHAAAAAAAAAAAAAAAAAAAAAAAAAAAAAAAAAAAAf39/ACUAAABYAAAAAAAAAAAAAAAAAAAAAAAAAAAAAAAAAAAAAAAAAAAAAAAAAAAAAAAAAAAAAAA/AAAAAAAAAKCGAQAAAAAAAAAAAAAAAAAMAAAAAQAAAAAAAAAAAAAAAAAAAB8AAABUAAAAu+DjBf///wEAAAAAAAAAAAAAAAAAAAAAAAAAAAAAAAAAAAAAAAAAAAAAAAJ/f38AgICAA8zMzADAwP8Af39/AAAAAAAAAAAAAAAAAAAAAAAAAAAAIQAAABgAAAAUAAAAEBcAAFQYAABRHwAAkBsAABAAAAAmAAAACAAAAP//////////"/>
               </a:ext>
             </a:extLst>
           </p:cNvCxnSpPr>
@@ -5296,7 +5208,7 @@
             <a:endCxn id="17" idx="3"/>
             <a:extLst>
               <a:ext uri="smNativeData">
-                <pr:smNativeData xmlns:pr="smNativeData" xmlns="smNativeData" val="SMDATA_15_AnHWaRMAAAAlAAAADQAAAA8BAAAAkAAAAEgAAACQAAAASAAAAAAAAAAAAAAAAAAAAAEAAABQAAAAAAAAAAAA4D8AAAAAAADgPwAAAAAAAOA/AAAAAAAA4D8AAAAAAADgPwAAAAAAAOA/AAAAAAAA4D8AAAAAAADgPwAAAAAAAOA/AAAAAAAA4D8CAAAAjAAAAAAAAAAAAAAAu+DjDP///wgAAAAAAAAAAAAAAAAAAAAAAAAAAAAAAAAAAAAAZAAAAAEAAABAAAAAAAAAAAAAAAAAAAAAAAAAAAAAAAAAAAAAAAAAAAAAAAAAAAAAAAAAAAAAAAAAAAAAAAAAAAAAAAAAAAAAAAAAAAAAAAAAAAAAAAAAAAAAAAAAAAAAFAAAADwAAAABAAAAAAAAAAAAAAkUAAAAAQAAABQAAAAUAAAAFAAAAAEAAAAAAAAAZAAAAGQAAAABAAAAlgAAAJYAAAAVAAAAYAAAAAAAAAAAAAAADwAAACADAAAAAAAAAAAAAAEAAACgMgAAVgcAAKr4//8BAAAAf39/AAEAAABkAAAAAAAAABQAAABAHwAAAAAAACYAAAAAAAAAwOD//wAAAAAmAAAAZAAAABYAAABMAAAAAAAAAAAAAAAEAAAAAAAAAAEAAACAgIAKAAAAACgAAAAoAAAAZAAAAGQAAAAAAAAAzMzMAAAAAABQAAAAUAAAAGQAAABkAAAAAAAAABcAAAAUAAAAAAAAAAAAAAD/fwAA/38AAAAAAAAJAAAABAAAAAAAAAAeAAAAaAAAAAAAAAAAAAAAAAAAAAAAAAAAAAAAECcAABAnAAAAAAAAAAAAAAAAAAAAAAAAAAAAAAAAAAAAAAAAAAAAABQAAAAAAAAAwMD/AAAAAABkAAAAMgAAAAAAAABkAAAAAAAAAH9/fwAKAAAAIgAAABgAAAAAAAAAAAAAAAAAAAAAAAAAAAAAAAAAAAAkAAAAJAAAAAAAAAAHAAAAAAAAAAAAAAAAAAAAAAAAAAAAAAAAAAAAf39/ACUAAABYAAAAAAAAAAAAAAAAAAAAAAAAAAAAAAAAAAAAAAAAAAAAAAAAAAAAAAAAAAAAAAA/AAAAAAAAAKCGAQAAAAAAAAAAAAAAAAAMAAAAAQAAAAAAAAAAAAAAAAAAAB8AAABUAAAAu+DjBf///wEAAAAAAAAAAAAAAAAAAAAAAAAAAAAAAAAAAAAAAAAAAAAAAAJ/f38AgICAA8zMzADAwP8Af39/AAAAAAAAAAAAAAAAAAAAAAAAAAAAIQAAABgAAAAUAAAAthkAAFgWAADxIAAAWBYAAAAAAAAmAAAACAAAAP//////////"/>
+                <pr:smNativeData xmlns:pr="smNativeData" xmlns="smNativeData" val="SMDATA_15_7aDWaRMAAAAlAAAADQAAAA8BAAAAkAAAAEgAAACQAAAASAAAAAAAAAAAAAAAAAAAAAEAAABQAAAAAAAAAAAA4D8AAAAAAADgPwAAAAAAAOA/AAAAAAAA4D8AAAAAAADgPwAAAAAAAOA/AAAAAAAA4D8AAAAAAADgPwAAAAAAAOA/AAAAAAAA4D8CAAAAjAAAAAAAAAAAAAAAu+DjDP///wgAAAAAAAAAAAAAAAAAAAAAAAAAAAAAAAAAAAAAZAAAAAEAAABAAAAAAAAAAAAAAAAAAAAAAAAAAAAAAAAAAAAAAAAAAAAAAAAAAAAAAAAAAAAAAAAAAAAAAAAAAAAAAAAAAAAAAAAAAAAAAAAAAAAAAAAAAAAAAAAAAAAAFAAAADwAAAABAAAAAAAAAAAAAAkUAAAAAQAAABQAAAAUAAAAFAAAAAEAAAAAAAAAZAAAAGQAAAABAAAAlgAAAJYAAAAVAAAAYAAAAAAAAAAAAAAADwAAACADAAAAAAAAAAAAAAEAAACgMgAAVgcAAKr4//8BAAAAf39/AAEAAABkAAAAAAAAABQAAABAHwAAAAAAACYAAAAAAAAAwOD//wAAAAAmAAAAZAAAABYAAABMAAAAAAAAAAAAAAAEAAAAAAAAAAEAAACAgIAKAAAAACgAAAAoAAAAZAAAAGQAAAAAAAAAzMzMAAAAAABQAAAAUAAAAGQAAABkAAAAAAAAABcAAAAUAAAAAAAAAAAAAAD/fwAA/38AAAAAAAAJAAAABAAAAAAAAAAeAAAAaAAAAAAAAAAAAAAAAAAAAAAAAAAAAAAAECcAABAnAAAAAAAAAAAAAAAAAAAAAAAAAAAAAAAAAAAAAAAAAAAAABQAAAAAAAAAwMD/AAAAAABkAAAAMgAAAAAAAABkAAAAAAAAAH9/fwAKAAAAIgAAABgAAAAAAAAAAAAAAAAAAAAAAAAAAAAAAAAAAAAkAAAAJAAAAAAAAAAHAAAAAAAAAAAAAAAAAAAAAAAAAAAAAAAAAAAAf39/ACUAAABYAAAAAAAAAAAAAAAAAAAAAAAAAAAAAAAAAAAAAAAAAAAAAAAAAAAAAAAAAAAAAAA/AAAAAAAAAKCGAQAAAAAAAAAAAAAAAAAMAAAAAQAAAAAAAAAAAAAAAAAAAB8AAABUAAAAu+DjBf///wEAAAAAAAAAAAAAAAAAAAAAAAAAAAAAAAAAAAAAAAAAAAAAAAJ/f38AgICAA8zMzADAwP8Af39/AAAAAAAAAAAAAAAAAAAAAAAAAAAAIQAAABgAAAAUAAAAthkAAFgWAADxIAAAWBYAABAAAAAmAAAACAAAAP//////////"/>
               </a:ext>
             </a:extLst>
           </p:cNvCxnSpPr>
@@ -5330,7 +5242,7 @@
             <a:endCxn id="11" idx="1"/>
             <a:extLst>
               <a:ext uri="smNativeData">
-                <pr:smNativeData xmlns:pr="smNativeData" xmlns="smNativeData" val="SMDATA_15_AnHWaRMAAAAlAAAADQAAAA8BAAAAkAAAAEgAAACQAAAASAAAAAAAAAAAAAAAAAAAAAEAAABQAAAAAAAAAAAA4D8AAAAAAADgPwAAAAAAAOA/AAAAAAAA4D8AAAAAAADgPwAAAAAAAOA/AAAAAAAA4D8AAAAAAADgPwAAAAAAAOA/AAAAAAAA4D8CAAAAjAAAAAAAAAAAAAAAu+DjDP///wgAAAAAAAAAAAAAAAAAAAAAAAAAAAAAAAAAAAAAZAAAAAEAAABAAAAAAAAAAAAAAAAAAAAAAAAAAAAAAAAAAAAAAAAAAAAAAAAAAAAAAAAAAAAAAAAAAAAAAAAAAAAAAAAAAAAAAAAAAAAAAAAAAAAAAAAAAAAAAAAAAAAAFAAAADwAAAABAAAAAAAAAAAAAAkUAAAAAQAAABQAAAAUAAAAFAAAAAEAAAAAAAAAZAAAAGQAAAABAAAAlgAAAJYAAAAVAAAAYAAAAAAAAAAAAAAADwAAACADAAAAAAAAAAAAAAEAAACgMgAAVgcAAKr4//8BAAAAf39/AAEAAABkAAAAAAAAABQAAABAHwAAAAAAACYAAAAAAAAAwOD//wAAAAAmAAAAZAAAABYAAABMAAAAAAAAAAAAAAAEAAAAAAAAAAEAAACAgIAKAAAAACgAAAAoAAAAZAAAAGQAAAAAAAAAzMzMAAAAAABQAAAAUAAAAGQAAABkAAAAAAAAABcAAAAUAAAAAAAAAAAAAAD/fwAA/38AAAAAAAAJAAAABAAAAAAAAAAeAAAAaAAAAAAAAAAAAAAAAAAAAAAAAAAAAAAAECcAABAnAAAAAAAAAAAAAAAAAAAAAAAAAAAAAAAAAAAAAAAAAAAAABQAAAAAAAAAwMD/AAAAAABkAAAAMgAAAAAAAABkAAAAAAAAAH9/fwAKAAAAIgAAABgAAAAAAAAAAAAAAAAAAAAAAAAAAAAAAAAAAAAkAAAAJAAAAAAAAAAHAAAAAAAAAAAAAAAAAAAAAAAAAAAAAAAAAAAAf39/ACUAAABYAAAAAAAAAAAAAAAAAAAAAAAAAAAAAAAAAAAAAAAAAAAAAAAAAAAAAAAAAAAAAAA/AAAAAAAAAKCGAQAAAAAAAAAAAAAAAAAMAAAAAQAAAAAAAAAAAAAAAAAAAB8AAABUAAAAu+DjBf///wEAAAAAAAAAAAAAAAAAAAAAAAAAAAAAAAAAAAAAAAAAAAAAAAJ/f38AgICAA8zMzADAwP8Af39/AAAAAAAAAAAAAAAAAAAAAAAAAAAAIQAAABgAAAAUAAAAGCsAAFgWAABGMQAAWBYAAAAAAAAmAAAACAAAAP//////////"/>
+                <pr:smNativeData xmlns:pr="smNativeData" xmlns="smNativeData" val="SMDATA_15_7aDWaRMAAAAlAAAADQAAAA8BAAAAkAAAAEgAAACQAAAASAAAAAAAAAAAAAAAAAAAAAEAAABQAAAAAAAAAAAA4D8AAAAAAADgPwAAAAAAAOA/AAAAAAAA4D8AAAAAAADgPwAAAAAAAOA/AAAAAAAA4D8AAAAAAADgPwAAAAAAAOA/AAAAAAAA4D8CAAAAjAAAAAAAAAAAAAAAu+DjDP///wgAAAAAAAAAAAAAAAAAAAAAAAAAAAAAAAAAAAAAZAAAAAEAAABAAAAAAAAAAAAAAAAAAAAAAAAAAAAAAAAAAAAAAAAAAAAAAAAAAAAAAAAAAAAAAAAAAAAAAAAAAAAAAAAAAAAAAAAAAAAAAAAAAAAAAAAAAAAAAAAAAAAAFAAAADwAAAABAAAAAAAAAAAAAAkUAAAAAQAAABQAAAAUAAAAFAAAAAEAAAAAAAAAZAAAAGQAAAABAAAAlgAAAJYAAAAVAAAAYAAAAAAAAAAAAAAADwAAACADAAAAAAAAAAAAAAEAAACgMgAAVgcAAKr4//8BAAAAf39/AAEAAABkAAAAAAAAABQAAABAHwAAAAAAACYAAAAAAAAAwOD//wAAAAAmAAAAZAAAABYAAABMAAAAAAAAAAAAAAAEAAAAAAAAAAEAAACAgIAKAAAAACgAAAAoAAAAZAAAAGQAAAAAAAAAzMzMAAAAAABQAAAAUAAAAGQAAABkAAAAAAAAABcAAAAUAAAAAAAAAAAAAAD/fwAA/38AAAAAAAAJAAAABAAAAAAAAAAeAAAAaAAAAAAAAAAAAAAAAAAAAAAAAAAAAAAAECcAABAnAAAAAAAAAAAAAAAAAAAAAAAAAAAAAAAAAAAAAAAAAAAAABQAAAAAAAAAwMD/AAAAAABkAAAAMgAAAAAAAABkAAAAAAAAAH9/fwAKAAAAIgAAABgAAAAAAAAAAAAAAAAAAAAAAAAAAAAAAAAAAAAkAAAAJAAAAAAAAAAHAAAAAAAAAAAAAAAAAAAAAAAAAAAAAAAAAAAAf39/ACUAAABYAAAAAAAAAAAAAAAAAAAAAAAAAAAAAAAAAAAAAAAAAAAAAAAAAAAAAAAAAAAAAAA/AAAAAAAAAKCGAQAAAAAAAAAAAAAAAAAMAAAAAQAAAAAAAAAAAAAAAAAAAB8AAABUAAAAu+DjBf///wEAAAAAAAAAAAAAAAAAAAAAAAAAAAAAAAAAAAAAAAAAAAAAAAJ/f38AgICAA8zMzADAwP8Af39/AAAAAAAAAAAAAAAAAAAAAAAAAAAAIQAAABgAAAAUAAAAGCsAAFgWAABGMQAAWBYAABAAAAAmAAAACAAAAP//////////"/>
               </a:ext>
             </a:extLst>
           </p:cNvCxnSpPr>
@@ -5363,7 +5275,7 @@
             <a:stCxn id="11" idx="2"/>
             <a:extLst>
               <a:ext uri="smNativeData">
-                <pr:smNativeData xmlns:pr="smNativeData" xmlns="smNativeData" val="SMDATA_15_AnHWaRMAAAAlAAAADgAAAA8BAAAAkAAAAEgAAACQAAAASAAAAAAAAAAAAAAAAAAAAAEAAABQAAAAIlGJdd5YUr8AAAAAAADgPwAAAAAAAOA/AAAAAAAA4D8AAAAAAADgPwAAAAAAAOA/AAAAAAAA4D8AAAAAAADgPwAAAAAAAOA/AAAAAAAA4D8CAAAAjAAAAAAAAAAAAAAAu+DjDP///wgAAAAAAAAAAAAAAAAAAAAAAAAAAAAAAAAAAAAAZAAAAAEAAABAAAAAAAAAAAAAAAAAAAAAAAAAAAAAAAAAAAAAAAAAAAAAAAAAAAAAAAAAAAAAAAAAAAAAAAAAAAAAAAAAAAAAAAAAAAAAAAAAAAAAAAAAAAAAAAAAAAAAFAAAADwAAAABAAAAAAAAAAAAAAkUAAAAAQAAABQAAAAUAAAAFAAAAAEAAAAAAAAAZAAAAGQAAAABAAAAlgAAAJYAAAAVAAAAYAAAAAAAAAAAAAAADwAAACADAAAAAAAAAAAAAAEAAACgMgAAVgcAAKr4//8BAAAAf39/AAEAAABkAAAAAAAAABQAAABAHwAAAAAAACYAAAAAAAAAwOD//wAAAAAmAAAAZAAAABYAAABMAAAAAAAAAAAAAAAEAAAAAAAAAAEAAACAgIAKAAAAACgAAAAoAAAAZAAAAGQAAAAAAAAAzMzMAAAAAABQAAAAUAAAAGQAAABkAAAAAAAAABcAAAAUAAAAAAAAAAAAAAD/fwAA/38AAAAAAAAJAAAABAAAAAAAAAAeAAAAaAAAAAAAAAAAAAAAAAAAAAAAAAAAAAAAECcAABAnAAAAAAAAAAAAAAAAAAAAAAAAAAAAAAAAAAAAAAAAAAAAABQAAAAAAAAAwMD/AAAAAABkAAAAMgAAAAAAAABkAAAAAAAAAH9/fwAKAAAAIgAAABgAAAAAAAAAAAAAAAAAAAAAAAAAAAAAAAAAAAAkAAAAJAAAAAAAAAAHAAAAAAAAAAAAAAAAAAAAAAAAAAAAAAAAAAAAf39/ACUAAABYAAAAAAAAAAAAAAAAAAAAAAAAAAAAAAAAAAAAAAAAAAAAAAAAAAAAAAAAAAAAAAA/AAAAAAAAAKCGAQAAAAAAAAAAAAAAAAAMAAAAAQAAAAAAAAAAAAAAAAAAAB8AAABUAAAAu+DjBf///wEAAAAAAAAAAAAAAAAAAAAAAAAAAAAAAAAAAAAAAAAAAAAAAAJ/f38AgICAA8zMzADAwP8Af39/AAAAAAAAAAAAAAAAAAAAAAAAAAAAIQAAABgAAAAUAAAASSwAAFQYAADsMwAA0RsAAAAAAAAmAAAACAAAAP//////////"/>
+                <pr:smNativeData xmlns:pr="smNativeData" xmlns="smNativeData" val="SMDATA_15_7aDWaRMAAAAlAAAADgAAAA8BAAAAkAAAAEgAAACQAAAASAAAAAAAAAAAAAAAAAAAAAEAAABQAAAAIlGJdd5YUr8AAAAAAADgPwAAAAAAAOA/AAAAAAAA4D8AAAAAAADgPwAAAAAAAOA/AAAAAAAA4D8AAAAAAADgPwAAAAAAAOA/AAAAAAAA4D8CAAAAjAAAAAAAAAAAAAAAu+DjDP///wgAAAAAAAAAAAAAAAAAAAAAAAAAAAAAAAAAAAAAZAAAAAEAAABAAAAAAAAAAAAAAAAAAAAAAAAAAAAAAAAAAAAAAAAAAAAAAAAAAAAAAAAAAAAAAAAAAAAAAAAAAAAAAAAAAAAAAAAAAAAAAAAAAAAAAAAAAAAAAAAAAAAAFAAAADwAAAABAAAAAAAAAAAAAAkUAAAAAQAAABQAAAAUAAAAFAAAAAEAAAAAAAAAZAAAAGQAAAABAAAAlgAAAJYAAAAVAAAAYAAAAAAAAAAAAAAADwAAACADAAAAAAAAAAAAAAEAAACgMgAAVgcAAKr4//8BAAAAf39/AAEAAABkAAAAAAAAABQAAABAHwAAAAAAACYAAAAAAAAAwOD//wAAAAAmAAAAZAAAABYAAABMAAAAAAAAAAAAAAAEAAAAAAAAAAEAAACAgIAKAAAAACgAAAAoAAAAZAAAAGQAAAAAAAAAzMzMAAAAAABQAAAAUAAAAGQAAABkAAAAAAAAABcAAAAUAAAAAAAAAAAAAAD/fwAA/38AAAAAAAAJAAAABAAAAAAAAAAeAAAAaAAAAAAAAAAAAAAAAAAAAAAAAAAAAAAAECcAABAnAAAAAAAAAAAAAAAAAAAAAAAAAAAAAAAAAAAAAAAAAAAAABQAAAAAAAAAwMD/AAAAAABkAAAAMgAAAAAAAABkAAAAAAAAAH9/fwAKAAAAIgAAABgAAAAAAAAAAAAAAAAAAAAAAAAAAAAAAAAAAAAkAAAAJAAAAAAAAAAHAAAAAAAAAAAAAAAAAAAAAAAAAAAAAAAAAAAAf39/ACUAAABYAAAAAAAAAAAAAAAAAAAAAAAAAAAAAAAAAAAAAAAAAAAAAAAAAAAAAAAAAAAAAAA/AAAAAAAAAKCGAQAAAAAAAAAAAAAAAAAMAAAAAQAAAAAAAAAAAAAAAAAAAB8AAABUAAAAu+DjBf///wEAAAAAAAAAAAAAAAAAAAAAAAAAAAAAAAAAAAAAAAAAAAAAAAJ/f38AgICAA8zMzADAwP8Af39/AAAAAAAAAAAAAAAAAAAAAAAAAAAAIQAAABgAAAAUAAAASSwAAFQYAADsMwAA0RsAABAAAAAmAAAACAAAAP//////////"/>
               </a:ext>
             </a:extLst>
           </p:cNvCxnSpPr>
@@ -5399,7 +5311,7 @@
             <a:endCxn id="15" idx="0"/>
             <a:extLst>
               <a:ext uri="smNativeData">
-                <pr:smNativeData xmlns:pr="smNativeData" xmlns="smNativeData" val="SMDATA_15_AnHWaRMAAAAlAAAADgAAAA8BAAAAkAAAAEgAAACQAAAASAAAAAAAAAAAAAAAAAAAAAEAAABQAAAAIFGJdd5YUr8AAAAAAADgPwAAAAAAAOA/AAAAAAAA4D8AAAAAAADgPwAAAAAAAOA/AAAAAAAA4D8AAAAAAADgPwAAAAAAAOA/AAAAAAAA4D8CAAAAjAAAAAAAAAAAAAAAu+DjDP///wgAAAAAAAAAAAAAAAAAAAAAAAAAAAAAAAAAAAAAZAAAAAEAAABAAAAAAAAAAAAAAAAAAAAAAAAAAAAAAAAAAAAAAAAAAAAAAAAAAAAAAAAAAAAAAAAAAAAAAAAAAAAAAAAAAAAAAAAAAAAAAAAAAAAAAAAAAAAAAAAAAAAAFAAAADwAAAABAAAAAAAAAAAAAAkUAAAAAQAAABQAAAAUAAAAFAAAAAEAAAAAAAAAZAAAAGQAAAABAAAAlgAAAJYAAAAVAAAAYAAAAAAAAAAAAAAADwAAACADAAAAAAAAAAAAAAEAAACgMgAAVgcAAKr4//8BAAAAf39/AAEAAABkAAAAAAAAABQAAABAHwAAAAAAACYAAAAAAAAAwOD//wAAAAAmAAAAZAAAABYAAABMAAAAAAAAAAAAAAAEAAAAAAAAAAEAAACAgIAKAAAAACgAAAAoAAAAZAAAAGQAAAAAAAAAzMzMAAAAAABQAAAAUAAAAGQAAABkAAAAAAAAABcAAAAUAAAAAAAAAAAAAAD/fwAA/38AAAAAAAAJAAAABAAAAAAAAAAeAAAAaAAAAAAAAAAAAAAAAAAAAAAAAAAAAAAAECcAABAnAAAAAAAAAAAAAAAAAAAAAAAAAAAAAAAAAAAAAAAAAAAAABQAAAAAAAAAwMD/AAAAAABkAAAAMgAAAAAAAABkAAAAAAAAAH9/fwAKAAAAIgAAABgAAAAAAAAAAAAAAAAAAAAAAAAAAAAAAAAAAAAkAAAAJAAAAAAAAAAHAAAAAAAAAAAAAAAAAAAAAAAAAAAAAAAAAAAAf39/ACUAAABYAAAAAAAAAAAAAAAAAAAAAAAAAAAAAAAAAAAAAAAAAAAAAAAAAAAAAAAAAAAAAAA/AAAAAAAAAKCGAQAAAAAAAAAAAAAAAAAMAAAAAQAAAAAAAAAAAAAAAAAAAB8AAABUAAAAu+DjBf///wEAAAAAAAAAAAAAAAAAAAAAAAAAAAAAAAAAAAAAAAAAAAAAAAJ/f38AgICAA8zMzADAwP8Af39/AAAAAAAAAAAAAAAAAAAAAAAAAAAAIQAAABgAAAAUAAAA7DMAAFQYAACjOwAA0RsAAAAAAAAmAAAACAAAAP//////////"/>
+                <pr:smNativeData xmlns:pr="smNativeData" xmlns="smNativeData" val="SMDATA_15_7aDWaRMAAAAlAAAADgAAAA8BAAAAkAAAAEgAAACQAAAASAAAAAAAAAAAAAAAAAAAAAEAAABQAAAAIFGJdd5YUr8AAAAAAADgPwAAAAAAAOA/AAAAAAAA4D8AAAAAAADgPwAAAAAAAOA/AAAAAAAA4D8AAAAAAADgPwAAAAAAAOA/AAAAAAAA4D8CAAAAjAAAAAAAAAAAAAAAu+DjDP///wgAAAAAAAAAAAAAAAAAAAAAAAAAAAAAAAAAAAAAZAAAAAEAAABAAAAAAAAAAAAAAAAAAAAAAAAAAAAAAAAAAAAAAAAAAAAAAAAAAAAAAAAAAAAAAAAAAAAAAAAAAAAAAAAAAAAAAAAAAAAAAAAAAAAAAAAAAAAAAAAAAAAAFAAAADwAAAABAAAAAAAAAAAAAAkUAAAAAQAAABQAAAAUAAAAFAAAAAEAAAAAAAAAZAAAAGQAAAABAAAAlgAAAJYAAAAVAAAAYAAAAAAAAAAAAAAADwAAACADAAAAAAAAAAAAAAEAAACgMgAAVgcAAKr4//8BAAAAf39/AAEAAABkAAAAAAAAABQAAABAHwAAAAAAACYAAAAAAAAAwOD//wAAAAAmAAAAZAAAABYAAABMAAAAAAAAAAAAAAAEAAAAAAAAAAEAAACAgIAKAAAAACgAAAAoAAAAZAAAAGQAAAAAAAAAzMzMAAAAAABQAAAAUAAAAGQAAABkAAAAAAAAABcAAAAUAAAAAAAAAAAAAAD/fwAA/38AAAAAAAAJAAAABAAAAAAAAAAeAAAAaAAAAAAAAAAAAAAAAAAAAAAAAAAAAAAAECcAABAnAAAAAAAAAAAAAAAAAAAAAAAAAAAAAAAAAAAAAAAAAAAAABQAAAAAAAAAwMD/AAAAAABkAAAAMgAAAAAAAABkAAAAAAAAAH9/fwAKAAAAIgAAABgAAAAAAAAAAAAAAAAAAAAAAAAAAAAAAAAAAAAkAAAAJAAAAAAAAAAHAAAAAAAAAAAAAAAAAAAAAAAAAAAAAAAAAAAAf39/ACUAAABYAAAAAAAAAAAAAAAAAAAAAAAAAAAAAAAAAAAAAAAAAAAAAAAAAAAAAAAAAAAAAAA/AAAAAAAAAKCGAQAAAAAAAAAAAAAAAAAMAAAAAQAAAAAAAAAAAAAAAAAAAB8AAABUAAAAu+DjBf///wEAAAAAAAAAAAAAAAAAAAAAAAAAAAAAAAAAAAAAAAAAAAAAAAJ/f38AgICAA8zMzADAwP8Af39/AAAAAAAAAAAAAAAAAAAAAAAAAAAAIQAAABgAAAAUAAAA7DMAAFQYAACjOwAA0RsAABAAAAAmAAAACAAAAP//////////"/>
               </a:ext>
             </a:extLst>
           </p:cNvCxnSpPr>
@@ -5435,7 +5347,7 @@
             <a:endCxn id="16" idx="0"/>
             <a:extLst>
               <a:ext uri="smNativeData">
-                <pr:smNativeData xmlns:pr="smNativeData" xmlns="smNativeData" val="SMDATA_15_AnHWaRMAAAAlAAAADQAAAA8BAAAAkAAAAEgAAACQAAAASAAAAAAAAAAAAAAAAAAAAAEAAABQAAAAU01UIIFqDDwAAAAAAADgPwAAAAAAAOA/AAAAAAAA4D8AAAAAAADgPwAAAAAAAOA/AAAAAAAA4D8AAAAAAADgPwAAAAAAAOA/AAAAAAAA4D8CAAAAjAAAAAAAAAAAAAAAu+DjDP///wgAAAAAAAAAAAAAAAAAAAAAAAAAAAAAAAAAAAAAZAAAAAEAAABAAAAAAAAAAAAAAAAAAAAAAAAAAAAAAAAAAAAAAAAAAAAAAAAAAAAAAAAAAAAAAAAAAAAAAAAAAAAAAAAAAAAAAAAAAAAAAAAAAAAAAAAAAAAAAAAAAAAAFAAAADwAAAABAAAAAAAAAAAAAAkUAAAAAQAAABQAAAAUAAAAFAAAAAEAAAAAAAAAZAAAAGQAAAABAAAAlgAAAJYAAAAVAAAAYAAAAAAAAAAAAAAADwAAACADAAAAAAAAAAAAAAEAAACgMgAAVgcAAKr4//8BAAAAf39/AAEAAABkAAAAAAAAABQAAABAHwAAAAAAACYAAAAAAAAAwOD//wAAAAAmAAAAZAAAABYAAABMAAAAAAAAAAAAAAAEAAAAAAAAAAEAAACAgIAKAAAAACgAAAAoAAAAZAAAAGQAAAAAAAAAzMzMAAAAAABQAAAAUAAAAGQAAABkAAAAAAAAABcAAAAUAAAAAAAAAAAAAAD/fwAA/38AAAAAAAAJAAAABAAAAAAAAAAeAAAAaAAAAAAAAAAAAAAAAAAAAAAAAAAAAAAAECcAABAnAAAAAAAAAAAAAAAAAAAAAAAAAAAAAAAAAAAAAAAAAAAAABQAAAAAAAAAwMD/AAAAAABkAAAAMgAAAAAAAABkAAAAAAAAAH9/fwAKAAAAIgAAABgAAAAAAAAAAAAAAAAAAAAAAAAAAAAAAAAAAAAkAAAAJAAAAAAAAAAHAAAAAAAAAAAAAAAAAAAAAAAAAAAAAAAAAAAAf39/ACUAAABYAAAAAAAAAAAAAAAAAAAAAAAAAAAAAAAAAAAAAAAAAAAAAAAAAAAAAAAAAAAAAAA/AAAAAAAAAKCGAQAAAAAAAAAAAAAAAAAMAAAAAQAAAAAAAAAAAAAAAAAAAB8AAABUAAAAu+DjBf///wEAAAAAAAAAAAAAAAAAAAAAAAAAAAAAAAAAAAAAAAAAAAAAAAJ/f38AgICAA8zMzADAwP8Af39/AAAAAAAAAAAAAAAAAAAAAAAAAAAAIQAAABgAAAAUAAAAozsAAKYeAACjOwAAfCAAAAAAAAAmAAAACAAAAP//////////"/>
+                <pr:smNativeData xmlns:pr="smNativeData" xmlns="smNativeData" val="SMDATA_15_7aDWaRMAAAAlAAAADQAAAA8BAAAAkAAAAEgAAACQAAAASAAAAAAAAAAAAAAAAAAAAAEAAABQAAAAU01UIIFqDDwAAAAAAADgPwAAAAAAAOA/AAAAAAAA4D8AAAAAAADgPwAAAAAAAOA/AAAAAAAA4D8AAAAAAADgPwAAAAAAAOA/AAAAAAAA4D8CAAAAjAAAAAAAAAAAAAAAu+DjDP///wgAAAAAAAAAAAAAAAAAAAAAAAAAAAAAAAAAAAAAZAAAAAEAAABAAAAAAAAAAAAAAAAAAAAAAAAAAAAAAAAAAAAAAAAAAAAAAAAAAAAAAAAAAAAAAAAAAAAAAAAAAAAAAAAAAAAAAAAAAAAAAAAAAAAAAAAAAAAAAAAAAAAAFAAAADwAAAABAAAAAAAAAAAAAAkUAAAAAQAAABQAAAAUAAAAFAAAAAEAAAAAAAAAZAAAAGQAAAABAAAAlgAAAJYAAAAVAAAAYAAAAAAAAAAAAAAADwAAACADAAAAAAAAAAAAAAEAAACgMgAAVgcAAKr4//8BAAAAf39/AAEAAABkAAAAAAAAABQAAABAHwAAAAAAACYAAAAAAAAAwOD//wAAAAAmAAAAZAAAABYAAABMAAAAAAAAAAAAAAAEAAAAAAAAAAEAAACAgIAKAAAAACgAAAAoAAAAZAAAAGQAAAAAAAAAzMzMAAAAAABQAAAAUAAAAGQAAABkAAAAAAAAABcAAAAUAAAAAAAAAAAAAAD/fwAA/38AAAAAAAAJAAAABAAAAAAAAAAeAAAAaAAAAAAAAAAAAAAAAAAAAAAAAAAAAAAAECcAABAnAAAAAAAAAAAAAAAAAAAAAAAAAAAAAAAAAAAAAAAAAAAAABQAAAAAAAAAwMD/AAAAAABkAAAAMgAAAAAAAABkAAAAAAAAAH9/fwAKAAAAIgAAABgAAAAAAAAAAAAAAAAAAAAAAAAAAAAAAAAAAAAkAAAAJAAAAAAAAAAHAAAAAAAAAAAAAAAAAAAAAAAAAAAAAAAAAAAAf39/ACUAAABYAAAAAAAAAAAAAAAAAAAAAAAAAAAAAAAAAAAAAAAAAAAAAAAAAAAAAAAAAAAAAAA/AAAAAAAAAKCGAQAAAAAAAAAAAAAAAAAMAAAAAQAAAAAAAAAAAAAAAAAAAB8AAABUAAAAu+DjBf///wEAAAAAAAAAAAAAAAAAAAAAAAAAAAAAAAAAAAAAAAAAAAAAAAJ/f38AgICAA8zMzADAwP8Af39/AAAAAAAAAAAAAAAAAAAAAAAAAAAAIQAAABgAAAAUAAAAozsAAKYeAACjOwAAfCAAABAAAAAmAAAACAAAAP//////////"/>
               </a:ext>
             </a:extLst>
           </p:cNvCxnSpPr>
@@ -5469,7 +5381,7 @@
             <a:endCxn id="7" idx="0"/>
             <a:extLst>
               <a:ext uri="smNativeData">
-                <pr:smNativeData xmlns:pr="smNativeData" xmlns="smNativeData" val="SMDATA_15_AnHWaRMAAAAlAAAADgAAAA8BAAAAkAAAAEgAAACQAAAASAAAAAAAAAAAAAAAAAAAAAEAAABQAAAA9uN+f2jSSb8AAAAAAADgPwAAAAAAAOA/AAAAAAAA4D8AAAAAAADgPwAAAAAAAOA/AAAAAAAA4D8AAAAAAADgPwAAAAAAAOA/AAAAAAAA4D8CAAAAjAAAAAAAAAAAAAAAu+DjDP///wgAAAAAAAAAAAAAAAAAAAAAAAAAAAAAAAAAAAAAZAAAAAEAAABAAAAAAAAAAAAAAAAAAAAAAAAAAAAAAAAAAAAAAAAAAAAAAAAAAAAAAAAAAAAAAAAAAAAAAAAAAAAAAAAAAAAAAAAAAAAAAAAAAAAAAAAAAAAAAAAAAAAAFAAAADwAAAABAAAAAAAAAAAAAAkUAAAAAQAAABQAAAAUAAAAFAAAAAEAAAAAAAAAZAAAAGQAAAABAAAAlgAAAJYAAAAVAAAAYAAAAAAAAAAAAAAADwAAACADAAAAAAAAAAAAAAEAAACgMgAAVgcAAKr4//8BAAAAf39/AAEAAABkAAAAAAAAABQAAABAHwAAAAAAACYAAAAAAAAAwOD//wAAAAAmAAAAZAAAABYAAABMAAAAAAAAAAAAAAAEAAAAAAAAAAEAAACAgIAKAAAAACgAAAAoAAAAZAAAAGQAAAAAAAAAzMzMAAAAAABQAAAAUAAAAGQAAABkAAAAAAAAABcAAAAUAAAAAAAAAAAAAAD/fwAA/38AAAAAAAAJAAAABAAAAAIAAAAeAAAAaAAAAAAAAAAAAAAAAAAAAAAAAAAAAAAAECcAABAnAAAAAAAAAAAAAAAAAAAAAAAAAAAAAAAAAAAAAAAAAAAAABQAAAAAAAAAwMD/AAAAAABkAAAAMgAAAAAAAABkAAAAAAAAAH9/fwAKAAAAIgAAABgAAAAAAAAAAAAAAAAAAAAAAAAAAAAAAAAAAAAkAAAAJAAAAAAAAAAHAAAAAAAAAAAAAAAAAAAAAAAAAAAAAAAAAAAAf39/ACUAAABYAAAAAAAAAAAAAAAAAAAAAAAAAAAAAAAAAAAAAAAAAAAAAAAAAAAAAAAAAAAAAAA/AAAAAAAAAKCGAQAAAAAAAAAAAAAAAAAMAAAAAQAAAAAAAAAAAAAAAAAAAB8AAABUAAAAu+DjBf///wEAAAAAAAAAAAAAAAAAAAAAAAAAAAAAAAAAAAAAAAAAAAAAAAJ/f38AgICAA8zMzADAwP8Af39/AAAAAAAAAAAAAAAAAAAAAAAAAAAAIQAAABgAAAAUAAAABSYAAPYQAAAFJgAAWxQAAAAAAAAmAAAACAAAAP//////////"/>
+                <pr:smNativeData xmlns:pr="smNativeData" xmlns="smNativeData" val="SMDATA_15_7aDWaRMAAAAlAAAADgAAAA8BAAAAkAAAAEgAAACQAAAASAAAAAAAAAAAAAAAAAAAAAEAAABQAAAA9uN+f2jSSb8AAAAAAADgPwAAAAAAAOA/AAAAAAAA4D8AAAAAAADgPwAAAAAAAOA/AAAAAAAA4D8AAAAAAADgPwAAAAAAAOA/AAAAAAAA4D8CAAAAjAAAAAAAAAAAAAAAu+DjDP///wgAAAAAAAAAAAAAAAAAAAAAAAAAAAAAAAAAAAAAZAAAAAEAAABAAAAAAAAAAAAAAAAAAAAAAAAAAAAAAAAAAAAAAAAAAAAAAAAAAAAAAAAAAAAAAAAAAAAAAAAAAAAAAAAAAAAAAAAAAAAAAAAAAAAAAAAAAAAAAAAAAAAAFAAAADwAAAABAAAAAAAAAAAAAAkUAAAAAQAAABQAAAAUAAAAFAAAAAEAAAAAAAAAZAAAAGQAAAABAAAAlgAAAJYAAAAVAAAAYAAAAAAAAAAAAAAADwAAACADAAAAAAAAAAAAAAEAAACgMgAAVgcAAKr4//8BAAAAf39/AAEAAABkAAAAAAAAABQAAABAHwAAAAAAACYAAAAAAAAAwOD//wAAAAAmAAAAZAAAABYAAABMAAAAAAAAAAAAAAAEAAAAAAAAAAEAAACAgIAKAAAAACgAAAAoAAAAZAAAAGQAAAAAAAAAzMzMAAAAAABQAAAAUAAAAGQAAABkAAAAAAAAABcAAAAUAAAAAAAAAAAAAAD/fwAA/38AAAAAAAAJAAAABAAAAAIAAAAeAAAAaAAAAAAAAAAAAAAAAAAAAAAAAAAAAAAAECcAABAnAAAAAAAAAAAAAAAAAAAAAAAAAAAAAAAAAAAAAAAAAAAAABQAAAAAAAAAwMD/AAAAAABkAAAAMgAAAAAAAABkAAAAAAAAAH9/fwAKAAAAIgAAABgAAAAAAAAAAAAAAAAAAAAAAAAAAAAAAAAAAAAkAAAAJAAAAAAAAAAHAAAAAAAAAAAAAAAAAAAAAAAAAAAAAAAAAAAAf39/ACUAAABYAAAAAAAAAAAAAAAAAAAAAAAAAAAAAAAAAAAAAAAAAAAAAAAAAAAAAAAAAAAAAAA/AAAAAAAAAKCGAQAAAAAAAAAAAAAAAAAMAAAAAQAAAAAAAAAAAAAAAAAAAB8AAABUAAAAu+DjBf///wEAAAAAAAAAAAAAAAAAAAAAAAAAAAAAAAAAAAAAAAAAAAAAAAJ/f38AgICAA8zMzADAwP8Af39/AAAAAAAAAAAAAAAAAAAAAAAAAAAAIQAAABgAAAAUAAAABCYAAPYQAAAEJgAAWxQAABAAAAAmAAAACAAAAP//////////"/>
               </a:ext>
             </a:extLst>
           </p:cNvCxnSpPr>
@@ -5477,7 +5389,7 @@
         </p:nvCxnSpPr>
         <p:spPr>
           <a:xfrm rot="16200000" flipH="1">
-            <a:off x="5904865" y="3032760"/>
+            <a:off x="5904230" y="3032760"/>
             <a:ext cx="551815" cy="12700"/>
           </a:xfrm>
           <a:prstGeom prst="bentConnector2">
@@ -5503,7 +5415,7 @@
             <a:endCxn id="10" idx="1"/>
             <a:extLst>
               <a:ext uri="smNativeData">
-                <pr:smNativeData xmlns:pr="smNativeData" xmlns="smNativeData" val="SMDATA_15_AnHWaRMAAAAlAAAADgAAAA8BAAAAkAAAAEgAAACQAAAASAAAAAAAAAAAAAAAAAAAAAEAAABQAAAAAAAAAAAAAAAAAAAAAADgPwAAAAAAAOA/AAAAAAAA4D8AAAAAAADgPwAAAAAAAOA/AAAAAAAA4D8AAAAAAADgPwAAAAAAAOA/AAAAAAAA4D8CAAAAjAAAAAAAAAAAAAAAu+DjDP///wgAAAAAAAAAAAAAAAAAAAAAAAAAAAAAAAAAAAAAZAAAAAEAAABAAAAAAAAAAAAAAAAAAAAAAAAAAAAAAAAAAAAAAAAAAAAAAAAAAAAAAAAAAAAAAAAAAAAAAAAAAAAAAAAAAAAAAAAAAAAAAAAAAAAAAAAAAAAAAAAAAAAAFAAAADwAAAABAAAAAAAAAAAAAAkUAAAAAQAAABQAAAAUAAAAFAAAAAEAAAAAAAAAZAAAAGQAAAABAAAAlgAAAJYAAAAVAAAAYAAAAAAAAAAAAAAADwAAACADAAAAAAAAAAAAAAEAAACgMgAAVgcAAKr4//8BAAAAf39/AAEAAABkAAAAAAAAABQAAABAHwAAAAAAACYAAAAAAAAAwOD//wAAAAAmAAAAZAAAABYAAABMAAAAAAAAAAAAAAAEAAAAAAAAAAEAAACAgIAKAAAAACgAAAAoAAAAZAAAAGQAAAAAAAAAzMzMAAAAAABQAAAAUAAAAGQAAABkAAAAAAAAABcAAAAUAAAAAAAAAAAAAAD/fwAA/38AAAAAAAAJAAAABAAAAAsAAAAeAAAAaAAAAAAAAAAAAAAAAAAAAAAAAAAAAAAAECcAABAnAAAAAAAAAAAAAAAAAAAAAAAAAAAAAAAAAAAAAAAAAAAAABQAAAAAAAAAwMD/AAAAAABkAAAAMgAAAAAAAABkAAAAAAAAAH9/fwAKAAAAIgAAABgAAAAAAAAAAAAAAAAAAAAAAAAAAAAAAAAAAAAkAAAAJAAAAAAAAAAHAAAAAAAAAAAAAAAAAAAAAAAAAAAAAAAAAAAAf39/ACUAAABYAAAAAAAAAAAAAAAAAAAAAAAAAAAAAAAAAAAAAAAAAAAAAAAAAAAAAAAAAAAAAAA/AAAAAAAAAKCGAQAAAAAAAAAAAAAAAAAMAAAAAQAAAAAAAAAAAAAAAAAAAB8AAABUAAAAu+DjBf///wEAAAAAAAAAAAAAAAAAAAAAAAAAAAAAAAAAAAAAAAAAAAAAAAJ/f38AgICAA8zMzADAwP8Af39/AAAAAAAAAAAAAAAAAAAAAAAAAAAAIQAAABgAAAAUAAAAGCsAABAQAACAMgAAWBYAAAAAAAAmAAAACAAAAP//////////"/>
+                <pr:smNativeData xmlns:pr="smNativeData" xmlns="smNativeData" val="SMDATA_15_7aDWaRMAAAAlAAAADgAAAA8BAAAAkAAAAEgAAACQAAAASAAAAAAAAAAAAAAAAAAAAAEAAABQAAAAAAAAAAAAAAAAAAAAAADgPwAAAAAAAOA/AAAAAAAA4D8AAAAAAADgPwAAAAAAAOA/AAAAAAAA4D8AAAAAAADgPwAAAAAAAOA/AAAAAAAA4D8CAAAAjAAAAAAAAAAAAAAAu+DjDP///wgAAAAAAAAAAAAAAAAAAAAAAAAAAAAAAAAAAAAAZAAAAAEAAABAAAAAAAAAAAAAAAAAAAAAAAAAAAAAAAAAAAAAAAAAAAAAAAAAAAAAAAAAAAAAAAAAAAAAAAAAAAAAAAAAAAAAAAAAAAAAAAAAAAAAAAAAAAAAAAAAAAAAFAAAADwAAAABAAAAAAAAAAAAAAkUAAAAAQAAABQAAAAUAAAAFAAAAAEAAAAAAAAAZAAAAGQAAAABAAAAlgAAAJYAAAAVAAAAYAAAAAAAAAAAAAAADwAAACADAAAAAAAAAAAAAAEAAACgMgAAVgcAAKr4//8BAAAAf39/AAEAAABkAAAAAAAAABQAAABAHwAAAAAAACYAAAAAAAAAwOD//wAAAAAmAAAAZAAAABYAAABMAAAAAAAAAAAAAAAEAAAAAAAAAAEAAACAgIAKAAAAACgAAAAoAAAAZAAAAGQAAAAAAAAAzMzMAAAAAABQAAAAUAAAAGQAAABkAAAAAAAAABcAAAAUAAAAAAAAAAAAAAD/fwAA/38AAAAAAAAJAAAABAAAAAsAAAAeAAAAaAAAAAAAAAAAAAAAAAAAAAAAAAAAAAAAECcAABAnAAAAAAAAAAAAAAAAAAAAAAAAAAAAAAAAAAAAAAAAAAAAABQAAAAAAAAAwMD/AAAAAABkAAAAMgAAAAAAAABkAAAAAAAAAH9/fwAKAAAAIgAAABgAAAAAAAAAAAAAAAAAAAAAAAAAAAAAAAAAAAAkAAAAJAAAAAAAAAAHAAAAAAAAAAAAAAAAAAAAAAAAAAAAAAAAAAAAf39/ACUAAABYAAAAAAAAAAAAAAAAAAAAAAAAAAAAAAAAAAAAAAAAAAAAAAAAAAAAAAAAAAAAAAA/AAAAAAAAAKCGAQAAAAAAAAAAAAAAAAAMAAAAAQAAAAAAAAAAAAAAAAAAAB8AAABUAAAAu+DjBf///wEAAAAAAAAAAAAAAAAAAAAAAAAAAAAAAAAAAAAAAAAAAAAAAAJ/f38AgICAA8zMzADAwP8Af39/AAAAAAAAAAAAAAAAAAAAAAAAAAAAIQAAABgAAAAUAAAAGCsAABAQAACAMgAAWBYAABAAAAAmAAAACAAAAP//////////"/>
               </a:ext>
             </a:extLst>
           </p:cNvCxnSpPr>
@@ -5539,7 +5451,7 @@
             <a:endCxn id="8" idx="1"/>
             <a:extLst>
               <a:ext uri="smNativeData">
-                <pr:smNativeData xmlns:pr="smNativeData" xmlns="smNativeData" val="SMDATA_15_AnHWaRMAAAAlAAAADgAAAA8BAAAAkAAAAEgAAACQAAAASAAAAAAAAAAAAAAAAAAAAAEAAABQAAAA+cV9/AlGQb8AAAAAAADgPwAAAAAAAOA/AAAAAAAA4D8AAAAAAADgPwAAAAAAAOA/AAAAAAAA4D8AAAAAAADgPwAAAAAAAOA/AAAAAAAA4D8CAAAAjAAAAAAAAAAAAAAAu+DjDP///wgAAAAAAAAAAAAAAAAAAAAAAAAAAAAAAAAAAAAAZAAAAAEAAABAAAAAAAAAAAAAAAAAAAAAAAAAAAAAAAAAAAAAAAAAAAAAAAAAAAAAAAAAAAAAAAAAAAAAAAAAAAAAAAAAAAAAAAAAAAAAAAAAAAAAAAAAAAAAAAAAAAAAFAAAADwAAAABAAAAAAAAAAAAAAkUAAAAAQAAABQAAAAUAAAAFAAAAAEAAAAAAAAAZAAAAGQAAAABAAAAlgAAAJYAAAAVAAAAYAAAAAAAAAAAAAAADwAAACADAAAAAAAAAAAAAAEAAACgMgAAVgcAAKr4//8BAAAAf39/AAEAAABkAAAAAAAAABQAAABAHwAAAAAAACYAAAAAAAAAwOD//wAAAAAmAAAAZAAAABYAAABMAAAAAAAAAAAAAAAEAAAAAAAAAAEAAACAgIAKAAAAACgAAAAoAAAAZAAAAGQAAAAAAAAAzMzMAAAAAABQAAAAUAAAAGQAAABkAAAAAAAAABcAAAAUAAAAAAAAAAAAAAD/fwAA/38AAAAAAAAJAAAABAAAAAAAAAAeAAAAaAAAAAAAAAAAAAAAAAAAAAAAAAAAAAAAECcAABAnAAAAAAAAAAAAAAAAAAAAAAAAAAAAAAAAAAAAAAAAAAAAABQAAAAAAAAAwMD/AAAAAABkAAAAMgAAAAAAAABkAAAAAAAAAH9/fwAKAAAAIgAAABgAAAAAAAAAAAAAAAAAAAAAAAAAAAAAAAAAAAAkAAAAJAAAAAAAAAAHAAAAAAAAAAAAAAAAAAAAAAAAAAAAAAAAAAAAf39/ACUAAABYAAAAAAAAAAAAAAAAAAAAAAAAAAAAAAAAAAAAAAAAAAAAAAAAAAAAAAAAAAAAAAA/AAAAAAAAAKCGAQAAAAAAAAAAAAAAAAAMAAAAAQAAAAAAAAAAAAAAAAAAAB8AAABUAAAAu+DjBf///wEAAAAAAAAAAAAAAAAAAAAAAAAAAAAAAAAAAAAAAAAAAAAAAAJ/f38AgICAA8zMzADAwP8Af39/AAAAAAAAAAAAAAAAAAAAAAAAAAAAIQAAABgAAAAUAAAAGCsAAHEJAACBMgAAWBYAAAAAAAAmAAAACAAAAP//////////"/>
+                <pr:smNativeData xmlns:pr="smNativeData" xmlns="smNativeData" val="SMDATA_15_7aDWaRMAAAAlAAAADgAAAA8BAAAAkAAAAEgAAACQAAAASAAAAAAAAAAAAAAAAAAAAAEAAABQAAAA+cV9/AlGQb8AAAAAAADgPwAAAAAAAOA/AAAAAAAA4D8AAAAAAADgPwAAAAAAAOA/AAAAAAAA4D8AAAAAAADgPwAAAAAAAOA/AAAAAAAA4D8CAAAAjAAAAAAAAAAAAAAAu+DjDP///wgAAAAAAAAAAAAAAAAAAAAAAAAAAAAAAAAAAAAAZAAAAAEAAABAAAAAAAAAAAAAAAAAAAAAAAAAAAAAAAAAAAAAAAAAAAAAAAAAAAAAAAAAAAAAAAAAAAAAAAAAAAAAAAAAAAAAAAAAAAAAAAAAAAAAAAAAAAAAAAAAAAAAFAAAADwAAAABAAAAAAAAAAAAAAkUAAAAAQAAABQAAAAUAAAAFAAAAAEAAAAAAAAAZAAAAGQAAAABAAAAlgAAAJYAAAAVAAAAYAAAAAAAAAAAAAAADwAAACADAAAAAAAAAAAAAAEAAACgMgAAVgcAAKr4//8BAAAAf39/AAEAAABkAAAAAAAAABQAAABAHwAAAAAAACYAAAAAAAAAwOD//wAAAAAmAAAAZAAAABYAAABMAAAAAAAAAAAAAAAEAAAAAAAAAAEAAACAgIAKAAAAACgAAAAoAAAAZAAAAGQAAAAAAAAAzMzMAAAAAABQAAAAUAAAAGQAAABkAAAAAAAAABcAAAAUAAAAAAAAAAAAAAD/fwAA/38AAAAAAAAJAAAABAAAAAAAAAAeAAAAaAAAAAAAAAAAAAAAAAAAAAAAAAAAAAAAECcAABAnAAAAAAAAAAAAAAAAAAAAAAAAAAAAAAAAAAAAAAAAAAAAABQAAAAAAAAAwMD/AAAAAABkAAAAMgAAAAAAAABkAAAAAAAAAH9/fwAKAAAAIgAAABgAAAAAAAAAAAAAAAAAAAAAAAAAAAAAAAAAAAAkAAAAJAAAAAAAAAAHAAAAAAAAAAAAAAAAAAAAAAAAAAAAAAAAAAAAf39/ACUAAABYAAAAAAAAAAAAAAAAAAAAAAAAAAAAAAAAAAAAAAAAAAAAAAAAAAAAAAAAAAAAAAA/AAAAAAAAAKCGAQAAAAAAAAAAAAAAAAAMAAAAAQAAAAAAAAAAAAAAAAAAAB8AAABUAAAAu+DjBf///wEAAAAAAAAAAAAAAAAAAAAAAAAAAAAAAAAAAAAAAAAAAAAAAAJ/f38AgICAA8zMzADAwP8Af39/AAAAAAAAAAAAAAAAAAAAAAAAAAAAIQAAABgAAAAUAAAAGCsAAHEJAACBMgAAWBYAABAAAAAmAAAACAAAAP//////////"/>
               </a:ext>
             </a:extLst>
           </p:cNvCxnSpPr>
@@ -5575,7 +5487,7 @@
             <a:endCxn id="9" idx="2"/>
             <a:extLst>
               <a:ext uri="smNativeData">
-                <pr:smNativeData xmlns:pr="smNativeData" xmlns="smNativeData" val="SMDATA_15_AnHWaRMAAAAlAAAADgAAAA8BAAAAkAAAAEgAAACQAAAASAAAAAAAAAAAAAAAAAAAAAEAAABQAAAAk5SHCfa4Wz8AAAAAAADgPwAAAAAAAOA/AAAAAAAA4D8AAAAAAADgPwAAAAAAAOA/AAAAAAAA4D8AAAAAAADgPwAAAAAAAOA/AAAAAAAA4D8CAAAAjAAAAAAAAAAAAAAAu+DjDP///wgAAAAAAAAAAAAAAAAAAAAAAAAAAAAAAAAAAAAAZAAAAAEAAABAAAAAAAAAAAAAAAAAAAAAAAAAAAAAAAAAAAAAAAAAAAAAAAAAAAAAAAAAAAAAAAAAAAAAAAAAAAAAAAAAAAAAAAAAAAAAAAAAAAAAAAAAAAAAAAAAAAAAFAAAADwAAAABAAAAAAAAAAAAAAkUAAAAAQAAABQAAAAUAAAAFAAAAAEAAAAAAAAAZAAAAGQAAAABAAAAlgAAAJYAAAAVAAAAYAAAAAAAAAAAAAAADwAAACADAAAAAAAAAAAAAAEAAACgMgAAVgcAAKr4//8BAAAAf39/AAEAAABkAAAAAAAAABQAAABAHwAAAAAAACYAAAAAAAAAwOD//wAAAAAmAAAAZAAAABYAAABMAAAAAAAAAAAAAAAEAAAAAAAAAAEAAACAgIAKAAAAACgAAAAoAAAAZAAAAGQAAAAAAAAAzMzMAAAAAABQAAAAUAAAAGQAAABkAAAAAAAAABcAAAAUAAAAAAAAAAAAAAD/fwAA/38AAAAAAAAJAAAABAAAAAAAAAAeAAAAaAAAAAAAAAAAAAAAAAAAAAAAAAAAAAAAECcAABAnAAAAAAAAAAAAAAAAAAAAAAAAAAAAAAAAAAAAAAAAAAAAABQAAAAAAAAAwMD/AAAAAABkAAAAMgAAAAAAAABkAAAAAAAAAH9/fwAKAAAAIgAAABgAAAAAAAAAAAAAAAAAAAAAAAAAAAAAAAAAAAAkAAAAJAAAAAAAAAAHAAAAAAAAAAAAAAAAAAAAAAAAAAAAAAAAAAAAf39/ACUAAABYAAAAAAAAAAAAAAAAAAAAAAAAAAAAAAAAAAAAAAAAAAAAAAAAAAAAAAAAAAAAAAA/AAAAAAAAAKCGAQAAAAAAAAAAAAAAAAAMAAAAAQAAAAAAAAAAAAAAAAAAAB8AAABUAAAAu+DjBf///wEAAAAAAAAAAAAAAAAAAAAAAAAAAAAAAAAAAAAAAAAAAAAAAAJ/f38AgICAA8zMzADAwP8Af39/AAAAAAAAAAAAAAAAAAAAAAAAAAAAIQAAABgAAAAUAAAAsTYAAJYFAACzNgAA5QcAAAAAAAAmAAAACAAAAP//////////"/>
+                <pr:smNativeData xmlns:pr="smNativeData" xmlns="smNativeData" val="SMDATA_15_7aDWaRMAAAAlAAAADgAAAA8BAAAAkAAAAEgAAACQAAAASAAAAAAAAAAAAAAAAAAAAAEAAABQAAAAk5SHCfa4Wz8AAAAAAADgPwAAAAAAAOA/AAAAAAAA4D8AAAAAAADgPwAAAAAAAOA/AAAAAAAA4D8AAAAAAADgPwAAAAAAAOA/AAAAAAAA4D8CAAAAjAAAAAAAAAAAAAAAu+DjDP///wgAAAAAAAAAAAAAAAAAAAAAAAAAAAAAAAAAAAAAZAAAAAEAAABAAAAAAAAAAAAAAAAAAAAAAAAAAAAAAAAAAAAAAAAAAAAAAAAAAAAAAAAAAAAAAAAAAAAAAAAAAAAAAAAAAAAAAAAAAAAAAAAAAAAAAAAAAAAAAAAAAAAAFAAAADwAAAABAAAAAAAAAAAAAAkUAAAAAQAAABQAAAAUAAAAFAAAAAEAAAAAAAAAZAAAAGQAAAABAAAAlgAAAJYAAAAVAAAAYAAAAAAAAAAAAAAADwAAACADAAAAAAAAAAAAAAEAAACgMgAAVgcAAKr4//8BAAAAf39/AAEAAABkAAAAAAAAABQAAABAHwAAAAAAACYAAAAAAAAAwOD//wAAAAAmAAAAZAAAABYAAABMAAAAAAAAAAAAAAAEAAAAAAAAAAEAAACAgIAKAAAAACgAAAAoAAAAZAAAAGQAAAAAAAAAzMzMAAAAAABQAAAAUAAAAGQAAABkAAAAAAAAABcAAAAUAAAAAAAAAAAAAAD/fwAA/38AAAAAAAAJAAAABAAAAAAAAAAeAAAAaAAAAAAAAAAAAAAAAAAAAAAAAAAAAAAAECcAABAnAAAAAAAAAAAAAAAAAAAAAAAAAAAAAAAAAAAAAAAAAAAAABQAAAAAAAAAwMD/AAAAAABkAAAAMgAAAAAAAABkAAAAAAAAAH9/fwAKAAAAIgAAABgAAAAAAAAAAAAAAAAAAAAAAAAAAAAAAAAAAAAkAAAAJAAAAAAAAAAHAAAAAAAAAAAAAAAAAAAAAAAAAAAAAAAAAAAAf39/ACUAAABYAAAAAAAAAAAAAAAAAAAAAAAAAAAAAAAAAAAAAAAAAAAAAAAAAAAAAAAAAAAAAAA/AAAAAAAAAKCGAQAAAAAAAAAAAAAAAAAMAAAAAQAAAAAAAAAAAAAAAAAAAB8AAABUAAAAu+DjBf///wEAAAAAAAAAAAAAAAAAAAAAAAAAAAAAAAAAAAAAAAAAAAAAAAJ/f38AgICAA8zMzADAwP8Af39/AAAAAAAAAAAAAAAAAAAAAAAAAAAAIQAAABgAAAAUAAAAsTYAAJYFAACzNgAA5QcAABAAAAAmAAAACAAAAP//////////"/>
               </a:ext>
             </a:extLst>
           </p:cNvCxnSpPr>
@@ -5611,7 +5523,7 @@
             <a:endCxn id="6" idx="2"/>
             <a:extLst>
               <a:ext uri="smNativeData">
-                <pr:smNativeData xmlns:pr="smNativeData" xmlns="smNativeData" val="SMDATA_15_AnHWaRMAAAAlAAAADgAAAA8BAAAAkAAAAEgAAACQAAAASAAAAAAAAAAAAAAAAAAAAAEAAABQAAAAhLEZLP23+7sAAAAAAADgPwAAAAAAAOA/AAAAAAAA4D8AAAAAAADgPwAAAAAAAOA/AAAAAAAA4D8AAAAAAADgPwAAAAAAAOA/AAAAAAAA4D8CAAAAjAAAAAAAAAAAAAAAu+DjDP///wgAAAAAAAAAAAAAAAAAAAAAAAAAAAAAAAAAAAAAZAAAAAEAAABAAAAAAAAAAAAAAAAAAAAAAAAAAAAAAAAAAAAAAAAAAAAAAAAAAAAAAAAAAAAAAAAAAAAAAAAAAAAAAAAAAAAAAAAAAAAAAAAAAAAAAAAAAAAAAAAAAAAAFAAAADwAAAABAAAAAAAAAAAAAAkUAAAAAQAAABQAAAAUAAAAFAAAAAEAAAAAAAAAZAAAAGQAAAABAAAAlgAAAJYAAAAVAAAAYAAAAAAAAAAAAAAADwAAACADAAAAAAAAAAAAAAEAAACgMgAAVgcAAKr4//8BAAAAf39/AAEAAABkAAAAAAAAABQAAABAHwAAAAAAACYAAAAAAAAAwOD//wAAAAAmAAAAZAAAABYAAABMAAAAAAAAAAAAAAAEAAAAAAAAAAEAAACAgIAKAAAAACgAAAAoAAAAZAAAAGQAAAAAAAAAzMzMAAAAAABQAAAAUAAAAGQAAABkAAAAAAAAABcAAAAUAAAAAAAAAAAAAAD/fwAA/38AAAAAAAAJAAAABAAAAJYAAAAeAAAAaAAAAAAAAAAAAAAAAAAAAAAAAAAAAAAAECcAABAnAAAAAAAAAAAAAAAAAAAAAAAAAAAAAAAAAAAAAAAAAAAAABQAAAAAAAAAwMD/AAAAAABkAAAAMgAAAAAAAABkAAAAAAAAAH9/fwAKAAAAIgAAABgAAAAAAAAAAAAAAAAAAAAAAAAAAAAAAAAAAAAkAAAAJAAAAAAAAAAHAAAAAAAAAAAAAAAAAAAAAAAAAAAAAAAAAAAAf39/ACUAAABYAAAAAAAAAAAAAAAAAAAAAAAAAAAAAAAAAAAAAAAAAAAAAAAAAAAAAAAAAAAAAAA/AAAAAAAAAKCGAQAAAAAAAAAAAAAAAAAMAAAAAQAAAAAAAAAAAAAAAAAAAB8AAABUAAAAu+DjBf///wEAAAAAAAAAAAAAAAAAAAAAAAAAAAAAAAAAAAAAAAAAAAAAAAJ/f38AgICAA8zMzADAwP8Af39/AAAAAAAAAAAAAAAAAAAAAAAAAAAAIQAAABgAAAAUAAAABSYAAHEKAAAGJgAA/QwAAAAAAAAmAAAACAAAAP//////////"/>
+                <pr:smNativeData xmlns:pr="smNativeData" xmlns="smNativeData" val="SMDATA_15_7aDWaRMAAAAlAAAADgAAAA8BAAAAkAAAAEgAAACQAAAASAAAAAAAAAAAAAAAAAAAAAEAAABQAAAAhLEZLP23+7sAAAAAAADgPwAAAAAAAOA/AAAAAAAA4D8AAAAAAADgPwAAAAAAAOA/AAAAAAAA4D8AAAAAAADgPwAAAAAAAOA/AAAAAAAA4D8CAAAAjAAAAAAAAAAAAAAAu+DjDP///wgAAAAAAAAAAAAAAAAAAAAAAAAAAAAAAAAAAAAAZAAAAAEAAABAAAAAAAAAAAAAAAAAAAAAAAAAAAAAAAAAAAAAAAAAAAAAAAAAAAAAAAAAAAAAAAAAAAAAAAAAAAAAAAAAAAAAAAAAAAAAAAAAAAAAAAAAAAAAAAAAAAAAFAAAADwAAAABAAAAAAAAAAAAAAkUAAAAAQAAABQAAAAUAAAAFAAAAAEAAAAAAAAAZAAAAGQAAAABAAAAlgAAAJYAAAAVAAAAYAAAAAAAAAAAAAAADwAAACADAAAAAAAAAAAAAAEAAACgMgAAVgcAAKr4//8BAAAAf39/AAEAAABkAAAAAAAAABQAAABAHwAAAAAAACYAAAAAAAAAwOD//wAAAAAmAAAAZAAAABYAAABMAAAAAAAAAAAAAAAEAAAAAAAAAAEAAACAgIAKAAAAACgAAAAoAAAAZAAAAGQAAAAAAAAAzMzMAAAAAABQAAAAUAAAAGQAAABkAAAAAAAAABcAAAAUAAAAAAAAAAAAAAD/fwAA/38AAAAAAAAJAAAABAAAAJYAAAAeAAAAaAAAAAAAAAAAAAAAAAAAAAAAAAAAAAAAECcAABAnAAAAAAAAAAAAAAAAAAAAAAAAAAAAAAAAAAAAAAAAAAAAABQAAAAAAAAAwMD/AAAAAABkAAAAMgAAAAAAAABkAAAAAAAAAH9/fwAKAAAAIgAAABgAAAAAAAAAAAAAAAAAAAAAAAAAAAAAAAAAAAAkAAAAJAAAAAAAAAAHAAAAAAAAAAAAAAAAAAAAAAAAAAAAAAAAAAAAf39/ACUAAABYAAAAAAAAAAAAAAAAAAAAAAAAAAAAAAAAAAAAAAAAAAAAAAAAAAAAAAAAAAAAAAA/AAAAAAAAAKCGAQAAAAAAAAAAAAAAAAAMAAAAAQAAAAAAAAAAAAAAAAAAAB8AAABUAAAAu+DjBf///wEAAAAAAAAAAAAAAAAAAAAAAAAAAAAAAAAAAAAAAAAAAAAAAAJ/f38AgICAA8zMzADAwP8Af39/AAAAAAAAAAAAAAAAAAAAAAAAAAAAIQAAABgAAAAUAAAABCYAAHEKAAAGJgAA/QwAABAAAAAmAAAACAAAAP//////////"/>
               </a:ext>
             </a:extLst>
           </p:cNvCxnSpPr>
@@ -5619,8 +5531,8 @@
         </p:nvCxnSpPr>
         <p:spPr>
           <a:xfrm rot="16200000">
-            <a:off x="5974080" y="1903730"/>
-            <a:ext cx="414020" cy="635"/>
+            <a:off x="5973445" y="1903730"/>
+            <a:ext cx="414020" cy="1270"/>
           </a:xfrm>
           <a:prstGeom prst="bentConnector3">
             <a:avLst>
@@ -5647,7 +5559,7 @@
             <a:endCxn id="4" idx="3"/>
             <a:extLst>
               <a:ext uri="smNativeData">
-                <pr:smNativeData xmlns:pr="smNativeData" xmlns="smNativeData" val="SMDATA_15_AnHWaRMAAAAlAAAADwAAAA8BAAAAkAAAAEgAAACQAAAASAAAAAAAAAAAAAAAAAAAAAEAAABQAAAAXqfsgsWR3L8rL7VBsjQCQAAAAAAAAOA/AAAAAAAA4D8AAAAAAADgPwAAAAAAAOA/AAAAAAAA4D8AAAAAAADgPwAAAAAAAOA/AAAAAAAA4D8CAAAAjAAAAAAAAAAAAAAAu+DjDP///wgAAAAAAAAAAAAAAAAAAAAAAAAAAAAAAAAAAAAAZAAAAAEAAABAAAAAAAAAAAAAAAAAAAAAAAAAAAAAAAAAAAAAAAAAAAAAAAAAAAAAAAAAAAAAAAAAAAAAAAAAAAAAAAAAAAAAAAAAAAAAAAAAAAAAAAAAAAAAAAAAAAAAFAAAADwAAAABAAAAAgAAAAAAAAkUAAAAAQAAABQAAAAUAAAAFAAAAAEAAAAAAAAAZAAAAGQAAAABAAAAlgAAAJYAAAAVAAAAYAAAAAAAAAAAAAAADwAAACADAAAAAAAAAAAAAAEAAACgMgAAVgcAAKr4//8BAAAAf39/AAEAAABkAAAAAAAAABQAAABAHwAAAAAAACYAAAAAAAAAwOD//wAAAAAmAAAAZAAAABYAAABMAAAAAAAAAAAAAAAEAAAAAAAAAAEAAACAgIAKAAAAACgAAAAoAAAAZAAAAGQAAAAAAAAAzMzMAAAAAABQAAAAUAAAAGQAAABkAAAAAAAAABcAAAAUAAAAAAAAAAAAAAD/fwAA/38AAAAAAAAJAAAABAAAAAsAAAAeAAAAaAAAAAAAAAAAAAAAAAAAAAAAAAAAAAAAECcAABAnAAAAAAAAAAAAAAAAAAAAAAAAAAAAAAAAAAAAAAAAAAAAABQAAAAAAAAAwMD/AAAAAABkAAAAMgAAAAAAAABkAAAAAAAAAH9/fwAKAAAAIgAAABgAAAAAAAAAAAAAAAAAAAAAAAAAAAAAAAAAAAAkAAAAJAAAAAAAAAAHAAAAAAAAAAAAAAAAAAAAAAAAAAAAAAAAAAAAf39/ACUAAABYAAAAAAAAAAAAAAAAAAAAAAAAAAAAAAAAAAAAAAAAAAAAAAAAAAAAAAAAAAAAAAA/AAAAAAAAAKCGAQAAAAAAAAAAAAAAAAAMAAAAAQAAAAAAAAAAAAAAAAAAAB8AAABUAAAAu+DjBf///wEAAAAAAAAAAAAAAAAAAAAAAAAAAAAAAAAAAAAAAAAAAAAAAAJ/f38AgICAA8zMzADAwP8Af39/AAAAAAAAAAAAAAAAAAAAAAAAAAAAIQAAABgAAAAUAAAAVhgAAI8IAABpGwAAAQ0AAAAAAAAmAAAACAAAAP//////////"/>
+                <pr:smNativeData xmlns:pr="smNativeData" xmlns="smNativeData" val="SMDATA_15_7aDWaRMAAAAlAAAADwAAAA8BAAAAkAAAAEgAAACQAAAASAAAAAAAAAAAAAAAAAAAAAEAAABQAAAAXqfsgsWR3L8rL7VBsjQCQAAAAAAAAOA/AAAAAAAA4D8AAAAAAADgPwAAAAAAAOA/AAAAAAAA4D8AAAAAAADgPwAAAAAAAOA/AAAAAAAA4D8CAAAAjAAAAAAAAAAAAAAAu+DjDP///wgAAAAAAAAAAAAAAAAAAAAAAAAAAAAAAAAAAAAAZAAAAAEAAABAAAAAAAAAAAAAAAAAAAAAAAAAAAAAAAAAAAAAAAAAAAAAAAAAAAAAAAAAAAAAAAAAAAAAAAAAAAAAAAAAAAAAAAAAAAAAAAAAAAAAAAAAAAAAAAAAAAAAFAAAADwAAAABAAAAAgAAAAAAAAkUAAAAAQAAABQAAAAUAAAAFAAAAAEAAAAAAAAAZAAAAGQAAAABAAAAlgAAAJYAAAAVAAAAYAAAAAAAAAAAAAAADwAAACADAAAAAAAAAAAAAAEAAACgMgAAVgcAAKr4//8BAAAAf39/AAEAAABkAAAAAAAAABQAAABAHwAAAAAAACYAAAAAAAAAwOD//wAAAAAmAAAAZAAAABYAAABMAAAAAAAAAAAAAAAEAAAAAAAAAAEAAACAgIAKAAAAACgAAAAoAAAAZAAAAGQAAAAAAAAAzMzMAAAAAABQAAAAUAAAAGQAAABkAAAAAAAAABcAAAAUAAAAAAAAAAAAAAD/fwAA/38AAAAAAAAJAAAABAAAAAsAAAAeAAAAaAAAAAAAAAAAAAAAAAAAAAAAAAAAAAAAECcAABAnAAAAAAAAAAAAAAAAAAAAAAAAAAAAAAAAAAAAAAAAAAAAABQAAAAAAAAAwMD/AAAAAABkAAAAMgAAAAAAAABkAAAAAAAAAH9/fwAKAAAAIgAAABgAAAAAAAAAAAAAAAAAAAAAAAAAAAAAAAAAAAAkAAAAJAAAAAAAAAAHAAAAAAAAAAAAAAAAAAAAAAAAAAAAAAAAAAAAf39/ACUAAABYAAAAAAAAAAAAAAAAAAAAAAAAAAAAAAAAAAAAAAAAAAAAAAAAAAAAAAAAAAAAAAA/AAAAAAAAAKCGAQAAAAAAAAAAAAAAAAAMAAAAAQAAAAAAAAAAAAAAAAAAAB8AAABUAAAAu+DjBf///wEAAAAAAAAAAAAAAAAAAAAAAAAAAAAAAAAAAAAAAAAAAAAAAAJ/f38AgICAA8zMzADAwP8Af39/AAAAAAAAAAAAAAAAAAAAAAAAAAAAIQAAABgAAAAUAAAAVhgAAI8IAABpGwAAAQ0AABAAAAAmAAAACAAAAP//////////"/>
               </a:ext>
             </a:extLst>
           </p:cNvCxnSpPr>
@@ -5684,7 +5596,7 @@
             <a:endCxn id="6" idx="3"/>
             <a:extLst>
               <a:ext uri="smNativeData">
-                <pr:smNativeData xmlns:pr="smNativeData" xmlns="smNativeData" val="SMDATA_15_AnHWaRMAAAAlAAAADwAAAA8BAAAAkAAAAEgAAACQAAAASAAAAAAAAAAAAAAAAAAAAAEAAABQAAAA/nDA4w8H3L+9RGVK8ZP9PwAAAAAAAOA/AAAAAAAA4D8AAAAAAADgPwAAAAAAAOA/AAAAAAAA4D8AAAAAAADgPwAAAAAAAOA/AAAAAAAA4D8CAAAAjAAAAAAAAAAAAAAAu+DjDP///wgAAAAAAAAAAAAAAAAAAAAAAAAAAAAAAAAAAAAAZAAAAAEAAABAAAAAAAAAAAAAAAAAAAAAAAAAAAAAAAAAAAAAAAAAAAAAAAAAAAAAAAAAAAAAAAAAAAAAAAAAAAAAAAAAAAAAAAAAAAAAAAAAAAAAAAAAAAAAAAAAAAAAFAAAADwAAAABAAAAAgAAAAAAAAkUAAAAAQAAABQAAAAUAAAAFAAAAAEAAAAAAAAAZAAAAGQAAAABAAAAlgAAAJYAAAAVAAAAYAAAAAAAAAAAAAAADwAAACADAAAAAAAAAAAAAAEAAACgMgAAVgcAAKr4//8BAAAAf39/AAEAAABkAAAAAAAAABQAAABAHwAAAAAAACYAAAAAAAAAwOD//wAAAAAmAAAAZAAAABYAAABMAAAAAAAAAAAAAAAEAAAAAAAAAAEAAACAgIAKAAAAACgAAAAoAAAAZAAAAGQAAAAAAAAAzMzMAAAAAABQAAAAUAAAAGQAAABkAAAAAAAAABcAAAAUAAAAAAAAAAAAAAD/fwAA/38AAAAAAAAJAAAABAAAAAAAAAAeAAAAaAAAAAAAAAAAAAAAAAAAAAAAAAAAAAAAECcAABAnAAAAAAAAAAAAAAAAAAAAAAAAAAAAAAAAAAAAAAAAAAAAABQAAAAAAAAAwMD/AAAAAABkAAAAMgAAAAAAAABkAAAAAAAAAH9/fwAKAAAAIgAAABgAAAAAAAAAAAAAAAAAAAAAAAAAAAAAAAAAAAAkAAAAJAAAAAAAAAAHAAAAAAAAAAAAAAAAAAAAAAAAAAAAAAAAAAAAf39/ACUAAABYAAAAAAAAAAAAAAAAAAAAAAAAAAAAAAAAAAAAAAAAAAAAAAAAAAAAAAAAAAAAAAA/AAAAAAAAAKCGAQAAAAAAAAAAAAAAAAAMAAAAAQAAAAAAAAAAAAAAAAAAAB8AAABUAAAAu+DjBf///wEAAAAAAAAAAAAAAAAAAAAAAAAAAAAAAAAAAAAAAAAAAAAAAAJ/f38AgICAA8zMzADAwP8Af39/AAAAAAAAAAAAAAAAAAAAAAAAAAAAIQAAABgAAAAUAAAABSYAAHUIAACOKQAA/QwAAAAAAAAmAAAACAAAAP//////////"/>
+                <pr:smNativeData xmlns:pr="smNativeData" xmlns="smNativeData" val="SMDATA_15_7aDWaRMAAAAlAAAADwAAAA8BAAAAkAAAAEgAAACQAAAASAAAAAAAAAAAAAAAAAAAAAEAAABQAAAA/nDA4w8H3L+9RGVK8ZP9PwAAAAAAAOA/AAAAAAAA4D8AAAAAAADgPwAAAAAAAOA/AAAAAAAA4D8AAAAAAADgPwAAAAAAAOA/AAAAAAAA4D8CAAAAjAAAAAAAAAAAAAAAu+DjDP///wgAAAAAAAAAAAAAAAAAAAAAAAAAAAAAAAAAAAAAZAAAAAEAAABAAAAAAAAAAAAAAAAAAAAAAAAAAAAAAAAAAAAAAAAAAAAAAAAAAAAAAAAAAAAAAAAAAAAAAAAAAAAAAAAAAAAAAAAAAAAAAAAAAAAAAAAAAAAAAAAAAAAAFAAAADwAAAABAAAAAgAAAAAAAAkUAAAAAQAAABQAAAAUAAAAFAAAAAEAAAAAAAAAZAAAAGQAAAABAAAAlgAAAJYAAAAVAAAAYAAAAAAAAAAAAAAADwAAACADAAAAAAAAAAAAAAEAAACgMgAAVgcAAKr4//8BAAAAf39/AAEAAABkAAAAAAAAABQAAABAHwAAAAAAACYAAAAAAAAAwOD//wAAAAAmAAAAZAAAABYAAABMAAAAAAAAAAAAAAAEAAAAAAAAAAEAAACAgIAKAAAAACgAAAAoAAAAZAAAAGQAAAAAAAAAzMzMAAAAAABQAAAAUAAAAGQAAABkAAAAAAAAABcAAAAUAAAAAAAAAAAAAAD/fwAA/38AAAAAAAAJAAAABAAAAAAAAAAeAAAAaAAAAAAAAAAAAAAAAAAAAAAAAAAAAAAAECcAABAnAAAAAAAAAAAAAAAAAAAAAAAAAAAAAAAAAAAAAAAAAAAAABQAAAAAAAAAwMD/AAAAAABkAAAAMgAAAAAAAABkAAAAAAAAAH9/fwAKAAAAIgAAABgAAAAAAAAAAAAAAAAAAAAAAAAAAAAAAAAAAAAkAAAAJAAAAAAAAAAHAAAAAAAAAAAAAAAAAAAAAAAAAAAAAAAAAAAAf39/ACUAAABYAAAAAAAAAAAAAAAAAAAAAAAAAAAAAAAAAAAAAAAAAAAAAAAAAAAAAAAAAAAAAAA/AAAAAAAAAKCGAQAAAAAAAAAAAAAAAAAMAAAAAQAAAAAAAAAAAAAAAAAAAB8AAABUAAAAu+DjBf///wEAAAAAAAAAAAAAAAAAAAAAAAAAAAAAAAAAAAAAAAAAAAAAAAJ/f38AgICAA8zMzADAwP8Af39/AAAAAAAAAAAAAAAAAAAAAAAAAAAAIQAAABgAAAAUAAAABCYAAHUIAACOKQAA/QwAABAAAAAmAAAACAAAAP//////////"/>
               </a:ext>
             </a:extLst>
           </p:cNvCxnSpPr>
@@ -5692,8 +5604,8 @@
         </p:nvCxnSpPr>
         <p:spPr>
           <a:xfrm rot="16200000">
-            <a:off x="6099810" y="1455420"/>
-            <a:ext cx="736600" cy="574675"/>
+            <a:off x="6099175" y="1455420"/>
+            <a:ext cx="736600" cy="575310"/>
           </a:xfrm>
           <a:prstGeom prst="curvedConnector4">
             <a:avLst>
@@ -5721,7 +5633,7 @@
             <a:endCxn id="19" idx="1"/>
             <a:extLst>
               <a:ext uri="smNativeData">
-                <pr:smNativeData xmlns:pr="smNativeData" xmlns="smNativeData" val="SMDATA_15_AnHWaRMAAAAlAAAADwAAAA8BAAAAkAAAAEgAAACQAAAASAAAAAAAAAAAAAAAAAAAAAEAAABQAAAA4m9TjBr+5L+ev8Vpzfb5PwAAAAAAAOA/AAAAAAAA4D8AAAAAAADgPwAAAAAAAOA/AAAAAAAA4D8AAAAAAADgPwAAAAAAAOA/AAAAAAAA4D8CAAAAjAAAAAAAAAAAAAAAu+DjDP///wgAAAAAAAAAAAAAAAAAAAAAAAAAAAAAAAAAAAAAZAAAAAEAAABAAAAAAAAAAAAAAAAAAAAAAAAAAAAAAAAAAAAAAAAAAAAAAAAAAAAAAAAAAAAAAAAAAAAAAAAAAAAAAAAAAAAAAAAAAAAAAAAAAAAAAAAAAAAAAAAAAAAAFAAAADwAAAABAAAAAgAAAAAAAAkUAAAAAQAAABQAAAAUAAAAFAAAAAEAAAAAAAAAZAAAAGQAAAABAAAAlgAAAJYAAAAVAAAAYAAAAAAAAAAAAAAADwAAACADAAAAAAAAAAAAAAEAAACgMgAAVgcAAKr4//8BAAAAf39/AAEAAABkAAAAAAAAABQAAABAHwAAAAAAACYAAAAAAAAAwOD//wAAAAAmAAAAZAAAABYAAABMAAAAAAAAAAAAAAAEAAAAAAAAAAEAAACAgIAKAAAAACgAAAAoAAAAZAAAAGQAAAAAAAAAzMzMAAAAAABQAAAAUAAAAGQAAABkAAAAAAAAABcAAAAUAAAAAAAAAAAAAAD/fwAA/38AAAAAAAAJAAAABAAAAAAAAAAeAAAAaAAAAAAAAAAAAAAAAAAAAAAAAAAAAAAAECcAABAnAAAAAAAAAAAAAAAAAAAAAAAAAAAAAAAAAAAAAAAAAAAAABQAAAAAAAAAwMD/AAAAAABkAAAAMgAAAAAAAABkAAAAAAAAAH9/fwAKAAAAIgAAABgAAAAAAAAAAAAAAAAAAAAAAAAAAAAAAAAAAAAkAAAAJAAAAAAAAAAHAAAAAAAAAAAAAAAAAAAAAAAAAAAAAAAAAAAAf39/ACUAAABYAAAAAAAAAAAAAAAAAAAAAAAAAAAAAAAAAAAAAAAAAAAAAAAAAAAAAAAAAAAAAAA/AAAAAAAAAKCGAQAAAAAAAAAAAAAAAAAMAAAAAQAAAAAAAAAAAAAAAAAAAB8AAABUAAAAu+DjBf///wEAAAAAAAAAAAAAAAAAAAAAAAAAAAAAAAAAAAAAAAAAAAAAAAJ/f38AgICAA8zMzADAwP8Af39/AAAAAAAAAAAAAAAAAAAAAAAAAAAAIQAAABgAAAAUAAAA4xwAAPYQAAAFJgAA1iEAAAAAAAAmAAAACAAAAP//////////"/>
+                <pr:smNativeData xmlns:pr="smNativeData" xmlns="smNativeData" val="SMDATA_15_7aDWaRMAAAAlAAAADwAAAA8BAAAAkAAAAEgAAACQAAAASAAAAAAAAAAAAAAAAAAAAAEAAABQAAAA4m9TjBr+5L+ev8Vpzfb5PwAAAAAAAOA/AAAAAAAA4D8AAAAAAADgPwAAAAAAAOA/AAAAAAAA4D8AAAAAAADgPwAAAAAAAOA/AAAAAAAA4D8CAAAAjAAAAAAAAAAAAAAAu+DjDP///wgAAAAAAAAAAAAAAAAAAAAAAAAAAAAAAAAAAAAAZAAAAAEAAABAAAAAAAAAAAAAAAAAAAAAAAAAAAAAAAAAAAAAAAAAAAAAAAAAAAAAAAAAAAAAAAAAAAAAAAAAAAAAAAAAAAAAAAAAAAAAAAAAAAAAAAAAAAAAAAAAAAAAFAAAADwAAAABAAAAAgAAAAAAAAkUAAAAAQAAABQAAAAUAAAAFAAAAAEAAAAAAAAAZAAAAGQAAAABAAAAlgAAAJYAAAAVAAAAYAAAAAAAAAAAAAAADwAAACADAAAAAAAAAAAAAAEAAACgMgAAVgcAAKr4//8BAAAAf39/AAEAAABkAAAAAAAAABQAAABAHwAAAAAAACYAAAAAAAAAwOD//wAAAAAmAAAAZAAAABYAAABMAAAAAAAAAAAAAAAEAAAAAAAAAAEAAACAgIAKAAAAACgAAAAoAAAAZAAAAGQAAAAAAAAAzMzMAAAAAABQAAAAUAAAAGQAAABkAAAAAAAAABcAAAAUAAAAAAAAAAAAAAD/fwAA/38AAAAAAAAJAAAABAAAAAAAAAAeAAAAaAAAAAAAAAAAAAAAAAAAAAAAAAAAAAAAECcAABAnAAAAAAAAAAAAAAAAAAAAAAAAAAAAAAAAAAAAAAAAAAAAABQAAAAAAAAAwMD/AAAAAABkAAAAMgAAAAAAAABkAAAAAAAAAH9/fwAKAAAAIgAAABgAAAAAAAAAAAAAAAAAAAAAAAAAAAAAAAAAAAAkAAAAJAAAAAAAAAAHAAAAAAAAAAAAAAAAAAAAAAAAAAAAAAAAAAAAf39/ACUAAABYAAAAAAAAAAAAAAAAAAAAAAAAAAAAAAAAAAAAAAAAAAAAAAAAAAAAAAAAAAAAAAA/AAAAAAAAAKCGAQAAAAAAAAAAAAAAAAAMAAAAAQAAAAAAAAAAAAAAAAAAAB8AAABUAAAAu+DjBf///wEAAAAAAAAAAAAAAAAAAAAAAAAAAAAAAAAAAAAAAAAAAAAAAAJ/f38AgICAA8zMzADAwP8Af39/AAAAAAAAAAAAAAAAAAAAAAAAAAAAIQAAABgAAAAUAAAA4xwAAPYQAAAEJgAA1iEAABAAAAAmAAAACAAAAP//////////"/>
               </a:ext>
             </a:extLst>
           </p:cNvCxnSpPr>
@@ -5730,7 +5642,7 @@
         <p:spPr>
           <a:xfrm rot="5400000">
             <a:off x="4066540" y="3386455"/>
-            <a:ext cx="2743200" cy="1484630"/>
+            <a:ext cx="2743200" cy="1483995"/>
           </a:xfrm>
           <a:prstGeom prst="curvedConnector4">
             <a:avLst>
@@ -5757,7 +5669,7 @@
             <a:stCxn id="2" idx="2"/>
             <a:extLst>
               <a:ext uri="smNativeData">
-                <pr:smNativeData xmlns:pr="smNativeData" xmlns="smNativeData" val="SMDATA_15_AnHWaRMAAAAlAAAADwAAAA8BAAAAkAAAAEgAAACQAAAASAAAAAAAAAAAAAAAAAAAAAEAAABQAAAAQtr79nGI5r8qniQtlC/2PwAAAAAAAOA/AAAAAAAA4D8AAAAAAADgPwAAAAAAAOA/AAAAAAAA4D8AAAAAAADgPwAAAAAAAOA/AAAAAAAA4D8CAAAAjAAAAAAAAAAAAAAAu+DjDP///wgAAAAAAAAAAAAAAAAAAAAAAAAAAAAAAAAAAAAAZAAAAAEAAABAAAAAAAAAAAAAAAAAAAAAAAAAAAAAAAAAAAAAAAAAAAAAAAAAAAAAAAAAAAAAAAAAAAAAAAAAAAAAAAAAAAAAAAAAAAAAAAAAAAAAAAAAAAAAAAAAAAAAFAAAADwAAAABAAAAAgAAAAAAAAkUAAAAAQAAABQAAAAUAAAAFAAAAAEAAAAAAAAAZAAAAGQAAAABAAAAlgAAAJYAAAAVAAAAYAAAAAAAAAAAAAAADwAAACADAAAAAAAAAAAAAAEAAACgMgAAVgcAAKr4//8BAAAAf39/AAEAAABkAAAAAAAAABQAAABAHwAAAAAAACYAAAAAAAAAwOD//wAAAAAmAAAAZAAAABYAAABMAAAAAAAAAAAAAAAEAAAAAAAAAAEAAACAgIAKAAAAACgAAAAoAAAAZAAAAGQAAAAAAAAAzMzMAAAAAABQAAAAUAAAAGQAAABkAAAAAAAAABcAAAAUAAAAAAAAAAAAAAD/fwAA/38AAAAAAAAJAAAABAAAAAAAAAAeAAAAaAAAAAAAAAAAAAAAAAAAAAAAAAAAAAAAECcAABAnAAAAAAAAAAAAAAAAAAAAAAAAAAAAAAAAAAAAAAAAAAAAABQAAAAAAAAAwMD/AAAAAABkAAAAMgAAAAAAAABkAAAAAAAAAH9/fwAKAAAAIgAAABgAAAAAAAAAAAAAAAAAAAAAAAAAAAAAAAAAAAAkAAAAJAAAAAAAAAAHAAAAAAAAAAAAAAAAAAAAAAAAAAAAAAAAAAAAf39/ACUAAABYAAAAAAAAAAAAAAAAAAAAAAAAAAAAAAAAAAAAAAAAAAAAAAAAAAAAAAAAAAAAAAA/AAAAAAAAAKCGAQAAAAAAAAAAAAAAAAAMAAAAAQAAAAAAAAAAAAAAAAAAAB8AAABUAAAAu+DjBf///wEAAAAAAAAAAAAAAAAAAAAAAAAAAAAAAAAAAAAAAAAAAAAAAAJ/f38AgICAA8zMzADAwP8Af39/AAAAAAAAAAAAAAAAAAAAAAAAAAAAIQAAABgAAAAUAAAAYw0AAPYQAAAFJgAAmSEAAAAAAAAmAAAACAAAAP//////////"/>
+                <pr:smNativeData xmlns:pr="smNativeData" xmlns="smNativeData" val="SMDATA_15_7aDWaRMAAAAlAAAADwAAAA8BAAAAkAAAAEgAAACQAAAASAAAAAAAAAAAAAAAAAAAAAEAAABQAAAAQtr79nGI5r8qniQtlC/2PwAAAAAAAOA/AAAAAAAA4D8AAAAAAADgPwAAAAAAAOA/AAAAAAAA4D8AAAAAAADgPwAAAAAAAOA/AAAAAAAA4D8CAAAAjAAAAAAAAAAAAAAAu+DjDP///wgAAAAAAAAAAAAAAAAAAAAAAAAAAAAAAAAAAAAAZAAAAAEAAABAAAAAAAAAAAAAAAAAAAAAAAAAAAAAAAAAAAAAAAAAAAAAAAAAAAAAAAAAAAAAAAAAAAAAAAAAAAAAAAAAAAAAAAAAAAAAAAAAAAAAAAAAAAAAAAAAAAAAFAAAADwAAAABAAAAAgAAAAAAAAkUAAAAAQAAABQAAAAUAAAAFAAAAAEAAAAAAAAAZAAAAGQAAAABAAAAlgAAAJYAAAAVAAAAYAAAAAAAAAAAAAAADwAAACADAAAAAAAAAAAAAAEAAACgMgAAVgcAAKr4//8BAAAAf39/AAEAAABkAAAAAAAAABQAAABAHwAAAAAAACYAAAAAAAAAwOD//wAAAAAmAAAAZAAAABYAAABMAAAAAAAAAAAAAAAEAAAAAAAAAAEAAACAgIAKAAAAACgAAAAoAAAAZAAAAGQAAAAAAAAAzMzMAAAAAABQAAAAUAAAAGQAAABkAAAAAAAAABcAAAAUAAAAAAAAAAAAAAD/fwAA/38AAAAAAAAJAAAABAAAAAAAAAAeAAAAaAAAAAAAAAAAAAAAAAAAAAAAAAAAAAAAECcAABAnAAAAAAAAAAAAAAAAAAAAAAAAAAAAAAAAAAAAAAAAAAAAABQAAAAAAAAAwMD/AAAAAABkAAAAMgAAAAAAAABkAAAAAAAAAH9/fwAKAAAAIgAAABgAAAAAAAAAAAAAAAAAAAAAAAAAAAAAAAAAAAAkAAAAJAAAAAAAAAAHAAAAAAAAAAAAAAAAAAAAAAAAAAAAAAAAAAAAf39/ACUAAABYAAAAAAAAAAAAAAAAAAAAAAAAAAAAAAAAAAAAAAAAAAAAAAAAAAAAAAAAAAAAAAA/AAAAAAAAAKCGAQAAAAAAAAAAAAAAAAAMAAAAAQAAAAAAAAAAAAAAAAAAAB8AAABUAAAAu+DjBf///wEAAAAAAAAAAAAAAAAAAAAAAAAAAAAAAAAAAAAAAAAAAAAAAAJ/f38AgICAA8zMzADAwP8Af39/AAAAAAAAAAAAAAAAAAAAAAAAAAAAIQAAABgAAAAUAAAAYw0AAPYQAAAFJgAAmSEAABAAAAAmAAAACAAAAP//////////"/>
               </a:ext>
             </a:extLst>
           </p:cNvCxnSpPr>
@@ -5794,7 +5706,7 @@
             <a:endCxn id="2" idx="3"/>
             <a:extLst>
               <a:ext uri="smNativeData">
-                <pr:smNativeData xmlns:pr="smNativeData" xmlns="smNativeData" val="SMDATA_15_AnHWaRMAAAAlAAAADwAAAA8BAAAAkAAAAEgAAACQAAAASAAAAAAAAAAAAAAAAAAAAAEAAABQAAAAAAAAAAAAFEAAAAAAAADgPwAAAAAAAOA/AAAAAAAA4D8AAAAAAADgPwAAAAAAAOA/AAAAAAAA4D8AAAAAAADgPwAAAAAAAOA/AAAAAAAA4D8CAAAAjAAAAAAAAAAAAAAAu+DjDP///wgAAAAAAAAAAAAAAAAAAAAAAAAAAAAAAAAAAAAAZAAAAAEAAABAAAAAAAAAAAAAAAAAAAAAAAAAAAAAAAAAAAAAAAAAAAAAAAAAAAAAAAAAAAAAAAAAAAAAAAAAAAAAAAAAAAAAAAAAAAAAAAAAAAAAAAAAAAAAAAAAAAAAFAAAADwAAAABAAAAAQAAAAAAAAkUAAAAAQAAABQAAAAUAAAAFAAAAAEAAAAAAAAAZAAAAGQAAAABAAAAlgAAAJYAAAAVAAAAYAAAAAAAAAAAAAAADwAAACADAAAAAAAAAAAAAAEAAACgMgAAVgcAAKr4//8BAAAAf39/AAEAAABkAAAAAAAAABQAAABAHwAAAAAAACYAAAAAAAAAwOD//wAAAAAmAAAAZAAAABYAAABMAAAAAAAAAAAAAAAEAAAAAAAAAAEAAACAgIAKAAAAACgAAAAoAAAAZAAAAGQAAAAAAAAAzMzMAAAAAABQAAAAUAAAAGQAAABkAAAAAAAAABcAAAAUAAAAAAAAAAAAAAD/fwAA/38AAAAAAAAJAAAABAAAAAAAAAAeAAAAaAAAAAAAAAAAAAAAAAAAAAAAAAAAAAAAECcAABAnAAAAAAAAAAAAAAAAAAAAAAAAAAAAAAAAAAAAAAAAAAAAABQAAAAAAAAAwMD/AAAAAABkAAAAMgAAAAAAAABkAAAAAAAAAH9/fwAKAAAAIgAAABgAAAAAAAAAAAAAAAAAAAAAAAAAAAAAAAAAAAAkAAAAJAAAAAAAAAAHAAAAAAAAAAAAAAAAAAAAAAAAAAAAAAAAAAAAf39/ACUAAABYAAAAAAAAAAAAAAAAAAAAAAAAAAAAAAAAAAAAAAAAAAAAAAAAAAAAAAAAAAAAAAA/AAAAAAAAAKCGAQAAAAAAAAAAAAAAAAAMAAAAAQAAAAAAAAAAAAAAAAAAAB8AAABUAAAAu+DjBf///wEAAAAAAAAAAAAAAAAAAAAAAAAAAAAAAAAAAAAAAAAAAAAAAAJ/f38AgICAA8zMzADAwP8Af39/AAAAAAAAAAAAAAAAAAAAAAAAAAAAIQAAABgAAAAUAAAAGCsAAPoOAAD6KwAAWBYAAAAAAAAmAAAACAAAAP//////////"/>
+                <pr:smNativeData xmlns:pr="smNativeData" xmlns="smNativeData" val="SMDATA_15_7aDWaRMAAAAlAAAADwAAAA8BAAAAkAAAAEgAAACQAAAASAAAAAAAAAAAAAAAAAAAAAEAAABQAAAAAAAAAAAAFEAAAAAAAADgPwAAAAAAAOA/AAAAAAAA4D8AAAAAAADgPwAAAAAAAOA/AAAAAAAA4D8AAAAAAADgPwAAAAAAAOA/AAAAAAAA4D8CAAAAjAAAAAAAAAAAAAAAu+DjDP///wgAAAAAAAAAAAAAAAAAAAAAAAAAAAAAAAAAAAAAZAAAAAEAAABAAAAAAAAAAAAAAAAAAAAAAAAAAAAAAAAAAAAAAAAAAAAAAAAAAAAAAAAAAAAAAAAAAAAAAAAAAAAAAAAAAAAAAAAAAAAAAAAAAAAAAAAAAAAAAAAAAAAAFAAAADwAAAABAAAAAQAAAAAAAAkUAAAAAQAAABQAAAAUAAAAFAAAAAEAAAAAAAAAZAAAAGQAAAABAAAAlgAAAJYAAAAVAAAAYAAAAAAAAAAAAAAADwAAACADAAAAAAAAAAAAAAEAAACgMgAAVgcAAKr4//8BAAAAf39/AAEAAABkAAAAAAAAABQAAABAHwAAAAAAACYAAAAAAAAAwOD//wAAAAAmAAAAZAAAABYAAABMAAAAAAAAAAAAAAAEAAAAAAAAAAEAAACAgIAKAAAAACgAAAAoAAAAZAAAAGQAAAAAAAAAzMzMAAAAAABQAAAAUAAAAGQAAABkAAAAAAAAABcAAAAUAAAAAAAAAAAAAAD/fwAA/38AAAAAAAAJAAAABAAAAAAAAAAeAAAAaAAAAAAAAAAAAAAAAAAAAAAAAAAAAAAAECcAABAnAAAAAAAAAAAAAAAAAAAAAAAAAAAAAAAAAAAAAAAAAAAAABQAAAAAAAAAwMD/AAAAAABkAAAAMgAAAAAAAABkAAAAAAAAAH9/fwAKAAAAIgAAABgAAAAAAAAAAAAAAAAAAAAAAAAAAAAAAAAAAAAkAAAAJAAAAAAAAAAHAAAAAAAAAAAAAAAAAAAAAAAAAAAAAAAAAAAAf39/ACUAAABYAAAAAAAAAAAAAAAAAAAAAAAAAAAAAAAAAAAAAAAAAAAAAAAAAAAAAAAAAAAAAAA/AAAAAAAAAKCGAQAAAAAAAAAAAAAAAAAMAAAAAQAAAAAAAAAAAAAAAAAAAB8AAABUAAAAu+DjBf///wEAAAAAAAAAAAAAAAAAAAAAAAAAAAAAAAAAAAAAAAAAAAAAAAJ/f38AgICAA8zMzADAwP8Af39/AAAAAAAAAAAAAAAAAAAAAAAAAAAAIQAAABgAAAAUAAAAGCsAAPoOAAD6KwAAWBYAABAAAAAmAAAACAAAAP//////////"/>
               </a:ext>
             </a:extLst>
           </p:cNvCxnSpPr>
@@ -5830,7 +5742,7 @@
             <a:endCxn id="2" idx="1"/>
             <a:extLst>
               <a:ext uri="smNativeData">
-                <pr:smNativeData xmlns:pr="smNativeData" xmlns="smNativeData" val="SMDATA_15_AnHWaRMAAAAlAAAADwAAAA8BAAAAkAAAAEgAAACQAAAASAAAAAAAAAAAAAAAAAAAAAEAAABQAAAAAAAAAACABMA3jx60mcXaPwAAAAAAAOA/AAAAAAAA4D8AAAAAAADgPwAAAAAAAOA/AAAAAAAA4D8AAAAAAADgPwAAAAAAAOA/AAAAAAAA4D8CAAAAjAAAAAAAAAAAAAAAu+DjDP///wgAAAAAAAAAAAAAAAAAAAAAAAAAAAAAAAAAAAAAZAAAAAEAAABAAAAAAAAAAAAAAAAAAAAAAAAAAAAAAAAAAAAAAAAAAAAAAAAAAAAAAAAAAAAAAAAAAAAAAAAAAAAAAAAAAAAAAAAAAAAAAAAAAAAAAAAAAAAAAAAAAAAAFAAAADwAAAABAAAAAgAAAAAAAAkUAAAAAQAAABQAAAAUAAAAFAAAAAEAAAAAAAAAZAAAAGQAAAABAAAAlgAAAJYAAAAVAAAAYAAAAAAAAAAAAAAADwAAACADAAAAAAAAAAAAAAEAAACgMgAAVgcAAKr4//8BAAAAf39/AAEAAABkAAAAAAAAABQAAABAHwAAAAAAACYAAAAAAAAAwOD//wAAAAAmAAAAZAAAABYAAABMAAAAAAAAAAAAAAAEAAAAAAAAAAEAAACAgIAKAAAAACgAAAAoAAAAZAAAAGQAAAAAAAAAzMzMAAAAAABQAAAAUAAAAGQAAABkAAAAAAAAABcAAAAUAAAAAAAAAAAAAAD/fwAA/38AAAAAAAAJAAAABAAAAAAAAAAeAAAAaAAAAAAAAAAAAAAAAAAAAAAAAAAAAAAAECcAABAnAAAAAAAAAAAAAAAAAAAAAAAAAAAAAAAAAAAAAAAAAAAAABQAAAAAAAAAwMD/AAAAAABkAAAAMgAAAAAAAABkAAAAAAAAAH9/fwAKAAAAIgAAABgAAAAAAAAAAAAAAAAAAAAAAAAAAAAAAAAAAAAkAAAAJAAAAAAAAAAHAAAAAAAAAAAAAAAAAAAAAAAAAAAAAAAAAAAAf39/ACUAAABYAAAAAAAAAAAAAAAAAAAAAAAAAAAAAAAAAAAAAAAAAAAAAAAAAAAAAAAAAAAAAAA/AAAAAAAAAKCGAQAAAAAAAAAAAAAAAAAMAAAAAQAAAAAAAAAAAAAAAAAAAB8AAABUAAAAu+DjBf///wEAAAAAAAAAAAAAAAAAAAAAAAAAAAAAAAAAAAAAAAAAAAAAAAJ/f38AgICAA8zMzADAwP8Af39/AAAAAAAAAAAAAAAAAAAAAAAAAAAAIQAAABgAAAAUAAAAVhgAAPoOAAAPIAAA+hAAAAAAAAAmAAAACAAAAP//////////"/>
+                <pr:smNativeData xmlns:pr="smNativeData" xmlns="smNativeData" val="SMDATA_15_7aDWaRMAAAAlAAAADwAAAA8BAAAAkAAAAEgAAACQAAAASAAAAAAAAAAAAAAAAAAAAAEAAABQAAAAAAAAAACABMA3jx60mcXaPwAAAAAAAOA/AAAAAAAA4D8AAAAAAADgPwAAAAAAAOA/AAAAAAAA4D8AAAAAAADgPwAAAAAAAOA/AAAAAAAA4D8CAAAAjAAAAAAAAAAAAAAAu+DjDP///wgAAAAAAAAAAAAAAAAAAAAAAAAAAAAAAAAAAAAAZAAAAAEAAABAAAAAAAAAAAAAAAAAAAAAAAAAAAAAAAAAAAAAAAAAAAAAAAAAAAAAAAAAAAAAAAAAAAAAAAAAAAAAAAAAAAAAAAAAAAAAAAAAAAAAAAAAAAAAAAAAAAAAFAAAADwAAAABAAAAAgAAAAAAAAkUAAAAAQAAABQAAAAUAAAAFAAAAAEAAAAAAAAAZAAAAGQAAAABAAAAlgAAAJYAAAAVAAAAYAAAAAAAAAAAAAAADwAAACADAAAAAAAAAAAAAAEAAACgMgAAVgcAAKr4//8BAAAAf39/AAEAAABkAAAAAAAAABQAAABAHwAAAAAAACYAAAAAAAAAwOD//wAAAAAmAAAAZAAAABYAAABMAAAAAAAAAAAAAAAEAAAAAAAAAAEAAACAgIAKAAAAACgAAAAoAAAAZAAAAGQAAAAAAAAAzMzMAAAAAABQAAAAUAAAAGQAAABkAAAAAAAAABcAAAAUAAAAAAAAAAAAAAD/fwAA/38AAAAAAAAJAAAABAAAAAAAAAAeAAAAaAAAAAAAAAAAAAAAAAAAAAAAAAAAAAAAECcAABAnAAAAAAAAAAAAAAAAAAAAAAAAAAAAAAAAAAAAAAAAAAAAABQAAAAAAAAAwMD/AAAAAABkAAAAMgAAAAAAAABkAAAAAAAAAH9/fwAKAAAAIgAAABgAAAAAAAAAAAAAAAAAAAAAAAAAAAAAAAAAAAAkAAAAJAAAAAAAAAAHAAAAAAAAAAAAAAAAAAAAAAAAAAAAAAAAAAAAf39/ACUAAABYAAAAAAAAAAAAAAAAAAAAAAAAAAAAAAAAAAAAAAAAAAAAAAAAAAAAAAAAAAAAAAA/AAAAAAAAAKCGAQAAAAAAAAAAAAAAAAAMAAAAAQAAAAAAAAAAAAAAAAAAAB8AAABUAAAAu+DjBf///wEAAAAAAAAAAAAAAAAAAAAAAAAAAAAAAAAAAAAAAAAAAAAAAAJ/f38AgICAA8zMzADAwP8Af39/AAAAAAAAAAAAAAAAAAAAAAAAAAAAIQAAABgAAAAUAAAAVhgAAPoOAAAPIAAA+hAAABAAAAAmAAAACAAAAP//////////"/>
               </a:ext>
             </a:extLst>
           </p:cNvCxnSpPr>
@@ -5867,7 +5779,7 @@
             <a:endCxn id="2" idx="1"/>
             <a:extLst>
               <a:ext uri="smNativeData">
-                <pr:smNativeData xmlns:pr="smNativeData" xmlns="smNativeData" val="SMDATA_15_AnHWaRMAAAAlAAAADQAAAA8BAAAAkAAAAEgAAACQAAAASAAAAAAAAAAAAAAAAAAAAAEAAABQAAAAAAAAAAAA4D8AAAAAAADgPwAAAAAAAOA/AAAAAAAA4D8AAAAAAADgPwAAAAAAAOA/AAAAAAAA4D8AAAAAAADgPwAAAAAAAOA/AAAAAAAA4D8CAAAAjAAAAAAAAAAAAAAAu+DjDP///wgAAAAAAAAAAAAAAAAAAAAAAAAAAAAAAAAAAAAAZAAAAAEAAABAAAAAAAAAAAAAAAAAAAAAAAAAAAAAAAAAAAAAAAAAAAAAAAAAAAAAAAAAAAAAAAAAAAAAAAAAAAAAAAAAAAAAAAAAAAAAAAAAAAAAAAAAAAAAAAAAAAAAFAAAADwAAAABAAAAAAAAAAAAAAkUAAAAAQAAABQAAAAUAAAAFAAAAAEAAAAAAAAAZAAAAGQAAAABAAAAlgAAAJYAAAAVAAAAYAAAAAAAAAAAAAAADwAAACADAAAAAAAAAAAAAAEAAACgMgAAVgcAAKr4//8BAAAAf39/AAEAAABkAAAAAAAAABQAAABAHwAAAAAAACYAAAAAAAAAwOD//wAAAAAmAAAAZAAAABYAAABMAAAAAAAAAAAAAAAEAAAAAAAAAAEAAACAgIAKAAAAACgAAAAoAAAAZAAAAGQAAAAAAAAAzMzMAAAAAABQAAAAUAAAAGQAAABkAAAAAAAAABcAAAAUAAAAAAAAAAAAAAD/fwAA/38AAAAAAAAJAAAABAAAAAAAAAAeAAAAaAAAAAAAAAAAAAAAAAAAAAAAAAAAAAAAECcAABAnAAAAAAAAAAAAAAAAAAAAAAAAAAAAAAAAAAAAAAAAAAAAABQAAAAAAAAAwMD/AAAAAABkAAAAMgAAAAAAAABkAAAAAAAAAH9/fwAKAAAAIgAAABgAAAAAAAAAAAAAAAAAAAAAAAAAAAAAAAAAAAAkAAAAJAAAAAAAAAAHAAAAAAAAAAAAAAAAAAAAAAAAAAAAAAAAAAAAf39/ACUAAABYAAAAAAAAAAAAAAAAAAAAAAAAAAAAAAAAAAAAAAAAAAAAAAAAAAAAAAAAAAAAAAA/AAAAAAAAAKCGAQAAAAAAAAAAAAAAAAAMAAAAAQAAAAAAAAAAAAAAAAAAAB8AAABUAAAAu+DjBf///wEAAAAAAAAAAAAAAAAAAAAAAAAAAAAAAAAAAAAAAAAAAAAAAAJ/f38AgICAA8zMzADAwP8Af39/AAAAAAAAAAAAAAAAAAAAAAAAAAAAIQAAABgAAAAUAAAAhxwAAPoOAAAPIAAA/g4AAAAAAAAmAAAACAAAAP//////////"/>
+                <pr:smNativeData xmlns:pr="smNativeData" xmlns="smNativeData" val="SMDATA_15_7aDWaRMAAAAlAAAADQAAAA8BAAAAkAAAAEgAAACQAAAASAAAAAAAAAAAAAAAAAAAAAEAAABQAAAAAAAAAAAA4D8AAAAAAADgPwAAAAAAAOA/AAAAAAAA4D8AAAAAAADgPwAAAAAAAOA/AAAAAAAA4D8AAAAAAADgPwAAAAAAAOA/AAAAAAAA4D8CAAAAjAAAAAAAAAAAAAAAu+DjDP///wgAAAAAAAAAAAAAAAAAAAAAAAAAAAAAAAAAAAAAZAAAAAEAAABAAAAAAAAAAAAAAAAAAAAAAAAAAAAAAAAAAAAAAAAAAAAAAAAAAAAAAAAAAAAAAAAAAAAAAAAAAAAAAAAAAAAAAAAAAAAAAAAAAAAAAAAAAAAAAAAAAAAAFAAAADwAAAABAAAAAAAAAAAAAAkUAAAAAQAAABQAAAAUAAAAFAAAAAEAAAAAAAAAZAAAAGQAAAABAAAAlgAAAJYAAAAVAAAAYAAAAAAAAAAAAAAADwAAACADAAAAAAAAAAAAAAEAAACgMgAAVgcAAKr4//8BAAAAf39/AAEAAABkAAAAAAAAABQAAABAHwAAAAAAACYAAAAAAAAAwOD//wAAAAAmAAAAZAAAABYAAABMAAAAAAAAAAAAAAAEAAAAAAAAAAEAAACAgIAKAAAAACgAAAAoAAAAZAAAAGQAAAAAAAAAzMzMAAAAAABQAAAAUAAAAGQAAABkAAAAAAAAABcAAAAUAAAAAAAAAAAAAAD/fwAA/38AAAAAAAAJAAAABAAAAAAAAAAeAAAAaAAAAAAAAAAAAAAAAAAAAAAAAAAAAAAAECcAABAnAAAAAAAAAAAAAAAAAAAAAAAAAAAAAAAAAAAAAAAAAAAAABQAAAAAAAAAwMD/AAAAAABkAAAAMgAAAAAAAABkAAAAAAAAAH9/fwAKAAAAIgAAABgAAAAAAAAAAAAAAAAAAAAAAAAAAAAAAAAAAAAkAAAAJAAAAAAAAAAHAAAAAAAAAAAAAAAAAAAAAAAAAAAAAAAAAAAAf39/ACUAAABYAAAAAAAAAAAAAAAAAAAAAAAAAAAAAAAAAAAAAAAAAAAAAAAAAAAAAAAAAAAAAAA/AAAAAAAAAKCGAQAAAAAAAAAAAAAAAAAMAAAAAQAAAAAAAAAAAAAAAAAAAB8AAABUAAAAu+DjBf///wEAAAAAAAAAAAAAAAAAAAAAAAAAAAAAAAAAAAAAAAAAAAAAAAJ/f38AgICAA8zMzADAwP8Af39/AAAAAAAAAAAAAAAAAAAAAAAAAAAAIQAAABgAAAAUAAAAhxwAAPoOAAAPIAAA/g4AABAAAAAmAAAACAAAAP//////////"/>
               </a:ext>
             </a:extLst>
           </p:cNvCxnSpPr>
@@ -5901,7 +5813,7 @@
             <a:endCxn id="5" idx="3"/>
             <a:extLst>
               <a:ext uri="smNativeData">
-                <pr:smNativeData xmlns:pr="smNativeData" xmlns="smNativeData" val="SMDATA_15_AnHWaRMAAAAlAAAADQAAAA8BAAAAkAAAAEgAAACQAAAASAAAAAAAAAAAAAAAAAAAAAEAAABQAAAAAAAAAAAA4D8AAAAAAADgPwAAAAAAAOA/AAAAAAAA4D8AAAAAAADgPwAAAAAAAOA/AAAAAAAA4D8AAAAAAADgPwAAAAAAAOA/AAAAAAAA4D8CAAAAjAAAAAAAAAAAAAAAu+DjDP///wgAAAAAAAAAAAAAAAAAAAAAAAAAAAAAAAAAAAAAZAAAAAEAAABAAAAAAAAAAAAAAAAAAAAAAAAAAAAAAAAAAAAAAAAAAAAAAAAAAAAAAAAAAAAAAAAAAAAAAAAAAAAAAAAAAAAAAAAAAAAAAAAAAAAAAAAAAAAAAAAAAAAAFAAAADwAAAABAAAAAAAAAAAAAAkUAAAAAQAAABQAAAAUAAAAFAAAAAEAAAAAAAAAZAAAAGQAAAABAAAAlgAAAJYAAAAVAAAAYAAAAAAAAAAAAAAADwAAACADAAAAAAAAAAAAAAEAAACgMgAAVgcAAKr4//8BAAAAf39/AAEAAABkAAAAAAAAABQAAABAHwAAAAAAACYAAAAAAAAAwOD//wAAAAAmAAAAZAAAABYAAABMAAAAAAAAAAAAAAAEAAAAAAAAAAEAAACAgIAKAAAAACgAAAAoAAAAZAAAAGQAAAAAAAAAzMzMAAAAAABQAAAAUAAAAGQAAABkAAAAAAAAABcAAAAUAAAAAAAAAAAAAAD/fwAA/38AAAAAAAAJAAAABAAAAAAAAQAeAAAAaAAAAAAAAAAAAAAAAAAAAAAAAAAAAAAAECcAABAnAAAAAAAAAAAAAAAAAAAAAAAAAAAAAAAAAAAAAAAAAAAAABQAAAAAAAAAwMD/AAAAAABkAAAAMgAAAAAAAABkAAAAAAAAAH9/fwAKAAAAIgAAABgAAAAAAAAAAAAAAAAAAAAAAAAAAAAAAAAAAAAkAAAAJAAAAAAAAAAHAAAAAAAAAAAAAAAAAAAAAAAAAAAAAAAAAAAAf39/ACUAAABYAAAAAAAAAAAAAAAAAAAAAAAAAAAAAAAAAAAAAAAAAAAAAAAAAAAAAAAAAAAAAAA/AAAAAAAAAKCGAQAAAAAAAAAAAAAAAAAMAAAAAQAAAAAAAAAAAAAAAAAAAB8AAABUAAAAu+DjBf///wEAAAAAAAAAAAAAAAAAAAAAAAAAAAAAAAAAAAAAAAAAAAAAAAJ/f38AgICAA8zMzADAwP8Af39/AAAAAAAAAAAAAAAAAAAAAAAAAAAAIQAAABgAAAAUAAAA7xEAAP4OAAAkFAAAAQ8AAAAAAAAmAAAACAAAAP//////////"/>
+                <pr:smNativeData xmlns:pr="smNativeData" xmlns="smNativeData" val="SMDATA_15_7aDWaRMAAAAlAAAADQAAAA8BAAAAkAAAAEgAAACQAAAASAAAAAAAAAAAAAAAAAAAAAEAAABQAAAAAAAAAAAA4D8AAAAAAADgPwAAAAAAAOA/AAAAAAAA4D8AAAAAAADgPwAAAAAAAOA/AAAAAAAA4D8AAAAAAADgPwAAAAAAAOA/AAAAAAAA4D8CAAAAjAAAAAAAAAAAAAAAu+DjDP///wgAAAAAAAAAAAAAAAAAAAAAAAAAAAAAAAAAAAAAZAAAAAEAAABAAAAAAAAAAAAAAAAAAAAAAAAAAAAAAAAAAAAAAAAAAAAAAAAAAAAAAAAAAAAAAAAAAAAAAAAAAAAAAAAAAAAAAAAAAAAAAAAAAAAAAAAAAAAAAAAAAAAAFAAAADwAAAABAAAAAAAAAAAAAAkUAAAAAQAAABQAAAAUAAAAFAAAAAEAAAAAAAAAZAAAAGQAAAABAAAAlgAAAJYAAAAVAAAAYAAAAAAAAAAAAAAADwAAACADAAAAAAAAAAAAAAEAAACgMgAAVgcAAKr4//8BAAAAf39/AAEAAABkAAAAAAAAABQAAABAHwAAAAAAACYAAAAAAAAAwOD//wAAAAAmAAAAZAAAABYAAABMAAAAAAAAAAAAAAAEAAAAAAAAAAEAAACAgIAKAAAAACgAAAAoAAAAZAAAAGQAAAAAAAAAzMzMAAAAAABQAAAAUAAAAGQAAABkAAAAAAAAABcAAAAUAAAAAAAAAAAAAAD/fwAA/38AAAAAAAAJAAAABAAAAAAAAQAeAAAAaAAAAAAAAAAAAAAAAAAAAAAAAAAAAAAAECcAABAnAAAAAAAAAAAAAAAAAAAAAAAAAAAAAAAAAAAAAAAAAAAAABQAAAAAAAAAwMD/AAAAAABkAAAAMgAAAAAAAABkAAAAAAAAAH9/fwAKAAAAIgAAABgAAAAAAAAAAAAAAAAAAAAAAAAAAAAAAAAAAAAkAAAAJAAAAAAAAAAHAAAAAAAAAAAAAAAAAAAAAAAAAAAAAAAAAAAAf39/ACUAAABYAAAAAAAAAAAAAAAAAAAAAAAAAAAAAAAAAAAAAAAAAAAAAAAAAAAAAAAAAAAAAAA/AAAAAAAAAKCGAQAAAAAAAAAAAAAAAAAMAAAAAQAAAAAAAAAAAAAAAAAAAB8AAABUAAAAu+DjBf///wEAAAAAAAAAAAAAAAAAAAAAAAAAAAAAAAAAAAAAAAAAAAAAAAJ/f38AgICAA8zMzADAwP8Af39/AAAAAAAAAAAAAAAAAAAAAAAAAAAAIQAAABgAAAAUAAAA7xEAAP4OAAAkFAAAAQ8AABAAAAAmAAAACAAAAP//////////"/>
               </a:ext>
             </a:extLst>
           </p:cNvCxnSpPr>
@@ -5935,7 +5847,7 @@
             <a:endCxn id="4" idx="2"/>
             <a:extLst>
               <a:ext uri="smNativeData">
-                <pr:smNativeData xmlns:pr="smNativeData" xmlns="smNativeData" val="SMDATA_15_AnHWaRMAAAAlAAAADQAAAA8BAAAAkAAAAEgAAACQAAAASAAAAAAAAAAAAAAAAAAAAAEAAABQAAAAAAAAAAAA4D8AAAAAAADgPwAAAAAAAOA/AAAAAAAA4D8AAAAAAADgPwAAAAAAAOA/AAAAAAAA4D8AAAAAAADgPwAAAAAAAOA/AAAAAAAA4D8CAAAAjAAAAAAAAAAAAAAAu+DjDP///wgAAAAAAAAAAAAAAAAAAAAAAAAAAAAAAAAAAAAAZAAAAAEAAABAAAAAAAAAAAAAAAAAAAAAAAAAAAAAAAAAAAAAAAAAAAAAAAAAAAAAAAAAAAAAAAAAAAAAAAAAAAAAAAAAAAAAAAAAAAAAAAAAAAAAAAAAAAAAAAAAAAAAFAAAADwAAAABAAAAAAAAAAAAAAkUAAAAAQAAABQAAAAUAAAAFAAAAAEAAAAAAAAAZAAAAGQAAAABAAAAlgAAAJYAAAAVAAAAYAAAAAAAAAAAAAAADwAAACADAAAAAAAAAAAAAAEAAACgMgAAVgcAAKr4//8BAAAAf39/AAEAAABkAAAAAAAAABQAAABAHwAAAAAAACYAAAAAAAAAwOD//wAAAAAmAAAAZAAAABYAAABMAAAAAAAAAAAAAAAEAAAAAAAAAAEAAACAgIAKAAAAACgAAAAoAAAAZAAAAGQAAAAAAAAAzMzMAAAAAABQAAAAUAAAAGQAAABkAAAAAAAAABcAAAAUAAAAAAAAAAAAAAD/fwAA/38AAAAAAAAJAAAABAAAAAsAAAAeAAAAaAAAAAAAAAAAAAAAAAAAAAAAAAAAAAAAECcAABAnAAAAAAAAAAAAAAAAAAAAAAAAAAAAAAAAAAAAAAAAAAAAABQAAAAAAAAAwMD/AAAAAABkAAAAMgAAAAAAAABkAAAAAAAAAH9/fwAKAAAAIgAAABgAAAAAAAAAAAAAAAAAAAAAAAAAAAAAAAAAAAAkAAAAJAAAAAAAAAAHAAAAAAAAAAAAAAAAAAAAAAAAAAAAAAAAAAAAf39/ACUAAABYAAAAAAAAAAAAAAAAAAAAAAAAAAAAAAAAAAAAAAAAAAAAAAAAAAAAAAAAAAAAAAA/AAAAAAAAAKCGAQAAAAAAAAAAAAAAAAAMAAAAAQAAAAAAAAAAAAAAAAAAAB8AAABUAAAAu+DjBf///wEAAAAAAAAAAAAAAAAAAAAAAAAAAAAAAAAAAAAAAAAAAAAAAAJ/f38AgICAA8zMzADAwP8Af39/AAAAAAAAAAAAAAAAAAAAAAAAAAAAIQAAABgAAAAUAAAAUhgAAIsKAABWGAAAAQ0AAAAAAAAmAAAACAAAAP//////////"/>
+                <pr:smNativeData xmlns:pr="smNativeData" xmlns="smNativeData" val="SMDATA_15_7aDWaRMAAAAlAAAADQAAAA8BAAAAkAAAAEgAAACQAAAASAAAAAAAAAAAAAAAAAAAAAEAAABQAAAAAAAAAAAA4D8AAAAAAADgPwAAAAAAAOA/AAAAAAAA4D8AAAAAAADgPwAAAAAAAOA/AAAAAAAA4D8AAAAAAADgPwAAAAAAAOA/AAAAAAAA4D8CAAAAjAAAAAAAAAAAAAAAu+DjDP///wgAAAAAAAAAAAAAAAAAAAAAAAAAAAAAAAAAAAAAZAAAAAEAAABAAAAAAAAAAAAAAAAAAAAAAAAAAAAAAAAAAAAAAAAAAAAAAAAAAAAAAAAAAAAAAAAAAAAAAAAAAAAAAAAAAAAAAAAAAAAAAAAAAAAAAAAAAAAAAAAAAAAAFAAAADwAAAABAAAAAAAAAAAAAAkUAAAAAQAAABQAAAAUAAAAFAAAAAEAAAAAAAAAZAAAAGQAAAABAAAAlgAAAJYAAAAVAAAAYAAAAAAAAAAAAAAADwAAACADAAAAAAAAAAAAAAEAAACgMgAAVgcAAKr4//8BAAAAf39/AAEAAABkAAAAAAAAABQAAABAHwAAAAAAACYAAAAAAAAAwOD//wAAAAAmAAAAZAAAABYAAABMAAAAAAAAAAAAAAAEAAAAAAAAAAEAAACAgIAKAAAAACgAAAAoAAAAZAAAAGQAAAAAAAAAzMzMAAAAAABQAAAAUAAAAGQAAABkAAAAAAAAABcAAAAUAAAAAAAAAAAAAAD/fwAA/38AAAAAAAAJAAAABAAAAAsAAAAeAAAAaAAAAAAAAAAAAAAAAAAAAAAAAAAAAAAAECcAABAnAAAAAAAAAAAAAAAAAAAAAAAAAAAAAAAAAAAAAAAAAAAAABQAAAAAAAAAwMD/AAAAAABkAAAAMgAAAAAAAABkAAAAAAAAAH9/fwAKAAAAIgAAABgAAAAAAAAAAAAAAAAAAAAAAAAAAAAAAAAAAAAkAAAAJAAAAAAAAAAHAAAAAAAAAAAAAAAAAAAAAAAAAAAAAAAAAAAAf39/ACUAAABYAAAAAAAAAAAAAAAAAAAAAAAAAAAAAAAAAAAAAAAAAAAAAAAAAAAAAAAAAAAAAAA/AAAAAAAAAKCGAQAAAAAAAAAAAAAAAAAMAAAAAQAAAAAAAAAAAAAAAAAAAB8AAABUAAAAu+DjBf///wEAAAAAAAAAAAAAAAAAAAAAAAAAAAAAAAAAAAAAAAAAAAAAAAJ/f38AgICAA8zMzADAwP8Af39/AAAAAAAAAAAAAAAAAAAAAAAAAAAAIQAAABgAAAAUAAAAUhgAAIsKAABWGAAAAQ0AABAAAAAmAAAACAAAAP//////////"/>
               </a:ext>
             </a:extLst>
           </p:cNvCxnSpPr>
@@ -5967,7 +5879,7 @@
           <p:cNvGrpSpPr>
             <a:extLst>
               <a:ext uri="smNativeData">
-                <pr:smNativeData xmlns:pr="smNativeData" xmlns="smNativeData" val="SMDATA_6_AnHWaRMAAAAlAAAAAQAAAC8BAAAAkAAAAEgAAACQAAAASAAAAAAAAAAAAAAAAAAAABcAAAAUAAAAAAAAAAAAAAD/fwAA/38AAAAAAAAJAAAABAAAAAUAAAAfAAAAVAAAAAAAAAAAAAAAAAAAAAAAAAAAAAAAAAAAAAAAAAAAAAAAAAAAAAAAAAAAAAAAAAAAAAAAAAAAAAAAAAAAAAAAAAAAAAAAAAAAAAAAAAAAAAAAAAAAACEAAAAYAAAAFAAAABooAACqIAAA4TAAALQjAAAAAAAAJgAAAAgAAAD/////AAAAAA=="/>
+                <pr:smNativeData xmlns:pr="smNativeData" xmlns="smNativeData" val="SMDATA_6_7aDWaRMAAAAlAAAAAQAAAA8BAAAAkAAAAEgAAACQAAAASAAAAAAAAAAAAAAAAAAAABcAAAAUAAAAAAAAAAAAAAD/fwAA/38AAAAAAAAJAAAABAAAAA8AAAAfAAAAVAAAAAAAAAAAAAAAAAAAAAAAAAAAAAAAAAAAAAAAAAAAAAAAAAAAAAAAAAAAAAAAAAAAAAAAAAAAAAAAAAAAAAAAAAAAAAAAAAAAAAAAAAAAAAAAAAAAACEAAAAYAAAAFAAAABooAACqIAAA4TAAALQjAAAQAAAAJgAAAAgAAAD/////AAAAAA=="/>
               </a:ext>
             </a:extLst>
           </p:cNvGrpSpPr>
@@ -5987,7 +5899,7 @@
             <p:cNvSpPr txBox="1">
               <a:extLst>
                 <a:ext uri="smNativeData">
-                  <pr:smNativeData xmlns:pr="smNativeData" xmlns="smNativeData" val="SMDATA_15_AnHWaRMAAAAlAAAAEgAAAA8BAAAAkAAAAEgAAACQAAAASAAAAAAAAAABAAAAAAAAAAEAAABQAAAAAAAAAAAA4D8AAAAAAADgPwAAAAAAAOA/AAAAAAAA4D8AAAAAAADgPwAAAAAAAOA/AAAAAAAA4D8AAAAAAADgPwAAAAAAAOA/AAAAAAAA4D8CAAAAjAAAAAEAAAAAAAAAAP8AAP///wgAAAAAAAAAAAAAAAAAAAAAAAAAAAAAAAAAAAAAZAAAAAEAAABAAAAAAAAAAAAAAAAAAAAAAAAAAAAAAAAAAAAAAAAAAAAAAAAAAAAAAAAAAAAAAAAAAAAAAAAAAAAAAAAAAAAAAAAAAAAAAAAAAAAAAAAAAAAAAAAAAAAAFAAAADwAAAABAAAAAAAAAAAAAAkUAAAAAQAAABQAAAAUAAAAFAAAAAEAAAAAAAAAZAAAAGQAAAAAAAAAZAAAAGQAAAAVAAAAYAAAAAAAAAAAAAAADwAAACADAAAAAAAAAAAAAAEAAACgMgAAVgcAAKr4//8BAAAAf39/AAEAAABkAAAAAAAAABQAAABAHwAAAAAAACYAAAAAAAAAwOD//wAAAAAmAAAAZAAAABYAAABMAAAAAAAAAAAAAAAEAAAAAAAAAAEAAACAgIAKAAAAACgAAAAoAAAAZAAAAGQAAAAAAAAAzMzMAAAAAABQAAAAUAAAAGQAAABkAAAAAAAAABcAAAAUAAAAAAAAAIgDAAD/fwAA/38AAAAAAAAJAAAABAAAACMAAAAeAAAAaAAAAAAAAAAAAAAAAAAAAAAAAAAAAAAAECcAABAnAAAAAAAAAAAAAAAAAAAAAAAAAAAAAAAAAAAAAAAAAAAAABQAAAAAAAAAwMD/AAAAAABkAAAAMgAAAAAAAABkAAAAAAAAAH9/fwAKAAAAIgAAABgAAAAAAAAAAAAAAAAAAAAAAAAAAAAAAAAAAAAkAAAAJAAAAAAAAAAHAAAAAAAAAAAAAAAAAAAAAAAAAAAAAAAAAAAAf39/ACUAAABYAAAAAAAAAAAAAAAAAAAAAAAAAAAAAAAAAAAAAAAAAAAAAAAAAAAAAAAAAAAAAAA/AAAAAAAAAKCGAQAAAAAAAAAAAAAAAAAMAAAAAQAAAAAAAAAAAAAAAAAAAB8AAABUAAAAAP8AAP///wEAAAAAAAAAAAAAAAAAAAAAAAAAAAAAAAAAAAAAAAAAAAAAAAJ/f38AgICAA8zMzADAwP8Af39/AAAAAAAAAAAAAAAAAAAAAAAAAAAAIQAAABgAAAAUAAAAfigAAA4hAADhMAAAtCMAAAAAAAAmAAAACAAAAP//////////"/>
+                  <pr:smNativeData xmlns:pr="smNativeData" xmlns="smNativeData" val="SMDATA_15_7aDWaRMAAAAlAAAAEgAAAA8BAAAAkAAAAEgAAACQAAAASAAAAAAAAAABAAAAAAAAAAEAAABQAAAAAAAAAAAA4D8AAAAAAADgPwAAAAAAAOA/AAAAAAAA4D8AAAAAAADgPwAAAAAAAOA/AAAAAAAA4D8AAAAAAADgPwAAAAAAAOA/AAAAAAAA4D8CAAAAjAAAAAEAAAAAAAAAAP8AAP///wgAAAAAAAAAAAAAAAAAAAAAAAAAAAAAAAAAAAAAZAAAAAEAAABAAAAAAAAAAAAAAAAAAAAAAAAAAAAAAAAAAAAAAAAAAAAAAAAAAAAAAAAAAAAAAAAAAAAAAAAAAAAAAAAAAAAAAAAAAAAAAAAAAAAAAAAAAAAAAAAAAAAAFAAAADwAAAABAAAAAAAAAAAAAAkUAAAAAQAAABQAAAAUAAAAFAAAAAEAAAAAAAAAZAAAAGQAAAAAAAAAZAAAAGQAAAAVAAAAYAAAAAAAAAAAAAAADwAAACADAAAAAAAAAAAAAAEAAACgMgAAVgcAAKr4//8BAAAAf39/AAEAAABkAAAAAAAAABQAAABAHwAAAAAAACYAAAAAAAAAwOD//wAAAAAmAAAAZAAAABYAAABMAAAAAAAAAAAAAAAEAAAAAAAAAAEAAACAgIAKAAAAACgAAAAoAAAAZAAAAGQAAAAAAAAAzMzMAAAAAABQAAAAUAAAAGQAAABkAAAAAAAAABcAAAAUAAAAAAAAAIgDAAD/fwAA/38AAAAAAAAJAAAABAAAACMAAAAeAAAAaAAAAAAAAAAAAAAAAAAAAAAAAAAAAAAAECcAABAnAAAAAAAAAAAAAAAAAAAAAAAAAAAAAAAAAAAAAAAAAAAAABQAAAAAAAAAwMD/AAAAAABkAAAAMgAAAAAAAABkAAAAAAAAAH9/fwAKAAAAIgAAABgAAAAAAAAAAAAAAAAAAAAAAAAAAAAAAAAAAAAkAAAAJAAAAAAAAAAHAAAAAAAAAAAAAAAAAAAAAAAAAAAAAAAAAAAAf39/ACUAAABYAAAAAAAAAAAAAAAAAAAAAAAAAAAAAAAAAAAAAAAAAAAAAAAAAAAAAAAAAAAAAAA/AAAAAAAAAKCGAQAAAAAAAAAAAAAAAAAMAAAAAQAAAAAAAAAAAAAAAAAAAB8AAABUAAAAAP8AAP///wEAAAAAAAAAAAAAAAAAAAAAAAAAAAAAAAAAAAAAAAAAAAAAAAJ/f38AgICAA8zMzADAwP8Af39/AAAAAAAAAAAAAAAAAAAAAAAAAAAAIQAAABgAAAAUAAAAfigAAA4hAADhMAAAtCMAAAAAAAAmAAAACAAAAP//////////"/>
                 </a:ext>
               </a:extLst>
             </p:cNvSpPr>
@@ -6031,7 +5943,7 @@
             <p:cNvSpPr txBox="1">
               <a:extLst>
                 <a:ext uri="smNativeData">
-                  <pr:smNativeData xmlns:pr="smNativeData" xmlns="smNativeData" val="SMDATA_15_AnHWaRMAAAAlAAAAEgAAAA8BAAAAkAAAAEgAAACQAAAASAAAAAAAAAABAAAAAAAAAAEAAABQAAAAAAAAAAAA4D8AAAAAAADgPwAAAAAAAOA/AAAAAAAA4D8AAAAAAADgPwAAAAAAAOA/AAAAAAAA4D8AAAAAAADgPwAAAAAAAOA/AAAAAAAA4D8CAAAAjAAAAAEAAAAAAAAAAP8AAP///wgAAAAAAAAAAAAAAAAAAAAAAAAAAAAAAAAAAAAAZAAAAAEAAABAAAAAAAAAAAAAAAAAAAAAAAAAAAAAAAAAAAAAAAAAAAAAAAAAAAAAAAAAAAAAAAAAAAAAAAAAAAAAAAAAAAAAAAAAAAAAAAAAAAAAAAAAAAAAAAAAAAAAFAAAADwAAAABAAAAAAAAAAAAAAkUAAAAAQAAABQAAAAUAAAAFAAAAAEAAAAAAAAAZAAAAGQAAAAAAAAAZAAAAGQAAAAVAAAAYAAAAAAAAAAAAAAADwAAACADAAAAAAAAAAAAAAEAAACgMgAAVgcAAKr4//8BAAAAf39/AAEAAABkAAAAAAAAABQAAABAHwAAAAAAACYAAAAAAAAAwOD//wAAAAAmAAAAZAAAABYAAABMAAAAAAAAAAAAAAAEAAAAAAAAAAEAAACAgIAKAAAAACgAAAAoAAAAZAAAAGQAAAAAAAAAzMzMAAAAAABQAAAAUAAAAGQAAABkAAAAAAAAABcAAAAUAAAAAAAAAIgDAAD/fwAA/38AAAAAAAAJAAAABAAAAAAAAAAeAAAAaAAAAAAAAAAAAAAAAAAAAAAAAAAAAAAAECcAABAnAAAAAAAAAAAAAAAAAAAAAAAAAAAAAAAAAAAAAAAAAAAAABQAAAAAAAAAwMD/AAAAAABkAAAAMgAAAAAAAABkAAAAAAAAAH9/fwAKAAAAIgAAABgAAAAAAAAAAAAAAAAAAAAAAAAAAAAAAAAAAAAkAAAAJAAAAAAAAAAHAAAAAAAAAAAAAAAAAAAAAAAAAAAAAAAAAAAAf39/ACUAAABYAAAAAAAAAAAAAAAAAAAAAAAAAAAAAAAAAAAAAAAAAAAAAAAAAAAAAAAAAAAAAAA/AAAAAAAAAKCGAQAAAAAAAAAAAAAAAAAMAAAAAQAAAAAAAAAAAAAAAAAAAB8AAABUAAAAAP8AAP///wEAAAAAAAAAAAAAAAAAAAAAAAAAAAAAAAAAAAAAAAAAAAAAAAJ/f38AgICAA8zMzADAwP8Af39/AAAAAAAAAAAAAAAAAAAAAAAAAAAAIQAAABgAAAAUAAAAGigAAKogAAB9MAAAUCMAAAAAAAAmAAAACAAAAP//////////"/>
+                  <pr:smNativeData xmlns:pr="smNativeData" xmlns="smNativeData" val="SMDATA_15_7aDWaRMAAAAlAAAAEgAAAA8BAAAAkAAAAEgAAACQAAAASAAAAAAAAAABAAAAAAAAAAEAAABQAAAAAAAAAAAA4D8AAAAAAADgPwAAAAAAAOA/AAAAAAAA4D8AAAAAAADgPwAAAAAAAOA/AAAAAAAA4D8AAAAAAADgPwAAAAAAAOA/AAAAAAAA4D8CAAAAjAAAAAEAAAAAAAAAAP8AAP///wgAAAAAAAAAAAAAAAAAAAAAAAAAAAAAAAAAAAAAZAAAAAEAAABAAAAAAAAAAAAAAAAAAAAAAAAAAAAAAAAAAAAAAAAAAAAAAAAAAAAAAAAAAAAAAAAAAAAAAAAAAAAAAAAAAAAAAAAAAAAAAAAAAAAAAAAAAAAAAAAAAAAAFAAAADwAAAABAAAAAAAAAAAAAAkUAAAAAQAAABQAAAAUAAAAFAAAAAEAAAAAAAAAZAAAAGQAAAAAAAAAZAAAAGQAAAAVAAAAYAAAAAAAAAAAAAAADwAAACADAAAAAAAAAAAAAAEAAACgMgAAVgcAAKr4//8BAAAAf39/AAEAAABkAAAAAAAAABQAAABAHwAAAAAAACYAAAAAAAAAwOD//wAAAAAmAAAAZAAAABYAAABMAAAAAAAAAAAAAAAEAAAAAAAAAAEAAACAgIAKAAAAACgAAAAoAAAAZAAAAGQAAAAAAAAAzMzMAAAAAABQAAAAUAAAAGQAAABkAAAAAAAAABcAAAAUAAAAAAAAAIgDAAD/fwAA/38AAAAAAAAJAAAABAAAAAAAAAAeAAAAaAAAAAAAAAAAAAAAAAAAAAAAAAAAAAAAECcAABAnAAAAAAAAAAAAAAAAAAAAAAAAAAAAAAAAAAAAAAAAAAAAABQAAAAAAAAAwMD/AAAAAABkAAAAMgAAAAAAAABkAAAAAAAAAH9/fwAKAAAAIgAAABgAAAAAAAAAAAAAAAAAAAAAAAAAAAAAAAAAAAAkAAAAJAAAAAAAAAAHAAAAAAAAAAAAAAAAAAAAAAAAAAAAAAAAAAAAf39/ACUAAABYAAAAAAAAAAAAAAAAAAAAAAAAAAAAAAAAAAAAAAAAAAAAAAAAAAAAAAAAAAAAAAA/AAAAAAAAAKCGAQAAAAAAAAAAAAAAAAAMAAAAAQAAAAAAAAAAAAAAAAAAAB8AAABUAAAAAP8AAP///wEAAAAAAAAAAAAAAAAAAAAAAAAAAAAAAAAAAAAAAAAAAAAAAAJ/f38AgICAA8zMzADAwP8Af39/AAAAAAAAAAAAAAAAAAAAAAAAAAAAIQAAABgAAAAUAAAAGigAAKogAAB9MAAAUCMAAAAAAAAmAAAACAAAAP//////////"/>
                 </a:ext>
               </a:extLst>
             </p:cNvSpPr>
@@ -6076,7 +5988,7 @@
           <p:cNvCxnSpPr>
             <a:extLst>
               <a:ext uri="smNativeData">
-                <pr:smNativeData xmlns:pr="smNativeData" xmlns="smNativeData" val="SMDATA_15_AnHWaRMAAAAlAAAADQAAAA8BAAAAkAAAAEgAAACQAAAASAAAAAAAAAAAAAAAAAAAAAEAAABQAAAAAAAAAAAA4D8AAAAAAADgPwAAAAAAAOA/AAAAAAAA4D8AAAAAAADgPwAAAAAAAOA/AAAAAAAA4D8AAAAAAADgPwAAAAAAAOA/AAAAAAAA4D8CAAAAjAAAAAAAAAAAAAAAu+DjDP///wgAAAAAAAAAAAAAAAAAAAAAAAAAAAAAAAAAAAAAZAAAAAEAAABAAAAAAAAAAAAAAAAAAAAAAAAAAAAAAAAAAAAAAAAAAAAAAAAAAAAAAAAAAAAAAAAAAAAAAAAAAAAAAAAAAAAAAAAAAAAAAAAAAAAAAAAAAAAAAAAAAAAAFAAAADwAAAABAAAAAAAAAAAAAAkUAAAAAQAAABQAAAAUAAAAFAAAAAEAAAAAAAAAZAAAAGQAAAABAAAAlgAAAJYAAAAVAAAAYAAAAAAAAAAAAAAADwAAACADAAAAAAAAAAAAAAEAAACgMgAAVgcAAKr4//8BAAAAf39/AAEAAABkAAAAAAAAABQAAABAHwAAAAAAACYAAAAAAAAAwOD//wAAAAAmAAAAZAAAABYAAABMAAAAAAAAAAAAAAAEAAAAAAAAAAEAAACAgIAKAAAAACgAAAAoAAAAZAAAAGQAAAAAAAAAzMzMAAAAAABQAAAAUAAAAGQAAABkAAAAAAAAABcAAAAUAAAAAAAAAAAAAAD/fwAA/38AAAAAAAAJAAAABAAAAAAAED4eAAAAaAAAAAAAAAAAAAAAAAAAAAAAAAAAAAAAECcAABAnAAAAAAAAAAAAAAAAAAAAAAAAAAAAAAAAAAAAAAAAAAAAABQAAAAAAAAAwMD/AAAAAABkAAAAMgAAAAAAAABkAAAAAAAAAH9/fwAKAAAAIgAAABgAAAAAAAAAAAAAAAAAAAAAAAAAAAAAAAAAAAAkAAAAJAAAAAAAAAAHAAAAAAAAAAAAAAAAAAAAAAAAAAAAAAAAAAAAf39/ACUAAABYAAAAAAAAAAAAAAAAAAAAAAAAAAAAAAAAAAAAAAAAAAAAAAAAAAAAAAAAAAAAAAA/AAAAAAAAAKCGAQAAAAAAAAAAAAAAAAAMAAAAAQAAAAAAAAAAAAAAAAAAAB8AAABUAAAAu+DjBf///wEAAAAAAAAAAAAAAAAAAAAAAAAAAAAAAAAAAAAAAAAAAAAAAAJ/f38AgICAA8zMzADAwP8Af39/AAAAAAAAAAAAAAAAAAAAAAAAAAAAIQAAABgAAAAUAAAAgSsAAJoeAACEKwAAqiAAAAAAAAAmAAAACAAAAP//////////"/>
+                <pr:smNativeData xmlns:pr="smNativeData" xmlns="smNativeData" val="SMDATA_15_7aDWaRMAAAAlAAAADQAAAA8BAAAAkAAAAEgAAACQAAAASAAAAAAAAAAAAAAAAAAAAAEAAABQAAAAAAAAAAAA4D8AAAAAAADgPwAAAAAAAOA/AAAAAAAA4D8AAAAAAADgPwAAAAAAAOA/AAAAAAAA4D8AAAAAAADgPwAAAAAAAOA/AAAAAAAA4D8CAAAAjAAAAAAAAAAAAAAAu+DjDP///wgAAAAAAAAAAAAAAAAAAAAAAAAAAAAAAAAAAAAAZAAAAAEAAABAAAAAAAAAAAAAAAAAAAAAAAAAAAAAAAAAAAAAAAAAAAAAAAAAAAAAAAAAAAAAAAAAAAAAAAAAAAAAAAAAAAAAAAAAAAAAAAAAAAAAAAAAAAAAAAAAAAAAFAAAADwAAAABAAAAAAAAAAAAAAkUAAAAAQAAABQAAAAUAAAAFAAAAAEAAAAAAAAAZAAAAGQAAAABAAAAlgAAAJYAAAAVAAAAYAAAAAAAAAAAAAAADwAAACADAAAAAAAAAAAAAAEAAACgMgAAVgcAAKr4//8BAAAAf39/AAEAAABkAAAAAAAAABQAAABAHwAAAAAAACYAAAAAAAAAwOD//wAAAAAmAAAAZAAAABYAAABMAAAAAAAAAAAAAAAEAAAAAAAAAAEAAACAgIAKAAAAACgAAAAoAAAAZAAAAGQAAAAAAAAAzMzMAAAAAABQAAAAUAAAAGQAAABkAAAAAAAAABcAAAAUAAAAAAAAAAAAAAD/fwAA/38AAAAAAAAJAAAABAAAAAAAED4eAAAAaAAAAAAAAAAAAAAAAAAAAAAAAAAAAAAAECcAABAnAAAAAAAAAAAAAAAAAAAAAAAAAAAAAAAAAAAAAAAAAAAAABQAAAAAAAAAwMD/AAAAAABkAAAAMgAAAAAAAABkAAAAAAAAAH9/fwAKAAAAIgAAABgAAAAAAAAAAAAAAAAAAAAAAAAAAAAAAAAAAAAkAAAAJAAAAAAAAAAHAAAAAAAAAAAAAAAAAAAAAAAAAAAAAAAAAAAAf39/ACUAAABYAAAAAAAAAAAAAAAAAAAAAAAAAAAAAAAAAAAAAAAAAAAAAAAAAAAAAAAAAAAAAAA/AAAAAAAAAKCGAQAAAAAAAAAAAAAAAAAMAAAAAQAAAAAAAAAAAAAAAAAAAB8AAABUAAAAu+DjBf///wEAAAAAAAAAAAAAAAAAAAAAAAAAAAAAAAAAAAAAAAAAAAAAAAJ/f38AgICAA8zMzADAwP8Af39/AAAAAAAAAAAAAAAAAAAAAAAAAAAAIQAAABgAAAAUAAAAgSsAAJoeAACEKwAAqiAAABAAAAAmAAAACAAAAP//////////"/>
               </a:ext>
             </a:extLst>
           </p:cNvCxnSpPr>
@@ -6109,7 +6021,7 @@
             <a:stCxn id="21" idx="2"/>
             <a:extLst>
               <a:ext uri="smNativeData">
-                <pr:smNativeData xmlns:pr="smNativeData" xmlns="smNativeData" val="SMDATA_15_AnHWaRMAAAAlAAAADQAAAA8BAAAAkAAAAEgAAACQAAAASAAAAAAAAAAAAAAAAAAAAAEAAABQAAAAAAAAAAAA4D8AAAAAAADgPwAAAAAAAOA/AAAAAAAA4D8AAAAAAADgPwAAAAAAAOA/AAAAAAAA4D8AAAAAAADgPwAAAAAAAOA/AAAAAAAA4D8CAAAAjAAAAAAAAAAAAAAAu+DjDP///wgAAAAAAAAAAAAAAAAAAAAAAAAAAAAAAAAAAAAAZAAAAAEAAABAAAAAAAAAAAAAAAAAAAAAAAAAAAAAAAAAAAAAAAAAAAAAAAAAAAAAAAAAAAAAAAAAAAAAAAAAAAAAAAAAAAAAAAAAAAAAAAAAAAAAAAAAAAAAAAAAAAAAFAAAADwAAAABAAAAAAAAAAAAAAkUAAAAAQAAABQAAAAUAAAAFAAAAAEAAAAAAAAAZAAAAGQAAAABAAAAlgAAAJYAAAAVAAAAYAAAAAAAAAAAAAAADwAAACADAAAAAAAAAAAAAAEAAACgMgAAVgcAAKr4//8BAAAAf39/AAEAAABkAAAAAAAAABQAAABAHwAAAAAAACYAAAAAAAAAwOD//wAAAAAmAAAAZAAAABYAAABMAAAAAAAAAAAAAAAEAAAAAAAAAAEAAACAgIAKAAAAACgAAAAoAAAAZAAAAGQAAAAAAAAAzMzMAAAAAABQAAAAUAAAAGQAAABkAAAAAAAAABcAAAAUAAAAAAAAAAAAAAD/fwAA/38AAAAAAAAJAAAABAAAAAAAAAAeAAAAaAAAAAAAAAAAAAAAAAAAAAAAAAAAAAAAECcAABAnAAAAAAAAAAAAAAAAAAAAAAAAAAAAAAAAAAAAAAAAAAAAABQAAAAAAAAAwMD/AAAAAABkAAAAMgAAAAAAAABkAAAAAAAAAH9/fwAKAAAAIgAAABgAAAAAAAAAAAAAAAAAAAAAAAAAAAAAAAAAAAAkAAAAJAAAAAAAAAAHAAAAAAAAAAAAAAAAAAAAAAAAAAAAAAAAAAAAf39/ACUAAABYAAAAAAAAAAAAAAAAAAAAAAAAAAAAAAAAAAAAAAAAAAAAAAAAAAAAAAAAAAAAAAA/AAAAAAAAAKCGAQAAAAAAAAAAAAAAAAAMAAAAAQAAAAAAAAAAAAAAAAAAAB8AAABUAAAAu+DjBf///wEAAAAAAAAAAAAAAAAAAAAAAAAAAAAAAAAAAAAAAAAAAAAAAAJ/f38AgICAA8zMzADAwP8Af39/AAAAAAAAAAAAAAAAAAAAAAAAAAAAIQAAABgAAAAUAAAAqBEAAHEeAACpEQAAaiAAAAAAAAAmAAAACAAAAP//////////"/>
+                <pr:smNativeData xmlns:pr="smNativeData" xmlns="smNativeData" val="SMDATA_15_7aDWaRMAAAAlAAAADQAAAA8BAAAAkAAAAEgAAACQAAAASAAAAAAAAAAAAAAAAAAAAAEAAABQAAAAAAAAAAAA4D8AAAAAAADgPwAAAAAAAOA/AAAAAAAA4D8AAAAAAADgPwAAAAAAAOA/AAAAAAAA4D8AAAAAAADgPwAAAAAAAOA/AAAAAAAA4D8CAAAAjAAAAAAAAAAAAAAAu+DjDP///wgAAAAAAAAAAAAAAAAAAAAAAAAAAAAAAAAAAAAAZAAAAAEAAABAAAAAAAAAAAAAAAAAAAAAAAAAAAAAAAAAAAAAAAAAAAAAAAAAAAAAAAAAAAAAAAAAAAAAAAAAAAAAAAAAAAAAAAAAAAAAAAAAAAAAAAAAAAAAAAAAAAAAFAAAADwAAAABAAAAAAAAAAAAAAkUAAAAAQAAABQAAAAUAAAAFAAAAAEAAAAAAAAAZAAAAGQAAAABAAAAlgAAAJYAAAAVAAAAYAAAAAAAAAAAAAAADwAAACADAAAAAAAAAAAAAAEAAACgMgAAVgcAAKr4//8BAAAAf39/AAEAAABkAAAAAAAAABQAAABAHwAAAAAAACYAAAAAAAAAwOD//wAAAAAmAAAAZAAAABYAAABMAAAAAAAAAAAAAAAEAAAAAAAAAAEAAACAgIAKAAAAACgAAAAoAAAAZAAAAGQAAAAAAAAAzMzMAAAAAABQAAAAUAAAAGQAAABkAAAAAAAAABcAAAAUAAAAAAAAAAAAAAD/fwAA/38AAAAAAAAJAAAABAAAAAAAAAAeAAAAaAAAAAAAAAAAAAAAAAAAAAAAAAAAAAAAECcAABAnAAAAAAAAAAAAAAAAAAAAAAAAAAAAAAAAAAAAAAAAAAAAABQAAAAAAAAAwMD/AAAAAABkAAAAMgAAAAAAAABkAAAAAAAAAH9/fwAKAAAAIgAAABgAAAAAAAAAAAAAAAAAAAAAAAAAAAAAAAAAAAAkAAAAJAAAAAAAAAAHAAAAAAAAAAAAAAAAAAAAAAAAAAAAAAAAAAAAf39/ACUAAABYAAAAAAAAAAAAAAAAAAAAAAAAAAAAAAAAAAAAAAAAAAAAAAAAAAAAAAAAAAAAAAA/AAAAAAAAAKCGAQAAAAAAAAAAAAAAAAAMAAAAAQAAAAAAAAAAAAAAAAAAAB8AAABUAAAAu+DjBf///wEAAAAAAAAAAAAAAAAAAAAAAAAAAAAAAAAAAAAAAAAAAAAAAAJ/f38AgICAA8zMzADAwP8Af39/AAAAAAAAAAAAAAAAAAAAAAAAAAAAIQAAABgAAAAUAAAAqBEAAHEeAACpEQAAaiAAABAAAAAmAAAACAAAAP//////////"/>
               </a:ext>
             </a:extLst>
           </p:cNvCxnSpPr>
@@ -6141,7 +6053,7 @@
           <p:cNvCxnSpPr>
             <a:extLst>
               <a:ext uri="smNativeData">
-                <pr:smNativeData xmlns:pr="smNativeData" xmlns="smNativeData" val="SMDATA_15_AnHWaRMAAAAlAAAADQAAAA8BAAAAkAAAAEgAAACQAAAASAAAAAAAAAAAAAAAAAAAAAEAAABQAAAAAAAAAAAA4D8AAAAAAADgPwAAAAAAAOA/AAAAAAAA4D8AAAAAAADgPwAAAAAAAOA/AAAAAAAA4D8AAAAAAADgPwAAAAAAAOA/AAAAAAAA4D8CAAAAjAAAAAAAAAAAAAAAu+DjDP///wgAAAAAAAAAAAAAAAAAAAAAAAAAAAAAAAAAAAAAZAAAAAEAAABAAAAAAAAAAAAAAAAAAAAAAAAAAAAAAAAAAAAAAAAAAAAAAAAAAAAAAAAAAAAAAAAAAAAAAAAAAAAAAAAAAAAAAAAAAAAAAAAAAAAAAAAAAAAAAAAAAAAAFAAAADwAAAABAAAAAAAAAAAAAAkUAAAAAQAAABQAAAAUAAAAFAAAAAEAAAAAAAAAZAAAAGQAAAABAAAAlgAAAJYAAAAVAAAAYAAAAAAAAAAAAAAADwAAACADAAAAAAAAAAAAAAEAAACgMgAAVgcAAKr4//8BAAAAf39/AAEAAABkAAAAAAAAABQAAABAHwAAAAAAACYAAAAAAAAAwOD//wAAAAAmAAAAZAAAABYAAABMAAAAAAAAAAAAAAAEAAAAAAAAAAEAAACAgIAKAAAAACgAAAAoAAAAZAAAAGQAAAAAAAAAzMzMAAAAAABQAAAAUAAAAGQAAABkAAAAAAAAABcAAAAUAAAAAAAAAAAAAAD/fwAA/38AAAAAAAAJAAAABAAAAAAAAAAeAAAAaAAAAAAAAAAAAAAAAAAAAAAAAAAAAAAAECcAABAnAAAAAAAAAAAAAAAAAAAAAAAAAAAAAAAAAAAAAAAAAAAAABQAAAAAAAAAwMD/AAAAAABkAAAAMgAAAAAAAABkAAAAAAAAAH9/fwAKAAAAIgAAABgAAAAAAAAAAAAAAAAAAAAAAAAAAAAAAAAAAAAkAAAAJAAAAAAAAAAHAAAAAAAAAAAAAAAAAAAAAAAAAAAAAAAAAAAAf39/ACUAAABYAAAAAAAAAAAAAAAAAAAAAAAAAAAAAAAAAAAAAAAAAAAAAAAAAAAAAAAAAAAAAAA/AAAAAAAAAKCGAQAAAAAAAAAAAAAAAAAMAAAAAQAAAAAAAAAAAAAAAAAAAB8AAABUAAAAu+DjBf///wEAAAAAAAAAAAAAAAAAAAAAAAAAAAAAAAAAAAAAAAAAAAAAAAJ/f38AgICAA8zMzADAwP8Af39/AAAAAAAAAAAAAAAAAAAAAAAAAAAAIQAAABgAAAAUAAAAqBEAABAjAACpEQAAqCQAAAAAAAAmAAAACAAAAP//////////"/>
+                <pr:smNativeData xmlns:pr="smNativeData" xmlns="smNativeData" val="SMDATA_15_7aDWaRMAAAAlAAAADQAAAA8BAAAAkAAAAEgAAACQAAAASAAAAAAAAAAAAAAAAAAAAAEAAABQAAAAAAAAAAAA4D8AAAAAAADgPwAAAAAAAOA/AAAAAAAA4D8AAAAAAADgPwAAAAAAAOA/AAAAAAAA4D8AAAAAAADgPwAAAAAAAOA/AAAAAAAA4D8CAAAAjAAAAAAAAAAAAAAAu+DjDP///wgAAAAAAAAAAAAAAAAAAAAAAAAAAAAAAAAAAAAAZAAAAAEAAABAAAAAAAAAAAAAAAAAAAAAAAAAAAAAAAAAAAAAAAAAAAAAAAAAAAAAAAAAAAAAAAAAAAAAAAAAAAAAAAAAAAAAAAAAAAAAAAAAAAAAAAAAAAAAAAAAAAAAFAAAADwAAAABAAAAAAAAAAAAAAkUAAAAAQAAABQAAAAUAAAAFAAAAAEAAAAAAAAAZAAAAGQAAAABAAAAlgAAAJYAAAAVAAAAYAAAAAAAAAAAAAAADwAAACADAAAAAAAAAAAAAAEAAACgMgAAVgcAAKr4//8BAAAAf39/AAEAAABkAAAAAAAAABQAAABAHwAAAAAAACYAAAAAAAAAwOD//wAAAAAmAAAAZAAAABYAAABMAAAAAAAAAAAAAAAEAAAAAAAAAAEAAACAgIAKAAAAACgAAAAoAAAAZAAAAGQAAAAAAAAAzMzMAAAAAABQAAAAUAAAAGQAAABkAAAAAAAAABcAAAAUAAAAAAAAAAAAAAD/fwAA/38AAAAAAAAJAAAABAAAAAAAAAAeAAAAaAAAAAAAAAAAAAAAAAAAAAAAAAAAAAAAECcAABAnAAAAAAAAAAAAAAAAAAAAAAAAAAAAAAAAAAAAAAAAAAAAABQAAAAAAAAAwMD/AAAAAABkAAAAMgAAAAAAAABkAAAAAAAAAH9/fwAKAAAAIgAAABgAAAAAAAAAAAAAAAAAAAAAAAAAAAAAAAAAAAAkAAAAJAAAAAAAAAAHAAAAAAAAAAAAAAAAAAAAAAAAAAAAAAAAAAAAf39/ACUAAABYAAAAAAAAAAAAAAAAAAAAAAAAAAAAAAAAAAAAAAAAAAAAAAAAAAAAAAAAAAAAAAA/AAAAAAAAAKCGAQAAAAAAAAAAAAAAAAAMAAAAAQAAAAAAAAAAAAAAAAAAAB8AAABUAAAAu+DjBf///wEAAAAAAAAAAAAAAAAAAAAAAAAAAAAAAAAAAAAAAAAAAAAAAAJ/f38AgICAA8zMzADAwP8Af39/AAAAAAAAAAAAAAAAAAAAAAAAAAAAIQAAABgAAAAUAAAAqBEAABAjAACpEQAAqCQAABAAAAAmAAAACAAAAP//////////"/>
               </a:ext>
             </a:extLst>
           </p:cNvCxnSpPr>
@@ -6173,7 +6085,7 @@
           <p:cNvSpPr txBox="1">
             <a:extLst>
               <a:ext uri="smNativeData">
-                <pr:smNativeData xmlns:pr="smNativeData" xmlns="smNativeData" val="SMDATA_15_AnHWaRMAAAAlAAAAEgAAAE8BAAAAkAAAAEgAAACQAAAASAAAAAAAAAAAAAAAAAAAAAEAAABQAAAAAAAAAAAA4D8AAAAAAADgPwAAAAAAAOA/AAAAAAAA4D8AAAAAAADgPwAAAAAAAOA/AAAAAAAA4D8AAAAAAADgPwAAAAAAAOA/AAAAAAAA4D8CAAAAjAAAAAAAAAAAAAAAu+DjDP///wgAAAAAAAAAAAAAAAAAAAAAAAAAAAAAAAAAAAAAZAAAAAEAAABAAAAAAAAAAAAAAAAAAAAAAAAAAAAAAAAAAAAAAAAAAAAAAAAAAAAAAAAAAAAAAAAAAAAAAAAAAAAAAAAAAAAAAAAAAAAAAAAAAAAAAAAAAAAAAAAAAAAAFAAAADwAAAAAAAAAAAAAAAAAAAkUAAAAAQAAABQAAAAUAAAAFAAAAAEAAAAAAAAAZAAAAGQAAAAAAAAAZAAAAGQAAAAVAAAAYAAAAAAAAAAAAAAADwAAACADAAAAAAAAAAAAAAEAAACgMgAAVgcAAKr4//8BAAAAf39/AAEAAABkAAAAAAAAABQAAABAHwAAAAAAACYAAAAAAAAAwOD//wAAAAAmAAAAZAAAABYAAABMAAAAAAAAAAAAAAAEAAAAAAAAAAEAAACAgIAKAAAAACgAAAAoAAAAZAAAAGQAAAAAAAAAzMzMAAAAAABQAAAAUAAAAGQAAABkAAAAAAAAABcAAAAUAAAAAAAAANwIAAD/fwAA/38AAAAAAAAJAAAABAAAAAAAAAAeAAAAaAAAAAAAAAAAAAAAAAAAAAAAAAAAAAAAECcAABAnAAAAAAAAAAAAAAAAAAAAAAAAAAAAAAAAAAAAAAAAAAAAABQAAAAAAAAAwMD/AAAAAABkAAAAMgAAAAAAAABkAAAAAAAAAH9/fwAKAAAAIgAAABgAAAAAAAAAAAAAAAAAAAAAAAAAAAAAAAAAAAAkAAAAJAAAAAAAAAAHAAAAAAAAAAAAAAAAAAAAAAAAAAAAAAAAAAAAf39/ACUAAABYAAAAAAAAAAAAAAAAAAAAAAAAAAAAAAAAAAAAAAAAAAAAAAAAAAAAAAAAAAAAAAA/AAAAAAAAAKCGAQAAAAAAAAAAAAAAAAAMAAAAAQAAAAAAAAAAAAAAAAAAAB8AAABUAAAAu+DjBf///wEAAAAAAAAAAAAAAAAAAAAAAAAAAAAAAAAAAAAAAAAAAAAAAAJ/f38AgICAA8zMzADAwP8Af39/AAAAAAAAAAAAAAAAAAAAAAAAAAAAIQAAABgAAAAUAAAAXD8AAFQiAAA4SAAAZCcAAAAgAAAmAAAACAAAAP//////////"/>
+                <pr:smNativeData xmlns:pr="smNativeData" xmlns="smNativeData" val="SMDATA_15_7aDWaRMAAAAlAAAAEgAAAE8BAAAAkAAAAEgAAACQAAAASAAAAAAAAAAAAAAAAAAAAAEAAABQAAAAAAAAAAAA4D8AAAAAAADgPwAAAAAAAOA/AAAAAAAA4D8AAAAAAADgPwAAAAAAAOA/AAAAAAAA4D8AAAAAAADgPwAAAAAAAOA/AAAAAAAA4D8CAAAAjAAAAAAAAAAAAAAAu+DjDP///wgAAAAAAAAAAAAAAAAAAAAAAAAAAAAAAAAAAAAAZAAAAAEAAABAAAAAAAAAAAAAAAAAAAAAAAAAAAAAAAAAAAAAAAAAAAAAAAAAAAAAAAAAAAAAAAAAAAAAAAAAAAAAAAAAAAAAAAAAAAAAAAAAAAAAAAAAAAAAAAAAAAAAFAAAADwAAAAAAAAAAAAAAAAAAAkUAAAAAQAAABQAAAAUAAAAFAAAAAEAAAAAAAAAZAAAAGQAAAAAAAAAZAAAAGQAAAAVAAAAYAAAAAAAAAAAAAAADwAAACADAAAAAAAAAAAAAAEAAACgMgAAVgcAAKr4//8BAAAAf39/AAEAAABkAAAAAAAAABQAAABAHwAAAAAAACYAAAAAAAAAwOD//wAAAAAmAAAAZAAAABYAAABMAAAAAAAAAAAAAAAEAAAAAAAAAAEAAACAgIAKAAAAACgAAAAoAAAAZAAAAGQAAAAAAAAAzMzMAAAAAABQAAAAUAAAAGQAAABkAAAAAAAAABcAAAAUAAAAAAAAANwIAAD/fwAA/38AAAAAAAAJAAAABAAAAAAAAAAeAAAAaAAAAAAAAAAAAAAAAAAAAAAAAAAAAAAAECcAABAnAAAAAAAAAAAAAAAAAAAAAAAAAAAAAAAAAAAAAAAAAAAAABQAAAAAAAAAwMD/AAAAAABkAAAAMgAAAAAAAABkAAAAAAAAAH9/fwAKAAAAIgAAABgAAAAAAAAAAAAAAAAAAAAAAAAAAAAAAAAAAAAkAAAAJAAAAAAAAAAHAAAAAAAAAAAAAAAAAAAAAAAAAAAAAAAAAAAAf39/ACUAAABYAAAAAAAAAAAAAAAAAAAAAAAAAAAAAAAAAAAAAAAAAAAAAAAAAAAAAAAAAAAAAAA/AAAAAAAAAKCGAQAAAAAAAAAAAAAAAAAMAAAAAQAAAAAAAAAAAAAAAAAAAB8AAABUAAAAu+DjBf///wEAAAAAAAAAAAAAAAAAAAAAAAAAAAAAAAAAAAAAAAAAAAAAAAJ/f38AgICAA8zMzADAwP8Af39/AAAAAAAAAAAAAAAAAAAAAAAAAAAAIQAAABgAAAAUAAAAXD8AAFQiAAA4SAAAZCcAABAgAAAmAAAACAAAAP//////////"/>
               </a:ext>
             </a:extLst>
           </p:cNvSpPr>
@@ -6212,7 +6124,7 @@
           <p:cNvSpPr txBox="1">
             <a:extLst>
               <a:ext uri="smNativeData">
-                <pr:smNativeData xmlns:pr="smNativeData" xmlns="smNativeData" val="SMDATA_15_AnHWaRMAAAAlAAAAEgAAAE8BAAAAkAAAAEgAAACQAAAASAAAAAAAAAAAAAAAAAAAAAEAAABQAAAAAAAAAAAA4D8AAAAAAADgPwAAAAAAAOA/AAAAAAAA4D8AAAAAAADgPwAAAAAAAOA/AAAAAAAA4D8AAAAAAADgPwAAAAAAAOA/AAAAAAAA4D8CAAAAjAAAAAAAAAAAAAAAu+DjDP///wgAAAAAAAAAAAAAAAAAAAAAAAAAAAAAAAAAAAAAZAAAAAEAAABAAAAAAAAAAAAAAAAAAAAAAAAAAAAAAAAAAAAAAAAAAAAAAAAAAAAAAAAAAAAAAAAAAAAAAAAAAAAAAAAAAAAAAAAAAAAAAAAAAAAAAAAAAAAAAAAAAAAAFAAAADwAAAAAAAAAAAAAAAAAAAkUAAAAAQAAABQAAAAUAAAAFAAAAAEAAAAAAAAAZAAAAGQAAAAAAAAAZAAAAGQAAAAVAAAAYAAAAAAAAAAAAAAADwAAACADAAAAAAAAAAAAAAEAAACgMgAAVgcAAKr4//8BAAAAf39/AAEAAABkAAAAAAAAABQAAABAHwAAAAAAACYAAAAAAAAAwOD//wAAAAAmAAAAZAAAABYAAABMAAAAAAAAAAAAAAAEAAAAAAAAAAEAAACAgIAKAAAAACgAAAAoAAAAZAAAAGQAAAAAAAAAzMzMAAAAAABQAAAAUAAAAGQAAABkAAAAAAAAABcAAAAUAAAAAAAAANwIAAD/fwAA/38AAAAAAAAJAAAABAAAACMAAAAeAAAAaAAAAAAAAAAAAAAAAAAAAAAAAAAAAAAAECcAABAnAAAAAAAAAAAAAAAAAAAAAAAAAAAAAAAAAAAAAAAAAAAAABQAAAAAAAAAwMD/AAAAAABkAAAAMgAAAAAAAABkAAAAAAAAAH9/fwAKAAAAIgAAABgAAAAAAAAAAAAAAAAAAAAAAAAAAAAAAAAAAAAkAAAAJAAAAAAAAAAHAAAAAAAAAAAAAAAAAAAAAAAAAAAAAAAAAAAAf39/ACUAAABYAAAAAAAAAAAAAAAAAAAAAAAAAAAAAAAAAAAAAAAAAAAAAAAAAAAAAAAAAAAAAAA/AAAAAAAAAKCGAQAAAAAAAAAAAAAAAAAMAAAAAQAAAAAAAAAAAAAAAAAAAB8AAABUAAAAu+DjBf///wEAAAAAAAAAAAAAAAAAAAAAAAAAAAAAAAAAAAAAAAAAAAAAAAJ/f38AgICAA8zMzADAwP8Af39/AAAAAAAAAAAAAAAAAAAAAAAAAAAAIQAAABgAAAAUAAAAOQEAAM4iAADRCwAA3icAAAAgAAAmAAAACAAAAP//////////"/>
+                <pr:smNativeData xmlns:pr="smNativeData" xmlns="smNativeData" val="SMDATA_15_7aDWaRMAAAAlAAAAEgAAAE8BAAAAkAAAAEgAAACQAAAASAAAAAAAAAAAAAAAAAAAAAEAAABQAAAAAAAAAAAA4D8AAAAAAADgPwAAAAAAAOA/AAAAAAAA4D8AAAAAAADgPwAAAAAAAOA/AAAAAAAA4D8AAAAAAADgPwAAAAAAAOA/AAAAAAAA4D8CAAAAjAAAAAAAAAAAAAAAu+DjDP///wgAAAAAAAAAAAAAAAAAAAAAAAAAAAAAAAAAAAAAZAAAAAEAAABAAAAAAAAAAAAAAAAAAAAAAAAAAAAAAAAAAAAAAAAAAAAAAAAAAAAAAAAAAAAAAAAAAAAAAAAAAAAAAAAAAAAAAAAAAAAAAAAAAAAAAAAAAAAAAAAAAAAAFAAAADwAAAAAAAAAAAAAAAAAAAkUAAAAAQAAABQAAAAUAAAAFAAAAAEAAAAAAAAAZAAAAGQAAAAAAAAAZAAAAGQAAAAVAAAAYAAAAAAAAAAAAAAADwAAACADAAAAAAAAAAAAAAEAAACgMgAAVgcAAKr4//8BAAAAf39/AAEAAABkAAAAAAAAABQAAABAHwAAAAAAACYAAAAAAAAAwOD//wAAAAAmAAAAZAAAABYAAABMAAAAAAAAAAAAAAAEAAAAAAAAAAEAAACAgIAKAAAAACgAAAAoAAAAZAAAAGQAAAAAAAAAzMzMAAAAAABQAAAAUAAAAGQAAABkAAAAAAAAABcAAAAUAAAAAAAAANwIAAD/fwAA/38AAAAAAAAJAAAABAAAACMAAAAeAAAAaAAAAAAAAAAAAAAAAAAAAAAAAAAAAAAAECcAABAnAAAAAAAAAAAAAAAAAAAAAAAAAAAAAAAAAAAAAAAAAAAAABQAAAAAAAAAwMD/AAAAAABkAAAAMgAAAAAAAABkAAAAAAAAAH9/fwAKAAAAIgAAABgAAAAAAAAAAAAAAAAAAAAAAAAAAAAAAAAAAAAkAAAAJAAAAAAAAAAHAAAAAAAAAAAAAAAAAAAAAAAAAAAAAAAAAAAAf39/ACUAAABYAAAAAAAAAAAAAAAAAAAAAAAAAAAAAAAAAAAAAAAAAAAAAAAAAAAAAAAAAAAAAAA/AAAAAAAAAKCGAQAAAAAAAAAAAAAAAAAMAAAAAQAAAAAAAAAAAAAAAAAAAB8AAABUAAAAu+DjBf///wEAAAAAAAAAAAAAAAAAAAAAAAAAAAAAAAAAAAAAAAAAAAAAAAJ/f38AgICAA8zMzADAwP8Af39/AAAAAAAAAAAAAAAAAAAAAAAAAAAAIQAAABgAAAAUAAAAOQEAAM4iAADRCwAA3icAABAgAAAmAAAACAAAAP//////////"/>
               </a:ext>
             </a:extLst>
           </p:cNvSpPr>
@@ -6251,7 +6163,7 @@
           <p:cNvCxnSpPr>
             <a:extLst>
               <a:ext uri="smNativeData">
-                <pr:smNativeData xmlns:pr="smNativeData" xmlns="smNativeData" val="SMDATA_15_AnHWaRMAAAAlAAAADwAAAA8BAAAAkAAAAEgAAACQAAAASAAAAAAAAAAAAAAAAAAAAAEAAABQAAAAa6211lprGcAAAAAAAADgPwAAAAAAAOA/AAAAAAAA4D8AAAAAAADgPwAAAAAAAOA/AAAAAAAA4D8AAAAAAADgPwAAAAAAAOA/AAAAAAAA4D8CAAAAjAAAAAAAAAAAAAAAu+DjDP///wgAAAAAAAAAAAAAAAAAAAAAAAAAAAAAAAAAAAAAZAAAAAEAAABAAAAAAAAAAAAAAAAAAAAAAAAAAAAAAAAAAAAAAAAAAAAAAAAAAAAAAAAAAAAAAAAAAAAAAAAAAAAAAAAAAAAAAAAAAAAAAAAAAAAAAAAAAAAAAAAAAAAAFAAAADwAAAABAAAAAQAAAAAAAAkUAAAAAQAAABQAAAAUAAAAFAAAAAEAAAAAAAAAZAAAAGQAAAABAAAAlgAAAJYAAAAVAAAAYAAAAAAAAAAAAAAADwAAACADAAAAAAAAAAAAAAEAAACgMgAAVgcAAKr4//8BAAAAf39/AAEAAABkAAAAAAAAABQAAABAHwAAAAAAACYAAAAAAAAAwOD//wAAAAAmAAAAZAAAABYAAABMAAAAAAAAAAAAAAAEAAAAAAAAAAEAAACAgIAKAAAAACgAAAAoAAAAZAAAAGQAAAAAAAAAzMzMAAAAAABQAAAAUAAAAGQAAABkAAAAAAAAABcAAAAUAAAAAAAAAAAAAAD/fwAA/38AAAAAAAAJAAAABAAAAAAAAAAeAAAAaAAAAAAAAAAAAAAAAAAAAAAAAAAAAAAAECcAABAnAAAAAAAAAAAAAAAAAAAAAAAAAAAAAAAAAAAAAAAAAAAAABQAAAAAAAAAwMD/AAAAAABkAAAAMgAAAAAAAABkAAAAAAAAAH9/fwAKAAAAIgAAABgAAAAAAAAAAAAAAAAAAAAAAAAAAAAAAAAAAAAkAAAAJAAAAAAAAAAHAAAAAAAAAAAAAAAAAAAAAAAAAAAAAAAAAAAAf39/ACUAAABYAAAAAAAAAAAAAAAAAAAAAAAAAAAAAAAAAAAAAAAAAAAAAAAAAAAAAAAAAAAAAAA/AAAAAAAAAKCGAQAAAAAAAAAAAAAAAAAMAAAAAQAAAAAAAAAAAAAAAAAAAB8AAABUAAAAu+DjBf///wEAAAAAAAAAAAAAAAAAAAAAAAAAAAAAAAAAAAAAAAAAAAAAAAJ/f38AgICAA8zMzADAwP8Af39/AAAAAAAAAAAAAAAAAAAAAAAAAAAAIQAAABgAAAAUAAAA2RUAAL0hAAB0FgAAdCYAAAAAAAAmAAAACAAAAP//////////"/>
+                <pr:smNativeData xmlns:pr="smNativeData" xmlns="smNativeData" val="SMDATA_15_7aDWaRMAAAAlAAAADwAAAA8BAAAAkAAAAEgAAACQAAAASAAAAAAAAAAAAAAAAAAAAAEAAABQAAAAa6211lprGcAAAAAAAADgPwAAAAAAAOA/AAAAAAAA4D8AAAAAAADgPwAAAAAAAOA/AAAAAAAA4D8AAAAAAADgPwAAAAAAAOA/AAAAAAAA4D8CAAAAjAAAAAAAAAAAAAAAu+DjDP///wgAAAAAAAAAAAAAAAAAAAAAAAAAAAAAAAAAAAAAZAAAAAEAAABAAAAAAAAAAAAAAAAAAAAAAAAAAAAAAAAAAAAAAAAAAAAAAAAAAAAAAAAAAAAAAAAAAAAAAAAAAAAAAAAAAAAAAAAAAAAAAAAAAAAAAAAAAAAAAAAAAAAAFAAAADwAAAABAAAAAQAAAAAAAAkUAAAAAQAAABQAAAAUAAAAFAAAAAEAAAAAAAAAZAAAAGQAAAABAAAAlgAAAJYAAAAVAAAAYAAAAAAAAAAAAAAADwAAACADAAAAAAAAAAAAAAEAAACgMgAAVgcAAKr4//8BAAAAf39/AAEAAABkAAAAAAAAABQAAABAHwAAAAAAACYAAAAAAAAAwOD//wAAAAAmAAAAZAAAABYAAABMAAAAAAAAAAAAAAAEAAAAAAAAAAEAAACAgIAKAAAAACgAAAAoAAAAZAAAAGQAAAAAAAAAzMzMAAAAAABQAAAAUAAAAGQAAABkAAAAAAAAABcAAAAUAAAAAAAAAAAAAAD/fwAA/38AAAAAAAAJAAAABAAAAAAAAAAeAAAAaAAAAAAAAAAAAAAAAAAAAAAAAAAAAAAAECcAABAnAAAAAAAAAAAAAAAAAAAAAAAAAAAAAAAAAAAAAAAAAAAAABQAAAAAAAAAwMD/AAAAAABkAAAAMgAAAAAAAABkAAAAAAAAAH9/fwAKAAAAIgAAABgAAAAAAAAAAAAAAAAAAAAAAAAAAAAAAAAAAAAkAAAAJAAAAAAAAAAHAAAAAAAAAAAAAAAAAAAAAAAAAAAAAAAAAAAAf39/ACUAAABYAAAAAAAAAAAAAAAAAAAAAAAAAAAAAAAAAAAAAAAAAAAAAAAAAAAAAAAAAAAAAAA/AAAAAAAAAKCGAQAAAAAAAAAAAAAAAAAMAAAAAQAAAAAAAAAAAAAAAAAAAB8AAABUAAAAu+DjBf///wEAAAAAAAAAAAAAAAAAAAAAAAAAAAAAAAAAAAAAAAAAAAAAAAJ/f38AgICAA8zMzADAwP8Af39/AAAAAAAAAAAAAAAAAAAAAAAAAAAAIQAAABgAAAAUAAAA2RUAAL0hAAB0FgAAdCYAABAAAAAmAAAACAAAAP//////////"/>
               </a:ext>
             </a:extLst>
           </p:cNvCxnSpPr>
@@ -7078,6 +6990,47 @@
       </a:clrScheme>
       <a:clrMap bg1="lt1" tx1="dk1" bg2="lt2" tx2="dk2" accent1="accent1" accent2="accent2" accent3="accent3" accent4="accent4" accent5="accent5" accent6="accent6" hlink="hlink" folHlink="folHlink"/>
     </a:extraClrScheme>
+    <a:extraClrScheme>
+      <a:clrScheme name="Presentation 14">
+        <a:dk1>
+          <a:srgbClr val="000000"/>
+        </a:dk1>
+        <a:lt1>
+          <a:srgbClr val="FFFFFF"/>
+        </a:lt1>
+        <a:dk2>
+          <a:srgbClr val="000000"/>
+        </a:dk2>
+        <a:lt2>
+          <a:srgbClr val="808080"/>
+        </a:lt2>
+        <a:accent1>
+          <a:srgbClr val="BBE0E3"/>
+        </a:accent1>
+        <a:accent2>
+          <a:srgbClr val="333399"/>
+        </a:accent2>
+        <a:accent3>
+          <a:srgbClr val="535379"/>
+        </a:accent3>
+        <a:accent4>
+          <a:srgbClr val="737359"/>
+        </a:accent4>
+        <a:accent5>
+          <a:srgbClr val="939339"/>
+        </a:accent5>
+        <a:accent6>
+          <a:srgbClr val="B3B319"/>
+        </a:accent6>
+        <a:hlink>
+          <a:srgbClr val="009999"/>
+        </a:hlink>
+        <a:folHlink>
+          <a:srgbClr val="99CC00"/>
+        </a:folHlink>
+      </a:clrScheme>
+      <a:clrMap bg1="lt1" tx1="dk1" bg2="lt2" tx2="dk2" accent1="accent1" accent2="accent2" accent3="accent3" accent4="accent4" accent5="accent5" accent6="accent6" hlink="hlink" folHlink="folHlink"/>
+    </a:extraClrScheme>
   </a:extraClrSchemeLst>
 </a:theme>
 </file>
</xml_diff>

<commit_message>
Reworked value transform (#894)
</commit_message>
<xml_diff>
--- a/php-zigar/doc/object-ownership.pptx
+++ b/php-zigar/doc/object-ownership.pptx
@@ -237,7 +237,7 @@
             <a:spLocks noGrp="1" noChangeArrowheads="1"/>
             <a:extLst>
               <a:ext uri="smNativeData">
-                <pr:smNativeData xmlns:pr="smNativeData" xmlns="smNativeData" val="SMDATA_15_7aDWaRMAAAAlAAAAZAAAAA8BAAAAkAAAAEgAAACQAAAASAAAAAAAAAABAAAAAAAAAAEAAABQAAAAAAAAAAAA4D8AAAAAAADgPwAAAAAAAOA/AAAAAAAA4D8AAAAAAADgPwAAAAAAAOA/AAAAAAAA4D8AAAAAAADgPwAAAAAAAOA/AAAAAAAA4D8CAAAAjAAAAAAAAAAAAAAAu+DjDP///wgAAAAAAAAAAAAAAAAAAAAAAAAAAAAAAAAAAAAAZAAAAAEAAABAAAAAAAAAAAAAAAAAAAAAAAAAAAAAAAAAAAAAAAAAAAAAAAAAAAAAAAAAAAAAAAAAAAAAAAAAAAAAAAAAAAAAAAAAAAAAAAAAAAAAAAAAAAAAAAAAAAAAFAAAADwAAAAAAAAAAAAAAAAAAAkUAAAAAQAAABQAAAAUAAAAFAAAAAEAAAAAAAAAZAAAAGQAAAAAAAAAZAAAAGQAAAAVAAAAYAAAAAAAAAAAAAAADwAAACADAAAAAAAAAAAAAAEAAACgMgAAVgcAAKr4//8BAAAAf39/AAEAAABkAAAAAAAAABQAAABAHwAAAAAAACYAAAAAAAAAwOD//wAAAAAmAAAAZAAAABYAAABMAAAAAAAAAAAAAAAEAAAAAAAAAAEAAACAgIAKAAAAACgAAAAoAAAAZAAAAGQAAAAAAAAAzMzMAAAAAABQAAAAUAAAAGQAAABkAAAAAAAAABcAAAAUAAAAAAAAAAAAAAD/fwAA/38AAAAAAAAJAAAABAAAAAAAAAAeAAAAaAAAAAAAAAAAAAAAAAAAAAAAAAAAAAAAECcAABAnAAAAAAAAAAAAAAAAAAAAAAAAAAAAAAAAAAAAAAAAAAAAABQAAAAAAAAAwMD/AAAAAABkAAAAMgAAAAAAAABkAAAAAAAAAH9/fwAKAAAAIgAAABgAAAAAAAAAAAAAAAAAAAAAAAAAAAAAAAAAAAAkAAAAJAAAAAAAAAAHAAAAAAAAAAAAAAAAAAAAAAAAAAAAAAAAAAAAf39/ACUAAABYAAAAAAAAAAAAAAAAAAAAAAAAAAAAAAAAAAAAAAAAAAAAAAAAAAAAAAAAAAAAAAA/AAAAAAAAAKCGAQAAAAAAAAAAAAAAAAAMAAAAAQAAAAAAAAAAAAAAAAAAAB8AAABUAAAAAAAABQAAAAEAAAAAAAAAAAAAAAAAAAAAAAAAAAAAAAAAAAAAAAAAAAAAAAJ/f38AAAAAA8zMzADAwP8Af39/AAAAAAAAAAAAAAAAAAAAAAAAAAAAIQAAABgAAAAUAAAAoAUAABoNAABgRQAAJhYAABAAAAAmAAAACAAAAAEAAAAAAAAA"/>
+                <pr:smNativeData xmlns:pr="smNativeData" xmlns="smNativeData" val="SMDATA_15_ZqHWaRMAAAAlAAAAZAAAAA8BAAAAkAAAAEgAAACQAAAASAAAAAAAAAABAAAAAAAAAAEAAABQAAAAAAAAAAAA4D8AAAAAAADgPwAAAAAAAOA/AAAAAAAA4D8AAAAAAADgPwAAAAAAAOA/AAAAAAAA4D8AAAAAAADgPwAAAAAAAOA/AAAAAAAA4D8CAAAAjAAAAAAAAAAAAAAAu+DjDP///wgAAAAAAAAAAAAAAAAAAAAAAAAAAAAAAAAAAAAAZAAAAAEAAABAAAAAAAAAAAAAAAAAAAAAAAAAAAAAAAAAAAAAAAAAAAAAAAAAAAAAAAAAAAAAAAAAAAAAAAAAAAAAAAAAAAAAAAAAAAAAAAAAAAAAAAAAAAAAAAAAAAAAFAAAADwAAAAAAAAAAAAAAAAAAAkUAAAAAQAAABQAAAAUAAAAFAAAAAEAAAAAAAAAZAAAAGQAAAAAAAAAZAAAAGQAAAAVAAAAYAAAAAAAAAAAAAAADwAAACADAAAAAAAAAAAAAAEAAACgMgAAVgcAAKr4//8BAAAAf39/AAEAAABkAAAAAAAAABQAAABAHwAAAAAAACYAAAAAAAAAwOD//wAAAAAmAAAAZAAAABYAAABMAAAAAAAAAAAAAAAEAAAAAAAAAAEAAACAgIAKAAAAACgAAAAoAAAAZAAAAGQAAAAAAAAAzMzMAAAAAABQAAAAUAAAAGQAAABkAAAAAAAAABcAAAAUAAAAAAAAAAAAAAD/fwAA/38AAAAAAAAJAAAABAAAAAAAAAAeAAAAaAAAAAAAAAAAAAAAAAAAAAAAAAAAAAAAECcAABAnAAAAAAAAAAAAAAAAAAAAAAAAAAAAAAAAAAAAAAAAAAAAABQAAAAAAAAAwMD/AAAAAABkAAAAMgAAAAAAAABkAAAAAAAAAH9/fwAKAAAAIgAAABgAAAAAAAAAAAAAAAAAAAAAAAAAAAAAAAAAAAAkAAAAJAAAAAAAAAAHAAAAAAAAAAAAAAAAAAAAAAAAAAAAAAAAAAAAf39/ACUAAABYAAAAAAAAAAAAAAAAAAAAAAAAAAAAAAAAAAAAAAAAAAAAAAAAAAAAAAAAAAAAAAA/AAAAAAAAAKCGAQAAAAAAAAAAAAAAAAAMAAAAAQAAAAAAAAAAAAAAAAAAAB8AAABUAAAAAAAABQAAAAEAAAAAAAAAAAAAAAAAAAAAAAAAAAAAAAAAAAAAAAAAAAAAAAJ/f38AAAAAA8zMzADAwP8Af39/AAAAAAAAAAAAAAAAAAAAAAAAAAAAIQAAABgAAAAUAAAAoAUAABoNAABgRQAAJhYAABAAAAAmAAAACAAAAAEAAAAAAAAA"/>
               </a:ext>
             </a:extLst>
           </p:cNvSpPr>
@@ -269,7 +269,7 @@
             <a:spLocks noGrp="1" noChangeArrowheads="1"/>
             <a:extLst>
               <a:ext uri="smNativeData">
-                <pr:smNativeData xmlns:pr="smNativeData" xmlns="smNativeData" val="SMDATA_15_7aDWaRMAAAAlAAAAZAAAAA8BAAAAkAAAAEgAAACQAAAASAAAAAAAAAAAAAAAAAAAAAEAAABQAAAAAAAAAAAA4D8AAAAAAADgPwAAAAAAAOA/AAAAAAAA4D8AAAAAAADgPwAAAAAAAOA/AAAAAAAA4D8AAAAAAADgPwAAAAAAAOA/AAAAAAAA4D8CAAAAjAAAAAAAAAAAAAAAu+DjDP///wgAAAAAAAAAAAAAAAAAAAAAAAAAAAAAAAAAAAAAZAAAAAEAAABAAAAAAAAAAAAAAAAAAAAAAAAAAAAAAAAAAAAAAAAAAAAAAAAAAAAAAAAAAAAAAAAAAAAAAAAAAAAAAAAAAAAAAAAAAAAAAAAAAAAAAAAAAAAAAAAAAAAAFAAAADwAAAAAAAAAAAAAAAAAAAkUAAAAAQAAABQAAAAUAAAAFAAAAAEAAAAAAAAAZAAAAGQAAAAAAAAAZAAAAGQAAAAVAAAAYAAAAAAAAAAAAAAADwAAACADAAAAAAAAAAAAAAEAAACgMgAAVgcAAKr4//8BAAAAf39/AAEAAABkAAAAAAAAABQAAABAHwAAAAAAACYAAAAAAAAAwOD//wAAAAAmAAAAZAAAABYAAABMAAAAAAAAAAAAAAAEAAAAAAAAAAEAAACAgIAKAAAAACgAAAAoAAAAZAAAAGQAAAAAAAAAzMzMAAAAAABQAAAAUAAAAGQAAABkAAAAAAAAABcAAAAUAAAAAAAAAAAAAAD/fwAA/38AAAAAAAAJAAAABAAAAAAAAAAeAAAAaAAAAAAAAAAAAAAAAAAAAAAAAAAAAAAAECcAABAnAAAAAAAAAAAAAAAAAAAAAAAAAAAAAAAAAAAAAAAAAAAAABQAAAAAAAAAwMD/AAAAAABkAAAAMgAAAAAAAABkAAAAAAAAAH9/fwAKAAAAIgAAABgAAAAAAAAAAAAAAAAAAAAAAAAAAAAAAAAAAAAkAAAAJAAAAAAAAAAHAAAAAAAAAAAAAAAAAAAAAAAAAAAAAAAAAAAAf39/ACUAAABYAAAAAAAAAAAAAAAAAAAAAAAAAAAAAAAAAAAAAAAAAAAAAAAAAAAAAAAAAAAAAAA/AAAAAAAAAKCGAQAAAAAAAAAAAAAAAAAMAAAAAQAAAAAAAAAAAAAAAAAAAB8AAABUAAAAAAAABQAAAAEAAAAAAAAAAAAAAAAAAAAAAAAAAAAAAAAAAAAAAAAAAAAAAAJ/f38AAAAAA8zMzADAwP8Af39/AAAAAAAAAAAAAAAAAAAAAAAAAAAAIQAAABgAAAAUAAAAQAsAAOgXAADAPwAAsCIAABAAAAAmAAAACAAAAAGAAAAAAAAA"/>
+                <pr:smNativeData xmlns:pr="smNativeData" xmlns="smNativeData" val="SMDATA_15_ZqHWaRMAAAAlAAAAZAAAAA8BAAAAkAAAAEgAAACQAAAASAAAAAAAAAAAAAAAAAAAAAEAAABQAAAAAAAAAAAA4D8AAAAAAADgPwAAAAAAAOA/AAAAAAAA4D8AAAAAAADgPwAAAAAAAOA/AAAAAAAA4D8AAAAAAADgPwAAAAAAAOA/AAAAAAAA4D8CAAAAjAAAAAAAAAAAAAAAu+DjDP///wgAAAAAAAAAAAAAAAAAAAAAAAAAAAAAAAAAAAAAZAAAAAEAAABAAAAAAAAAAAAAAAAAAAAAAAAAAAAAAAAAAAAAAAAAAAAAAAAAAAAAAAAAAAAAAAAAAAAAAAAAAAAAAAAAAAAAAAAAAAAAAAAAAAAAAAAAAAAAAAAAAAAAFAAAADwAAAAAAAAAAAAAAAAAAAkUAAAAAQAAABQAAAAUAAAAFAAAAAEAAAAAAAAAZAAAAGQAAAAAAAAAZAAAAGQAAAAVAAAAYAAAAAAAAAAAAAAADwAAACADAAAAAAAAAAAAAAEAAACgMgAAVgcAAKr4//8BAAAAf39/AAEAAABkAAAAAAAAABQAAABAHwAAAAAAACYAAAAAAAAAwOD//wAAAAAmAAAAZAAAABYAAABMAAAAAAAAAAAAAAAEAAAAAAAAAAEAAACAgIAKAAAAACgAAAAoAAAAZAAAAGQAAAAAAAAAzMzMAAAAAABQAAAAUAAAAGQAAABkAAAAAAAAABcAAAAUAAAAAAAAAAAAAAD/fwAA/38AAAAAAAAJAAAABAAAAAAAAAAeAAAAaAAAAAAAAAAAAAAAAAAAAAAAAAAAAAAAECcAABAnAAAAAAAAAAAAAAAAAAAAAAAAAAAAAAAAAAAAAAAAAAAAABQAAAAAAAAAwMD/AAAAAABkAAAAMgAAAAAAAABkAAAAAAAAAH9/fwAKAAAAIgAAABgAAAAAAAAAAAAAAAAAAAAAAAAAAAAAAAAAAAAkAAAAJAAAAAAAAAAHAAAAAAAAAAAAAAAAAAAAAAAAAAAAAAAAAAAAf39/ACUAAABYAAAAAAAAAAAAAAAAAAAAAAAAAAAAAAAAAAAAAAAAAAAAAAAAAAAAAAAAAAAAAAA/AAAAAAAAAKCGAQAAAAAAAAAAAAAAAAAMAAAAAQAAAAAAAAAAAAAAAAAAAB8AAABUAAAAAAAABQAAAAEAAAAAAAAAAAAAAAAAAAAAAAAAAAAAAAAAAAAAAAAAAAAAAAJ/f38AAAAAA8zMzADAwP8Af39/AAAAAAAAAAAAAAAAAAAAAAAAAAAAIQAAABgAAAAUAAAAQAsAAOgXAADAPwAAsCIAABAAAAAmAAAACAAAAAGAAAAAAAAA"/>
               </a:ext>
             </a:extLst>
           </p:cNvSpPr>
@@ -329,7 +329,7 @@
             <a:spLocks noGrp="1" noChangeArrowheads="1"/>
             <a:extLst>
               <a:ext uri="smNativeData">
-                <pr:smNativeData xmlns:pr="smNativeData" xmlns="smNativeData" val="SMDATA_15_7aDWaRMAAAAlAAAAZAAAAA8BAAAAkAAAAEgAAACQAAAASAAAAAAAAAABAAAAAAAAAAEAAABQAAAAAAAAAAAA4D8AAAAAAADgPwAAAAAAAOA/AAAAAAAA4D8AAAAAAADgPwAAAAAAAOA/AAAAAAAA4D8AAAAAAADgPwAAAAAAAOA/AAAAAAAA4D8CAAAAjAAAAAAAAAAAAAAAu+DjDP///wgAAAAAAAAAAAAAAAAAAAAAAAAAAAAAAAAAAAAAZAAAAAEAAABAAAAAAAAAAAAAAAAAAAAAAAAAAAAAAAAAAAAAAAAAAAAAAAAAAAAAAAAAAAAAAAAAAAAAAAAAAAAAAAAAAAAAAAAAAAAAAAAAAAAAAAAAAAAAAAAAAAAAFAAAADwAAAAAAAAAAAAAAAAAAAkUAAAAAQAAABQAAAAUAAAAFAAAAAEAAAAAAAAAZAAAAGQAAAAAAAAAZAAAAGQAAAAVAAAAYAAAAAAAAAAAAAAADwAAACADAAAAAAAAAAAAAAEAAACgMgAAVgcAAKr4//8BAAAAf39/AAEAAABkAAAAAAAAABQAAABAHwAAAAAAACYAAAAAAAAAwOD//wAAAAAmAAAAZAAAABYAAABMAAAAAAAAAAAAAAAEAAAAAAAAAAEAAACAgIAKAAAAACgAAAAoAAAAZAAAAGQAAAAAAAAAzMzMAAAAAABQAAAAUAAAAGQAAABkAAAAAAAAABcAAAAUAAAAAAAAAAAAAAD/fwAA/38AAAAAAAAJAAAABAAAAAAAAAAeAAAAaAAAAAAAAAAAAAAAAAAAAAAAAAAAAAAAECcAABAnAAAAAAAAAAAAAAAAAAAAAAAAAAAAAAAAAAAAAAAAAAAAABQAAAAAAAAAwMD/AAAAAABkAAAAMgAAAAAAAABkAAAAAAAAAH9/fwAKAAAAIgAAABgAAAAAAAAAAAAAAAAAAAAAAAAAAAAAAAAAAAAkAAAAJAAAAAAAAAAHAAAAAAAAAAAAAAAAAAAAAAAAAAAAAAAAAAAAf39/ACUAAABYAAAAAAAAAAAAAAAAAAAAAAAAAAAAAAAAAAAAAAAAAAAAAAAAAAAAAAAAAAAAAAA/AAAAAAAAAKCGAQAAAAAAAAAAAAAAAAAMAAAAAQAAAAAAAAAAAAAAAAAAAB8AAABUAAAAAAAABQAAAAEAAAAAAAAAAAAAAAAAAAAAAAAAAAAAAAAAAAAAAAAAAAAAAAJ/f38AAAAAA8zMzADAwP8Af39/AAAAAAAAAAAAAAAAAAAAAAAAAAAAIQAAABgAAAAUAAAAwAMAABsnAAA/FQAAWSkAABAAAAAmAAAACAAAAAAAAAAAAAAA"/>
+                <pr:smNativeData xmlns:pr="smNativeData" xmlns="smNativeData" val="SMDATA_15_ZqHWaRMAAAAlAAAAZAAAAA8BAAAAkAAAAEgAAACQAAAASAAAAAAAAAABAAAAAAAAAAEAAABQAAAAAAAAAAAA4D8AAAAAAADgPwAAAAAAAOA/AAAAAAAA4D8AAAAAAADgPwAAAAAAAOA/AAAAAAAA4D8AAAAAAADgPwAAAAAAAOA/AAAAAAAA4D8CAAAAjAAAAAAAAAAAAAAAu+DjDP///wgAAAAAAAAAAAAAAAAAAAAAAAAAAAAAAAAAAAAAZAAAAAEAAABAAAAAAAAAAAAAAAAAAAAAAAAAAAAAAAAAAAAAAAAAAAAAAAAAAAAAAAAAAAAAAAAAAAAAAAAAAAAAAAAAAAAAAAAAAAAAAAAAAAAAAAAAAAAAAAAAAAAAFAAAADwAAAAAAAAAAAAAAAAAAAkUAAAAAQAAABQAAAAUAAAAFAAAAAEAAAAAAAAAZAAAAGQAAAAAAAAAZAAAAGQAAAAVAAAAYAAAAAAAAAAAAAAADwAAACADAAAAAAAAAAAAAAEAAACgMgAAVgcAAKr4//8BAAAAf39/AAEAAABkAAAAAAAAABQAAABAHwAAAAAAACYAAAAAAAAAwOD//wAAAAAmAAAAZAAAABYAAABMAAAAAAAAAAAAAAAEAAAAAAAAAAEAAACAgIAKAAAAACgAAAAoAAAAZAAAAGQAAAAAAAAAzMzMAAAAAABQAAAAUAAAAGQAAABkAAAAAAAAABcAAAAUAAAAAAAAAAAAAAD/fwAA/38AAAAAAAAJAAAABAAAAAAAAAAeAAAAaAAAAAAAAAAAAAAAAAAAAAAAAAAAAAAAECcAABAnAAAAAAAAAAAAAAAAAAAAAAAAAAAAAAAAAAAAAAAAAAAAABQAAAAAAAAAwMD/AAAAAABkAAAAMgAAAAAAAABkAAAAAAAAAH9/fwAKAAAAIgAAABgAAAAAAAAAAAAAAAAAAAAAAAAAAAAAAAAAAAAkAAAAJAAAAAAAAAAHAAAAAAAAAAAAAAAAAAAAAAAAAAAAAAAAAAAAf39/ACUAAABYAAAAAAAAAAAAAAAAAAAAAAAAAAAAAAAAAAAAAAAAAAAAAAAAAAAAAAAAAAAAAAA/AAAAAAAAAKCGAQAAAAAAAAAAAAAAAAAMAAAAAQAAAAAAAAAAAAAAAAAAAB8AAABUAAAAAAAABQAAAAEAAAAAAAAAAAAAAAAAAAAAAAAAAAAAAAAAAAAAAAAAAAAAAAJ/f38AAAAAA8zMzADAwP8Af39/AAAAAAAAAAAAAAAAAAAAAAAAAAAAIQAAABgAAAAUAAAAwAMAABsnAAA/FQAAWSkAABAAAAAmAAAACAAAAAAAAAAAAAAA"/>
               </a:ext>
             </a:extLst>
           </p:cNvSpPr>
@@ -343,7 +343,7 @@
           <a:lstStyle/>
           <a:p>
             <a:pPr/>
-            <a:fld id="{4FF01712-5CA2-A5E1-EC48-AAB459061AFF}" type="datetime1">
+            <a:fld id="{38D42F66-28D5-81D9-9B6C-DE8C61226D8B}" type="datetime1">
               <a:t/>
             </a:fld>
           </a:p>
@@ -356,7 +356,7 @@
             <a:spLocks noGrp="1" noChangeArrowheads="1"/>
             <a:extLst>
               <a:ext uri="smNativeData">
-                <pr:smNativeData xmlns:pr="smNativeData" xmlns="smNativeData" val="SMDATA_15_7aDWaRMAAAAlAAAAZAAAAA8BAAAAkAAAAEgAAACQAAAASAAAAAAAAAABAAAAAAAAAAEAAABQAAAAAAAAAAAA4D8AAAAAAADgPwAAAAAAAOA/AAAAAAAA4D8AAAAAAADgPwAAAAAAAOA/AAAAAAAA4D8AAAAAAADgPwAAAAAAAOA/AAAAAAAA4D8CAAAAjAAAAAAAAAAAAAAAu+DjDP///wgAAAAAAAAAAAAAAAAAAAAAAAAAAAAAAAAAAAAAZAAAAAEAAABAAAAAAAAAAAAAAAAAAAAAAAAAAAAAAAAAAAAAAAAAAAAAAAAAAAAAAAAAAAAAAAAAAAAAAAAAAAAAAAAAAAAAAAAAAAAAAAAAAAAAAAAAAAAAAAAAAAAAFAAAADwAAAAAAAAAAAAAAAAAAAkUAAAAAQAAABQAAAAUAAAAFAAAAAEAAAAAAAAAZAAAAGQAAAAAAAAAZAAAAGQAAAAVAAAAYAAAAAAAAAAAAAAADwAAACADAAAAAAAAAAAAAAEAAACgMgAAVgcAAKr4//8BAAAAf39/AAEAAABkAAAAAAAAABQAAABAHwAAAAAAACYAAAAAAAAAwOD//wAAAAAmAAAAZAAAABYAAABMAAAAAAAAAAAAAAAEAAAAAAAAAAEAAACAgIAKAAAAACgAAAAoAAAAZAAAAGQAAAAAAAAAzMzMAAAAAABQAAAAUAAAAGQAAABkAAAAAAAAABcAAAAUAAAAAAAAAAAAAAD/fwAA/38AAAAAAAAJAAAABAAAAAAAAAAeAAAAaAAAAAAAAAAAAAAAAAAAAAAAAAAAAAAAECcAABAnAAAAAAAAAAAAAAAAAAAAAAAAAAAAAAAAAAAAAAAAAAAAABQAAAAAAAAAwMD/AAAAAABkAAAAMgAAAAAAAABkAAAAAAAAAH9/fwAKAAAAIgAAABgAAAAAAAAAAAAAAAAAAAAAAAAAAAAAAAAAAAAkAAAAJAAAAAAAAAAHAAAAAAAAAAAAAAAAAAAAAAAAAAAAAAAAAAAAf39/ACUAAABYAAAAAAAAAAAAAAAAAAAAAAAAAAAAAAAAAAAAAAAAAAAAAAAAAAAAAAAAAAAAAAA/AAAAAAAAAKCGAQAAAAAAAAAAAAAAAAAMAAAAAQAAAAAAAAAAAAAAAAAAAB8AAABUAAAAAAAABQAAAAEAAAAAAAAAAAAAAAAAAAAAAAAAAAAAAAAAAAAAAAAAAAAAAAJ/f38AAAAAA8zMzADAwP8Af39/AAAAAAAAAAAAAAAAAAAAAAAAAAAAIQAAABgAAAAUAAAAoRkAABsnAABfMQAAWSkAABAAAAAmAAAACAAAAAAAAAAAAAAA"/>
+                <pr:smNativeData xmlns:pr="smNativeData" xmlns="smNativeData" val="SMDATA_15_ZqHWaRMAAAAlAAAAZAAAAA8BAAAAkAAAAEgAAACQAAAASAAAAAAAAAABAAAAAAAAAAEAAABQAAAAAAAAAAAA4D8AAAAAAADgPwAAAAAAAOA/AAAAAAAA4D8AAAAAAADgPwAAAAAAAOA/AAAAAAAA4D8AAAAAAADgPwAAAAAAAOA/AAAAAAAA4D8CAAAAjAAAAAAAAAAAAAAAu+DjDP///wgAAAAAAAAAAAAAAAAAAAAAAAAAAAAAAAAAAAAAZAAAAAEAAABAAAAAAAAAAAAAAAAAAAAAAAAAAAAAAAAAAAAAAAAAAAAAAAAAAAAAAAAAAAAAAAAAAAAAAAAAAAAAAAAAAAAAAAAAAAAAAAAAAAAAAAAAAAAAAAAAAAAAFAAAADwAAAAAAAAAAAAAAAAAAAkUAAAAAQAAABQAAAAUAAAAFAAAAAEAAAAAAAAAZAAAAGQAAAAAAAAAZAAAAGQAAAAVAAAAYAAAAAAAAAAAAAAADwAAACADAAAAAAAAAAAAAAEAAACgMgAAVgcAAKr4//8BAAAAf39/AAEAAABkAAAAAAAAABQAAABAHwAAAAAAACYAAAAAAAAAwOD//wAAAAAmAAAAZAAAABYAAABMAAAAAAAAAAAAAAAEAAAAAAAAAAEAAACAgIAKAAAAACgAAAAoAAAAZAAAAGQAAAAAAAAAzMzMAAAAAABQAAAAUAAAAGQAAABkAAAAAAAAABcAAAAUAAAAAAAAAAAAAAD/fwAA/38AAAAAAAAJAAAABAAAAAAAAAAeAAAAaAAAAAAAAAAAAAAAAAAAAAAAAAAAAAAAECcAABAnAAAAAAAAAAAAAAAAAAAAAAAAAAAAAAAAAAAAAAAAAAAAABQAAAAAAAAAwMD/AAAAAABkAAAAMgAAAAAAAABkAAAAAAAAAH9/fwAKAAAAIgAAABgAAAAAAAAAAAAAAAAAAAAAAAAAAAAAAAAAAAAkAAAAJAAAAAAAAAAHAAAAAAAAAAAAAAAAAAAAAAAAAAAAAAAAAAAAf39/ACUAAABYAAAAAAAAAAAAAAAAAAAAAAAAAAAAAAAAAAAAAAAAAAAAAAAAAAAAAAAAAAAAAAA/AAAAAAAAAKCGAQAAAAAAAAAAAAAAAAAMAAAAAQAAAAAAAAAAAAAAAAAAAB8AAABUAAAAAAAABQAAAAEAAAAAAAAAAAAAAAAAAAAAAAAAAAAAAAAAAAAAAAAAAAAAAAJ/f38AAAAAA8zMzADAwP8Af39/AAAAAAAAAAAAAAAAAAAAAAAAAAAAIQAAABgAAAAUAAAAoRkAABsnAABfMQAAWSkAABAAAAAmAAAACAAAAAAAAAAAAAAA"/>
               </a:ext>
             </a:extLst>
           </p:cNvSpPr>
@@ -380,7 +380,7 @@
             <a:spLocks noGrp="1" noChangeArrowheads="1"/>
             <a:extLst>
               <a:ext uri="smNativeData">
-                <pr:smNativeData xmlns:pr="smNativeData" xmlns="smNativeData" val="SMDATA_15_7aDWaRMAAAAlAAAAZAAAAA8BAAAAkAAAAEgAAACQAAAASAAAAAAAAAABAAAAAAAAAAEAAABQAAAAAAAAAAAA4D8AAAAAAADgPwAAAAAAAOA/AAAAAAAA4D8AAAAAAADgPwAAAAAAAOA/AAAAAAAA4D8AAAAAAADgPwAAAAAAAOA/AAAAAAAA4D8CAAAAjAAAAAAAAAAAAAAAu+DjDP///wgAAAAAAAAAAAAAAAAAAAAAAAAAAAAAAAAAAAAAZAAAAAEAAABAAAAAAAAAAAAAAAAAAAAAAAAAAAAAAAAAAAAAAAAAAAAAAAAAAAAAAAAAAAAAAAAAAAAAAAAAAAAAAAAAAAAAAAAAAAAAAAAAAAAAAAAAAAAAAAAAAAAAFAAAADwAAAAAAAAAAAAAAAAAAAkUAAAAAQAAABQAAAAUAAAAFAAAAAEAAAAAAAAAZAAAAGQAAAAAAAAAZAAAAGQAAAAVAAAAYAAAAAAAAAAAAAAADwAAACADAAAAAAAAAAAAAAEAAACgMgAAVgcAAKr4//8BAAAAf39/AAEAAABkAAAAAAAAABQAAABAHwAAAAAAACYAAAAAAAAAwOD//wAAAAAmAAAAZAAAABYAAABMAAAAAAAAAAAAAAAEAAAAAAAAAAEAAACAgIAKAAAAACgAAAAoAAAAZAAAAGQAAAAAAAAAzMzMAAAAAABQAAAAUAAAAGQAAABkAAAAAAAAABcAAAAUAAAAAAAAAAAAAAD/fwAA/38AAAAAAAAJAAAABAAAAHsAfAAeAAAAaAAAAAAAAAAAAAAAAAAAAAAAAAAAAAAAECcAABAnAAAAAAAAAAAAAAAAAAAAAAAAAAAAAAAAAAAAAAAAAAAAABQAAAAAAAAAwMD/AAAAAABkAAAAMgAAAAAAAABkAAAAAAAAAH9/fwAKAAAAIgAAABgAAAAAAAAAAAAAAAAAAAAAAAAAAAAAAAAAAAAkAAAAJAAAAAAAAAAHAAAAAAAAAAAAAAAAAAAAAAAAAAAAAAAAAAAAf39/ACUAAABYAAAAAAAAAAAAAAAAAAAAAAAAAAAAAAAAAAAAAAAAAAAAAAAAAAAAAAAAAAAAAAA/AAAAAAAAAKCGAQAAAAAAAAAAAAAAAAAMAAAAAQAAAAAAAAAAAAAAAAAAAB8AAABUAAAAAAAABQAAAAEAAAAAAAAAAAAAAAAAAAAAAAAAAAAAAAAAAAAAAAAAAAAAAAJ/f38AAAAAA8zMzADAwP8Af39/AAAAAAAAAAAAAAAAAAAAAAAAAAAAIQAAABgAAAAUAAAAwTUAABsnAABARwAAWSkAABAAAAAmAAAACAAAAAAAAAAAAAAA"/>
+                <pr:smNativeData xmlns:pr="smNativeData" xmlns="smNativeData" val="SMDATA_15_ZqHWaRMAAAAlAAAAZAAAAA8BAAAAkAAAAEgAAACQAAAASAAAAAAAAAABAAAAAAAAAAEAAABQAAAAAAAAAAAA4D8AAAAAAADgPwAAAAAAAOA/AAAAAAAA4D8AAAAAAADgPwAAAAAAAOA/AAAAAAAA4D8AAAAAAADgPwAAAAAAAOA/AAAAAAAA4D8CAAAAjAAAAAAAAAAAAAAAu+DjDP///wgAAAAAAAAAAAAAAAAAAAAAAAAAAAAAAAAAAAAAZAAAAAEAAABAAAAAAAAAAAAAAAAAAAAAAAAAAAAAAAAAAAAAAAAAAAAAAAAAAAAAAAAAAAAAAAAAAAAAAAAAAAAAAAAAAAAAAAAAAAAAAAAAAAAAAAAAAAAAAAAAAAAAFAAAADwAAAAAAAAAAAAAAAAAAAkUAAAAAQAAABQAAAAUAAAAFAAAAAEAAAAAAAAAZAAAAGQAAAAAAAAAZAAAAGQAAAAVAAAAYAAAAAAAAAAAAAAADwAAACADAAAAAAAAAAAAAAEAAACgMgAAVgcAAKr4//8BAAAAf39/AAEAAABkAAAAAAAAABQAAABAHwAAAAAAACYAAAAAAAAAwOD//wAAAAAmAAAAZAAAABYAAABMAAAAAAAAAAAAAAAEAAAAAAAAAAEAAACAgIAKAAAAACgAAAAoAAAAZAAAAGQAAAAAAAAAzMzMAAAAAABQAAAAUAAAAGQAAABkAAAAAAAAABcAAAAUAAAAAAAAAAAAAAD/fwAA/38AAAAAAAAJAAAABAAAAHsAfAAeAAAAaAAAAAAAAAAAAAAAAAAAAAAAAAAAAAAAECcAABAnAAAAAAAAAAAAAAAAAAAAAAAAAAAAAAAAAAAAAAAAAAAAABQAAAAAAAAAwMD/AAAAAABkAAAAMgAAAAAAAABkAAAAAAAAAH9/fwAKAAAAIgAAABgAAAAAAAAAAAAAAAAAAAAAAAAAAAAAAAAAAAAkAAAAJAAAAAAAAAAHAAAAAAAAAAAAAAAAAAAAAAAAAAAAAAAAAAAAf39/ACUAAABYAAAAAAAAAAAAAAAAAAAAAAAAAAAAAAAAAAAAAAAAAAAAAAAAAAAAAAAAAAAAAAA/AAAAAAAAAKCGAQAAAAAAAAAAAAAAAAAMAAAAAQAAAAAAAAAAAAAAAAAAAB8AAABUAAAAAAAABQAAAAEAAAAAAAAAAAAAAAAAAAAAAAAAAAAAAAAAAAAAAAAAAAAAAAJ/f38AAAAAA8zMzADAwP8Af39/AAAAAAAAAAAAAAAAAAAAAAAAAAAAIQAAABgAAAAUAAAAwTUAABsnAABARwAAWSkAABAAAAAmAAAACAAAAAAAAAAAAAAA"/>
               </a:ext>
             </a:extLst>
           </p:cNvSpPr>
@@ -394,7 +394,7 @@
           <a:lstStyle/>
           <a:p>
             <a:pPr/>
-            <a:fld id="{65A3423A-7488-F6B4-C61B-82E10C5530D7}" type="slidenum">
+            <a:fld id="{1DD602DE-90F0-83F4-BE6E-66A14C204833}" type="slidenum">
               <a:t/>
             </a:fld>
           </a:p>
@@ -433,7 +433,7 @@
             <a:spLocks noGrp="1" noChangeArrowheads="1"/>
             <a:extLst>
               <a:ext uri="smNativeData">
-                <pr:smNativeData xmlns:pr="smNativeData" xmlns="smNativeData" val="SMDATA_15_7aDWaRMAAAAlAAAAZAAAAA8BAAAAkAAAAEgAAACQAAAASAAAAAAAAAABAAAAAAAAAAEAAABQAAAAAAAAAAAA4D8AAAAAAADgPwAAAAAAAOA/AAAAAAAA4D8AAAAAAADgPwAAAAAAAOA/AAAAAAAA4D8AAAAAAADgPwAAAAAAAOA/AAAAAAAA4D8CAAAAjAAAAAAAAAAAAAAAu+DjDP///wgAAAAAAAAAAAAAAAAAAAAAAAAAAAAAAAAAAAAAZAAAAAEAAABAAAAAAAAAAAAAAAAAAAAAAAAAAAAAAAAAAAAAAAAAAAAAAAAAAAAAAAAAAAAAAAAAAAAAAAAAAAAAAAAAAAAAAAAAAAAAAAAAAAAAAAAAAAAAAAAAAAAAFAAAADwAAAAAAAAAAAAAAAAAAAkUAAAAAQAAABQAAAAUAAAAFAAAAAEAAAAAAAAAZAAAAGQAAAAAAAAAZAAAAGQAAAAVAAAAYAAAAAAAAAAAAAAADwAAACADAAAAAAAAAAAAAAEAAACgMgAAVgcAAKr4//8BAAAAf39/AAEAAABkAAAAAAAAABQAAABAHwAAAAAAACYAAAAAAAAAwOD//wAAAAAmAAAAZAAAABYAAABMAAAAAAAAAAAAAAAEAAAAAAAAAAEAAACAgIAKAAAAACgAAAAoAAAAZAAAAGQAAAAAAAAAzMzMAAAAAABQAAAAUAAAAGQAAABkAAAAAAAAABcAAAAUAAAAAAAAAAAAAAD/fwAA/38AAAAAAAAJAAAABAAAAG49IjEeAAAAaAAAAAAAAAAAAAAAAAAAAAAAAAAAAAAAECcAABAnAAAAAAAAAAAAAAAAAAAAAAAAAAAAAAAAAAAAAAAAAAAAABQAAAAAAAAAwMD/AAAAAABkAAAAMgAAAAAAAABkAAAAAAAAAH9/fwAKAAAAIgAAABgAAAAAAAAAAAAAAAAAAAAAAAAAAAAAAAAAAAAkAAAAJAAAAAAAAAAHAAAAAAAAAAAAAAAAAAAAAAAAAAAAAAAAAAAAf39/ACUAAABYAAAAAAAAAAAAAAAAAAAAAAAAAAAAAAAAAAAAAAAAAAAAAAAAAAAAAAAAAAAAAAA/AAAAAAAAAKCGAQAAAAAAAAAAAAAAAAAMAAAAAQAAAAAAAAAAAAAAAAAAAB8AAABUAAAAAAAABQAAAAEAAAAAAAAAAAAAAAAAAAAAAAAAAAAAAAAAAAAAAAAAAAAAAAJ/f38AAAAAA8zMzADAwP8Af39/AAAAAAAAAAAAAAAAAAAAAAAAAAAAIQAAABgAAAAUAAAAwAMAALABAABARwAAuAgAABAAAAAmAAAACAAAAAAAAAAAAAAA"/>
+                <pr:smNativeData xmlns:pr="smNativeData" xmlns="smNativeData" val="SMDATA_15_ZqHWaRMAAAAlAAAAZAAAAA8BAAAAkAAAAEgAAACQAAAASAAAAAAAAAABAAAAAAAAAAEAAABQAAAAAAAAAAAA4D8AAAAAAADgPwAAAAAAAOA/AAAAAAAA4D8AAAAAAADgPwAAAAAAAOA/AAAAAAAA4D8AAAAAAADgPwAAAAAAAOA/AAAAAAAA4D8CAAAAjAAAAAAAAAAAAAAAu+DjDP///wgAAAAAAAAAAAAAAAAAAAAAAAAAAAAAAAAAAAAAZAAAAAEAAABAAAAAAAAAAAAAAAAAAAAAAAAAAAAAAAAAAAAAAAAAAAAAAAAAAAAAAAAAAAAAAAAAAAAAAAAAAAAAAAAAAAAAAAAAAAAAAAAAAAAAAAAAAAAAAAAAAAAAFAAAADwAAAAAAAAAAAAAAAAAAAkUAAAAAQAAABQAAAAUAAAAFAAAAAEAAAAAAAAAZAAAAGQAAAAAAAAAZAAAAGQAAAAVAAAAYAAAAAAAAAAAAAAADwAAACADAAAAAAAAAAAAAAEAAACgMgAAVgcAAKr4//8BAAAAf39/AAEAAABkAAAAAAAAABQAAABAHwAAAAAAACYAAAAAAAAAwOD//wAAAAAmAAAAZAAAABYAAABMAAAAAAAAAAAAAAAEAAAAAAAAAAEAAACAgIAKAAAAACgAAAAoAAAAZAAAAGQAAAAAAAAAzMzMAAAAAABQAAAAUAAAAGQAAABkAAAAAAAAABcAAAAUAAAAAAAAAAAAAAD/fwAA/38AAAAAAAAJAAAABAAAAG49IjEeAAAAaAAAAAAAAAAAAAAAAAAAAAAAAAAAAAAAECcAABAnAAAAAAAAAAAAAAAAAAAAAAAAAAAAAAAAAAAAAAAAAAAAABQAAAAAAAAAwMD/AAAAAABkAAAAMgAAAAAAAABkAAAAAAAAAH9/fwAKAAAAIgAAABgAAAAAAAAAAAAAAAAAAAAAAAAAAAAAAAAAAAAkAAAAJAAAAAAAAAAHAAAAAAAAAAAAAAAAAAAAAAAAAAAAAAAAAAAAf39/ACUAAABYAAAAAAAAAAAAAAAAAAAAAAAAAAAAAAAAAAAAAAAAAAAAAAAAAAAAAAAAAAAAAAA/AAAAAAAAAKCGAQAAAAAAAAAAAAAAAAAMAAAAAQAAAAAAAAAAAAAAAAAAAB8AAABUAAAAAAAABQAAAAEAAAAAAAAAAAAAAAAAAAAAAAAAAAAAAAAAAAAAAAAAAAAAAAJ/f38AAAAAA8zMzADAwP8Af39/AAAAAAAAAAAAAAAAAAAAAAAAAAAAIQAAABgAAAAUAAAAwAMAALABAABARwAAuAgAABAAAAAmAAAACAAAAAAAAAAAAAAA"/>
               </a:ext>
             </a:extLst>
           </p:cNvSpPr>
@@ -460,7 +460,7 @@
             <a:spLocks noGrp="1" noChangeArrowheads="1"/>
             <a:extLst>
               <a:ext uri="smNativeData">
-                <pr:smNativeData xmlns:pr="smNativeData" xmlns="smNativeData" val="SMDATA_15_7aDWaRMAAAAlAAAAZAAAAA8BAAAAkAAAAEgAAACQAAAASAAAAAAAAAAAAAAAAQAAAAEAAABQAAAAAAAAAAAA4D8AAAAAAADgPwAAAAAAAOA/AAAAAAAA4D8AAAAAAADgPwAAAAAAAOA/AAAAAAAA4D8AAAAAAADgPwAAAAAAAOA/AAAAAAAA4D8CAAAAjAAAAAAAAAAAAAAAu+DjDP///wgAAAAAAAAAAAAAAAAAAAAAAAAAAAAAAAAAAAAAZAAAAAEAAABAAAAAAAAAAAAAAAAAAAAAAAAAAAAAAAAAAAAAAAAAAAAAAAAAAAAAAAAAAAAAAAAAAAAAAAAAAAAAAAAAAAAAAAAAAAAAAAAAAAAAAAAAAAAAAAAAAAAAFAAAADwAAAAAAAAAAAAAAAAAAAkUAAAAAQAAABQAAAAUAAAAFAAAAAEAAAAAAAAAZAAAAGQAAAAAAAAAZAAAAGQAAAAVAAAAYAAAAAAAAAAAAAAADwAAACADAAAAAAAAAAAAAAEAAACgMgAAVgcAAKr4//8BAAAAf39/AAEAAABkAAAAAAAAABQAAABAHwAAAAAAACYAAAAAAAAAwOD//wAAAAAmAAAAZAAAABYAAABMAAAAAAAAAAAAAAAEAAAAAAAAAAEAAACAgIAKAAAAACgAAAAoAAAAZAAAAGQAAAAAAAAAzMzMAAAAAABQAAAAUAAAAGQAAABkAAAAAAAAABcAAAAUAAAAAAAAAAAAAAD/fwAA/38AAAAAAAAJAAAABAAAAAAAAAAeAAAAaAAAAAAAAAAAAAAAAAAAAAAAAAAAAAAAECcAABAnAAAAAAAAAAAAAAAAAAAAAAAAAAAAAAAAAAAAAAAAAAAAABQAAAAAAAAAwMD/AAAAAABkAAAAMgAAAAAAAABkAAAAAAAAAH9/fwAKAAAAIgAAABgAAAAAAAAAAAAAAAAAAAAAAAAAAAAAAAAAAAAkAAAAJAAAAAAAAAAHAAAAAAAAAAAAAAAAAAAAAAAAAAAAAAAAAAAAf39/ACUAAABYAAAAAAAAAAAAAAAAAAAAAAAAAAAAAAAAAAAAAAAAAAAAAAAAAAAAAAAAAAAAAAA/AAAAAAAAAKCGAQAAAAAAAAAAAAAAAAAMAAAAAQAAAAAAAAAAAAAAAAAAAB8AAABUAAAAAAAABQAAAAEAAAAAAAAAAAAAAAAAAAAAAAAAAAAAAAAAAAAAAAAAAAAAAAJ/f38AAAAAA8zMzADAwP8Af39/AAAAAAAAAAAAAAAAAAAAAAAAAAAAIQAAABgAAAAUAAAAwAMAANgJAABARwAAsCUAABAAAAAmAAAACAAAAAIAAAAAAAAA"/>
+                <pr:smNativeData xmlns:pr="smNativeData" xmlns="smNativeData" val="SMDATA_15_ZqHWaRMAAAAlAAAAZAAAAA8BAAAAkAAAAEgAAACQAAAASAAAAAAAAAAAAAAAAQAAAAEAAABQAAAAAAAAAAAA4D8AAAAAAADgPwAAAAAAAOA/AAAAAAAA4D8AAAAAAADgPwAAAAAAAOA/AAAAAAAA4D8AAAAAAADgPwAAAAAAAOA/AAAAAAAA4D8CAAAAjAAAAAAAAAAAAAAAu+DjDP///wgAAAAAAAAAAAAAAAAAAAAAAAAAAAAAAAAAAAAAZAAAAAEAAABAAAAAAAAAAAAAAAAAAAAAAAAAAAAAAAAAAAAAAAAAAAAAAAAAAAAAAAAAAAAAAAAAAAAAAAAAAAAAAAAAAAAAAAAAAAAAAAAAAAAAAAAAAAAAAAAAAAAAFAAAADwAAAAAAAAAAAAAAAAAAAkUAAAAAQAAABQAAAAUAAAAFAAAAAEAAAAAAAAAZAAAAGQAAAAAAAAAZAAAAGQAAAAVAAAAYAAAAAAAAAAAAAAADwAAACADAAAAAAAAAAAAAAEAAACgMgAAVgcAAKr4//8BAAAAf39/AAEAAABkAAAAAAAAABQAAABAHwAAAAAAACYAAAAAAAAAwOD//wAAAAAmAAAAZAAAABYAAABMAAAAAAAAAAAAAAAEAAAAAAAAAAEAAACAgIAKAAAAACgAAAAoAAAAZAAAAGQAAAAAAAAAzMzMAAAAAABQAAAAUAAAAGQAAABkAAAAAAAAABcAAAAUAAAAAAAAAAAAAAD/fwAA/38AAAAAAAAJAAAABAAAAAAAAAAeAAAAaAAAAAAAAAAAAAAAAAAAAAAAAAAAAAAAECcAABAnAAAAAAAAAAAAAAAAAAAAAAAAAAAAAAAAAAAAAAAAAAAAABQAAAAAAAAAwMD/AAAAAABkAAAAMgAAAAAAAABkAAAAAAAAAH9/fwAKAAAAIgAAABgAAAAAAAAAAAAAAAAAAAAAAAAAAAAAAAAAAAAkAAAAJAAAAAAAAAAHAAAAAAAAAAAAAAAAAAAAAAAAAAAAAAAAAAAAf39/ACUAAABYAAAAAAAAAAAAAAAAAAAAAAAAAAAAAAAAAAAAAAAAAAAAAAAAAAAAAAAAAAAAAAA/AAAAAAAAAKCGAQAAAAAAAAAAAAAAAAAMAAAAAQAAAAAAAAAAAAAAAAAAAB8AAABUAAAAAAAABQAAAAEAAAAAAAAAAAAAAAAAAAAAAAAAAAAAAAAAAAAAAAAAAAAAAAJ/f38AAAAAA8zMzADAwP8Af39/AAAAAAAAAAAAAAAAAAAAAAAAAAAAIQAAABgAAAAUAAAAwAMAANgJAABARwAAsCUAABAAAAAmAAAACAAAAAIAAAAAAAAA"/>
               </a:ext>
             </a:extLst>
           </p:cNvSpPr>
@@ -515,7 +515,7 @@
             <a:spLocks noGrp="1" noChangeArrowheads="1"/>
             <a:extLst>
               <a:ext uri="smNativeData">
-                <pr:smNativeData xmlns:pr="smNativeData" xmlns="smNativeData" val="SMDATA_15_7aDWaRMAAAAlAAAAZAAAAA8BAAAAkAAAAEgAAACQAAAASAAAAAAAAAABAAAAAAAAAAEAAABQAAAAAAAAAAAA4D8AAAAAAADgPwAAAAAAAOA/AAAAAAAA4D8AAAAAAADgPwAAAAAAAOA/AAAAAAAA4D8AAAAAAADgPwAAAAAAAOA/AAAAAAAA4D8CAAAAjAAAAAAAAAAAAAAAu+DjDP///wgAAAAAAAAAAAAAAAAAAAAAAAAAAAAAAAAAAAAAZAAAAAEAAABAAAAAAAAAAAAAAAAAAAAAAAAAAAAAAAAAAAAAAAAAAAAAAAAAAAAAAAAAAAAAAAAAAAAAAAAAAAAAAAAAAAAAAAAAAAAAAAAAAAAAAAAAAAAAAAAAAAAAFAAAADwAAAAAAAAAAAAAAAAAAAkUAAAAAQAAABQAAAAUAAAAFAAAAAEAAAAAAAAAZAAAAGQAAAAAAAAAZAAAAGQAAAAVAAAAYAAAAAAAAAAAAAAADwAAACADAAAAAAAAAAAAAAEAAACgMgAAVgcAAKr4//8BAAAAf39/AAEAAABkAAAAAAAAABQAAABAHwAAAAAAACYAAAAAAAAAwOD//wAAAAAmAAAAZAAAABYAAABMAAAAAAAAAAAAAAAEAAAAAAAAAAEAAACAgIAKAAAAACgAAAAoAAAAZAAAAGQAAAAAAAAAzMzMAAAAAABQAAAAUAAAAGQAAABkAAAAAAAAABcAAAAUAAAAAAAAAAAAAAD/fwAA/38AAAAAAAAJAAAABAAAAAAAAAAeAAAAaAAAAAAAAAAAAAAAAAAAAAAAAAAAAAAAECcAABAnAAAAAAAAAAAAAAAAAAAAAAAAAAAAAAAAAAAAAAAAAAAAABQAAAAAAAAAwMD/AAAAAABkAAAAMgAAAAAAAABkAAAAAAAAAH9/fwAKAAAAIgAAABgAAAAAAAAAAAAAAAAAAAAAAAAAAAAAAAAAAAAkAAAAJAAAAAAAAAAHAAAAAAAAAAAAAAAAAAAAAAAAAAAAAAAAAAAAf39/ACUAAABYAAAAAAAAAAAAAAAAAAAAAAAAAAAAAAAAAAAAAAAAAAAAAAAAAAAAAAAAAAAAAAA/AAAAAAAAAKCGAQAAAAAAAAAAAAAAAAAMAAAAAQAAAAAAAAAAAAAAAAAAAB8AAABUAAAAAAAABQAAAAEAAAAAAAAAAAAAAAAAAAAAAAAAAAAAAAAAAAAAAAAAAAAAAAJ/f38AAAAAA8zMzADAwP8Af39/AAAAAAAAAAAAAAAAAAAAAAAAAAAAIQAAABgAAAAUAAAAwAMAABsnAAA/FQAAWSkAABAAAAAmAAAACAAAAAAAAAAAAAAA"/>
+                <pr:smNativeData xmlns:pr="smNativeData" xmlns="smNativeData" val="SMDATA_15_ZqHWaRMAAAAlAAAAZAAAAA8BAAAAkAAAAEgAAACQAAAASAAAAAAAAAABAAAAAAAAAAEAAABQAAAAAAAAAAAA4D8AAAAAAADgPwAAAAAAAOA/AAAAAAAA4D8AAAAAAADgPwAAAAAAAOA/AAAAAAAA4D8AAAAAAADgPwAAAAAAAOA/AAAAAAAA4D8CAAAAjAAAAAAAAAAAAAAAu+DjDP///wgAAAAAAAAAAAAAAAAAAAAAAAAAAAAAAAAAAAAAZAAAAAEAAABAAAAAAAAAAAAAAAAAAAAAAAAAAAAAAAAAAAAAAAAAAAAAAAAAAAAAAAAAAAAAAAAAAAAAAAAAAAAAAAAAAAAAAAAAAAAAAAAAAAAAAAAAAAAAAAAAAAAAFAAAADwAAAAAAAAAAAAAAAAAAAkUAAAAAQAAABQAAAAUAAAAFAAAAAEAAAAAAAAAZAAAAGQAAAAAAAAAZAAAAGQAAAAVAAAAYAAAAAAAAAAAAAAADwAAACADAAAAAAAAAAAAAAEAAACgMgAAVgcAAKr4//8BAAAAf39/AAEAAABkAAAAAAAAABQAAABAHwAAAAAAACYAAAAAAAAAwOD//wAAAAAmAAAAZAAAABYAAABMAAAAAAAAAAAAAAAEAAAAAAAAAAEAAACAgIAKAAAAACgAAAAoAAAAZAAAAGQAAAAAAAAAzMzMAAAAAABQAAAAUAAAAGQAAABkAAAAAAAAABcAAAAUAAAAAAAAAAAAAAD/fwAA/38AAAAAAAAJAAAABAAAAAAAAAAeAAAAaAAAAAAAAAAAAAAAAAAAAAAAAAAAAAAAECcAABAnAAAAAAAAAAAAAAAAAAAAAAAAAAAAAAAAAAAAAAAAAAAAABQAAAAAAAAAwMD/AAAAAABkAAAAMgAAAAAAAABkAAAAAAAAAH9/fwAKAAAAIgAAABgAAAAAAAAAAAAAAAAAAAAAAAAAAAAAAAAAAAAkAAAAJAAAAAAAAAAHAAAAAAAAAAAAAAAAAAAAAAAAAAAAAAAAAAAAf39/ACUAAABYAAAAAAAAAAAAAAAAAAAAAAAAAAAAAAAAAAAAAAAAAAAAAAAAAAAAAAAAAAAAAAA/AAAAAAAAAKCGAQAAAAAAAAAAAAAAAAAMAAAAAQAAAAAAAAAAAAAAAAAAAB8AAABUAAAAAAAABQAAAAEAAAAAAAAAAAAAAAAAAAAAAAAAAAAAAAAAAAAAAAAAAAAAAAJ/f38AAAAAA8zMzADAwP8Af39/AAAAAAAAAAAAAAAAAAAAAAAAAAAAIQAAABgAAAAUAAAAwAMAABsnAAA/FQAAWSkAABAAAAAmAAAACAAAAAAAAAAAAAAA"/>
               </a:ext>
             </a:extLst>
           </p:cNvSpPr>
@@ -529,7 +529,7 @@
           <a:lstStyle/>
           <a:p>
             <a:pPr/>
-            <a:fld id="{426D1226-68AF-38E4-E1D5-9EB15C9B17CB}" type="datetime1">
+            <a:fld id="{2A784A67-29C7-2DBC-89C0-DFE9048E7F8A}" type="datetime1">
               <a:t/>
             </a:fld>
           </a:p>
@@ -542,7 +542,7 @@
             <a:spLocks noGrp="1" noChangeArrowheads="1"/>
             <a:extLst>
               <a:ext uri="smNativeData">
-                <pr:smNativeData xmlns:pr="smNativeData" xmlns="smNativeData" val="SMDATA_15_7aDWaRMAAAAlAAAAZAAAAA8BAAAAkAAAAEgAAACQAAAASAAAAAAAAAABAAAAAAAAAAEAAABQAAAAAAAAAAAA4D8AAAAAAADgPwAAAAAAAOA/AAAAAAAA4D8AAAAAAADgPwAAAAAAAOA/AAAAAAAA4D8AAAAAAADgPwAAAAAAAOA/AAAAAAAA4D8CAAAAjAAAAAAAAAAAAAAAu+DjDP///wgAAAAAAAAAAAAAAAAAAAAAAAAAAAAAAAAAAAAAZAAAAAEAAABAAAAAAAAAAAAAAAAAAAAAAAAAAAAAAAAAAAAAAAAAAAAAAAAAAAAAAAAAAAAAAAAAAAAAAAAAAAAAAAAAAAAAAAAAAAAAAAAAAAAAAAAAAAAAAAAAAAAAFAAAADwAAAAAAAAAAAAAAAAAAAkUAAAAAQAAABQAAAAUAAAAFAAAAAEAAAAAAAAAZAAAAGQAAAAAAAAAZAAAAGQAAAAVAAAAYAAAAAAAAAAAAAAADwAAACADAAAAAAAAAAAAAAEAAACgMgAAVgcAAKr4//8BAAAAf39/AAEAAABkAAAAAAAAABQAAABAHwAAAAAAACYAAAAAAAAAwOD//wAAAAAmAAAAZAAAABYAAABMAAAAAAAAAAAAAAAEAAAAAAAAAAEAAACAgIAKAAAAACgAAAAoAAAAZAAAAGQAAAAAAAAAzMzMAAAAAABQAAAAUAAAAGQAAABkAAAAAAAAABcAAAAUAAAAAAAAAAAAAAD/fwAA/38AAAAAAAAJAAAABAAAAGE6c3AeAAAAaAAAAAAAAAAAAAAAAAAAAAAAAAAAAAAAECcAABAnAAAAAAAAAAAAAAAAAAAAAAAAAAAAAAAAAAAAAAAAAAAAABQAAAAAAAAAwMD/AAAAAABkAAAAMgAAAAAAAABkAAAAAAAAAH9/fwAKAAAAIgAAABgAAAAAAAAAAAAAAAAAAAAAAAAAAAAAAAAAAAAkAAAAJAAAAAAAAAAHAAAAAAAAAAAAAAAAAAAAAAAAAAAAAAAAAAAAf39/ACUAAABYAAAAAAAAAAAAAAAAAAAAAAAAAAAAAAAAAAAAAAAAAAAAAAAAAAAAAAAAAAAAAAA/AAAAAAAAAKCGAQAAAAAAAAAAAAAAAAAMAAAAAQAAAAAAAAAAAAAAAAAAAB8AAABUAAAAAAAABQAAAAEAAAAAAAAAAAAAAAAAAAAAAAAAAAAAAAAAAAAAAAAAAAAAAAJ/f38AAAAAA8zMzADAwP8Af39/AAAAAAAAAAAAAAAAAAAAAAAAAAAAIQAAABgAAAAUAAAAoRkAABsnAABfMQAAWSkAABAAAAAmAAAACAAAAAAAAAAAAAAA"/>
+                <pr:smNativeData xmlns:pr="smNativeData" xmlns="smNativeData" val="SMDATA_15_ZqHWaRMAAAAlAAAAZAAAAA8BAAAAkAAAAEgAAACQAAAASAAAAAAAAAABAAAAAAAAAAEAAABQAAAAAAAAAAAA4D8AAAAAAADgPwAAAAAAAOA/AAAAAAAA4D8AAAAAAADgPwAAAAAAAOA/AAAAAAAA4D8AAAAAAADgPwAAAAAAAOA/AAAAAAAA4D8CAAAAjAAAAAAAAAAAAAAAu+DjDP///wgAAAAAAAAAAAAAAAAAAAAAAAAAAAAAAAAAAAAAZAAAAAEAAABAAAAAAAAAAAAAAAAAAAAAAAAAAAAAAAAAAAAAAAAAAAAAAAAAAAAAAAAAAAAAAAAAAAAAAAAAAAAAAAAAAAAAAAAAAAAAAAAAAAAAAAAAAAAAAAAAAAAAFAAAADwAAAAAAAAAAAAAAAAAAAkUAAAAAQAAABQAAAAUAAAAFAAAAAEAAAAAAAAAZAAAAGQAAAAAAAAAZAAAAGQAAAAVAAAAYAAAAAAAAAAAAAAADwAAACADAAAAAAAAAAAAAAEAAACgMgAAVgcAAKr4//8BAAAAf39/AAEAAABkAAAAAAAAABQAAABAHwAAAAAAACYAAAAAAAAAwOD//wAAAAAmAAAAZAAAABYAAABMAAAAAAAAAAAAAAAEAAAAAAAAAAEAAACAgIAKAAAAACgAAAAoAAAAZAAAAGQAAAAAAAAAzMzMAAAAAABQAAAAUAAAAGQAAABkAAAAAAAAABcAAAAUAAAAAAAAAAAAAAD/fwAA/38AAAAAAAAJAAAABAAAAGE6c3AeAAAAaAAAAAAAAAAAAAAAAAAAAAAAAAAAAAAAECcAABAnAAAAAAAAAAAAAAAAAAAAAAAAAAAAAAAAAAAAAAAAAAAAABQAAAAAAAAAwMD/AAAAAABkAAAAMgAAAAAAAABkAAAAAAAAAH9/fwAKAAAAIgAAABgAAAAAAAAAAAAAAAAAAAAAAAAAAAAAAAAAAAAkAAAAJAAAAAAAAAAHAAAAAAAAAAAAAAAAAAAAAAAAAAAAAAAAAAAAf39/ACUAAABYAAAAAAAAAAAAAAAAAAAAAAAAAAAAAAAAAAAAAAAAAAAAAAAAAAAAAAAAAAAAAAA/AAAAAAAAAKCGAQAAAAAAAAAAAAAAAAAMAAAAAQAAAAAAAAAAAAAAAAAAAB8AAABUAAAAAAAABQAAAAEAAAAAAAAAAAAAAAAAAAAAAAAAAAAAAAAAAAAAAAAAAAAAAAJ/f38AAAAAA8zMzADAwP8Af39/AAAAAAAAAAAAAAAAAAAAAAAAAAAAIQAAABgAAAAUAAAAoRkAABsnAABfMQAAWSkAABAAAAAmAAAACAAAAAAAAAAAAAAA"/>
               </a:ext>
             </a:extLst>
           </p:cNvSpPr>
@@ -566,7 +566,7 @@
             <a:spLocks noGrp="1" noChangeArrowheads="1"/>
             <a:extLst>
               <a:ext uri="smNativeData">
-                <pr:smNativeData xmlns:pr="smNativeData" xmlns="smNativeData" val="SMDATA_15_7aDWaRMAAAAlAAAAZAAAAA8BAAAAkAAAAEgAAACQAAAASAAAAAAAAAABAAAAAAAAAAEAAABQAAAAAAAAAAAA4D8AAAAAAADgPwAAAAAAAOA/AAAAAAAA4D8AAAAAAADgPwAAAAAAAOA/AAAAAAAA4D8AAAAAAADgPwAAAAAAAOA/AAAAAAAA4D8CAAAAjAAAAAAAAAAAAAAAu+DjDP///wgAAAAAAAAAAAAAAAAAAAAAAAAAAAAAAAAAAAAAZAAAAAEAAABAAAAAAAAAAAAAAAAAAAAAAAAAAAAAAAAAAAAAAAAAAAAAAAAAAAAAAAAAAAAAAAAAAAAAAAAAAAAAAAAAAAAAAAAAAAAAAAAAAAAAAAAAAAAAAAAAAAAAFAAAADwAAAAAAAAAAAAAAAAAAAkUAAAAAQAAABQAAAAUAAAAFAAAAAEAAAAAAAAAZAAAAGQAAAAAAAAAZAAAAGQAAAAVAAAAYAAAAAAAAAAAAAAADwAAACADAAAAAAAAAAAAAAEAAACgMgAAVgcAAKr4//8BAAAAf39/AAEAAABkAAAAAAAAABQAAABAHwAAAAAAACYAAAAAAAAAwOD//wAAAAAmAAAAZAAAABYAAABMAAAAAAAAAAAAAAAEAAAAAAAAAAEAAACAgIAKAAAAACgAAAAoAAAAZAAAAGQAAAAAAAAAzMzMAAAAAABQAAAAUAAAAGQAAABkAAAAAAAAABcAAAAUAAAAAAAAAAAAAAD/fwAA/38AAAAAAAAJAAAABAAAAAAAAAAeAAAAaAAAAAAAAAAAAAAAAAAAAAAAAAAAAAAAECcAABAnAAAAAAAAAAAAAAAAAAAAAAAAAAAAAAAAAAAAAAAAAAAAABQAAAAAAAAAwMD/AAAAAABkAAAAMgAAAAAAAABkAAAAAAAAAH9/fwAKAAAAIgAAABgAAAAAAAAAAAAAAAAAAAAAAAAAAAAAAAAAAAAkAAAAJAAAAAAAAAAHAAAAAAAAAAAAAAAAAAAAAAAAAAAAAAAAAAAAf39/ACUAAABYAAAAAAAAAAAAAAAAAAAAAAAAAAAAAAAAAAAAAAAAAAAAAAAAAAAAAAAAAAAAAAA/AAAAAAAAAKCGAQAAAAAAAAAAAAAAAAAMAAAAAQAAAAAAAAAAAAAAAAAAAB8AAABUAAAAAAAABQAAAAEAAAAAAAAAAAAAAAAAAAAAAAAAAAAAAAAAAAAAAAAAAAAAAAJ/f38AAAAAA8zMzADAwP8Af39/AAAAAAAAAAAAAAAAAAAAAAAAAAAAIQAAABgAAAAUAAAAwTUAABsnAABARwAAWSkAABAAAAAmAAAACAAAAAAAAAAAAAAA"/>
+                <pr:smNativeData xmlns:pr="smNativeData" xmlns="smNativeData" val="SMDATA_15_ZqHWaRMAAAAlAAAAZAAAAA8BAAAAkAAAAEgAAACQAAAASAAAAAAAAAABAAAAAAAAAAEAAABQAAAAAAAAAAAA4D8AAAAAAADgPwAAAAAAAOA/AAAAAAAA4D8AAAAAAADgPwAAAAAAAOA/AAAAAAAA4D8AAAAAAADgPwAAAAAAAOA/AAAAAAAA4D8CAAAAjAAAAAAAAAAAAAAAu+DjDP///wgAAAAAAAAAAAAAAAAAAAAAAAAAAAAAAAAAAAAAZAAAAAEAAABAAAAAAAAAAAAAAAAAAAAAAAAAAAAAAAAAAAAAAAAAAAAAAAAAAAAAAAAAAAAAAAAAAAAAAAAAAAAAAAAAAAAAAAAAAAAAAAAAAAAAAAAAAAAAAAAAAAAAFAAAADwAAAAAAAAAAAAAAAAAAAkUAAAAAQAAABQAAAAUAAAAFAAAAAEAAAAAAAAAZAAAAGQAAAAAAAAAZAAAAGQAAAAVAAAAYAAAAAAAAAAAAAAADwAAACADAAAAAAAAAAAAAAEAAACgMgAAVgcAAKr4//8BAAAAf39/AAEAAABkAAAAAAAAABQAAABAHwAAAAAAACYAAAAAAAAAwOD//wAAAAAmAAAAZAAAABYAAABMAAAAAAAAAAAAAAAEAAAAAAAAAAEAAACAgIAKAAAAACgAAAAoAAAAZAAAAGQAAAAAAAAAzMzMAAAAAABQAAAAUAAAAGQAAABkAAAAAAAAABcAAAAUAAAAAAAAAAAAAAD/fwAA/38AAAAAAAAJAAAABAAAAAAAAAAeAAAAaAAAAAAAAAAAAAAAAAAAAAAAAAAAAAAAECcAABAnAAAAAAAAAAAAAAAAAAAAAAAAAAAAAAAAAAAAAAAAAAAAABQAAAAAAAAAwMD/AAAAAABkAAAAMgAAAAAAAABkAAAAAAAAAH9/fwAKAAAAIgAAABgAAAAAAAAAAAAAAAAAAAAAAAAAAAAAAAAAAAAkAAAAJAAAAAAAAAAHAAAAAAAAAAAAAAAAAAAAAAAAAAAAAAAAAAAAf39/ACUAAABYAAAAAAAAAAAAAAAAAAAAAAAAAAAAAAAAAAAAAAAAAAAAAAAAAAAAAAAAAAAAAAA/AAAAAAAAAKCGAQAAAAAAAAAAAAAAAAAMAAAAAQAAAAAAAAAAAAAAAAAAAB8AAABUAAAAAAAABQAAAAEAAAAAAAAAAAAAAAAAAAAAAAAAAAAAAAAAAAAAAAAAAAAAAAJ/f38AAAAAA8zMzADAwP8Af39/AAAAAAAAAAAAAAAAAAAAAAAAAAAAIQAAABgAAAAUAAAAwTUAABsnAABARwAAWSkAABAAAAAmAAAACAAAAAAAAAAAAAAA"/>
               </a:ext>
             </a:extLst>
           </p:cNvSpPr>
@@ -580,7 +580,7 @@
           <a:lstStyle/>
           <a:p>
             <a:pPr/>
-            <a:fld id="{62202A29-678F-75DC-C198-918964D637C4}" type="slidenum">
+            <a:fld id="{1F58A682-CCF2-0D50-BCE0-3A05E8AE4A6F}" type="slidenum">
               <a:t/>
             </a:fld>
           </a:p>
@@ -619,7 +619,7 @@
             <a:spLocks noGrp="1" noChangeArrowheads="1"/>
             <a:extLst>
               <a:ext uri="smNativeData">
-                <pr:smNativeData xmlns:pr="smNativeData" xmlns="smNativeData" val="SMDATA_15_7aDWaRMAAAAlAAAAZAAAAA8BAAAAkAAAAEgAAACQAAAASAAAAAAAAAACAAAAAQAAAAEAAABQAAAAAAAAAAAA4D8AAAAAAADgPwAAAAAAAOA/AAAAAAAA4D8AAAAAAADgPwAAAAAAAOA/AAAAAAAA4D8AAAAAAADgPwAAAAAAAOA/AAAAAAAA4D8CAAAAjAAAAAAAAAAAAAAAu+DjDP///wgAAAAAAAAAAAAAAAAAAAAAAAAAAAAAAAAAAAAAZAAAAAEAAABAAAAAAAAAAAAAAAAAAAAAAAAAAAAAAAAAAAAAAAAAAAAAAAAAAAAAAAAAAAAAAAAAAAAAAAAAAAAAAAAAAAAAAAAAAAAAAAAAAAAAAAAAAAAAAAAAAAAAFAAAADwAAAAAAAAAAAAAAAAAAAkUAAAAAQAAABQAAAAUAAAAFAAAAAEAAAAAAAAAZAAAAGQAAAAAAAAAZAAAAGQAAAAVAAAAYAAAAAAAAAAAAAAADwAAACADAAAAAAAAAAAAAAEAAACgMgAAVgcAAKr4//8BAAAAf39/AAEAAABkAAAAAAAAABQAAABAHwAAAAAAACYAAAAAAAAAwOD//wAAAAAmAAAAZAAAABYAAABMAAAAAAAAAAAAAAAEAAAAAAAAAAEAAACAgIAKAAAAACgAAAAoAAAAZAAAAGQAAAAAAAAAzMzMAAAAAABQAAAAUAAAAGQAAABkAAAAAAAAABcAAAAUAAAAAAAAAAAAAAD/fwAA/38AAAAAAAAJAAAABAAAAAAAAAAeAAAAaAAAAAAAAAAAAAAAAAAAAAAAAAAAAAAAECcAABAnAAAAAAAAAAAAAAAAAAAAAAAAAAAAAAAAAAAAAAAAAAAAABQAAAAAAAAAwMD/AAAAAABkAAAAMgAAAAAAAABkAAAAAAAAAH9/fwAKAAAAIgAAABgAAAAAAAAAAAAAAAAAAAAAAAAAAAAAAAAAAAAkAAAAJAAAAAAAAAAHAAAAAAAAAAAAAAAAAAAAAAAAAAAAAAAAAAAAf39/ACUAAABYAAAAAAAAAAAAAAAAAAAAAAAAAAAAAAAAAAAAAAAAAAAAAAAAAAAAAAAAAAAAAAA/AAAAAAAAAKCGAQAAAAAAAAAAAAAAAAAMAAAAAQAAAAAAAAAAAAAAAAAAAB8AAABUAAAAAAAABQAAAAEAAAAAAAAAAAAAAAAAAAAAAAAAAAAAAAAAAAAAAAAAAAAAAAJ/f38AAAAAA8zMzADAwP8Af39/AAAAAAAAAAAAAAAAAAAAAAAAAAAAIQAAABgAAAAUAAAAYDYAALABAABARwAAsCUAABAAAAAmAAAACAAAAIMAAAAAAAAA"/>
+                <pr:smNativeData xmlns:pr="smNativeData" xmlns="smNativeData" val="SMDATA_15_ZqHWaRMAAAAlAAAAZAAAAA8BAAAAkAAAAEgAAACQAAAASAAAAAAAAAACAAAAAQAAAAEAAABQAAAAAAAAAAAA4D8AAAAAAADgPwAAAAAAAOA/AAAAAAAA4D8AAAAAAADgPwAAAAAAAOA/AAAAAAAA4D8AAAAAAADgPwAAAAAAAOA/AAAAAAAA4D8CAAAAjAAAAAAAAAAAAAAAu+DjDP///wgAAAAAAAAAAAAAAAAAAAAAAAAAAAAAAAAAAAAAZAAAAAEAAABAAAAAAAAAAAAAAAAAAAAAAAAAAAAAAAAAAAAAAAAAAAAAAAAAAAAAAAAAAAAAAAAAAAAAAAAAAAAAAAAAAAAAAAAAAAAAAAAAAAAAAAAAAAAAAAAAAAAAFAAAADwAAAAAAAAAAAAAAAAAAAkUAAAAAQAAABQAAAAUAAAAFAAAAAEAAAAAAAAAZAAAAGQAAAAAAAAAZAAAAGQAAAAVAAAAYAAAAAAAAAAAAAAADwAAACADAAAAAAAAAAAAAAEAAACgMgAAVgcAAKr4//8BAAAAf39/AAEAAABkAAAAAAAAABQAAABAHwAAAAAAACYAAAAAAAAAwOD//wAAAAAmAAAAZAAAABYAAABMAAAAAAAAAAAAAAAEAAAAAAAAAAEAAACAgIAKAAAAACgAAAAoAAAAZAAAAGQAAAAAAAAAzMzMAAAAAABQAAAAUAAAAGQAAABkAAAAAAAAABcAAAAUAAAAAAAAAAAAAAD/fwAA/38AAAAAAAAJAAAABAAAAAAAAAAeAAAAaAAAAAAAAAAAAAAAAAAAAAAAAAAAAAAAECcAABAnAAAAAAAAAAAAAAAAAAAAAAAAAAAAAAAAAAAAAAAAAAAAABQAAAAAAAAAwMD/AAAAAABkAAAAMgAAAAAAAABkAAAAAAAAAH9/fwAKAAAAIgAAABgAAAAAAAAAAAAAAAAAAAAAAAAAAAAAAAAAAAAkAAAAJAAAAAAAAAAHAAAAAAAAAAAAAAAAAAAAAAAAAAAAAAAAAAAAf39/ACUAAABYAAAAAAAAAAAAAAAAAAAAAAAAAAAAAAAAAAAAAAAAAAAAAAAAAAAAAAAAAAAAAAA/AAAAAAAAAKCGAQAAAAAAAAAAAAAAAAAMAAAAAQAAAAAAAAAAAAAAAAAAAB8AAABUAAAAAAAABQAAAAEAAAAAAAAAAAAAAAAAAAAAAAAAAAAAAAAAAAAAAAAAAAAAAAJ/f38AAAAAA8zMzADAwP8Af39/AAAAAAAAAAAAAAAAAAAAAAAAAAAAIQAAABgAAAAUAAAAYDYAALABAABARwAAsCUAABAAAAAmAAAACAAAAIMAAAAAAAAA"/>
               </a:ext>
             </a:extLst>
           </p:cNvSpPr>
@@ -655,7 +655,7 @@
             <a:spLocks noGrp="1" noChangeArrowheads="1"/>
             <a:extLst>
               <a:ext uri="smNativeData">
-                <pr:smNativeData xmlns:pr="smNativeData" xmlns="smNativeData" val="SMDATA_15_7aDWaRMAAAAlAAAAZAAAAA8BAAAAkAAAAEgAAACQAAAASAAAAAAAAAAAAAAAAQAAAAEAAABQAAAAAAAAAAAA4D8AAAAAAADgPwAAAAAAAOA/AAAAAAAA4D8AAAAAAADgPwAAAAAAAOA/AAAAAAAA4D8AAAAAAADgPwAAAAAAAOA/AAAAAAAA4D8CAAAAjAAAAAAAAAAAAAAAu+DjDP///wgAAAAAAAAAAAAAAAAAAAAAAAAAAAAAAAAAAAAAZAAAAAEAAABAAAAAAAAAAAAAAAAAAAAAAAAAAAAAAAAAAAAAAAAAAAAAAAAAAAAAAAAAAAAAAAAAAAAAAAAAAAAAAAAAAAAAAAAAAAAAAAAAAAAAAAAAAAAAAAAAAAAAFAAAADwAAAAAAAAAAAAAAAAAAAkUAAAAAQAAABQAAAAUAAAAFAAAAAEAAAAAAAAAZAAAAGQAAAAAAAAAZAAAAGQAAAAVAAAAYAAAAAAAAAAAAAAADwAAACADAAAAAAAAAAAAAAEAAACgMgAAVgcAAKr4//8BAAAAf39/AAEAAABkAAAAAAAAABQAAABAHwAAAAAAACYAAAAAAAAAwOD//wAAAAAmAAAAZAAAABYAAABMAAAAAAAAAAAAAAAEAAAAAAAAAAEAAACAgIAKAAAAACgAAAAoAAAAZAAAAGQAAAAAAAAAzMzMAAAAAABQAAAAUAAAAGQAAABkAAAAAAAAABcAAAAUAAAAAAAAAAAAAAD/fwAA/38AAAAAAAAJAAAABAAAAAAAAAAeAAAAaAAAAAAAAAAAAAAAAAAAAAAAAAAAAAAAECcAABAnAAAAAAAAAAAAAAAAAAAAAAAAAAAAAAAAAAAAAAAAAAAAABQAAAAAAAAAwMD/AAAAAABkAAAAMgAAAAAAAABkAAAAAAAAAH9/fwAKAAAAIgAAABgAAAAAAAAAAAAAAAAAAAAAAAAAAAAAAAAAAAAkAAAAJAAAAAAAAAAHAAAAAAAAAAAAAAAAAAAAAAAAAAAAAAAAAAAAf39/ACUAAABYAAAAAAAAAAAAAAAAAAAAAAAAAAAAAAAAAAAAAAAAAAAAAAAAAAAAAAAAAAAAAAA/AAAAAAAAAKCGAQAAAAAAAAAAAAAAAAAMAAAAAQAAAAAAAAAAAAAAAAAAAB8AAABUAAAAAAAABQAAAAEAAAAAAAAAAAAAAAAAAAAAAAAAAAAAAAAAAAAAAAAAAAAAAAJ/f38AAAAAA8zMzADAwP8Af39/AAAAAAAAAAAAAAAAAAAAAAAAAAAAIQAAABgAAAAUAAAAwAMAALABAAAfNQAAsCUAABAAAAAmAAAACAAAAAMAAAAAAAAA"/>
+                <pr:smNativeData xmlns:pr="smNativeData" xmlns="smNativeData" val="SMDATA_15_ZqHWaRMAAAAlAAAAZAAAAA8BAAAAkAAAAEgAAACQAAAASAAAAAAAAAAAAAAAAQAAAAEAAABQAAAAAAAAAAAA4D8AAAAAAADgPwAAAAAAAOA/AAAAAAAA4D8AAAAAAADgPwAAAAAAAOA/AAAAAAAA4D8AAAAAAADgPwAAAAAAAOA/AAAAAAAA4D8CAAAAjAAAAAAAAAAAAAAAu+DjDP///wgAAAAAAAAAAAAAAAAAAAAAAAAAAAAAAAAAAAAAZAAAAAEAAABAAAAAAAAAAAAAAAAAAAAAAAAAAAAAAAAAAAAAAAAAAAAAAAAAAAAAAAAAAAAAAAAAAAAAAAAAAAAAAAAAAAAAAAAAAAAAAAAAAAAAAAAAAAAAAAAAAAAAFAAAADwAAAAAAAAAAAAAAAAAAAkUAAAAAQAAABQAAAAUAAAAFAAAAAEAAAAAAAAAZAAAAGQAAAAAAAAAZAAAAGQAAAAVAAAAYAAAAAAAAAAAAAAADwAAACADAAAAAAAAAAAAAAEAAACgMgAAVgcAAKr4//8BAAAAf39/AAEAAABkAAAAAAAAABQAAABAHwAAAAAAACYAAAAAAAAAwOD//wAAAAAmAAAAZAAAABYAAABMAAAAAAAAAAAAAAAEAAAAAAAAAAEAAACAgIAKAAAAACgAAAAoAAAAZAAAAGQAAAAAAAAAzMzMAAAAAABQAAAAUAAAAGQAAABkAAAAAAAAABcAAAAUAAAAAAAAAAAAAAD/fwAA/38AAAAAAAAJAAAABAAAAAAAAAAeAAAAaAAAAAAAAAAAAAAAAAAAAAAAAAAAAAAAECcAABAnAAAAAAAAAAAAAAAAAAAAAAAAAAAAAAAAAAAAAAAAAAAAABQAAAAAAAAAwMD/AAAAAABkAAAAMgAAAAAAAABkAAAAAAAAAH9/fwAKAAAAIgAAABgAAAAAAAAAAAAAAAAAAAAAAAAAAAAAAAAAAAAkAAAAJAAAAAAAAAAHAAAAAAAAAAAAAAAAAAAAAAAAAAAAAAAAAAAAf39/ACUAAABYAAAAAAAAAAAAAAAAAAAAAAAAAAAAAAAAAAAAAAAAAAAAAAAAAAAAAAAAAAAAAAA/AAAAAAAAAKCGAQAAAAAAAAAAAAAAAAAMAAAAAQAAAAAAAAAAAAAAAAAAAB8AAABUAAAAAAAABQAAAAEAAAAAAAAAAAAAAAAAAAAAAAAAAAAAAAAAAAAAAAAAAAAAAAJ/f38AAAAAA8zMzADAwP8Af39/AAAAAAAAAAAAAAAAAAAAAAAAAAAAIQAAABgAAAAUAAAAwAMAALABAAAfNQAAsCUAABAAAAAmAAAACAAAAAMAAAAAAAAA"/>
               </a:ext>
             </a:extLst>
           </p:cNvSpPr>
@@ -715,7 +715,7 @@
             <a:spLocks noGrp="1" noChangeArrowheads="1"/>
             <a:extLst>
               <a:ext uri="smNativeData">
-                <pr:smNativeData xmlns:pr="smNativeData" xmlns="smNativeData" val="SMDATA_15_7aDWaRMAAAAlAAAAZAAAAA8BAAAAkAAAAEgAAACQAAAASAAAAAAAAAABAAAAAAAAAAEAAABQAAAAAAAAAAAA4D8AAAAAAADgPwAAAAAAAOA/AAAAAAAA4D8AAAAAAADgPwAAAAAAAOA/AAAAAAAA4D8AAAAAAADgPwAAAAAAAOA/AAAAAAAA4D8CAAAAjAAAAAAAAAAAAAAAu+DjDP///wgAAAAAAAAAAAAAAAAAAAAAAAAAAAAAAAAAAAAAZAAAAAEAAABAAAAAAAAAAAAAAAAAAAAAAAAAAAAAAAAAAAAAAAAAAAAAAAAAAAAAAAAAAAAAAAAAAAAAAAAAAAAAAAAAAAAAAAAAAAAAAAAAAAAAAAAAAAAAAAAAAAAAFAAAADwAAAAAAAAAAAAAAAAAAAkUAAAAAQAAABQAAAAUAAAAFAAAAAEAAAAAAAAAZAAAAGQAAAAAAAAAZAAAAGQAAAAVAAAAYAAAAAAAAAAAAAAADwAAACADAAAAAAAAAAAAAAEAAACgMgAAVgcAAKr4//8BAAAAf39/AAEAAABkAAAAAAAAABQAAABAHwAAAAAAACYAAAAAAAAAwOD//wAAAAAmAAAAZAAAABYAAABMAAAAAAAAAAAAAAAEAAAAAAAAAAEAAACAgIAKAAAAACgAAAAoAAAAZAAAAGQAAAAAAAAAzMzMAAAAAABQAAAAUAAAAGQAAABkAAAAAAAAABcAAAAUAAAAAAAAAAAAAAD/fwAA/38AAAAAAAAJAAAABAAAAAAAAAAeAAAAaAAAAAAAAAAAAAAAAAAAAAAAAAAAAAAAECcAABAnAAAAAAAAAAAAAAAAAAAAAAAAAAAAAAAAAAAAAAAAAAAAABQAAAAAAAAAwMD/AAAAAABkAAAAMgAAAAAAAABkAAAAAAAAAH9/fwAKAAAAIgAAABgAAAAAAAAAAAAAAAAAAAAAAAAAAAAAAAAAAAAkAAAAJAAAAAAAAAAHAAAAAAAAAAAAAAAAAAAAAAAAAAAAAAAAAAAAf39/ACUAAABYAAAAAAAAAAAAAAAAAAAAAAAAAAAAAAAAAAAAAAAAAAAAAAAAAAAAAAAAAAAAAAA/AAAAAAAAAKCGAQAAAAAAAAAAAAAAAAAMAAAAAQAAAAAAAAAAAAAAAAAAAB8AAABUAAAAAAAABQAAAAEAAAAAAAAAAAAAAAAAAAAAAAAAAAAAAAAAAAAAAAAAAAAAAAJ/f38AAAAAA8zMzADAwP8Af39/AAAAAAAAAAAAAAAAAAAAAAAAAAAAIQAAABgAAAAUAAAAwAMAABsnAAA/FQAAWSkAABAAAAAmAAAACAAAAAAAAAAAAAAA"/>
+                <pr:smNativeData xmlns:pr="smNativeData" xmlns="smNativeData" val="SMDATA_15_ZqHWaRMAAAAlAAAAZAAAAA8BAAAAkAAAAEgAAACQAAAASAAAAAAAAAABAAAAAAAAAAEAAABQAAAAAAAAAAAA4D8AAAAAAADgPwAAAAAAAOA/AAAAAAAA4D8AAAAAAADgPwAAAAAAAOA/AAAAAAAA4D8AAAAAAADgPwAAAAAAAOA/AAAAAAAA4D8CAAAAjAAAAAAAAAAAAAAAu+DjDP///wgAAAAAAAAAAAAAAAAAAAAAAAAAAAAAAAAAAAAAZAAAAAEAAABAAAAAAAAAAAAAAAAAAAAAAAAAAAAAAAAAAAAAAAAAAAAAAAAAAAAAAAAAAAAAAAAAAAAAAAAAAAAAAAAAAAAAAAAAAAAAAAAAAAAAAAAAAAAAAAAAAAAAFAAAADwAAAAAAAAAAAAAAAAAAAkUAAAAAQAAABQAAAAUAAAAFAAAAAEAAAAAAAAAZAAAAGQAAAAAAAAAZAAAAGQAAAAVAAAAYAAAAAAAAAAAAAAADwAAACADAAAAAAAAAAAAAAEAAACgMgAAVgcAAKr4//8BAAAAf39/AAEAAABkAAAAAAAAABQAAABAHwAAAAAAACYAAAAAAAAAwOD//wAAAAAmAAAAZAAAABYAAABMAAAAAAAAAAAAAAAEAAAAAAAAAAEAAACAgIAKAAAAACgAAAAoAAAAZAAAAGQAAAAAAAAAzMzMAAAAAABQAAAAUAAAAGQAAABkAAAAAAAAABcAAAAUAAAAAAAAAAAAAAD/fwAA/38AAAAAAAAJAAAABAAAAAAAAAAeAAAAaAAAAAAAAAAAAAAAAAAAAAAAAAAAAAAAECcAABAnAAAAAAAAAAAAAAAAAAAAAAAAAAAAAAAAAAAAAAAAAAAAABQAAAAAAAAAwMD/AAAAAABkAAAAMgAAAAAAAABkAAAAAAAAAH9/fwAKAAAAIgAAABgAAAAAAAAAAAAAAAAAAAAAAAAAAAAAAAAAAAAkAAAAJAAAAAAAAAAHAAAAAAAAAAAAAAAAAAAAAAAAAAAAAAAAAAAAf39/ACUAAABYAAAAAAAAAAAAAAAAAAAAAAAAAAAAAAAAAAAAAAAAAAAAAAAAAAAAAAAAAAAAAAA/AAAAAAAAAKCGAQAAAAAAAAAAAAAAAAAMAAAAAQAAAAAAAAAAAAAAAAAAAB8AAABUAAAAAAAABQAAAAEAAAAAAAAAAAAAAAAAAAAAAAAAAAAAAAAAAAAAAAAAAAAAAAJ/f38AAAAAA8zMzADAwP8Af39/AAAAAAAAAAAAAAAAAAAAAAAAAAAAIQAAABgAAAAUAAAAwAMAABsnAAA/FQAAWSkAABAAAAAmAAAACAAAAAAAAAAAAAAA"/>
               </a:ext>
             </a:extLst>
           </p:cNvSpPr>
@@ -729,7 +729,7 @@
           <a:lstStyle/>
           <a:p>
             <a:pPr/>
-            <a:fld id="{2FA06291-DFC2-F594-8C18-29C12C567A7C}" type="datetime1">
+            <a:fld id="{0F5E14A8-E6E2-0BE2-ACE6-10B75AA85A45}" type="datetime1">
               <a:t/>
             </a:fld>
           </a:p>
@@ -742,7 +742,7 @@
             <a:spLocks noGrp="1" noChangeArrowheads="1"/>
             <a:extLst>
               <a:ext uri="smNativeData">
-                <pr:smNativeData xmlns:pr="smNativeData" xmlns="smNativeData" val="SMDATA_15_7aDWaRMAAAAlAAAAZAAAAA8BAAAAkAAAAEgAAACQAAAASAAAAAAAAAABAAAAAAAAAAEAAABQAAAAAAAAAAAA4D8AAAAAAADgPwAAAAAAAOA/AAAAAAAA4D8AAAAAAADgPwAAAAAAAOA/AAAAAAAA4D8AAAAAAADgPwAAAAAAAOA/AAAAAAAA4D8CAAAAjAAAAAAAAAAAAAAAu+DjDP///wgAAAAAAAAAAAAAAAAAAAAAAAAAAAAAAAAAAAAAZAAAAAEAAABAAAAAAAAAAAAAAAAAAAAAAAAAAAAAAAAAAAAAAAAAAAAAAAAAAAAAAAAAAAAAAAAAAAAAAAAAAAAAAAAAAAAAAAAAAAAAAAAAAAAAAAAAAAAAAAAAAAAAFAAAADwAAAAAAAAAAAAAAAAAAAkUAAAAAQAAABQAAAAUAAAAFAAAAAEAAAAAAAAAZAAAAGQAAAAAAAAAZAAAAGQAAAAVAAAAYAAAAAAAAAAAAAAADwAAACADAAAAAAAAAAAAAAEAAACgMgAAVgcAAKr4//8BAAAAf39/AAEAAABkAAAAAAAAABQAAABAHwAAAAAAACYAAAAAAAAAwOD//wAAAAAmAAAAZAAAABYAAABMAAAAAAAAAAAAAAAEAAAAAAAAAAEAAACAgIAKAAAAACgAAAAoAAAAZAAAAGQAAAAAAAAAzMzMAAAAAABQAAAAUAAAAGQAAABkAAAAAAAAABcAAAAUAAAAAAAAAAAAAAD/fwAA/38AAAAAAAAJAAAABAAAAAAAAAAeAAAAaAAAAAAAAAAAAAAAAAAAAAAAAAAAAAAAECcAABAnAAAAAAAAAAAAAAAAAAAAAAAAAAAAAAAAAAAAAAAAAAAAABQAAAAAAAAAwMD/AAAAAABkAAAAMgAAAAAAAABkAAAAAAAAAH9/fwAKAAAAIgAAABgAAAAAAAAAAAAAAAAAAAAAAAAAAAAAAAAAAAAkAAAAJAAAAAAAAAAHAAAAAAAAAAAAAAAAAAAAAAAAAAAAAAAAAAAAf39/ACUAAABYAAAAAAAAAAAAAAAAAAAAAAAAAAAAAAAAAAAAAAAAAAAAAAAAAAAAAAAAAAAAAAA/AAAAAAAAAKCGAQAAAAAAAAAAAAAAAAAMAAAAAQAAAAAAAAAAAAAAAAAAAB8AAABUAAAAAAAABQAAAAEAAAAAAAAAAAAAAAAAAAAAAAAAAAAAAAAAAAAAAAAAAAAAAAJ/f38AAAAAA8zMzADAwP8Af39/AAAAAAAAAAAAAAAAAAAAAAAAAAAAIQAAABgAAAAUAAAAoRkAABsnAABfMQAAWSkAABAAAAAmAAAACAAAAAAAAAAAAAAA"/>
+                <pr:smNativeData xmlns:pr="smNativeData" xmlns="smNativeData" val="SMDATA_15_ZqHWaRMAAAAlAAAAZAAAAA8BAAAAkAAAAEgAAACQAAAASAAAAAAAAAABAAAAAAAAAAEAAABQAAAAAAAAAAAA4D8AAAAAAADgPwAAAAAAAOA/AAAAAAAA4D8AAAAAAADgPwAAAAAAAOA/AAAAAAAA4D8AAAAAAADgPwAAAAAAAOA/AAAAAAAA4D8CAAAAjAAAAAAAAAAAAAAAu+DjDP///wgAAAAAAAAAAAAAAAAAAAAAAAAAAAAAAAAAAAAAZAAAAAEAAABAAAAAAAAAAAAAAAAAAAAAAAAAAAAAAAAAAAAAAAAAAAAAAAAAAAAAAAAAAAAAAAAAAAAAAAAAAAAAAAAAAAAAAAAAAAAAAAAAAAAAAAAAAAAAAAAAAAAAFAAAADwAAAAAAAAAAAAAAAAAAAkUAAAAAQAAABQAAAAUAAAAFAAAAAEAAAAAAAAAZAAAAGQAAAAAAAAAZAAAAGQAAAAVAAAAYAAAAAAAAAAAAAAADwAAACADAAAAAAAAAAAAAAEAAACgMgAAVgcAAKr4//8BAAAAf39/AAEAAABkAAAAAAAAABQAAABAHwAAAAAAACYAAAAAAAAAwOD//wAAAAAmAAAAZAAAABYAAABMAAAAAAAAAAAAAAAEAAAAAAAAAAEAAACAgIAKAAAAACgAAAAoAAAAZAAAAGQAAAAAAAAAzMzMAAAAAABQAAAAUAAAAGQAAABkAAAAAAAAABcAAAAUAAAAAAAAAAAAAAD/fwAA/38AAAAAAAAJAAAABAAAAAAAAAAeAAAAaAAAAAAAAAAAAAAAAAAAAAAAAAAAAAAAECcAABAnAAAAAAAAAAAAAAAAAAAAAAAAAAAAAAAAAAAAAAAAAAAAABQAAAAAAAAAwMD/AAAAAABkAAAAMgAAAAAAAABkAAAAAAAAAH9/fwAKAAAAIgAAABgAAAAAAAAAAAAAAAAAAAAAAAAAAAAAAAAAAAAkAAAAJAAAAAAAAAAHAAAAAAAAAAAAAAAAAAAAAAAAAAAAAAAAAAAAf39/ACUAAABYAAAAAAAAAAAAAAAAAAAAAAAAAAAAAAAAAAAAAAAAAAAAAAAAAAAAAAAAAAAAAAA/AAAAAAAAAKCGAQAAAAAAAAAAAAAAAAAMAAAAAQAAAAAAAAAAAAAAAAAAAB8AAABUAAAAAAAABQAAAAEAAAAAAAAAAAAAAAAAAAAAAAAAAAAAAAAAAAAAAAAAAAAAAAJ/f38AAAAAA8zMzADAwP8Af39/AAAAAAAAAAAAAAAAAAAAAAAAAAAAIQAAABgAAAAUAAAAoRkAABsnAABfMQAAWSkAABAAAAAmAAAACAAAAAAAAAAAAAAA"/>
               </a:ext>
             </a:extLst>
           </p:cNvSpPr>
@@ -766,7 +766,7 @@
             <a:spLocks noGrp="1" noChangeArrowheads="1"/>
             <a:extLst>
               <a:ext uri="smNativeData">
-                <pr:smNativeData xmlns:pr="smNativeData" xmlns="smNativeData" val="SMDATA_15_7aDWaRMAAAAlAAAAZAAAAA8BAAAAkAAAAEgAAACQAAAASAAAAAAAAAABAAAAAAAAAAEAAABQAAAAAAAAAAAA4D8AAAAAAADgPwAAAAAAAOA/AAAAAAAA4D8AAAAAAADgPwAAAAAAAOA/AAAAAAAA4D8AAAAAAADgPwAAAAAAAOA/AAAAAAAA4D8CAAAAjAAAAAAAAAAAAAAAu+DjDP///wgAAAAAAAAAAAAAAAAAAAAAAAAAAAAAAAAAAAAAZAAAAAEAAABAAAAAAAAAAAAAAAAAAAAAAAAAAAAAAAAAAAAAAAAAAAAAAAAAAAAAAAAAAAAAAAAAAAAAAAAAAAAAAAAAAAAAAAAAAAAAAAAAAAAAAAAAAAAAAAAAAAAAFAAAADwAAAAAAAAAAAAAAAAAAAkUAAAAAQAAABQAAAAUAAAAFAAAAAEAAAAAAAAAZAAAAGQAAAAAAAAAZAAAAGQAAAAVAAAAYAAAAAAAAAAAAAAADwAAACADAAAAAAAAAAAAAAEAAACgMgAAVgcAAKr4//8BAAAAf39/AAEAAABkAAAAAAAAABQAAABAHwAAAAAAACYAAAAAAAAAwOD//wAAAAAmAAAAZAAAABYAAABMAAAAAAAAAAAAAAAEAAAAAAAAAAEAAACAgIAKAAAAACgAAAAoAAAAZAAAAGQAAAAAAAAAzMzMAAAAAABQAAAAUAAAAGQAAABkAAAAAAAAABcAAAAUAAAAAAAAAAAAAAD/fwAA/38AAAAAAAAJAAAABAAAAAAAAAAeAAAAaAAAAAAAAAAAAAAAAAAAAAAAAAAAAAAAECcAABAnAAAAAAAAAAAAAAAAAAAAAAAAAAAAAAAAAAAAAAAAAAAAABQAAAAAAAAAwMD/AAAAAABkAAAAMgAAAAAAAABkAAAAAAAAAH9/fwAKAAAAIgAAABgAAAAAAAAAAAAAAAAAAAAAAAAAAAAAAAAAAAAkAAAAJAAAAAAAAAAHAAAAAAAAAAAAAAAAAAAAAAAAAAAAAAAAAAAAf39/ACUAAABYAAAAAAAAAAAAAAAAAAAAAAAAAAAAAAAAAAAAAAAAAAAAAAAAAAAAAAAAAAAAAAA/AAAAAAAAAKCGAQAAAAAAAAAAAAAAAAAMAAAAAQAAAAAAAAAAAAAAAAAAAB8AAABUAAAAAAAABQAAAAEAAAAAAAAAAAAAAAAAAAAAAAAAAAAAAAAAAAAAAAAAAAAAAAJ/f38AAAAAA8zMzADAwP8Af39/AAAAAAAAAAAAAAAAAAAAAAAAAAAAIQAAABgAAAAUAAAAwTUAABsnAABARwAAWSkAABAAAAAmAAAACAAAAAAAAAAAAAAA"/>
+                <pr:smNativeData xmlns:pr="smNativeData" xmlns="smNativeData" val="SMDATA_15_ZqHWaRMAAAAlAAAAZAAAAA8BAAAAkAAAAEgAAACQAAAASAAAAAAAAAABAAAAAAAAAAEAAABQAAAAAAAAAAAA4D8AAAAAAADgPwAAAAAAAOA/AAAAAAAA4D8AAAAAAADgPwAAAAAAAOA/AAAAAAAA4D8AAAAAAADgPwAAAAAAAOA/AAAAAAAA4D8CAAAAjAAAAAAAAAAAAAAAu+DjDP///wgAAAAAAAAAAAAAAAAAAAAAAAAAAAAAAAAAAAAAZAAAAAEAAABAAAAAAAAAAAAAAAAAAAAAAAAAAAAAAAAAAAAAAAAAAAAAAAAAAAAAAAAAAAAAAAAAAAAAAAAAAAAAAAAAAAAAAAAAAAAAAAAAAAAAAAAAAAAAAAAAAAAAFAAAADwAAAAAAAAAAAAAAAAAAAkUAAAAAQAAABQAAAAUAAAAFAAAAAEAAAAAAAAAZAAAAGQAAAAAAAAAZAAAAGQAAAAVAAAAYAAAAAAAAAAAAAAADwAAACADAAAAAAAAAAAAAAEAAACgMgAAVgcAAKr4//8BAAAAf39/AAEAAABkAAAAAAAAABQAAABAHwAAAAAAACYAAAAAAAAAwOD//wAAAAAmAAAAZAAAABYAAABMAAAAAAAAAAAAAAAEAAAAAAAAAAEAAACAgIAKAAAAACgAAAAoAAAAZAAAAGQAAAAAAAAAzMzMAAAAAABQAAAAUAAAAGQAAABkAAAAAAAAABcAAAAUAAAAAAAAAAAAAAD/fwAA/38AAAAAAAAJAAAABAAAAAAAAAAeAAAAaAAAAAAAAAAAAAAAAAAAAAAAAAAAAAAAECcAABAnAAAAAAAAAAAAAAAAAAAAAAAAAAAAAAAAAAAAAAAAAAAAABQAAAAAAAAAwMD/AAAAAABkAAAAMgAAAAAAAABkAAAAAAAAAH9/fwAKAAAAIgAAABgAAAAAAAAAAAAAAAAAAAAAAAAAAAAAAAAAAAAkAAAAJAAAAAAAAAAHAAAAAAAAAAAAAAAAAAAAAAAAAAAAAAAAAAAAf39/ACUAAABYAAAAAAAAAAAAAAAAAAAAAAAAAAAAAAAAAAAAAAAAAAAAAAAAAAAAAAAAAAAAAAA/AAAAAAAAAKCGAQAAAAAAAAAAAAAAAAAMAAAAAQAAAAAAAAAAAAAAAAAAAB8AAABUAAAAAAAABQAAAAEAAAAAAAAAAAAAAAAAAAAAAAAAAAAAAAAAAAAAAAAAAAAAAAJ/f38AAAAAA8zMzADAwP8Af39/AAAAAAAAAAAAAAAAAAAAAAAAAAAAIQAAABgAAAAUAAAAwTUAABsnAABARwAAWSkAABAAAAAmAAAACAAAAAAAAAAAAAAA"/>
               </a:ext>
             </a:extLst>
           </p:cNvSpPr>
@@ -780,7 +780,7 @@
           <a:lstStyle/>
           <a:p>
             <a:pPr/>
-            <a:fld id="{3F1875E0-AED2-4D83-9CA0-58D63BEE6A0D}" type="slidenum">
+            <a:fld id="{7EE416F2-BC93-B1E0-DD5C-4AB558122B1F}" type="slidenum">
               <a:t/>
             </a:fld>
           </a:p>
@@ -819,7 +819,7 @@
             <a:spLocks noGrp="1" noChangeArrowheads="1"/>
             <a:extLst>
               <a:ext uri="smNativeData">
-                <pr:smNativeData xmlns:pr="smNativeData" xmlns="smNativeData" val="SMDATA_15_7aDWaRMAAAAlAAAAZAAAAA8BAAAAkAAAAEgAAACQAAAASAAAAAAAAAABAAAAAAAAAAEAAABQAAAAAAAAAAAA4D8AAAAAAADgPwAAAAAAAOA/AAAAAAAA4D8AAAAAAADgPwAAAAAAAOA/AAAAAAAA4D8AAAAAAADgPwAAAAAAAOA/AAAAAAAA4D8CAAAAjAAAAAAAAAAAAAAAu+DjDP///wgAAAAAAAAAAAAAAAAAAAAAAAAAAAAAAAAAAAAAZAAAAAEAAABAAAAAAAAAAAAAAAAAAAAAAAAAAAAAAAAAAAAAAAAAAAAAAAAAAAAAAAAAAAAAAAAAAAAAAAAAAAAAAAAAAAAAAAAAAAAAAAAAAAAAAAAAAAAAAAAAAAAAFAAAADwAAAAAAAAAAAAAAAAAAAkUAAAAAQAAABQAAAAUAAAAFAAAAAEAAAAAAAAAZAAAAGQAAAAAAAAAZAAAAGQAAAAVAAAAYAAAAAAAAAAAAAAADwAAACADAAAAAAAAAAAAAAEAAACgMgAAVgcAAKr4//8BAAAAf39/AAEAAABkAAAAAAAAABQAAABAHwAAAAAAACYAAAAAAAAAwOD//wAAAAAmAAAAZAAAABYAAABMAAAAAAAAAAAAAAAEAAAAAAAAAAEAAACAgIAKAAAAACgAAAAoAAAAZAAAAGQAAAAAAAAAzMzMAAAAAABQAAAAUAAAAGQAAABkAAAAAAAAABcAAAAUAAAAAAAAAAAAAAD/fwAA/38AAAAAAAAJAAAABAAAAAAAAAAeAAAAaAAAAAAAAAAAAAAAAAAAAAAAAAAAAAAAECcAABAnAAAAAAAAAAAAAAAAAAAAAAAAAAAAAAAAAAAAAAAAAAAAABQAAAAAAAAAwMD/AAAAAABkAAAAMgAAAAAAAABkAAAAAAAAAH9/fwAKAAAAIgAAABgAAAAAAAAAAAAAAAAAAAAAAAAAAAAAAAAAAAAkAAAAJAAAAAAAAAAHAAAAAAAAAAAAAAAAAAAAAAAAAAAAAAAAAAAAf39/ACUAAABYAAAAAAAAAAAAAAAAAAAAAAAAAAAAAAAAAAAAAAAAAAAAAAAAAAAAAAAAAAAAAAA/AAAAAAAAAKCGAQAAAAAAAAAAAAAAAAAMAAAAAQAAAAAAAAAAAAAAAAAAAB8AAABUAAAAAAAABQAAAAEAAAAAAAAAAAAAAAAAAAAAAAAAAAAAAAAAAAAAAAAAAAAAAAJ/f38AAAAAA8zMzADAwP8Af39/AAAAAAAAAAAAAAAAAAAAAAAAAAAAIQAAABgAAAAUAAAAwAMAALABAABARwAAuAgAABAAAAAmAAAACAAAAAAAAAAAAAAA"/>
+                <pr:smNativeData xmlns:pr="smNativeData" xmlns="smNativeData" val="SMDATA_15_ZqHWaRMAAAAlAAAAZAAAAA8BAAAAkAAAAEgAAACQAAAASAAAAAAAAAABAAAAAAAAAAEAAABQAAAAAAAAAAAA4D8AAAAAAADgPwAAAAAAAOA/AAAAAAAA4D8AAAAAAADgPwAAAAAAAOA/AAAAAAAA4D8AAAAAAADgPwAAAAAAAOA/AAAAAAAA4D8CAAAAjAAAAAAAAAAAAAAAu+DjDP///wgAAAAAAAAAAAAAAAAAAAAAAAAAAAAAAAAAAAAAZAAAAAEAAABAAAAAAAAAAAAAAAAAAAAAAAAAAAAAAAAAAAAAAAAAAAAAAAAAAAAAAAAAAAAAAAAAAAAAAAAAAAAAAAAAAAAAAAAAAAAAAAAAAAAAAAAAAAAAAAAAAAAAFAAAADwAAAAAAAAAAAAAAAAAAAkUAAAAAQAAABQAAAAUAAAAFAAAAAEAAAAAAAAAZAAAAGQAAAAAAAAAZAAAAGQAAAAVAAAAYAAAAAAAAAAAAAAADwAAACADAAAAAAAAAAAAAAEAAACgMgAAVgcAAKr4//8BAAAAf39/AAEAAABkAAAAAAAAABQAAABAHwAAAAAAACYAAAAAAAAAwOD//wAAAAAmAAAAZAAAABYAAABMAAAAAAAAAAAAAAAEAAAAAAAAAAEAAACAgIAKAAAAACgAAAAoAAAAZAAAAGQAAAAAAAAAzMzMAAAAAABQAAAAUAAAAGQAAABkAAAAAAAAABcAAAAUAAAAAAAAAAAAAAD/fwAA/38AAAAAAAAJAAAABAAAAAAAAAAeAAAAaAAAAAAAAAAAAAAAAAAAAAAAAAAAAAAAECcAABAnAAAAAAAAAAAAAAAAAAAAAAAAAAAAAAAAAAAAAAAAAAAAABQAAAAAAAAAwMD/AAAAAABkAAAAMgAAAAAAAABkAAAAAAAAAH9/fwAKAAAAIgAAABgAAAAAAAAAAAAAAAAAAAAAAAAAAAAAAAAAAAAkAAAAJAAAAAAAAAAHAAAAAAAAAAAAAAAAAAAAAAAAAAAAAAAAAAAAf39/ACUAAABYAAAAAAAAAAAAAAAAAAAAAAAAAAAAAAAAAAAAAAAAAAAAAAAAAAAAAAAAAAAAAAA/AAAAAAAAAKCGAQAAAAAAAAAAAAAAAAAMAAAAAQAAAAAAAAAAAAAAAAAAAB8AAABUAAAAAAAABQAAAAEAAAAAAAAAAAAAAAAAAAAAAAAAAAAAAAAAAAAAAAAAAAAAAAJ/f38AAAAAA8zMzADAwP8Af39/AAAAAAAAAAAAAAAAAAAAAAAAAAAAIQAAABgAAAAUAAAAwAMAALABAABARwAAuAgAABAAAAAmAAAACAAAAAAAAAAAAAAA"/>
               </a:ext>
             </a:extLst>
           </p:cNvSpPr>
@@ -846,7 +846,7 @@
             <a:spLocks noGrp="1" noChangeArrowheads="1"/>
             <a:extLst>
               <a:ext uri="smNativeData">
-                <pr:smNativeData xmlns:pr="smNativeData" xmlns="smNativeData" val="SMDATA_15_7aDWaRMAAAAlAAAAZAAAAA8BAAAAkAAAAEgAAACQAAAASAAAAAAAAAAAAAAAAAAAAAEAAABQAAAAAAAAAAAA4D8AAAAAAADgPwAAAAAAAOA/AAAAAAAA4D8AAAAAAADgPwAAAAAAAOA/AAAAAAAA4D8AAAAAAADgPwAAAAAAAOA/AAAAAAAA4D8CAAAAjAAAAAAAAAAAAAAAu+DjDP///wgAAAAAAAAAAAAAAAAAAAAAAAAAAAAAAAAAAAAAZAAAAAEAAABAAAAAAAAAAAAAAAAAAAAAAAAAAAAAAAAAAAAAAAAAAAAAAAAAAAAAAAAAAAAAAAAAAAAAAAAAAAAAAAAAAAAAAAAAAAAAAAAAAAAAAAAAAAAAAAAAAAAAFAAAADwAAAAAAAAAAAAAAAAAAAkUAAAAAQAAABQAAAAUAAAAFAAAAAEAAAAAAAAAZAAAAGQAAAAAAAAAZAAAAGQAAAAVAAAAYAAAAAAAAAAAAAAADwAAACADAAAAAAAAAAAAAAEAAACgMgAAVgcAAKr4//8BAAAAf39/AAEAAABkAAAAAAAAABQAAABAHwAAAAAAACYAAAAAAAAAwOD//wAAAAAmAAAAZAAAABYAAABMAAAAAAAAAAAAAAAEAAAAAAAAAAEAAACAgIAKAAAAACgAAAAoAAAAZAAAAGQAAAAAAAAAzMzMAAAAAABQAAAAUAAAAGQAAABkAAAAAAAAABcAAAAUAAAAAAAAAAAAAAD/fwAA/38AAAAAAAAJAAAABAAAAAAAAAAeAAAAaAAAAAAAAAAAAAAAAAAAAAAAAAAAAAAAECcAABAnAAAAAAAAAAAAAAAAAAAAAAAAAAAAAAAAAAAAAAAAAAAAABQAAAAAAAAAwMD/AAAAAABkAAAAMgAAAAAAAABkAAAAAAAAAH9/fwAKAAAAIgAAABgAAAAAAAAAAAAAAAAAAAAAAAAAAAAAAAAAAAAkAAAAJAAAAAAAAAAHAAAAAAAAAAAAAAAAAAAAAAAAAAAAAAAAAAAAf39/ACUAAABYAAAAAAAAAAAAAAAAAAAAAAAAAAAAAAAAAAAAAAAAAAAAAAAAAAAAAAAAAAAAAAA/AAAAAAAAAKCGAQAAAAAAAAAAAAAAAAAMAAAAAQAAAAAAAAAAAAAAAAAAAB8AAABUAAAAAAAABQAAAAEAAAAAAAAAAAAAAAAAAAAAAAAAAAAAAAAAAAAAAAAAAAAAAAJ/f38AAAAAA8zMzADAwP8Af39/AAAAAAAAAAAAAAAAAAAAAAAAAAAAIQAAABgAAAAUAAAAwAMAANgJAABARwAAsCUAABAAAAAmAAAACAAAAAAAAAAAAAAA"/>
+                <pr:smNativeData xmlns:pr="smNativeData" xmlns="smNativeData" val="SMDATA_15_ZqHWaRMAAAAlAAAAZAAAAA8BAAAAkAAAAEgAAACQAAAASAAAAAAAAAAAAAAAAAAAAAEAAABQAAAAAAAAAAAA4D8AAAAAAADgPwAAAAAAAOA/AAAAAAAA4D8AAAAAAADgPwAAAAAAAOA/AAAAAAAA4D8AAAAAAADgPwAAAAAAAOA/AAAAAAAA4D8CAAAAjAAAAAAAAAAAAAAAu+DjDP///wgAAAAAAAAAAAAAAAAAAAAAAAAAAAAAAAAAAAAAZAAAAAEAAABAAAAAAAAAAAAAAAAAAAAAAAAAAAAAAAAAAAAAAAAAAAAAAAAAAAAAAAAAAAAAAAAAAAAAAAAAAAAAAAAAAAAAAAAAAAAAAAAAAAAAAAAAAAAAAAAAAAAAFAAAADwAAAAAAAAAAAAAAAAAAAkUAAAAAQAAABQAAAAUAAAAFAAAAAEAAAAAAAAAZAAAAGQAAAAAAAAAZAAAAGQAAAAVAAAAYAAAAAAAAAAAAAAADwAAACADAAAAAAAAAAAAAAEAAACgMgAAVgcAAKr4//8BAAAAf39/AAEAAABkAAAAAAAAABQAAABAHwAAAAAAACYAAAAAAAAAwOD//wAAAAAmAAAAZAAAABYAAABMAAAAAAAAAAAAAAAEAAAAAAAAAAEAAACAgIAKAAAAACgAAAAoAAAAZAAAAGQAAAAAAAAAzMzMAAAAAABQAAAAUAAAAGQAAABkAAAAAAAAABcAAAAUAAAAAAAAAAAAAAD/fwAA/38AAAAAAAAJAAAABAAAAAAAAAAeAAAAaAAAAAAAAAAAAAAAAAAAAAAAAAAAAAAAECcAABAnAAAAAAAAAAAAAAAAAAAAAAAAAAAAAAAAAAAAAAAAAAAAABQAAAAAAAAAwMD/AAAAAABkAAAAMgAAAAAAAABkAAAAAAAAAH9/fwAKAAAAIgAAABgAAAAAAAAAAAAAAAAAAAAAAAAAAAAAAAAAAAAkAAAAJAAAAAAAAAAHAAAAAAAAAAAAAAAAAAAAAAAAAAAAAAAAAAAAf39/ACUAAABYAAAAAAAAAAAAAAAAAAAAAAAAAAAAAAAAAAAAAAAAAAAAAAAAAAAAAAAAAAAAAAA/AAAAAAAAAKCGAQAAAAAAAAAAAAAAAAAMAAAAAQAAAAAAAAAAAAAAAAAAAB8AAABUAAAAAAAABQAAAAEAAAAAAAAAAAAAAAAAAAAAAAAAAAAAAAAAAAAAAAAAAAAAAAJ/f38AAAAAA8zMzADAwP8Af39/AAAAAAAAAAAAAAAAAAAAAAAAAAAAIQAAABgAAAAUAAAAwAMAANgJAABARwAAsCUAABAAAAAmAAAACAAAAAAAAAAAAAAA"/>
               </a:ext>
             </a:extLst>
           </p:cNvSpPr>
@@ -897,7 +897,7 @@
             <a:spLocks noGrp="1" noChangeArrowheads="1"/>
             <a:extLst>
               <a:ext uri="smNativeData">
-                <pr:smNativeData xmlns:pr="smNativeData" xmlns="smNativeData" val="SMDATA_15_7aDWaRMAAAAlAAAAZAAAAA8BAAAAkAAAAEgAAACQAAAASAAAAAAAAAABAAAAAAAAAAEAAABQAAAAAAAAAAAA4D8AAAAAAADgPwAAAAAAAOA/AAAAAAAA4D8AAAAAAADgPwAAAAAAAOA/AAAAAAAA4D8AAAAAAADgPwAAAAAAAOA/AAAAAAAA4D8CAAAAjAAAAAAAAAAAAAAAu+DjDP///wgAAAAAAAAAAAAAAAAAAAAAAAAAAAAAAAAAAAAAZAAAAAEAAABAAAAAAAAAAAAAAAAAAAAAAAAAAAAAAAAAAAAAAAAAAAAAAAAAAAAAAAAAAAAAAAAAAAAAAAAAAAAAAAAAAAAAAAAAAAAAAAAAAAAAAAAAAAAAAAAAAAAAFAAAADwAAAAAAAAAAAAAAAAAAAkUAAAAAQAAABQAAAAUAAAAFAAAAAEAAAAAAAAAZAAAAGQAAAAAAAAAZAAAAGQAAAAVAAAAYAAAAAAAAAAAAAAADwAAACADAAAAAAAAAAAAAAEAAACgMgAAVgcAAKr4//8BAAAAf39/AAEAAABkAAAAAAAAABQAAABAHwAAAAAAACYAAAAAAAAAwOD//wAAAAAmAAAAZAAAABYAAABMAAAAAAAAAAAAAAAEAAAAAAAAAAEAAACAgIAKAAAAACgAAAAoAAAAZAAAAGQAAAAAAAAAzMzMAAAAAABQAAAAUAAAAGQAAABkAAAAAAAAABcAAAAUAAAAAAAAAAAAAAD/fwAA/38AAAAAAAAJAAAABAAAANw7IAEeAAAAaAAAAAAAAAAAAAAAAAAAAAAAAAAAAAAAECcAABAnAAAAAAAAAAAAAAAAAAAAAAAAAAAAAAAAAAAAAAAAAAAAABQAAAAAAAAAwMD/AAAAAABkAAAAMgAAAAAAAABkAAAAAAAAAH9/fwAKAAAAIgAAABgAAAAAAAAAAAAAAAAAAAAAAAAAAAAAAAAAAAAkAAAAJAAAAAAAAAAHAAAAAAAAAAAAAAAAAAAAAAAAAAAAAAAAAAAAf39/ACUAAABYAAAAAAAAAAAAAAAAAAAAAAAAAAAAAAAAAAAAAAAAAAAAAAAAAAAAAAAAAAAAAAA/AAAAAAAAAKCGAQAAAAAAAAAAAAAAAAAMAAAAAQAAAAAAAAAAAAAAAAAAAB8AAABUAAAAAAAABQAAAAEAAAAAAAAAAAAAAAAAAAAAAAAAAAAAAAAAAAAAAAAAAAAAAAJ/f38AAAAAA8zMzADAwP8Af39/AAAAAAAAAAAAAAAAAAAAAAAAAAAAIQAAABgAAAAUAAAAwAMAABsnAAA/FQAAWSkAABAAAAAmAAAACAAAAAAAAAAAAAAA"/>
+                <pr:smNativeData xmlns:pr="smNativeData" xmlns="smNativeData" val="SMDATA_15_ZqHWaRMAAAAlAAAAZAAAAA8BAAAAkAAAAEgAAACQAAAASAAAAAAAAAABAAAAAAAAAAEAAABQAAAAAAAAAAAA4D8AAAAAAADgPwAAAAAAAOA/AAAAAAAA4D8AAAAAAADgPwAAAAAAAOA/AAAAAAAA4D8AAAAAAADgPwAAAAAAAOA/AAAAAAAA4D8CAAAAjAAAAAAAAAAAAAAAu+DjDP///wgAAAAAAAAAAAAAAAAAAAAAAAAAAAAAAAAAAAAAZAAAAAEAAABAAAAAAAAAAAAAAAAAAAAAAAAAAAAAAAAAAAAAAAAAAAAAAAAAAAAAAAAAAAAAAAAAAAAAAAAAAAAAAAAAAAAAAAAAAAAAAAAAAAAAAAAAAAAAAAAAAAAAFAAAADwAAAAAAAAAAAAAAAAAAAkUAAAAAQAAABQAAAAUAAAAFAAAAAEAAAAAAAAAZAAAAGQAAAAAAAAAZAAAAGQAAAAVAAAAYAAAAAAAAAAAAAAADwAAACADAAAAAAAAAAAAAAEAAACgMgAAVgcAAKr4//8BAAAAf39/AAEAAABkAAAAAAAAABQAAABAHwAAAAAAACYAAAAAAAAAwOD//wAAAAAmAAAAZAAAABYAAABMAAAAAAAAAAAAAAAEAAAAAAAAAAEAAACAgIAKAAAAACgAAAAoAAAAZAAAAGQAAAAAAAAAzMzMAAAAAABQAAAAUAAAAGQAAABkAAAAAAAAABcAAAAUAAAAAAAAAAAAAAD/fwAA/38AAAAAAAAJAAAABAAAANw7IAEeAAAAaAAAAAAAAAAAAAAAAAAAAAAAAAAAAAAAECcAABAnAAAAAAAAAAAAAAAAAAAAAAAAAAAAAAAAAAAAAAAAAAAAABQAAAAAAAAAwMD/AAAAAABkAAAAMgAAAAAAAABkAAAAAAAAAH9/fwAKAAAAIgAAABgAAAAAAAAAAAAAAAAAAAAAAAAAAAAAAAAAAAAkAAAAJAAAAAAAAAAHAAAAAAAAAAAAAAAAAAAAAAAAAAAAAAAAAAAAf39/ACUAAABYAAAAAAAAAAAAAAAAAAAAAAAAAAAAAAAAAAAAAAAAAAAAAAAAAAAAAAAAAAAAAAA/AAAAAAAAAKCGAQAAAAAAAAAAAAAAAAAMAAAAAQAAAAAAAAAAAAAAAAAAAB8AAABUAAAAAAAABQAAAAEAAAAAAAAAAAAAAAAAAAAAAAAAAAAAAAAAAAAAAAAAAAAAAAJ/f38AAAAAA8zMzADAwP8Af39/AAAAAAAAAAAAAAAAAAAAAAAAAAAAIQAAABgAAAAUAAAAwAMAABsnAAA/FQAAWSkAABAAAAAmAAAACAAAAAAAAAAAAAAA"/>
               </a:ext>
             </a:extLst>
           </p:cNvSpPr>
@@ -911,7 +911,7 @@
           <a:lstStyle/>
           <a:p>
             <a:pPr/>
-            <a:fld id="{69BDC9B9-F784-E83F-CA05-016A874B3C54}" type="datetime1">
+            <a:fld id="{2A600E77-39C7-35F8-89D8-CFAD40967F9A}" type="datetime1">
               <a:t/>
             </a:fld>
           </a:p>
@@ -924,7 +924,7 @@
             <a:spLocks noGrp="1" noChangeArrowheads="1"/>
             <a:extLst>
               <a:ext uri="smNativeData">
-                <pr:smNativeData xmlns:pr="smNativeData" xmlns="smNativeData" val="SMDATA_15_7aDWaRMAAAAlAAAAZAAAAA8BAAAAkAAAAEgAAACQAAAASAAAAAAAAAABAAAAAAAAAAEAAABQAAAAAAAAAAAA4D8AAAAAAADgPwAAAAAAAOA/AAAAAAAA4D8AAAAAAADgPwAAAAAAAOA/AAAAAAAA4D8AAAAAAADgPwAAAAAAAOA/AAAAAAAA4D8CAAAAjAAAAAAAAAAAAAAAu+DjDP///wgAAAAAAAAAAAAAAAAAAAAAAAAAAAAAAAAAAAAAZAAAAAEAAABAAAAAAAAAAAAAAAAAAAAAAAAAAAAAAAAAAAAAAAAAAAAAAAAAAAAAAAAAAAAAAAAAAAAAAAAAAAAAAAAAAAAAAAAAAAAAAAAAAAAAAAAAAAAAAAAAAAAAFAAAADwAAAAAAAAAAAAAAAAAAAkUAAAAAQAAABQAAAAUAAAAFAAAAAEAAAAAAAAAZAAAAGQAAAAAAAAAZAAAAGQAAAAVAAAAYAAAAAAAAAAAAAAADwAAACADAAAAAAAAAAAAAAEAAACgMgAAVgcAAKr4//8BAAAAf39/AAEAAABkAAAAAAAAABQAAABAHwAAAAAAACYAAAAAAAAAwOD//wAAAAAmAAAAZAAAABYAAABMAAAAAAAAAAAAAAAEAAAAAAAAAAEAAACAgIAKAAAAACgAAAAoAAAAZAAAAGQAAAAAAAAAzMzMAAAAAABQAAAAUAAAAGQAAABkAAAAAAAAABcAAAAUAAAAAAAAAAAAAAD/fwAA/38AAAAAAAAJAAAABAAAANw7IAEeAAAAaAAAAAAAAAAAAAAAAAAAAAAAAAAAAAAAECcAABAnAAAAAAAAAAAAAAAAAAAAAAAAAAAAAAAAAAAAAAAAAAAAABQAAAAAAAAAwMD/AAAAAABkAAAAMgAAAAAAAABkAAAAAAAAAH9/fwAKAAAAIgAAABgAAAAAAAAAAAAAAAAAAAAAAAAAAAAAAAAAAAAkAAAAJAAAAAAAAAAHAAAAAAAAAAAAAAAAAAAAAAAAAAAAAAAAAAAAf39/ACUAAABYAAAAAAAAAAAAAAAAAAAAAAAAAAAAAAAAAAAAAAAAAAAAAAAAAAAAAAAAAAAAAAA/AAAAAAAAAKCGAQAAAAAAAAAAAAAAAAAMAAAAAQAAAAAAAAAAAAAAAAAAAB8AAABUAAAAAAAABQAAAAEAAAAAAAAAAAAAAAAAAAAAAAAAAAAAAAAAAAAAAAAAAAAAAAJ/f38AAAAAA8zMzADAwP8Af39/AAAAAAAAAAAAAAAAAAAAAAAAAAAAIQAAABgAAAAUAAAAoRkAABsnAABfMQAAWSkAABAAAAAmAAAACAAAAAAAAAAAAAAA"/>
+                <pr:smNativeData xmlns:pr="smNativeData" xmlns="smNativeData" val="SMDATA_15_ZqHWaRMAAAAlAAAAZAAAAA8BAAAAkAAAAEgAAACQAAAASAAAAAAAAAABAAAAAAAAAAEAAABQAAAAAAAAAAAA4D8AAAAAAADgPwAAAAAAAOA/AAAAAAAA4D8AAAAAAADgPwAAAAAAAOA/AAAAAAAA4D8AAAAAAADgPwAAAAAAAOA/AAAAAAAA4D8CAAAAjAAAAAAAAAAAAAAAu+DjDP///wgAAAAAAAAAAAAAAAAAAAAAAAAAAAAAAAAAAAAAZAAAAAEAAABAAAAAAAAAAAAAAAAAAAAAAAAAAAAAAAAAAAAAAAAAAAAAAAAAAAAAAAAAAAAAAAAAAAAAAAAAAAAAAAAAAAAAAAAAAAAAAAAAAAAAAAAAAAAAAAAAAAAAFAAAADwAAAAAAAAAAAAAAAAAAAkUAAAAAQAAABQAAAAUAAAAFAAAAAEAAAAAAAAAZAAAAGQAAAAAAAAAZAAAAGQAAAAVAAAAYAAAAAAAAAAAAAAADwAAACADAAAAAAAAAAAAAAEAAACgMgAAVgcAAKr4//8BAAAAf39/AAEAAABkAAAAAAAAABQAAABAHwAAAAAAACYAAAAAAAAAwOD//wAAAAAmAAAAZAAAABYAAABMAAAAAAAAAAAAAAAEAAAAAAAAAAEAAACAgIAKAAAAACgAAAAoAAAAZAAAAGQAAAAAAAAAzMzMAAAAAABQAAAAUAAAAGQAAABkAAAAAAAAABcAAAAUAAAAAAAAAAAAAAD/fwAA/38AAAAAAAAJAAAABAAAANw7IAEeAAAAaAAAAAAAAAAAAAAAAAAAAAAAAAAAAAAAECcAABAnAAAAAAAAAAAAAAAAAAAAAAAAAAAAAAAAAAAAAAAAAAAAABQAAAAAAAAAwMD/AAAAAABkAAAAMgAAAAAAAABkAAAAAAAAAH9/fwAKAAAAIgAAABgAAAAAAAAAAAAAAAAAAAAAAAAAAAAAAAAAAAAkAAAAJAAAAAAAAAAHAAAAAAAAAAAAAAAAAAAAAAAAAAAAAAAAAAAAf39/ACUAAABYAAAAAAAAAAAAAAAAAAAAAAAAAAAAAAAAAAAAAAAAAAAAAAAAAAAAAAAAAAAAAAA/AAAAAAAAAKCGAQAAAAAAAAAAAAAAAAAMAAAAAQAAAAAAAAAAAAAAAAAAAB8AAABUAAAAAAAABQAAAAEAAAAAAAAAAAAAAAAAAAAAAAAAAAAAAAAAAAAAAAAAAAAAAAJ/f38AAAAAA8zMzADAwP8Af39/AAAAAAAAAAAAAAAAAAAAAAAAAAAAIQAAABgAAAAUAAAAoRkAABsnAABfMQAAWSkAABAAAAAmAAAACAAAAAAAAAAAAAAA"/>
               </a:ext>
             </a:extLst>
           </p:cNvSpPr>
@@ -948,7 +948,7 @@
             <a:spLocks noGrp="1" noChangeArrowheads="1"/>
             <a:extLst>
               <a:ext uri="smNativeData">
-                <pr:smNativeData xmlns:pr="smNativeData" xmlns="smNativeData" val="SMDATA_15_7aDWaRMAAAAlAAAAZAAAAA8BAAAAkAAAAEgAAACQAAAASAAAAAAAAAABAAAAAAAAAAEAAABQAAAAAAAAAAAA4D8AAAAAAADgPwAAAAAAAOA/AAAAAAAA4D8AAAAAAADgPwAAAAAAAOA/AAAAAAAA4D8AAAAAAADgPwAAAAAAAOA/AAAAAAAA4D8CAAAAjAAAAAAAAAAAAAAAu+DjDP///wgAAAAAAAAAAAAAAAAAAAAAAAAAAAAAAAAAAAAAZAAAAAEAAABAAAAAAAAAAAAAAAAAAAAAAAAAAAAAAAAAAAAAAAAAAAAAAAAAAAAAAAAAAAAAAAAAAAAAAAAAAAAAAAAAAAAAAAAAAAAAAAAAAAAAAAAAAAAAAAAAAAAAFAAAADwAAAAAAAAAAAAAAAAAAAkUAAAAAQAAABQAAAAUAAAAFAAAAAEAAAAAAAAAZAAAAGQAAAAAAAAAZAAAAGQAAAAVAAAAYAAAAAAAAAAAAAAADwAAACADAAAAAAAAAAAAAAEAAACgMgAAVgcAAKr4//8BAAAAf39/AAEAAABkAAAAAAAAABQAAABAHwAAAAAAACYAAAAAAAAAwOD//wAAAAAmAAAAZAAAABYAAABMAAAAAAAAAAAAAAAEAAAAAAAAAAEAAACAgIAKAAAAACgAAAAoAAAAZAAAAGQAAAAAAAAAzMzMAAAAAABQAAAAUAAAAGQAAABkAAAAAAAAABcAAAAUAAAAAAAAAAAAAAD/fwAA/38AAAAAAAAJAAAABAAAAAAAAAAeAAAAaAAAAAAAAAAAAAAAAAAAAAAAAAAAAAAAECcAABAnAAAAAAAAAAAAAAAAAAAAAAAAAAAAAAAAAAAAAAAAAAAAABQAAAAAAAAAwMD/AAAAAABkAAAAMgAAAAAAAABkAAAAAAAAAH9/fwAKAAAAIgAAABgAAAAAAAAAAAAAAAAAAAAAAAAAAAAAAAAAAAAkAAAAJAAAAAAAAAAHAAAAAAAAAAAAAAAAAAAAAAAAAAAAAAAAAAAAf39/ACUAAABYAAAAAAAAAAAAAAAAAAAAAAAAAAAAAAAAAAAAAAAAAAAAAAAAAAAAAAAAAAAAAAA/AAAAAAAAAKCGAQAAAAAAAAAAAAAAAAAMAAAAAQAAAAAAAAAAAAAAAAAAAB8AAABUAAAAAAAABQAAAAEAAAAAAAAAAAAAAAAAAAAAAAAAAAAAAAAAAAAAAAAAAAAAAAJ/f38AAAAAA8zMzADAwP8Af39/AAAAAAAAAAAAAAAAAAAAAAAAAAAAIQAAABgAAAAUAAAAwTUAABsnAABARwAAWSkAABAAAAAmAAAACAAAAAAAAAAAAAAA"/>
+                <pr:smNativeData xmlns:pr="smNativeData" xmlns="smNativeData" val="SMDATA_15_ZqHWaRMAAAAlAAAAZAAAAA8BAAAAkAAAAEgAAACQAAAASAAAAAAAAAABAAAAAAAAAAEAAABQAAAAAAAAAAAA4D8AAAAAAADgPwAAAAAAAOA/AAAAAAAA4D8AAAAAAADgPwAAAAAAAOA/AAAAAAAA4D8AAAAAAADgPwAAAAAAAOA/AAAAAAAA4D8CAAAAjAAAAAAAAAAAAAAAu+DjDP///wgAAAAAAAAAAAAAAAAAAAAAAAAAAAAAAAAAAAAAZAAAAAEAAABAAAAAAAAAAAAAAAAAAAAAAAAAAAAAAAAAAAAAAAAAAAAAAAAAAAAAAAAAAAAAAAAAAAAAAAAAAAAAAAAAAAAAAAAAAAAAAAAAAAAAAAAAAAAAAAAAAAAAFAAAADwAAAAAAAAAAAAAAAAAAAkUAAAAAQAAABQAAAAUAAAAFAAAAAEAAAAAAAAAZAAAAGQAAAAAAAAAZAAAAGQAAAAVAAAAYAAAAAAAAAAAAAAADwAAACADAAAAAAAAAAAAAAEAAACgMgAAVgcAAKr4//8BAAAAf39/AAEAAABkAAAAAAAAABQAAABAHwAAAAAAACYAAAAAAAAAwOD//wAAAAAmAAAAZAAAABYAAABMAAAAAAAAAAAAAAAEAAAAAAAAAAEAAACAgIAKAAAAACgAAAAoAAAAZAAAAGQAAAAAAAAAzMzMAAAAAABQAAAAUAAAAGQAAABkAAAAAAAAABcAAAAUAAAAAAAAAAAAAAD/fwAA/38AAAAAAAAJAAAABAAAAAAAAAAeAAAAaAAAAAAAAAAAAAAAAAAAAAAAAAAAAAAAECcAABAnAAAAAAAAAAAAAAAAAAAAAAAAAAAAAAAAAAAAAAAAAAAAABQAAAAAAAAAwMD/AAAAAABkAAAAMgAAAAAAAABkAAAAAAAAAH9/fwAKAAAAIgAAABgAAAAAAAAAAAAAAAAAAAAAAAAAAAAAAAAAAAAkAAAAJAAAAAAAAAAHAAAAAAAAAAAAAAAAAAAAAAAAAAAAAAAAAAAAf39/ACUAAABYAAAAAAAAAAAAAAAAAAAAAAAAAAAAAAAAAAAAAAAAAAAAAAAAAAAAAAAAAAAAAAA/AAAAAAAAAKCGAQAAAAAAAAAAAAAAAAAMAAAAAQAAAAAAAAAAAAAAAAAAAB8AAABUAAAAAAAABQAAAAEAAAAAAAAAAAAAAAAAAAAAAAAAAAAAAAAAAAAAAAAAAAAAAAJ/f38AAAAAA8zMzADAwP8Af39/AAAAAAAAAAAAAAAAAAAAAAAAAAAAIQAAABgAAAAUAAAAwTUAABsnAABARwAAWSkAABAAAAAmAAAACAAAAAAAAAAAAAAA"/>
               </a:ext>
             </a:extLst>
           </p:cNvSpPr>
@@ -962,7 +962,7 @@
           <a:lstStyle/>
           <a:p>
             <a:pPr/>
-            <a:fld id="{1C000438-76F1-55F2-BFB8-80A74AF649D5}" type="slidenum">
+            <a:fld id="{2CE80035-7BC1-BDF6-8F50-8DA34E1E79D8}" type="slidenum">
               <a:t/>
             </a:fld>
           </a:p>
@@ -1001,7 +1001,7 @@
             <a:spLocks noGrp="1" noChangeArrowheads="1"/>
             <a:extLst>
               <a:ext uri="smNativeData">
-                <pr:smNativeData xmlns:pr="smNativeData" xmlns="smNativeData" val="SMDATA_15_7aDWaRMAAAAlAAAAZAAAAA8BAAAAkAAAAEgAAACQAAAASAAAAAAAAAAAAAAAAAAAAAEAAABQAAAAAAAAAAAA4D8AAAAAAADgPwAAAAAAAOA/AAAAAAAA4D8AAAAAAADgPwAAAAAAAOA/AAAAAAAA4D8AAAAAAADgPwAAAAAAAOA/AAAAAAAA4D8CAAAAjAAAAAAAAAAAAAAAu+DjDP///wgAAAAAAAAAAAAAAAAAAAAAAAAAAAAAAAAAAAAAZAAAAAEAAABAAAAAAAAAAAAAAAAAAAAAAAAAAAAAAAAAAAAAAAAAAAAAAAAAAAAAAAAAAAAAAAAAAAAAAAAAAAAAAAAAAAAAAAAAAAAAAAAAAAAAAAAAAAAAAAAAAAAAFAAAADwAAAAAAAAAAAAAAAAAAAkUAAAAAQAAABQAAAAUAAAAFAAAAAEAAAAAAAAAZAAAAGQAAAAAAAAAZAAAAGQAAAAVAAAAYAAAAAAAAAAAAAAADwAAACADAAAAAAAAAAAAAAEAAACgMgAAVgcAAKr4//8BAAAAf39/AAEAAABkAAAAAAAAABQAAABAHwAAAAAAACYAAAAAAAAAwOD//wAAAAAmAAAAZAAAABYAAABMAAAAAAAAAAAAAAAEAAAAAAAAAAEAAACAgIAKAAAAACgAAAAoAAAAZAAAAGQAAAAAAAAAzMzMAAAAAABQAAAAUAAAAGQAAABkAAAAAAAAABcAAAAUAAAAAAAAAAAAAAD/fwAA/38AAAAAAAAJAAAABAAAANw7IAEeAAAAaAAAAAAAAAAAAAAAAAAAAAAAAAAAAAAAECcAABAnAAAAAAAAAAAAAAAAAAAAAAAAAAAAAAAAAAAAAAAAAAAAABQAAAAAAAAAwMD/AAAAAABkAAAAMgAAAAAAAABkAAAAAAAAAH9/fwAKAAAAIgAAABgAAAAAAAAAAAAAAAAAAAAAAAAAAAAAAAAAAAAkAAAAJAAAAAAAAAAHAAAAAAAAAAAAAAAAAAAAAAAAAAAAAAAAAAAAf39/ACUAAABYAAAAAAAAAAAAAAAAAAAAAAAAAAAAAAAAAAAAAAAAAAAAAAAAAAAAAAAAAAAAAAA/AAAAAAAAAKCGAQAAAAAAAAAAAAAAAAAMAAAAAQAAAAAAAAAAAAAAAAAAAB8AAABUAAAAAAAABQAAAAEAAAAAAAAAAAAAAAAAAAAAAAAAAAAAAAAAAAAAAAAAAAAAAAJ/f38AAAAAA8zMzADAwP8Af39/AAAAAAAAAAAAAAAAAAAAAAAAAAAAIQAAABgAAAAUAAAA7QUAABwbAACtRQAAfSMAABAAAAAmAAAACAAAAIGAAAAAAAAA"/>
+                <pr:smNativeData xmlns:pr="smNativeData" xmlns="smNativeData" val="SMDATA_15_ZqHWaRMAAAAlAAAAZAAAAA8BAAAAkAAAAEgAAACQAAAASAAAAAAAAAAAAAAAAAAAAAEAAABQAAAAAAAAAAAA4D8AAAAAAADgPwAAAAAAAOA/AAAAAAAA4D8AAAAAAADgPwAAAAAAAOA/AAAAAAAA4D8AAAAAAADgPwAAAAAAAOA/AAAAAAAA4D8CAAAAjAAAAAAAAAAAAAAAu+DjDP///wgAAAAAAAAAAAAAAAAAAAAAAAAAAAAAAAAAAAAAZAAAAAEAAABAAAAAAAAAAAAAAAAAAAAAAAAAAAAAAAAAAAAAAAAAAAAAAAAAAAAAAAAAAAAAAAAAAAAAAAAAAAAAAAAAAAAAAAAAAAAAAAAAAAAAAAAAAAAAAAAAAAAAFAAAADwAAAAAAAAAAAAAAAAAAAkUAAAAAQAAABQAAAAUAAAAFAAAAAEAAAAAAAAAZAAAAGQAAAAAAAAAZAAAAGQAAAAVAAAAYAAAAAAAAAAAAAAADwAAACADAAAAAAAAAAAAAAEAAACgMgAAVgcAAKr4//8BAAAAf39/AAEAAABkAAAAAAAAABQAAABAHwAAAAAAACYAAAAAAAAAwOD//wAAAAAmAAAAZAAAABYAAABMAAAAAAAAAAAAAAAEAAAAAAAAAAEAAACAgIAKAAAAACgAAAAoAAAAZAAAAGQAAAAAAAAAzMzMAAAAAABQAAAAUAAAAGQAAABkAAAAAAAAABcAAAAUAAAAAAAAAAAAAAD/fwAA/38AAAAAAAAJAAAABAAAANw7IAEeAAAAaAAAAAAAAAAAAAAAAAAAAAAAAAAAAAAAECcAABAnAAAAAAAAAAAAAAAAAAAAAAAAAAAAAAAAAAAAAAAAAAAAABQAAAAAAAAAwMD/AAAAAABkAAAAMgAAAAAAAABkAAAAAAAAAH9/fwAKAAAAIgAAABgAAAAAAAAAAAAAAAAAAAAAAAAAAAAAAAAAAAAkAAAAJAAAAAAAAAAHAAAAAAAAAAAAAAAAAAAAAAAAAAAAAAAAAAAAf39/ACUAAABYAAAAAAAAAAAAAAAAAAAAAAAAAAAAAAAAAAAAAAAAAAAAAAAAAAAAAAAAAAAAAAA/AAAAAAAAAKCGAQAAAAAAAAAAAAAAAAAMAAAAAQAAAAAAAAAAAAAAAAAAAB8AAABUAAAAAAAABQAAAAEAAAAAAAAAAAAAAAAAAAAAAAAAAAAAAAAAAAAAAAAAAAAAAAJ/f38AAAAAA8zMzADAwP8Af39/AAAAAAAAAAAAAAAAAAAAAAAAAAAAIQAAABgAAAAUAAAA7QUAABwbAACtRQAAfSMAABAAAAAmAAAACAAAAIGAAAAAAAAA"/>
               </a:ext>
             </a:extLst>
           </p:cNvSpPr>
@@ -1041,7 +1041,7 @@
             <a:spLocks noGrp="1" noChangeArrowheads="1"/>
             <a:extLst>
               <a:ext uri="smNativeData">
-                <pr:smNativeData xmlns:pr="smNativeData" xmlns="smNativeData" val="SMDATA_15_7aDWaRMAAAAlAAAAZAAAAA8BAAAAkAAAAEgAAACQAAAASAAAAAAAAAACAAAAAAAAAAEAAABQAAAAAAAAAAAA4D8AAAAAAADgPwAAAAAAAOA/AAAAAAAA4D8AAAAAAADgPwAAAAAAAOA/AAAAAAAA4D8AAAAAAADgPwAAAAAAAOA/AAAAAAAA4D8CAAAAjAAAAAAAAAAAAAAAu+DjDP///wgAAAAAAAAAAAAAAAAAAAAAAAAAAAAAAAAAAAAAZAAAAAEAAABAAAAAAAAAAAAAAAAAAAAAAAAAAAAAAAAAAAAAAAAAAAAAAAAAAAAAAAAAAAAAAAAAAAAAAAAAAAAAAAAAAAAAAAAAAAAAAAAAAAAAAAAAAAAAAAAAAAAAFAAAADwAAAAAAAAAAAAAAAAAAAkUAAAAAQAAABQAAAAUAAAAFAAAAAEAAAAAAAAAZAAAAGQAAAAAAAAAZAAAAGQAAAAVAAAAYAAAAAAAAAAAAAAADwAAACADAAAAAAAAAAAAAAEAAACgMgAAVgcAAKr4//8BAAAAf39/AAEAAABkAAAAAAAAABQAAABAHwAAAAAAACYAAAAAAAAAwOD//wAAAAAmAAAAZAAAABYAAABMAAAAAAAAAAAAAAAEAAAAAAAAAAEAAACAgIAKAAAAACgAAAAoAAAAZAAAAGQAAAAAAAAAzMzMAAAAAABQAAAAUAAAAGQAAABkAAAAAAAAABcAAAAUAAAAAAAAAAAAAAD/fwAA/38AAAAAAAAJAAAABAAAANw7IAEeAAAAaAAAAAAAAAAAAAAAAAAAAAAAAAAAAAAAECcAABAnAAAAAAAAAAAAAAAAAAAAAAAAAAAAAAAAAAAAAAAAAAAAABQAAAAAAAAAwMD/AAAAAABkAAAAMgAAAAAAAABkAAAAAAAAAH9/fwAKAAAAIgAAABgAAAAAAAAAAAAAAAAAAAAAAAAAAAAAAAAAAAAkAAAAJAAAAAAAAAAHAAAAAAAAAAAAAAAAAAAAAAAAAAAAAAAAAAAAf39/ACUAAABYAAAAAAAAAAAAAAAAAAAAAAAAAAAAAAAAAAAAAAAAAAAAAAAAAAAAAAAAAAAAAAA/AAAAAAAAAKCGAQAAAAAAAAAAAAAAAAAMAAAAAQAAAAAAAAAAAAAAAAAAAB8AAABUAAAAAAAABQAAAAEAAAAAAAAAAAAAAAAAAAAAAAAAAAAAAAAAAAAAAAAAAAAAAAJ/f38AAAAAA8zMzADAwP8Af39/AAAAAAAAAAAAAAAAAAAAAAAAAAAAIQAAABgAAAAUAAAA7QUAAOERAACtRQAAHBsAABAAAAAmAAAACAAAAIGAAAAAAAAA"/>
+                <pr:smNativeData xmlns:pr="smNativeData" xmlns="smNativeData" val="SMDATA_15_ZqHWaRMAAAAlAAAAZAAAAA8BAAAAkAAAAEgAAACQAAAASAAAAAAAAAACAAAAAAAAAAEAAABQAAAAAAAAAAAA4D8AAAAAAADgPwAAAAAAAOA/AAAAAAAA4D8AAAAAAADgPwAAAAAAAOA/AAAAAAAA4D8AAAAAAADgPwAAAAAAAOA/AAAAAAAA4D8CAAAAjAAAAAAAAAAAAAAAu+DjDP///wgAAAAAAAAAAAAAAAAAAAAAAAAAAAAAAAAAAAAAZAAAAAEAAABAAAAAAAAAAAAAAAAAAAAAAAAAAAAAAAAAAAAAAAAAAAAAAAAAAAAAAAAAAAAAAAAAAAAAAAAAAAAAAAAAAAAAAAAAAAAAAAAAAAAAAAAAAAAAAAAAAAAAFAAAADwAAAAAAAAAAAAAAAAAAAkUAAAAAQAAABQAAAAUAAAAFAAAAAEAAAAAAAAAZAAAAGQAAAAAAAAAZAAAAGQAAAAVAAAAYAAAAAAAAAAAAAAADwAAACADAAAAAAAAAAAAAAEAAACgMgAAVgcAAKr4//8BAAAAf39/AAEAAABkAAAAAAAAABQAAABAHwAAAAAAACYAAAAAAAAAwOD//wAAAAAmAAAAZAAAABYAAABMAAAAAAAAAAAAAAAEAAAAAAAAAAEAAACAgIAKAAAAACgAAAAoAAAAZAAAAGQAAAAAAAAAzMzMAAAAAABQAAAAUAAAAGQAAABkAAAAAAAAABcAAAAUAAAAAAAAAAAAAAD/fwAA/38AAAAAAAAJAAAABAAAANw7IAEeAAAAaAAAAAAAAAAAAAAAAAAAAAAAAAAAAAAAECcAABAnAAAAAAAAAAAAAAAAAAAAAAAAAAAAAAAAAAAAAAAAAAAAABQAAAAAAAAAwMD/AAAAAABkAAAAMgAAAAAAAABkAAAAAAAAAH9/fwAKAAAAIgAAABgAAAAAAAAAAAAAAAAAAAAAAAAAAAAAAAAAAAAkAAAAJAAAAAAAAAAHAAAAAAAAAAAAAAAAAAAAAAAAAAAAAAAAAAAAf39/ACUAAABYAAAAAAAAAAAAAAAAAAAAAAAAAAAAAAAAAAAAAAAAAAAAAAAAAAAAAAAAAAAAAAA/AAAAAAAAAKCGAQAAAAAAAAAAAAAAAAAMAAAAAQAAAAAAAAAAAAAAAAAAAB8AAABUAAAAAAAABQAAAAEAAAAAAAAAAAAAAAAAAAAAAAAAAAAAAAAAAAAAAAAAAAAAAAJ/f38AAAAAA8zMzADAwP8Af39/AAAAAAAAAAAAAAAAAAAAAAAAAAAAIQAAABgAAAAUAAAA7QUAAOERAACtRQAAHBsAABAAAAAmAAAACAAAAIGAAAAAAAAA"/>
               </a:ext>
             </a:extLst>
           </p:cNvSpPr>
@@ -1114,7 +1114,7 @@
             <a:spLocks noGrp="1" noChangeArrowheads="1"/>
             <a:extLst>
               <a:ext uri="smNativeData">
-                <pr:smNativeData xmlns:pr="smNativeData" xmlns="smNativeData" val="SMDATA_15_7aDWaRMAAAAlAAAAZAAAAA8BAAAAkAAAAEgAAACQAAAASAAAAAAAAAABAAAAAAAAAAEAAABQAAAAAAAAAAAA4D8AAAAAAADgPwAAAAAAAOA/AAAAAAAA4D8AAAAAAADgPwAAAAAAAOA/AAAAAAAA4D8AAAAAAADgPwAAAAAAAOA/AAAAAAAA4D8CAAAAjAAAAAAAAAAAAAAAu+DjDP///wgAAAAAAAAAAAAAAAAAAAAAAAAAAAAAAAAAAAAAZAAAAAEAAABAAAAAAAAAAAAAAAAAAAAAAAAAAAAAAAAAAAAAAAAAAAAAAAAAAAAAAAAAAAAAAAAAAAAAAAAAAAAAAAAAAAAAAAAAAAAAAAAAAAAAAAAAAAAAAAAAAAAAFAAAADwAAAAAAAAAAAAAAAAAAAkUAAAAAQAAABQAAAAUAAAAFAAAAAEAAAAAAAAAZAAAAGQAAAAAAAAAZAAAAGQAAAAVAAAAYAAAAAAAAAAAAAAADwAAACADAAAAAAAAAAAAAAEAAACgMgAAVgcAAKr4//8BAAAAf39/AAEAAABkAAAAAAAAABQAAABAHwAAAAAAACYAAAAAAAAAwOD//wAAAAAmAAAAZAAAABYAAABMAAAAAAAAAAAAAAAEAAAAAAAAAAEAAACAgIAKAAAAACgAAAAoAAAAZAAAAGQAAAAAAAAAzMzMAAAAAABQAAAAUAAAAGQAAABkAAAAAAAAABcAAAAUAAAAAAAAAAAAAAD/fwAA/38AAAAAAAAJAAAABAAAAAAAAAAeAAAAaAAAAAAAAAAAAAAAAAAAAAAAAAAAAAAAECcAABAnAAAAAAAAAAAAAAAAAAAAAAAAAAAAAAAAAAAAAAAAAAAAABQAAAAAAAAAwMD/AAAAAABkAAAAMgAAAAAAAABkAAAAAAAAAH9/fwAKAAAAIgAAABgAAAAAAAAAAAAAAAAAAAAAAAAAAAAAAAAAAAAkAAAAJAAAAAAAAAAHAAAAAAAAAAAAAAAAAAAAAAAAAAAAAAAAAAAAf39/ACUAAABYAAAAAAAAAAAAAAAAAAAAAAAAAAAAAAAAAAAAAAAAAAAAAAAAAAAAAAAAAAAAAAA/AAAAAAAAAKCGAQAAAAAAAAAAAAAAAAAMAAAAAQAAAAAAAAAAAAAAAAAAAB8AAABUAAAAAAAABQAAAAEAAAAAAAAAAAAAAAAAAAAAAAAAAAAAAAAAAAAAAAAAAAAAAAJ/f38AAAAAA8zMzADAwP8Af39/AAAAAAAAAAAAAAAAAAAAAAAAAAAAIQAAABgAAAAUAAAAwAMAABsnAAA/FQAAWSkAABAAAAAmAAAACAAAAAAAAAAAAAAA"/>
+                <pr:smNativeData xmlns:pr="smNativeData" xmlns="smNativeData" val="SMDATA_15_ZqHWaRMAAAAlAAAAZAAAAA8BAAAAkAAAAEgAAACQAAAASAAAAAAAAAABAAAAAAAAAAEAAABQAAAAAAAAAAAA4D8AAAAAAADgPwAAAAAAAOA/AAAAAAAA4D8AAAAAAADgPwAAAAAAAOA/AAAAAAAA4D8AAAAAAADgPwAAAAAAAOA/AAAAAAAA4D8CAAAAjAAAAAAAAAAAAAAAu+DjDP///wgAAAAAAAAAAAAAAAAAAAAAAAAAAAAAAAAAAAAAZAAAAAEAAABAAAAAAAAAAAAAAAAAAAAAAAAAAAAAAAAAAAAAAAAAAAAAAAAAAAAAAAAAAAAAAAAAAAAAAAAAAAAAAAAAAAAAAAAAAAAAAAAAAAAAAAAAAAAAAAAAAAAAFAAAADwAAAAAAAAAAAAAAAAAAAkUAAAAAQAAABQAAAAUAAAAFAAAAAEAAAAAAAAAZAAAAGQAAAAAAAAAZAAAAGQAAAAVAAAAYAAAAAAAAAAAAAAADwAAACADAAAAAAAAAAAAAAEAAACgMgAAVgcAAKr4//8BAAAAf39/AAEAAABkAAAAAAAAABQAAABAHwAAAAAAACYAAAAAAAAAwOD//wAAAAAmAAAAZAAAABYAAABMAAAAAAAAAAAAAAAEAAAAAAAAAAEAAACAgIAKAAAAACgAAAAoAAAAZAAAAGQAAAAAAAAAzMzMAAAAAABQAAAAUAAAAGQAAABkAAAAAAAAABcAAAAUAAAAAAAAAAAAAAD/fwAA/38AAAAAAAAJAAAABAAAAAAAAAAeAAAAaAAAAAAAAAAAAAAAAAAAAAAAAAAAAAAAECcAABAnAAAAAAAAAAAAAAAAAAAAAAAAAAAAAAAAAAAAAAAAAAAAABQAAAAAAAAAwMD/AAAAAABkAAAAMgAAAAAAAABkAAAAAAAAAH9/fwAKAAAAIgAAABgAAAAAAAAAAAAAAAAAAAAAAAAAAAAAAAAAAAAkAAAAJAAAAAAAAAAHAAAAAAAAAAAAAAAAAAAAAAAAAAAAAAAAAAAAf39/ACUAAABYAAAAAAAAAAAAAAAAAAAAAAAAAAAAAAAAAAAAAAAAAAAAAAAAAAAAAAAAAAAAAAA/AAAAAAAAAKCGAQAAAAAAAAAAAAAAAAAMAAAAAQAAAAAAAAAAAAAAAAAAAB8AAABUAAAAAAAABQAAAAEAAAAAAAAAAAAAAAAAAAAAAAAAAAAAAAAAAAAAAAAAAAAAAAJ/f38AAAAAA8zMzADAwP8Af39/AAAAAAAAAAAAAAAAAAAAAAAAAAAAIQAAABgAAAAUAAAAwAMAABsnAAA/FQAAWSkAABAAAAAmAAAACAAAAAAAAAAAAAAA"/>
               </a:ext>
             </a:extLst>
           </p:cNvSpPr>
@@ -1128,7 +1128,7 @@
           <a:lstStyle/>
           <a:p>
             <a:pPr/>
-            <a:fld id="{1F3FF9B4-FAF2-6A0F-BC87-0C5AB7C94A59}" type="datetime1">
+            <a:fld id="{17871FEA-A4FA-D2E9-B43F-52BC51714207}" type="datetime1">
               <a:t/>
             </a:fld>
           </a:p>
@@ -1141,7 +1141,7 @@
             <a:spLocks noGrp="1" noChangeArrowheads="1"/>
             <a:extLst>
               <a:ext uri="smNativeData">
-                <pr:smNativeData xmlns:pr="smNativeData" xmlns="smNativeData" val="SMDATA_15_7aDWaRMAAAAlAAAAZAAAAA8BAAAAkAAAAEgAAACQAAAASAAAAAAAAAABAAAAAAAAAAEAAABQAAAAAAAAAAAA4D8AAAAAAADgPwAAAAAAAOA/AAAAAAAA4D8AAAAAAADgPwAAAAAAAOA/AAAAAAAA4D8AAAAAAADgPwAAAAAAAOA/AAAAAAAA4D8CAAAAjAAAAAAAAAAAAAAAu+DjDP///wgAAAAAAAAAAAAAAAAAAAAAAAAAAAAAAAAAAAAAZAAAAAEAAABAAAAAAAAAAAAAAAAAAAAAAAAAAAAAAAAAAAAAAAAAAAAAAAAAAAAAAAAAAAAAAAAAAAAAAAAAAAAAAAAAAAAAAAAAAAAAAAAAAAAAAAAAAAAAAAAAAAAAFAAAADwAAAAAAAAAAAAAAAAAAAkUAAAAAQAAABQAAAAUAAAAFAAAAAEAAAAAAAAAZAAAAGQAAAAAAAAAZAAAAGQAAAAVAAAAYAAAAAAAAAAAAAAADwAAACADAAAAAAAAAAAAAAEAAACgMgAAVgcAAKr4//8BAAAAf39/AAEAAABkAAAAAAAAABQAAABAHwAAAAAAACYAAAAAAAAAwOD//wAAAAAmAAAAZAAAABYAAABMAAAAAAAAAAAAAAAEAAAAAAAAAAEAAACAgIAKAAAAACgAAAAoAAAAZAAAAGQAAAAAAAAAzMzMAAAAAABQAAAAUAAAAGQAAABkAAAAAAAAABcAAAAUAAAAAAAAAAAAAAD/fwAA/38AAAAAAAAJAAAABAAAANw7IAEeAAAAaAAAAAAAAAAAAAAAAAAAAAAAAAAAAAAAECcAABAnAAAAAAAAAAAAAAAAAAAAAAAAAAAAAAAAAAAAAAAAAAAAABQAAAAAAAAAwMD/AAAAAABkAAAAMgAAAAAAAABkAAAAAAAAAH9/fwAKAAAAIgAAABgAAAAAAAAAAAAAAAAAAAAAAAAAAAAAAAAAAAAkAAAAJAAAAAAAAAAHAAAAAAAAAAAAAAAAAAAAAAAAAAAAAAAAAAAAf39/ACUAAABYAAAAAAAAAAAAAAAAAAAAAAAAAAAAAAAAAAAAAAAAAAAAAAAAAAAAAAAAAAAAAAA/AAAAAAAAAKCGAQAAAAAAAAAAAAAAAAAMAAAAAQAAAAAAAAAAAAAAAAAAAB8AAABUAAAAAAAABQAAAAEAAAAAAAAAAAAAAAAAAAAAAAAAAAAAAAAAAAAAAAAAAAAAAAJ/f38AAAAAA8zMzADAwP8Af39/AAAAAAAAAAAAAAAAAAAAAAAAAAAAIQAAABgAAAAUAAAAoRkAABsnAABfMQAAWSkAABAAAAAmAAAACAAAAAAAAAAAAAAA"/>
+                <pr:smNativeData xmlns:pr="smNativeData" xmlns="smNativeData" val="SMDATA_15_ZqHWaRMAAAAlAAAAZAAAAA8BAAAAkAAAAEgAAACQAAAASAAAAAAAAAABAAAAAAAAAAEAAABQAAAAAAAAAAAA4D8AAAAAAADgPwAAAAAAAOA/AAAAAAAA4D8AAAAAAADgPwAAAAAAAOA/AAAAAAAA4D8AAAAAAADgPwAAAAAAAOA/AAAAAAAA4D8CAAAAjAAAAAAAAAAAAAAAu+DjDP///wgAAAAAAAAAAAAAAAAAAAAAAAAAAAAAAAAAAAAAZAAAAAEAAABAAAAAAAAAAAAAAAAAAAAAAAAAAAAAAAAAAAAAAAAAAAAAAAAAAAAAAAAAAAAAAAAAAAAAAAAAAAAAAAAAAAAAAAAAAAAAAAAAAAAAAAAAAAAAAAAAAAAAFAAAADwAAAAAAAAAAAAAAAAAAAkUAAAAAQAAABQAAAAUAAAAFAAAAAEAAAAAAAAAZAAAAGQAAAAAAAAAZAAAAGQAAAAVAAAAYAAAAAAAAAAAAAAADwAAACADAAAAAAAAAAAAAAEAAACgMgAAVgcAAKr4//8BAAAAf39/AAEAAABkAAAAAAAAABQAAABAHwAAAAAAACYAAAAAAAAAwOD//wAAAAAmAAAAZAAAABYAAABMAAAAAAAAAAAAAAAEAAAAAAAAAAEAAACAgIAKAAAAACgAAAAoAAAAZAAAAGQAAAAAAAAAzMzMAAAAAABQAAAAUAAAAGQAAABkAAAAAAAAABcAAAAUAAAAAAAAAAAAAAD/fwAA/38AAAAAAAAJAAAABAAAANw7IAEeAAAAaAAAAAAAAAAAAAAAAAAAAAAAAAAAAAAAECcAABAnAAAAAAAAAAAAAAAAAAAAAAAAAAAAAAAAAAAAAAAAAAAAABQAAAAAAAAAwMD/AAAAAABkAAAAMgAAAAAAAABkAAAAAAAAAH9/fwAKAAAAIgAAABgAAAAAAAAAAAAAAAAAAAAAAAAAAAAAAAAAAAAkAAAAJAAAAAAAAAAHAAAAAAAAAAAAAAAAAAAAAAAAAAAAAAAAAAAAf39/ACUAAABYAAAAAAAAAAAAAAAAAAAAAAAAAAAAAAAAAAAAAAAAAAAAAAAAAAAAAAAAAAAAAAA/AAAAAAAAAKCGAQAAAAAAAAAAAAAAAAAMAAAAAQAAAAAAAAAAAAAAAAAAAB8AAABUAAAAAAAABQAAAAEAAAAAAAAAAAAAAAAAAAAAAAAAAAAAAAAAAAAAAAAAAAAAAAJ/f38AAAAAA8zMzADAwP8Af39/AAAAAAAAAAAAAAAAAAAAAAAAAAAAIQAAABgAAAAUAAAAoRkAABsnAABfMQAAWSkAABAAAAAmAAAACAAAAAAAAAAAAAAA"/>
               </a:ext>
             </a:extLst>
           </p:cNvSpPr>
@@ -1165,7 +1165,7 @@
             <a:spLocks noGrp="1" noChangeArrowheads="1"/>
             <a:extLst>
               <a:ext uri="smNativeData">
-                <pr:smNativeData xmlns:pr="smNativeData" xmlns="smNativeData" val="SMDATA_15_7aDWaRMAAAAlAAAAZAAAAA8BAAAAkAAAAEgAAACQAAAASAAAAAAAAAABAAAAAAAAAAEAAABQAAAAAAAAAAAA4D8AAAAAAADgPwAAAAAAAOA/AAAAAAAA4D8AAAAAAADgPwAAAAAAAOA/AAAAAAAA4D8AAAAAAADgPwAAAAAAAOA/AAAAAAAA4D8CAAAAjAAAAAAAAAAAAAAAu+DjDP///wgAAAAAAAAAAAAAAAAAAAAAAAAAAAAAAAAAAAAAZAAAAAEAAABAAAAAAAAAAAAAAAAAAAAAAAAAAAAAAAAAAAAAAAAAAAAAAAAAAAAAAAAAAAAAAAAAAAAAAAAAAAAAAAAAAAAAAAAAAAAAAAAAAAAAAAAAAAAAAAAAAAAAFAAAADwAAAAAAAAAAAAAAAAAAAkUAAAAAQAAABQAAAAUAAAAFAAAAAEAAAAAAAAAZAAAAGQAAAAAAAAAZAAAAGQAAAAVAAAAYAAAAAAAAAAAAAAADwAAACADAAAAAAAAAAAAAAEAAACgMgAAVgcAAKr4//8BAAAAf39/AAEAAABkAAAAAAAAABQAAABAHwAAAAAAACYAAAAAAAAAwOD//wAAAAAmAAAAZAAAABYAAABMAAAAAAAAAAAAAAAEAAAAAAAAAAEAAACAgIAKAAAAACgAAAAoAAAAZAAAAGQAAAAAAAAAzMzMAAAAAABQAAAAUAAAAGQAAABkAAAAAAAAABcAAAAUAAAAAAAAAAAAAAD/fwAA/38AAAAAAAAJAAAABAAAANw7IAEeAAAAaAAAAAAAAAAAAAAAAAAAAAAAAAAAAAAAECcAABAnAAAAAAAAAAAAAAAAAAAAAAAAAAAAAAAAAAAAAAAAAAAAABQAAAAAAAAAwMD/AAAAAABkAAAAMgAAAAAAAABkAAAAAAAAAH9/fwAKAAAAIgAAABgAAAAAAAAAAAAAAAAAAAAAAAAAAAAAAAAAAAAkAAAAJAAAAAAAAAAHAAAAAAAAAAAAAAAAAAAAAAAAAAAAAAAAAAAAf39/ACUAAABYAAAAAAAAAAAAAAAAAAAAAAAAAAAAAAAAAAAAAAAAAAAAAAAAAAAAAAAAAAAAAAA/AAAAAAAAAKCGAQAAAAAAAAAAAAAAAAAMAAAAAQAAAAAAAAAAAAAAAAAAAB8AAABUAAAAAAAABQAAAAEAAAAAAAAAAAAAAAAAAAAAAAAAAAAAAAAAAAAAAAAAAAAAAAJ/f38AAAAAA8zMzADAwP8Af39/AAAAAAAAAAAAAAAAAAAAAAAAAAAAIQAAABgAAAAUAAAAwTUAABsnAABARwAAWSkAABAAAAAmAAAACAAAAAAAAAAAAAAA"/>
+                <pr:smNativeData xmlns:pr="smNativeData" xmlns="smNativeData" val="SMDATA_15_ZqHWaRMAAAAlAAAAZAAAAA8BAAAAkAAAAEgAAACQAAAASAAAAAAAAAABAAAAAAAAAAEAAABQAAAAAAAAAAAA4D8AAAAAAADgPwAAAAAAAOA/AAAAAAAA4D8AAAAAAADgPwAAAAAAAOA/AAAAAAAA4D8AAAAAAADgPwAAAAAAAOA/AAAAAAAA4D8CAAAAjAAAAAAAAAAAAAAAu+DjDP///wgAAAAAAAAAAAAAAAAAAAAAAAAAAAAAAAAAAAAAZAAAAAEAAABAAAAAAAAAAAAAAAAAAAAAAAAAAAAAAAAAAAAAAAAAAAAAAAAAAAAAAAAAAAAAAAAAAAAAAAAAAAAAAAAAAAAAAAAAAAAAAAAAAAAAAAAAAAAAAAAAAAAAFAAAADwAAAAAAAAAAAAAAAAAAAkUAAAAAQAAABQAAAAUAAAAFAAAAAEAAAAAAAAAZAAAAGQAAAAAAAAAZAAAAGQAAAAVAAAAYAAAAAAAAAAAAAAADwAAACADAAAAAAAAAAAAAAEAAACgMgAAVgcAAKr4//8BAAAAf39/AAEAAABkAAAAAAAAABQAAABAHwAAAAAAACYAAAAAAAAAwOD//wAAAAAmAAAAZAAAABYAAABMAAAAAAAAAAAAAAAEAAAAAAAAAAEAAACAgIAKAAAAACgAAAAoAAAAZAAAAGQAAAAAAAAAzMzMAAAAAABQAAAAUAAAAGQAAABkAAAAAAAAABcAAAAUAAAAAAAAAAAAAAD/fwAA/38AAAAAAAAJAAAABAAAANw7IAEeAAAAaAAAAAAAAAAAAAAAAAAAAAAAAAAAAAAAECcAABAnAAAAAAAAAAAAAAAAAAAAAAAAAAAAAAAAAAAAAAAAAAAAABQAAAAAAAAAwMD/AAAAAABkAAAAMgAAAAAAAABkAAAAAAAAAH9/fwAKAAAAIgAAABgAAAAAAAAAAAAAAAAAAAAAAAAAAAAAAAAAAAAkAAAAJAAAAAAAAAAHAAAAAAAAAAAAAAAAAAAAAAAAAAAAAAAAAAAAf39/ACUAAABYAAAAAAAAAAAAAAAAAAAAAAAAAAAAAAAAAAAAAAAAAAAAAAAAAAAAAAAAAAAAAAA/AAAAAAAAAKCGAQAAAAAAAAAAAAAAAAAMAAAAAQAAAAAAAAAAAAAAAAAAAB8AAABUAAAAAAAABQAAAAEAAAAAAAAAAAAAAAAAAAAAAAAAAAAAAAAAAAAAAAAAAAAAAAJ/f38AAAAAA8zMzADAwP8Af39/AAAAAAAAAAAAAAAAAAAAAAAAAAAAIQAAABgAAAAUAAAAwTUAABsnAABARwAAWSkAABAAAAAmAAAACAAAAAAAAAAAAAAA"/>
               </a:ext>
             </a:extLst>
           </p:cNvSpPr>
@@ -1179,7 +1179,7 @@
           <a:lstStyle/>
           <a:p>
             <a:pPr/>
-            <a:fld id="{5A1F8A31-7FB7-4A7C-F9A7-8929C4E90FDC}" type="slidenum">
+            <a:fld id="{2FF24BE4-AAC2-A7BD-8C4A-5CE805047A09}" type="slidenum">
               <a:t/>
             </a:fld>
           </a:p>
@@ -1218,7 +1218,7 @@
             <a:spLocks noGrp="1" noChangeArrowheads="1"/>
             <a:extLst>
               <a:ext uri="smNativeData">
-                <pr:smNativeData xmlns:pr="smNativeData" xmlns="smNativeData" val="SMDATA_15_7aDWaRMAAAAlAAAAZAAAAA8BAAAAkAAAAEgAAACQAAAASAAAAAAAAAABAAAAAAAAAAEAAABQAAAAAAAAAAAA4D8AAAAAAADgPwAAAAAAAOA/AAAAAAAA4D8AAAAAAADgPwAAAAAAAOA/AAAAAAAA4D8AAAAAAADgPwAAAAAAAOA/AAAAAAAA4D8CAAAAjAAAAAAAAAAAAAAAu+DjDP///wgAAAAAAAAAAAAAAAAAAAAAAAAAAAAAAAAAAAAAZAAAAAEAAABAAAAAAAAAAAAAAAAAAAAAAAAAAAAAAAAAAAAAAAAAAAAAAAAAAAAAAAAAAAAAAAAAAAAAAAAAAAAAAAAAAAAAAAAAAAAAAAAAAAAAAAAAAAAAAAAAAAAAFAAAADwAAAAAAAAAAAAAAAAAAAkUAAAAAQAAABQAAAAUAAAAFAAAAAEAAAAAAAAAZAAAAGQAAAAAAAAAZAAAAGQAAAAVAAAAYAAAAAAAAAAAAAAADwAAACADAAAAAAAAAAAAAAEAAACgMgAAVgcAAKr4//8BAAAAf39/AAEAAABkAAAAAAAAABQAAABAHwAAAAAAACYAAAAAAAAAwOD//wAAAAAmAAAAZAAAABYAAABMAAAAAAAAAAAAAAAEAAAAAAAAAAEAAACAgIAKAAAAACgAAAAoAAAAZAAAAGQAAAAAAAAAzMzMAAAAAABQAAAAUAAAAGQAAABkAAAAAAAAABcAAAAUAAAAAAAAAAAAAAD/fwAA/38AAAAAAAAJAAAABAAAANw7IAEeAAAAaAAAAAAAAAAAAAAAAAAAAAAAAAAAAAAAECcAABAnAAAAAAAAAAAAAAAAAAAAAAAAAAAAAAAAAAAAAAAAAAAAABQAAAAAAAAAwMD/AAAAAABkAAAAMgAAAAAAAABkAAAAAAAAAH9/fwAKAAAAIgAAABgAAAAAAAAAAAAAAAAAAAAAAAAAAAAAAAAAAAAkAAAAJAAAAAAAAAAHAAAAAAAAAAAAAAAAAAAAAAAAAAAAAAAAAAAAf39/ACUAAABYAAAAAAAAAAAAAAAAAAAAAAAAAAAAAAAAAAAAAAAAAAAAAAAAAAAAAAAAAAAAAAA/AAAAAAAAAKCGAQAAAAAAAAAAAAAAAAAMAAAAAQAAAAAAAAAAAAAAAAAAAB8AAABUAAAAAAAABQAAAAEAAAAAAAAAAAAAAAAAAAAAAAAAAAAAAAAAAAAAAAAAAAAAAAJ/f38AAAAAA8zMzADAwP8Af39/AAAAAAAAAAAAAAAAAAAAAAAAAAAAIQAAABgAAAAUAAAAwAMAALABAABARwAAuAgAABAAAAAmAAAACAAAAAAAAAAAAAAA"/>
+                <pr:smNativeData xmlns:pr="smNativeData" xmlns="smNativeData" val="SMDATA_15_ZqHWaRMAAAAlAAAAZAAAAA8BAAAAkAAAAEgAAACQAAAASAAAAAAAAAABAAAAAAAAAAEAAABQAAAAAAAAAAAA4D8AAAAAAADgPwAAAAAAAOA/AAAAAAAA4D8AAAAAAADgPwAAAAAAAOA/AAAAAAAA4D8AAAAAAADgPwAAAAAAAOA/AAAAAAAA4D8CAAAAjAAAAAAAAAAAAAAAu+DjDP///wgAAAAAAAAAAAAAAAAAAAAAAAAAAAAAAAAAAAAAZAAAAAEAAABAAAAAAAAAAAAAAAAAAAAAAAAAAAAAAAAAAAAAAAAAAAAAAAAAAAAAAAAAAAAAAAAAAAAAAAAAAAAAAAAAAAAAAAAAAAAAAAAAAAAAAAAAAAAAAAAAAAAAFAAAADwAAAAAAAAAAAAAAAAAAAkUAAAAAQAAABQAAAAUAAAAFAAAAAEAAAAAAAAAZAAAAGQAAAAAAAAAZAAAAGQAAAAVAAAAYAAAAAAAAAAAAAAADwAAACADAAAAAAAAAAAAAAEAAACgMgAAVgcAAKr4//8BAAAAf39/AAEAAABkAAAAAAAAABQAAABAHwAAAAAAACYAAAAAAAAAwOD//wAAAAAmAAAAZAAAABYAAABMAAAAAAAAAAAAAAAEAAAAAAAAAAEAAACAgIAKAAAAACgAAAAoAAAAZAAAAGQAAAAAAAAAzMzMAAAAAABQAAAAUAAAAGQAAABkAAAAAAAAABcAAAAUAAAAAAAAAAAAAAD/fwAA/38AAAAAAAAJAAAABAAAANw7IAEeAAAAaAAAAAAAAAAAAAAAAAAAAAAAAAAAAAAAECcAABAnAAAAAAAAAAAAAAAAAAAAAAAAAAAAAAAAAAAAAAAAAAAAABQAAAAAAAAAwMD/AAAAAABkAAAAMgAAAAAAAABkAAAAAAAAAH9/fwAKAAAAIgAAABgAAAAAAAAAAAAAAAAAAAAAAAAAAAAAAAAAAAAkAAAAJAAAAAAAAAAHAAAAAAAAAAAAAAAAAAAAAAAAAAAAAAAAAAAAf39/ACUAAABYAAAAAAAAAAAAAAAAAAAAAAAAAAAAAAAAAAAAAAAAAAAAAAAAAAAAAAAAAAAAAAA/AAAAAAAAAKCGAQAAAAAAAAAAAAAAAAAMAAAAAQAAAAAAAAAAAAAAAAAAAB8AAABUAAAAAAAABQAAAAEAAAAAAAAAAAAAAAAAAAAAAAAAAAAAAAAAAAAAAAAAAAAAAAJ/f38AAAAAA8zMzADAwP8Af39/AAAAAAAAAAAAAAAAAAAAAAAAAAAAIQAAABgAAAAUAAAAwAMAALABAABARwAAuAgAABAAAAAmAAAACAAAAAAAAAAAAAAA"/>
               </a:ext>
             </a:extLst>
           </p:cNvSpPr>
@@ -1245,7 +1245,7 @@
             <a:spLocks noGrp="1" noChangeArrowheads="1"/>
             <a:extLst>
               <a:ext uri="smNativeData">
-                <pr:smNativeData xmlns:pr="smNativeData" xmlns="smNativeData" val="SMDATA_15_7aDWaRMAAAAlAAAAZAAAAA8BAAAAkAAAAEgAAACQAAAASAAAAAAAAAAAAAAAAAAAAAEAAABQAAAAAAAAAAAA4D8AAAAAAADgPwAAAAAAAOA/AAAAAAAA4D8AAAAAAADgPwAAAAAAAOA/AAAAAAAA4D8AAAAAAADgPwAAAAAAAOA/AAAAAAAA4D8CAAAAjAAAAAAAAAAAAAAAu+DjDP///wgAAAAAAAAAAAAAAAAAAAAAAAAAAAAAAAAAAAAAZAAAAAEAAABAAAAAAAAAAAAAAAAAAAAAAAAAAAAAAAAAAAAAAAAAAAAAAAAAAAAAAAAAAAAAAAAAAAAAAAAAAAAAAAAAAAAAAAAAAAAAAAAAAAAAAAAAAAAAAAAAAAAAFAAAADwAAAAAAAAAAAAAAAAAAAkUAAAAAQAAABQAAAAUAAAAFAAAAAEAAAAAAAAAZAAAAGQAAAAAAAAAZAAAAGQAAAAVAAAAYAAAAAAAAAAAAAAADwAAACADAAAAAAAAAAAAAAEAAACgMgAAVgcAAKr4//8BAAAAf39/AAEAAABkAAAAAAAAABQAAABAHwAAAAAAACYAAAAAAAAAwOD//wAAAAAmAAAAZAAAABYAAABMAAAAAAAAAAAAAAAEAAAAAAAAAAEAAACAgIAKAAAAACgAAAAoAAAAZAAAAGQAAAAAAAAAzMzMAAAAAABQAAAAUAAAAGQAAABkAAAAAAAAABcAAAAUAAAAAAAAAAAAAAD/fwAA/38AAAAAAAAJAAAABAAAANw7IAEeAAAAaAAAAAAAAAAAAAAAAAAAAAAAAAAAAAAAECcAABAnAAAAAAAAAAAAAAAAAAAAAAAAAAAAAAAAAAAAAAAAAAAAABQAAAAAAAAAwMD/AAAAAABkAAAAMgAAAAAAAABkAAAAAAAAAH9/fwAKAAAAIgAAABgAAAAAAAAAAAAAAAAAAAAAAAAAAAAAAAAAAAAkAAAAJAAAAAAAAAAHAAAAAAAAAAAAAAAAAAAAAAAAAAAAAAAAAAAAf39/ACUAAABYAAAAAAAAAAAAAAAAAAAAAAAAAAAAAAAAAAAAAAAAAAAAAAAAAAAAAAAAAAAAAAA/AAAAAAAAAKCGAQAAAAAAAAAAAAAAAAAMAAAAAQAAAAAAAAAAAAAAAAAAAB8AAABUAAAAAAAABQAAAAEAAAAAAAAAAAAAAAAAAAAAAAAAAAAAAAAAAAAAAAAAAAAAAAJ/f38AAAAAA8zMzADAwP8Af39/AAAAAAAAAAAAAAAAAAAAAAAAAAAAIQAAABgAAAAUAAAAwAMAANgJAADhJAAAsCUAABAAAAAmAAAACAAAAAGAAAAAAAAA"/>
+                <pr:smNativeData xmlns:pr="smNativeData" xmlns="smNativeData" val="SMDATA_15_ZqHWaRMAAAAlAAAAZAAAAA8BAAAAkAAAAEgAAACQAAAASAAAAAAAAAAAAAAAAAAAAAEAAABQAAAAAAAAAAAA4D8AAAAAAADgPwAAAAAAAOA/AAAAAAAA4D8AAAAAAADgPwAAAAAAAOA/AAAAAAAA4D8AAAAAAADgPwAAAAAAAOA/AAAAAAAA4D8CAAAAjAAAAAAAAAAAAAAAu+DjDP///wgAAAAAAAAAAAAAAAAAAAAAAAAAAAAAAAAAAAAAZAAAAAEAAABAAAAAAAAAAAAAAAAAAAAAAAAAAAAAAAAAAAAAAAAAAAAAAAAAAAAAAAAAAAAAAAAAAAAAAAAAAAAAAAAAAAAAAAAAAAAAAAAAAAAAAAAAAAAAAAAAAAAAFAAAADwAAAAAAAAAAAAAAAAAAAkUAAAAAQAAABQAAAAUAAAAFAAAAAEAAAAAAAAAZAAAAGQAAAAAAAAAZAAAAGQAAAAVAAAAYAAAAAAAAAAAAAAADwAAACADAAAAAAAAAAAAAAEAAACgMgAAVgcAAKr4//8BAAAAf39/AAEAAABkAAAAAAAAABQAAABAHwAAAAAAACYAAAAAAAAAwOD//wAAAAAmAAAAZAAAABYAAABMAAAAAAAAAAAAAAAEAAAAAAAAAAEAAACAgIAKAAAAACgAAAAoAAAAZAAAAGQAAAAAAAAAzMzMAAAAAABQAAAAUAAAAGQAAABkAAAAAAAAABcAAAAUAAAAAAAAAAAAAAD/fwAA/38AAAAAAAAJAAAABAAAANw7IAEeAAAAaAAAAAAAAAAAAAAAAAAAAAAAAAAAAAAAECcAABAnAAAAAAAAAAAAAAAAAAAAAAAAAAAAAAAAAAAAAAAAAAAAABQAAAAAAAAAwMD/AAAAAABkAAAAMgAAAAAAAABkAAAAAAAAAH9/fwAKAAAAIgAAABgAAAAAAAAAAAAAAAAAAAAAAAAAAAAAAAAAAAAkAAAAJAAAAAAAAAAHAAAAAAAAAAAAAAAAAAAAAAAAAAAAAAAAAAAAf39/ACUAAABYAAAAAAAAAAAAAAAAAAAAAAAAAAAAAAAAAAAAAAAAAAAAAAAAAAAAAAAAAAAAAAA/AAAAAAAAAKCGAQAAAAAAAAAAAAAAAAAMAAAAAQAAAAAAAAAAAAAAAAAAAB8AAABUAAAAAAAABQAAAAEAAAAAAAAAAAAAAAAAAAAAAAAAAAAAAAAAAAAAAAAAAAAAAAJ/f38AAAAAA8zMzADAwP8Af39/AAAAAAAAAAAAAAAAAAAAAAAAAAAAIQAAABgAAAAUAAAAwAMAANgJAADhJAAAsCUAABAAAAAmAAAACAAAAAGAAAAAAAAA"/>
               </a:ext>
             </a:extLst>
           </p:cNvSpPr>
@@ -1329,7 +1329,7 @@
             <a:spLocks noGrp="1" noChangeArrowheads="1"/>
             <a:extLst>
               <a:ext uri="smNativeData">
-                <pr:smNativeData xmlns:pr="smNativeData" xmlns="smNativeData" val="SMDATA_15_7aDWaRMAAAAlAAAAZAAAAA8BAAAAkAAAAEgAAACQAAAASAAAAAAAAAAAAAAAAAAAAAEAAABQAAAAAAAAAAAA4D8AAAAAAADgPwAAAAAAAOA/AAAAAAAA4D8AAAAAAADgPwAAAAAAAOA/AAAAAAAA4D8AAAAAAADgPwAAAAAAAOA/AAAAAAAA4D8CAAAAjAAAAAAAAAAAAAAAu+DjDP///wgAAAAAAAAAAAAAAAAAAAAAAAAAAAAAAAAAAAAAZAAAAAEAAABAAAAAAAAAAAAAAAAAAAAAAAAAAAAAAAAAAAAAAAAAAAAAAAAAAAAAAAAAAAAAAAAAAAAAAAAAAAAAAAAAAAAAAAAAAAAAAAAAAAAAAAAAAAAAAAAAAAAAFAAAADwAAAAAAAAAAAAAAAAAAAkUAAAAAQAAABQAAAAUAAAAFAAAAAEAAAAAAAAAZAAAAGQAAAAAAAAAZAAAAGQAAAAVAAAAYAAAAAAAAAAAAAAADwAAACADAAAAAAAAAAAAAAEAAACgMgAAVgcAAKr4//8BAAAAf39/AAEAAABkAAAAAAAAABQAAABAHwAAAAAAACYAAAAAAAAAwOD//wAAAAAmAAAAZAAAABYAAABMAAAAAAAAAAAAAAAEAAAAAAAAAAEAAACAgIAKAAAAACgAAAAoAAAAZAAAAGQAAAAAAAAAzMzMAAAAAABQAAAAUAAAAGQAAABkAAAAAAAAABcAAAAUAAAAAAAAAAAAAAD/fwAA/38AAAAAAAAJAAAABAAAANw7IAEeAAAAaAAAAAAAAAAAAAAAAAAAAAAAAAAAAAAAECcAABAnAAAAAAAAAAAAAAAAAAAAAAAAAAAAAAAAAAAAAAAAAAAAABQAAAAAAAAAwMD/AAAAAABkAAAAMgAAAAAAAABkAAAAAAAAAH9/fwAKAAAAIgAAABgAAAAAAAAAAAAAAAAAAAAAAAAAAAAAAAAAAAAkAAAAJAAAAAAAAAAHAAAAAAAAAAAAAAAAAAAAAAAAAAAAAAAAAAAAf39/ACUAAABYAAAAAAAAAAAAAAAAAAAAAAAAAAAAAAAAAAAAAAAAAAAAAAAAAAAAAAAAAAAAAAA/AAAAAAAAAKCGAQAAAAAAAAAAAAAAAAAMAAAAAQAAAAAAAAAAAAAAAAAAAB8AAABUAAAAAAAABQAAAAEAAAAAAAAAAAAAAAAAAAAAAAAAAAAAAAAAAAAAAAAAAAAAAAJ/f38AAAAAA8zMzADAwP8Af39/AAAAAAAAAAAAAAAAAAAAAAAAAAAAIQAAABgAAAAUAAAAHyYAANgJAABARwAAsCUAABAAAAAmAAAACAAAAAGAAAAAAAAA"/>
+                <pr:smNativeData xmlns:pr="smNativeData" xmlns="smNativeData" val="SMDATA_15_ZqHWaRMAAAAlAAAAZAAAAA8BAAAAkAAAAEgAAACQAAAASAAAAAAAAAAAAAAAAAAAAAEAAABQAAAAAAAAAAAA4D8AAAAAAADgPwAAAAAAAOA/AAAAAAAA4D8AAAAAAADgPwAAAAAAAOA/AAAAAAAA4D8AAAAAAADgPwAAAAAAAOA/AAAAAAAA4D8CAAAAjAAAAAAAAAAAAAAAu+DjDP///wgAAAAAAAAAAAAAAAAAAAAAAAAAAAAAAAAAAAAAZAAAAAEAAABAAAAAAAAAAAAAAAAAAAAAAAAAAAAAAAAAAAAAAAAAAAAAAAAAAAAAAAAAAAAAAAAAAAAAAAAAAAAAAAAAAAAAAAAAAAAAAAAAAAAAAAAAAAAAAAAAAAAAFAAAADwAAAAAAAAAAAAAAAAAAAkUAAAAAQAAABQAAAAUAAAAFAAAAAEAAAAAAAAAZAAAAGQAAAAAAAAAZAAAAGQAAAAVAAAAYAAAAAAAAAAAAAAADwAAACADAAAAAAAAAAAAAAEAAACgMgAAVgcAAKr4//8BAAAAf39/AAEAAABkAAAAAAAAABQAAABAHwAAAAAAACYAAAAAAAAAwOD//wAAAAAmAAAAZAAAABYAAABMAAAAAAAAAAAAAAAEAAAAAAAAAAEAAACAgIAKAAAAACgAAAAoAAAAZAAAAGQAAAAAAAAAzMzMAAAAAABQAAAAUAAAAGQAAABkAAAAAAAAABcAAAAUAAAAAAAAAAAAAAD/fwAA/38AAAAAAAAJAAAABAAAANw7IAEeAAAAaAAAAAAAAAAAAAAAAAAAAAAAAAAAAAAAECcAABAnAAAAAAAAAAAAAAAAAAAAAAAAAAAAAAAAAAAAAAAAAAAAABQAAAAAAAAAwMD/AAAAAABkAAAAMgAAAAAAAABkAAAAAAAAAH9/fwAKAAAAIgAAABgAAAAAAAAAAAAAAAAAAAAAAAAAAAAAAAAAAAAkAAAAJAAAAAAAAAAHAAAAAAAAAAAAAAAAAAAAAAAAAAAAAAAAAAAAf39/ACUAAABYAAAAAAAAAAAAAAAAAAAAAAAAAAAAAAAAAAAAAAAAAAAAAAAAAAAAAAAAAAAAAAA/AAAAAAAAAKCGAQAAAAAAAAAAAAAAAAAMAAAAAQAAAAAAAAAAAAAAAAAAAB8AAABUAAAAAAAABQAAAAEAAAAAAAAAAAAAAAAAAAAAAAAAAAAAAAAAAAAAAAAAAAAAAAJ/f38AAAAAA8zMzADAwP8Af39/AAAAAAAAAAAAAAAAAAAAAAAAAAAAIQAAABgAAAAUAAAAHyYAANgJAABARwAAsCUAABAAAAAmAAAACAAAAAGAAAAAAAAA"/>
               </a:ext>
             </a:extLst>
           </p:cNvSpPr>
@@ -1413,7 +1413,7 @@
             <a:spLocks noGrp="1" noChangeArrowheads="1"/>
             <a:extLst>
               <a:ext uri="smNativeData">
-                <pr:smNativeData xmlns:pr="smNativeData" xmlns="smNativeData" val="SMDATA_15_7aDWaRMAAAAlAAAAZAAAAA8BAAAAkAAAAEgAAACQAAAASAAAAAAAAAABAAAAAAAAAAEAAABQAAAAAAAAAAAA4D8AAAAAAADgPwAAAAAAAOA/AAAAAAAA4D8AAAAAAADgPwAAAAAAAOA/AAAAAAAA4D8AAAAAAADgPwAAAAAAAOA/AAAAAAAA4D8CAAAAjAAAAAAAAAAAAAAAu+DjDP///wgAAAAAAAAAAAAAAAAAAAAAAAAAAAAAAAAAAAAAZAAAAAEAAABAAAAAAAAAAAAAAAAAAAAAAAAAAAAAAAAAAAAAAAAAAAAAAAAAAAAAAAAAAAAAAAAAAAAAAAAAAAAAAAAAAAAAAAAAAAAAAAAAAAAAAAAAAAAAAAAAAAAAFAAAADwAAAAAAAAAAAAAAAAAAAkUAAAAAQAAABQAAAAUAAAAFAAAAAEAAAAAAAAAZAAAAGQAAAAAAAAAZAAAAGQAAAAVAAAAYAAAAAAAAAAAAAAADwAAACADAAAAAAAAAAAAAAEAAACgMgAAVgcAAKr4//8BAAAAf39/AAEAAABkAAAAAAAAABQAAABAHwAAAAAAACYAAAAAAAAAwOD//wAAAAAmAAAAZAAAABYAAABMAAAAAAAAAAAAAAAEAAAAAAAAAAEAAACAgIAKAAAAACgAAAAoAAAAZAAAAGQAAAAAAAAAzMzMAAAAAABQAAAAUAAAAGQAAABkAAAAAAAAABcAAAAUAAAAAAAAAAAAAAD/fwAA/38AAAAAAAAJAAAABAAAANw7IAEeAAAAaAAAAAAAAAAAAAAAAAAAAAAAAAAAAAAAECcAABAnAAAAAAAAAAAAAAAAAAAAAAAAAAAAAAAAAAAAAAAAAAAAABQAAAAAAAAAwMD/AAAAAABkAAAAMgAAAAAAAABkAAAAAAAAAH9/fwAKAAAAIgAAABgAAAAAAAAAAAAAAAAAAAAAAAAAAAAAAAAAAAAkAAAAJAAAAAAAAAAHAAAAAAAAAAAAAAAAAAAAAAAAAAAAAAAAAAAAf39/ACUAAABYAAAAAAAAAAAAAAAAAAAAAAAAAAAAAAAAAAAAAAAAAAAAAAAAAAAAAAAAAAAAAAA/AAAAAAAAAKCGAQAAAAAAAAAAAAAAAAAMAAAAAQAAAAAAAAAAAAAAAAAAAB8AAABUAAAAAAAABQAAAAEAAAAAAAAAAAAAAAAAAAAAAAAAAAAAAAAAAAAAAAAAAAAAAAJ/f38AAAAAA8zMzADAwP8Af39/AAAAAAAAAAAAAAAAAAAAAAAAAAAAIQAAABgAAAAUAAAAwAMAABsnAAA/FQAAWSkAABAAAAAmAAAACAAAAAAAAAAAAAAA"/>
+                <pr:smNativeData xmlns:pr="smNativeData" xmlns="smNativeData" val="SMDATA_15_ZqHWaRMAAAAlAAAAZAAAAA8BAAAAkAAAAEgAAACQAAAASAAAAAAAAAABAAAAAAAAAAEAAABQAAAAAAAAAAAA4D8AAAAAAADgPwAAAAAAAOA/AAAAAAAA4D8AAAAAAADgPwAAAAAAAOA/AAAAAAAA4D8AAAAAAADgPwAAAAAAAOA/AAAAAAAA4D8CAAAAjAAAAAAAAAAAAAAAu+DjDP///wgAAAAAAAAAAAAAAAAAAAAAAAAAAAAAAAAAAAAAZAAAAAEAAABAAAAAAAAAAAAAAAAAAAAAAAAAAAAAAAAAAAAAAAAAAAAAAAAAAAAAAAAAAAAAAAAAAAAAAAAAAAAAAAAAAAAAAAAAAAAAAAAAAAAAAAAAAAAAAAAAAAAAFAAAADwAAAAAAAAAAAAAAAAAAAkUAAAAAQAAABQAAAAUAAAAFAAAAAEAAAAAAAAAZAAAAGQAAAAAAAAAZAAAAGQAAAAVAAAAYAAAAAAAAAAAAAAADwAAACADAAAAAAAAAAAAAAEAAACgMgAAVgcAAKr4//8BAAAAf39/AAEAAABkAAAAAAAAABQAAABAHwAAAAAAACYAAAAAAAAAwOD//wAAAAAmAAAAZAAAABYAAABMAAAAAAAAAAAAAAAEAAAAAAAAAAEAAACAgIAKAAAAACgAAAAoAAAAZAAAAGQAAAAAAAAAzMzMAAAAAABQAAAAUAAAAGQAAABkAAAAAAAAABcAAAAUAAAAAAAAAAAAAAD/fwAA/38AAAAAAAAJAAAABAAAANw7IAEeAAAAaAAAAAAAAAAAAAAAAAAAAAAAAAAAAAAAECcAABAnAAAAAAAAAAAAAAAAAAAAAAAAAAAAAAAAAAAAAAAAAAAAABQAAAAAAAAAwMD/AAAAAABkAAAAMgAAAAAAAABkAAAAAAAAAH9/fwAKAAAAIgAAABgAAAAAAAAAAAAAAAAAAAAAAAAAAAAAAAAAAAAkAAAAJAAAAAAAAAAHAAAAAAAAAAAAAAAAAAAAAAAAAAAAAAAAAAAAf39/ACUAAABYAAAAAAAAAAAAAAAAAAAAAAAAAAAAAAAAAAAAAAAAAAAAAAAAAAAAAAAAAAAAAAA/AAAAAAAAAKCGAQAAAAAAAAAAAAAAAAAMAAAAAQAAAAAAAAAAAAAAAAAAAB8AAABUAAAAAAAABQAAAAEAAAAAAAAAAAAAAAAAAAAAAAAAAAAAAAAAAAAAAAAAAAAAAAJ/f38AAAAAA8zMzADAwP8Af39/AAAAAAAAAAAAAAAAAAAAAAAAAAAAIQAAABgAAAAUAAAAwAMAABsnAAA/FQAAWSkAABAAAAAmAAAACAAAAAAAAAAAAAAA"/>
               </a:ext>
             </a:extLst>
           </p:cNvSpPr>
@@ -1427,7 +1427,7 @@
           <a:lstStyle/>
           <a:p>
             <a:pPr/>
-            <a:fld id="{490CEAED-A3A4-591C-EAB4-5549A4FA1C00}" type="datetime1">
+            <a:fld id="{5F0F75AA-E4B2-5A83-FCB7-12D63BF90A47}" type="datetime1">
               <a:t/>
             </a:fld>
           </a:p>
@@ -1440,7 +1440,7 @@
             <a:spLocks noGrp="1" noChangeArrowheads="1"/>
             <a:extLst>
               <a:ext uri="smNativeData">
-                <pr:smNativeData xmlns:pr="smNativeData" xmlns="smNativeData" val="SMDATA_15_7aDWaRMAAAAlAAAAZAAAAA8BAAAAkAAAAEgAAACQAAAASAAAAAAAAAABAAAAAAAAAAEAAABQAAAAAAAAAAAA4D8AAAAAAADgPwAAAAAAAOA/AAAAAAAA4D8AAAAAAADgPwAAAAAAAOA/AAAAAAAA4D8AAAAAAADgPwAAAAAAAOA/AAAAAAAA4D8CAAAAjAAAAAAAAAAAAAAAu+DjDP///wgAAAAAAAAAAAAAAAAAAAAAAAAAAAAAAAAAAAAAZAAAAAEAAABAAAAAAAAAAAAAAAAAAAAAAAAAAAAAAAAAAAAAAAAAAAAAAAAAAAAAAAAAAAAAAAAAAAAAAAAAAAAAAAAAAAAAAAAAAAAAAAAAAAAAAAAAAAAAAAAAAAAAFAAAADwAAAAAAAAAAAAAAAAAAAkUAAAAAQAAABQAAAAUAAAAFAAAAAEAAAAAAAAAZAAAAGQAAAAAAAAAZAAAAGQAAAAVAAAAYAAAAAAAAAAAAAAADwAAACADAAAAAAAAAAAAAAEAAACgMgAAVgcAAKr4//8BAAAAf39/AAEAAABkAAAAAAAAABQAAABAHwAAAAAAACYAAAAAAAAAwOD//wAAAAAmAAAAZAAAABYAAABMAAAAAAAAAAAAAAAEAAAAAAAAAAEAAACAgIAKAAAAACgAAAAoAAAAZAAAAGQAAAAAAAAAzMzMAAAAAABQAAAAUAAAAGQAAABkAAAAAAAAABcAAAAUAAAAAAAAAAAAAAD/fwAA/38AAAAAAAAJAAAABAAAANw7IAEeAAAAaAAAAAAAAAAAAAAAAAAAAAAAAAAAAAAAECcAABAnAAAAAAAAAAAAAAAAAAAAAAAAAAAAAAAAAAAAAAAAAAAAABQAAAAAAAAAwMD/AAAAAABkAAAAMgAAAAAAAABkAAAAAAAAAH9/fwAKAAAAIgAAABgAAAAAAAAAAAAAAAAAAAAAAAAAAAAAAAAAAAAkAAAAJAAAAAAAAAAHAAAAAAAAAAAAAAAAAAAAAAAAAAAAAAAAAAAAf39/ACUAAABYAAAAAAAAAAAAAAAAAAAAAAAAAAAAAAAAAAAAAAAAAAAAAAAAAAAAAAAAAAAAAAA/AAAAAAAAAKCGAQAAAAAAAAAAAAAAAAAMAAAAAQAAAAAAAAAAAAAAAAAAAB8AAABUAAAAAAAABQAAAAEAAAAAAAAAAAAAAAAAAAAAAAAAAAAAAAAAAAAAAAAAAAAAAAJ/f38AAAAAA8zMzADAwP8Af39/AAAAAAAAAAAAAAAAAAAAAAAAAAAAIQAAABgAAAAUAAAAoRkAABsnAABfMQAAWSkAABAAAAAmAAAACAAAAAAAAAAAAAAA"/>
+                <pr:smNativeData xmlns:pr="smNativeData" xmlns="smNativeData" val="SMDATA_15_ZqHWaRMAAAAlAAAAZAAAAA8BAAAAkAAAAEgAAACQAAAASAAAAAAAAAABAAAAAAAAAAEAAABQAAAAAAAAAAAA4D8AAAAAAADgPwAAAAAAAOA/AAAAAAAA4D8AAAAAAADgPwAAAAAAAOA/AAAAAAAA4D8AAAAAAADgPwAAAAAAAOA/AAAAAAAA4D8CAAAAjAAAAAAAAAAAAAAAu+DjDP///wgAAAAAAAAAAAAAAAAAAAAAAAAAAAAAAAAAAAAAZAAAAAEAAABAAAAAAAAAAAAAAAAAAAAAAAAAAAAAAAAAAAAAAAAAAAAAAAAAAAAAAAAAAAAAAAAAAAAAAAAAAAAAAAAAAAAAAAAAAAAAAAAAAAAAAAAAAAAAAAAAAAAAFAAAADwAAAAAAAAAAAAAAAAAAAkUAAAAAQAAABQAAAAUAAAAFAAAAAEAAAAAAAAAZAAAAGQAAAAAAAAAZAAAAGQAAAAVAAAAYAAAAAAAAAAAAAAADwAAACADAAAAAAAAAAAAAAEAAACgMgAAVgcAAKr4//8BAAAAf39/AAEAAABkAAAAAAAAABQAAABAHwAAAAAAACYAAAAAAAAAwOD//wAAAAAmAAAAZAAAABYAAABMAAAAAAAAAAAAAAAEAAAAAAAAAAEAAACAgIAKAAAAACgAAAAoAAAAZAAAAGQAAAAAAAAAzMzMAAAAAABQAAAAUAAAAGQAAABkAAAAAAAAABcAAAAUAAAAAAAAAAAAAAD/fwAA/38AAAAAAAAJAAAABAAAANw7IAEeAAAAaAAAAAAAAAAAAAAAAAAAAAAAAAAAAAAAECcAABAnAAAAAAAAAAAAAAAAAAAAAAAAAAAAAAAAAAAAAAAAAAAAABQAAAAAAAAAwMD/AAAAAABkAAAAMgAAAAAAAABkAAAAAAAAAH9/fwAKAAAAIgAAABgAAAAAAAAAAAAAAAAAAAAAAAAAAAAAAAAAAAAkAAAAJAAAAAAAAAAHAAAAAAAAAAAAAAAAAAAAAAAAAAAAAAAAAAAAf39/ACUAAABYAAAAAAAAAAAAAAAAAAAAAAAAAAAAAAAAAAAAAAAAAAAAAAAAAAAAAAAAAAAAAAA/AAAAAAAAAKCGAQAAAAAAAAAAAAAAAAAMAAAAAQAAAAAAAAAAAAAAAAAAAB8AAABUAAAAAAAABQAAAAEAAAAAAAAAAAAAAAAAAAAAAAAAAAAAAAAAAAAAAAAAAAAAAAJ/f38AAAAAA8zMzADAwP8Af39/AAAAAAAAAAAAAAAAAAAAAAAAAAAAIQAAABgAAAAUAAAAoRkAABsnAABfMQAAWSkAABAAAAAmAAAACAAAAAAAAAAAAAAA"/>
               </a:ext>
             </a:extLst>
           </p:cNvSpPr>
@@ -1464,7 +1464,7 @@
             <a:spLocks noGrp="1" noChangeArrowheads="1"/>
             <a:extLst>
               <a:ext uri="smNativeData">
-                <pr:smNativeData xmlns:pr="smNativeData" xmlns="smNativeData" val="SMDATA_15_7aDWaRMAAAAlAAAAZAAAAA8BAAAAkAAAAEgAAACQAAAASAAAAAAAAAABAAAAAAAAAAEAAABQAAAAAAAAAAAA4D8AAAAAAADgPwAAAAAAAOA/AAAAAAAA4D8AAAAAAADgPwAAAAAAAOA/AAAAAAAA4D8AAAAAAADgPwAAAAAAAOA/AAAAAAAA4D8CAAAAjAAAAAAAAAAAAAAAu+DjDP///wgAAAAAAAAAAAAAAAAAAAAAAAAAAAAAAAAAAAAAZAAAAAEAAABAAAAAAAAAAAAAAAAAAAAAAAAAAAAAAAAAAAAAAAAAAAAAAAAAAAAAAAAAAAAAAAAAAAAAAAAAAAAAAAAAAAAAAAAAAAAAAAAAAAAAAAAAAAAAAAAAAAAAFAAAADwAAAAAAAAAAAAAAAAAAAkUAAAAAQAAABQAAAAUAAAAFAAAAAEAAAAAAAAAZAAAAGQAAAAAAAAAZAAAAGQAAAAVAAAAYAAAAAAAAAAAAAAADwAAACADAAAAAAAAAAAAAAEAAACgMgAAVgcAAKr4//8BAAAAf39/AAEAAABkAAAAAAAAABQAAABAHwAAAAAAACYAAAAAAAAAwOD//wAAAAAmAAAAZAAAABYAAABMAAAAAAAAAAAAAAAEAAAAAAAAAAEAAACAgIAKAAAAACgAAAAoAAAAZAAAAGQAAAAAAAAAzMzMAAAAAABQAAAAUAAAAGQAAABkAAAAAAAAABcAAAAUAAAAAAAAAAAAAAD/fwAA/38AAAAAAAAJAAAABAAAANw7IAEeAAAAaAAAAAAAAAAAAAAAAAAAAAAAAAAAAAAAECcAABAnAAAAAAAAAAAAAAAAAAAAAAAAAAAAAAAAAAAAAAAAAAAAABQAAAAAAAAAwMD/AAAAAABkAAAAMgAAAAAAAABkAAAAAAAAAH9/fwAKAAAAIgAAABgAAAAAAAAAAAAAAAAAAAAAAAAAAAAAAAAAAAAkAAAAJAAAAAAAAAAHAAAAAAAAAAAAAAAAAAAAAAAAAAAAAAAAAAAAf39/ACUAAABYAAAAAAAAAAAAAAAAAAAAAAAAAAAAAAAAAAAAAAAAAAAAAAAAAAAAAAAAAAAAAAA/AAAAAAAAAKCGAQAAAAAAAAAAAAAAAAAMAAAAAQAAAAAAAAAAAAAAAAAAAB8AAABUAAAAAAAABQAAAAEAAAAAAAAAAAAAAAAAAAAAAAAAAAAAAAAAAAAAAAAAAAAAAAJ/f38AAAAAA8zMzADAwP8Af39/AAAAAAAAAAAAAAAAAAAAAAAAAAAAIQAAABgAAAAUAAAAwTUAABsnAABARwAAWSkAABAAAAAmAAAACAAAAAAAAAAAAAAA"/>
+                <pr:smNativeData xmlns:pr="smNativeData" xmlns="smNativeData" val="SMDATA_15_ZqHWaRMAAAAlAAAAZAAAAA8BAAAAkAAAAEgAAACQAAAASAAAAAAAAAABAAAAAAAAAAEAAABQAAAAAAAAAAAA4D8AAAAAAADgPwAAAAAAAOA/AAAAAAAA4D8AAAAAAADgPwAAAAAAAOA/AAAAAAAA4D8AAAAAAADgPwAAAAAAAOA/AAAAAAAA4D8CAAAAjAAAAAAAAAAAAAAAu+DjDP///wgAAAAAAAAAAAAAAAAAAAAAAAAAAAAAAAAAAAAAZAAAAAEAAABAAAAAAAAAAAAAAAAAAAAAAAAAAAAAAAAAAAAAAAAAAAAAAAAAAAAAAAAAAAAAAAAAAAAAAAAAAAAAAAAAAAAAAAAAAAAAAAAAAAAAAAAAAAAAAAAAAAAAFAAAADwAAAAAAAAAAAAAAAAAAAkUAAAAAQAAABQAAAAUAAAAFAAAAAEAAAAAAAAAZAAAAGQAAAAAAAAAZAAAAGQAAAAVAAAAYAAAAAAAAAAAAAAADwAAACADAAAAAAAAAAAAAAEAAACgMgAAVgcAAKr4//8BAAAAf39/AAEAAABkAAAAAAAAABQAAABAHwAAAAAAACYAAAAAAAAAwOD//wAAAAAmAAAAZAAAABYAAABMAAAAAAAAAAAAAAAEAAAAAAAAAAEAAACAgIAKAAAAACgAAAAoAAAAZAAAAGQAAAAAAAAAzMzMAAAAAABQAAAAUAAAAGQAAABkAAAAAAAAABcAAAAUAAAAAAAAAAAAAAD/fwAA/38AAAAAAAAJAAAABAAAANw7IAEeAAAAaAAAAAAAAAAAAAAAAAAAAAAAAAAAAAAAECcAABAnAAAAAAAAAAAAAAAAAAAAAAAAAAAAAAAAAAAAAAAAAAAAABQAAAAAAAAAwMD/AAAAAABkAAAAMgAAAAAAAABkAAAAAAAAAH9/fwAKAAAAIgAAABgAAAAAAAAAAAAAAAAAAAAAAAAAAAAAAAAAAAAkAAAAJAAAAAAAAAAHAAAAAAAAAAAAAAAAAAAAAAAAAAAAAAAAAAAAf39/ACUAAABYAAAAAAAAAAAAAAAAAAAAAAAAAAAAAAAAAAAAAAAAAAAAAAAAAAAAAAAAAAAAAAA/AAAAAAAAAKCGAQAAAAAAAAAAAAAAAAAMAAAAAQAAAAAAAAAAAAAAAAAAAB8AAABUAAAAAAAABQAAAAEAAAAAAAAAAAAAAAAAAAAAAAAAAAAAAAAAAAAAAAAAAAAAAAJ/f38AAAAAA8zMzADAwP8Af39/AAAAAAAAAAAAAAAAAAAAAAAAAAAAIQAAABgAAAAUAAAAwTUAABsnAABARwAAWSkAABAAAAAmAAAACAAAAAAAAAAAAAAA"/>
               </a:ext>
             </a:extLst>
           </p:cNvSpPr>
@@ -1478,7 +1478,7 @@
           <a:lstStyle/>
           <a:p>
             <a:pPr/>
-            <a:fld id="{3C7D8877-39D1-287E-9FC5-CF2BC68B699A}" type="slidenum">
+            <a:fld id="{57B50146-08BA-E0F7-F40D-FEA24F4302AB}" type="slidenum">
               <a:t/>
             </a:fld>
           </a:p>
@@ -1517,7 +1517,7 @@
             <a:spLocks noGrp="1" noChangeArrowheads="1"/>
             <a:extLst>
               <a:ext uri="smNativeData">
-                <pr:smNativeData xmlns:pr="smNativeData" xmlns="smNativeData" val="SMDATA_15_7aDWaRMAAAAlAAAAZAAAAA8BAAAAkAAAAEgAAACQAAAASAAAAAAAAAABAAAAAAAAAAEAAABQAAAAAAAAAAAA4D8AAAAAAADgPwAAAAAAAOA/AAAAAAAA4D8AAAAAAADgPwAAAAAAAOA/AAAAAAAA4D8AAAAAAADgPwAAAAAAAOA/AAAAAAAA4D8CAAAAjAAAAAAAAAAAAAAAu+DjDP///wgAAAAAAAAAAAAAAAAAAAAAAAAAAAAAAAAAAAAAZAAAAAEAAABAAAAAAAAAAAAAAAAAAAAAAAAAAAAAAAAAAAAAAAAAAAAAAAAAAAAAAAAAAAAAAAAAAAAAAAAAAAAAAAAAAAAAAAAAAAAAAAAAAAAAAAAAAAAAAAAAAAAAFAAAADwAAAAAAAAAAAAAAAAAAAkUAAAAAQAAABQAAAAUAAAAFAAAAAEAAAAAAAAAZAAAAGQAAAAAAAAAZAAAAGQAAAAVAAAAYAAAAAAAAAAAAAAADwAAACADAAAAAAAAAAAAAAEAAACgMgAAVgcAAKr4//8BAAAAf39/AAEAAABkAAAAAAAAABQAAABAHwAAAAAAACYAAAAAAAAAwOD//wAAAAAmAAAAZAAAABYAAABMAAAAAAAAAAAAAAAEAAAAAAAAAAEAAACAgIAKAAAAACgAAAAoAAAAZAAAAGQAAAAAAAAAzMzMAAAAAABQAAAAUAAAAGQAAABkAAAAAAAAABcAAAAUAAAAAAAAAAAAAAD/fwAA/38AAAAAAAAJAAAABAAAANw7IAEeAAAAaAAAAAAAAAAAAAAAAAAAAAAAAAAAAAAAECcAABAnAAAAAAAAAAAAAAAAAAAAAAAAAAAAAAAAAAAAAAAAAAAAABQAAAAAAAAAwMD/AAAAAABkAAAAMgAAAAAAAABkAAAAAAAAAH9/fwAKAAAAIgAAABgAAAAAAAAAAAAAAAAAAAAAAAAAAAAAAAAAAAAkAAAAJAAAAAAAAAAHAAAAAAAAAAAAAAAAAAAAAAAAAAAAAAAAAAAAf39/ACUAAABYAAAAAAAAAAAAAAAAAAAAAAAAAAAAAAAAAAAAAAAAAAAAAAAAAAAAAAAAAAAAAAA/AAAAAAAAAKCGAQAAAAAAAAAAAAAAAAAMAAAAAQAAAAAAAAAAAAAAAAAAAB8AAABUAAAAAAAABQAAAAEAAAAAAAAAAAAAAAAAAAAAAAAAAAAAAAAAAAAAAAAAAAAAAAJ/f38AAAAAA8zMzADAwP8Af39/AAAAAAAAAAAAAAAAAAAAAAAAAAAAIQAAABgAAAAUAAAAwAMAALABAABARwAAuAgAABAAAAAmAAAACAAAAAAAAAAAAAAA"/>
+                <pr:smNativeData xmlns:pr="smNativeData" xmlns="smNativeData" val="SMDATA_15_ZqHWaRMAAAAlAAAAZAAAAA8BAAAAkAAAAEgAAACQAAAASAAAAAAAAAABAAAAAAAAAAEAAABQAAAAAAAAAAAA4D8AAAAAAADgPwAAAAAAAOA/AAAAAAAA4D8AAAAAAADgPwAAAAAAAOA/AAAAAAAA4D8AAAAAAADgPwAAAAAAAOA/AAAAAAAA4D8CAAAAjAAAAAAAAAAAAAAAu+DjDP///wgAAAAAAAAAAAAAAAAAAAAAAAAAAAAAAAAAAAAAZAAAAAEAAABAAAAAAAAAAAAAAAAAAAAAAAAAAAAAAAAAAAAAAAAAAAAAAAAAAAAAAAAAAAAAAAAAAAAAAAAAAAAAAAAAAAAAAAAAAAAAAAAAAAAAAAAAAAAAAAAAAAAAFAAAADwAAAAAAAAAAAAAAAAAAAkUAAAAAQAAABQAAAAUAAAAFAAAAAEAAAAAAAAAZAAAAGQAAAAAAAAAZAAAAGQAAAAVAAAAYAAAAAAAAAAAAAAADwAAACADAAAAAAAAAAAAAAEAAACgMgAAVgcAAKr4//8BAAAAf39/AAEAAABkAAAAAAAAABQAAABAHwAAAAAAACYAAAAAAAAAwOD//wAAAAAmAAAAZAAAABYAAABMAAAAAAAAAAAAAAAEAAAAAAAAAAEAAACAgIAKAAAAACgAAAAoAAAAZAAAAGQAAAAAAAAAzMzMAAAAAABQAAAAUAAAAGQAAABkAAAAAAAAABcAAAAUAAAAAAAAAAAAAAD/fwAA/38AAAAAAAAJAAAABAAAANw7IAEeAAAAaAAAAAAAAAAAAAAAAAAAAAAAAAAAAAAAECcAABAnAAAAAAAAAAAAAAAAAAAAAAAAAAAAAAAAAAAAAAAAAAAAABQAAAAAAAAAwMD/AAAAAABkAAAAMgAAAAAAAABkAAAAAAAAAH9/fwAKAAAAIgAAABgAAAAAAAAAAAAAAAAAAAAAAAAAAAAAAAAAAAAkAAAAJAAAAAAAAAAHAAAAAAAAAAAAAAAAAAAAAAAAAAAAAAAAAAAAf39/ACUAAABYAAAAAAAAAAAAAAAAAAAAAAAAAAAAAAAAAAAAAAAAAAAAAAAAAAAAAAAAAAAAAAA/AAAAAAAAAKCGAQAAAAAAAAAAAAAAAAAMAAAAAQAAAAAAAAAAAAAAAAAAAB8AAABUAAAAAAAABQAAAAEAAAAAAAAAAAAAAAAAAAAAAAAAAAAAAAAAAAAAAAAAAAAAAAJ/f38AAAAAA8zMzADAwP8Af39/AAAAAAAAAAAAAAAAAAAAAAAAAAAAIQAAABgAAAAUAAAAwAMAALABAABARwAAuAgAABAAAAAmAAAACAAAAAAAAAAAAAAA"/>
               </a:ext>
             </a:extLst>
           </p:cNvSpPr>
@@ -1544,7 +1544,7 @@
             <a:spLocks noGrp="1" noChangeArrowheads="1"/>
             <a:extLst>
               <a:ext uri="smNativeData">
-                <pr:smNativeData xmlns:pr="smNativeData" xmlns="smNativeData" val="SMDATA_15_7aDWaRMAAAAlAAAAZAAAAA8BAAAAkAAAAEgAAACQAAAASAAAAAAAAAACAAAAAAAAAAEAAABQAAAAAAAAAAAA4D8AAAAAAADgPwAAAAAAAOA/AAAAAAAA4D8AAAAAAADgPwAAAAAAAOA/AAAAAAAA4D8AAAAAAADgPwAAAAAAAOA/AAAAAAAA4D8CAAAAjAAAAAAAAAAAAAAAu+DjDP///wgAAAAAAAAAAAAAAAAAAAAAAAAAAAAAAAAAAAAAZAAAAAEAAABAAAAAAAAAAAAAAAAAAAAAAAAAAAAAAAAAAAAAAAAAAAAAAAAAAAAAAAAAAAAAAAAAAAAAAAAAAAAAAAAAAAAAAAAAAAAAAAAAAAAAAAAAAAAAAAAAAAAAFAAAADwAAAAAAAAAAAAAAAAAAAkUAAAAAQAAABQAAAAUAAAAFAAAAAEAAAAAAAAAZAAAAGQAAAAAAAAAZAAAAGQAAAAVAAAAYAAAAAAAAAAAAAAADwAAACADAAAAAAAAAAAAAAEAAACgMgAAVgcAAKr4//8BAAAAf39/AAEAAABkAAAAAAAAABQAAABAHwAAAAAAACYAAAAAAAAAwOD//wAAAAAmAAAAZAAAABYAAABMAAAAAAAAAAAAAAAEAAAAAAAAAAEAAACAgIAKAAAAACgAAAAoAAAAZAAAAGQAAAAAAAAAzMzMAAAAAABQAAAAUAAAAGQAAABkAAAAAAAAABcAAAAUAAAAAAAAAAAAAAD/fwAA/38AAAAAAAAJAAAABAAAANw7IAEeAAAAaAAAAAAAAAAAAAAAAAAAAAAAAAAAAAAAECcAABAnAAAAAAAAAAAAAAAAAAAAAAAAAAAAAAAAAAAAAAAAAAAAABQAAAAAAAAAwMD/AAAAAABkAAAAMgAAAAAAAABkAAAAAAAAAH9/fwAKAAAAIgAAABgAAAAAAAAAAAAAAAAAAAAAAAAAAAAAAAAAAAAkAAAAJAAAAAAAAAAHAAAAAAAAAAAAAAAAAAAAAAAAAAAAAAAAAAAAf39/ACUAAABYAAAAAAAAAAAAAAAAAAAAAAAAAAAAAAAAAAAAAAAAAAAAAAAAAAAAAAAAAAAAAAA/AAAAAAAAAKCGAQAAAAAAAAAAAAAAAAAMAAAAAQAAAAAAAAAAAAAAAAAAAB8AAABUAAAAAAAABQAAAAEAAAAAAAAAAAAAAAAAAAAAAAAAAAAAAAAAAAAAAAAAAAAAAAJ/f38AAAAAA8zMzADAwP8Af39/AAAAAAAAAAAAAAAAAAAAAAAAAAAAIQAAABgAAAAUAAAAwAMAAHEJAADjJAAAYQ0AABAAAAAmAAAACAAAAIGAAAAAAAAA"/>
+                <pr:smNativeData xmlns:pr="smNativeData" xmlns="smNativeData" val="SMDATA_15_ZqHWaRMAAAAlAAAAZAAAAA8BAAAAkAAAAEgAAACQAAAASAAAAAAAAAACAAAAAAAAAAEAAABQAAAAAAAAAAAA4D8AAAAAAADgPwAAAAAAAOA/AAAAAAAA4D8AAAAAAADgPwAAAAAAAOA/AAAAAAAA4D8AAAAAAADgPwAAAAAAAOA/AAAAAAAA4D8CAAAAjAAAAAAAAAAAAAAAu+DjDP///wgAAAAAAAAAAAAAAAAAAAAAAAAAAAAAAAAAAAAAZAAAAAEAAABAAAAAAAAAAAAAAAAAAAAAAAAAAAAAAAAAAAAAAAAAAAAAAAAAAAAAAAAAAAAAAAAAAAAAAAAAAAAAAAAAAAAAAAAAAAAAAAAAAAAAAAAAAAAAAAAAAAAAFAAAADwAAAAAAAAAAAAAAAAAAAkUAAAAAQAAABQAAAAUAAAAFAAAAAEAAAAAAAAAZAAAAGQAAAAAAAAAZAAAAGQAAAAVAAAAYAAAAAAAAAAAAAAADwAAACADAAAAAAAAAAAAAAEAAACgMgAAVgcAAKr4//8BAAAAf39/AAEAAABkAAAAAAAAABQAAABAHwAAAAAAACYAAAAAAAAAwOD//wAAAAAmAAAAZAAAABYAAABMAAAAAAAAAAAAAAAEAAAAAAAAAAEAAACAgIAKAAAAACgAAAAoAAAAZAAAAGQAAAAAAAAAzMzMAAAAAABQAAAAUAAAAGQAAABkAAAAAAAAABcAAAAUAAAAAAAAAAAAAAD/fwAA/38AAAAAAAAJAAAABAAAANw7IAEeAAAAaAAAAAAAAAAAAAAAAAAAAAAAAAAAAAAAECcAABAnAAAAAAAAAAAAAAAAAAAAAAAAAAAAAAAAAAAAAAAAAAAAABQAAAAAAAAAwMD/AAAAAABkAAAAMgAAAAAAAABkAAAAAAAAAH9/fwAKAAAAIgAAABgAAAAAAAAAAAAAAAAAAAAAAAAAAAAAAAAAAAAkAAAAJAAAAAAAAAAHAAAAAAAAAAAAAAAAAAAAAAAAAAAAAAAAAAAAf39/ACUAAABYAAAAAAAAAAAAAAAAAAAAAAAAAAAAAAAAAAAAAAAAAAAAAAAAAAAAAAAAAAAAAAA/AAAAAAAAAKCGAQAAAAAAAAAAAAAAAAAMAAAAAQAAAAAAAAAAAAAAAAAAAB8AAABUAAAAAAAABQAAAAEAAAAAAAAAAAAAAAAAAAAAAAAAAAAAAAAAAAAAAAAAAAAAAAJ/f38AAAAAA8zMzADAwP8Af39/AAAAAAAAAAAAAAAAAAAAAAAAAAAAIQAAABgAAAAUAAAAwAMAAHEJAADjJAAAYQ0AABAAAAAmAAAACAAAAIGAAAAAAAAA"/>
               </a:ext>
             </a:extLst>
           </p:cNvSpPr>
@@ -1617,7 +1617,7 @@
             <a:spLocks noGrp="1" noChangeArrowheads="1"/>
             <a:extLst>
               <a:ext uri="smNativeData">
-                <pr:smNativeData xmlns:pr="smNativeData" xmlns="smNativeData" val="SMDATA_15_7aDWaRMAAAAlAAAAZAAAAA8BAAAAkAAAAEgAAACQAAAASAAAAAAAAAAAAAAAAAAAAAEAAABQAAAAAAAAAAAA4D8AAAAAAADgPwAAAAAAAOA/AAAAAAAA4D8AAAAAAADgPwAAAAAAAOA/AAAAAAAA4D8AAAAAAADgPwAAAAAAAOA/AAAAAAAA4D8CAAAAjAAAAAAAAAAAAAAAu+DjDP///wgAAAAAAAAAAAAAAAAAAAAAAAAAAAAAAAAAAAAAZAAAAAEAAABAAAAAAAAAAAAAAAAAAAAAAAAAAAAAAAAAAAAAAAAAAAAAAAAAAAAAAAAAAAAAAAAAAAAAAAAAAAAAAAAAAAAAAAAAAAAAAAAAAAAAAAAAAAAAAAAAAAAAFAAAADwAAAAAAAAAAAAAAAAAAAkUAAAAAQAAABQAAAAUAAAAFAAAAAEAAAAAAAAAZAAAAGQAAAAAAAAAZAAAAGQAAAAVAAAAYAAAAAAAAAAAAAAADwAAACADAAAAAAAAAAAAAAEAAACgMgAAVgcAAKr4//8BAAAAf39/AAEAAABkAAAAAAAAABQAAABAHwAAAAAAACYAAAAAAAAAwOD//wAAAAAmAAAAZAAAABYAAABMAAAAAAAAAAAAAAAEAAAAAAAAAAEAAACAgIAKAAAAACgAAAAoAAAAZAAAAGQAAAAAAAAAzMzMAAAAAABQAAAAUAAAAGQAAABkAAAAAAAAABcAAAAUAAAAAAAAAAAAAAD/fwAA/38AAAAAAAAJAAAABAAAANw7IAEeAAAAaAAAAAAAAAAAAAAAAAAAAAAAAAAAAAAAECcAABAnAAAAAAAAAAAAAAAAAAAAAAAAAAAAAAAAAAAAAAAAAAAAABQAAAAAAAAAwMD/AAAAAABkAAAAMgAAAAAAAABkAAAAAAAAAH9/fwAKAAAAIgAAABgAAAAAAAAAAAAAAAAAAAAAAAAAAAAAAAAAAAAkAAAAJAAAAAAAAAAHAAAAAAAAAAAAAAAAAAAAAAAAAAAAAAAAAAAAf39/ACUAAABYAAAAAAAAAAAAAAAAAAAAAAAAAAAAAAAAAAAAAAAAAAAAAAAAAAAAAAAAAAAAAAA/AAAAAAAAAKCGAQAAAAAAAAAAAAAAAAAMAAAAAQAAAAAAAAAAAAAAAAAAAB8AAABUAAAAAAAABQAAAAEAAAAAAAAAAAAAAAAAAAAAAAAAAAAAAAAAAAAAAAAAAAAAAAJ/f38AAAAAA8zMzADAwP8Af39/AAAAAAAAAAAAAAAAAAAAAAAAAAAAIQAAABgAAAAUAAAAwAMAAGENAADjJAAAsCUAABAAAAAmAAAACAAAAAGAAAAAAAAA"/>
+                <pr:smNativeData xmlns:pr="smNativeData" xmlns="smNativeData" val="SMDATA_15_ZqHWaRMAAAAlAAAAZAAAAA8BAAAAkAAAAEgAAACQAAAASAAAAAAAAAAAAAAAAAAAAAEAAABQAAAAAAAAAAAA4D8AAAAAAADgPwAAAAAAAOA/AAAAAAAA4D8AAAAAAADgPwAAAAAAAOA/AAAAAAAA4D8AAAAAAADgPwAAAAAAAOA/AAAAAAAA4D8CAAAAjAAAAAAAAAAAAAAAu+DjDP///wgAAAAAAAAAAAAAAAAAAAAAAAAAAAAAAAAAAAAAZAAAAAEAAABAAAAAAAAAAAAAAAAAAAAAAAAAAAAAAAAAAAAAAAAAAAAAAAAAAAAAAAAAAAAAAAAAAAAAAAAAAAAAAAAAAAAAAAAAAAAAAAAAAAAAAAAAAAAAAAAAAAAAFAAAADwAAAAAAAAAAAAAAAAAAAkUAAAAAQAAABQAAAAUAAAAFAAAAAEAAAAAAAAAZAAAAGQAAAAAAAAAZAAAAGQAAAAVAAAAYAAAAAAAAAAAAAAADwAAACADAAAAAAAAAAAAAAEAAACgMgAAVgcAAKr4//8BAAAAf39/AAEAAABkAAAAAAAAABQAAABAHwAAAAAAACYAAAAAAAAAwOD//wAAAAAmAAAAZAAAABYAAABMAAAAAAAAAAAAAAAEAAAAAAAAAAEAAACAgIAKAAAAACgAAAAoAAAAZAAAAGQAAAAAAAAAzMzMAAAAAABQAAAAUAAAAGQAAABkAAAAAAAAABcAAAAUAAAAAAAAAAAAAAD/fwAA/38AAAAAAAAJAAAABAAAANw7IAEeAAAAaAAAAAAAAAAAAAAAAAAAAAAAAAAAAAAAECcAABAnAAAAAAAAAAAAAAAAAAAAAAAAAAAAAAAAAAAAAAAAAAAAABQAAAAAAAAAwMD/AAAAAABkAAAAMgAAAAAAAABkAAAAAAAAAH9/fwAKAAAAIgAAABgAAAAAAAAAAAAAAAAAAAAAAAAAAAAAAAAAAAAkAAAAJAAAAAAAAAAHAAAAAAAAAAAAAAAAAAAAAAAAAAAAAAAAAAAAf39/ACUAAABYAAAAAAAAAAAAAAAAAAAAAAAAAAAAAAAAAAAAAAAAAAAAAAAAAAAAAAAAAAAAAAA/AAAAAAAAAKCGAQAAAAAAAAAAAAAAAAAMAAAAAQAAAAAAAAAAAAAAAAAAAB8AAABUAAAAAAAABQAAAAEAAAAAAAAAAAAAAAAAAAAAAAAAAAAAAAAAAAAAAAAAAAAAAAJ/f38AAAAAA8zMzADAwP8Af39/AAAAAAAAAAAAAAAAAAAAAAAAAAAAIQAAABgAAAAUAAAAwAMAAGENAADjJAAAsCUAABAAAAAmAAAACAAAAAGAAAAAAAAA"/>
               </a:ext>
             </a:extLst>
           </p:cNvSpPr>
@@ -1701,7 +1701,7 @@
             <a:spLocks noGrp="1" noChangeArrowheads="1"/>
             <a:extLst>
               <a:ext uri="smNativeData">
-                <pr:smNativeData xmlns:pr="smNativeData" xmlns="smNativeData" val="SMDATA_15_7aDWaRMAAAAlAAAAZAAAAA8BAAAAkAAAAEgAAACQAAAASAAAAAAAAAACAAAAAAAAAAEAAABQAAAAAAAAAAAA4D8AAAAAAADgPwAAAAAAAOA/AAAAAAAA4D8AAAAAAADgPwAAAAAAAOA/AAAAAAAA4D8AAAAAAADgPwAAAAAAAOA/AAAAAAAA4D8CAAAAjAAAAAAAAAAAAAAAu+DjDP///wgAAAAAAAAAAAAAAAAAAAAAAAAAAAAAAAAAAAAAZAAAAAEAAABAAAAAAAAAAAAAAAAAAAAAAAAAAAAAAAAAAAAAAAAAAAAAAAAAAAAAAAAAAAAAAAAAAAAAAAAAAAAAAAAAAAAAAAAAAAAAAAAAAAAAAAAAAAAAAAAAAAAAFAAAADwAAAAAAAAAAAAAAAAAAAkUAAAAAQAAABQAAAAUAAAAFAAAAAEAAAAAAAAAZAAAAGQAAAAAAAAAZAAAAGQAAAAVAAAAYAAAAAAAAAAAAAAADwAAACADAAAAAAAAAAAAAAEAAACgMgAAVgcAAKr4//8BAAAAf39/AAEAAABkAAAAAAAAABQAAABAHwAAAAAAACYAAAAAAAAAwOD//wAAAAAmAAAAZAAAABYAAABMAAAAAAAAAAAAAAAEAAAAAAAAAAEAAACAgIAKAAAAACgAAAAoAAAAZAAAAGQAAAAAAAAAzMzMAAAAAABQAAAAUAAAAGQAAABkAAAAAAAAABcAAAAUAAAAAAAAAAAAAAD/fwAA/38AAAAAAAAJAAAABAAAANw7IAEeAAAAaAAAAAAAAAAAAAAAAAAAAAAAAAAAAAAAECcAABAnAAAAAAAAAAAAAAAAAAAAAAAAAAAAAAAAAAAAAAAAAAAAABQAAAAAAAAAwMD/AAAAAABkAAAAMgAAAAAAAABkAAAAAAAAAH9/fwAKAAAAIgAAABgAAAAAAAAAAAAAAAAAAAAAAAAAAAAAAAAAAAAkAAAAJAAAAAAAAAAHAAAAAAAAAAAAAAAAAAAAAAAAAAAAAAAAAAAAf39/ACUAAABYAAAAAAAAAAAAAAAAAAAAAAAAAAAAAAAAAAAAAAAAAAAAAAAAAAAAAAAAAAAAAAA/AAAAAAAAAKCGAQAAAAAAAAAAAAAAAAAMAAAAAQAAAAAAAAAAAAAAAAAAAB8AAABUAAAAAAAABQAAAAEAAAAAAAAAAAAAAAAAAAAAAAAAAAAAAAAAAAAAAAAAAAAAAAJ/f38AAAAAA8zMzADAwP8Af39/AAAAAAAAAAAAAAAAAAAAAAAAAAAAIQAAABgAAAAUAAAAHSYAAHEJAABARwAAYQ0AABAAAAAmAAAACAAAAIGAAAAAAAAA"/>
+                <pr:smNativeData xmlns:pr="smNativeData" xmlns="smNativeData" val="SMDATA_15_ZqHWaRMAAAAlAAAAZAAAAA8BAAAAkAAAAEgAAACQAAAASAAAAAAAAAACAAAAAAAAAAEAAABQAAAAAAAAAAAA4D8AAAAAAADgPwAAAAAAAOA/AAAAAAAA4D8AAAAAAADgPwAAAAAAAOA/AAAAAAAA4D8AAAAAAADgPwAAAAAAAOA/AAAAAAAA4D8CAAAAjAAAAAAAAAAAAAAAu+DjDP///wgAAAAAAAAAAAAAAAAAAAAAAAAAAAAAAAAAAAAAZAAAAAEAAABAAAAAAAAAAAAAAAAAAAAAAAAAAAAAAAAAAAAAAAAAAAAAAAAAAAAAAAAAAAAAAAAAAAAAAAAAAAAAAAAAAAAAAAAAAAAAAAAAAAAAAAAAAAAAAAAAAAAAFAAAADwAAAAAAAAAAAAAAAAAAAkUAAAAAQAAABQAAAAUAAAAFAAAAAEAAAAAAAAAZAAAAGQAAAAAAAAAZAAAAGQAAAAVAAAAYAAAAAAAAAAAAAAADwAAACADAAAAAAAAAAAAAAEAAACgMgAAVgcAAKr4//8BAAAAf39/AAEAAABkAAAAAAAAABQAAABAHwAAAAAAACYAAAAAAAAAwOD//wAAAAAmAAAAZAAAABYAAABMAAAAAAAAAAAAAAAEAAAAAAAAAAEAAACAgIAKAAAAACgAAAAoAAAAZAAAAGQAAAAAAAAAzMzMAAAAAABQAAAAUAAAAGQAAABkAAAAAAAAABcAAAAUAAAAAAAAAAAAAAD/fwAA/38AAAAAAAAJAAAABAAAANw7IAEeAAAAaAAAAAAAAAAAAAAAAAAAAAAAAAAAAAAAECcAABAnAAAAAAAAAAAAAAAAAAAAAAAAAAAAAAAAAAAAAAAAAAAAABQAAAAAAAAAwMD/AAAAAABkAAAAMgAAAAAAAABkAAAAAAAAAH9/fwAKAAAAIgAAABgAAAAAAAAAAAAAAAAAAAAAAAAAAAAAAAAAAAAkAAAAJAAAAAAAAAAHAAAAAAAAAAAAAAAAAAAAAAAAAAAAAAAAAAAAf39/ACUAAABYAAAAAAAAAAAAAAAAAAAAAAAAAAAAAAAAAAAAAAAAAAAAAAAAAAAAAAAAAAAAAAA/AAAAAAAAAKCGAQAAAAAAAAAAAAAAAAAMAAAAAQAAAAAAAAAAAAAAAAAAAB8AAABUAAAAAAAABQAAAAEAAAAAAAAAAAAAAAAAAAAAAAAAAAAAAAAAAAAAAAAAAAAAAAJ/f38AAAAAA8zMzADAwP8Af39/AAAAAAAAAAAAAAAAAAAAAAAAAAAAIQAAABgAAAAUAAAAHSYAAHEJAABARwAAYQ0AABAAAAAmAAAACAAAAIGAAAAAAAAA"/>
               </a:ext>
             </a:extLst>
           </p:cNvSpPr>
@@ -1774,7 +1774,7 @@
             <a:spLocks noGrp="1" noChangeArrowheads="1"/>
             <a:extLst>
               <a:ext uri="smNativeData">
-                <pr:smNativeData xmlns:pr="smNativeData" xmlns="smNativeData" val="SMDATA_15_7aDWaRMAAAAlAAAAZAAAAA8BAAAAkAAAAEgAAACQAAAASAAAAAAAAAAAAAAAAAAAAAEAAABQAAAAAAAAAAAA4D8AAAAAAADgPwAAAAAAAOA/AAAAAAAA4D8AAAAAAADgPwAAAAAAAOA/AAAAAAAA4D8AAAAAAADgPwAAAAAAAOA/AAAAAAAA4D8CAAAAjAAAAAAAAAAAAAAAu+DjDP///wgAAAAAAAAAAAAAAAAAAAAAAAAAAAAAAAAAAAAAZAAAAAEAAABAAAAAAAAAAAAAAAAAAAAAAAAAAAAAAAAAAAAAAAAAAAAAAAAAAAAAAAAAAAAAAAAAAAAAAAAAAAAAAAAAAAAAAAAAAAAAAAAAAAAAAAAAAAAAAAAAAAAAFAAAADwAAAAAAAAAAAAAAAAAAAkUAAAAAQAAABQAAAAUAAAAFAAAAAEAAAAAAAAAZAAAAGQAAAAAAAAAZAAAAGQAAAAVAAAAYAAAAAAAAAAAAAAADwAAACADAAAAAAAAAAAAAAEAAACgMgAAVgcAAKr4//8BAAAAf39/AAEAAABkAAAAAAAAABQAAABAHwAAAAAAACYAAAAAAAAAwOD//wAAAAAmAAAAZAAAABYAAABMAAAAAAAAAAAAAAAEAAAAAAAAAAEAAACAgIAKAAAAACgAAAAoAAAAZAAAAGQAAAAAAAAAzMzMAAAAAABQAAAAUAAAAGQAAABkAAAAAAAAABcAAAAUAAAAAAAAAAAAAAD/fwAA/38AAAAAAAAJAAAABAAAANw7IAEeAAAAaAAAAAAAAAAAAAAAAAAAAAAAAAAAAAAAECcAABAnAAAAAAAAAAAAAAAAAAAAAAAAAAAAAAAAAAAAAAAAAAAAABQAAAAAAAAAwMD/AAAAAABkAAAAMgAAAAAAAABkAAAAAAAAAH9/fwAKAAAAIgAAABgAAAAAAAAAAAAAAAAAAAAAAAAAAAAAAAAAAAAkAAAAJAAAAAAAAAAHAAAAAAAAAAAAAAAAAAAAAAAAAAAAAAAAAAAAf39/ACUAAABYAAAAAAAAAAAAAAAAAAAAAAAAAAAAAAAAAAAAAAAAAAAAAAAAAAAAAAAAAAAAAAA/AAAAAAAAAKCGAQAAAAAAAAAAAAAAAAAMAAAAAQAAAAAAAAAAAAAAAAAAAB8AAABUAAAAAAAABQAAAAEAAAAAAAAAAAAAAAAAAAAAAAAAAAAAAAAAAAAAAAAAAAAAAAJ/f38AAAAAA8zMzADAwP8Af39/AAAAAAAAAAAAAAAAAAAAAAAAAAAAIQAAABgAAAAUAAAAHSYAAGENAABARwAAsCUAABAAAAAmAAAACAAAAAGAAAAAAAAA"/>
+                <pr:smNativeData xmlns:pr="smNativeData" xmlns="smNativeData" val="SMDATA_15_ZqHWaRMAAAAlAAAAZAAAAA8BAAAAkAAAAEgAAACQAAAASAAAAAAAAAAAAAAAAAAAAAEAAABQAAAAAAAAAAAA4D8AAAAAAADgPwAAAAAAAOA/AAAAAAAA4D8AAAAAAADgPwAAAAAAAOA/AAAAAAAA4D8AAAAAAADgPwAAAAAAAOA/AAAAAAAA4D8CAAAAjAAAAAAAAAAAAAAAu+DjDP///wgAAAAAAAAAAAAAAAAAAAAAAAAAAAAAAAAAAAAAZAAAAAEAAABAAAAAAAAAAAAAAAAAAAAAAAAAAAAAAAAAAAAAAAAAAAAAAAAAAAAAAAAAAAAAAAAAAAAAAAAAAAAAAAAAAAAAAAAAAAAAAAAAAAAAAAAAAAAAAAAAAAAAFAAAADwAAAAAAAAAAAAAAAAAAAkUAAAAAQAAABQAAAAUAAAAFAAAAAEAAAAAAAAAZAAAAGQAAAAAAAAAZAAAAGQAAAAVAAAAYAAAAAAAAAAAAAAADwAAACADAAAAAAAAAAAAAAEAAACgMgAAVgcAAKr4//8BAAAAf39/AAEAAABkAAAAAAAAABQAAABAHwAAAAAAACYAAAAAAAAAwOD//wAAAAAmAAAAZAAAABYAAABMAAAAAAAAAAAAAAAEAAAAAAAAAAEAAACAgIAKAAAAACgAAAAoAAAAZAAAAGQAAAAAAAAAzMzMAAAAAABQAAAAUAAAAGQAAABkAAAAAAAAABcAAAAUAAAAAAAAAAAAAAD/fwAA/38AAAAAAAAJAAAABAAAANw7IAEeAAAAaAAAAAAAAAAAAAAAAAAAAAAAAAAAAAAAECcAABAnAAAAAAAAAAAAAAAAAAAAAAAAAAAAAAAAAAAAAAAAAAAAABQAAAAAAAAAwMD/AAAAAABkAAAAMgAAAAAAAABkAAAAAAAAAH9/fwAKAAAAIgAAABgAAAAAAAAAAAAAAAAAAAAAAAAAAAAAAAAAAAAkAAAAJAAAAAAAAAAHAAAAAAAAAAAAAAAAAAAAAAAAAAAAAAAAAAAAf39/ACUAAABYAAAAAAAAAAAAAAAAAAAAAAAAAAAAAAAAAAAAAAAAAAAAAAAAAAAAAAAAAAAAAAA/AAAAAAAAAKCGAQAAAAAAAAAAAAAAAAAMAAAAAQAAAAAAAAAAAAAAAAAAAB8AAABUAAAAAAAABQAAAAEAAAAAAAAAAAAAAAAAAAAAAAAAAAAAAAAAAAAAAAAAAAAAAAJ/f38AAAAAA8zMzADAwP8Af39/AAAAAAAAAAAAAAAAAAAAAAAAAAAAIQAAABgAAAAUAAAAHSYAAGENAABARwAAsCUAABAAAAAmAAAACAAAAAGAAAAAAAAA"/>
               </a:ext>
             </a:extLst>
           </p:cNvSpPr>
@@ -1858,7 +1858,7 @@
             <a:spLocks noGrp="1" noChangeArrowheads="1"/>
             <a:extLst>
               <a:ext uri="smNativeData">
-                <pr:smNativeData xmlns:pr="smNativeData" xmlns="smNativeData" val="SMDATA_15_7aDWaRMAAAAlAAAAZAAAAA8BAAAAkAAAAEgAAACQAAAASAAAAAAAAAABAAAAAAAAAAEAAABQAAAAAAAAAAAA4D8AAAAAAADgPwAAAAAAAOA/AAAAAAAA4D8AAAAAAADgPwAAAAAAAOA/AAAAAAAA4D8AAAAAAADgPwAAAAAAAOA/AAAAAAAA4D8CAAAAjAAAAAAAAAAAAAAAu+DjDP///wgAAAAAAAAAAAAAAAAAAAAAAAAAAAAAAAAAAAAAZAAAAAEAAABAAAAAAAAAAAAAAAAAAAAAAAAAAAAAAAAAAAAAAAAAAAAAAAAAAAAAAAAAAAAAAAAAAAAAAAAAAAAAAAAAAAAAAAAAAAAAAAAAAAAAAAAAAAAAAAAAAAAAFAAAADwAAAAAAAAAAAAAAAAAAAkUAAAAAQAAABQAAAAUAAAAFAAAAAEAAAAAAAAAZAAAAGQAAAAAAAAAZAAAAGQAAAAVAAAAYAAAAAAAAAAAAAAADwAAACADAAAAAAAAAAAAAAEAAACgMgAAVgcAAKr4//8BAAAAf39/AAEAAABkAAAAAAAAABQAAABAHwAAAAAAACYAAAAAAAAAwOD//wAAAAAmAAAAZAAAABYAAABMAAAAAAAAAAAAAAAEAAAAAAAAAAEAAACAgIAKAAAAACgAAAAoAAAAZAAAAGQAAAAAAAAAzMzMAAAAAABQAAAAUAAAAGQAAABkAAAAAAAAABcAAAAUAAAAAAAAAAAAAAD/fwAA/38AAAAAAAAJAAAABAAAANw7IAEeAAAAaAAAAAAAAAAAAAAAAAAAAAAAAAAAAAAAECcAABAnAAAAAAAAAAAAAAAAAAAAAAAAAAAAAAAAAAAAAAAAAAAAABQAAAAAAAAAwMD/AAAAAABkAAAAMgAAAAAAAABkAAAAAAAAAH9/fwAKAAAAIgAAABgAAAAAAAAAAAAAAAAAAAAAAAAAAAAAAAAAAAAkAAAAJAAAAAAAAAAHAAAAAAAAAAAAAAAAAAAAAAAAAAAAAAAAAAAAf39/ACUAAABYAAAAAAAAAAAAAAAAAAAAAAAAAAAAAAAAAAAAAAAAAAAAAAAAAAAAAAAAAAAAAAA/AAAAAAAAAKCGAQAAAAAAAAAAAAAAAAAMAAAAAQAAAAAAAAAAAAAAAAAAAB8AAABUAAAAAAAABQAAAAEAAAAAAAAAAAAAAAAAAAAAAAAAAAAAAAAAAAAAAAAAAAAAAAJ/f38AAAAAA8zMzADAwP8Af39/AAAAAAAAAAAAAAAAAAAAAAAAAAAAIQAAABgAAAAUAAAAwAMAABsnAAA/FQAAWSkAABAAAAAmAAAACAAAAAAAAAAAAAAA"/>
+                <pr:smNativeData xmlns:pr="smNativeData" xmlns="smNativeData" val="SMDATA_15_ZqHWaRMAAAAlAAAAZAAAAA8BAAAAkAAAAEgAAACQAAAASAAAAAAAAAABAAAAAAAAAAEAAABQAAAAAAAAAAAA4D8AAAAAAADgPwAAAAAAAOA/AAAAAAAA4D8AAAAAAADgPwAAAAAAAOA/AAAAAAAA4D8AAAAAAADgPwAAAAAAAOA/AAAAAAAA4D8CAAAAjAAAAAAAAAAAAAAAu+DjDP///wgAAAAAAAAAAAAAAAAAAAAAAAAAAAAAAAAAAAAAZAAAAAEAAABAAAAAAAAAAAAAAAAAAAAAAAAAAAAAAAAAAAAAAAAAAAAAAAAAAAAAAAAAAAAAAAAAAAAAAAAAAAAAAAAAAAAAAAAAAAAAAAAAAAAAAAAAAAAAAAAAAAAAFAAAADwAAAAAAAAAAAAAAAAAAAkUAAAAAQAAABQAAAAUAAAAFAAAAAEAAAAAAAAAZAAAAGQAAAAAAAAAZAAAAGQAAAAVAAAAYAAAAAAAAAAAAAAADwAAACADAAAAAAAAAAAAAAEAAACgMgAAVgcAAKr4//8BAAAAf39/AAEAAABkAAAAAAAAABQAAABAHwAAAAAAACYAAAAAAAAAwOD//wAAAAAmAAAAZAAAABYAAABMAAAAAAAAAAAAAAAEAAAAAAAAAAEAAACAgIAKAAAAACgAAAAoAAAAZAAAAGQAAAAAAAAAzMzMAAAAAABQAAAAUAAAAGQAAABkAAAAAAAAABcAAAAUAAAAAAAAAAAAAAD/fwAA/38AAAAAAAAJAAAABAAAANw7IAEeAAAAaAAAAAAAAAAAAAAAAAAAAAAAAAAAAAAAECcAABAnAAAAAAAAAAAAAAAAAAAAAAAAAAAAAAAAAAAAAAAAAAAAABQAAAAAAAAAwMD/AAAAAABkAAAAMgAAAAAAAABkAAAAAAAAAH9/fwAKAAAAIgAAABgAAAAAAAAAAAAAAAAAAAAAAAAAAAAAAAAAAAAkAAAAJAAAAAAAAAAHAAAAAAAAAAAAAAAAAAAAAAAAAAAAAAAAAAAAf39/ACUAAABYAAAAAAAAAAAAAAAAAAAAAAAAAAAAAAAAAAAAAAAAAAAAAAAAAAAAAAAAAAAAAAA/AAAAAAAAAKCGAQAAAAAAAAAAAAAAAAAMAAAAAQAAAAAAAAAAAAAAAAAAAB8AAABUAAAAAAAABQAAAAEAAAAAAAAAAAAAAAAAAAAAAAAAAAAAAAAAAAAAAAAAAAAAAAJ/f38AAAAAA8zMzADAwP8Af39/AAAAAAAAAAAAAAAAAAAAAAAAAAAAIQAAABgAAAAUAAAAwAMAABsnAAA/FQAAWSkAABAAAAAmAAAACAAAAAAAAAAAAAAA"/>
               </a:ext>
             </a:extLst>
           </p:cNvSpPr>
@@ -1872,7 +1872,7 @@
           <a:lstStyle/>
           <a:p>
             <a:pPr/>
-            <a:fld id="{2D80004B-05C0-D5F6-8E38-F3A34E7678A6}" type="datetime1">
+            <a:fld id="{6E3EAD50-1E83-6B5B-CD86-E80EE3C83BBD}" type="datetime1">
               <a:t/>
             </a:fld>
           </a:p>
@@ -1885,7 +1885,7 @@
             <a:spLocks noGrp="1" noChangeArrowheads="1"/>
             <a:extLst>
               <a:ext uri="smNativeData">
-                <pr:smNativeData xmlns:pr="smNativeData" xmlns="smNativeData" val="SMDATA_15_7aDWaRMAAAAlAAAAZAAAAA8BAAAAkAAAAEgAAACQAAAASAAAAAAAAAABAAAAAAAAAAEAAABQAAAAAAAAAAAA4D8AAAAAAADgPwAAAAAAAOA/AAAAAAAA4D8AAAAAAADgPwAAAAAAAOA/AAAAAAAA4D8AAAAAAADgPwAAAAAAAOA/AAAAAAAA4D8CAAAAjAAAAAAAAAAAAAAAu+DjDP///wgAAAAAAAAAAAAAAAAAAAAAAAAAAAAAAAAAAAAAZAAAAAEAAABAAAAAAAAAAAAAAAAAAAAAAAAAAAAAAAAAAAAAAAAAAAAAAAAAAAAAAAAAAAAAAAAAAAAAAAAAAAAAAAAAAAAAAAAAAAAAAAAAAAAAAAAAAAAAAAAAAAAAFAAAADwAAAAAAAAAAAAAAAAAAAkUAAAAAQAAABQAAAAUAAAAFAAAAAEAAAAAAAAAZAAAAGQAAAAAAAAAZAAAAGQAAAAVAAAAYAAAAAAAAAAAAAAADwAAACADAAAAAAAAAAAAAAEAAACgMgAAVgcAAKr4//8BAAAAf39/AAEAAABkAAAAAAAAABQAAABAHwAAAAAAACYAAAAAAAAAwOD//wAAAAAmAAAAZAAAABYAAABMAAAAAAAAAAAAAAAEAAAAAAAAAAEAAACAgIAKAAAAACgAAAAoAAAAZAAAAGQAAAAAAAAAzMzMAAAAAABQAAAAUAAAAGQAAABkAAAAAAAAABcAAAAUAAAAAAAAAAAAAAD/fwAA/38AAAAAAAAJAAAABAAAANw7IAEeAAAAaAAAAAAAAAAAAAAAAAAAAAAAAAAAAAAAECcAABAnAAAAAAAAAAAAAAAAAAAAAAAAAAAAAAAAAAAAAAAAAAAAABQAAAAAAAAAwMD/AAAAAABkAAAAMgAAAAAAAABkAAAAAAAAAH9/fwAKAAAAIgAAABgAAAAAAAAAAAAAAAAAAAAAAAAAAAAAAAAAAAAkAAAAJAAAAAAAAAAHAAAAAAAAAAAAAAAAAAAAAAAAAAAAAAAAAAAAf39/ACUAAABYAAAAAAAAAAAAAAAAAAAAAAAAAAAAAAAAAAAAAAAAAAAAAAAAAAAAAAAAAAAAAAA/AAAAAAAAAKCGAQAAAAAAAAAAAAAAAAAMAAAAAQAAAAAAAAAAAAAAAAAAAB8AAABUAAAAAAAABQAAAAEAAAAAAAAAAAAAAAAAAAAAAAAAAAAAAAAAAAAAAAAAAAAAAAJ/f38AAAAAA8zMzADAwP8Af39/AAAAAAAAAAAAAAAAAAAAAAAAAAAAIQAAABgAAAAUAAAAoRkAABsnAABfMQAAWSkAABAAAAAmAAAACAAAAAAAAAAAAAAA"/>
+                <pr:smNativeData xmlns:pr="smNativeData" xmlns="smNativeData" val="SMDATA_15_ZqHWaRMAAAAlAAAAZAAAAA8BAAAAkAAAAEgAAACQAAAASAAAAAAAAAABAAAAAAAAAAEAAABQAAAAAAAAAAAA4D8AAAAAAADgPwAAAAAAAOA/AAAAAAAA4D8AAAAAAADgPwAAAAAAAOA/AAAAAAAA4D8AAAAAAADgPwAAAAAAAOA/AAAAAAAA4D8CAAAAjAAAAAAAAAAAAAAAu+DjDP///wgAAAAAAAAAAAAAAAAAAAAAAAAAAAAAAAAAAAAAZAAAAAEAAABAAAAAAAAAAAAAAAAAAAAAAAAAAAAAAAAAAAAAAAAAAAAAAAAAAAAAAAAAAAAAAAAAAAAAAAAAAAAAAAAAAAAAAAAAAAAAAAAAAAAAAAAAAAAAAAAAAAAAFAAAADwAAAAAAAAAAAAAAAAAAAkUAAAAAQAAABQAAAAUAAAAFAAAAAEAAAAAAAAAZAAAAGQAAAAAAAAAZAAAAGQAAAAVAAAAYAAAAAAAAAAAAAAADwAAACADAAAAAAAAAAAAAAEAAACgMgAAVgcAAKr4//8BAAAAf39/AAEAAABkAAAAAAAAABQAAABAHwAAAAAAACYAAAAAAAAAwOD//wAAAAAmAAAAZAAAABYAAABMAAAAAAAAAAAAAAAEAAAAAAAAAAEAAACAgIAKAAAAACgAAAAoAAAAZAAAAGQAAAAAAAAAzMzMAAAAAABQAAAAUAAAAGQAAABkAAAAAAAAABcAAAAUAAAAAAAAAAAAAAD/fwAA/38AAAAAAAAJAAAABAAAANw7IAEeAAAAaAAAAAAAAAAAAAAAAAAAAAAAAAAAAAAAECcAABAnAAAAAAAAAAAAAAAAAAAAAAAAAAAAAAAAAAAAAAAAAAAAABQAAAAAAAAAwMD/AAAAAABkAAAAMgAAAAAAAABkAAAAAAAAAH9/fwAKAAAAIgAAABgAAAAAAAAAAAAAAAAAAAAAAAAAAAAAAAAAAAAkAAAAJAAAAAAAAAAHAAAAAAAAAAAAAAAAAAAAAAAAAAAAAAAAAAAAf39/ACUAAABYAAAAAAAAAAAAAAAAAAAAAAAAAAAAAAAAAAAAAAAAAAAAAAAAAAAAAAAAAAAAAAA/AAAAAAAAAKCGAQAAAAAAAAAAAAAAAAAMAAAAAQAAAAAAAAAAAAAAAAAAAB8AAABUAAAAAAAABQAAAAEAAAAAAAAAAAAAAAAAAAAAAAAAAAAAAAAAAAAAAAAAAAAAAAJ/f38AAAAAA8zMzADAwP8Af39/AAAAAAAAAAAAAAAAAAAAAAAAAAAAIQAAABgAAAAUAAAAoRkAABsnAABfMQAAWSkAABAAAAAmAAAACAAAAAAAAAAAAAAA"/>
               </a:ext>
             </a:extLst>
           </p:cNvSpPr>
@@ -1909,7 +1909,7 @@
             <a:spLocks noGrp="1" noChangeArrowheads="1"/>
             <a:extLst>
               <a:ext uri="smNativeData">
-                <pr:smNativeData xmlns:pr="smNativeData" xmlns="smNativeData" val="SMDATA_15_7aDWaRMAAAAlAAAAZAAAAA8BAAAAkAAAAEgAAACQAAAASAAAAAAAAAABAAAAAAAAAAEAAABQAAAAAAAAAAAA4D8AAAAAAADgPwAAAAAAAOA/AAAAAAAA4D8AAAAAAADgPwAAAAAAAOA/AAAAAAAA4D8AAAAAAADgPwAAAAAAAOA/AAAAAAAA4D8CAAAAjAAAAAAAAAAAAAAAu+DjDP///wgAAAAAAAAAAAAAAAAAAAAAAAAAAAAAAAAAAAAAZAAAAAEAAABAAAAAAAAAAAAAAAAAAAAAAAAAAAAAAAAAAAAAAAAAAAAAAAAAAAAAAAAAAAAAAAAAAAAAAAAAAAAAAAAAAAAAAAAAAAAAAAAAAAAAAAAAAAAAAAAAAAAAFAAAADwAAAAAAAAAAAAAAAAAAAkUAAAAAQAAABQAAAAUAAAAFAAAAAEAAAAAAAAAZAAAAGQAAAAAAAAAZAAAAGQAAAAVAAAAYAAAAAAAAAAAAAAADwAAACADAAAAAAAAAAAAAAEAAACgMgAAVgcAAKr4//8BAAAAf39/AAEAAABkAAAAAAAAABQAAABAHwAAAAAAACYAAAAAAAAAwOD//wAAAAAmAAAAZAAAABYAAABMAAAAAAAAAAAAAAAEAAAAAAAAAAEAAACAgIAKAAAAACgAAAAoAAAAZAAAAGQAAAAAAAAAzMzMAAAAAABQAAAAUAAAAGQAAABkAAAAAAAAABcAAAAUAAAAAAAAAAAAAAD/fwAA/38AAAAAAAAJAAAABAAAANw7IAEeAAAAaAAAAAAAAAAAAAAAAAAAAAAAAAAAAAAAECcAABAnAAAAAAAAAAAAAAAAAAAAAAAAAAAAAAAAAAAAAAAAAAAAABQAAAAAAAAAwMD/AAAAAABkAAAAMgAAAAAAAABkAAAAAAAAAH9/fwAKAAAAIgAAABgAAAAAAAAAAAAAAAAAAAAAAAAAAAAAAAAAAAAkAAAAJAAAAAAAAAAHAAAAAAAAAAAAAAAAAAAAAAAAAAAAAAAAAAAAf39/ACUAAABYAAAAAAAAAAAAAAAAAAAAAAAAAAAAAAAAAAAAAAAAAAAAAAAAAAAAAAAAAAAAAAA/AAAAAAAAAKCGAQAAAAAAAAAAAAAAAAAMAAAAAQAAAAAAAAAAAAAAAAAAAB8AAABUAAAAAAAABQAAAAEAAAAAAAAAAAAAAAAAAAAAAAAAAAAAAAAAAAAAAAAAAAAAAAJ/f38AAAAAA8zMzADAwP8Af39/AAAAAAAAAAAAAAAAAAAAAAAAAAAAIQAAABgAAAAUAAAAwTUAABsnAABARwAAWSkAABAAAAAmAAAACAAAAAAAAAAAAAAA"/>
+                <pr:smNativeData xmlns:pr="smNativeData" xmlns="smNativeData" val="SMDATA_15_ZqHWaRMAAAAlAAAAZAAAAA8BAAAAkAAAAEgAAACQAAAASAAAAAAAAAABAAAAAAAAAAEAAABQAAAAAAAAAAAA4D8AAAAAAADgPwAAAAAAAOA/AAAAAAAA4D8AAAAAAADgPwAAAAAAAOA/AAAAAAAA4D8AAAAAAADgPwAAAAAAAOA/AAAAAAAA4D8CAAAAjAAAAAAAAAAAAAAAu+DjDP///wgAAAAAAAAAAAAAAAAAAAAAAAAAAAAAAAAAAAAAZAAAAAEAAABAAAAAAAAAAAAAAAAAAAAAAAAAAAAAAAAAAAAAAAAAAAAAAAAAAAAAAAAAAAAAAAAAAAAAAAAAAAAAAAAAAAAAAAAAAAAAAAAAAAAAAAAAAAAAAAAAAAAAFAAAADwAAAAAAAAAAAAAAAAAAAkUAAAAAQAAABQAAAAUAAAAFAAAAAEAAAAAAAAAZAAAAGQAAAAAAAAAZAAAAGQAAAAVAAAAYAAAAAAAAAAAAAAADwAAACADAAAAAAAAAAAAAAEAAACgMgAAVgcAAKr4//8BAAAAf39/AAEAAABkAAAAAAAAABQAAABAHwAAAAAAACYAAAAAAAAAwOD//wAAAAAmAAAAZAAAABYAAABMAAAAAAAAAAAAAAAEAAAAAAAAAAEAAACAgIAKAAAAACgAAAAoAAAAZAAAAGQAAAAAAAAAzMzMAAAAAABQAAAAUAAAAGQAAABkAAAAAAAAABcAAAAUAAAAAAAAAAAAAAD/fwAA/38AAAAAAAAJAAAABAAAANw7IAEeAAAAaAAAAAAAAAAAAAAAAAAAAAAAAAAAAAAAECcAABAnAAAAAAAAAAAAAAAAAAAAAAAAAAAAAAAAAAAAAAAAAAAAABQAAAAAAAAAwMD/AAAAAABkAAAAMgAAAAAAAABkAAAAAAAAAH9/fwAKAAAAIgAAABgAAAAAAAAAAAAAAAAAAAAAAAAAAAAAAAAAAAAkAAAAJAAAAAAAAAAHAAAAAAAAAAAAAAAAAAAAAAAAAAAAAAAAAAAAf39/ACUAAABYAAAAAAAAAAAAAAAAAAAAAAAAAAAAAAAAAAAAAAAAAAAAAAAAAAAAAAAAAAAAAAA/AAAAAAAAAKCGAQAAAAAAAAAAAAAAAAAMAAAAAQAAAAAAAAAAAAAAAAAAAB8AAABUAAAAAAAABQAAAAEAAAAAAAAAAAAAAAAAAAAAAAAAAAAAAAAAAAAAAAAAAAAAAAJ/f38AAAAAA8zMzADAwP8Af39/AAAAAAAAAAAAAAAAAAAAAAAAAAAAIQAAABgAAAAUAAAAwTUAABsnAABARwAAWSkAABAAAAAmAAAACAAAAAAAAAAAAAAA"/>
               </a:ext>
             </a:extLst>
           </p:cNvSpPr>
@@ -1923,7 +1923,7 @@
           <a:lstStyle/>
           <a:p>
             <a:pPr/>
-            <a:fld id="{7D363FCC-8290-63C9-DE8E-749C71C02821}" type="slidenum">
+            <a:fld id="{22AFEE02-4CCF-FA18-8117-BA4DA05977EF}" type="slidenum">
               <a:t/>
             </a:fld>
           </a:p>
@@ -1962,7 +1962,7 @@
             <a:spLocks noGrp="1" noChangeArrowheads="1"/>
             <a:extLst>
               <a:ext uri="smNativeData">
-                <pr:smNativeData xmlns:pr="smNativeData" xmlns="smNativeData" val="SMDATA_15_7aDWaRMAAAAlAAAAZAAAAA8BAAAAkAAAAEgAAACQAAAASAAAAAAAAAABAAAAAAAAAAEAAABQAAAAAAAAAAAA4D8AAAAAAADgPwAAAAAAAOA/AAAAAAAA4D8AAAAAAADgPwAAAAAAAOA/AAAAAAAA4D8AAAAAAADgPwAAAAAAAOA/AAAAAAAA4D8CAAAAjAAAAAAAAAAAAAAAu+DjDP///wgAAAAAAAAAAAAAAAAAAAAAAAAAAAAAAAAAAAAAZAAAAAEAAABAAAAAAAAAAAAAAAAAAAAAAAAAAAAAAAAAAAAAAAAAAAAAAAAAAAAAAAAAAAAAAAAAAAAAAAAAAAAAAAAAAAAAAAAAAAAAAAAAAAAAAAAAAAAAAAAAAAAAFAAAADwAAAAAAAAAAAAAAAAAAAkUAAAAAQAAABQAAAAUAAAAFAAAAAEAAAAAAAAAZAAAAGQAAAAAAAAAZAAAAGQAAAAVAAAAYAAAAAAAAAAAAAAADwAAACADAAAAAAAAAAAAAAEAAACgMgAAVgcAAKr4//8BAAAAf39/AAEAAABkAAAAAAAAABQAAABAHwAAAAAAACYAAAAAAAAAwOD//wAAAAAmAAAAZAAAABYAAABMAAAAAAAAAAAAAAAEAAAAAAAAAAEAAACAgIAKAAAAACgAAAAoAAAAZAAAAGQAAAAAAAAAzMzMAAAAAABQAAAAUAAAAGQAAABkAAAAAAAAABcAAAAUAAAAAAAAAAAAAAD/fwAA/38AAAAAAAAJAAAABAAAANw7IAEeAAAAaAAAAAAAAAAAAAAAAAAAAAAAAAAAAAAAECcAABAnAAAAAAAAAAAAAAAAAAAAAAAAAAAAAAAAAAAAAAAAAAAAABQAAAAAAAAAwMD/AAAAAABkAAAAMgAAAAAAAABkAAAAAAAAAH9/fwAKAAAAIgAAABgAAAAAAAAAAAAAAAAAAAAAAAAAAAAAAAAAAAAkAAAAJAAAAAAAAAAHAAAAAAAAAAAAAAAAAAAAAAAAAAAAAAAAAAAAf39/ACUAAABYAAAAAAAAAAAAAAAAAAAAAAAAAAAAAAAAAAAAAAAAAAAAAAAAAAAAAAAAAAAAAAA/AAAAAAAAAKCGAQAAAAAAAAAAAAAAAAAMAAAAAQAAAAAAAAAAAAAAAAAAAB8AAABUAAAAAAAABQAAAAEAAAAAAAAAAAAAAAAAAAAAAAAAAAAAAAAAAAAAAAAAAAAAAAJ/f38AAAAAA8zMzADAwP8Af39/AAAAAAAAAAAAAAAAAAAAAAAAAAAAIQAAABgAAAAUAAAAwAMAALABAABARwAAuAgAABAAAAAmAAAACAAAAAAAAAAAAAAA"/>
+                <pr:smNativeData xmlns:pr="smNativeData" xmlns="smNativeData" val="SMDATA_15_ZqHWaRMAAAAlAAAAZAAAAA8BAAAAkAAAAEgAAACQAAAASAAAAAAAAAABAAAAAAAAAAEAAABQAAAAAAAAAAAA4D8AAAAAAADgPwAAAAAAAOA/AAAAAAAA4D8AAAAAAADgPwAAAAAAAOA/AAAAAAAA4D8AAAAAAADgPwAAAAAAAOA/AAAAAAAA4D8CAAAAjAAAAAAAAAAAAAAAu+DjDP///wgAAAAAAAAAAAAAAAAAAAAAAAAAAAAAAAAAAAAAZAAAAAEAAABAAAAAAAAAAAAAAAAAAAAAAAAAAAAAAAAAAAAAAAAAAAAAAAAAAAAAAAAAAAAAAAAAAAAAAAAAAAAAAAAAAAAAAAAAAAAAAAAAAAAAAAAAAAAAAAAAAAAAFAAAADwAAAAAAAAAAAAAAAAAAAkUAAAAAQAAABQAAAAUAAAAFAAAAAEAAAAAAAAAZAAAAGQAAAAAAAAAZAAAAGQAAAAVAAAAYAAAAAAAAAAAAAAADwAAACADAAAAAAAAAAAAAAEAAACgMgAAVgcAAKr4//8BAAAAf39/AAEAAABkAAAAAAAAABQAAABAHwAAAAAAACYAAAAAAAAAwOD//wAAAAAmAAAAZAAAABYAAABMAAAAAAAAAAAAAAAEAAAAAAAAAAEAAACAgIAKAAAAACgAAAAoAAAAZAAAAGQAAAAAAAAAzMzMAAAAAABQAAAAUAAAAGQAAABkAAAAAAAAABcAAAAUAAAAAAAAAAAAAAD/fwAA/38AAAAAAAAJAAAABAAAANw7IAEeAAAAaAAAAAAAAAAAAAAAAAAAAAAAAAAAAAAAECcAABAnAAAAAAAAAAAAAAAAAAAAAAAAAAAAAAAAAAAAAAAAAAAAABQAAAAAAAAAwMD/AAAAAABkAAAAMgAAAAAAAABkAAAAAAAAAH9/fwAKAAAAIgAAABgAAAAAAAAAAAAAAAAAAAAAAAAAAAAAAAAAAAAkAAAAJAAAAAAAAAAHAAAAAAAAAAAAAAAAAAAAAAAAAAAAAAAAAAAAf39/ACUAAABYAAAAAAAAAAAAAAAAAAAAAAAAAAAAAAAAAAAAAAAAAAAAAAAAAAAAAAAAAAAAAAA/AAAAAAAAAKCGAQAAAAAAAAAAAAAAAAAMAAAAAQAAAAAAAAAAAAAAAAAAAB8AAABUAAAAAAAABQAAAAEAAAAAAAAAAAAAAAAAAAAAAAAAAAAAAAAAAAAAAAAAAAAAAAJ/f38AAAAAA8zMzADAwP8Af39/AAAAAAAAAAAAAAAAAAAAAAAAAAAAIQAAABgAAAAUAAAAwAMAALABAABARwAAuAgAABAAAAAmAAAACAAAAAAAAAAAAAAA"/>
               </a:ext>
             </a:extLst>
           </p:cNvSpPr>
@@ -1989,7 +1989,7 @@
             <a:spLocks noGrp="1" noChangeArrowheads="1"/>
             <a:extLst>
               <a:ext uri="smNativeData">
-                <pr:smNativeData xmlns:pr="smNativeData" xmlns="smNativeData" val="SMDATA_15_7aDWaRMAAAAlAAAAZAAAAA8BAAAAkAAAAEgAAACQAAAASAAAAAAAAAABAAAAAAAAAAEAAABQAAAAAAAAAAAA4D8AAAAAAADgPwAAAAAAAOA/AAAAAAAA4D8AAAAAAADgPwAAAAAAAOA/AAAAAAAA4D8AAAAAAADgPwAAAAAAAOA/AAAAAAAA4D8CAAAAjAAAAAAAAAAAAAAAu+DjDP///wgAAAAAAAAAAAAAAAAAAAAAAAAAAAAAAAAAAAAAZAAAAAEAAABAAAAAAAAAAAAAAAAAAAAAAAAAAAAAAAAAAAAAAAAAAAAAAAAAAAAAAAAAAAAAAAAAAAAAAAAAAAAAAAAAAAAAAAAAAAAAAAAAAAAAAAAAAAAAAAAAAAAAFAAAADwAAAAAAAAAAAAAAAAAAAkUAAAAAQAAABQAAAAUAAAAFAAAAAEAAAAAAAAAZAAAAGQAAAAAAAAAZAAAAGQAAAAVAAAAYAAAAAAAAAAAAAAADwAAACADAAAAAAAAAAAAAAEAAACgMgAAVgcAAKr4//8BAAAAf39/AAEAAABkAAAAAAAAABQAAABAHwAAAAAAACYAAAAAAAAAwOD//wAAAAAmAAAAZAAAABYAAABMAAAAAAAAAAAAAAAEAAAAAAAAAAEAAACAgIAKAAAAACgAAAAoAAAAZAAAAGQAAAAAAAAAzMzMAAAAAABQAAAAUAAAAGQAAABkAAAAAAAAABcAAAAUAAAAAAAAAAAAAAD/fwAA/38AAAAAAAAJAAAABAAAANw7IAEeAAAAaAAAAAAAAAAAAAAAAAAAAAAAAAAAAAAAECcAABAnAAAAAAAAAAAAAAAAAAAAAAAAAAAAAAAAAAAAAAAAAAAAABQAAAAAAAAAwMD/AAAAAABkAAAAMgAAAAAAAABkAAAAAAAAAH9/fwAKAAAAIgAAABgAAAAAAAAAAAAAAAAAAAAAAAAAAAAAAAAAAAAkAAAAJAAAAAAAAAAHAAAAAAAAAAAAAAAAAAAAAAAAAAAAAAAAAAAAf39/ACUAAABYAAAAAAAAAAAAAAAAAAAAAAAAAAAAAAAAAAAAAAAAAAAAAAAAAAAAAAAAAAAAAAA/AAAAAAAAAKCGAQAAAAAAAAAAAAAAAAAMAAAAAQAAAAAAAAAAAAAAAAAAAB8AAABUAAAAAAAABQAAAAEAAAAAAAAAAAAAAAAAAAAAAAAAAAAAAAAAAAAAAAAAAAAAAAJ/f38AAAAAA8zMzADAwP8Af39/AAAAAAAAAAAAAAAAAAAAAAAAAAAAIQAAABgAAAAUAAAAwAMAABsnAAA/FQAAWSkAABAAAAAmAAAACAAAAAAAAAAAAAAA"/>
+                <pr:smNativeData xmlns:pr="smNativeData" xmlns="smNativeData" val="SMDATA_15_ZqHWaRMAAAAlAAAAZAAAAA8BAAAAkAAAAEgAAACQAAAASAAAAAAAAAABAAAAAAAAAAEAAABQAAAAAAAAAAAA4D8AAAAAAADgPwAAAAAAAOA/AAAAAAAA4D8AAAAAAADgPwAAAAAAAOA/AAAAAAAA4D8AAAAAAADgPwAAAAAAAOA/AAAAAAAA4D8CAAAAjAAAAAAAAAAAAAAAu+DjDP///wgAAAAAAAAAAAAAAAAAAAAAAAAAAAAAAAAAAAAAZAAAAAEAAABAAAAAAAAAAAAAAAAAAAAAAAAAAAAAAAAAAAAAAAAAAAAAAAAAAAAAAAAAAAAAAAAAAAAAAAAAAAAAAAAAAAAAAAAAAAAAAAAAAAAAAAAAAAAAAAAAAAAAFAAAADwAAAAAAAAAAAAAAAAAAAkUAAAAAQAAABQAAAAUAAAAFAAAAAEAAAAAAAAAZAAAAGQAAAAAAAAAZAAAAGQAAAAVAAAAYAAAAAAAAAAAAAAADwAAACADAAAAAAAAAAAAAAEAAACgMgAAVgcAAKr4//8BAAAAf39/AAEAAABkAAAAAAAAABQAAABAHwAAAAAAACYAAAAAAAAAwOD//wAAAAAmAAAAZAAAABYAAABMAAAAAAAAAAAAAAAEAAAAAAAAAAEAAACAgIAKAAAAACgAAAAoAAAAZAAAAGQAAAAAAAAAzMzMAAAAAABQAAAAUAAAAGQAAABkAAAAAAAAABcAAAAUAAAAAAAAAAAAAAD/fwAA/38AAAAAAAAJAAAABAAAANw7IAEeAAAAaAAAAAAAAAAAAAAAAAAAAAAAAAAAAAAAECcAABAnAAAAAAAAAAAAAAAAAAAAAAAAAAAAAAAAAAAAAAAAAAAAABQAAAAAAAAAwMD/AAAAAABkAAAAMgAAAAAAAABkAAAAAAAAAH9/fwAKAAAAIgAAABgAAAAAAAAAAAAAAAAAAAAAAAAAAAAAAAAAAAAkAAAAJAAAAAAAAAAHAAAAAAAAAAAAAAAAAAAAAAAAAAAAAAAAAAAAf39/ACUAAABYAAAAAAAAAAAAAAAAAAAAAAAAAAAAAAAAAAAAAAAAAAAAAAAAAAAAAAAAAAAAAAA/AAAAAAAAAKCGAQAAAAAAAAAAAAAAAAAMAAAAAQAAAAAAAAAAAAAAAAAAAB8AAABUAAAAAAAABQAAAAEAAAAAAAAAAAAAAAAAAAAAAAAAAAAAAAAAAAAAAAAAAAAAAAJ/f38AAAAAA8zMzADAwP8Af39/AAAAAAAAAAAAAAAAAAAAAAAAAAAAIQAAABgAAAAUAAAAwAMAABsnAAA/FQAAWSkAABAAAAAmAAAACAAAAAAAAAAAAAAA"/>
               </a:ext>
             </a:extLst>
           </p:cNvSpPr>
@@ -2003,7 +2003,7 @@
           <a:lstStyle/>
           <a:p>
             <a:pPr/>
-            <a:fld id="{0DA4810B-45E0-F177-AE1C-B322CF5258E6}" type="datetime1">
+            <a:fld id="{51D4160F-41BC-81E0-F26C-B7B5582204E2}" type="datetime1">
               <a:t/>
             </a:fld>
           </a:p>
@@ -2016,7 +2016,7 @@
             <a:spLocks noGrp="1" noChangeArrowheads="1"/>
             <a:extLst>
               <a:ext uri="smNativeData">
-                <pr:smNativeData xmlns:pr="smNativeData" xmlns="smNativeData" val="SMDATA_15_7aDWaRMAAAAlAAAAZAAAAA8BAAAAkAAAAEgAAACQAAAASAAAAAAAAAABAAAAAAAAAAEAAABQAAAAAAAAAAAA4D8AAAAAAADgPwAAAAAAAOA/AAAAAAAA4D8AAAAAAADgPwAAAAAAAOA/AAAAAAAA4D8AAAAAAADgPwAAAAAAAOA/AAAAAAAA4D8CAAAAjAAAAAAAAAAAAAAAu+DjDP///wgAAAAAAAAAAAAAAAAAAAAAAAAAAAAAAAAAAAAAZAAAAAEAAABAAAAAAAAAAAAAAAAAAAAAAAAAAAAAAAAAAAAAAAAAAAAAAAAAAAAAAAAAAAAAAAAAAAAAAAAAAAAAAAAAAAAAAAAAAAAAAAAAAAAAAAAAAAAAAAAAAAAAFAAAADwAAAAAAAAAAAAAAAAAAAkUAAAAAQAAABQAAAAUAAAAFAAAAAEAAAAAAAAAZAAAAGQAAAAAAAAAZAAAAGQAAAAVAAAAYAAAAAAAAAAAAAAADwAAACADAAAAAAAAAAAAAAEAAACgMgAAVgcAAKr4//8BAAAAf39/AAEAAABkAAAAAAAAABQAAABAHwAAAAAAACYAAAAAAAAAwOD//wAAAAAmAAAAZAAAABYAAABMAAAAAAAAAAAAAAAEAAAAAAAAAAEAAACAgIAKAAAAACgAAAAoAAAAZAAAAGQAAAAAAAAAzMzMAAAAAABQAAAAUAAAAGQAAABkAAAAAAAAABcAAAAUAAAAAAAAAAAAAAD/fwAA/38AAAAAAAAJAAAABAAAANw7IAEeAAAAaAAAAAAAAAAAAAAAAAAAAAAAAAAAAAAAECcAABAnAAAAAAAAAAAAAAAAAAAAAAAAAAAAAAAAAAAAAAAAAAAAABQAAAAAAAAAwMD/AAAAAABkAAAAMgAAAAAAAABkAAAAAAAAAH9/fwAKAAAAIgAAABgAAAAAAAAAAAAAAAAAAAAAAAAAAAAAAAAAAAAkAAAAJAAAAAAAAAAHAAAAAAAAAAAAAAAAAAAAAAAAAAAAAAAAAAAAf39/ACUAAABYAAAAAAAAAAAAAAAAAAAAAAAAAAAAAAAAAAAAAAAAAAAAAAAAAAAAAAAAAAAAAAA/AAAAAAAAAKCGAQAAAAAAAAAAAAAAAAAMAAAAAQAAAAAAAAAAAAAAAAAAAB8AAABUAAAAAAAABQAAAAEAAAAAAAAAAAAAAAAAAAAAAAAAAAAAAAAAAAAAAAAAAAAAAAJ/f38AAAAAA8zMzADAwP8Af39/AAAAAAAAAAAAAAAAAAAAAAAAAAAAIQAAABgAAAAUAAAAoRkAABsnAABfMQAAWSkAABAAAAAmAAAACAAAAAAAAAAAAAAA"/>
+                <pr:smNativeData xmlns:pr="smNativeData" xmlns="smNativeData" val="SMDATA_15_ZqHWaRMAAAAlAAAAZAAAAA8BAAAAkAAAAEgAAACQAAAASAAAAAAAAAABAAAAAAAAAAEAAABQAAAAAAAAAAAA4D8AAAAAAADgPwAAAAAAAOA/AAAAAAAA4D8AAAAAAADgPwAAAAAAAOA/AAAAAAAA4D8AAAAAAADgPwAAAAAAAOA/AAAAAAAA4D8CAAAAjAAAAAAAAAAAAAAAu+DjDP///wgAAAAAAAAAAAAAAAAAAAAAAAAAAAAAAAAAAAAAZAAAAAEAAABAAAAAAAAAAAAAAAAAAAAAAAAAAAAAAAAAAAAAAAAAAAAAAAAAAAAAAAAAAAAAAAAAAAAAAAAAAAAAAAAAAAAAAAAAAAAAAAAAAAAAAAAAAAAAAAAAAAAAFAAAADwAAAAAAAAAAAAAAAAAAAkUAAAAAQAAABQAAAAUAAAAFAAAAAEAAAAAAAAAZAAAAGQAAAAAAAAAZAAAAGQAAAAVAAAAYAAAAAAAAAAAAAAADwAAACADAAAAAAAAAAAAAAEAAACgMgAAVgcAAKr4//8BAAAAf39/AAEAAABkAAAAAAAAABQAAABAHwAAAAAAACYAAAAAAAAAwOD//wAAAAAmAAAAZAAAABYAAABMAAAAAAAAAAAAAAAEAAAAAAAAAAEAAACAgIAKAAAAACgAAAAoAAAAZAAAAGQAAAAAAAAAzMzMAAAAAABQAAAAUAAAAGQAAABkAAAAAAAAABcAAAAUAAAAAAAAAAAAAAD/fwAA/38AAAAAAAAJAAAABAAAANw7IAEeAAAAaAAAAAAAAAAAAAAAAAAAAAAAAAAAAAAAECcAABAnAAAAAAAAAAAAAAAAAAAAAAAAAAAAAAAAAAAAAAAAAAAAABQAAAAAAAAAwMD/AAAAAABkAAAAMgAAAAAAAABkAAAAAAAAAH9/fwAKAAAAIgAAABgAAAAAAAAAAAAAAAAAAAAAAAAAAAAAAAAAAAAkAAAAJAAAAAAAAAAHAAAAAAAAAAAAAAAAAAAAAAAAAAAAAAAAAAAAf39/ACUAAABYAAAAAAAAAAAAAAAAAAAAAAAAAAAAAAAAAAAAAAAAAAAAAAAAAAAAAAAAAAAAAAA/AAAAAAAAAKCGAQAAAAAAAAAAAAAAAAAMAAAAAQAAAAAAAAAAAAAAAAAAAB8AAABUAAAAAAAABQAAAAEAAAAAAAAAAAAAAAAAAAAAAAAAAAAAAAAAAAAAAAAAAAAAAAJ/f38AAAAAA8zMzADAwP8Af39/AAAAAAAAAAAAAAAAAAAAAAAAAAAAIQAAABgAAAAUAAAAoRkAABsnAABfMQAAWSkAABAAAAAmAAAACAAAAAAAAAAAAAAA"/>
               </a:ext>
             </a:extLst>
           </p:cNvSpPr>
@@ -2040,7 +2040,7 @@
             <a:spLocks noGrp="1" noChangeArrowheads="1"/>
             <a:extLst>
               <a:ext uri="smNativeData">
-                <pr:smNativeData xmlns:pr="smNativeData" xmlns="smNativeData" val="SMDATA_15_7aDWaRMAAAAlAAAAZAAAAA8BAAAAkAAAAEgAAACQAAAASAAAAAAAAAABAAAAAAAAAAEAAABQAAAAAAAAAAAA4D8AAAAAAADgPwAAAAAAAOA/AAAAAAAA4D8AAAAAAADgPwAAAAAAAOA/AAAAAAAA4D8AAAAAAADgPwAAAAAAAOA/AAAAAAAA4D8CAAAAjAAAAAAAAAAAAAAAu+DjDP///wgAAAAAAAAAAAAAAAAAAAAAAAAAAAAAAAAAAAAAZAAAAAEAAABAAAAAAAAAAAAAAAAAAAAAAAAAAAAAAAAAAAAAAAAAAAAAAAAAAAAAAAAAAAAAAAAAAAAAAAAAAAAAAAAAAAAAAAAAAAAAAAAAAAAAAAAAAAAAAAAAAAAAFAAAADwAAAAAAAAAAAAAAAAAAAkUAAAAAQAAABQAAAAUAAAAFAAAAAEAAAAAAAAAZAAAAGQAAAAAAAAAZAAAAGQAAAAVAAAAYAAAAAAAAAAAAAAADwAAACADAAAAAAAAAAAAAAEAAACgMgAAVgcAAKr4//8BAAAAf39/AAEAAABkAAAAAAAAABQAAABAHwAAAAAAACYAAAAAAAAAwOD//wAAAAAmAAAAZAAAABYAAABMAAAAAAAAAAAAAAAEAAAAAAAAAAEAAACAgIAKAAAAACgAAAAoAAAAZAAAAGQAAAAAAAAAzMzMAAAAAABQAAAAUAAAAGQAAABkAAAAAAAAABcAAAAUAAAAAAAAAAAAAAD/fwAA/38AAAAAAAAJAAAABAAAANw7IAEeAAAAaAAAAAAAAAAAAAAAAAAAAAAAAAAAAAAAECcAABAnAAAAAAAAAAAAAAAAAAAAAAAAAAAAAAAAAAAAAAAAAAAAABQAAAAAAAAAwMD/AAAAAABkAAAAMgAAAAAAAABkAAAAAAAAAH9/fwAKAAAAIgAAABgAAAAAAAAAAAAAAAAAAAAAAAAAAAAAAAAAAAAkAAAAJAAAAAAAAAAHAAAAAAAAAAAAAAAAAAAAAAAAAAAAAAAAAAAAf39/ACUAAABYAAAAAAAAAAAAAAAAAAAAAAAAAAAAAAAAAAAAAAAAAAAAAAAAAAAAAAAAAAAAAAA/AAAAAAAAAKCGAQAAAAAAAAAAAAAAAAAMAAAAAQAAAAAAAAAAAAAAAAAAAB8AAABUAAAAAAAABQAAAAEAAAAAAAAAAAAAAAAAAAAAAAAAAAAAAAAAAAAAAAAAAAAAAAJ/f38AAAAAA8zMzADAwP8Af39/AAAAAAAAAAAAAAAAAAAAAAAAAAAAIQAAABgAAAAUAAAAwTUAABsnAABARwAAWSkAABAAAAAmAAAACAAAAAAAAAAAAAAA"/>
+                <pr:smNativeData xmlns:pr="smNativeData" xmlns="smNativeData" val="SMDATA_15_ZqHWaRMAAAAlAAAAZAAAAA8BAAAAkAAAAEgAAACQAAAASAAAAAAAAAABAAAAAAAAAAEAAABQAAAAAAAAAAAA4D8AAAAAAADgPwAAAAAAAOA/AAAAAAAA4D8AAAAAAADgPwAAAAAAAOA/AAAAAAAA4D8AAAAAAADgPwAAAAAAAOA/AAAAAAAA4D8CAAAAjAAAAAAAAAAAAAAAu+DjDP///wgAAAAAAAAAAAAAAAAAAAAAAAAAAAAAAAAAAAAAZAAAAAEAAABAAAAAAAAAAAAAAAAAAAAAAAAAAAAAAAAAAAAAAAAAAAAAAAAAAAAAAAAAAAAAAAAAAAAAAAAAAAAAAAAAAAAAAAAAAAAAAAAAAAAAAAAAAAAAAAAAAAAAFAAAADwAAAAAAAAAAAAAAAAAAAkUAAAAAQAAABQAAAAUAAAAFAAAAAEAAAAAAAAAZAAAAGQAAAAAAAAAZAAAAGQAAAAVAAAAYAAAAAAAAAAAAAAADwAAACADAAAAAAAAAAAAAAEAAACgMgAAVgcAAKr4//8BAAAAf39/AAEAAABkAAAAAAAAABQAAABAHwAAAAAAACYAAAAAAAAAwOD//wAAAAAmAAAAZAAAABYAAABMAAAAAAAAAAAAAAAEAAAAAAAAAAEAAACAgIAKAAAAACgAAAAoAAAAZAAAAGQAAAAAAAAAzMzMAAAAAABQAAAAUAAAAGQAAABkAAAAAAAAABcAAAAUAAAAAAAAAAAAAAD/fwAA/38AAAAAAAAJAAAABAAAANw7IAEeAAAAaAAAAAAAAAAAAAAAAAAAAAAAAAAAAAAAECcAABAnAAAAAAAAAAAAAAAAAAAAAAAAAAAAAAAAAAAAAAAAAAAAABQAAAAAAAAAwMD/AAAAAABkAAAAMgAAAAAAAABkAAAAAAAAAH9/fwAKAAAAIgAAABgAAAAAAAAAAAAAAAAAAAAAAAAAAAAAAAAAAAAkAAAAJAAAAAAAAAAHAAAAAAAAAAAAAAAAAAAAAAAAAAAAAAAAAAAAf39/ACUAAABYAAAAAAAAAAAAAAAAAAAAAAAAAAAAAAAAAAAAAAAAAAAAAAAAAAAAAAAAAAAAAAA/AAAAAAAAAKCGAQAAAAAAAAAAAAAAAAAMAAAAAQAAAAAAAAAAAAAAAAAAAB8AAABUAAAAAAAABQAAAAEAAAAAAAAAAAAAAAAAAAAAAAAAAAAAAAAAAAAAAAAAAAAAAAJ/f38AAAAAA8zMzADAwP8Af39/AAAAAAAAAAAAAAAAAAAAAAAAAAAAIQAAABgAAAAUAAAAwTUAABsnAABARwAAWSkAABAAAAAmAAAACAAAAAAAAAAAAAAA"/>
               </a:ext>
             </a:extLst>
           </p:cNvSpPr>
@@ -2054,7 +2054,7 @@
           <a:lstStyle/>
           <a:p>
             <a:pPr/>
-            <a:fld id="{31996BDC-92DC-CC9D-9221-64C8256F6431}" type="slidenum">
+            <a:fld id="{67CE2585-CB8A-9BD3-C476-3D866B383268}" type="slidenum">
               <a:t/>
             </a:fld>
           </a:p>
@@ -2093,7 +2093,7 @@
             <a:spLocks noGrp="1" noChangeArrowheads="1"/>
             <a:extLst>
               <a:ext uri="smNativeData">
-                <pr:smNativeData xmlns:pr="smNativeData" xmlns="smNativeData" val="SMDATA_15_7aDWaRMAAAAlAAAAZAAAAA8BAAAAkAAAAEgAAACQAAAASAAAAAAAAAABAAAAAAAAAAEAAABQAAAAAAAAAAAA4D8AAAAAAADgPwAAAAAAAOA/AAAAAAAA4D8AAAAAAADgPwAAAAAAAOA/AAAAAAAA4D8AAAAAAADgPwAAAAAAAOA/AAAAAAAA4D8CAAAAjAAAAAAAAAAAAAAAu+DjDP///wgAAAAAAAAAAAAAAAAAAAAAAAAAAAAAAAAAAAAAZAAAAAEAAABAAAAAAAAAAAAAAAAAAAAAAAAAAAAAAAAAAAAAAAAAAAAAAAAAAAAAAAAAAAAAAAAAAAAAAAAAAAAAAAAAAAAAAAAAAAAAAAAAAAAAAAAAAAAAAAAAAAAAFAAAADwAAAAAAAAAAAAAAAAAAAkUAAAAAQAAABQAAAAUAAAAFAAAAAEAAAAAAAAAZAAAAGQAAAAAAAAAZAAAAGQAAAAVAAAAYAAAAAAAAAAAAAAADwAAACADAAAAAAAAAAAAAAEAAACgMgAAVgcAAKr4//8BAAAAf39/AAEAAABkAAAAAAAAABQAAABAHwAAAAAAACYAAAAAAAAAwOD//wAAAAAmAAAAZAAAABYAAABMAAAAAAAAAAAAAAAEAAAAAAAAAAEAAACAgIAKAAAAACgAAAAoAAAAZAAAAGQAAAAAAAAAzMzMAAAAAABQAAAAUAAAAGQAAABkAAAAAAAAABcAAAAUAAAAAAAAAAAAAAD/fwAA/38AAAAAAAAJAAAABAAAANw7IAEeAAAAaAAAAAAAAAAAAAAAAAAAAAAAAAAAAAAAECcAABAnAAAAAAAAAAAAAAAAAAAAAAAAAAAAAAAAAAAAAAAAAAAAABQAAAAAAAAAwMD/AAAAAABkAAAAMgAAAAAAAABkAAAAAAAAAH9/fwAKAAAAIgAAABgAAAAAAAAAAAAAAAAAAAAAAAAAAAAAAAAAAAAkAAAAJAAAAAAAAAAHAAAAAAAAAAAAAAAAAAAAAAAAAAAAAAAAAAAAf39/ACUAAABYAAAAAAAAAAAAAAAAAAAAAAAAAAAAAAAAAAAAAAAAAAAAAAAAAAAAAAAAAAAAAAA/AAAAAAAAAKCGAQAAAAAAAAAAAAAAAAAMAAAAAQAAAAAAAAAAAAAAAAAAAB8AAABUAAAAAAAABQAAAAEAAAAAAAAAAAAAAAAAAAAAAAAAAAAAAAAAAAAAAAAAAAAAAAJ/f38AAAAAA8zMzADAwP8Af39/AAAAAAAAAAAAAAAAAAAAAAAAAAAAIQAAABgAAAAUAAAAwAMAABsnAAA/FQAAWSkAABAAAAAmAAAACAAAAAAAAAAAAAAA"/>
+                <pr:smNativeData xmlns:pr="smNativeData" xmlns="smNativeData" val="SMDATA_15_ZqHWaRMAAAAlAAAAZAAAAA8BAAAAkAAAAEgAAACQAAAASAAAAAAAAAABAAAAAAAAAAEAAABQAAAAAAAAAAAA4D8AAAAAAADgPwAAAAAAAOA/AAAAAAAA4D8AAAAAAADgPwAAAAAAAOA/AAAAAAAA4D8AAAAAAADgPwAAAAAAAOA/AAAAAAAA4D8CAAAAjAAAAAAAAAAAAAAAu+DjDP///wgAAAAAAAAAAAAAAAAAAAAAAAAAAAAAAAAAAAAAZAAAAAEAAABAAAAAAAAAAAAAAAAAAAAAAAAAAAAAAAAAAAAAAAAAAAAAAAAAAAAAAAAAAAAAAAAAAAAAAAAAAAAAAAAAAAAAAAAAAAAAAAAAAAAAAAAAAAAAAAAAAAAAFAAAADwAAAAAAAAAAAAAAAAAAAkUAAAAAQAAABQAAAAUAAAAFAAAAAEAAAAAAAAAZAAAAGQAAAAAAAAAZAAAAGQAAAAVAAAAYAAAAAAAAAAAAAAADwAAACADAAAAAAAAAAAAAAEAAACgMgAAVgcAAKr4//8BAAAAf39/AAEAAABkAAAAAAAAABQAAABAHwAAAAAAACYAAAAAAAAAwOD//wAAAAAmAAAAZAAAABYAAABMAAAAAAAAAAAAAAAEAAAAAAAAAAEAAACAgIAKAAAAACgAAAAoAAAAZAAAAGQAAAAAAAAAzMzMAAAAAABQAAAAUAAAAGQAAABkAAAAAAAAABcAAAAUAAAAAAAAAAAAAAD/fwAA/38AAAAAAAAJAAAABAAAANw7IAEeAAAAaAAAAAAAAAAAAAAAAAAAAAAAAAAAAAAAECcAABAnAAAAAAAAAAAAAAAAAAAAAAAAAAAAAAAAAAAAAAAAAAAAABQAAAAAAAAAwMD/AAAAAABkAAAAMgAAAAAAAABkAAAAAAAAAH9/fwAKAAAAIgAAABgAAAAAAAAAAAAAAAAAAAAAAAAAAAAAAAAAAAAkAAAAJAAAAAAAAAAHAAAAAAAAAAAAAAAAAAAAAAAAAAAAAAAAAAAAf39/ACUAAABYAAAAAAAAAAAAAAAAAAAAAAAAAAAAAAAAAAAAAAAAAAAAAAAAAAAAAAAAAAAAAAA/AAAAAAAAAKCGAQAAAAAAAAAAAAAAAAAMAAAAAQAAAAAAAAAAAAAAAAAAAB8AAABUAAAAAAAABQAAAAEAAAAAAAAAAAAAAAAAAAAAAAAAAAAAAAAAAAAAAAAAAAAAAAJ/f38AAAAAA8zMzADAwP8Af39/AAAAAAAAAAAAAAAAAAAAAAAAAAAAIQAAABgAAAAUAAAAwAMAABsnAAA/FQAAWSkAABAAAAAmAAAACAAAAAAAAAAAAAAA"/>
               </a:ext>
             </a:extLst>
           </p:cNvSpPr>
@@ -2107,7 +2107,7 @@
           <a:lstStyle/>
           <a:p>
             <a:pPr/>
-            <a:fld id="{63B8F16D-238E-ED07-C000-D552BF4E3680}" type="datetime1">
+            <a:fld id="{2CD735F1-BFC1-82C3-8F6F-49967B21791C}" type="datetime1">
               <a:t/>
             </a:fld>
           </a:p>
@@ -2120,7 +2120,7 @@
             <a:spLocks noGrp="1" noChangeArrowheads="1"/>
             <a:extLst>
               <a:ext uri="smNativeData">
-                <pr:smNativeData xmlns:pr="smNativeData" xmlns="smNativeData" val="SMDATA_15_7aDWaRMAAAAlAAAAZAAAAA8BAAAAkAAAAEgAAACQAAAASAAAAAAAAAABAAAAAAAAAAEAAABQAAAAAAAAAAAA4D8AAAAAAADgPwAAAAAAAOA/AAAAAAAA4D8AAAAAAADgPwAAAAAAAOA/AAAAAAAA4D8AAAAAAADgPwAAAAAAAOA/AAAAAAAA4D8CAAAAjAAAAAAAAAAAAAAAu+DjDP///wgAAAAAAAAAAAAAAAAAAAAAAAAAAAAAAAAAAAAAZAAAAAEAAABAAAAAAAAAAAAAAAAAAAAAAAAAAAAAAAAAAAAAAAAAAAAAAAAAAAAAAAAAAAAAAAAAAAAAAAAAAAAAAAAAAAAAAAAAAAAAAAAAAAAAAAAAAAAAAAAAAAAAFAAAADwAAAAAAAAAAAAAAAAAAAkUAAAAAQAAABQAAAAUAAAAFAAAAAEAAAAAAAAAZAAAAGQAAAAAAAAAZAAAAGQAAAAVAAAAYAAAAAAAAAAAAAAADwAAACADAAAAAAAAAAAAAAEAAACgMgAAVgcAAKr4//8BAAAAf39/AAEAAABkAAAAAAAAABQAAABAHwAAAAAAACYAAAAAAAAAwOD//wAAAAAmAAAAZAAAABYAAABMAAAAAAAAAAAAAAAEAAAAAAAAAAEAAACAgIAKAAAAACgAAAAoAAAAZAAAAGQAAAAAAAAAzMzMAAAAAABQAAAAUAAAAGQAAABkAAAAAAAAABcAAAAUAAAAAAAAAAAAAAD/fwAA/38AAAAAAAAJAAAABAAAAAAAAAAeAAAAaAAAAAAAAAAAAAAAAAAAAAAAAAAAAAAAECcAABAnAAAAAAAAAAAAAAAAAAAAAAAAAAAAAAAAAAAAAAAAAAAAABQAAAAAAAAAwMD/AAAAAABkAAAAMgAAAAAAAABkAAAAAAAAAH9/fwAKAAAAIgAAABgAAAAAAAAAAAAAAAAAAAAAAAAAAAAAAAAAAAAkAAAAJAAAAAAAAAAHAAAAAAAAAAAAAAAAAAAAAAAAAAAAAAAAAAAAf39/ACUAAABYAAAAAAAAAAAAAAAAAAAAAAAAAAAAAAAAAAAAAAAAAAAAAAAAAAAAAAAAAAAAAAA/AAAAAAAAAKCGAQAAAAAAAAAAAAAAAAAMAAAAAQAAAAAAAAAAAAAAAAAAAB8AAABUAAAAAAAABQAAAAEAAAAAAAAAAAAAAAAAAAAAAAAAAAAAAAAAAAAAAAAAAAAAAAJ/f38AAAAAA8zMzADAwP8Af39/AAAAAAAAAAAAAAAAAAAAAAAAAAAAIQAAABgAAAAUAAAAoRkAABsnAABfMQAAWSkAABAAAAAmAAAACAAAAAAAAAAAAAAA"/>
+                <pr:smNativeData xmlns:pr="smNativeData" xmlns="smNativeData" val="SMDATA_15_ZqHWaRMAAAAlAAAAZAAAAA8BAAAAkAAAAEgAAACQAAAASAAAAAAAAAABAAAAAAAAAAEAAABQAAAAAAAAAAAA4D8AAAAAAADgPwAAAAAAAOA/AAAAAAAA4D8AAAAAAADgPwAAAAAAAOA/AAAAAAAA4D8AAAAAAADgPwAAAAAAAOA/AAAAAAAA4D8CAAAAjAAAAAAAAAAAAAAAu+DjDP///wgAAAAAAAAAAAAAAAAAAAAAAAAAAAAAAAAAAAAAZAAAAAEAAABAAAAAAAAAAAAAAAAAAAAAAAAAAAAAAAAAAAAAAAAAAAAAAAAAAAAAAAAAAAAAAAAAAAAAAAAAAAAAAAAAAAAAAAAAAAAAAAAAAAAAAAAAAAAAAAAAAAAAFAAAADwAAAAAAAAAAAAAAAAAAAkUAAAAAQAAABQAAAAUAAAAFAAAAAEAAAAAAAAAZAAAAGQAAAAAAAAAZAAAAGQAAAAVAAAAYAAAAAAAAAAAAAAADwAAACADAAAAAAAAAAAAAAEAAACgMgAAVgcAAKr4//8BAAAAf39/AAEAAABkAAAAAAAAABQAAABAHwAAAAAAACYAAAAAAAAAwOD//wAAAAAmAAAAZAAAABYAAABMAAAAAAAAAAAAAAAEAAAAAAAAAAEAAACAgIAKAAAAACgAAAAoAAAAZAAAAGQAAAAAAAAAzMzMAAAAAABQAAAAUAAAAGQAAABkAAAAAAAAABcAAAAUAAAAAAAAAAAAAAD/fwAA/38AAAAAAAAJAAAABAAAAAAAAAAeAAAAaAAAAAAAAAAAAAAAAAAAAAAAAAAAAAAAECcAABAnAAAAAAAAAAAAAAAAAAAAAAAAAAAAAAAAAAAAAAAAAAAAABQAAAAAAAAAwMD/AAAAAABkAAAAMgAAAAAAAABkAAAAAAAAAH9/fwAKAAAAIgAAABgAAAAAAAAAAAAAAAAAAAAAAAAAAAAAAAAAAAAkAAAAJAAAAAAAAAAHAAAAAAAAAAAAAAAAAAAAAAAAAAAAAAAAAAAAf39/ACUAAABYAAAAAAAAAAAAAAAAAAAAAAAAAAAAAAAAAAAAAAAAAAAAAAAAAAAAAAAAAAAAAAA/AAAAAAAAAKCGAQAAAAAAAAAAAAAAAAAMAAAAAQAAAAAAAAAAAAAAAAAAAB8AAABUAAAAAAAABQAAAAEAAAAAAAAAAAAAAAAAAAAAAAAAAAAAAAAAAAAAAAAAAAAAAAJ/f38AAAAAA8zMzADAwP8Af39/AAAAAAAAAAAAAAAAAAAAAAAAAAAAIQAAABgAAAAUAAAAoRkAABsnAABfMQAAWSkAABAAAAAmAAAACAAAAAAAAAAAAAAA"/>
               </a:ext>
             </a:extLst>
           </p:cNvSpPr>
@@ -2144,7 +2144,7 @@
             <a:spLocks noGrp="1" noChangeArrowheads="1"/>
             <a:extLst>
               <a:ext uri="smNativeData">
-                <pr:smNativeData xmlns:pr="smNativeData" xmlns="smNativeData" val="SMDATA_15_7aDWaRMAAAAlAAAAZAAAAA8BAAAAkAAAAEgAAACQAAAASAAAAAAAAAABAAAAAAAAAAEAAABQAAAAAAAAAAAA4D8AAAAAAADgPwAAAAAAAOA/AAAAAAAA4D8AAAAAAADgPwAAAAAAAOA/AAAAAAAA4D8AAAAAAADgPwAAAAAAAOA/AAAAAAAA4D8CAAAAjAAAAAAAAAAAAAAAu+DjDP///wgAAAAAAAAAAAAAAAAAAAAAAAAAAAAAAAAAAAAAZAAAAAEAAABAAAAAAAAAAAAAAAAAAAAAAAAAAAAAAAAAAAAAAAAAAAAAAAAAAAAAAAAAAAAAAAAAAAAAAAAAAAAAAAAAAAAAAAAAAAAAAAAAAAAAAAAAAAAAAAAAAAAAFAAAADwAAAAAAAAAAAAAAAAAAAkUAAAAAQAAABQAAAAUAAAAFAAAAAEAAAAAAAAAZAAAAGQAAAAAAAAAZAAAAGQAAAAVAAAAYAAAAAAAAAAAAAAADwAAACADAAAAAAAAAAAAAAEAAACgMgAAVgcAAKr4//8BAAAAf39/AAEAAABkAAAAAAAAABQAAABAHwAAAAAAACYAAAAAAAAAwOD//wAAAAAmAAAAZAAAABYAAABMAAAAAAAAAAAAAAAEAAAAAAAAAAEAAACAgIAKAAAAACgAAAAoAAAAZAAAAGQAAAAAAAAAzMzMAAAAAABQAAAAUAAAAGQAAABkAAAAAAAAABcAAAAUAAAAAAAAAAAAAAD/fwAA/38AAAAAAAAJAAAABAAAAAAAAAAeAAAAaAAAAAAAAAAAAAAAAAAAAAAAAAAAAAAAECcAABAnAAAAAAAAAAAAAAAAAAAAAAAAAAAAAAAAAAAAAAAAAAAAABQAAAAAAAAAwMD/AAAAAABkAAAAMgAAAAAAAABkAAAAAAAAAH9/fwAKAAAAIgAAABgAAAAAAAAAAAAAAAAAAAAAAAAAAAAAAAAAAAAkAAAAJAAAAAAAAAAHAAAAAAAAAAAAAAAAAAAAAAAAAAAAAAAAAAAAf39/ACUAAABYAAAAAAAAAAAAAAAAAAAAAAAAAAAAAAAAAAAAAAAAAAAAAAAAAAAAAAAAAAAAAAA/AAAAAAAAAKCGAQAAAAAAAAAAAAAAAAAMAAAAAQAAAAAAAAAAAAAAAAAAAB8AAABUAAAAAAAABQAAAAEAAAAAAAAAAAAAAAAAAAAAAAAAAAAAAAAAAAAAAAAAAAAAAAJ/f38AAAAAA8zMzADAwP8Af39/AAAAAAAAAAAAAAAAAAAAAAAAAAAAIQAAABgAAAAUAAAAwTUAABsnAABARwAAWSkAABAAAAAmAAAACAAAAAAAAAAAAAAA"/>
+                <pr:smNativeData xmlns:pr="smNativeData" xmlns="smNativeData" val="SMDATA_15_ZqHWaRMAAAAlAAAAZAAAAA8BAAAAkAAAAEgAAACQAAAASAAAAAAAAAABAAAAAAAAAAEAAABQAAAAAAAAAAAA4D8AAAAAAADgPwAAAAAAAOA/AAAAAAAA4D8AAAAAAADgPwAAAAAAAOA/AAAAAAAA4D8AAAAAAADgPwAAAAAAAOA/AAAAAAAA4D8CAAAAjAAAAAAAAAAAAAAAu+DjDP///wgAAAAAAAAAAAAAAAAAAAAAAAAAAAAAAAAAAAAAZAAAAAEAAABAAAAAAAAAAAAAAAAAAAAAAAAAAAAAAAAAAAAAAAAAAAAAAAAAAAAAAAAAAAAAAAAAAAAAAAAAAAAAAAAAAAAAAAAAAAAAAAAAAAAAAAAAAAAAAAAAAAAAFAAAADwAAAAAAAAAAAAAAAAAAAkUAAAAAQAAABQAAAAUAAAAFAAAAAEAAAAAAAAAZAAAAGQAAAAAAAAAZAAAAGQAAAAVAAAAYAAAAAAAAAAAAAAADwAAACADAAAAAAAAAAAAAAEAAACgMgAAVgcAAKr4//8BAAAAf39/AAEAAABkAAAAAAAAABQAAABAHwAAAAAAACYAAAAAAAAAwOD//wAAAAAmAAAAZAAAABYAAABMAAAAAAAAAAAAAAAEAAAAAAAAAAEAAACAgIAKAAAAACgAAAAoAAAAZAAAAGQAAAAAAAAAzMzMAAAAAABQAAAAUAAAAGQAAABkAAAAAAAAABcAAAAUAAAAAAAAAAAAAAD/fwAA/38AAAAAAAAJAAAABAAAAAAAAAAeAAAAaAAAAAAAAAAAAAAAAAAAAAAAAAAAAAAAECcAABAnAAAAAAAAAAAAAAAAAAAAAAAAAAAAAAAAAAAAAAAAAAAAABQAAAAAAAAAwMD/AAAAAABkAAAAMgAAAAAAAABkAAAAAAAAAH9/fwAKAAAAIgAAABgAAAAAAAAAAAAAAAAAAAAAAAAAAAAAAAAAAAAkAAAAJAAAAAAAAAAHAAAAAAAAAAAAAAAAAAAAAAAAAAAAAAAAAAAAf39/ACUAAABYAAAAAAAAAAAAAAAAAAAAAAAAAAAAAAAAAAAAAAAAAAAAAAAAAAAAAAAAAAAAAAA/AAAAAAAAAKCGAQAAAAAAAAAAAAAAAAAMAAAAAQAAAAAAAAAAAAAAAAAAAB8AAABUAAAAAAAABQAAAAEAAAAAAAAAAAAAAAAAAAAAAAAAAAAAAAAAAAAAAAAAAAAAAAJ/f38AAAAAA8zMzADAwP8Af39/AAAAAAAAAAAAAAAAAAAAAAAAAAAAIQAAABgAAAAUAAAAwTUAABsnAABARwAAWSkAABAAAAAmAAAACAAAAAAAAAAAAAAA"/>
               </a:ext>
             </a:extLst>
           </p:cNvSpPr>
@@ -2158,7 +2158,7 @@
           <a:lstStyle/>
           <a:p>
             <a:pPr/>
-            <a:fld id="{528B5113-5DBF-DEA7-F133-ABF21F7D07FE}" type="slidenum">
+            <a:fld id="{08995FE2-ACE5-CCA9-AB21-5AFC116F5D0F}" type="slidenum">
               <a:t/>
             </a:fld>
           </a:p>
@@ -2197,7 +2197,7 @@
             <a:spLocks noGrp="1" noChangeArrowheads="1"/>
             <a:extLst>
               <a:ext uri="smNativeData">
-                <pr:smNativeData xmlns:pr="smNativeData" xmlns="smNativeData" val="SMDATA_15_7aDWaRMAAAAlAAAAZAAAAA8BAAAAkAAAAEgAAACQAAAASAAAAAAAAAACAAAAAAAAAAEAAABQAAAAAAAAAAAA4D8AAAAAAADgPwAAAAAAAOA/AAAAAAAA4D8AAAAAAADgPwAAAAAAAOA/AAAAAAAA4D8AAAAAAADgPwAAAAAAAOA/AAAAAAAA4D8CAAAAjAAAAAAAAAAAAAAAu+DjDP///wgAAAAAAAAAAAAAAAAAAAAAAAAAAAAAAAAAAAAAZAAAAAEAAABAAAAAAAAAAAAAAAAAAAAAAAAAAAAAAAAAAAAAAAAAAAAAAAAAAAAAAAAAAAAAAAAAAAAAAAAAAAAAAAAAAAAAAAAAAAAAAAAAAAAAAAAAAAAAAAAAAAAAFAAAADwAAAAAAAAAAAAAAAAAAAkUAAAAAQAAABQAAAAUAAAAFAAAAAEAAAAAAAAAZAAAAGQAAAAAAAAAZAAAAGQAAAAVAAAAYAAAAAAAAAAAAAAADwAAACADAAAAAAAAAAAAAAEAAACgMgAAVgcAAKr4//8BAAAAf39/AAEAAABkAAAAAAAAABQAAABAHwAAAAAAACYAAAAAAAAAwOD//wAAAAAmAAAAZAAAABYAAABMAAAAAAAAAAAAAAAEAAAAAAAAAAEAAACAgIAKAAAAACgAAAAoAAAAZAAAAGQAAAAAAAAAzMzMAAAAAABQAAAAUAAAAGQAAABkAAAAAAAAABcAAAAUAAAAAAAAAAAAAAD/fwAA/38AAAAAAAAJAAAABAAAAAAAAAAeAAAAaAAAAAAAAAAAAAAAAAAAAAAAAAAAAAAAECcAABAnAAAAAAAAAAAAAAAAAAAAAAAAAAAAAAAAAAAAAAAAAAAAABQAAAAAAAAAwMD/AAAAAABkAAAAMgAAAAAAAABkAAAAAAAAAH9/fwAKAAAAIgAAABgAAAAAAAAAAAAAAAAAAAAAAAAAAAAAAAAAAAAkAAAAJAAAAAAAAAAHAAAAAAAAAAAAAAAAAAAAAAAAAAAAAAAAAAAAf39/ACUAAABYAAAAAAAAAAAAAAAAAAAAAAAAAAAAAAAAAAAAAAAAAAAAAAAAAAAAAAAAAAAAAAA/AAAAAAAAAKCGAQAAAAAAAAAAAAAAAAAMAAAAAQAAAAAAAAAAAAAAAAAAAB8AAABUAAAAAAAABQAAAAEAAAAAAAAAAAAAAAAAAAAAAAAAAAAAAAAAAAAAAAAAAAAAAAJ/f38AAAAAA8zMzADAwP8Af39/AAAAAAAAAAAAAAAAAAAAAAAAAAAAIQAAABgAAAAUAAAAwAMAAK4BAABtHAAA1AgAABAAAAAmAAAACAAAAIGAAAAAAAAA"/>
+                <pr:smNativeData xmlns:pr="smNativeData" xmlns="smNativeData" val="SMDATA_15_ZqHWaRMAAAAlAAAAZAAAAA8BAAAAkAAAAEgAAACQAAAASAAAAAAAAAACAAAAAAAAAAEAAABQAAAAAAAAAAAA4D8AAAAAAADgPwAAAAAAAOA/AAAAAAAA4D8AAAAAAADgPwAAAAAAAOA/AAAAAAAA4D8AAAAAAADgPwAAAAAAAOA/AAAAAAAA4D8CAAAAjAAAAAAAAAAAAAAAu+DjDP///wgAAAAAAAAAAAAAAAAAAAAAAAAAAAAAAAAAAAAAZAAAAAEAAABAAAAAAAAAAAAAAAAAAAAAAAAAAAAAAAAAAAAAAAAAAAAAAAAAAAAAAAAAAAAAAAAAAAAAAAAAAAAAAAAAAAAAAAAAAAAAAAAAAAAAAAAAAAAAAAAAAAAAFAAAADwAAAAAAAAAAAAAAAAAAAkUAAAAAQAAABQAAAAUAAAAFAAAAAEAAAAAAAAAZAAAAGQAAAAAAAAAZAAAAGQAAAAVAAAAYAAAAAAAAAAAAAAADwAAACADAAAAAAAAAAAAAAEAAACgMgAAVgcAAKr4//8BAAAAf39/AAEAAABkAAAAAAAAABQAAABAHwAAAAAAACYAAAAAAAAAwOD//wAAAAAmAAAAZAAAABYAAABMAAAAAAAAAAAAAAAEAAAAAAAAAAEAAACAgIAKAAAAACgAAAAoAAAAZAAAAGQAAAAAAAAAzMzMAAAAAABQAAAAUAAAAGQAAABkAAAAAAAAABcAAAAUAAAAAAAAAAAAAAD/fwAA/38AAAAAAAAJAAAABAAAAAAAAAAeAAAAaAAAAAAAAAAAAAAAAAAAAAAAAAAAAAAAECcAABAnAAAAAAAAAAAAAAAAAAAAAAAAAAAAAAAAAAAAAAAAAAAAABQAAAAAAAAAwMD/AAAAAABkAAAAMgAAAAAAAABkAAAAAAAAAH9/fwAKAAAAIgAAABgAAAAAAAAAAAAAAAAAAAAAAAAAAAAAAAAAAAAkAAAAJAAAAAAAAAAHAAAAAAAAAAAAAAAAAAAAAAAAAAAAAAAAAAAAf39/ACUAAABYAAAAAAAAAAAAAAAAAAAAAAAAAAAAAAAAAAAAAAAAAAAAAAAAAAAAAAAAAAAAAAA/AAAAAAAAAKCGAQAAAAAAAAAAAAAAAAAMAAAAAQAAAAAAAAAAAAAAAAAAAB8AAABUAAAAAAAABQAAAAEAAAAAAAAAAAAAAAAAAAAAAAAAAAAAAAAAAAAAAAAAAAAAAAJ/f38AAAAAA8zMzADAwP8Af39/AAAAAAAAAAAAAAAAAAAAAAAAAAAAIQAAABgAAAAUAAAAwAMAAK4BAABtHAAA1AgAABAAAAAmAAAACAAAAIGAAAAAAAAA"/>
               </a:ext>
             </a:extLst>
           </p:cNvSpPr>
@@ -2237,7 +2237,7 @@
             <a:spLocks noGrp="1" noChangeArrowheads="1"/>
             <a:extLst>
               <a:ext uri="smNativeData">
-                <pr:smNativeData xmlns:pr="smNativeData" xmlns="smNativeData" val="SMDATA_15_7aDWaRMAAAAlAAAAZAAAAA8BAAAAkAAAAEgAAACQAAAASAAAAAAAAAAAAAAAAAAAAAEAAABQAAAAAAAAAAAA4D8AAAAAAADgPwAAAAAAAOA/AAAAAAAA4D8AAAAAAADgPwAAAAAAAOA/AAAAAAAA4D8AAAAAAADgPwAAAAAAAOA/AAAAAAAA4D8CAAAAjAAAAAAAAAAAAAAAu+DjDP///wgAAAAAAAAAAAAAAAAAAAAAAAAAAAAAAAAAAAAAZAAAAAEAAABAAAAAAAAAAAAAAAAAAAAAAAAAAAAAAAAAAAAAAAAAAAAAAAAAAAAAAAAAAAAAAAAAAAAAAAAAAAAAAAAAAAAAAAAAAAAAAAAAAAAAAAAAAAAAAAAAAAAAFAAAADwAAAAAAAAAAAAAAAAAAAkUAAAAAQAAABQAAAAUAAAAFAAAAAEAAAAAAAAAZAAAAGQAAAAAAAAAZAAAAGQAAAAVAAAAYAAAAAAAAAAAAAAADwAAACADAAAAAAAAAAAAAAEAAACgMgAAVgcAAKr4//8BAAAAf39/AAEAAABkAAAAAAAAABQAAABAHwAAAAAAACYAAAAAAAAAwOD//wAAAAAmAAAAZAAAABYAAABMAAAAAAAAAAAAAAAEAAAAAAAAAAEAAACAgIAKAAAAACgAAAAoAAAAZAAAAGQAAAAAAAAAzMzMAAAAAABQAAAAUAAAAGQAAABkAAAAAAAAABcAAAAUAAAAAAAAAAAAAAD/fwAA/38AAAAAAAAJAAAABAAAAAAAAAAeAAAAaAAAAAAAAAAAAAAAAAAAAAAAAAAAAAAAECcAABAnAAAAAAAAAAAAAAAAAAAAAAAAAAAAAAAAAAAAAAAAAAAAABQAAAAAAAAAwMD/AAAAAABkAAAAMgAAAAAAAABkAAAAAAAAAH9/fwAKAAAAIgAAABgAAAAAAAAAAAAAAAAAAAAAAAAAAAAAAAAAAAAkAAAAJAAAAAAAAAAHAAAAAAAAAAAAAAAAAAAAAAAAAAAAAAAAAAAAf39/ACUAAABYAAAAAAAAAAAAAAAAAAAAAAAAAAAAAAAAAAAAAAAAAAAAAAAAAAAAAAAAAAAAAAA/AAAAAAAAAKCGAQAAAAAAAAAAAAAAAAAMAAAAAQAAAAAAAAAAAAAAAAAAAB8AAABUAAAAAAAABQAAAAEAAAAAAAAAAAAAAAAAAAAAAAAAAAAAAAAAAAAAAAAAAAAAAAJ/f38AAAAAA8zMzADAwP8Af39/AAAAAAAAAAAAAAAAAAAAAAAAAAAAIQAAABgAAAAUAAAAUx0AAK4BAABARwAAsCUAABAAAAAmAAAACAAAAAGAAAAAAAAA"/>
+                <pr:smNativeData xmlns:pr="smNativeData" xmlns="smNativeData" val="SMDATA_15_ZqHWaRMAAAAlAAAAZAAAAA8BAAAAkAAAAEgAAACQAAAASAAAAAAAAAAAAAAAAAAAAAEAAABQAAAAAAAAAAAA4D8AAAAAAADgPwAAAAAAAOA/AAAAAAAA4D8AAAAAAADgPwAAAAAAAOA/AAAAAAAA4D8AAAAAAADgPwAAAAAAAOA/AAAAAAAA4D8CAAAAjAAAAAAAAAAAAAAAu+DjDP///wgAAAAAAAAAAAAAAAAAAAAAAAAAAAAAAAAAAAAAZAAAAAEAAABAAAAAAAAAAAAAAAAAAAAAAAAAAAAAAAAAAAAAAAAAAAAAAAAAAAAAAAAAAAAAAAAAAAAAAAAAAAAAAAAAAAAAAAAAAAAAAAAAAAAAAAAAAAAAAAAAAAAAFAAAADwAAAAAAAAAAAAAAAAAAAkUAAAAAQAAABQAAAAUAAAAFAAAAAEAAAAAAAAAZAAAAGQAAAAAAAAAZAAAAGQAAAAVAAAAYAAAAAAAAAAAAAAADwAAACADAAAAAAAAAAAAAAEAAACgMgAAVgcAAKr4//8BAAAAf39/AAEAAABkAAAAAAAAABQAAABAHwAAAAAAACYAAAAAAAAAwOD//wAAAAAmAAAAZAAAABYAAABMAAAAAAAAAAAAAAAEAAAAAAAAAAEAAACAgIAKAAAAACgAAAAoAAAAZAAAAGQAAAAAAAAAzMzMAAAAAABQAAAAUAAAAGQAAABkAAAAAAAAABcAAAAUAAAAAAAAAAAAAAD/fwAA/38AAAAAAAAJAAAABAAAAAAAAAAeAAAAaAAAAAAAAAAAAAAAAAAAAAAAAAAAAAAAECcAABAnAAAAAAAAAAAAAAAAAAAAAAAAAAAAAAAAAAAAAAAAAAAAABQAAAAAAAAAwMD/AAAAAABkAAAAMgAAAAAAAABkAAAAAAAAAH9/fwAKAAAAIgAAABgAAAAAAAAAAAAAAAAAAAAAAAAAAAAAAAAAAAAkAAAAJAAAAAAAAAAHAAAAAAAAAAAAAAAAAAAAAAAAAAAAAAAAAAAAf39/ACUAAABYAAAAAAAAAAAAAAAAAAAAAAAAAAAAAAAAAAAAAAAAAAAAAAAAAAAAAAAAAAAAAAA/AAAAAAAAAKCGAQAAAAAAAAAAAAAAAAAMAAAAAQAAAAAAAAAAAAAAAAAAAB8AAABUAAAAAAAABQAAAAEAAAAAAAAAAAAAAAAAAAAAAAAAAAAAAAAAAAAAAAAAAAAAAAJ/f38AAAAAA8zMzADAwP8Af39/AAAAAAAAAAAAAAAAAAAAAAAAAAAAIQAAABgAAAAUAAAAUx0AAK4BAABARwAAsCUAABAAAAAmAAAACAAAAAGAAAAAAAAA"/>
               </a:ext>
             </a:extLst>
           </p:cNvSpPr>
@@ -2321,7 +2321,7 @@
             <a:spLocks noGrp="1" noChangeArrowheads="1"/>
             <a:extLst>
               <a:ext uri="smNativeData">
-                <pr:smNativeData xmlns:pr="smNativeData" xmlns="smNativeData" val="SMDATA_15_7aDWaRMAAAAlAAAAZAAAAA8BAAAAkAAAAEgAAACQAAAASAAAAAAAAAAAAAAAAAAAAAEAAABQAAAAAAAAAAAA4D8AAAAAAADgPwAAAAAAAOA/AAAAAAAA4D8AAAAAAADgPwAAAAAAAOA/AAAAAAAA4D8AAAAAAADgPwAAAAAAAOA/AAAAAAAA4D8CAAAAjAAAAAAAAAAAAAAAu+DjDP///wgAAAAAAAAAAAAAAAAAAAAAAAAAAAAAAAAAAAAAZAAAAAEAAABAAAAAAAAAAAAAAAAAAAAAAAAAAAAAAAAAAAAAAAAAAAAAAAAAAAAAAAAAAAAAAAAAAAAAAAAAAAAAAAAAAAAAAAAAAAAAAAAAAAAAAAAAAAAAAAAAAAAAFAAAADwAAAAAAAAAAAAAAAAAAAkUAAAAAQAAABQAAAAUAAAAFAAAAAEAAAAAAAAAZAAAAGQAAAAAAAAAZAAAAGQAAAAVAAAAYAAAAAAAAAAAAAAADwAAACADAAAAAAAAAAAAAAEAAACgMgAAVgcAAKr4//8BAAAAf39/AAEAAABkAAAAAAAAABQAAABAHwAAAAAAACYAAAAAAAAAwOD//wAAAAAmAAAAZAAAABYAAABMAAAAAAAAAAAAAAAEAAAAAAAAAAEAAACAgIAKAAAAACgAAAAoAAAAZAAAAGQAAAAAAAAAzMzMAAAAAABQAAAAUAAAAGQAAABkAAAAAAAAABcAAAAUAAAAAAAAAAAAAAD/fwAA/38AAAAAAAAJAAAABAAAAAAAAAAeAAAAaAAAAAAAAAAAAAAAAAAAAAAAAAAAAAAAECcAABAnAAAAAAAAAAAAAAAAAAAAAAAAAAAAAAAAAAAAAAAAAAAAABQAAAAAAAAAwMD/AAAAAABkAAAAMgAAAAAAAABkAAAAAAAAAH9/fwAKAAAAIgAAABgAAAAAAAAAAAAAAAAAAAAAAAAAAAAAAAAAAAAkAAAAJAAAAAAAAAAHAAAAAAAAAAAAAAAAAAAAAAAAAAAAAAAAAAAAf39/ACUAAABYAAAAAAAAAAAAAAAAAAAAAAAAAAAAAAAAAAAAAAAAAAAAAAAAAAAAAAAAAAAAAAA/AAAAAAAAAKCGAQAAAAAAAAAAAAAAAAAMAAAAAQAAAAAAAAAAAAAAAAAAAB8AAABUAAAAAAAABQAAAAEAAAAAAAAAAAAAAAAAAAAAAAAAAAAAAAAAAAAAAAAAAAAAAAJ/f38AAAAAA8zMzADAwP8Af39/AAAAAAAAAAAAAAAAAAAAAAAAAAAAIQAAABgAAAAUAAAAwAMAANQIAABtHAAAsCUAABAAAAAmAAAACAAAAAGAAAAAAAAA"/>
+                <pr:smNativeData xmlns:pr="smNativeData" xmlns="smNativeData" val="SMDATA_15_ZqHWaRMAAAAlAAAAZAAAAA8BAAAAkAAAAEgAAACQAAAASAAAAAAAAAAAAAAAAAAAAAEAAABQAAAAAAAAAAAA4D8AAAAAAADgPwAAAAAAAOA/AAAAAAAA4D8AAAAAAADgPwAAAAAAAOA/AAAAAAAA4D8AAAAAAADgPwAAAAAAAOA/AAAAAAAA4D8CAAAAjAAAAAAAAAAAAAAAu+DjDP///wgAAAAAAAAAAAAAAAAAAAAAAAAAAAAAAAAAAAAAZAAAAAEAAABAAAAAAAAAAAAAAAAAAAAAAAAAAAAAAAAAAAAAAAAAAAAAAAAAAAAAAAAAAAAAAAAAAAAAAAAAAAAAAAAAAAAAAAAAAAAAAAAAAAAAAAAAAAAAAAAAAAAAFAAAADwAAAAAAAAAAAAAAAAAAAkUAAAAAQAAABQAAAAUAAAAFAAAAAEAAAAAAAAAZAAAAGQAAAAAAAAAZAAAAGQAAAAVAAAAYAAAAAAAAAAAAAAADwAAACADAAAAAAAAAAAAAAEAAACgMgAAVgcAAKr4//8BAAAAf39/AAEAAABkAAAAAAAAABQAAABAHwAAAAAAACYAAAAAAAAAwOD//wAAAAAmAAAAZAAAABYAAABMAAAAAAAAAAAAAAAEAAAAAAAAAAEAAACAgIAKAAAAACgAAAAoAAAAZAAAAGQAAAAAAAAAzMzMAAAAAABQAAAAUAAAAGQAAABkAAAAAAAAABcAAAAUAAAAAAAAAAAAAAD/fwAA/38AAAAAAAAJAAAABAAAAAAAAAAeAAAAaAAAAAAAAAAAAAAAAAAAAAAAAAAAAAAAECcAABAnAAAAAAAAAAAAAAAAAAAAAAAAAAAAAAAAAAAAAAAAAAAAABQAAAAAAAAAwMD/AAAAAABkAAAAMgAAAAAAAABkAAAAAAAAAH9/fwAKAAAAIgAAABgAAAAAAAAAAAAAAAAAAAAAAAAAAAAAAAAAAAAkAAAAJAAAAAAAAAAHAAAAAAAAAAAAAAAAAAAAAAAAAAAAAAAAAAAAf39/ACUAAABYAAAAAAAAAAAAAAAAAAAAAAAAAAAAAAAAAAAAAAAAAAAAAAAAAAAAAAAAAAAAAAA/AAAAAAAAAKCGAQAAAAAAAAAAAAAAAAAMAAAAAQAAAAAAAAAAAAAAAAAAAB8AAABUAAAAAAAABQAAAAEAAAAAAAAAAAAAAAAAAAAAAAAAAAAAAAAAAAAAAAAAAAAAAAJ/f38AAAAAA8zMzADAwP8Af39/AAAAAAAAAAAAAAAAAAAAAAAAAAAAIQAAABgAAAAUAAAAwAMAANQIAABtHAAAsCUAABAAAAAmAAAACAAAAAGAAAAAAAAA"/>
               </a:ext>
             </a:extLst>
           </p:cNvSpPr>
@@ -2390,7 +2390,7 @@
             <a:spLocks noGrp="1" noChangeArrowheads="1"/>
             <a:extLst>
               <a:ext uri="smNativeData">
-                <pr:smNativeData xmlns:pr="smNativeData" xmlns="smNativeData" val="SMDATA_15_7aDWaRMAAAAlAAAAZAAAAA8BAAAAkAAAAEgAAACQAAAASAAAAAAAAAABAAAAAAAAAAEAAABQAAAAAAAAAAAA4D8AAAAAAADgPwAAAAAAAOA/AAAAAAAA4D8AAAAAAADgPwAAAAAAAOA/AAAAAAAA4D8AAAAAAADgPwAAAAAAAOA/AAAAAAAA4D8CAAAAjAAAAAAAAAAAAAAAu+DjDP///wgAAAAAAAAAAAAAAAAAAAAAAAAAAAAAAAAAAAAAZAAAAAEAAABAAAAAAAAAAAAAAAAAAAAAAAAAAAAAAAAAAAAAAAAAAAAAAAAAAAAAAAAAAAAAAAAAAAAAAAAAAAAAAAAAAAAAAAAAAAAAAAAAAAAAAAAAAAAAAAAAAAAAFAAAADwAAAAAAAAAAAAAAAAAAAkUAAAAAQAAABQAAAAUAAAAFAAAAAEAAAAAAAAAZAAAAGQAAAAAAAAAZAAAAGQAAAAVAAAAYAAAAAAAAAAAAAAADwAAACADAAAAAAAAAAAAAAEAAACgMgAAVgcAAKr4//8BAAAAf39/AAEAAABkAAAAAAAAABQAAABAHwAAAAAAACYAAAAAAAAAwOD//wAAAAAmAAAAZAAAABYAAABMAAAAAAAAAAAAAAAEAAAAAAAAAAEAAACAgIAKAAAAACgAAAAoAAAAZAAAAGQAAAAAAAAAzMzMAAAAAABQAAAAUAAAAGQAAABkAAAAAAAAABcAAAAUAAAAAAAAAAAAAAD/fwAA/38AAAAAAAAJAAAABAAAAAAAAAAeAAAAaAAAAAAAAAAAAAAAAAAAAAAAAAAAAAAAECcAABAnAAAAAAAAAAAAAAAAAAAAAAAAAAAAAAAAAAAAAAAAAAAAABQAAAAAAAAAwMD/AAAAAABkAAAAMgAAAAAAAABkAAAAAAAAAH9/fwAKAAAAIgAAABgAAAAAAAAAAAAAAAAAAAAAAAAAAAAAAAAAAAAkAAAAJAAAAAAAAAAHAAAAAAAAAAAAAAAAAAAAAAAAAAAAAAAAAAAAf39/ACUAAABYAAAAAAAAAAAAAAAAAAAAAAAAAAAAAAAAAAAAAAAAAAAAAAAAAAAAAAAAAAAAAAA/AAAAAAAAAKCGAQAAAAAAAAAAAAAAAAAMAAAAAQAAAAAAAAAAAAAAAAAAAB8AAABUAAAAAAAABQAAAAEAAAAAAAAAAAAAAAAAAAAAAAAAAAAAAAAAAAAAAAAAAAAAAAJ/f38AAAAAA8zMzADAwP8Af39/AAAAAAAAAAAAAAAAAAAAAAAAAAAAIQAAABgAAAAUAAAAwAMAABsnAAA/FQAAWSkAABAAAAAmAAAACAAAAAAAAAAAAAAA"/>
+                <pr:smNativeData xmlns:pr="smNativeData" xmlns="smNativeData" val="SMDATA_15_ZqHWaRMAAAAlAAAAZAAAAA8BAAAAkAAAAEgAAACQAAAASAAAAAAAAAABAAAAAAAAAAEAAABQAAAAAAAAAAAA4D8AAAAAAADgPwAAAAAAAOA/AAAAAAAA4D8AAAAAAADgPwAAAAAAAOA/AAAAAAAA4D8AAAAAAADgPwAAAAAAAOA/AAAAAAAA4D8CAAAAjAAAAAAAAAAAAAAAu+DjDP///wgAAAAAAAAAAAAAAAAAAAAAAAAAAAAAAAAAAAAAZAAAAAEAAABAAAAAAAAAAAAAAAAAAAAAAAAAAAAAAAAAAAAAAAAAAAAAAAAAAAAAAAAAAAAAAAAAAAAAAAAAAAAAAAAAAAAAAAAAAAAAAAAAAAAAAAAAAAAAAAAAAAAAFAAAADwAAAAAAAAAAAAAAAAAAAkUAAAAAQAAABQAAAAUAAAAFAAAAAEAAAAAAAAAZAAAAGQAAAAAAAAAZAAAAGQAAAAVAAAAYAAAAAAAAAAAAAAADwAAACADAAAAAAAAAAAAAAEAAACgMgAAVgcAAKr4//8BAAAAf39/AAEAAABkAAAAAAAAABQAAABAHwAAAAAAACYAAAAAAAAAwOD//wAAAAAmAAAAZAAAABYAAABMAAAAAAAAAAAAAAAEAAAAAAAAAAEAAACAgIAKAAAAACgAAAAoAAAAZAAAAGQAAAAAAAAAzMzMAAAAAABQAAAAUAAAAGQAAABkAAAAAAAAABcAAAAUAAAAAAAAAAAAAAD/fwAA/38AAAAAAAAJAAAABAAAAAAAAAAeAAAAaAAAAAAAAAAAAAAAAAAAAAAAAAAAAAAAECcAABAnAAAAAAAAAAAAAAAAAAAAAAAAAAAAAAAAAAAAAAAAAAAAABQAAAAAAAAAwMD/AAAAAABkAAAAMgAAAAAAAABkAAAAAAAAAH9/fwAKAAAAIgAAABgAAAAAAAAAAAAAAAAAAAAAAAAAAAAAAAAAAAAkAAAAJAAAAAAAAAAHAAAAAAAAAAAAAAAAAAAAAAAAAAAAAAAAAAAAf39/ACUAAABYAAAAAAAAAAAAAAAAAAAAAAAAAAAAAAAAAAAAAAAAAAAAAAAAAAAAAAAAAAAAAAA/AAAAAAAAAKCGAQAAAAAAAAAAAAAAAAAMAAAAAQAAAAAAAAAAAAAAAAAAAB8AAABUAAAAAAAABQAAAAEAAAAAAAAAAAAAAAAAAAAAAAAAAAAAAAAAAAAAAAAAAAAAAAJ/f38AAAAAA8zMzADAwP8Af39/AAAAAAAAAAAAAAAAAAAAAAAAAAAAIQAAABgAAAAUAAAAwAMAABsnAAA/FQAAWSkAABAAAAAmAAAACAAAAAAAAAAAAAAA"/>
               </a:ext>
             </a:extLst>
           </p:cNvSpPr>
@@ -2404,7 +2404,7 @@
           <a:lstStyle/>
           <a:p>
             <a:pPr/>
-            <a:fld id="{21C0AF25-6BCC-9559-8278-9D0CE13674C8}" type="datetime1">
+            <a:fld id="{5FD72428-66B2-82D2-FC6F-90876A210AC5}" type="datetime1">
               <a:t/>
             </a:fld>
           </a:p>
@@ -2417,7 +2417,7 @@
             <a:spLocks noGrp="1" noChangeArrowheads="1"/>
             <a:extLst>
               <a:ext uri="smNativeData">
-                <pr:smNativeData xmlns:pr="smNativeData" xmlns="smNativeData" val="SMDATA_15_7aDWaRMAAAAlAAAAZAAAAA8BAAAAkAAAAEgAAACQAAAASAAAAAAAAAABAAAAAAAAAAEAAABQAAAAAAAAAAAA4D8AAAAAAADgPwAAAAAAAOA/AAAAAAAA4D8AAAAAAADgPwAAAAAAAOA/AAAAAAAA4D8AAAAAAADgPwAAAAAAAOA/AAAAAAAA4D8CAAAAjAAAAAAAAAAAAAAAu+DjDP///wgAAAAAAAAAAAAAAAAAAAAAAAAAAAAAAAAAAAAAZAAAAAEAAABAAAAAAAAAAAAAAAAAAAAAAAAAAAAAAAAAAAAAAAAAAAAAAAAAAAAAAAAAAAAAAAAAAAAAAAAAAAAAAAAAAAAAAAAAAAAAAAAAAAAAAAAAAAAAAAAAAAAAFAAAADwAAAAAAAAAAAAAAAAAAAkUAAAAAQAAABQAAAAUAAAAFAAAAAEAAAAAAAAAZAAAAGQAAAAAAAAAZAAAAGQAAAAVAAAAYAAAAAAAAAAAAAAADwAAACADAAAAAAAAAAAAAAEAAACgMgAAVgcAAKr4//8BAAAAf39/AAEAAABkAAAAAAAAABQAAABAHwAAAAAAACYAAAAAAAAAwOD//wAAAAAmAAAAZAAAABYAAABMAAAAAAAAAAAAAAAEAAAAAAAAAAEAAACAgIAKAAAAACgAAAAoAAAAZAAAAGQAAAAAAAAAzMzMAAAAAABQAAAAUAAAAGQAAABkAAAAAAAAABcAAAAUAAAAAAAAAAAAAAD/fwAA/38AAAAAAAAJAAAABAAAAHNwY0IeAAAAaAAAAAAAAAAAAAAAAAAAAAAAAAAAAAAAECcAABAnAAAAAAAAAAAAAAAAAAAAAAAAAAAAAAAAAAAAAAAAAAAAABQAAAAAAAAAwMD/AAAAAABkAAAAMgAAAAAAAABkAAAAAAAAAH9/fwAKAAAAIgAAABgAAAAAAAAAAAAAAAAAAAAAAAAAAAAAAAAAAAAkAAAAJAAAAAAAAAAHAAAAAAAAAAAAAAAAAAAAAAAAAAAAAAAAAAAAf39/ACUAAABYAAAAAAAAAAAAAAAAAAAAAAAAAAAAAAAAAAAAAAAAAAAAAAAAAAAAAAAAAAAAAAA/AAAAAAAAAKCGAQAAAAAAAAAAAAAAAAAMAAAAAQAAAAAAAAAAAAAAAAAAAB8AAABUAAAAAAAABQAAAAEAAAAAAAAAAAAAAAAAAAAAAAAAAAAAAAAAAAAAAAAAAAAAAAJ/f38AAAAAA8zMzADAwP8Af39/AAAAAAAAAAAAAAAAAAAAAAAAAAAAIQAAABgAAAAUAAAAoRkAABsnAABfMQAAWSkAABAAAAAmAAAACAAAAAAAAAAAAAAA"/>
+                <pr:smNativeData xmlns:pr="smNativeData" xmlns="smNativeData" val="SMDATA_15_ZqHWaRMAAAAlAAAAZAAAAA8BAAAAkAAAAEgAAACQAAAASAAAAAAAAAABAAAAAAAAAAEAAABQAAAAAAAAAAAA4D8AAAAAAADgPwAAAAAAAOA/AAAAAAAA4D8AAAAAAADgPwAAAAAAAOA/AAAAAAAA4D8AAAAAAADgPwAAAAAAAOA/AAAAAAAA4D8CAAAAjAAAAAAAAAAAAAAAu+DjDP///wgAAAAAAAAAAAAAAAAAAAAAAAAAAAAAAAAAAAAAZAAAAAEAAABAAAAAAAAAAAAAAAAAAAAAAAAAAAAAAAAAAAAAAAAAAAAAAAAAAAAAAAAAAAAAAAAAAAAAAAAAAAAAAAAAAAAAAAAAAAAAAAAAAAAAAAAAAAAAAAAAAAAAFAAAADwAAAAAAAAAAAAAAAAAAAkUAAAAAQAAABQAAAAUAAAAFAAAAAEAAAAAAAAAZAAAAGQAAAAAAAAAZAAAAGQAAAAVAAAAYAAAAAAAAAAAAAAADwAAACADAAAAAAAAAAAAAAEAAACgMgAAVgcAAKr4//8BAAAAf39/AAEAAABkAAAAAAAAABQAAABAHwAAAAAAACYAAAAAAAAAwOD//wAAAAAmAAAAZAAAABYAAABMAAAAAAAAAAAAAAAEAAAAAAAAAAEAAACAgIAKAAAAACgAAAAoAAAAZAAAAGQAAAAAAAAAzMzMAAAAAABQAAAAUAAAAGQAAABkAAAAAAAAABcAAAAUAAAAAAAAAAAAAAD/fwAA/38AAAAAAAAJAAAABAAAAHNwY0IeAAAAaAAAAAAAAAAAAAAAAAAAAAAAAAAAAAAAECcAABAnAAAAAAAAAAAAAAAAAAAAAAAAAAAAAAAAAAAAAAAAAAAAABQAAAAAAAAAwMD/AAAAAABkAAAAMgAAAAAAAABkAAAAAAAAAH9/fwAKAAAAIgAAABgAAAAAAAAAAAAAAAAAAAAAAAAAAAAAAAAAAAAkAAAAJAAAAAAAAAAHAAAAAAAAAAAAAAAAAAAAAAAAAAAAAAAAAAAAf39/ACUAAABYAAAAAAAAAAAAAAAAAAAAAAAAAAAAAAAAAAAAAAAAAAAAAAAAAAAAAAAAAAAAAAA/AAAAAAAAAKCGAQAAAAAAAAAAAAAAAAAMAAAAAQAAAAAAAAAAAAAAAAAAAB8AAABUAAAAAAAABQAAAAEAAAAAAAAAAAAAAAAAAAAAAAAAAAAAAAAAAAAAAAAAAAAAAAJ/f38AAAAAA8zMzADAwP8Af39/AAAAAAAAAAAAAAAAAAAAAAAAAAAAIQAAABgAAAAUAAAAoRkAABsnAABfMQAAWSkAABAAAAAmAAAACAAAAAAAAAAAAAAA"/>
               </a:ext>
             </a:extLst>
           </p:cNvSpPr>
@@ -2441,7 +2441,7 @@
             <a:spLocks noGrp="1" noChangeArrowheads="1"/>
             <a:extLst>
               <a:ext uri="smNativeData">
-                <pr:smNativeData xmlns:pr="smNativeData" xmlns="smNativeData" val="SMDATA_15_7aDWaRMAAAAlAAAAZAAAAA8BAAAAkAAAAEgAAACQAAAASAAAAAAAAAABAAAAAAAAAAEAAABQAAAAAAAAAAAA4D8AAAAAAADgPwAAAAAAAOA/AAAAAAAA4D8AAAAAAADgPwAAAAAAAOA/AAAAAAAA4D8AAAAAAADgPwAAAAAAAOA/AAAAAAAA4D8CAAAAjAAAAAAAAAAAAAAAu+DjDP///wgAAAAAAAAAAAAAAAAAAAAAAAAAAAAAAAAAAAAAZAAAAAEAAABAAAAAAAAAAAAAAAAAAAAAAAAAAAAAAAAAAAAAAAAAAAAAAAAAAAAAAAAAAAAAAAAAAAAAAAAAAAAAAAAAAAAAAAAAAAAAAAAAAAAAAAAAAAAAAAAAAAAAFAAAADwAAAAAAAAAAAAAAAAAAAkUAAAAAQAAABQAAAAUAAAAFAAAAAEAAAAAAAAAZAAAAGQAAAAAAAAAZAAAAGQAAAAVAAAAYAAAAAAAAAAAAAAADwAAACADAAAAAAAAAAAAAAEAAACgMgAAVgcAAKr4//8BAAAAf39/AAEAAABkAAAAAAAAABQAAABAHwAAAAAAACYAAAAAAAAAwOD//wAAAAAmAAAAZAAAABYAAABMAAAAAAAAAAAAAAAEAAAAAAAAAAEAAACAgIAKAAAAACgAAAAoAAAAZAAAAGQAAAAAAAAAzMzMAAAAAABQAAAAUAAAAGQAAABkAAAAAAAAABcAAAAUAAAAAAAAAAAAAAD/fwAA/38AAAAAAAAJAAAABAAAAAAAAAAeAAAAaAAAAAAAAAAAAAAAAAAAAAAAAAAAAAAAECcAABAnAAAAAAAAAAAAAAAAAAAAAAAAAAAAAAAAAAAAAAAAAAAAABQAAAAAAAAAwMD/AAAAAABkAAAAMgAAAAAAAABkAAAAAAAAAH9/fwAKAAAAIgAAABgAAAAAAAAAAAAAAAAAAAAAAAAAAAAAAAAAAAAkAAAAJAAAAAAAAAAHAAAAAAAAAAAAAAAAAAAAAAAAAAAAAAAAAAAAf39/ACUAAABYAAAAAAAAAAAAAAAAAAAAAAAAAAAAAAAAAAAAAAAAAAAAAAAAAAAAAAAAAAAAAAA/AAAAAAAAAKCGAQAAAAAAAAAAAAAAAAAMAAAAAQAAAAAAAAAAAAAAAAAAAB8AAABUAAAAAAAABQAAAAEAAAAAAAAAAAAAAAAAAAAAAAAAAAAAAAAAAAAAAAAAAAAAAAJ/f38AAAAAA8zMzADAwP8Af39/AAAAAAAAAAAAAAAAAAAAAAAAAAAAIQAAABgAAAAUAAAAwTUAABsnAABARwAAWSkAABAAAAAmAAAACAAAAAAAAAAAAAAA"/>
+                <pr:smNativeData xmlns:pr="smNativeData" xmlns="smNativeData" val="SMDATA_15_ZqHWaRMAAAAlAAAAZAAAAA8BAAAAkAAAAEgAAACQAAAASAAAAAAAAAABAAAAAAAAAAEAAABQAAAAAAAAAAAA4D8AAAAAAADgPwAAAAAAAOA/AAAAAAAA4D8AAAAAAADgPwAAAAAAAOA/AAAAAAAA4D8AAAAAAADgPwAAAAAAAOA/AAAAAAAA4D8CAAAAjAAAAAAAAAAAAAAAu+DjDP///wgAAAAAAAAAAAAAAAAAAAAAAAAAAAAAAAAAAAAAZAAAAAEAAABAAAAAAAAAAAAAAAAAAAAAAAAAAAAAAAAAAAAAAAAAAAAAAAAAAAAAAAAAAAAAAAAAAAAAAAAAAAAAAAAAAAAAAAAAAAAAAAAAAAAAAAAAAAAAAAAAAAAAFAAAADwAAAAAAAAAAAAAAAAAAAkUAAAAAQAAABQAAAAUAAAAFAAAAAEAAAAAAAAAZAAAAGQAAAAAAAAAZAAAAGQAAAAVAAAAYAAAAAAAAAAAAAAADwAAACADAAAAAAAAAAAAAAEAAACgMgAAVgcAAKr4//8BAAAAf39/AAEAAABkAAAAAAAAABQAAABAHwAAAAAAACYAAAAAAAAAwOD//wAAAAAmAAAAZAAAABYAAABMAAAAAAAAAAAAAAAEAAAAAAAAAAEAAACAgIAKAAAAACgAAAAoAAAAZAAAAGQAAAAAAAAAzMzMAAAAAABQAAAAUAAAAGQAAABkAAAAAAAAABcAAAAUAAAAAAAAAAAAAAD/fwAA/38AAAAAAAAJAAAABAAAAAAAAAAeAAAAaAAAAAAAAAAAAAAAAAAAAAAAAAAAAAAAECcAABAnAAAAAAAAAAAAAAAAAAAAAAAAAAAAAAAAAAAAAAAAAAAAABQAAAAAAAAAwMD/AAAAAABkAAAAMgAAAAAAAABkAAAAAAAAAH9/fwAKAAAAIgAAABgAAAAAAAAAAAAAAAAAAAAAAAAAAAAAAAAAAAAkAAAAJAAAAAAAAAAHAAAAAAAAAAAAAAAAAAAAAAAAAAAAAAAAAAAAf39/ACUAAABYAAAAAAAAAAAAAAAAAAAAAAAAAAAAAAAAAAAAAAAAAAAAAAAAAAAAAAAAAAAAAAA/AAAAAAAAAKCGAQAAAAAAAAAAAAAAAAAMAAAAAQAAAAAAAAAAAAAAAAAAAB8AAABUAAAAAAAABQAAAAEAAAAAAAAAAAAAAAAAAAAAAAAAAAAAAAAAAAAAAAAAAAAAAAJ/f38AAAAAA8zMzADAwP8Af39/AAAAAAAAAAAAAAAAAAAAAAAAAAAAIQAAABgAAAAUAAAAwTUAABsnAABARwAAWSkAABAAAAAmAAAACAAAAAAAAAAAAAAA"/>
               </a:ext>
             </a:extLst>
           </p:cNvSpPr>
@@ -2455,7 +2455,7 @@
           <a:lstStyle/>
           <a:p>
             <a:pPr/>
-            <a:fld id="{65B799D9-9788-E26F-C60F-613AD7413034}" type="slidenum">
+            <a:fld id="{118205C8-86FC-D7F3-B23A-70A64B744425}" type="slidenum">
               <a:t/>
             </a:fld>
           </a:p>
@@ -2494,7 +2494,7 @@
             <a:spLocks noGrp="1" noChangeArrowheads="1"/>
             <a:extLst>
               <a:ext uri="smNativeData">
-                <pr:smNativeData xmlns:pr="smNativeData" xmlns="smNativeData" val="SMDATA_15_7aDWaRMAAAAlAAAAZAAAAA8BAAAAkAAAAEgAAACQAAAASAAAAAAAAAACAAAAAAAAAAEAAABQAAAAAAAAAAAA4D8AAAAAAADgPwAAAAAAAOA/AAAAAAAA4D8AAAAAAADgPwAAAAAAAOA/AAAAAAAA4D8AAAAAAADgPwAAAAAAAOA/AAAAAAAA4D8CAAAAjAAAAAAAAAAAAAAAu+DjDP///wgAAAAAAAAAAAAAAAAAAAAAAAAAAAAAAAAAAAAAZAAAAAEAAABAAAAAAAAAAAAAAAAAAAAAAAAAAAAAAAAAAAAAAAAAAAAAAAAAAAAAAAAAAAAAAAAAAAAAAAAAAAAAAAAAAAAAAAAAAAAAAAAAAAAAAAAAAAAAAAAAAAAAFAAAADwAAAAAAAAAAAAAAAAAAAkUAAAAAQAAABQAAAAUAAAAFAAAAAEAAAAAAAAAZAAAAGQAAAAAAAAAZAAAAGQAAAAVAAAAYAAAAAAAAAAAAAAADwAAACADAAAAAAAAAAAAAAEAAACgMgAAVgcAAKr4//8BAAAAf39/AAEAAABkAAAAAAAAABQAAABAHwAAAAAAACYAAAAAAAAAwOD//wAAAAAmAAAAZAAAABYAAABMAAAAAAAAAAAAAAAEAAAAAAAAAAEAAACAgIAKAAAAACgAAAAoAAAAZAAAAGQAAAAAAAAAzMzMAAAAAABQAAAAUAAAAGQAAABkAAAAAAAAABcAAAAUAAAAAAAAAAAAAAD/fwAA/38AAAAAAAAJAAAABAAAAAAAAAAeAAAAaAAAAAAAAAAAAAAAAAAAAAAAAAAAAAAAECcAABAnAAAAAAAAAAAAAAAAAAAAAAAAAAAAAAAAAAAAAAAAAAAAABQAAAAAAAAAwMD/AAAAAABkAAAAMgAAAAAAAABkAAAAAAAAAH9/fwAKAAAAIgAAABgAAAAAAAAAAAAAAAAAAAAAAAAAAAAAAAAAAAAkAAAAJAAAAAAAAAAHAAAAAAAAAAAAAAAAAAAAAAAAAAAAAAAAAAAAf39/ACUAAABYAAAAAAAAAAAAAAAAAAAAAAAAAAAAAAAAAAAAAAAAAAAAAAAAAAAAAAAAAAAAAAA/AAAAAAAAAKCGAQAAAAAAAAAAAAAAAAAMAAAAAQAAAAAAAAAAAAAAAAAAAB8AAABUAAAAAAAABQAAAAEAAAAAAAAAAAAAAAAAAAAAAAAAAAAAAAAAAAAAAAAAAAAAAAJ/f38AAAAAA8zMzADAwP8Af39/AAAAAAAAAAAAAAAAAAAAAAAAAAAAIQAAABgAAAAUAAAAsw4AAIgdAACzOwAABCEAABAAAAAmAAAACAAAAIGAAAAAAAAA"/>
+                <pr:smNativeData xmlns:pr="smNativeData" xmlns="smNativeData" val="SMDATA_15_ZqHWaRMAAAAlAAAAZAAAAA8BAAAAkAAAAEgAAACQAAAASAAAAAAAAAACAAAAAAAAAAEAAABQAAAAAAAAAAAA4D8AAAAAAADgPwAAAAAAAOA/AAAAAAAA4D8AAAAAAADgPwAAAAAAAOA/AAAAAAAA4D8AAAAAAADgPwAAAAAAAOA/AAAAAAAA4D8CAAAAjAAAAAAAAAAAAAAAu+DjDP///wgAAAAAAAAAAAAAAAAAAAAAAAAAAAAAAAAAAAAAZAAAAAEAAABAAAAAAAAAAAAAAAAAAAAAAAAAAAAAAAAAAAAAAAAAAAAAAAAAAAAAAAAAAAAAAAAAAAAAAAAAAAAAAAAAAAAAAAAAAAAAAAAAAAAAAAAAAAAAAAAAAAAAFAAAADwAAAAAAAAAAAAAAAAAAAkUAAAAAQAAABQAAAAUAAAAFAAAAAEAAAAAAAAAZAAAAGQAAAAAAAAAZAAAAGQAAAAVAAAAYAAAAAAAAAAAAAAADwAAACADAAAAAAAAAAAAAAEAAACgMgAAVgcAAKr4//8BAAAAf39/AAEAAABkAAAAAAAAABQAAABAHwAAAAAAACYAAAAAAAAAwOD//wAAAAAmAAAAZAAAABYAAABMAAAAAAAAAAAAAAAEAAAAAAAAAAEAAACAgIAKAAAAACgAAAAoAAAAZAAAAGQAAAAAAAAAzMzMAAAAAABQAAAAUAAAAGQAAABkAAAAAAAAABcAAAAUAAAAAAAAAAAAAAD/fwAA/38AAAAAAAAJAAAABAAAAAAAAAAeAAAAaAAAAAAAAAAAAAAAAAAAAAAAAAAAAAAAECcAABAnAAAAAAAAAAAAAAAAAAAAAAAAAAAAAAAAAAAAAAAAAAAAABQAAAAAAAAAwMD/AAAAAABkAAAAMgAAAAAAAABkAAAAAAAAAH9/fwAKAAAAIgAAABgAAAAAAAAAAAAAAAAAAAAAAAAAAAAAAAAAAAAkAAAAJAAAAAAAAAAHAAAAAAAAAAAAAAAAAAAAAAAAAAAAAAAAAAAAf39/ACUAAABYAAAAAAAAAAAAAAAAAAAAAAAAAAAAAAAAAAAAAAAAAAAAAAAAAAAAAAAAAAAAAAA/AAAAAAAAAKCGAQAAAAAAAAAAAAAAAAAMAAAAAQAAAAAAAAAAAAAAAAAAAB8AAABUAAAAAAAABQAAAAEAAAAAAAAAAAAAAAAAAAAAAAAAAAAAAAAAAAAAAAAAAAAAAAJ/f38AAAAAA8zMzADAwP8Af39/AAAAAAAAAAAAAAAAAAAAAAAAAAAAIQAAABgAAAAUAAAAsw4AAIgdAACzOwAABCEAABAAAAAmAAAACAAAAIGAAAAAAAAA"/>
               </a:ext>
             </a:extLst>
           </p:cNvSpPr>
@@ -2534,7 +2534,7 @@
             <a:spLocks noGrp="1" noChangeArrowheads="1"/>
             <a:extLst>
               <a:ext uri="smNativeData">
-                <pr:smNativeData xmlns:pr="smNativeData" xmlns="smNativeData" val="SMDATA_15_7aDWaRMAAAAlAAAAZAAAAA8BAAAAkAAAAEgAAACQAAAASAAAAAAAAAAAAAAAAAAAAAEAAABQAAAAAAAAAAAA4D8AAAAAAADgPwAAAAAAAOA/AAAAAAAA4D8AAAAAAADgPwAAAAAAAOA/AAAAAAAA4D8AAAAAAADgPwAAAAAAAOA/AAAAAAAA4D8CAAAAjAAAAAAAAAAAAAAAu+DjDP///wgAAAAAAAAAAAAAAAAAAAAAAAAAAAAAAAAAAAAAZAAAAAEAAABAAAAAAAAAAAAAAAAAAAAAAAAAAAAAAAAAAAAAAAAAAAAAAAAAAAAAAAAAAAAAAAAAAAAAAAAAAAAAAAAAAAAAAAAAAAAAAAAAAAAAAAAAAAAAAAAAAAAAFAAAADwAAAAAAAAAAAAAAAAAAAkUAAAAAQAAABQAAAAUAAAAFAAAAAEAAAAAAAAAZAAAAGQAAAAAAAAAZAAAAGQAAAAVAAAAYAAAAAAAAAAAAAAADwAAACADAAAAAAAAAAAAAAEAAACgMgAAVgcAAKr4//8BAAAAf39/AAEAAABkAAAAAAAAABQAAABAHwAAAAAAACYAAAAAAAAAwOD//wAAAAAmAAAAZAAAABYAAABMAAAAAAAAAAAAAAAEAAAAAAAAAAEAAACAgIAKAAAAACgAAAAoAAAAZAAAAGQAAAAAAAAAzMzMAAAAAABQAAAAUAAAAGQAAABkAAAAAAAAABcAAAAUAAAAAAAAAAAAAAD/fwAA/38AAAAAAAAJAAAABAAAAAAAAAAeAAAAaAAAAAAAAAAAAAAAAAAAAAAAAAAAAAAAECcAABAnAAAAAAAAAAAAAAAAAAAAAAAAAAAAAAAAAAAAAAAAAAAAABQAAAAAAAAAwMD/AAAAAABkAAAAMgAAAAAAAABkAAAAAAAAAH9/fwAKAAAAIgAAABgAAAAAAAAAAAAAAAAAAAAAAAAAAAAAAAAAAAAkAAAAJAAAAAAAAAAHAAAAAAAAAAAAAAAAAAAAAAAAAAAAAAAAAAAAf39/ACUAAABYAAAAAAAAAAAAAAAAAAAAAAAAAAAAAAAAAAAAAAAAAAAAAAAAAAAAAAAAAAAAAAA/AAAAAAAAAKCGAQAAAAAAAAAAAAAAAAAMAAAAAQAAAAAAAAAAAAAAAAAAAB8AAABUAAAAAAAABQAAAAEAAAAAAAAAAAAAAAAAAAAAAAAAAAAAAAAAAAAAAAAAAAAAAAJ/f38AAAAAA8zMzADAwP8Af39/AAAAAAAAAAAAAAAAAAAAAAAAAAAAIQAAABgAAAAUAAAAsw4AAMYDAACzOwAAFh0AABAAAAAmAAAACAAAAAGAAAAAAAAA"/>
+                <pr:smNativeData xmlns:pr="smNativeData" xmlns="smNativeData" val="SMDATA_15_ZqHWaRMAAAAlAAAAZAAAAA8BAAAAkAAAAEgAAACQAAAASAAAAAAAAAAAAAAAAAAAAAEAAABQAAAAAAAAAAAA4D8AAAAAAADgPwAAAAAAAOA/AAAAAAAA4D8AAAAAAADgPwAAAAAAAOA/AAAAAAAA4D8AAAAAAADgPwAAAAAAAOA/AAAAAAAA4D8CAAAAjAAAAAAAAAAAAAAAu+DjDP///wgAAAAAAAAAAAAAAAAAAAAAAAAAAAAAAAAAAAAAZAAAAAEAAABAAAAAAAAAAAAAAAAAAAAAAAAAAAAAAAAAAAAAAAAAAAAAAAAAAAAAAAAAAAAAAAAAAAAAAAAAAAAAAAAAAAAAAAAAAAAAAAAAAAAAAAAAAAAAAAAAAAAAFAAAADwAAAAAAAAAAAAAAAAAAAkUAAAAAQAAABQAAAAUAAAAFAAAAAEAAAAAAAAAZAAAAGQAAAAAAAAAZAAAAGQAAAAVAAAAYAAAAAAAAAAAAAAADwAAACADAAAAAAAAAAAAAAEAAACgMgAAVgcAAKr4//8BAAAAf39/AAEAAABkAAAAAAAAABQAAABAHwAAAAAAACYAAAAAAAAAwOD//wAAAAAmAAAAZAAAABYAAABMAAAAAAAAAAAAAAAEAAAAAAAAAAEAAACAgIAKAAAAACgAAAAoAAAAZAAAAGQAAAAAAAAAzMzMAAAAAABQAAAAUAAAAGQAAABkAAAAAAAAABcAAAAUAAAAAAAAAAAAAAD/fwAA/38AAAAAAAAJAAAABAAAAAAAAAAeAAAAaAAAAAAAAAAAAAAAAAAAAAAAAAAAAAAAECcAABAnAAAAAAAAAAAAAAAAAAAAAAAAAAAAAAAAAAAAAAAAAAAAABQAAAAAAAAAwMD/AAAAAABkAAAAMgAAAAAAAABkAAAAAAAAAH9/fwAKAAAAIgAAABgAAAAAAAAAAAAAAAAAAAAAAAAAAAAAAAAAAAAkAAAAJAAAAAAAAAAHAAAAAAAAAAAAAAAAAAAAAAAAAAAAAAAAAAAAf39/ACUAAABYAAAAAAAAAAAAAAAAAAAAAAAAAAAAAAAAAAAAAAAAAAAAAAAAAAAAAAAAAAAAAAA/AAAAAAAAAKCGAQAAAAAAAAAAAAAAAAAMAAAAAQAAAAAAAAAAAAAAAAAAAB8AAABUAAAAAAAABQAAAAEAAAAAAAAAAAAAAAAAAAAAAAAAAAAAAAAAAAAAAAAAAAAAAAJ/f38AAAAAA8zMzADAwP8Af39/AAAAAAAAAAAAAAAAAAAAAAAAAAAAIQAAABgAAAAUAAAAsw4AAMYDAACzOwAAFh0AABAAAAAmAAAACAAAAAGAAAAAAAAA"/>
               </a:ext>
             </a:extLst>
           </p:cNvSpPr>
@@ -2603,7 +2603,7 @@
             <a:spLocks noGrp="1" noChangeArrowheads="1"/>
             <a:extLst>
               <a:ext uri="smNativeData">
-                <pr:smNativeData xmlns:pr="smNativeData" xmlns="smNativeData" val="SMDATA_15_7aDWaRMAAAAlAAAAZAAAAA8BAAAAkAAAAEgAAACQAAAASAAAAAAAAAAAAAAAAAAAAAEAAABQAAAAAAAAAAAA4D8AAAAAAADgPwAAAAAAAOA/AAAAAAAA4D8AAAAAAADgPwAAAAAAAOA/AAAAAAAA4D8AAAAAAADgPwAAAAAAAOA/AAAAAAAA4D8CAAAAjAAAAAAAAAAAAAAAu+DjDP///wgAAAAAAAAAAAAAAAAAAAAAAAAAAAAAAAAAAAAAZAAAAAEAAABAAAAAAAAAAAAAAAAAAAAAAAAAAAAAAAAAAAAAAAAAAAAAAAAAAAAAAAAAAAAAAAAAAAAAAAAAAAAAAAAAAAAAAAAAAAAAAAAAAAAAAAAAAAAAAAAAAAAAFAAAADwAAAAAAAAAAAAAAAAAAAkUAAAAAQAAABQAAAAUAAAAFAAAAAEAAAAAAAAAZAAAAGQAAAAAAAAAZAAAAGQAAAAVAAAAYAAAAAAAAAAAAAAADwAAACADAAAAAAAAAAAAAAEAAACgMgAAVgcAAKr4//8BAAAAf39/AAEAAABkAAAAAAAAABQAAABAHwAAAAAAACYAAAAAAAAAwOD//wAAAAAmAAAAZAAAABYAAABMAAAAAAAAAAAAAAAEAAAAAAAAAAEAAACAgIAKAAAAACgAAAAoAAAAZAAAAGQAAAAAAAAAzMzMAAAAAABQAAAAUAAAAGQAAABkAAAAAAAAABcAAAAUAAAAAAAAAAAAAAD/fwAA/38AAAAAAAAJAAAABAAAAAAAAAAeAAAAaAAAAAAAAAAAAAAAAAAAAAAAAAAAAAAAECcAABAnAAAAAAAAAAAAAAAAAAAAAAAAAAAAAAAAAAAAAAAAAAAAABQAAAAAAAAAwMD/AAAAAABkAAAAMgAAAAAAAABkAAAAAAAAAH9/fwAKAAAAIgAAABgAAAAAAAAAAAAAAAAAAAAAAAAAAAAAAAAAAAAkAAAAJAAAAAAAAAAHAAAAAAAAAAAAAAAAAAAAAAAAAAAAAAAAAAAAf39/ACUAAABYAAAAAAAAAAAAAAAAAAAAAAAAAAAAAAAAAAAAAAAAAAAAAAAAAAAAAAAAAAAAAAA/AAAAAAAAAKCGAQAAAAAAAAAAAAAAAAAMAAAAAQAAAAAAAAAAAAAAAAAAAB8AAABUAAAAAAAABQAAAAEAAAAAAAAAAAAAAAAAAAAAAAAAAAAAAAAAAAAAAAAAAAAAAAJ/f38AAAAAA8zMzADAwP8Af39/AAAAAAAAAAAAAAAAAAAAAAAAAAAAIQAAABgAAAAUAAAAsw4AAAQhAACzOwAA+CUAABAAAAAmAAAACAAAAAGAAAAAAAAA"/>
+                <pr:smNativeData xmlns:pr="smNativeData" xmlns="smNativeData" val="SMDATA_15_ZqHWaRMAAAAlAAAAZAAAAA8BAAAAkAAAAEgAAACQAAAASAAAAAAAAAAAAAAAAAAAAAEAAABQAAAAAAAAAAAA4D8AAAAAAADgPwAAAAAAAOA/AAAAAAAA4D8AAAAAAADgPwAAAAAAAOA/AAAAAAAA4D8AAAAAAADgPwAAAAAAAOA/AAAAAAAA4D8CAAAAjAAAAAAAAAAAAAAAu+DjDP///wgAAAAAAAAAAAAAAAAAAAAAAAAAAAAAAAAAAAAAZAAAAAEAAABAAAAAAAAAAAAAAAAAAAAAAAAAAAAAAAAAAAAAAAAAAAAAAAAAAAAAAAAAAAAAAAAAAAAAAAAAAAAAAAAAAAAAAAAAAAAAAAAAAAAAAAAAAAAAAAAAAAAAFAAAADwAAAAAAAAAAAAAAAAAAAkUAAAAAQAAABQAAAAUAAAAFAAAAAEAAAAAAAAAZAAAAGQAAAAAAAAAZAAAAGQAAAAVAAAAYAAAAAAAAAAAAAAADwAAACADAAAAAAAAAAAAAAEAAACgMgAAVgcAAKr4//8BAAAAf39/AAEAAABkAAAAAAAAABQAAABAHwAAAAAAACYAAAAAAAAAwOD//wAAAAAmAAAAZAAAABYAAABMAAAAAAAAAAAAAAAEAAAAAAAAAAEAAACAgIAKAAAAACgAAAAoAAAAZAAAAGQAAAAAAAAAzMzMAAAAAABQAAAAUAAAAGQAAABkAAAAAAAAABcAAAAUAAAAAAAAAAAAAAD/fwAA/38AAAAAAAAJAAAABAAAAAAAAAAeAAAAaAAAAAAAAAAAAAAAAAAAAAAAAAAAAAAAECcAABAnAAAAAAAAAAAAAAAAAAAAAAAAAAAAAAAAAAAAAAAAAAAAABQAAAAAAAAAwMD/AAAAAABkAAAAMgAAAAAAAABkAAAAAAAAAH9/fwAKAAAAIgAAABgAAAAAAAAAAAAAAAAAAAAAAAAAAAAAAAAAAAAkAAAAJAAAAAAAAAAHAAAAAAAAAAAAAAAAAAAAAAAAAAAAAAAAAAAAf39/ACUAAABYAAAAAAAAAAAAAAAAAAAAAAAAAAAAAAAAAAAAAAAAAAAAAAAAAAAAAAAAAAAAAAA/AAAAAAAAAKCGAQAAAAAAAAAAAAAAAAAMAAAAAQAAAAAAAAAAAAAAAAAAAB8AAABUAAAAAAAABQAAAAEAAAAAAAAAAAAAAAAAAAAAAAAAAAAAAAAAAAAAAAAAAAAAAAJ/f38AAAAAA8zMzADAwP8Af39/AAAAAAAAAAAAAAAAAAAAAAAAAAAAIQAAABgAAAAUAAAAsw4AAAQhAACzOwAA+CUAABAAAAAmAAAACAAAAAGAAAAAAAAA"/>
               </a:ext>
             </a:extLst>
           </p:cNvSpPr>
@@ -2672,7 +2672,7 @@
             <a:spLocks noGrp="1" noChangeArrowheads="1"/>
             <a:extLst>
               <a:ext uri="smNativeData">
-                <pr:smNativeData xmlns:pr="smNativeData" xmlns="smNativeData" val="SMDATA_15_7aDWaRMAAAAlAAAAZAAAAA8BAAAAkAAAAEgAAACQAAAASAAAAAAAAAABAAAAAAAAAAEAAABQAAAAAAAAAAAA4D8AAAAAAADgPwAAAAAAAOA/AAAAAAAA4D8AAAAAAADgPwAAAAAAAOA/AAAAAAAA4D8AAAAAAADgPwAAAAAAAOA/AAAAAAAA4D8CAAAAjAAAAAAAAAAAAAAAu+DjDP///wgAAAAAAAAAAAAAAAAAAAAAAAAAAAAAAAAAAAAAZAAAAAEAAABAAAAAAAAAAAAAAAAAAAAAAAAAAAAAAAAAAAAAAAAAAAAAAAAAAAAAAAAAAAAAAAAAAAAAAAAAAAAAAAAAAAAAAAAAAAAAAAAAAAAAAAAAAAAAAAAAAAAAFAAAADwAAAAAAAAAAAAAAAAAAAkUAAAAAQAAABQAAAAUAAAAFAAAAAEAAAAAAAAAZAAAAGQAAAAAAAAAZAAAAGQAAAAVAAAAYAAAAAAAAAAAAAAADwAAACADAAAAAAAAAAAAAAEAAACgMgAAVgcAAKr4//8BAAAAf39/AAEAAABkAAAAAAAAABQAAABAHwAAAAAAACYAAAAAAAAAwOD//wAAAAAmAAAAZAAAABYAAABMAAAAAAAAAAAAAAAEAAAAAAAAAAEAAACAgIAKAAAAACgAAAAoAAAAZAAAAGQAAAAAAAAAzMzMAAAAAABQAAAAUAAAAGQAAABkAAAAAAAAABcAAAAUAAAAAAAAAAAAAAD/fwAA/38AAAAAAAAJAAAABAAAAAAAAAAeAAAAaAAAAAAAAAAAAAAAAAAAAAAAAAAAAAAAECcAABAnAAAAAAAAAAAAAAAAAAAAAAAAAAAAAAAAAAAAAAAAAAAAABQAAAAAAAAAwMD/AAAAAABkAAAAMgAAAAAAAABkAAAAAAAAAH9/fwAKAAAAIgAAABgAAAAAAAAAAAAAAAAAAAAAAAAAAAAAAAAAAAAkAAAAJAAAAAAAAAAHAAAAAAAAAAAAAAAAAAAAAAAAAAAAAAAAAAAAf39/ACUAAABYAAAAAAAAAAAAAAAAAAAAAAAAAAAAAAAAAAAAAAAAAAAAAAAAAAAAAAAAAAAAAAA/AAAAAAAAAKCGAQAAAAAAAAAAAAAAAAAMAAAAAQAAAAAAAAAAAAAAAAAAAB8AAABUAAAAAAAABQAAAAEAAAAAAAAAAAAAAAAAAAAAAAAAAAAAAAAAAAAAAAAAAAAAAAJ/f38AAAAAA8zMzADAwP8Af39/AAAAAAAAAAAAAAAAAAAAAAAAAAAAIQAAABgAAAAUAAAAwAMAABsnAAA/FQAAWSkAABAAAAAmAAAACAAAAAAAAAAAAAAA"/>
+                <pr:smNativeData xmlns:pr="smNativeData" xmlns="smNativeData" val="SMDATA_15_ZqHWaRMAAAAlAAAAZAAAAA8BAAAAkAAAAEgAAACQAAAASAAAAAAAAAABAAAAAAAAAAEAAABQAAAAAAAAAAAA4D8AAAAAAADgPwAAAAAAAOA/AAAAAAAA4D8AAAAAAADgPwAAAAAAAOA/AAAAAAAA4D8AAAAAAADgPwAAAAAAAOA/AAAAAAAA4D8CAAAAjAAAAAAAAAAAAAAAu+DjDP///wgAAAAAAAAAAAAAAAAAAAAAAAAAAAAAAAAAAAAAZAAAAAEAAABAAAAAAAAAAAAAAAAAAAAAAAAAAAAAAAAAAAAAAAAAAAAAAAAAAAAAAAAAAAAAAAAAAAAAAAAAAAAAAAAAAAAAAAAAAAAAAAAAAAAAAAAAAAAAAAAAAAAAFAAAADwAAAAAAAAAAAAAAAAAAAkUAAAAAQAAABQAAAAUAAAAFAAAAAEAAAAAAAAAZAAAAGQAAAAAAAAAZAAAAGQAAAAVAAAAYAAAAAAAAAAAAAAADwAAACADAAAAAAAAAAAAAAEAAACgMgAAVgcAAKr4//8BAAAAf39/AAEAAABkAAAAAAAAABQAAABAHwAAAAAAACYAAAAAAAAAwOD//wAAAAAmAAAAZAAAABYAAABMAAAAAAAAAAAAAAAEAAAAAAAAAAEAAACAgIAKAAAAACgAAAAoAAAAZAAAAGQAAAAAAAAAzMzMAAAAAABQAAAAUAAAAGQAAABkAAAAAAAAABcAAAAUAAAAAAAAAAAAAAD/fwAA/38AAAAAAAAJAAAABAAAAAAAAAAeAAAAaAAAAAAAAAAAAAAAAAAAAAAAAAAAAAAAECcAABAnAAAAAAAAAAAAAAAAAAAAAAAAAAAAAAAAAAAAAAAAAAAAABQAAAAAAAAAwMD/AAAAAABkAAAAMgAAAAAAAABkAAAAAAAAAH9/fwAKAAAAIgAAABgAAAAAAAAAAAAAAAAAAAAAAAAAAAAAAAAAAAAkAAAAJAAAAAAAAAAHAAAAAAAAAAAAAAAAAAAAAAAAAAAAAAAAAAAAf39/ACUAAABYAAAAAAAAAAAAAAAAAAAAAAAAAAAAAAAAAAAAAAAAAAAAAAAAAAAAAAAAAAAAAAA/AAAAAAAAAKCGAQAAAAAAAAAAAAAAAAAMAAAAAQAAAAAAAAAAAAAAAAAAAB8AAABUAAAAAAAABQAAAAEAAAAAAAAAAAAAAAAAAAAAAAAAAAAAAAAAAAAAAAAAAAAAAAJ/f38AAAAAA8zMzADAwP8Af39/AAAAAAAAAAAAAAAAAAAAAAAAAAAAIQAAABgAAAAUAAAAwAMAABsnAAA/FQAAWSkAABAAAAAmAAAACAAAAAAAAAAAAAAA"/>
               </a:ext>
             </a:extLst>
           </p:cNvSpPr>
@@ -2686,7 +2686,7 @@
           <a:lstStyle/>
           <a:p>
             <a:pPr/>
-            <a:fld id="{08843BDD-93E5-D1CD-AB3C-659875725D30}" type="datetime1">
+            <a:fld id="{0DD7AE41-0FE0-8258-AE6F-F90DE02158AC}" type="datetime1">
               <a:t/>
             </a:fld>
           </a:p>
@@ -2699,7 +2699,7 @@
             <a:spLocks noGrp="1" noChangeArrowheads="1"/>
             <a:extLst>
               <a:ext uri="smNativeData">
-                <pr:smNativeData xmlns:pr="smNativeData" xmlns="smNativeData" val="SMDATA_15_7aDWaRMAAAAlAAAAZAAAAA8BAAAAkAAAAEgAAACQAAAASAAAAAAAAAABAAAAAAAAAAEAAABQAAAAAAAAAAAA4D8AAAAAAADgPwAAAAAAAOA/AAAAAAAA4D8AAAAAAADgPwAAAAAAAOA/AAAAAAAA4D8AAAAAAADgPwAAAAAAAOA/AAAAAAAA4D8CAAAAjAAAAAAAAAAAAAAAu+DjDP///wgAAAAAAAAAAAAAAAAAAAAAAAAAAAAAAAAAAAAAZAAAAAEAAABAAAAAAAAAAAAAAAAAAAAAAAAAAAAAAAAAAAAAAAAAAAAAAAAAAAAAAAAAAAAAAAAAAAAAAAAAAAAAAAAAAAAAAAAAAAAAAAAAAAAAAAAAAAAAAAAAAAAAFAAAADwAAAAAAAAAAAAAAAAAAAkUAAAAAQAAABQAAAAUAAAAFAAAAAEAAAAAAAAAZAAAAGQAAAAAAAAAZAAAAGQAAAAVAAAAYAAAAAAAAAAAAAAADwAAACADAAAAAAAAAAAAAAEAAACgMgAAVgcAAKr4//8BAAAAf39/AAEAAABkAAAAAAAAABQAAABAHwAAAAAAACYAAAAAAAAAwOD//wAAAAAmAAAAZAAAABYAAABMAAAAAAAAAAAAAAAEAAAAAAAAAAEAAACAgIAKAAAAACgAAAAoAAAAZAAAAGQAAAAAAAAAzMzMAAAAAABQAAAAUAAAAGQAAABkAAAAAAAAABcAAAAUAAAAAAAAAAAAAAD/fwAA/38AAAAAAAAJAAAABAAAAAAAAAAeAAAAaAAAAAAAAAAAAAAAAAAAAAAAAAAAAAAAECcAABAnAAAAAAAAAAAAAAAAAAAAAAAAAAAAAAAAAAAAAAAAAAAAABQAAAAAAAAAwMD/AAAAAABkAAAAMgAAAAAAAABkAAAAAAAAAH9/fwAKAAAAIgAAABgAAAAAAAAAAAAAAAAAAAAAAAAAAAAAAAAAAAAkAAAAJAAAAAAAAAAHAAAAAAAAAAAAAAAAAAAAAAAAAAAAAAAAAAAAf39/ACUAAABYAAAAAAAAAAAAAAAAAAAAAAAAAAAAAAAAAAAAAAAAAAAAAAAAAAAAAAAAAAAAAAA/AAAAAAAAAKCGAQAAAAAAAAAAAAAAAAAMAAAAAQAAAAAAAAAAAAAAAAAAAB8AAABUAAAAAAAABQAAAAEAAAAAAAAAAAAAAAAAAAAAAAAAAAAAAAAAAAAAAAAAAAAAAAJ/f38AAAAAA8zMzADAwP8Af39/AAAAAAAAAAAAAAAAAAAAAAAAAAAAIQAAABgAAAAUAAAAoRkAABsnAABfMQAAWSkAABAAAAAmAAAACAAAAAAAAAAAAAAA"/>
+                <pr:smNativeData xmlns:pr="smNativeData" xmlns="smNativeData" val="SMDATA_15_ZqHWaRMAAAAlAAAAZAAAAA8BAAAAkAAAAEgAAACQAAAASAAAAAAAAAABAAAAAAAAAAEAAABQAAAAAAAAAAAA4D8AAAAAAADgPwAAAAAAAOA/AAAAAAAA4D8AAAAAAADgPwAAAAAAAOA/AAAAAAAA4D8AAAAAAADgPwAAAAAAAOA/AAAAAAAA4D8CAAAAjAAAAAAAAAAAAAAAu+DjDP///wgAAAAAAAAAAAAAAAAAAAAAAAAAAAAAAAAAAAAAZAAAAAEAAABAAAAAAAAAAAAAAAAAAAAAAAAAAAAAAAAAAAAAAAAAAAAAAAAAAAAAAAAAAAAAAAAAAAAAAAAAAAAAAAAAAAAAAAAAAAAAAAAAAAAAAAAAAAAAAAAAAAAAFAAAADwAAAAAAAAAAAAAAAAAAAkUAAAAAQAAABQAAAAUAAAAFAAAAAEAAAAAAAAAZAAAAGQAAAAAAAAAZAAAAGQAAAAVAAAAYAAAAAAAAAAAAAAADwAAACADAAAAAAAAAAAAAAEAAACgMgAAVgcAAKr4//8BAAAAf39/AAEAAABkAAAAAAAAABQAAABAHwAAAAAAACYAAAAAAAAAwOD//wAAAAAmAAAAZAAAABYAAABMAAAAAAAAAAAAAAAEAAAAAAAAAAEAAACAgIAKAAAAACgAAAAoAAAAZAAAAGQAAAAAAAAAzMzMAAAAAABQAAAAUAAAAGQAAABkAAAAAAAAABcAAAAUAAAAAAAAAAAAAAD/fwAA/38AAAAAAAAJAAAABAAAAAAAAAAeAAAAaAAAAAAAAAAAAAAAAAAAAAAAAAAAAAAAECcAABAnAAAAAAAAAAAAAAAAAAAAAAAAAAAAAAAAAAAAAAAAAAAAABQAAAAAAAAAwMD/AAAAAABkAAAAMgAAAAAAAABkAAAAAAAAAH9/fwAKAAAAIgAAABgAAAAAAAAAAAAAAAAAAAAAAAAAAAAAAAAAAAAkAAAAJAAAAAAAAAAHAAAAAAAAAAAAAAAAAAAAAAAAAAAAAAAAAAAAf39/ACUAAABYAAAAAAAAAAAAAAAAAAAAAAAAAAAAAAAAAAAAAAAAAAAAAAAAAAAAAAAAAAAAAAA/AAAAAAAAAKCGAQAAAAAAAAAAAAAAAAAMAAAAAQAAAAAAAAAAAAAAAAAAAB8AAABUAAAAAAAABQAAAAEAAAAAAAAAAAAAAAAAAAAAAAAAAAAAAAAAAAAAAAAAAAAAAAJ/f38AAAAAA8zMzADAwP8Af39/AAAAAAAAAAAAAAAAAAAAAAAAAAAAIQAAABgAAAAUAAAAoRkAABsnAABfMQAAWSkAABAAAAAmAAAACAAAAAAAAAAAAAAA"/>
               </a:ext>
             </a:extLst>
           </p:cNvSpPr>
@@ -2723,7 +2723,7 @@
             <a:spLocks noGrp="1" noChangeArrowheads="1"/>
             <a:extLst>
               <a:ext uri="smNativeData">
-                <pr:smNativeData xmlns:pr="smNativeData" xmlns="smNativeData" val="SMDATA_15_7aDWaRMAAAAlAAAAZAAAAA8BAAAAkAAAAEgAAACQAAAASAAAAAAAAAABAAAAAAAAAAEAAABQAAAAAAAAAAAA4D8AAAAAAADgPwAAAAAAAOA/AAAAAAAA4D8AAAAAAADgPwAAAAAAAOA/AAAAAAAA4D8AAAAAAADgPwAAAAAAAOA/AAAAAAAA4D8CAAAAjAAAAAAAAAAAAAAAu+DjDP///wgAAAAAAAAAAAAAAAAAAAAAAAAAAAAAAAAAAAAAZAAAAAEAAABAAAAAAAAAAAAAAAAAAAAAAAAAAAAAAAAAAAAAAAAAAAAAAAAAAAAAAAAAAAAAAAAAAAAAAAAAAAAAAAAAAAAAAAAAAAAAAAAAAAAAAAAAAAAAAAAAAAAAFAAAADwAAAAAAAAAAAAAAAAAAAkUAAAAAQAAABQAAAAUAAAAFAAAAAEAAAAAAAAAZAAAAGQAAAAAAAAAZAAAAGQAAAAVAAAAYAAAAAAAAAAAAAAADwAAACADAAAAAAAAAAAAAAEAAACgMgAAVgcAAKr4//8BAAAAf39/AAEAAABkAAAAAAAAABQAAABAHwAAAAAAACYAAAAAAAAAwOD//wAAAAAmAAAAZAAAABYAAABMAAAAAAAAAAAAAAAEAAAAAAAAAAEAAACAgIAKAAAAACgAAAAoAAAAZAAAAGQAAAAAAAAAzMzMAAAAAABQAAAAUAAAAGQAAABkAAAAAAAAABcAAAAUAAAAAAAAAAAAAAD/fwAA/38AAAAAAAAJAAAABAAAAAAAAAAeAAAAaAAAAAAAAAAAAAAAAAAAAAAAAAAAAAAAECcAABAnAAAAAAAAAAAAAAAAAAAAAAAAAAAAAAAAAAAAAAAAAAAAABQAAAAAAAAAwMD/AAAAAABkAAAAMgAAAAAAAABkAAAAAAAAAH9/fwAKAAAAIgAAABgAAAAAAAAAAAAAAAAAAAAAAAAAAAAAAAAAAAAkAAAAJAAAAAAAAAAHAAAAAAAAAAAAAAAAAAAAAAAAAAAAAAAAAAAAf39/ACUAAABYAAAAAAAAAAAAAAAAAAAAAAAAAAAAAAAAAAAAAAAAAAAAAAAAAAAAAAAAAAAAAAA/AAAAAAAAAKCGAQAAAAAAAAAAAAAAAAAMAAAAAQAAAAAAAAAAAAAAAAAAAB8AAABUAAAAAAAABQAAAAEAAAAAAAAAAAAAAAAAAAAAAAAAAAAAAAAAAAAAAAAAAAAAAAJ/f38AAAAAA8zMzADAwP8Af39/AAAAAAAAAAAAAAAAAAAAAAAAAAAAIQAAABgAAAAUAAAAwTUAABsnAABARwAAWSkAABAAAAAmAAAACAAAAAAAAAAAAAAA"/>
+                <pr:smNativeData xmlns:pr="smNativeData" xmlns="smNativeData" val="SMDATA_15_ZqHWaRMAAAAlAAAAZAAAAA8BAAAAkAAAAEgAAACQAAAASAAAAAAAAAABAAAAAAAAAAEAAABQAAAAAAAAAAAA4D8AAAAAAADgPwAAAAAAAOA/AAAAAAAA4D8AAAAAAADgPwAAAAAAAOA/AAAAAAAA4D8AAAAAAADgPwAAAAAAAOA/AAAAAAAA4D8CAAAAjAAAAAAAAAAAAAAAu+DjDP///wgAAAAAAAAAAAAAAAAAAAAAAAAAAAAAAAAAAAAAZAAAAAEAAABAAAAAAAAAAAAAAAAAAAAAAAAAAAAAAAAAAAAAAAAAAAAAAAAAAAAAAAAAAAAAAAAAAAAAAAAAAAAAAAAAAAAAAAAAAAAAAAAAAAAAAAAAAAAAAAAAAAAAFAAAADwAAAAAAAAAAAAAAAAAAAkUAAAAAQAAABQAAAAUAAAAFAAAAAEAAAAAAAAAZAAAAGQAAAAAAAAAZAAAAGQAAAAVAAAAYAAAAAAAAAAAAAAADwAAACADAAAAAAAAAAAAAAEAAACgMgAAVgcAAKr4//8BAAAAf39/AAEAAABkAAAAAAAAABQAAABAHwAAAAAAACYAAAAAAAAAwOD//wAAAAAmAAAAZAAAABYAAABMAAAAAAAAAAAAAAAEAAAAAAAAAAEAAACAgIAKAAAAACgAAAAoAAAAZAAAAGQAAAAAAAAAzMzMAAAAAABQAAAAUAAAAGQAAABkAAAAAAAAABcAAAAUAAAAAAAAAAAAAAD/fwAA/38AAAAAAAAJAAAABAAAAAAAAAAeAAAAaAAAAAAAAAAAAAAAAAAAAAAAAAAAAAAAECcAABAnAAAAAAAAAAAAAAAAAAAAAAAAAAAAAAAAAAAAAAAAAAAAABQAAAAAAAAAwMD/AAAAAABkAAAAMgAAAAAAAABkAAAAAAAAAH9/fwAKAAAAIgAAABgAAAAAAAAAAAAAAAAAAAAAAAAAAAAAAAAAAAAkAAAAJAAAAAAAAAAHAAAAAAAAAAAAAAAAAAAAAAAAAAAAAAAAAAAAf39/ACUAAABYAAAAAAAAAAAAAAAAAAAAAAAAAAAAAAAAAAAAAAAAAAAAAAAAAAAAAAAAAAAAAAA/AAAAAAAAAKCGAQAAAAAAAAAAAAAAAAAMAAAAAQAAAAAAAAAAAAAAAAAAAB8AAABUAAAAAAAABQAAAAEAAAAAAAAAAAAAAAAAAAAAAAAAAAAAAAAAAAAAAAAAAAAAAAJ/f38AAAAAA8zMzADAwP8Af39/AAAAAAAAAAAAAAAAAAAAAAAAAAAAIQAAABgAAAAUAAAAwTUAABsnAABARwAAWSkAABAAAAAmAAAACAAAAAAAAAAAAAAA"/>
               </a:ext>
             </a:extLst>
           </p:cNvSpPr>
@@ -2737,7 +2737,7 @@
           <a:lstStyle/>
           <a:p>
             <a:pPr/>
-            <a:fld id="{743B99ED-A399-6E6F-D783-553AD7CD2100}" type="slidenum">
+            <a:fld id="{12CA112A-64FF-9FE7-B172-92B25F3C47C7}" type="slidenum">
               <a:t/>
             </a:fld>
           </a:p>
@@ -2784,7 +2784,7 @@
             <a:spLocks noGrp="1" noChangeArrowheads="1"/>
             <a:extLst>
               <a:ext uri="smNativeData">
-                <pr:smNativeData xmlns:pr="smNativeData" xmlns="smNativeData" val="SMDATA_15_7aDWaRMAAAAlAAAAZAAAAA8BAAAAkAAAAEgAAACQAAAASAAAAAAAAAABAAAAAAAAAAEAAABQAAAAAAAAAAAA4D8AAAAAAADgPwAAAAAAAOA/AAAAAAAA4D8AAAAAAADgPwAAAAAAAOA/AAAAAAAA4D8AAAAAAADgPwAAAAAAAOA/AAAAAAAA4D8CAAAAjAAAAAAAAAAAAAAAu+DjDP///wgAAAAAAAAAAAAAAAAAAAAAAAAAAAAAAAAAAAAAZAAAAAEAAABAAAAAAAAAAAAAAAAAAAAAAAAAAAAAAAAAAAAAAAAAAAAAAAAAAAAAAAAAAAAAAAAAAAAAAAAAAAAAAAAAAAAAAAAAAAAAAAAAAAAAAAAAAAAAAAAAAAAAFAAAADwAAAAAAAAAAAAAAAAAAAkUAAAAAQAAABQAAAAUAAAAFAAAAAEAAAAAAAAAZAAAAGQAAAAAAAAAZAAAAGQAAAAVAAAAYAAAAAAAAAAAAAAADwAAACADAAAAAAAAAAAAAAEAAACgMgAAVgcAAKr4//8BAAAAf39/AAEAAABkAAAAAAAAABQAAABAHwAAAAAAACYAAAAAAAAAwOD//wAAAAAmAAAAZAAAABYAAABMAAAAAAAAAAAAAAAEAAAAAAAAAAEAAACAgIAKAAAAACgAAAAoAAAAZAAAAGQAAAAAAAAAzMzMAAAAAABQAAAAUAAAAGQAAABkAAAAAAAAABcAAAAUAAAAAAAAAAAAAAD/fwAA/38AAAAAAAAJAAAABAAAAHsAfAAeAAAAaAAAAAAAAAAAAAAAAAAAAAAAAAAAAAAAECcAABAnAAAAAAAAAAAAAAAAAAAAAAAAAAAAAAAAAAAAAAAAAAAAABQAAAAAAAAAwMD/AAAAAABkAAAAMgAAAAAAAABkAAAAAAAAAH9/fwAKAAAAIgAAABgAAAAAAAAAAAAAAAAAAAAAAAAAAAAAAAAAAAAkAAAAJAAAAAAAAAAHAAAAAAAAAAAAAAAAAAAAAAAAAAAAAAAAAAAAf39/ACUAAABYAAAAAAAAAAAAAAAAAAAAAAAAAAAAAAAAAAAAAAAAAAAAAAAAAAAAAAAAAAAAAAA/AAAAAAAAAKCGAQAAAAAAAAAAAAAAAAAMAAAAAQAAAAAAAAAAAAAAAAAAAB8AAABUAAAAAAAABQAAAAEAAAAAAAAAAAAAAAAAAAAAAAAAAAAAAAAAAAAAAAAAAAAAAAJ/f38AAAAAA8zMzADAwP8Af39/AAAAAAAAAAAAAAAAAAAAAAAAAAAAIQAAABgAAAAUAAAAwAMAALABAABARwAAuAgAABAAAAAmAAAACAAAAP//////////"/>
+                <pr:smNativeData xmlns:pr="smNativeData" xmlns="smNativeData" val="SMDATA_15_ZqHWaRMAAAAlAAAAZAAAAA8BAAAAkAAAAEgAAACQAAAASAAAAAAAAAABAAAAAAAAAAEAAABQAAAAAAAAAAAA4D8AAAAAAADgPwAAAAAAAOA/AAAAAAAA4D8AAAAAAADgPwAAAAAAAOA/AAAAAAAA4D8AAAAAAADgPwAAAAAAAOA/AAAAAAAA4D8CAAAAjAAAAAAAAAAAAAAAu+DjDP///wgAAAAAAAAAAAAAAAAAAAAAAAAAAAAAAAAAAAAAZAAAAAEAAABAAAAAAAAAAAAAAAAAAAAAAAAAAAAAAAAAAAAAAAAAAAAAAAAAAAAAAAAAAAAAAAAAAAAAAAAAAAAAAAAAAAAAAAAAAAAAAAAAAAAAAAAAAAAAAAAAAAAAFAAAADwAAAAAAAAAAAAAAAAAAAkUAAAAAQAAABQAAAAUAAAAFAAAAAEAAAAAAAAAZAAAAGQAAAAAAAAAZAAAAGQAAAAVAAAAYAAAAAAAAAAAAAAADwAAACADAAAAAAAAAAAAAAEAAACgMgAAVgcAAKr4//8BAAAAf39/AAEAAABkAAAAAAAAABQAAABAHwAAAAAAACYAAAAAAAAAwOD//wAAAAAmAAAAZAAAABYAAABMAAAAAAAAAAAAAAAEAAAAAAAAAAEAAACAgIAKAAAAACgAAAAoAAAAZAAAAGQAAAAAAAAAzMzMAAAAAABQAAAAUAAAAGQAAABkAAAAAAAAABcAAAAUAAAAAAAAAAAAAAD/fwAA/38AAAAAAAAJAAAABAAAAHsAfAAeAAAAaAAAAAAAAAAAAAAAAAAAAAAAAAAAAAAAECcAABAnAAAAAAAAAAAAAAAAAAAAAAAAAAAAAAAAAAAAAAAAAAAAABQAAAAAAAAAwMD/AAAAAABkAAAAMgAAAAAAAABkAAAAAAAAAH9/fwAKAAAAIgAAABgAAAAAAAAAAAAAAAAAAAAAAAAAAAAAAAAAAAAkAAAAJAAAAAAAAAAHAAAAAAAAAAAAAAAAAAAAAAAAAAAAAAAAAAAAf39/ACUAAABYAAAAAAAAAAAAAAAAAAAAAAAAAAAAAAAAAAAAAAAAAAAAAAAAAAAAAAAAAAAAAAA/AAAAAAAAAKCGAQAAAAAAAAAAAAAAAAAMAAAAAQAAAAAAAAAAAAAAAAAAAB8AAABUAAAAAAAABQAAAAEAAAAAAAAAAAAAAAAAAAAAAAAAAAAAAAAAAAAAAAAAAAAAAAJ/f38AAAAAA8zMzADAwP8Af39/AAAAAAAAAAAAAAAAAAAAAAAAAAAAIQAAABgAAAAUAAAAwAMAALABAABARwAAuAgAABAAAAAmAAAACAAAAP//////////"/>
               </a:ext>
             </a:extLst>
           </p:cNvSpPr>
@@ -2828,7 +2828,7 @@
             <a:spLocks noGrp="1" noChangeArrowheads="1"/>
             <a:extLst>
               <a:ext uri="smNativeData">
-                <pr:smNativeData xmlns:pr="smNativeData" xmlns="smNativeData" val="SMDATA_15_7aDWaRMAAAAlAAAAZAAAAA8BAAAAkAAAAEgAAACQAAAASAAAAAAAAAAAAAAAAAAAAAEAAABQAAAAAAAAAAAA4D8AAAAAAADgPwAAAAAAAOA/AAAAAAAA4D8AAAAAAADgPwAAAAAAAOA/AAAAAAAA4D8AAAAAAADgPwAAAAAAAOA/AAAAAAAA4D8CAAAAjAAAAAAAAAAAAAAAu+DjDP///wgAAAAAAAAAAAAAAAAAAAAAAAAAAAAAAAAAAAAAZAAAAAEAAABAAAAAAAAAAAAAAAAAAAAAAAAAAAAAAAAAAAAAAAAAAAAAAAAAAAAAAAAAAAAAAAAAAAAAAAAAAAAAAAAAAAAAAAAAAAAAAAAAAAAAAAAAAAAAAAAAAAAAFAAAADwAAAAAAAAAAAAAAAAAAAkUAAAAAQAAABQAAAAUAAAAFAAAAAEAAAAAAAAAZAAAAGQAAAAAAAAAZAAAAGQAAAAVAAAAYAAAAAAAAAAAAAAADwAAACADAAAAAAAAAAAAAAEAAACgMgAAVgcAAKr4//8BAAAAf39/AAEAAABkAAAAAAAAABQAAABAHwAAAAAAACYAAAAAAAAAwOD//wAAAAAmAAAAZAAAABYAAABMAAAAAAAAAAAAAAAEAAAAAAAAAAEAAACAgIAKAAAAACgAAAAoAAAAZAAAAGQAAAAAAAAAzMzMAAAAAABQAAAAUAAAAGQAAABkAAAAAAAAABcAAAAUAAAAAAAAAAAAAAD/fwAA/38AAAAAAAAJAAAABAAAAHsAfAAeAAAAaAAAAAAAAAAAAAAAAAAAAAAAAAAAAAAAECcAABAnAAAAAAAAAAAAAAAAAAAAAAAAAAAAAAAAAAAAAAAAAAAAABQAAAAAAAAAwMD/AAAAAABkAAAAMgAAAAAAAABkAAAAAAAAAH9/fwAKAAAAIgAAABgAAAAAAAAAAAAAAAAAAAAAAAAAAAAAAAAAAAAkAAAAJAAAAAAAAAAHAAAAAAAAAAAAAAAAAAAAAAAAAAAAAAAAAAAAf39/ACUAAABYAAAAAAAAAAAAAAAAAAAAAAAAAAAAAAAAAAAAAAAAAAAAAAAAAAAAAAAAAAAAAAA/AAAAAAAAAKCGAQAAAAAAAAAAAAAAAAAMAAAAAQAAAAAAAAAAAAAAAAAAAB8AAABUAAAAAAAABQAAAAEAAAAAAAAAAAAAAAAAAAAAAAAAAAAAAAAAAAAAAAAAAAAAAAJ/f38AAAAAA8zMzADAwP8Af39/AAAAAAAAAAAAAAAAAAAAAAAAAAAAIQAAABgAAAAUAAAAwAMAANgJAABARwAAsCUAABAAAAAmAAAACAAAAP//////////"/>
+                <pr:smNativeData xmlns:pr="smNativeData" xmlns="smNativeData" val="SMDATA_15_ZqHWaRMAAAAlAAAAZAAAAA8BAAAAkAAAAEgAAACQAAAASAAAAAAAAAAAAAAAAAAAAAEAAABQAAAAAAAAAAAA4D8AAAAAAADgPwAAAAAAAOA/AAAAAAAA4D8AAAAAAADgPwAAAAAAAOA/AAAAAAAA4D8AAAAAAADgPwAAAAAAAOA/AAAAAAAA4D8CAAAAjAAAAAAAAAAAAAAAu+DjDP///wgAAAAAAAAAAAAAAAAAAAAAAAAAAAAAAAAAAAAAZAAAAAEAAABAAAAAAAAAAAAAAAAAAAAAAAAAAAAAAAAAAAAAAAAAAAAAAAAAAAAAAAAAAAAAAAAAAAAAAAAAAAAAAAAAAAAAAAAAAAAAAAAAAAAAAAAAAAAAAAAAAAAAFAAAADwAAAAAAAAAAAAAAAAAAAkUAAAAAQAAABQAAAAUAAAAFAAAAAEAAAAAAAAAZAAAAGQAAAAAAAAAZAAAAGQAAAAVAAAAYAAAAAAAAAAAAAAADwAAACADAAAAAAAAAAAAAAEAAACgMgAAVgcAAKr4//8BAAAAf39/AAEAAABkAAAAAAAAABQAAABAHwAAAAAAACYAAAAAAAAAwOD//wAAAAAmAAAAZAAAABYAAABMAAAAAAAAAAAAAAAEAAAAAAAAAAEAAACAgIAKAAAAACgAAAAoAAAAZAAAAGQAAAAAAAAAzMzMAAAAAABQAAAAUAAAAGQAAABkAAAAAAAAABcAAAAUAAAAAAAAAAAAAAD/fwAA/38AAAAAAAAJAAAABAAAAHsAfAAeAAAAaAAAAAAAAAAAAAAAAAAAAAAAAAAAAAAAECcAABAnAAAAAAAAAAAAAAAAAAAAAAAAAAAAAAAAAAAAAAAAAAAAABQAAAAAAAAAwMD/AAAAAABkAAAAMgAAAAAAAABkAAAAAAAAAH9/fwAKAAAAIgAAABgAAAAAAAAAAAAAAAAAAAAAAAAAAAAAAAAAAAAkAAAAJAAAAAAAAAAHAAAAAAAAAAAAAAAAAAAAAAAAAAAAAAAAAAAAf39/ACUAAABYAAAAAAAAAAAAAAAAAAAAAAAAAAAAAAAAAAAAAAAAAAAAAAAAAAAAAAAAAAAAAAA/AAAAAAAAAKCGAQAAAAAAAAAAAAAAAAAMAAAAAQAAAAAAAAAAAAAAAAAAAB8AAABUAAAAAAAABQAAAAEAAAAAAAAAAAAAAAAAAAAAAAAAAAAAAAAAAAAAAAAAAAAAAAJ/f38AAAAAA8zMzADAwP8Af39/AAAAAAAAAAAAAAAAAAAAAAAAAAAAIQAAABgAAAAUAAAAwAMAANgJAABARwAAsCUAABAAAAAmAAAACAAAAP//////////"/>
               </a:ext>
             </a:extLst>
           </p:cNvSpPr>
@@ -2896,7 +2896,7 @@
             <a:spLocks noGrp="1" noChangeArrowheads="1"/>
             <a:extLst>
               <a:ext uri="smNativeData">
-                <pr:smNativeData xmlns:pr="smNativeData" xmlns="smNativeData" val="SMDATA_15_7aDWaRMAAAAlAAAAZAAAAA8BAAAAkAAAAEgAAACQAAAASAAAAAAAAAABAAAAAAAAAAEAAABQAAAAAAAAAAAA4D8AAAAAAADgPwAAAAAAAOA/AAAAAAAA4D8AAAAAAADgPwAAAAAAAOA/AAAAAAAA4D8AAAAAAADgPwAAAAAAAOA/AAAAAAAA4D8CAAAAjAAAAAAAAAAAAAAAu+DjDP///wgAAAAAAAAAAAAAAAAAAAAAAAAAAAAAAAAAAAAAZAAAAAEAAABAAAAAAAAAAAAAAAAAAAAAAAAAAAAAAAAAAAAAAAAAAAAAAAAAAAAAAAAAAAAAAAAAAAAAAAAAAAAAAAAAAAAAAAAAAAAAAAAAAAAAAAAAAAAAAAAAAAAAFAAAADwAAAAAAAAAAAAAAAAAAAkUAAAAAQAAABQAAAAUAAAAFAAAAAEAAAAAAAAAZAAAAGQAAAAAAAAAZAAAAGQAAAAVAAAAYAAAAAAAAAAAAAAADwAAACADAAAAAAAAAAAAAAEAAACgMgAAVgcAAKr4//8BAAAAf39/AAEAAABkAAAAAAAAABQAAABAHwAAAAAAACYAAAAAAAAAwOD//wAAAAAmAAAAZAAAABYAAABMAAAAAAAAAAAAAAAEAAAAAAAAAAEAAACAgIAKAAAAACgAAAAoAAAAZAAAAGQAAAAAAAAAzMzMAAAAAABQAAAAUAAAAGQAAABkAAAAAAAAABcAAAAUAAAAAAAAAAAAAAD/fwAA/38AAAAAAAAJAAAABAAAAHsAfAAeAAAAaAAAAAAAAAAAAAAAAAAAAAAAAAAAAAAAECcAABAnAAAAAAAAAAAAAAAAAAAAAAAAAAAAAAAAAAAAAAAAAAAAABQAAAAAAAAAwMD/AAAAAABkAAAAMgAAAAAAAABkAAAAAAAAAH9/fwAKAAAAIgAAABgAAAAAAAAAAAAAAAAAAAAAAAAAAAAAAAAAAAAkAAAAJAAAAAAAAAAHAAAAAAAAAAAAAAAAAAAAAAAAAAAAAAAAAAAAf39/ACUAAABYAAAAAAAAAAAAAAAAAAAAAAAAAAAAAAAAAAAAAAAAAAAAAAAAAAAAAAAAAAAAAAA/AAAAAAAAAKCGAQAAAAAAAAAAAAAAAAAMAAAAAQAAAAAAAAAAAAAAAAAAAB8AAABUAAAAAAAABQAAAAEAAAAAAAAAAAAAAAAAAAAAAAAAAAAAAAAAAAAAAAAAAAAAAAJ/f38AAAAAA8zMzADAwP8Af39/AAAAAAAAAAAAAAAAAAAAAAAAAAAAIQAAABgAAAAUAAAAwAMAABsnAAA/FQAAWSkAABAAAAAmAAAACAAAAP//////////"/>
+                <pr:smNativeData xmlns:pr="smNativeData" xmlns="smNativeData" val="SMDATA_15_ZqHWaRMAAAAlAAAAZAAAAA8BAAAAkAAAAEgAAACQAAAASAAAAAAAAAABAAAAAAAAAAEAAABQAAAAAAAAAAAA4D8AAAAAAADgPwAAAAAAAOA/AAAAAAAA4D8AAAAAAADgPwAAAAAAAOA/AAAAAAAA4D8AAAAAAADgPwAAAAAAAOA/AAAAAAAA4D8CAAAAjAAAAAAAAAAAAAAAu+DjDP///wgAAAAAAAAAAAAAAAAAAAAAAAAAAAAAAAAAAAAAZAAAAAEAAABAAAAAAAAAAAAAAAAAAAAAAAAAAAAAAAAAAAAAAAAAAAAAAAAAAAAAAAAAAAAAAAAAAAAAAAAAAAAAAAAAAAAAAAAAAAAAAAAAAAAAAAAAAAAAAAAAAAAAFAAAADwAAAAAAAAAAAAAAAAAAAkUAAAAAQAAABQAAAAUAAAAFAAAAAEAAAAAAAAAZAAAAGQAAAAAAAAAZAAAAGQAAAAVAAAAYAAAAAAAAAAAAAAADwAAACADAAAAAAAAAAAAAAEAAACgMgAAVgcAAKr4//8BAAAAf39/AAEAAABkAAAAAAAAABQAAABAHwAAAAAAACYAAAAAAAAAwOD//wAAAAAmAAAAZAAAABYAAABMAAAAAAAAAAAAAAAEAAAAAAAAAAEAAACAgIAKAAAAACgAAAAoAAAAZAAAAGQAAAAAAAAAzMzMAAAAAABQAAAAUAAAAGQAAABkAAAAAAAAABcAAAAUAAAAAAAAAAAAAAD/fwAA/38AAAAAAAAJAAAABAAAAHsAfAAeAAAAaAAAAAAAAAAAAAAAAAAAAAAAAAAAAAAAECcAABAnAAAAAAAAAAAAAAAAAAAAAAAAAAAAAAAAAAAAAAAAAAAAABQAAAAAAAAAwMD/AAAAAABkAAAAMgAAAAAAAABkAAAAAAAAAH9/fwAKAAAAIgAAABgAAAAAAAAAAAAAAAAAAAAAAAAAAAAAAAAAAAAkAAAAJAAAAAAAAAAHAAAAAAAAAAAAAAAAAAAAAAAAAAAAAAAAAAAAf39/ACUAAABYAAAAAAAAAAAAAAAAAAAAAAAAAAAAAAAAAAAAAAAAAAAAAAAAAAAAAAAAAAAAAAA/AAAAAAAAAKCGAQAAAAAAAAAAAAAAAAAMAAAAAQAAAAAAAAAAAAAAAAAAAB8AAABUAAAAAAAABQAAAAEAAAAAAAAAAAAAAAAAAAAAAAAAAAAAAAAAAAAAAAAAAAAAAAJ/f38AAAAAA8zMzADAwP8Af39/AAAAAAAAAAAAAAAAAAAAAAAAAAAAIQAAABgAAAAUAAAAwAMAABsnAAA/FQAAWSkAABAAAAAmAAAACAAAAP//////////"/>
               </a:ext>
             </a:extLst>
           </p:cNvSpPr>
@@ -2931,7 +2931,7 @@
           </a:lstStyle>
           <a:p>
             <a:pPr/>
-            <a:fld id="{06D32DB8-F6EB-86DB-A56B-008E63255355}" type="datetime1">
+            <a:fld id="{0F85D4D5-9BE2-D022-AC3D-6D779A735A38}" type="datetime1">
               <a:t/>
             </a:fld>
           </a:p>
@@ -2944,7 +2944,7 @@
             <a:spLocks noGrp="1" noChangeArrowheads="1"/>
             <a:extLst>
               <a:ext uri="smNativeData">
-                <pr:smNativeData xmlns:pr="smNativeData" xmlns="smNativeData" val="SMDATA_15_7aDWaRMAAAAlAAAAZAAAAA8BAAAAkAAAAEgAAACQAAAASAAAAAAAAAABAAAAAAAAAAEAAABQAAAAAAAAAAAA4D8AAAAAAADgPwAAAAAAAOA/AAAAAAAA4D8AAAAAAADgPwAAAAAAAOA/AAAAAAAA4D8AAAAAAADgPwAAAAAAAOA/AAAAAAAA4D8CAAAAjAAAAAAAAAAAAAAAu+DjDP///wgAAAAAAAAAAAAAAAAAAAAAAAAAAAAAAAAAAAAAZAAAAAEAAABAAAAAAAAAAAAAAAAAAAAAAAAAAAAAAAAAAAAAAAAAAAAAAAAAAAAAAAAAAAAAAAAAAAAAAAAAAAAAAAAAAAAAAAAAAAAAAAAAAAAAAAAAAAAAAAAAAAAAFAAAADwAAAAAAAAAAAAAAAAAAAkUAAAAAQAAABQAAAAUAAAAFAAAAAEAAAAAAAAAZAAAAGQAAAAAAAAAZAAAAGQAAAAVAAAAYAAAAAAAAAAAAAAADwAAACADAAAAAAAAAAAAAAEAAACgMgAAVgcAAKr4//8BAAAAf39/AAEAAABkAAAAAAAAABQAAABAHwAAAAAAACYAAAAAAAAAwOD//wAAAAAmAAAAZAAAABYAAABMAAAAAAAAAAAAAAAEAAAAAAAAAAEAAACAgIAKAAAAACgAAAAoAAAAZAAAAGQAAAAAAAAAzMzMAAAAAABQAAAAUAAAAGQAAABkAAAAAAAAABcAAAAUAAAAAAAAAAAAAAD/fwAA/38AAAAAAAAJAAAABAAAAAAAAAAeAAAAaAAAAAAAAAAAAAAAAAAAAAAAAAAAAAAAECcAABAnAAAAAAAAAAAAAAAAAAAAAAAAAAAAAAAAAAAAAAAAAAAAABQAAAAAAAAAwMD/AAAAAABkAAAAMgAAAAAAAABkAAAAAAAAAH9/fwAKAAAAIgAAABgAAAAAAAAAAAAAAAAAAAAAAAAAAAAAAAAAAAAkAAAAJAAAAAAAAAAHAAAAAAAAAAAAAAAAAAAAAAAAAAAAAAAAAAAAf39/ACUAAABYAAAAAAAAAAAAAAAAAAAAAAAAAAAAAAAAAAAAAAAAAAAAAAAAAAAAAAAAAAAAAAA/AAAAAAAAAKCGAQAAAAAAAAAAAAAAAAAMAAAAAQAAAAAAAAAAAAAAAAAAAB8AAABUAAAAAAAABQAAAAEAAAAAAAAAAAAAAAAAAAAAAAAAAAAAAAAAAAAAAAAAAAAAAAJ/f38AAAAAA8zMzADAwP8Af39/AAAAAAAAAAAAAAAAAAAAAAAAAAAAIQAAABgAAAAUAAAAoRkAABsnAABfMQAAWSkAABAAAAAmAAAACAAAAP//////////"/>
+                <pr:smNativeData xmlns:pr="smNativeData" xmlns="smNativeData" val="SMDATA_15_ZqHWaRMAAAAlAAAAZAAAAA8BAAAAkAAAAEgAAACQAAAASAAAAAAAAAABAAAAAAAAAAEAAABQAAAAAAAAAAAA4D8AAAAAAADgPwAAAAAAAOA/AAAAAAAA4D8AAAAAAADgPwAAAAAAAOA/AAAAAAAA4D8AAAAAAADgPwAAAAAAAOA/AAAAAAAA4D8CAAAAjAAAAAAAAAAAAAAAu+DjDP///wgAAAAAAAAAAAAAAAAAAAAAAAAAAAAAAAAAAAAAZAAAAAEAAABAAAAAAAAAAAAAAAAAAAAAAAAAAAAAAAAAAAAAAAAAAAAAAAAAAAAAAAAAAAAAAAAAAAAAAAAAAAAAAAAAAAAAAAAAAAAAAAAAAAAAAAAAAAAAAAAAAAAAFAAAADwAAAAAAAAAAAAAAAAAAAkUAAAAAQAAABQAAAAUAAAAFAAAAAEAAAAAAAAAZAAAAGQAAAAAAAAAZAAAAGQAAAAVAAAAYAAAAAAAAAAAAAAADwAAACADAAAAAAAAAAAAAAEAAACgMgAAVgcAAKr4//8BAAAAf39/AAEAAABkAAAAAAAAABQAAABAHwAAAAAAACYAAAAAAAAAwOD//wAAAAAmAAAAZAAAABYAAABMAAAAAAAAAAAAAAAEAAAAAAAAAAEAAACAgIAKAAAAACgAAAAoAAAAZAAAAGQAAAAAAAAAzMzMAAAAAABQAAAAUAAAAGQAAABkAAAAAAAAABcAAAAUAAAAAAAAAAAAAAD/fwAA/38AAAAAAAAJAAAABAAAAAAAAAAeAAAAaAAAAAAAAAAAAAAAAAAAAAAAAAAAAAAAECcAABAnAAAAAAAAAAAAAAAAAAAAAAAAAAAAAAAAAAAAAAAAAAAAABQAAAAAAAAAwMD/AAAAAABkAAAAMgAAAAAAAABkAAAAAAAAAH9/fwAKAAAAIgAAABgAAAAAAAAAAAAAAAAAAAAAAAAAAAAAAAAAAAAkAAAAJAAAAAAAAAAHAAAAAAAAAAAAAAAAAAAAAAAAAAAAAAAAAAAAf39/ACUAAABYAAAAAAAAAAAAAAAAAAAAAAAAAAAAAAAAAAAAAAAAAAAAAAAAAAAAAAAAAAAAAAA/AAAAAAAAAKCGAQAAAAAAAAAAAAAAAAAMAAAAAQAAAAAAAAAAAAAAAAAAAB8AAABUAAAAAAAABQAAAAEAAAAAAAAAAAAAAAAAAAAAAAAAAAAAAAAAAAAAAAAAAAAAAAJ/f38AAAAAA8zMzADAwP8Af39/AAAAAAAAAAAAAAAAAAAAAAAAAAAAIQAAABgAAAAUAAAAoRkAABsnAABfMQAAWSkAABAAAAAmAAAACAAAAP//////////"/>
               </a:ext>
             </a:extLst>
           </p:cNvSpPr>
@@ -2989,7 +2989,7 @@
             <a:spLocks noGrp="1" noChangeArrowheads="1"/>
             <a:extLst>
               <a:ext uri="smNativeData">
-                <pr:smNativeData xmlns:pr="smNativeData" xmlns="smNativeData" val="SMDATA_15_7aDWaRMAAAAlAAAAZAAAAA8BAAAAkAAAAEgAAACQAAAASAAAAAAAAAABAAAAAAAAAAEAAABQAAAAAAAAAAAA4D8AAAAAAADgPwAAAAAAAOA/AAAAAAAA4D8AAAAAAADgPwAAAAAAAOA/AAAAAAAA4D8AAAAAAADgPwAAAAAAAOA/AAAAAAAA4D8CAAAAjAAAAAAAAAAAAAAAu+DjDP///wgAAAAAAAAAAAAAAAAAAAAAAAAAAAAAAAAAAAAAZAAAAAEAAABAAAAAAAAAAAAAAAAAAAAAAAAAAAAAAAAAAAAAAAAAAAAAAAAAAAAAAAAAAAAAAAAAAAAAAAAAAAAAAAAAAAAAAAAAAAAAAAAAAAAAAAAAAAAAAAAAAAAAFAAAADwAAAAAAAAAAAAAAAAAAAkUAAAAAQAAABQAAAAUAAAAFAAAAAEAAAAAAAAAZAAAAGQAAAAAAAAAZAAAAGQAAAAVAAAAYAAAAAAAAAAAAAAADwAAACADAAAAAAAAAAAAAAEAAACgMgAAVgcAAKr4//8BAAAAf39/AAEAAABkAAAAAAAAABQAAABAHwAAAAAAACYAAAAAAAAAwOD//wAAAAAmAAAAZAAAABYAAABMAAAAAAAAAAAAAAAEAAAAAAAAAAEAAACAgIAKAAAAACgAAAAoAAAAZAAAAGQAAAAAAAAAzMzMAAAAAABQAAAAUAAAAGQAAABkAAAAAAAAABcAAAAUAAAAAAAAAAAAAAD/fwAA/38AAAAAAAAJAAAABAAAAP////8eAAAAaAAAAAAAAAAAAAAAAAAAAAAAAAAAAAAAECcAABAnAAAAAAAAAAAAAAAAAAAAAAAAAAAAAAAAAAAAAAAAAAAAABQAAAAAAAAAwMD/AAAAAABkAAAAMgAAAAAAAABkAAAAAAAAAH9/fwAKAAAAIgAAABgAAAAAAAAAAAAAAAAAAAAAAAAAAAAAAAAAAAAkAAAAJAAAAAAAAAAHAAAAAAAAAAAAAAAAAAAAAAAAAAAAAAAAAAAAf39/ACUAAABYAAAAAAAAAAAAAAAAAAAAAAAAAAAAAAAAAAAAAAAAAAAAAAAAAAAAAAAAAAAAAAA/AAAAAAAAAKCGAQAAAAAAAAAAAAAAAAAMAAAAAQAAAAAAAAAAAAAAAAAAAB8AAABUAAAAAAAABQAAAAEAAAAAAAAAAAAAAAAAAAAAAAAAAAAAAAAAAAAAAAAAAAAAAAJ/f38AAAAAA8zMzADAwP8Af39/AAAAAAAAAAAAAAAAAAAAAAAAAAAAIQAAABgAAAAUAAAAwTUAABsnAABARwAAWSkAABAAAAAmAAAACAAAAP//////////"/>
+                <pr:smNativeData xmlns:pr="smNativeData" xmlns="smNativeData" val="SMDATA_15_ZqHWaRMAAAAlAAAAZAAAAA8BAAAAkAAAAEgAAACQAAAASAAAAAAAAAABAAAAAAAAAAEAAABQAAAAAAAAAAAA4D8AAAAAAADgPwAAAAAAAOA/AAAAAAAA4D8AAAAAAADgPwAAAAAAAOA/AAAAAAAA4D8AAAAAAADgPwAAAAAAAOA/AAAAAAAA4D8CAAAAjAAAAAAAAAAAAAAAu+DjDP///wgAAAAAAAAAAAAAAAAAAAAAAAAAAAAAAAAAAAAAZAAAAAEAAABAAAAAAAAAAAAAAAAAAAAAAAAAAAAAAAAAAAAAAAAAAAAAAAAAAAAAAAAAAAAAAAAAAAAAAAAAAAAAAAAAAAAAAAAAAAAAAAAAAAAAAAAAAAAAAAAAAAAAFAAAADwAAAAAAAAAAAAAAAAAAAkUAAAAAQAAABQAAAAUAAAAFAAAAAEAAAAAAAAAZAAAAGQAAAAAAAAAZAAAAGQAAAAVAAAAYAAAAAAAAAAAAAAADwAAACADAAAAAAAAAAAAAAEAAACgMgAAVgcAAKr4//8BAAAAf39/AAEAAABkAAAAAAAAABQAAABAHwAAAAAAACYAAAAAAAAAwOD//wAAAAAmAAAAZAAAABYAAABMAAAAAAAAAAAAAAAEAAAAAAAAAAEAAACAgIAKAAAAACgAAAAoAAAAZAAAAGQAAAAAAAAAzMzMAAAAAABQAAAAUAAAAGQAAABkAAAAAAAAABcAAAAUAAAAAAAAAAAAAAD/fwAA/38AAAAAAAAJAAAABAAAAP////8eAAAAaAAAAAAAAAAAAAAAAAAAAAAAAAAAAAAAECcAABAnAAAAAAAAAAAAAAAAAAAAAAAAAAAAAAAAAAAAAAAAAAAAABQAAAAAAAAAwMD/AAAAAABkAAAAMgAAAAAAAABkAAAAAAAAAH9/fwAKAAAAIgAAABgAAAAAAAAAAAAAAAAAAAAAAAAAAAAAAAAAAAAkAAAAJAAAAAAAAAAHAAAAAAAAAAAAAAAAAAAAAAAAAAAAAAAAAAAAf39/ACUAAABYAAAAAAAAAAAAAAAAAAAAAAAAAAAAAAAAAAAAAAAAAAAAAAAAAAAAAAAAAAAAAAA/AAAAAAAAAKCGAQAAAAAAAAAAAAAAAAAMAAAAAQAAAAAAAAAAAAAAAAAAAB8AAABUAAAAAAAABQAAAAEAAAAAAAAAAAAAAAAAAAAAAAAAAAAAAAAAAAAAAAAAAAAAAAJ/f38AAAAAA8zMzADAwP8Af39/AAAAAAAAAAAAAAAAAAAAAAAAAAAAIQAAABgAAAAUAAAAwTUAABsnAABARwAAWSkAABAAAAAmAAAACAAAAP//////////"/>
               </a:ext>
             </a:extLst>
           </p:cNvSpPr>
@@ -3024,7 +3024,7 @@
           </a:lstStyle>
           <a:p>
             <a:pPr/>
-            <a:fld id="{2850A038-76C5-0556-8BE8-8003EEA67DD5}" type="slidenum">
+            <a:fld id="{01B672B6-F8EC-E384-A20E-0ED13C40545B}" type="slidenum">
               <a:t/>
             </a:fld>
           </a:p>
@@ -3702,7 +3702,7 @@
           <p:cNvSpPr txBox="1">
             <a:extLst>
               <a:ext uri="smNativeData">
-                <pr:smNativeData xmlns:pr="smNativeData" xmlns="smNativeData" val="SMDATA_15_7aDWaRMAAAAlAAAAEgAAAE8BAAAAkAAAAEgAAACQAAAASAAAAAAAAAAAAAAAAAAAAAEAAABQAAAAAAAAAAAA4D8AAAAAAADgPwAAAAAAAOA/AAAAAAAA4D8AAAAAAADgPwAAAAAAAOA/AAAAAAAA4D8AAAAAAADgPwAAAAAAAOA/AAAAAAAA4D8CAAAAjAAAAAAAAAAAAAAAu+DjDP///wgAAAAAAAAAAAAAAAAAAAAAAAAAAAAAAAAAAAAAZAAAAAEAAABAAAAAAAAAAAAAAAAAAAAAAAAAAAAAAAAAAAAAAAAAAAAAAAAAAAAAAAAAAAAAAAAAAAAAAAAAAAAAAAAAAAAAAAAAAAAAAAAAAAAAAAAAAAAAAAAAAAAAFAAAADwAAAAAAAAAAAAAAAAAAAkUAAAAAQAAABQAAAAUAAAAFAAAAAEAAAAAAAAAZAAAAGQAAAAAAAAAZAAAAGQAAAAVAAAAYAAAAAAAAAAAAAAADwAAACADAAAAAAAAAAAAAAEAAACgMgAAVgcAAKr4//8BAAAAf39/AAEAAABkAAAAAAAAABQAAABAHwAAAAAAACYAAAAAAAAAwOD//wAAAAAmAAAAZAAAABYAAABMAAAAAAAAAAAAAAAEAAAAAAAAAAEAAACAgIAKAAAAACgAAAAoAAAAZAAAAGQAAAAAAAAAzMzMAAAAAABQAAAAUAAAAGQAAABkAAAAAAAAABcAAAAUAAAAAAAAANwIAAD/fwAA/38AAAAAAAAJAAAABAAAACMAAAAeAAAAaAAAAAAAAAAAAAAAAAAAAAAAAAAAAAAAECcAABAnAAAAAAAAAAAAAAAAAAAAAAAAAAAAAAAAAAAAAAAAAAAAABQAAAAAAAAAwMD/AAAAAABkAAAAMgAAAAAAAABkAAAAAAAAAH9/fwAKAAAAIgAAABgAAAAAAAAAAAAAAAAAAAAAAAAAAAAAAAAAAAAkAAAAJAAAAAAAAAAHAAAAAAAAAAAAAAAAAAAAAAAAAAAAAAAAAAAAf39/ACUAAABYAAAAAAAAAAAAAAAAAAAAAAAAAAAAAAAAAAAAAAAAAAAAAAAAAAAAAAAAAAAAAAA/AAAAAAAAAKCGAQAAAAAAAAAAAAAAAAAMAAAAAQAAAAAAAAAAAAAAAAAAAB8AAABUAAAAu+DjBf///wEAAAAAAAAAAAAAAAAAAAAAAAAAAAAAAAAAAAAAAAAAAAAAAAJ/f38AgICAA8zMzADAwP8Af39/AAAAAAAAAAAAAAAAAAAAAAAAAAAAIQAAABgAAAAUAAAA3yIAADUNAABpNQAAdQ8AAAAgAAAmAAAACAAAAP//////////"/>
+                <pr:smNativeData xmlns:pr="smNativeData" xmlns="smNativeData" val="SMDATA_15_ZqHWaRMAAAAlAAAAEgAAAE8BAAAAkAAAAEgAAACQAAAASAAAAAAAAAAAAAAAAAAAAAEAAABQAAAAAAAAAAAA4D8AAAAAAADgPwAAAAAAAOA/AAAAAAAA4D8AAAAAAADgPwAAAAAAAOA/AAAAAAAA4D8AAAAAAADgPwAAAAAAAOA/AAAAAAAA4D8CAAAAjAAAAAAAAAAAAAAAu+DjDP///wgAAAAAAAAAAAAAAAAAAAAAAAAAAAAAAAAAAAAAZAAAAAEAAABAAAAAAAAAAAAAAAAAAAAAAAAAAAAAAAAAAAAAAAAAAAAAAAAAAAAAAAAAAAAAAAAAAAAAAAAAAAAAAAAAAAAAAAAAAAAAAAAAAAAAAAAAAAAAAAAAAAAAFAAAADwAAAAAAAAAAAAAAAAAAAkUAAAAAQAAABQAAAAUAAAAFAAAAAEAAAAAAAAAZAAAAGQAAAAAAAAAZAAAAGQAAAAVAAAAYAAAAAAAAAAAAAAADwAAACADAAAAAAAAAAAAAAEAAACgMgAAVgcAAKr4//8BAAAAf39/AAEAAABkAAAAAAAAABQAAABAHwAAAAAAACYAAAAAAAAAwOD//wAAAAAmAAAAZAAAABYAAABMAAAAAAAAAAAAAAAEAAAAAAAAAAEAAACAgIAKAAAAACgAAAAoAAAAZAAAAGQAAAAAAAAAzMzMAAAAAABQAAAAUAAAAGQAAABkAAAAAAAAABcAAAAUAAAAAAAAANwIAAD/fwAA/38AAAAAAAAJAAAABAAAACMAAAAeAAAAaAAAAAAAAAAAAAAAAAAAAAAAAAAAAAAAECcAABAnAAAAAAAAAAAAAAAAAAAAAAAAAAAAAAAAAAAAAAAAAAAAABQAAAAAAAAAwMD/AAAAAABkAAAAMgAAAAAAAABkAAAAAAAAAH9/fwAKAAAAIgAAABgAAAAAAAAAAAAAAAAAAAAAAAAAAAAAAAAAAAAkAAAAJAAAAAAAAAAHAAAAAAAAAAAAAAAAAAAAAAAAAAAAAAAAAAAAf39/ACUAAABYAAAAAAAAAAAAAAAAAAAAAAAAAAAAAAAAAAAAAAAAAAAAAAAAAAAAAAAAAAAAAAA/AAAAAAAAAKCGAQAAAAAAAAAAAAAAAAAMAAAAAQAAAAAAAAAAAAAAAAAAAB8AAABUAAAAu+DjBf///wEAAAAAAAAAAAAAAAAAAAAAAAAAAAAAAAAAAAAAAAAAAAAAAAJ/f38AgICAA8zMzADAwP8Af39/AAAAAAAAAAAAAAAAAAAAAAAAAAAAIQAAABgAAAAUAAAA3yIAADUNAABpNQAAdQ8AAAAgAAAmAAAACAAAAP//////////"/>
               </a:ext>
             </a:extLst>
           </p:cNvSpPr>
@@ -3739,7 +3739,7 @@
           <p:cNvSpPr txBox="1">
             <a:extLst>
               <a:ext uri="smNativeData">
-                <pr:smNativeData xmlns:pr="smNativeData" xmlns="smNativeData" val="SMDATA_15_7aDWaRMAAAAlAAAAEgAAAE8BAAAAkAAAAEgAAACQAAAASAAAAAAAAAAAAAAAAAAAAAEAAABQAAAAAAAAAAAA4D8AAAAAAADgPwAAAAAAAOA/AAAAAAAA4D8AAAAAAADgPwAAAAAAAOA/AAAAAAAA4D8AAAAAAADgPwAAAAAAAOA/AAAAAAAA4D8CAAAAjAAAAAAAAAAAAAAAu+DjDP///wgAAAAAAAAAAAAAAAAAAAAAAAAAAAAAAAAAAAAAZAAAAAEAAABAAAAAAAAAAAAAAAAAAAAAAAAAAAAAAAAAAAAAAAAAAAAAAAAAAAAAAAAAAAAAAAAAAAAAAAAAAAAAAAAAAAAAAAAAAAAAAAAAAAAAAAAAAAAAAAAAAAAAFAAAADwAAAAAAAAAAAAAAAAAAAkUAAAAAQAAABQAAAAUAAAAFAAAAAEAAAAAAAAAZAAAAGQAAAAAAAAAZAAAAGQAAAAVAAAAYAAAAAAAAAAAAAAADwAAACADAAAAAAAAAAAAAAEAAACgMgAAVgcAAKr4//8BAAAAf39/AAEAAABkAAAAAAAAABQAAABAHwAAAAAAACYAAAAAAAAAwOD//wAAAAAmAAAAZAAAABYAAABMAAAAAAAAAAAAAAAEAAAAAAAAAAEAAACAgIAKAAAAACgAAAAoAAAAZAAAAGQAAAAAAAAAzMzMAAAAAABQAAAAUAAAAGQAAABkAAAAAAAAABcAAAAUAAAAAAAAANwIAAD/fwAA/38AAAAAAAAJAAAABAAAAEkAAAAeAAAAaAAAAAAAAAAAAAAAAAAAAAAAAAAAAAAAECcAABAnAAAAAAAAAAAAAAAAAAAAAAAAAAAAAAAAAAAAAAAAAAAAABQAAAAAAAAAwMD/AAAAAABkAAAAMgAAAAAAAABkAAAAAAAAAH9/fwAKAAAAIgAAABgAAAAAAAAAAAAAAAAAAAAAAAAAAAAAAAAAAAAkAAAAJAAAAAAAAAAHAAAAAAAAAAAAAAAAAAAAAAAAAAAAAAAAAAAAf39/ACUAAABYAAAAAAAAAAAAAAAAAAAAAAAAAAAAAAAAAAAAAAAAAAAAAAAAAAAAAAAAAAAAAAA/AAAAAAAAAKCGAQAAAAAAAAAAAAAAAAAMAAAAAQAAAAAAAAAAAAAAAAAAAB8AAABUAAAAu+DjBf///wEAAAAAAAAAAAAAAAAAAAAAAAAAAAAAAAAAAAAAAAAAAAAAAAJ/f38AgICAA8zMzADAwP8Af39/AAAAAAAAAAAAAAAAAAAAAAAAAAAAIQAAABgAAAAUAAAA3yIAAO4QAABpNQAALhMAAAAgAAAmAAAACAAAAP//////////"/>
+                <pr:smNativeData xmlns:pr="smNativeData" xmlns="smNativeData" val="SMDATA_15_ZqHWaRMAAAAlAAAAEgAAAE8BAAAAkAAAAEgAAACQAAAASAAAAAAAAAAAAAAAAAAAAAEAAABQAAAAAAAAAAAA4D8AAAAAAADgPwAAAAAAAOA/AAAAAAAA4D8AAAAAAADgPwAAAAAAAOA/AAAAAAAA4D8AAAAAAADgPwAAAAAAAOA/AAAAAAAA4D8CAAAAjAAAAAAAAAAAAAAAu+DjDP///wgAAAAAAAAAAAAAAAAAAAAAAAAAAAAAAAAAAAAAZAAAAAEAAABAAAAAAAAAAAAAAAAAAAAAAAAAAAAAAAAAAAAAAAAAAAAAAAAAAAAAAAAAAAAAAAAAAAAAAAAAAAAAAAAAAAAAAAAAAAAAAAAAAAAAAAAAAAAAAAAAAAAAFAAAADwAAAAAAAAAAAAAAAAAAAkUAAAAAQAAABQAAAAUAAAAFAAAAAEAAAAAAAAAZAAAAGQAAAAAAAAAZAAAAGQAAAAVAAAAYAAAAAAAAAAAAAAADwAAACADAAAAAAAAAAAAAAEAAACgMgAAVgcAAKr4//8BAAAAf39/AAEAAABkAAAAAAAAABQAAABAHwAAAAAAACYAAAAAAAAAwOD//wAAAAAmAAAAZAAAABYAAABMAAAAAAAAAAAAAAAEAAAAAAAAAAEAAACAgIAKAAAAACgAAAAoAAAAZAAAAGQAAAAAAAAAzMzMAAAAAABQAAAAUAAAAGQAAABkAAAAAAAAABcAAAAUAAAAAAAAANwIAAD/fwAA/38AAAAAAAAJAAAABAAAAEkAAAAeAAAAaAAAAAAAAAAAAAAAAAAAAAAAAAAAAAAAECcAABAnAAAAAAAAAAAAAAAAAAAAAAAAAAAAAAAAAAAAAAAAAAAAABQAAAAAAAAAwMD/AAAAAABkAAAAMgAAAAAAAABkAAAAAAAAAH9/fwAKAAAAIgAAABgAAAAAAAAAAAAAAAAAAAAAAAAAAAAAAAAAAAAkAAAAJAAAAAAAAAAHAAAAAAAAAAAAAAAAAAAAAAAAAAAAAAAAAAAAf39/ACUAAABYAAAAAAAAAAAAAAAAAAAAAAAAAAAAAAAAAAAAAAAAAAAAAAAAAAAAAAAAAAAAAAA/AAAAAAAAAKCGAQAAAAAAAAAAAAAAAAAMAAAAAQAAAAAAAAAAAAAAAAAAAB8AAABUAAAAu+DjBf///wEAAAAAAAAAAAAAAAAAAAAAAAAAAAAAAAAAAAAAAAAAAAAAAAJ/f38AgICAA8zMzADAwP8Af39/AAAAAAAAAAAAAAAAAAAAAAAAAAAAIQAAABgAAAAUAAAA3yIAAO4QAABpNQAALhMAAAAgAAAmAAAACAAAAP//////////"/>
               </a:ext>
             </a:extLst>
           </p:cNvSpPr>
@@ -3776,7 +3776,7 @@
           <p:cNvSpPr txBox="1">
             <a:extLst>
               <a:ext uri="smNativeData">
-                <pr:smNativeData xmlns:pr="smNativeData" xmlns="smNativeData" val="SMDATA_15_7aDWaRMAAAAlAAAAEgAAAE8BAAAAkAAAAEgAAACQAAAASAAAAAAAAAAAAAAAAAAAAAEAAABQAAAAAAAAAAAA4D8AAAAAAADgPwAAAAAAAOA/AAAAAAAA4D8AAAAAAADgPwAAAAAAAOA/AAAAAAAA4D8AAAAAAADgPwAAAAAAAOA/AAAAAAAA4D8CAAAAjAAAAAAAAAAAAAAAu+DjDP///wgAAAAAAAAAAAAAAAAAAAAAAAAAAAAAAAAAAAAAZAAAAAEAAABAAAAAAAAAAAAAAAAAAAAAAAAAAAAAAAAAAAAAAAAAAAAAAAAAAAAAAAAAAAAAAAAAAAAAAAAAAAAAAAAAAAAAAAAAAAAAAAAAAAAAAAAAAAAAAAAAAAAAFAAAADwAAAAAAAAAAAAAAAAAAAkUAAAAAQAAABQAAAAUAAAAFAAAAAEAAAAAAAAAZAAAAGQAAAAAAAAAZAAAAGQAAAAVAAAAYAAAAAAAAAAAAAAADwAAACADAAAAAAAAAAAAAAEAAACgMgAAVgcAAKr4//8BAAAAf39/AAEAAABkAAAAAAAAABQAAABAHwAAAAAAACYAAAAAAAAAwOD//wAAAAAmAAAAZAAAABYAAABMAAAAAAAAAAAAAAAEAAAAAAAAAAEAAACAgIAKAAAAACgAAAAoAAAAZAAAAGQAAAAAAAAAzMzMAAAAAABQAAAAUAAAAGQAAABkAAAAAAAAABcAAAAUAAAAAAAAANwIAAD/fwAA/38AAAAAAAAJAAAABAAAAAAAAQAeAAAAaAAAAAAAAAAAAAAAAAAAAAAAAAAAAAAAECcAABAnAAAAAAAAAAAAAAAAAAAAAAAAAAAAAAAAAAAAAAAAAAAAABQAAAAAAAAAwMD/AAAAAABkAAAAMgAAAAAAAABkAAAAAAAAAH9/fwAKAAAAIgAAABgAAAAAAAAAAAAAAAAAAAAAAAAAAAAAAAAAAAAkAAAAJAAAAAAAAAAHAAAAAAAAAAAAAAAAAAAAAAAAAAAAAAAAAAAAf39/ACUAAABYAAAAAAAAAAAAAAAAAAAAAAAAAAAAAAAAAAAAAAAAAAAAAAAAAAAAAAAAAAAAAAA/AAAAAAAAAKCGAQAAAAAAAAAAAAAAAAAMAAAAAQAAAAAAAAAAAAAAAAAAAB8AAABUAAAAu+DjBf///wEAAAAAAAAAAAAAAAAAAAAAAAAAAAAAAAAAAAAAAAAAAAAAAAJ/f38AgICAA8zMzADAwP8Af39/AAAAAAAAAAAAAAAAAAAAAAAAAAAAIQAAABgAAAAUAAAA3yIAAKcUAABpNQAA5xYAAAAgAAAmAAAACAAAAP//////////"/>
+                <pr:smNativeData xmlns:pr="smNativeData" xmlns="smNativeData" val="SMDATA_15_ZqHWaRMAAAAlAAAAEgAAAE8BAAAAkAAAAEgAAACQAAAASAAAAAAAAAAAAAAAAAAAAAEAAABQAAAAAAAAAAAA4D8AAAAAAADgPwAAAAAAAOA/AAAAAAAA4D8AAAAAAADgPwAAAAAAAOA/AAAAAAAA4D8AAAAAAADgPwAAAAAAAOA/AAAAAAAA4D8CAAAAjAAAAAAAAAAAAAAAu+DjDP///wgAAAAAAAAAAAAAAAAAAAAAAAAAAAAAAAAAAAAAZAAAAAEAAABAAAAAAAAAAAAAAAAAAAAAAAAAAAAAAAAAAAAAAAAAAAAAAAAAAAAAAAAAAAAAAAAAAAAAAAAAAAAAAAAAAAAAAAAAAAAAAAAAAAAAAAAAAAAAAAAAAAAAFAAAADwAAAAAAAAAAAAAAAAAAAkUAAAAAQAAABQAAAAUAAAAFAAAAAEAAAAAAAAAZAAAAGQAAAAAAAAAZAAAAGQAAAAVAAAAYAAAAAAAAAAAAAAADwAAACADAAAAAAAAAAAAAAEAAACgMgAAVgcAAKr4//8BAAAAf39/AAEAAABkAAAAAAAAABQAAABAHwAAAAAAACYAAAAAAAAAwOD//wAAAAAmAAAAZAAAABYAAABMAAAAAAAAAAAAAAAEAAAAAAAAAAEAAACAgIAKAAAAACgAAAAoAAAAZAAAAGQAAAAAAAAAzMzMAAAAAABQAAAAUAAAAGQAAABkAAAAAAAAABcAAAAUAAAAAAAAANwIAAD/fwAA/38AAAAAAAAJAAAABAAAAAAAAQAeAAAAaAAAAAAAAAAAAAAAAAAAAAAAAAAAAAAAECcAABAnAAAAAAAAAAAAAAAAAAAAAAAAAAAAAAAAAAAAAAAAAAAAABQAAAAAAAAAwMD/AAAAAABkAAAAMgAAAAAAAABkAAAAAAAAAH9/fwAKAAAAIgAAABgAAAAAAAAAAAAAAAAAAAAAAAAAAAAAAAAAAAAkAAAAJAAAAAAAAAAHAAAAAAAAAAAAAAAAAAAAAAAAAAAAAAAAAAAAf39/ACUAAABYAAAAAAAAAAAAAAAAAAAAAAAAAAAAAAAAAAAAAAAAAAAAAAAAAAAAAAAAAAAAAAA/AAAAAAAAAKCGAQAAAAAAAAAAAAAAAAAMAAAAAQAAAAAAAAAAAAAAAAAAAB8AAABUAAAAu+DjBf///wEAAAAAAAAAAAAAAAAAAAAAAAAAAAAAAAAAAAAAAAAAAAAAAAJ/f38AgICAA8zMzADAwP8Af39/AAAAAAAAAAAAAAAAAAAAAAAAAAAAIQAAABgAAAAUAAAA3yIAAKcUAABpNQAA5xYAAAAgAAAmAAAACAAAAP//////////"/>
               </a:ext>
             </a:extLst>
           </p:cNvSpPr>
@@ -3813,7 +3813,7 @@
           <p:cNvSpPr>
             <a:extLst>
               <a:ext uri="smNativeData">
-                <pr:smNativeData xmlns:pr="smNativeData" xmlns="smNativeData" val="SMDATA_15_7aDWaRMAAAAlAAAACgAAAA8BAAAAkAAAAEgAAACQAAAASAAAAAAAAAAAAAAAAAAAAAEAAABQAAAAAAAAAAAA4D8AAAAAAADgPwAAAAAAAOA/AAAAAAAA4D8AAAAAAADgPwAAAAAAAOA/AAAAAAAA4D8AAAAAAADgPwAAAAAAAOA/AAAAAAAA4D8CAAAAjAAAAAAAAAAAAAAAu+DjDP///wgAAAAAAAAAAAAAAAAAAAAAAAAAAAAAAAAAAAAAZAAAAAEAAABAAAAAAAAAAAAAAAAAAAAAAAAAAAAAAAAAAAAAAAAAAAAAAAAAAAAAAAAAAAAAAAAAAAAAAAAAAAAAAAAAAAAAAAAAAAAAAAAAAAAAAAAAAAAAAAAAAAAAFAAAADwAAAABAAAAAAAAAAAAAAlkAAAAAQAAABQAAAAUAAAAFAAAAAEAAAAAAAAAZAAAAGQAAAABAAAAlgAAAJYAAAAVAAAAYAAAAAAAAAAAAAAADwAAACADAAAAAAAAAAAAAAEAAACgMgAAVgcAAKr4//8BAAAAf39/AAEAAABkAAAAAAAAABQAAABAHwAAAAAAACYAAAAAAAAAwOD//wAAAAAmAAAAZAAAABYAAABMAAAAAAAAAAAAAAAEAAAAAAAAAAEAAACAgIAKAAAAACgAAAAoAAAAZAAAAGQAAAAAAAAAzMzMAAAAAABQAAAAUAAAAGQAAABkAAAAAAAAABcAAAAUAAAAAAAAAAAAAAD/fwAA/38AAAAAAAAJAAAABAAAAAAAAAAeAAAAaAAAAAAAAAAAAAAAAAAAAAAAAAAAAAAAECcAABAnAAAAAAAAAAAAAAAAAAAAAAAAAAAAAAAAAAAAAAAAAAAAABQAAAAAAAAAwMD/AAAAAABkAAAAMgAAAAAAAABkAAAAAAAAAH9/fwAKAAAAIgAAABgAAAAAAAAAAAAAAAAAAAAAAAAAAAAAAAAAAAAkAAAAJAAAAAAAAAAHAAAAAAAAAAAAAAAAAAAAAAAAAAAAAAAAAAAAf39/ACUAAABYAAAAAAAAAAAAAAAAAAAAAAAAAAAAAAAAAAAAAAAAAAAAAAAAAAAAAAAAAAAAAAA/AAAAAAAAAKCGAQAAAAAAAAAAAAAAAAAMAAAAAQAAAAAAAAAAAAAAAAAAAB8AAABUAAAAu+DjBf///wEAAAAAAAAAAAAAAAAAAAAAAAAAAAAAAAAAAAAAAAAAAAAAAAJ/f38AgICAA8zMzADAwP8Af39/AAAAAAAAAAAAAAAAAAAAAAAAAAAAIQAAABgAAAAUAAAAMBUAAI8OAACqIAAAkQ4AAAAAAAAmAAAACAAAAP//////////"/>
+                <pr:smNativeData xmlns:pr="smNativeData" xmlns="smNativeData" val="SMDATA_15_ZqHWaRMAAAAlAAAACgAAAA8BAAAAkAAAAEgAAACQAAAASAAAAAAAAAAAAAAAAAAAAAEAAABQAAAAAAAAAAAA4D8AAAAAAADgPwAAAAAAAOA/AAAAAAAA4D8AAAAAAADgPwAAAAAAAOA/AAAAAAAA4D8AAAAAAADgPwAAAAAAAOA/AAAAAAAA4D8CAAAAjAAAAAAAAAAAAAAAu+DjDP///wgAAAAAAAAAAAAAAAAAAAAAAAAAAAAAAAAAAAAAZAAAAAEAAABAAAAAAAAAAAAAAAAAAAAAAAAAAAAAAAAAAAAAAAAAAAAAAAAAAAAAAAAAAAAAAAAAAAAAAAAAAAAAAAAAAAAAAAAAAAAAAAAAAAAAAAAAAAAAAAAAAAAAFAAAADwAAAABAAAAAAAAAAAAAAlkAAAAAQAAABQAAAAUAAAAFAAAAAEAAAAAAAAAZAAAAGQAAAABAAAAlgAAAJYAAAAVAAAAYAAAAAAAAAAAAAAADwAAACADAAAAAAAAAAAAAAEAAACgMgAAVgcAAKr4//8BAAAAf39/AAEAAABkAAAAAAAAABQAAABAHwAAAAAAACYAAAAAAAAAwOD//wAAAAAmAAAAZAAAABYAAABMAAAAAAAAAAAAAAAEAAAAAAAAAAEAAACAgIAKAAAAACgAAAAoAAAAZAAAAGQAAAAAAAAAzMzMAAAAAABQAAAAUAAAAGQAAABkAAAAAAAAABcAAAAUAAAAAAAAAAAAAAD/fwAA/38AAAAAAAAJAAAABAAAAAAAAAAeAAAAaAAAAAAAAAAAAAAAAAAAAAAAAAAAAAAAECcAABAnAAAAAAAAAAAAAAAAAAAAAAAAAAAAAAAAAAAAAAAAAAAAABQAAAAAAAAAwMD/AAAAAABkAAAAMgAAAAAAAABkAAAAAAAAAH9/fwAKAAAAIgAAABgAAAAAAAAAAAAAAAAAAAAAAAAAAAAAAAAAAAAkAAAAJAAAAAAAAAAHAAAAAAAAAAAAAAAAAAAAAAAAAAAAAAAAAAAAf39/ACUAAABYAAAAAAAAAAAAAAAAAAAAAAAAAAAAAAAAAAAAAAAAAAAAAAAAAAAAAAAAAAAAAAA/AAAAAAAAAKCGAQAAAAAAAAAAAAAAAAAMAAAAAQAAAAAAAAAAAAAAAAAAAB8AAABUAAAAu+DjBf///wEAAAAAAAAAAAAAAAAAAAAAAAAAAAAAAAAAAAAAAAAAAAAAAAJ/f38AgICAA8zMzADAwP8Af39/AAAAAAAAAAAAAAAAAAAAAAAAAAAAIQAAABgAAAAUAAAAMBUAAI8OAACqIAAAkQ4AAAAAAAAmAAAACAAAAP//////////"/>
               </a:ext>
             </a:extLst>
           </p:cNvSpPr>
@@ -3845,7 +3845,7 @@
           <p:cNvSpPr>
             <a:extLst>
               <a:ext uri="smNativeData">
-                <pr:smNativeData xmlns:pr="smNativeData" xmlns="smNativeData" val="SMDATA_15_7aDWaRMAAAAlAAAACgAAAA8BAAAAkAAAAEgAAACQAAAASAAAAAAAAAAAAAAAAAAAAAEAAABQAAAAAAAAAAAA4D8AAAAAAADgPwAAAAAAAOA/AAAAAAAA4D8AAAAAAADgPwAAAAAAAOA/AAAAAAAA4D8AAAAAAADgPwAAAAAAAOA/AAAAAAAA4D8CAAAAjAAAAAAAAAAAAAAAu+DjDP///wgAAAAAAAAAAAAAAAAAAAAAAAAAAAAAAAAAAAAAZAAAAAEAAABAAAAAAAAAAAAAAAAAAAAAAAAAAAAAAAAAAAAAAAAAAAAAAAAAAAAAAAAAAAAAAAAAAAAAAAAAAAAAAAAAAAAAAAAAAAAAAAAAAAAAAAAAAAAAAAAAAAAAFAAAADwAAAABAAAAAQAAAAAAAAlkAAAAAQAAABQAAAAUAAAAFAAAAAEAAAAAAAAAZAAAAGQAAAABAAAAlgAAAJYAAAAVAAAAYAAAAAAAAAAAAAAADwAAACADAAAAAAAAAAAAAAEAAACgMgAAVgcAAKr4//8BAAAAf39/AAEAAABkAAAAAAAAABQAAABAHwAAAAAAACYAAAAAAAAAwOD//wAAAAAmAAAAZAAAABYAAABMAAAAAAAAAAAAAAAEAAAAAAAAAAEAAACAgIAKAAAAACgAAAAoAAAAZAAAAGQAAAAAAAAAzMzMAAAAAABQAAAAUAAAAGQAAABkAAAAAAAAABcAAAAUAAAAAAAAAAAAAAD/fwAA/38AAAAAAAAJAAAABAAAAEC5/SQeAAAAaAAAAAAAAAAAAAAAAAAAAAAAAAAAAAAAECcAABAnAAAAAAAAAAAAAAAAAAAAAAAAAAAAAAAAAAAAAAAAAAAAABQAAAAAAAAAwMD/AAAAAABkAAAAMgAAAAAAAABkAAAAAAAAAH9/fwAKAAAAIgAAABgAAAAAAAAAAAAAAAAAAAAAAAAAAAAAAAAAAAAkAAAAJAAAAAAAAAAHAAAAAAAAAAAAAAAAAAAAAAAAAAAAAAAAAAAAf39/ACUAAABYAAAAAAAAAAAAAAAAAAAAAAAAAAAAAAAAAAAAAAAAAAAAAAAAAAAAAAAAAAAAAAA/AAAAAAAAAKCGAQAAAAAAAAAAAAAAAAAMAAAAAQAAAAAAAAAAAAAAAAAAAB8AAABUAAAAu+DjBf///wEAAAAAAAAAAAAAAAAAAAAAAAAAAAAAAAAAAAAAAAAAAAAAAAJ/f38AgICAA8zMzADAwP8Af39/AAAAAAAAAAAAAAAAAAAAAAAAAAAAIQAAABgAAAAUAAAAMBUAABkSAACqIAAAGxIAAAAAAAAmAAAACAAAAP//////////"/>
+                <pr:smNativeData xmlns:pr="smNativeData" xmlns="smNativeData" val="SMDATA_15_ZqHWaRMAAAAlAAAACgAAAA8BAAAAkAAAAEgAAACQAAAASAAAAAAAAAAAAAAAAAAAAAEAAABQAAAAAAAAAAAA4D8AAAAAAADgPwAAAAAAAOA/AAAAAAAA4D8AAAAAAADgPwAAAAAAAOA/AAAAAAAA4D8AAAAAAADgPwAAAAAAAOA/AAAAAAAA4D8CAAAAjAAAAAAAAAAAAAAAu+DjDP///wgAAAAAAAAAAAAAAAAAAAAAAAAAAAAAAAAAAAAAZAAAAAEAAABAAAAAAAAAAAAAAAAAAAAAAAAAAAAAAAAAAAAAAAAAAAAAAAAAAAAAAAAAAAAAAAAAAAAAAAAAAAAAAAAAAAAAAAAAAAAAAAAAAAAAAAAAAAAAAAAAAAAAFAAAADwAAAABAAAAAQAAAAAAAAlkAAAAAQAAABQAAAAUAAAAFAAAAAEAAAAAAAAAZAAAAGQAAAABAAAAlgAAAJYAAAAVAAAAYAAAAAAAAAAAAAAADwAAACADAAAAAAAAAAAAAAEAAACgMgAAVgcAAKr4//8BAAAAf39/AAEAAABkAAAAAAAAABQAAABAHwAAAAAAACYAAAAAAAAAwOD//wAAAAAmAAAAZAAAABYAAABMAAAAAAAAAAAAAAAEAAAAAAAAAAEAAACAgIAKAAAAACgAAAAoAAAAZAAAAGQAAAAAAAAAzMzMAAAAAABQAAAAUAAAAGQAAABkAAAAAAAAABcAAAAUAAAAAAAAAAAAAAD/fwAA/38AAAAAAAAJAAAABAAAAEC5/SQeAAAAaAAAAAAAAAAAAAAAAAAAAAAAAAAAAAAAECcAABAnAAAAAAAAAAAAAAAAAAAAAAAAAAAAAAAAAAAAAAAAAAAAABQAAAAAAAAAwMD/AAAAAABkAAAAMgAAAAAAAABkAAAAAAAAAH9/fwAKAAAAIgAAABgAAAAAAAAAAAAAAAAAAAAAAAAAAAAAAAAAAAAkAAAAJAAAAAAAAAAHAAAAAAAAAAAAAAAAAAAAAAAAAAAAAAAAAAAAf39/ACUAAABYAAAAAAAAAAAAAAAAAAAAAAAAAAAAAAAAAAAAAAAAAAAAAAAAAAAAAAAAAAAAAAA/AAAAAAAAAKCGAQAAAAAAAAAAAAAAAAAMAAAAAQAAAAAAAAAAAAAAAAAAAB8AAABUAAAAu+DjBf///wEAAAAAAAAAAAAAAAAAAAAAAAAAAAAAAAAAAAAAAAAAAAAAAAJ/f38AgICAA8zMzADAwP8Af39/AAAAAAAAAAAAAAAAAAAAAAAAAAAAIQAAABgAAAAUAAAAMBUAABkSAACqIAAAGxIAAAAAAAAmAAAACAAAAP//////////"/>
               </a:ext>
             </a:extLst>
           </p:cNvSpPr>
@@ -3877,7 +3877,7 @@
           <p:cNvSpPr>
             <a:extLst>
               <a:ext uri="smNativeData">
-                <pr:smNativeData xmlns:pr="smNativeData" xmlns="smNativeData" val="SMDATA_15_7aDWaRMAAAAlAAAACgAAAA8BAAAAkAAAAEgAAACQAAAASAAAAAAAAAAAAAAAAAAAAAEAAABQAAAAAAAAAAAA4D8AAAAAAADgPwAAAAAAAOA/AAAAAAAA4D8AAAAAAADgPwAAAAAAAOA/AAAAAAAA4D8AAAAAAADgPwAAAAAAAOA/AAAAAAAA4D8CAAAAjAAAAAAAAAAAAAAAu+DjDP///wgAAAAAAAAAAAAAAAAAAAAAAAAAAAAAAAAAAAAAZAAAAAEAAABAAAAAAAAAAAAAAAAAAAAAAAAAAAAAAAAAAAAAAAAAAAAAAAAAAAAAAAAAAAAAAAAAAAAAAAAAAAAAAAAAAAAAAAAAAAAAAAAAAAAAAAAAAAAAAAAAAAAAFAAAADwAAAABAAAAAgAAAAAAAAlkAAAAAQAAABQAAAAUAAAAFAAAAAEAAAAAAAAAZAAAAGQAAAABAAAAlgAAAJYAAAAVAAAAYAAAAAAAAAAAAAAADwAAACADAAAAAAAAAAAAAAEAAACgMgAAVgcAAKr4//8BAAAAf39/AAEAAABkAAAAAAAAABQAAABAHwAAAAAAACYAAAAAAAAAwOD//wAAAAAmAAAAZAAAABYAAABMAAAAAAAAAAAAAAAEAAAAAAAAAAEAAACAgIAKAAAAACgAAAAoAAAAZAAAAGQAAAAAAAAAzMzMAAAAAABQAAAAUAAAAGQAAABkAAAAAAAAABcAAAAUAAAAAAAAAAAAAAD/fwAA/38AAAAAAAAJAAAABAAAAADB/SQeAAAAaAAAAAAAAAAAAAAAAAAAAAAAAAAAAAAAECcAABAnAAAAAAAAAAAAAAAAAAAAAAAAAAAAAAAAAAAAAAAAAAAAABQAAAAAAAAAwMD/AAAAAABkAAAAMgAAAAAAAABkAAAAAAAAAH9/fwAKAAAAIgAAABgAAAAAAAAAAAAAAAAAAAAAAAAAAAAAAAAAAAAkAAAAJAAAAAAAAAAHAAAAAAAAAAAAAAAAAAAAAAAAAAAAAAAAAAAAf39/ACUAAABYAAAAAAAAAAAAAAAAAAAAAAAAAAAAAAAAAAAAAAAAAAAAAAAAAAAAAAAAAAAAAAA/AAAAAAAAAKCGAQAAAAAAAAAAAAAAAAAMAAAAAQAAAAAAAAAAAAAAAAAAAB8AAABUAAAAu+DjBf///wEAAAAAAAAAAAAAAAAAAAAAAAAAAAAAAAAAAAAAAAAAAAAAAAJ/f38AgICAA8zMzADAwP8Af39/AAAAAAAAAAAAAAAAAAAAAAAAAAAAIQAAABgAAAAUAAAAMBUAABAWAACqIAAAEhYAAAAAAAAmAAAACAAAAP//////////"/>
+                <pr:smNativeData xmlns:pr="smNativeData" xmlns="smNativeData" val="SMDATA_15_ZqHWaRMAAAAlAAAACgAAAA8BAAAAkAAAAEgAAACQAAAASAAAAAAAAAAAAAAAAAAAAAEAAABQAAAAAAAAAAAA4D8AAAAAAADgPwAAAAAAAOA/AAAAAAAA4D8AAAAAAADgPwAAAAAAAOA/AAAAAAAA4D8AAAAAAADgPwAAAAAAAOA/AAAAAAAA4D8CAAAAjAAAAAAAAAAAAAAAu+DjDP///wgAAAAAAAAAAAAAAAAAAAAAAAAAAAAAAAAAAAAAZAAAAAEAAABAAAAAAAAAAAAAAAAAAAAAAAAAAAAAAAAAAAAAAAAAAAAAAAAAAAAAAAAAAAAAAAAAAAAAAAAAAAAAAAAAAAAAAAAAAAAAAAAAAAAAAAAAAAAAAAAAAAAAFAAAADwAAAABAAAAAgAAAAAAAAlkAAAAAQAAABQAAAAUAAAAFAAAAAEAAAAAAAAAZAAAAGQAAAABAAAAlgAAAJYAAAAVAAAAYAAAAAAAAAAAAAAADwAAACADAAAAAAAAAAAAAAEAAACgMgAAVgcAAKr4//8BAAAAf39/AAEAAABkAAAAAAAAABQAAABAHwAAAAAAACYAAAAAAAAAwOD//wAAAAAmAAAAZAAAABYAAABMAAAAAAAAAAAAAAAEAAAAAAAAAAEAAACAgIAKAAAAACgAAAAoAAAAZAAAAGQAAAAAAAAAzMzMAAAAAABQAAAAUAAAAGQAAABkAAAAAAAAABcAAAAUAAAAAAAAAAAAAAD/fwAA/38AAAAAAAAJAAAABAAAAADB/SQeAAAAaAAAAAAAAAAAAAAAAAAAAAAAAAAAAAAAECcAABAnAAAAAAAAAAAAAAAAAAAAAAAAAAAAAAAAAAAAAAAAAAAAABQAAAAAAAAAwMD/AAAAAABkAAAAMgAAAAAAAABkAAAAAAAAAH9/fwAKAAAAIgAAABgAAAAAAAAAAAAAAAAAAAAAAAAAAAAAAAAAAAAkAAAAJAAAAAAAAAAHAAAAAAAAAAAAAAAAAAAAAAAAAAAAAAAAAAAAf39/ACUAAABYAAAAAAAAAAAAAAAAAAAAAAAAAAAAAAAAAAAAAAAAAAAAAAAAAAAAAAAAAAAAAAA/AAAAAAAAAKCGAQAAAAAAAAAAAAAAAAAMAAAAAQAAAAAAAAAAAAAAAAAAAB8AAABUAAAAu+DjBf///wEAAAAAAAAAAAAAAAAAAAAAAAAAAAAAAAAAAAAAAAAAAAAAAAJ/f38AgICAA8zMzADAwP8Af39/AAAAAAAAAAAAAAAAAAAAAAAAAAAAIQAAABgAAAAUAAAAMBUAABAWAACqIAAAEhYAAAAAAAAmAAAACAAAAP//////////"/>
               </a:ext>
             </a:extLst>
           </p:cNvSpPr>
@@ -3941,7 +3941,7 @@
           <p:cNvSpPr txBox="1">
             <a:extLst>
               <a:ext uri="smNativeData">
-                <pr:smNativeData xmlns:pr="smNativeData" xmlns="smNativeData" val="SMDATA_15_7aDWaRMAAAAlAAAAEgAAAA8BAAAAkAAAAEgAAACQAAAASAAAAAAAAAABAAAAAAAAAAEAAABQAAAAAAAAAAAA4D8AAAAAAADgPwAAAAAAAOA/AAAAAAAA4D8AAAAAAADgPwAAAAAAAOA/AAAAAAAA4D8AAAAAAADgPwAAAAAAAOA/AAAAAAAA4D8CAAAAjAAAAAEAAAAAAAAAAP8AAP///wgAAAAAAAAAAAAAAAAAAAAAAAAAAAAAAAAAAAAAZAAAAAEAAABAAAAAAAAAAAAAAAAAAAAAAAAAAAAAAAAAAAAAAAAAAAAAAAAAAAAAAAAAAAAAAAAAAAAAAAAAAAAAAAAAAAAAAAAAAAAAAAAAAAAAAAAAAAAAAAAAAAAAFAAAADwAAAABAAAAAAAAAAAAAAkUAAAAAQAAABQAAAAUAAAAFAAAAAEAAAAAAAAAZAAAAGQAAAAAAAAAZAAAAGQAAAAVAAAAYAAAAAAAAAAAAAAADwAAACADAAAAAAAAAAAAAAEAAACgMgAAVgcAAKr4//8BAAAAf39/AAEAAABkAAAAAAAAABQAAABAHwAAAAAAACYAAAAAAAAAwOD//wAAAAAmAAAAZAAAABYAAABMAAAAAAAAAAAAAAAEAAAAAAAAAAEAAACAgIAKAAAAACgAAAAoAAAAZAAAAGQAAAAAAAAAzMzMAAAAAABQAAAAUAAAAGQAAABkAAAAAAAAABcAAAAUAAAAAAAAAIEHAAD/fwAA/38AAAAAAAAJAAAABAAAAAsAAAAeAAAAaAAAAAAAAAAAAAAAAAAAAAAAAAAAAAAAECcAABAnAAAAAAAAAAAAAAAAAAAAAAAAAAAAAAAAAAAAAAAAAAAAABQAAAAAAAAAwMD/AAAAAABkAAAAMgAAAAAAAABkAAAAAAAAAH9/fwAKAAAAIgAAABgAAAAAAAAAAAAAAAAAAAAAAAAAAAAAAAAAAAAkAAAAJAAAAAAAAAAHAAAAAAAAAAAAAAAAAAAAAAAAAAAAAAAAAAAAf39/ACUAAABYAAAAAAAAAAAAAAAAAAAAAAAAAAAAAAAAAAAAAAAAAAAAAAAAAAAAAAAAAAAAAAA/AAAAAAAAAKCGAQAAAAAAAAAAAAAAAAAMAAAAAQAAAAAAAAAAAAAAAAAAAB8AAABUAAAAAP8AAP///wEAAAAAAAAAAAAAAAAAAAAAAAAAAAAAAAAAAAAAAAAAAAAAAAJ/f38AgICAA8zMzADAwP8Af39/AAAAAAAAAAAAAAAAAAAAAAAAAAAAIQAAABgAAAAUAAAADyAAAP0MAAD6KwAA9hAAABAAAAAmAAAACAAAAP//////////"/>
+                <pr:smNativeData xmlns:pr="smNativeData" xmlns="smNativeData" val="SMDATA_15_ZqHWaRMAAAAlAAAAEgAAAA8BAAAAkAAAAEgAAACQAAAASAAAAAAAAAABAAAAAAAAAAEAAABQAAAAAAAAAAAA4D8AAAAAAADgPwAAAAAAAOA/AAAAAAAA4D8AAAAAAADgPwAAAAAAAOA/AAAAAAAA4D8AAAAAAADgPwAAAAAAAOA/AAAAAAAA4D8CAAAAjAAAAAEAAAAAAAAAAP8AAP///wgAAAAAAAAAAAAAAAAAAAAAAAAAAAAAAAAAAAAAZAAAAAEAAABAAAAAAAAAAAAAAAAAAAAAAAAAAAAAAAAAAAAAAAAAAAAAAAAAAAAAAAAAAAAAAAAAAAAAAAAAAAAAAAAAAAAAAAAAAAAAAAAAAAAAAAAAAAAAAAAAAAAAFAAAADwAAAABAAAAAAAAAAAAAAkUAAAAAQAAABQAAAAUAAAAFAAAAAEAAAAAAAAAZAAAAGQAAAAAAAAAZAAAAGQAAAAVAAAAYAAAAAAAAAAAAAAADwAAACADAAAAAAAAAAAAAAEAAACgMgAAVgcAAKr4//8BAAAAf39/AAEAAABkAAAAAAAAABQAAABAHwAAAAAAACYAAAAAAAAAwOD//wAAAAAmAAAAZAAAABYAAABMAAAAAAAAAAAAAAAEAAAAAAAAAAEAAACAgIAKAAAAACgAAAAoAAAAZAAAAGQAAAAAAAAAzMzMAAAAAABQAAAAUAAAAGQAAABkAAAAAAAAABcAAAAUAAAAAAAAAIEHAAD/fwAA/38AAAAAAAAJAAAABAAAAAsAAAAeAAAAaAAAAAAAAAAAAAAAAAAAAAAAAAAAAAAAECcAABAnAAAAAAAAAAAAAAAAAAAAAAAAAAAAAAAAAAAAAAAAAAAAABQAAAAAAAAAwMD/AAAAAABkAAAAMgAAAAAAAABkAAAAAAAAAH9/fwAKAAAAIgAAABgAAAAAAAAAAAAAAAAAAAAAAAAAAAAAAAAAAAAkAAAAJAAAAAAAAAAHAAAAAAAAAAAAAAAAAAAAAAAAAAAAAAAAAAAAf39/ACUAAABYAAAAAAAAAAAAAAAAAAAAAAAAAAAAAAAAAAAAAAAAAAAAAAAAAAAAAAAAAAAAAAA/AAAAAAAAAKCGAQAAAAAAAAAAAAAAAAAMAAAAAQAAAAAAAAAAAAAAAAAAAB8AAABUAAAAAP8AAP///wEAAAAAAAAAAAAAAAAAAAAAAAAAAAAAAAAAAAAAAAAAAAAAAAJ/f38AgICAA8zMzADAwP8Af39/AAAAAAAAAAAAAAAAAAAAAAAAAAAAIQAAABgAAAAUAAAADyAAAP0MAAD6KwAA9hAAABAAAAAmAAAACAAAAP//////////"/>
               </a:ext>
             </a:extLst>
           </p:cNvSpPr>
@@ -3993,7 +3993,7 @@
           <p:cNvSpPr txBox="1">
             <a:extLst>
               <a:ext uri="smNativeData">
-                <pr:smNativeData xmlns:pr="smNativeData" xmlns="smNativeData" val="SMDATA_15_7aDWaRMAAAAlAAAAEgAAAA8BAAAAkAAAAEgAAACQAAAASAAAAAAAAAABAAAAAAAAAAEAAABQAAAAAAAAAAAA4D8AAAAAAADgPwAAAAAAAOA/AAAAAAAA4D8AAAAAAADgPwAAAAAAAOA/AAAAAAAA4D8AAAAAAADgPwAAAAAAAOA/AAAAAAAA4D8CAAAAjAAAAAEAAAAAAAAAAP8AAP///wgAAAAAAAAAAAAAAAAAAAAAAAAAAAAAAAAAAAAAZAAAAAEAAABAAAAAAAAAAAAAAAAAAAAAAAAAAAAAAAAAAAAAAAAAAAAAAAAAAAAAAAAAAAAAAAAAAAAAAAAAAAAAAAAAAAAAAAAAAAAAAAAAAAAAAAAAAAAAAAAAAAAAFAAAADwAAAABAAAAAAAAAAAAAAkUAAAAAQAAABQAAAAUAAAAFAAAAAEAAAAAAAAAZAAAAGQAAAAAAAAAZAAAAGQAAAAVAAAAYAAAAAAAAAAAAAAADwAAACADAAAAAAAAAAAAAAEAAACgMgAAVgcAAKr4//8BAAAAf39/AAEAAABkAAAAAAAAABQAAABAHwAAAAAAACYAAAAAAAAAwOD//wAAAAAmAAAAZAAAABYAAABMAAAAAAAAAAAAAAAEAAAAAAAAAAEAAACAgIAKAAAAACgAAAAoAAAAZAAAAGQAAAAAAAAAzMzMAAAAAABQAAAAUAAAAGQAAABkAAAAAAAAABcAAAAUAAAAAAAAAIgDAAD/fwAA/38AAAAAAAAJAAAABAAAAA4AAAAeAAAAaAAAAAAAAAAAAAAAAAAAAAAAAAAAAAAAECcAABAnAAAAAAAAAAAAAAAAAAAAAAAAAAAAAAAAAAAAAAAAAAAAABQAAAAAAAAAwMD/AAAAAABkAAAAMgAAAAAAAABkAAAAAAAAAH9/fwAKAAAAIgAAABgAAAAAAAAAAAAAAAAAAAAAAAAAAAAAAAAAAAAkAAAAJAAAAAAAAAAHAAAAAAAAAAAAAAAAAAAAAAAAAAAAAAAAAAAAf39/ACUAAABYAAAAAAAAAAAAAAAAAAAAAAAAAAAAAAAAAAAAAAAAAAAAAAAAAAAAAAAAAAAAAAA/AAAAAAAAAKCGAQAAAAAAAAAAAAAAAAAMAAAAAQAAAAAAAAAAAAAAAAAAAB8AAABUAAAAAP8AAP///wEAAAAAAAAAAAAAAAAAAAAAAAAAAAAAAAAAAAAAAAAAAAAAAAJ/f38AgICAA8zMzADAwP8Af39/AAAAAAAAAAAAAAAAAAAAAAAAAAAAIQAAABgAAAAUAAAAJBQAAAENAACHHAAA+hAAABAAAAAmAAAACAAAAP//////////"/>
+                <pr:smNativeData xmlns:pr="smNativeData" xmlns="smNativeData" val="SMDATA_15_ZqHWaRMAAAAlAAAAEgAAAA8BAAAAkAAAAEgAAACQAAAASAAAAAAAAAABAAAAAAAAAAEAAABQAAAAAAAAAAAA4D8AAAAAAADgPwAAAAAAAOA/AAAAAAAA4D8AAAAAAADgPwAAAAAAAOA/AAAAAAAA4D8AAAAAAADgPwAAAAAAAOA/AAAAAAAA4D8CAAAAjAAAAAEAAAAAAAAAAP8AAP///wgAAAAAAAAAAAAAAAAAAAAAAAAAAAAAAAAAAAAAZAAAAAEAAABAAAAAAAAAAAAAAAAAAAAAAAAAAAAAAAAAAAAAAAAAAAAAAAAAAAAAAAAAAAAAAAAAAAAAAAAAAAAAAAAAAAAAAAAAAAAAAAAAAAAAAAAAAAAAAAAAAAAAFAAAADwAAAABAAAAAAAAAAAAAAkUAAAAAQAAABQAAAAUAAAAFAAAAAEAAAAAAAAAZAAAAGQAAAAAAAAAZAAAAGQAAAAVAAAAYAAAAAAAAAAAAAAADwAAACADAAAAAAAAAAAAAAEAAACgMgAAVgcAAKr4//8BAAAAf39/AAEAAABkAAAAAAAAABQAAABAHwAAAAAAACYAAAAAAAAAwOD//wAAAAAmAAAAZAAAABYAAABMAAAAAAAAAAAAAAAEAAAAAAAAAAEAAACAgIAKAAAAACgAAAAoAAAAZAAAAGQAAAAAAAAAzMzMAAAAAABQAAAAUAAAAGQAAABkAAAAAAAAABcAAAAUAAAAAAAAAIgDAAD/fwAA/38AAAAAAAAJAAAABAAAAA4AAAAeAAAAaAAAAAAAAAAAAAAAAAAAAAAAAAAAAAAAECcAABAnAAAAAAAAAAAAAAAAAAAAAAAAAAAAAAAAAAAAAAAAAAAAABQAAAAAAAAAwMD/AAAAAABkAAAAMgAAAAAAAABkAAAAAAAAAH9/fwAKAAAAIgAAABgAAAAAAAAAAAAAAAAAAAAAAAAAAAAAAAAAAAAkAAAAJAAAAAAAAAAHAAAAAAAAAAAAAAAAAAAAAAAAAAAAAAAAAAAAf39/ACUAAABYAAAAAAAAAAAAAAAAAAAAAAAAAAAAAAAAAAAAAAAAAAAAAAAAAAAAAAAAAAAAAAA/AAAAAAAAAKCGAQAAAAAAAAAAAAAAAAAMAAAAAQAAAAAAAAAAAAAAAAAAAB8AAABUAAAAAP8AAP///wEAAAAAAAAAAAAAAAAAAAAAAAAAAAAAAAAAAAAAAAAAAAAAAAJ/f38AgICAA8zMzADAwP8Af39/AAAAAAAAAAAAAAAAAAAAAAAAAAAAIQAAABgAAAAUAAAAJBQAAAENAACHHAAA+hAAABAAAAAmAAAACAAAAP//////////"/>
               </a:ext>
             </a:extLst>
           </p:cNvSpPr>
@@ -4045,7 +4045,7 @@
           <p:cNvSpPr txBox="1">
             <a:extLst>
               <a:ext uri="smNativeData">
-                <pr:smNativeData xmlns:pr="smNativeData" xmlns="smNativeData" val="SMDATA_15_7aDWaRMAAAAlAAAAEgAAAA8BAAAAkAAAAEgAAACQAAAASAAAAAAAAAABAAAAAAAAAAEAAABQAAAAAAAAAAAA4D8AAAAAAADgPwAAAAAAAOA/AAAAAAAA4D8AAAAAAADgPwAAAAAAAOA/AAAAAAAA4D8AAAAAAADgPwAAAAAAAOA/AAAAAAAA4D8CAAAAjAAAAAEAAAAAAAAAAP8AAP///wgAAAAAAAAAAAAAAAAAAAAAAAAAAAAAAAAAAAAAZAAAAAEAAABAAAAAAAAAAAAAAAAAAAAAAAAAAAAAAAAAAAAAAAAAAAAAAAAAAAAAAAAAAAAAAAAAAAAAAAAAAAAAAAAAAAAAAAAAAAAAAAAAAAAAAAAAAAAAAAAAAAAAFAAAADwAAAABAAAAAAAAAAAAAAkUAAAAAQAAABQAAAAUAAAAFAAAAAEAAAAAAAAAZAAAAGQAAAAAAAAAZAAAAGQAAAAVAAAAYAAAAAAAAAAAAAAADwAAACADAAAAAAAAAAAAAAEAAACgMgAAVgcAAKr4//8BAAAAf39/AAEAAABkAAAAAAAAABQAAABAHwAAAAAAACYAAAAAAAAAwOD//wAAAAAmAAAAZAAAABYAAABMAAAAAAAAAAAAAAAEAAAAAAAAAAEAAACAgIAKAAAAACgAAAAoAAAAZAAAAGQAAAAAAAAAzMzMAAAAAABQAAAAUAAAAGQAAABkAAAAAAAAABcAAAAUAAAAAAAAAIgDAAD/fwAA/38AAAAAAAAJAAAABAAAACMAAAAeAAAAaAAAAAAAAAAAAAAAAAAAAAAAAAAAAAAAECcAABAnAAAAAAAAAAAAAAAAAAAAAAAAAAAAAAAAAAAAAAAAAAAAABQAAAAAAAAAwMD/AAAAAABkAAAAMgAAAAAAAABkAAAAAAAAAH9/fwAKAAAAIgAAABgAAAAAAAAAAAAAAAAAAAAAAAAAAAAAAAAAAAAkAAAAJAAAAAAAAAAHAAAAAAAAAAAAAAAAAAAAAAAAAAAAAAAAAAAAf39/ACUAAABYAAAAAAAAAAAAAAAAAAAAAAAAAAAAAAAAAAAAAAAAAAAAAAAAAAAAAAAAAAAAAAA/AAAAAAAAAKCGAQAAAAAAAAAAAAAAAAAMAAAAAQAAAAAAAAAAAAAAAAAAAB8AAABUAAAAAP8AAP///wEAAAAAAAAAAAAAAAAAAAAAAAAAAAAAAAAAAAAAAAAAAAAAAAJ/f38AgICAA8zMzADAwP8Af39/AAAAAAAAAAAAAAAAAAAAAAAAAAAAIQAAABgAAAAUAAAAOxUAAJIGAABpGwAAiwoAABAAAAAmAAAACAAAAP//////////"/>
+                <pr:smNativeData xmlns:pr="smNativeData" xmlns="smNativeData" val="SMDATA_15_ZqHWaRMAAAAlAAAAEgAAAA8BAAAAkAAAAEgAAACQAAAASAAAAAAAAAABAAAAAAAAAAEAAABQAAAAAAAAAAAA4D8AAAAAAADgPwAAAAAAAOA/AAAAAAAA4D8AAAAAAADgPwAAAAAAAOA/AAAAAAAA4D8AAAAAAADgPwAAAAAAAOA/AAAAAAAA4D8CAAAAjAAAAAEAAAAAAAAAAP8AAP///wgAAAAAAAAAAAAAAAAAAAAAAAAAAAAAAAAAAAAAZAAAAAEAAABAAAAAAAAAAAAAAAAAAAAAAAAAAAAAAAAAAAAAAAAAAAAAAAAAAAAAAAAAAAAAAAAAAAAAAAAAAAAAAAAAAAAAAAAAAAAAAAAAAAAAAAAAAAAAAAAAAAAAFAAAADwAAAABAAAAAAAAAAAAAAkUAAAAAQAAABQAAAAUAAAAFAAAAAEAAAAAAAAAZAAAAGQAAAAAAAAAZAAAAGQAAAAVAAAAYAAAAAAAAAAAAAAADwAAACADAAAAAAAAAAAAAAEAAACgMgAAVgcAAKr4//8BAAAAf39/AAEAAABkAAAAAAAAABQAAABAHwAAAAAAACYAAAAAAAAAwOD//wAAAAAmAAAAZAAAABYAAABMAAAAAAAAAAAAAAAEAAAAAAAAAAEAAACAgIAKAAAAACgAAAAoAAAAZAAAAGQAAAAAAAAAzMzMAAAAAABQAAAAUAAAAGQAAABkAAAAAAAAABcAAAAUAAAAAAAAAIgDAAD/fwAA/38AAAAAAAAJAAAABAAAACMAAAAeAAAAaAAAAAAAAAAAAAAAAAAAAAAAAAAAAAAAECcAABAnAAAAAAAAAAAAAAAAAAAAAAAAAAAAAAAAAAAAAAAAAAAAABQAAAAAAAAAwMD/AAAAAABkAAAAMgAAAAAAAABkAAAAAAAAAH9/fwAKAAAAIgAAABgAAAAAAAAAAAAAAAAAAAAAAAAAAAAAAAAAAAAkAAAAJAAAAAAAAAAHAAAAAAAAAAAAAAAAAAAAAAAAAAAAAAAAAAAAf39/ACUAAABYAAAAAAAAAAAAAAAAAAAAAAAAAAAAAAAAAAAAAAAAAAAAAAAAAAAAAAAAAAAAAAA/AAAAAAAAAKCGAQAAAAAAAAAAAAAAAAAMAAAAAQAAAAAAAAAAAAAAAAAAAB8AAABUAAAAAP8AAP///wEAAAAAAAAAAAAAAAAAAAAAAAAAAAAAAAAAAAAAAAAAAAAAAAJ/f38AgICAA8zMzADAwP8Af39/AAAAAAAAAAAAAAAAAAAAAAAAAAAAIQAAABgAAAAUAAAAOxUAAJIGAABpGwAAiwoAABAAAAAmAAAACAAAAP//////////"/>
               </a:ext>
             </a:extLst>
           </p:cNvSpPr>
@@ -4097,7 +4097,7 @@
           <p:cNvSpPr txBox="1">
             <a:extLst>
               <a:ext uri="smNativeData">
-                <pr:smNativeData xmlns:pr="smNativeData" xmlns="smNativeData" val="SMDATA_15_7aDWaRMAAAAlAAAAEgAAAA8BAAAAkAAAAEgAAACQAAAASAAAAAAAAAABAAAAAAAAAAEAAABQAAAAAAAAAAAA4D8AAAAAAADgPwAAAAAAAOA/AAAAAAAA4D8AAAAAAADgPwAAAAAAAOA/AAAAAAAA4D8AAAAAAADgPwAAAAAAAOA/AAAAAAAA4D8CAAAAjAAAAAEAAAAAAAAA//8AAP///wgAAAAAAAAAAAAAAAAAAAAAAAAAAAAAAAAAAAAAZAAAAAEAAABAAAAAAAAAAAAAAAAAAAAAAAAAAAAAAAAAAAAAAAAAAAAAAAAAAAAAAAAAAAAAAAAAAAAAAAAAAAAAAAAAAAAAAAAAAAAAAAAAAAAAAAAAAAAAAAAAAAAAFAAAADwAAAABAAAAAAAAAAAAAAkUAAAAAQAAABQAAAAUAAAAFAAAAAEAAAAAAAAAZAAAAGQAAAAAAAAAZAAAAGQAAAAVAAAAYAAAAAAAAAAAAAAADwAAACADAAAAAAAAAAAAAAEAAACgMgAAVgcAAKr4//8BAAAAf39/AAEAAABkAAAAAAAAABQAAABAHwAAAAAAACYAAAAAAAAAwOD//wAAAAAmAAAAZAAAABYAAABMAAAAAAAAAAAAAAAEAAAAAAAAAAEAAACAgIAKAAAAACgAAAAoAAAAZAAAAGQAAAAAAAAAzMzMAAAAAABQAAAAUAAAAGQAAABkAAAAAAAAABcAAAAUAAAAAAAAAIgDAAD/fwAA/38AAAAAAAAJAAAABAAAAAEBAQEeAAAAaAAAAAAAAAAAAAAAAAAAAAAAAAAAAAAAECcAABAnAAAAAAAAAAAAAAAAAAAAAAAAAAAAAAAAAAAAAAAAAAAAABQAAAAAAAAAwMD/AAAAAABkAAAAMgAAAAAAAABkAAAAAAAAAH9/fwAKAAAAIgAAABgAAAAAAAAAAAAAAAAAAAAAAAAAAAAAAAAAAAAkAAAAJAAAAAAAAAAHAAAAAAAAAAAAAAAAAAAAAAAAAAAAAAAAAAAAf39/ACUAAABYAAAAAAAAAAAAAAAAAAAAAAAAAAAAAAAAAAAAAAAAAAAAAAAAAAAAAAAAAAAAAAA/AAAAAAAAAKCGAQAAAAAAAAAAAAAAAAAMAAAAAQAAAAAAAAAAAAAAAAAAAB8AAABUAAAA//8AAP///wEAAAAAAAAAAAAAAAAAAAAAAAAAAAAAAAAAAAAAAAAAAAAAAAJ/f38AgICAA8zMzADAwP8Af39/AAAAAAAAAAAAAAAAAAAAAAAAAAAAIQAAABgAAAAUAAAAwQsAAIgNAADvEQAAehAAABAAAAAmAAAACAAAAP//////////"/>
+                <pr:smNativeData xmlns:pr="smNativeData" xmlns="smNativeData" val="SMDATA_15_ZqHWaRMAAAAlAAAAEgAAAA8BAAAAkAAAAEgAAACQAAAASAAAAAAAAAABAAAAAAAAAAEAAABQAAAAAAAAAAAA4D8AAAAAAADgPwAAAAAAAOA/AAAAAAAA4D8AAAAAAADgPwAAAAAAAOA/AAAAAAAA4D8AAAAAAADgPwAAAAAAAOA/AAAAAAAA4D8CAAAAjAAAAAEAAAAAAAAA//8AAP///wgAAAAAAAAAAAAAAAAAAAAAAAAAAAAAAAAAAAAAZAAAAAEAAABAAAAAAAAAAAAAAAAAAAAAAAAAAAAAAAAAAAAAAAAAAAAAAAAAAAAAAAAAAAAAAAAAAAAAAAAAAAAAAAAAAAAAAAAAAAAAAAAAAAAAAAAAAAAAAAAAAAAAFAAAADwAAAABAAAAAAAAAAAAAAkUAAAAAQAAABQAAAAUAAAAFAAAAAEAAAAAAAAAZAAAAGQAAAAAAAAAZAAAAGQAAAAVAAAAYAAAAAAAAAAAAAAADwAAACADAAAAAAAAAAAAAAEAAACgMgAAVgcAAKr4//8BAAAAf39/AAEAAABkAAAAAAAAABQAAABAHwAAAAAAACYAAAAAAAAAwOD//wAAAAAmAAAAZAAAABYAAABMAAAAAAAAAAAAAAAEAAAAAAAAAAEAAACAgIAKAAAAACgAAAAoAAAAZAAAAGQAAAAAAAAAzMzMAAAAAABQAAAAUAAAAGQAAABkAAAAAAAAABcAAAAUAAAAAAAAAIgDAAD/fwAA/38AAAAAAAAJAAAABAAAAAEBAQEeAAAAaAAAAAAAAAAAAAAAAAAAAAAAAAAAAAAAECcAABAnAAAAAAAAAAAAAAAAAAAAAAAAAAAAAAAAAAAAAAAAAAAAABQAAAAAAAAAwMD/AAAAAABkAAAAMgAAAAAAAABkAAAAAAAAAH9/fwAKAAAAIgAAABgAAAAAAAAAAAAAAAAAAAAAAAAAAAAAAAAAAAAkAAAAJAAAAAAAAAAHAAAAAAAAAAAAAAAAAAAAAAAAAAAAAAAAAAAAf39/ACUAAABYAAAAAAAAAAAAAAAAAAAAAAAAAAAAAAAAAAAAAAAAAAAAAAAAAAAAAAAAAAAAAAA/AAAAAAAAAKCGAQAAAAAAAAAAAAAAAAAMAAAAAQAAAAAAAAAAAAAAAAAAAB8AAABUAAAA//8AAP///wEAAAAAAAAAAAAAAAAAAAAAAAAAAAAAAAAAAAAAAAAAAAAAAAJ/f38AgICAA8zMzADAwP8Af39/AAAAAAAAAAAAAAAAAAAAAAAAAAAAIQAAABgAAAAUAAAAwQsAAIgNAADvEQAAehAAABAAAAAmAAAACAAAAP//////////"/>
               </a:ext>
             </a:extLst>
           </p:cNvSpPr>
@@ -4141,7 +4141,7 @@
           <p:cNvSpPr txBox="1">
             <a:extLst>
               <a:ext uri="smNativeData">
-                <pr:smNativeData xmlns:pr="smNativeData" xmlns="smNativeData" val="SMDATA_15_7aDWaRMAAAAlAAAAEgAAAA8BAAAAkAAAAEgAAACQAAAASAAAAAAAAAABAAAAAAAAAAEAAABQAAAAAAAAAAAA4D8AAAAAAADgPwAAAAAAAOA/AAAAAAAA4D8AAAAAAADgPwAAAAAAAOA/AAAAAAAA4D8AAAAAAADgPwAAAAAAAOA/AAAAAAAA4D8CAAAAjAAAAAEAAAAAAAAAAP8AAP///wgAAAAAAAAAAAAAAAAAAAAAAAAAAAAAAAAAAAAAZAAAAAEAAABAAAAAAAAAAAAAAAAAAAAAAAAAAAAAAAAAAAAAAAAAAAAAAAAAAAAAAAAAAAAAAAAAAAAAAAAAAAAAAAAAAAAAAAAAAAAAAAAAAAAAAAAAAAAAAAAAAAAAFAAAADwAAAABAAAAAAAAAAAAAAkUAAAAAQAAABQAAAAUAAAAFAAAAAEAAAAAAAAAZAAAAGQAAAAAAAAAZAAAAGQAAAAVAAAAYAAAAAAAAAAAAAAADwAAACADAAAAAAAAAAAAAAEAAACgMgAAVgcAAKr4//8BAAAAf39/AAEAAABkAAAAAAAAABQAAABAHwAAAAAAACYAAAAAAAAAwOD//wAAAAAmAAAAZAAAABYAAABMAAAAAAAAAAAAAAAEAAAAAAAAAAEAAACAgIAKAAAAACgAAAAoAAAAZAAAAGQAAAAAAAAAzMzMAAAAAABQAAAAUAAAAGQAAABkAAAAAAAAABcAAAAUAAAAAAAAAIgDAAD/fwAA/38AAAAAAAAJAAAABAAAACMAAAAeAAAAaAAAAAAAAAAAAAAAAAAAAAAAAAAAAAAAECcAABAnAAAAAAAAAAAAAAAAAAAAAAAAAAAAAAAAAAAAAAAAAAAAABQAAAAAAAAAwMD/AAAAAABkAAAAMgAAAAAAAABkAAAAAAAAAH9/fwAKAAAAIgAAABgAAAAAAAAAAAAAAAAAAAAAAAAAAAAAAAAAAAAkAAAAJAAAAAAAAAAHAAAAAAAAAAAAAAAAAAAAAAAAAAAAAAAAAAAAf39/ACUAAABYAAAAAAAAAAAAAAAAAAAAAAAAAAAAAAAAAAAAAAAAAAAAAAAAAAAAAAAAAAAAAAA/AAAAAAAAAKCGAQAAAAAAAAAAAAAAAAAMAAAAAQAAAAAAAAAAAAAAAAAAAB8AAABUAAAAAP8AAP///wEAAAAAAAAAAAAAAAAAAAAAAAAAAAAAAAAAAAAAAAAAAAAAAAJ/f38AgICAA8zMzADAwP8Af39/AAAAAAAAAAAAAAAAAAAAAAAAAAAAIQAAABgAAAAUAAAAfiIAAHgGAACOKQAAcQoAABAAAAAmAAAACAAAAP//////////"/>
+                <pr:smNativeData xmlns:pr="smNativeData" xmlns="smNativeData" val="SMDATA_15_ZqHWaRMAAAAlAAAAEgAAAA8BAAAAkAAAAEgAAACQAAAASAAAAAAAAAABAAAAAAAAAAEAAABQAAAAAAAAAAAA4D8AAAAAAADgPwAAAAAAAOA/AAAAAAAA4D8AAAAAAADgPwAAAAAAAOA/AAAAAAAA4D8AAAAAAADgPwAAAAAAAOA/AAAAAAAA4D8CAAAAjAAAAAEAAAAAAAAAAP8AAP///wgAAAAAAAAAAAAAAAAAAAAAAAAAAAAAAAAAAAAAZAAAAAEAAABAAAAAAAAAAAAAAAAAAAAAAAAAAAAAAAAAAAAAAAAAAAAAAAAAAAAAAAAAAAAAAAAAAAAAAAAAAAAAAAAAAAAAAAAAAAAAAAAAAAAAAAAAAAAAAAAAAAAAFAAAADwAAAABAAAAAAAAAAAAAAkUAAAAAQAAABQAAAAUAAAAFAAAAAEAAAAAAAAAZAAAAGQAAAAAAAAAZAAAAGQAAAAVAAAAYAAAAAAAAAAAAAAADwAAACADAAAAAAAAAAAAAAEAAACgMgAAVgcAAKr4//8BAAAAf39/AAEAAABkAAAAAAAAABQAAABAHwAAAAAAACYAAAAAAAAAwOD//wAAAAAmAAAAZAAAABYAAABMAAAAAAAAAAAAAAAEAAAAAAAAAAEAAACAgIAKAAAAACgAAAAoAAAAZAAAAGQAAAAAAAAAzMzMAAAAAABQAAAAUAAAAGQAAABkAAAAAAAAABcAAAAUAAAAAAAAAIgDAAD/fwAA/38AAAAAAAAJAAAABAAAACMAAAAeAAAAaAAAAAAAAAAAAAAAAAAAAAAAAAAAAAAAECcAABAnAAAAAAAAAAAAAAAAAAAAAAAAAAAAAAAAAAAAAAAAAAAAABQAAAAAAAAAwMD/AAAAAABkAAAAMgAAAAAAAABkAAAAAAAAAH9/fwAKAAAAIgAAABgAAAAAAAAAAAAAAAAAAAAAAAAAAAAAAAAAAAAkAAAAJAAAAAAAAAAHAAAAAAAAAAAAAAAAAAAAAAAAAAAAAAAAAAAAf39/ACUAAABYAAAAAAAAAAAAAAAAAAAAAAAAAAAAAAAAAAAAAAAAAAAAAAAAAAAAAAAAAAAAAAA/AAAAAAAAAKCGAQAAAAAAAAAAAAAAAAAMAAAAAQAAAAAAAAAAAAAAAAAAAB8AAABUAAAAAP8AAP///wEAAAAAAAAAAAAAAAAAAAAAAAAAAAAAAAAAAAAAAAAAAAAAAAJ/f38AgICAA8zMzADAwP8Af39/AAAAAAAAAAAAAAAAAAAAAAAAAAAAIQAAABgAAAAUAAAAfiIAAHgGAACOKQAAcQoAABAAAAAmAAAACAAAAP//////////"/>
               </a:ext>
             </a:extLst>
           </p:cNvSpPr>
@@ -4193,7 +4193,7 @@
           <p:cNvSpPr txBox="1">
             <a:extLst>
               <a:ext uri="smNativeData">
-                <pr:smNativeData xmlns:pr="smNativeData" xmlns="smNativeData" val="SMDATA_15_7aDWaRMAAAAlAAAAEgAAAA8BAAAAkAAAAEgAAACQAAAASAAAAAAAAAABAAAAAAAAAAEAAABQAAAAAAAAAAAA4D8AAAAAAADgPwAAAAAAAOA/AAAAAAAA4D8AAAAAAADgPwAAAAAAAOA/AAAAAAAA4D8AAAAAAADgPwAAAAAAAOA/AAAAAAAA4D8CAAAAjAAAAAEAAAAAAAAA//8AAP///wgAAAAAAAAAAAAAAAAAAAAAAAAAAAAAAAAAAAAAZAAAAAEAAABAAAAAAAAAAAAAAAAAAAAAAAAAAAAAAAAAAAAAAAAAAAAAAAAAAAAAAAAAAAAAAAAAAAAAAAAAAAAAAAAAAAAAAAAAAAAAAAAAAAAAAAAAAAAAAAAAAAAAFAAAADwAAAABAAAAAAAAAAAAAAkUAAAAAQAAABQAAAAUAAAAFAAAAAEAAAAAAAAAZAAAAGQAAAAAAAAAZAAAAGQAAAAVAAAAYAAAAAAAAAAAAAAADwAAACADAAAAAAAAAAAAAAEAAACgMgAAVgcAAKr4//8BAAAAf39/AAEAAABkAAAAAAAAABQAAABAHwAAAAAAACYAAAAAAAAAwOD//wAAAAAmAAAAZAAAABYAAABMAAAAAAAAAAAAAAAEAAAAAAAAAAEAAACAgIAKAAAAACgAAAAoAAAAZAAAAGQAAAAAAAAAzMzMAAAAAABQAAAAUAAAAGQAAABkAAAAAAAAABcAAAAUAAAAAAAAAIEHAAD/fwAA/38AAAAAAAAJAAAABAAAACMAAAAeAAAAaAAAAAAAAAAAAAAAAAAAAAAAAAAAAAAAECcAABAnAAAAAAAAAAAAAAAAAAAAAAAAAAAAAAAAAAAAAAAAAAAAABQAAAAAAAAAwMD/AAAAAABkAAAAMgAAAAAAAABkAAAAAAAAAH9/fwAKAAAAIgAAABgAAAAAAAAAAAAAAAAAAAAAAAAAAAAAAAAAAAAkAAAAJAAAAAAAAAAHAAAAAAAAAAAAAAAAAAAAAAAAAAAAAAAAAAAAf39/ACUAAABYAAAAAAAAAAAAAAAAAAAAAAAAAAAAAAAAAAAAAAAAAAAAAAAAAAAAAAAAAAAAAAA/AAAAAAAAAKCGAQAAAAAAAAAAAAAAAAAMAAAAAQAAAAAAAAAAAAAAAAAAAB8AAABUAAAA//8AAP///wEAAAAAAAAAAAAAAAAAAAAAAAAAAAAAAAAAAAAAAAAAAAAAAAJ/f38AgICAA8zMzADAwP8Af39/AAAAAAAAAAAAAAAAAAAAAAAAAAAAIQAAABgAAAAUAAAA8SAAAFsUAAAYKwAAVBgAABAAAAAmAAAACAAAAP//////////"/>
+                <pr:smNativeData xmlns:pr="smNativeData" xmlns="smNativeData" val="SMDATA_15_ZqHWaRMAAAAlAAAAEgAAAA8BAAAAkAAAAEgAAACQAAAASAAAAAAAAAABAAAAAAAAAAEAAABQAAAAAAAAAAAA4D8AAAAAAADgPwAAAAAAAOA/AAAAAAAA4D8AAAAAAADgPwAAAAAAAOA/AAAAAAAA4D8AAAAAAADgPwAAAAAAAOA/AAAAAAAA4D8CAAAAjAAAAAEAAAAAAAAA//8AAP///wgAAAAAAAAAAAAAAAAAAAAAAAAAAAAAAAAAAAAAZAAAAAEAAABAAAAAAAAAAAAAAAAAAAAAAAAAAAAAAAAAAAAAAAAAAAAAAAAAAAAAAAAAAAAAAAAAAAAAAAAAAAAAAAAAAAAAAAAAAAAAAAAAAAAAAAAAAAAAAAAAAAAAFAAAADwAAAABAAAAAAAAAAAAAAkUAAAAAQAAABQAAAAUAAAAFAAAAAEAAAAAAAAAZAAAAGQAAAAAAAAAZAAAAGQAAAAVAAAAYAAAAAAAAAAAAAAADwAAACADAAAAAAAAAAAAAAEAAACgMgAAVgcAAKr4//8BAAAAf39/AAEAAABkAAAAAAAAABQAAABAHwAAAAAAACYAAAAAAAAAwOD//wAAAAAmAAAAZAAAABYAAABMAAAAAAAAAAAAAAAEAAAAAAAAAAEAAACAgIAKAAAAACgAAAAoAAAAZAAAAGQAAAAAAAAAzMzMAAAAAABQAAAAUAAAAGQAAABkAAAAAAAAABcAAAAUAAAAAAAAAIEHAAD/fwAA/38AAAAAAAAJAAAABAAAACMAAAAeAAAAaAAAAAAAAAAAAAAAAAAAAAAAAAAAAAAAECcAABAnAAAAAAAAAAAAAAAAAAAAAAAAAAAAAAAAAAAAAAAAAAAAABQAAAAAAAAAwMD/AAAAAABkAAAAMgAAAAAAAABkAAAAAAAAAH9/fwAKAAAAIgAAABgAAAAAAAAAAAAAAAAAAAAAAAAAAAAAAAAAAAAkAAAAJAAAAAAAAAAHAAAAAAAAAAAAAAAAAAAAAAAAAAAAAAAAAAAAf39/ACUAAABYAAAAAAAAAAAAAAAAAAAAAAAAAAAAAAAAAAAAAAAAAAAAAAAAAAAAAAAAAAAAAAA/AAAAAAAAAKCGAQAAAAAAAAAAAAAAAAAMAAAAAQAAAAAAAAAAAAAAAAAAAB8AAABUAAAA//8AAP///wEAAAAAAAAAAAAAAAAAAAAAAAAAAAAAAAAAAAAAAAAAAAAAAAJ/f38AgICAA8zMzADAwP8Af39/AAAAAAAAAAAAAAAAAAAAAAAAAAAAIQAAABgAAAAUAAAA8SAAAFsUAAAYKwAAVBgAABAAAAAmAAAACAAAAP//////////"/>
               </a:ext>
             </a:extLst>
           </p:cNvSpPr>
@@ -4245,7 +4245,7 @@
           <p:cNvSpPr txBox="1">
             <a:extLst>
               <a:ext uri="smNativeData">
-                <pr:smNativeData xmlns:pr="smNativeData" xmlns="smNativeData" val="SMDATA_15_7aDWaRMAAAAlAAAAEgAAAA8BAAAAkAAAAEgAAACQAAAASAAAAAAAAAABAAAAAAAAAAEAAABQAAAAAAAAAAAA4D8AAAAAAADgPwAAAAAAAOA/AAAAAAAA4D8AAAAAAADgPwAAAAAAAOA/AAAAAAAA4D8AAAAAAADgPwAAAAAAAOA/AAAAAAAA4D8CAAAAjAAAAAEAAAAAAAAA//8AAP///wgAAAAAAAAAAAAAAAAAAAAAAAAAAAAAAAAAAAAAZAAAAAEAAABAAAAAAAAAAAAAAAAAAAAAAAAAAAAAAAAAAAAAAAAAAAAAAAAAAAAAAAAAAAAAAAAAAAAAAAAAAAAAAAAAAAAAAAAAAAAAAAAAAAAAAAAAAAAAAAAAAAAAFAAAADwAAAABAAAAAAAAAAAAAAkUAAAAAQAAABQAAAAUAAAAFAAAAAEAAAAAAAAAZAAAAGQAAAAAAAAAZAAAAGQAAAAVAAAAYAAAAAAAAAAAAAAADwAAACADAAAAAAAAAAAAAAEAAACgMgAAVgcAAKr4//8BAAAAf39/AAEAAABkAAAAAAAAABQAAABAHwAAAAAAACYAAAAAAAAAwOD//wAAAAAmAAAAZAAAABYAAABMAAAAAAAAAAAAAAAEAAAAAAAAAAEAAACAgIAKAAAAACgAAAAoAAAAZAAAAGQAAAAAAAAAzMzMAAAAAABQAAAAUAAAAGQAAABkAAAAAAAAABcAAAAUAAAAAAAAAIgDAAD/fwAA/38AAAAAAAAJAAAABAAAACMAAAAeAAAAaAAAAAAAAAAAAAAAAAAAAAAAAAAAAAAAECcAABAnAAAAAAAAAAAAAAAAAAAAAAAAAAAAAAAAAAAAAAAAAAAAABQAAAAAAAAAwMD/AAAAAABkAAAAMgAAAAAAAABkAAAAAAAAAH9/fwAKAAAAIgAAABgAAAAAAAAAAAAAAAAAAAAAAAAAAAAAAAAAAAAkAAAAJAAAAAAAAAAHAAAAAAAAAAAAAAAAAAAAAAAAAAAAAAAAAAAAf39/ACUAAABYAAAAAAAAAAAAAAAAAAAAAAAAAAAAAAAAAAAAAAAAAAAAAAAAAAAAAAAAAAAAAAA/AAAAAAAAAKCGAQAAAAAAAAAAAAAAAAAMAAAAAQAAAAAAAAAAAAAAAAAAAB8AAABUAAAA//8AAP///wEAAAAAAAAAAAAAAAAAAAAAAAAAAAAAAAAAAAAAAAAAAAAAAAJ/f38AgICAA8zMzADAwP8Af39/AAAAAAAAAAAAAAAAAAAAAAAAAAAAIQAAABgAAAAUAAAAgTIAAOUHAADkOgAA/AoAABAAAAAmAAAACAAAAP//////////"/>
+                <pr:smNativeData xmlns:pr="smNativeData" xmlns="smNativeData" val="SMDATA_15_ZqHWaRMAAAAlAAAAEgAAAA8BAAAAkAAAAEgAAACQAAAASAAAAAAAAAABAAAAAAAAAAEAAABQAAAAAAAAAAAA4D8AAAAAAADgPwAAAAAAAOA/AAAAAAAA4D8AAAAAAADgPwAAAAAAAOA/AAAAAAAA4D8AAAAAAADgPwAAAAAAAOA/AAAAAAAA4D8CAAAAjAAAAAEAAAAAAAAA//8AAP///wgAAAAAAAAAAAAAAAAAAAAAAAAAAAAAAAAAAAAAZAAAAAEAAABAAAAAAAAAAAAAAAAAAAAAAAAAAAAAAAAAAAAAAAAAAAAAAAAAAAAAAAAAAAAAAAAAAAAAAAAAAAAAAAAAAAAAAAAAAAAAAAAAAAAAAAAAAAAAAAAAAAAAFAAAADwAAAABAAAAAAAAAAAAAAkUAAAAAQAAABQAAAAUAAAAFAAAAAEAAAAAAAAAZAAAAGQAAAAAAAAAZAAAAGQAAAAVAAAAYAAAAAAAAAAAAAAADwAAACADAAAAAAAAAAAAAAEAAACgMgAAVgcAAKr4//8BAAAAf39/AAEAAABkAAAAAAAAABQAAABAHwAAAAAAACYAAAAAAAAAwOD//wAAAAAmAAAAZAAAABYAAABMAAAAAAAAAAAAAAAEAAAAAAAAAAEAAACAgIAKAAAAACgAAAAoAAAAZAAAAGQAAAAAAAAAzMzMAAAAAABQAAAAUAAAAGQAAABkAAAAAAAAABcAAAAUAAAAAAAAAIgDAAD/fwAA/38AAAAAAAAJAAAABAAAACMAAAAeAAAAaAAAAAAAAAAAAAAAAAAAAAAAAAAAAAAAECcAABAnAAAAAAAAAAAAAAAAAAAAAAAAAAAAAAAAAAAAAAAAAAAAABQAAAAAAAAAwMD/AAAAAABkAAAAMgAAAAAAAABkAAAAAAAAAH9/fwAKAAAAIgAAABgAAAAAAAAAAAAAAAAAAAAAAAAAAAAAAAAAAAAkAAAAJAAAAAAAAAAHAAAAAAAAAAAAAAAAAAAAAAAAAAAAAAAAAAAAf39/ACUAAABYAAAAAAAAAAAAAAAAAAAAAAAAAAAAAAAAAAAAAAAAAAAAAAAAAAAAAAAAAAAAAAA/AAAAAAAAAKCGAQAAAAAAAAAAAAAAAAAMAAAAAQAAAAAAAAAAAAAAAAAAAB8AAABUAAAA//8AAP///wEAAAAAAAAAAAAAAAAAAAAAAAAAAAAAAAAAAAAAAAAAAAAAAAJ/f38AgICAA8zMzADAwP8Af39/AAAAAAAAAAAAAAAAAAAAAAAAAAAAIQAAABgAAAAUAAAAgTIAAOUHAADkOgAA/AoAABAAAAAmAAAACAAAAP//////////"/>
               </a:ext>
             </a:extLst>
           </p:cNvSpPr>
@@ -4289,7 +4289,7 @@
           <p:cNvSpPr txBox="1">
             <a:extLst>
               <a:ext uri="smNativeData">
-                <pr:smNativeData xmlns:pr="smNativeData" xmlns="smNativeData" val="SMDATA_15_7aDWaRMAAAAlAAAAEgAAAA8BAAAAkAAAAEgAAACQAAAASAAAAAAAAAABAAAAAAAAAAEAAABQAAAAAAAAAAAA4D8AAAAAAADgPwAAAAAAAOA/AAAAAAAA4D8AAAAAAADgPwAAAAAAAOA/AAAAAAAA4D8AAAAAAADgPwAAAAAAAOA/AAAAAAAA4D8CAAAAjAAAAAEAAAAAAAAAAP8AAP///wgAAAAAAAAAAAAAAAAAAAAAAAAAAAAAAAAAAAAAZAAAAAEAAABAAAAAAAAAAAAAAAAAAAAAAAAAAAAAAAAAAAAAAAAAAAAAAAAAAAAAAAAAAAAAAAAAAAAAAAAAAAAAAAAAAAAAAAAAAAAAAAAAAAAAAAAAAAAAAAAAAAAAFAAAADwAAAABAAAAAAAAAAAAAAkUAAAAAQAAABQAAAAUAAAAFAAAAAEAAAAAAAAAZAAAAGQAAAAAAAAAZAAAAGQAAAAVAAAAYAAAAAAAAAAAAAAADwAAACADAAAAAAAAAAAAAAEAAACgMgAAVgcAAKr4//8BAAAAf39/AAEAAABkAAAAAAAAABQAAABAHwAAAAAAACYAAAAAAAAAwOD//wAAAAAmAAAAZAAAABYAAABMAAAAAAAAAAAAAAAEAAAAAAAAAAEAAACAgIAKAAAAACgAAAAoAAAAZAAAAGQAAAAAAAAAzMzMAAAAAABQAAAAUAAAAGQAAABkAAAAAAAAABcAAAAUAAAAAAAAAIgDAAD/fwAA/38AAAAAAAAJAAAABAAAACMAAAAeAAAAaAAAAAAAAAAAAAAAAAAAAAAAAAAAAAAAECcAABAnAAAAAAAAAAAAAAAAAAAAAAAAAAAAAAAAAAAAAAAAAAAAABQAAAAAAAAAwMD/AAAAAABkAAAAMgAAAAAAAABkAAAAAAAAAH9/fwAKAAAAIgAAABgAAAAAAAAAAAAAAAAAAAAAAAAAAAAAAAAAAAAkAAAAJAAAAAAAAAAHAAAAAAAAAAAAAAAAAAAAAAAAAAAAAAAAAAAAf39/ACUAAABYAAAAAAAAAAAAAAAAAAAAAAAAAAAAAAAAAAAAAAAAAAAAAAAAAAAAAAAAAAAAAAA/AAAAAAAAAKCGAQAAAAAAAAAAAAAAAAAMAAAAAQAAAAAAAAAAAAAAAAAAAB8AAABUAAAAAP8AAP///wEAAAAAAAAAAAAAAAAAAAAAAAAAAAAAAAAAAAAAAAAAAAAAAAJ/f38AgICAA8zMzADAwP8Af39/AAAAAAAAAAAAAAAAAAAAAAAAAAAAIQAAABgAAAAUAAAALDEAAH8CAAA1PAAAlgUAABAAAAAmAAAACAAAAP//////////"/>
+                <pr:smNativeData xmlns:pr="smNativeData" xmlns="smNativeData" val="SMDATA_15_ZqHWaRMAAAAlAAAAEgAAAA8BAAAAkAAAAEgAAACQAAAASAAAAAAAAAABAAAAAAAAAAEAAABQAAAAAAAAAAAA4D8AAAAAAADgPwAAAAAAAOA/AAAAAAAA4D8AAAAAAADgPwAAAAAAAOA/AAAAAAAA4D8AAAAAAADgPwAAAAAAAOA/AAAAAAAA4D8CAAAAjAAAAAEAAAAAAAAAAP8AAP///wgAAAAAAAAAAAAAAAAAAAAAAAAAAAAAAAAAAAAAZAAAAAEAAABAAAAAAAAAAAAAAAAAAAAAAAAAAAAAAAAAAAAAAAAAAAAAAAAAAAAAAAAAAAAAAAAAAAAAAAAAAAAAAAAAAAAAAAAAAAAAAAAAAAAAAAAAAAAAAAAAAAAAFAAAADwAAAABAAAAAAAAAAAAAAkUAAAAAQAAABQAAAAUAAAAFAAAAAEAAAAAAAAAZAAAAGQAAAAAAAAAZAAAAGQAAAAVAAAAYAAAAAAAAAAAAAAADwAAACADAAAAAAAAAAAAAAEAAACgMgAAVgcAAKr4//8BAAAAf39/AAEAAABkAAAAAAAAABQAAABAHwAAAAAAACYAAAAAAAAAwOD//wAAAAAmAAAAZAAAABYAAABMAAAAAAAAAAAAAAAEAAAAAAAAAAEAAACAgIAKAAAAACgAAAAoAAAAZAAAAGQAAAAAAAAAzMzMAAAAAABQAAAAUAAAAGQAAABkAAAAAAAAABcAAAAUAAAAAAAAAIgDAAD/fwAA/38AAAAAAAAJAAAABAAAACMAAAAeAAAAaAAAAAAAAAAAAAAAAAAAAAAAAAAAAAAAECcAABAnAAAAAAAAAAAAAAAAAAAAAAAAAAAAAAAAAAAAAAAAAAAAABQAAAAAAAAAwMD/AAAAAABkAAAAMgAAAAAAAABkAAAAAAAAAH9/fwAKAAAAIgAAABgAAAAAAAAAAAAAAAAAAAAAAAAAAAAAAAAAAAAkAAAAJAAAAAAAAAAHAAAAAAAAAAAAAAAAAAAAAAAAAAAAAAAAAAAAf39/ACUAAABYAAAAAAAAAAAAAAAAAAAAAAAAAAAAAAAAAAAAAAAAAAAAAAAAAAAAAAAAAAAAAAA/AAAAAAAAAKCGAQAAAAAAAAAAAAAAAAAMAAAAAQAAAAAAAAAAAAAAAAAAAB8AAABUAAAAAP8AAP///wEAAAAAAAAAAAAAAAAAAAAAAAAAAAAAAAAAAAAAAAAAAAAAAAJ/f38AgICAA8zMzADAwP8Af39/AAAAAAAAAAAAAAAAAAAAAAAAAAAAIQAAABgAAAAUAAAALDEAAH8CAAA1PAAAlgUAABAAAAAmAAAACAAAAP//////////"/>
               </a:ext>
             </a:extLst>
           </p:cNvSpPr>
@@ -4333,7 +4333,7 @@
           <p:cNvSpPr txBox="1">
             <a:extLst>
               <a:ext uri="smNativeData">
-                <pr:smNativeData xmlns:pr="smNativeData" xmlns="smNativeData" val="SMDATA_15_7aDWaRMAAAAlAAAAEgAAAA8BAAAAkAAAAEgAAACQAAAASAAAAAAAAAABAAAAAAAAAAEAAABQAAAAAAAAAAAA4D8AAAAAAADgPwAAAAAAAOA/AAAAAAAA4D8AAAAAAADgPwAAAAAAAOA/AAAAAAAA4D8AAAAAAADgPwAAAAAAAOA/AAAAAAAA4D8CAAAAjAAAAAEAAAAAAAAA//8AAP///wgAAAAAAAAAAAAAAAAAAAAAAAAAAAAAAAAAAAAAZAAAAAEAAABAAAAAAAAAAAAAAAAAAAAAAAAAAAAAAAAAAAAAAAAAAAAAAAAAAAAAAAAAAAAAAAAAAAAAAAAAAAAAAAAAAAAAAAAAAAAAAAAAAAAAAAAAAAAAAAAAAAAAFAAAADwAAAABAAAAAAAAAAAAAAkUAAAAAQAAABQAAAAUAAAAFAAAAAEAAAAAAAAAZAAAAGQAAAAAAAAAZAAAAGQAAAAVAAAAYAAAAAAAAAAAAAAADwAAACADAAAAAAAAAAAAAAEAAACgMgAAVgcAAKr4//8BAAAAf39/AAEAAABkAAAAAAAAABQAAABAHwAAAAAAACYAAAAAAAAAwOD//wAAAAAmAAAAZAAAABYAAABMAAAAAAAAAAAAAAAEAAAAAAAAAAEAAACAgIAKAAAAACgAAAAoAAAAZAAAAGQAAAAAAAAAzMzMAAAAAABQAAAAUAAAAGQAAABkAAAAAAAAABcAAAAUAAAAAAAAAIEHAAD/fwAA/38AAAAAAAAJAAAABAAAACMAAAAeAAAAaAAAAAAAAAAAAAAAAAAAAAAAAAAAAAAAECcAABAnAAAAAAAAAAAAAAAAAAAAAAAAAAAAAAAAAAAAAAAAAAAAABQAAAAAAAAAwMD/AAAAAABkAAAAMgAAAAAAAABkAAAAAAAAAH9/fwAKAAAAIgAAABgAAAAAAAAAAAAAAAAAAAAAAAAAAAAAAAAAAAAkAAAAJAAAAAAAAAAHAAAAAAAAAAAAAAAAAAAAAAAAAAAAAAAAAAAAf39/ACUAAABYAAAAAAAAAAAAAAAAAAAAAAAAAAAAAAAAAAAAAAAAAAAAAAAAAAAAAAAAAAAAAAA/AAAAAAAAAKCGAQAAAAAAAAAAAAAAAAAMAAAAAQAAAAAAAAAAAAAAAAAAAB8AAABUAAAA//8AAP///wEAAAAAAAAAAAAAAAAAAAAAAAAAAAAAAAAAAAAAAAAAAAAAAAJ/f38AgICAA8zMzADAwP8Af39/AAAAAAAAAAAAAAAAAAAAAAAAAAAAIQAAABgAAAAUAAAAgDIAABMOAACnPAAADBIAABAAAAAmAAAACAAAAP//////////"/>
+                <pr:smNativeData xmlns:pr="smNativeData" xmlns="smNativeData" val="SMDATA_15_ZqHWaRMAAAAlAAAAEgAAAA8BAAAAkAAAAEgAAACQAAAASAAAAAAAAAABAAAAAAAAAAEAAABQAAAAAAAAAAAA4D8AAAAAAADgPwAAAAAAAOA/AAAAAAAA4D8AAAAAAADgPwAAAAAAAOA/AAAAAAAA4D8AAAAAAADgPwAAAAAAAOA/AAAAAAAA4D8CAAAAjAAAAAEAAAAAAAAA//8AAP///wgAAAAAAAAAAAAAAAAAAAAAAAAAAAAAAAAAAAAAZAAAAAEAAABAAAAAAAAAAAAAAAAAAAAAAAAAAAAAAAAAAAAAAAAAAAAAAAAAAAAAAAAAAAAAAAAAAAAAAAAAAAAAAAAAAAAAAAAAAAAAAAAAAAAAAAAAAAAAAAAAAAAAFAAAADwAAAABAAAAAAAAAAAAAAkUAAAAAQAAABQAAAAUAAAAFAAAAAEAAAAAAAAAZAAAAGQAAAAAAAAAZAAAAGQAAAAVAAAAYAAAAAAAAAAAAAAADwAAACADAAAAAAAAAAAAAAEAAACgMgAAVgcAAKr4//8BAAAAf39/AAEAAABkAAAAAAAAABQAAABAHwAAAAAAACYAAAAAAAAAwOD//wAAAAAmAAAAZAAAABYAAABMAAAAAAAAAAAAAAAEAAAAAAAAAAEAAACAgIAKAAAAACgAAAAoAAAAZAAAAGQAAAAAAAAAzMzMAAAAAABQAAAAUAAAAGQAAABkAAAAAAAAABcAAAAUAAAAAAAAAIEHAAD/fwAA/38AAAAAAAAJAAAABAAAACMAAAAeAAAAaAAAAAAAAAAAAAAAAAAAAAAAAAAAAAAAECcAABAnAAAAAAAAAAAAAAAAAAAAAAAAAAAAAAAAAAAAAAAAAAAAABQAAAAAAAAAwMD/AAAAAABkAAAAMgAAAAAAAABkAAAAAAAAAH9/fwAKAAAAIgAAABgAAAAAAAAAAAAAAAAAAAAAAAAAAAAAAAAAAAAkAAAAJAAAAAAAAAAHAAAAAAAAAAAAAAAAAAAAAAAAAAAAAAAAAAAAf39/ACUAAABYAAAAAAAAAAAAAAAAAAAAAAAAAAAAAAAAAAAAAAAAAAAAAAAAAAAAAAAAAAAAAAA/AAAAAAAAAKCGAQAAAAAAAAAAAAAAAAAMAAAAAQAAAAAAAAAAAAAAAAAAAB8AAABUAAAA//8AAP///wEAAAAAAAAAAAAAAAAAAAAAAAAAAAAAAAAAAAAAAAAAAAAAAAJ/f38AgICAA8zMzADAwP8Af39/AAAAAAAAAAAAAAAAAAAAAAAAAAAAIQAAABgAAAAUAAAAgDIAABMOAACnPAAADBIAABAAAAAmAAAACAAAAP//////////"/>
               </a:ext>
             </a:extLst>
           </p:cNvSpPr>
@@ -4385,7 +4385,7 @@
           <p:cNvSpPr txBox="1">
             <a:extLst>
               <a:ext uri="smNativeData">
-                <pr:smNativeData xmlns:pr="smNativeData" xmlns="smNativeData" val="SMDATA_15_7aDWaRMAAAAlAAAAEgAAAA8BAAAAkAAAAEgAAACQAAAASAAAAAAAAAABAAAAAAAAAAEAAABQAAAAAAAAAAAA4D8AAAAAAADgPwAAAAAAAOA/AAAAAAAA4D8AAAAAAADgPwAAAAAAAOA/AAAAAAAA4D8AAAAAAADgPwAAAAAAAOA/AAAAAAAA4D8CAAAAjAAAAAEAAAAAAAAA//8AAP///wgAAAAAAAAAAAAAAAAAAAAAAAAAAAAAAAAAAAAAZAAAAAEAAABAAAAAAAAAAAAAAAAAAAAAAAAAAAAAAAAAAAAAAAAAAAAAAAAAAAAAAAAAAAAAAAAAAAAAAAAAAAAAAAAAAAAAAAAAAAAAAAAAAAAAAAAAAAAAAAAAAAAAFAAAADwAAAABAAAAAAAAAAAAAAkUAAAAAQAAABQAAAAUAAAAFAAAAAEAAAAAAAAAZAAAAGQAAAAAAAAAZAAAAGQAAAAVAAAAYAAAAAAAAAAAAAAADwAAACADAAAAAAAAAAAAAAEAAACgMgAAVgcAAKr4//8BAAAAf39/AAEAAABkAAAAAAAAABQAAABAHwAAAAAAACYAAAAAAAAAwOD//wAAAAAmAAAAZAAAABYAAABMAAAAAAAAAAAAAAAEAAAAAAAAAAEAAACAgIAKAAAAACgAAAAoAAAAZAAAAGQAAAAAAAAAzMzMAAAAAABQAAAAUAAAAGQAAABkAAAAAAAAABcAAAAUAAAAAAAAAIEHAAD/fwAA/38AAAAAAAAJAAAABAAAAJCbpzEeAAAAaAAAAAAAAAAAAAAAAAAAAAAAAAAAAAAAECcAABAnAAAAAAAAAAAAAAAAAAAAAAAAAAAAAAAAAAAAAAAAAAAAABQAAAAAAAAAwMD/AAAAAABkAAAAMgAAAAAAAABkAAAAAAAAAH9/fwAKAAAAIgAAABgAAAAAAAAAAAAAAAAAAAAAAAAAAAAAAAAAAAAkAAAAJAAAAAAAAAAHAAAAAAAAAAAAAAAAAAAAAAAAAAAAAAAAAAAAf39/ACUAAABYAAAAAAAAAAAAAAAAAAAAAAAAAAAAAAAAAAAAAAAAAAAAAAAAAAAAAAAAAAAAAAA/AAAAAAAAAKCGAQAAAAAAAAAAAAAAAAAMAAAAAQAAAAAAAAAAAAAAAAAAAB8AAABUAAAA//8AAP///wEAAAAAAAAAAAAAAAAAAAAAAAAAAAAAAAAAAAAAAAAAAAAAAAJ/f38AgICAA8zMzADAwP8Af39/AAAAAAAAAAAAAAAAAAAAAAAAAAAAIQAAABgAAAAUAAAARjEAAFsUAACSNgAAVBgAABAAAAAmAAAACAAAAP//////////"/>
+                <pr:smNativeData xmlns:pr="smNativeData" xmlns="smNativeData" val="SMDATA_15_ZqHWaRMAAAAlAAAAEgAAAA8BAAAAkAAAAEgAAACQAAAASAAAAAAAAAABAAAAAAAAAAEAAABQAAAAAAAAAAAA4D8AAAAAAADgPwAAAAAAAOA/AAAAAAAA4D8AAAAAAADgPwAAAAAAAOA/AAAAAAAA4D8AAAAAAADgPwAAAAAAAOA/AAAAAAAA4D8CAAAAjAAAAAEAAAAAAAAA//8AAP///wgAAAAAAAAAAAAAAAAAAAAAAAAAAAAAAAAAAAAAZAAAAAEAAABAAAAAAAAAAAAAAAAAAAAAAAAAAAAAAAAAAAAAAAAAAAAAAAAAAAAAAAAAAAAAAAAAAAAAAAAAAAAAAAAAAAAAAAAAAAAAAAAAAAAAAAAAAAAAAAAAAAAAFAAAADwAAAABAAAAAAAAAAAAAAkUAAAAAQAAABQAAAAUAAAAFAAAAAEAAAAAAAAAZAAAAGQAAAAAAAAAZAAAAGQAAAAVAAAAYAAAAAAAAAAAAAAADwAAACADAAAAAAAAAAAAAAEAAACgMgAAVgcAAKr4//8BAAAAf39/AAEAAABkAAAAAAAAABQAAABAHwAAAAAAACYAAAAAAAAAwOD//wAAAAAmAAAAZAAAABYAAABMAAAAAAAAAAAAAAAEAAAAAAAAAAEAAACAgIAKAAAAACgAAAAoAAAAZAAAAGQAAAAAAAAAzMzMAAAAAABQAAAAUAAAAGQAAABkAAAAAAAAABcAAAAUAAAAAAAAAIEHAAD/fwAA/38AAAAAAAAJAAAABAAAAJCbpzEeAAAAaAAAAAAAAAAAAAAAAAAAAAAAAAAAAAAAECcAABAnAAAAAAAAAAAAAAAAAAAAAAAAAAAAAAAAAAAAAAAAAAAAABQAAAAAAAAAwMD/AAAAAABkAAAAMgAAAAAAAABkAAAAAAAAAH9/fwAKAAAAIgAAABgAAAAAAAAAAAAAAAAAAAAAAAAAAAAAAAAAAAAkAAAAJAAAAAAAAAAHAAAAAAAAAAAAAAAAAAAAAAAAAAAAAAAAAAAAf39/ACUAAABYAAAAAAAAAAAAAAAAAAAAAAAAAAAAAAAAAAAAAAAAAAAAAAAAAAAAAAAAAAAAAAA/AAAAAAAAAKCGAQAAAAAAAAAAAAAAAAAMAAAAAQAAAAAAAAAAAAAAAAAAAB8AAABUAAAA//8AAP///wEAAAAAAAAAAAAAAAAAAAAAAAAAAAAAAAAAAAAAAAAAAAAAAAJ/f38AgICAA8zMzADAwP8Af39/AAAAAAAAAAAAAAAAAAAAAAAAAAAAIQAAABgAAAAUAAAARjEAAFsUAACSNgAAVBgAABAAAAAmAAAACAAAAP//////////"/>
               </a:ext>
             </a:extLst>
           </p:cNvSpPr>
@@ -4437,7 +4437,7 @@
           <p:cNvGrpSpPr>
             <a:extLst>
               <a:ext uri="smNativeData">
-                <pr:smNativeData xmlns:pr="smNativeData" xmlns="smNativeData" val="SMDATA_6_7aDWaRMAAAAlAAAAAQAAAA8BAAAAkAAAAEgAAACQAAAASAAAAAAAAAAAAAAAAAAAABcAAAAUAAAAAAAAAAAAAAD/fwAA/38AAAAAAAAJAAAABAAAAN4aAAAfAAAAVAAAAAAAAAAAAAAAAAAAAAAAAAAAAAAAAAAAAAAAAAAAAAAAAAAAAAAAAAAAAAAAAAAAAAAAAAAAAAAAAAAAAAAAAAAAAAAAAAAAAAAAAAAAAAAAAAAAACEAAAAYAAAAFAAAAKkoAADFGwAATDAAAP4eAAAQAAAAJgAAAAgAAAD/////AAAAAA=="/>
+                <pr:smNativeData xmlns:pr="smNativeData" xmlns="smNativeData" val="SMDATA_6_ZqHWaRMAAAAlAAAAAQAAAA8BAAAAkAAAAEgAAACQAAAASAAAAAAAAAAAAAAAAAAAABcAAAAUAAAAAAAAAAAAAAD/fwAA/38AAAAAAAAJAAAABAAAAN4aAAAfAAAAVAAAAAAAAAAAAAAAAAAAAAAAAAAAAAAAAAAAAAAAAAAAAAAAAAAAAAAAAAAAAAAAAAAAAAAAAAAAAAAAAAAAAAAAAAAAAAAAAAAAAAAAAAAAAAAAAAAAACEAAAAYAAAAFAAAAKkoAADFGwAATDAAAP4eAAAQAAAAJgAAAAgAAAD/////AAAAAA=="/>
               </a:ext>
             </a:extLst>
           </p:cNvGrpSpPr>
@@ -4457,7 +4457,7 @@
             <p:cNvSpPr txBox="1">
               <a:extLst>
                 <a:ext uri="smNativeData">
-                  <pr:smNativeData xmlns:pr="smNativeData" xmlns="smNativeData" val="SMDATA_15_7aDWaRMAAAAlAAAAEgAAAA8BAAAAkAAAAEgAAACQAAAASAAAAAAAAAABAAAAAAAAAAEAAABQAAAAAAAAAAAA4D8AAAAAAADgPwAAAAAAAOA/AAAAAAAA4D8AAAAAAADgPwAAAAAAAOA/AAAAAAAA4D8AAAAAAADgPwAAAAAAAOA/AAAAAAAA4D8CAAAAjAAAAAEAAAAAAAAA//8AAP///wgAAAAAAAAAAAAAAAAAAAAAAAAAAAAAAAAAAAAAZAAAAAEAAABAAAAAAAAAAAAAAAAAAAAAAAAAAAAAAAAAAAAAAAAAAAAAAAAAAAAAAAAAAAAAAAAAAAAAAAAAAAAAAAAAAAAAAAAAAAAAAAAAAAAAAAAAAAAAAAAAAAAAFAAAADwAAAABAAAAAAAAAAAAAAkUAAAAAQAAABQAAAAUAAAAFAAAAAEAAAAAAAAAZAAAAGQAAAAAAAAAZAAAAGQAAAAVAAAAYAAAAAAAAAAAAAAADwAAACADAAAAAAAAAAAAAAEAAACgMgAAVgcAAKr4//8BAAAAf39/AAEAAABkAAAAAAAAABQAAABAHwAAAAAAACYAAAAAAAAAwOD//wAAAAAmAAAAZAAAABYAAABMAAAAAAAAAAAAAAAEAAAAAAAAAAEAAACAgIAKAAAAACgAAAAoAAAAZAAAAGQAAAAAAAAAzMzMAAAAAABQAAAAUAAAAGQAAABkAAAAAAAAABcAAAAUAAAAAAAAAIgDAAD/fwAA/38AAAAAAAAJAAAABAAAACMAAAAeAAAAaAAAAAAAAAAAAAAAAAAAAAAAAAAAAAAAECcAABAnAAAAAAAAAAAAAAAAAAAAAAAAAAAAAAAAAAAAAAAAAAAAABQAAAAAAAAAwMD/AAAAAABkAAAAMgAAAAAAAABkAAAAAAAAAH9/fwAKAAAAIgAAABgAAAAAAAAAAAAAAAAAAAAAAAAAAAAAAAAAAAAkAAAAJAAAAAAAAAAHAAAAAAAAAAAAAAAAAAAAAAAAAAAAAAAAAAAAf39/ACUAAABYAAAAAAAAAAAAAAAAAAAAAAAAAAAAAAAAAAAAAAAAAAAAAAAAAAAAAAAAAAAAAAA/AAAAAAAAAKCGAQAAAAAAAAAAAAAAAAAMAAAAAQAAAAAAAAAAAAAAAAAAAB8AAABUAAAA//8AAP///wEAAAAAAAAAAAAAAAAAAAAAAAAAAAAAAAAAAAAAAAAAAAAAAAJ/f38AgICAA8zMzADAwP8Af39/AAAAAAAAAAAAAAAAAAAAAAAAAAAAIQAAABgAAAAUAAAADSkAACkcAABMMAAA/h4AAAAAAAAmAAAACAAAAP//////////"/>
+                  <pr:smNativeData xmlns:pr="smNativeData" xmlns="smNativeData" val="SMDATA_15_ZqHWaRMAAAAlAAAAEgAAAA8BAAAAkAAAAEgAAACQAAAASAAAAAAAAAABAAAAAAAAAAEAAABQAAAAAAAAAAAA4D8AAAAAAADgPwAAAAAAAOA/AAAAAAAA4D8AAAAAAADgPwAAAAAAAOA/AAAAAAAA4D8AAAAAAADgPwAAAAAAAOA/AAAAAAAA4D8CAAAAjAAAAAEAAAAAAAAA//8AAP///wgAAAAAAAAAAAAAAAAAAAAAAAAAAAAAAAAAAAAAZAAAAAEAAABAAAAAAAAAAAAAAAAAAAAAAAAAAAAAAAAAAAAAAAAAAAAAAAAAAAAAAAAAAAAAAAAAAAAAAAAAAAAAAAAAAAAAAAAAAAAAAAAAAAAAAAAAAAAAAAAAAAAAFAAAADwAAAABAAAAAAAAAAAAAAkUAAAAAQAAABQAAAAUAAAAFAAAAAEAAAAAAAAAZAAAAGQAAAAAAAAAZAAAAGQAAAAVAAAAYAAAAAAAAAAAAAAADwAAACADAAAAAAAAAAAAAAEAAACgMgAAVgcAAKr4//8BAAAAf39/AAEAAABkAAAAAAAAABQAAABAHwAAAAAAACYAAAAAAAAAwOD//wAAAAAmAAAAZAAAABYAAABMAAAAAAAAAAAAAAAEAAAAAAAAAAEAAACAgIAKAAAAACgAAAAoAAAAZAAAAGQAAAAAAAAAzMzMAAAAAABQAAAAUAAAAGQAAABkAAAAAAAAABcAAAAUAAAAAAAAAIgDAAD/fwAA/38AAAAAAAAJAAAABAAAACMAAAAeAAAAaAAAAAAAAAAAAAAAAAAAAAAAAAAAAAAAECcAABAnAAAAAAAAAAAAAAAAAAAAAAAAAAAAAAAAAAAAAAAAAAAAABQAAAAAAAAAwMD/AAAAAABkAAAAMgAAAAAAAABkAAAAAAAAAH9/fwAKAAAAIgAAABgAAAAAAAAAAAAAAAAAAAAAAAAAAAAAAAAAAAAkAAAAJAAAAAAAAAAHAAAAAAAAAAAAAAAAAAAAAAAAAAAAAAAAAAAAf39/ACUAAABYAAAAAAAAAAAAAAAAAAAAAAAAAAAAAAAAAAAAAAAAAAAAAAAAAAAAAAAAAAAAAAA/AAAAAAAAAKCGAQAAAAAAAAAAAAAAAAAMAAAAAQAAAAAAAAAAAAAAAAAAAB8AAABUAAAA//8AAP///wEAAAAAAAAAAAAAAAAAAAAAAAAAAAAAAAAAAAAAAAAAAAAAAAJ/f38AgICAA8zMzADAwP8Af39/AAAAAAAAAAAAAAAAAAAAAAAAAAAAIQAAABgAAAAUAAAADSkAACkcAABMMAAA/h4AAAAAAAAmAAAACAAAAP//////////"/>
                 </a:ext>
               </a:extLst>
             </p:cNvSpPr>
@@ -4501,7 +4501,7 @@
             <p:cNvSpPr txBox="1">
               <a:extLst>
                 <a:ext uri="smNativeData">
-                  <pr:smNativeData xmlns:pr="smNativeData" xmlns="smNativeData" val="SMDATA_15_7aDWaRMAAAAlAAAAEgAAAA8BAAAAkAAAAEgAAACQAAAASAAAAAAAAAABAAAAAAAAAAEAAABQAAAAAAAAAAAA4D8AAAAAAADgPwAAAAAAAOA/AAAAAAAA4D8AAAAAAADgPwAAAAAAAOA/AAAAAAAA4D8AAAAAAADgPwAAAAAAAOA/AAAAAAAA4D8CAAAAjAAAAAEAAAAAAAAA//8AAP///wgAAAAAAAAAAAAAAAAAAAAAAAAAAAAAAAAAAAAAZAAAAAEAAABAAAAAAAAAAAAAAAAAAAAAAAAAAAAAAAAAAAAAAAAAAAAAAAAAAAAAAAAAAAAAAAAAAAAAAAAAAAAAAAAAAAAAAAAAAAAAAAAAAAAAAAAAAAAAAAAAAAAAFAAAADwAAAABAAAAAAAAAAAAAAkUAAAAAQAAABQAAAAUAAAAFAAAAAEAAAAAAAAAZAAAAGQAAAAAAAAAZAAAAGQAAAAVAAAAYAAAAAAAAAAAAAAADwAAACADAAAAAAAAAAAAAAEAAACgMgAAVgcAAKr4//8BAAAAf39/AAEAAABkAAAAAAAAABQAAABAHwAAAAAAACYAAAAAAAAAwOD//wAAAAAmAAAAZAAAABYAAABMAAAAAAAAAAAAAAAEAAAAAAAAAAEAAACAgIAKAAAAACgAAAAoAAAAZAAAAGQAAAAAAAAAzMzMAAAAAABQAAAAUAAAAGQAAABkAAAAAAAAABcAAAAUAAAAAAAAAIgDAAD/fwAA/38AAAAAAAAJAAAABAAAAID8+zAeAAAAaAAAAAAAAAAAAAAAAAAAAAAAAAAAAAAAECcAABAnAAAAAAAAAAAAAAAAAAAAAAAAAAAAAAAAAAAAAAAAAAAAABQAAAAAAAAAwMD/AAAAAABkAAAAMgAAAAAAAABkAAAAAAAAAH9/fwAKAAAAIgAAABgAAAAAAAAAAAAAAAAAAAAAAAAAAAAAAAAAAAAkAAAAJAAAAAAAAAAHAAAAAAAAAAAAAAAAAAAAAAAAAAAAAAAAAAAAf39/ACUAAABYAAAAAAAAAAAAAAAAAAAAAAAAAAAAAAAAAAAAAAAAAAAAAAAAAAAAAAAAAAAAAAA/AAAAAAAAAKCGAQAAAAAAAAAAAAAAAAAMAAAAAQAAAAAAAAAAAAAAAAAAAB8AAABUAAAA//8AAP///wEAAAAAAAAAAAAAAAAAAAAAAAAAAAAAAAAAAAAAAAAAAAAAAAJ/f38AgICAA8zMzADAwP8Af39/AAAAAAAAAAAAAAAAAAAAAAAAAAAAIQAAABgAAAAUAAAAqSgAAMUbAADoLwAAmh4AAAAAAAAmAAAACAAAAP//////////"/>
+                  <pr:smNativeData xmlns:pr="smNativeData" xmlns="smNativeData" val="SMDATA_15_ZqHWaRMAAAAlAAAAEgAAAA8BAAAAkAAAAEgAAACQAAAASAAAAAAAAAABAAAAAAAAAAEAAABQAAAAAAAAAAAA4D8AAAAAAADgPwAAAAAAAOA/AAAAAAAA4D8AAAAAAADgPwAAAAAAAOA/AAAAAAAA4D8AAAAAAADgPwAAAAAAAOA/AAAAAAAA4D8CAAAAjAAAAAEAAAAAAAAA//8AAP///wgAAAAAAAAAAAAAAAAAAAAAAAAAAAAAAAAAAAAAZAAAAAEAAABAAAAAAAAAAAAAAAAAAAAAAAAAAAAAAAAAAAAAAAAAAAAAAAAAAAAAAAAAAAAAAAAAAAAAAAAAAAAAAAAAAAAAAAAAAAAAAAAAAAAAAAAAAAAAAAAAAAAAFAAAADwAAAABAAAAAAAAAAAAAAkUAAAAAQAAABQAAAAUAAAAFAAAAAEAAAAAAAAAZAAAAGQAAAAAAAAAZAAAAGQAAAAVAAAAYAAAAAAAAAAAAAAADwAAACADAAAAAAAAAAAAAAEAAACgMgAAVgcAAKr4//8BAAAAf39/AAEAAABkAAAAAAAAABQAAABAHwAAAAAAACYAAAAAAAAAwOD//wAAAAAmAAAAZAAAABYAAABMAAAAAAAAAAAAAAAEAAAAAAAAAAEAAACAgIAKAAAAACgAAAAoAAAAZAAAAGQAAAAAAAAAzMzMAAAAAABQAAAAUAAAAGQAAABkAAAAAAAAABcAAAAUAAAAAAAAAIgDAAD/fwAA/38AAAAAAAAJAAAABAAAAID8+zAeAAAAaAAAAAAAAAAAAAAAAAAAAAAAAAAAAAAAECcAABAnAAAAAAAAAAAAAAAAAAAAAAAAAAAAAAAAAAAAAAAAAAAAABQAAAAAAAAAwMD/AAAAAABkAAAAMgAAAAAAAABkAAAAAAAAAH9/fwAKAAAAIgAAABgAAAAAAAAAAAAAAAAAAAAAAAAAAAAAAAAAAAAkAAAAJAAAAAAAAAAHAAAAAAAAAAAAAAAAAAAAAAAAAAAAAAAAAAAAf39/ACUAAABYAAAAAAAAAAAAAAAAAAAAAAAAAAAAAAAAAAAAAAAAAAAAAAAAAAAAAAAAAAAAAAA/AAAAAAAAAKCGAQAAAAAAAAAAAAAAAAAMAAAAAQAAAAAAAAAAAAAAAAAAAB8AAABUAAAA//8AAP///wEAAAAAAAAAAAAAAAAAAAAAAAAAAAAAAAAAAAAAAAAAAAAAAAJ/f38AgICAA8zMzADAwP8Af39/AAAAAAAAAAAAAAAAAAAAAAAAAAAAIQAAABgAAAAUAAAAqSgAAMUbAADoLwAAmh4AAAAAAAAmAAAACAAAAP//////////"/>
                 </a:ext>
               </a:extLst>
             </p:cNvSpPr>
@@ -4546,7 +4546,7 @@
           <p:cNvSpPr txBox="1">
             <a:extLst>
               <a:ext uri="smNativeData">
-                <pr:smNativeData xmlns:pr="smNativeData" xmlns="smNativeData" val="SMDATA_15_7aDWaRMAAAAlAAAAEgAAAA8BAAAAkAAAAEgAAACQAAAASAAAAAAAAAABAAAAAAAAAAEAAABQAAAAAAAAAAAA4D8AAAAAAADgPwAAAAAAAOA/AAAAAAAA4D8AAAAAAADgPwAAAAAAAOA/AAAAAAAA4D8AAAAAAADgPwAAAAAAAOA/AAAAAAAA4D8CAAAAjAAAAAEAAAAAAAAA//8AAP///wgAAAAAAAAAAAAAAAAAAAAAAAAAAAAAAAAAAAAAZAAAAAEAAABAAAAAAAAAAAAAAAAAAAAAAAAAAAAAAAAAAAAAAAAAAAAAAAAAAAAAAAAAAAAAAAAAAAAAAAAAAAAAAAAAAAAAAAAAAAAAAAAAAAAAAAAAAAAAAAAAAAAAFAAAADwAAAABAAAAAAAAAAAAAAkUAAAAAQAAABQAAAAUAAAAFAAAAAEAAAAAAAAAZAAAAGQAAAAAAAAAZAAAAGQAAAAVAAAAYAAAAAAAAAAAAAAADwAAACADAAAAAAAAAAAAAAEAAACgMgAAVgcAAKr4//8BAAAAf39/AAEAAABkAAAAAAAAABQAAABAHwAAAAAAACYAAAAAAAAAwOD//wAAAAAmAAAAZAAAABYAAABMAAAAAAAAAAAAAAAEAAAAAAAAAAEAAACAgIAKAAAAACgAAAAoAAAAZAAAAGQAAAAAAAAAzMzMAAAAAABQAAAAUAAAAGQAAABkAAAAAAAAABcAAAAUAAAAAAAAAIgDAAD/fwAA/38AAAAAAAAJAAAABAAAACMAAAAeAAAAaAAAAAAAAAAAAAAAAAAAAAAAAAAAAAAAECcAABAnAAAAAAAAAAAAAAAAAAAAAAAAAAAAAAAAAAAAAAAAAAAAABQAAAAAAAAAwMD/AAAAAABkAAAAMgAAAAAAAABkAAAAAAAAAH9/fwAKAAAAIgAAABgAAAAAAAAAAAAAAAAAAAAAAAAAAAAAAAAAAAAkAAAAJAAAAAAAAAAHAAAAAAAAAAAAAAAAAAAAAAAAAAAAAAAAAAAAf39/ACUAAABYAAAAAAAAAAAAAAAAAAAAAAAAAAAAAAAAAAAAAAAAAAAAAAAAAAAAAAAAAAAAAAA/AAAAAAAAAKCGAQAAAAAAAAAAAAAAAAAMAAAAAQAAAAAAAAAAAAAAAAAAAB8AAABUAAAA//8AAP///wEAAAAAAAAAAAAAAAAAAAAAAAAAAAAAAAAAAAAAAAAAAAAAAAJ/f38AgICAA8zMzADAwP8Af39/AAAAAAAAAAAAAAAAAAAAAAAAAAAAIQAAABgAAAAUAAAAAzgAANEbAABCPwAAph4AABAAAAAmAAAACAAAAP//////////"/>
+                <pr:smNativeData xmlns:pr="smNativeData" xmlns="smNativeData" val="SMDATA_15_ZqHWaRMAAAAlAAAAEgAAAA8BAAAAkAAAAEgAAACQAAAASAAAAAAAAAABAAAAAAAAAAEAAABQAAAAAAAAAAAA4D8AAAAAAADgPwAAAAAAAOA/AAAAAAAA4D8AAAAAAADgPwAAAAAAAOA/AAAAAAAA4D8AAAAAAADgPwAAAAAAAOA/AAAAAAAA4D8CAAAAjAAAAAEAAAAAAAAA//8AAP///wgAAAAAAAAAAAAAAAAAAAAAAAAAAAAAAAAAAAAAZAAAAAEAAABAAAAAAAAAAAAAAAAAAAAAAAAAAAAAAAAAAAAAAAAAAAAAAAAAAAAAAAAAAAAAAAAAAAAAAAAAAAAAAAAAAAAAAAAAAAAAAAAAAAAAAAAAAAAAAAAAAAAAFAAAADwAAAABAAAAAAAAAAAAAAkUAAAAAQAAABQAAAAUAAAAFAAAAAEAAAAAAAAAZAAAAGQAAAAAAAAAZAAAAGQAAAAVAAAAYAAAAAAAAAAAAAAADwAAACADAAAAAAAAAAAAAAEAAACgMgAAVgcAAKr4//8BAAAAf39/AAEAAABkAAAAAAAAABQAAABAHwAAAAAAACYAAAAAAAAAwOD//wAAAAAmAAAAZAAAABYAAABMAAAAAAAAAAAAAAAEAAAAAAAAAAEAAACAgIAKAAAAACgAAAAoAAAAZAAAAGQAAAAAAAAAzMzMAAAAAABQAAAAUAAAAGQAAABkAAAAAAAAABcAAAAUAAAAAAAAAIgDAAD/fwAA/38AAAAAAAAJAAAABAAAACMAAAAeAAAAaAAAAAAAAAAAAAAAAAAAAAAAAAAAAAAAECcAABAnAAAAAAAAAAAAAAAAAAAAAAAAAAAAAAAAAAAAAAAAAAAAABQAAAAAAAAAwMD/AAAAAABkAAAAMgAAAAAAAABkAAAAAAAAAH9/fwAKAAAAIgAAABgAAAAAAAAAAAAAAAAAAAAAAAAAAAAAAAAAAAAkAAAAJAAAAAAAAAAHAAAAAAAAAAAAAAAAAAAAAAAAAAAAAAAAAAAAf39/ACUAAABYAAAAAAAAAAAAAAAAAAAAAAAAAAAAAAAAAAAAAAAAAAAAAAAAAAAAAAAAAAAAAAA/AAAAAAAAAKCGAQAAAAAAAAAAAAAAAAAMAAAAAQAAAAAAAAAAAAAAAAAAAB8AAABUAAAA//8AAP///wEAAAAAAAAAAAAAAAAAAAAAAAAAAAAAAAAAAAAAAAAAAAAAAAJ/f38AgICAA8zMzADAwP8Af39/AAAAAAAAAAAAAAAAAAAAAAAAAAAAIQAAABgAAAAUAAAAAzgAANEbAABCPwAAph4AABAAAAAmAAAACAAAAP//////////"/>
               </a:ext>
             </a:extLst>
           </p:cNvSpPr>
@@ -4590,7 +4590,7 @@
           <p:cNvSpPr txBox="1">
             <a:extLst>
               <a:ext uri="smNativeData">
-                <pr:smNativeData xmlns:pr="smNativeData" xmlns="smNativeData" val="SMDATA_15_7aDWaRMAAAAlAAAAEgAAAA8BAAAAkAAAAEgAAACQAAAASAAAAAAAAAABAAAAAAAAAAEAAABQAAAAAAAAAAAA4D8AAAAAAADgPwAAAAAAAOA/AAAAAAAA4D8AAAAAAADgPwAAAAAAAOA/AAAAAAAA4D8AAAAAAADgPwAAAAAAAOA/AAAAAAAA4D8CAAAAjAAAAAEAAAAAAAAAAP8AAP///wgAAAAAAAAAAAAAAAAAAAAAAAAAAAAAAAAAAAAAZAAAAAEAAABAAAAAAAAAAAAAAAAAAAAAAAAAAAAAAAAAAAAAAAAAAAAAAAAAAAAAAAAAAAAAAAAAAAAAAAAAAAAAAAAAAAAAAAAAAAAAAAAAAAAAAAAAAAAAAAAAAAAAFAAAADwAAAABAAAAAAAAAAAAAAkUAAAAAQAAABQAAAAUAAAAFAAAAAEAAAAAAAAAZAAAAGQAAAAAAAAAZAAAAGQAAAAVAAAAYAAAAAAAAAAAAAAADwAAACADAAAAAAAAAAAAAAEAAACgMgAAVgcAAKr4//8BAAAAf39/AAEAAABkAAAAAAAAABQAAABAHwAAAAAAACYAAAAAAAAAwOD//wAAAAAmAAAAZAAAABYAAABMAAAAAAAAAAAAAAAEAAAAAAAAAAEAAACAgIAKAAAAACgAAAAoAAAAZAAAAGQAAAAAAAAAzMzMAAAAAABQAAAAUAAAAGQAAABkAAAAAAAAABcAAAAUAAAAAAAAAIgDAAD/fwAA/38AAAAAAAAJAAAABAAAACMAAAAeAAAAaAAAAAAAAAAAAAAAAAAAAAAAAAAAAAAAECcAABAnAAAAAAAAAAAAAAAAAAAAAAAAAAAAAAAAAAAAAAAAAAAAABQAAAAAAAAAwMD/AAAAAABkAAAAMgAAAAAAAABkAAAAAAAAAH9/fwAKAAAAIgAAABgAAAAAAAAAAAAAAAAAAAAAAAAAAAAAAAAAAAAkAAAAJAAAAAAAAAAHAAAAAAAAAAAAAAAAAAAAAAAAAAAAAAAAAAAAf39/ACUAAABYAAAAAAAAAAAAAAAAAAAAAAAAAAAAAAAAAAAAAAAAAAAAAAAAAAAAAAAAAAAAAAA/AAAAAAAAAKCGAQAAAAAAAAAAAAAAAAAMAAAAAQAAAAAAAAAAAAAAAAAAAB8AAABUAAAAAP8AAP///wEAAAAAAAAAAAAAAAAAAAAAAAAAAAAAAAAAAAAAAAAAAAAAAAJ/f38AgICAA8zMzADAwP8Af39/AAAAAAAAAAAAAAAAAAAAAAAAAAAAIQAAABgAAAAUAAAANTkAAHwgAAAQPgAAUSMAABAAAAAmAAAACAAAAP//////////"/>
+                <pr:smNativeData xmlns:pr="smNativeData" xmlns="smNativeData" val="SMDATA_15_ZqHWaRMAAAAlAAAAEgAAAA8BAAAAkAAAAEgAAACQAAAASAAAAAAAAAABAAAAAAAAAAEAAABQAAAAAAAAAAAA4D8AAAAAAADgPwAAAAAAAOA/AAAAAAAA4D8AAAAAAADgPwAAAAAAAOA/AAAAAAAA4D8AAAAAAADgPwAAAAAAAOA/AAAAAAAA4D8CAAAAjAAAAAEAAAAAAAAAAP8AAP///wgAAAAAAAAAAAAAAAAAAAAAAAAAAAAAAAAAAAAAZAAAAAEAAABAAAAAAAAAAAAAAAAAAAAAAAAAAAAAAAAAAAAAAAAAAAAAAAAAAAAAAAAAAAAAAAAAAAAAAAAAAAAAAAAAAAAAAAAAAAAAAAAAAAAAAAAAAAAAAAAAAAAAFAAAADwAAAABAAAAAAAAAAAAAAkUAAAAAQAAABQAAAAUAAAAFAAAAAEAAAAAAAAAZAAAAGQAAAAAAAAAZAAAAGQAAAAVAAAAYAAAAAAAAAAAAAAADwAAACADAAAAAAAAAAAAAAEAAACgMgAAVgcAAKr4//8BAAAAf39/AAEAAABkAAAAAAAAABQAAABAHwAAAAAAACYAAAAAAAAAwOD//wAAAAAmAAAAZAAAABYAAABMAAAAAAAAAAAAAAAEAAAAAAAAAAEAAACAgIAKAAAAACgAAAAoAAAAZAAAAGQAAAAAAAAAzMzMAAAAAABQAAAAUAAAAGQAAABkAAAAAAAAABcAAAAUAAAAAAAAAIgDAAD/fwAA/38AAAAAAAAJAAAABAAAACMAAAAeAAAAaAAAAAAAAAAAAAAAAAAAAAAAAAAAAAAAECcAABAnAAAAAAAAAAAAAAAAAAAAAAAAAAAAAAAAAAAAAAAAAAAAABQAAAAAAAAAwMD/AAAAAABkAAAAMgAAAAAAAABkAAAAAAAAAH9/fwAKAAAAIgAAABgAAAAAAAAAAAAAAAAAAAAAAAAAAAAAAAAAAAAkAAAAJAAAAAAAAAAHAAAAAAAAAAAAAAAAAAAAAAAAAAAAAAAAAAAAf39/ACUAAABYAAAAAAAAAAAAAAAAAAAAAAAAAAAAAAAAAAAAAAAAAAAAAAAAAAAAAAAAAAAAAAA/AAAAAAAAAKCGAQAAAAAAAAAAAAAAAAAMAAAAAQAAAAAAAAAAAAAAAAAAAB8AAABUAAAAAP8AAP///wEAAAAAAAAAAAAAAAAAAAAAAAAAAAAAAAAAAAAAAAAAAAAAAAJ/f38AgICAA8zMzADAwP8Af39/AAAAAAAAAAAAAAAAAAAAAAAAAAAAIQAAABgAAAAUAAAANTkAAHwgAAAQPgAAUSMAABAAAAAmAAAACAAAAP//////////"/>
               </a:ext>
             </a:extLst>
           </p:cNvSpPr>
@@ -4634,7 +4634,7 @@
           <p:cNvSpPr txBox="1">
             <a:extLst>
               <a:ext uri="smNativeData">
-                <pr:smNativeData xmlns:pr="smNativeData" xmlns="smNativeData" val="SMDATA_15_7aDWaRMAAAAlAAAAEgAAAA8BAAAAkAAAAEgAAACQAAAASAAAAAAAAAABAAAAAAAAAAEAAABQAAAAAAAAAAAA4D8AAAAAAADgPwAAAAAAAOA/AAAAAAAA4D8AAAAAAADgPwAAAAAAAOA/AAAAAAAA4D8AAAAAAADgPwAAAAAAAOA/AAAAAAAA4D8CAAAAjAAAAAEAAAAAAAAA//8AAP///wgAAAAAAAAAAAAAAAAAAAAAAAAAAAAAAAAAAAAAZAAAAAEAAABAAAAAAAAAAAAAAAAAAAAAAAAAAAAAAAAAAAAAAAAAAAAAAAAAAAAAAAAAAAAAAAAAAAAAAAAAAAAAAAAAAAAAAAAAAAAAAAAAAAAAAAAAAAAAAAAAAAAAFAAAADwAAAABAAAAAAAAAAAAAAkUAAAAAQAAABQAAAAUAAAAFAAAAAEAAAAAAAAAZAAAAGQAAAAAAAAAZAAAAGQAAAAVAAAAYAAAAAAAAAAAAAAADwAAACADAAAAAAAAAAAAAAEAAACgMgAAVgcAAKr4//8BAAAAf39/AAEAAABkAAAAAAAAABQAAABAHwAAAAAAACYAAAAAAAAAwOD//wAAAAAmAAAAZAAAABYAAABMAAAAAAAAAAAAAAAEAAAAAAAAAAEAAACAgIAKAAAAACgAAAAoAAAAZAAAAGQAAAAAAAAAzMzMAAAAAABQAAAAUAAAAGQAAABkAAAAAAAAABcAAAAUAAAAAAAAAIEHAAD/fwAA/38AAAAAAAAJAAAABAAAACJIYW4eAAAAaAAAAAAAAAAAAAAAAAAAAAAAAAAAAAAAECcAABAnAAAAAAAAAAAAAAAAAAAAAAAAAAAAAAAAAAAAAAAAAAAAABQAAAAAAAAAwMD/AAAAAABkAAAAMgAAAAAAAABkAAAAAAAAAH9/fwAKAAAAIgAAABgAAAAAAAAAAAAAAAAAAAAAAAAAAAAAAAAAAAAkAAAAJAAAAAAAAAAHAAAAAAAAAAAAAAAAAAAAAAAAAAAAAAAAAAAAf39/ACUAAABYAAAAAAAAAAAAAAAAAAAAAAAAAAAAAAAAAAAAAAAAAAAAAAAAAAAAAAAAAAAAAAA/AAAAAAAAAKCGAQAAAAAAAAAAAAAAAAAMAAAAAQAAAAAAAAAAAAAAAAAAAB8AAABUAAAA//8AAP///wEAAAAAAAAAAAAAAAAAAAAAAAAAAAAAAAAAAAAAAAAAAAAAAAJ/f38AgICAA8zMzADAwP8Af39/AAAAAAAAAAAAAAAAAAAAAAAAAAAAIQAAABgAAAAUAAAAahQAAFsUAAC2GQAAVBgAABAAAAAmAAAACAAAAP//////////"/>
+                <pr:smNativeData xmlns:pr="smNativeData" xmlns="smNativeData" val="SMDATA_15_ZqHWaRMAAAAlAAAAEgAAAA8BAAAAkAAAAEgAAACQAAAASAAAAAAAAAABAAAAAAAAAAEAAABQAAAAAAAAAAAA4D8AAAAAAADgPwAAAAAAAOA/AAAAAAAA4D8AAAAAAADgPwAAAAAAAOA/AAAAAAAA4D8AAAAAAADgPwAAAAAAAOA/AAAAAAAA4D8CAAAAjAAAAAEAAAAAAAAA//8AAP///wgAAAAAAAAAAAAAAAAAAAAAAAAAAAAAAAAAAAAAZAAAAAEAAABAAAAAAAAAAAAAAAAAAAAAAAAAAAAAAAAAAAAAAAAAAAAAAAAAAAAAAAAAAAAAAAAAAAAAAAAAAAAAAAAAAAAAAAAAAAAAAAAAAAAAAAAAAAAAAAAAAAAAFAAAADwAAAABAAAAAAAAAAAAAAkUAAAAAQAAABQAAAAUAAAAFAAAAAEAAAAAAAAAZAAAAGQAAAAAAAAAZAAAAGQAAAAVAAAAYAAAAAAAAAAAAAAADwAAACADAAAAAAAAAAAAAAEAAACgMgAAVgcAAKr4//8BAAAAf39/AAEAAABkAAAAAAAAABQAAABAHwAAAAAAACYAAAAAAAAAwOD//wAAAAAmAAAAZAAAABYAAABMAAAAAAAAAAAAAAAEAAAAAAAAAAEAAACAgIAKAAAAACgAAAAoAAAAZAAAAGQAAAAAAAAAzMzMAAAAAABQAAAAUAAAAGQAAABkAAAAAAAAABcAAAAUAAAAAAAAAIEHAAD/fwAA/38AAAAAAAAJAAAABAAAACJIYW4eAAAAaAAAAAAAAAAAAAAAAAAAAAAAAAAAAAAAECcAABAnAAAAAAAAAAAAAAAAAAAAAAAAAAAAAAAAAAAAAAAAAAAAABQAAAAAAAAAwMD/AAAAAABkAAAAMgAAAAAAAABkAAAAAAAAAH9/fwAKAAAAIgAAABgAAAAAAAAAAAAAAAAAAAAAAAAAAAAAAAAAAAAkAAAAJAAAAAAAAAAHAAAAAAAAAAAAAAAAAAAAAAAAAAAAAAAAAAAAf39/ACUAAABYAAAAAAAAAAAAAAAAAAAAAAAAAAAAAAAAAAAAAAAAAAAAAAAAAAAAAAAAAAAAAAA/AAAAAAAAAKCGAQAAAAAAAAAAAAAAAAAMAAAAAQAAAAAAAAAAAAAAAAAAAB8AAABUAAAA//8AAP///wEAAAAAAAAAAAAAAAAAAAAAAAAAAAAAAAAAAAAAAAAAAAAAAAJ/f38AgICAA8zMzADAwP8Af39/AAAAAAAAAAAAAAAAAAAAAAAAAAAAIQAAABgAAAAUAAAAahQAAFsUAAC2GQAAVBgAABAAAAAmAAAACAAAAP//////////"/>
               </a:ext>
             </a:extLst>
           </p:cNvSpPr>
@@ -4686,7 +4686,7 @@
           <p:cNvSpPr txBox="1">
             <a:extLst>
               <a:ext uri="smNativeData">
-                <pr:smNativeData xmlns:pr="smNativeData" xmlns="smNativeData" val="SMDATA_15_7aDWaRMAAAAlAAAAEgAAAA8BAAAAkAAAAEgAAACQAAAASAAAAAAAAAABAAAAAAAAAAEAAABQAAAAAAAAAAAA4D8AAAAAAADgPwAAAAAAAOA/AAAAAAAA4D8AAAAAAADgPwAAAAAAAOA/AAAAAAAA4D8AAAAAAADgPwAAAAAAAOA/AAAAAAAA4D8CAAAAjAAAAAEAAAAAAAAA//8AAP///wgAAAAAAAAAAAAAAAAAAAAAAAAAAAAAAAAAAAAAZAAAAAEAAABAAAAAAAAAAAAAAAAAAAAAAAAAAAAAAAAAAAAAAAAAAAAAAAAAAAAAAAAAAAAAAAAAAAAAAAAAAAAAAAAAAAAAAAAAAAAAAAAAAAAAAAAAAAAAAAAAAAAAFAAAADwAAAABAAAAAAAAAAAAAAkUAAAAAQAAABQAAAAUAAAAFAAAAAEAAAAAAAAAZAAAAGQAAAAAAAAAZAAAAGQAAAAVAAAAYAAAAAAAAAAAAAAADwAAACADAAAAAAAAAAAAAAEAAACgMgAAVgcAAKr4//8BAAAAf39/AAEAAABkAAAAAAAAABQAAABAHwAAAAAAACYAAAAAAAAAwOD//wAAAAAmAAAAZAAAABYAAABMAAAAAAAAAAAAAAAEAAAAAAAAAAEAAACAgIAKAAAAACgAAAAoAAAAZAAAAGQAAAAAAAAAzMzMAAAAAABQAAAAUAAAAGQAAABkAAAAAAAAABcAAAAUAAAAAAAAAIgDAAD/fwAA/38AAAAAAAAJAAAABAAAACMAAAAeAAAAaAAAAAAAAAAAAAAAAAAAAAAAAAAAAAAAECcAABAnAAAAAAAAAAAAAAAAAAAAAAAAAAAAAAAAAAAAAAAAAAAAABQAAAAAAAAAwMD/AAAAAABkAAAAMgAAAAAAAABkAAAAAAAAAH9/fwAKAAAAIgAAABgAAAAAAAAAAAAAAAAAAAAAAAAAAAAAAAAAAAAkAAAAJAAAAAAAAAAHAAAAAAAAAAAAAAAAAAAAAAAAAAAAAAAAAAAAf39/ACUAAABYAAAAAAAAAAAAAAAAAAAAAAAAAAAAAAAAAAAAAAAAAAAAAAAAAAAAAAAAAAAAAAA/AAAAAAAAAKCGAQAAAAAAAAAAAAAAAAAMAAAAAQAAAAAAAAAAAAAAAAAAAB8AAABUAAAA//8AAP///wEAAAAAAAAAAAAAAAAAAAAAAAAAAAAAAAAAAAAAAAAAAAAAAAJ/f38AgICAA8zMzADAwP8Af39/AAAAAAAAAAAAAAAAAAAAAAAAAAAAIQAAABgAAAAUAAAAsRsAAJAbAADwIgAAZR4AABAAAAAmAAAACAAAAP//////////"/>
+                <pr:smNativeData xmlns:pr="smNativeData" xmlns="smNativeData" val="SMDATA_15_ZqHWaRMAAAAlAAAAEgAAAA8BAAAAkAAAAEgAAACQAAAASAAAAAAAAAABAAAAAAAAAAEAAABQAAAAAAAAAAAA4D8AAAAAAADgPwAAAAAAAOA/AAAAAAAA4D8AAAAAAADgPwAAAAAAAOA/AAAAAAAA4D8AAAAAAADgPwAAAAAAAOA/AAAAAAAA4D8CAAAAjAAAAAEAAAAAAAAA//8AAP///wgAAAAAAAAAAAAAAAAAAAAAAAAAAAAAAAAAAAAAZAAAAAEAAABAAAAAAAAAAAAAAAAAAAAAAAAAAAAAAAAAAAAAAAAAAAAAAAAAAAAAAAAAAAAAAAAAAAAAAAAAAAAAAAAAAAAAAAAAAAAAAAAAAAAAAAAAAAAAAAAAAAAAFAAAADwAAAABAAAAAAAAAAAAAAkUAAAAAQAAABQAAAAUAAAAFAAAAAEAAAAAAAAAZAAAAGQAAAAAAAAAZAAAAGQAAAAVAAAAYAAAAAAAAAAAAAAADwAAACADAAAAAAAAAAAAAAEAAACgMgAAVgcAAKr4//8BAAAAf39/AAEAAABkAAAAAAAAABQAAABAHwAAAAAAACYAAAAAAAAAwOD//wAAAAAmAAAAZAAAABYAAABMAAAAAAAAAAAAAAAEAAAAAAAAAAEAAACAgIAKAAAAACgAAAAoAAAAZAAAAGQAAAAAAAAAzMzMAAAAAABQAAAAUAAAAGQAAABkAAAAAAAAABcAAAAUAAAAAAAAAIgDAAD/fwAA/38AAAAAAAAJAAAABAAAACMAAAAeAAAAaAAAAAAAAAAAAAAAAAAAAAAAAAAAAAAAECcAABAnAAAAAAAAAAAAAAAAAAAAAAAAAAAAAAAAAAAAAAAAAAAAABQAAAAAAAAAwMD/AAAAAABkAAAAMgAAAAAAAABkAAAAAAAAAH9/fwAKAAAAIgAAABgAAAAAAAAAAAAAAAAAAAAAAAAAAAAAAAAAAAAkAAAAJAAAAAAAAAAHAAAAAAAAAAAAAAAAAAAAAAAAAAAAAAAAAAAAf39/ACUAAABYAAAAAAAAAAAAAAAAAAAAAAAAAAAAAAAAAAAAAAAAAAAAAAAAAAAAAAAAAAAAAAA/AAAAAAAAAKCGAQAAAAAAAAAAAAAAAAAMAAAAAQAAAAAAAAAAAAAAAAAAAB8AAABUAAAA//8AAP///wEAAAAAAAAAAAAAAAAAAAAAAAAAAAAAAAAAAAAAAAAAAAAAAAJ/f38AgICAA8zMzADAwP8Af39/AAAAAAAAAAAAAAAAAAAAAAAAAAAAIQAAABgAAAAUAAAAsRsAAJAbAADwIgAAZR4AABAAAAAmAAAACAAAAP//////////"/>
               </a:ext>
             </a:extLst>
           </p:cNvSpPr>
@@ -4730,7 +4730,7 @@
           <p:cNvSpPr txBox="1">
             <a:extLst>
               <a:ext uri="smNativeData">
-                <pr:smNativeData xmlns:pr="smNativeData" xmlns="smNativeData" val="SMDATA_15_7aDWaRMAAAAlAAAAEgAAAA8BAAAAkAAAAEgAAACQAAAASAAAAAAAAAABAAAAAAAAAAEAAABQAAAAAAAAAAAA4D8AAAAAAADgPwAAAAAAAOA/AAAAAAAA4D8AAAAAAADgPwAAAAAAAOA/AAAAAAAA4D8AAAAAAADgPwAAAAAAAOA/AAAAAAAA4D8CAAAAjAAAAAEAAAAAAAAAAP8AAP///wgAAAAAAAAAAAAAAAAAAAAAAAAAAAAAAAAAAAAAZAAAAAEAAABAAAAAAAAAAAAAAAAAAAAAAAAAAAAAAAAAAAAAAAAAAAAAAAAAAAAAAAAAAAAAAAAAAAAAAAAAAAAAAAAAAAAAAAAAAAAAAAAAAAAAAAAAAAAAAAAAAAAAFAAAADwAAAABAAAAAAAAAAAAAAkUAAAAAQAAABQAAAAUAAAAFAAAAAEAAAAAAAAAZAAAAGQAAAAAAAAAZAAAAGQAAAAVAAAAYAAAAAAAAAAAAAAADwAAACADAAAAAAAAAAAAAAEAAACgMgAAVgcAAKr4//8BAAAAf39/AAEAAABkAAAAAAAAABQAAABAHwAAAAAAACYAAAAAAAAAwOD//wAAAAAmAAAAZAAAABYAAABMAAAAAAAAAAAAAAAEAAAAAAAAAAEAAACAgIAKAAAAACgAAAAoAAAAZAAAAGQAAAAAAAAAzMzMAAAAAABQAAAAUAAAAGQAAABkAAAAAAAAABcAAAAUAAAAAAAAAIgDAAD/fwAA/38AAAAAAAAJAAAABAAAAAAAAAAeAAAAaAAAAAAAAAAAAAAAAAAAAAAAAAAAAAAAECcAABAnAAAAAAAAAAAAAAAAAAAAAAAAAAAAAAAAAAAAAAAAAAAAABQAAAAAAAAAwMD/AAAAAABkAAAAMgAAAAAAAABkAAAAAAAAAH9/fwAKAAAAIgAAABgAAAAAAAAAAAAAAAAAAAAAAAAAAAAAAAAAAAAkAAAAJAAAAAAAAAAHAAAAAAAAAAAAAAAAAAAAAAAAAAAAAAAAAAAAf39/ACUAAABYAAAAAAAAAAAAAAAAAAAAAAAAAAAAAAAAAAAAAAAAAAAAAAAAAAAAAAAAAAAAAAA/AAAAAAAAAKCGAQAAAAAAAAAAAAAAAAAMAAAAAQAAAAAAAAAAAAAAAAAAAB8AAABUAAAAAP8AAP///wEAAAAAAAAAAAAAAAAAAAAAAAAAAAAAAAAAAAAAAAAAAAAAAAJ/f38AgICAA8zMzADAwP8Af39/AAAAAAAAAAAAAAAAAAAAAAAAAAAAIQAAABgAAAAUAAAA4xwAAGsgAAC+IQAAQCMAABAAAAAmAAAACAAAAP//////////"/>
+                <pr:smNativeData xmlns:pr="smNativeData" xmlns="smNativeData" val="SMDATA_15_ZqHWaRMAAAAlAAAAEgAAAA8BAAAAkAAAAEgAAACQAAAASAAAAAAAAAABAAAAAAAAAAEAAABQAAAAAAAAAAAA4D8AAAAAAADgPwAAAAAAAOA/AAAAAAAA4D8AAAAAAADgPwAAAAAAAOA/AAAAAAAA4D8AAAAAAADgPwAAAAAAAOA/AAAAAAAA4D8CAAAAjAAAAAEAAAAAAAAAAP8AAP///wgAAAAAAAAAAAAAAAAAAAAAAAAAAAAAAAAAAAAAZAAAAAEAAABAAAAAAAAAAAAAAAAAAAAAAAAAAAAAAAAAAAAAAAAAAAAAAAAAAAAAAAAAAAAAAAAAAAAAAAAAAAAAAAAAAAAAAAAAAAAAAAAAAAAAAAAAAAAAAAAAAAAAFAAAADwAAAABAAAAAAAAAAAAAAkUAAAAAQAAABQAAAAUAAAAFAAAAAEAAAAAAAAAZAAAAGQAAAAAAAAAZAAAAGQAAAAVAAAAYAAAAAAAAAAAAAAADwAAACADAAAAAAAAAAAAAAEAAACgMgAAVgcAAKr4//8BAAAAf39/AAEAAABkAAAAAAAAABQAAABAHwAAAAAAACYAAAAAAAAAwOD//wAAAAAmAAAAZAAAABYAAABMAAAAAAAAAAAAAAAEAAAAAAAAAAEAAACAgIAKAAAAACgAAAAoAAAAZAAAAGQAAAAAAAAAzMzMAAAAAABQAAAAUAAAAGQAAABkAAAAAAAAABcAAAAUAAAAAAAAAIgDAAD/fwAA/38AAAAAAAAJAAAABAAAAAAAAAAeAAAAaAAAAAAAAAAAAAAAAAAAAAAAAAAAAAAAECcAABAnAAAAAAAAAAAAAAAAAAAAAAAAAAAAAAAAAAAAAAAAAAAAABQAAAAAAAAAwMD/AAAAAABkAAAAMgAAAAAAAABkAAAAAAAAAH9/fwAKAAAAIgAAABgAAAAAAAAAAAAAAAAAAAAAAAAAAAAAAAAAAAAkAAAAJAAAAAAAAAAHAAAAAAAAAAAAAAAAAAAAAAAAAAAAAAAAAAAAf39/ACUAAABYAAAAAAAAAAAAAAAAAAAAAAAAAAAAAAAAAAAAAAAAAAAAAAAAAAAAAAAAAAAAAAA/AAAAAAAAAKCGAQAAAAAAAAAAAAAAAAAMAAAAAQAAAAAAAAAAAAAAAAAAAB8AAABUAAAAAP8AAP///wEAAAAAAAAAAAAAAAAAAAAAAAAAAAAAAAAAAAAAAAAAAAAAAAJ/f38AgICAA8zMzADAwP8Af39/AAAAAAAAAAAAAAAAAAAAAAAAAAAAIQAAABgAAAAUAAAA4xwAAGsgAAC+IQAAQCMAABAAAAAmAAAACAAAAP//////////"/>
               </a:ext>
             </a:extLst>
           </p:cNvSpPr>
@@ -4774,7 +4774,7 @@
           <p:cNvGrpSpPr>
             <a:extLst>
               <a:ext uri="smNativeData">
-                <pr:smNativeData xmlns:pr="smNativeData" xmlns="smNativeData" val="SMDATA_6_7aDWaRMAAAAlAAAAAQAAAA8BAAAAkAAAAEgAAACQAAAASAAAAAAAAAAAAAAAAAAAABcAAAAUAAAAAAAAAAAAAAD/fwAA/38AAAAAAAAJAAAABAAAAF0AAAAfAAAAVAAAAAAAAAAAAAAAAAAAAAAAAAAAAAAAAAAAAAAAAAAAAAAAAAAAAAAAAAAAAAAAAAAAAAAAAAAAAAAAAAAAAAAAAAAAAAAAAAAAAAAAAAAAAAAAAAAAACEAAAAYAAAAFAAAAAgOAACcGwAAqxUAANUeAAAQAAAAJgAAAAgAAAD/////AAAAAA=="/>
+                <pr:smNativeData xmlns:pr="smNativeData" xmlns="smNativeData" val="SMDATA_6_ZqHWaRMAAAAlAAAAAQAAAA8BAAAAkAAAAEgAAACQAAAASAAAAAAAAAAAAAAAAAAAABcAAAAUAAAAAAAAAAAAAAD/fwAA/38AAAAAAAAJAAAABAAAAF0AAAAfAAAAVAAAAAAAAAAAAAAAAAAAAAAAAAAAAAAAAAAAAAAAAAAAAAAAAAAAAAAAAAAAAAAAAAAAAAAAAAAAAAAAAAAAAAAAAAAAAAAAAAAAAAAAAAAAAAAAAAAAACEAAAAYAAAAFAAAAAgOAACcGwAAqxUAANUeAAAQAAAAJgAAAAgAAAD/////AAAAAA=="/>
               </a:ext>
             </a:extLst>
           </p:cNvGrpSpPr>
@@ -4794,7 +4794,7 @@
             <p:cNvSpPr txBox="1">
               <a:extLst>
                 <a:ext uri="smNativeData">
-                  <pr:smNativeData xmlns:pr="smNativeData" xmlns="smNativeData" val="SMDATA_15_7aDWaRMAAAAlAAAAEgAAAA8BAAAAkAAAAEgAAACQAAAASAAAAAAAAAABAAAAAAAAAAEAAABQAAAAAAAAAAAA4D8AAAAAAADgPwAAAAAAAOA/AAAAAAAA4D8AAAAAAADgPwAAAAAAAOA/AAAAAAAA4D8AAAAAAADgPwAAAAAAAOA/AAAAAAAA4D8CAAAAjAAAAAEAAAAAAAAA//8AAP///wgAAAAAAAAAAAAAAAAAAAAAAAAAAAAAAAAAAAAAZAAAAAEAAABAAAAAAAAAAAAAAAAAAAAAAAAAAAAAAAAAAAAAAAAAAAAAAAAAAAAAAAAAAAAAAAAAAAAAAAAAAAAAAAAAAAAAAAAAAAAAAAAAAAAAAAAAAAAAAAAAAAAAFAAAADwAAAABAAAAAAAAAAAAAAkUAAAAAQAAABQAAAAUAAAAFAAAAAEAAAAAAAAAZAAAAGQAAAAAAAAAZAAAAGQAAAAVAAAAYAAAAAAAAAAAAAAADwAAACADAAAAAAAAAAAAAAEAAACgMgAAVgcAAKr4//8BAAAAf39/AAEAAABkAAAAAAAAABQAAABAHwAAAAAAACYAAAAAAAAAwOD//wAAAAAmAAAAZAAAABYAAABMAAAAAAAAAAAAAAAEAAAAAAAAAAEAAACAgIAKAAAAACgAAAAoAAAAZAAAAGQAAAAAAAAAzMzMAAAAAABQAAAAUAAAAGQAAABkAAAAAAAAABcAAAAUAAAAAAAAAIgDAAD/fwAA/38AAAAAAAAJAAAABAAAAJD3rDEeAAAAaAAAAAAAAAAAAAAAAAAAAAAAAAAAAAAAECcAABAnAAAAAAAAAAAAAAAAAAAAAAAAAAAAAAAAAAAAAAAAAAAAABQAAAAAAAAAwMD/AAAAAABkAAAAMgAAAAAAAABkAAAAAAAAAH9/fwAKAAAAIgAAABgAAAAAAAAAAAAAAAAAAAAAAAAAAAAAAAAAAAAkAAAAJAAAAAAAAAAHAAAAAAAAAAAAAAAAAAAAAAAAAAAAAAAAAAAAf39/ACUAAABYAAAAAAAAAAAAAAAAAAAAAAAAAAAAAAAAAAAAAAAAAAAAAAAAAAAAAAAAAAAAAAA/AAAAAAAAAKCGAQAAAAAAAAAAAAAAAAAMAAAAAQAAAAAAAAAAAAAAAAAAAB8AAABUAAAA//8AAP///wEAAAAAAAAAAAAAAAAAAAAAAAAAAAAAAAAAAAAAAAAAAAAAAAJ/f38AgICAA8zMzADAwP8Af39/AAAAAAAAAAAAAAAAAAAAAAAAAAAAIQAAABgAAAAUAAAAbA4AAAAcAACrFQAA1R4AAAAAAAAmAAAACAAAAP//////////"/>
+                  <pr:smNativeData xmlns:pr="smNativeData" xmlns="smNativeData" val="SMDATA_15_ZqHWaRMAAAAlAAAAEgAAAA8BAAAAkAAAAEgAAACQAAAASAAAAAAAAAABAAAAAAAAAAEAAABQAAAAAAAAAAAA4D8AAAAAAADgPwAAAAAAAOA/AAAAAAAA4D8AAAAAAADgPwAAAAAAAOA/AAAAAAAA4D8AAAAAAADgPwAAAAAAAOA/AAAAAAAA4D8CAAAAjAAAAAEAAAAAAAAA//8AAP///wgAAAAAAAAAAAAAAAAAAAAAAAAAAAAAAAAAAAAAZAAAAAEAAABAAAAAAAAAAAAAAAAAAAAAAAAAAAAAAAAAAAAAAAAAAAAAAAAAAAAAAAAAAAAAAAAAAAAAAAAAAAAAAAAAAAAAAAAAAAAAAAAAAAAAAAAAAAAAAAAAAAAAFAAAADwAAAABAAAAAAAAAAAAAAkUAAAAAQAAABQAAAAUAAAAFAAAAAEAAAAAAAAAZAAAAGQAAAAAAAAAZAAAAGQAAAAVAAAAYAAAAAAAAAAAAAAADwAAACADAAAAAAAAAAAAAAEAAACgMgAAVgcAAKr4//8BAAAAf39/AAEAAABkAAAAAAAAABQAAABAHwAAAAAAACYAAAAAAAAAwOD//wAAAAAmAAAAZAAAABYAAABMAAAAAAAAAAAAAAAEAAAAAAAAAAEAAACAgIAKAAAAACgAAAAoAAAAZAAAAGQAAAAAAAAAzMzMAAAAAABQAAAAUAAAAGQAAABkAAAAAAAAABcAAAAUAAAAAAAAAIgDAAD/fwAA/38AAAAAAAAJAAAABAAAAJD3rDEeAAAAaAAAAAAAAAAAAAAAAAAAAAAAAAAAAAAAECcAABAnAAAAAAAAAAAAAAAAAAAAAAAAAAAAAAAAAAAAAAAAAAAAABQAAAAAAAAAwMD/AAAAAABkAAAAMgAAAAAAAABkAAAAAAAAAH9/fwAKAAAAIgAAABgAAAAAAAAAAAAAAAAAAAAAAAAAAAAAAAAAAAAkAAAAJAAAAAAAAAAHAAAAAAAAAAAAAAAAAAAAAAAAAAAAAAAAAAAAf39/ACUAAABYAAAAAAAAAAAAAAAAAAAAAAAAAAAAAAAAAAAAAAAAAAAAAAAAAAAAAAAAAAAAAAA/AAAAAAAAAKCGAQAAAAAAAAAAAAAAAAAMAAAAAQAAAAAAAAAAAAAAAAAAAB8AAABUAAAA//8AAP///wEAAAAAAAAAAAAAAAAAAAAAAAAAAAAAAAAAAAAAAAAAAAAAAAJ/f38AgICAA8zMzADAwP8Af39/AAAAAAAAAAAAAAAAAAAAAAAAAAAAIQAAABgAAAAUAAAAbA4AAAAcAACrFQAA1R4AAAAAAAAmAAAACAAAAP//////////"/>
                 </a:ext>
               </a:extLst>
             </p:cNvSpPr>
@@ -4838,7 +4838,7 @@
             <p:cNvSpPr txBox="1">
               <a:extLst>
                 <a:ext uri="smNativeData">
-                  <pr:smNativeData xmlns:pr="smNativeData" xmlns="smNativeData" val="SMDATA_15_7aDWaRMAAAAlAAAAEgAAAA8BAAAAkAAAAEgAAACQAAAASAAAAAAAAAABAAAAAAAAAAEAAABQAAAAAAAAAAAA4D8AAAAAAADgPwAAAAAAAOA/AAAAAAAA4D8AAAAAAADgPwAAAAAAAOA/AAAAAAAA4D8AAAAAAADgPwAAAAAAAOA/AAAAAAAA4D8CAAAAjAAAAAEAAAAAAAAA//8AAP///wgAAAAAAAAAAAAAAAAAAAAAAAAAAAAAAAAAAAAAZAAAAAEAAABAAAAAAAAAAAAAAAAAAAAAAAAAAAAAAAAAAAAAAAAAAAAAAAAAAAAAAAAAAAAAAAAAAAAAAAAAAAAAAAAAAAAAAAAAAAAAAAAAAAAAAAAAAAAAAAAAAAAAFAAAADwAAAABAAAAAAAAAAAAAAkUAAAAAQAAABQAAAAUAAAAFAAAAAEAAAAAAAAAZAAAAGQAAAAAAAAAZAAAAGQAAAAVAAAAYAAAAAAAAAAAAAAADwAAACADAAAAAAAAAAAAAAEAAACgMgAAVgcAAKr4//8BAAAAf39/AAEAAABkAAAAAAAAABQAAABAHwAAAAAAACYAAAAAAAAAwOD//wAAAAAmAAAAZAAAABYAAABMAAAAAAAAAAAAAAAEAAAAAAAAAAEAAACAgIAKAAAAACgAAAAoAAAAZAAAAGQAAAAAAAAAzMzMAAAAAABQAAAAUAAAAGQAAABkAAAAAAAAABcAAAAUAAAAAAAAAIgDAAD/fwAA/38AAAAAAAAJAAAABAAAACMAAAAeAAAAaAAAAAAAAAAAAAAAAAAAAAAAAAAAAAAAECcAABAnAAAAAAAAAAAAAAAAAAAAAAAAAAAAAAAAAAAAAAAAAAAAABQAAAAAAAAAwMD/AAAAAABkAAAAMgAAAAAAAABkAAAAAAAAAH9/fwAKAAAAIgAAABgAAAAAAAAAAAAAAAAAAAAAAAAAAAAAAAAAAAAkAAAAJAAAAAAAAAAHAAAAAAAAAAAAAAAAAAAAAAAAAAAAAAAAAAAAf39/ACUAAABYAAAAAAAAAAAAAAAAAAAAAAAAAAAAAAAAAAAAAAAAAAAAAAAAAAAAAAAAAAAAAAA/AAAAAAAAAKCGAQAAAAAAAAAAAAAAAAAMAAAAAQAAAAAAAAAAAAAAAAAAAB8AAABUAAAA//8AAP///wEAAAAAAAAAAAAAAAAAAAAAAAAAAAAAAAAAAAAAAAAAAAAAAAJ/f38AgICAA8zMzADAwP8Af39/AAAAAAAAAAAAAAAAAAAAAAAAAAAAIQAAABgAAAAUAAAACA4AAJwbAABHFQAAcR4AAAAAAAAmAAAACAAAAP//////////"/>
+                  <pr:smNativeData xmlns:pr="smNativeData" xmlns="smNativeData" val="SMDATA_15_ZqHWaRMAAAAlAAAAEgAAAA8BAAAAkAAAAEgAAACQAAAASAAAAAAAAAABAAAAAAAAAAEAAABQAAAAAAAAAAAA4D8AAAAAAADgPwAAAAAAAOA/AAAAAAAA4D8AAAAAAADgPwAAAAAAAOA/AAAAAAAA4D8AAAAAAADgPwAAAAAAAOA/AAAAAAAA4D8CAAAAjAAAAAEAAAAAAAAA//8AAP///wgAAAAAAAAAAAAAAAAAAAAAAAAAAAAAAAAAAAAAZAAAAAEAAABAAAAAAAAAAAAAAAAAAAAAAAAAAAAAAAAAAAAAAAAAAAAAAAAAAAAAAAAAAAAAAAAAAAAAAAAAAAAAAAAAAAAAAAAAAAAAAAAAAAAAAAAAAAAAAAAAAAAAFAAAADwAAAABAAAAAAAAAAAAAAkUAAAAAQAAABQAAAAUAAAAFAAAAAEAAAAAAAAAZAAAAGQAAAAAAAAAZAAAAGQAAAAVAAAAYAAAAAAAAAAAAAAADwAAACADAAAAAAAAAAAAAAEAAACgMgAAVgcAAKr4//8BAAAAf39/AAEAAABkAAAAAAAAABQAAABAHwAAAAAAACYAAAAAAAAAwOD//wAAAAAmAAAAZAAAABYAAABMAAAAAAAAAAAAAAAEAAAAAAAAAAEAAACAgIAKAAAAACgAAAAoAAAAZAAAAGQAAAAAAAAAzMzMAAAAAABQAAAAUAAAAGQAAABkAAAAAAAAABcAAAAUAAAAAAAAAIgDAAD/fwAA/38AAAAAAAAJAAAABAAAACMAAAAeAAAAaAAAAAAAAAAAAAAAAAAAAAAAAAAAAAAAECcAABAnAAAAAAAAAAAAAAAAAAAAAAAAAAAAAAAAAAAAAAAAAAAAABQAAAAAAAAAwMD/AAAAAABkAAAAMgAAAAAAAABkAAAAAAAAAH9/fwAKAAAAIgAAABgAAAAAAAAAAAAAAAAAAAAAAAAAAAAAAAAAAAAkAAAAJAAAAAAAAAAHAAAAAAAAAAAAAAAAAAAAAAAAAAAAAAAAAAAAf39/ACUAAABYAAAAAAAAAAAAAAAAAAAAAAAAAAAAAAAAAAAAAAAAAAAAAAAAAAAAAAAAAAAAAAA/AAAAAAAAAKCGAQAAAAAAAAAAAAAAAAAMAAAAAQAAAAAAAAAAAAAAAAAAAB8AAABUAAAA//8AAP///wEAAAAAAAAAAAAAAAAAAAAAAAAAAAAAAAAAAAAAAAAAAAAAAAJ/f38AgICAA8zMzADAwP8Af39/AAAAAAAAAAAAAAAAAAAAAAAAAAAAIQAAABgAAAAUAAAACA4AAJwbAABHFQAAcR4AAAAAAAAmAAAACAAAAP//////////"/>
                 </a:ext>
               </a:extLst>
             </p:cNvSpPr>
@@ -4883,7 +4883,7 @@
           <p:cNvGrpSpPr>
             <a:extLst>
               <a:ext uri="smNativeData">
-                <pr:smNativeData xmlns:pr="smNativeData" xmlns="smNativeData" val="SMDATA_6_7aDWaRMAAAAlAAAAAQAAAA8BAAAAkAAAAEgAAACQAAAASAAAAAAAAAAAAAAAAAAAABcAAAAUAAAAAAAAAAAAAAD/fwAA/38AAAAAAAAJAAAABAAAABQeAjMfAAAAVAAAAAAAAAAAAAAAAAAAAAAAAAAAAAAAAAAAAAAAAAAAAAAAAAAAAAAAAAAAAAAAAAAAAAAAAAAAAAAAAAAAAAAAAAAAAAAAAAAAAAAAAAAAAAAAAAAAACEAAAAYAAAAFAAAADMNAACoJAAAaBYAAN4nAAAQAAAAJgAAAAgAAAD/////AAAAAA=="/>
+                <pr:smNativeData xmlns:pr="smNativeData" xmlns="smNativeData" val="SMDATA_6_ZqHWaRMAAAAlAAAAAQAAAA8BAAAAkAAAAEgAAACQAAAASAAAAAAAAAAAAAAAAAAAABcAAAAUAAAAAAAAAAAAAAD/fwAA/38AAAAAAAAJAAAABAAAABQeAjMfAAAAVAAAAAAAAAAAAAAAAAAAAAAAAAAAAAAAAAAAAAAAAAAAAAAAAAAAAAAAAAAAAAAAAAAAAAAAAAAAAAAAAAAAAAAAAAAAAAAAAAAAAAAAAAAAAAAAAAAAACEAAAAYAAAAFAAAADMNAACoJAAAaBYAAN4nAAAQAAAAJgAAAAgAAAD/////AAAAAA=="/>
               </a:ext>
             </a:extLst>
           </p:cNvGrpSpPr>
@@ -4903,7 +4903,7 @@
             <p:cNvSpPr txBox="1">
               <a:extLst>
                 <a:ext uri="smNativeData">
-                  <pr:smNativeData xmlns:pr="smNativeData" xmlns="smNativeData" val="SMDATA_15_7aDWaRMAAAAlAAAAEgAAAA8BAAAAkAAAAEgAAACQAAAASAAAAAAAAAABAAAAAAAAAAEAAABQAAAAAAAAAAAA4D8AAAAAAADgPwAAAAAAAOA/AAAAAAAA4D8AAAAAAADgPwAAAAAAAOA/AAAAAAAA4D8AAAAAAADgPwAAAAAAAOA/AAAAAAAA4D8CAAAAjAAAAAEAAAAAAAAA//8AAP///wgAAAAAAAAAAAAAAAAAAAAAAAAAAAAAAAAAAAAAZAAAAAEAAABAAAAAAAAAAAAAAAAAAAAAAAAAAAAAAAAAAAAAAAAAAAAAAAAAAAAAAAAAAAAAAAAAAAAAAAAAAAAAAAAAAAAAAAAAAAAAAAAAAAAAAAAAAAAAAAAAAAAAFAAAADwAAAABAAAAAAAAAAAAAAkUAAAAAQAAABQAAAAUAAAAFAAAAAEAAAAAAAAAZAAAAGQAAAAAAAAAZAAAAGQAAAAVAAAAYAAAAAAAAAAAAAAADwAAACADAAAAAAAAAAAAAAEAAACgMgAAVgcAAKr4//8BAAAAf39/AAEAAABkAAAAAAAAABQAAABAHwAAAAAAACYAAAAAAAAAwOD//wAAAAAmAAAAZAAAABYAAABMAAAAAAAAAAAAAAAEAAAAAAAAAAEAAACAgIAKAAAAACgAAAAoAAAAZAAAAGQAAAAAAAAAzMzMAAAAAABQAAAAUAAAAGQAAABkAAAAAAAAABcAAAAUAAAAAAAAAIgDAAD/fwAA/38AAAAAAAAJAAAABAAAAAAAAAAeAAAAaAAAAAAAAAAAAAAAAAAAAAAAAAAAAAAAECcAABAnAAAAAAAAAAAAAAAAAAAAAAAAAAAAAAAAAAAAAAAAAAAAABQAAAAAAAAAwMD/AAAAAABkAAAAMgAAAAAAAABkAAAAAAAAAH9/fwAKAAAAIgAAABgAAAAAAAAAAAAAAAAAAAAAAAAAAAAAAAAAAAAkAAAAJAAAAAAAAAAHAAAAAAAAAAAAAAAAAAAAAAAAAAAAAAAAAAAAf39/ACUAAABYAAAAAAAAAAAAAAAAAAAAAAAAAAAAAAAAAAAAAAAAAAAAAAAAAAAAAAAAAAAAAAA/AAAAAAAAAKCGAQAAAAAAAAAAAAAAAAAMAAAAAQAAAAAAAAAAAAAAAAAAAB8AAABUAAAA//8AAP///wEAAAAAAAAAAAAAAAAAAAAAAAAAAAAAAAAAAAAAAAAAAAAAAAJ/f38AgICAA8zMzADAwP8Af39/AAAAAAAAAAAAAAAAAAAAAAAAAAAAIQAAABgAAAAUAAAAlA0AAAklAABoFgAA3icAAAAAAAAmAAAACAAAAP//////////"/>
+                  <pr:smNativeData xmlns:pr="smNativeData" xmlns="smNativeData" val="SMDATA_15_ZqHWaRMAAAAlAAAAEgAAAA8BAAAAkAAAAEgAAACQAAAASAAAAAAAAAABAAAAAAAAAAEAAABQAAAAAAAAAAAA4D8AAAAAAADgPwAAAAAAAOA/AAAAAAAA4D8AAAAAAADgPwAAAAAAAOA/AAAAAAAA4D8AAAAAAADgPwAAAAAAAOA/AAAAAAAA4D8CAAAAjAAAAAEAAAAAAAAA//8AAP///wgAAAAAAAAAAAAAAAAAAAAAAAAAAAAAAAAAAAAAZAAAAAEAAABAAAAAAAAAAAAAAAAAAAAAAAAAAAAAAAAAAAAAAAAAAAAAAAAAAAAAAAAAAAAAAAAAAAAAAAAAAAAAAAAAAAAAAAAAAAAAAAAAAAAAAAAAAAAAAAAAAAAAFAAAADwAAAABAAAAAAAAAAAAAAkUAAAAAQAAABQAAAAUAAAAFAAAAAEAAAAAAAAAZAAAAGQAAAAAAAAAZAAAAGQAAAAVAAAAYAAAAAAAAAAAAAAADwAAACADAAAAAAAAAAAAAAEAAACgMgAAVgcAAKr4//8BAAAAf39/AAEAAABkAAAAAAAAABQAAABAHwAAAAAAACYAAAAAAAAAwOD//wAAAAAmAAAAZAAAABYAAABMAAAAAAAAAAAAAAAEAAAAAAAAAAEAAACAgIAKAAAAACgAAAAoAAAAZAAAAGQAAAAAAAAAzMzMAAAAAABQAAAAUAAAAGQAAABkAAAAAAAAABcAAAAUAAAAAAAAAIgDAAD/fwAA/38AAAAAAAAJAAAABAAAAAAAAAAeAAAAaAAAAAAAAAAAAAAAAAAAAAAAAAAAAAAAECcAABAnAAAAAAAAAAAAAAAAAAAAAAAAAAAAAAAAAAAAAAAAAAAAABQAAAAAAAAAwMD/AAAAAABkAAAAMgAAAAAAAABkAAAAAAAAAH9/fwAKAAAAIgAAABgAAAAAAAAAAAAAAAAAAAAAAAAAAAAAAAAAAAAkAAAAJAAAAAAAAAAHAAAAAAAAAAAAAAAAAAAAAAAAAAAAAAAAAAAAf39/ACUAAABYAAAAAAAAAAAAAAAAAAAAAAAAAAAAAAAAAAAAAAAAAAAAAAAAAAAAAAAAAAAAAAA/AAAAAAAAAKCGAQAAAAAAAAAAAAAAAAAMAAAAAQAAAAAAAAAAAAAAAAAAAB8AAABUAAAA//8AAP///wEAAAAAAAAAAAAAAAAAAAAAAAAAAAAAAAAAAAAAAAAAAAAAAAJ/f38AgICAA8zMzADAwP8Af39/AAAAAAAAAAAAAAAAAAAAAAAAAAAAIQAAABgAAAAUAAAAlA0AAAklAABoFgAA3icAAAAAAAAmAAAACAAAAP//////////"/>
                 </a:ext>
               </a:extLst>
             </p:cNvSpPr>
@@ -4947,7 +4947,7 @@
             <p:cNvSpPr txBox="1">
               <a:extLst>
                 <a:ext uri="smNativeData">
-                  <pr:smNativeData xmlns:pr="smNativeData" xmlns="smNativeData" val="SMDATA_15_7aDWaRMAAAAlAAAAEgAAAA8BAAAAkAAAAEgAAACQAAAASAAAAAAAAAABAAAAAAAAAAEAAABQAAAAAAAAAAAA4D8AAAAAAADgPwAAAAAAAOA/AAAAAAAA4D8AAAAAAADgPwAAAAAAAOA/AAAAAAAA4D8AAAAAAADgPwAAAAAAAOA/AAAAAAAA4D8CAAAAjAAAAAEAAAAAAAAA//8AAP///wgAAAAAAAAAAAAAAAAAAAAAAAAAAAAAAAAAAAAAZAAAAAEAAABAAAAAAAAAAAAAAAAAAAAAAAAAAAAAAAAAAAAAAAAAAAAAAAAAAAAAAAAAAAAAAAAAAAAAAAAAAAAAAAAAAAAAAAAAAAAAAAAAAAAAAAAAAAAAAAAAAAAAFAAAADwAAAABAAAAAAAAAAAAAAkUAAAAAQAAABQAAAAUAAAAFAAAAAEAAAAAAAAAZAAAAGQAAAAAAAAAZAAAAGQAAAAVAAAAYAAAAAAAAAAAAAAADwAAACADAAAAAAAAAAAAAAEAAACgMgAAVgcAAKr4//8BAAAAf39/AAEAAABkAAAAAAAAABQAAABAHwAAAAAAACYAAAAAAAAAwOD//wAAAAAmAAAAZAAAABYAAABMAAAAAAAAAAAAAAAEAAAAAAAAAAEAAACAgIAKAAAAACgAAAAoAAAAZAAAAGQAAAAAAAAAzMzMAAAAAABQAAAAUAAAAGQAAABkAAAAAAAAABcAAAAUAAAAAAAAAIgDAAD/fwAA/38AAAAAAAAJAAAABAAAAA+Qx/8eAAAAaAAAAAAAAAAAAAAAAAAAAAAAAAAAAAAAECcAABAnAAAAAAAAAAAAAAAAAAAAAAAAAAAAAAAAAAAAAAAAAAAAABQAAAAAAAAAwMD/AAAAAABkAAAAMgAAAAAAAABkAAAAAAAAAH9/fwAKAAAAIgAAABgAAAAAAAAAAAAAAAAAAAAAAAAAAAAAAAAAAAAkAAAAJAAAAAAAAAAHAAAAAAAAAAAAAAAAAAAAAAAAAAAAAAAAAAAAf39/ACUAAABYAAAAAAAAAAAAAAAAAAAAAAAAAAAAAAAAAAAAAAAAAAAAAAAAAAAAAAAAAAAAAAA/AAAAAAAAAKCGAQAAAAAAAAAAAAAAAAAMAAAAAQAAAAAAAAAAAAAAAAAAAB8AAABUAAAA//8AAP///wEAAAAAAAAAAAAAAAAAAAAAAAAAAAAAAAAAAAAAAAAAAAAAAAJ/f38AgICAA8zMzADAwP8Af39/AAAAAAAAAAAAAAAAAAAAAAAAAAAAIQAAABgAAAAUAAAAMw0AAKgkAAAHFgAAfScAAAAAAAAmAAAACAAAAP//////////"/>
+                  <pr:smNativeData xmlns:pr="smNativeData" xmlns="smNativeData" val="SMDATA_15_ZqHWaRMAAAAlAAAAEgAAAA8BAAAAkAAAAEgAAACQAAAASAAAAAAAAAABAAAAAAAAAAEAAABQAAAAAAAAAAAA4D8AAAAAAADgPwAAAAAAAOA/AAAAAAAA4D8AAAAAAADgPwAAAAAAAOA/AAAAAAAA4D8AAAAAAADgPwAAAAAAAOA/AAAAAAAA4D8CAAAAjAAAAAEAAAAAAAAA//8AAP///wgAAAAAAAAAAAAAAAAAAAAAAAAAAAAAAAAAAAAAZAAAAAEAAABAAAAAAAAAAAAAAAAAAAAAAAAAAAAAAAAAAAAAAAAAAAAAAAAAAAAAAAAAAAAAAAAAAAAAAAAAAAAAAAAAAAAAAAAAAAAAAAAAAAAAAAAAAAAAAAAAAAAAFAAAADwAAAABAAAAAAAAAAAAAAkUAAAAAQAAABQAAAAUAAAAFAAAAAEAAAAAAAAAZAAAAGQAAAAAAAAAZAAAAGQAAAAVAAAAYAAAAAAAAAAAAAAADwAAACADAAAAAAAAAAAAAAEAAACgMgAAVgcAAKr4//8BAAAAf39/AAEAAABkAAAAAAAAABQAAABAHwAAAAAAACYAAAAAAAAAwOD//wAAAAAmAAAAZAAAABYAAABMAAAAAAAAAAAAAAAEAAAAAAAAAAEAAACAgIAKAAAAACgAAAAoAAAAZAAAAGQAAAAAAAAAzMzMAAAAAABQAAAAUAAAAGQAAABkAAAAAAAAABcAAAAUAAAAAAAAAIgDAAD/fwAA/38AAAAAAAAJAAAABAAAAA+Qx/8eAAAAaAAAAAAAAAAAAAAAAAAAAAAAAAAAAAAAECcAABAnAAAAAAAAAAAAAAAAAAAAAAAAAAAAAAAAAAAAAAAAAAAAABQAAAAAAAAAwMD/AAAAAABkAAAAMgAAAAAAAABkAAAAAAAAAH9/fwAKAAAAIgAAABgAAAAAAAAAAAAAAAAAAAAAAAAAAAAAAAAAAAAkAAAAJAAAAAAAAAAHAAAAAAAAAAAAAAAAAAAAAAAAAAAAAAAAAAAAf39/ACUAAABYAAAAAAAAAAAAAAAAAAAAAAAAAAAAAAAAAAAAAAAAAAAAAAAAAAAAAAAAAAAAAAA/AAAAAAAAAKCGAQAAAAAAAAAAAAAAAAAMAAAAAQAAAAAAAAAAAAAAAAAAAB8AAABUAAAA//8AAP///wEAAAAAAAAAAAAAAAAAAAAAAAAAAAAAAAAAAAAAAAAAAAAAAAJ/f38AgICAA8zMzADAwP8Af39/AAAAAAAAAAAAAAAAAAAAAAAAAAAAIQAAABgAAAAUAAAAMw0AAKgkAAAHFgAAfScAAAAAAAAmAAAACAAAAP//////////"/>
                 </a:ext>
               </a:extLst>
             </p:cNvSpPr>
@@ -4992,7 +4992,7 @@
           <p:cNvGrpSpPr>
             <a:extLst>
               <a:ext uri="smNativeData">
-                <pr:smNativeData xmlns:pr="smNativeData" xmlns="smNativeData" val="SMDATA_6_7aDWaRMAAAAlAAAAAQAAAA8BAAAAkAAAAEgAAACQAAAASAAAAAAAAAAAAAAAAAAAABcAAAAUAAAAAAAAAAAAAAD/fwAA/38AAAAAAAAJAAAABAAAAHIGAAAfAAAAVAAAAAAAAAAAAAAAAAAAAAAAAAAAAAAAAAAAAAAAAAAAAAAAAAAAAAAAAAAAAAAAAAAAAAAAAAAAAAAAAAAAAAAAAAAAAAAAAAAAAAAAAAAAAAAAAAAAACEAAAAYAAAAFAAAAGoNAABqIAAAMRYAAHQjAAAQAAAAJgAAAAgAAAD/////AAAAAA=="/>
+                <pr:smNativeData xmlns:pr="smNativeData" xmlns="smNativeData" val="SMDATA_6_ZqHWaRMAAAAlAAAAAQAAAA8BAAAAkAAAAEgAAACQAAAASAAAAAAAAAAAAAAAAAAAABcAAAAUAAAAAAAAAAAAAAD/fwAA/38AAAAAAAAJAAAABAAAAHIGAAAfAAAAVAAAAAAAAAAAAAAAAAAAAAAAAAAAAAAAAAAAAAAAAAAAAAAAAAAAAAAAAAAAAAAAAAAAAAAAAAAAAAAAAAAAAAAAAAAAAAAAAAAAAAAAAAAAAAAAAAAAACEAAAAYAAAAFAAAAGoNAABqIAAAMRYAAHQjAAAQAAAAJgAAAAgAAAD/////AAAAAA=="/>
               </a:ext>
             </a:extLst>
           </p:cNvGrpSpPr>
@@ -5012,7 +5012,7 @@
             <p:cNvSpPr txBox="1">
               <a:extLst>
                 <a:ext uri="smNativeData">
-                  <pr:smNativeData xmlns:pr="smNativeData" xmlns="smNativeData" val="SMDATA_15_7aDWaRMAAAAlAAAAEgAAAA8BAAAAkAAAAEgAAACQAAAASAAAAAAAAAABAAAAAAAAAAEAAABQAAAAAAAAAAAA4D8AAAAAAADgPwAAAAAAAOA/AAAAAAAA4D8AAAAAAADgPwAAAAAAAOA/AAAAAAAA4D8AAAAAAADgPwAAAAAAAOA/AAAAAAAA4D8CAAAAjAAAAAEAAAAAAAAAAP8AAP///wgAAAAAAAAAAAAAAAAAAAAAAAAAAAAAAAAAAAAAZAAAAAEAAABAAAAAAAAAAAAAAAAAAAAAAAAAAAAAAAAAAAAAAAAAAAAAAAAAAAAAAAAAAAAAAAAAAAAAAAAAAAAAAAAAAAAAAAAAAAAAAAAAAAAAAAAAAAAAAAAAAAAAFAAAADwAAAABAAAAAAAAAAAAAAkUAAAAAQAAABQAAAAUAAAAFAAAAAEAAAAAAAAAZAAAAGQAAAAAAAAAZAAAAGQAAAAVAAAAYAAAAAAAAAAAAAAADwAAACADAAAAAAAAAAAAAAEAAACgMgAAVgcAAKr4//8BAAAAf39/AAEAAABkAAAAAAAAABQAAABAHwAAAAAAACYAAAAAAAAAwOD//wAAAAAmAAAAZAAAABYAAABMAAAAAAAAAAAAAAAEAAAAAAAAAAEAAACAgIAKAAAAACgAAAAoAAAAZAAAAGQAAAAAAAAAzMzMAAAAAABQAAAAUAAAAGQAAABkAAAAAAAAABcAAAAUAAAAAAAAAIgDAAD/fwAA/38AAAAAAAAJAAAABAAAACMAAAAeAAAAaAAAAAAAAAAAAAAAAAAAAAAAAAAAAAAAECcAABAnAAAAAAAAAAAAAAAAAAAAAAAAAAAAAAAAAAAAAAAAAAAAABQAAAAAAAAAwMD/AAAAAABkAAAAMgAAAAAAAABkAAAAAAAAAH9/fwAKAAAAIgAAABgAAAAAAAAAAAAAAAAAAAAAAAAAAAAAAAAAAAAkAAAAJAAAAAAAAAAHAAAAAAAAAAAAAAAAAAAAAAAAAAAAAAAAAAAAf39/ACUAAABYAAAAAAAAAAAAAAAAAAAAAAAAAAAAAAAAAAAAAAAAAAAAAAAAAAAAAAAAAAAAAAA/AAAAAAAAAKCGAQAAAAAAAAAAAAAAAAAMAAAAAQAAAAAAAAAAAAAAAAAAAB8AAABUAAAAAP8AAP///wEAAAAAAAAAAAAAAAAAAAAAAAAAAAAAAAAAAAAAAAAAAAAAAAJ/f38AgICAA8zMzADAwP8Af39/AAAAAAAAAAAAAAAAAAAAAAAAAAAAIQAAABgAAAAUAAAAzg0AAM4gAAAxFgAAdCMAAAAAAAAmAAAACAAAAP//////////"/>
+                  <pr:smNativeData xmlns:pr="smNativeData" xmlns="smNativeData" val="SMDATA_15_ZqHWaRMAAAAlAAAAEgAAAA8BAAAAkAAAAEgAAACQAAAASAAAAAAAAAABAAAAAAAAAAEAAABQAAAAAAAAAAAA4D8AAAAAAADgPwAAAAAAAOA/AAAAAAAA4D8AAAAAAADgPwAAAAAAAOA/AAAAAAAA4D8AAAAAAADgPwAAAAAAAOA/AAAAAAAA4D8CAAAAjAAAAAEAAAAAAAAAAP8AAP///wgAAAAAAAAAAAAAAAAAAAAAAAAAAAAAAAAAAAAAZAAAAAEAAABAAAAAAAAAAAAAAAAAAAAAAAAAAAAAAAAAAAAAAAAAAAAAAAAAAAAAAAAAAAAAAAAAAAAAAAAAAAAAAAAAAAAAAAAAAAAAAAAAAAAAAAAAAAAAAAAAAAAAFAAAADwAAAABAAAAAAAAAAAAAAkUAAAAAQAAABQAAAAUAAAAFAAAAAEAAAAAAAAAZAAAAGQAAAAAAAAAZAAAAGQAAAAVAAAAYAAAAAAAAAAAAAAADwAAACADAAAAAAAAAAAAAAEAAACgMgAAVgcAAKr4//8BAAAAf39/AAEAAABkAAAAAAAAABQAAABAHwAAAAAAACYAAAAAAAAAwOD//wAAAAAmAAAAZAAAABYAAABMAAAAAAAAAAAAAAAEAAAAAAAAAAEAAACAgIAKAAAAACgAAAAoAAAAZAAAAGQAAAAAAAAAzMzMAAAAAABQAAAAUAAAAGQAAABkAAAAAAAAABcAAAAUAAAAAAAAAIgDAAD/fwAA/38AAAAAAAAJAAAABAAAACMAAAAeAAAAaAAAAAAAAAAAAAAAAAAAAAAAAAAAAAAAECcAABAnAAAAAAAAAAAAAAAAAAAAAAAAAAAAAAAAAAAAAAAAAAAAABQAAAAAAAAAwMD/AAAAAABkAAAAMgAAAAAAAABkAAAAAAAAAH9/fwAKAAAAIgAAABgAAAAAAAAAAAAAAAAAAAAAAAAAAAAAAAAAAAAkAAAAJAAAAAAAAAAHAAAAAAAAAAAAAAAAAAAAAAAAAAAAAAAAAAAAf39/ACUAAABYAAAAAAAAAAAAAAAAAAAAAAAAAAAAAAAAAAAAAAAAAAAAAAAAAAAAAAAAAAAAAAA/AAAAAAAAAKCGAQAAAAAAAAAAAAAAAAAMAAAAAQAAAAAAAAAAAAAAAAAAAB8AAABUAAAAAP8AAP///wEAAAAAAAAAAAAAAAAAAAAAAAAAAAAAAAAAAAAAAAAAAAAAAAJ/f38AgICAA8zMzADAwP8Af39/AAAAAAAAAAAAAAAAAAAAAAAAAAAAIQAAABgAAAAUAAAAzg0AAM4gAAAxFgAAdCMAAAAAAAAmAAAACAAAAP//////////"/>
                 </a:ext>
               </a:extLst>
             </p:cNvSpPr>
@@ -5056,7 +5056,7 @@
             <p:cNvSpPr txBox="1">
               <a:extLst>
                 <a:ext uri="smNativeData">
-                  <pr:smNativeData xmlns:pr="smNativeData" xmlns="smNativeData" val="SMDATA_15_7aDWaRMAAAAlAAAAEgAAAA8BAAAAkAAAAEgAAACQAAAASAAAAAAAAAABAAAAAAAAAAEAAABQAAAAAAAAAAAA4D8AAAAAAADgPwAAAAAAAOA/AAAAAAAA4D8AAAAAAADgPwAAAAAAAOA/AAAAAAAA4D8AAAAAAADgPwAAAAAAAOA/AAAAAAAA4D8CAAAAjAAAAAEAAAAAAAAAAP8AAP///wgAAAAAAAAAAAAAAAAAAAAAAAAAAAAAAAAAAAAAZAAAAAEAAABAAAAAAAAAAAAAAAAAAAAAAAAAAAAAAAAAAAAAAAAAAAAAAAAAAAAAAAAAAAAAAAAAAAAAAAAAAAAAAAAAAAAAAAAAAAAAAAAAAAAAAAAAAAAAAAAAAAAAFAAAADwAAAABAAAAAAAAAAAAAAkUAAAAAQAAABQAAAAUAAAAFAAAAAEAAAAAAAAAZAAAAGQAAAAAAAAAZAAAAGQAAAAVAAAAYAAAAAAAAAAAAAAADwAAACADAAAAAAAAAAAAAAEAAACgMgAAVgcAAKr4//8BAAAAf39/AAEAAABkAAAAAAAAABQAAABAHwAAAAAAACYAAAAAAAAAwOD//wAAAAAmAAAAZAAAABYAAABMAAAAAAAAAAAAAAAEAAAAAAAAAAEAAACAgIAKAAAAACgAAAAoAAAAZAAAAGQAAAAAAAAAzMzMAAAAAABQAAAAUAAAAGQAAABkAAAAAAAAABcAAAAUAAAAAAAAAIgDAAD/fwAA/38AAAAAAAAJAAAABAAAACMAAAAeAAAAaAAAAAAAAAAAAAAAAAAAAAAAAAAAAAAAECcAABAnAAAAAAAAAAAAAAAAAAAAAAAAAAAAAAAAAAAAAAAAAAAAABQAAAAAAAAAwMD/AAAAAABkAAAAMgAAAAAAAABkAAAAAAAAAH9/fwAKAAAAIgAAABgAAAAAAAAAAAAAAAAAAAAAAAAAAAAAAAAAAAAkAAAAJAAAAAAAAAAHAAAAAAAAAAAAAAAAAAAAAAAAAAAAAAAAAAAAf39/ACUAAABYAAAAAAAAAAAAAAAAAAAAAAAAAAAAAAAAAAAAAAAAAAAAAAAAAAAAAAAAAAAAAAA/AAAAAAAAAKCGAQAAAAAAAAAAAAAAAAAMAAAAAQAAAAAAAAAAAAAAAAAAAB8AAABUAAAAAP8AAP///wEAAAAAAAAAAAAAAAAAAAAAAAAAAAAAAAAAAAAAAAAAAAAAAAJ/f38AgICAA8zMzADAwP8Af39/AAAAAAAAAAAAAAAAAAAAAAAAAAAAIQAAABgAAAAUAAAAag0AAGogAADNFQAAECMAAAAAAAAmAAAACAAAAP//////////"/>
+                  <pr:smNativeData xmlns:pr="smNativeData" xmlns="smNativeData" val="SMDATA_15_ZqHWaRMAAAAlAAAAEgAAAA8BAAAAkAAAAEgAAACQAAAASAAAAAAAAAABAAAAAAAAAAEAAABQAAAAAAAAAAAA4D8AAAAAAADgPwAAAAAAAOA/AAAAAAAA4D8AAAAAAADgPwAAAAAAAOA/AAAAAAAA4D8AAAAAAADgPwAAAAAAAOA/AAAAAAAA4D8CAAAAjAAAAAEAAAAAAAAAAP8AAP///wgAAAAAAAAAAAAAAAAAAAAAAAAAAAAAAAAAAAAAZAAAAAEAAABAAAAAAAAAAAAAAAAAAAAAAAAAAAAAAAAAAAAAAAAAAAAAAAAAAAAAAAAAAAAAAAAAAAAAAAAAAAAAAAAAAAAAAAAAAAAAAAAAAAAAAAAAAAAAAAAAAAAAFAAAADwAAAABAAAAAAAAAAAAAAkUAAAAAQAAABQAAAAUAAAAFAAAAAEAAAAAAAAAZAAAAGQAAAAAAAAAZAAAAGQAAAAVAAAAYAAAAAAAAAAAAAAADwAAACADAAAAAAAAAAAAAAEAAACgMgAAVgcAAKr4//8BAAAAf39/AAEAAABkAAAAAAAAABQAAABAHwAAAAAAACYAAAAAAAAAwOD//wAAAAAmAAAAZAAAABYAAABMAAAAAAAAAAAAAAAEAAAAAAAAAAEAAACAgIAKAAAAACgAAAAoAAAAZAAAAGQAAAAAAAAAzMzMAAAAAABQAAAAUAAAAGQAAABkAAAAAAAAABcAAAAUAAAAAAAAAIgDAAD/fwAA/38AAAAAAAAJAAAABAAAACMAAAAeAAAAaAAAAAAAAAAAAAAAAAAAAAAAAAAAAAAAECcAABAnAAAAAAAAAAAAAAAAAAAAAAAAAAAAAAAAAAAAAAAAAAAAABQAAAAAAAAAwMD/AAAAAABkAAAAMgAAAAAAAABkAAAAAAAAAH9/fwAKAAAAIgAAABgAAAAAAAAAAAAAAAAAAAAAAAAAAAAAAAAAAAAkAAAAJAAAAAAAAAAHAAAAAAAAAAAAAAAAAAAAAAAAAAAAAAAAAAAAf39/ACUAAABYAAAAAAAAAAAAAAAAAAAAAAAAAAAAAAAAAAAAAAAAAAAAAAAAAAAAAAAAAAAAAAA/AAAAAAAAAKCGAQAAAAAAAAAAAAAAAAAMAAAAAQAAAAAAAAAAAAAAAAAAAB8AAABUAAAAAP8AAP///wEAAAAAAAAAAAAAAAAAAAAAAAAAAAAAAAAAAAAAAAAAAAAAAAJ/f38AgICAA8zMzADAwP8Af39/AAAAAAAAAAAAAAAAAAAAAAAAAAAAIQAAABgAAAAUAAAAag0AAGogAADNFQAAECMAAAAAAAAmAAAACAAAAP//////////"/>
                 </a:ext>
               </a:extLst>
             </p:cNvSpPr>
@@ -5103,7 +5103,7 @@
             <a:endCxn id="19" idx="0"/>
             <a:extLst>
               <a:ext uri="smNativeData">
-                <pr:smNativeData xmlns:pr="smNativeData" xmlns="smNativeData" val="SMDATA_15_7aDWaRMAAAAlAAAADgAAAA8BAAAAkAAAAEgAAACQAAAASAAAAAAAAAAAAAAAAAAAAAEAAABQAAAAVObRwNBxAbwAAAAAAADgPwAAAAAAAOA/AAAAAAAA4D8AAAAAAADgPwAAAAAAAOA/AAAAAAAA4D8AAAAAAADgPwAAAAAAAOA/AAAAAAAA4D8CAAAAjAAAAAAAAAAAAAAAu+DjDP///wgAAAAAAAAAAAAAAAAAAAAAAAAAAAAAAAAAAAAAZAAAAAEAAABAAAAAAAAAAAAAAAAAAAAAAAAAAAAAAAAAAAAAAAAAAAAAAAAAAAAAAAAAAAAAAAAAAAAAAAAAAAAAAAAAAAAAAAAAAAAAAAAAAAAAAAAAAAAAAAAAAAAAFAAAADwAAAABAAAAAAAAAAAAAAkUAAAAAQAAABQAAAAUAAAAFAAAAAEAAAAAAAAAZAAAAGQAAAABAAAAlgAAAJYAAAAVAAAAYAAAAAAAAAAAAAAADwAAACADAAAAAAAAAAAAAAEAAACgMgAAVgcAAKr4//8BAAAAf39/AAEAAABkAAAAAAAAABQAAABAHwAAAAAAACYAAAAAAAAAwOD//wAAAAAmAAAAZAAAABYAAABMAAAAAAAAAAAAAAAEAAAAAAAAAAEAAACAgIAKAAAAACgAAAAoAAAAZAAAAGQAAAAAAAAAzMzMAAAAAABQAAAAUAAAAGQAAABkAAAAAAAAABcAAAAUAAAAAAAAAAAAAAD/fwAA/38AAAAAAAAJAAAABAAAAAIAAAAeAAAAaAAAAAAAAAAAAAAAAAAAAAAAAAAAAAAAECcAABAnAAAAAAAAAAAAAAAAAAAAAAAAAAAAAAAAAAAAAAAAAAAAABQAAAAAAAAAwMD/AAAAAABkAAAAMgAAAAAAAABkAAAAAAAAAH9/fwAKAAAAIgAAABgAAAAAAAAAAAAAAAAAAAAAAAAAAAAAAAAAAAAkAAAAJAAAAAAAAAAHAAAAAAAAAAAAAAAAAAAAAAAAAAAAAAAAAAAAf39/ACUAAABYAAAAAAAAAAAAAAAAAAAAAAAAAAAAAAAAAAAAAAAAAAAAAAAAAAAAAAAAAAAAAAA/AAAAAAAAAKCGAQAAAAAAAAAAAAAAAAAMAAAAAQAAAAAAAAAAAAAAAAAAAB8AAABUAAAAu+DjBf///wEAAAAAAAAAAAAAAAAAAAAAAAAAAAAAAAAAAAAAAAAAAAAAAAJ/f38AgICAA8zMzADAwP8Af39/AAAAAAAAAAAAAAAAAAAAAAAAAAAAIQAAABgAAAAUAAAAUR8AAGUeAABRHwAAayAAABAAAAAmAAAACAAAAP//////////"/>
+                <pr:smNativeData xmlns:pr="smNativeData" xmlns="smNativeData" val="SMDATA_15_ZqHWaRMAAAAlAAAADgAAAA8BAAAAkAAAAEgAAACQAAAASAAAAAAAAAAAAAAAAAAAAAEAAABQAAAAVObRwNBxAbwAAAAAAADgPwAAAAAAAOA/AAAAAAAA4D8AAAAAAADgPwAAAAAAAOA/AAAAAAAA4D8AAAAAAADgPwAAAAAAAOA/AAAAAAAA4D8CAAAAjAAAAAAAAAAAAAAAu+DjDP///wgAAAAAAAAAAAAAAAAAAAAAAAAAAAAAAAAAAAAAZAAAAAEAAABAAAAAAAAAAAAAAAAAAAAAAAAAAAAAAAAAAAAAAAAAAAAAAAAAAAAAAAAAAAAAAAAAAAAAAAAAAAAAAAAAAAAAAAAAAAAAAAAAAAAAAAAAAAAAAAAAAAAAFAAAADwAAAABAAAAAAAAAAAAAAkUAAAAAQAAABQAAAAUAAAAFAAAAAEAAAAAAAAAZAAAAGQAAAABAAAAlgAAAJYAAAAVAAAAYAAAAAAAAAAAAAAADwAAACADAAAAAAAAAAAAAAEAAACgMgAAVgcAAKr4//8BAAAAf39/AAEAAABkAAAAAAAAABQAAABAHwAAAAAAACYAAAAAAAAAwOD//wAAAAAmAAAAZAAAABYAAABMAAAAAAAAAAAAAAAEAAAAAAAAAAEAAACAgIAKAAAAACgAAAAoAAAAZAAAAGQAAAAAAAAAzMzMAAAAAABQAAAAUAAAAGQAAABkAAAAAAAAABcAAAAUAAAAAAAAAAAAAAD/fwAA/38AAAAAAAAJAAAABAAAAAIAAAAeAAAAaAAAAAAAAAAAAAAAAAAAAAAAAAAAAAAAECcAABAnAAAAAAAAAAAAAAAAAAAAAAAAAAAAAAAAAAAAAAAAAAAAABQAAAAAAAAAwMD/AAAAAABkAAAAMgAAAAAAAABkAAAAAAAAAH9/fwAKAAAAIgAAABgAAAAAAAAAAAAAAAAAAAAAAAAAAAAAAAAAAAAkAAAAJAAAAAAAAAAHAAAAAAAAAAAAAAAAAAAAAAAAAAAAAAAAAAAAf39/ACUAAABYAAAAAAAAAAAAAAAAAAAAAAAAAAAAAAAAAAAAAAAAAAAAAAAAAAAAAAAAAAAAAAA/AAAAAAAAAKCGAQAAAAAAAAAAAAAAAAAMAAAAAQAAAAAAAAAAAAAAAAAAAB8AAABUAAAAu+DjBf///wEAAAAAAAAAAAAAAAAAAAAAAAAAAAAAAAAAAAAAAAAAAAAAAAJ/f38AgICAA8zMzADAwP8Af39/AAAAAAAAAAAAAAAAAAAAAAAAAAAAIQAAABgAAAAUAAAAUR8AAGUeAABRHwAAayAAABAAAAAmAAAACAAAAP//////////"/>
               </a:ext>
             </a:extLst>
           </p:cNvCxnSpPr>
@@ -5136,7 +5136,7 @@
             <a:stCxn id="17" idx="2"/>
             <a:extLst>
               <a:ext uri="smNativeData">
-                <pr:smNativeData xmlns:pr="smNativeData" xmlns="smNativeData" val="SMDATA_15_7aDWaRMAAAAlAAAADgAAAA8BAAAAkAAAAEgAAACQAAAASAAAAAAAAAAAAAAAAAAAAAEAAABQAAAAAAAAAAAAAAAAAAAAAADgPwAAAAAAAOA/AAAAAAAA4D8AAAAAAADgPwAAAAAAAOA/AAAAAAAA4D8AAAAAAADgPwAAAAAAAOA/AAAAAAAA4D8CAAAAjAAAAAAAAAAAAAAAu+DjDP///wgAAAAAAAAAAAAAAAAAAAAAAAAAAAAAAAAAAAAAZAAAAAEAAABAAAAAAAAAAAAAAAAAAAAAAAAAAAAAAAAAAAAAAAAAAAAAAAAAAAAAAAAAAAAAAAAAAAAAAAAAAAAAAAAAAAAAAAAAAAAAAAAAAAAAAAAAAAAAAAAAAAAAFAAAADwAAAABAAAAAAAAAAAAAAkUAAAAAQAAABQAAAAUAAAAFAAAAAEAAAAAAAAAZAAAAGQAAAABAAAAlgAAAJYAAAAVAAAAYAAAAAAAAAAAAAAADwAAACADAAAAAAAAAAAAAAEAAACgMgAAVgcAAKr4//8BAAAAf39/AAEAAABkAAAAAAAAABQAAABAHwAAAAAAACYAAAAAAAAAwOD//wAAAAAmAAAAZAAAABYAAABMAAAAAAAAAAAAAAAEAAAAAAAAAAEAAACAgIAKAAAAACgAAAAoAAAAZAAAAGQAAAAAAAAAzMzMAAAAAABQAAAAUAAAAGQAAABkAAAAAAAAABcAAAAUAAAAAAAAAAAAAAD/fwAA/38AAAAAAAAJAAAABAAAAAAAAAAeAAAAaAAAAAAAAAAAAAAAAAAAAAAAAAAAAAAAECcAABAnAAAAAAAAAAAAAAAAAAAAAAAAAAAAAAAAAAAAAAAAAAAAABQAAAAAAAAAwMD/AAAAAABkAAAAMgAAAAAAAABkAAAAAAAAAH9/fwAKAAAAIgAAABgAAAAAAAAAAAAAAAAAAAAAAAAAAAAAAAAAAAAkAAAAJAAAAAAAAAAHAAAAAAAAAAAAAAAAAAAAAAAAAAAAAAAAAAAAf39/ACUAAABYAAAAAAAAAAAAAAAAAAAAAAAAAAAAAAAAAAAAAAAAAAAAAAAAAAAAAAAAAAAAAAA/AAAAAAAAAKCGAQAAAAAAAAAAAAAAAAAMAAAAAQAAAAAAAAAAAAAAAAAAAB8AAABUAAAAu+DjBf///wEAAAAAAAAAAAAAAAAAAAAAAAAAAAAAAAAAAAAAAAAAAAAAAAJ/f38AgICAA8zMzADAwP8Af39/AAAAAAAAAAAAAAAAAAAAAAAAAAAAIQAAABgAAAAUAAAA1hEAAFQYAAAQFwAAkBsAABAAAAAmAAAACAAAAP//////////"/>
+                <pr:smNativeData xmlns:pr="smNativeData" xmlns="smNativeData" val="SMDATA_15_ZqHWaRMAAAAlAAAADgAAAA8BAAAAkAAAAEgAAACQAAAASAAAAAAAAAAAAAAAAAAAAAEAAABQAAAAAAAAAAAAAAAAAAAAAADgPwAAAAAAAOA/AAAAAAAA4D8AAAAAAADgPwAAAAAAAOA/AAAAAAAA4D8AAAAAAADgPwAAAAAAAOA/AAAAAAAA4D8CAAAAjAAAAAAAAAAAAAAAu+DjDP///wgAAAAAAAAAAAAAAAAAAAAAAAAAAAAAAAAAAAAAZAAAAAEAAABAAAAAAAAAAAAAAAAAAAAAAAAAAAAAAAAAAAAAAAAAAAAAAAAAAAAAAAAAAAAAAAAAAAAAAAAAAAAAAAAAAAAAAAAAAAAAAAAAAAAAAAAAAAAAAAAAAAAAFAAAADwAAAABAAAAAAAAAAAAAAkUAAAAAQAAABQAAAAUAAAAFAAAAAEAAAAAAAAAZAAAAGQAAAABAAAAlgAAAJYAAAAVAAAAYAAAAAAAAAAAAAAADwAAACADAAAAAAAAAAAAAAEAAACgMgAAVgcAAKr4//8BAAAAf39/AAEAAABkAAAAAAAAABQAAABAHwAAAAAAACYAAAAAAAAAwOD//wAAAAAmAAAAZAAAABYAAABMAAAAAAAAAAAAAAAEAAAAAAAAAAEAAACAgIAKAAAAACgAAAAoAAAAZAAAAGQAAAAAAAAAzMzMAAAAAABQAAAAUAAAAGQAAABkAAAAAAAAABcAAAAUAAAAAAAAAAAAAAD/fwAA/38AAAAAAAAJAAAABAAAAAAAAAAeAAAAaAAAAAAAAAAAAAAAAAAAAAAAAAAAAAAAECcAABAnAAAAAAAAAAAAAAAAAAAAAAAAAAAAAAAAAAAAAAAAAAAAABQAAAAAAAAAwMD/AAAAAABkAAAAMgAAAAAAAABkAAAAAAAAAH9/fwAKAAAAIgAAABgAAAAAAAAAAAAAAAAAAAAAAAAAAAAAAAAAAAAkAAAAJAAAAAAAAAAHAAAAAAAAAAAAAAAAAAAAAAAAAAAAAAAAAAAAf39/ACUAAABYAAAAAAAAAAAAAAAAAAAAAAAAAAAAAAAAAAAAAAAAAAAAAAAAAAAAAAAAAAAAAAA/AAAAAAAAAKCGAQAAAAAAAAAAAAAAAAAMAAAAAQAAAAAAAAAAAAAAAAAAAB8AAABUAAAAu+DjBf///wEAAAAAAAAAAAAAAAAAAAAAAAAAAAAAAAAAAAAAAAAAAAAAAAJ/f38AgICAA8zMzADAwP8Af39/AAAAAAAAAAAAAAAAAAAAAAAAAAAAIQAAABgAAAAUAAAA1hEAAFQYAAAQFwAAkBsAABAAAAAmAAAACAAAAP//////////"/>
               </a:ext>
             </a:extLst>
           </p:cNvCxnSpPr>
@@ -5172,7 +5172,7 @@
             <a:endCxn id="18" idx="0"/>
             <a:extLst>
               <a:ext uri="smNativeData">
-                <pr:smNativeData xmlns:pr="smNativeData" xmlns="smNativeData" val="SMDATA_15_7aDWaRMAAAAlAAAADgAAAA8BAAAAkAAAAEgAAACQAAAASAAAAAAAAAAAAAAAAAAAAAEAAABQAAAAKgs9ranT9TsAAAAAAADgPwAAAAAAAOA/AAAAAAAA4D8AAAAAAADgPwAAAAAAAOA/AAAAAAAA4D8AAAAAAADgPwAAAAAAAOA/AAAAAAAA4D8CAAAAjAAAAAAAAAAAAAAAu+DjDP///wgAAAAAAAAAAAAAAAAAAAAAAAAAAAAAAAAAAAAAZAAAAAEAAABAAAAAAAAAAAAAAAAAAAAAAAAAAAAAAAAAAAAAAAAAAAAAAAAAAAAAAAAAAAAAAAAAAAAAAAAAAAAAAAAAAAAAAAAAAAAAAAAAAAAAAAAAAAAAAAAAAAAAFAAAADwAAAABAAAAAAAAAAAAAAkUAAAAAQAAABQAAAAUAAAAFAAAAAEAAAAAAAAAZAAAAGQAAAABAAAAlgAAAJYAAAAVAAAAYAAAAAAAAAAAAAAADwAAACADAAAAAAAAAAAAAAEAAACgMgAAVgcAAKr4//8BAAAAf39/AAEAAABkAAAAAAAAABQAAABAHwAAAAAAACYAAAAAAAAAwOD//wAAAAAmAAAAZAAAABYAAABMAAAAAAAAAAAAAAAEAAAAAAAAAAEAAACAgIAKAAAAACgAAAAoAAAAZAAAAGQAAAAAAAAAzMzMAAAAAABQAAAAUAAAAGQAAABkAAAAAAAAABcAAAAUAAAAAAAAAAAAAAD/fwAA/38AAAAAAAAJAAAABAAAAAAAAAAeAAAAaAAAAAAAAAAAAAAAAAAAAAAAAAAAAAAAECcAABAnAAAAAAAAAAAAAAAAAAAAAAAAAAAAAAAAAAAAAAAAAAAAABQAAAAAAAAAwMD/AAAAAABkAAAAMgAAAAAAAABkAAAAAAAAAH9/fwAKAAAAIgAAABgAAAAAAAAAAAAAAAAAAAAAAAAAAAAAAAAAAAAkAAAAJAAAAAAAAAAHAAAAAAAAAAAAAAAAAAAAAAAAAAAAAAAAAAAAf39/ACUAAABYAAAAAAAAAAAAAAAAAAAAAAAAAAAAAAAAAAAAAAAAAAAAAAAAAAAAAAAAAAAAAAA/AAAAAAAAAKCGAQAAAAAAAAAAAAAAAAAMAAAAAQAAAAAAAAAAAAAAAAAAAB8AAABUAAAAu+DjBf///wEAAAAAAAAAAAAAAAAAAAAAAAAAAAAAAAAAAAAAAAAAAAAAAAJ/f38AgICAA8zMzADAwP8Af39/AAAAAAAAAAAAAAAAAAAAAAAAAAAAIQAAABgAAAAUAAAAEBcAAFQYAABRHwAAkBsAABAAAAAmAAAACAAAAP//////////"/>
+                <pr:smNativeData xmlns:pr="smNativeData" xmlns="smNativeData" val="SMDATA_15_ZqHWaRMAAAAlAAAADgAAAA8BAAAAkAAAAEgAAACQAAAASAAAAAAAAAAAAAAAAAAAAAEAAABQAAAAKgs9ranT9TsAAAAAAADgPwAAAAAAAOA/AAAAAAAA4D8AAAAAAADgPwAAAAAAAOA/AAAAAAAA4D8AAAAAAADgPwAAAAAAAOA/AAAAAAAA4D8CAAAAjAAAAAAAAAAAAAAAu+DjDP///wgAAAAAAAAAAAAAAAAAAAAAAAAAAAAAAAAAAAAAZAAAAAEAAABAAAAAAAAAAAAAAAAAAAAAAAAAAAAAAAAAAAAAAAAAAAAAAAAAAAAAAAAAAAAAAAAAAAAAAAAAAAAAAAAAAAAAAAAAAAAAAAAAAAAAAAAAAAAAAAAAAAAAFAAAADwAAAABAAAAAAAAAAAAAAkUAAAAAQAAABQAAAAUAAAAFAAAAAEAAAAAAAAAZAAAAGQAAAABAAAAlgAAAJYAAAAVAAAAYAAAAAAAAAAAAAAADwAAACADAAAAAAAAAAAAAAEAAACgMgAAVgcAAKr4//8BAAAAf39/AAEAAABkAAAAAAAAABQAAABAHwAAAAAAACYAAAAAAAAAwOD//wAAAAAmAAAAZAAAABYAAABMAAAAAAAAAAAAAAAEAAAAAAAAAAEAAACAgIAKAAAAACgAAAAoAAAAZAAAAGQAAAAAAAAAzMzMAAAAAABQAAAAUAAAAGQAAABkAAAAAAAAABcAAAAUAAAAAAAAAAAAAAD/fwAA/38AAAAAAAAJAAAABAAAAAAAAAAeAAAAaAAAAAAAAAAAAAAAAAAAAAAAAAAAAAAAECcAABAnAAAAAAAAAAAAAAAAAAAAAAAAAAAAAAAAAAAAAAAAAAAAABQAAAAAAAAAwMD/AAAAAABkAAAAMgAAAAAAAABkAAAAAAAAAH9/fwAKAAAAIgAAABgAAAAAAAAAAAAAAAAAAAAAAAAAAAAAAAAAAAAkAAAAJAAAAAAAAAAHAAAAAAAAAAAAAAAAAAAAAAAAAAAAAAAAAAAAf39/ACUAAABYAAAAAAAAAAAAAAAAAAAAAAAAAAAAAAAAAAAAAAAAAAAAAAAAAAAAAAAAAAAAAAA/AAAAAAAAAKCGAQAAAAAAAAAAAAAAAAAMAAAAAQAAAAAAAAAAAAAAAAAAAB8AAABUAAAAu+DjBf///wEAAAAAAAAAAAAAAAAAAAAAAAAAAAAAAAAAAAAAAAAAAAAAAAJ/f38AgICAA8zMzADAwP8Af39/AAAAAAAAAAAAAAAAAAAAAAAAAAAAIQAAABgAAAAUAAAAEBcAAFQYAABRHwAAkBsAABAAAAAmAAAACAAAAP//////////"/>
               </a:ext>
             </a:extLst>
           </p:cNvCxnSpPr>
@@ -5208,7 +5208,7 @@
             <a:endCxn id="17" idx="3"/>
             <a:extLst>
               <a:ext uri="smNativeData">
-                <pr:smNativeData xmlns:pr="smNativeData" xmlns="smNativeData" val="SMDATA_15_7aDWaRMAAAAlAAAADQAAAA8BAAAAkAAAAEgAAACQAAAASAAAAAAAAAAAAAAAAAAAAAEAAABQAAAAAAAAAAAA4D8AAAAAAADgPwAAAAAAAOA/AAAAAAAA4D8AAAAAAADgPwAAAAAAAOA/AAAAAAAA4D8AAAAAAADgPwAAAAAAAOA/AAAAAAAA4D8CAAAAjAAAAAAAAAAAAAAAu+DjDP///wgAAAAAAAAAAAAAAAAAAAAAAAAAAAAAAAAAAAAAZAAAAAEAAABAAAAAAAAAAAAAAAAAAAAAAAAAAAAAAAAAAAAAAAAAAAAAAAAAAAAAAAAAAAAAAAAAAAAAAAAAAAAAAAAAAAAAAAAAAAAAAAAAAAAAAAAAAAAAAAAAAAAAFAAAADwAAAABAAAAAAAAAAAAAAkUAAAAAQAAABQAAAAUAAAAFAAAAAEAAAAAAAAAZAAAAGQAAAABAAAAlgAAAJYAAAAVAAAAYAAAAAAAAAAAAAAADwAAACADAAAAAAAAAAAAAAEAAACgMgAAVgcAAKr4//8BAAAAf39/AAEAAABkAAAAAAAAABQAAABAHwAAAAAAACYAAAAAAAAAwOD//wAAAAAmAAAAZAAAABYAAABMAAAAAAAAAAAAAAAEAAAAAAAAAAEAAACAgIAKAAAAACgAAAAoAAAAZAAAAGQAAAAAAAAAzMzMAAAAAABQAAAAUAAAAGQAAABkAAAAAAAAABcAAAAUAAAAAAAAAAAAAAD/fwAA/38AAAAAAAAJAAAABAAAAAAAAAAeAAAAaAAAAAAAAAAAAAAAAAAAAAAAAAAAAAAAECcAABAnAAAAAAAAAAAAAAAAAAAAAAAAAAAAAAAAAAAAAAAAAAAAABQAAAAAAAAAwMD/AAAAAABkAAAAMgAAAAAAAABkAAAAAAAAAH9/fwAKAAAAIgAAABgAAAAAAAAAAAAAAAAAAAAAAAAAAAAAAAAAAAAkAAAAJAAAAAAAAAAHAAAAAAAAAAAAAAAAAAAAAAAAAAAAAAAAAAAAf39/ACUAAABYAAAAAAAAAAAAAAAAAAAAAAAAAAAAAAAAAAAAAAAAAAAAAAAAAAAAAAAAAAAAAAA/AAAAAAAAAKCGAQAAAAAAAAAAAAAAAAAMAAAAAQAAAAAAAAAAAAAAAAAAAB8AAABUAAAAu+DjBf///wEAAAAAAAAAAAAAAAAAAAAAAAAAAAAAAAAAAAAAAAAAAAAAAAJ/f38AgICAA8zMzADAwP8Af39/AAAAAAAAAAAAAAAAAAAAAAAAAAAAIQAAABgAAAAUAAAAthkAAFgWAADxIAAAWBYAABAAAAAmAAAACAAAAP//////////"/>
+                <pr:smNativeData xmlns:pr="smNativeData" xmlns="smNativeData" val="SMDATA_15_ZqHWaRMAAAAlAAAADQAAAA8BAAAAkAAAAEgAAACQAAAASAAAAAAAAAAAAAAAAAAAAAEAAABQAAAAAAAAAAAA4D8AAAAAAADgPwAAAAAAAOA/AAAAAAAA4D8AAAAAAADgPwAAAAAAAOA/AAAAAAAA4D8AAAAAAADgPwAAAAAAAOA/AAAAAAAA4D8CAAAAjAAAAAAAAAAAAAAAu+DjDP///wgAAAAAAAAAAAAAAAAAAAAAAAAAAAAAAAAAAAAAZAAAAAEAAABAAAAAAAAAAAAAAAAAAAAAAAAAAAAAAAAAAAAAAAAAAAAAAAAAAAAAAAAAAAAAAAAAAAAAAAAAAAAAAAAAAAAAAAAAAAAAAAAAAAAAAAAAAAAAAAAAAAAAFAAAADwAAAABAAAAAAAAAAAAAAkUAAAAAQAAABQAAAAUAAAAFAAAAAEAAAAAAAAAZAAAAGQAAAABAAAAlgAAAJYAAAAVAAAAYAAAAAAAAAAAAAAADwAAACADAAAAAAAAAAAAAAEAAACgMgAAVgcAAKr4//8BAAAAf39/AAEAAABkAAAAAAAAABQAAABAHwAAAAAAACYAAAAAAAAAwOD//wAAAAAmAAAAZAAAABYAAABMAAAAAAAAAAAAAAAEAAAAAAAAAAEAAACAgIAKAAAAACgAAAAoAAAAZAAAAGQAAAAAAAAAzMzMAAAAAABQAAAAUAAAAGQAAABkAAAAAAAAABcAAAAUAAAAAAAAAAAAAAD/fwAA/38AAAAAAAAJAAAABAAAAAAAAAAeAAAAaAAAAAAAAAAAAAAAAAAAAAAAAAAAAAAAECcAABAnAAAAAAAAAAAAAAAAAAAAAAAAAAAAAAAAAAAAAAAAAAAAABQAAAAAAAAAwMD/AAAAAABkAAAAMgAAAAAAAABkAAAAAAAAAH9/fwAKAAAAIgAAABgAAAAAAAAAAAAAAAAAAAAAAAAAAAAAAAAAAAAkAAAAJAAAAAAAAAAHAAAAAAAAAAAAAAAAAAAAAAAAAAAAAAAAAAAAf39/ACUAAABYAAAAAAAAAAAAAAAAAAAAAAAAAAAAAAAAAAAAAAAAAAAAAAAAAAAAAAAAAAAAAAA/AAAAAAAAAKCGAQAAAAAAAAAAAAAAAAAMAAAAAQAAAAAAAAAAAAAAAAAAAB8AAABUAAAAu+DjBf///wEAAAAAAAAAAAAAAAAAAAAAAAAAAAAAAAAAAAAAAAAAAAAAAAJ/f38AgICAA8zMzADAwP8Af39/AAAAAAAAAAAAAAAAAAAAAAAAAAAAIQAAABgAAAAUAAAAthkAAFgWAADxIAAAWBYAABAAAAAmAAAACAAAAP//////////"/>
               </a:ext>
             </a:extLst>
           </p:cNvCxnSpPr>
@@ -5242,7 +5242,7 @@
             <a:endCxn id="11" idx="1"/>
             <a:extLst>
               <a:ext uri="smNativeData">
-                <pr:smNativeData xmlns:pr="smNativeData" xmlns="smNativeData" val="SMDATA_15_7aDWaRMAAAAlAAAADQAAAA8BAAAAkAAAAEgAAACQAAAASAAAAAAAAAAAAAAAAAAAAAEAAABQAAAAAAAAAAAA4D8AAAAAAADgPwAAAAAAAOA/AAAAAAAA4D8AAAAAAADgPwAAAAAAAOA/AAAAAAAA4D8AAAAAAADgPwAAAAAAAOA/AAAAAAAA4D8CAAAAjAAAAAAAAAAAAAAAu+DjDP///wgAAAAAAAAAAAAAAAAAAAAAAAAAAAAAAAAAAAAAZAAAAAEAAABAAAAAAAAAAAAAAAAAAAAAAAAAAAAAAAAAAAAAAAAAAAAAAAAAAAAAAAAAAAAAAAAAAAAAAAAAAAAAAAAAAAAAAAAAAAAAAAAAAAAAAAAAAAAAAAAAAAAAFAAAADwAAAABAAAAAAAAAAAAAAkUAAAAAQAAABQAAAAUAAAAFAAAAAEAAAAAAAAAZAAAAGQAAAABAAAAlgAAAJYAAAAVAAAAYAAAAAAAAAAAAAAADwAAACADAAAAAAAAAAAAAAEAAACgMgAAVgcAAKr4//8BAAAAf39/AAEAAABkAAAAAAAAABQAAABAHwAAAAAAACYAAAAAAAAAwOD//wAAAAAmAAAAZAAAABYAAABMAAAAAAAAAAAAAAAEAAAAAAAAAAEAAACAgIAKAAAAACgAAAAoAAAAZAAAAGQAAAAAAAAAzMzMAAAAAABQAAAAUAAAAGQAAABkAAAAAAAAABcAAAAUAAAAAAAAAAAAAAD/fwAA/38AAAAAAAAJAAAABAAAAAAAAAAeAAAAaAAAAAAAAAAAAAAAAAAAAAAAAAAAAAAAECcAABAnAAAAAAAAAAAAAAAAAAAAAAAAAAAAAAAAAAAAAAAAAAAAABQAAAAAAAAAwMD/AAAAAABkAAAAMgAAAAAAAABkAAAAAAAAAH9/fwAKAAAAIgAAABgAAAAAAAAAAAAAAAAAAAAAAAAAAAAAAAAAAAAkAAAAJAAAAAAAAAAHAAAAAAAAAAAAAAAAAAAAAAAAAAAAAAAAAAAAf39/ACUAAABYAAAAAAAAAAAAAAAAAAAAAAAAAAAAAAAAAAAAAAAAAAAAAAAAAAAAAAAAAAAAAAA/AAAAAAAAAKCGAQAAAAAAAAAAAAAAAAAMAAAAAQAAAAAAAAAAAAAAAAAAAB8AAABUAAAAu+DjBf///wEAAAAAAAAAAAAAAAAAAAAAAAAAAAAAAAAAAAAAAAAAAAAAAAJ/f38AgICAA8zMzADAwP8Af39/AAAAAAAAAAAAAAAAAAAAAAAAAAAAIQAAABgAAAAUAAAAGCsAAFgWAABGMQAAWBYAABAAAAAmAAAACAAAAP//////////"/>
+                <pr:smNativeData xmlns:pr="smNativeData" xmlns="smNativeData" val="SMDATA_15_ZqHWaRMAAAAlAAAADQAAAA8BAAAAkAAAAEgAAACQAAAASAAAAAAAAAAAAAAAAAAAAAEAAABQAAAAAAAAAAAA4D8AAAAAAADgPwAAAAAAAOA/AAAAAAAA4D8AAAAAAADgPwAAAAAAAOA/AAAAAAAA4D8AAAAAAADgPwAAAAAAAOA/AAAAAAAA4D8CAAAAjAAAAAAAAAAAAAAAu+DjDP///wgAAAAAAAAAAAAAAAAAAAAAAAAAAAAAAAAAAAAAZAAAAAEAAABAAAAAAAAAAAAAAAAAAAAAAAAAAAAAAAAAAAAAAAAAAAAAAAAAAAAAAAAAAAAAAAAAAAAAAAAAAAAAAAAAAAAAAAAAAAAAAAAAAAAAAAAAAAAAAAAAAAAAFAAAADwAAAABAAAAAAAAAAAAAAkUAAAAAQAAABQAAAAUAAAAFAAAAAEAAAAAAAAAZAAAAGQAAAABAAAAlgAAAJYAAAAVAAAAYAAAAAAAAAAAAAAADwAAACADAAAAAAAAAAAAAAEAAACgMgAAVgcAAKr4//8BAAAAf39/AAEAAABkAAAAAAAAABQAAABAHwAAAAAAACYAAAAAAAAAwOD//wAAAAAmAAAAZAAAABYAAABMAAAAAAAAAAAAAAAEAAAAAAAAAAEAAACAgIAKAAAAACgAAAAoAAAAZAAAAGQAAAAAAAAAzMzMAAAAAABQAAAAUAAAAGQAAABkAAAAAAAAABcAAAAUAAAAAAAAAAAAAAD/fwAA/38AAAAAAAAJAAAABAAAAAAAAAAeAAAAaAAAAAAAAAAAAAAAAAAAAAAAAAAAAAAAECcAABAnAAAAAAAAAAAAAAAAAAAAAAAAAAAAAAAAAAAAAAAAAAAAABQAAAAAAAAAwMD/AAAAAABkAAAAMgAAAAAAAABkAAAAAAAAAH9/fwAKAAAAIgAAABgAAAAAAAAAAAAAAAAAAAAAAAAAAAAAAAAAAAAkAAAAJAAAAAAAAAAHAAAAAAAAAAAAAAAAAAAAAAAAAAAAAAAAAAAAf39/ACUAAABYAAAAAAAAAAAAAAAAAAAAAAAAAAAAAAAAAAAAAAAAAAAAAAAAAAAAAAAAAAAAAAA/AAAAAAAAAKCGAQAAAAAAAAAAAAAAAAAMAAAAAQAAAAAAAAAAAAAAAAAAAB8AAABUAAAAu+DjBf///wEAAAAAAAAAAAAAAAAAAAAAAAAAAAAAAAAAAAAAAAAAAAAAAAJ/f38AgICAA8zMzADAwP8Af39/AAAAAAAAAAAAAAAAAAAAAAAAAAAAIQAAABgAAAAUAAAAGCsAAFgWAABGMQAAWBYAABAAAAAmAAAACAAAAP//////////"/>
               </a:ext>
             </a:extLst>
           </p:cNvCxnSpPr>
@@ -5275,7 +5275,7 @@
             <a:stCxn id="11" idx="2"/>
             <a:extLst>
               <a:ext uri="smNativeData">
-                <pr:smNativeData xmlns:pr="smNativeData" xmlns="smNativeData" val="SMDATA_15_7aDWaRMAAAAlAAAADgAAAA8BAAAAkAAAAEgAAACQAAAASAAAAAAAAAAAAAAAAAAAAAEAAABQAAAAIlGJdd5YUr8AAAAAAADgPwAAAAAAAOA/AAAAAAAA4D8AAAAAAADgPwAAAAAAAOA/AAAAAAAA4D8AAAAAAADgPwAAAAAAAOA/AAAAAAAA4D8CAAAAjAAAAAAAAAAAAAAAu+DjDP///wgAAAAAAAAAAAAAAAAAAAAAAAAAAAAAAAAAAAAAZAAAAAEAAABAAAAAAAAAAAAAAAAAAAAAAAAAAAAAAAAAAAAAAAAAAAAAAAAAAAAAAAAAAAAAAAAAAAAAAAAAAAAAAAAAAAAAAAAAAAAAAAAAAAAAAAAAAAAAAAAAAAAAFAAAADwAAAABAAAAAAAAAAAAAAkUAAAAAQAAABQAAAAUAAAAFAAAAAEAAAAAAAAAZAAAAGQAAAABAAAAlgAAAJYAAAAVAAAAYAAAAAAAAAAAAAAADwAAACADAAAAAAAAAAAAAAEAAACgMgAAVgcAAKr4//8BAAAAf39/AAEAAABkAAAAAAAAABQAAABAHwAAAAAAACYAAAAAAAAAwOD//wAAAAAmAAAAZAAAABYAAABMAAAAAAAAAAAAAAAEAAAAAAAAAAEAAACAgIAKAAAAACgAAAAoAAAAZAAAAGQAAAAAAAAAzMzMAAAAAABQAAAAUAAAAGQAAABkAAAAAAAAABcAAAAUAAAAAAAAAAAAAAD/fwAA/38AAAAAAAAJAAAABAAAAAAAAAAeAAAAaAAAAAAAAAAAAAAAAAAAAAAAAAAAAAAAECcAABAnAAAAAAAAAAAAAAAAAAAAAAAAAAAAAAAAAAAAAAAAAAAAABQAAAAAAAAAwMD/AAAAAABkAAAAMgAAAAAAAABkAAAAAAAAAH9/fwAKAAAAIgAAABgAAAAAAAAAAAAAAAAAAAAAAAAAAAAAAAAAAAAkAAAAJAAAAAAAAAAHAAAAAAAAAAAAAAAAAAAAAAAAAAAAAAAAAAAAf39/ACUAAABYAAAAAAAAAAAAAAAAAAAAAAAAAAAAAAAAAAAAAAAAAAAAAAAAAAAAAAAAAAAAAAA/AAAAAAAAAKCGAQAAAAAAAAAAAAAAAAAMAAAAAQAAAAAAAAAAAAAAAAAAAB8AAABUAAAAu+DjBf///wEAAAAAAAAAAAAAAAAAAAAAAAAAAAAAAAAAAAAAAAAAAAAAAAJ/f38AgICAA8zMzADAwP8Af39/AAAAAAAAAAAAAAAAAAAAAAAAAAAAIQAAABgAAAAUAAAASSwAAFQYAADsMwAA0RsAABAAAAAmAAAACAAAAP//////////"/>
+                <pr:smNativeData xmlns:pr="smNativeData" xmlns="smNativeData" val="SMDATA_15_ZqHWaRMAAAAlAAAADgAAAA8BAAAAkAAAAEgAAACQAAAASAAAAAAAAAAAAAAAAAAAAAEAAABQAAAAIlGJdd5YUr8AAAAAAADgPwAAAAAAAOA/AAAAAAAA4D8AAAAAAADgPwAAAAAAAOA/AAAAAAAA4D8AAAAAAADgPwAAAAAAAOA/AAAAAAAA4D8CAAAAjAAAAAAAAAAAAAAAu+DjDP///wgAAAAAAAAAAAAAAAAAAAAAAAAAAAAAAAAAAAAAZAAAAAEAAABAAAAAAAAAAAAAAAAAAAAAAAAAAAAAAAAAAAAAAAAAAAAAAAAAAAAAAAAAAAAAAAAAAAAAAAAAAAAAAAAAAAAAAAAAAAAAAAAAAAAAAAAAAAAAAAAAAAAAFAAAADwAAAABAAAAAAAAAAAAAAkUAAAAAQAAABQAAAAUAAAAFAAAAAEAAAAAAAAAZAAAAGQAAAABAAAAlgAAAJYAAAAVAAAAYAAAAAAAAAAAAAAADwAAACADAAAAAAAAAAAAAAEAAACgMgAAVgcAAKr4//8BAAAAf39/AAEAAABkAAAAAAAAABQAAABAHwAAAAAAACYAAAAAAAAAwOD//wAAAAAmAAAAZAAAABYAAABMAAAAAAAAAAAAAAAEAAAAAAAAAAEAAACAgIAKAAAAACgAAAAoAAAAZAAAAGQAAAAAAAAAzMzMAAAAAABQAAAAUAAAAGQAAABkAAAAAAAAABcAAAAUAAAAAAAAAAAAAAD/fwAA/38AAAAAAAAJAAAABAAAAAAAAAAeAAAAaAAAAAAAAAAAAAAAAAAAAAAAAAAAAAAAECcAABAnAAAAAAAAAAAAAAAAAAAAAAAAAAAAAAAAAAAAAAAAAAAAABQAAAAAAAAAwMD/AAAAAABkAAAAMgAAAAAAAABkAAAAAAAAAH9/fwAKAAAAIgAAABgAAAAAAAAAAAAAAAAAAAAAAAAAAAAAAAAAAAAkAAAAJAAAAAAAAAAHAAAAAAAAAAAAAAAAAAAAAAAAAAAAAAAAAAAAf39/ACUAAABYAAAAAAAAAAAAAAAAAAAAAAAAAAAAAAAAAAAAAAAAAAAAAAAAAAAAAAAAAAAAAAA/AAAAAAAAAKCGAQAAAAAAAAAAAAAAAAAMAAAAAQAAAAAAAAAAAAAAAAAAAB8AAABUAAAAu+DjBf///wEAAAAAAAAAAAAAAAAAAAAAAAAAAAAAAAAAAAAAAAAAAAAAAAJ/f38AgICAA8zMzADAwP8Af39/AAAAAAAAAAAAAAAAAAAAAAAAAAAAIQAAABgAAAAUAAAASSwAAFQYAADsMwAA0RsAABAAAAAmAAAACAAAAP//////////"/>
               </a:ext>
             </a:extLst>
           </p:cNvCxnSpPr>
@@ -5311,7 +5311,7 @@
             <a:endCxn id="15" idx="0"/>
             <a:extLst>
               <a:ext uri="smNativeData">
-                <pr:smNativeData xmlns:pr="smNativeData" xmlns="smNativeData" val="SMDATA_15_7aDWaRMAAAAlAAAADgAAAA8BAAAAkAAAAEgAAACQAAAASAAAAAAAAAAAAAAAAAAAAAEAAABQAAAAIFGJdd5YUr8AAAAAAADgPwAAAAAAAOA/AAAAAAAA4D8AAAAAAADgPwAAAAAAAOA/AAAAAAAA4D8AAAAAAADgPwAAAAAAAOA/AAAAAAAA4D8CAAAAjAAAAAAAAAAAAAAAu+DjDP///wgAAAAAAAAAAAAAAAAAAAAAAAAAAAAAAAAAAAAAZAAAAAEAAABAAAAAAAAAAAAAAAAAAAAAAAAAAAAAAAAAAAAAAAAAAAAAAAAAAAAAAAAAAAAAAAAAAAAAAAAAAAAAAAAAAAAAAAAAAAAAAAAAAAAAAAAAAAAAAAAAAAAAFAAAADwAAAABAAAAAAAAAAAAAAkUAAAAAQAAABQAAAAUAAAAFAAAAAEAAAAAAAAAZAAAAGQAAAABAAAAlgAAAJYAAAAVAAAAYAAAAAAAAAAAAAAADwAAACADAAAAAAAAAAAAAAEAAACgMgAAVgcAAKr4//8BAAAAf39/AAEAAABkAAAAAAAAABQAAABAHwAAAAAAACYAAAAAAAAAwOD//wAAAAAmAAAAZAAAABYAAABMAAAAAAAAAAAAAAAEAAAAAAAAAAEAAACAgIAKAAAAACgAAAAoAAAAZAAAAGQAAAAAAAAAzMzMAAAAAABQAAAAUAAAAGQAAABkAAAAAAAAABcAAAAUAAAAAAAAAAAAAAD/fwAA/38AAAAAAAAJAAAABAAAAAAAAAAeAAAAaAAAAAAAAAAAAAAAAAAAAAAAAAAAAAAAECcAABAnAAAAAAAAAAAAAAAAAAAAAAAAAAAAAAAAAAAAAAAAAAAAABQAAAAAAAAAwMD/AAAAAABkAAAAMgAAAAAAAABkAAAAAAAAAH9/fwAKAAAAIgAAABgAAAAAAAAAAAAAAAAAAAAAAAAAAAAAAAAAAAAkAAAAJAAAAAAAAAAHAAAAAAAAAAAAAAAAAAAAAAAAAAAAAAAAAAAAf39/ACUAAABYAAAAAAAAAAAAAAAAAAAAAAAAAAAAAAAAAAAAAAAAAAAAAAAAAAAAAAAAAAAAAAA/AAAAAAAAAKCGAQAAAAAAAAAAAAAAAAAMAAAAAQAAAAAAAAAAAAAAAAAAAB8AAABUAAAAu+DjBf///wEAAAAAAAAAAAAAAAAAAAAAAAAAAAAAAAAAAAAAAAAAAAAAAAJ/f38AgICAA8zMzADAwP8Af39/AAAAAAAAAAAAAAAAAAAAAAAAAAAAIQAAABgAAAAUAAAA7DMAAFQYAACjOwAA0RsAABAAAAAmAAAACAAAAP//////////"/>
+                <pr:smNativeData xmlns:pr="smNativeData" xmlns="smNativeData" val="SMDATA_15_ZqHWaRMAAAAlAAAADgAAAA8BAAAAkAAAAEgAAACQAAAASAAAAAAAAAAAAAAAAAAAAAEAAABQAAAAIFGJdd5YUr8AAAAAAADgPwAAAAAAAOA/AAAAAAAA4D8AAAAAAADgPwAAAAAAAOA/AAAAAAAA4D8AAAAAAADgPwAAAAAAAOA/AAAAAAAA4D8CAAAAjAAAAAAAAAAAAAAAu+DjDP///wgAAAAAAAAAAAAAAAAAAAAAAAAAAAAAAAAAAAAAZAAAAAEAAABAAAAAAAAAAAAAAAAAAAAAAAAAAAAAAAAAAAAAAAAAAAAAAAAAAAAAAAAAAAAAAAAAAAAAAAAAAAAAAAAAAAAAAAAAAAAAAAAAAAAAAAAAAAAAAAAAAAAAFAAAADwAAAABAAAAAAAAAAAAAAkUAAAAAQAAABQAAAAUAAAAFAAAAAEAAAAAAAAAZAAAAGQAAAABAAAAlgAAAJYAAAAVAAAAYAAAAAAAAAAAAAAADwAAACADAAAAAAAAAAAAAAEAAACgMgAAVgcAAKr4//8BAAAAf39/AAEAAABkAAAAAAAAABQAAABAHwAAAAAAACYAAAAAAAAAwOD//wAAAAAmAAAAZAAAABYAAABMAAAAAAAAAAAAAAAEAAAAAAAAAAEAAACAgIAKAAAAACgAAAAoAAAAZAAAAGQAAAAAAAAAzMzMAAAAAABQAAAAUAAAAGQAAABkAAAAAAAAABcAAAAUAAAAAAAAAAAAAAD/fwAA/38AAAAAAAAJAAAABAAAAAAAAAAeAAAAaAAAAAAAAAAAAAAAAAAAAAAAAAAAAAAAECcAABAnAAAAAAAAAAAAAAAAAAAAAAAAAAAAAAAAAAAAAAAAAAAAABQAAAAAAAAAwMD/AAAAAABkAAAAMgAAAAAAAABkAAAAAAAAAH9/fwAKAAAAIgAAABgAAAAAAAAAAAAAAAAAAAAAAAAAAAAAAAAAAAAkAAAAJAAAAAAAAAAHAAAAAAAAAAAAAAAAAAAAAAAAAAAAAAAAAAAAf39/ACUAAABYAAAAAAAAAAAAAAAAAAAAAAAAAAAAAAAAAAAAAAAAAAAAAAAAAAAAAAAAAAAAAAA/AAAAAAAAAKCGAQAAAAAAAAAAAAAAAAAMAAAAAQAAAAAAAAAAAAAAAAAAAB8AAABUAAAAu+DjBf///wEAAAAAAAAAAAAAAAAAAAAAAAAAAAAAAAAAAAAAAAAAAAAAAAJ/f38AgICAA8zMzADAwP8Af39/AAAAAAAAAAAAAAAAAAAAAAAAAAAAIQAAABgAAAAUAAAA7DMAAFQYAACjOwAA0RsAABAAAAAmAAAACAAAAP//////////"/>
               </a:ext>
             </a:extLst>
           </p:cNvCxnSpPr>
@@ -5347,7 +5347,7 @@
             <a:endCxn id="16" idx="0"/>
             <a:extLst>
               <a:ext uri="smNativeData">
-                <pr:smNativeData xmlns:pr="smNativeData" xmlns="smNativeData" val="SMDATA_15_7aDWaRMAAAAlAAAADQAAAA8BAAAAkAAAAEgAAACQAAAASAAAAAAAAAAAAAAAAAAAAAEAAABQAAAAU01UIIFqDDwAAAAAAADgPwAAAAAAAOA/AAAAAAAA4D8AAAAAAADgPwAAAAAAAOA/AAAAAAAA4D8AAAAAAADgPwAAAAAAAOA/AAAAAAAA4D8CAAAAjAAAAAAAAAAAAAAAu+DjDP///wgAAAAAAAAAAAAAAAAAAAAAAAAAAAAAAAAAAAAAZAAAAAEAAABAAAAAAAAAAAAAAAAAAAAAAAAAAAAAAAAAAAAAAAAAAAAAAAAAAAAAAAAAAAAAAAAAAAAAAAAAAAAAAAAAAAAAAAAAAAAAAAAAAAAAAAAAAAAAAAAAAAAAFAAAADwAAAABAAAAAAAAAAAAAAkUAAAAAQAAABQAAAAUAAAAFAAAAAEAAAAAAAAAZAAAAGQAAAABAAAAlgAAAJYAAAAVAAAAYAAAAAAAAAAAAAAADwAAACADAAAAAAAAAAAAAAEAAACgMgAAVgcAAKr4//8BAAAAf39/AAEAAABkAAAAAAAAABQAAABAHwAAAAAAACYAAAAAAAAAwOD//wAAAAAmAAAAZAAAABYAAABMAAAAAAAAAAAAAAAEAAAAAAAAAAEAAACAgIAKAAAAACgAAAAoAAAAZAAAAGQAAAAAAAAAzMzMAAAAAABQAAAAUAAAAGQAAABkAAAAAAAAABcAAAAUAAAAAAAAAAAAAAD/fwAA/38AAAAAAAAJAAAABAAAAAAAAAAeAAAAaAAAAAAAAAAAAAAAAAAAAAAAAAAAAAAAECcAABAnAAAAAAAAAAAAAAAAAAAAAAAAAAAAAAAAAAAAAAAAAAAAABQAAAAAAAAAwMD/AAAAAABkAAAAMgAAAAAAAABkAAAAAAAAAH9/fwAKAAAAIgAAABgAAAAAAAAAAAAAAAAAAAAAAAAAAAAAAAAAAAAkAAAAJAAAAAAAAAAHAAAAAAAAAAAAAAAAAAAAAAAAAAAAAAAAAAAAf39/ACUAAABYAAAAAAAAAAAAAAAAAAAAAAAAAAAAAAAAAAAAAAAAAAAAAAAAAAAAAAAAAAAAAAA/AAAAAAAAAKCGAQAAAAAAAAAAAAAAAAAMAAAAAQAAAAAAAAAAAAAAAAAAAB8AAABUAAAAu+DjBf///wEAAAAAAAAAAAAAAAAAAAAAAAAAAAAAAAAAAAAAAAAAAAAAAAJ/f38AgICAA8zMzADAwP8Af39/AAAAAAAAAAAAAAAAAAAAAAAAAAAAIQAAABgAAAAUAAAAozsAAKYeAACjOwAAfCAAABAAAAAmAAAACAAAAP//////////"/>
+                <pr:smNativeData xmlns:pr="smNativeData" xmlns="smNativeData" val="SMDATA_15_ZqHWaRMAAAAlAAAADQAAAA8BAAAAkAAAAEgAAACQAAAASAAAAAAAAAAAAAAAAAAAAAEAAABQAAAAU01UIIFqDDwAAAAAAADgPwAAAAAAAOA/AAAAAAAA4D8AAAAAAADgPwAAAAAAAOA/AAAAAAAA4D8AAAAAAADgPwAAAAAAAOA/AAAAAAAA4D8CAAAAjAAAAAAAAAAAAAAAu+DjDP///wgAAAAAAAAAAAAAAAAAAAAAAAAAAAAAAAAAAAAAZAAAAAEAAABAAAAAAAAAAAAAAAAAAAAAAAAAAAAAAAAAAAAAAAAAAAAAAAAAAAAAAAAAAAAAAAAAAAAAAAAAAAAAAAAAAAAAAAAAAAAAAAAAAAAAAAAAAAAAAAAAAAAAFAAAADwAAAABAAAAAAAAAAAAAAkUAAAAAQAAABQAAAAUAAAAFAAAAAEAAAAAAAAAZAAAAGQAAAABAAAAlgAAAJYAAAAVAAAAYAAAAAAAAAAAAAAADwAAACADAAAAAAAAAAAAAAEAAACgMgAAVgcAAKr4//8BAAAAf39/AAEAAABkAAAAAAAAABQAAABAHwAAAAAAACYAAAAAAAAAwOD//wAAAAAmAAAAZAAAABYAAABMAAAAAAAAAAAAAAAEAAAAAAAAAAEAAACAgIAKAAAAACgAAAAoAAAAZAAAAGQAAAAAAAAAzMzMAAAAAABQAAAAUAAAAGQAAABkAAAAAAAAABcAAAAUAAAAAAAAAAAAAAD/fwAA/38AAAAAAAAJAAAABAAAAAAAAAAeAAAAaAAAAAAAAAAAAAAAAAAAAAAAAAAAAAAAECcAABAnAAAAAAAAAAAAAAAAAAAAAAAAAAAAAAAAAAAAAAAAAAAAABQAAAAAAAAAwMD/AAAAAABkAAAAMgAAAAAAAABkAAAAAAAAAH9/fwAKAAAAIgAAABgAAAAAAAAAAAAAAAAAAAAAAAAAAAAAAAAAAAAkAAAAJAAAAAAAAAAHAAAAAAAAAAAAAAAAAAAAAAAAAAAAAAAAAAAAf39/ACUAAABYAAAAAAAAAAAAAAAAAAAAAAAAAAAAAAAAAAAAAAAAAAAAAAAAAAAAAAAAAAAAAAA/AAAAAAAAAKCGAQAAAAAAAAAAAAAAAAAMAAAAAQAAAAAAAAAAAAAAAAAAAB8AAABUAAAAu+DjBf///wEAAAAAAAAAAAAAAAAAAAAAAAAAAAAAAAAAAAAAAAAAAAAAAAJ/f38AgICAA8zMzADAwP8Af39/AAAAAAAAAAAAAAAAAAAAAAAAAAAAIQAAABgAAAAUAAAAozsAAKYeAACjOwAAfCAAABAAAAAmAAAACAAAAP//////////"/>
               </a:ext>
             </a:extLst>
           </p:cNvCxnSpPr>
@@ -5381,7 +5381,7 @@
             <a:endCxn id="7" idx="0"/>
             <a:extLst>
               <a:ext uri="smNativeData">
-                <pr:smNativeData xmlns:pr="smNativeData" xmlns="smNativeData" val="SMDATA_15_7aDWaRMAAAAlAAAADgAAAA8BAAAAkAAAAEgAAACQAAAASAAAAAAAAAAAAAAAAAAAAAEAAABQAAAA9uN+f2jSSb8AAAAAAADgPwAAAAAAAOA/AAAAAAAA4D8AAAAAAADgPwAAAAAAAOA/AAAAAAAA4D8AAAAAAADgPwAAAAAAAOA/AAAAAAAA4D8CAAAAjAAAAAAAAAAAAAAAu+DjDP///wgAAAAAAAAAAAAAAAAAAAAAAAAAAAAAAAAAAAAAZAAAAAEAAABAAAAAAAAAAAAAAAAAAAAAAAAAAAAAAAAAAAAAAAAAAAAAAAAAAAAAAAAAAAAAAAAAAAAAAAAAAAAAAAAAAAAAAAAAAAAAAAAAAAAAAAAAAAAAAAAAAAAAFAAAADwAAAABAAAAAAAAAAAAAAkUAAAAAQAAABQAAAAUAAAAFAAAAAEAAAAAAAAAZAAAAGQAAAABAAAAlgAAAJYAAAAVAAAAYAAAAAAAAAAAAAAADwAAACADAAAAAAAAAAAAAAEAAACgMgAAVgcAAKr4//8BAAAAf39/AAEAAABkAAAAAAAAABQAAABAHwAAAAAAACYAAAAAAAAAwOD//wAAAAAmAAAAZAAAABYAAABMAAAAAAAAAAAAAAAEAAAAAAAAAAEAAACAgIAKAAAAACgAAAAoAAAAZAAAAGQAAAAAAAAAzMzMAAAAAABQAAAAUAAAAGQAAABkAAAAAAAAABcAAAAUAAAAAAAAAAAAAAD/fwAA/38AAAAAAAAJAAAABAAAAAIAAAAeAAAAaAAAAAAAAAAAAAAAAAAAAAAAAAAAAAAAECcAABAnAAAAAAAAAAAAAAAAAAAAAAAAAAAAAAAAAAAAAAAAAAAAABQAAAAAAAAAwMD/AAAAAABkAAAAMgAAAAAAAABkAAAAAAAAAH9/fwAKAAAAIgAAABgAAAAAAAAAAAAAAAAAAAAAAAAAAAAAAAAAAAAkAAAAJAAAAAAAAAAHAAAAAAAAAAAAAAAAAAAAAAAAAAAAAAAAAAAAf39/ACUAAABYAAAAAAAAAAAAAAAAAAAAAAAAAAAAAAAAAAAAAAAAAAAAAAAAAAAAAAAAAAAAAAA/AAAAAAAAAKCGAQAAAAAAAAAAAAAAAAAMAAAAAQAAAAAAAAAAAAAAAAAAAB8AAABUAAAAu+DjBf///wEAAAAAAAAAAAAAAAAAAAAAAAAAAAAAAAAAAAAAAAAAAAAAAAJ/f38AgICAA8zMzADAwP8Af39/AAAAAAAAAAAAAAAAAAAAAAAAAAAAIQAAABgAAAAUAAAABCYAAPYQAAAEJgAAWxQAABAAAAAmAAAACAAAAP//////////"/>
+                <pr:smNativeData xmlns:pr="smNativeData" xmlns="smNativeData" val="SMDATA_15_ZqHWaRMAAAAlAAAADgAAAA8BAAAAkAAAAEgAAACQAAAASAAAAAAAAAAAAAAAAAAAAAEAAABQAAAA9uN+f2jSSb8AAAAAAADgPwAAAAAAAOA/AAAAAAAA4D8AAAAAAADgPwAAAAAAAOA/AAAAAAAA4D8AAAAAAADgPwAAAAAAAOA/AAAAAAAA4D8CAAAAjAAAAAAAAAAAAAAAu+DjDP///wgAAAAAAAAAAAAAAAAAAAAAAAAAAAAAAAAAAAAAZAAAAAEAAABAAAAAAAAAAAAAAAAAAAAAAAAAAAAAAAAAAAAAAAAAAAAAAAAAAAAAAAAAAAAAAAAAAAAAAAAAAAAAAAAAAAAAAAAAAAAAAAAAAAAAAAAAAAAAAAAAAAAAFAAAADwAAAABAAAAAAAAAAAAAAkUAAAAAQAAABQAAAAUAAAAFAAAAAEAAAAAAAAAZAAAAGQAAAABAAAAlgAAAJYAAAAVAAAAYAAAAAAAAAAAAAAADwAAACADAAAAAAAAAAAAAAEAAACgMgAAVgcAAKr4//8BAAAAf39/AAEAAABkAAAAAAAAABQAAABAHwAAAAAAACYAAAAAAAAAwOD//wAAAAAmAAAAZAAAABYAAABMAAAAAAAAAAAAAAAEAAAAAAAAAAEAAACAgIAKAAAAACgAAAAoAAAAZAAAAGQAAAAAAAAAzMzMAAAAAABQAAAAUAAAAGQAAABkAAAAAAAAABcAAAAUAAAAAAAAAAAAAAD/fwAA/38AAAAAAAAJAAAABAAAAAIAAAAeAAAAaAAAAAAAAAAAAAAAAAAAAAAAAAAAAAAAECcAABAnAAAAAAAAAAAAAAAAAAAAAAAAAAAAAAAAAAAAAAAAAAAAABQAAAAAAAAAwMD/AAAAAABkAAAAMgAAAAAAAABkAAAAAAAAAH9/fwAKAAAAIgAAABgAAAAAAAAAAAAAAAAAAAAAAAAAAAAAAAAAAAAkAAAAJAAAAAAAAAAHAAAAAAAAAAAAAAAAAAAAAAAAAAAAAAAAAAAAf39/ACUAAABYAAAAAAAAAAAAAAAAAAAAAAAAAAAAAAAAAAAAAAAAAAAAAAAAAAAAAAAAAAAAAAA/AAAAAAAAAKCGAQAAAAAAAAAAAAAAAAAMAAAAAQAAAAAAAAAAAAAAAAAAAB8AAABUAAAAu+DjBf///wEAAAAAAAAAAAAAAAAAAAAAAAAAAAAAAAAAAAAAAAAAAAAAAAJ/f38AgICAA8zMzADAwP8Af39/AAAAAAAAAAAAAAAAAAAAAAAAAAAAIQAAABgAAAAUAAAABCYAAPYQAAAEJgAAWxQAABAAAAAmAAAACAAAAP//////////"/>
               </a:ext>
             </a:extLst>
           </p:cNvCxnSpPr>
@@ -5415,7 +5415,7 @@
             <a:endCxn id="10" idx="1"/>
             <a:extLst>
               <a:ext uri="smNativeData">
-                <pr:smNativeData xmlns:pr="smNativeData" xmlns="smNativeData" val="SMDATA_15_7aDWaRMAAAAlAAAADgAAAA8BAAAAkAAAAEgAAACQAAAASAAAAAAAAAAAAAAAAAAAAAEAAABQAAAAAAAAAAAAAAAAAAAAAADgPwAAAAAAAOA/AAAAAAAA4D8AAAAAAADgPwAAAAAAAOA/AAAAAAAA4D8AAAAAAADgPwAAAAAAAOA/AAAAAAAA4D8CAAAAjAAAAAAAAAAAAAAAu+DjDP///wgAAAAAAAAAAAAAAAAAAAAAAAAAAAAAAAAAAAAAZAAAAAEAAABAAAAAAAAAAAAAAAAAAAAAAAAAAAAAAAAAAAAAAAAAAAAAAAAAAAAAAAAAAAAAAAAAAAAAAAAAAAAAAAAAAAAAAAAAAAAAAAAAAAAAAAAAAAAAAAAAAAAAFAAAADwAAAABAAAAAAAAAAAAAAkUAAAAAQAAABQAAAAUAAAAFAAAAAEAAAAAAAAAZAAAAGQAAAABAAAAlgAAAJYAAAAVAAAAYAAAAAAAAAAAAAAADwAAACADAAAAAAAAAAAAAAEAAACgMgAAVgcAAKr4//8BAAAAf39/AAEAAABkAAAAAAAAABQAAABAHwAAAAAAACYAAAAAAAAAwOD//wAAAAAmAAAAZAAAABYAAABMAAAAAAAAAAAAAAAEAAAAAAAAAAEAAACAgIAKAAAAACgAAAAoAAAAZAAAAGQAAAAAAAAAzMzMAAAAAABQAAAAUAAAAGQAAABkAAAAAAAAABcAAAAUAAAAAAAAAAAAAAD/fwAA/38AAAAAAAAJAAAABAAAAAsAAAAeAAAAaAAAAAAAAAAAAAAAAAAAAAAAAAAAAAAAECcAABAnAAAAAAAAAAAAAAAAAAAAAAAAAAAAAAAAAAAAAAAAAAAAABQAAAAAAAAAwMD/AAAAAABkAAAAMgAAAAAAAABkAAAAAAAAAH9/fwAKAAAAIgAAABgAAAAAAAAAAAAAAAAAAAAAAAAAAAAAAAAAAAAkAAAAJAAAAAAAAAAHAAAAAAAAAAAAAAAAAAAAAAAAAAAAAAAAAAAAf39/ACUAAABYAAAAAAAAAAAAAAAAAAAAAAAAAAAAAAAAAAAAAAAAAAAAAAAAAAAAAAAAAAAAAAA/AAAAAAAAAKCGAQAAAAAAAAAAAAAAAAAMAAAAAQAAAAAAAAAAAAAAAAAAAB8AAABUAAAAu+DjBf///wEAAAAAAAAAAAAAAAAAAAAAAAAAAAAAAAAAAAAAAAAAAAAAAAJ/f38AgICAA8zMzADAwP8Af39/AAAAAAAAAAAAAAAAAAAAAAAAAAAAIQAAABgAAAAUAAAAGCsAABAQAACAMgAAWBYAABAAAAAmAAAACAAAAP//////////"/>
+                <pr:smNativeData xmlns:pr="smNativeData" xmlns="smNativeData" val="SMDATA_15_ZqHWaRMAAAAlAAAADgAAAA8BAAAAkAAAAEgAAACQAAAASAAAAAAAAAAAAAAAAAAAAAEAAABQAAAAAAAAAAAAAAAAAAAAAADgPwAAAAAAAOA/AAAAAAAA4D8AAAAAAADgPwAAAAAAAOA/AAAAAAAA4D8AAAAAAADgPwAAAAAAAOA/AAAAAAAA4D8CAAAAjAAAAAAAAAAAAAAAu+DjDP///wgAAAAAAAAAAAAAAAAAAAAAAAAAAAAAAAAAAAAAZAAAAAEAAABAAAAAAAAAAAAAAAAAAAAAAAAAAAAAAAAAAAAAAAAAAAAAAAAAAAAAAAAAAAAAAAAAAAAAAAAAAAAAAAAAAAAAAAAAAAAAAAAAAAAAAAAAAAAAAAAAAAAAFAAAADwAAAABAAAAAAAAAAAAAAkUAAAAAQAAABQAAAAUAAAAFAAAAAEAAAAAAAAAZAAAAGQAAAABAAAAlgAAAJYAAAAVAAAAYAAAAAAAAAAAAAAADwAAACADAAAAAAAAAAAAAAEAAACgMgAAVgcAAKr4//8BAAAAf39/AAEAAABkAAAAAAAAABQAAABAHwAAAAAAACYAAAAAAAAAwOD//wAAAAAmAAAAZAAAABYAAABMAAAAAAAAAAAAAAAEAAAAAAAAAAEAAACAgIAKAAAAACgAAAAoAAAAZAAAAGQAAAAAAAAAzMzMAAAAAABQAAAAUAAAAGQAAABkAAAAAAAAABcAAAAUAAAAAAAAAAAAAAD/fwAA/38AAAAAAAAJAAAABAAAAAsAAAAeAAAAaAAAAAAAAAAAAAAAAAAAAAAAAAAAAAAAECcAABAnAAAAAAAAAAAAAAAAAAAAAAAAAAAAAAAAAAAAAAAAAAAAABQAAAAAAAAAwMD/AAAAAABkAAAAMgAAAAAAAABkAAAAAAAAAH9/fwAKAAAAIgAAABgAAAAAAAAAAAAAAAAAAAAAAAAAAAAAAAAAAAAkAAAAJAAAAAAAAAAHAAAAAAAAAAAAAAAAAAAAAAAAAAAAAAAAAAAAf39/ACUAAABYAAAAAAAAAAAAAAAAAAAAAAAAAAAAAAAAAAAAAAAAAAAAAAAAAAAAAAAAAAAAAAA/AAAAAAAAAKCGAQAAAAAAAAAAAAAAAAAMAAAAAQAAAAAAAAAAAAAAAAAAAB8AAABUAAAAu+DjBf///wEAAAAAAAAAAAAAAAAAAAAAAAAAAAAAAAAAAAAAAAAAAAAAAAJ/f38AgICAA8zMzADAwP8Af39/AAAAAAAAAAAAAAAAAAAAAAAAAAAAIQAAABgAAAAUAAAAGCsAABAQAACAMgAAWBYAABAAAAAmAAAACAAAAP//////////"/>
               </a:ext>
             </a:extLst>
           </p:cNvCxnSpPr>
@@ -5451,7 +5451,7 @@
             <a:endCxn id="8" idx="1"/>
             <a:extLst>
               <a:ext uri="smNativeData">
-                <pr:smNativeData xmlns:pr="smNativeData" xmlns="smNativeData" val="SMDATA_15_7aDWaRMAAAAlAAAADgAAAA8BAAAAkAAAAEgAAACQAAAASAAAAAAAAAAAAAAAAAAAAAEAAABQAAAA+cV9/AlGQb8AAAAAAADgPwAAAAAAAOA/AAAAAAAA4D8AAAAAAADgPwAAAAAAAOA/AAAAAAAA4D8AAAAAAADgPwAAAAAAAOA/AAAAAAAA4D8CAAAAjAAAAAAAAAAAAAAAu+DjDP///wgAAAAAAAAAAAAAAAAAAAAAAAAAAAAAAAAAAAAAZAAAAAEAAABAAAAAAAAAAAAAAAAAAAAAAAAAAAAAAAAAAAAAAAAAAAAAAAAAAAAAAAAAAAAAAAAAAAAAAAAAAAAAAAAAAAAAAAAAAAAAAAAAAAAAAAAAAAAAAAAAAAAAFAAAADwAAAABAAAAAAAAAAAAAAkUAAAAAQAAABQAAAAUAAAAFAAAAAEAAAAAAAAAZAAAAGQAAAABAAAAlgAAAJYAAAAVAAAAYAAAAAAAAAAAAAAADwAAACADAAAAAAAAAAAAAAEAAACgMgAAVgcAAKr4//8BAAAAf39/AAEAAABkAAAAAAAAABQAAABAHwAAAAAAACYAAAAAAAAAwOD//wAAAAAmAAAAZAAAABYAAABMAAAAAAAAAAAAAAAEAAAAAAAAAAEAAACAgIAKAAAAACgAAAAoAAAAZAAAAGQAAAAAAAAAzMzMAAAAAABQAAAAUAAAAGQAAABkAAAAAAAAABcAAAAUAAAAAAAAAAAAAAD/fwAA/38AAAAAAAAJAAAABAAAAAAAAAAeAAAAaAAAAAAAAAAAAAAAAAAAAAAAAAAAAAAAECcAABAnAAAAAAAAAAAAAAAAAAAAAAAAAAAAAAAAAAAAAAAAAAAAABQAAAAAAAAAwMD/AAAAAABkAAAAMgAAAAAAAABkAAAAAAAAAH9/fwAKAAAAIgAAABgAAAAAAAAAAAAAAAAAAAAAAAAAAAAAAAAAAAAkAAAAJAAAAAAAAAAHAAAAAAAAAAAAAAAAAAAAAAAAAAAAAAAAAAAAf39/ACUAAABYAAAAAAAAAAAAAAAAAAAAAAAAAAAAAAAAAAAAAAAAAAAAAAAAAAAAAAAAAAAAAAA/AAAAAAAAAKCGAQAAAAAAAAAAAAAAAAAMAAAAAQAAAAAAAAAAAAAAAAAAAB8AAABUAAAAu+DjBf///wEAAAAAAAAAAAAAAAAAAAAAAAAAAAAAAAAAAAAAAAAAAAAAAAJ/f38AgICAA8zMzADAwP8Af39/AAAAAAAAAAAAAAAAAAAAAAAAAAAAIQAAABgAAAAUAAAAGCsAAHEJAACBMgAAWBYAABAAAAAmAAAACAAAAP//////////"/>
+                <pr:smNativeData xmlns:pr="smNativeData" xmlns="smNativeData" val="SMDATA_15_ZqHWaRMAAAAlAAAADgAAAA8BAAAAkAAAAEgAAACQAAAASAAAAAAAAAAAAAAAAAAAAAEAAABQAAAA+cV9/AlGQb8AAAAAAADgPwAAAAAAAOA/AAAAAAAA4D8AAAAAAADgPwAAAAAAAOA/AAAAAAAA4D8AAAAAAADgPwAAAAAAAOA/AAAAAAAA4D8CAAAAjAAAAAAAAAAAAAAAu+DjDP///wgAAAAAAAAAAAAAAAAAAAAAAAAAAAAAAAAAAAAAZAAAAAEAAABAAAAAAAAAAAAAAAAAAAAAAAAAAAAAAAAAAAAAAAAAAAAAAAAAAAAAAAAAAAAAAAAAAAAAAAAAAAAAAAAAAAAAAAAAAAAAAAAAAAAAAAAAAAAAAAAAAAAAFAAAADwAAAABAAAAAAAAAAAAAAkUAAAAAQAAABQAAAAUAAAAFAAAAAEAAAAAAAAAZAAAAGQAAAABAAAAlgAAAJYAAAAVAAAAYAAAAAAAAAAAAAAADwAAACADAAAAAAAAAAAAAAEAAACgMgAAVgcAAKr4//8BAAAAf39/AAEAAABkAAAAAAAAABQAAABAHwAAAAAAACYAAAAAAAAAwOD//wAAAAAmAAAAZAAAABYAAABMAAAAAAAAAAAAAAAEAAAAAAAAAAEAAACAgIAKAAAAACgAAAAoAAAAZAAAAGQAAAAAAAAAzMzMAAAAAABQAAAAUAAAAGQAAABkAAAAAAAAABcAAAAUAAAAAAAAAAAAAAD/fwAA/38AAAAAAAAJAAAABAAAAAAAAAAeAAAAaAAAAAAAAAAAAAAAAAAAAAAAAAAAAAAAECcAABAnAAAAAAAAAAAAAAAAAAAAAAAAAAAAAAAAAAAAAAAAAAAAABQAAAAAAAAAwMD/AAAAAABkAAAAMgAAAAAAAABkAAAAAAAAAH9/fwAKAAAAIgAAABgAAAAAAAAAAAAAAAAAAAAAAAAAAAAAAAAAAAAkAAAAJAAAAAAAAAAHAAAAAAAAAAAAAAAAAAAAAAAAAAAAAAAAAAAAf39/ACUAAABYAAAAAAAAAAAAAAAAAAAAAAAAAAAAAAAAAAAAAAAAAAAAAAAAAAAAAAAAAAAAAAA/AAAAAAAAAKCGAQAAAAAAAAAAAAAAAAAMAAAAAQAAAAAAAAAAAAAAAAAAAB8AAABUAAAAu+DjBf///wEAAAAAAAAAAAAAAAAAAAAAAAAAAAAAAAAAAAAAAAAAAAAAAAJ/f38AgICAA8zMzADAwP8Af39/AAAAAAAAAAAAAAAAAAAAAAAAAAAAIQAAABgAAAAUAAAAGCsAAHEJAACBMgAAWBYAABAAAAAmAAAACAAAAP//////////"/>
               </a:ext>
             </a:extLst>
           </p:cNvCxnSpPr>
@@ -5487,7 +5487,7 @@
             <a:endCxn id="9" idx="2"/>
             <a:extLst>
               <a:ext uri="smNativeData">
-                <pr:smNativeData xmlns:pr="smNativeData" xmlns="smNativeData" val="SMDATA_15_7aDWaRMAAAAlAAAADgAAAA8BAAAAkAAAAEgAAACQAAAASAAAAAAAAAAAAAAAAAAAAAEAAABQAAAAk5SHCfa4Wz8AAAAAAADgPwAAAAAAAOA/AAAAAAAA4D8AAAAAAADgPwAAAAAAAOA/AAAAAAAA4D8AAAAAAADgPwAAAAAAAOA/AAAAAAAA4D8CAAAAjAAAAAAAAAAAAAAAu+DjDP///wgAAAAAAAAAAAAAAAAAAAAAAAAAAAAAAAAAAAAAZAAAAAEAAABAAAAAAAAAAAAAAAAAAAAAAAAAAAAAAAAAAAAAAAAAAAAAAAAAAAAAAAAAAAAAAAAAAAAAAAAAAAAAAAAAAAAAAAAAAAAAAAAAAAAAAAAAAAAAAAAAAAAAFAAAADwAAAABAAAAAAAAAAAAAAkUAAAAAQAAABQAAAAUAAAAFAAAAAEAAAAAAAAAZAAAAGQAAAABAAAAlgAAAJYAAAAVAAAAYAAAAAAAAAAAAAAADwAAACADAAAAAAAAAAAAAAEAAACgMgAAVgcAAKr4//8BAAAAf39/AAEAAABkAAAAAAAAABQAAABAHwAAAAAAACYAAAAAAAAAwOD//wAAAAAmAAAAZAAAABYAAABMAAAAAAAAAAAAAAAEAAAAAAAAAAEAAACAgIAKAAAAACgAAAAoAAAAZAAAAGQAAAAAAAAAzMzMAAAAAABQAAAAUAAAAGQAAABkAAAAAAAAABcAAAAUAAAAAAAAAAAAAAD/fwAA/38AAAAAAAAJAAAABAAAAAAAAAAeAAAAaAAAAAAAAAAAAAAAAAAAAAAAAAAAAAAAECcAABAnAAAAAAAAAAAAAAAAAAAAAAAAAAAAAAAAAAAAAAAAAAAAABQAAAAAAAAAwMD/AAAAAABkAAAAMgAAAAAAAABkAAAAAAAAAH9/fwAKAAAAIgAAABgAAAAAAAAAAAAAAAAAAAAAAAAAAAAAAAAAAAAkAAAAJAAAAAAAAAAHAAAAAAAAAAAAAAAAAAAAAAAAAAAAAAAAAAAAf39/ACUAAABYAAAAAAAAAAAAAAAAAAAAAAAAAAAAAAAAAAAAAAAAAAAAAAAAAAAAAAAAAAAAAAA/AAAAAAAAAKCGAQAAAAAAAAAAAAAAAAAMAAAAAQAAAAAAAAAAAAAAAAAAAB8AAABUAAAAu+DjBf///wEAAAAAAAAAAAAAAAAAAAAAAAAAAAAAAAAAAAAAAAAAAAAAAAJ/f38AgICAA8zMzADAwP8Af39/AAAAAAAAAAAAAAAAAAAAAAAAAAAAIQAAABgAAAAUAAAAsTYAAJYFAACzNgAA5QcAABAAAAAmAAAACAAAAP//////////"/>
+                <pr:smNativeData xmlns:pr="smNativeData" xmlns="smNativeData" val="SMDATA_15_ZqHWaRMAAAAlAAAADgAAAA8BAAAAkAAAAEgAAACQAAAASAAAAAAAAAAAAAAAAAAAAAEAAABQAAAAk5SHCfa4Wz8AAAAAAADgPwAAAAAAAOA/AAAAAAAA4D8AAAAAAADgPwAAAAAAAOA/AAAAAAAA4D8AAAAAAADgPwAAAAAAAOA/AAAAAAAA4D8CAAAAjAAAAAAAAAAAAAAAu+DjDP///wgAAAAAAAAAAAAAAAAAAAAAAAAAAAAAAAAAAAAAZAAAAAEAAABAAAAAAAAAAAAAAAAAAAAAAAAAAAAAAAAAAAAAAAAAAAAAAAAAAAAAAAAAAAAAAAAAAAAAAAAAAAAAAAAAAAAAAAAAAAAAAAAAAAAAAAAAAAAAAAAAAAAAFAAAADwAAAABAAAAAAAAAAAAAAkUAAAAAQAAABQAAAAUAAAAFAAAAAEAAAAAAAAAZAAAAGQAAAABAAAAlgAAAJYAAAAVAAAAYAAAAAAAAAAAAAAADwAAACADAAAAAAAAAAAAAAEAAACgMgAAVgcAAKr4//8BAAAAf39/AAEAAABkAAAAAAAAABQAAABAHwAAAAAAACYAAAAAAAAAwOD//wAAAAAmAAAAZAAAABYAAABMAAAAAAAAAAAAAAAEAAAAAAAAAAEAAACAgIAKAAAAACgAAAAoAAAAZAAAAGQAAAAAAAAAzMzMAAAAAABQAAAAUAAAAGQAAABkAAAAAAAAABcAAAAUAAAAAAAAAAAAAAD/fwAA/38AAAAAAAAJAAAABAAAAAAAAAAeAAAAaAAAAAAAAAAAAAAAAAAAAAAAAAAAAAAAECcAABAnAAAAAAAAAAAAAAAAAAAAAAAAAAAAAAAAAAAAAAAAAAAAABQAAAAAAAAAwMD/AAAAAABkAAAAMgAAAAAAAABkAAAAAAAAAH9/fwAKAAAAIgAAABgAAAAAAAAAAAAAAAAAAAAAAAAAAAAAAAAAAAAkAAAAJAAAAAAAAAAHAAAAAAAAAAAAAAAAAAAAAAAAAAAAAAAAAAAAf39/ACUAAABYAAAAAAAAAAAAAAAAAAAAAAAAAAAAAAAAAAAAAAAAAAAAAAAAAAAAAAAAAAAAAAA/AAAAAAAAAKCGAQAAAAAAAAAAAAAAAAAMAAAAAQAAAAAAAAAAAAAAAAAAAB8AAABUAAAAu+DjBf///wEAAAAAAAAAAAAAAAAAAAAAAAAAAAAAAAAAAAAAAAAAAAAAAAJ/f38AgICAA8zMzADAwP8Af39/AAAAAAAAAAAAAAAAAAAAAAAAAAAAIQAAABgAAAAUAAAAsTYAAJYFAACzNgAA5QcAABAAAAAmAAAACAAAAP//////////"/>
               </a:ext>
             </a:extLst>
           </p:cNvCxnSpPr>
@@ -5523,7 +5523,7 @@
             <a:endCxn id="6" idx="2"/>
             <a:extLst>
               <a:ext uri="smNativeData">
-                <pr:smNativeData xmlns:pr="smNativeData" xmlns="smNativeData" val="SMDATA_15_7aDWaRMAAAAlAAAADgAAAA8BAAAAkAAAAEgAAACQAAAASAAAAAAAAAAAAAAAAAAAAAEAAABQAAAAhLEZLP23+7sAAAAAAADgPwAAAAAAAOA/AAAAAAAA4D8AAAAAAADgPwAAAAAAAOA/AAAAAAAA4D8AAAAAAADgPwAAAAAAAOA/AAAAAAAA4D8CAAAAjAAAAAAAAAAAAAAAu+DjDP///wgAAAAAAAAAAAAAAAAAAAAAAAAAAAAAAAAAAAAAZAAAAAEAAABAAAAAAAAAAAAAAAAAAAAAAAAAAAAAAAAAAAAAAAAAAAAAAAAAAAAAAAAAAAAAAAAAAAAAAAAAAAAAAAAAAAAAAAAAAAAAAAAAAAAAAAAAAAAAAAAAAAAAFAAAADwAAAABAAAAAAAAAAAAAAkUAAAAAQAAABQAAAAUAAAAFAAAAAEAAAAAAAAAZAAAAGQAAAABAAAAlgAAAJYAAAAVAAAAYAAAAAAAAAAAAAAADwAAACADAAAAAAAAAAAAAAEAAACgMgAAVgcAAKr4//8BAAAAf39/AAEAAABkAAAAAAAAABQAAABAHwAAAAAAACYAAAAAAAAAwOD//wAAAAAmAAAAZAAAABYAAABMAAAAAAAAAAAAAAAEAAAAAAAAAAEAAACAgIAKAAAAACgAAAAoAAAAZAAAAGQAAAAAAAAAzMzMAAAAAABQAAAAUAAAAGQAAABkAAAAAAAAABcAAAAUAAAAAAAAAAAAAAD/fwAA/38AAAAAAAAJAAAABAAAAJYAAAAeAAAAaAAAAAAAAAAAAAAAAAAAAAAAAAAAAAAAECcAABAnAAAAAAAAAAAAAAAAAAAAAAAAAAAAAAAAAAAAAAAAAAAAABQAAAAAAAAAwMD/AAAAAABkAAAAMgAAAAAAAABkAAAAAAAAAH9/fwAKAAAAIgAAABgAAAAAAAAAAAAAAAAAAAAAAAAAAAAAAAAAAAAkAAAAJAAAAAAAAAAHAAAAAAAAAAAAAAAAAAAAAAAAAAAAAAAAAAAAf39/ACUAAABYAAAAAAAAAAAAAAAAAAAAAAAAAAAAAAAAAAAAAAAAAAAAAAAAAAAAAAAAAAAAAAA/AAAAAAAAAKCGAQAAAAAAAAAAAAAAAAAMAAAAAQAAAAAAAAAAAAAAAAAAAB8AAABUAAAAu+DjBf///wEAAAAAAAAAAAAAAAAAAAAAAAAAAAAAAAAAAAAAAAAAAAAAAAJ/f38AgICAA8zMzADAwP8Af39/AAAAAAAAAAAAAAAAAAAAAAAAAAAAIQAAABgAAAAUAAAABCYAAHEKAAAGJgAA/QwAABAAAAAmAAAACAAAAP//////////"/>
+                <pr:smNativeData xmlns:pr="smNativeData" xmlns="smNativeData" val="SMDATA_15_ZqHWaRMAAAAlAAAADgAAAA8BAAAAkAAAAEgAAACQAAAASAAAAAAAAAAAAAAAAAAAAAEAAABQAAAAhLEZLP23+7sAAAAAAADgPwAAAAAAAOA/AAAAAAAA4D8AAAAAAADgPwAAAAAAAOA/AAAAAAAA4D8AAAAAAADgPwAAAAAAAOA/AAAAAAAA4D8CAAAAjAAAAAAAAAAAAAAAu+DjDP///wgAAAAAAAAAAAAAAAAAAAAAAAAAAAAAAAAAAAAAZAAAAAEAAABAAAAAAAAAAAAAAAAAAAAAAAAAAAAAAAAAAAAAAAAAAAAAAAAAAAAAAAAAAAAAAAAAAAAAAAAAAAAAAAAAAAAAAAAAAAAAAAAAAAAAAAAAAAAAAAAAAAAAFAAAADwAAAABAAAAAAAAAAAAAAkUAAAAAQAAABQAAAAUAAAAFAAAAAEAAAAAAAAAZAAAAGQAAAABAAAAlgAAAJYAAAAVAAAAYAAAAAAAAAAAAAAADwAAACADAAAAAAAAAAAAAAEAAACgMgAAVgcAAKr4//8BAAAAf39/AAEAAABkAAAAAAAAABQAAABAHwAAAAAAACYAAAAAAAAAwOD//wAAAAAmAAAAZAAAABYAAABMAAAAAAAAAAAAAAAEAAAAAAAAAAEAAACAgIAKAAAAACgAAAAoAAAAZAAAAGQAAAAAAAAAzMzMAAAAAABQAAAAUAAAAGQAAABkAAAAAAAAABcAAAAUAAAAAAAAAAAAAAD/fwAA/38AAAAAAAAJAAAABAAAAJYAAAAeAAAAaAAAAAAAAAAAAAAAAAAAAAAAAAAAAAAAECcAABAnAAAAAAAAAAAAAAAAAAAAAAAAAAAAAAAAAAAAAAAAAAAAABQAAAAAAAAAwMD/AAAAAABkAAAAMgAAAAAAAABkAAAAAAAAAH9/fwAKAAAAIgAAABgAAAAAAAAAAAAAAAAAAAAAAAAAAAAAAAAAAAAkAAAAJAAAAAAAAAAHAAAAAAAAAAAAAAAAAAAAAAAAAAAAAAAAAAAAf39/ACUAAABYAAAAAAAAAAAAAAAAAAAAAAAAAAAAAAAAAAAAAAAAAAAAAAAAAAAAAAAAAAAAAAA/AAAAAAAAAKCGAQAAAAAAAAAAAAAAAAAMAAAAAQAAAAAAAAAAAAAAAAAAAB8AAABUAAAAu+DjBf///wEAAAAAAAAAAAAAAAAAAAAAAAAAAAAAAAAAAAAAAAAAAAAAAAJ/f38AgICAA8zMzADAwP8Af39/AAAAAAAAAAAAAAAAAAAAAAAAAAAAIQAAABgAAAAUAAAABCYAAHEKAAAGJgAA/QwAABAAAAAmAAAACAAAAP//////////"/>
               </a:ext>
             </a:extLst>
           </p:cNvCxnSpPr>
@@ -5559,7 +5559,7 @@
             <a:endCxn id="4" idx="3"/>
             <a:extLst>
               <a:ext uri="smNativeData">
-                <pr:smNativeData xmlns:pr="smNativeData" xmlns="smNativeData" val="SMDATA_15_7aDWaRMAAAAlAAAADwAAAA8BAAAAkAAAAEgAAACQAAAASAAAAAAAAAAAAAAAAAAAAAEAAABQAAAAXqfsgsWR3L8rL7VBsjQCQAAAAAAAAOA/AAAAAAAA4D8AAAAAAADgPwAAAAAAAOA/AAAAAAAA4D8AAAAAAADgPwAAAAAAAOA/AAAAAAAA4D8CAAAAjAAAAAAAAAAAAAAAu+DjDP///wgAAAAAAAAAAAAAAAAAAAAAAAAAAAAAAAAAAAAAZAAAAAEAAABAAAAAAAAAAAAAAAAAAAAAAAAAAAAAAAAAAAAAAAAAAAAAAAAAAAAAAAAAAAAAAAAAAAAAAAAAAAAAAAAAAAAAAAAAAAAAAAAAAAAAAAAAAAAAAAAAAAAAFAAAADwAAAABAAAAAgAAAAAAAAkUAAAAAQAAABQAAAAUAAAAFAAAAAEAAAAAAAAAZAAAAGQAAAABAAAAlgAAAJYAAAAVAAAAYAAAAAAAAAAAAAAADwAAACADAAAAAAAAAAAAAAEAAACgMgAAVgcAAKr4//8BAAAAf39/AAEAAABkAAAAAAAAABQAAABAHwAAAAAAACYAAAAAAAAAwOD//wAAAAAmAAAAZAAAABYAAABMAAAAAAAAAAAAAAAEAAAAAAAAAAEAAACAgIAKAAAAACgAAAAoAAAAZAAAAGQAAAAAAAAAzMzMAAAAAABQAAAAUAAAAGQAAABkAAAAAAAAABcAAAAUAAAAAAAAAAAAAAD/fwAA/38AAAAAAAAJAAAABAAAAAsAAAAeAAAAaAAAAAAAAAAAAAAAAAAAAAAAAAAAAAAAECcAABAnAAAAAAAAAAAAAAAAAAAAAAAAAAAAAAAAAAAAAAAAAAAAABQAAAAAAAAAwMD/AAAAAABkAAAAMgAAAAAAAABkAAAAAAAAAH9/fwAKAAAAIgAAABgAAAAAAAAAAAAAAAAAAAAAAAAAAAAAAAAAAAAkAAAAJAAAAAAAAAAHAAAAAAAAAAAAAAAAAAAAAAAAAAAAAAAAAAAAf39/ACUAAABYAAAAAAAAAAAAAAAAAAAAAAAAAAAAAAAAAAAAAAAAAAAAAAAAAAAAAAAAAAAAAAA/AAAAAAAAAKCGAQAAAAAAAAAAAAAAAAAMAAAAAQAAAAAAAAAAAAAAAAAAAB8AAABUAAAAu+DjBf///wEAAAAAAAAAAAAAAAAAAAAAAAAAAAAAAAAAAAAAAAAAAAAAAAJ/f38AgICAA8zMzADAwP8Af39/AAAAAAAAAAAAAAAAAAAAAAAAAAAAIQAAABgAAAAUAAAAVhgAAI8IAABpGwAAAQ0AABAAAAAmAAAACAAAAP//////////"/>
+                <pr:smNativeData xmlns:pr="smNativeData" xmlns="smNativeData" val="SMDATA_15_ZqHWaRMAAAAlAAAADwAAAA8BAAAAkAAAAEgAAACQAAAASAAAAAAAAAAAAAAAAAAAAAEAAABQAAAAXqfsgsWR3L8rL7VBsjQCQAAAAAAAAOA/AAAAAAAA4D8AAAAAAADgPwAAAAAAAOA/AAAAAAAA4D8AAAAAAADgPwAAAAAAAOA/AAAAAAAA4D8CAAAAjAAAAAAAAAAAAAAAu+DjDP///wgAAAAAAAAAAAAAAAAAAAAAAAAAAAAAAAAAAAAAZAAAAAEAAABAAAAAAAAAAAAAAAAAAAAAAAAAAAAAAAAAAAAAAAAAAAAAAAAAAAAAAAAAAAAAAAAAAAAAAAAAAAAAAAAAAAAAAAAAAAAAAAAAAAAAAAAAAAAAAAAAAAAAFAAAADwAAAABAAAAAgAAAAAAAAkUAAAAAQAAABQAAAAUAAAAFAAAAAEAAAAAAAAAZAAAAGQAAAABAAAAlgAAAJYAAAAVAAAAYAAAAAAAAAAAAAAADwAAACADAAAAAAAAAAAAAAEAAACgMgAAVgcAAKr4//8BAAAAf39/AAEAAABkAAAAAAAAABQAAABAHwAAAAAAACYAAAAAAAAAwOD//wAAAAAmAAAAZAAAABYAAABMAAAAAAAAAAAAAAAEAAAAAAAAAAEAAACAgIAKAAAAACgAAAAoAAAAZAAAAGQAAAAAAAAAzMzMAAAAAABQAAAAUAAAAGQAAABkAAAAAAAAABcAAAAUAAAAAAAAAAAAAAD/fwAA/38AAAAAAAAJAAAABAAAAAsAAAAeAAAAaAAAAAAAAAAAAAAAAAAAAAAAAAAAAAAAECcAABAnAAAAAAAAAAAAAAAAAAAAAAAAAAAAAAAAAAAAAAAAAAAAABQAAAAAAAAAwMD/AAAAAABkAAAAMgAAAAAAAABkAAAAAAAAAH9/fwAKAAAAIgAAABgAAAAAAAAAAAAAAAAAAAAAAAAAAAAAAAAAAAAkAAAAJAAAAAAAAAAHAAAAAAAAAAAAAAAAAAAAAAAAAAAAAAAAAAAAf39/ACUAAABYAAAAAAAAAAAAAAAAAAAAAAAAAAAAAAAAAAAAAAAAAAAAAAAAAAAAAAAAAAAAAAA/AAAAAAAAAKCGAQAAAAAAAAAAAAAAAAAMAAAAAQAAAAAAAAAAAAAAAAAAAB8AAABUAAAAu+DjBf///wEAAAAAAAAAAAAAAAAAAAAAAAAAAAAAAAAAAAAAAAAAAAAAAAJ/f38AgICAA8zMzADAwP8Af39/AAAAAAAAAAAAAAAAAAAAAAAAAAAAIQAAABgAAAAUAAAAVhgAAI8IAABpGwAAAQ0AABAAAAAmAAAACAAAAP//////////"/>
               </a:ext>
             </a:extLst>
           </p:cNvCxnSpPr>
@@ -5592,25 +5592,25 @@
         <p:nvCxnSpPr>
           <p:cNvPr id="43" name="Connector22"/>
           <p:cNvCxnSpPr>
-            <a:stCxn id="2" idx="0"/>
-            <a:endCxn id="6" idx="3"/>
-            <a:extLst>
-              <a:ext uri="smNativeData">
-                <pr:smNativeData xmlns:pr="smNativeData" xmlns="smNativeData" val="SMDATA_15_7aDWaRMAAAAlAAAADwAAAA8BAAAAkAAAAEgAAACQAAAASAAAAAAAAAAAAAAAAAAAAAEAAABQAAAA/nDA4w8H3L+9RGVK8ZP9PwAAAAAAAOA/AAAAAAAA4D8AAAAAAADgPwAAAAAAAOA/AAAAAAAA4D8AAAAAAADgPwAAAAAAAOA/AAAAAAAA4D8CAAAAjAAAAAAAAAAAAAAAu+DjDP///wgAAAAAAAAAAAAAAAAAAAAAAAAAAAAAAAAAAAAAZAAAAAEAAABAAAAAAAAAAAAAAAAAAAAAAAAAAAAAAAAAAAAAAAAAAAAAAAAAAAAAAAAAAAAAAAAAAAAAAAAAAAAAAAAAAAAAAAAAAAAAAAAAAAAAAAAAAAAAAAAAAAAAFAAAADwAAAABAAAAAgAAAAAAAAkUAAAAAQAAABQAAAAUAAAAFAAAAAEAAAAAAAAAZAAAAGQAAAABAAAAlgAAAJYAAAAVAAAAYAAAAAAAAAAAAAAADwAAACADAAAAAAAAAAAAAAEAAACgMgAAVgcAAKr4//8BAAAAf39/AAEAAABkAAAAAAAAABQAAABAHwAAAAAAACYAAAAAAAAAwOD//wAAAAAmAAAAZAAAABYAAABMAAAAAAAAAAAAAAAEAAAAAAAAAAEAAACAgIAKAAAAACgAAAAoAAAAZAAAAGQAAAAAAAAAzMzMAAAAAABQAAAAUAAAAGQAAABkAAAAAAAAABcAAAAUAAAAAAAAAAAAAAD/fwAA/38AAAAAAAAJAAAABAAAAAAAAAAeAAAAaAAAAAAAAAAAAAAAAAAAAAAAAAAAAAAAECcAABAnAAAAAAAAAAAAAAAAAAAAAAAAAAAAAAAAAAAAAAAAAAAAABQAAAAAAAAAwMD/AAAAAABkAAAAMgAAAAAAAABkAAAAAAAAAH9/fwAKAAAAIgAAABgAAAAAAAAAAAAAAAAAAAAAAAAAAAAAAAAAAAAkAAAAJAAAAAAAAAAHAAAAAAAAAAAAAAAAAAAAAAAAAAAAAAAAAAAAf39/ACUAAABYAAAAAAAAAAAAAAAAAAAAAAAAAAAAAAAAAAAAAAAAAAAAAAAAAAAAAAAAAAAAAAA/AAAAAAAAAKCGAQAAAAAAAAAAAAAAAAAMAAAAAQAAAAAAAAAAAAAAAAAAAB8AAABUAAAAu+DjBf///wEAAAAAAAAAAAAAAAAAAAAAAAAAAAAAAAAAAAAAAAAAAAAAAAJ/f38AgICAA8zMzADAwP8Af39/AAAAAAAAAAAAAAAAAAAAAAAAAAAAIQAAABgAAAAUAAAABCYAAHUIAACOKQAA/QwAABAAAAAmAAAACAAAAP//////////"/>
+            <a:stCxn id="2" idx="2"/>
+            <a:endCxn id="16" idx="3"/>
+            <a:extLst>
+              <a:ext uri="smNativeData">
+                <pr:smNativeData xmlns:pr="smNativeData" xmlns="smNativeData" val="SMDATA_15_ZqHWaRMAAAAlAAAADwAAAA8BAAAAkAAAAEgAAACQAAAASAAAAAAAAAAAAAAAAAAAAAEAAABQAAAAbeCGQwi05r9vsApdqUj3PwAAAAAAAOA/AAAAAAAA4D8AAAAAAADgPwAAAAAAAOA/AAAAAAAA4D8AAAAAAADgPwAAAAAAAOA/AAAAAAAA4D8CAAAAjAAAAAAAAAAAAAAAu+DjDP///wgAAAAAAAAAAAAAAAAAAAAAAAAAAAAAAAAAAAAAZAAAAAEAAABAAAAAAAAAAAAAAAAAAAAAAAAAAAAAAAAAAAAAAAAAAAAAAAAAAAAAAAAAAAAAAAAAAAAAAAAAAAAAAAAAAAAAAAAAAAAAAAAAAAAAAAAAAAAAAAAAAAAAFAAAADwAAAABAAAAAgAAAAAAAAkUAAAAAQAAABQAAAAUAAAAFAAAAAEAAAAAAAAAZAAAAGQAAAABAAAAlgAAAJYAAAAVAAAAYAAAAAAAAAAAAAAADwAAACADAAAAAAAAAAAAAAEAAACgMgAAVgcAAKr4//8BAAAAf39/AAEAAABkAAAAAAAAABQAAABAHwAAAAAAACYAAAAAAAAAwOD//wAAAAAmAAAAZAAAABYAAABMAAAAAAAAAAAAAAAEAAAAAAAAAAEAAACAgIAKAAAAACgAAAAoAAAAZAAAAGQAAAAAAAAAzMzMAAAAAABQAAAAUAAAAGQAAABkAAAAAAAAABcAAAAUAAAAAAAAAAAAAAD/fwAA/38AAAAAAAAJAAAABAAAAAAAAAAeAAAAaAAAAAAAAAAAAAAAAAAAAAAAAAAAAAAAECcAABAnAAAAAAAAAAAAAAAAAAAAAAAAAAAAAAAAAAAAAAAAAAAAABQAAAAAAAAAwMD/AAAAAABkAAAAMgAAAAAAAABkAAAAAAAAAH9/fwAKAAAAIgAAABgAAAAAAAAAAAAAAAAAAAAAAAAAAAAAAAAAAAAkAAAAJAAAAAAAAAAHAAAAAAAAAAAAAAAAAAAAAAAAAAAAAAAAAAAAf39/ACUAAABYAAAAAAAAAAAAAAAAAAAAAAAAAAAAAAAAAAAAAAAAAAAAAAAAAAAAAAAAAAAAAAA/AAAAAAAAAKCGAQAAAAAAAAAAAAAAAAAMAAAAAQAAAAAAAAAAAAAAAAAAAB8AAABUAAAAu+DjBf///wEAAAAAAAAAAAAAAAAAAAAAAAAAAAAAAAAAAAAAAAAAAAAAAAJ/f38AgICAA8zMzADAwP8Af39/AAAAAAAAAAAAAAAAAAAAAAAAAAAAIQAAABgAAAAUAAAABSYAAPYQAAAQPgAA5yEAABAAAAAmAAAACAAAAP//////////"/>
               </a:ext>
             </a:extLst>
           </p:cNvCxnSpPr>
           <p:nvPr/>
         </p:nvCxnSpPr>
         <p:spPr>
-          <a:xfrm rot="16200000">
-            <a:off x="6099175" y="1455420"/>
-            <a:ext cx="736600" cy="575310"/>
+          <a:xfrm rot="16200000" flipH="1">
+            <a:off x="6757670" y="2179955"/>
+            <a:ext cx="2753995" cy="3908425"/>
           </a:xfrm>
           <a:prstGeom prst="curvedConnector4">
             <a:avLst>
-              <a:gd name="adj1" fmla="val 28103"/>
-              <a:gd name="adj2" fmla="val 142431"/>
+              <a:gd name="adj1" fmla="val 14526"/>
+              <a:gd name="adj2" fmla="val 122762"/>
             </a:avLst>
           </a:prstGeom>
           <a:noFill/>
@@ -5633,7 +5633,7 @@
             <a:endCxn id="19" idx="1"/>
             <a:extLst>
               <a:ext uri="smNativeData">
-                <pr:smNativeData xmlns:pr="smNativeData" xmlns="smNativeData" val="SMDATA_15_7aDWaRMAAAAlAAAADwAAAA8BAAAAkAAAAEgAAACQAAAASAAAAAAAAAAAAAAAAAAAAAEAAABQAAAA4m9TjBr+5L+ev8Vpzfb5PwAAAAAAAOA/AAAAAAAA4D8AAAAAAADgPwAAAAAAAOA/AAAAAAAA4D8AAAAAAADgPwAAAAAAAOA/AAAAAAAA4D8CAAAAjAAAAAAAAAAAAAAAu+DjDP///wgAAAAAAAAAAAAAAAAAAAAAAAAAAAAAAAAAAAAAZAAAAAEAAABAAAAAAAAAAAAAAAAAAAAAAAAAAAAAAAAAAAAAAAAAAAAAAAAAAAAAAAAAAAAAAAAAAAAAAAAAAAAAAAAAAAAAAAAAAAAAAAAAAAAAAAAAAAAAAAAAAAAAFAAAADwAAAABAAAAAgAAAAAAAAkUAAAAAQAAABQAAAAUAAAAFAAAAAEAAAAAAAAAZAAAAGQAAAABAAAAlgAAAJYAAAAVAAAAYAAAAAAAAAAAAAAADwAAACADAAAAAAAAAAAAAAEAAACgMgAAVgcAAKr4//8BAAAAf39/AAEAAABkAAAAAAAAABQAAABAHwAAAAAAACYAAAAAAAAAwOD//wAAAAAmAAAAZAAAABYAAABMAAAAAAAAAAAAAAAEAAAAAAAAAAEAAACAgIAKAAAAACgAAAAoAAAAZAAAAGQAAAAAAAAAzMzMAAAAAABQAAAAUAAAAGQAAABkAAAAAAAAABcAAAAUAAAAAAAAAAAAAAD/fwAA/38AAAAAAAAJAAAABAAAAAAAAAAeAAAAaAAAAAAAAAAAAAAAAAAAAAAAAAAAAAAAECcAABAnAAAAAAAAAAAAAAAAAAAAAAAAAAAAAAAAAAAAAAAAAAAAABQAAAAAAAAAwMD/AAAAAABkAAAAMgAAAAAAAABkAAAAAAAAAH9/fwAKAAAAIgAAABgAAAAAAAAAAAAAAAAAAAAAAAAAAAAAAAAAAAAkAAAAJAAAAAAAAAAHAAAAAAAAAAAAAAAAAAAAAAAAAAAAAAAAAAAAf39/ACUAAABYAAAAAAAAAAAAAAAAAAAAAAAAAAAAAAAAAAAAAAAAAAAAAAAAAAAAAAAAAAAAAAA/AAAAAAAAAKCGAQAAAAAAAAAAAAAAAAAMAAAAAQAAAAAAAAAAAAAAAAAAAB8AAABUAAAAu+DjBf///wEAAAAAAAAAAAAAAAAAAAAAAAAAAAAAAAAAAAAAAAAAAAAAAAJ/f38AgICAA8zMzADAwP8Af39/AAAAAAAAAAAAAAAAAAAAAAAAAAAAIQAAABgAAAAUAAAA4xwAAPYQAAAEJgAA1iEAABAAAAAmAAAACAAAAP//////////"/>
+                <pr:smNativeData xmlns:pr="smNativeData" xmlns="smNativeData" val="SMDATA_15_ZqHWaRMAAAAlAAAADwAAAA8BAAAAkAAAAEgAAACQAAAASAAAAAAAAAAAAAAAAAAAAAEAAABQAAAA4m9TjBr+5L+ev8Vpzfb5PwAAAAAAAOA/AAAAAAAA4D8AAAAAAADgPwAAAAAAAOA/AAAAAAAA4D8AAAAAAADgPwAAAAAAAOA/AAAAAAAA4D8CAAAAjAAAAAAAAAAAAAAAu+DjDP///wgAAAAAAAAAAAAAAAAAAAAAAAAAAAAAAAAAAAAAZAAAAAEAAABAAAAAAAAAAAAAAAAAAAAAAAAAAAAAAAAAAAAAAAAAAAAAAAAAAAAAAAAAAAAAAAAAAAAAAAAAAAAAAAAAAAAAAAAAAAAAAAAAAAAAAAAAAAAAAAAAAAAAFAAAADwAAAABAAAAAgAAAAAAAAkUAAAAAQAAABQAAAAUAAAAFAAAAAEAAAAAAAAAZAAAAGQAAAABAAAAlgAAAJYAAAAVAAAAYAAAAAAAAAAAAAAADwAAACADAAAAAAAAAAAAAAEAAACgMgAAVgcAAKr4//8BAAAAf39/AAEAAABkAAAAAAAAABQAAABAHwAAAAAAACYAAAAAAAAAwOD//wAAAAAmAAAAZAAAABYAAABMAAAAAAAAAAAAAAAEAAAAAAAAAAEAAACAgIAKAAAAACgAAAAoAAAAZAAAAGQAAAAAAAAAzMzMAAAAAABQAAAAUAAAAGQAAABkAAAAAAAAABcAAAAUAAAAAAAAAAAAAAD/fwAA/38AAAAAAAAJAAAABAAAAAAAAAAeAAAAaAAAAAAAAAAAAAAAAAAAAAAAAAAAAAAAECcAABAnAAAAAAAAAAAAAAAAAAAAAAAAAAAAAAAAAAAAAAAAAAAAABQAAAAAAAAAwMD/AAAAAABkAAAAMgAAAAAAAABkAAAAAAAAAH9/fwAKAAAAIgAAABgAAAAAAAAAAAAAAAAAAAAAAAAAAAAAAAAAAAAkAAAAJAAAAAAAAAAHAAAAAAAAAAAAAAAAAAAAAAAAAAAAAAAAAAAAf39/ACUAAABYAAAAAAAAAAAAAAAAAAAAAAAAAAAAAAAAAAAAAAAAAAAAAAAAAAAAAAAAAAAAAAA/AAAAAAAAAKCGAQAAAAAAAAAAAAAAAAAMAAAAAQAAAAAAAAAAAAAAAAAAAB8AAABUAAAAu+DjBf///wEAAAAAAAAAAAAAAAAAAAAAAAAAAAAAAAAAAAAAAAAAAAAAAAJ/f38AgICAA8zMzADAwP8Af39/AAAAAAAAAAAAAAAAAAAAAAAAAAAAIQAAABgAAAAUAAAA4xwAAPYQAAAEJgAA1iEAABAAAAAmAAAACAAAAP//////////"/>
               </a:ext>
             </a:extLst>
           </p:cNvCxnSpPr>
@@ -5669,7 +5669,7 @@
             <a:stCxn id="2" idx="2"/>
             <a:extLst>
               <a:ext uri="smNativeData">
-                <pr:smNativeData xmlns:pr="smNativeData" xmlns="smNativeData" val="SMDATA_15_7aDWaRMAAAAlAAAADwAAAA8BAAAAkAAAAEgAAACQAAAASAAAAAAAAAAAAAAAAAAAAAEAAABQAAAAQtr79nGI5r8qniQtlC/2PwAAAAAAAOA/AAAAAAAA4D8AAAAAAADgPwAAAAAAAOA/AAAAAAAA4D8AAAAAAADgPwAAAAAAAOA/AAAAAAAA4D8CAAAAjAAAAAAAAAAAAAAAu+DjDP///wgAAAAAAAAAAAAAAAAAAAAAAAAAAAAAAAAAAAAAZAAAAAEAAABAAAAAAAAAAAAAAAAAAAAAAAAAAAAAAAAAAAAAAAAAAAAAAAAAAAAAAAAAAAAAAAAAAAAAAAAAAAAAAAAAAAAAAAAAAAAAAAAAAAAAAAAAAAAAAAAAAAAAFAAAADwAAAABAAAAAgAAAAAAAAkUAAAAAQAAABQAAAAUAAAAFAAAAAEAAAAAAAAAZAAAAGQAAAABAAAAlgAAAJYAAAAVAAAAYAAAAAAAAAAAAAAADwAAACADAAAAAAAAAAAAAAEAAACgMgAAVgcAAKr4//8BAAAAf39/AAEAAABkAAAAAAAAABQAAABAHwAAAAAAACYAAAAAAAAAwOD//wAAAAAmAAAAZAAAABYAAABMAAAAAAAAAAAAAAAEAAAAAAAAAAEAAACAgIAKAAAAACgAAAAoAAAAZAAAAGQAAAAAAAAAzMzMAAAAAABQAAAAUAAAAGQAAABkAAAAAAAAABcAAAAUAAAAAAAAAAAAAAD/fwAA/38AAAAAAAAJAAAABAAAAAAAAAAeAAAAaAAAAAAAAAAAAAAAAAAAAAAAAAAAAAAAECcAABAnAAAAAAAAAAAAAAAAAAAAAAAAAAAAAAAAAAAAAAAAAAAAABQAAAAAAAAAwMD/AAAAAABkAAAAMgAAAAAAAABkAAAAAAAAAH9/fwAKAAAAIgAAABgAAAAAAAAAAAAAAAAAAAAAAAAAAAAAAAAAAAAkAAAAJAAAAAAAAAAHAAAAAAAAAAAAAAAAAAAAAAAAAAAAAAAAAAAAf39/ACUAAABYAAAAAAAAAAAAAAAAAAAAAAAAAAAAAAAAAAAAAAAAAAAAAAAAAAAAAAAAAAAAAAA/AAAAAAAAAKCGAQAAAAAAAAAAAAAAAAAMAAAAAQAAAAAAAAAAAAAAAAAAAB8AAABUAAAAu+DjBf///wEAAAAAAAAAAAAAAAAAAAAAAAAAAAAAAAAAAAAAAAAAAAAAAAJ/f38AgICAA8zMzADAwP8Af39/AAAAAAAAAAAAAAAAAAAAAAAAAAAAIQAAABgAAAAUAAAAYw0AAPYQAAAFJgAAmSEAABAAAAAmAAAACAAAAP//////////"/>
+                <pr:smNativeData xmlns:pr="smNativeData" xmlns="smNativeData" val="SMDATA_15_ZqHWaRMAAAAlAAAADwAAAA8BAAAAkAAAAEgAAACQAAAASAAAAAAAAAAAAAAAAAAAAAEAAABQAAAAQtr79nGI5r8qniQtlC/2PwAAAAAAAOA/AAAAAAAA4D8AAAAAAADgPwAAAAAAAOA/AAAAAAAA4D8AAAAAAADgPwAAAAAAAOA/AAAAAAAA4D8CAAAAjAAAAAAAAAAAAAAAu+DjDP///wgAAAAAAAAAAAAAAAAAAAAAAAAAAAAAAAAAAAAAZAAAAAEAAABAAAAAAAAAAAAAAAAAAAAAAAAAAAAAAAAAAAAAAAAAAAAAAAAAAAAAAAAAAAAAAAAAAAAAAAAAAAAAAAAAAAAAAAAAAAAAAAAAAAAAAAAAAAAAAAAAAAAAFAAAADwAAAABAAAAAgAAAAAAAAkUAAAAAQAAABQAAAAUAAAAFAAAAAEAAAAAAAAAZAAAAGQAAAABAAAAlgAAAJYAAAAVAAAAYAAAAAAAAAAAAAAADwAAACADAAAAAAAAAAAAAAEAAACgMgAAVgcAAKr4//8BAAAAf39/AAEAAABkAAAAAAAAABQAAABAHwAAAAAAACYAAAAAAAAAwOD//wAAAAAmAAAAZAAAABYAAABMAAAAAAAAAAAAAAAEAAAAAAAAAAEAAACAgIAKAAAAACgAAAAoAAAAZAAAAGQAAAAAAAAAzMzMAAAAAABQAAAAUAAAAGQAAABkAAAAAAAAABcAAAAUAAAAAAAAAAAAAAD/fwAA/38AAAAAAAAJAAAABAAAAAAAAAAeAAAAaAAAAAAAAAAAAAAAAAAAAAAAAAAAAAAAECcAABAnAAAAAAAAAAAAAAAAAAAAAAAAAAAAAAAAAAAAAAAAAAAAABQAAAAAAAAAwMD/AAAAAABkAAAAMgAAAAAAAABkAAAAAAAAAH9/fwAKAAAAIgAAABgAAAAAAAAAAAAAAAAAAAAAAAAAAAAAAAAAAAAkAAAAJAAAAAAAAAAHAAAAAAAAAAAAAAAAAAAAAAAAAAAAAAAAAAAAf39/ACUAAABYAAAAAAAAAAAAAAAAAAAAAAAAAAAAAAAAAAAAAAAAAAAAAAAAAAAAAAAAAAAAAAA/AAAAAAAAAKCGAQAAAAAAAAAAAAAAAAAMAAAAAQAAAAAAAAAAAAAAAAAAAB8AAABUAAAAu+DjBf///wEAAAAAAAAAAAAAAAAAAAAAAAAAAAAAAAAAAAAAAAAAAAAAAAJ/f38AgICAA8zMzADAwP8Af39/AAAAAAAAAAAAAAAAAAAAAAAAAAAAIQAAABgAAAAUAAAAYw0AAPYQAAAFJgAAmSEAABAAAAAmAAAACAAAAP//////////"/>
               </a:ext>
             </a:extLst>
           </p:cNvCxnSpPr>
@@ -5706,7 +5706,7 @@
             <a:endCxn id="2" idx="3"/>
             <a:extLst>
               <a:ext uri="smNativeData">
-                <pr:smNativeData xmlns:pr="smNativeData" xmlns="smNativeData" val="SMDATA_15_7aDWaRMAAAAlAAAADwAAAA8BAAAAkAAAAEgAAACQAAAASAAAAAAAAAAAAAAAAAAAAAEAAABQAAAAAAAAAAAAFEAAAAAAAADgPwAAAAAAAOA/AAAAAAAA4D8AAAAAAADgPwAAAAAAAOA/AAAAAAAA4D8AAAAAAADgPwAAAAAAAOA/AAAAAAAA4D8CAAAAjAAAAAAAAAAAAAAAu+DjDP///wgAAAAAAAAAAAAAAAAAAAAAAAAAAAAAAAAAAAAAZAAAAAEAAABAAAAAAAAAAAAAAAAAAAAAAAAAAAAAAAAAAAAAAAAAAAAAAAAAAAAAAAAAAAAAAAAAAAAAAAAAAAAAAAAAAAAAAAAAAAAAAAAAAAAAAAAAAAAAAAAAAAAAFAAAADwAAAABAAAAAQAAAAAAAAkUAAAAAQAAABQAAAAUAAAAFAAAAAEAAAAAAAAAZAAAAGQAAAABAAAAlgAAAJYAAAAVAAAAYAAAAAAAAAAAAAAADwAAACADAAAAAAAAAAAAAAEAAACgMgAAVgcAAKr4//8BAAAAf39/AAEAAABkAAAAAAAAABQAAABAHwAAAAAAACYAAAAAAAAAwOD//wAAAAAmAAAAZAAAABYAAABMAAAAAAAAAAAAAAAEAAAAAAAAAAEAAACAgIAKAAAAACgAAAAoAAAAZAAAAGQAAAAAAAAAzMzMAAAAAABQAAAAUAAAAGQAAABkAAAAAAAAABcAAAAUAAAAAAAAAAAAAAD/fwAA/38AAAAAAAAJAAAABAAAAAAAAAAeAAAAaAAAAAAAAAAAAAAAAAAAAAAAAAAAAAAAECcAABAnAAAAAAAAAAAAAAAAAAAAAAAAAAAAAAAAAAAAAAAAAAAAABQAAAAAAAAAwMD/AAAAAABkAAAAMgAAAAAAAABkAAAAAAAAAH9/fwAKAAAAIgAAABgAAAAAAAAAAAAAAAAAAAAAAAAAAAAAAAAAAAAkAAAAJAAAAAAAAAAHAAAAAAAAAAAAAAAAAAAAAAAAAAAAAAAAAAAAf39/ACUAAABYAAAAAAAAAAAAAAAAAAAAAAAAAAAAAAAAAAAAAAAAAAAAAAAAAAAAAAAAAAAAAAA/AAAAAAAAAKCGAQAAAAAAAAAAAAAAAAAMAAAAAQAAAAAAAAAAAAAAAAAAAB8AAABUAAAAu+DjBf///wEAAAAAAAAAAAAAAAAAAAAAAAAAAAAAAAAAAAAAAAAAAAAAAAJ/f38AgICAA8zMzADAwP8Af39/AAAAAAAAAAAAAAAAAAAAAAAAAAAAIQAAABgAAAAUAAAAGCsAAPoOAAD6KwAAWBYAABAAAAAmAAAACAAAAP//////////"/>
+                <pr:smNativeData xmlns:pr="smNativeData" xmlns="smNativeData" val="SMDATA_15_ZqHWaRMAAAAlAAAADwAAAA8BAAAAkAAAAEgAAACQAAAASAAAAAAAAAAAAAAAAAAAAAEAAABQAAAAAAAAAAAAFEAAAAAAAADgPwAAAAAAAOA/AAAAAAAA4D8AAAAAAADgPwAAAAAAAOA/AAAAAAAA4D8AAAAAAADgPwAAAAAAAOA/AAAAAAAA4D8CAAAAjAAAAAAAAAAAAAAAu+DjDP///wgAAAAAAAAAAAAAAAAAAAAAAAAAAAAAAAAAAAAAZAAAAAEAAABAAAAAAAAAAAAAAAAAAAAAAAAAAAAAAAAAAAAAAAAAAAAAAAAAAAAAAAAAAAAAAAAAAAAAAAAAAAAAAAAAAAAAAAAAAAAAAAAAAAAAAAAAAAAAAAAAAAAAFAAAADwAAAABAAAAAQAAAAAAAAkUAAAAAQAAABQAAAAUAAAAFAAAAAEAAAAAAAAAZAAAAGQAAAABAAAAlgAAAJYAAAAVAAAAYAAAAAAAAAAAAAAADwAAACADAAAAAAAAAAAAAAEAAACgMgAAVgcAAKr4//8BAAAAf39/AAEAAABkAAAAAAAAABQAAABAHwAAAAAAACYAAAAAAAAAwOD//wAAAAAmAAAAZAAAABYAAABMAAAAAAAAAAAAAAAEAAAAAAAAAAEAAACAgIAKAAAAACgAAAAoAAAAZAAAAGQAAAAAAAAAzMzMAAAAAABQAAAAUAAAAGQAAABkAAAAAAAAABcAAAAUAAAAAAAAAAAAAAD/fwAA/38AAAAAAAAJAAAABAAAAAAAAAAeAAAAaAAAAAAAAAAAAAAAAAAAAAAAAAAAAAAAECcAABAnAAAAAAAAAAAAAAAAAAAAAAAAAAAAAAAAAAAAAAAAAAAAABQAAAAAAAAAwMD/AAAAAABkAAAAMgAAAAAAAABkAAAAAAAAAH9/fwAKAAAAIgAAABgAAAAAAAAAAAAAAAAAAAAAAAAAAAAAAAAAAAAkAAAAJAAAAAAAAAAHAAAAAAAAAAAAAAAAAAAAAAAAAAAAAAAAAAAAf39/ACUAAABYAAAAAAAAAAAAAAAAAAAAAAAAAAAAAAAAAAAAAAAAAAAAAAAAAAAAAAAAAAAAAAA/AAAAAAAAAKCGAQAAAAAAAAAAAAAAAAAMAAAAAQAAAAAAAAAAAAAAAAAAAB8AAABUAAAAu+DjBf///wEAAAAAAAAAAAAAAAAAAAAAAAAAAAAAAAAAAAAAAAAAAAAAAAJ/f38AgICAA8zMzADAwP8Af39/AAAAAAAAAAAAAAAAAAAAAAAAAAAAIQAAABgAAAAUAAAAGCsAAPoOAAD6KwAAWBYAABAAAAAmAAAACAAAAP//////////"/>
               </a:ext>
             </a:extLst>
           </p:cNvCxnSpPr>
@@ -5742,7 +5742,7 @@
             <a:endCxn id="2" idx="1"/>
             <a:extLst>
               <a:ext uri="smNativeData">
-                <pr:smNativeData xmlns:pr="smNativeData" xmlns="smNativeData" val="SMDATA_15_7aDWaRMAAAAlAAAADwAAAA8BAAAAkAAAAEgAAACQAAAASAAAAAAAAAAAAAAAAAAAAAEAAABQAAAAAAAAAACABMA3jx60mcXaPwAAAAAAAOA/AAAAAAAA4D8AAAAAAADgPwAAAAAAAOA/AAAAAAAA4D8AAAAAAADgPwAAAAAAAOA/AAAAAAAA4D8CAAAAjAAAAAAAAAAAAAAAu+DjDP///wgAAAAAAAAAAAAAAAAAAAAAAAAAAAAAAAAAAAAAZAAAAAEAAABAAAAAAAAAAAAAAAAAAAAAAAAAAAAAAAAAAAAAAAAAAAAAAAAAAAAAAAAAAAAAAAAAAAAAAAAAAAAAAAAAAAAAAAAAAAAAAAAAAAAAAAAAAAAAAAAAAAAAFAAAADwAAAABAAAAAgAAAAAAAAkUAAAAAQAAABQAAAAUAAAAFAAAAAEAAAAAAAAAZAAAAGQAAAABAAAAlgAAAJYAAAAVAAAAYAAAAAAAAAAAAAAADwAAACADAAAAAAAAAAAAAAEAAACgMgAAVgcAAKr4//8BAAAAf39/AAEAAABkAAAAAAAAABQAAABAHwAAAAAAACYAAAAAAAAAwOD//wAAAAAmAAAAZAAAABYAAABMAAAAAAAAAAAAAAAEAAAAAAAAAAEAAACAgIAKAAAAACgAAAAoAAAAZAAAAGQAAAAAAAAAzMzMAAAAAABQAAAAUAAAAGQAAABkAAAAAAAAABcAAAAUAAAAAAAAAAAAAAD/fwAA/38AAAAAAAAJAAAABAAAAAAAAAAeAAAAaAAAAAAAAAAAAAAAAAAAAAAAAAAAAAAAECcAABAnAAAAAAAAAAAAAAAAAAAAAAAAAAAAAAAAAAAAAAAAAAAAABQAAAAAAAAAwMD/AAAAAABkAAAAMgAAAAAAAABkAAAAAAAAAH9/fwAKAAAAIgAAABgAAAAAAAAAAAAAAAAAAAAAAAAAAAAAAAAAAAAkAAAAJAAAAAAAAAAHAAAAAAAAAAAAAAAAAAAAAAAAAAAAAAAAAAAAf39/ACUAAABYAAAAAAAAAAAAAAAAAAAAAAAAAAAAAAAAAAAAAAAAAAAAAAAAAAAAAAAAAAAAAAA/AAAAAAAAAKCGAQAAAAAAAAAAAAAAAAAMAAAAAQAAAAAAAAAAAAAAAAAAAB8AAABUAAAAu+DjBf///wEAAAAAAAAAAAAAAAAAAAAAAAAAAAAAAAAAAAAAAAAAAAAAAAJ/f38AgICAA8zMzADAwP8Af39/AAAAAAAAAAAAAAAAAAAAAAAAAAAAIQAAABgAAAAUAAAAVhgAAPoOAAAPIAAA+hAAABAAAAAmAAAACAAAAP//////////"/>
+                <pr:smNativeData xmlns:pr="smNativeData" xmlns="smNativeData" val="SMDATA_15_ZqHWaRMAAAAlAAAADwAAAA8BAAAAkAAAAEgAAACQAAAASAAAAAAAAAAAAAAAAAAAAAEAAABQAAAAAAAAAACABMA3jx60mcXaPwAAAAAAAOA/AAAAAAAA4D8AAAAAAADgPwAAAAAAAOA/AAAAAAAA4D8AAAAAAADgPwAAAAAAAOA/AAAAAAAA4D8CAAAAjAAAAAAAAAAAAAAAu+DjDP///wgAAAAAAAAAAAAAAAAAAAAAAAAAAAAAAAAAAAAAZAAAAAEAAABAAAAAAAAAAAAAAAAAAAAAAAAAAAAAAAAAAAAAAAAAAAAAAAAAAAAAAAAAAAAAAAAAAAAAAAAAAAAAAAAAAAAAAAAAAAAAAAAAAAAAAAAAAAAAAAAAAAAAFAAAADwAAAABAAAAAgAAAAAAAAkUAAAAAQAAABQAAAAUAAAAFAAAAAEAAAAAAAAAZAAAAGQAAAABAAAAlgAAAJYAAAAVAAAAYAAAAAAAAAAAAAAADwAAACADAAAAAAAAAAAAAAEAAACgMgAAVgcAAKr4//8BAAAAf39/AAEAAABkAAAAAAAAABQAAABAHwAAAAAAACYAAAAAAAAAwOD//wAAAAAmAAAAZAAAABYAAABMAAAAAAAAAAAAAAAEAAAAAAAAAAEAAACAgIAKAAAAACgAAAAoAAAAZAAAAGQAAAAAAAAAzMzMAAAAAABQAAAAUAAAAGQAAABkAAAAAAAAABcAAAAUAAAAAAAAAAAAAAD/fwAA/38AAAAAAAAJAAAABAAAAAAAAAAeAAAAaAAAAAAAAAAAAAAAAAAAAAAAAAAAAAAAECcAABAnAAAAAAAAAAAAAAAAAAAAAAAAAAAAAAAAAAAAAAAAAAAAABQAAAAAAAAAwMD/AAAAAABkAAAAMgAAAAAAAABkAAAAAAAAAH9/fwAKAAAAIgAAABgAAAAAAAAAAAAAAAAAAAAAAAAAAAAAAAAAAAAkAAAAJAAAAAAAAAAHAAAAAAAAAAAAAAAAAAAAAAAAAAAAAAAAAAAAf39/ACUAAABYAAAAAAAAAAAAAAAAAAAAAAAAAAAAAAAAAAAAAAAAAAAAAAAAAAAAAAAAAAAAAAA/AAAAAAAAAKCGAQAAAAAAAAAAAAAAAAAMAAAAAQAAAAAAAAAAAAAAAAAAAB8AAABUAAAAu+DjBf///wEAAAAAAAAAAAAAAAAAAAAAAAAAAAAAAAAAAAAAAAAAAAAAAAJ/f38AgICAA8zMzADAwP8Af39/AAAAAAAAAAAAAAAAAAAAAAAAAAAAIQAAABgAAAAUAAAAVhgAAPoOAAAPIAAA+hAAABAAAAAmAAAACAAAAP//////////"/>
               </a:ext>
             </a:extLst>
           </p:cNvCxnSpPr>
@@ -5779,7 +5779,7 @@
             <a:endCxn id="2" idx="1"/>
             <a:extLst>
               <a:ext uri="smNativeData">
-                <pr:smNativeData xmlns:pr="smNativeData" xmlns="smNativeData" val="SMDATA_15_7aDWaRMAAAAlAAAADQAAAA8BAAAAkAAAAEgAAACQAAAASAAAAAAAAAAAAAAAAAAAAAEAAABQAAAAAAAAAAAA4D8AAAAAAADgPwAAAAAAAOA/AAAAAAAA4D8AAAAAAADgPwAAAAAAAOA/AAAAAAAA4D8AAAAAAADgPwAAAAAAAOA/AAAAAAAA4D8CAAAAjAAAAAAAAAAAAAAAu+DjDP///wgAAAAAAAAAAAAAAAAAAAAAAAAAAAAAAAAAAAAAZAAAAAEAAABAAAAAAAAAAAAAAAAAAAAAAAAAAAAAAAAAAAAAAAAAAAAAAAAAAAAAAAAAAAAAAAAAAAAAAAAAAAAAAAAAAAAAAAAAAAAAAAAAAAAAAAAAAAAAAAAAAAAAFAAAADwAAAABAAAAAAAAAAAAAAkUAAAAAQAAABQAAAAUAAAAFAAAAAEAAAAAAAAAZAAAAGQAAAABAAAAlgAAAJYAAAAVAAAAYAAAAAAAAAAAAAAADwAAACADAAAAAAAAAAAAAAEAAACgMgAAVgcAAKr4//8BAAAAf39/AAEAAABkAAAAAAAAABQAAABAHwAAAAAAACYAAAAAAAAAwOD//wAAAAAmAAAAZAAAABYAAABMAAAAAAAAAAAAAAAEAAAAAAAAAAEAAACAgIAKAAAAACgAAAAoAAAAZAAAAGQAAAAAAAAAzMzMAAAAAABQAAAAUAAAAGQAAABkAAAAAAAAABcAAAAUAAAAAAAAAAAAAAD/fwAA/38AAAAAAAAJAAAABAAAAAAAAAAeAAAAaAAAAAAAAAAAAAAAAAAAAAAAAAAAAAAAECcAABAnAAAAAAAAAAAAAAAAAAAAAAAAAAAAAAAAAAAAAAAAAAAAABQAAAAAAAAAwMD/AAAAAABkAAAAMgAAAAAAAABkAAAAAAAAAH9/fwAKAAAAIgAAABgAAAAAAAAAAAAAAAAAAAAAAAAAAAAAAAAAAAAkAAAAJAAAAAAAAAAHAAAAAAAAAAAAAAAAAAAAAAAAAAAAAAAAAAAAf39/ACUAAABYAAAAAAAAAAAAAAAAAAAAAAAAAAAAAAAAAAAAAAAAAAAAAAAAAAAAAAAAAAAAAAA/AAAAAAAAAKCGAQAAAAAAAAAAAAAAAAAMAAAAAQAAAAAAAAAAAAAAAAAAAB8AAABUAAAAu+DjBf///wEAAAAAAAAAAAAAAAAAAAAAAAAAAAAAAAAAAAAAAAAAAAAAAAJ/f38AgICAA8zMzADAwP8Af39/AAAAAAAAAAAAAAAAAAAAAAAAAAAAIQAAABgAAAAUAAAAhxwAAPoOAAAPIAAA/g4AABAAAAAmAAAACAAAAP//////////"/>
+                <pr:smNativeData xmlns:pr="smNativeData" xmlns="smNativeData" val="SMDATA_15_ZqHWaRMAAAAlAAAADQAAAA8BAAAAkAAAAEgAAACQAAAASAAAAAAAAAAAAAAAAAAAAAEAAABQAAAAAAAAAAAA4D8AAAAAAADgPwAAAAAAAOA/AAAAAAAA4D8AAAAAAADgPwAAAAAAAOA/AAAAAAAA4D8AAAAAAADgPwAAAAAAAOA/AAAAAAAA4D8CAAAAjAAAAAAAAAAAAAAAu+DjDP///wgAAAAAAAAAAAAAAAAAAAAAAAAAAAAAAAAAAAAAZAAAAAEAAABAAAAAAAAAAAAAAAAAAAAAAAAAAAAAAAAAAAAAAAAAAAAAAAAAAAAAAAAAAAAAAAAAAAAAAAAAAAAAAAAAAAAAAAAAAAAAAAAAAAAAAAAAAAAAAAAAAAAAFAAAADwAAAABAAAAAAAAAAAAAAkUAAAAAQAAABQAAAAUAAAAFAAAAAEAAAAAAAAAZAAAAGQAAAABAAAAlgAAAJYAAAAVAAAAYAAAAAAAAAAAAAAADwAAACADAAAAAAAAAAAAAAEAAACgMgAAVgcAAKr4//8BAAAAf39/AAEAAABkAAAAAAAAABQAAABAHwAAAAAAACYAAAAAAAAAwOD//wAAAAAmAAAAZAAAABYAAABMAAAAAAAAAAAAAAAEAAAAAAAAAAEAAACAgIAKAAAAACgAAAAoAAAAZAAAAGQAAAAAAAAAzMzMAAAAAABQAAAAUAAAAGQAAABkAAAAAAAAABcAAAAUAAAAAAAAAAAAAAD/fwAA/38AAAAAAAAJAAAABAAAAAAAAAAeAAAAaAAAAAAAAAAAAAAAAAAAAAAAAAAAAAAAECcAABAnAAAAAAAAAAAAAAAAAAAAAAAAAAAAAAAAAAAAAAAAAAAAABQAAAAAAAAAwMD/AAAAAABkAAAAMgAAAAAAAABkAAAAAAAAAH9/fwAKAAAAIgAAABgAAAAAAAAAAAAAAAAAAAAAAAAAAAAAAAAAAAAkAAAAJAAAAAAAAAAHAAAAAAAAAAAAAAAAAAAAAAAAAAAAAAAAAAAAf39/ACUAAABYAAAAAAAAAAAAAAAAAAAAAAAAAAAAAAAAAAAAAAAAAAAAAAAAAAAAAAAAAAAAAAA/AAAAAAAAAKCGAQAAAAAAAAAAAAAAAAAMAAAAAQAAAAAAAAAAAAAAAAAAAB8AAABUAAAAu+DjBf///wEAAAAAAAAAAAAAAAAAAAAAAAAAAAAAAAAAAAAAAAAAAAAAAAJ/f38AgICAA8zMzADAwP8Af39/AAAAAAAAAAAAAAAAAAAAAAAAAAAAIQAAABgAAAAUAAAAhxwAAPoOAAAPIAAA/g4AABAAAAAmAAAACAAAAP//////////"/>
               </a:ext>
             </a:extLst>
           </p:cNvCxnSpPr>
@@ -5813,7 +5813,7 @@
             <a:endCxn id="5" idx="3"/>
             <a:extLst>
               <a:ext uri="smNativeData">
-                <pr:smNativeData xmlns:pr="smNativeData" xmlns="smNativeData" val="SMDATA_15_7aDWaRMAAAAlAAAADQAAAA8BAAAAkAAAAEgAAACQAAAASAAAAAAAAAAAAAAAAAAAAAEAAABQAAAAAAAAAAAA4D8AAAAAAADgPwAAAAAAAOA/AAAAAAAA4D8AAAAAAADgPwAAAAAAAOA/AAAAAAAA4D8AAAAAAADgPwAAAAAAAOA/AAAAAAAA4D8CAAAAjAAAAAAAAAAAAAAAu+DjDP///wgAAAAAAAAAAAAAAAAAAAAAAAAAAAAAAAAAAAAAZAAAAAEAAABAAAAAAAAAAAAAAAAAAAAAAAAAAAAAAAAAAAAAAAAAAAAAAAAAAAAAAAAAAAAAAAAAAAAAAAAAAAAAAAAAAAAAAAAAAAAAAAAAAAAAAAAAAAAAAAAAAAAAFAAAADwAAAABAAAAAAAAAAAAAAkUAAAAAQAAABQAAAAUAAAAFAAAAAEAAAAAAAAAZAAAAGQAAAABAAAAlgAAAJYAAAAVAAAAYAAAAAAAAAAAAAAADwAAACADAAAAAAAAAAAAAAEAAACgMgAAVgcAAKr4//8BAAAAf39/AAEAAABkAAAAAAAAABQAAABAHwAAAAAAACYAAAAAAAAAwOD//wAAAAAmAAAAZAAAABYAAABMAAAAAAAAAAAAAAAEAAAAAAAAAAEAAACAgIAKAAAAACgAAAAoAAAAZAAAAGQAAAAAAAAAzMzMAAAAAABQAAAAUAAAAGQAAABkAAAAAAAAABcAAAAUAAAAAAAAAAAAAAD/fwAA/38AAAAAAAAJAAAABAAAAAAAAQAeAAAAaAAAAAAAAAAAAAAAAAAAAAAAAAAAAAAAECcAABAnAAAAAAAAAAAAAAAAAAAAAAAAAAAAAAAAAAAAAAAAAAAAABQAAAAAAAAAwMD/AAAAAABkAAAAMgAAAAAAAABkAAAAAAAAAH9/fwAKAAAAIgAAABgAAAAAAAAAAAAAAAAAAAAAAAAAAAAAAAAAAAAkAAAAJAAAAAAAAAAHAAAAAAAAAAAAAAAAAAAAAAAAAAAAAAAAAAAAf39/ACUAAABYAAAAAAAAAAAAAAAAAAAAAAAAAAAAAAAAAAAAAAAAAAAAAAAAAAAAAAAAAAAAAAA/AAAAAAAAAKCGAQAAAAAAAAAAAAAAAAAMAAAAAQAAAAAAAAAAAAAAAAAAAB8AAABUAAAAu+DjBf///wEAAAAAAAAAAAAAAAAAAAAAAAAAAAAAAAAAAAAAAAAAAAAAAAJ/f38AgICAA8zMzADAwP8Af39/AAAAAAAAAAAAAAAAAAAAAAAAAAAAIQAAABgAAAAUAAAA7xEAAP4OAAAkFAAAAQ8AABAAAAAmAAAACAAAAP//////////"/>
+                <pr:smNativeData xmlns:pr="smNativeData" xmlns="smNativeData" val="SMDATA_15_ZqHWaRMAAAAlAAAADQAAAA8BAAAAkAAAAEgAAACQAAAASAAAAAAAAAAAAAAAAAAAAAEAAABQAAAAAAAAAAAA4D8AAAAAAADgPwAAAAAAAOA/AAAAAAAA4D8AAAAAAADgPwAAAAAAAOA/AAAAAAAA4D8AAAAAAADgPwAAAAAAAOA/AAAAAAAA4D8CAAAAjAAAAAAAAAAAAAAAu+DjDP///wgAAAAAAAAAAAAAAAAAAAAAAAAAAAAAAAAAAAAAZAAAAAEAAABAAAAAAAAAAAAAAAAAAAAAAAAAAAAAAAAAAAAAAAAAAAAAAAAAAAAAAAAAAAAAAAAAAAAAAAAAAAAAAAAAAAAAAAAAAAAAAAAAAAAAAAAAAAAAAAAAAAAAFAAAADwAAAABAAAAAAAAAAAAAAkUAAAAAQAAABQAAAAUAAAAFAAAAAEAAAAAAAAAZAAAAGQAAAABAAAAlgAAAJYAAAAVAAAAYAAAAAAAAAAAAAAADwAAACADAAAAAAAAAAAAAAEAAACgMgAAVgcAAKr4//8BAAAAf39/AAEAAABkAAAAAAAAABQAAABAHwAAAAAAACYAAAAAAAAAwOD//wAAAAAmAAAAZAAAABYAAABMAAAAAAAAAAAAAAAEAAAAAAAAAAEAAACAgIAKAAAAACgAAAAoAAAAZAAAAGQAAAAAAAAAzMzMAAAAAABQAAAAUAAAAGQAAABkAAAAAAAAABcAAAAUAAAAAAAAAAAAAAD/fwAA/38AAAAAAAAJAAAABAAAAAAAAQAeAAAAaAAAAAAAAAAAAAAAAAAAAAAAAAAAAAAAECcAABAnAAAAAAAAAAAAAAAAAAAAAAAAAAAAAAAAAAAAAAAAAAAAABQAAAAAAAAAwMD/AAAAAABkAAAAMgAAAAAAAABkAAAAAAAAAH9/fwAKAAAAIgAAABgAAAAAAAAAAAAAAAAAAAAAAAAAAAAAAAAAAAAkAAAAJAAAAAAAAAAHAAAAAAAAAAAAAAAAAAAAAAAAAAAAAAAAAAAAf39/ACUAAABYAAAAAAAAAAAAAAAAAAAAAAAAAAAAAAAAAAAAAAAAAAAAAAAAAAAAAAAAAAAAAAA/AAAAAAAAAKCGAQAAAAAAAAAAAAAAAAAMAAAAAQAAAAAAAAAAAAAAAAAAAB8AAABUAAAAu+DjBf///wEAAAAAAAAAAAAAAAAAAAAAAAAAAAAAAAAAAAAAAAAAAAAAAAJ/f38AgICAA8zMzADAwP8Af39/AAAAAAAAAAAAAAAAAAAAAAAAAAAAIQAAABgAAAAUAAAA7xEAAP4OAAAkFAAAAQ8AABAAAAAmAAAACAAAAP//////////"/>
               </a:ext>
             </a:extLst>
           </p:cNvCxnSpPr>
@@ -5847,7 +5847,7 @@
             <a:endCxn id="4" idx="2"/>
             <a:extLst>
               <a:ext uri="smNativeData">
-                <pr:smNativeData xmlns:pr="smNativeData" xmlns="smNativeData" val="SMDATA_15_7aDWaRMAAAAlAAAADQAAAA8BAAAAkAAAAEgAAACQAAAASAAAAAAAAAAAAAAAAAAAAAEAAABQAAAAAAAAAAAA4D8AAAAAAADgPwAAAAAAAOA/AAAAAAAA4D8AAAAAAADgPwAAAAAAAOA/AAAAAAAA4D8AAAAAAADgPwAAAAAAAOA/AAAAAAAA4D8CAAAAjAAAAAAAAAAAAAAAu+DjDP///wgAAAAAAAAAAAAAAAAAAAAAAAAAAAAAAAAAAAAAZAAAAAEAAABAAAAAAAAAAAAAAAAAAAAAAAAAAAAAAAAAAAAAAAAAAAAAAAAAAAAAAAAAAAAAAAAAAAAAAAAAAAAAAAAAAAAAAAAAAAAAAAAAAAAAAAAAAAAAAAAAAAAAFAAAADwAAAABAAAAAAAAAAAAAAkUAAAAAQAAABQAAAAUAAAAFAAAAAEAAAAAAAAAZAAAAGQAAAABAAAAlgAAAJYAAAAVAAAAYAAAAAAAAAAAAAAADwAAACADAAAAAAAAAAAAAAEAAACgMgAAVgcAAKr4//8BAAAAf39/AAEAAABkAAAAAAAAABQAAABAHwAAAAAAACYAAAAAAAAAwOD//wAAAAAmAAAAZAAAABYAAABMAAAAAAAAAAAAAAAEAAAAAAAAAAEAAACAgIAKAAAAACgAAAAoAAAAZAAAAGQAAAAAAAAAzMzMAAAAAABQAAAAUAAAAGQAAABkAAAAAAAAABcAAAAUAAAAAAAAAAAAAAD/fwAA/38AAAAAAAAJAAAABAAAAAsAAAAeAAAAaAAAAAAAAAAAAAAAAAAAAAAAAAAAAAAAECcAABAnAAAAAAAAAAAAAAAAAAAAAAAAAAAAAAAAAAAAAAAAAAAAABQAAAAAAAAAwMD/AAAAAABkAAAAMgAAAAAAAABkAAAAAAAAAH9/fwAKAAAAIgAAABgAAAAAAAAAAAAAAAAAAAAAAAAAAAAAAAAAAAAkAAAAJAAAAAAAAAAHAAAAAAAAAAAAAAAAAAAAAAAAAAAAAAAAAAAAf39/ACUAAABYAAAAAAAAAAAAAAAAAAAAAAAAAAAAAAAAAAAAAAAAAAAAAAAAAAAAAAAAAAAAAAA/AAAAAAAAAKCGAQAAAAAAAAAAAAAAAAAMAAAAAQAAAAAAAAAAAAAAAAAAAB8AAABUAAAAu+DjBf///wEAAAAAAAAAAAAAAAAAAAAAAAAAAAAAAAAAAAAAAAAAAAAAAAJ/f38AgICAA8zMzADAwP8Af39/AAAAAAAAAAAAAAAAAAAAAAAAAAAAIQAAABgAAAAUAAAAUhgAAIsKAABWGAAAAQ0AABAAAAAmAAAACAAAAP//////////"/>
+                <pr:smNativeData xmlns:pr="smNativeData" xmlns="smNativeData" val="SMDATA_15_ZqHWaRMAAAAlAAAADQAAAA8BAAAAkAAAAEgAAACQAAAASAAAAAAAAAAAAAAAAAAAAAEAAABQAAAAAAAAAAAA4D8AAAAAAADgPwAAAAAAAOA/AAAAAAAA4D8AAAAAAADgPwAAAAAAAOA/AAAAAAAA4D8AAAAAAADgPwAAAAAAAOA/AAAAAAAA4D8CAAAAjAAAAAAAAAAAAAAAu+DjDP///wgAAAAAAAAAAAAAAAAAAAAAAAAAAAAAAAAAAAAAZAAAAAEAAABAAAAAAAAAAAAAAAAAAAAAAAAAAAAAAAAAAAAAAAAAAAAAAAAAAAAAAAAAAAAAAAAAAAAAAAAAAAAAAAAAAAAAAAAAAAAAAAAAAAAAAAAAAAAAAAAAAAAAFAAAADwAAAABAAAAAAAAAAAAAAkUAAAAAQAAABQAAAAUAAAAFAAAAAEAAAAAAAAAZAAAAGQAAAABAAAAlgAAAJYAAAAVAAAAYAAAAAAAAAAAAAAADwAAACADAAAAAAAAAAAAAAEAAACgMgAAVgcAAKr4//8BAAAAf39/AAEAAABkAAAAAAAAABQAAABAHwAAAAAAACYAAAAAAAAAwOD//wAAAAAmAAAAZAAAABYAAABMAAAAAAAAAAAAAAAEAAAAAAAAAAEAAACAgIAKAAAAACgAAAAoAAAAZAAAAGQAAAAAAAAAzMzMAAAAAABQAAAAUAAAAGQAAABkAAAAAAAAABcAAAAUAAAAAAAAAAAAAAD/fwAA/38AAAAAAAAJAAAABAAAAAsAAAAeAAAAaAAAAAAAAAAAAAAAAAAAAAAAAAAAAAAAECcAABAnAAAAAAAAAAAAAAAAAAAAAAAAAAAAAAAAAAAAAAAAAAAAABQAAAAAAAAAwMD/AAAAAABkAAAAMgAAAAAAAABkAAAAAAAAAH9/fwAKAAAAIgAAABgAAAAAAAAAAAAAAAAAAAAAAAAAAAAAAAAAAAAkAAAAJAAAAAAAAAAHAAAAAAAAAAAAAAAAAAAAAAAAAAAAAAAAAAAAf39/ACUAAABYAAAAAAAAAAAAAAAAAAAAAAAAAAAAAAAAAAAAAAAAAAAAAAAAAAAAAAAAAAAAAAA/AAAAAAAAAKCGAQAAAAAAAAAAAAAAAAAMAAAAAQAAAAAAAAAAAAAAAAAAAB8AAABUAAAAu+DjBf///wEAAAAAAAAAAAAAAAAAAAAAAAAAAAAAAAAAAAAAAAAAAAAAAAJ/f38AgICAA8zMzADAwP8Af39/AAAAAAAAAAAAAAAAAAAAAAAAAAAAIQAAABgAAAAUAAAAUhgAAIsKAABWGAAAAQ0AABAAAAAmAAAACAAAAP//////////"/>
               </a:ext>
             </a:extLst>
           </p:cNvCxnSpPr>
@@ -5879,7 +5879,7 @@
           <p:cNvGrpSpPr>
             <a:extLst>
               <a:ext uri="smNativeData">
-                <pr:smNativeData xmlns:pr="smNativeData" xmlns="smNativeData" val="SMDATA_6_7aDWaRMAAAAlAAAAAQAAAA8BAAAAkAAAAEgAAACQAAAASAAAAAAAAAAAAAAAAAAAABcAAAAUAAAAAAAAAAAAAAD/fwAA/38AAAAAAAAJAAAABAAAAA8AAAAfAAAAVAAAAAAAAAAAAAAAAAAAAAAAAAAAAAAAAAAAAAAAAAAAAAAAAAAAAAAAAAAAAAAAAAAAAAAAAAAAAAAAAAAAAAAAAAAAAAAAAAAAAAAAAAAAAAAAAAAAACEAAAAYAAAAFAAAABooAACqIAAA4TAAALQjAAAQAAAAJgAAAAgAAAD/////AAAAAA=="/>
+                <pr:smNativeData xmlns:pr="smNativeData" xmlns="smNativeData" val="SMDATA_6_ZqHWaRMAAAAlAAAAAQAAAA8BAAAAkAAAAEgAAACQAAAASAAAAAAAAAAAAAAAAAAAABcAAAAUAAAAAAAAAAAAAAD/fwAA/38AAAAAAAAJAAAABAAAAA8AAAAfAAAAVAAAAAAAAAAAAAAAAAAAAAAAAAAAAAAAAAAAAAAAAAAAAAAAAAAAAAAAAAAAAAAAAAAAAAAAAAAAAAAAAAAAAAAAAAAAAAAAAAAAAAAAAAAAAAAAAAAAACEAAAAYAAAAFAAAABooAACqIAAA4TAAALQjAAAQAAAAJgAAAAgAAAD/////AAAAAA=="/>
               </a:ext>
             </a:extLst>
           </p:cNvGrpSpPr>
@@ -5899,7 +5899,7 @@
             <p:cNvSpPr txBox="1">
               <a:extLst>
                 <a:ext uri="smNativeData">
-                  <pr:smNativeData xmlns:pr="smNativeData" xmlns="smNativeData" val="SMDATA_15_7aDWaRMAAAAlAAAAEgAAAA8BAAAAkAAAAEgAAACQAAAASAAAAAAAAAABAAAAAAAAAAEAAABQAAAAAAAAAAAA4D8AAAAAAADgPwAAAAAAAOA/AAAAAAAA4D8AAAAAAADgPwAAAAAAAOA/AAAAAAAA4D8AAAAAAADgPwAAAAAAAOA/AAAAAAAA4D8CAAAAjAAAAAEAAAAAAAAAAP8AAP///wgAAAAAAAAAAAAAAAAAAAAAAAAAAAAAAAAAAAAAZAAAAAEAAABAAAAAAAAAAAAAAAAAAAAAAAAAAAAAAAAAAAAAAAAAAAAAAAAAAAAAAAAAAAAAAAAAAAAAAAAAAAAAAAAAAAAAAAAAAAAAAAAAAAAAAAAAAAAAAAAAAAAAFAAAADwAAAABAAAAAAAAAAAAAAkUAAAAAQAAABQAAAAUAAAAFAAAAAEAAAAAAAAAZAAAAGQAAAAAAAAAZAAAAGQAAAAVAAAAYAAAAAAAAAAAAAAADwAAACADAAAAAAAAAAAAAAEAAACgMgAAVgcAAKr4//8BAAAAf39/AAEAAABkAAAAAAAAABQAAABAHwAAAAAAACYAAAAAAAAAwOD//wAAAAAmAAAAZAAAABYAAABMAAAAAAAAAAAAAAAEAAAAAAAAAAEAAACAgIAKAAAAACgAAAAoAAAAZAAAAGQAAAAAAAAAzMzMAAAAAABQAAAAUAAAAGQAAABkAAAAAAAAABcAAAAUAAAAAAAAAIgDAAD/fwAA/38AAAAAAAAJAAAABAAAACMAAAAeAAAAaAAAAAAAAAAAAAAAAAAAAAAAAAAAAAAAECcAABAnAAAAAAAAAAAAAAAAAAAAAAAAAAAAAAAAAAAAAAAAAAAAABQAAAAAAAAAwMD/AAAAAABkAAAAMgAAAAAAAABkAAAAAAAAAH9/fwAKAAAAIgAAABgAAAAAAAAAAAAAAAAAAAAAAAAAAAAAAAAAAAAkAAAAJAAAAAAAAAAHAAAAAAAAAAAAAAAAAAAAAAAAAAAAAAAAAAAAf39/ACUAAABYAAAAAAAAAAAAAAAAAAAAAAAAAAAAAAAAAAAAAAAAAAAAAAAAAAAAAAAAAAAAAAA/AAAAAAAAAKCGAQAAAAAAAAAAAAAAAAAMAAAAAQAAAAAAAAAAAAAAAAAAAB8AAABUAAAAAP8AAP///wEAAAAAAAAAAAAAAAAAAAAAAAAAAAAAAAAAAAAAAAAAAAAAAAJ/f38AgICAA8zMzADAwP8Af39/AAAAAAAAAAAAAAAAAAAAAAAAAAAAIQAAABgAAAAUAAAAfigAAA4hAADhMAAAtCMAAAAAAAAmAAAACAAAAP//////////"/>
+                  <pr:smNativeData xmlns:pr="smNativeData" xmlns="smNativeData" val="SMDATA_15_ZqHWaRMAAAAlAAAAEgAAAA8BAAAAkAAAAEgAAACQAAAASAAAAAAAAAABAAAAAAAAAAEAAABQAAAAAAAAAAAA4D8AAAAAAADgPwAAAAAAAOA/AAAAAAAA4D8AAAAAAADgPwAAAAAAAOA/AAAAAAAA4D8AAAAAAADgPwAAAAAAAOA/AAAAAAAA4D8CAAAAjAAAAAEAAAAAAAAAAP8AAP///wgAAAAAAAAAAAAAAAAAAAAAAAAAAAAAAAAAAAAAZAAAAAEAAABAAAAAAAAAAAAAAAAAAAAAAAAAAAAAAAAAAAAAAAAAAAAAAAAAAAAAAAAAAAAAAAAAAAAAAAAAAAAAAAAAAAAAAAAAAAAAAAAAAAAAAAAAAAAAAAAAAAAAFAAAADwAAAABAAAAAAAAAAAAAAkUAAAAAQAAABQAAAAUAAAAFAAAAAEAAAAAAAAAZAAAAGQAAAAAAAAAZAAAAGQAAAAVAAAAYAAAAAAAAAAAAAAADwAAACADAAAAAAAAAAAAAAEAAACgMgAAVgcAAKr4//8BAAAAf39/AAEAAABkAAAAAAAAABQAAABAHwAAAAAAACYAAAAAAAAAwOD//wAAAAAmAAAAZAAAABYAAABMAAAAAAAAAAAAAAAEAAAAAAAAAAEAAACAgIAKAAAAACgAAAAoAAAAZAAAAGQAAAAAAAAAzMzMAAAAAABQAAAAUAAAAGQAAABkAAAAAAAAABcAAAAUAAAAAAAAAIgDAAD/fwAA/38AAAAAAAAJAAAABAAAACMAAAAeAAAAaAAAAAAAAAAAAAAAAAAAAAAAAAAAAAAAECcAABAnAAAAAAAAAAAAAAAAAAAAAAAAAAAAAAAAAAAAAAAAAAAAABQAAAAAAAAAwMD/AAAAAABkAAAAMgAAAAAAAABkAAAAAAAAAH9/fwAKAAAAIgAAABgAAAAAAAAAAAAAAAAAAAAAAAAAAAAAAAAAAAAkAAAAJAAAAAAAAAAHAAAAAAAAAAAAAAAAAAAAAAAAAAAAAAAAAAAAf39/ACUAAABYAAAAAAAAAAAAAAAAAAAAAAAAAAAAAAAAAAAAAAAAAAAAAAAAAAAAAAAAAAAAAAA/AAAAAAAAAKCGAQAAAAAAAAAAAAAAAAAMAAAAAQAAAAAAAAAAAAAAAAAAAB8AAABUAAAAAP8AAP///wEAAAAAAAAAAAAAAAAAAAAAAAAAAAAAAAAAAAAAAAAAAAAAAAJ/f38AgICAA8zMzADAwP8Af39/AAAAAAAAAAAAAAAAAAAAAAAAAAAAIQAAABgAAAAUAAAAfigAAA4hAADhMAAAtCMAAAAAAAAmAAAACAAAAP//////////"/>
                 </a:ext>
               </a:extLst>
             </p:cNvSpPr>
@@ -5943,7 +5943,7 @@
             <p:cNvSpPr txBox="1">
               <a:extLst>
                 <a:ext uri="smNativeData">
-                  <pr:smNativeData xmlns:pr="smNativeData" xmlns="smNativeData" val="SMDATA_15_7aDWaRMAAAAlAAAAEgAAAA8BAAAAkAAAAEgAAACQAAAASAAAAAAAAAABAAAAAAAAAAEAAABQAAAAAAAAAAAA4D8AAAAAAADgPwAAAAAAAOA/AAAAAAAA4D8AAAAAAADgPwAAAAAAAOA/AAAAAAAA4D8AAAAAAADgPwAAAAAAAOA/AAAAAAAA4D8CAAAAjAAAAAEAAAAAAAAAAP8AAP///wgAAAAAAAAAAAAAAAAAAAAAAAAAAAAAAAAAAAAAZAAAAAEAAABAAAAAAAAAAAAAAAAAAAAAAAAAAAAAAAAAAAAAAAAAAAAAAAAAAAAAAAAAAAAAAAAAAAAAAAAAAAAAAAAAAAAAAAAAAAAAAAAAAAAAAAAAAAAAAAAAAAAAFAAAADwAAAABAAAAAAAAAAAAAAkUAAAAAQAAABQAAAAUAAAAFAAAAAEAAAAAAAAAZAAAAGQAAAAAAAAAZAAAAGQAAAAVAAAAYAAAAAAAAAAAAAAADwAAACADAAAAAAAAAAAAAAEAAACgMgAAVgcAAKr4//8BAAAAf39/AAEAAABkAAAAAAAAABQAAABAHwAAAAAAACYAAAAAAAAAwOD//wAAAAAmAAAAZAAAABYAAABMAAAAAAAAAAAAAAAEAAAAAAAAAAEAAACAgIAKAAAAACgAAAAoAAAAZAAAAGQAAAAAAAAAzMzMAAAAAABQAAAAUAAAAGQAAABkAAAAAAAAABcAAAAUAAAAAAAAAIgDAAD/fwAA/38AAAAAAAAJAAAABAAAAAAAAAAeAAAAaAAAAAAAAAAAAAAAAAAAAAAAAAAAAAAAECcAABAnAAAAAAAAAAAAAAAAAAAAAAAAAAAAAAAAAAAAAAAAAAAAABQAAAAAAAAAwMD/AAAAAABkAAAAMgAAAAAAAABkAAAAAAAAAH9/fwAKAAAAIgAAABgAAAAAAAAAAAAAAAAAAAAAAAAAAAAAAAAAAAAkAAAAJAAAAAAAAAAHAAAAAAAAAAAAAAAAAAAAAAAAAAAAAAAAAAAAf39/ACUAAABYAAAAAAAAAAAAAAAAAAAAAAAAAAAAAAAAAAAAAAAAAAAAAAAAAAAAAAAAAAAAAAA/AAAAAAAAAKCGAQAAAAAAAAAAAAAAAAAMAAAAAQAAAAAAAAAAAAAAAAAAAB8AAABUAAAAAP8AAP///wEAAAAAAAAAAAAAAAAAAAAAAAAAAAAAAAAAAAAAAAAAAAAAAAJ/f38AgICAA8zMzADAwP8Af39/AAAAAAAAAAAAAAAAAAAAAAAAAAAAIQAAABgAAAAUAAAAGigAAKogAAB9MAAAUCMAAAAAAAAmAAAACAAAAP//////////"/>
+                  <pr:smNativeData xmlns:pr="smNativeData" xmlns="smNativeData" val="SMDATA_15_ZqHWaRMAAAAlAAAAEgAAAA8BAAAAkAAAAEgAAACQAAAASAAAAAAAAAABAAAAAAAAAAEAAABQAAAAAAAAAAAA4D8AAAAAAADgPwAAAAAAAOA/AAAAAAAA4D8AAAAAAADgPwAAAAAAAOA/AAAAAAAA4D8AAAAAAADgPwAAAAAAAOA/AAAAAAAA4D8CAAAAjAAAAAEAAAAAAAAAAP8AAP///wgAAAAAAAAAAAAAAAAAAAAAAAAAAAAAAAAAAAAAZAAAAAEAAABAAAAAAAAAAAAAAAAAAAAAAAAAAAAAAAAAAAAAAAAAAAAAAAAAAAAAAAAAAAAAAAAAAAAAAAAAAAAAAAAAAAAAAAAAAAAAAAAAAAAAAAAAAAAAAAAAAAAAFAAAADwAAAABAAAAAAAAAAAAAAkUAAAAAQAAABQAAAAUAAAAFAAAAAEAAAAAAAAAZAAAAGQAAAAAAAAAZAAAAGQAAAAVAAAAYAAAAAAAAAAAAAAADwAAACADAAAAAAAAAAAAAAEAAACgMgAAVgcAAKr4//8BAAAAf39/AAEAAABkAAAAAAAAABQAAABAHwAAAAAAACYAAAAAAAAAwOD//wAAAAAmAAAAZAAAABYAAABMAAAAAAAAAAAAAAAEAAAAAAAAAAEAAACAgIAKAAAAACgAAAAoAAAAZAAAAGQAAAAAAAAAzMzMAAAAAABQAAAAUAAAAGQAAABkAAAAAAAAABcAAAAUAAAAAAAAAIgDAAD/fwAA/38AAAAAAAAJAAAABAAAAAAAAAAeAAAAaAAAAAAAAAAAAAAAAAAAAAAAAAAAAAAAECcAABAnAAAAAAAAAAAAAAAAAAAAAAAAAAAAAAAAAAAAAAAAAAAAABQAAAAAAAAAwMD/AAAAAABkAAAAMgAAAAAAAABkAAAAAAAAAH9/fwAKAAAAIgAAABgAAAAAAAAAAAAAAAAAAAAAAAAAAAAAAAAAAAAkAAAAJAAAAAAAAAAHAAAAAAAAAAAAAAAAAAAAAAAAAAAAAAAAAAAAf39/ACUAAABYAAAAAAAAAAAAAAAAAAAAAAAAAAAAAAAAAAAAAAAAAAAAAAAAAAAAAAAAAAAAAAA/AAAAAAAAAKCGAQAAAAAAAAAAAAAAAAAMAAAAAQAAAAAAAAAAAAAAAAAAAB8AAABUAAAAAP8AAP///wEAAAAAAAAAAAAAAAAAAAAAAAAAAAAAAAAAAAAAAAAAAAAAAAJ/f38AgICAA8zMzADAwP8Af39/AAAAAAAAAAAAAAAAAAAAAAAAAAAAIQAAABgAAAAUAAAAGigAAKogAAB9MAAAUCMAAAAAAAAmAAAACAAAAP//////////"/>
                 </a:ext>
               </a:extLst>
             </p:cNvSpPr>
@@ -5988,7 +5988,7 @@
           <p:cNvCxnSpPr>
             <a:extLst>
               <a:ext uri="smNativeData">
-                <pr:smNativeData xmlns:pr="smNativeData" xmlns="smNativeData" val="SMDATA_15_7aDWaRMAAAAlAAAADQAAAA8BAAAAkAAAAEgAAACQAAAASAAAAAAAAAAAAAAAAAAAAAEAAABQAAAAAAAAAAAA4D8AAAAAAADgPwAAAAAAAOA/AAAAAAAA4D8AAAAAAADgPwAAAAAAAOA/AAAAAAAA4D8AAAAAAADgPwAAAAAAAOA/AAAAAAAA4D8CAAAAjAAAAAAAAAAAAAAAu+DjDP///wgAAAAAAAAAAAAAAAAAAAAAAAAAAAAAAAAAAAAAZAAAAAEAAABAAAAAAAAAAAAAAAAAAAAAAAAAAAAAAAAAAAAAAAAAAAAAAAAAAAAAAAAAAAAAAAAAAAAAAAAAAAAAAAAAAAAAAAAAAAAAAAAAAAAAAAAAAAAAAAAAAAAAFAAAADwAAAABAAAAAAAAAAAAAAkUAAAAAQAAABQAAAAUAAAAFAAAAAEAAAAAAAAAZAAAAGQAAAABAAAAlgAAAJYAAAAVAAAAYAAAAAAAAAAAAAAADwAAACADAAAAAAAAAAAAAAEAAACgMgAAVgcAAKr4//8BAAAAf39/AAEAAABkAAAAAAAAABQAAABAHwAAAAAAACYAAAAAAAAAwOD//wAAAAAmAAAAZAAAABYAAABMAAAAAAAAAAAAAAAEAAAAAAAAAAEAAACAgIAKAAAAACgAAAAoAAAAZAAAAGQAAAAAAAAAzMzMAAAAAABQAAAAUAAAAGQAAABkAAAAAAAAABcAAAAUAAAAAAAAAAAAAAD/fwAA/38AAAAAAAAJAAAABAAAAAAAED4eAAAAaAAAAAAAAAAAAAAAAAAAAAAAAAAAAAAAECcAABAnAAAAAAAAAAAAAAAAAAAAAAAAAAAAAAAAAAAAAAAAAAAAABQAAAAAAAAAwMD/AAAAAABkAAAAMgAAAAAAAABkAAAAAAAAAH9/fwAKAAAAIgAAABgAAAAAAAAAAAAAAAAAAAAAAAAAAAAAAAAAAAAkAAAAJAAAAAAAAAAHAAAAAAAAAAAAAAAAAAAAAAAAAAAAAAAAAAAAf39/ACUAAABYAAAAAAAAAAAAAAAAAAAAAAAAAAAAAAAAAAAAAAAAAAAAAAAAAAAAAAAAAAAAAAA/AAAAAAAAAKCGAQAAAAAAAAAAAAAAAAAMAAAAAQAAAAAAAAAAAAAAAAAAAB8AAABUAAAAu+DjBf///wEAAAAAAAAAAAAAAAAAAAAAAAAAAAAAAAAAAAAAAAAAAAAAAAJ/f38AgICAA8zMzADAwP8Af39/AAAAAAAAAAAAAAAAAAAAAAAAAAAAIQAAABgAAAAUAAAAgSsAAJoeAACEKwAAqiAAABAAAAAmAAAACAAAAP//////////"/>
+                <pr:smNativeData xmlns:pr="smNativeData" xmlns="smNativeData" val="SMDATA_15_ZqHWaRMAAAAlAAAADQAAAA8BAAAAkAAAAEgAAACQAAAASAAAAAAAAAAAAAAAAAAAAAEAAABQAAAAAAAAAAAA4D8AAAAAAADgPwAAAAAAAOA/AAAAAAAA4D8AAAAAAADgPwAAAAAAAOA/AAAAAAAA4D8AAAAAAADgPwAAAAAAAOA/AAAAAAAA4D8CAAAAjAAAAAAAAAAAAAAAu+DjDP///wgAAAAAAAAAAAAAAAAAAAAAAAAAAAAAAAAAAAAAZAAAAAEAAABAAAAAAAAAAAAAAAAAAAAAAAAAAAAAAAAAAAAAAAAAAAAAAAAAAAAAAAAAAAAAAAAAAAAAAAAAAAAAAAAAAAAAAAAAAAAAAAAAAAAAAAAAAAAAAAAAAAAAFAAAADwAAAABAAAAAAAAAAAAAAkUAAAAAQAAABQAAAAUAAAAFAAAAAEAAAAAAAAAZAAAAGQAAAABAAAAlgAAAJYAAAAVAAAAYAAAAAAAAAAAAAAADwAAACADAAAAAAAAAAAAAAEAAACgMgAAVgcAAKr4//8BAAAAf39/AAEAAABkAAAAAAAAABQAAABAHwAAAAAAACYAAAAAAAAAwOD//wAAAAAmAAAAZAAAABYAAABMAAAAAAAAAAAAAAAEAAAAAAAAAAEAAACAgIAKAAAAACgAAAAoAAAAZAAAAGQAAAAAAAAAzMzMAAAAAABQAAAAUAAAAGQAAABkAAAAAAAAABcAAAAUAAAAAAAAAAAAAAD/fwAA/38AAAAAAAAJAAAABAAAAAAAED4eAAAAaAAAAAAAAAAAAAAAAAAAAAAAAAAAAAAAECcAABAnAAAAAAAAAAAAAAAAAAAAAAAAAAAAAAAAAAAAAAAAAAAAABQAAAAAAAAAwMD/AAAAAABkAAAAMgAAAAAAAABkAAAAAAAAAH9/fwAKAAAAIgAAABgAAAAAAAAAAAAAAAAAAAAAAAAAAAAAAAAAAAAkAAAAJAAAAAAAAAAHAAAAAAAAAAAAAAAAAAAAAAAAAAAAAAAAAAAAf39/ACUAAABYAAAAAAAAAAAAAAAAAAAAAAAAAAAAAAAAAAAAAAAAAAAAAAAAAAAAAAAAAAAAAAA/AAAAAAAAAKCGAQAAAAAAAAAAAAAAAAAMAAAAAQAAAAAAAAAAAAAAAAAAAB8AAABUAAAAu+DjBf///wEAAAAAAAAAAAAAAAAAAAAAAAAAAAAAAAAAAAAAAAAAAAAAAAJ/f38AgICAA8zMzADAwP8Af39/AAAAAAAAAAAAAAAAAAAAAAAAAAAAIQAAABgAAAAUAAAAgSsAAJoeAACEKwAAqiAAABAAAAAmAAAACAAAAP//////////"/>
               </a:ext>
             </a:extLst>
           </p:cNvCxnSpPr>
@@ -6021,7 +6021,7 @@
             <a:stCxn id="21" idx="2"/>
             <a:extLst>
               <a:ext uri="smNativeData">
-                <pr:smNativeData xmlns:pr="smNativeData" xmlns="smNativeData" val="SMDATA_15_7aDWaRMAAAAlAAAADQAAAA8BAAAAkAAAAEgAAACQAAAASAAAAAAAAAAAAAAAAAAAAAEAAABQAAAAAAAAAAAA4D8AAAAAAADgPwAAAAAAAOA/AAAAAAAA4D8AAAAAAADgPwAAAAAAAOA/AAAAAAAA4D8AAAAAAADgPwAAAAAAAOA/AAAAAAAA4D8CAAAAjAAAAAAAAAAAAAAAu+DjDP///wgAAAAAAAAAAAAAAAAAAAAAAAAAAAAAAAAAAAAAZAAAAAEAAABAAAAAAAAAAAAAAAAAAAAAAAAAAAAAAAAAAAAAAAAAAAAAAAAAAAAAAAAAAAAAAAAAAAAAAAAAAAAAAAAAAAAAAAAAAAAAAAAAAAAAAAAAAAAAAAAAAAAAFAAAADwAAAABAAAAAAAAAAAAAAkUAAAAAQAAABQAAAAUAAAAFAAAAAEAAAAAAAAAZAAAAGQAAAABAAAAlgAAAJYAAAAVAAAAYAAAAAAAAAAAAAAADwAAACADAAAAAAAAAAAAAAEAAACgMgAAVgcAAKr4//8BAAAAf39/AAEAAABkAAAAAAAAABQAAABAHwAAAAAAACYAAAAAAAAAwOD//wAAAAAmAAAAZAAAABYAAABMAAAAAAAAAAAAAAAEAAAAAAAAAAEAAACAgIAKAAAAACgAAAAoAAAAZAAAAGQAAAAAAAAAzMzMAAAAAABQAAAAUAAAAGQAAABkAAAAAAAAABcAAAAUAAAAAAAAAAAAAAD/fwAA/38AAAAAAAAJAAAABAAAAAAAAAAeAAAAaAAAAAAAAAAAAAAAAAAAAAAAAAAAAAAAECcAABAnAAAAAAAAAAAAAAAAAAAAAAAAAAAAAAAAAAAAAAAAAAAAABQAAAAAAAAAwMD/AAAAAABkAAAAMgAAAAAAAABkAAAAAAAAAH9/fwAKAAAAIgAAABgAAAAAAAAAAAAAAAAAAAAAAAAAAAAAAAAAAAAkAAAAJAAAAAAAAAAHAAAAAAAAAAAAAAAAAAAAAAAAAAAAAAAAAAAAf39/ACUAAABYAAAAAAAAAAAAAAAAAAAAAAAAAAAAAAAAAAAAAAAAAAAAAAAAAAAAAAAAAAAAAAA/AAAAAAAAAKCGAQAAAAAAAAAAAAAAAAAMAAAAAQAAAAAAAAAAAAAAAAAAAB8AAABUAAAAu+DjBf///wEAAAAAAAAAAAAAAAAAAAAAAAAAAAAAAAAAAAAAAAAAAAAAAAJ/f38AgICAA8zMzADAwP8Af39/AAAAAAAAAAAAAAAAAAAAAAAAAAAAIQAAABgAAAAUAAAAqBEAAHEeAACpEQAAaiAAABAAAAAmAAAACAAAAP//////////"/>
+                <pr:smNativeData xmlns:pr="smNativeData" xmlns="smNativeData" val="SMDATA_15_ZqHWaRMAAAAlAAAADQAAAA8BAAAAkAAAAEgAAACQAAAASAAAAAAAAAAAAAAAAAAAAAEAAABQAAAAAAAAAAAA4D8AAAAAAADgPwAAAAAAAOA/AAAAAAAA4D8AAAAAAADgPwAAAAAAAOA/AAAAAAAA4D8AAAAAAADgPwAAAAAAAOA/AAAAAAAA4D8CAAAAjAAAAAAAAAAAAAAAu+DjDP///wgAAAAAAAAAAAAAAAAAAAAAAAAAAAAAAAAAAAAAZAAAAAEAAABAAAAAAAAAAAAAAAAAAAAAAAAAAAAAAAAAAAAAAAAAAAAAAAAAAAAAAAAAAAAAAAAAAAAAAAAAAAAAAAAAAAAAAAAAAAAAAAAAAAAAAAAAAAAAAAAAAAAAFAAAADwAAAABAAAAAAAAAAAAAAkUAAAAAQAAABQAAAAUAAAAFAAAAAEAAAAAAAAAZAAAAGQAAAABAAAAlgAAAJYAAAAVAAAAYAAAAAAAAAAAAAAADwAAACADAAAAAAAAAAAAAAEAAACgMgAAVgcAAKr4//8BAAAAf39/AAEAAABkAAAAAAAAABQAAABAHwAAAAAAACYAAAAAAAAAwOD//wAAAAAmAAAAZAAAABYAAABMAAAAAAAAAAAAAAAEAAAAAAAAAAEAAACAgIAKAAAAACgAAAAoAAAAZAAAAGQAAAAAAAAAzMzMAAAAAABQAAAAUAAAAGQAAABkAAAAAAAAABcAAAAUAAAAAAAAAAAAAAD/fwAA/38AAAAAAAAJAAAABAAAAAAAAAAeAAAAaAAAAAAAAAAAAAAAAAAAAAAAAAAAAAAAECcAABAnAAAAAAAAAAAAAAAAAAAAAAAAAAAAAAAAAAAAAAAAAAAAABQAAAAAAAAAwMD/AAAAAABkAAAAMgAAAAAAAABkAAAAAAAAAH9/fwAKAAAAIgAAABgAAAAAAAAAAAAAAAAAAAAAAAAAAAAAAAAAAAAkAAAAJAAAAAAAAAAHAAAAAAAAAAAAAAAAAAAAAAAAAAAAAAAAAAAAf39/ACUAAABYAAAAAAAAAAAAAAAAAAAAAAAAAAAAAAAAAAAAAAAAAAAAAAAAAAAAAAAAAAAAAAA/AAAAAAAAAKCGAQAAAAAAAAAAAAAAAAAMAAAAAQAAAAAAAAAAAAAAAAAAAB8AAABUAAAAu+DjBf///wEAAAAAAAAAAAAAAAAAAAAAAAAAAAAAAAAAAAAAAAAAAAAAAAJ/f38AgICAA8zMzADAwP8Af39/AAAAAAAAAAAAAAAAAAAAAAAAAAAAIQAAABgAAAAUAAAAqBEAAHEeAACpEQAAaiAAABAAAAAmAAAACAAAAP//////////"/>
               </a:ext>
             </a:extLst>
           </p:cNvCxnSpPr>
@@ -6053,7 +6053,7 @@
           <p:cNvCxnSpPr>
             <a:extLst>
               <a:ext uri="smNativeData">
-                <pr:smNativeData xmlns:pr="smNativeData" xmlns="smNativeData" val="SMDATA_15_7aDWaRMAAAAlAAAADQAAAA8BAAAAkAAAAEgAAACQAAAASAAAAAAAAAAAAAAAAAAAAAEAAABQAAAAAAAAAAAA4D8AAAAAAADgPwAAAAAAAOA/AAAAAAAA4D8AAAAAAADgPwAAAAAAAOA/AAAAAAAA4D8AAAAAAADgPwAAAAAAAOA/AAAAAAAA4D8CAAAAjAAAAAAAAAAAAAAAu+DjDP///wgAAAAAAAAAAAAAAAAAAAAAAAAAAAAAAAAAAAAAZAAAAAEAAABAAAAAAAAAAAAAAAAAAAAAAAAAAAAAAAAAAAAAAAAAAAAAAAAAAAAAAAAAAAAAAAAAAAAAAAAAAAAAAAAAAAAAAAAAAAAAAAAAAAAAAAAAAAAAAAAAAAAAFAAAADwAAAABAAAAAAAAAAAAAAkUAAAAAQAAABQAAAAUAAAAFAAAAAEAAAAAAAAAZAAAAGQAAAABAAAAlgAAAJYAAAAVAAAAYAAAAAAAAAAAAAAADwAAACADAAAAAAAAAAAAAAEAAACgMgAAVgcAAKr4//8BAAAAf39/AAEAAABkAAAAAAAAABQAAABAHwAAAAAAACYAAAAAAAAAwOD//wAAAAAmAAAAZAAAABYAAABMAAAAAAAAAAAAAAAEAAAAAAAAAAEAAACAgIAKAAAAACgAAAAoAAAAZAAAAGQAAAAAAAAAzMzMAAAAAABQAAAAUAAAAGQAAABkAAAAAAAAABcAAAAUAAAAAAAAAAAAAAD/fwAA/38AAAAAAAAJAAAABAAAAAAAAAAeAAAAaAAAAAAAAAAAAAAAAAAAAAAAAAAAAAAAECcAABAnAAAAAAAAAAAAAAAAAAAAAAAAAAAAAAAAAAAAAAAAAAAAABQAAAAAAAAAwMD/AAAAAABkAAAAMgAAAAAAAABkAAAAAAAAAH9/fwAKAAAAIgAAABgAAAAAAAAAAAAAAAAAAAAAAAAAAAAAAAAAAAAkAAAAJAAAAAAAAAAHAAAAAAAAAAAAAAAAAAAAAAAAAAAAAAAAAAAAf39/ACUAAABYAAAAAAAAAAAAAAAAAAAAAAAAAAAAAAAAAAAAAAAAAAAAAAAAAAAAAAAAAAAAAAA/AAAAAAAAAKCGAQAAAAAAAAAAAAAAAAAMAAAAAQAAAAAAAAAAAAAAAAAAAB8AAABUAAAAu+DjBf///wEAAAAAAAAAAAAAAAAAAAAAAAAAAAAAAAAAAAAAAAAAAAAAAAJ/f38AgICAA8zMzADAwP8Af39/AAAAAAAAAAAAAAAAAAAAAAAAAAAAIQAAABgAAAAUAAAAqBEAABAjAACpEQAAqCQAABAAAAAmAAAACAAAAP//////////"/>
+                <pr:smNativeData xmlns:pr="smNativeData" xmlns="smNativeData" val="SMDATA_15_ZqHWaRMAAAAlAAAADQAAAA8BAAAAkAAAAEgAAACQAAAASAAAAAAAAAAAAAAAAAAAAAEAAABQAAAAAAAAAAAA4D8AAAAAAADgPwAAAAAAAOA/AAAAAAAA4D8AAAAAAADgPwAAAAAAAOA/AAAAAAAA4D8AAAAAAADgPwAAAAAAAOA/AAAAAAAA4D8CAAAAjAAAAAAAAAAAAAAAu+DjDP///wgAAAAAAAAAAAAAAAAAAAAAAAAAAAAAAAAAAAAAZAAAAAEAAABAAAAAAAAAAAAAAAAAAAAAAAAAAAAAAAAAAAAAAAAAAAAAAAAAAAAAAAAAAAAAAAAAAAAAAAAAAAAAAAAAAAAAAAAAAAAAAAAAAAAAAAAAAAAAAAAAAAAAFAAAADwAAAABAAAAAAAAAAAAAAkUAAAAAQAAABQAAAAUAAAAFAAAAAEAAAAAAAAAZAAAAGQAAAABAAAAlgAAAJYAAAAVAAAAYAAAAAAAAAAAAAAADwAAACADAAAAAAAAAAAAAAEAAACgMgAAVgcAAKr4//8BAAAAf39/AAEAAABkAAAAAAAAABQAAABAHwAAAAAAACYAAAAAAAAAwOD//wAAAAAmAAAAZAAAABYAAABMAAAAAAAAAAAAAAAEAAAAAAAAAAEAAACAgIAKAAAAACgAAAAoAAAAZAAAAGQAAAAAAAAAzMzMAAAAAABQAAAAUAAAAGQAAABkAAAAAAAAABcAAAAUAAAAAAAAAAAAAAD/fwAA/38AAAAAAAAJAAAABAAAAAAAAAAeAAAAaAAAAAAAAAAAAAAAAAAAAAAAAAAAAAAAECcAABAnAAAAAAAAAAAAAAAAAAAAAAAAAAAAAAAAAAAAAAAAAAAAABQAAAAAAAAAwMD/AAAAAABkAAAAMgAAAAAAAABkAAAAAAAAAH9/fwAKAAAAIgAAABgAAAAAAAAAAAAAAAAAAAAAAAAAAAAAAAAAAAAkAAAAJAAAAAAAAAAHAAAAAAAAAAAAAAAAAAAAAAAAAAAAAAAAAAAAf39/ACUAAABYAAAAAAAAAAAAAAAAAAAAAAAAAAAAAAAAAAAAAAAAAAAAAAAAAAAAAAAAAAAAAAA/AAAAAAAAAKCGAQAAAAAAAAAAAAAAAAAMAAAAAQAAAAAAAAAAAAAAAAAAAB8AAABUAAAAu+DjBf///wEAAAAAAAAAAAAAAAAAAAAAAAAAAAAAAAAAAAAAAAAAAAAAAAJ/f38AgICAA8zMzADAwP8Af39/AAAAAAAAAAAAAAAAAAAAAAAAAAAAIQAAABgAAAAUAAAAqBEAABAjAACpEQAAqCQAABAAAAAmAAAACAAAAP//////////"/>
               </a:ext>
             </a:extLst>
           </p:cNvCxnSpPr>
@@ -6085,7 +6085,7 @@
           <p:cNvSpPr txBox="1">
             <a:extLst>
               <a:ext uri="smNativeData">
-                <pr:smNativeData xmlns:pr="smNativeData" xmlns="smNativeData" val="SMDATA_15_7aDWaRMAAAAlAAAAEgAAAE8BAAAAkAAAAEgAAACQAAAASAAAAAAAAAAAAAAAAAAAAAEAAABQAAAAAAAAAAAA4D8AAAAAAADgPwAAAAAAAOA/AAAAAAAA4D8AAAAAAADgPwAAAAAAAOA/AAAAAAAA4D8AAAAAAADgPwAAAAAAAOA/AAAAAAAA4D8CAAAAjAAAAAAAAAAAAAAAu+DjDP///wgAAAAAAAAAAAAAAAAAAAAAAAAAAAAAAAAAAAAAZAAAAAEAAABAAAAAAAAAAAAAAAAAAAAAAAAAAAAAAAAAAAAAAAAAAAAAAAAAAAAAAAAAAAAAAAAAAAAAAAAAAAAAAAAAAAAAAAAAAAAAAAAAAAAAAAAAAAAAAAAAAAAAFAAAADwAAAAAAAAAAAAAAAAAAAkUAAAAAQAAABQAAAAUAAAAFAAAAAEAAAAAAAAAZAAAAGQAAAAAAAAAZAAAAGQAAAAVAAAAYAAAAAAAAAAAAAAADwAAACADAAAAAAAAAAAAAAEAAACgMgAAVgcAAKr4//8BAAAAf39/AAEAAABkAAAAAAAAABQAAABAHwAAAAAAACYAAAAAAAAAwOD//wAAAAAmAAAAZAAAABYAAABMAAAAAAAAAAAAAAAEAAAAAAAAAAEAAACAgIAKAAAAACgAAAAoAAAAZAAAAGQAAAAAAAAAzMzMAAAAAABQAAAAUAAAAGQAAABkAAAAAAAAABcAAAAUAAAAAAAAANwIAAD/fwAA/38AAAAAAAAJAAAABAAAAAAAAAAeAAAAaAAAAAAAAAAAAAAAAAAAAAAAAAAAAAAAECcAABAnAAAAAAAAAAAAAAAAAAAAAAAAAAAAAAAAAAAAAAAAAAAAABQAAAAAAAAAwMD/AAAAAABkAAAAMgAAAAAAAABkAAAAAAAAAH9/fwAKAAAAIgAAABgAAAAAAAAAAAAAAAAAAAAAAAAAAAAAAAAAAAAkAAAAJAAAAAAAAAAHAAAAAAAAAAAAAAAAAAAAAAAAAAAAAAAAAAAAf39/ACUAAABYAAAAAAAAAAAAAAAAAAAAAAAAAAAAAAAAAAAAAAAAAAAAAAAAAAAAAAAAAAAAAAA/AAAAAAAAAKCGAQAAAAAAAAAAAAAAAAAMAAAAAQAAAAAAAAAAAAAAAAAAAB8AAABUAAAAu+DjBf///wEAAAAAAAAAAAAAAAAAAAAAAAAAAAAAAAAAAAAAAAAAAAAAAAJ/f38AgICAA8zMzADAwP8Af39/AAAAAAAAAAAAAAAAAAAAAAAAAAAAIQAAABgAAAAUAAAAXD8AAFQiAAA4SAAAZCcAABAgAAAmAAAACAAAAP//////////"/>
+                <pr:smNativeData xmlns:pr="smNativeData" xmlns="smNativeData" val="SMDATA_15_ZqHWaRMAAAAlAAAAEgAAAE8BAAAAkAAAAEgAAACQAAAASAAAAAAAAAAAAAAAAAAAAAEAAABQAAAAAAAAAAAA4D8AAAAAAADgPwAAAAAAAOA/AAAAAAAA4D8AAAAAAADgPwAAAAAAAOA/AAAAAAAA4D8AAAAAAADgPwAAAAAAAOA/AAAAAAAA4D8CAAAAjAAAAAAAAAAAAAAAu+DjDP///wgAAAAAAAAAAAAAAAAAAAAAAAAAAAAAAAAAAAAAZAAAAAEAAABAAAAAAAAAAAAAAAAAAAAAAAAAAAAAAAAAAAAAAAAAAAAAAAAAAAAAAAAAAAAAAAAAAAAAAAAAAAAAAAAAAAAAAAAAAAAAAAAAAAAAAAAAAAAAAAAAAAAAFAAAADwAAAAAAAAAAAAAAAAAAAkUAAAAAQAAABQAAAAUAAAAFAAAAAEAAAAAAAAAZAAAAGQAAAAAAAAAZAAAAGQAAAAVAAAAYAAAAAAAAAAAAAAADwAAACADAAAAAAAAAAAAAAEAAACgMgAAVgcAAKr4//8BAAAAf39/AAEAAABkAAAAAAAAABQAAABAHwAAAAAAACYAAAAAAAAAwOD//wAAAAAmAAAAZAAAABYAAABMAAAAAAAAAAAAAAAEAAAAAAAAAAEAAACAgIAKAAAAACgAAAAoAAAAZAAAAGQAAAAAAAAAzMzMAAAAAABQAAAAUAAAAGQAAABkAAAAAAAAABcAAAAUAAAAAAAAANwIAAD/fwAA/38AAAAAAAAJAAAABAAAAAAAAAAeAAAAaAAAAAAAAAAAAAAAAAAAAAAAAAAAAAAAECcAABAnAAAAAAAAAAAAAAAAAAAAAAAAAAAAAAAAAAAAAAAAAAAAABQAAAAAAAAAwMD/AAAAAABkAAAAMgAAAAAAAABkAAAAAAAAAH9/fwAKAAAAIgAAABgAAAAAAAAAAAAAAAAAAAAAAAAAAAAAAAAAAAAkAAAAJAAAAAAAAAAHAAAAAAAAAAAAAAAAAAAAAAAAAAAAAAAAAAAAf39/ACUAAABYAAAAAAAAAAAAAAAAAAAAAAAAAAAAAAAAAAAAAAAAAAAAAAAAAAAAAAAAAAAAAAA/AAAAAAAAAKCGAQAAAAAAAAAAAAAAAAAMAAAAAQAAAAAAAAAAAAAAAAAAAB8AAABUAAAAu+DjBf///wEAAAAAAAAAAAAAAAAAAAAAAAAAAAAAAAAAAAAAAAAAAAAAAAJ/f38AgICAA8zMzADAwP8Af39/AAAAAAAAAAAAAAAAAAAAAAAAAAAAIQAAABgAAAAUAAAAXD8AAFQiAAA4SAAAZCcAABAgAAAmAAAACAAAAP//////////"/>
               </a:ext>
             </a:extLst>
           </p:cNvSpPr>
@@ -6124,7 +6124,7 @@
           <p:cNvSpPr txBox="1">
             <a:extLst>
               <a:ext uri="smNativeData">
-                <pr:smNativeData xmlns:pr="smNativeData" xmlns="smNativeData" val="SMDATA_15_7aDWaRMAAAAlAAAAEgAAAE8BAAAAkAAAAEgAAACQAAAASAAAAAAAAAAAAAAAAAAAAAEAAABQAAAAAAAAAAAA4D8AAAAAAADgPwAAAAAAAOA/AAAAAAAA4D8AAAAAAADgPwAAAAAAAOA/AAAAAAAA4D8AAAAAAADgPwAAAAAAAOA/AAAAAAAA4D8CAAAAjAAAAAAAAAAAAAAAu+DjDP///wgAAAAAAAAAAAAAAAAAAAAAAAAAAAAAAAAAAAAAZAAAAAEAAABAAAAAAAAAAAAAAAAAAAAAAAAAAAAAAAAAAAAAAAAAAAAAAAAAAAAAAAAAAAAAAAAAAAAAAAAAAAAAAAAAAAAAAAAAAAAAAAAAAAAAAAAAAAAAAAAAAAAAFAAAADwAAAAAAAAAAAAAAAAAAAkUAAAAAQAAABQAAAAUAAAAFAAAAAEAAAAAAAAAZAAAAGQAAAAAAAAAZAAAAGQAAAAVAAAAYAAAAAAAAAAAAAAADwAAACADAAAAAAAAAAAAAAEAAACgMgAAVgcAAKr4//8BAAAAf39/AAEAAABkAAAAAAAAABQAAABAHwAAAAAAACYAAAAAAAAAwOD//wAAAAAmAAAAZAAAABYAAABMAAAAAAAAAAAAAAAEAAAAAAAAAAEAAACAgIAKAAAAACgAAAAoAAAAZAAAAGQAAAAAAAAAzMzMAAAAAABQAAAAUAAAAGQAAABkAAAAAAAAABcAAAAUAAAAAAAAANwIAAD/fwAA/38AAAAAAAAJAAAABAAAACMAAAAeAAAAaAAAAAAAAAAAAAAAAAAAAAAAAAAAAAAAECcAABAnAAAAAAAAAAAAAAAAAAAAAAAAAAAAAAAAAAAAAAAAAAAAABQAAAAAAAAAwMD/AAAAAABkAAAAMgAAAAAAAABkAAAAAAAAAH9/fwAKAAAAIgAAABgAAAAAAAAAAAAAAAAAAAAAAAAAAAAAAAAAAAAkAAAAJAAAAAAAAAAHAAAAAAAAAAAAAAAAAAAAAAAAAAAAAAAAAAAAf39/ACUAAABYAAAAAAAAAAAAAAAAAAAAAAAAAAAAAAAAAAAAAAAAAAAAAAAAAAAAAAAAAAAAAAA/AAAAAAAAAKCGAQAAAAAAAAAAAAAAAAAMAAAAAQAAAAAAAAAAAAAAAAAAAB8AAABUAAAAu+DjBf///wEAAAAAAAAAAAAAAAAAAAAAAAAAAAAAAAAAAAAAAAAAAAAAAAJ/f38AgICAA8zMzADAwP8Af39/AAAAAAAAAAAAAAAAAAAAAAAAAAAAIQAAABgAAAAUAAAAOQEAAM4iAADRCwAA3icAABAgAAAmAAAACAAAAP//////////"/>
+                <pr:smNativeData xmlns:pr="smNativeData" xmlns="smNativeData" val="SMDATA_15_ZqHWaRMAAAAlAAAAEgAAAE8BAAAAkAAAAEgAAACQAAAASAAAAAAAAAAAAAAAAAAAAAEAAABQAAAAAAAAAAAA4D8AAAAAAADgPwAAAAAAAOA/AAAAAAAA4D8AAAAAAADgPwAAAAAAAOA/AAAAAAAA4D8AAAAAAADgPwAAAAAAAOA/AAAAAAAA4D8CAAAAjAAAAAAAAAAAAAAAu+DjDP///wgAAAAAAAAAAAAAAAAAAAAAAAAAAAAAAAAAAAAAZAAAAAEAAABAAAAAAAAAAAAAAAAAAAAAAAAAAAAAAAAAAAAAAAAAAAAAAAAAAAAAAAAAAAAAAAAAAAAAAAAAAAAAAAAAAAAAAAAAAAAAAAAAAAAAAAAAAAAAAAAAAAAAFAAAADwAAAAAAAAAAAAAAAAAAAkUAAAAAQAAABQAAAAUAAAAFAAAAAEAAAAAAAAAZAAAAGQAAAAAAAAAZAAAAGQAAAAVAAAAYAAAAAAAAAAAAAAADwAAACADAAAAAAAAAAAAAAEAAACgMgAAVgcAAKr4//8BAAAAf39/AAEAAABkAAAAAAAAABQAAABAHwAAAAAAACYAAAAAAAAAwOD//wAAAAAmAAAAZAAAABYAAABMAAAAAAAAAAAAAAAEAAAAAAAAAAEAAACAgIAKAAAAACgAAAAoAAAAZAAAAGQAAAAAAAAAzMzMAAAAAABQAAAAUAAAAGQAAABkAAAAAAAAABcAAAAUAAAAAAAAANwIAAD/fwAA/38AAAAAAAAJAAAABAAAACMAAAAeAAAAaAAAAAAAAAAAAAAAAAAAAAAAAAAAAAAAECcAABAnAAAAAAAAAAAAAAAAAAAAAAAAAAAAAAAAAAAAAAAAAAAAABQAAAAAAAAAwMD/AAAAAABkAAAAMgAAAAAAAABkAAAAAAAAAH9/fwAKAAAAIgAAABgAAAAAAAAAAAAAAAAAAAAAAAAAAAAAAAAAAAAkAAAAJAAAAAAAAAAHAAAAAAAAAAAAAAAAAAAAAAAAAAAAAAAAAAAAf39/ACUAAABYAAAAAAAAAAAAAAAAAAAAAAAAAAAAAAAAAAAAAAAAAAAAAAAAAAAAAAAAAAAAAAA/AAAAAAAAAKCGAQAAAAAAAAAAAAAAAAAMAAAAAQAAAAAAAAAAAAAAAAAAAB8AAABUAAAAu+DjBf///wEAAAAAAAAAAAAAAAAAAAAAAAAAAAAAAAAAAAAAAAAAAAAAAAJ/f38AgICAA8zMzADAwP8Af39/AAAAAAAAAAAAAAAAAAAAAAAAAAAAIQAAABgAAAAUAAAAOQEAAM4iAADRCwAA3icAABAgAAAmAAAACAAAAP//////////"/>
               </a:ext>
             </a:extLst>
           </p:cNvSpPr>
@@ -6163,7 +6163,7 @@
           <p:cNvCxnSpPr>
             <a:extLst>
               <a:ext uri="smNativeData">
-                <pr:smNativeData xmlns:pr="smNativeData" xmlns="smNativeData" val="SMDATA_15_7aDWaRMAAAAlAAAADwAAAA8BAAAAkAAAAEgAAACQAAAASAAAAAAAAAAAAAAAAAAAAAEAAABQAAAAa6211lprGcAAAAAAAADgPwAAAAAAAOA/AAAAAAAA4D8AAAAAAADgPwAAAAAAAOA/AAAAAAAA4D8AAAAAAADgPwAAAAAAAOA/AAAAAAAA4D8CAAAAjAAAAAAAAAAAAAAAu+DjDP///wgAAAAAAAAAAAAAAAAAAAAAAAAAAAAAAAAAAAAAZAAAAAEAAABAAAAAAAAAAAAAAAAAAAAAAAAAAAAAAAAAAAAAAAAAAAAAAAAAAAAAAAAAAAAAAAAAAAAAAAAAAAAAAAAAAAAAAAAAAAAAAAAAAAAAAAAAAAAAAAAAAAAAFAAAADwAAAABAAAAAQAAAAAAAAkUAAAAAQAAABQAAAAUAAAAFAAAAAEAAAAAAAAAZAAAAGQAAAABAAAAlgAAAJYAAAAVAAAAYAAAAAAAAAAAAAAADwAAACADAAAAAAAAAAAAAAEAAACgMgAAVgcAAKr4//8BAAAAf39/AAEAAABkAAAAAAAAABQAAABAHwAAAAAAACYAAAAAAAAAwOD//wAAAAAmAAAAZAAAABYAAABMAAAAAAAAAAAAAAAEAAAAAAAAAAEAAACAgIAKAAAAACgAAAAoAAAAZAAAAGQAAAAAAAAAzMzMAAAAAABQAAAAUAAAAGQAAABkAAAAAAAAABcAAAAUAAAAAAAAAAAAAAD/fwAA/38AAAAAAAAJAAAABAAAAAAAAAAeAAAAaAAAAAAAAAAAAAAAAAAAAAAAAAAAAAAAECcAABAnAAAAAAAAAAAAAAAAAAAAAAAAAAAAAAAAAAAAAAAAAAAAABQAAAAAAAAAwMD/AAAAAABkAAAAMgAAAAAAAABkAAAAAAAAAH9/fwAKAAAAIgAAABgAAAAAAAAAAAAAAAAAAAAAAAAAAAAAAAAAAAAkAAAAJAAAAAAAAAAHAAAAAAAAAAAAAAAAAAAAAAAAAAAAAAAAAAAAf39/ACUAAABYAAAAAAAAAAAAAAAAAAAAAAAAAAAAAAAAAAAAAAAAAAAAAAAAAAAAAAAAAAAAAAA/AAAAAAAAAKCGAQAAAAAAAAAAAAAAAAAMAAAAAQAAAAAAAAAAAAAAAAAAAB8AAABUAAAAu+DjBf///wEAAAAAAAAAAAAAAAAAAAAAAAAAAAAAAAAAAAAAAAAAAAAAAAJ/f38AgICAA8zMzADAwP8Af39/AAAAAAAAAAAAAAAAAAAAAAAAAAAAIQAAABgAAAAUAAAA2RUAAL0hAAB0FgAAdCYAABAAAAAmAAAACAAAAP//////////"/>
+                <pr:smNativeData xmlns:pr="smNativeData" xmlns="smNativeData" val="SMDATA_15_ZqHWaRMAAAAlAAAADwAAAA8BAAAAkAAAAEgAAACQAAAASAAAAAAAAAAAAAAAAAAAAAEAAABQAAAAa6211lprGcAAAAAAAADgPwAAAAAAAOA/AAAAAAAA4D8AAAAAAADgPwAAAAAAAOA/AAAAAAAA4D8AAAAAAADgPwAAAAAAAOA/AAAAAAAA4D8CAAAAjAAAAAAAAAAAAAAAu+DjDP///wgAAAAAAAAAAAAAAAAAAAAAAAAAAAAAAAAAAAAAZAAAAAEAAABAAAAAAAAAAAAAAAAAAAAAAAAAAAAAAAAAAAAAAAAAAAAAAAAAAAAAAAAAAAAAAAAAAAAAAAAAAAAAAAAAAAAAAAAAAAAAAAAAAAAAAAAAAAAAAAAAAAAAFAAAADwAAAABAAAAAQAAAAAAAAkUAAAAAQAAABQAAAAUAAAAFAAAAAEAAAAAAAAAZAAAAGQAAAABAAAAlgAAAJYAAAAVAAAAYAAAAAAAAAAAAAAADwAAACADAAAAAAAAAAAAAAEAAACgMgAAVgcAAKr4//8BAAAAf39/AAEAAABkAAAAAAAAABQAAABAHwAAAAAAACYAAAAAAAAAwOD//wAAAAAmAAAAZAAAABYAAABMAAAAAAAAAAAAAAAEAAAAAAAAAAEAAACAgIAKAAAAACgAAAAoAAAAZAAAAGQAAAAAAAAAzMzMAAAAAABQAAAAUAAAAGQAAABkAAAAAAAAABcAAAAUAAAAAAAAAAAAAAD/fwAA/38AAAAAAAAJAAAABAAAAAAAAAAeAAAAaAAAAAAAAAAAAAAAAAAAAAAAAAAAAAAAECcAABAnAAAAAAAAAAAAAAAAAAAAAAAAAAAAAAAAAAAAAAAAAAAAABQAAAAAAAAAwMD/AAAAAABkAAAAMgAAAAAAAABkAAAAAAAAAH9/fwAKAAAAIgAAABgAAAAAAAAAAAAAAAAAAAAAAAAAAAAAAAAAAAAkAAAAJAAAAAAAAAAHAAAAAAAAAAAAAAAAAAAAAAAAAAAAAAAAAAAAf39/ACUAAABYAAAAAAAAAAAAAAAAAAAAAAAAAAAAAAAAAAAAAAAAAAAAAAAAAAAAAAAAAAAAAAA/AAAAAAAAAKCGAQAAAAAAAAAAAAAAAAAMAAAAAQAAAAAAAAAAAAAAAAAAAB8AAABUAAAAu+DjBf///wEAAAAAAAAAAAAAAAAAAAAAAAAAAAAAAAAAAAAAAAAAAAAAAAJ/f38AgICAA8zMzADAwP8Af39/AAAAAAAAAAAAAAAAAAAAAAAAAAAAIQAAABgAAAAUAAAA2RUAAL0hAAB0FgAAdCYAABAAAAAmAAAACAAAAP//////////"/>
               </a:ext>
             </a:extLst>
           </p:cNvCxnSpPr>

</xml_diff>

<commit_message>
Fixed gc issues  (#898, #888)
</commit_message>
<xml_diff>
--- a/php-zigar/doc/object-ownership.pptx
+++ b/php-zigar/doc/object-ownership.pptx
@@ -237,7 +237,7 @@
             <a:spLocks noGrp="1" noChangeArrowheads="1"/>
             <a:extLst>
               <a:ext uri="smNativeData">
-                <pr:smNativeData xmlns:pr="smNativeData" xmlns="smNativeData" val="SMDATA_15_ZqHWaRMAAAAlAAAAZAAAAA8BAAAAkAAAAEgAAACQAAAASAAAAAAAAAABAAAAAAAAAAEAAABQAAAAAAAAAAAA4D8AAAAAAADgPwAAAAAAAOA/AAAAAAAA4D8AAAAAAADgPwAAAAAAAOA/AAAAAAAA4D8AAAAAAADgPwAAAAAAAOA/AAAAAAAA4D8CAAAAjAAAAAAAAAAAAAAAu+DjDP///wgAAAAAAAAAAAAAAAAAAAAAAAAAAAAAAAAAAAAAZAAAAAEAAABAAAAAAAAAAAAAAAAAAAAAAAAAAAAAAAAAAAAAAAAAAAAAAAAAAAAAAAAAAAAAAAAAAAAAAAAAAAAAAAAAAAAAAAAAAAAAAAAAAAAAAAAAAAAAAAAAAAAAFAAAADwAAAAAAAAAAAAAAAAAAAkUAAAAAQAAABQAAAAUAAAAFAAAAAEAAAAAAAAAZAAAAGQAAAAAAAAAZAAAAGQAAAAVAAAAYAAAAAAAAAAAAAAADwAAACADAAAAAAAAAAAAAAEAAACgMgAAVgcAAKr4//8BAAAAf39/AAEAAABkAAAAAAAAABQAAABAHwAAAAAAACYAAAAAAAAAwOD//wAAAAAmAAAAZAAAABYAAABMAAAAAAAAAAAAAAAEAAAAAAAAAAEAAACAgIAKAAAAACgAAAAoAAAAZAAAAGQAAAAAAAAAzMzMAAAAAABQAAAAUAAAAGQAAABkAAAAAAAAABcAAAAUAAAAAAAAAAAAAAD/fwAA/38AAAAAAAAJAAAABAAAAAAAAAAeAAAAaAAAAAAAAAAAAAAAAAAAAAAAAAAAAAAAECcAABAnAAAAAAAAAAAAAAAAAAAAAAAAAAAAAAAAAAAAAAAAAAAAABQAAAAAAAAAwMD/AAAAAABkAAAAMgAAAAAAAABkAAAAAAAAAH9/fwAKAAAAIgAAABgAAAAAAAAAAAAAAAAAAAAAAAAAAAAAAAAAAAAkAAAAJAAAAAAAAAAHAAAAAAAAAAAAAAAAAAAAAAAAAAAAAAAAAAAAf39/ACUAAABYAAAAAAAAAAAAAAAAAAAAAAAAAAAAAAAAAAAAAAAAAAAAAAAAAAAAAAAAAAAAAAA/AAAAAAAAAKCGAQAAAAAAAAAAAAAAAAAMAAAAAQAAAAAAAAAAAAAAAAAAAB8AAABUAAAAAAAABQAAAAEAAAAAAAAAAAAAAAAAAAAAAAAAAAAAAAAAAAAAAAAAAAAAAAJ/f38AAAAAA8zMzADAwP8Af39/AAAAAAAAAAAAAAAAAAAAAAAAAAAAIQAAABgAAAAUAAAAoAUAABoNAABgRQAAJhYAABAAAAAmAAAACAAAAAEAAAAAAAAA"/>
+                <pr:smNativeData xmlns:pr="smNativeData" xmlns="smNativeData" val="SMDATA_15_MvzhaRMAAAAlAAAAZAAAAA8BAAAAkAAAAEgAAACQAAAASAAAAAAAAAABAAAAAAAAAAEAAABQAAAAAAAAAAAA4D8AAAAAAADgPwAAAAAAAOA/AAAAAAAA4D8AAAAAAADgPwAAAAAAAOA/AAAAAAAA4D8AAAAAAADgPwAAAAAAAOA/AAAAAAAA4D8CAAAAjAAAAAAAAAAAAAAAu+DjDP///wgAAAAAAAAAAAAAAAAAAAAAAAAAAAAAAAAAAAAAZAAAAAEAAABAAAAAAAAAAAAAAAAAAAAAAAAAAAAAAAAAAAAAAAAAAAAAAAAAAAAAAAAAAAAAAAAAAAAAAAAAAAAAAAAAAAAAAAAAAAAAAAAAAAAAAAAAAAAAAAAAAAAAFAAAADwAAAAAAAAAAAAAAAAAAAkUAAAAAQAAABQAAAAUAAAAFAAAAAEAAAAAAAAAZAAAAGQAAAAAAAAAZAAAAGQAAAAVAAAAYAAAAAAAAAAAAAAADwAAACADAAAAAAAAAAAAAAEAAACgMgAAVgcAAKr4//8BAAAAf39/AAEAAABkAAAAAAAAABQAAABAHwAAAAAAACYAAAAAAAAAwOD//wAAAAAmAAAAZAAAABYAAABMAAAAAAAAAAAAAAAEAAAAAAAAAAEAAACAgIAKAAAAACgAAAAoAAAAZAAAAGQAAAAAAAAAzMzMAAAAAABQAAAAUAAAAGQAAABkAAAAAAAAABcAAAAUAAAAAAAAAAAAAAD/fwAA/38AAAAAAAAJAAAABAAAAAAAAAAeAAAAaAAAAAAAAAAAAAAAAAAAAAAAAAAAAAAAECcAABAnAAAAAAAAAAAAAAAAAAAAAAAAAAAAAAAAAAAAAAAAAAAAABQAAAAAAAAAwMD/AAAAAABkAAAAMgAAAAAAAABkAAAAAAAAAH9/fwAKAAAAIgAAABgAAAAAAAAAAAAAAAAAAAAAAAAAAAAAAAAAAAAkAAAAJAAAAAAAAAAHAAAAAAAAAAAAAAAAAAAAAAAAAAAAAAAAAAAAf39/ACUAAABYAAAAAAAAAAAAAAAAAAAAAAAAAAAAAAAAAAAAAAAAAAAAAAAAAAAAAAAAAAAAAAA/AAAAAAAAAKCGAQAAAAAAAAAAAAAAAAAMAAAAAQAAAAAAAAAAAAAAAAAAAB8AAABUAAAAAAAABQAAAAEAAAAAAAAAAAAAAAAAAAAAAAAAAAAAAAAAAAAAAAAAAAAAAAJ/f38AAAAAA8zMzADAwP8Af39/AAAAAAAAAAAAAAAAAAAAAAAAAAAAIQAAABgAAAAUAAAAoAUAABoNAABgRQAAJhYAABAAAAAmAAAACAAAAAEAAAAAAAAA"/>
               </a:ext>
             </a:extLst>
           </p:cNvSpPr>
@@ -269,7 +269,7 @@
             <a:spLocks noGrp="1" noChangeArrowheads="1"/>
             <a:extLst>
               <a:ext uri="smNativeData">
-                <pr:smNativeData xmlns:pr="smNativeData" xmlns="smNativeData" val="SMDATA_15_ZqHWaRMAAAAlAAAAZAAAAA8BAAAAkAAAAEgAAACQAAAASAAAAAAAAAAAAAAAAAAAAAEAAABQAAAAAAAAAAAA4D8AAAAAAADgPwAAAAAAAOA/AAAAAAAA4D8AAAAAAADgPwAAAAAAAOA/AAAAAAAA4D8AAAAAAADgPwAAAAAAAOA/AAAAAAAA4D8CAAAAjAAAAAAAAAAAAAAAu+DjDP///wgAAAAAAAAAAAAAAAAAAAAAAAAAAAAAAAAAAAAAZAAAAAEAAABAAAAAAAAAAAAAAAAAAAAAAAAAAAAAAAAAAAAAAAAAAAAAAAAAAAAAAAAAAAAAAAAAAAAAAAAAAAAAAAAAAAAAAAAAAAAAAAAAAAAAAAAAAAAAAAAAAAAAFAAAADwAAAAAAAAAAAAAAAAAAAkUAAAAAQAAABQAAAAUAAAAFAAAAAEAAAAAAAAAZAAAAGQAAAAAAAAAZAAAAGQAAAAVAAAAYAAAAAAAAAAAAAAADwAAACADAAAAAAAAAAAAAAEAAACgMgAAVgcAAKr4//8BAAAAf39/AAEAAABkAAAAAAAAABQAAABAHwAAAAAAACYAAAAAAAAAwOD//wAAAAAmAAAAZAAAABYAAABMAAAAAAAAAAAAAAAEAAAAAAAAAAEAAACAgIAKAAAAACgAAAAoAAAAZAAAAGQAAAAAAAAAzMzMAAAAAABQAAAAUAAAAGQAAABkAAAAAAAAABcAAAAUAAAAAAAAAAAAAAD/fwAA/38AAAAAAAAJAAAABAAAAAAAAAAeAAAAaAAAAAAAAAAAAAAAAAAAAAAAAAAAAAAAECcAABAnAAAAAAAAAAAAAAAAAAAAAAAAAAAAAAAAAAAAAAAAAAAAABQAAAAAAAAAwMD/AAAAAABkAAAAMgAAAAAAAABkAAAAAAAAAH9/fwAKAAAAIgAAABgAAAAAAAAAAAAAAAAAAAAAAAAAAAAAAAAAAAAkAAAAJAAAAAAAAAAHAAAAAAAAAAAAAAAAAAAAAAAAAAAAAAAAAAAAf39/ACUAAABYAAAAAAAAAAAAAAAAAAAAAAAAAAAAAAAAAAAAAAAAAAAAAAAAAAAAAAAAAAAAAAA/AAAAAAAAAKCGAQAAAAAAAAAAAAAAAAAMAAAAAQAAAAAAAAAAAAAAAAAAAB8AAABUAAAAAAAABQAAAAEAAAAAAAAAAAAAAAAAAAAAAAAAAAAAAAAAAAAAAAAAAAAAAAJ/f38AAAAAA8zMzADAwP8Af39/AAAAAAAAAAAAAAAAAAAAAAAAAAAAIQAAABgAAAAUAAAAQAsAAOgXAADAPwAAsCIAABAAAAAmAAAACAAAAAGAAAAAAAAA"/>
+                <pr:smNativeData xmlns:pr="smNativeData" xmlns="smNativeData" val="SMDATA_15_MvzhaRMAAAAlAAAAZAAAAA8BAAAAkAAAAEgAAACQAAAASAAAAAAAAAAAAAAAAAAAAAEAAABQAAAAAAAAAAAA4D8AAAAAAADgPwAAAAAAAOA/AAAAAAAA4D8AAAAAAADgPwAAAAAAAOA/AAAAAAAA4D8AAAAAAADgPwAAAAAAAOA/AAAAAAAA4D8CAAAAjAAAAAAAAAAAAAAAu+DjDP///wgAAAAAAAAAAAAAAAAAAAAAAAAAAAAAAAAAAAAAZAAAAAEAAABAAAAAAAAAAAAAAAAAAAAAAAAAAAAAAAAAAAAAAAAAAAAAAAAAAAAAAAAAAAAAAAAAAAAAAAAAAAAAAAAAAAAAAAAAAAAAAAAAAAAAAAAAAAAAAAAAAAAAFAAAADwAAAAAAAAAAAAAAAAAAAkUAAAAAQAAABQAAAAUAAAAFAAAAAEAAAAAAAAAZAAAAGQAAAAAAAAAZAAAAGQAAAAVAAAAYAAAAAAAAAAAAAAADwAAACADAAAAAAAAAAAAAAEAAACgMgAAVgcAAKr4//8BAAAAf39/AAEAAABkAAAAAAAAABQAAABAHwAAAAAAACYAAAAAAAAAwOD//wAAAAAmAAAAZAAAABYAAABMAAAAAAAAAAAAAAAEAAAAAAAAAAEAAACAgIAKAAAAACgAAAAoAAAAZAAAAGQAAAAAAAAAzMzMAAAAAABQAAAAUAAAAGQAAABkAAAAAAAAABcAAAAUAAAAAAAAAAAAAAD/fwAA/38AAAAAAAAJAAAABAAAAAAAAAAeAAAAaAAAAAAAAAAAAAAAAAAAAAAAAAAAAAAAECcAABAnAAAAAAAAAAAAAAAAAAAAAAAAAAAAAAAAAAAAAAAAAAAAABQAAAAAAAAAwMD/AAAAAABkAAAAMgAAAAAAAABkAAAAAAAAAH9/fwAKAAAAIgAAABgAAAAAAAAAAAAAAAAAAAAAAAAAAAAAAAAAAAAkAAAAJAAAAAAAAAAHAAAAAAAAAAAAAAAAAAAAAAAAAAAAAAAAAAAAf39/ACUAAABYAAAAAAAAAAAAAAAAAAAAAAAAAAAAAAAAAAAAAAAAAAAAAAAAAAAAAAAAAAAAAAA/AAAAAAAAAKCGAQAAAAAAAAAAAAAAAAAMAAAAAQAAAAAAAAAAAAAAAAAAAB8AAABUAAAAAAAABQAAAAEAAAAAAAAAAAAAAAAAAAAAAAAAAAAAAAAAAAAAAAAAAAAAAAJ/f38AAAAAA8zMzADAwP8Af39/AAAAAAAAAAAAAAAAAAAAAAAAAAAAIQAAABgAAAAUAAAAQAsAAOgXAADAPwAAsCIAABAAAAAmAAAACAAAAAGAAAAAAAAA"/>
               </a:ext>
             </a:extLst>
           </p:cNvSpPr>
@@ -329,7 +329,7 @@
             <a:spLocks noGrp="1" noChangeArrowheads="1"/>
             <a:extLst>
               <a:ext uri="smNativeData">
-                <pr:smNativeData xmlns:pr="smNativeData" xmlns="smNativeData" val="SMDATA_15_ZqHWaRMAAAAlAAAAZAAAAA8BAAAAkAAAAEgAAACQAAAASAAAAAAAAAABAAAAAAAAAAEAAABQAAAAAAAAAAAA4D8AAAAAAADgPwAAAAAAAOA/AAAAAAAA4D8AAAAAAADgPwAAAAAAAOA/AAAAAAAA4D8AAAAAAADgPwAAAAAAAOA/AAAAAAAA4D8CAAAAjAAAAAAAAAAAAAAAu+DjDP///wgAAAAAAAAAAAAAAAAAAAAAAAAAAAAAAAAAAAAAZAAAAAEAAABAAAAAAAAAAAAAAAAAAAAAAAAAAAAAAAAAAAAAAAAAAAAAAAAAAAAAAAAAAAAAAAAAAAAAAAAAAAAAAAAAAAAAAAAAAAAAAAAAAAAAAAAAAAAAAAAAAAAAFAAAADwAAAAAAAAAAAAAAAAAAAkUAAAAAQAAABQAAAAUAAAAFAAAAAEAAAAAAAAAZAAAAGQAAAAAAAAAZAAAAGQAAAAVAAAAYAAAAAAAAAAAAAAADwAAACADAAAAAAAAAAAAAAEAAACgMgAAVgcAAKr4//8BAAAAf39/AAEAAABkAAAAAAAAABQAAABAHwAAAAAAACYAAAAAAAAAwOD//wAAAAAmAAAAZAAAABYAAABMAAAAAAAAAAAAAAAEAAAAAAAAAAEAAACAgIAKAAAAACgAAAAoAAAAZAAAAGQAAAAAAAAAzMzMAAAAAABQAAAAUAAAAGQAAABkAAAAAAAAABcAAAAUAAAAAAAAAAAAAAD/fwAA/38AAAAAAAAJAAAABAAAAAAAAAAeAAAAaAAAAAAAAAAAAAAAAAAAAAAAAAAAAAAAECcAABAnAAAAAAAAAAAAAAAAAAAAAAAAAAAAAAAAAAAAAAAAAAAAABQAAAAAAAAAwMD/AAAAAABkAAAAMgAAAAAAAABkAAAAAAAAAH9/fwAKAAAAIgAAABgAAAAAAAAAAAAAAAAAAAAAAAAAAAAAAAAAAAAkAAAAJAAAAAAAAAAHAAAAAAAAAAAAAAAAAAAAAAAAAAAAAAAAAAAAf39/ACUAAABYAAAAAAAAAAAAAAAAAAAAAAAAAAAAAAAAAAAAAAAAAAAAAAAAAAAAAAAAAAAAAAA/AAAAAAAAAKCGAQAAAAAAAAAAAAAAAAAMAAAAAQAAAAAAAAAAAAAAAAAAAB8AAABUAAAAAAAABQAAAAEAAAAAAAAAAAAAAAAAAAAAAAAAAAAAAAAAAAAAAAAAAAAAAAJ/f38AAAAAA8zMzADAwP8Af39/AAAAAAAAAAAAAAAAAAAAAAAAAAAAIQAAABgAAAAUAAAAwAMAABsnAAA/FQAAWSkAABAAAAAmAAAACAAAAAAAAAAAAAAA"/>
+                <pr:smNativeData xmlns:pr="smNativeData" xmlns="smNativeData" val="SMDATA_15_MvzhaRMAAAAlAAAAZAAAAA8BAAAAkAAAAEgAAACQAAAASAAAAAAAAAABAAAAAAAAAAEAAABQAAAAAAAAAAAA4D8AAAAAAADgPwAAAAAAAOA/AAAAAAAA4D8AAAAAAADgPwAAAAAAAOA/AAAAAAAA4D8AAAAAAADgPwAAAAAAAOA/AAAAAAAA4D8CAAAAjAAAAAAAAAAAAAAAu+DjDP///wgAAAAAAAAAAAAAAAAAAAAAAAAAAAAAAAAAAAAAZAAAAAEAAABAAAAAAAAAAAAAAAAAAAAAAAAAAAAAAAAAAAAAAAAAAAAAAAAAAAAAAAAAAAAAAAAAAAAAAAAAAAAAAAAAAAAAAAAAAAAAAAAAAAAAAAAAAAAAAAAAAAAAFAAAADwAAAAAAAAAAAAAAAAAAAkUAAAAAQAAABQAAAAUAAAAFAAAAAEAAAAAAAAAZAAAAGQAAAAAAAAAZAAAAGQAAAAVAAAAYAAAAAAAAAAAAAAADwAAACADAAAAAAAAAAAAAAEAAACgMgAAVgcAAKr4//8BAAAAf39/AAEAAABkAAAAAAAAABQAAABAHwAAAAAAACYAAAAAAAAAwOD//wAAAAAmAAAAZAAAABYAAABMAAAAAAAAAAAAAAAEAAAAAAAAAAEAAACAgIAKAAAAACgAAAAoAAAAZAAAAGQAAAAAAAAAzMzMAAAAAABQAAAAUAAAAGQAAABkAAAAAAAAABcAAAAUAAAAAAAAAAAAAAD/fwAA/38AAAAAAAAJAAAABAAAAAAAAAAeAAAAaAAAAAAAAAAAAAAAAAAAAAAAAAAAAAAAECcAABAnAAAAAAAAAAAAAAAAAAAAAAAAAAAAAAAAAAAAAAAAAAAAABQAAAAAAAAAwMD/AAAAAABkAAAAMgAAAAAAAABkAAAAAAAAAH9/fwAKAAAAIgAAABgAAAAAAAAAAAAAAAAAAAAAAAAAAAAAAAAAAAAkAAAAJAAAAAAAAAAHAAAAAAAAAAAAAAAAAAAAAAAAAAAAAAAAAAAAf39/ACUAAABYAAAAAAAAAAAAAAAAAAAAAAAAAAAAAAAAAAAAAAAAAAAAAAAAAAAAAAAAAAAAAAA/AAAAAAAAAKCGAQAAAAAAAAAAAAAAAAAMAAAAAQAAAAAAAAAAAAAAAAAAAB8AAABUAAAAAAAABQAAAAEAAAAAAAAAAAAAAAAAAAAAAAAAAAAAAAAAAAAAAAAAAAAAAAJ/f38AAAAAA8zMzADAwP8Af39/AAAAAAAAAAAAAAAAAAAAAAAAAAAAIQAAABgAAAAUAAAAwAMAABsnAAA/FQAAWSkAABAAAAAmAAAACAAAAAAAAAAAAAAA"/>
               </a:ext>
             </a:extLst>
           </p:cNvSpPr>
@@ -343,7 +343,7 @@
           <a:lstStyle/>
           <a:p>
             <a:pPr/>
-            <a:fld id="{38D42F66-28D5-81D9-9B6C-DE8C61226D8B}" type="datetime1">
+            <a:fld id="{54FF623A-74B9-AA94-F747-82C12C0901D7}" type="datetime1">
               <a:t/>
             </a:fld>
           </a:p>
@@ -356,7 +356,7 @@
             <a:spLocks noGrp="1" noChangeArrowheads="1"/>
             <a:extLst>
               <a:ext uri="smNativeData">
-                <pr:smNativeData xmlns:pr="smNativeData" xmlns="smNativeData" val="SMDATA_15_ZqHWaRMAAAAlAAAAZAAAAA8BAAAAkAAAAEgAAACQAAAASAAAAAAAAAABAAAAAAAAAAEAAABQAAAAAAAAAAAA4D8AAAAAAADgPwAAAAAAAOA/AAAAAAAA4D8AAAAAAADgPwAAAAAAAOA/AAAAAAAA4D8AAAAAAADgPwAAAAAAAOA/AAAAAAAA4D8CAAAAjAAAAAAAAAAAAAAAu+DjDP///wgAAAAAAAAAAAAAAAAAAAAAAAAAAAAAAAAAAAAAZAAAAAEAAABAAAAAAAAAAAAAAAAAAAAAAAAAAAAAAAAAAAAAAAAAAAAAAAAAAAAAAAAAAAAAAAAAAAAAAAAAAAAAAAAAAAAAAAAAAAAAAAAAAAAAAAAAAAAAAAAAAAAAFAAAADwAAAAAAAAAAAAAAAAAAAkUAAAAAQAAABQAAAAUAAAAFAAAAAEAAAAAAAAAZAAAAGQAAAAAAAAAZAAAAGQAAAAVAAAAYAAAAAAAAAAAAAAADwAAACADAAAAAAAAAAAAAAEAAACgMgAAVgcAAKr4//8BAAAAf39/AAEAAABkAAAAAAAAABQAAABAHwAAAAAAACYAAAAAAAAAwOD//wAAAAAmAAAAZAAAABYAAABMAAAAAAAAAAAAAAAEAAAAAAAAAAEAAACAgIAKAAAAACgAAAAoAAAAZAAAAGQAAAAAAAAAzMzMAAAAAABQAAAAUAAAAGQAAABkAAAAAAAAABcAAAAUAAAAAAAAAAAAAAD/fwAA/38AAAAAAAAJAAAABAAAAAAAAAAeAAAAaAAAAAAAAAAAAAAAAAAAAAAAAAAAAAAAECcAABAnAAAAAAAAAAAAAAAAAAAAAAAAAAAAAAAAAAAAAAAAAAAAABQAAAAAAAAAwMD/AAAAAABkAAAAMgAAAAAAAABkAAAAAAAAAH9/fwAKAAAAIgAAABgAAAAAAAAAAAAAAAAAAAAAAAAAAAAAAAAAAAAkAAAAJAAAAAAAAAAHAAAAAAAAAAAAAAAAAAAAAAAAAAAAAAAAAAAAf39/ACUAAABYAAAAAAAAAAAAAAAAAAAAAAAAAAAAAAAAAAAAAAAAAAAAAAAAAAAAAAAAAAAAAAA/AAAAAAAAAKCGAQAAAAAAAAAAAAAAAAAMAAAAAQAAAAAAAAAAAAAAAAAAAB8AAABUAAAAAAAABQAAAAEAAAAAAAAAAAAAAAAAAAAAAAAAAAAAAAAAAAAAAAAAAAAAAAJ/f38AAAAAA8zMzADAwP8Af39/AAAAAAAAAAAAAAAAAAAAAAAAAAAAIQAAABgAAAAUAAAAoRkAABsnAABfMQAAWSkAABAAAAAmAAAACAAAAAAAAAAAAAAA"/>
+                <pr:smNativeData xmlns:pr="smNativeData" xmlns="smNativeData" val="SMDATA_15_MvzhaRMAAAAlAAAAZAAAAA8BAAAAkAAAAEgAAACQAAAASAAAAAAAAAABAAAAAAAAAAEAAABQAAAAAAAAAAAA4D8AAAAAAADgPwAAAAAAAOA/AAAAAAAA4D8AAAAAAADgPwAAAAAAAOA/AAAAAAAA4D8AAAAAAADgPwAAAAAAAOA/AAAAAAAA4D8CAAAAjAAAAAAAAAAAAAAAu+DjDP///wgAAAAAAAAAAAAAAAAAAAAAAAAAAAAAAAAAAAAAZAAAAAEAAABAAAAAAAAAAAAAAAAAAAAAAAAAAAAAAAAAAAAAAAAAAAAAAAAAAAAAAAAAAAAAAAAAAAAAAAAAAAAAAAAAAAAAAAAAAAAAAAAAAAAAAAAAAAAAAAAAAAAAFAAAADwAAAAAAAAAAAAAAAAAAAkUAAAAAQAAABQAAAAUAAAAFAAAAAEAAAAAAAAAZAAAAGQAAAAAAAAAZAAAAGQAAAAVAAAAYAAAAAAAAAAAAAAADwAAACADAAAAAAAAAAAAAAEAAACgMgAAVgcAAKr4//8BAAAAf39/AAEAAABkAAAAAAAAABQAAABAHwAAAAAAACYAAAAAAAAAwOD//wAAAAAmAAAAZAAAABYAAABMAAAAAAAAAAAAAAAEAAAAAAAAAAEAAACAgIAKAAAAACgAAAAoAAAAZAAAAGQAAAAAAAAAzMzMAAAAAABQAAAAUAAAAGQAAABkAAAAAAAAABcAAAAUAAAAAAAAAAAAAAD/fwAA/38AAAAAAAAJAAAABAAAAAAAAAAeAAAAaAAAAAAAAAAAAAAAAAAAAAAAAAAAAAAAECcAABAnAAAAAAAAAAAAAAAAAAAAAAAAAAAAAAAAAAAAAAAAAAAAABQAAAAAAAAAwMD/AAAAAABkAAAAMgAAAAAAAABkAAAAAAAAAH9/fwAKAAAAIgAAABgAAAAAAAAAAAAAAAAAAAAAAAAAAAAAAAAAAAAkAAAAJAAAAAAAAAAHAAAAAAAAAAAAAAAAAAAAAAAAAAAAAAAAAAAAf39/ACUAAABYAAAAAAAAAAAAAAAAAAAAAAAAAAAAAAAAAAAAAAAAAAAAAAAAAAAAAAAAAAAAAAA/AAAAAAAAAKCGAQAAAAAAAAAAAAAAAAAMAAAAAQAAAAAAAAAAAAAAAAAAAB8AAABUAAAAAAAABQAAAAEAAAAAAAAAAAAAAAAAAAAAAAAAAAAAAAAAAAAAAAAAAAAAAAJ/f38AAAAAA8zMzADAwP8Af39/AAAAAAAAAAAAAAAAAAAAAAAAAAAAIQAAABgAAAAUAAAAoRkAABsnAABfMQAAWSkAABAAAAAmAAAACAAAAAAAAAAAAAAA"/>
               </a:ext>
             </a:extLst>
           </p:cNvSpPr>
@@ -380,7 +380,7 @@
             <a:spLocks noGrp="1" noChangeArrowheads="1"/>
             <a:extLst>
               <a:ext uri="smNativeData">
-                <pr:smNativeData xmlns:pr="smNativeData" xmlns="smNativeData" val="SMDATA_15_ZqHWaRMAAAAlAAAAZAAAAA8BAAAAkAAAAEgAAACQAAAASAAAAAAAAAABAAAAAAAAAAEAAABQAAAAAAAAAAAA4D8AAAAAAADgPwAAAAAAAOA/AAAAAAAA4D8AAAAAAADgPwAAAAAAAOA/AAAAAAAA4D8AAAAAAADgPwAAAAAAAOA/AAAAAAAA4D8CAAAAjAAAAAAAAAAAAAAAu+DjDP///wgAAAAAAAAAAAAAAAAAAAAAAAAAAAAAAAAAAAAAZAAAAAEAAABAAAAAAAAAAAAAAAAAAAAAAAAAAAAAAAAAAAAAAAAAAAAAAAAAAAAAAAAAAAAAAAAAAAAAAAAAAAAAAAAAAAAAAAAAAAAAAAAAAAAAAAAAAAAAAAAAAAAAFAAAADwAAAAAAAAAAAAAAAAAAAkUAAAAAQAAABQAAAAUAAAAFAAAAAEAAAAAAAAAZAAAAGQAAAAAAAAAZAAAAGQAAAAVAAAAYAAAAAAAAAAAAAAADwAAACADAAAAAAAAAAAAAAEAAACgMgAAVgcAAKr4//8BAAAAf39/AAEAAABkAAAAAAAAABQAAABAHwAAAAAAACYAAAAAAAAAwOD//wAAAAAmAAAAZAAAABYAAABMAAAAAAAAAAAAAAAEAAAAAAAAAAEAAACAgIAKAAAAACgAAAAoAAAAZAAAAGQAAAAAAAAAzMzMAAAAAABQAAAAUAAAAGQAAABkAAAAAAAAABcAAAAUAAAAAAAAAAAAAAD/fwAA/38AAAAAAAAJAAAABAAAAHsAfAAeAAAAaAAAAAAAAAAAAAAAAAAAAAAAAAAAAAAAECcAABAnAAAAAAAAAAAAAAAAAAAAAAAAAAAAAAAAAAAAAAAAAAAAABQAAAAAAAAAwMD/AAAAAABkAAAAMgAAAAAAAABkAAAAAAAAAH9/fwAKAAAAIgAAABgAAAAAAAAAAAAAAAAAAAAAAAAAAAAAAAAAAAAkAAAAJAAAAAAAAAAHAAAAAAAAAAAAAAAAAAAAAAAAAAAAAAAAAAAAf39/ACUAAABYAAAAAAAAAAAAAAAAAAAAAAAAAAAAAAAAAAAAAAAAAAAAAAAAAAAAAAAAAAAAAAA/AAAAAAAAAKCGAQAAAAAAAAAAAAAAAAAMAAAAAQAAAAAAAAAAAAAAAAAAAB8AAABUAAAAAAAABQAAAAEAAAAAAAAAAAAAAAAAAAAAAAAAAAAAAAAAAAAAAAAAAAAAAAJ/f38AAAAAA8zMzADAwP8Af39/AAAAAAAAAAAAAAAAAAAAAAAAAAAAIQAAABgAAAAUAAAAwTUAABsnAABARwAAWSkAABAAAAAmAAAACAAAAAAAAAAAAAAA"/>
+                <pr:smNativeData xmlns:pr="smNativeData" xmlns="smNativeData" val="SMDATA_15_MvzhaRMAAAAlAAAAZAAAAA8BAAAAkAAAAEgAAACQAAAASAAAAAAAAAABAAAAAAAAAAEAAABQAAAAAAAAAAAA4D8AAAAAAADgPwAAAAAAAOA/AAAAAAAA4D8AAAAAAADgPwAAAAAAAOA/AAAAAAAA4D8AAAAAAADgPwAAAAAAAOA/AAAAAAAA4D8CAAAAjAAAAAAAAAAAAAAAu+DjDP///wgAAAAAAAAAAAAAAAAAAAAAAAAAAAAAAAAAAAAAZAAAAAEAAABAAAAAAAAAAAAAAAAAAAAAAAAAAAAAAAAAAAAAAAAAAAAAAAAAAAAAAAAAAAAAAAAAAAAAAAAAAAAAAAAAAAAAAAAAAAAAAAAAAAAAAAAAAAAAAAAAAAAAFAAAADwAAAAAAAAAAAAAAAAAAAkUAAAAAQAAABQAAAAUAAAAFAAAAAEAAAAAAAAAZAAAAGQAAAAAAAAAZAAAAGQAAAAVAAAAYAAAAAAAAAAAAAAADwAAACADAAAAAAAAAAAAAAEAAACgMgAAVgcAAKr4//8BAAAAf39/AAEAAABkAAAAAAAAABQAAABAHwAAAAAAACYAAAAAAAAAwOD//wAAAAAmAAAAZAAAABYAAABMAAAAAAAAAAAAAAAEAAAAAAAAAAEAAACAgIAKAAAAACgAAAAoAAAAZAAAAGQAAAAAAAAAzMzMAAAAAABQAAAAUAAAAGQAAABkAAAAAAAAABcAAAAUAAAAAAAAAAAAAAD/fwAA/38AAAAAAAAJAAAABAAAAHsAfAAeAAAAaAAAAAAAAAAAAAAAAAAAAAAAAAAAAAAAECcAABAnAAAAAAAAAAAAAAAAAAAAAAAAAAAAAAAAAAAAAAAAAAAAABQAAAAAAAAAwMD/AAAAAABkAAAAMgAAAAAAAABkAAAAAAAAAH9/fwAKAAAAIgAAABgAAAAAAAAAAAAAAAAAAAAAAAAAAAAAAAAAAAAkAAAAJAAAAAAAAAAHAAAAAAAAAAAAAAAAAAAAAAAAAAAAAAAAAAAAf39/ACUAAABYAAAAAAAAAAAAAAAAAAAAAAAAAAAAAAAAAAAAAAAAAAAAAAAAAAAAAAAAAAAAAAA/AAAAAAAAAKCGAQAAAAAAAAAAAAAAAAAMAAAAAQAAAAAAAAAAAAAAAAAAAB8AAABUAAAAAAAABQAAAAEAAAAAAAAAAAAAAAAAAAAAAAAAAAAAAAAAAAAAAAAAAAAAAAJ/f38AAAAAA8zMzADAwP8Af39/AAAAAAAAAAAAAAAAAAAAAAAAAAAAIQAAABgAAAAUAAAAwTUAABsnAABARwAAWSkAABAAAAAmAAAACAAAAAAAAAAAAAAA"/>
               </a:ext>
             </a:extLst>
           </p:cNvSpPr>
@@ -394,7 +394,7 @@
           <a:lstStyle/>
           <a:p>
             <a:pPr/>
-            <a:fld id="{1DD602DE-90F0-83F4-BE6E-66A14C204833}" type="slidenum">
+            <a:fld id="{65BDD350-1E88-E825-C605-E8709D4B30BD}" type="slidenum">
               <a:t/>
             </a:fld>
           </a:p>
@@ -433,7 +433,7 @@
             <a:spLocks noGrp="1" noChangeArrowheads="1"/>
             <a:extLst>
               <a:ext uri="smNativeData">
-                <pr:smNativeData xmlns:pr="smNativeData" xmlns="smNativeData" val="SMDATA_15_ZqHWaRMAAAAlAAAAZAAAAA8BAAAAkAAAAEgAAACQAAAASAAAAAAAAAABAAAAAAAAAAEAAABQAAAAAAAAAAAA4D8AAAAAAADgPwAAAAAAAOA/AAAAAAAA4D8AAAAAAADgPwAAAAAAAOA/AAAAAAAA4D8AAAAAAADgPwAAAAAAAOA/AAAAAAAA4D8CAAAAjAAAAAAAAAAAAAAAu+DjDP///wgAAAAAAAAAAAAAAAAAAAAAAAAAAAAAAAAAAAAAZAAAAAEAAABAAAAAAAAAAAAAAAAAAAAAAAAAAAAAAAAAAAAAAAAAAAAAAAAAAAAAAAAAAAAAAAAAAAAAAAAAAAAAAAAAAAAAAAAAAAAAAAAAAAAAAAAAAAAAAAAAAAAAFAAAADwAAAAAAAAAAAAAAAAAAAkUAAAAAQAAABQAAAAUAAAAFAAAAAEAAAAAAAAAZAAAAGQAAAAAAAAAZAAAAGQAAAAVAAAAYAAAAAAAAAAAAAAADwAAACADAAAAAAAAAAAAAAEAAACgMgAAVgcAAKr4//8BAAAAf39/AAEAAABkAAAAAAAAABQAAABAHwAAAAAAACYAAAAAAAAAwOD//wAAAAAmAAAAZAAAABYAAABMAAAAAAAAAAAAAAAEAAAAAAAAAAEAAACAgIAKAAAAACgAAAAoAAAAZAAAAGQAAAAAAAAAzMzMAAAAAABQAAAAUAAAAGQAAABkAAAAAAAAABcAAAAUAAAAAAAAAAAAAAD/fwAA/38AAAAAAAAJAAAABAAAAG49IjEeAAAAaAAAAAAAAAAAAAAAAAAAAAAAAAAAAAAAECcAABAnAAAAAAAAAAAAAAAAAAAAAAAAAAAAAAAAAAAAAAAAAAAAABQAAAAAAAAAwMD/AAAAAABkAAAAMgAAAAAAAABkAAAAAAAAAH9/fwAKAAAAIgAAABgAAAAAAAAAAAAAAAAAAAAAAAAAAAAAAAAAAAAkAAAAJAAAAAAAAAAHAAAAAAAAAAAAAAAAAAAAAAAAAAAAAAAAAAAAf39/ACUAAABYAAAAAAAAAAAAAAAAAAAAAAAAAAAAAAAAAAAAAAAAAAAAAAAAAAAAAAAAAAAAAAA/AAAAAAAAAKCGAQAAAAAAAAAAAAAAAAAMAAAAAQAAAAAAAAAAAAAAAAAAAB8AAABUAAAAAAAABQAAAAEAAAAAAAAAAAAAAAAAAAAAAAAAAAAAAAAAAAAAAAAAAAAAAAJ/f38AAAAAA8zMzADAwP8Af39/AAAAAAAAAAAAAAAAAAAAAAAAAAAAIQAAABgAAAAUAAAAwAMAALABAABARwAAuAgAABAAAAAmAAAACAAAAAAAAAAAAAAA"/>
+                <pr:smNativeData xmlns:pr="smNativeData" xmlns="smNativeData" val="SMDATA_15_MvzhaRMAAAAlAAAAZAAAAA8BAAAAkAAAAEgAAACQAAAASAAAAAAAAAABAAAAAAAAAAEAAABQAAAAAAAAAAAA4D8AAAAAAADgPwAAAAAAAOA/AAAAAAAA4D8AAAAAAADgPwAAAAAAAOA/AAAAAAAA4D8AAAAAAADgPwAAAAAAAOA/AAAAAAAA4D8CAAAAjAAAAAAAAAAAAAAAu+DjDP///wgAAAAAAAAAAAAAAAAAAAAAAAAAAAAAAAAAAAAAZAAAAAEAAABAAAAAAAAAAAAAAAAAAAAAAAAAAAAAAAAAAAAAAAAAAAAAAAAAAAAAAAAAAAAAAAAAAAAAAAAAAAAAAAAAAAAAAAAAAAAAAAAAAAAAAAAAAAAAAAAAAAAAFAAAADwAAAAAAAAAAAAAAAAAAAkUAAAAAQAAABQAAAAUAAAAFAAAAAEAAAAAAAAAZAAAAGQAAAAAAAAAZAAAAGQAAAAVAAAAYAAAAAAAAAAAAAAADwAAACADAAAAAAAAAAAAAAEAAACgMgAAVgcAAKr4//8BAAAAf39/AAEAAABkAAAAAAAAABQAAABAHwAAAAAAACYAAAAAAAAAwOD//wAAAAAmAAAAZAAAABYAAABMAAAAAAAAAAAAAAAEAAAAAAAAAAEAAACAgIAKAAAAACgAAAAoAAAAZAAAAGQAAAAAAAAAzMzMAAAAAABQAAAAUAAAAGQAAABkAAAAAAAAABcAAAAUAAAAAAAAAAAAAAD/fwAA/38AAAAAAAAJAAAABAAAAG49IjEeAAAAaAAAAAAAAAAAAAAAAAAAAAAAAAAAAAAAECcAABAnAAAAAAAAAAAAAAAAAAAAAAAAAAAAAAAAAAAAAAAAAAAAABQAAAAAAAAAwMD/AAAAAABkAAAAMgAAAAAAAABkAAAAAAAAAH9/fwAKAAAAIgAAABgAAAAAAAAAAAAAAAAAAAAAAAAAAAAAAAAAAAAkAAAAJAAAAAAAAAAHAAAAAAAAAAAAAAAAAAAAAAAAAAAAAAAAAAAAf39/ACUAAABYAAAAAAAAAAAAAAAAAAAAAAAAAAAAAAAAAAAAAAAAAAAAAAAAAAAAAAAAAAAAAAA/AAAAAAAAAKCGAQAAAAAAAAAAAAAAAAAMAAAAAQAAAAAAAAAAAAAAAAAAAB8AAABUAAAAAAAABQAAAAEAAAAAAAAAAAAAAAAAAAAAAAAAAAAAAAAAAAAAAAAAAAAAAAJ/f38AAAAAA8zMzADAwP8Af39/AAAAAAAAAAAAAAAAAAAAAAAAAAAAIQAAABgAAAAUAAAAwAMAALABAABARwAAuAgAABAAAAAmAAAACAAAAAAAAAAAAAAA"/>
               </a:ext>
             </a:extLst>
           </p:cNvSpPr>
@@ -460,7 +460,7 @@
             <a:spLocks noGrp="1" noChangeArrowheads="1"/>
             <a:extLst>
               <a:ext uri="smNativeData">
-                <pr:smNativeData xmlns:pr="smNativeData" xmlns="smNativeData" val="SMDATA_15_ZqHWaRMAAAAlAAAAZAAAAA8BAAAAkAAAAEgAAACQAAAASAAAAAAAAAAAAAAAAQAAAAEAAABQAAAAAAAAAAAA4D8AAAAAAADgPwAAAAAAAOA/AAAAAAAA4D8AAAAAAADgPwAAAAAAAOA/AAAAAAAA4D8AAAAAAADgPwAAAAAAAOA/AAAAAAAA4D8CAAAAjAAAAAAAAAAAAAAAu+DjDP///wgAAAAAAAAAAAAAAAAAAAAAAAAAAAAAAAAAAAAAZAAAAAEAAABAAAAAAAAAAAAAAAAAAAAAAAAAAAAAAAAAAAAAAAAAAAAAAAAAAAAAAAAAAAAAAAAAAAAAAAAAAAAAAAAAAAAAAAAAAAAAAAAAAAAAAAAAAAAAAAAAAAAAFAAAADwAAAAAAAAAAAAAAAAAAAkUAAAAAQAAABQAAAAUAAAAFAAAAAEAAAAAAAAAZAAAAGQAAAAAAAAAZAAAAGQAAAAVAAAAYAAAAAAAAAAAAAAADwAAACADAAAAAAAAAAAAAAEAAACgMgAAVgcAAKr4//8BAAAAf39/AAEAAABkAAAAAAAAABQAAABAHwAAAAAAACYAAAAAAAAAwOD//wAAAAAmAAAAZAAAABYAAABMAAAAAAAAAAAAAAAEAAAAAAAAAAEAAACAgIAKAAAAACgAAAAoAAAAZAAAAGQAAAAAAAAAzMzMAAAAAABQAAAAUAAAAGQAAABkAAAAAAAAABcAAAAUAAAAAAAAAAAAAAD/fwAA/38AAAAAAAAJAAAABAAAAAAAAAAeAAAAaAAAAAAAAAAAAAAAAAAAAAAAAAAAAAAAECcAABAnAAAAAAAAAAAAAAAAAAAAAAAAAAAAAAAAAAAAAAAAAAAAABQAAAAAAAAAwMD/AAAAAABkAAAAMgAAAAAAAABkAAAAAAAAAH9/fwAKAAAAIgAAABgAAAAAAAAAAAAAAAAAAAAAAAAAAAAAAAAAAAAkAAAAJAAAAAAAAAAHAAAAAAAAAAAAAAAAAAAAAAAAAAAAAAAAAAAAf39/ACUAAABYAAAAAAAAAAAAAAAAAAAAAAAAAAAAAAAAAAAAAAAAAAAAAAAAAAAAAAAAAAAAAAA/AAAAAAAAAKCGAQAAAAAAAAAAAAAAAAAMAAAAAQAAAAAAAAAAAAAAAAAAAB8AAABUAAAAAAAABQAAAAEAAAAAAAAAAAAAAAAAAAAAAAAAAAAAAAAAAAAAAAAAAAAAAAJ/f38AAAAAA8zMzADAwP8Af39/AAAAAAAAAAAAAAAAAAAAAAAAAAAAIQAAABgAAAAUAAAAwAMAANgJAABARwAAsCUAABAAAAAmAAAACAAAAAIAAAAAAAAA"/>
+                <pr:smNativeData xmlns:pr="smNativeData" xmlns="smNativeData" val="SMDATA_15_MvzhaRMAAAAlAAAAZAAAAA8BAAAAkAAAAEgAAACQAAAASAAAAAAAAAAAAAAAAQAAAAEAAABQAAAAAAAAAAAA4D8AAAAAAADgPwAAAAAAAOA/AAAAAAAA4D8AAAAAAADgPwAAAAAAAOA/AAAAAAAA4D8AAAAAAADgPwAAAAAAAOA/AAAAAAAA4D8CAAAAjAAAAAAAAAAAAAAAu+DjDP///wgAAAAAAAAAAAAAAAAAAAAAAAAAAAAAAAAAAAAAZAAAAAEAAABAAAAAAAAAAAAAAAAAAAAAAAAAAAAAAAAAAAAAAAAAAAAAAAAAAAAAAAAAAAAAAAAAAAAAAAAAAAAAAAAAAAAAAAAAAAAAAAAAAAAAAAAAAAAAAAAAAAAAFAAAADwAAAAAAAAAAAAAAAAAAAkUAAAAAQAAABQAAAAUAAAAFAAAAAEAAAAAAAAAZAAAAGQAAAAAAAAAZAAAAGQAAAAVAAAAYAAAAAAAAAAAAAAADwAAACADAAAAAAAAAAAAAAEAAACgMgAAVgcAAKr4//8BAAAAf39/AAEAAABkAAAAAAAAABQAAABAHwAAAAAAACYAAAAAAAAAwOD//wAAAAAmAAAAZAAAABYAAABMAAAAAAAAAAAAAAAEAAAAAAAAAAEAAACAgIAKAAAAACgAAAAoAAAAZAAAAGQAAAAAAAAAzMzMAAAAAABQAAAAUAAAAGQAAABkAAAAAAAAABcAAAAUAAAAAAAAAAAAAAD/fwAA/38AAAAAAAAJAAAABAAAAAAAAAAeAAAAaAAAAAAAAAAAAAAAAAAAAAAAAAAAAAAAECcAABAnAAAAAAAAAAAAAAAAAAAAAAAAAAAAAAAAAAAAAAAAAAAAABQAAAAAAAAAwMD/AAAAAABkAAAAMgAAAAAAAABkAAAAAAAAAH9/fwAKAAAAIgAAABgAAAAAAAAAAAAAAAAAAAAAAAAAAAAAAAAAAAAkAAAAJAAAAAAAAAAHAAAAAAAAAAAAAAAAAAAAAAAAAAAAAAAAAAAAf39/ACUAAABYAAAAAAAAAAAAAAAAAAAAAAAAAAAAAAAAAAAAAAAAAAAAAAAAAAAAAAAAAAAAAAA/AAAAAAAAAKCGAQAAAAAAAAAAAAAAAAAMAAAAAQAAAAAAAAAAAAAAAAAAAB8AAABUAAAAAAAABQAAAAEAAAAAAAAAAAAAAAAAAAAAAAAAAAAAAAAAAAAAAAAAAAAAAAJ/f38AAAAAA8zMzADAwP8Af39/AAAAAAAAAAAAAAAAAAAAAAAAAAAAIQAAABgAAAAUAAAAwAMAANgJAABARwAAsCUAABAAAAAmAAAACAAAAAIAAAAAAAAA"/>
               </a:ext>
             </a:extLst>
           </p:cNvSpPr>
@@ -515,7 +515,7 @@
             <a:spLocks noGrp="1" noChangeArrowheads="1"/>
             <a:extLst>
               <a:ext uri="smNativeData">
-                <pr:smNativeData xmlns:pr="smNativeData" xmlns="smNativeData" val="SMDATA_15_ZqHWaRMAAAAlAAAAZAAAAA8BAAAAkAAAAEgAAACQAAAASAAAAAAAAAABAAAAAAAAAAEAAABQAAAAAAAAAAAA4D8AAAAAAADgPwAAAAAAAOA/AAAAAAAA4D8AAAAAAADgPwAAAAAAAOA/AAAAAAAA4D8AAAAAAADgPwAAAAAAAOA/AAAAAAAA4D8CAAAAjAAAAAAAAAAAAAAAu+DjDP///wgAAAAAAAAAAAAAAAAAAAAAAAAAAAAAAAAAAAAAZAAAAAEAAABAAAAAAAAAAAAAAAAAAAAAAAAAAAAAAAAAAAAAAAAAAAAAAAAAAAAAAAAAAAAAAAAAAAAAAAAAAAAAAAAAAAAAAAAAAAAAAAAAAAAAAAAAAAAAAAAAAAAAFAAAADwAAAAAAAAAAAAAAAAAAAkUAAAAAQAAABQAAAAUAAAAFAAAAAEAAAAAAAAAZAAAAGQAAAAAAAAAZAAAAGQAAAAVAAAAYAAAAAAAAAAAAAAADwAAACADAAAAAAAAAAAAAAEAAACgMgAAVgcAAKr4//8BAAAAf39/AAEAAABkAAAAAAAAABQAAABAHwAAAAAAACYAAAAAAAAAwOD//wAAAAAmAAAAZAAAABYAAABMAAAAAAAAAAAAAAAEAAAAAAAAAAEAAACAgIAKAAAAACgAAAAoAAAAZAAAAGQAAAAAAAAAzMzMAAAAAABQAAAAUAAAAGQAAABkAAAAAAAAABcAAAAUAAAAAAAAAAAAAAD/fwAA/38AAAAAAAAJAAAABAAAAAAAAAAeAAAAaAAAAAAAAAAAAAAAAAAAAAAAAAAAAAAAECcAABAnAAAAAAAAAAAAAAAAAAAAAAAAAAAAAAAAAAAAAAAAAAAAABQAAAAAAAAAwMD/AAAAAABkAAAAMgAAAAAAAABkAAAAAAAAAH9/fwAKAAAAIgAAABgAAAAAAAAAAAAAAAAAAAAAAAAAAAAAAAAAAAAkAAAAJAAAAAAAAAAHAAAAAAAAAAAAAAAAAAAAAAAAAAAAAAAAAAAAf39/ACUAAABYAAAAAAAAAAAAAAAAAAAAAAAAAAAAAAAAAAAAAAAAAAAAAAAAAAAAAAAAAAAAAAA/AAAAAAAAAKCGAQAAAAAAAAAAAAAAAAAMAAAAAQAAAAAAAAAAAAAAAAAAAB8AAABUAAAAAAAABQAAAAEAAAAAAAAAAAAAAAAAAAAAAAAAAAAAAAAAAAAAAAAAAAAAAAJ/f38AAAAAA8zMzADAwP8Af39/AAAAAAAAAAAAAAAAAAAAAAAAAAAAIQAAABgAAAAUAAAAwAMAABsnAAA/FQAAWSkAABAAAAAmAAAACAAAAAAAAAAAAAAA"/>
+                <pr:smNativeData xmlns:pr="smNativeData" xmlns="smNativeData" val="SMDATA_15_MvzhaRMAAAAlAAAAZAAAAA8BAAAAkAAAAEgAAACQAAAASAAAAAAAAAABAAAAAAAAAAEAAABQAAAAAAAAAAAA4D8AAAAAAADgPwAAAAAAAOA/AAAAAAAA4D8AAAAAAADgPwAAAAAAAOA/AAAAAAAA4D8AAAAAAADgPwAAAAAAAOA/AAAAAAAA4D8CAAAAjAAAAAAAAAAAAAAAu+DjDP///wgAAAAAAAAAAAAAAAAAAAAAAAAAAAAAAAAAAAAAZAAAAAEAAABAAAAAAAAAAAAAAAAAAAAAAAAAAAAAAAAAAAAAAAAAAAAAAAAAAAAAAAAAAAAAAAAAAAAAAAAAAAAAAAAAAAAAAAAAAAAAAAAAAAAAAAAAAAAAAAAAAAAAFAAAADwAAAAAAAAAAAAAAAAAAAkUAAAAAQAAABQAAAAUAAAAFAAAAAEAAAAAAAAAZAAAAGQAAAAAAAAAZAAAAGQAAAAVAAAAYAAAAAAAAAAAAAAADwAAACADAAAAAAAAAAAAAAEAAACgMgAAVgcAAKr4//8BAAAAf39/AAEAAABkAAAAAAAAABQAAABAHwAAAAAAACYAAAAAAAAAwOD//wAAAAAmAAAAZAAAABYAAABMAAAAAAAAAAAAAAAEAAAAAAAAAAEAAACAgIAKAAAAACgAAAAoAAAAZAAAAGQAAAAAAAAAzMzMAAAAAABQAAAAUAAAAGQAAABkAAAAAAAAABcAAAAUAAAAAAAAAAAAAAD/fwAA/38AAAAAAAAJAAAABAAAAAAAAAAeAAAAaAAAAAAAAAAAAAAAAAAAAAAAAAAAAAAAECcAABAnAAAAAAAAAAAAAAAAAAAAAAAAAAAAAAAAAAAAAAAAAAAAABQAAAAAAAAAwMD/AAAAAABkAAAAMgAAAAAAAABkAAAAAAAAAH9/fwAKAAAAIgAAABgAAAAAAAAAAAAAAAAAAAAAAAAAAAAAAAAAAAAkAAAAJAAAAAAAAAAHAAAAAAAAAAAAAAAAAAAAAAAAAAAAAAAAAAAAf39/ACUAAABYAAAAAAAAAAAAAAAAAAAAAAAAAAAAAAAAAAAAAAAAAAAAAAAAAAAAAAAAAAAAAAA/AAAAAAAAAKCGAQAAAAAAAAAAAAAAAAAMAAAAAQAAAAAAAAAAAAAAAAAAAB8AAABUAAAAAAAABQAAAAEAAAAAAAAAAAAAAAAAAAAAAAAAAAAAAAAAAAAAAAAAAAAAAAJ/f38AAAAAA8zMzADAwP8Af39/AAAAAAAAAAAAAAAAAAAAAAAAAAAAIQAAABgAAAAUAAAAwAMAABsnAAA/FQAAWSkAABAAAAAmAAAACAAAAAAAAAAAAAAA"/>
               </a:ext>
             </a:extLst>
           </p:cNvSpPr>
@@ -529,7 +529,7 @@
           <a:lstStyle/>
           <a:p>
             <a:pPr/>
-            <a:fld id="{2A784A67-29C7-2DBC-89C0-DFE9048E7F8A}" type="datetime1">
+            <a:fld id="{59266C61-2FB4-739A-FA9E-D9CF22D00C8C}" type="datetime1">
               <a:t/>
             </a:fld>
           </a:p>
@@ -542,7 +542,7 @@
             <a:spLocks noGrp="1" noChangeArrowheads="1"/>
             <a:extLst>
               <a:ext uri="smNativeData">
-                <pr:smNativeData xmlns:pr="smNativeData" xmlns="smNativeData" val="SMDATA_15_ZqHWaRMAAAAlAAAAZAAAAA8BAAAAkAAAAEgAAACQAAAASAAAAAAAAAABAAAAAAAAAAEAAABQAAAAAAAAAAAA4D8AAAAAAADgPwAAAAAAAOA/AAAAAAAA4D8AAAAAAADgPwAAAAAAAOA/AAAAAAAA4D8AAAAAAADgPwAAAAAAAOA/AAAAAAAA4D8CAAAAjAAAAAAAAAAAAAAAu+DjDP///wgAAAAAAAAAAAAAAAAAAAAAAAAAAAAAAAAAAAAAZAAAAAEAAABAAAAAAAAAAAAAAAAAAAAAAAAAAAAAAAAAAAAAAAAAAAAAAAAAAAAAAAAAAAAAAAAAAAAAAAAAAAAAAAAAAAAAAAAAAAAAAAAAAAAAAAAAAAAAAAAAAAAAFAAAADwAAAAAAAAAAAAAAAAAAAkUAAAAAQAAABQAAAAUAAAAFAAAAAEAAAAAAAAAZAAAAGQAAAAAAAAAZAAAAGQAAAAVAAAAYAAAAAAAAAAAAAAADwAAACADAAAAAAAAAAAAAAEAAACgMgAAVgcAAKr4//8BAAAAf39/AAEAAABkAAAAAAAAABQAAABAHwAAAAAAACYAAAAAAAAAwOD//wAAAAAmAAAAZAAAABYAAABMAAAAAAAAAAAAAAAEAAAAAAAAAAEAAACAgIAKAAAAACgAAAAoAAAAZAAAAGQAAAAAAAAAzMzMAAAAAABQAAAAUAAAAGQAAABkAAAAAAAAABcAAAAUAAAAAAAAAAAAAAD/fwAA/38AAAAAAAAJAAAABAAAAGE6c3AeAAAAaAAAAAAAAAAAAAAAAAAAAAAAAAAAAAAAECcAABAnAAAAAAAAAAAAAAAAAAAAAAAAAAAAAAAAAAAAAAAAAAAAABQAAAAAAAAAwMD/AAAAAABkAAAAMgAAAAAAAABkAAAAAAAAAH9/fwAKAAAAIgAAABgAAAAAAAAAAAAAAAAAAAAAAAAAAAAAAAAAAAAkAAAAJAAAAAAAAAAHAAAAAAAAAAAAAAAAAAAAAAAAAAAAAAAAAAAAf39/ACUAAABYAAAAAAAAAAAAAAAAAAAAAAAAAAAAAAAAAAAAAAAAAAAAAAAAAAAAAAAAAAAAAAA/AAAAAAAAAKCGAQAAAAAAAAAAAAAAAAAMAAAAAQAAAAAAAAAAAAAAAAAAAB8AAABUAAAAAAAABQAAAAEAAAAAAAAAAAAAAAAAAAAAAAAAAAAAAAAAAAAAAAAAAAAAAAJ/f38AAAAAA8zMzADAwP8Af39/AAAAAAAAAAAAAAAAAAAAAAAAAAAAIQAAABgAAAAUAAAAoRkAABsnAABfMQAAWSkAABAAAAAmAAAACAAAAAAAAAAAAAAA"/>
+                <pr:smNativeData xmlns:pr="smNativeData" xmlns="smNativeData" val="SMDATA_15_MvzhaRMAAAAlAAAAZAAAAA8BAAAAkAAAAEgAAACQAAAASAAAAAAAAAABAAAAAAAAAAEAAABQAAAAAAAAAAAA4D8AAAAAAADgPwAAAAAAAOA/AAAAAAAA4D8AAAAAAADgPwAAAAAAAOA/AAAAAAAA4D8AAAAAAADgPwAAAAAAAOA/AAAAAAAA4D8CAAAAjAAAAAAAAAAAAAAAu+DjDP///wgAAAAAAAAAAAAAAAAAAAAAAAAAAAAAAAAAAAAAZAAAAAEAAABAAAAAAAAAAAAAAAAAAAAAAAAAAAAAAAAAAAAAAAAAAAAAAAAAAAAAAAAAAAAAAAAAAAAAAAAAAAAAAAAAAAAAAAAAAAAAAAAAAAAAAAAAAAAAAAAAAAAAFAAAADwAAAAAAAAAAAAAAAAAAAkUAAAAAQAAABQAAAAUAAAAFAAAAAEAAAAAAAAAZAAAAGQAAAAAAAAAZAAAAGQAAAAVAAAAYAAAAAAAAAAAAAAADwAAACADAAAAAAAAAAAAAAEAAACgMgAAVgcAAKr4//8BAAAAf39/AAEAAABkAAAAAAAAABQAAABAHwAAAAAAACYAAAAAAAAAwOD//wAAAAAmAAAAZAAAABYAAABMAAAAAAAAAAAAAAAEAAAAAAAAAAEAAACAgIAKAAAAACgAAAAoAAAAZAAAAGQAAAAAAAAAzMzMAAAAAABQAAAAUAAAAGQAAABkAAAAAAAAABcAAAAUAAAAAAAAAAAAAAD/fwAA/38AAAAAAAAJAAAABAAAAGE6c3AeAAAAaAAAAAAAAAAAAAAAAAAAAAAAAAAAAAAAECcAABAnAAAAAAAAAAAAAAAAAAAAAAAAAAAAAAAAAAAAAAAAAAAAABQAAAAAAAAAwMD/AAAAAABkAAAAMgAAAAAAAABkAAAAAAAAAH9/fwAKAAAAIgAAABgAAAAAAAAAAAAAAAAAAAAAAAAAAAAAAAAAAAAkAAAAJAAAAAAAAAAHAAAAAAAAAAAAAAAAAAAAAAAAAAAAAAAAAAAAf39/ACUAAABYAAAAAAAAAAAAAAAAAAAAAAAAAAAAAAAAAAAAAAAAAAAAAAAAAAAAAAAAAAAAAAA/AAAAAAAAAKCGAQAAAAAAAAAAAAAAAAAMAAAAAQAAAAAAAAAAAAAAAAAAAB8AAABUAAAAAAAABQAAAAEAAAAAAAAAAAAAAAAAAAAAAAAAAAAAAAAAAAAAAAAAAAAAAAJ/f38AAAAAA8zMzADAwP8Af39/AAAAAAAAAAAAAAAAAAAAAAAAAAAAIQAAABgAAAAUAAAAoRkAABsnAABfMQAAWSkAABAAAAAmAAAACAAAAAAAAAAAAAAA"/>
               </a:ext>
             </a:extLst>
           </p:cNvSpPr>
@@ -566,7 +566,7 @@
             <a:spLocks noGrp="1" noChangeArrowheads="1"/>
             <a:extLst>
               <a:ext uri="smNativeData">
-                <pr:smNativeData xmlns:pr="smNativeData" xmlns="smNativeData" val="SMDATA_15_ZqHWaRMAAAAlAAAAZAAAAA8BAAAAkAAAAEgAAACQAAAASAAAAAAAAAABAAAAAAAAAAEAAABQAAAAAAAAAAAA4D8AAAAAAADgPwAAAAAAAOA/AAAAAAAA4D8AAAAAAADgPwAAAAAAAOA/AAAAAAAA4D8AAAAAAADgPwAAAAAAAOA/AAAAAAAA4D8CAAAAjAAAAAAAAAAAAAAAu+DjDP///wgAAAAAAAAAAAAAAAAAAAAAAAAAAAAAAAAAAAAAZAAAAAEAAABAAAAAAAAAAAAAAAAAAAAAAAAAAAAAAAAAAAAAAAAAAAAAAAAAAAAAAAAAAAAAAAAAAAAAAAAAAAAAAAAAAAAAAAAAAAAAAAAAAAAAAAAAAAAAAAAAAAAAFAAAADwAAAAAAAAAAAAAAAAAAAkUAAAAAQAAABQAAAAUAAAAFAAAAAEAAAAAAAAAZAAAAGQAAAAAAAAAZAAAAGQAAAAVAAAAYAAAAAAAAAAAAAAADwAAACADAAAAAAAAAAAAAAEAAACgMgAAVgcAAKr4//8BAAAAf39/AAEAAABkAAAAAAAAABQAAABAHwAAAAAAACYAAAAAAAAAwOD//wAAAAAmAAAAZAAAABYAAABMAAAAAAAAAAAAAAAEAAAAAAAAAAEAAACAgIAKAAAAACgAAAAoAAAAZAAAAGQAAAAAAAAAzMzMAAAAAABQAAAAUAAAAGQAAABkAAAAAAAAABcAAAAUAAAAAAAAAAAAAAD/fwAA/38AAAAAAAAJAAAABAAAAAAAAAAeAAAAaAAAAAAAAAAAAAAAAAAAAAAAAAAAAAAAECcAABAnAAAAAAAAAAAAAAAAAAAAAAAAAAAAAAAAAAAAAAAAAAAAABQAAAAAAAAAwMD/AAAAAABkAAAAMgAAAAAAAABkAAAAAAAAAH9/fwAKAAAAIgAAABgAAAAAAAAAAAAAAAAAAAAAAAAAAAAAAAAAAAAkAAAAJAAAAAAAAAAHAAAAAAAAAAAAAAAAAAAAAAAAAAAAAAAAAAAAf39/ACUAAABYAAAAAAAAAAAAAAAAAAAAAAAAAAAAAAAAAAAAAAAAAAAAAAAAAAAAAAAAAAAAAAA/AAAAAAAAAKCGAQAAAAAAAAAAAAAAAAAMAAAAAQAAAAAAAAAAAAAAAAAAAB8AAABUAAAAAAAABQAAAAEAAAAAAAAAAAAAAAAAAAAAAAAAAAAAAAAAAAAAAAAAAAAAAAJ/f38AAAAAA8zMzADAwP8Af39/AAAAAAAAAAAAAAAAAAAAAAAAAAAAIQAAABgAAAAUAAAAwTUAABsnAABARwAAWSkAABAAAAAmAAAACAAAAAAAAAAAAAAA"/>
+                <pr:smNativeData xmlns:pr="smNativeData" xmlns="smNativeData" val="SMDATA_15_MvzhaRMAAAAlAAAAZAAAAA8BAAAAkAAAAEgAAACQAAAASAAAAAAAAAABAAAAAAAAAAEAAABQAAAAAAAAAAAA4D8AAAAAAADgPwAAAAAAAOA/AAAAAAAA4D8AAAAAAADgPwAAAAAAAOA/AAAAAAAA4D8AAAAAAADgPwAAAAAAAOA/AAAAAAAA4D8CAAAAjAAAAAAAAAAAAAAAu+DjDP///wgAAAAAAAAAAAAAAAAAAAAAAAAAAAAAAAAAAAAAZAAAAAEAAABAAAAAAAAAAAAAAAAAAAAAAAAAAAAAAAAAAAAAAAAAAAAAAAAAAAAAAAAAAAAAAAAAAAAAAAAAAAAAAAAAAAAAAAAAAAAAAAAAAAAAAAAAAAAAAAAAAAAAFAAAADwAAAAAAAAAAAAAAAAAAAkUAAAAAQAAABQAAAAUAAAAFAAAAAEAAAAAAAAAZAAAAGQAAAAAAAAAZAAAAGQAAAAVAAAAYAAAAAAAAAAAAAAADwAAACADAAAAAAAAAAAAAAEAAACgMgAAVgcAAKr4//8BAAAAf39/AAEAAABkAAAAAAAAABQAAABAHwAAAAAAACYAAAAAAAAAwOD//wAAAAAmAAAAZAAAABYAAABMAAAAAAAAAAAAAAAEAAAAAAAAAAEAAACAgIAKAAAAACgAAAAoAAAAZAAAAGQAAAAAAAAAzMzMAAAAAABQAAAAUAAAAGQAAABkAAAAAAAAABcAAAAUAAAAAAAAAAAAAAD/fwAA/38AAAAAAAAJAAAABAAAAAAAAAAeAAAAaAAAAAAAAAAAAAAAAAAAAAAAAAAAAAAAECcAABAnAAAAAAAAAAAAAAAAAAAAAAAAAAAAAAAAAAAAAAAAAAAAABQAAAAAAAAAwMD/AAAAAABkAAAAMgAAAAAAAABkAAAAAAAAAH9/fwAKAAAAIgAAABgAAAAAAAAAAAAAAAAAAAAAAAAAAAAAAAAAAAAkAAAAJAAAAAAAAAAHAAAAAAAAAAAAAAAAAAAAAAAAAAAAAAAAAAAAf39/ACUAAABYAAAAAAAAAAAAAAAAAAAAAAAAAAAAAAAAAAAAAAAAAAAAAAAAAAAAAAAAAAAAAAA/AAAAAAAAAKCGAQAAAAAAAAAAAAAAAAAMAAAAAQAAAAAAAAAAAAAAAAAAAB8AAABUAAAAAAAABQAAAAEAAAAAAAAAAAAAAAAAAAAAAAAAAAAAAAAAAAAAAAAAAAAAAAJ/f38AAAAAA8zMzADAwP8Af39/AAAAAAAAAAAAAAAAAAAAAAAAAAAAIQAAABgAAAAUAAAAwTUAABsnAABARwAAWSkAABAAAAAmAAAACAAAAAAAAAAAAAAA"/>
               </a:ext>
             </a:extLst>
           </p:cNvSpPr>
@@ -580,7 +580,7 @@
           <a:lstStyle/>
           <a:p>
             <a:pPr/>
-            <a:fld id="{1F58A682-CCF2-0D50-BCE0-3A05E8AE4A6F}" type="slidenum">
+            <a:fld id="{554FE822-6CB8-1A1E-F6F7-9A4BA6B900CF}" type="slidenum">
               <a:t/>
             </a:fld>
           </a:p>
@@ -619,7 +619,7 @@
             <a:spLocks noGrp="1" noChangeArrowheads="1"/>
             <a:extLst>
               <a:ext uri="smNativeData">
-                <pr:smNativeData xmlns:pr="smNativeData" xmlns="smNativeData" val="SMDATA_15_ZqHWaRMAAAAlAAAAZAAAAA8BAAAAkAAAAEgAAACQAAAASAAAAAAAAAACAAAAAQAAAAEAAABQAAAAAAAAAAAA4D8AAAAAAADgPwAAAAAAAOA/AAAAAAAA4D8AAAAAAADgPwAAAAAAAOA/AAAAAAAA4D8AAAAAAADgPwAAAAAAAOA/AAAAAAAA4D8CAAAAjAAAAAAAAAAAAAAAu+DjDP///wgAAAAAAAAAAAAAAAAAAAAAAAAAAAAAAAAAAAAAZAAAAAEAAABAAAAAAAAAAAAAAAAAAAAAAAAAAAAAAAAAAAAAAAAAAAAAAAAAAAAAAAAAAAAAAAAAAAAAAAAAAAAAAAAAAAAAAAAAAAAAAAAAAAAAAAAAAAAAAAAAAAAAFAAAADwAAAAAAAAAAAAAAAAAAAkUAAAAAQAAABQAAAAUAAAAFAAAAAEAAAAAAAAAZAAAAGQAAAAAAAAAZAAAAGQAAAAVAAAAYAAAAAAAAAAAAAAADwAAACADAAAAAAAAAAAAAAEAAACgMgAAVgcAAKr4//8BAAAAf39/AAEAAABkAAAAAAAAABQAAABAHwAAAAAAACYAAAAAAAAAwOD//wAAAAAmAAAAZAAAABYAAABMAAAAAAAAAAAAAAAEAAAAAAAAAAEAAACAgIAKAAAAACgAAAAoAAAAZAAAAGQAAAAAAAAAzMzMAAAAAABQAAAAUAAAAGQAAABkAAAAAAAAABcAAAAUAAAAAAAAAAAAAAD/fwAA/38AAAAAAAAJAAAABAAAAAAAAAAeAAAAaAAAAAAAAAAAAAAAAAAAAAAAAAAAAAAAECcAABAnAAAAAAAAAAAAAAAAAAAAAAAAAAAAAAAAAAAAAAAAAAAAABQAAAAAAAAAwMD/AAAAAABkAAAAMgAAAAAAAABkAAAAAAAAAH9/fwAKAAAAIgAAABgAAAAAAAAAAAAAAAAAAAAAAAAAAAAAAAAAAAAkAAAAJAAAAAAAAAAHAAAAAAAAAAAAAAAAAAAAAAAAAAAAAAAAAAAAf39/ACUAAABYAAAAAAAAAAAAAAAAAAAAAAAAAAAAAAAAAAAAAAAAAAAAAAAAAAAAAAAAAAAAAAA/AAAAAAAAAKCGAQAAAAAAAAAAAAAAAAAMAAAAAQAAAAAAAAAAAAAAAAAAAB8AAABUAAAAAAAABQAAAAEAAAAAAAAAAAAAAAAAAAAAAAAAAAAAAAAAAAAAAAAAAAAAAAJ/f38AAAAAA8zMzADAwP8Af39/AAAAAAAAAAAAAAAAAAAAAAAAAAAAIQAAABgAAAAUAAAAYDYAALABAABARwAAsCUAABAAAAAmAAAACAAAAIMAAAAAAAAA"/>
+                <pr:smNativeData xmlns:pr="smNativeData" xmlns="smNativeData" val="SMDATA_15_MvzhaRMAAAAlAAAAZAAAAA8BAAAAkAAAAEgAAACQAAAASAAAAAAAAAACAAAAAQAAAAEAAABQAAAAAAAAAAAA4D8AAAAAAADgPwAAAAAAAOA/AAAAAAAA4D8AAAAAAADgPwAAAAAAAOA/AAAAAAAA4D8AAAAAAADgPwAAAAAAAOA/AAAAAAAA4D8CAAAAjAAAAAAAAAAAAAAAu+DjDP///wgAAAAAAAAAAAAAAAAAAAAAAAAAAAAAAAAAAAAAZAAAAAEAAABAAAAAAAAAAAAAAAAAAAAAAAAAAAAAAAAAAAAAAAAAAAAAAAAAAAAAAAAAAAAAAAAAAAAAAAAAAAAAAAAAAAAAAAAAAAAAAAAAAAAAAAAAAAAAAAAAAAAAFAAAADwAAAAAAAAAAAAAAAAAAAkUAAAAAQAAABQAAAAUAAAAFAAAAAEAAAAAAAAAZAAAAGQAAAAAAAAAZAAAAGQAAAAVAAAAYAAAAAAAAAAAAAAADwAAACADAAAAAAAAAAAAAAEAAACgMgAAVgcAAKr4//8BAAAAf39/AAEAAABkAAAAAAAAABQAAABAHwAAAAAAACYAAAAAAAAAwOD//wAAAAAmAAAAZAAAABYAAABMAAAAAAAAAAAAAAAEAAAAAAAAAAEAAACAgIAKAAAAACgAAAAoAAAAZAAAAGQAAAAAAAAAzMzMAAAAAABQAAAAUAAAAGQAAABkAAAAAAAAABcAAAAUAAAAAAAAAAAAAAD/fwAA/38AAAAAAAAJAAAABAAAAAAAAAAeAAAAaAAAAAAAAAAAAAAAAAAAAAAAAAAAAAAAECcAABAnAAAAAAAAAAAAAAAAAAAAAAAAAAAAAAAAAAAAAAAAAAAAABQAAAAAAAAAwMD/AAAAAABkAAAAMgAAAAAAAABkAAAAAAAAAH9/fwAKAAAAIgAAABgAAAAAAAAAAAAAAAAAAAAAAAAAAAAAAAAAAAAkAAAAJAAAAAAAAAAHAAAAAAAAAAAAAAAAAAAAAAAAAAAAAAAAAAAAf39/ACUAAABYAAAAAAAAAAAAAAAAAAAAAAAAAAAAAAAAAAAAAAAAAAAAAAAAAAAAAAAAAAAAAAA/AAAAAAAAAKCGAQAAAAAAAAAAAAAAAAAMAAAAAQAAAAAAAAAAAAAAAAAAAB8AAABUAAAAAAAABQAAAAEAAAAAAAAAAAAAAAAAAAAAAAAAAAAAAAAAAAAAAAAAAAAAAAJ/f38AAAAAA8zMzADAwP8Af39/AAAAAAAAAAAAAAAAAAAAAAAAAAAAIQAAABgAAAAUAAAAYDYAALABAABARwAAsCUAABAAAAAmAAAACAAAAIMAAAAAAAAA"/>
               </a:ext>
             </a:extLst>
           </p:cNvSpPr>
@@ -655,7 +655,7 @@
             <a:spLocks noGrp="1" noChangeArrowheads="1"/>
             <a:extLst>
               <a:ext uri="smNativeData">
-                <pr:smNativeData xmlns:pr="smNativeData" xmlns="smNativeData" val="SMDATA_15_ZqHWaRMAAAAlAAAAZAAAAA8BAAAAkAAAAEgAAACQAAAASAAAAAAAAAAAAAAAAQAAAAEAAABQAAAAAAAAAAAA4D8AAAAAAADgPwAAAAAAAOA/AAAAAAAA4D8AAAAAAADgPwAAAAAAAOA/AAAAAAAA4D8AAAAAAADgPwAAAAAAAOA/AAAAAAAA4D8CAAAAjAAAAAAAAAAAAAAAu+DjDP///wgAAAAAAAAAAAAAAAAAAAAAAAAAAAAAAAAAAAAAZAAAAAEAAABAAAAAAAAAAAAAAAAAAAAAAAAAAAAAAAAAAAAAAAAAAAAAAAAAAAAAAAAAAAAAAAAAAAAAAAAAAAAAAAAAAAAAAAAAAAAAAAAAAAAAAAAAAAAAAAAAAAAAFAAAADwAAAAAAAAAAAAAAAAAAAkUAAAAAQAAABQAAAAUAAAAFAAAAAEAAAAAAAAAZAAAAGQAAAAAAAAAZAAAAGQAAAAVAAAAYAAAAAAAAAAAAAAADwAAACADAAAAAAAAAAAAAAEAAACgMgAAVgcAAKr4//8BAAAAf39/AAEAAABkAAAAAAAAABQAAABAHwAAAAAAACYAAAAAAAAAwOD//wAAAAAmAAAAZAAAABYAAABMAAAAAAAAAAAAAAAEAAAAAAAAAAEAAACAgIAKAAAAACgAAAAoAAAAZAAAAGQAAAAAAAAAzMzMAAAAAABQAAAAUAAAAGQAAABkAAAAAAAAABcAAAAUAAAAAAAAAAAAAAD/fwAA/38AAAAAAAAJAAAABAAAAAAAAAAeAAAAaAAAAAAAAAAAAAAAAAAAAAAAAAAAAAAAECcAABAnAAAAAAAAAAAAAAAAAAAAAAAAAAAAAAAAAAAAAAAAAAAAABQAAAAAAAAAwMD/AAAAAABkAAAAMgAAAAAAAABkAAAAAAAAAH9/fwAKAAAAIgAAABgAAAAAAAAAAAAAAAAAAAAAAAAAAAAAAAAAAAAkAAAAJAAAAAAAAAAHAAAAAAAAAAAAAAAAAAAAAAAAAAAAAAAAAAAAf39/ACUAAABYAAAAAAAAAAAAAAAAAAAAAAAAAAAAAAAAAAAAAAAAAAAAAAAAAAAAAAAAAAAAAAA/AAAAAAAAAKCGAQAAAAAAAAAAAAAAAAAMAAAAAQAAAAAAAAAAAAAAAAAAAB8AAABUAAAAAAAABQAAAAEAAAAAAAAAAAAAAAAAAAAAAAAAAAAAAAAAAAAAAAAAAAAAAAJ/f38AAAAAA8zMzADAwP8Af39/AAAAAAAAAAAAAAAAAAAAAAAAAAAAIQAAABgAAAAUAAAAwAMAALABAAAfNQAAsCUAABAAAAAmAAAACAAAAAMAAAAAAAAA"/>
+                <pr:smNativeData xmlns:pr="smNativeData" xmlns="smNativeData" val="SMDATA_15_MvzhaRMAAAAlAAAAZAAAAA8BAAAAkAAAAEgAAACQAAAASAAAAAAAAAAAAAAAAQAAAAEAAABQAAAAAAAAAAAA4D8AAAAAAADgPwAAAAAAAOA/AAAAAAAA4D8AAAAAAADgPwAAAAAAAOA/AAAAAAAA4D8AAAAAAADgPwAAAAAAAOA/AAAAAAAA4D8CAAAAjAAAAAAAAAAAAAAAu+DjDP///wgAAAAAAAAAAAAAAAAAAAAAAAAAAAAAAAAAAAAAZAAAAAEAAABAAAAAAAAAAAAAAAAAAAAAAAAAAAAAAAAAAAAAAAAAAAAAAAAAAAAAAAAAAAAAAAAAAAAAAAAAAAAAAAAAAAAAAAAAAAAAAAAAAAAAAAAAAAAAAAAAAAAAFAAAADwAAAAAAAAAAAAAAAAAAAkUAAAAAQAAABQAAAAUAAAAFAAAAAEAAAAAAAAAZAAAAGQAAAAAAAAAZAAAAGQAAAAVAAAAYAAAAAAAAAAAAAAADwAAACADAAAAAAAAAAAAAAEAAACgMgAAVgcAAKr4//8BAAAAf39/AAEAAABkAAAAAAAAABQAAABAHwAAAAAAACYAAAAAAAAAwOD//wAAAAAmAAAAZAAAABYAAABMAAAAAAAAAAAAAAAEAAAAAAAAAAEAAACAgIAKAAAAACgAAAAoAAAAZAAAAGQAAAAAAAAAzMzMAAAAAABQAAAAUAAAAGQAAABkAAAAAAAAABcAAAAUAAAAAAAAAAAAAAD/fwAA/38AAAAAAAAJAAAABAAAAAAAAAAeAAAAaAAAAAAAAAAAAAAAAAAAAAAAAAAAAAAAECcAABAnAAAAAAAAAAAAAAAAAAAAAAAAAAAAAAAAAAAAAAAAAAAAABQAAAAAAAAAwMD/AAAAAABkAAAAMgAAAAAAAABkAAAAAAAAAH9/fwAKAAAAIgAAABgAAAAAAAAAAAAAAAAAAAAAAAAAAAAAAAAAAAAkAAAAJAAAAAAAAAAHAAAAAAAAAAAAAAAAAAAAAAAAAAAAAAAAAAAAf39/ACUAAABYAAAAAAAAAAAAAAAAAAAAAAAAAAAAAAAAAAAAAAAAAAAAAAAAAAAAAAAAAAAAAAA/AAAAAAAAAKCGAQAAAAAAAAAAAAAAAAAMAAAAAQAAAAAAAAAAAAAAAAAAAB8AAABUAAAAAAAABQAAAAEAAAAAAAAAAAAAAAAAAAAAAAAAAAAAAAAAAAAAAAAAAAAAAAJ/f38AAAAAA8zMzADAwP8Af39/AAAAAAAAAAAAAAAAAAAAAAAAAAAAIQAAABgAAAAUAAAAwAMAALABAAAfNQAAsCUAABAAAAAmAAAACAAAAAMAAAAAAAAA"/>
               </a:ext>
             </a:extLst>
           </p:cNvSpPr>
@@ -715,7 +715,7 @@
             <a:spLocks noGrp="1" noChangeArrowheads="1"/>
             <a:extLst>
               <a:ext uri="smNativeData">
-                <pr:smNativeData xmlns:pr="smNativeData" xmlns="smNativeData" val="SMDATA_15_ZqHWaRMAAAAlAAAAZAAAAA8BAAAAkAAAAEgAAACQAAAASAAAAAAAAAABAAAAAAAAAAEAAABQAAAAAAAAAAAA4D8AAAAAAADgPwAAAAAAAOA/AAAAAAAA4D8AAAAAAADgPwAAAAAAAOA/AAAAAAAA4D8AAAAAAADgPwAAAAAAAOA/AAAAAAAA4D8CAAAAjAAAAAAAAAAAAAAAu+DjDP///wgAAAAAAAAAAAAAAAAAAAAAAAAAAAAAAAAAAAAAZAAAAAEAAABAAAAAAAAAAAAAAAAAAAAAAAAAAAAAAAAAAAAAAAAAAAAAAAAAAAAAAAAAAAAAAAAAAAAAAAAAAAAAAAAAAAAAAAAAAAAAAAAAAAAAAAAAAAAAAAAAAAAAFAAAADwAAAAAAAAAAAAAAAAAAAkUAAAAAQAAABQAAAAUAAAAFAAAAAEAAAAAAAAAZAAAAGQAAAAAAAAAZAAAAGQAAAAVAAAAYAAAAAAAAAAAAAAADwAAACADAAAAAAAAAAAAAAEAAACgMgAAVgcAAKr4//8BAAAAf39/AAEAAABkAAAAAAAAABQAAABAHwAAAAAAACYAAAAAAAAAwOD//wAAAAAmAAAAZAAAABYAAABMAAAAAAAAAAAAAAAEAAAAAAAAAAEAAACAgIAKAAAAACgAAAAoAAAAZAAAAGQAAAAAAAAAzMzMAAAAAABQAAAAUAAAAGQAAABkAAAAAAAAABcAAAAUAAAAAAAAAAAAAAD/fwAA/38AAAAAAAAJAAAABAAAAAAAAAAeAAAAaAAAAAAAAAAAAAAAAAAAAAAAAAAAAAAAECcAABAnAAAAAAAAAAAAAAAAAAAAAAAAAAAAAAAAAAAAAAAAAAAAABQAAAAAAAAAwMD/AAAAAABkAAAAMgAAAAAAAABkAAAAAAAAAH9/fwAKAAAAIgAAABgAAAAAAAAAAAAAAAAAAAAAAAAAAAAAAAAAAAAkAAAAJAAAAAAAAAAHAAAAAAAAAAAAAAAAAAAAAAAAAAAAAAAAAAAAf39/ACUAAABYAAAAAAAAAAAAAAAAAAAAAAAAAAAAAAAAAAAAAAAAAAAAAAAAAAAAAAAAAAAAAAA/AAAAAAAAAKCGAQAAAAAAAAAAAAAAAAAMAAAAAQAAAAAAAAAAAAAAAAAAAB8AAABUAAAAAAAABQAAAAEAAAAAAAAAAAAAAAAAAAAAAAAAAAAAAAAAAAAAAAAAAAAAAAJ/f38AAAAAA8zMzADAwP8Af39/AAAAAAAAAAAAAAAAAAAAAAAAAAAAIQAAABgAAAAUAAAAwAMAABsnAAA/FQAAWSkAABAAAAAmAAAACAAAAAAAAAAAAAAA"/>
+                <pr:smNativeData xmlns:pr="smNativeData" xmlns="smNativeData" val="SMDATA_15_MvzhaRMAAAAlAAAAZAAAAA8BAAAAkAAAAEgAAACQAAAASAAAAAAAAAABAAAAAAAAAAEAAABQAAAAAAAAAAAA4D8AAAAAAADgPwAAAAAAAOA/AAAAAAAA4D8AAAAAAADgPwAAAAAAAOA/AAAAAAAA4D8AAAAAAADgPwAAAAAAAOA/AAAAAAAA4D8CAAAAjAAAAAAAAAAAAAAAu+DjDP///wgAAAAAAAAAAAAAAAAAAAAAAAAAAAAAAAAAAAAAZAAAAAEAAABAAAAAAAAAAAAAAAAAAAAAAAAAAAAAAAAAAAAAAAAAAAAAAAAAAAAAAAAAAAAAAAAAAAAAAAAAAAAAAAAAAAAAAAAAAAAAAAAAAAAAAAAAAAAAAAAAAAAAFAAAADwAAAAAAAAAAAAAAAAAAAkUAAAAAQAAABQAAAAUAAAAFAAAAAEAAAAAAAAAZAAAAGQAAAAAAAAAZAAAAGQAAAAVAAAAYAAAAAAAAAAAAAAADwAAACADAAAAAAAAAAAAAAEAAACgMgAAVgcAAKr4//8BAAAAf39/AAEAAABkAAAAAAAAABQAAABAHwAAAAAAACYAAAAAAAAAwOD//wAAAAAmAAAAZAAAABYAAABMAAAAAAAAAAAAAAAEAAAAAAAAAAEAAACAgIAKAAAAACgAAAAoAAAAZAAAAGQAAAAAAAAAzMzMAAAAAABQAAAAUAAAAGQAAABkAAAAAAAAABcAAAAUAAAAAAAAAAAAAAD/fwAA/38AAAAAAAAJAAAABAAAAAAAAAAeAAAAaAAAAAAAAAAAAAAAAAAAAAAAAAAAAAAAECcAABAnAAAAAAAAAAAAAAAAAAAAAAAAAAAAAAAAAAAAAAAAAAAAABQAAAAAAAAAwMD/AAAAAABkAAAAMgAAAAAAAABkAAAAAAAAAH9/fwAKAAAAIgAAABgAAAAAAAAAAAAAAAAAAAAAAAAAAAAAAAAAAAAkAAAAJAAAAAAAAAAHAAAAAAAAAAAAAAAAAAAAAAAAAAAAAAAAAAAAf39/ACUAAABYAAAAAAAAAAAAAAAAAAAAAAAAAAAAAAAAAAAAAAAAAAAAAAAAAAAAAAAAAAAAAAA/AAAAAAAAAKCGAQAAAAAAAAAAAAAAAAAMAAAAAQAAAAAAAAAAAAAAAAAAAB8AAABUAAAAAAAABQAAAAEAAAAAAAAAAAAAAAAAAAAAAAAAAAAAAAAAAAAAAAAAAAAAAAJ/f38AAAAAA8zMzADAwP8Af39/AAAAAAAAAAAAAAAAAAAAAAAAAAAAIQAAABgAAAAUAAAAwAMAABsnAAA/FQAAWSkAABAAAAAmAAAACAAAAAAAAAAAAAAA"/>
               </a:ext>
             </a:extLst>
           </p:cNvSpPr>
@@ -729,7 +729,7 @@
           <a:lstStyle/>
           <a:p>
             <a:pPr/>
-            <a:fld id="{0F5E14A8-E6E2-0BE2-ACE6-10B75AA85A45}" type="datetime1">
+            <a:fld id="{5D35B15E-10B0-6047-FE8D-E612FFC308B3}" type="datetime1">
               <a:t/>
             </a:fld>
           </a:p>
@@ -742,7 +742,7 @@
             <a:spLocks noGrp="1" noChangeArrowheads="1"/>
             <a:extLst>
               <a:ext uri="smNativeData">
-                <pr:smNativeData xmlns:pr="smNativeData" xmlns="smNativeData" val="SMDATA_15_ZqHWaRMAAAAlAAAAZAAAAA8BAAAAkAAAAEgAAACQAAAASAAAAAAAAAABAAAAAAAAAAEAAABQAAAAAAAAAAAA4D8AAAAAAADgPwAAAAAAAOA/AAAAAAAA4D8AAAAAAADgPwAAAAAAAOA/AAAAAAAA4D8AAAAAAADgPwAAAAAAAOA/AAAAAAAA4D8CAAAAjAAAAAAAAAAAAAAAu+DjDP///wgAAAAAAAAAAAAAAAAAAAAAAAAAAAAAAAAAAAAAZAAAAAEAAABAAAAAAAAAAAAAAAAAAAAAAAAAAAAAAAAAAAAAAAAAAAAAAAAAAAAAAAAAAAAAAAAAAAAAAAAAAAAAAAAAAAAAAAAAAAAAAAAAAAAAAAAAAAAAAAAAAAAAFAAAADwAAAAAAAAAAAAAAAAAAAkUAAAAAQAAABQAAAAUAAAAFAAAAAEAAAAAAAAAZAAAAGQAAAAAAAAAZAAAAGQAAAAVAAAAYAAAAAAAAAAAAAAADwAAACADAAAAAAAAAAAAAAEAAACgMgAAVgcAAKr4//8BAAAAf39/AAEAAABkAAAAAAAAABQAAABAHwAAAAAAACYAAAAAAAAAwOD//wAAAAAmAAAAZAAAABYAAABMAAAAAAAAAAAAAAAEAAAAAAAAAAEAAACAgIAKAAAAACgAAAAoAAAAZAAAAGQAAAAAAAAAzMzMAAAAAABQAAAAUAAAAGQAAABkAAAAAAAAABcAAAAUAAAAAAAAAAAAAAD/fwAA/38AAAAAAAAJAAAABAAAAAAAAAAeAAAAaAAAAAAAAAAAAAAAAAAAAAAAAAAAAAAAECcAABAnAAAAAAAAAAAAAAAAAAAAAAAAAAAAAAAAAAAAAAAAAAAAABQAAAAAAAAAwMD/AAAAAABkAAAAMgAAAAAAAABkAAAAAAAAAH9/fwAKAAAAIgAAABgAAAAAAAAAAAAAAAAAAAAAAAAAAAAAAAAAAAAkAAAAJAAAAAAAAAAHAAAAAAAAAAAAAAAAAAAAAAAAAAAAAAAAAAAAf39/ACUAAABYAAAAAAAAAAAAAAAAAAAAAAAAAAAAAAAAAAAAAAAAAAAAAAAAAAAAAAAAAAAAAAA/AAAAAAAAAKCGAQAAAAAAAAAAAAAAAAAMAAAAAQAAAAAAAAAAAAAAAAAAAB8AAABUAAAAAAAABQAAAAEAAAAAAAAAAAAAAAAAAAAAAAAAAAAAAAAAAAAAAAAAAAAAAAJ/f38AAAAAA8zMzADAwP8Af39/AAAAAAAAAAAAAAAAAAAAAAAAAAAAIQAAABgAAAAUAAAAoRkAABsnAABfMQAAWSkAABAAAAAmAAAACAAAAAAAAAAAAAAA"/>
+                <pr:smNativeData xmlns:pr="smNativeData" xmlns="smNativeData" val="SMDATA_15_MvzhaRMAAAAlAAAAZAAAAA8BAAAAkAAAAEgAAACQAAAASAAAAAAAAAABAAAAAAAAAAEAAABQAAAAAAAAAAAA4D8AAAAAAADgPwAAAAAAAOA/AAAAAAAA4D8AAAAAAADgPwAAAAAAAOA/AAAAAAAA4D8AAAAAAADgPwAAAAAAAOA/AAAAAAAA4D8CAAAAjAAAAAAAAAAAAAAAu+DjDP///wgAAAAAAAAAAAAAAAAAAAAAAAAAAAAAAAAAAAAAZAAAAAEAAABAAAAAAAAAAAAAAAAAAAAAAAAAAAAAAAAAAAAAAAAAAAAAAAAAAAAAAAAAAAAAAAAAAAAAAAAAAAAAAAAAAAAAAAAAAAAAAAAAAAAAAAAAAAAAAAAAAAAAFAAAADwAAAAAAAAAAAAAAAAAAAkUAAAAAQAAABQAAAAUAAAAFAAAAAEAAAAAAAAAZAAAAGQAAAAAAAAAZAAAAGQAAAAVAAAAYAAAAAAAAAAAAAAADwAAACADAAAAAAAAAAAAAAEAAACgMgAAVgcAAKr4//8BAAAAf39/AAEAAABkAAAAAAAAABQAAABAHwAAAAAAACYAAAAAAAAAwOD//wAAAAAmAAAAZAAAABYAAABMAAAAAAAAAAAAAAAEAAAAAAAAAAEAAACAgIAKAAAAACgAAAAoAAAAZAAAAGQAAAAAAAAAzMzMAAAAAABQAAAAUAAAAGQAAABkAAAAAAAAABcAAAAUAAAAAAAAAAAAAAD/fwAA/38AAAAAAAAJAAAABAAAAAAAAAAeAAAAaAAAAAAAAAAAAAAAAAAAAAAAAAAAAAAAECcAABAnAAAAAAAAAAAAAAAAAAAAAAAAAAAAAAAAAAAAAAAAAAAAABQAAAAAAAAAwMD/AAAAAABkAAAAMgAAAAAAAABkAAAAAAAAAH9/fwAKAAAAIgAAABgAAAAAAAAAAAAAAAAAAAAAAAAAAAAAAAAAAAAkAAAAJAAAAAAAAAAHAAAAAAAAAAAAAAAAAAAAAAAAAAAAAAAAAAAAf39/ACUAAABYAAAAAAAAAAAAAAAAAAAAAAAAAAAAAAAAAAAAAAAAAAAAAAAAAAAAAAAAAAAAAAA/AAAAAAAAAKCGAQAAAAAAAAAAAAAAAAAMAAAAAQAAAAAAAAAAAAAAAAAAAB8AAABUAAAAAAAABQAAAAEAAAAAAAAAAAAAAAAAAAAAAAAAAAAAAAAAAAAAAAAAAAAAAAJ/f38AAAAAA8zMzADAwP8Af39/AAAAAAAAAAAAAAAAAAAAAAAAAAAAIQAAABgAAAAUAAAAoRkAABsnAABfMQAAWSkAABAAAAAmAAAACAAAAAAAAAAAAAAA"/>
               </a:ext>
             </a:extLst>
           </p:cNvSpPr>
@@ -766,7 +766,7 @@
             <a:spLocks noGrp="1" noChangeArrowheads="1"/>
             <a:extLst>
               <a:ext uri="smNativeData">
-                <pr:smNativeData xmlns:pr="smNativeData" xmlns="smNativeData" val="SMDATA_15_ZqHWaRMAAAAlAAAAZAAAAA8BAAAAkAAAAEgAAACQAAAASAAAAAAAAAABAAAAAAAAAAEAAABQAAAAAAAAAAAA4D8AAAAAAADgPwAAAAAAAOA/AAAAAAAA4D8AAAAAAADgPwAAAAAAAOA/AAAAAAAA4D8AAAAAAADgPwAAAAAAAOA/AAAAAAAA4D8CAAAAjAAAAAAAAAAAAAAAu+DjDP///wgAAAAAAAAAAAAAAAAAAAAAAAAAAAAAAAAAAAAAZAAAAAEAAABAAAAAAAAAAAAAAAAAAAAAAAAAAAAAAAAAAAAAAAAAAAAAAAAAAAAAAAAAAAAAAAAAAAAAAAAAAAAAAAAAAAAAAAAAAAAAAAAAAAAAAAAAAAAAAAAAAAAAFAAAADwAAAAAAAAAAAAAAAAAAAkUAAAAAQAAABQAAAAUAAAAFAAAAAEAAAAAAAAAZAAAAGQAAAAAAAAAZAAAAGQAAAAVAAAAYAAAAAAAAAAAAAAADwAAACADAAAAAAAAAAAAAAEAAACgMgAAVgcAAKr4//8BAAAAf39/AAEAAABkAAAAAAAAABQAAABAHwAAAAAAACYAAAAAAAAAwOD//wAAAAAmAAAAZAAAABYAAABMAAAAAAAAAAAAAAAEAAAAAAAAAAEAAACAgIAKAAAAACgAAAAoAAAAZAAAAGQAAAAAAAAAzMzMAAAAAABQAAAAUAAAAGQAAABkAAAAAAAAABcAAAAUAAAAAAAAAAAAAAD/fwAA/38AAAAAAAAJAAAABAAAAAAAAAAeAAAAaAAAAAAAAAAAAAAAAAAAAAAAAAAAAAAAECcAABAnAAAAAAAAAAAAAAAAAAAAAAAAAAAAAAAAAAAAAAAAAAAAABQAAAAAAAAAwMD/AAAAAABkAAAAMgAAAAAAAABkAAAAAAAAAH9/fwAKAAAAIgAAABgAAAAAAAAAAAAAAAAAAAAAAAAAAAAAAAAAAAAkAAAAJAAAAAAAAAAHAAAAAAAAAAAAAAAAAAAAAAAAAAAAAAAAAAAAf39/ACUAAABYAAAAAAAAAAAAAAAAAAAAAAAAAAAAAAAAAAAAAAAAAAAAAAAAAAAAAAAAAAAAAAA/AAAAAAAAAKCGAQAAAAAAAAAAAAAAAAAMAAAAAQAAAAAAAAAAAAAAAAAAAB8AAABUAAAAAAAABQAAAAEAAAAAAAAAAAAAAAAAAAAAAAAAAAAAAAAAAAAAAAAAAAAAAAJ/f38AAAAAA8zMzADAwP8Af39/AAAAAAAAAAAAAAAAAAAAAAAAAAAAIQAAABgAAAAUAAAAwTUAABsnAABARwAAWSkAABAAAAAmAAAACAAAAAAAAAAAAAAA"/>
+                <pr:smNativeData xmlns:pr="smNativeData" xmlns="smNativeData" val="SMDATA_15_MvzhaRMAAAAlAAAAZAAAAA8BAAAAkAAAAEgAAACQAAAASAAAAAAAAAABAAAAAAAAAAEAAABQAAAAAAAAAAAA4D8AAAAAAADgPwAAAAAAAOA/AAAAAAAA4D8AAAAAAADgPwAAAAAAAOA/AAAAAAAA4D8AAAAAAADgPwAAAAAAAOA/AAAAAAAA4D8CAAAAjAAAAAAAAAAAAAAAu+DjDP///wgAAAAAAAAAAAAAAAAAAAAAAAAAAAAAAAAAAAAAZAAAAAEAAABAAAAAAAAAAAAAAAAAAAAAAAAAAAAAAAAAAAAAAAAAAAAAAAAAAAAAAAAAAAAAAAAAAAAAAAAAAAAAAAAAAAAAAAAAAAAAAAAAAAAAAAAAAAAAAAAAAAAAFAAAADwAAAAAAAAAAAAAAAAAAAkUAAAAAQAAABQAAAAUAAAAFAAAAAEAAAAAAAAAZAAAAGQAAAAAAAAAZAAAAGQAAAAVAAAAYAAAAAAAAAAAAAAADwAAACADAAAAAAAAAAAAAAEAAACgMgAAVgcAAKr4//8BAAAAf39/AAEAAABkAAAAAAAAABQAAABAHwAAAAAAACYAAAAAAAAAwOD//wAAAAAmAAAAZAAAABYAAABMAAAAAAAAAAAAAAAEAAAAAAAAAAEAAACAgIAKAAAAACgAAAAoAAAAZAAAAGQAAAAAAAAAzMzMAAAAAABQAAAAUAAAAGQAAABkAAAAAAAAABcAAAAUAAAAAAAAAAAAAAD/fwAA/38AAAAAAAAJAAAABAAAAAAAAAAeAAAAaAAAAAAAAAAAAAAAAAAAAAAAAAAAAAAAECcAABAnAAAAAAAAAAAAAAAAAAAAAAAAAAAAAAAAAAAAAAAAAAAAABQAAAAAAAAAwMD/AAAAAABkAAAAMgAAAAAAAABkAAAAAAAAAH9/fwAKAAAAIgAAABgAAAAAAAAAAAAAAAAAAAAAAAAAAAAAAAAAAAAkAAAAJAAAAAAAAAAHAAAAAAAAAAAAAAAAAAAAAAAAAAAAAAAAAAAAf39/ACUAAABYAAAAAAAAAAAAAAAAAAAAAAAAAAAAAAAAAAAAAAAAAAAAAAAAAAAAAAAAAAAAAAA/AAAAAAAAAKCGAQAAAAAAAAAAAAAAAAAMAAAAAQAAAAAAAAAAAAAAAAAAAB8AAABUAAAAAAAABQAAAAEAAAAAAAAAAAAAAAAAAAAAAAAAAAAAAAAAAAAAAAAAAAAAAAJ/f38AAAAAA8zMzADAwP8Af39/AAAAAAAAAAAAAAAAAAAAAAAAAAAAIQAAABgAAAAUAAAAwTUAABsnAABARwAAWSkAABAAAAAmAAAACAAAAAAAAAAAAAAA"/>
               </a:ext>
             </a:extLst>
           </p:cNvSpPr>
@@ -780,7 +780,7 @@
           <a:lstStyle/>
           <a:p>
             <a:pPr/>
-            <a:fld id="{7EE416F2-BC93-B1E0-DD5C-4AB558122B1F}" type="slidenum">
+            <a:fld id="{15163080-CEF8-43C6-B6AE-38937EE0406D}" type="slidenum">
               <a:t/>
             </a:fld>
           </a:p>
@@ -819,7 +819,7 @@
             <a:spLocks noGrp="1" noChangeArrowheads="1"/>
             <a:extLst>
               <a:ext uri="smNativeData">
-                <pr:smNativeData xmlns:pr="smNativeData" xmlns="smNativeData" val="SMDATA_15_ZqHWaRMAAAAlAAAAZAAAAA8BAAAAkAAAAEgAAACQAAAASAAAAAAAAAABAAAAAAAAAAEAAABQAAAAAAAAAAAA4D8AAAAAAADgPwAAAAAAAOA/AAAAAAAA4D8AAAAAAADgPwAAAAAAAOA/AAAAAAAA4D8AAAAAAADgPwAAAAAAAOA/AAAAAAAA4D8CAAAAjAAAAAAAAAAAAAAAu+DjDP///wgAAAAAAAAAAAAAAAAAAAAAAAAAAAAAAAAAAAAAZAAAAAEAAABAAAAAAAAAAAAAAAAAAAAAAAAAAAAAAAAAAAAAAAAAAAAAAAAAAAAAAAAAAAAAAAAAAAAAAAAAAAAAAAAAAAAAAAAAAAAAAAAAAAAAAAAAAAAAAAAAAAAAFAAAADwAAAAAAAAAAAAAAAAAAAkUAAAAAQAAABQAAAAUAAAAFAAAAAEAAAAAAAAAZAAAAGQAAAAAAAAAZAAAAGQAAAAVAAAAYAAAAAAAAAAAAAAADwAAACADAAAAAAAAAAAAAAEAAACgMgAAVgcAAKr4//8BAAAAf39/AAEAAABkAAAAAAAAABQAAABAHwAAAAAAACYAAAAAAAAAwOD//wAAAAAmAAAAZAAAABYAAABMAAAAAAAAAAAAAAAEAAAAAAAAAAEAAACAgIAKAAAAACgAAAAoAAAAZAAAAGQAAAAAAAAAzMzMAAAAAABQAAAAUAAAAGQAAABkAAAAAAAAABcAAAAUAAAAAAAAAAAAAAD/fwAA/38AAAAAAAAJAAAABAAAAAAAAAAeAAAAaAAAAAAAAAAAAAAAAAAAAAAAAAAAAAAAECcAABAnAAAAAAAAAAAAAAAAAAAAAAAAAAAAAAAAAAAAAAAAAAAAABQAAAAAAAAAwMD/AAAAAABkAAAAMgAAAAAAAABkAAAAAAAAAH9/fwAKAAAAIgAAABgAAAAAAAAAAAAAAAAAAAAAAAAAAAAAAAAAAAAkAAAAJAAAAAAAAAAHAAAAAAAAAAAAAAAAAAAAAAAAAAAAAAAAAAAAf39/ACUAAABYAAAAAAAAAAAAAAAAAAAAAAAAAAAAAAAAAAAAAAAAAAAAAAAAAAAAAAAAAAAAAAA/AAAAAAAAAKCGAQAAAAAAAAAAAAAAAAAMAAAAAQAAAAAAAAAAAAAAAAAAAB8AAABUAAAAAAAABQAAAAEAAAAAAAAAAAAAAAAAAAAAAAAAAAAAAAAAAAAAAAAAAAAAAAJ/f38AAAAAA8zMzADAwP8Af39/AAAAAAAAAAAAAAAAAAAAAAAAAAAAIQAAABgAAAAUAAAAwAMAALABAABARwAAuAgAABAAAAAmAAAACAAAAAAAAAAAAAAA"/>
+                <pr:smNativeData xmlns:pr="smNativeData" xmlns="smNativeData" val="SMDATA_15_MvzhaRMAAAAlAAAAZAAAAA8BAAAAkAAAAEgAAACQAAAASAAAAAAAAAABAAAAAAAAAAEAAABQAAAAAAAAAAAA4D8AAAAAAADgPwAAAAAAAOA/AAAAAAAA4D8AAAAAAADgPwAAAAAAAOA/AAAAAAAA4D8AAAAAAADgPwAAAAAAAOA/AAAAAAAA4D8CAAAAjAAAAAAAAAAAAAAAu+DjDP///wgAAAAAAAAAAAAAAAAAAAAAAAAAAAAAAAAAAAAAZAAAAAEAAABAAAAAAAAAAAAAAAAAAAAAAAAAAAAAAAAAAAAAAAAAAAAAAAAAAAAAAAAAAAAAAAAAAAAAAAAAAAAAAAAAAAAAAAAAAAAAAAAAAAAAAAAAAAAAAAAAAAAAFAAAADwAAAAAAAAAAAAAAAAAAAkUAAAAAQAAABQAAAAUAAAAFAAAAAEAAAAAAAAAZAAAAGQAAAAAAAAAZAAAAGQAAAAVAAAAYAAAAAAAAAAAAAAADwAAACADAAAAAAAAAAAAAAEAAACgMgAAVgcAAKr4//8BAAAAf39/AAEAAABkAAAAAAAAABQAAABAHwAAAAAAACYAAAAAAAAAwOD//wAAAAAmAAAAZAAAABYAAABMAAAAAAAAAAAAAAAEAAAAAAAAAAEAAACAgIAKAAAAACgAAAAoAAAAZAAAAGQAAAAAAAAAzMzMAAAAAABQAAAAUAAAAGQAAABkAAAAAAAAABcAAAAUAAAAAAAAAAAAAAD/fwAA/38AAAAAAAAJAAAABAAAAAAAAAAeAAAAaAAAAAAAAAAAAAAAAAAAAAAAAAAAAAAAECcAABAnAAAAAAAAAAAAAAAAAAAAAAAAAAAAAAAAAAAAAAAAAAAAABQAAAAAAAAAwMD/AAAAAABkAAAAMgAAAAAAAABkAAAAAAAAAH9/fwAKAAAAIgAAABgAAAAAAAAAAAAAAAAAAAAAAAAAAAAAAAAAAAAkAAAAJAAAAAAAAAAHAAAAAAAAAAAAAAAAAAAAAAAAAAAAAAAAAAAAf39/ACUAAABYAAAAAAAAAAAAAAAAAAAAAAAAAAAAAAAAAAAAAAAAAAAAAAAAAAAAAAAAAAAAAAA/AAAAAAAAAKCGAQAAAAAAAAAAAAAAAAAMAAAAAQAAAAAAAAAAAAAAAAAAAB8AAABUAAAAAAAABQAAAAEAAAAAAAAAAAAAAAAAAAAAAAAAAAAAAAAAAAAAAAAAAAAAAAJ/f38AAAAAA8zMzADAwP8Af39/AAAAAAAAAAAAAAAAAAAAAAAAAAAAIQAAABgAAAAUAAAAwAMAALABAABARwAAuAgAABAAAAAmAAAACAAAAAAAAAAAAAAA"/>
               </a:ext>
             </a:extLst>
           </p:cNvSpPr>
@@ -846,7 +846,7 @@
             <a:spLocks noGrp="1" noChangeArrowheads="1"/>
             <a:extLst>
               <a:ext uri="smNativeData">
-                <pr:smNativeData xmlns:pr="smNativeData" xmlns="smNativeData" val="SMDATA_15_ZqHWaRMAAAAlAAAAZAAAAA8BAAAAkAAAAEgAAACQAAAASAAAAAAAAAAAAAAAAAAAAAEAAABQAAAAAAAAAAAA4D8AAAAAAADgPwAAAAAAAOA/AAAAAAAA4D8AAAAAAADgPwAAAAAAAOA/AAAAAAAA4D8AAAAAAADgPwAAAAAAAOA/AAAAAAAA4D8CAAAAjAAAAAAAAAAAAAAAu+DjDP///wgAAAAAAAAAAAAAAAAAAAAAAAAAAAAAAAAAAAAAZAAAAAEAAABAAAAAAAAAAAAAAAAAAAAAAAAAAAAAAAAAAAAAAAAAAAAAAAAAAAAAAAAAAAAAAAAAAAAAAAAAAAAAAAAAAAAAAAAAAAAAAAAAAAAAAAAAAAAAAAAAAAAAFAAAADwAAAAAAAAAAAAAAAAAAAkUAAAAAQAAABQAAAAUAAAAFAAAAAEAAAAAAAAAZAAAAGQAAAAAAAAAZAAAAGQAAAAVAAAAYAAAAAAAAAAAAAAADwAAACADAAAAAAAAAAAAAAEAAACgMgAAVgcAAKr4//8BAAAAf39/AAEAAABkAAAAAAAAABQAAABAHwAAAAAAACYAAAAAAAAAwOD//wAAAAAmAAAAZAAAABYAAABMAAAAAAAAAAAAAAAEAAAAAAAAAAEAAACAgIAKAAAAACgAAAAoAAAAZAAAAGQAAAAAAAAAzMzMAAAAAABQAAAAUAAAAGQAAABkAAAAAAAAABcAAAAUAAAAAAAAAAAAAAD/fwAA/38AAAAAAAAJAAAABAAAAAAAAAAeAAAAaAAAAAAAAAAAAAAAAAAAAAAAAAAAAAAAECcAABAnAAAAAAAAAAAAAAAAAAAAAAAAAAAAAAAAAAAAAAAAAAAAABQAAAAAAAAAwMD/AAAAAABkAAAAMgAAAAAAAABkAAAAAAAAAH9/fwAKAAAAIgAAABgAAAAAAAAAAAAAAAAAAAAAAAAAAAAAAAAAAAAkAAAAJAAAAAAAAAAHAAAAAAAAAAAAAAAAAAAAAAAAAAAAAAAAAAAAf39/ACUAAABYAAAAAAAAAAAAAAAAAAAAAAAAAAAAAAAAAAAAAAAAAAAAAAAAAAAAAAAAAAAAAAA/AAAAAAAAAKCGAQAAAAAAAAAAAAAAAAAMAAAAAQAAAAAAAAAAAAAAAAAAAB8AAABUAAAAAAAABQAAAAEAAAAAAAAAAAAAAAAAAAAAAAAAAAAAAAAAAAAAAAAAAAAAAAJ/f38AAAAAA8zMzADAwP8Af39/AAAAAAAAAAAAAAAAAAAAAAAAAAAAIQAAABgAAAAUAAAAwAMAANgJAABARwAAsCUAABAAAAAmAAAACAAAAAAAAAAAAAAA"/>
+                <pr:smNativeData xmlns:pr="smNativeData" xmlns="smNativeData" val="SMDATA_15_MvzhaRMAAAAlAAAAZAAAAA8BAAAAkAAAAEgAAACQAAAASAAAAAAAAAAAAAAAAAAAAAEAAABQAAAAAAAAAAAA4D8AAAAAAADgPwAAAAAAAOA/AAAAAAAA4D8AAAAAAADgPwAAAAAAAOA/AAAAAAAA4D8AAAAAAADgPwAAAAAAAOA/AAAAAAAA4D8CAAAAjAAAAAAAAAAAAAAAu+DjDP///wgAAAAAAAAAAAAAAAAAAAAAAAAAAAAAAAAAAAAAZAAAAAEAAABAAAAAAAAAAAAAAAAAAAAAAAAAAAAAAAAAAAAAAAAAAAAAAAAAAAAAAAAAAAAAAAAAAAAAAAAAAAAAAAAAAAAAAAAAAAAAAAAAAAAAAAAAAAAAAAAAAAAAFAAAADwAAAAAAAAAAAAAAAAAAAkUAAAAAQAAABQAAAAUAAAAFAAAAAEAAAAAAAAAZAAAAGQAAAAAAAAAZAAAAGQAAAAVAAAAYAAAAAAAAAAAAAAADwAAACADAAAAAAAAAAAAAAEAAACgMgAAVgcAAKr4//8BAAAAf39/AAEAAABkAAAAAAAAABQAAABAHwAAAAAAACYAAAAAAAAAwOD//wAAAAAmAAAAZAAAABYAAABMAAAAAAAAAAAAAAAEAAAAAAAAAAEAAACAgIAKAAAAACgAAAAoAAAAZAAAAGQAAAAAAAAAzMzMAAAAAABQAAAAUAAAAGQAAABkAAAAAAAAABcAAAAUAAAAAAAAAAAAAAD/fwAA/38AAAAAAAAJAAAABAAAAAAAAAAeAAAAaAAAAAAAAAAAAAAAAAAAAAAAAAAAAAAAECcAABAnAAAAAAAAAAAAAAAAAAAAAAAAAAAAAAAAAAAAAAAAAAAAABQAAAAAAAAAwMD/AAAAAABkAAAAMgAAAAAAAABkAAAAAAAAAH9/fwAKAAAAIgAAABgAAAAAAAAAAAAAAAAAAAAAAAAAAAAAAAAAAAAkAAAAJAAAAAAAAAAHAAAAAAAAAAAAAAAAAAAAAAAAAAAAAAAAAAAAf39/ACUAAABYAAAAAAAAAAAAAAAAAAAAAAAAAAAAAAAAAAAAAAAAAAAAAAAAAAAAAAAAAAAAAAA/AAAAAAAAAKCGAQAAAAAAAAAAAAAAAAAMAAAAAQAAAAAAAAAAAAAAAAAAAB8AAABUAAAAAAAABQAAAAEAAAAAAAAAAAAAAAAAAAAAAAAAAAAAAAAAAAAAAAAAAAAAAAJ/f38AAAAAA8zMzADAwP8Af39/AAAAAAAAAAAAAAAAAAAAAAAAAAAAIQAAABgAAAAUAAAAwAMAANgJAABARwAAsCUAABAAAAAmAAAACAAAAAAAAAAAAAAA"/>
               </a:ext>
             </a:extLst>
           </p:cNvSpPr>
@@ -897,7 +897,7 @@
             <a:spLocks noGrp="1" noChangeArrowheads="1"/>
             <a:extLst>
               <a:ext uri="smNativeData">
-                <pr:smNativeData xmlns:pr="smNativeData" xmlns="smNativeData" val="SMDATA_15_ZqHWaRMAAAAlAAAAZAAAAA8BAAAAkAAAAEgAAACQAAAASAAAAAAAAAABAAAAAAAAAAEAAABQAAAAAAAAAAAA4D8AAAAAAADgPwAAAAAAAOA/AAAAAAAA4D8AAAAAAADgPwAAAAAAAOA/AAAAAAAA4D8AAAAAAADgPwAAAAAAAOA/AAAAAAAA4D8CAAAAjAAAAAAAAAAAAAAAu+DjDP///wgAAAAAAAAAAAAAAAAAAAAAAAAAAAAAAAAAAAAAZAAAAAEAAABAAAAAAAAAAAAAAAAAAAAAAAAAAAAAAAAAAAAAAAAAAAAAAAAAAAAAAAAAAAAAAAAAAAAAAAAAAAAAAAAAAAAAAAAAAAAAAAAAAAAAAAAAAAAAAAAAAAAAFAAAADwAAAAAAAAAAAAAAAAAAAkUAAAAAQAAABQAAAAUAAAAFAAAAAEAAAAAAAAAZAAAAGQAAAAAAAAAZAAAAGQAAAAVAAAAYAAAAAAAAAAAAAAADwAAACADAAAAAAAAAAAAAAEAAACgMgAAVgcAAKr4//8BAAAAf39/AAEAAABkAAAAAAAAABQAAABAHwAAAAAAACYAAAAAAAAAwOD//wAAAAAmAAAAZAAAABYAAABMAAAAAAAAAAAAAAAEAAAAAAAAAAEAAACAgIAKAAAAACgAAAAoAAAAZAAAAGQAAAAAAAAAzMzMAAAAAABQAAAAUAAAAGQAAABkAAAAAAAAABcAAAAUAAAAAAAAAAAAAAD/fwAA/38AAAAAAAAJAAAABAAAANw7IAEeAAAAaAAAAAAAAAAAAAAAAAAAAAAAAAAAAAAAECcAABAnAAAAAAAAAAAAAAAAAAAAAAAAAAAAAAAAAAAAAAAAAAAAABQAAAAAAAAAwMD/AAAAAABkAAAAMgAAAAAAAABkAAAAAAAAAH9/fwAKAAAAIgAAABgAAAAAAAAAAAAAAAAAAAAAAAAAAAAAAAAAAAAkAAAAJAAAAAAAAAAHAAAAAAAAAAAAAAAAAAAAAAAAAAAAAAAAAAAAf39/ACUAAABYAAAAAAAAAAAAAAAAAAAAAAAAAAAAAAAAAAAAAAAAAAAAAAAAAAAAAAAAAAAAAAA/AAAAAAAAAKCGAQAAAAAAAAAAAAAAAAAMAAAAAQAAAAAAAAAAAAAAAAAAAB8AAABUAAAAAAAABQAAAAEAAAAAAAAAAAAAAAAAAAAAAAAAAAAAAAAAAAAAAAAAAAAAAAJ/f38AAAAAA8zMzADAwP8Af39/AAAAAAAAAAAAAAAAAAAAAAAAAAAAIQAAABgAAAAUAAAAwAMAABsnAAA/FQAAWSkAABAAAAAmAAAACAAAAAAAAAAAAAAA"/>
+                <pr:smNativeData xmlns:pr="smNativeData" xmlns="smNativeData" val="SMDATA_15_MvzhaRMAAAAlAAAAZAAAAA8BAAAAkAAAAEgAAACQAAAASAAAAAAAAAABAAAAAAAAAAEAAABQAAAAAAAAAAAA4D8AAAAAAADgPwAAAAAAAOA/AAAAAAAA4D8AAAAAAADgPwAAAAAAAOA/AAAAAAAA4D8AAAAAAADgPwAAAAAAAOA/AAAAAAAA4D8CAAAAjAAAAAAAAAAAAAAAu+DjDP///wgAAAAAAAAAAAAAAAAAAAAAAAAAAAAAAAAAAAAAZAAAAAEAAABAAAAAAAAAAAAAAAAAAAAAAAAAAAAAAAAAAAAAAAAAAAAAAAAAAAAAAAAAAAAAAAAAAAAAAAAAAAAAAAAAAAAAAAAAAAAAAAAAAAAAAAAAAAAAAAAAAAAAFAAAADwAAAAAAAAAAAAAAAAAAAkUAAAAAQAAABQAAAAUAAAAFAAAAAEAAAAAAAAAZAAAAGQAAAAAAAAAZAAAAGQAAAAVAAAAYAAAAAAAAAAAAAAADwAAACADAAAAAAAAAAAAAAEAAACgMgAAVgcAAKr4//8BAAAAf39/AAEAAABkAAAAAAAAABQAAABAHwAAAAAAACYAAAAAAAAAwOD//wAAAAAmAAAAZAAAABYAAABMAAAAAAAAAAAAAAAEAAAAAAAAAAEAAACAgIAKAAAAACgAAAAoAAAAZAAAAGQAAAAAAAAAzMzMAAAAAABQAAAAUAAAAGQAAABkAAAAAAAAABcAAAAUAAAAAAAAAAAAAAD/fwAA/38AAAAAAAAJAAAABAAAANw7IAEeAAAAaAAAAAAAAAAAAAAAAAAAAAAAAAAAAAAAECcAABAnAAAAAAAAAAAAAAAAAAAAAAAAAAAAAAAAAAAAAAAAAAAAABQAAAAAAAAAwMD/AAAAAABkAAAAMgAAAAAAAABkAAAAAAAAAH9/fwAKAAAAIgAAABgAAAAAAAAAAAAAAAAAAAAAAAAAAAAAAAAAAAAkAAAAJAAAAAAAAAAHAAAAAAAAAAAAAAAAAAAAAAAAAAAAAAAAAAAAf39/ACUAAABYAAAAAAAAAAAAAAAAAAAAAAAAAAAAAAAAAAAAAAAAAAAAAAAAAAAAAAAAAAAAAAA/AAAAAAAAAKCGAQAAAAAAAAAAAAAAAAAMAAAAAQAAAAAAAAAAAAAAAAAAAB8AAABUAAAAAAAABQAAAAEAAAAAAAAAAAAAAAAAAAAAAAAAAAAAAAAAAAAAAAAAAAAAAAJ/f38AAAAAA8zMzADAwP8Af39/AAAAAAAAAAAAAAAAAAAAAAAAAAAAIQAAABgAAAAUAAAAwAMAABsnAAA/FQAAWSkAABAAAAAmAAAACAAAAAAAAAAAAAAA"/>
               </a:ext>
             </a:extLst>
           </p:cNvSpPr>
@@ -911,7 +911,7 @@
           <a:lstStyle/>
           <a:p>
             <a:pPr/>
-            <a:fld id="{2A600E77-39C7-35F8-89D8-CFAD40967F9A}" type="datetime1">
+            <a:fld id="{0BB85EF2-BCE6-EDA8-A800-4AFD104E5E1F}" type="datetime1">
               <a:t/>
             </a:fld>
           </a:p>
@@ -924,7 +924,7 @@
             <a:spLocks noGrp="1" noChangeArrowheads="1"/>
             <a:extLst>
               <a:ext uri="smNativeData">
-                <pr:smNativeData xmlns:pr="smNativeData" xmlns="smNativeData" val="SMDATA_15_ZqHWaRMAAAAlAAAAZAAAAA8BAAAAkAAAAEgAAACQAAAASAAAAAAAAAABAAAAAAAAAAEAAABQAAAAAAAAAAAA4D8AAAAAAADgPwAAAAAAAOA/AAAAAAAA4D8AAAAAAADgPwAAAAAAAOA/AAAAAAAA4D8AAAAAAADgPwAAAAAAAOA/AAAAAAAA4D8CAAAAjAAAAAAAAAAAAAAAu+DjDP///wgAAAAAAAAAAAAAAAAAAAAAAAAAAAAAAAAAAAAAZAAAAAEAAABAAAAAAAAAAAAAAAAAAAAAAAAAAAAAAAAAAAAAAAAAAAAAAAAAAAAAAAAAAAAAAAAAAAAAAAAAAAAAAAAAAAAAAAAAAAAAAAAAAAAAAAAAAAAAAAAAAAAAFAAAADwAAAAAAAAAAAAAAAAAAAkUAAAAAQAAABQAAAAUAAAAFAAAAAEAAAAAAAAAZAAAAGQAAAAAAAAAZAAAAGQAAAAVAAAAYAAAAAAAAAAAAAAADwAAACADAAAAAAAAAAAAAAEAAACgMgAAVgcAAKr4//8BAAAAf39/AAEAAABkAAAAAAAAABQAAABAHwAAAAAAACYAAAAAAAAAwOD//wAAAAAmAAAAZAAAABYAAABMAAAAAAAAAAAAAAAEAAAAAAAAAAEAAACAgIAKAAAAACgAAAAoAAAAZAAAAGQAAAAAAAAAzMzMAAAAAABQAAAAUAAAAGQAAABkAAAAAAAAABcAAAAUAAAAAAAAAAAAAAD/fwAA/38AAAAAAAAJAAAABAAAANw7IAEeAAAAaAAAAAAAAAAAAAAAAAAAAAAAAAAAAAAAECcAABAnAAAAAAAAAAAAAAAAAAAAAAAAAAAAAAAAAAAAAAAAAAAAABQAAAAAAAAAwMD/AAAAAABkAAAAMgAAAAAAAABkAAAAAAAAAH9/fwAKAAAAIgAAABgAAAAAAAAAAAAAAAAAAAAAAAAAAAAAAAAAAAAkAAAAJAAAAAAAAAAHAAAAAAAAAAAAAAAAAAAAAAAAAAAAAAAAAAAAf39/ACUAAABYAAAAAAAAAAAAAAAAAAAAAAAAAAAAAAAAAAAAAAAAAAAAAAAAAAAAAAAAAAAAAAA/AAAAAAAAAKCGAQAAAAAAAAAAAAAAAAAMAAAAAQAAAAAAAAAAAAAAAAAAAB8AAABUAAAAAAAABQAAAAEAAAAAAAAAAAAAAAAAAAAAAAAAAAAAAAAAAAAAAAAAAAAAAAJ/f38AAAAAA8zMzADAwP8Af39/AAAAAAAAAAAAAAAAAAAAAAAAAAAAIQAAABgAAAAUAAAAoRkAABsnAABfMQAAWSkAABAAAAAmAAAACAAAAAAAAAAAAAAA"/>
+                <pr:smNativeData xmlns:pr="smNativeData" xmlns="smNativeData" val="SMDATA_15_MvzhaRMAAAAlAAAAZAAAAA8BAAAAkAAAAEgAAACQAAAASAAAAAAAAAABAAAAAAAAAAEAAABQAAAAAAAAAAAA4D8AAAAAAADgPwAAAAAAAOA/AAAAAAAA4D8AAAAAAADgPwAAAAAAAOA/AAAAAAAA4D8AAAAAAADgPwAAAAAAAOA/AAAAAAAA4D8CAAAAjAAAAAAAAAAAAAAAu+DjDP///wgAAAAAAAAAAAAAAAAAAAAAAAAAAAAAAAAAAAAAZAAAAAEAAABAAAAAAAAAAAAAAAAAAAAAAAAAAAAAAAAAAAAAAAAAAAAAAAAAAAAAAAAAAAAAAAAAAAAAAAAAAAAAAAAAAAAAAAAAAAAAAAAAAAAAAAAAAAAAAAAAAAAAFAAAADwAAAAAAAAAAAAAAAAAAAkUAAAAAQAAABQAAAAUAAAAFAAAAAEAAAAAAAAAZAAAAGQAAAAAAAAAZAAAAGQAAAAVAAAAYAAAAAAAAAAAAAAADwAAACADAAAAAAAAAAAAAAEAAACgMgAAVgcAAKr4//8BAAAAf39/AAEAAABkAAAAAAAAABQAAABAHwAAAAAAACYAAAAAAAAAwOD//wAAAAAmAAAAZAAAABYAAABMAAAAAAAAAAAAAAAEAAAAAAAAAAEAAACAgIAKAAAAACgAAAAoAAAAZAAAAGQAAAAAAAAAzMzMAAAAAABQAAAAUAAAAGQAAABkAAAAAAAAABcAAAAUAAAAAAAAAAAAAAD/fwAA/38AAAAAAAAJAAAABAAAANw7IAEeAAAAaAAAAAAAAAAAAAAAAAAAAAAAAAAAAAAAECcAABAnAAAAAAAAAAAAAAAAAAAAAAAAAAAAAAAAAAAAAAAAAAAAABQAAAAAAAAAwMD/AAAAAABkAAAAMgAAAAAAAABkAAAAAAAAAH9/fwAKAAAAIgAAABgAAAAAAAAAAAAAAAAAAAAAAAAAAAAAAAAAAAAkAAAAJAAAAAAAAAAHAAAAAAAAAAAAAAAAAAAAAAAAAAAAAAAAAAAAf39/ACUAAABYAAAAAAAAAAAAAAAAAAAAAAAAAAAAAAAAAAAAAAAAAAAAAAAAAAAAAAAAAAAAAAA/AAAAAAAAAKCGAQAAAAAAAAAAAAAAAAAMAAAAAQAAAAAAAAAAAAAAAAAAAB8AAABUAAAAAAAABQAAAAEAAAAAAAAAAAAAAAAAAAAAAAAAAAAAAAAAAAAAAAAAAAAAAAJ/f38AAAAAA8zMzADAwP8Af39/AAAAAAAAAAAAAAAAAAAAAAAAAAAAIQAAABgAAAAUAAAAoRkAABsnAABfMQAAWSkAABAAAAAmAAAACAAAAAAAAAAAAAAA"/>
               </a:ext>
             </a:extLst>
           </p:cNvSpPr>
@@ -948,7 +948,7 @@
             <a:spLocks noGrp="1" noChangeArrowheads="1"/>
             <a:extLst>
               <a:ext uri="smNativeData">
-                <pr:smNativeData xmlns:pr="smNativeData" xmlns="smNativeData" val="SMDATA_15_ZqHWaRMAAAAlAAAAZAAAAA8BAAAAkAAAAEgAAACQAAAASAAAAAAAAAABAAAAAAAAAAEAAABQAAAAAAAAAAAA4D8AAAAAAADgPwAAAAAAAOA/AAAAAAAA4D8AAAAAAADgPwAAAAAAAOA/AAAAAAAA4D8AAAAAAADgPwAAAAAAAOA/AAAAAAAA4D8CAAAAjAAAAAAAAAAAAAAAu+DjDP///wgAAAAAAAAAAAAAAAAAAAAAAAAAAAAAAAAAAAAAZAAAAAEAAABAAAAAAAAAAAAAAAAAAAAAAAAAAAAAAAAAAAAAAAAAAAAAAAAAAAAAAAAAAAAAAAAAAAAAAAAAAAAAAAAAAAAAAAAAAAAAAAAAAAAAAAAAAAAAAAAAAAAAFAAAADwAAAAAAAAAAAAAAAAAAAkUAAAAAQAAABQAAAAUAAAAFAAAAAEAAAAAAAAAZAAAAGQAAAAAAAAAZAAAAGQAAAAVAAAAYAAAAAAAAAAAAAAADwAAACADAAAAAAAAAAAAAAEAAACgMgAAVgcAAKr4//8BAAAAf39/AAEAAABkAAAAAAAAABQAAABAHwAAAAAAACYAAAAAAAAAwOD//wAAAAAmAAAAZAAAABYAAABMAAAAAAAAAAAAAAAEAAAAAAAAAAEAAACAgIAKAAAAACgAAAAoAAAAZAAAAGQAAAAAAAAAzMzMAAAAAABQAAAAUAAAAGQAAABkAAAAAAAAABcAAAAUAAAAAAAAAAAAAAD/fwAA/38AAAAAAAAJAAAABAAAAAAAAAAeAAAAaAAAAAAAAAAAAAAAAAAAAAAAAAAAAAAAECcAABAnAAAAAAAAAAAAAAAAAAAAAAAAAAAAAAAAAAAAAAAAAAAAABQAAAAAAAAAwMD/AAAAAABkAAAAMgAAAAAAAABkAAAAAAAAAH9/fwAKAAAAIgAAABgAAAAAAAAAAAAAAAAAAAAAAAAAAAAAAAAAAAAkAAAAJAAAAAAAAAAHAAAAAAAAAAAAAAAAAAAAAAAAAAAAAAAAAAAAf39/ACUAAABYAAAAAAAAAAAAAAAAAAAAAAAAAAAAAAAAAAAAAAAAAAAAAAAAAAAAAAAAAAAAAAA/AAAAAAAAAKCGAQAAAAAAAAAAAAAAAAAMAAAAAQAAAAAAAAAAAAAAAAAAAB8AAABUAAAAAAAABQAAAAEAAAAAAAAAAAAAAAAAAAAAAAAAAAAAAAAAAAAAAAAAAAAAAAJ/f38AAAAAA8zMzADAwP8Af39/AAAAAAAAAAAAAAAAAAAAAAAAAAAAIQAAABgAAAAUAAAAwTUAABsnAABARwAAWSkAABAAAAAmAAAACAAAAAAAAAAAAAAA"/>
+                <pr:smNativeData xmlns:pr="smNativeData" xmlns="smNativeData" val="SMDATA_15_MvzhaRMAAAAlAAAAZAAAAA8BAAAAkAAAAEgAAACQAAAASAAAAAAAAAABAAAAAAAAAAEAAABQAAAAAAAAAAAA4D8AAAAAAADgPwAAAAAAAOA/AAAAAAAA4D8AAAAAAADgPwAAAAAAAOA/AAAAAAAA4D8AAAAAAADgPwAAAAAAAOA/AAAAAAAA4D8CAAAAjAAAAAAAAAAAAAAAu+DjDP///wgAAAAAAAAAAAAAAAAAAAAAAAAAAAAAAAAAAAAAZAAAAAEAAABAAAAAAAAAAAAAAAAAAAAAAAAAAAAAAAAAAAAAAAAAAAAAAAAAAAAAAAAAAAAAAAAAAAAAAAAAAAAAAAAAAAAAAAAAAAAAAAAAAAAAAAAAAAAAAAAAAAAAFAAAADwAAAAAAAAAAAAAAAAAAAkUAAAAAQAAABQAAAAUAAAAFAAAAAEAAAAAAAAAZAAAAGQAAAAAAAAAZAAAAGQAAAAVAAAAYAAAAAAAAAAAAAAADwAAACADAAAAAAAAAAAAAAEAAACgMgAAVgcAAKr4//8BAAAAf39/AAEAAABkAAAAAAAAABQAAABAHwAAAAAAACYAAAAAAAAAwOD//wAAAAAmAAAAZAAAABYAAABMAAAAAAAAAAAAAAAEAAAAAAAAAAEAAACAgIAKAAAAACgAAAAoAAAAZAAAAGQAAAAAAAAAzMzMAAAAAABQAAAAUAAAAGQAAABkAAAAAAAAABcAAAAUAAAAAAAAAAAAAAD/fwAA/38AAAAAAAAJAAAABAAAAAAAAAAeAAAAaAAAAAAAAAAAAAAAAAAAAAAAAAAAAAAAECcAABAnAAAAAAAAAAAAAAAAAAAAAAAAAAAAAAAAAAAAAAAAAAAAABQAAAAAAAAAwMD/AAAAAABkAAAAMgAAAAAAAABkAAAAAAAAAH9/fwAKAAAAIgAAABgAAAAAAAAAAAAAAAAAAAAAAAAAAAAAAAAAAAAkAAAAJAAAAAAAAAAHAAAAAAAAAAAAAAAAAAAAAAAAAAAAAAAAAAAAf39/ACUAAABYAAAAAAAAAAAAAAAAAAAAAAAAAAAAAAAAAAAAAAAAAAAAAAAAAAAAAAAAAAAAAAA/AAAAAAAAAKCGAQAAAAAAAAAAAAAAAAAMAAAAAQAAAAAAAAAAAAAAAAAAAB8AAABUAAAAAAAABQAAAAEAAAAAAAAAAAAAAAAAAAAAAAAAAAAAAAAAAAAAAAAAAAAAAAJ/f38AAAAAA8zMzADAwP8Af39/AAAAAAAAAAAAAAAAAAAAAAAAAAAAIQAAABgAAAAUAAAAwTUAABsnAABARwAAWSkAABAAAAAmAAAACAAAAAAAAAAAAAAA"/>
               </a:ext>
             </a:extLst>
           </p:cNvSpPr>
@@ -962,7 +962,7 @@
           <a:lstStyle/>
           <a:p>
             <a:pPr/>
-            <a:fld id="{2CE80035-7BC1-BDF6-8F50-8DA34E1E79D8}" type="slidenum">
+            <a:fld id="{5F1C63BA-F4B2-4995-FCA4-02C02DEA0A57}" type="slidenum">
               <a:t/>
             </a:fld>
           </a:p>
@@ -1001,7 +1001,7 @@
             <a:spLocks noGrp="1" noChangeArrowheads="1"/>
             <a:extLst>
               <a:ext uri="smNativeData">
-                <pr:smNativeData xmlns:pr="smNativeData" xmlns="smNativeData" val="SMDATA_15_ZqHWaRMAAAAlAAAAZAAAAA8BAAAAkAAAAEgAAACQAAAASAAAAAAAAAAAAAAAAAAAAAEAAABQAAAAAAAAAAAA4D8AAAAAAADgPwAAAAAAAOA/AAAAAAAA4D8AAAAAAADgPwAAAAAAAOA/AAAAAAAA4D8AAAAAAADgPwAAAAAAAOA/AAAAAAAA4D8CAAAAjAAAAAAAAAAAAAAAu+DjDP///wgAAAAAAAAAAAAAAAAAAAAAAAAAAAAAAAAAAAAAZAAAAAEAAABAAAAAAAAAAAAAAAAAAAAAAAAAAAAAAAAAAAAAAAAAAAAAAAAAAAAAAAAAAAAAAAAAAAAAAAAAAAAAAAAAAAAAAAAAAAAAAAAAAAAAAAAAAAAAAAAAAAAAFAAAADwAAAAAAAAAAAAAAAAAAAkUAAAAAQAAABQAAAAUAAAAFAAAAAEAAAAAAAAAZAAAAGQAAAAAAAAAZAAAAGQAAAAVAAAAYAAAAAAAAAAAAAAADwAAACADAAAAAAAAAAAAAAEAAACgMgAAVgcAAKr4//8BAAAAf39/AAEAAABkAAAAAAAAABQAAABAHwAAAAAAACYAAAAAAAAAwOD//wAAAAAmAAAAZAAAABYAAABMAAAAAAAAAAAAAAAEAAAAAAAAAAEAAACAgIAKAAAAACgAAAAoAAAAZAAAAGQAAAAAAAAAzMzMAAAAAABQAAAAUAAAAGQAAABkAAAAAAAAABcAAAAUAAAAAAAAAAAAAAD/fwAA/38AAAAAAAAJAAAABAAAANw7IAEeAAAAaAAAAAAAAAAAAAAAAAAAAAAAAAAAAAAAECcAABAnAAAAAAAAAAAAAAAAAAAAAAAAAAAAAAAAAAAAAAAAAAAAABQAAAAAAAAAwMD/AAAAAABkAAAAMgAAAAAAAABkAAAAAAAAAH9/fwAKAAAAIgAAABgAAAAAAAAAAAAAAAAAAAAAAAAAAAAAAAAAAAAkAAAAJAAAAAAAAAAHAAAAAAAAAAAAAAAAAAAAAAAAAAAAAAAAAAAAf39/ACUAAABYAAAAAAAAAAAAAAAAAAAAAAAAAAAAAAAAAAAAAAAAAAAAAAAAAAAAAAAAAAAAAAA/AAAAAAAAAKCGAQAAAAAAAAAAAAAAAAAMAAAAAQAAAAAAAAAAAAAAAAAAAB8AAABUAAAAAAAABQAAAAEAAAAAAAAAAAAAAAAAAAAAAAAAAAAAAAAAAAAAAAAAAAAAAAJ/f38AAAAAA8zMzADAwP8Af39/AAAAAAAAAAAAAAAAAAAAAAAAAAAAIQAAABgAAAAUAAAA7QUAABwbAACtRQAAfSMAABAAAAAmAAAACAAAAIGAAAAAAAAA"/>
+                <pr:smNativeData xmlns:pr="smNativeData" xmlns="smNativeData" val="SMDATA_15_MvzhaRMAAAAlAAAAZAAAAA8BAAAAkAAAAEgAAACQAAAASAAAAAAAAAAAAAAAAAAAAAEAAABQAAAAAAAAAAAA4D8AAAAAAADgPwAAAAAAAOA/AAAAAAAA4D8AAAAAAADgPwAAAAAAAOA/AAAAAAAA4D8AAAAAAADgPwAAAAAAAOA/AAAAAAAA4D8CAAAAjAAAAAAAAAAAAAAAu+DjDP///wgAAAAAAAAAAAAAAAAAAAAAAAAAAAAAAAAAAAAAZAAAAAEAAABAAAAAAAAAAAAAAAAAAAAAAAAAAAAAAAAAAAAAAAAAAAAAAAAAAAAAAAAAAAAAAAAAAAAAAAAAAAAAAAAAAAAAAAAAAAAAAAAAAAAAAAAAAAAAAAAAAAAAFAAAADwAAAAAAAAAAAAAAAAAAAkUAAAAAQAAABQAAAAUAAAAFAAAAAEAAAAAAAAAZAAAAGQAAAAAAAAAZAAAAGQAAAAVAAAAYAAAAAAAAAAAAAAADwAAACADAAAAAAAAAAAAAAEAAACgMgAAVgcAAKr4//8BAAAAf39/AAEAAABkAAAAAAAAABQAAABAHwAAAAAAACYAAAAAAAAAwOD//wAAAAAmAAAAZAAAABYAAABMAAAAAAAAAAAAAAAEAAAAAAAAAAEAAACAgIAKAAAAACgAAAAoAAAAZAAAAGQAAAAAAAAAzMzMAAAAAABQAAAAUAAAAGQAAABkAAAAAAAAABcAAAAUAAAAAAAAAAAAAAD/fwAA/38AAAAAAAAJAAAABAAAANw7IAEeAAAAaAAAAAAAAAAAAAAAAAAAAAAAAAAAAAAAECcAABAnAAAAAAAAAAAAAAAAAAAAAAAAAAAAAAAAAAAAAAAAAAAAABQAAAAAAAAAwMD/AAAAAABkAAAAMgAAAAAAAABkAAAAAAAAAH9/fwAKAAAAIgAAABgAAAAAAAAAAAAAAAAAAAAAAAAAAAAAAAAAAAAkAAAAJAAAAAAAAAAHAAAAAAAAAAAAAAAAAAAAAAAAAAAAAAAAAAAAf39/ACUAAABYAAAAAAAAAAAAAAAAAAAAAAAAAAAAAAAAAAAAAAAAAAAAAAAAAAAAAAAAAAAAAAA/AAAAAAAAAKCGAQAAAAAAAAAAAAAAAAAMAAAAAQAAAAAAAAAAAAAAAAAAAB8AAABUAAAAAAAABQAAAAEAAAAAAAAAAAAAAAAAAAAAAAAAAAAAAAAAAAAAAAAAAAAAAAJ/f38AAAAAA8zMzADAwP8Af39/AAAAAAAAAAAAAAAAAAAAAAAAAAAAIQAAABgAAAAUAAAA7QUAABwbAACtRQAAfSMAABAAAAAmAAAACAAAAIGAAAAAAAAA"/>
               </a:ext>
             </a:extLst>
           </p:cNvSpPr>
@@ -1041,7 +1041,7 @@
             <a:spLocks noGrp="1" noChangeArrowheads="1"/>
             <a:extLst>
               <a:ext uri="smNativeData">
-                <pr:smNativeData xmlns:pr="smNativeData" xmlns="smNativeData" val="SMDATA_15_ZqHWaRMAAAAlAAAAZAAAAA8BAAAAkAAAAEgAAACQAAAASAAAAAAAAAACAAAAAAAAAAEAAABQAAAAAAAAAAAA4D8AAAAAAADgPwAAAAAAAOA/AAAAAAAA4D8AAAAAAADgPwAAAAAAAOA/AAAAAAAA4D8AAAAAAADgPwAAAAAAAOA/AAAAAAAA4D8CAAAAjAAAAAAAAAAAAAAAu+DjDP///wgAAAAAAAAAAAAAAAAAAAAAAAAAAAAAAAAAAAAAZAAAAAEAAABAAAAAAAAAAAAAAAAAAAAAAAAAAAAAAAAAAAAAAAAAAAAAAAAAAAAAAAAAAAAAAAAAAAAAAAAAAAAAAAAAAAAAAAAAAAAAAAAAAAAAAAAAAAAAAAAAAAAAFAAAADwAAAAAAAAAAAAAAAAAAAkUAAAAAQAAABQAAAAUAAAAFAAAAAEAAAAAAAAAZAAAAGQAAAAAAAAAZAAAAGQAAAAVAAAAYAAAAAAAAAAAAAAADwAAACADAAAAAAAAAAAAAAEAAACgMgAAVgcAAKr4//8BAAAAf39/AAEAAABkAAAAAAAAABQAAABAHwAAAAAAACYAAAAAAAAAwOD//wAAAAAmAAAAZAAAABYAAABMAAAAAAAAAAAAAAAEAAAAAAAAAAEAAACAgIAKAAAAACgAAAAoAAAAZAAAAGQAAAAAAAAAzMzMAAAAAABQAAAAUAAAAGQAAABkAAAAAAAAABcAAAAUAAAAAAAAAAAAAAD/fwAA/38AAAAAAAAJAAAABAAAANw7IAEeAAAAaAAAAAAAAAAAAAAAAAAAAAAAAAAAAAAAECcAABAnAAAAAAAAAAAAAAAAAAAAAAAAAAAAAAAAAAAAAAAAAAAAABQAAAAAAAAAwMD/AAAAAABkAAAAMgAAAAAAAABkAAAAAAAAAH9/fwAKAAAAIgAAABgAAAAAAAAAAAAAAAAAAAAAAAAAAAAAAAAAAAAkAAAAJAAAAAAAAAAHAAAAAAAAAAAAAAAAAAAAAAAAAAAAAAAAAAAAf39/ACUAAABYAAAAAAAAAAAAAAAAAAAAAAAAAAAAAAAAAAAAAAAAAAAAAAAAAAAAAAAAAAAAAAA/AAAAAAAAAKCGAQAAAAAAAAAAAAAAAAAMAAAAAQAAAAAAAAAAAAAAAAAAAB8AAABUAAAAAAAABQAAAAEAAAAAAAAAAAAAAAAAAAAAAAAAAAAAAAAAAAAAAAAAAAAAAAJ/f38AAAAAA8zMzADAwP8Af39/AAAAAAAAAAAAAAAAAAAAAAAAAAAAIQAAABgAAAAUAAAA7QUAAOERAACtRQAAHBsAABAAAAAmAAAACAAAAIGAAAAAAAAA"/>
+                <pr:smNativeData xmlns:pr="smNativeData" xmlns="smNativeData" val="SMDATA_15_MvzhaRMAAAAlAAAAZAAAAA8BAAAAkAAAAEgAAACQAAAASAAAAAAAAAACAAAAAAAAAAEAAABQAAAAAAAAAAAA4D8AAAAAAADgPwAAAAAAAOA/AAAAAAAA4D8AAAAAAADgPwAAAAAAAOA/AAAAAAAA4D8AAAAAAADgPwAAAAAAAOA/AAAAAAAA4D8CAAAAjAAAAAAAAAAAAAAAu+DjDP///wgAAAAAAAAAAAAAAAAAAAAAAAAAAAAAAAAAAAAAZAAAAAEAAABAAAAAAAAAAAAAAAAAAAAAAAAAAAAAAAAAAAAAAAAAAAAAAAAAAAAAAAAAAAAAAAAAAAAAAAAAAAAAAAAAAAAAAAAAAAAAAAAAAAAAAAAAAAAAAAAAAAAAFAAAADwAAAAAAAAAAAAAAAAAAAkUAAAAAQAAABQAAAAUAAAAFAAAAAEAAAAAAAAAZAAAAGQAAAAAAAAAZAAAAGQAAAAVAAAAYAAAAAAAAAAAAAAADwAAACADAAAAAAAAAAAAAAEAAACgMgAAVgcAAKr4//8BAAAAf39/AAEAAABkAAAAAAAAABQAAABAHwAAAAAAACYAAAAAAAAAwOD//wAAAAAmAAAAZAAAABYAAABMAAAAAAAAAAAAAAAEAAAAAAAAAAEAAACAgIAKAAAAACgAAAAoAAAAZAAAAGQAAAAAAAAAzMzMAAAAAABQAAAAUAAAAGQAAABkAAAAAAAAABcAAAAUAAAAAAAAAAAAAAD/fwAA/38AAAAAAAAJAAAABAAAANw7IAEeAAAAaAAAAAAAAAAAAAAAAAAAAAAAAAAAAAAAECcAABAnAAAAAAAAAAAAAAAAAAAAAAAAAAAAAAAAAAAAAAAAAAAAABQAAAAAAAAAwMD/AAAAAABkAAAAMgAAAAAAAABkAAAAAAAAAH9/fwAKAAAAIgAAABgAAAAAAAAAAAAAAAAAAAAAAAAAAAAAAAAAAAAkAAAAJAAAAAAAAAAHAAAAAAAAAAAAAAAAAAAAAAAAAAAAAAAAAAAAf39/ACUAAABYAAAAAAAAAAAAAAAAAAAAAAAAAAAAAAAAAAAAAAAAAAAAAAAAAAAAAAAAAAAAAAA/AAAAAAAAAKCGAQAAAAAAAAAAAAAAAAAMAAAAAQAAAAAAAAAAAAAAAAAAAB8AAABUAAAAAAAABQAAAAEAAAAAAAAAAAAAAAAAAAAAAAAAAAAAAAAAAAAAAAAAAAAAAAJ/f38AAAAAA8zMzADAwP8Af39/AAAAAAAAAAAAAAAAAAAAAAAAAAAAIQAAABgAAAAUAAAA7QUAAOERAACtRQAAHBsAABAAAAAmAAAACAAAAIGAAAAAAAAA"/>
               </a:ext>
             </a:extLst>
           </p:cNvSpPr>
@@ -1114,7 +1114,7 @@
             <a:spLocks noGrp="1" noChangeArrowheads="1"/>
             <a:extLst>
               <a:ext uri="smNativeData">
-                <pr:smNativeData xmlns:pr="smNativeData" xmlns="smNativeData" val="SMDATA_15_ZqHWaRMAAAAlAAAAZAAAAA8BAAAAkAAAAEgAAACQAAAASAAAAAAAAAABAAAAAAAAAAEAAABQAAAAAAAAAAAA4D8AAAAAAADgPwAAAAAAAOA/AAAAAAAA4D8AAAAAAADgPwAAAAAAAOA/AAAAAAAA4D8AAAAAAADgPwAAAAAAAOA/AAAAAAAA4D8CAAAAjAAAAAAAAAAAAAAAu+DjDP///wgAAAAAAAAAAAAAAAAAAAAAAAAAAAAAAAAAAAAAZAAAAAEAAABAAAAAAAAAAAAAAAAAAAAAAAAAAAAAAAAAAAAAAAAAAAAAAAAAAAAAAAAAAAAAAAAAAAAAAAAAAAAAAAAAAAAAAAAAAAAAAAAAAAAAAAAAAAAAAAAAAAAAFAAAADwAAAAAAAAAAAAAAAAAAAkUAAAAAQAAABQAAAAUAAAAFAAAAAEAAAAAAAAAZAAAAGQAAAAAAAAAZAAAAGQAAAAVAAAAYAAAAAAAAAAAAAAADwAAACADAAAAAAAAAAAAAAEAAACgMgAAVgcAAKr4//8BAAAAf39/AAEAAABkAAAAAAAAABQAAABAHwAAAAAAACYAAAAAAAAAwOD//wAAAAAmAAAAZAAAABYAAABMAAAAAAAAAAAAAAAEAAAAAAAAAAEAAACAgIAKAAAAACgAAAAoAAAAZAAAAGQAAAAAAAAAzMzMAAAAAABQAAAAUAAAAGQAAABkAAAAAAAAABcAAAAUAAAAAAAAAAAAAAD/fwAA/38AAAAAAAAJAAAABAAAAAAAAAAeAAAAaAAAAAAAAAAAAAAAAAAAAAAAAAAAAAAAECcAABAnAAAAAAAAAAAAAAAAAAAAAAAAAAAAAAAAAAAAAAAAAAAAABQAAAAAAAAAwMD/AAAAAABkAAAAMgAAAAAAAABkAAAAAAAAAH9/fwAKAAAAIgAAABgAAAAAAAAAAAAAAAAAAAAAAAAAAAAAAAAAAAAkAAAAJAAAAAAAAAAHAAAAAAAAAAAAAAAAAAAAAAAAAAAAAAAAAAAAf39/ACUAAABYAAAAAAAAAAAAAAAAAAAAAAAAAAAAAAAAAAAAAAAAAAAAAAAAAAAAAAAAAAAAAAA/AAAAAAAAAKCGAQAAAAAAAAAAAAAAAAAMAAAAAQAAAAAAAAAAAAAAAAAAAB8AAABUAAAAAAAABQAAAAEAAAAAAAAAAAAAAAAAAAAAAAAAAAAAAAAAAAAAAAAAAAAAAAJ/f38AAAAAA8zMzADAwP8Af39/AAAAAAAAAAAAAAAAAAAAAAAAAAAAIQAAABgAAAAUAAAAwAMAABsnAAA/FQAAWSkAABAAAAAmAAAACAAAAAAAAAAAAAAA"/>
+                <pr:smNativeData xmlns:pr="smNativeData" xmlns="smNativeData" val="SMDATA_15_MvzhaRMAAAAlAAAAZAAAAA8BAAAAkAAAAEgAAACQAAAASAAAAAAAAAABAAAAAAAAAAEAAABQAAAAAAAAAAAA4D8AAAAAAADgPwAAAAAAAOA/AAAAAAAA4D8AAAAAAADgPwAAAAAAAOA/AAAAAAAA4D8AAAAAAADgPwAAAAAAAOA/AAAAAAAA4D8CAAAAjAAAAAAAAAAAAAAAu+DjDP///wgAAAAAAAAAAAAAAAAAAAAAAAAAAAAAAAAAAAAAZAAAAAEAAABAAAAAAAAAAAAAAAAAAAAAAAAAAAAAAAAAAAAAAAAAAAAAAAAAAAAAAAAAAAAAAAAAAAAAAAAAAAAAAAAAAAAAAAAAAAAAAAAAAAAAAAAAAAAAAAAAAAAAFAAAADwAAAAAAAAAAAAAAAAAAAkUAAAAAQAAABQAAAAUAAAAFAAAAAEAAAAAAAAAZAAAAGQAAAAAAAAAZAAAAGQAAAAVAAAAYAAAAAAAAAAAAAAADwAAACADAAAAAAAAAAAAAAEAAACgMgAAVgcAAKr4//8BAAAAf39/AAEAAABkAAAAAAAAABQAAABAHwAAAAAAACYAAAAAAAAAwOD//wAAAAAmAAAAZAAAABYAAABMAAAAAAAAAAAAAAAEAAAAAAAAAAEAAACAgIAKAAAAACgAAAAoAAAAZAAAAGQAAAAAAAAAzMzMAAAAAABQAAAAUAAAAGQAAABkAAAAAAAAABcAAAAUAAAAAAAAAAAAAAD/fwAA/38AAAAAAAAJAAAABAAAAAAAAAAeAAAAaAAAAAAAAAAAAAAAAAAAAAAAAAAAAAAAECcAABAnAAAAAAAAAAAAAAAAAAAAAAAAAAAAAAAAAAAAAAAAAAAAABQAAAAAAAAAwMD/AAAAAABkAAAAMgAAAAAAAABkAAAAAAAAAH9/fwAKAAAAIgAAABgAAAAAAAAAAAAAAAAAAAAAAAAAAAAAAAAAAAAkAAAAJAAAAAAAAAAHAAAAAAAAAAAAAAAAAAAAAAAAAAAAAAAAAAAAf39/ACUAAABYAAAAAAAAAAAAAAAAAAAAAAAAAAAAAAAAAAAAAAAAAAAAAAAAAAAAAAAAAAAAAAA/AAAAAAAAAKCGAQAAAAAAAAAAAAAAAAAMAAAAAQAAAAAAAAAAAAAAAAAAAB8AAABUAAAAAAAABQAAAAEAAAAAAAAAAAAAAAAAAAAAAAAAAAAAAAAAAAAAAAAAAAAAAAJ/f38AAAAAA8zMzADAwP8Af39/AAAAAAAAAAAAAAAAAAAAAAAAAAAAIQAAABgAAAAUAAAAwAMAABsnAAA/FQAAWSkAABAAAAAmAAAACAAAAAAAAAAAAAAA"/>
               </a:ext>
             </a:extLst>
           </p:cNvSpPr>
@@ -1128,7 +1128,7 @@
           <a:lstStyle/>
           <a:p>
             <a:pPr/>
-            <a:fld id="{17871FEA-A4FA-D2E9-B43F-52BC51714207}" type="datetime1">
+            <a:fld id="{14988BEB-A5F9-CD7D-B720-5328C56E4106}" type="datetime1">
               <a:t/>
             </a:fld>
           </a:p>
@@ -1141,7 +1141,7 @@
             <a:spLocks noGrp="1" noChangeArrowheads="1"/>
             <a:extLst>
               <a:ext uri="smNativeData">
-                <pr:smNativeData xmlns:pr="smNativeData" xmlns="smNativeData" val="SMDATA_15_ZqHWaRMAAAAlAAAAZAAAAA8BAAAAkAAAAEgAAACQAAAASAAAAAAAAAABAAAAAAAAAAEAAABQAAAAAAAAAAAA4D8AAAAAAADgPwAAAAAAAOA/AAAAAAAA4D8AAAAAAADgPwAAAAAAAOA/AAAAAAAA4D8AAAAAAADgPwAAAAAAAOA/AAAAAAAA4D8CAAAAjAAAAAAAAAAAAAAAu+DjDP///wgAAAAAAAAAAAAAAAAAAAAAAAAAAAAAAAAAAAAAZAAAAAEAAABAAAAAAAAAAAAAAAAAAAAAAAAAAAAAAAAAAAAAAAAAAAAAAAAAAAAAAAAAAAAAAAAAAAAAAAAAAAAAAAAAAAAAAAAAAAAAAAAAAAAAAAAAAAAAAAAAAAAAFAAAADwAAAAAAAAAAAAAAAAAAAkUAAAAAQAAABQAAAAUAAAAFAAAAAEAAAAAAAAAZAAAAGQAAAAAAAAAZAAAAGQAAAAVAAAAYAAAAAAAAAAAAAAADwAAACADAAAAAAAAAAAAAAEAAACgMgAAVgcAAKr4//8BAAAAf39/AAEAAABkAAAAAAAAABQAAABAHwAAAAAAACYAAAAAAAAAwOD//wAAAAAmAAAAZAAAABYAAABMAAAAAAAAAAAAAAAEAAAAAAAAAAEAAACAgIAKAAAAACgAAAAoAAAAZAAAAGQAAAAAAAAAzMzMAAAAAABQAAAAUAAAAGQAAABkAAAAAAAAABcAAAAUAAAAAAAAAAAAAAD/fwAA/38AAAAAAAAJAAAABAAAANw7IAEeAAAAaAAAAAAAAAAAAAAAAAAAAAAAAAAAAAAAECcAABAnAAAAAAAAAAAAAAAAAAAAAAAAAAAAAAAAAAAAAAAAAAAAABQAAAAAAAAAwMD/AAAAAABkAAAAMgAAAAAAAABkAAAAAAAAAH9/fwAKAAAAIgAAABgAAAAAAAAAAAAAAAAAAAAAAAAAAAAAAAAAAAAkAAAAJAAAAAAAAAAHAAAAAAAAAAAAAAAAAAAAAAAAAAAAAAAAAAAAf39/ACUAAABYAAAAAAAAAAAAAAAAAAAAAAAAAAAAAAAAAAAAAAAAAAAAAAAAAAAAAAAAAAAAAAA/AAAAAAAAAKCGAQAAAAAAAAAAAAAAAAAMAAAAAQAAAAAAAAAAAAAAAAAAAB8AAABUAAAAAAAABQAAAAEAAAAAAAAAAAAAAAAAAAAAAAAAAAAAAAAAAAAAAAAAAAAAAAJ/f38AAAAAA8zMzADAwP8Af39/AAAAAAAAAAAAAAAAAAAAAAAAAAAAIQAAABgAAAAUAAAAoRkAABsnAABfMQAAWSkAABAAAAAmAAAACAAAAAAAAAAAAAAA"/>
+                <pr:smNativeData xmlns:pr="smNativeData" xmlns="smNativeData" val="SMDATA_15_MvzhaRMAAAAlAAAAZAAAAA8BAAAAkAAAAEgAAACQAAAASAAAAAAAAAABAAAAAAAAAAEAAABQAAAAAAAAAAAA4D8AAAAAAADgPwAAAAAAAOA/AAAAAAAA4D8AAAAAAADgPwAAAAAAAOA/AAAAAAAA4D8AAAAAAADgPwAAAAAAAOA/AAAAAAAA4D8CAAAAjAAAAAAAAAAAAAAAu+DjDP///wgAAAAAAAAAAAAAAAAAAAAAAAAAAAAAAAAAAAAAZAAAAAEAAABAAAAAAAAAAAAAAAAAAAAAAAAAAAAAAAAAAAAAAAAAAAAAAAAAAAAAAAAAAAAAAAAAAAAAAAAAAAAAAAAAAAAAAAAAAAAAAAAAAAAAAAAAAAAAAAAAAAAAFAAAADwAAAAAAAAAAAAAAAAAAAkUAAAAAQAAABQAAAAUAAAAFAAAAAEAAAAAAAAAZAAAAGQAAAAAAAAAZAAAAGQAAAAVAAAAYAAAAAAAAAAAAAAADwAAACADAAAAAAAAAAAAAAEAAACgMgAAVgcAAKr4//8BAAAAf39/AAEAAABkAAAAAAAAABQAAABAHwAAAAAAACYAAAAAAAAAwOD//wAAAAAmAAAAZAAAABYAAABMAAAAAAAAAAAAAAAEAAAAAAAAAAEAAACAgIAKAAAAACgAAAAoAAAAZAAAAGQAAAAAAAAAzMzMAAAAAABQAAAAUAAAAGQAAABkAAAAAAAAABcAAAAUAAAAAAAAAAAAAAD/fwAA/38AAAAAAAAJAAAABAAAANw7IAEeAAAAaAAAAAAAAAAAAAAAAAAAAAAAAAAAAAAAECcAABAnAAAAAAAAAAAAAAAAAAAAAAAAAAAAAAAAAAAAAAAAAAAAABQAAAAAAAAAwMD/AAAAAABkAAAAMgAAAAAAAABkAAAAAAAAAH9/fwAKAAAAIgAAABgAAAAAAAAAAAAAAAAAAAAAAAAAAAAAAAAAAAAkAAAAJAAAAAAAAAAHAAAAAAAAAAAAAAAAAAAAAAAAAAAAAAAAAAAAf39/ACUAAABYAAAAAAAAAAAAAAAAAAAAAAAAAAAAAAAAAAAAAAAAAAAAAAAAAAAAAAAAAAAAAAA/AAAAAAAAAKCGAQAAAAAAAAAAAAAAAAAMAAAAAQAAAAAAAAAAAAAAAAAAAB8AAABUAAAAAAAABQAAAAEAAAAAAAAAAAAAAAAAAAAAAAAAAAAAAAAAAAAAAAAAAAAAAAJ/f38AAAAAA8zMzADAwP8Af39/AAAAAAAAAAAAAAAAAAAAAAAAAAAAIQAAABgAAAAUAAAAoRkAABsnAABfMQAAWSkAABAAAAAmAAAACAAAAAAAAAAAAAAA"/>
               </a:ext>
             </a:extLst>
           </p:cNvSpPr>
@@ -1165,7 +1165,7 @@
             <a:spLocks noGrp="1" noChangeArrowheads="1"/>
             <a:extLst>
               <a:ext uri="smNativeData">
-                <pr:smNativeData xmlns:pr="smNativeData" xmlns="smNativeData" val="SMDATA_15_ZqHWaRMAAAAlAAAAZAAAAA8BAAAAkAAAAEgAAACQAAAASAAAAAAAAAABAAAAAAAAAAEAAABQAAAAAAAAAAAA4D8AAAAAAADgPwAAAAAAAOA/AAAAAAAA4D8AAAAAAADgPwAAAAAAAOA/AAAAAAAA4D8AAAAAAADgPwAAAAAAAOA/AAAAAAAA4D8CAAAAjAAAAAAAAAAAAAAAu+DjDP///wgAAAAAAAAAAAAAAAAAAAAAAAAAAAAAAAAAAAAAZAAAAAEAAABAAAAAAAAAAAAAAAAAAAAAAAAAAAAAAAAAAAAAAAAAAAAAAAAAAAAAAAAAAAAAAAAAAAAAAAAAAAAAAAAAAAAAAAAAAAAAAAAAAAAAAAAAAAAAAAAAAAAAFAAAADwAAAAAAAAAAAAAAAAAAAkUAAAAAQAAABQAAAAUAAAAFAAAAAEAAAAAAAAAZAAAAGQAAAAAAAAAZAAAAGQAAAAVAAAAYAAAAAAAAAAAAAAADwAAACADAAAAAAAAAAAAAAEAAACgMgAAVgcAAKr4//8BAAAAf39/AAEAAABkAAAAAAAAABQAAABAHwAAAAAAACYAAAAAAAAAwOD//wAAAAAmAAAAZAAAABYAAABMAAAAAAAAAAAAAAAEAAAAAAAAAAEAAACAgIAKAAAAACgAAAAoAAAAZAAAAGQAAAAAAAAAzMzMAAAAAABQAAAAUAAAAGQAAABkAAAAAAAAABcAAAAUAAAAAAAAAAAAAAD/fwAA/38AAAAAAAAJAAAABAAAANw7IAEeAAAAaAAAAAAAAAAAAAAAAAAAAAAAAAAAAAAAECcAABAnAAAAAAAAAAAAAAAAAAAAAAAAAAAAAAAAAAAAAAAAAAAAABQAAAAAAAAAwMD/AAAAAABkAAAAMgAAAAAAAABkAAAAAAAAAH9/fwAKAAAAIgAAABgAAAAAAAAAAAAAAAAAAAAAAAAAAAAAAAAAAAAkAAAAJAAAAAAAAAAHAAAAAAAAAAAAAAAAAAAAAAAAAAAAAAAAAAAAf39/ACUAAABYAAAAAAAAAAAAAAAAAAAAAAAAAAAAAAAAAAAAAAAAAAAAAAAAAAAAAAAAAAAAAAA/AAAAAAAAAKCGAQAAAAAAAAAAAAAAAAAMAAAAAQAAAAAAAAAAAAAAAAAAAB8AAABUAAAAAAAABQAAAAEAAAAAAAAAAAAAAAAAAAAAAAAAAAAAAAAAAAAAAAAAAAAAAAJ/f38AAAAAA8zMzADAwP8Af39/AAAAAAAAAAAAAAAAAAAAAAAAAAAAIQAAABgAAAAUAAAAwTUAABsnAABARwAAWSkAABAAAAAmAAAACAAAAAAAAAAAAAAA"/>
+                <pr:smNativeData xmlns:pr="smNativeData" xmlns="smNativeData" val="SMDATA_15_MvzhaRMAAAAlAAAAZAAAAA8BAAAAkAAAAEgAAACQAAAASAAAAAAAAAABAAAAAAAAAAEAAABQAAAAAAAAAAAA4D8AAAAAAADgPwAAAAAAAOA/AAAAAAAA4D8AAAAAAADgPwAAAAAAAOA/AAAAAAAA4D8AAAAAAADgPwAAAAAAAOA/AAAAAAAA4D8CAAAAjAAAAAAAAAAAAAAAu+DjDP///wgAAAAAAAAAAAAAAAAAAAAAAAAAAAAAAAAAAAAAZAAAAAEAAABAAAAAAAAAAAAAAAAAAAAAAAAAAAAAAAAAAAAAAAAAAAAAAAAAAAAAAAAAAAAAAAAAAAAAAAAAAAAAAAAAAAAAAAAAAAAAAAAAAAAAAAAAAAAAAAAAAAAAFAAAADwAAAAAAAAAAAAAAAAAAAkUAAAAAQAAABQAAAAUAAAAFAAAAAEAAAAAAAAAZAAAAGQAAAAAAAAAZAAAAGQAAAAVAAAAYAAAAAAAAAAAAAAADwAAACADAAAAAAAAAAAAAAEAAACgMgAAVgcAAKr4//8BAAAAf39/AAEAAABkAAAAAAAAABQAAABAHwAAAAAAACYAAAAAAAAAwOD//wAAAAAmAAAAZAAAABYAAABMAAAAAAAAAAAAAAAEAAAAAAAAAAEAAACAgIAKAAAAACgAAAAoAAAAZAAAAGQAAAAAAAAAzMzMAAAAAABQAAAAUAAAAGQAAABkAAAAAAAAABcAAAAUAAAAAAAAAAAAAAD/fwAA/38AAAAAAAAJAAAABAAAANw7IAEeAAAAaAAAAAAAAAAAAAAAAAAAAAAAAAAAAAAAECcAABAnAAAAAAAAAAAAAAAAAAAAAAAAAAAAAAAAAAAAAAAAAAAAABQAAAAAAAAAwMD/AAAAAABkAAAAMgAAAAAAAABkAAAAAAAAAH9/fwAKAAAAIgAAABgAAAAAAAAAAAAAAAAAAAAAAAAAAAAAAAAAAAAkAAAAJAAAAAAAAAAHAAAAAAAAAAAAAAAAAAAAAAAAAAAAAAAAAAAAf39/ACUAAABYAAAAAAAAAAAAAAAAAAAAAAAAAAAAAAAAAAAAAAAAAAAAAAAAAAAAAAAAAAAAAAA/AAAAAAAAAKCGAQAAAAAAAAAAAAAAAAAMAAAAAQAAAAAAAAAAAAAAAAAAAB8AAABUAAAAAAAABQAAAAEAAAAAAAAAAAAAAAAAAAAAAAAAAAAAAAAAAAAAAAAAAAAAAAJ/f38AAAAAA8zMzADAwP8Af39/AAAAAAAAAAAAAAAAAAAAAAAAAAAAIQAAABgAAAAUAAAAwTUAABsnAABARwAAWSkAABAAAAAmAAAACAAAAAAAAAAAAAAA"/>
               </a:ext>
             </a:extLst>
           </p:cNvSpPr>
@@ -1179,7 +1179,7 @@
           <a:lstStyle/>
           <a:p>
             <a:pPr/>
-            <a:fld id="{2FF24BE4-AAC2-A7BD-8C4A-5CE805047A09}" type="slidenum">
+            <a:fld id="{20C6AC85-CBCD-935A-837E-3D0FE2307568}" type="slidenum">
               <a:t/>
             </a:fld>
           </a:p>
@@ -1218,7 +1218,7 @@
             <a:spLocks noGrp="1" noChangeArrowheads="1"/>
             <a:extLst>
               <a:ext uri="smNativeData">
-                <pr:smNativeData xmlns:pr="smNativeData" xmlns="smNativeData" val="SMDATA_15_ZqHWaRMAAAAlAAAAZAAAAA8BAAAAkAAAAEgAAACQAAAASAAAAAAAAAABAAAAAAAAAAEAAABQAAAAAAAAAAAA4D8AAAAAAADgPwAAAAAAAOA/AAAAAAAA4D8AAAAAAADgPwAAAAAAAOA/AAAAAAAA4D8AAAAAAADgPwAAAAAAAOA/AAAAAAAA4D8CAAAAjAAAAAAAAAAAAAAAu+DjDP///wgAAAAAAAAAAAAAAAAAAAAAAAAAAAAAAAAAAAAAZAAAAAEAAABAAAAAAAAAAAAAAAAAAAAAAAAAAAAAAAAAAAAAAAAAAAAAAAAAAAAAAAAAAAAAAAAAAAAAAAAAAAAAAAAAAAAAAAAAAAAAAAAAAAAAAAAAAAAAAAAAAAAAFAAAADwAAAAAAAAAAAAAAAAAAAkUAAAAAQAAABQAAAAUAAAAFAAAAAEAAAAAAAAAZAAAAGQAAAAAAAAAZAAAAGQAAAAVAAAAYAAAAAAAAAAAAAAADwAAACADAAAAAAAAAAAAAAEAAACgMgAAVgcAAKr4//8BAAAAf39/AAEAAABkAAAAAAAAABQAAABAHwAAAAAAACYAAAAAAAAAwOD//wAAAAAmAAAAZAAAABYAAABMAAAAAAAAAAAAAAAEAAAAAAAAAAEAAACAgIAKAAAAACgAAAAoAAAAZAAAAGQAAAAAAAAAzMzMAAAAAABQAAAAUAAAAGQAAABkAAAAAAAAABcAAAAUAAAAAAAAAAAAAAD/fwAA/38AAAAAAAAJAAAABAAAANw7IAEeAAAAaAAAAAAAAAAAAAAAAAAAAAAAAAAAAAAAECcAABAnAAAAAAAAAAAAAAAAAAAAAAAAAAAAAAAAAAAAAAAAAAAAABQAAAAAAAAAwMD/AAAAAABkAAAAMgAAAAAAAABkAAAAAAAAAH9/fwAKAAAAIgAAABgAAAAAAAAAAAAAAAAAAAAAAAAAAAAAAAAAAAAkAAAAJAAAAAAAAAAHAAAAAAAAAAAAAAAAAAAAAAAAAAAAAAAAAAAAf39/ACUAAABYAAAAAAAAAAAAAAAAAAAAAAAAAAAAAAAAAAAAAAAAAAAAAAAAAAAAAAAAAAAAAAA/AAAAAAAAAKCGAQAAAAAAAAAAAAAAAAAMAAAAAQAAAAAAAAAAAAAAAAAAAB8AAABUAAAAAAAABQAAAAEAAAAAAAAAAAAAAAAAAAAAAAAAAAAAAAAAAAAAAAAAAAAAAAJ/f38AAAAAA8zMzADAwP8Af39/AAAAAAAAAAAAAAAAAAAAAAAAAAAAIQAAABgAAAAUAAAAwAMAALABAABARwAAuAgAABAAAAAmAAAACAAAAAAAAAAAAAAA"/>
+                <pr:smNativeData xmlns:pr="smNativeData" xmlns="smNativeData" val="SMDATA_15_MvzhaRMAAAAlAAAAZAAAAA8BAAAAkAAAAEgAAACQAAAASAAAAAAAAAABAAAAAAAAAAEAAABQAAAAAAAAAAAA4D8AAAAAAADgPwAAAAAAAOA/AAAAAAAA4D8AAAAAAADgPwAAAAAAAOA/AAAAAAAA4D8AAAAAAADgPwAAAAAAAOA/AAAAAAAA4D8CAAAAjAAAAAAAAAAAAAAAu+DjDP///wgAAAAAAAAAAAAAAAAAAAAAAAAAAAAAAAAAAAAAZAAAAAEAAABAAAAAAAAAAAAAAAAAAAAAAAAAAAAAAAAAAAAAAAAAAAAAAAAAAAAAAAAAAAAAAAAAAAAAAAAAAAAAAAAAAAAAAAAAAAAAAAAAAAAAAAAAAAAAAAAAAAAAFAAAADwAAAAAAAAAAAAAAAAAAAkUAAAAAQAAABQAAAAUAAAAFAAAAAEAAAAAAAAAZAAAAGQAAAAAAAAAZAAAAGQAAAAVAAAAYAAAAAAAAAAAAAAADwAAACADAAAAAAAAAAAAAAEAAACgMgAAVgcAAKr4//8BAAAAf39/AAEAAABkAAAAAAAAABQAAABAHwAAAAAAACYAAAAAAAAAwOD//wAAAAAmAAAAZAAAABYAAABMAAAAAAAAAAAAAAAEAAAAAAAAAAEAAACAgIAKAAAAACgAAAAoAAAAZAAAAGQAAAAAAAAAzMzMAAAAAABQAAAAUAAAAGQAAABkAAAAAAAAABcAAAAUAAAAAAAAAAAAAAD/fwAA/38AAAAAAAAJAAAABAAAANw7IAEeAAAAaAAAAAAAAAAAAAAAAAAAAAAAAAAAAAAAECcAABAnAAAAAAAAAAAAAAAAAAAAAAAAAAAAAAAAAAAAAAAAAAAAABQAAAAAAAAAwMD/AAAAAABkAAAAMgAAAAAAAABkAAAAAAAAAH9/fwAKAAAAIgAAABgAAAAAAAAAAAAAAAAAAAAAAAAAAAAAAAAAAAAkAAAAJAAAAAAAAAAHAAAAAAAAAAAAAAAAAAAAAAAAAAAAAAAAAAAAf39/ACUAAABYAAAAAAAAAAAAAAAAAAAAAAAAAAAAAAAAAAAAAAAAAAAAAAAAAAAAAAAAAAAAAAA/AAAAAAAAAKCGAQAAAAAAAAAAAAAAAAAMAAAAAQAAAAAAAAAAAAAAAAAAAB8AAABUAAAAAAAABQAAAAEAAAAAAAAAAAAAAAAAAAAAAAAAAAAAAAAAAAAAAAAAAAAAAAJ/f38AAAAAA8zMzADAwP8Af39/AAAAAAAAAAAAAAAAAAAAAAAAAAAAIQAAABgAAAAUAAAAwAMAALABAABARwAAuAgAABAAAAAmAAAACAAAAAAAAAAAAAAA"/>
               </a:ext>
             </a:extLst>
           </p:cNvSpPr>
@@ -1245,7 +1245,7 @@
             <a:spLocks noGrp="1" noChangeArrowheads="1"/>
             <a:extLst>
               <a:ext uri="smNativeData">
-                <pr:smNativeData xmlns:pr="smNativeData" xmlns="smNativeData" val="SMDATA_15_ZqHWaRMAAAAlAAAAZAAAAA8BAAAAkAAAAEgAAACQAAAASAAAAAAAAAAAAAAAAAAAAAEAAABQAAAAAAAAAAAA4D8AAAAAAADgPwAAAAAAAOA/AAAAAAAA4D8AAAAAAADgPwAAAAAAAOA/AAAAAAAA4D8AAAAAAADgPwAAAAAAAOA/AAAAAAAA4D8CAAAAjAAAAAAAAAAAAAAAu+DjDP///wgAAAAAAAAAAAAAAAAAAAAAAAAAAAAAAAAAAAAAZAAAAAEAAABAAAAAAAAAAAAAAAAAAAAAAAAAAAAAAAAAAAAAAAAAAAAAAAAAAAAAAAAAAAAAAAAAAAAAAAAAAAAAAAAAAAAAAAAAAAAAAAAAAAAAAAAAAAAAAAAAAAAAFAAAADwAAAAAAAAAAAAAAAAAAAkUAAAAAQAAABQAAAAUAAAAFAAAAAEAAAAAAAAAZAAAAGQAAAAAAAAAZAAAAGQAAAAVAAAAYAAAAAAAAAAAAAAADwAAACADAAAAAAAAAAAAAAEAAACgMgAAVgcAAKr4//8BAAAAf39/AAEAAABkAAAAAAAAABQAAABAHwAAAAAAACYAAAAAAAAAwOD//wAAAAAmAAAAZAAAABYAAABMAAAAAAAAAAAAAAAEAAAAAAAAAAEAAACAgIAKAAAAACgAAAAoAAAAZAAAAGQAAAAAAAAAzMzMAAAAAABQAAAAUAAAAGQAAABkAAAAAAAAABcAAAAUAAAAAAAAAAAAAAD/fwAA/38AAAAAAAAJAAAABAAAANw7IAEeAAAAaAAAAAAAAAAAAAAAAAAAAAAAAAAAAAAAECcAABAnAAAAAAAAAAAAAAAAAAAAAAAAAAAAAAAAAAAAAAAAAAAAABQAAAAAAAAAwMD/AAAAAABkAAAAMgAAAAAAAABkAAAAAAAAAH9/fwAKAAAAIgAAABgAAAAAAAAAAAAAAAAAAAAAAAAAAAAAAAAAAAAkAAAAJAAAAAAAAAAHAAAAAAAAAAAAAAAAAAAAAAAAAAAAAAAAAAAAf39/ACUAAABYAAAAAAAAAAAAAAAAAAAAAAAAAAAAAAAAAAAAAAAAAAAAAAAAAAAAAAAAAAAAAAA/AAAAAAAAAKCGAQAAAAAAAAAAAAAAAAAMAAAAAQAAAAAAAAAAAAAAAAAAAB8AAABUAAAAAAAABQAAAAEAAAAAAAAAAAAAAAAAAAAAAAAAAAAAAAAAAAAAAAAAAAAAAAJ/f38AAAAAA8zMzADAwP8Af39/AAAAAAAAAAAAAAAAAAAAAAAAAAAAIQAAABgAAAAUAAAAwAMAANgJAADhJAAAsCUAABAAAAAmAAAACAAAAAGAAAAAAAAA"/>
+                <pr:smNativeData xmlns:pr="smNativeData" xmlns="smNativeData" val="SMDATA_15_MvzhaRMAAAAlAAAAZAAAAA8BAAAAkAAAAEgAAACQAAAASAAAAAAAAAAAAAAAAAAAAAEAAABQAAAAAAAAAAAA4D8AAAAAAADgPwAAAAAAAOA/AAAAAAAA4D8AAAAAAADgPwAAAAAAAOA/AAAAAAAA4D8AAAAAAADgPwAAAAAAAOA/AAAAAAAA4D8CAAAAjAAAAAAAAAAAAAAAu+DjDP///wgAAAAAAAAAAAAAAAAAAAAAAAAAAAAAAAAAAAAAZAAAAAEAAABAAAAAAAAAAAAAAAAAAAAAAAAAAAAAAAAAAAAAAAAAAAAAAAAAAAAAAAAAAAAAAAAAAAAAAAAAAAAAAAAAAAAAAAAAAAAAAAAAAAAAAAAAAAAAAAAAAAAAFAAAADwAAAAAAAAAAAAAAAAAAAkUAAAAAQAAABQAAAAUAAAAFAAAAAEAAAAAAAAAZAAAAGQAAAAAAAAAZAAAAGQAAAAVAAAAYAAAAAAAAAAAAAAADwAAACADAAAAAAAAAAAAAAEAAACgMgAAVgcAAKr4//8BAAAAf39/AAEAAABkAAAAAAAAABQAAABAHwAAAAAAACYAAAAAAAAAwOD//wAAAAAmAAAAZAAAABYAAABMAAAAAAAAAAAAAAAEAAAAAAAAAAEAAACAgIAKAAAAACgAAAAoAAAAZAAAAGQAAAAAAAAAzMzMAAAAAABQAAAAUAAAAGQAAABkAAAAAAAAABcAAAAUAAAAAAAAAAAAAAD/fwAA/38AAAAAAAAJAAAABAAAANw7IAEeAAAAaAAAAAAAAAAAAAAAAAAAAAAAAAAAAAAAECcAABAnAAAAAAAAAAAAAAAAAAAAAAAAAAAAAAAAAAAAAAAAAAAAABQAAAAAAAAAwMD/AAAAAABkAAAAMgAAAAAAAABkAAAAAAAAAH9/fwAKAAAAIgAAABgAAAAAAAAAAAAAAAAAAAAAAAAAAAAAAAAAAAAkAAAAJAAAAAAAAAAHAAAAAAAAAAAAAAAAAAAAAAAAAAAAAAAAAAAAf39/ACUAAABYAAAAAAAAAAAAAAAAAAAAAAAAAAAAAAAAAAAAAAAAAAAAAAAAAAAAAAAAAAAAAAA/AAAAAAAAAKCGAQAAAAAAAAAAAAAAAAAMAAAAAQAAAAAAAAAAAAAAAAAAAB8AAABUAAAAAAAABQAAAAEAAAAAAAAAAAAAAAAAAAAAAAAAAAAAAAAAAAAAAAAAAAAAAAJ/f38AAAAAA8zMzADAwP8Af39/AAAAAAAAAAAAAAAAAAAAAAAAAAAAIQAAABgAAAAUAAAAwAMAANgJAADhJAAAsCUAABAAAAAmAAAACAAAAAGAAAAAAAAA"/>
               </a:ext>
             </a:extLst>
           </p:cNvSpPr>
@@ -1329,7 +1329,7 @@
             <a:spLocks noGrp="1" noChangeArrowheads="1"/>
             <a:extLst>
               <a:ext uri="smNativeData">
-                <pr:smNativeData xmlns:pr="smNativeData" xmlns="smNativeData" val="SMDATA_15_ZqHWaRMAAAAlAAAAZAAAAA8BAAAAkAAAAEgAAACQAAAASAAAAAAAAAAAAAAAAAAAAAEAAABQAAAAAAAAAAAA4D8AAAAAAADgPwAAAAAAAOA/AAAAAAAA4D8AAAAAAADgPwAAAAAAAOA/AAAAAAAA4D8AAAAAAADgPwAAAAAAAOA/AAAAAAAA4D8CAAAAjAAAAAAAAAAAAAAAu+DjDP///wgAAAAAAAAAAAAAAAAAAAAAAAAAAAAAAAAAAAAAZAAAAAEAAABAAAAAAAAAAAAAAAAAAAAAAAAAAAAAAAAAAAAAAAAAAAAAAAAAAAAAAAAAAAAAAAAAAAAAAAAAAAAAAAAAAAAAAAAAAAAAAAAAAAAAAAAAAAAAAAAAAAAAFAAAADwAAAAAAAAAAAAAAAAAAAkUAAAAAQAAABQAAAAUAAAAFAAAAAEAAAAAAAAAZAAAAGQAAAAAAAAAZAAAAGQAAAAVAAAAYAAAAAAAAAAAAAAADwAAACADAAAAAAAAAAAAAAEAAACgMgAAVgcAAKr4//8BAAAAf39/AAEAAABkAAAAAAAAABQAAABAHwAAAAAAACYAAAAAAAAAwOD//wAAAAAmAAAAZAAAABYAAABMAAAAAAAAAAAAAAAEAAAAAAAAAAEAAACAgIAKAAAAACgAAAAoAAAAZAAAAGQAAAAAAAAAzMzMAAAAAABQAAAAUAAAAGQAAABkAAAAAAAAABcAAAAUAAAAAAAAAAAAAAD/fwAA/38AAAAAAAAJAAAABAAAANw7IAEeAAAAaAAAAAAAAAAAAAAAAAAAAAAAAAAAAAAAECcAABAnAAAAAAAAAAAAAAAAAAAAAAAAAAAAAAAAAAAAAAAAAAAAABQAAAAAAAAAwMD/AAAAAABkAAAAMgAAAAAAAABkAAAAAAAAAH9/fwAKAAAAIgAAABgAAAAAAAAAAAAAAAAAAAAAAAAAAAAAAAAAAAAkAAAAJAAAAAAAAAAHAAAAAAAAAAAAAAAAAAAAAAAAAAAAAAAAAAAAf39/ACUAAABYAAAAAAAAAAAAAAAAAAAAAAAAAAAAAAAAAAAAAAAAAAAAAAAAAAAAAAAAAAAAAAA/AAAAAAAAAKCGAQAAAAAAAAAAAAAAAAAMAAAAAQAAAAAAAAAAAAAAAAAAAB8AAABUAAAAAAAABQAAAAEAAAAAAAAAAAAAAAAAAAAAAAAAAAAAAAAAAAAAAAAAAAAAAAJ/f38AAAAAA8zMzADAwP8Af39/AAAAAAAAAAAAAAAAAAAAAAAAAAAAIQAAABgAAAAUAAAAHyYAANgJAABARwAAsCUAABAAAAAmAAAACAAAAAGAAAAAAAAA"/>
+                <pr:smNativeData xmlns:pr="smNativeData" xmlns="smNativeData" val="SMDATA_15_MvzhaRMAAAAlAAAAZAAAAA8BAAAAkAAAAEgAAACQAAAASAAAAAAAAAAAAAAAAAAAAAEAAABQAAAAAAAAAAAA4D8AAAAAAADgPwAAAAAAAOA/AAAAAAAA4D8AAAAAAADgPwAAAAAAAOA/AAAAAAAA4D8AAAAAAADgPwAAAAAAAOA/AAAAAAAA4D8CAAAAjAAAAAAAAAAAAAAAu+DjDP///wgAAAAAAAAAAAAAAAAAAAAAAAAAAAAAAAAAAAAAZAAAAAEAAABAAAAAAAAAAAAAAAAAAAAAAAAAAAAAAAAAAAAAAAAAAAAAAAAAAAAAAAAAAAAAAAAAAAAAAAAAAAAAAAAAAAAAAAAAAAAAAAAAAAAAAAAAAAAAAAAAAAAAFAAAADwAAAAAAAAAAAAAAAAAAAkUAAAAAQAAABQAAAAUAAAAFAAAAAEAAAAAAAAAZAAAAGQAAAAAAAAAZAAAAGQAAAAVAAAAYAAAAAAAAAAAAAAADwAAACADAAAAAAAAAAAAAAEAAACgMgAAVgcAAKr4//8BAAAAf39/AAEAAABkAAAAAAAAABQAAABAHwAAAAAAACYAAAAAAAAAwOD//wAAAAAmAAAAZAAAABYAAABMAAAAAAAAAAAAAAAEAAAAAAAAAAEAAACAgIAKAAAAACgAAAAoAAAAZAAAAGQAAAAAAAAAzMzMAAAAAABQAAAAUAAAAGQAAABkAAAAAAAAABcAAAAUAAAAAAAAAAAAAAD/fwAA/38AAAAAAAAJAAAABAAAANw7IAEeAAAAaAAAAAAAAAAAAAAAAAAAAAAAAAAAAAAAECcAABAnAAAAAAAAAAAAAAAAAAAAAAAAAAAAAAAAAAAAAAAAAAAAABQAAAAAAAAAwMD/AAAAAABkAAAAMgAAAAAAAABkAAAAAAAAAH9/fwAKAAAAIgAAABgAAAAAAAAAAAAAAAAAAAAAAAAAAAAAAAAAAAAkAAAAJAAAAAAAAAAHAAAAAAAAAAAAAAAAAAAAAAAAAAAAAAAAAAAAf39/ACUAAABYAAAAAAAAAAAAAAAAAAAAAAAAAAAAAAAAAAAAAAAAAAAAAAAAAAAAAAAAAAAAAAA/AAAAAAAAAKCGAQAAAAAAAAAAAAAAAAAMAAAAAQAAAAAAAAAAAAAAAAAAAB8AAABUAAAAAAAABQAAAAEAAAAAAAAAAAAAAAAAAAAAAAAAAAAAAAAAAAAAAAAAAAAAAAJ/f38AAAAAA8zMzADAwP8Af39/AAAAAAAAAAAAAAAAAAAAAAAAAAAAIQAAABgAAAAUAAAAHyYAANgJAABARwAAsCUAABAAAAAmAAAACAAAAAGAAAAAAAAA"/>
               </a:ext>
             </a:extLst>
           </p:cNvSpPr>
@@ -1413,7 +1413,7 @@
             <a:spLocks noGrp="1" noChangeArrowheads="1"/>
             <a:extLst>
               <a:ext uri="smNativeData">
-                <pr:smNativeData xmlns:pr="smNativeData" xmlns="smNativeData" val="SMDATA_15_ZqHWaRMAAAAlAAAAZAAAAA8BAAAAkAAAAEgAAACQAAAASAAAAAAAAAABAAAAAAAAAAEAAABQAAAAAAAAAAAA4D8AAAAAAADgPwAAAAAAAOA/AAAAAAAA4D8AAAAAAADgPwAAAAAAAOA/AAAAAAAA4D8AAAAAAADgPwAAAAAAAOA/AAAAAAAA4D8CAAAAjAAAAAAAAAAAAAAAu+DjDP///wgAAAAAAAAAAAAAAAAAAAAAAAAAAAAAAAAAAAAAZAAAAAEAAABAAAAAAAAAAAAAAAAAAAAAAAAAAAAAAAAAAAAAAAAAAAAAAAAAAAAAAAAAAAAAAAAAAAAAAAAAAAAAAAAAAAAAAAAAAAAAAAAAAAAAAAAAAAAAAAAAAAAAFAAAADwAAAAAAAAAAAAAAAAAAAkUAAAAAQAAABQAAAAUAAAAFAAAAAEAAAAAAAAAZAAAAGQAAAAAAAAAZAAAAGQAAAAVAAAAYAAAAAAAAAAAAAAADwAAACADAAAAAAAAAAAAAAEAAACgMgAAVgcAAKr4//8BAAAAf39/AAEAAABkAAAAAAAAABQAAABAHwAAAAAAACYAAAAAAAAAwOD//wAAAAAmAAAAZAAAABYAAABMAAAAAAAAAAAAAAAEAAAAAAAAAAEAAACAgIAKAAAAACgAAAAoAAAAZAAAAGQAAAAAAAAAzMzMAAAAAABQAAAAUAAAAGQAAABkAAAAAAAAABcAAAAUAAAAAAAAAAAAAAD/fwAA/38AAAAAAAAJAAAABAAAANw7IAEeAAAAaAAAAAAAAAAAAAAAAAAAAAAAAAAAAAAAECcAABAnAAAAAAAAAAAAAAAAAAAAAAAAAAAAAAAAAAAAAAAAAAAAABQAAAAAAAAAwMD/AAAAAABkAAAAMgAAAAAAAABkAAAAAAAAAH9/fwAKAAAAIgAAABgAAAAAAAAAAAAAAAAAAAAAAAAAAAAAAAAAAAAkAAAAJAAAAAAAAAAHAAAAAAAAAAAAAAAAAAAAAAAAAAAAAAAAAAAAf39/ACUAAABYAAAAAAAAAAAAAAAAAAAAAAAAAAAAAAAAAAAAAAAAAAAAAAAAAAAAAAAAAAAAAAA/AAAAAAAAAKCGAQAAAAAAAAAAAAAAAAAMAAAAAQAAAAAAAAAAAAAAAAAAAB8AAABUAAAAAAAABQAAAAEAAAAAAAAAAAAAAAAAAAAAAAAAAAAAAAAAAAAAAAAAAAAAAAJ/f38AAAAAA8zMzADAwP8Af39/AAAAAAAAAAAAAAAAAAAAAAAAAAAAIQAAABgAAAAUAAAAwAMAABsnAAA/FQAAWSkAABAAAAAmAAAACAAAAAAAAAAAAAAA"/>
+                <pr:smNativeData xmlns:pr="smNativeData" xmlns="smNativeData" val="SMDATA_15_MvzhaRMAAAAlAAAAZAAAAA8BAAAAkAAAAEgAAACQAAAASAAAAAAAAAABAAAAAAAAAAEAAABQAAAAAAAAAAAA4D8AAAAAAADgPwAAAAAAAOA/AAAAAAAA4D8AAAAAAADgPwAAAAAAAOA/AAAAAAAA4D8AAAAAAADgPwAAAAAAAOA/AAAAAAAA4D8CAAAAjAAAAAAAAAAAAAAAu+DjDP///wgAAAAAAAAAAAAAAAAAAAAAAAAAAAAAAAAAAAAAZAAAAAEAAABAAAAAAAAAAAAAAAAAAAAAAAAAAAAAAAAAAAAAAAAAAAAAAAAAAAAAAAAAAAAAAAAAAAAAAAAAAAAAAAAAAAAAAAAAAAAAAAAAAAAAAAAAAAAAAAAAAAAAFAAAADwAAAAAAAAAAAAAAAAAAAkUAAAAAQAAABQAAAAUAAAAFAAAAAEAAAAAAAAAZAAAAGQAAAAAAAAAZAAAAGQAAAAVAAAAYAAAAAAAAAAAAAAADwAAACADAAAAAAAAAAAAAAEAAACgMgAAVgcAAKr4//8BAAAAf39/AAEAAABkAAAAAAAAABQAAABAHwAAAAAAACYAAAAAAAAAwOD//wAAAAAmAAAAZAAAABYAAABMAAAAAAAAAAAAAAAEAAAAAAAAAAEAAACAgIAKAAAAACgAAAAoAAAAZAAAAGQAAAAAAAAAzMzMAAAAAABQAAAAUAAAAGQAAABkAAAAAAAAABcAAAAUAAAAAAAAAAAAAAD/fwAA/38AAAAAAAAJAAAABAAAANw7IAEeAAAAaAAAAAAAAAAAAAAAAAAAAAAAAAAAAAAAECcAABAnAAAAAAAAAAAAAAAAAAAAAAAAAAAAAAAAAAAAAAAAAAAAABQAAAAAAAAAwMD/AAAAAABkAAAAMgAAAAAAAABkAAAAAAAAAH9/fwAKAAAAIgAAABgAAAAAAAAAAAAAAAAAAAAAAAAAAAAAAAAAAAAkAAAAJAAAAAAAAAAHAAAAAAAAAAAAAAAAAAAAAAAAAAAAAAAAAAAAf39/ACUAAABYAAAAAAAAAAAAAAAAAAAAAAAAAAAAAAAAAAAAAAAAAAAAAAAAAAAAAAAAAAAAAAA/AAAAAAAAAKCGAQAAAAAAAAAAAAAAAAAMAAAAAQAAAAAAAAAAAAAAAAAAAB8AAABUAAAAAAAABQAAAAEAAAAAAAAAAAAAAAAAAAAAAAAAAAAAAAAAAAAAAAAAAAAAAAJ/f38AAAAAA8zMzADAwP8Af39/AAAAAAAAAAAAAAAAAAAAAAAAAAAAIQAAABgAAAAUAAAAwAMAABsnAAA/FQAAWSkAABAAAAAmAAAACAAAAAAAAAAAAAAA"/>
               </a:ext>
             </a:extLst>
           </p:cNvSpPr>
@@ -1427,7 +1427,7 @@
           <a:lstStyle/>
           <a:p>
             <a:pPr/>
-            <a:fld id="{5F0F75AA-E4B2-5A83-FCB7-12D63BF90A47}" type="datetime1">
+            <a:fld id="{628C5D59-178F-D9AB-C134-E1FE137A37B4}" type="datetime1">
               <a:t/>
             </a:fld>
           </a:p>
@@ -1440,7 +1440,7 @@
             <a:spLocks noGrp="1" noChangeArrowheads="1"/>
             <a:extLst>
               <a:ext uri="smNativeData">
-                <pr:smNativeData xmlns:pr="smNativeData" xmlns="smNativeData" val="SMDATA_15_ZqHWaRMAAAAlAAAAZAAAAA8BAAAAkAAAAEgAAACQAAAASAAAAAAAAAABAAAAAAAAAAEAAABQAAAAAAAAAAAA4D8AAAAAAADgPwAAAAAAAOA/AAAAAAAA4D8AAAAAAADgPwAAAAAAAOA/AAAAAAAA4D8AAAAAAADgPwAAAAAAAOA/AAAAAAAA4D8CAAAAjAAAAAAAAAAAAAAAu+DjDP///wgAAAAAAAAAAAAAAAAAAAAAAAAAAAAAAAAAAAAAZAAAAAEAAABAAAAAAAAAAAAAAAAAAAAAAAAAAAAAAAAAAAAAAAAAAAAAAAAAAAAAAAAAAAAAAAAAAAAAAAAAAAAAAAAAAAAAAAAAAAAAAAAAAAAAAAAAAAAAAAAAAAAAFAAAADwAAAAAAAAAAAAAAAAAAAkUAAAAAQAAABQAAAAUAAAAFAAAAAEAAAAAAAAAZAAAAGQAAAAAAAAAZAAAAGQAAAAVAAAAYAAAAAAAAAAAAAAADwAAACADAAAAAAAAAAAAAAEAAACgMgAAVgcAAKr4//8BAAAAf39/AAEAAABkAAAAAAAAABQAAABAHwAAAAAAACYAAAAAAAAAwOD//wAAAAAmAAAAZAAAABYAAABMAAAAAAAAAAAAAAAEAAAAAAAAAAEAAACAgIAKAAAAACgAAAAoAAAAZAAAAGQAAAAAAAAAzMzMAAAAAABQAAAAUAAAAGQAAABkAAAAAAAAABcAAAAUAAAAAAAAAAAAAAD/fwAA/38AAAAAAAAJAAAABAAAANw7IAEeAAAAaAAAAAAAAAAAAAAAAAAAAAAAAAAAAAAAECcAABAnAAAAAAAAAAAAAAAAAAAAAAAAAAAAAAAAAAAAAAAAAAAAABQAAAAAAAAAwMD/AAAAAABkAAAAMgAAAAAAAABkAAAAAAAAAH9/fwAKAAAAIgAAABgAAAAAAAAAAAAAAAAAAAAAAAAAAAAAAAAAAAAkAAAAJAAAAAAAAAAHAAAAAAAAAAAAAAAAAAAAAAAAAAAAAAAAAAAAf39/ACUAAABYAAAAAAAAAAAAAAAAAAAAAAAAAAAAAAAAAAAAAAAAAAAAAAAAAAAAAAAAAAAAAAA/AAAAAAAAAKCGAQAAAAAAAAAAAAAAAAAMAAAAAQAAAAAAAAAAAAAAAAAAAB8AAABUAAAAAAAABQAAAAEAAAAAAAAAAAAAAAAAAAAAAAAAAAAAAAAAAAAAAAAAAAAAAAJ/f38AAAAAA8zMzADAwP8Af39/AAAAAAAAAAAAAAAAAAAAAAAAAAAAIQAAABgAAAAUAAAAoRkAABsnAABfMQAAWSkAABAAAAAmAAAACAAAAAAAAAAAAAAA"/>
+                <pr:smNativeData xmlns:pr="smNativeData" xmlns="smNativeData" val="SMDATA_15_MvzhaRMAAAAlAAAAZAAAAA8BAAAAkAAAAEgAAACQAAAASAAAAAAAAAABAAAAAAAAAAEAAABQAAAAAAAAAAAA4D8AAAAAAADgPwAAAAAAAOA/AAAAAAAA4D8AAAAAAADgPwAAAAAAAOA/AAAAAAAA4D8AAAAAAADgPwAAAAAAAOA/AAAAAAAA4D8CAAAAjAAAAAAAAAAAAAAAu+DjDP///wgAAAAAAAAAAAAAAAAAAAAAAAAAAAAAAAAAAAAAZAAAAAEAAABAAAAAAAAAAAAAAAAAAAAAAAAAAAAAAAAAAAAAAAAAAAAAAAAAAAAAAAAAAAAAAAAAAAAAAAAAAAAAAAAAAAAAAAAAAAAAAAAAAAAAAAAAAAAAAAAAAAAAFAAAADwAAAAAAAAAAAAAAAAAAAkUAAAAAQAAABQAAAAUAAAAFAAAAAEAAAAAAAAAZAAAAGQAAAAAAAAAZAAAAGQAAAAVAAAAYAAAAAAAAAAAAAAADwAAACADAAAAAAAAAAAAAAEAAACgMgAAVgcAAKr4//8BAAAAf39/AAEAAABkAAAAAAAAABQAAABAHwAAAAAAACYAAAAAAAAAwOD//wAAAAAmAAAAZAAAABYAAABMAAAAAAAAAAAAAAAEAAAAAAAAAAEAAACAgIAKAAAAACgAAAAoAAAAZAAAAGQAAAAAAAAAzMzMAAAAAABQAAAAUAAAAGQAAABkAAAAAAAAABcAAAAUAAAAAAAAAAAAAAD/fwAA/38AAAAAAAAJAAAABAAAANw7IAEeAAAAaAAAAAAAAAAAAAAAAAAAAAAAAAAAAAAAECcAABAnAAAAAAAAAAAAAAAAAAAAAAAAAAAAAAAAAAAAAAAAAAAAABQAAAAAAAAAwMD/AAAAAABkAAAAMgAAAAAAAABkAAAAAAAAAH9/fwAKAAAAIgAAABgAAAAAAAAAAAAAAAAAAAAAAAAAAAAAAAAAAAAkAAAAJAAAAAAAAAAHAAAAAAAAAAAAAAAAAAAAAAAAAAAAAAAAAAAAf39/ACUAAABYAAAAAAAAAAAAAAAAAAAAAAAAAAAAAAAAAAAAAAAAAAAAAAAAAAAAAAAAAAAAAAA/AAAAAAAAAKCGAQAAAAAAAAAAAAAAAAAMAAAAAQAAAAAAAAAAAAAAAAAAAB8AAABUAAAAAAAABQAAAAEAAAAAAAAAAAAAAAAAAAAAAAAAAAAAAAAAAAAAAAAAAAAAAAJ/f38AAAAAA8zMzADAwP8Af39/AAAAAAAAAAAAAAAAAAAAAAAAAAAAIQAAABgAAAAUAAAAoRkAABsnAABfMQAAWSkAABAAAAAmAAAACAAAAAAAAAAAAAAA"/>
               </a:ext>
             </a:extLst>
           </p:cNvSpPr>
@@ -1464,7 +1464,7 @@
             <a:spLocks noGrp="1" noChangeArrowheads="1"/>
             <a:extLst>
               <a:ext uri="smNativeData">
-                <pr:smNativeData xmlns:pr="smNativeData" xmlns="smNativeData" val="SMDATA_15_ZqHWaRMAAAAlAAAAZAAAAA8BAAAAkAAAAEgAAACQAAAASAAAAAAAAAABAAAAAAAAAAEAAABQAAAAAAAAAAAA4D8AAAAAAADgPwAAAAAAAOA/AAAAAAAA4D8AAAAAAADgPwAAAAAAAOA/AAAAAAAA4D8AAAAAAADgPwAAAAAAAOA/AAAAAAAA4D8CAAAAjAAAAAAAAAAAAAAAu+DjDP///wgAAAAAAAAAAAAAAAAAAAAAAAAAAAAAAAAAAAAAZAAAAAEAAABAAAAAAAAAAAAAAAAAAAAAAAAAAAAAAAAAAAAAAAAAAAAAAAAAAAAAAAAAAAAAAAAAAAAAAAAAAAAAAAAAAAAAAAAAAAAAAAAAAAAAAAAAAAAAAAAAAAAAFAAAADwAAAAAAAAAAAAAAAAAAAkUAAAAAQAAABQAAAAUAAAAFAAAAAEAAAAAAAAAZAAAAGQAAAAAAAAAZAAAAGQAAAAVAAAAYAAAAAAAAAAAAAAADwAAACADAAAAAAAAAAAAAAEAAACgMgAAVgcAAKr4//8BAAAAf39/AAEAAABkAAAAAAAAABQAAABAHwAAAAAAACYAAAAAAAAAwOD//wAAAAAmAAAAZAAAABYAAABMAAAAAAAAAAAAAAAEAAAAAAAAAAEAAACAgIAKAAAAACgAAAAoAAAAZAAAAGQAAAAAAAAAzMzMAAAAAABQAAAAUAAAAGQAAABkAAAAAAAAABcAAAAUAAAAAAAAAAAAAAD/fwAA/38AAAAAAAAJAAAABAAAANw7IAEeAAAAaAAAAAAAAAAAAAAAAAAAAAAAAAAAAAAAECcAABAnAAAAAAAAAAAAAAAAAAAAAAAAAAAAAAAAAAAAAAAAAAAAABQAAAAAAAAAwMD/AAAAAABkAAAAMgAAAAAAAABkAAAAAAAAAH9/fwAKAAAAIgAAABgAAAAAAAAAAAAAAAAAAAAAAAAAAAAAAAAAAAAkAAAAJAAAAAAAAAAHAAAAAAAAAAAAAAAAAAAAAAAAAAAAAAAAAAAAf39/ACUAAABYAAAAAAAAAAAAAAAAAAAAAAAAAAAAAAAAAAAAAAAAAAAAAAAAAAAAAAAAAAAAAAA/AAAAAAAAAKCGAQAAAAAAAAAAAAAAAAAMAAAAAQAAAAAAAAAAAAAAAAAAAB8AAABUAAAAAAAABQAAAAEAAAAAAAAAAAAAAAAAAAAAAAAAAAAAAAAAAAAAAAAAAAAAAAJ/f38AAAAAA8zMzADAwP8Af39/AAAAAAAAAAAAAAAAAAAAAAAAAAAAIQAAABgAAAAUAAAAwTUAABsnAABARwAAWSkAABAAAAAmAAAACAAAAAAAAAAAAAAA"/>
+                <pr:smNativeData xmlns:pr="smNativeData" xmlns="smNativeData" val="SMDATA_15_MvzhaRMAAAAlAAAAZAAAAA8BAAAAkAAAAEgAAACQAAAASAAAAAAAAAABAAAAAAAAAAEAAABQAAAAAAAAAAAA4D8AAAAAAADgPwAAAAAAAOA/AAAAAAAA4D8AAAAAAADgPwAAAAAAAOA/AAAAAAAA4D8AAAAAAADgPwAAAAAAAOA/AAAAAAAA4D8CAAAAjAAAAAAAAAAAAAAAu+DjDP///wgAAAAAAAAAAAAAAAAAAAAAAAAAAAAAAAAAAAAAZAAAAAEAAABAAAAAAAAAAAAAAAAAAAAAAAAAAAAAAAAAAAAAAAAAAAAAAAAAAAAAAAAAAAAAAAAAAAAAAAAAAAAAAAAAAAAAAAAAAAAAAAAAAAAAAAAAAAAAAAAAAAAAFAAAADwAAAAAAAAAAAAAAAAAAAkUAAAAAQAAABQAAAAUAAAAFAAAAAEAAAAAAAAAZAAAAGQAAAAAAAAAZAAAAGQAAAAVAAAAYAAAAAAAAAAAAAAADwAAACADAAAAAAAAAAAAAAEAAACgMgAAVgcAAKr4//8BAAAAf39/AAEAAABkAAAAAAAAABQAAABAHwAAAAAAACYAAAAAAAAAwOD//wAAAAAmAAAAZAAAABYAAABMAAAAAAAAAAAAAAAEAAAAAAAAAAEAAACAgIAKAAAAACgAAAAoAAAAZAAAAGQAAAAAAAAAzMzMAAAAAABQAAAAUAAAAGQAAABkAAAAAAAAABcAAAAUAAAAAAAAAAAAAAD/fwAA/38AAAAAAAAJAAAABAAAANw7IAEeAAAAaAAAAAAAAAAAAAAAAAAAAAAAAAAAAAAAECcAABAnAAAAAAAAAAAAAAAAAAAAAAAAAAAAAAAAAAAAAAAAAAAAABQAAAAAAAAAwMD/AAAAAABkAAAAMgAAAAAAAABkAAAAAAAAAH9/fwAKAAAAIgAAABgAAAAAAAAAAAAAAAAAAAAAAAAAAAAAAAAAAAAkAAAAJAAAAAAAAAAHAAAAAAAAAAAAAAAAAAAAAAAAAAAAAAAAAAAAf39/ACUAAABYAAAAAAAAAAAAAAAAAAAAAAAAAAAAAAAAAAAAAAAAAAAAAAAAAAAAAAAAAAAAAAA/AAAAAAAAAKCGAQAAAAAAAAAAAAAAAAAMAAAAAQAAAAAAAAAAAAAAAAAAAB8AAABUAAAAAAAABQAAAAEAAAAAAAAAAAAAAAAAAAAAAAAAAAAAAAAAAAAAAAAAAAAAAAJ/f38AAAAAA8zMzADAwP8Af39/AAAAAAAAAAAAAAAAAAAAAAAAAAAAIQAAABgAAAAUAAAAwTUAABsnAABARwAAWSkAABAAAAAmAAAACAAAAAAAAAAAAAAA"/>
               </a:ext>
             </a:extLst>
           </p:cNvSpPr>
@@ -1478,7 +1478,7 @@
           <a:lstStyle/>
           <a:p>
             <a:pPr/>
-            <a:fld id="{57B50146-08BA-E0F7-F40D-FEA24F4302AB}" type="slidenum">
+            <a:fld id="{376D2FBA-F4DA-38D9-94D5-028C619B6257}" type="slidenum">
               <a:t/>
             </a:fld>
           </a:p>
@@ -1517,7 +1517,7 @@
             <a:spLocks noGrp="1" noChangeArrowheads="1"/>
             <a:extLst>
               <a:ext uri="smNativeData">
-                <pr:smNativeData xmlns:pr="smNativeData" xmlns="smNativeData" val="SMDATA_15_ZqHWaRMAAAAlAAAAZAAAAA8BAAAAkAAAAEgAAACQAAAASAAAAAAAAAABAAAAAAAAAAEAAABQAAAAAAAAAAAA4D8AAAAAAADgPwAAAAAAAOA/AAAAAAAA4D8AAAAAAADgPwAAAAAAAOA/AAAAAAAA4D8AAAAAAADgPwAAAAAAAOA/AAAAAAAA4D8CAAAAjAAAAAAAAAAAAAAAu+DjDP///wgAAAAAAAAAAAAAAAAAAAAAAAAAAAAAAAAAAAAAZAAAAAEAAABAAAAAAAAAAAAAAAAAAAAAAAAAAAAAAAAAAAAAAAAAAAAAAAAAAAAAAAAAAAAAAAAAAAAAAAAAAAAAAAAAAAAAAAAAAAAAAAAAAAAAAAAAAAAAAAAAAAAAFAAAADwAAAAAAAAAAAAAAAAAAAkUAAAAAQAAABQAAAAUAAAAFAAAAAEAAAAAAAAAZAAAAGQAAAAAAAAAZAAAAGQAAAAVAAAAYAAAAAAAAAAAAAAADwAAACADAAAAAAAAAAAAAAEAAACgMgAAVgcAAKr4//8BAAAAf39/AAEAAABkAAAAAAAAABQAAABAHwAAAAAAACYAAAAAAAAAwOD//wAAAAAmAAAAZAAAABYAAABMAAAAAAAAAAAAAAAEAAAAAAAAAAEAAACAgIAKAAAAACgAAAAoAAAAZAAAAGQAAAAAAAAAzMzMAAAAAABQAAAAUAAAAGQAAABkAAAAAAAAABcAAAAUAAAAAAAAAAAAAAD/fwAA/38AAAAAAAAJAAAABAAAANw7IAEeAAAAaAAAAAAAAAAAAAAAAAAAAAAAAAAAAAAAECcAABAnAAAAAAAAAAAAAAAAAAAAAAAAAAAAAAAAAAAAAAAAAAAAABQAAAAAAAAAwMD/AAAAAABkAAAAMgAAAAAAAABkAAAAAAAAAH9/fwAKAAAAIgAAABgAAAAAAAAAAAAAAAAAAAAAAAAAAAAAAAAAAAAkAAAAJAAAAAAAAAAHAAAAAAAAAAAAAAAAAAAAAAAAAAAAAAAAAAAAf39/ACUAAABYAAAAAAAAAAAAAAAAAAAAAAAAAAAAAAAAAAAAAAAAAAAAAAAAAAAAAAAAAAAAAAA/AAAAAAAAAKCGAQAAAAAAAAAAAAAAAAAMAAAAAQAAAAAAAAAAAAAAAAAAAB8AAABUAAAAAAAABQAAAAEAAAAAAAAAAAAAAAAAAAAAAAAAAAAAAAAAAAAAAAAAAAAAAAJ/f38AAAAAA8zMzADAwP8Af39/AAAAAAAAAAAAAAAAAAAAAAAAAAAAIQAAABgAAAAUAAAAwAMAALABAABARwAAuAgAABAAAAAmAAAACAAAAAAAAAAAAAAA"/>
+                <pr:smNativeData xmlns:pr="smNativeData" xmlns="smNativeData" val="SMDATA_15_MvzhaRMAAAAlAAAAZAAAAA8BAAAAkAAAAEgAAACQAAAASAAAAAAAAAABAAAAAAAAAAEAAABQAAAAAAAAAAAA4D8AAAAAAADgPwAAAAAAAOA/AAAAAAAA4D8AAAAAAADgPwAAAAAAAOA/AAAAAAAA4D8AAAAAAADgPwAAAAAAAOA/AAAAAAAA4D8CAAAAjAAAAAAAAAAAAAAAu+DjDP///wgAAAAAAAAAAAAAAAAAAAAAAAAAAAAAAAAAAAAAZAAAAAEAAABAAAAAAAAAAAAAAAAAAAAAAAAAAAAAAAAAAAAAAAAAAAAAAAAAAAAAAAAAAAAAAAAAAAAAAAAAAAAAAAAAAAAAAAAAAAAAAAAAAAAAAAAAAAAAAAAAAAAAFAAAADwAAAAAAAAAAAAAAAAAAAkUAAAAAQAAABQAAAAUAAAAFAAAAAEAAAAAAAAAZAAAAGQAAAAAAAAAZAAAAGQAAAAVAAAAYAAAAAAAAAAAAAAADwAAACADAAAAAAAAAAAAAAEAAACgMgAAVgcAAKr4//8BAAAAf39/AAEAAABkAAAAAAAAABQAAABAHwAAAAAAACYAAAAAAAAAwOD//wAAAAAmAAAAZAAAABYAAABMAAAAAAAAAAAAAAAEAAAAAAAAAAEAAACAgIAKAAAAACgAAAAoAAAAZAAAAGQAAAAAAAAAzMzMAAAAAABQAAAAUAAAAGQAAABkAAAAAAAAABcAAAAUAAAAAAAAAAAAAAD/fwAA/38AAAAAAAAJAAAABAAAANw7IAEeAAAAaAAAAAAAAAAAAAAAAAAAAAAAAAAAAAAAECcAABAnAAAAAAAAAAAAAAAAAAAAAAAAAAAAAAAAAAAAAAAAAAAAABQAAAAAAAAAwMD/AAAAAABkAAAAMgAAAAAAAABkAAAAAAAAAH9/fwAKAAAAIgAAABgAAAAAAAAAAAAAAAAAAAAAAAAAAAAAAAAAAAAkAAAAJAAAAAAAAAAHAAAAAAAAAAAAAAAAAAAAAAAAAAAAAAAAAAAAf39/ACUAAABYAAAAAAAAAAAAAAAAAAAAAAAAAAAAAAAAAAAAAAAAAAAAAAAAAAAAAAAAAAAAAAA/AAAAAAAAAKCGAQAAAAAAAAAAAAAAAAAMAAAAAQAAAAAAAAAAAAAAAAAAAB8AAABUAAAAAAAABQAAAAEAAAAAAAAAAAAAAAAAAAAAAAAAAAAAAAAAAAAAAAAAAAAAAAJ/f38AAAAAA8zMzADAwP8Af39/AAAAAAAAAAAAAAAAAAAAAAAAAAAAIQAAABgAAAAUAAAAwAMAALABAABARwAAuAgAABAAAAAmAAAACAAAAAAAAAAAAAAA"/>
               </a:ext>
             </a:extLst>
           </p:cNvSpPr>
@@ -1544,7 +1544,7 @@
             <a:spLocks noGrp="1" noChangeArrowheads="1"/>
             <a:extLst>
               <a:ext uri="smNativeData">
-                <pr:smNativeData xmlns:pr="smNativeData" xmlns="smNativeData" val="SMDATA_15_ZqHWaRMAAAAlAAAAZAAAAA8BAAAAkAAAAEgAAACQAAAASAAAAAAAAAACAAAAAAAAAAEAAABQAAAAAAAAAAAA4D8AAAAAAADgPwAAAAAAAOA/AAAAAAAA4D8AAAAAAADgPwAAAAAAAOA/AAAAAAAA4D8AAAAAAADgPwAAAAAAAOA/AAAAAAAA4D8CAAAAjAAAAAAAAAAAAAAAu+DjDP///wgAAAAAAAAAAAAAAAAAAAAAAAAAAAAAAAAAAAAAZAAAAAEAAABAAAAAAAAAAAAAAAAAAAAAAAAAAAAAAAAAAAAAAAAAAAAAAAAAAAAAAAAAAAAAAAAAAAAAAAAAAAAAAAAAAAAAAAAAAAAAAAAAAAAAAAAAAAAAAAAAAAAAFAAAADwAAAAAAAAAAAAAAAAAAAkUAAAAAQAAABQAAAAUAAAAFAAAAAEAAAAAAAAAZAAAAGQAAAAAAAAAZAAAAGQAAAAVAAAAYAAAAAAAAAAAAAAADwAAACADAAAAAAAAAAAAAAEAAACgMgAAVgcAAKr4//8BAAAAf39/AAEAAABkAAAAAAAAABQAAABAHwAAAAAAACYAAAAAAAAAwOD//wAAAAAmAAAAZAAAABYAAABMAAAAAAAAAAAAAAAEAAAAAAAAAAEAAACAgIAKAAAAACgAAAAoAAAAZAAAAGQAAAAAAAAAzMzMAAAAAABQAAAAUAAAAGQAAABkAAAAAAAAABcAAAAUAAAAAAAAAAAAAAD/fwAA/38AAAAAAAAJAAAABAAAANw7IAEeAAAAaAAAAAAAAAAAAAAAAAAAAAAAAAAAAAAAECcAABAnAAAAAAAAAAAAAAAAAAAAAAAAAAAAAAAAAAAAAAAAAAAAABQAAAAAAAAAwMD/AAAAAABkAAAAMgAAAAAAAABkAAAAAAAAAH9/fwAKAAAAIgAAABgAAAAAAAAAAAAAAAAAAAAAAAAAAAAAAAAAAAAkAAAAJAAAAAAAAAAHAAAAAAAAAAAAAAAAAAAAAAAAAAAAAAAAAAAAf39/ACUAAABYAAAAAAAAAAAAAAAAAAAAAAAAAAAAAAAAAAAAAAAAAAAAAAAAAAAAAAAAAAAAAAA/AAAAAAAAAKCGAQAAAAAAAAAAAAAAAAAMAAAAAQAAAAAAAAAAAAAAAAAAAB8AAABUAAAAAAAABQAAAAEAAAAAAAAAAAAAAAAAAAAAAAAAAAAAAAAAAAAAAAAAAAAAAAJ/f38AAAAAA8zMzADAwP8Af39/AAAAAAAAAAAAAAAAAAAAAAAAAAAAIQAAABgAAAAUAAAAwAMAAHEJAADjJAAAYQ0AABAAAAAmAAAACAAAAIGAAAAAAAAA"/>
+                <pr:smNativeData xmlns:pr="smNativeData" xmlns="smNativeData" val="SMDATA_15_MvzhaRMAAAAlAAAAZAAAAA8BAAAAkAAAAEgAAACQAAAASAAAAAAAAAACAAAAAAAAAAEAAABQAAAAAAAAAAAA4D8AAAAAAADgPwAAAAAAAOA/AAAAAAAA4D8AAAAAAADgPwAAAAAAAOA/AAAAAAAA4D8AAAAAAADgPwAAAAAAAOA/AAAAAAAA4D8CAAAAjAAAAAAAAAAAAAAAu+DjDP///wgAAAAAAAAAAAAAAAAAAAAAAAAAAAAAAAAAAAAAZAAAAAEAAABAAAAAAAAAAAAAAAAAAAAAAAAAAAAAAAAAAAAAAAAAAAAAAAAAAAAAAAAAAAAAAAAAAAAAAAAAAAAAAAAAAAAAAAAAAAAAAAAAAAAAAAAAAAAAAAAAAAAAFAAAADwAAAAAAAAAAAAAAAAAAAkUAAAAAQAAABQAAAAUAAAAFAAAAAEAAAAAAAAAZAAAAGQAAAAAAAAAZAAAAGQAAAAVAAAAYAAAAAAAAAAAAAAADwAAACADAAAAAAAAAAAAAAEAAACgMgAAVgcAAKr4//8BAAAAf39/AAEAAABkAAAAAAAAABQAAABAHwAAAAAAACYAAAAAAAAAwOD//wAAAAAmAAAAZAAAABYAAABMAAAAAAAAAAAAAAAEAAAAAAAAAAEAAACAgIAKAAAAACgAAAAoAAAAZAAAAGQAAAAAAAAAzMzMAAAAAABQAAAAUAAAAGQAAABkAAAAAAAAABcAAAAUAAAAAAAAAAAAAAD/fwAA/38AAAAAAAAJAAAABAAAANw7IAEeAAAAaAAAAAAAAAAAAAAAAAAAAAAAAAAAAAAAECcAABAnAAAAAAAAAAAAAAAAAAAAAAAAAAAAAAAAAAAAAAAAAAAAABQAAAAAAAAAwMD/AAAAAABkAAAAMgAAAAAAAABkAAAAAAAAAH9/fwAKAAAAIgAAABgAAAAAAAAAAAAAAAAAAAAAAAAAAAAAAAAAAAAkAAAAJAAAAAAAAAAHAAAAAAAAAAAAAAAAAAAAAAAAAAAAAAAAAAAAf39/ACUAAABYAAAAAAAAAAAAAAAAAAAAAAAAAAAAAAAAAAAAAAAAAAAAAAAAAAAAAAAAAAAAAAA/AAAAAAAAAKCGAQAAAAAAAAAAAAAAAAAMAAAAAQAAAAAAAAAAAAAAAAAAAB8AAABUAAAAAAAABQAAAAEAAAAAAAAAAAAAAAAAAAAAAAAAAAAAAAAAAAAAAAAAAAAAAAJ/f38AAAAAA8zMzADAwP8Af39/AAAAAAAAAAAAAAAAAAAAAAAAAAAAIQAAABgAAAAUAAAAwAMAAHEJAADjJAAAYQ0AABAAAAAmAAAACAAAAIGAAAAAAAAA"/>
               </a:ext>
             </a:extLst>
           </p:cNvSpPr>
@@ -1617,7 +1617,7 @@
             <a:spLocks noGrp="1" noChangeArrowheads="1"/>
             <a:extLst>
               <a:ext uri="smNativeData">
-                <pr:smNativeData xmlns:pr="smNativeData" xmlns="smNativeData" val="SMDATA_15_ZqHWaRMAAAAlAAAAZAAAAA8BAAAAkAAAAEgAAACQAAAASAAAAAAAAAAAAAAAAAAAAAEAAABQAAAAAAAAAAAA4D8AAAAAAADgPwAAAAAAAOA/AAAAAAAA4D8AAAAAAADgPwAAAAAAAOA/AAAAAAAA4D8AAAAAAADgPwAAAAAAAOA/AAAAAAAA4D8CAAAAjAAAAAAAAAAAAAAAu+DjDP///wgAAAAAAAAAAAAAAAAAAAAAAAAAAAAAAAAAAAAAZAAAAAEAAABAAAAAAAAAAAAAAAAAAAAAAAAAAAAAAAAAAAAAAAAAAAAAAAAAAAAAAAAAAAAAAAAAAAAAAAAAAAAAAAAAAAAAAAAAAAAAAAAAAAAAAAAAAAAAAAAAAAAAFAAAADwAAAAAAAAAAAAAAAAAAAkUAAAAAQAAABQAAAAUAAAAFAAAAAEAAAAAAAAAZAAAAGQAAAAAAAAAZAAAAGQAAAAVAAAAYAAAAAAAAAAAAAAADwAAACADAAAAAAAAAAAAAAEAAACgMgAAVgcAAKr4//8BAAAAf39/AAEAAABkAAAAAAAAABQAAABAHwAAAAAAACYAAAAAAAAAwOD//wAAAAAmAAAAZAAAABYAAABMAAAAAAAAAAAAAAAEAAAAAAAAAAEAAACAgIAKAAAAACgAAAAoAAAAZAAAAGQAAAAAAAAAzMzMAAAAAABQAAAAUAAAAGQAAABkAAAAAAAAABcAAAAUAAAAAAAAAAAAAAD/fwAA/38AAAAAAAAJAAAABAAAANw7IAEeAAAAaAAAAAAAAAAAAAAAAAAAAAAAAAAAAAAAECcAABAnAAAAAAAAAAAAAAAAAAAAAAAAAAAAAAAAAAAAAAAAAAAAABQAAAAAAAAAwMD/AAAAAABkAAAAMgAAAAAAAABkAAAAAAAAAH9/fwAKAAAAIgAAABgAAAAAAAAAAAAAAAAAAAAAAAAAAAAAAAAAAAAkAAAAJAAAAAAAAAAHAAAAAAAAAAAAAAAAAAAAAAAAAAAAAAAAAAAAf39/ACUAAABYAAAAAAAAAAAAAAAAAAAAAAAAAAAAAAAAAAAAAAAAAAAAAAAAAAAAAAAAAAAAAAA/AAAAAAAAAKCGAQAAAAAAAAAAAAAAAAAMAAAAAQAAAAAAAAAAAAAAAAAAAB8AAABUAAAAAAAABQAAAAEAAAAAAAAAAAAAAAAAAAAAAAAAAAAAAAAAAAAAAAAAAAAAAAJ/f38AAAAAA8zMzADAwP8Af39/AAAAAAAAAAAAAAAAAAAAAAAAAAAAIQAAABgAAAAUAAAAwAMAAGENAADjJAAAsCUAABAAAAAmAAAACAAAAAGAAAAAAAAA"/>
+                <pr:smNativeData xmlns:pr="smNativeData" xmlns="smNativeData" val="SMDATA_15_MvzhaRMAAAAlAAAAZAAAAA8BAAAAkAAAAEgAAACQAAAASAAAAAAAAAAAAAAAAAAAAAEAAABQAAAAAAAAAAAA4D8AAAAAAADgPwAAAAAAAOA/AAAAAAAA4D8AAAAAAADgPwAAAAAAAOA/AAAAAAAA4D8AAAAAAADgPwAAAAAAAOA/AAAAAAAA4D8CAAAAjAAAAAAAAAAAAAAAu+DjDP///wgAAAAAAAAAAAAAAAAAAAAAAAAAAAAAAAAAAAAAZAAAAAEAAABAAAAAAAAAAAAAAAAAAAAAAAAAAAAAAAAAAAAAAAAAAAAAAAAAAAAAAAAAAAAAAAAAAAAAAAAAAAAAAAAAAAAAAAAAAAAAAAAAAAAAAAAAAAAAAAAAAAAAFAAAADwAAAAAAAAAAAAAAAAAAAkUAAAAAQAAABQAAAAUAAAAFAAAAAEAAAAAAAAAZAAAAGQAAAAAAAAAZAAAAGQAAAAVAAAAYAAAAAAAAAAAAAAADwAAACADAAAAAAAAAAAAAAEAAACgMgAAVgcAAKr4//8BAAAAf39/AAEAAABkAAAAAAAAABQAAABAHwAAAAAAACYAAAAAAAAAwOD//wAAAAAmAAAAZAAAABYAAABMAAAAAAAAAAAAAAAEAAAAAAAAAAEAAACAgIAKAAAAACgAAAAoAAAAZAAAAGQAAAAAAAAAzMzMAAAAAABQAAAAUAAAAGQAAABkAAAAAAAAABcAAAAUAAAAAAAAAAAAAAD/fwAA/38AAAAAAAAJAAAABAAAANw7IAEeAAAAaAAAAAAAAAAAAAAAAAAAAAAAAAAAAAAAECcAABAnAAAAAAAAAAAAAAAAAAAAAAAAAAAAAAAAAAAAAAAAAAAAABQAAAAAAAAAwMD/AAAAAABkAAAAMgAAAAAAAABkAAAAAAAAAH9/fwAKAAAAIgAAABgAAAAAAAAAAAAAAAAAAAAAAAAAAAAAAAAAAAAkAAAAJAAAAAAAAAAHAAAAAAAAAAAAAAAAAAAAAAAAAAAAAAAAAAAAf39/ACUAAABYAAAAAAAAAAAAAAAAAAAAAAAAAAAAAAAAAAAAAAAAAAAAAAAAAAAAAAAAAAAAAAA/AAAAAAAAAKCGAQAAAAAAAAAAAAAAAAAMAAAAAQAAAAAAAAAAAAAAAAAAAB8AAABUAAAAAAAABQAAAAEAAAAAAAAAAAAAAAAAAAAAAAAAAAAAAAAAAAAAAAAAAAAAAAJ/f38AAAAAA8zMzADAwP8Af39/AAAAAAAAAAAAAAAAAAAAAAAAAAAAIQAAABgAAAAUAAAAwAMAAGENAADjJAAAsCUAABAAAAAmAAAACAAAAAGAAAAAAAAA"/>
               </a:ext>
             </a:extLst>
           </p:cNvSpPr>
@@ -1701,7 +1701,7 @@
             <a:spLocks noGrp="1" noChangeArrowheads="1"/>
             <a:extLst>
               <a:ext uri="smNativeData">
-                <pr:smNativeData xmlns:pr="smNativeData" xmlns="smNativeData" val="SMDATA_15_ZqHWaRMAAAAlAAAAZAAAAA8BAAAAkAAAAEgAAACQAAAASAAAAAAAAAACAAAAAAAAAAEAAABQAAAAAAAAAAAA4D8AAAAAAADgPwAAAAAAAOA/AAAAAAAA4D8AAAAAAADgPwAAAAAAAOA/AAAAAAAA4D8AAAAAAADgPwAAAAAAAOA/AAAAAAAA4D8CAAAAjAAAAAAAAAAAAAAAu+DjDP///wgAAAAAAAAAAAAAAAAAAAAAAAAAAAAAAAAAAAAAZAAAAAEAAABAAAAAAAAAAAAAAAAAAAAAAAAAAAAAAAAAAAAAAAAAAAAAAAAAAAAAAAAAAAAAAAAAAAAAAAAAAAAAAAAAAAAAAAAAAAAAAAAAAAAAAAAAAAAAAAAAAAAAFAAAADwAAAAAAAAAAAAAAAAAAAkUAAAAAQAAABQAAAAUAAAAFAAAAAEAAAAAAAAAZAAAAGQAAAAAAAAAZAAAAGQAAAAVAAAAYAAAAAAAAAAAAAAADwAAACADAAAAAAAAAAAAAAEAAACgMgAAVgcAAKr4//8BAAAAf39/AAEAAABkAAAAAAAAABQAAABAHwAAAAAAACYAAAAAAAAAwOD//wAAAAAmAAAAZAAAABYAAABMAAAAAAAAAAAAAAAEAAAAAAAAAAEAAACAgIAKAAAAACgAAAAoAAAAZAAAAGQAAAAAAAAAzMzMAAAAAABQAAAAUAAAAGQAAABkAAAAAAAAABcAAAAUAAAAAAAAAAAAAAD/fwAA/38AAAAAAAAJAAAABAAAANw7IAEeAAAAaAAAAAAAAAAAAAAAAAAAAAAAAAAAAAAAECcAABAnAAAAAAAAAAAAAAAAAAAAAAAAAAAAAAAAAAAAAAAAAAAAABQAAAAAAAAAwMD/AAAAAABkAAAAMgAAAAAAAABkAAAAAAAAAH9/fwAKAAAAIgAAABgAAAAAAAAAAAAAAAAAAAAAAAAAAAAAAAAAAAAkAAAAJAAAAAAAAAAHAAAAAAAAAAAAAAAAAAAAAAAAAAAAAAAAAAAAf39/ACUAAABYAAAAAAAAAAAAAAAAAAAAAAAAAAAAAAAAAAAAAAAAAAAAAAAAAAAAAAAAAAAAAAA/AAAAAAAAAKCGAQAAAAAAAAAAAAAAAAAMAAAAAQAAAAAAAAAAAAAAAAAAAB8AAABUAAAAAAAABQAAAAEAAAAAAAAAAAAAAAAAAAAAAAAAAAAAAAAAAAAAAAAAAAAAAAJ/f38AAAAAA8zMzADAwP8Af39/AAAAAAAAAAAAAAAAAAAAAAAAAAAAIQAAABgAAAAUAAAAHSYAAHEJAABARwAAYQ0AABAAAAAmAAAACAAAAIGAAAAAAAAA"/>
+                <pr:smNativeData xmlns:pr="smNativeData" xmlns="smNativeData" val="SMDATA_15_MvzhaRMAAAAlAAAAZAAAAA8BAAAAkAAAAEgAAACQAAAASAAAAAAAAAACAAAAAAAAAAEAAABQAAAAAAAAAAAA4D8AAAAAAADgPwAAAAAAAOA/AAAAAAAA4D8AAAAAAADgPwAAAAAAAOA/AAAAAAAA4D8AAAAAAADgPwAAAAAAAOA/AAAAAAAA4D8CAAAAjAAAAAAAAAAAAAAAu+DjDP///wgAAAAAAAAAAAAAAAAAAAAAAAAAAAAAAAAAAAAAZAAAAAEAAABAAAAAAAAAAAAAAAAAAAAAAAAAAAAAAAAAAAAAAAAAAAAAAAAAAAAAAAAAAAAAAAAAAAAAAAAAAAAAAAAAAAAAAAAAAAAAAAAAAAAAAAAAAAAAAAAAAAAAFAAAADwAAAAAAAAAAAAAAAAAAAkUAAAAAQAAABQAAAAUAAAAFAAAAAEAAAAAAAAAZAAAAGQAAAAAAAAAZAAAAGQAAAAVAAAAYAAAAAAAAAAAAAAADwAAACADAAAAAAAAAAAAAAEAAACgMgAAVgcAAKr4//8BAAAAf39/AAEAAABkAAAAAAAAABQAAABAHwAAAAAAACYAAAAAAAAAwOD//wAAAAAmAAAAZAAAABYAAABMAAAAAAAAAAAAAAAEAAAAAAAAAAEAAACAgIAKAAAAACgAAAAoAAAAZAAAAGQAAAAAAAAAzMzMAAAAAABQAAAAUAAAAGQAAABkAAAAAAAAABcAAAAUAAAAAAAAAAAAAAD/fwAA/38AAAAAAAAJAAAABAAAANw7IAEeAAAAaAAAAAAAAAAAAAAAAAAAAAAAAAAAAAAAECcAABAnAAAAAAAAAAAAAAAAAAAAAAAAAAAAAAAAAAAAAAAAAAAAABQAAAAAAAAAwMD/AAAAAABkAAAAMgAAAAAAAABkAAAAAAAAAH9/fwAKAAAAIgAAABgAAAAAAAAAAAAAAAAAAAAAAAAAAAAAAAAAAAAkAAAAJAAAAAAAAAAHAAAAAAAAAAAAAAAAAAAAAAAAAAAAAAAAAAAAf39/ACUAAABYAAAAAAAAAAAAAAAAAAAAAAAAAAAAAAAAAAAAAAAAAAAAAAAAAAAAAAAAAAAAAAA/AAAAAAAAAKCGAQAAAAAAAAAAAAAAAAAMAAAAAQAAAAAAAAAAAAAAAAAAAB8AAABUAAAAAAAABQAAAAEAAAAAAAAAAAAAAAAAAAAAAAAAAAAAAAAAAAAAAAAAAAAAAAJ/f38AAAAAA8zMzADAwP8Af39/AAAAAAAAAAAAAAAAAAAAAAAAAAAAIQAAABgAAAAUAAAAHSYAAHEJAABARwAAYQ0AABAAAAAmAAAACAAAAIGAAAAAAAAA"/>
               </a:ext>
             </a:extLst>
           </p:cNvSpPr>
@@ -1774,7 +1774,7 @@
             <a:spLocks noGrp="1" noChangeArrowheads="1"/>
             <a:extLst>
               <a:ext uri="smNativeData">
-                <pr:smNativeData xmlns:pr="smNativeData" xmlns="smNativeData" val="SMDATA_15_ZqHWaRMAAAAlAAAAZAAAAA8BAAAAkAAAAEgAAACQAAAASAAAAAAAAAAAAAAAAAAAAAEAAABQAAAAAAAAAAAA4D8AAAAAAADgPwAAAAAAAOA/AAAAAAAA4D8AAAAAAADgPwAAAAAAAOA/AAAAAAAA4D8AAAAAAADgPwAAAAAAAOA/AAAAAAAA4D8CAAAAjAAAAAAAAAAAAAAAu+DjDP///wgAAAAAAAAAAAAAAAAAAAAAAAAAAAAAAAAAAAAAZAAAAAEAAABAAAAAAAAAAAAAAAAAAAAAAAAAAAAAAAAAAAAAAAAAAAAAAAAAAAAAAAAAAAAAAAAAAAAAAAAAAAAAAAAAAAAAAAAAAAAAAAAAAAAAAAAAAAAAAAAAAAAAFAAAADwAAAAAAAAAAAAAAAAAAAkUAAAAAQAAABQAAAAUAAAAFAAAAAEAAAAAAAAAZAAAAGQAAAAAAAAAZAAAAGQAAAAVAAAAYAAAAAAAAAAAAAAADwAAACADAAAAAAAAAAAAAAEAAACgMgAAVgcAAKr4//8BAAAAf39/AAEAAABkAAAAAAAAABQAAABAHwAAAAAAACYAAAAAAAAAwOD//wAAAAAmAAAAZAAAABYAAABMAAAAAAAAAAAAAAAEAAAAAAAAAAEAAACAgIAKAAAAACgAAAAoAAAAZAAAAGQAAAAAAAAAzMzMAAAAAABQAAAAUAAAAGQAAABkAAAAAAAAABcAAAAUAAAAAAAAAAAAAAD/fwAA/38AAAAAAAAJAAAABAAAANw7IAEeAAAAaAAAAAAAAAAAAAAAAAAAAAAAAAAAAAAAECcAABAnAAAAAAAAAAAAAAAAAAAAAAAAAAAAAAAAAAAAAAAAAAAAABQAAAAAAAAAwMD/AAAAAABkAAAAMgAAAAAAAABkAAAAAAAAAH9/fwAKAAAAIgAAABgAAAAAAAAAAAAAAAAAAAAAAAAAAAAAAAAAAAAkAAAAJAAAAAAAAAAHAAAAAAAAAAAAAAAAAAAAAAAAAAAAAAAAAAAAf39/ACUAAABYAAAAAAAAAAAAAAAAAAAAAAAAAAAAAAAAAAAAAAAAAAAAAAAAAAAAAAAAAAAAAAA/AAAAAAAAAKCGAQAAAAAAAAAAAAAAAAAMAAAAAQAAAAAAAAAAAAAAAAAAAB8AAABUAAAAAAAABQAAAAEAAAAAAAAAAAAAAAAAAAAAAAAAAAAAAAAAAAAAAAAAAAAAAAJ/f38AAAAAA8zMzADAwP8Af39/AAAAAAAAAAAAAAAAAAAAAAAAAAAAIQAAABgAAAAUAAAAHSYAAGENAABARwAAsCUAABAAAAAmAAAACAAAAAGAAAAAAAAA"/>
+                <pr:smNativeData xmlns:pr="smNativeData" xmlns="smNativeData" val="SMDATA_15_MvzhaRMAAAAlAAAAZAAAAA8BAAAAkAAAAEgAAACQAAAASAAAAAAAAAAAAAAAAAAAAAEAAABQAAAAAAAAAAAA4D8AAAAAAADgPwAAAAAAAOA/AAAAAAAA4D8AAAAAAADgPwAAAAAAAOA/AAAAAAAA4D8AAAAAAADgPwAAAAAAAOA/AAAAAAAA4D8CAAAAjAAAAAAAAAAAAAAAu+DjDP///wgAAAAAAAAAAAAAAAAAAAAAAAAAAAAAAAAAAAAAZAAAAAEAAABAAAAAAAAAAAAAAAAAAAAAAAAAAAAAAAAAAAAAAAAAAAAAAAAAAAAAAAAAAAAAAAAAAAAAAAAAAAAAAAAAAAAAAAAAAAAAAAAAAAAAAAAAAAAAAAAAAAAAFAAAADwAAAAAAAAAAAAAAAAAAAkUAAAAAQAAABQAAAAUAAAAFAAAAAEAAAAAAAAAZAAAAGQAAAAAAAAAZAAAAGQAAAAVAAAAYAAAAAAAAAAAAAAADwAAACADAAAAAAAAAAAAAAEAAACgMgAAVgcAAKr4//8BAAAAf39/AAEAAABkAAAAAAAAABQAAABAHwAAAAAAACYAAAAAAAAAwOD//wAAAAAmAAAAZAAAABYAAABMAAAAAAAAAAAAAAAEAAAAAAAAAAEAAACAgIAKAAAAACgAAAAoAAAAZAAAAGQAAAAAAAAAzMzMAAAAAABQAAAAUAAAAGQAAABkAAAAAAAAABcAAAAUAAAAAAAAAAAAAAD/fwAA/38AAAAAAAAJAAAABAAAANw7IAEeAAAAaAAAAAAAAAAAAAAAAAAAAAAAAAAAAAAAECcAABAnAAAAAAAAAAAAAAAAAAAAAAAAAAAAAAAAAAAAAAAAAAAAABQAAAAAAAAAwMD/AAAAAABkAAAAMgAAAAAAAABkAAAAAAAAAH9/fwAKAAAAIgAAABgAAAAAAAAAAAAAAAAAAAAAAAAAAAAAAAAAAAAkAAAAJAAAAAAAAAAHAAAAAAAAAAAAAAAAAAAAAAAAAAAAAAAAAAAAf39/ACUAAABYAAAAAAAAAAAAAAAAAAAAAAAAAAAAAAAAAAAAAAAAAAAAAAAAAAAAAAAAAAAAAAA/AAAAAAAAAKCGAQAAAAAAAAAAAAAAAAAMAAAAAQAAAAAAAAAAAAAAAAAAAB8AAABUAAAAAAAABQAAAAEAAAAAAAAAAAAAAAAAAAAAAAAAAAAAAAAAAAAAAAAAAAAAAAJ/f38AAAAAA8zMzADAwP8Af39/AAAAAAAAAAAAAAAAAAAAAAAAAAAAIQAAABgAAAAUAAAAHSYAAGENAABARwAAsCUAABAAAAAmAAAACAAAAAGAAAAAAAAA"/>
               </a:ext>
             </a:extLst>
           </p:cNvSpPr>
@@ -1858,7 +1858,7 @@
             <a:spLocks noGrp="1" noChangeArrowheads="1"/>
             <a:extLst>
               <a:ext uri="smNativeData">
-                <pr:smNativeData xmlns:pr="smNativeData" xmlns="smNativeData" val="SMDATA_15_ZqHWaRMAAAAlAAAAZAAAAA8BAAAAkAAAAEgAAACQAAAASAAAAAAAAAABAAAAAAAAAAEAAABQAAAAAAAAAAAA4D8AAAAAAADgPwAAAAAAAOA/AAAAAAAA4D8AAAAAAADgPwAAAAAAAOA/AAAAAAAA4D8AAAAAAADgPwAAAAAAAOA/AAAAAAAA4D8CAAAAjAAAAAAAAAAAAAAAu+DjDP///wgAAAAAAAAAAAAAAAAAAAAAAAAAAAAAAAAAAAAAZAAAAAEAAABAAAAAAAAAAAAAAAAAAAAAAAAAAAAAAAAAAAAAAAAAAAAAAAAAAAAAAAAAAAAAAAAAAAAAAAAAAAAAAAAAAAAAAAAAAAAAAAAAAAAAAAAAAAAAAAAAAAAAFAAAADwAAAAAAAAAAAAAAAAAAAkUAAAAAQAAABQAAAAUAAAAFAAAAAEAAAAAAAAAZAAAAGQAAAAAAAAAZAAAAGQAAAAVAAAAYAAAAAAAAAAAAAAADwAAACADAAAAAAAAAAAAAAEAAACgMgAAVgcAAKr4//8BAAAAf39/AAEAAABkAAAAAAAAABQAAABAHwAAAAAAACYAAAAAAAAAwOD//wAAAAAmAAAAZAAAABYAAABMAAAAAAAAAAAAAAAEAAAAAAAAAAEAAACAgIAKAAAAACgAAAAoAAAAZAAAAGQAAAAAAAAAzMzMAAAAAABQAAAAUAAAAGQAAABkAAAAAAAAABcAAAAUAAAAAAAAAAAAAAD/fwAA/38AAAAAAAAJAAAABAAAANw7IAEeAAAAaAAAAAAAAAAAAAAAAAAAAAAAAAAAAAAAECcAABAnAAAAAAAAAAAAAAAAAAAAAAAAAAAAAAAAAAAAAAAAAAAAABQAAAAAAAAAwMD/AAAAAABkAAAAMgAAAAAAAABkAAAAAAAAAH9/fwAKAAAAIgAAABgAAAAAAAAAAAAAAAAAAAAAAAAAAAAAAAAAAAAkAAAAJAAAAAAAAAAHAAAAAAAAAAAAAAAAAAAAAAAAAAAAAAAAAAAAf39/ACUAAABYAAAAAAAAAAAAAAAAAAAAAAAAAAAAAAAAAAAAAAAAAAAAAAAAAAAAAAAAAAAAAAA/AAAAAAAAAKCGAQAAAAAAAAAAAAAAAAAMAAAAAQAAAAAAAAAAAAAAAAAAAB8AAABUAAAAAAAABQAAAAEAAAAAAAAAAAAAAAAAAAAAAAAAAAAAAAAAAAAAAAAAAAAAAAJ/f38AAAAAA8zMzADAwP8Af39/AAAAAAAAAAAAAAAAAAAAAAAAAAAAIQAAABgAAAAUAAAAwAMAABsnAAA/FQAAWSkAABAAAAAmAAAACAAAAAAAAAAAAAAA"/>
+                <pr:smNativeData xmlns:pr="smNativeData" xmlns="smNativeData" val="SMDATA_15_MvzhaRMAAAAlAAAAZAAAAA8BAAAAkAAAAEgAAACQAAAASAAAAAAAAAABAAAAAAAAAAEAAABQAAAAAAAAAAAA4D8AAAAAAADgPwAAAAAAAOA/AAAAAAAA4D8AAAAAAADgPwAAAAAAAOA/AAAAAAAA4D8AAAAAAADgPwAAAAAAAOA/AAAAAAAA4D8CAAAAjAAAAAAAAAAAAAAAu+DjDP///wgAAAAAAAAAAAAAAAAAAAAAAAAAAAAAAAAAAAAAZAAAAAEAAABAAAAAAAAAAAAAAAAAAAAAAAAAAAAAAAAAAAAAAAAAAAAAAAAAAAAAAAAAAAAAAAAAAAAAAAAAAAAAAAAAAAAAAAAAAAAAAAAAAAAAAAAAAAAAAAAAAAAAFAAAADwAAAAAAAAAAAAAAAAAAAkUAAAAAQAAABQAAAAUAAAAFAAAAAEAAAAAAAAAZAAAAGQAAAAAAAAAZAAAAGQAAAAVAAAAYAAAAAAAAAAAAAAADwAAACADAAAAAAAAAAAAAAEAAACgMgAAVgcAAKr4//8BAAAAf39/AAEAAABkAAAAAAAAABQAAABAHwAAAAAAACYAAAAAAAAAwOD//wAAAAAmAAAAZAAAABYAAABMAAAAAAAAAAAAAAAEAAAAAAAAAAEAAACAgIAKAAAAACgAAAAoAAAAZAAAAGQAAAAAAAAAzMzMAAAAAABQAAAAUAAAAGQAAABkAAAAAAAAABcAAAAUAAAAAAAAAAAAAAD/fwAA/38AAAAAAAAJAAAABAAAANw7IAEeAAAAaAAAAAAAAAAAAAAAAAAAAAAAAAAAAAAAECcAABAnAAAAAAAAAAAAAAAAAAAAAAAAAAAAAAAAAAAAAAAAAAAAABQAAAAAAAAAwMD/AAAAAABkAAAAMgAAAAAAAABkAAAAAAAAAH9/fwAKAAAAIgAAABgAAAAAAAAAAAAAAAAAAAAAAAAAAAAAAAAAAAAkAAAAJAAAAAAAAAAHAAAAAAAAAAAAAAAAAAAAAAAAAAAAAAAAAAAAf39/ACUAAABYAAAAAAAAAAAAAAAAAAAAAAAAAAAAAAAAAAAAAAAAAAAAAAAAAAAAAAAAAAAAAAA/AAAAAAAAAKCGAQAAAAAAAAAAAAAAAAAMAAAAAQAAAAAAAAAAAAAAAAAAAB8AAABUAAAAAAAABQAAAAEAAAAAAAAAAAAAAAAAAAAAAAAAAAAAAAAAAAAAAAAAAAAAAAJ/f38AAAAAA8zMzADAwP8Af39/AAAAAAAAAAAAAAAAAAAAAAAAAAAAIQAAABgAAAAUAAAAwAMAABsnAAA/FQAAWSkAABAAAAAmAAAACAAAAAAAAAAAAAAA"/>
               </a:ext>
             </a:extLst>
           </p:cNvSpPr>
@@ -1872,7 +1872,7 @@
           <a:lstStyle/>
           <a:p>
             <a:pPr/>
-            <a:fld id="{6E3EAD50-1E83-6B5B-CD86-E80EE3C83BBD}" type="datetime1">
+            <a:fld id="{380835E5-ABD5-5DC3-9BB0-5D967BFE6D08}" type="datetime1">
               <a:t/>
             </a:fld>
           </a:p>
@@ -1885,7 +1885,7 @@
             <a:spLocks noGrp="1" noChangeArrowheads="1"/>
             <a:extLst>
               <a:ext uri="smNativeData">
-                <pr:smNativeData xmlns:pr="smNativeData" xmlns="smNativeData" val="SMDATA_15_ZqHWaRMAAAAlAAAAZAAAAA8BAAAAkAAAAEgAAACQAAAASAAAAAAAAAABAAAAAAAAAAEAAABQAAAAAAAAAAAA4D8AAAAAAADgPwAAAAAAAOA/AAAAAAAA4D8AAAAAAADgPwAAAAAAAOA/AAAAAAAA4D8AAAAAAADgPwAAAAAAAOA/AAAAAAAA4D8CAAAAjAAAAAAAAAAAAAAAu+DjDP///wgAAAAAAAAAAAAAAAAAAAAAAAAAAAAAAAAAAAAAZAAAAAEAAABAAAAAAAAAAAAAAAAAAAAAAAAAAAAAAAAAAAAAAAAAAAAAAAAAAAAAAAAAAAAAAAAAAAAAAAAAAAAAAAAAAAAAAAAAAAAAAAAAAAAAAAAAAAAAAAAAAAAAFAAAADwAAAAAAAAAAAAAAAAAAAkUAAAAAQAAABQAAAAUAAAAFAAAAAEAAAAAAAAAZAAAAGQAAAAAAAAAZAAAAGQAAAAVAAAAYAAAAAAAAAAAAAAADwAAACADAAAAAAAAAAAAAAEAAACgMgAAVgcAAKr4//8BAAAAf39/AAEAAABkAAAAAAAAABQAAABAHwAAAAAAACYAAAAAAAAAwOD//wAAAAAmAAAAZAAAABYAAABMAAAAAAAAAAAAAAAEAAAAAAAAAAEAAACAgIAKAAAAACgAAAAoAAAAZAAAAGQAAAAAAAAAzMzMAAAAAABQAAAAUAAAAGQAAABkAAAAAAAAABcAAAAUAAAAAAAAAAAAAAD/fwAA/38AAAAAAAAJAAAABAAAANw7IAEeAAAAaAAAAAAAAAAAAAAAAAAAAAAAAAAAAAAAECcAABAnAAAAAAAAAAAAAAAAAAAAAAAAAAAAAAAAAAAAAAAAAAAAABQAAAAAAAAAwMD/AAAAAABkAAAAMgAAAAAAAABkAAAAAAAAAH9/fwAKAAAAIgAAABgAAAAAAAAAAAAAAAAAAAAAAAAAAAAAAAAAAAAkAAAAJAAAAAAAAAAHAAAAAAAAAAAAAAAAAAAAAAAAAAAAAAAAAAAAf39/ACUAAABYAAAAAAAAAAAAAAAAAAAAAAAAAAAAAAAAAAAAAAAAAAAAAAAAAAAAAAAAAAAAAAA/AAAAAAAAAKCGAQAAAAAAAAAAAAAAAAAMAAAAAQAAAAAAAAAAAAAAAAAAAB8AAABUAAAAAAAABQAAAAEAAAAAAAAAAAAAAAAAAAAAAAAAAAAAAAAAAAAAAAAAAAAAAAJ/f38AAAAAA8zMzADAwP8Af39/AAAAAAAAAAAAAAAAAAAAAAAAAAAAIQAAABgAAAAUAAAAoRkAABsnAABfMQAAWSkAABAAAAAmAAAACAAAAAAAAAAAAAAA"/>
+                <pr:smNativeData xmlns:pr="smNativeData" xmlns="smNativeData" val="SMDATA_15_MvzhaRMAAAAlAAAAZAAAAA8BAAAAkAAAAEgAAACQAAAASAAAAAAAAAABAAAAAAAAAAEAAABQAAAAAAAAAAAA4D8AAAAAAADgPwAAAAAAAOA/AAAAAAAA4D8AAAAAAADgPwAAAAAAAOA/AAAAAAAA4D8AAAAAAADgPwAAAAAAAOA/AAAAAAAA4D8CAAAAjAAAAAAAAAAAAAAAu+DjDP///wgAAAAAAAAAAAAAAAAAAAAAAAAAAAAAAAAAAAAAZAAAAAEAAABAAAAAAAAAAAAAAAAAAAAAAAAAAAAAAAAAAAAAAAAAAAAAAAAAAAAAAAAAAAAAAAAAAAAAAAAAAAAAAAAAAAAAAAAAAAAAAAAAAAAAAAAAAAAAAAAAAAAAFAAAADwAAAAAAAAAAAAAAAAAAAkUAAAAAQAAABQAAAAUAAAAFAAAAAEAAAAAAAAAZAAAAGQAAAAAAAAAZAAAAGQAAAAVAAAAYAAAAAAAAAAAAAAADwAAACADAAAAAAAAAAAAAAEAAACgMgAAVgcAAKr4//8BAAAAf39/AAEAAABkAAAAAAAAABQAAABAHwAAAAAAACYAAAAAAAAAwOD//wAAAAAmAAAAZAAAABYAAABMAAAAAAAAAAAAAAAEAAAAAAAAAAEAAACAgIAKAAAAACgAAAAoAAAAZAAAAGQAAAAAAAAAzMzMAAAAAABQAAAAUAAAAGQAAABkAAAAAAAAABcAAAAUAAAAAAAAAAAAAAD/fwAA/38AAAAAAAAJAAAABAAAANw7IAEeAAAAaAAAAAAAAAAAAAAAAAAAAAAAAAAAAAAAECcAABAnAAAAAAAAAAAAAAAAAAAAAAAAAAAAAAAAAAAAAAAAAAAAABQAAAAAAAAAwMD/AAAAAABkAAAAMgAAAAAAAABkAAAAAAAAAH9/fwAKAAAAIgAAABgAAAAAAAAAAAAAAAAAAAAAAAAAAAAAAAAAAAAkAAAAJAAAAAAAAAAHAAAAAAAAAAAAAAAAAAAAAAAAAAAAAAAAAAAAf39/ACUAAABYAAAAAAAAAAAAAAAAAAAAAAAAAAAAAAAAAAAAAAAAAAAAAAAAAAAAAAAAAAAAAAA/AAAAAAAAAKCGAQAAAAAAAAAAAAAAAAAMAAAAAQAAAAAAAAAAAAAAAAAAAB8AAABUAAAAAAAABQAAAAEAAAAAAAAAAAAAAAAAAAAAAAAAAAAAAAAAAAAAAAAAAAAAAAJ/f38AAAAAA8zMzADAwP8Af39/AAAAAAAAAAAAAAAAAAAAAAAAAAAAIQAAABgAAAAUAAAAoRkAABsnAABfMQAAWSkAABAAAAAmAAAACAAAAAAAAAAAAAAA"/>
               </a:ext>
             </a:extLst>
           </p:cNvSpPr>
@@ -1909,7 +1909,7 @@
             <a:spLocks noGrp="1" noChangeArrowheads="1"/>
             <a:extLst>
               <a:ext uri="smNativeData">
-                <pr:smNativeData xmlns:pr="smNativeData" xmlns="smNativeData" val="SMDATA_15_ZqHWaRMAAAAlAAAAZAAAAA8BAAAAkAAAAEgAAACQAAAASAAAAAAAAAABAAAAAAAAAAEAAABQAAAAAAAAAAAA4D8AAAAAAADgPwAAAAAAAOA/AAAAAAAA4D8AAAAAAADgPwAAAAAAAOA/AAAAAAAA4D8AAAAAAADgPwAAAAAAAOA/AAAAAAAA4D8CAAAAjAAAAAAAAAAAAAAAu+DjDP///wgAAAAAAAAAAAAAAAAAAAAAAAAAAAAAAAAAAAAAZAAAAAEAAABAAAAAAAAAAAAAAAAAAAAAAAAAAAAAAAAAAAAAAAAAAAAAAAAAAAAAAAAAAAAAAAAAAAAAAAAAAAAAAAAAAAAAAAAAAAAAAAAAAAAAAAAAAAAAAAAAAAAAFAAAADwAAAAAAAAAAAAAAAAAAAkUAAAAAQAAABQAAAAUAAAAFAAAAAEAAAAAAAAAZAAAAGQAAAAAAAAAZAAAAGQAAAAVAAAAYAAAAAAAAAAAAAAADwAAACADAAAAAAAAAAAAAAEAAACgMgAAVgcAAKr4//8BAAAAf39/AAEAAABkAAAAAAAAABQAAABAHwAAAAAAACYAAAAAAAAAwOD//wAAAAAmAAAAZAAAABYAAABMAAAAAAAAAAAAAAAEAAAAAAAAAAEAAACAgIAKAAAAACgAAAAoAAAAZAAAAGQAAAAAAAAAzMzMAAAAAABQAAAAUAAAAGQAAABkAAAAAAAAABcAAAAUAAAAAAAAAAAAAAD/fwAA/38AAAAAAAAJAAAABAAAANw7IAEeAAAAaAAAAAAAAAAAAAAAAAAAAAAAAAAAAAAAECcAABAnAAAAAAAAAAAAAAAAAAAAAAAAAAAAAAAAAAAAAAAAAAAAABQAAAAAAAAAwMD/AAAAAABkAAAAMgAAAAAAAABkAAAAAAAAAH9/fwAKAAAAIgAAABgAAAAAAAAAAAAAAAAAAAAAAAAAAAAAAAAAAAAkAAAAJAAAAAAAAAAHAAAAAAAAAAAAAAAAAAAAAAAAAAAAAAAAAAAAf39/ACUAAABYAAAAAAAAAAAAAAAAAAAAAAAAAAAAAAAAAAAAAAAAAAAAAAAAAAAAAAAAAAAAAAA/AAAAAAAAAKCGAQAAAAAAAAAAAAAAAAAMAAAAAQAAAAAAAAAAAAAAAAAAAB8AAABUAAAAAAAABQAAAAEAAAAAAAAAAAAAAAAAAAAAAAAAAAAAAAAAAAAAAAAAAAAAAAJ/f38AAAAAA8zMzADAwP8Af39/AAAAAAAAAAAAAAAAAAAAAAAAAAAAIQAAABgAAAAUAAAAwTUAABsnAABARwAAWSkAABAAAAAmAAAACAAAAAAAAAAAAAAA"/>
+                <pr:smNativeData xmlns:pr="smNativeData" xmlns="smNativeData" val="SMDATA_15_MvzhaRMAAAAlAAAAZAAAAA8BAAAAkAAAAEgAAACQAAAASAAAAAAAAAABAAAAAAAAAAEAAABQAAAAAAAAAAAA4D8AAAAAAADgPwAAAAAAAOA/AAAAAAAA4D8AAAAAAADgPwAAAAAAAOA/AAAAAAAA4D8AAAAAAADgPwAAAAAAAOA/AAAAAAAA4D8CAAAAjAAAAAAAAAAAAAAAu+DjDP///wgAAAAAAAAAAAAAAAAAAAAAAAAAAAAAAAAAAAAAZAAAAAEAAABAAAAAAAAAAAAAAAAAAAAAAAAAAAAAAAAAAAAAAAAAAAAAAAAAAAAAAAAAAAAAAAAAAAAAAAAAAAAAAAAAAAAAAAAAAAAAAAAAAAAAAAAAAAAAAAAAAAAAFAAAADwAAAAAAAAAAAAAAAAAAAkUAAAAAQAAABQAAAAUAAAAFAAAAAEAAAAAAAAAZAAAAGQAAAAAAAAAZAAAAGQAAAAVAAAAYAAAAAAAAAAAAAAADwAAACADAAAAAAAAAAAAAAEAAACgMgAAVgcAAKr4//8BAAAAf39/AAEAAABkAAAAAAAAABQAAABAHwAAAAAAACYAAAAAAAAAwOD//wAAAAAmAAAAZAAAABYAAABMAAAAAAAAAAAAAAAEAAAAAAAAAAEAAACAgIAKAAAAACgAAAAoAAAAZAAAAGQAAAAAAAAAzMzMAAAAAABQAAAAUAAAAGQAAABkAAAAAAAAABcAAAAUAAAAAAAAAAAAAAD/fwAA/38AAAAAAAAJAAAABAAAANw7IAEeAAAAaAAAAAAAAAAAAAAAAAAAAAAAAAAAAAAAECcAABAnAAAAAAAAAAAAAAAAAAAAAAAAAAAAAAAAAAAAAAAAAAAAABQAAAAAAAAAwMD/AAAAAABkAAAAMgAAAAAAAABkAAAAAAAAAH9/fwAKAAAAIgAAABgAAAAAAAAAAAAAAAAAAAAAAAAAAAAAAAAAAAAkAAAAJAAAAAAAAAAHAAAAAAAAAAAAAAAAAAAAAAAAAAAAAAAAAAAAf39/ACUAAABYAAAAAAAAAAAAAAAAAAAAAAAAAAAAAAAAAAAAAAAAAAAAAAAAAAAAAAAAAAAAAAA/AAAAAAAAAKCGAQAAAAAAAAAAAAAAAAAMAAAAAQAAAAAAAAAAAAAAAAAAAB8AAABUAAAAAAAABQAAAAEAAAAAAAAAAAAAAAAAAAAAAAAAAAAAAAAAAAAAAAAAAAAAAAJ/f38AAAAAA8zMzADAwP8Af39/AAAAAAAAAAAAAAAAAAAAAAAAAAAAIQAAABgAAAAUAAAAwTUAABsnAABARwAAWSkAABAAAAAmAAAACAAAAAAAAAAAAAAA"/>
               </a:ext>
             </a:extLst>
           </p:cNvSpPr>
@@ -1923,7 +1923,7 @@
           <a:lstStyle/>
           <a:p>
             <a:pPr/>
-            <a:fld id="{22AFEE02-4CCF-FA18-8117-BA4DA05977EF}" type="slidenum">
+            <a:fld id="{027E97C5-8BEF-2B61-A1C6-7D34D9885728}" type="slidenum">
               <a:t/>
             </a:fld>
           </a:p>
@@ -1962,7 +1962,7 @@
             <a:spLocks noGrp="1" noChangeArrowheads="1"/>
             <a:extLst>
               <a:ext uri="smNativeData">
-                <pr:smNativeData xmlns:pr="smNativeData" xmlns="smNativeData" val="SMDATA_15_ZqHWaRMAAAAlAAAAZAAAAA8BAAAAkAAAAEgAAACQAAAASAAAAAAAAAABAAAAAAAAAAEAAABQAAAAAAAAAAAA4D8AAAAAAADgPwAAAAAAAOA/AAAAAAAA4D8AAAAAAADgPwAAAAAAAOA/AAAAAAAA4D8AAAAAAADgPwAAAAAAAOA/AAAAAAAA4D8CAAAAjAAAAAAAAAAAAAAAu+DjDP///wgAAAAAAAAAAAAAAAAAAAAAAAAAAAAAAAAAAAAAZAAAAAEAAABAAAAAAAAAAAAAAAAAAAAAAAAAAAAAAAAAAAAAAAAAAAAAAAAAAAAAAAAAAAAAAAAAAAAAAAAAAAAAAAAAAAAAAAAAAAAAAAAAAAAAAAAAAAAAAAAAAAAAFAAAADwAAAAAAAAAAAAAAAAAAAkUAAAAAQAAABQAAAAUAAAAFAAAAAEAAAAAAAAAZAAAAGQAAAAAAAAAZAAAAGQAAAAVAAAAYAAAAAAAAAAAAAAADwAAACADAAAAAAAAAAAAAAEAAACgMgAAVgcAAKr4//8BAAAAf39/AAEAAABkAAAAAAAAABQAAABAHwAAAAAAACYAAAAAAAAAwOD//wAAAAAmAAAAZAAAABYAAABMAAAAAAAAAAAAAAAEAAAAAAAAAAEAAACAgIAKAAAAACgAAAAoAAAAZAAAAGQAAAAAAAAAzMzMAAAAAABQAAAAUAAAAGQAAABkAAAAAAAAABcAAAAUAAAAAAAAAAAAAAD/fwAA/38AAAAAAAAJAAAABAAAANw7IAEeAAAAaAAAAAAAAAAAAAAAAAAAAAAAAAAAAAAAECcAABAnAAAAAAAAAAAAAAAAAAAAAAAAAAAAAAAAAAAAAAAAAAAAABQAAAAAAAAAwMD/AAAAAABkAAAAMgAAAAAAAABkAAAAAAAAAH9/fwAKAAAAIgAAABgAAAAAAAAAAAAAAAAAAAAAAAAAAAAAAAAAAAAkAAAAJAAAAAAAAAAHAAAAAAAAAAAAAAAAAAAAAAAAAAAAAAAAAAAAf39/ACUAAABYAAAAAAAAAAAAAAAAAAAAAAAAAAAAAAAAAAAAAAAAAAAAAAAAAAAAAAAAAAAAAAA/AAAAAAAAAKCGAQAAAAAAAAAAAAAAAAAMAAAAAQAAAAAAAAAAAAAAAAAAAB8AAABUAAAAAAAABQAAAAEAAAAAAAAAAAAAAAAAAAAAAAAAAAAAAAAAAAAAAAAAAAAAAAJ/f38AAAAAA8zMzADAwP8Af39/AAAAAAAAAAAAAAAAAAAAAAAAAAAAIQAAABgAAAAUAAAAwAMAALABAABARwAAuAgAABAAAAAmAAAACAAAAAAAAAAAAAAA"/>
+                <pr:smNativeData xmlns:pr="smNativeData" xmlns="smNativeData" val="SMDATA_15_MvzhaRMAAAAlAAAAZAAAAA8BAAAAkAAAAEgAAACQAAAASAAAAAAAAAABAAAAAAAAAAEAAABQAAAAAAAAAAAA4D8AAAAAAADgPwAAAAAAAOA/AAAAAAAA4D8AAAAAAADgPwAAAAAAAOA/AAAAAAAA4D8AAAAAAADgPwAAAAAAAOA/AAAAAAAA4D8CAAAAjAAAAAAAAAAAAAAAu+DjDP///wgAAAAAAAAAAAAAAAAAAAAAAAAAAAAAAAAAAAAAZAAAAAEAAABAAAAAAAAAAAAAAAAAAAAAAAAAAAAAAAAAAAAAAAAAAAAAAAAAAAAAAAAAAAAAAAAAAAAAAAAAAAAAAAAAAAAAAAAAAAAAAAAAAAAAAAAAAAAAAAAAAAAAFAAAADwAAAAAAAAAAAAAAAAAAAkUAAAAAQAAABQAAAAUAAAAFAAAAAEAAAAAAAAAZAAAAGQAAAAAAAAAZAAAAGQAAAAVAAAAYAAAAAAAAAAAAAAADwAAACADAAAAAAAAAAAAAAEAAACgMgAAVgcAAKr4//8BAAAAf39/AAEAAABkAAAAAAAAABQAAABAHwAAAAAAACYAAAAAAAAAwOD//wAAAAAmAAAAZAAAABYAAABMAAAAAAAAAAAAAAAEAAAAAAAAAAEAAACAgIAKAAAAACgAAAAoAAAAZAAAAGQAAAAAAAAAzMzMAAAAAABQAAAAUAAAAGQAAABkAAAAAAAAABcAAAAUAAAAAAAAAAAAAAD/fwAA/38AAAAAAAAJAAAABAAAANw7IAEeAAAAaAAAAAAAAAAAAAAAAAAAAAAAAAAAAAAAECcAABAnAAAAAAAAAAAAAAAAAAAAAAAAAAAAAAAAAAAAAAAAAAAAABQAAAAAAAAAwMD/AAAAAABkAAAAMgAAAAAAAABkAAAAAAAAAH9/fwAKAAAAIgAAABgAAAAAAAAAAAAAAAAAAAAAAAAAAAAAAAAAAAAkAAAAJAAAAAAAAAAHAAAAAAAAAAAAAAAAAAAAAAAAAAAAAAAAAAAAf39/ACUAAABYAAAAAAAAAAAAAAAAAAAAAAAAAAAAAAAAAAAAAAAAAAAAAAAAAAAAAAAAAAAAAAA/AAAAAAAAAKCGAQAAAAAAAAAAAAAAAAAMAAAAAQAAAAAAAAAAAAAAAAAAAB8AAABUAAAAAAAABQAAAAEAAAAAAAAAAAAAAAAAAAAAAAAAAAAAAAAAAAAAAAAAAAAAAAJ/f38AAAAAA8zMzADAwP8Af39/AAAAAAAAAAAAAAAAAAAAAAAAAAAAIQAAABgAAAAUAAAAwAMAALABAABARwAAuAgAABAAAAAmAAAACAAAAAAAAAAAAAAA"/>
               </a:ext>
             </a:extLst>
           </p:cNvSpPr>
@@ -1989,7 +1989,7 @@
             <a:spLocks noGrp="1" noChangeArrowheads="1"/>
             <a:extLst>
               <a:ext uri="smNativeData">
-                <pr:smNativeData xmlns:pr="smNativeData" xmlns="smNativeData" val="SMDATA_15_ZqHWaRMAAAAlAAAAZAAAAA8BAAAAkAAAAEgAAACQAAAASAAAAAAAAAABAAAAAAAAAAEAAABQAAAAAAAAAAAA4D8AAAAAAADgPwAAAAAAAOA/AAAAAAAA4D8AAAAAAADgPwAAAAAAAOA/AAAAAAAA4D8AAAAAAADgPwAAAAAAAOA/AAAAAAAA4D8CAAAAjAAAAAAAAAAAAAAAu+DjDP///wgAAAAAAAAAAAAAAAAAAAAAAAAAAAAAAAAAAAAAZAAAAAEAAABAAAAAAAAAAAAAAAAAAAAAAAAAAAAAAAAAAAAAAAAAAAAAAAAAAAAAAAAAAAAAAAAAAAAAAAAAAAAAAAAAAAAAAAAAAAAAAAAAAAAAAAAAAAAAAAAAAAAAFAAAADwAAAAAAAAAAAAAAAAAAAkUAAAAAQAAABQAAAAUAAAAFAAAAAEAAAAAAAAAZAAAAGQAAAAAAAAAZAAAAGQAAAAVAAAAYAAAAAAAAAAAAAAADwAAACADAAAAAAAAAAAAAAEAAACgMgAAVgcAAKr4//8BAAAAf39/AAEAAABkAAAAAAAAABQAAABAHwAAAAAAACYAAAAAAAAAwOD//wAAAAAmAAAAZAAAABYAAABMAAAAAAAAAAAAAAAEAAAAAAAAAAEAAACAgIAKAAAAACgAAAAoAAAAZAAAAGQAAAAAAAAAzMzMAAAAAABQAAAAUAAAAGQAAABkAAAAAAAAABcAAAAUAAAAAAAAAAAAAAD/fwAA/38AAAAAAAAJAAAABAAAANw7IAEeAAAAaAAAAAAAAAAAAAAAAAAAAAAAAAAAAAAAECcAABAnAAAAAAAAAAAAAAAAAAAAAAAAAAAAAAAAAAAAAAAAAAAAABQAAAAAAAAAwMD/AAAAAABkAAAAMgAAAAAAAABkAAAAAAAAAH9/fwAKAAAAIgAAABgAAAAAAAAAAAAAAAAAAAAAAAAAAAAAAAAAAAAkAAAAJAAAAAAAAAAHAAAAAAAAAAAAAAAAAAAAAAAAAAAAAAAAAAAAf39/ACUAAABYAAAAAAAAAAAAAAAAAAAAAAAAAAAAAAAAAAAAAAAAAAAAAAAAAAAAAAAAAAAAAAA/AAAAAAAAAKCGAQAAAAAAAAAAAAAAAAAMAAAAAQAAAAAAAAAAAAAAAAAAAB8AAABUAAAAAAAABQAAAAEAAAAAAAAAAAAAAAAAAAAAAAAAAAAAAAAAAAAAAAAAAAAAAAJ/f38AAAAAA8zMzADAwP8Af39/AAAAAAAAAAAAAAAAAAAAAAAAAAAAIQAAABgAAAAUAAAAwAMAABsnAAA/FQAAWSkAABAAAAAmAAAACAAAAAAAAAAAAAAA"/>
+                <pr:smNativeData xmlns:pr="smNativeData" xmlns="smNativeData" val="SMDATA_15_MvzhaRMAAAAlAAAAZAAAAA8BAAAAkAAAAEgAAACQAAAASAAAAAAAAAABAAAAAAAAAAEAAABQAAAAAAAAAAAA4D8AAAAAAADgPwAAAAAAAOA/AAAAAAAA4D8AAAAAAADgPwAAAAAAAOA/AAAAAAAA4D8AAAAAAADgPwAAAAAAAOA/AAAAAAAA4D8CAAAAjAAAAAAAAAAAAAAAu+DjDP///wgAAAAAAAAAAAAAAAAAAAAAAAAAAAAAAAAAAAAAZAAAAAEAAABAAAAAAAAAAAAAAAAAAAAAAAAAAAAAAAAAAAAAAAAAAAAAAAAAAAAAAAAAAAAAAAAAAAAAAAAAAAAAAAAAAAAAAAAAAAAAAAAAAAAAAAAAAAAAAAAAAAAAFAAAADwAAAAAAAAAAAAAAAAAAAkUAAAAAQAAABQAAAAUAAAAFAAAAAEAAAAAAAAAZAAAAGQAAAAAAAAAZAAAAGQAAAAVAAAAYAAAAAAAAAAAAAAADwAAACADAAAAAAAAAAAAAAEAAACgMgAAVgcAAKr4//8BAAAAf39/AAEAAABkAAAAAAAAABQAAABAHwAAAAAAACYAAAAAAAAAwOD//wAAAAAmAAAAZAAAABYAAABMAAAAAAAAAAAAAAAEAAAAAAAAAAEAAACAgIAKAAAAACgAAAAoAAAAZAAAAGQAAAAAAAAAzMzMAAAAAABQAAAAUAAAAGQAAABkAAAAAAAAABcAAAAUAAAAAAAAAAAAAAD/fwAA/38AAAAAAAAJAAAABAAAANw7IAEeAAAAaAAAAAAAAAAAAAAAAAAAAAAAAAAAAAAAECcAABAnAAAAAAAAAAAAAAAAAAAAAAAAAAAAAAAAAAAAAAAAAAAAABQAAAAAAAAAwMD/AAAAAABkAAAAMgAAAAAAAABkAAAAAAAAAH9/fwAKAAAAIgAAABgAAAAAAAAAAAAAAAAAAAAAAAAAAAAAAAAAAAAkAAAAJAAAAAAAAAAHAAAAAAAAAAAAAAAAAAAAAAAAAAAAAAAAAAAAf39/ACUAAABYAAAAAAAAAAAAAAAAAAAAAAAAAAAAAAAAAAAAAAAAAAAAAAAAAAAAAAAAAAAAAAA/AAAAAAAAAKCGAQAAAAAAAAAAAAAAAAAMAAAAAQAAAAAAAAAAAAAAAAAAAB8AAABUAAAAAAAABQAAAAEAAAAAAAAAAAAAAAAAAAAAAAAAAAAAAAAAAAAAAAAAAAAAAAJ/f38AAAAAA8zMzADAwP8Af39/AAAAAAAAAAAAAAAAAAAAAAAAAAAAIQAAABgAAAAUAAAAwAMAABsnAAA/FQAAWSkAABAAAAAmAAAACAAAAAAAAAAAAAAA"/>
               </a:ext>
             </a:extLst>
           </p:cNvSpPr>
@@ -2003,7 +2003,7 @@
           <a:lstStyle/>
           <a:p>
             <a:pPr/>
-            <a:fld id="{51D4160F-41BC-81E0-F26C-B7B5582204E2}" type="datetime1">
+            <a:fld id="{6BEDC688-C686-B830-C855-3065881B3E65}" type="datetime1">
               <a:t/>
             </a:fld>
           </a:p>
@@ -2016,7 +2016,7 @@
             <a:spLocks noGrp="1" noChangeArrowheads="1"/>
             <a:extLst>
               <a:ext uri="smNativeData">
-                <pr:smNativeData xmlns:pr="smNativeData" xmlns="smNativeData" val="SMDATA_15_ZqHWaRMAAAAlAAAAZAAAAA8BAAAAkAAAAEgAAACQAAAASAAAAAAAAAABAAAAAAAAAAEAAABQAAAAAAAAAAAA4D8AAAAAAADgPwAAAAAAAOA/AAAAAAAA4D8AAAAAAADgPwAAAAAAAOA/AAAAAAAA4D8AAAAAAADgPwAAAAAAAOA/AAAAAAAA4D8CAAAAjAAAAAAAAAAAAAAAu+DjDP///wgAAAAAAAAAAAAAAAAAAAAAAAAAAAAAAAAAAAAAZAAAAAEAAABAAAAAAAAAAAAAAAAAAAAAAAAAAAAAAAAAAAAAAAAAAAAAAAAAAAAAAAAAAAAAAAAAAAAAAAAAAAAAAAAAAAAAAAAAAAAAAAAAAAAAAAAAAAAAAAAAAAAAFAAAADwAAAAAAAAAAAAAAAAAAAkUAAAAAQAAABQAAAAUAAAAFAAAAAEAAAAAAAAAZAAAAGQAAAAAAAAAZAAAAGQAAAAVAAAAYAAAAAAAAAAAAAAADwAAACADAAAAAAAAAAAAAAEAAACgMgAAVgcAAKr4//8BAAAAf39/AAEAAABkAAAAAAAAABQAAABAHwAAAAAAACYAAAAAAAAAwOD//wAAAAAmAAAAZAAAABYAAABMAAAAAAAAAAAAAAAEAAAAAAAAAAEAAACAgIAKAAAAACgAAAAoAAAAZAAAAGQAAAAAAAAAzMzMAAAAAABQAAAAUAAAAGQAAABkAAAAAAAAABcAAAAUAAAAAAAAAAAAAAD/fwAA/38AAAAAAAAJAAAABAAAANw7IAEeAAAAaAAAAAAAAAAAAAAAAAAAAAAAAAAAAAAAECcAABAnAAAAAAAAAAAAAAAAAAAAAAAAAAAAAAAAAAAAAAAAAAAAABQAAAAAAAAAwMD/AAAAAABkAAAAMgAAAAAAAABkAAAAAAAAAH9/fwAKAAAAIgAAABgAAAAAAAAAAAAAAAAAAAAAAAAAAAAAAAAAAAAkAAAAJAAAAAAAAAAHAAAAAAAAAAAAAAAAAAAAAAAAAAAAAAAAAAAAf39/ACUAAABYAAAAAAAAAAAAAAAAAAAAAAAAAAAAAAAAAAAAAAAAAAAAAAAAAAAAAAAAAAAAAAA/AAAAAAAAAKCGAQAAAAAAAAAAAAAAAAAMAAAAAQAAAAAAAAAAAAAAAAAAAB8AAABUAAAAAAAABQAAAAEAAAAAAAAAAAAAAAAAAAAAAAAAAAAAAAAAAAAAAAAAAAAAAAJ/f38AAAAAA8zMzADAwP8Af39/AAAAAAAAAAAAAAAAAAAAAAAAAAAAIQAAABgAAAAUAAAAoRkAABsnAABfMQAAWSkAABAAAAAmAAAACAAAAAAAAAAAAAAA"/>
+                <pr:smNativeData xmlns:pr="smNativeData" xmlns="smNativeData" val="SMDATA_15_MvzhaRMAAAAlAAAAZAAAAA8BAAAAkAAAAEgAAACQAAAASAAAAAAAAAABAAAAAAAAAAEAAABQAAAAAAAAAAAA4D8AAAAAAADgPwAAAAAAAOA/AAAAAAAA4D8AAAAAAADgPwAAAAAAAOA/AAAAAAAA4D8AAAAAAADgPwAAAAAAAOA/AAAAAAAA4D8CAAAAjAAAAAAAAAAAAAAAu+DjDP///wgAAAAAAAAAAAAAAAAAAAAAAAAAAAAAAAAAAAAAZAAAAAEAAABAAAAAAAAAAAAAAAAAAAAAAAAAAAAAAAAAAAAAAAAAAAAAAAAAAAAAAAAAAAAAAAAAAAAAAAAAAAAAAAAAAAAAAAAAAAAAAAAAAAAAAAAAAAAAAAAAAAAAFAAAADwAAAAAAAAAAAAAAAAAAAkUAAAAAQAAABQAAAAUAAAAFAAAAAEAAAAAAAAAZAAAAGQAAAAAAAAAZAAAAGQAAAAVAAAAYAAAAAAAAAAAAAAADwAAACADAAAAAAAAAAAAAAEAAACgMgAAVgcAAKr4//8BAAAAf39/AAEAAABkAAAAAAAAABQAAABAHwAAAAAAACYAAAAAAAAAwOD//wAAAAAmAAAAZAAAABYAAABMAAAAAAAAAAAAAAAEAAAAAAAAAAEAAACAgIAKAAAAACgAAAAoAAAAZAAAAGQAAAAAAAAAzMzMAAAAAABQAAAAUAAAAGQAAABkAAAAAAAAABcAAAAUAAAAAAAAAAAAAAD/fwAA/38AAAAAAAAJAAAABAAAANw7IAEeAAAAaAAAAAAAAAAAAAAAAAAAAAAAAAAAAAAAECcAABAnAAAAAAAAAAAAAAAAAAAAAAAAAAAAAAAAAAAAAAAAAAAAABQAAAAAAAAAwMD/AAAAAABkAAAAMgAAAAAAAABkAAAAAAAAAH9/fwAKAAAAIgAAABgAAAAAAAAAAAAAAAAAAAAAAAAAAAAAAAAAAAAkAAAAJAAAAAAAAAAHAAAAAAAAAAAAAAAAAAAAAAAAAAAAAAAAAAAAf39/ACUAAABYAAAAAAAAAAAAAAAAAAAAAAAAAAAAAAAAAAAAAAAAAAAAAAAAAAAAAAAAAAAAAAA/AAAAAAAAAKCGAQAAAAAAAAAAAAAAAAAMAAAAAQAAAAAAAAAAAAAAAAAAAB8AAABUAAAAAAAABQAAAAEAAAAAAAAAAAAAAAAAAAAAAAAAAAAAAAAAAAAAAAAAAAAAAAJ/f38AAAAAA8zMzADAwP8Af39/AAAAAAAAAAAAAAAAAAAAAAAAAAAAIQAAABgAAAAUAAAAoRkAABsnAABfMQAAWSkAABAAAAAmAAAACAAAAAAAAAAAAAAA"/>
               </a:ext>
             </a:extLst>
           </p:cNvSpPr>
@@ -2040,7 +2040,7 @@
             <a:spLocks noGrp="1" noChangeArrowheads="1"/>
             <a:extLst>
               <a:ext uri="smNativeData">
-                <pr:smNativeData xmlns:pr="smNativeData" xmlns="smNativeData" val="SMDATA_15_ZqHWaRMAAAAlAAAAZAAAAA8BAAAAkAAAAEgAAACQAAAASAAAAAAAAAABAAAAAAAAAAEAAABQAAAAAAAAAAAA4D8AAAAAAADgPwAAAAAAAOA/AAAAAAAA4D8AAAAAAADgPwAAAAAAAOA/AAAAAAAA4D8AAAAAAADgPwAAAAAAAOA/AAAAAAAA4D8CAAAAjAAAAAAAAAAAAAAAu+DjDP///wgAAAAAAAAAAAAAAAAAAAAAAAAAAAAAAAAAAAAAZAAAAAEAAABAAAAAAAAAAAAAAAAAAAAAAAAAAAAAAAAAAAAAAAAAAAAAAAAAAAAAAAAAAAAAAAAAAAAAAAAAAAAAAAAAAAAAAAAAAAAAAAAAAAAAAAAAAAAAAAAAAAAAFAAAADwAAAAAAAAAAAAAAAAAAAkUAAAAAQAAABQAAAAUAAAAFAAAAAEAAAAAAAAAZAAAAGQAAAAAAAAAZAAAAGQAAAAVAAAAYAAAAAAAAAAAAAAADwAAACADAAAAAAAAAAAAAAEAAACgMgAAVgcAAKr4//8BAAAAf39/AAEAAABkAAAAAAAAABQAAABAHwAAAAAAACYAAAAAAAAAwOD//wAAAAAmAAAAZAAAABYAAABMAAAAAAAAAAAAAAAEAAAAAAAAAAEAAACAgIAKAAAAACgAAAAoAAAAZAAAAGQAAAAAAAAAzMzMAAAAAABQAAAAUAAAAGQAAABkAAAAAAAAABcAAAAUAAAAAAAAAAAAAAD/fwAA/38AAAAAAAAJAAAABAAAANw7IAEeAAAAaAAAAAAAAAAAAAAAAAAAAAAAAAAAAAAAECcAABAnAAAAAAAAAAAAAAAAAAAAAAAAAAAAAAAAAAAAAAAAAAAAABQAAAAAAAAAwMD/AAAAAABkAAAAMgAAAAAAAABkAAAAAAAAAH9/fwAKAAAAIgAAABgAAAAAAAAAAAAAAAAAAAAAAAAAAAAAAAAAAAAkAAAAJAAAAAAAAAAHAAAAAAAAAAAAAAAAAAAAAAAAAAAAAAAAAAAAf39/ACUAAABYAAAAAAAAAAAAAAAAAAAAAAAAAAAAAAAAAAAAAAAAAAAAAAAAAAAAAAAAAAAAAAA/AAAAAAAAAKCGAQAAAAAAAAAAAAAAAAAMAAAAAQAAAAAAAAAAAAAAAAAAAB8AAABUAAAAAAAABQAAAAEAAAAAAAAAAAAAAAAAAAAAAAAAAAAAAAAAAAAAAAAAAAAAAAJ/f38AAAAAA8zMzADAwP8Af39/AAAAAAAAAAAAAAAAAAAAAAAAAAAAIQAAABgAAAAUAAAAwTUAABsnAABARwAAWSkAABAAAAAmAAAACAAAAAAAAAAAAAAA"/>
+                <pr:smNativeData xmlns:pr="smNativeData" xmlns="smNativeData" val="SMDATA_15_MvzhaRMAAAAlAAAAZAAAAA8BAAAAkAAAAEgAAACQAAAASAAAAAAAAAABAAAAAAAAAAEAAABQAAAAAAAAAAAA4D8AAAAAAADgPwAAAAAAAOA/AAAAAAAA4D8AAAAAAADgPwAAAAAAAOA/AAAAAAAA4D8AAAAAAADgPwAAAAAAAOA/AAAAAAAA4D8CAAAAjAAAAAAAAAAAAAAAu+DjDP///wgAAAAAAAAAAAAAAAAAAAAAAAAAAAAAAAAAAAAAZAAAAAEAAABAAAAAAAAAAAAAAAAAAAAAAAAAAAAAAAAAAAAAAAAAAAAAAAAAAAAAAAAAAAAAAAAAAAAAAAAAAAAAAAAAAAAAAAAAAAAAAAAAAAAAAAAAAAAAAAAAAAAAFAAAADwAAAAAAAAAAAAAAAAAAAkUAAAAAQAAABQAAAAUAAAAFAAAAAEAAAAAAAAAZAAAAGQAAAAAAAAAZAAAAGQAAAAVAAAAYAAAAAAAAAAAAAAADwAAACADAAAAAAAAAAAAAAEAAACgMgAAVgcAAKr4//8BAAAAf39/AAEAAABkAAAAAAAAABQAAABAHwAAAAAAACYAAAAAAAAAwOD//wAAAAAmAAAAZAAAABYAAABMAAAAAAAAAAAAAAAEAAAAAAAAAAEAAACAgIAKAAAAACgAAAAoAAAAZAAAAGQAAAAAAAAAzMzMAAAAAABQAAAAUAAAAGQAAABkAAAAAAAAABcAAAAUAAAAAAAAAAAAAAD/fwAA/38AAAAAAAAJAAAABAAAANw7IAEeAAAAaAAAAAAAAAAAAAAAAAAAAAAAAAAAAAAAECcAABAnAAAAAAAAAAAAAAAAAAAAAAAAAAAAAAAAAAAAAAAAAAAAABQAAAAAAAAAwMD/AAAAAABkAAAAMgAAAAAAAABkAAAAAAAAAH9/fwAKAAAAIgAAABgAAAAAAAAAAAAAAAAAAAAAAAAAAAAAAAAAAAAkAAAAJAAAAAAAAAAHAAAAAAAAAAAAAAAAAAAAAAAAAAAAAAAAAAAAf39/ACUAAABYAAAAAAAAAAAAAAAAAAAAAAAAAAAAAAAAAAAAAAAAAAAAAAAAAAAAAAAAAAAAAAA/AAAAAAAAAKCGAQAAAAAAAAAAAAAAAAAMAAAAAQAAAAAAAAAAAAAAAAAAAB8AAABUAAAAAAAABQAAAAEAAAAAAAAAAAAAAAAAAAAAAAAAAAAAAAAAAAAAAAAAAAAAAAJ/f38AAAAAA8zMzADAwP8Af39/AAAAAAAAAAAAAAAAAAAAAAAAAAAAIQAAABgAAAAUAAAAwTUAABsnAABARwAAWSkAABAAAAAmAAAACAAAAAAAAAAAAAAA"/>
               </a:ext>
             </a:extLst>
           </p:cNvSpPr>
@@ -2054,7 +2054,7 @@
           <a:lstStyle/>
           <a:p>
             <a:pPr/>
-            <a:fld id="{67CE2585-CB8A-9BD3-C476-3D866B383268}" type="slidenum">
+            <a:fld id="{64585B5D-1389-0DAD-C7E0-E5F815AE31B0}" type="slidenum">
               <a:t/>
             </a:fld>
           </a:p>
@@ -2093,7 +2093,7 @@
             <a:spLocks noGrp="1" noChangeArrowheads="1"/>
             <a:extLst>
               <a:ext uri="smNativeData">
-                <pr:smNativeData xmlns:pr="smNativeData" xmlns="smNativeData" val="SMDATA_15_ZqHWaRMAAAAlAAAAZAAAAA8BAAAAkAAAAEgAAACQAAAASAAAAAAAAAABAAAAAAAAAAEAAABQAAAAAAAAAAAA4D8AAAAAAADgPwAAAAAAAOA/AAAAAAAA4D8AAAAAAADgPwAAAAAAAOA/AAAAAAAA4D8AAAAAAADgPwAAAAAAAOA/AAAAAAAA4D8CAAAAjAAAAAAAAAAAAAAAu+DjDP///wgAAAAAAAAAAAAAAAAAAAAAAAAAAAAAAAAAAAAAZAAAAAEAAABAAAAAAAAAAAAAAAAAAAAAAAAAAAAAAAAAAAAAAAAAAAAAAAAAAAAAAAAAAAAAAAAAAAAAAAAAAAAAAAAAAAAAAAAAAAAAAAAAAAAAAAAAAAAAAAAAAAAAFAAAADwAAAAAAAAAAAAAAAAAAAkUAAAAAQAAABQAAAAUAAAAFAAAAAEAAAAAAAAAZAAAAGQAAAAAAAAAZAAAAGQAAAAVAAAAYAAAAAAAAAAAAAAADwAAACADAAAAAAAAAAAAAAEAAACgMgAAVgcAAKr4//8BAAAAf39/AAEAAABkAAAAAAAAABQAAABAHwAAAAAAACYAAAAAAAAAwOD//wAAAAAmAAAAZAAAABYAAABMAAAAAAAAAAAAAAAEAAAAAAAAAAEAAACAgIAKAAAAACgAAAAoAAAAZAAAAGQAAAAAAAAAzMzMAAAAAABQAAAAUAAAAGQAAABkAAAAAAAAABcAAAAUAAAAAAAAAAAAAAD/fwAA/38AAAAAAAAJAAAABAAAANw7IAEeAAAAaAAAAAAAAAAAAAAAAAAAAAAAAAAAAAAAECcAABAnAAAAAAAAAAAAAAAAAAAAAAAAAAAAAAAAAAAAAAAAAAAAABQAAAAAAAAAwMD/AAAAAABkAAAAMgAAAAAAAABkAAAAAAAAAH9/fwAKAAAAIgAAABgAAAAAAAAAAAAAAAAAAAAAAAAAAAAAAAAAAAAkAAAAJAAAAAAAAAAHAAAAAAAAAAAAAAAAAAAAAAAAAAAAAAAAAAAAf39/ACUAAABYAAAAAAAAAAAAAAAAAAAAAAAAAAAAAAAAAAAAAAAAAAAAAAAAAAAAAAAAAAAAAAA/AAAAAAAAAKCGAQAAAAAAAAAAAAAAAAAMAAAAAQAAAAAAAAAAAAAAAAAAAB8AAABUAAAAAAAABQAAAAEAAAAAAAAAAAAAAAAAAAAAAAAAAAAAAAAAAAAAAAAAAAAAAAJ/f38AAAAAA8zMzADAwP8Af39/AAAAAAAAAAAAAAAAAAAAAAAAAAAAIQAAABgAAAAUAAAAwAMAABsnAAA/FQAAWSkAABAAAAAmAAAACAAAAAAAAAAAAAAA"/>
+                <pr:smNativeData xmlns:pr="smNativeData" xmlns="smNativeData" val="SMDATA_15_MvzhaRMAAAAlAAAAZAAAAA8BAAAAkAAAAEgAAACQAAAASAAAAAAAAAABAAAAAAAAAAEAAABQAAAAAAAAAAAA4D8AAAAAAADgPwAAAAAAAOA/AAAAAAAA4D8AAAAAAADgPwAAAAAAAOA/AAAAAAAA4D8AAAAAAADgPwAAAAAAAOA/AAAAAAAA4D8CAAAAjAAAAAAAAAAAAAAAu+DjDP///wgAAAAAAAAAAAAAAAAAAAAAAAAAAAAAAAAAAAAAZAAAAAEAAABAAAAAAAAAAAAAAAAAAAAAAAAAAAAAAAAAAAAAAAAAAAAAAAAAAAAAAAAAAAAAAAAAAAAAAAAAAAAAAAAAAAAAAAAAAAAAAAAAAAAAAAAAAAAAAAAAAAAAFAAAADwAAAAAAAAAAAAAAAAAAAkUAAAAAQAAABQAAAAUAAAAFAAAAAEAAAAAAAAAZAAAAGQAAAAAAAAAZAAAAGQAAAAVAAAAYAAAAAAAAAAAAAAADwAAACADAAAAAAAAAAAAAAEAAACgMgAAVgcAAKr4//8BAAAAf39/AAEAAABkAAAAAAAAABQAAABAHwAAAAAAACYAAAAAAAAAwOD//wAAAAAmAAAAZAAAABYAAABMAAAAAAAAAAAAAAAEAAAAAAAAAAEAAACAgIAKAAAAACgAAAAoAAAAZAAAAGQAAAAAAAAAzMzMAAAAAABQAAAAUAAAAGQAAABkAAAAAAAAABcAAAAUAAAAAAAAAAAAAAD/fwAA/38AAAAAAAAJAAAABAAAANw7IAEeAAAAaAAAAAAAAAAAAAAAAAAAAAAAAAAAAAAAECcAABAnAAAAAAAAAAAAAAAAAAAAAAAAAAAAAAAAAAAAAAAAAAAAABQAAAAAAAAAwMD/AAAAAABkAAAAMgAAAAAAAABkAAAAAAAAAH9/fwAKAAAAIgAAABgAAAAAAAAAAAAAAAAAAAAAAAAAAAAAAAAAAAAkAAAAJAAAAAAAAAAHAAAAAAAAAAAAAAAAAAAAAAAAAAAAAAAAAAAAf39/ACUAAABYAAAAAAAAAAAAAAAAAAAAAAAAAAAAAAAAAAAAAAAAAAAAAAAAAAAAAAAAAAAAAAA/AAAAAAAAAKCGAQAAAAAAAAAAAAAAAAAMAAAAAQAAAAAAAAAAAAAAAAAAAB8AAABUAAAAAAAABQAAAAEAAAAAAAAAAAAAAAAAAAAAAAAAAAAAAAAAAAAAAAAAAAAAAAJ/f38AAAAAA8zMzADAwP8Af39/AAAAAAAAAAAAAAAAAAAAAAAAAAAAIQAAABgAAAAUAAAAwAMAABsnAAA/FQAAWSkAABAAAAAmAAAACAAAAAAAAAAAAAAA"/>
               </a:ext>
             </a:extLst>
           </p:cNvSpPr>
@@ -2107,7 +2107,7 @@
           <a:lstStyle/>
           <a:p>
             <a:pPr/>
-            <a:fld id="{2CD735F1-BFC1-82C3-8F6F-49967B21791C}" type="datetime1">
+            <a:fld id="{657DE349-0788-2815-C6C5-F140AD8B30A4}" type="datetime1">
               <a:t/>
             </a:fld>
           </a:p>
@@ -2120,7 +2120,7 @@
             <a:spLocks noGrp="1" noChangeArrowheads="1"/>
             <a:extLst>
               <a:ext uri="smNativeData">
-                <pr:smNativeData xmlns:pr="smNativeData" xmlns="smNativeData" val="SMDATA_15_ZqHWaRMAAAAlAAAAZAAAAA8BAAAAkAAAAEgAAACQAAAASAAAAAAAAAABAAAAAAAAAAEAAABQAAAAAAAAAAAA4D8AAAAAAADgPwAAAAAAAOA/AAAAAAAA4D8AAAAAAADgPwAAAAAAAOA/AAAAAAAA4D8AAAAAAADgPwAAAAAAAOA/AAAAAAAA4D8CAAAAjAAAAAAAAAAAAAAAu+DjDP///wgAAAAAAAAAAAAAAAAAAAAAAAAAAAAAAAAAAAAAZAAAAAEAAABAAAAAAAAAAAAAAAAAAAAAAAAAAAAAAAAAAAAAAAAAAAAAAAAAAAAAAAAAAAAAAAAAAAAAAAAAAAAAAAAAAAAAAAAAAAAAAAAAAAAAAAAAAAAAAAAAAAAAFAAAADwAAAAAAAAAAAAAAAAAAAkUAAAAAQAAABQAAAAUAAAAFAAAAAEAAAAAAAAAZAAAAGQAAAAAAAAAZAAAAGQAAAAVAAAAYAAAAAAAAAAAAAAADwAAACADAAAAAAAAAAAAAAEAAACgMgAAVgcAAKr4//8BAAAAf39/AAEAAABkAAAAAAAAABQAAABAHwAAAAAAACYAAAAAAAAAwOD//wAAAAAmAAAAZAAAABYAAABMAAAAAAAAAAAAAAAEAAAAAAAAAAEAAACAgIAKAAAAACgAAAAoAAAAZAAAAGQAAAAAAAAAzMzMAAAAAABQAAAAUAAAAGQAAABkAAAAAAAAABcAAAAUAAAAAAAAAAAAAAD/fwAA/38AAAAAAAAJAAAABAAAAAAAAAAeAAAAaAAAAAAAAAAAAAAAAAAAAAAAAAAAAAAAECcAABAnAAAAAAAAAAAAAAAAAAAAAAAAAAAAAAAAAAAAAAAAAAAAABQAAAAAAAAAwMD/AAAAAABkAAAAMgAAAAAAAABkAAAAAAAAAH9/fwAKAAAAIgAAABgAAAAAAAAAAAAAAAAAAAAAAAAAAAAAAAAAAAAkAAAAJAAAAAAAAAAHAAAAAAAAAAAAAAAAAAAAAAAAAAAAAAAAAAAAf39/ACUAAABYAAAAAAAAAAAAAAAAAAAAAAAAAAAAAAAAAAAAAAAAAAAAAAAAAAAAAAAAAAAAAAA/AAAAAAAAAKCGAQAAAAAAAAAAAAAAAAAMAAAAAQAAAAAAAAAAAAAAAAAAAB8AAABUAAAAAAAABQAAAAEAAAAAAAAAAAAAAAAAAAAAAAAAAAAAAAAAAAAAAAAAAAAAAAJ/f38AAAAAA8zMzADAwP8Af39/AAAAAAAAAAAAAAAAAAAAAAAAAAAAIQAAABgAAAAUAAAAoRkAABsnAABfMQAAWSkAABAAAAAmAAAACAAAAAAAAAAAAAAA"/>
+                <pr:smNativeData xmlns:pr="smNativeData" xmlns="smNativeData" val="SMDATA_15_MvzhaRMAAAAlAAAAZAAAAA8BAAAAkAAAAEgAAACQAAAASAAAAAAAAAABAAAAAAAAAAEAAABQAAAAAAAAAAAA4D8AAAAAAADgPwAAAAAAAOA/AAAAAAAA4D8AAAAAAADgPwAAAAAAAOA/AAAAAAAA4D8AAAAAAADgPwAAAAAAAOA/AAAAAAAA4D8CAAAAjAAAAAAAAAAAAAAAu+DjDP///wgAAAAAAAAAAAAAAAAAAAAAAAAAAAAAAAAAAAAAZAAAAAEAAABAAAAAAAAAAAAAAAAAAAAAAAAAAAAAAAAAAAAAAAAAAAAAAAAAAAAAAAAAAAAAAAAAAAAAAAAAAAAAAAAAAAAAAAAAAAAAAAAAAAAAAAAAAAAAAAAAAAAAFAAAADwAAAAAAAAAAAAAAAAAAAkUAAAAAQAAABQAAAAUAAAAFAAAAAEAAAAAAAAAZAAAAGQAAAAAAAAAZAAAAGQAAAAVAAAAYAAAAAAAAAAAAAAADwAAACADAAAAAAAAAAAAAAEAAACgMgAAVgcAAKr4//8BAAAAf39/AAEAAABkAAAAAAAAABQAAABAHwAAAAAAACYAAAAAAAAAwOD//wAAAAAmAAAAZAAAABYAAABMAAAAAAAAAAAAAAAEAAAAAAAAAAEAAACAgIAKAAAAACgAAAAoAAAAZAAAAGQAAAAAAAAAzMzMAAAAAABQAAAAUAAAAGQAAABkAAAAAAAAABcAAAAUAAAAAAAAAAAAAAD/fwAA/38AAAAAAAAJAAAABAAAAAAAAAAeAAAAaAAAAAAAAAAAAAAAAAAAAAAAAAAAAAAAECcAABAnAAAAAAAAAAAAAAAAAAAAAAAAAAAAAAAAAAAAAAAAAAAAABQAAAAAAAAAwMD/AAAAAABkAAAAMgAAAAAAAABkAAAAAAAAAH9/fwAKAAAAIgAAABgAAAAAAAAAAAAAAAAAAAAAAAAAAAAAAAAAAAAkAAAAJAAAAAAAAAAHAAAAAAAAAAAAAAAAAAAAAAAAAAAAAAAAAAAAf39/ACUAAABYAAAAAAAAAAAAAAAAAAAAAAAAAAAAAAAAAAAAAAAAAAAAAAAAAAAAAAAAAAAAAAA/AAAAAAAAAKCGAQAAAAAAAAAAAAAAAAAMAAAAAQAAAAAAAAAAAAAAAAAAAB8AAABUAAAAAAAABQAAAAEAAAAAAAAAAAAAAAAAAAAAAAAAAAAAAAAAAAAAAAAAAAAAAAJ/f38AAAAAA8zMzADAwP8Af39/AAAAAAAAAAAAAAAAAAAAAAAAAAAAIQAAABgAAAAUAAAAoRkAABsnAABfMQAAWSkAABAAAAAmAAAACAAAAAAAAAAAAAAA"/>
               </a:ext>
             </a:extLst>
           </p:cNvSpPr>
@@ -2144,7 +2144,7 @@
             <a:spLocks noGrp="1" noChangeArrowheads="1"/>
             <a:extLst>
               <a:ext uri="smNativeData">
-                <pr:smNativeData xmlns:pr="smNativeData" xmlns="smNativeData" val="SMDATA_15_ZqHWaRMAAAAlAAAAZAAAAA8BAAAAkAAAAEgAAACQAAAASAAAAAAAAAABAAAAAAAAAAEAAABQAAAAAAAAAAAA4D8AAAAAAADgPwAAAAAAAOA/AAAAAAAA4D8AAAAAAADgPwAAAAAAAOA/AAAAAAAA4D8AAAAAAADgPwAAAAAAAOA/AAAAAAAA4D8CAAAAjAAAAAAAAAAAAAAAu+DjDP///wgAAAAAAAAAAAAAAAAAAAAAAAAAAAAAAAAAAAAAZAAAAAEAAABAAAAAAAAAAAAAAAAAAAAAAAAAAAAAAAAAAAAAAAAAAAAAAAAAAAAAAAAAAAAAAAAAAAAAAAAAAAAAAAAAAAAAAAAAAAAAAAAAAAAAAAAAAAAAAAAAAAAAFAAAADwAAAAAAAAAAAAAAAAAAAkUAAAAAQAAABQAAAAUAAAAFAAAAAEAAAAAAAAAZAAAAGQAAAAAAAAAZAAAAGQAAAAVAAAAYAAAAAAAAAAAAAAADwAAACADAAAAAAAAAAAAAAEAAACgMgAAVgcAAKr4//8BAAAAf39/AAEAAABkAAAAAAAAABQAAABAHwAAAAAAACYAAAAAAAAAwOD//wAAAAAmAAAAZAAAABYAAABMAAAAAAAAAAAAAAAEAAAAAAAAAAEAAACAgIAKAAAAACgAAAAoAAAAZAAAAGQAAAAAAAAAzMzMAAAAAABQAAAAUAAAAGQAAABkAAAAAAAAABcAAAAUAAAAAAAAAAAAAAD/fwAA/38AAAAAAAAJAAAABAAAAAAAAAAeAAAAaAAAAAAAAAAAAAAAAAAAAAAAAAAAAAAAECcAABAnAAAAAAAAAAAAAAAAAAAAAAAAAAAAAAAAAAAAAAAAAAAAABQAAAAAAAAAwMD/AAAAAABkAAAAMgAAAAAAAABkAAAAAAAAAH9/fwAKAAAAIgAAABgAAAAAAAAAAAAAAAAAAAAAAAAAAAAAAAAAAAAkAAAAJAAAAAAAAAAHAAAAAAAAAAAAAAAAAAAAAAAAAAAAAAAAAAAAf39/ACUAAABYAAAAAAAAAAAAAAAAAAAAAAAAAAAAAAAAAAAAAAAAAAAAAAAAAAAAAAAAAAAAAAA/AAAAAAAAAKCGAQAAAAAAAAAAAAAAAAAMAAAAAQAAAAAAAAAAAAAAAAAAAB8AAABUAAAAAAAABQAAAAEAAAAAAAAAAAAAAAAAAAAAAAAAAAAAAAAAAAAAAAAAAAAAAAJ/f38AAAAAA8zMzADAwP8Af39/AAAAAAAAAAAAAAAAAAAAAAAAAAAAIQAAABgAAAAUAAAAwTUAABsnAABARwAAWSkAABAAAAAmAAAACAAAAAAAAAAAAAAA"/>
+                <pr:smNativeData xmlns:pr="smNativeData" xmlns="smNativeData" val="SMDATA_15_MvzhaRMAAAAlAAAAZAAAAA8BAAAAkAAAAEgAAACQAAAASAAAAAAAAAABAAAAAAAAAAEAAABQAAAAAAAAAAAA4D8AAAAAAADgPwAAAAAAAOA/AAAAAAAA4D8AAAAAAADgPwAAAAAAAOA/AAAAAAAA4D8AAAAAAADgPwAAAAAAAOA/AAAAAAAA4D8CAAAAjAAAAAAAAAAAAAAAu+DjDP///wgAAAAAAAAAAAAAAAAAAAAAAAAAAAAAAAAAAAAAZAAAAAEAAABAAAAAAAAAAAAAAAAAAAAAAAAAAAAAAAAAAAAAAAAAAAAAAAAAAAAAAAAAAAAAAAAAAAAAAAAAAAAAAAAAAAAAAAAAAAAAAAAAAAAAAAAAAAAAAAAAAAAAFAAAADwAAAAAAAAAAAAAAAAAAAkUAAAAAQAAABQAAAAUAAAAFAAAAAEAAAAAAAAAZAAAAGQAAAAAAAAAZAAAAGQAAAAVAAAAYAAAAAAAAAAAAAAADwAAACADAAAAAAAAAAAAAAEAAACgMgAAVgcAAKr4//8BAAAAf39/AAEAAABkAAAAAAAAABQAAABAHwAAAAAAACYAAAAAAAAAwOD//wAAAAAmAAAAZAAAABYAAABMAAAAAAAAAAAAAAAEAAAAAAAAAAEAAACAgIAKAAAAACgAAAAoAAAAZAAAAGQAAAAAAAAAzMzMAAAAAABQAAAAUAAAAGQAAABkAAAAAAAAABcAAAAUAAAAAAAAAAAAAAD/fwAA/38AAAAAAAAJAAAABAAAAAAAAAAeAAAAaAAAAAAAAAAAAAAAAAAAAAAAAAAAAAAAECcAABAnAAAAAAAAAAAAAAAAAAAAAAAAAAAAAAAAAAAAAAAAAAAAABQAAAAAAAAAwMD/AAAAAABkAAAAMgAAAAAAAABkAAAAAAAAAH9/fwAKAAAAIgAAABgAAAAAAAAAAAAAAAAAAAAAAAAAAAAAAAAAAAAkAAAAJAAAAAAAAAAHAAAAAAAAAAAAAAAAAAAAAAAAAAAAAAAAAAAAf39/ACUAAABYAAAAAAAAAAAAAAAAAAAAAAAAAAAAAAAAAAAAAAAAAAAAAAAAAAAAAAAAAAAAAAA/AAAAAAAAAKCGAQAAAAAAAAAAAAAAAAAMAAAAAQAAAAAAAAAAAAAAAAAAAB8AAABUAAAAAAAABQAAAAEAAAAAAAAAAAAAAAAAAAAAAAAAAAAAAAAAAAAAAAAAAAAAAAJ/f38AAAAAA8zMzADAwP8Af39/AAAAAAAAAAAAAAAAAAAAAAAAAAAAIQAAABgAAAAUAAAAwTUAABsnAABARwAAWSkAABAAAAAmAAAACAAAAAAAAAAAAAAA"/>
               </a:ext>
             </a:extLst>
           </p:cNvSpPr>
@@ -2158,7 +2158,7 @@
           <a:lstStyle/>
           <a:p>
             <a:pPr/>
-            <a:fld id="{08995FE2-ACE5-CCA9-AB21-5AFC116F5D0F}" type="slidenum">
+            <a:fld id="{405F1DD1-9FAD-0AEB-E3E7-69BE53A9153C}" type="slidenum">
               <a:t/>
             </a:fld>
           </a:p>
@@ -2197,7 +2197,7 @@
             <a:spLocks noGrp="1" noChangeArrowheads="1"/>
             <a:extLst>
               <a:ext uri="smNativeData">
-                <pr:smNativeData xmlns:pr="smNativeData" xmlns="smNativeData" val="SMDATA_15_ZqHWaRMAAAAlAAAAZAAAAA8BAAAAkAAAAEgAAACQAAAASAAAAAAAAAACAAAAAAAAAAEAAABQAAAAAAAAAAAA4D8AAAAAAADgPwAAAAAAAOA/AAAAAAAA4D8AAAAAAADgPwAAAAAAAOA/AAAAAAAA4D8AAAAAAADgPwAAAAAAAOA/AAAAAAAA4D8CAAAAjAAAAAAAAAAAAAAAu+DjDP///wgAAAAAAAAAAAAAAAAAAAAAAAAAAAAAAAAAAAAAZAAAAAEAAABAAAAAAAAAAAAAAAAAAAAAAAAAAAAAAAAAAAAAAAAAAAAAAAAAAAAAAAAAAAAAAAAAAAAAAAAAAAAAAAAAAAAAAAAAAAAAAAAAAAAAAAAAAAAAAAAAAAAAFAAAADwAAAAAAAAAAAAAAAAAAAkUAAAAAQAAABQAAAAUAAAAFAAAAAEAAAAAAAAAZAAAAGQAAAAAAAAAZAAAAGQAAAAVAAAAYAAAAAAAAAAAAAAADwAAACADAAAAAAAAAAAAAAEAAACgMgAAVgcAAKr4//8BAAAAf39/AAEAAABkAAAAAAAAABQAAABAHwAAAAAAACYAAAAAAAAAwOD//wAAAAAmAAAAZAAAABYAAABMAAAAAAAAAAAAAAAEAAAAAAAAAAEAAACAgIAKAAAAACgAAAAoAAAAZAAAAGQAAAAAAAAAzMzMAAAAAABQAAAAUAAAAGQAAABkAAAAAAAAABcAAAAUAAAAAAAAAAAAAAD/fwAA/38AAAAAAAAJAAAABAAAAAAAAAAeAAAAaAAAAAAAAAAAAAAAAAAAAAAAAAAAAAAAECcAABAnAAAAAAAAAAAAAAAAAAAAAAAAAAAAAAAAAAAAAAAAAAAAABQAAAAAAAAAwMD/AAAAAABkAAAAMgAAAAAAAABkAAAAAAAAAH9/fwAKAAAAIgAAABgAAAAAAAAAAAAAAAAAAAAAAAAAAAAAAAAAAAAkAAAAJAAAAAAAAAAHAAAAAAAAAAAAAAAAAAAAAAAAAAAAAAAAAAAAf39/ACUAAABYAAAAAAAAAAAAAAAAAAAAAAAAAAAAAAAAAAAAAAAAAAAAAAAAAAAAAAAAAAAAAAA/AAAAAAAAAKCGAQAAAAAAAAAAAAAAAAAMAAAAAQAAAAAAAAAAAAAAAAAAAB8AAABUAAAAAAAABQAAAAEAAAAAAAAAAAAAAAAAAAAAAAAAAAAAAAAAAAAAAAAAAAAAAAJ/f38AAAAAA8zMzADAwP8Af39/AAAAAAAAAAAAAAAAAAAAAAAAAAAAIQAAABgAAAAUAAAAwAMAAK4BAABtHAAA1AgAABAAAAAmAAAACAAAAIGAAAAAAAAA"/>
+                <pr:smNativeData xmlns:pr="smNativeData" xmlns="smNativeData" val="SMDATA_15_MvzhaRMAAAAlAAAAZAAAAA8BAAAAkAAAAEgAAACQAAAASAAAAAAAAAACAAAAAAAAAAEAAABQAAAAAAAAAAAA4D8AAAAAAADgPwAAAAAAAOA/AAAAAAAA4D8AAAAAAADgPwAAAAAAAOA/AAAAAAAA4D8AAAAAAADgPwAAAAAAAOA/AAAAAAAA4D8CAAAAjAAAAAAAAAAAAAAAu+DjDP///wgAAAAAAAAAAAAAAAAAAAAAAAAAAAAAAAAAAAAAZAAAAAEAAABAAAAAAAAAAAAAAAAAAAAAAAAAAAAAAAAAAAAAAAAAAAAAAAAAAAAAAAAAAAAAAAAAAAAAAAAAAAAAAAAAAAAAAAAAAAAAAAAAAAAAAAAAAAAAAAAAAAAAFAAAADwAAAAAAAAAAAAAAAAAAAkUAAAAAQAAABQAAAAUAAAAFAAAAAEAAAAAAAAAZAAAAGQAAAAAAAAAZAAAAGQAAAAVAAAAYAAAAAAAAAAAAAAADwAAACADAAAAAAAAAAAAAAEAAACgMgAAVgcAAKr4//8BAAAAf39/AAEAAABkAAAAAAAAABQAAABAHwAAAAAAACYAAAAAAAAAwOD//wAAAAAmAAAAZAAAABYAAABMAAAAAAAAAAAAAAAEAAAAAAAAAAEAAACAgIAKAAAAACgAAAAoAAAAZAAAAGQAAAAAAAAAzMzMAAAAAABQAAAAUAAAAGQAAABkAAAAAAAAABcAAAAUAAAAAAAAAAAAAAD/fwAA/38AAAAAAAAJAAAABAAAAAAAAAAeAAAAaAAAAAAAAAAAAAAAAAAAAAAAAAAAAAAAECcAABAnAAAAAAAAAAAAAAAAAAAAAAAAAAAAAAAAAAAAAAAAAAAAABQAAAAAAAAAwMD/AAAAAABkAAAAMgAAAAAAAABkAAAAAAAAAH9/fwAKAAAAIgAAABgAAAAAAAAAAAAAAAAAAAAAAAAAAAAAAAAAAAAkAAAAJAAAAAAAAAAHAAAAAAAAAAAAAAAAAAAAAAAAAAAAAAAAAAAAf39/ACUAAABYAAAAAAAAAAAAAAAAAAAAAAAAAAAAAAAAAAAAAAAAAAAAAAAAAAAAAAAAAAAAAAA/AAAAAAAAAKCGAQAAAAAAAAAAAAAAAAAMAAAAAQAAAAAAAAAAAAAAAAAAAB8AAABUAAAAAAAABQAAAAEAAAAAAAAAAAAAAAAAAAAAAAAAAAAAAAAAAAAAAAAAAAAAAAJ/f38AAAAAA8zMzADAwP8Af39/AAAAAAAAAAAAAAAAAAAAAAAAAAAAIQAAABgAAAAUAAAAwAMAAK4BAABtHAAA1AgAABAAAAAmAAAACAAAAIGAAAAAAAAA"/>
               </a:ext>
             </a:extLst>
           </p:cNvSpPr>
@@ -2237,7 +2237,7 @@
             <a:spLocks noGrp="1" noChangeArrowheads="1"/>
             <a:extLst>
               <a:ext uri="smNativeData">
-                <pr:smNativeData xmlns:pr="smNativeData" xmlns="smNativeData" val="SMDATA_15_ZqHWaRMAAAAlAAAAZAAAAA8BAAAAkAAAAEgAAACQAAAASAAAAAAAAAAAAAAAAAAAAAEAAABQAAAAAAAAAAAA4D8AAAAAAADgPwAAAAAAAOA/AAAAAAAA4D8AAAAAAADgPwAAAAAAAOA/AAAAAAAA4D8AAAAAAADgPwAAAAAAAOA/AAAAAAAA4D8CAAAAjAAAAAAAAAAAAAAAu+DjDP///wgAAAAAAAAAAAAAAAAAAAAAAAAAAAAAAAAAAAAAZAAAAAEAAABAAAAAAAAAAAAAAAAAAAAAAAAAAAAAAAAAAAAAAAAAAAAAAAAAAAAAAAAAAAAAAAAAAAAAAAAAAAAAAAAAAAAAAAAAAAAAAAAAAAAAAAAAAAAAAAAAAAAAFAAAADwAAAAAAAAAAAAAAAAAAAkUAAAAAQAAABQAAAAUAAAAFAAAAAEAAAAAAAAAZAAAAGQAAAAAAAAAZAAAAGQAAAAVAAAAYAAAAAAAAAAAAAAADwAAACADAAAAAAAAAAAAAAEAAACgMgAAVgcAAKr4//8BAAAAf39/AAEAAABkAAAAAAAAABQAAABAHwAAAAAAACYAAAAAAAAAwOD//wAAAAAmAAAAZAAAABYAAABMAAAAAAAAAAAAAAAEAAAAAAAAAAEAAACAgIAKAAAAACgAAAAoAAAAZAAAAGQAAAAAAAAAzMzMAAAAAABQAAAAUAAAAGQAAABkAAAAAAAAABcAAAAUAAAAAAAAAAAAAAD/fwAA/38AAAAAAAAJAAAABAAAAAAAAAAeAAAAaAAAAAAAAAAAAAAAAAAAAAAAAAAAAAAAECcAABAnAAAAAAAAAAAAAAAAAAAAAAAAAAAAAAAAAAAAAAAAAAAAABQAAAAAAAAAwMD/AAAAAABkAAAAMgAAAAAAAABkAAAAAAAAAH9/fwAKAAAAIgAAABgAAAAAAAAAAAAAAAAAAAAAAAAAAAAAAAAAAAAkAAAAJAAAAAAAAAAHAAAAAAAAAAAAAAAAAAAAAAAAAAAAAAAAAAAAf39/ACUAAABYAAAAAAAAAAAAAAAAAAAAAAAAAAAAAAAAAAAAAAAAAAAAAAAAAAAAAAAAAAAAAAA/AAAAAAAAAKCGAQAAAAAAAAAAAAAAAAAMAAAAAQAAAAAAAAAAAAAAAAAAAB8AAABUAAAAAAAABQAAAAEAAAAAAAAAAAAAAAAAAAAAAAAAAAAAAAAAAAAAAAAAAAAAAAJ/f38AAAAAA8zMzADAwP8Af39/AAAAAAAAAAAAAAAAAAAAAAAAAAAAIQAAABgAAAAUAAAAUx0AAK4BAABARwAAsCUAABAAAAAmAAAACAAAAAGAAAAAAAAA"/>
+                <pr:smNativeData xmlns:pr="smNativeData" xmlns="smNativeData" val="SMDATA_15_MvzhaRMAAAAlAAAAZAAAAA8BAAAAkAAAAEgAAACQAAAASAAAAAAAAAAAAAAAAAAAAAEAAABQAAAAAAAAAAAA4D8AAAAAAADgPwAAAAAAAOA/AAAAAAAA4D8AAAAAAADgPwAAAAAAAOA/AAAAAAAA4D8AAAAAAADgPwAAAAAAAOA/AAAAAAAA4D8CAAAAjAAAAAAAAAAAAAAAu+DjDP///wgAAAAAAAAAAAAAAAAAAAAAAAAAAAAAAAAAAAAAZAAAAAEAAABAAAAAAAAAAAAAAAAAAAAAAAAAAAAAAAAAAAAAAAAAAAAAAAAAAAAAAAAAAAAAAAAAAAAAAAAAAAAAAAAAAAAAAAAAAAAAAAAAAAAAAAAAAAAAAAAAAAAAFAAAADwAAAAAAAAAAAAAAAAAAAkUAAAAAQAAABQAAAAUAAAAFAAAAAEAAAAAAAAAZAAAAGQAAAAAAAAAZAAAAGQAAAAVAAAAYAAAAAAAAAAAAAAADwAAACADAAAAAAAAAAAAAAEAAACgMgAAVgcAAKr4//8BAAAAf39/AAEAAABkAAAAAAAAABQAAABAHwAAAAAAACYAAAAAAAAAwOD//wAAAAAmAAAAZAAAABYAAABMAAAAAAAAAAAAAAAEAAAAAAAAAAEAAACAgIAKAAAAACgAAAAoAAAAZAAAAGQAAAAAAAAAzMzMAAAAAABQAAAAUAAAAGQAAABkAAAAAAAAABcAAAAUAAAAAAAAAAAAAAD/fwAA/38AAAAAAAAJAAAABAAAAAAAAAAeAAAAaAAAAAAAAAAAAAAAAAAAAAAAAAAAAAAAECcAABAnAAAAAAAAAAAAAAAAAAAAAAAAAAAAAAAAAAAAAAAAAAAAABQAAAAAAAAAwMD/AAAAAABkAAAAMgAAAAAAAABkAAAAAAAAAH9/fwAKAAAAIgAAABgAAAAAAAAAAAAAAAAAAAAAAAAAAAAAAAAAAAAkAAAAJAAAAAAAAAAHAAAAAAAAAAAAAAAAAAAAAAAAAAAAAAAAAAAAf39/ACUAAABYAAAAAAAAAAAAAAAAAAAAAAAAAAAAAAAAAAAAAAAAAAAAAAAAAAAAAAAAAAAAAAA/AAAAAAAAAKCGAQAAAAAAAAAAAAAAAAAMAAAAAQAAAAAAAAAAAAAAAAAAAB8AAABUAAAAAAAABQAAAAEAAAAAAAAAAAAAAAAAAAAAAAAAAAAAAAAAAAAAAAAAAAAAAAJ/f38AAAAAA8zMzADAwP8Af39/AAAAAAAAAAAAAAAAAAAAAAAAAAAAIQAAABgAAAAUAAAAUx0AAK4BAABARwAAsCUAABAAAAAmAAAACAAAAAGAAAAAAAAA"/>
               </a:ext>
             </a:extLst>
           </p:cNvSpPr>
@@ -2321,7 +2321,7 @@
             <a:spLocks noGrp="1" noChangeArrowheads="1"/>
             <a:extLst>
               <a:ext uri="smNativeData">
-                <pr:smNativeData xmlns:pr="smNativeData" xmlns="smNativeData" val="SMDATA_15_ZqHWaRMAAAAlAAAAZAAAAA8BAAAAkAAAAEgAAACQAAAASAAAAAAAAAAAAAAAAAAAAAEAAABQAAAAAAAAAAAA4D8AAAAAAADgPwAAAAAAAOA/AAAAAAAA4D8AAAAAAADgPwAAAAAAAOA/AAAAAAAA4D8AAAAAAADgPwAAAAAAAOA/AAAAAAAA4D8CAAAAjAAAAAAAAAAAAAAAu+DjDP///wgAAAAAAAAAAAAAAAAAAAAAAAAAAAAAAAAAAAAAZAAAAAEAAABAAAAAAAAAAAAAAAAAAAAAAAAAAAAAAAAAAAAAAAAAAAAAAAAAAAAAAAAAAAAAAAAAAAAAAAAAAAAAAAAAAAAAAAAAAAAAAAAAAAAAAAAAAAAAAAAAAAAAFAAAADwAAAAAAAAAAAAAAAAAAAkUAAAAAQAAABQAAAAUAAAAFAAAAAEAAAAAAAAAZAAAAGQAAAAAAAAAZAAAAGQAAAAVAAAAYAAAAAAAAAAAAAAADwAAACADAAAAAAAAAAAAAAEAAACgMgAAVgcAAKr4//8BAAAAf39/AAEAAABkAAAAAAAAABQAAABAHwAAAAAAACYAAAAAAAAAwOD//wAAAAAmAAAAZAAAABYAAABMAAAAAAAAAAAAAAAEAAAAAAAAAAEAAACAgIAKAAAAACgAAAAoAAAAZAAAAGQAAAAAAAAAzMzMAAAAAABQAAAAUAAAAGQAAABkAAAAAAAAABcAAAAUAAAAAAAAAAAAAAD/fwAA/38AAAAAAAAJAAAABAAAAAAAAAAeAAAAaAAAAAAAAAAAAAAAAAAAAAAAAAAAAAAAECcAABAnAAAAAAAAAAAAAAAAAAAAAAAAAAAAAAAAAAAAAAAAAAAAABQAAAAAAAAAwMD/AAAAAABkAAAAMgAAAAAAAABkAAAAAAAAAH9/fwAKAAAAIgAAABgAAAAAAAAAAAAAAAAAAAAAAAAAAAAAAAAAAAAkAAAAJAAAAAAAAAAHAAAAAAAAAAAAAAAAAAAAAAAAAAAAAAAAAAAAf39/ACUAAABYAAAAAAAAAAAAAAAAAAAAAAAAAAAAAAAAAAAAAAAAAAAAAAAAAAAAAAAAAAAAAAA/AAAAAAAAAKCGAQAAAAAAAAAAAAAAAAAMAAAAAQAAAAAAAAAAAAAAAAAAAB8AAABUAAAAAAAABQAAAAEAAAAAAAAAAAAAAAAAAAAAAAAAAAAAAAAAAAAAAAAAAAAAAAJ/f38AAAAAA8zMzADAwP8Af39/AAAAAAAAAAAAAAAAAAAAAAAAAAAAIQAAABgAAAAUAAAAwAMAANQIAABtHAAAsCUAABAAAAAmAAAACAAAAAGAAAAAAAAA"/>
+                <pr:smNativeData xmlns:pr="smNativeData" xmlns="smNativeData" val="SMDATA_15_MvzhaRMAAAAlAAAAZAAAAA8BAAAAkAAAAEgAAACQAAAASAAAAAAAAAAAAAAAAAAAAAEAAABQAAAAAAAAAAAA4D8AAAAAAADgPwAAAAAAAOA/AAAAAAAA4D8AAAAAAADgPwAAAAAAAOA/AAAAAAAA4D8AAAAAAADgPwAAAAAAAOA/AAAAAAAA4D8CAAAAjAAAAAAAAAAAAAAAu+DjDP///wgAAAAAAAAAAAAAAAAAAAAAAAAAAAAAAAAAAAAAZAAAAAEAAABAAAAAAAAAAAAAAAAAAAAAAAAAAAAAAAAAAAAAAAAAAAAAAAAAAAAAAAAAAAAAAAAAAAAAAAAAAAAAAAAAAAAAAAAAAAAAAAAAAAAAAAAAAAAAAAAAAAAAFAAAADwAAAAAAAAAAAAAAAAAAAkUAAAAAQAAABQAAAAUAAAAFAAAAAEAAAAAAAAAZAAAAGQAAAAAAAAAZAAAAGQAAAAVAAAAYAAAAAAAAAAAAAAADwAAACADAAAAAAAAAAAAAAEAAACgMgAAVgcAAKr4//8BAAAAf39/AAEAAABkAAAAAAAAABQAAABAHwAAAAAAACYAAAAAAAAAwOD//wAAAAAmAAAAZAAAABYAAABMAAAAAAAAAAAAAAAEAAAAAAAAAAEAAACAgIAKAAAAACgAAAAoAAAAZAAAAGQAAAAAAAAAzMzMAAAAAABQAAAAUAAAAGQAAABkAAAAAAAAABcAAAAUAAAAAAAAAAAAAAD/fwAA/38AAAAAAAAJAAAABAAAAAAAAAAeAAAAaAAAAAAAAAAAAAAAAAAAAAAAAAAAAAAAECcAABAnAAAAAAAAAAAAAAAAAAAAAAAAAAAAAAAAAAAAAAAAAAAAABQAAAAAAAAAwMD/AAAAAABkAAAAMgAAAAAAAABkAAAAAAAAAH9/fwAKAAAAIgAAABgAAAAAAAAAAAAAAAAAAAAAAAAAAAAAAAAAAAAkAAAAJAAAAAAAAAAHAAAAAAAAAAAAAAAAAAAAAAAAAAAAAAAAAAAAf39/ACUAAABYAAAAAAAAAAAAAAAAAAAAAAAAAAAAAAAAAAAAAAAAAAAAAAAAAAAAAAAAAAAAAAA/AAAAAAAAAKCGAQAAAAAAAAAAAAAAAAAMAAAAAQAAAAAAAAAAAAAAAAAAAB8AAABUAAAAAAAABQAAAAEAAAAAAAAAAAAAAAAAAAAAAAAAAAAAAAAAAAAAAAAAAAAAAAJ/f38AAAAAA8zMzADAwP8Af39/AAAAAAAAAAAAAAAAAAAAAAAAAAAAIQAAABgAAAAUAAAAwAMAANQIAABtHAAAsCUAABAAAAAmAAAACAAAAAGAAAAAAAAA"/>
               </a:ext>
             </a:extLst>
           </p:cNvSpPr>
@@ -2390,7 +2390,7 @@
             <a:spLocks noGrp="1" noChangeArrowheads="1"/>
             <a:extLst>
               <a:ext uri="smNativeData">
-                <pr:smNativeData xmlns:pr="smNativeData" xmlns="smNativeData" val="SMDATA_15_ZqHWaRMAAAAlAAAAZAAAAA8BAAAAkAAAAEgAAACQAAAASAAAAAAAAAABAAAAAAAAAAEAAABQAAAAAAAAAAAA4D8AAAAAAADgPwAAAAAAAOA/AAAAAAAA4D8AAAAAAADgPwAAAAAAAOA/AAAAAAAA4D8AAAAAAADgPwAAAAAAAOA/AAAAAAAA4D8CAAAAjAAAAAAAAAAAAAAAu+DjDP///wgAAAAAAAAAAAAAAAAAAAAAAAAAAAAAAAAAAAAAZAAAAAEAAABAAAAAAAAAAAAAAAAAAAAAAAAAAAAAAAAAAAAAAAAAAAAAAAAAAAAAAAAAAAAAAAAAAAAAAAAAAAAAAAAAAAAAAAAAAAAAAAAAAAAAAAAAAAAAAAAAAAAAFAAAADwAAAAAAAAAAAAAAAAAAAkUAAAAAQAAABQAAAAUAAAAFAAAAAEAAAAAAAAAZAAAAGQAAAAAAAAAZAAAAGQAAAAVAAAAYAAAAAAAAAAAAAAADwAAACADAAAAAAAAAAAAAAEAAACgMgAAVgcAAKr4//8BAAAAf39/AAEAAABkAAAAAAAAABQAAABAHwAAAAAAACYAAAAAAAAAwOD//wAAAAAmAAAAZAAAABYAAABMAAAAAAAAAAAAAAAEAAAAAAAAAAEAAACAgIAKAAAAACgAAAAoAAAAZAAAAGQAAAAAAAAAzMzMAAAAAABQAAAAUAAAAGQAAABkAAAAAAAAABcAAAAUAAAAAAAAAAAAAAD/fwAA/38AAAAAAAAJAAAABAAAAAAAAAAeAAAAaAAAAAAAAAAAAAAAAAAAAAAAAAAAAAAAECcAABAnAAAAAAAAAAAAAAAAAAAAAAAAAAAAAAAAAAAAAAAAAAAAABQAAAAAAAAAwMD/AAAAAABkAAAAMgAAAAAAAABkAAAAAAAAAH9/fwAKAAAAIgAAABgAAAAAAAAAAAAAAAAAAAAAAAAAAAAAAAAAAAAkAAAAJAAAAAAAAAAHAAAAAAAAAAAAAAAAAAAAAAAAAAAAAAAAAAAAf39/ACUAAABYAAAAAAAAAAAAAAAAAAAAAAAAAAAAAAAAAAAAAAAAAAAAAAAAAAAAAAAAAAAAAAA/AAAAAAAAAKCGAQAAAAAAAAAAAAAAAAAMAAAAAQAAAAAAAAAAAAAAAAAAAB8AAABUAAAAAAAABQAAAAEAAAAAAAAAAAAAAAAAAAAAAAAAAAAAAAAAAAAAAAAAAAAAAAJ/f38AAAAAA8zMzADAwP8Af39/AAAAAAAAAAAAAAAAAAAAAAAAAAAAIQAAABgAAAAUAAAAwAMAABsnAAA/FQAAWSkAABAAAAAmAAAACAAAAAAAAAAAAAAA"/>
+                <pr:smNativeData xmlns:pr="smNativeData" xmlns="smNativeData" val="SMDATA_15_MvzhaRMAAAAlAAAAZAAAAA8BAAAAkAAAAEgAAACQAAAASAAAAAAAAAABAAAAAAAAAAEAAABQAAAAAAAAAAAA4D8AAAAAAADgPwAAAAAAAOA/AAAAAAAA4D8AAAAAAADgPwAAAAAAAOA/AAAAAAAA4D8AAAAAAADgPwAAAAAAAOA/AAAAAAAA4D8CAAAAjAAAAAAAAAAAAAAAu+DjDP///wgAAAAAAAAAAAAAAAAAAAAAAAAAAAAAAAAAAAAAZAAAAAEAAABAAAAAAAAAAAAAAAAAAAAAAAAAAAAAAAAAAAAAAAAAAAAAAAAAAAAAAAAAAAAAAAAAAAAAAAAAAAAAAAAAAAAAAAAAAAAAAAAAAAAAAAAAAAAAAAAAAAAAFAAAADwAAAAAAAAAAAAAAAAAAAkUAAAAAQAAABQAAAAUAAAAFAAAAAEAAAAAAAAAZAAAAGQAAAAAAAAAZAAAAGQAAAAVAAAAYAAAAAAAAAAAAAAADwAAACADAAAAAAAAAAAAAAEAAACgMgAAVgcAAKr4//8BAAAAf39/AAEAAABkAAAAAAAAABQAAABAHwAAAAAAACYAAAAAAAAAwOD//wAAAAAmAAAAZAAAABYAAABMAAAAAAAAAAAAAAAEAAAAAAAAAAEAAACAgIAKAAAAACgAAAAoAAAAZAAAAGQAAAAAAAAAzMzMAAAAAABQAAAAUAAAAGQAAABkAAAAAAAAABcAAAAUAAAAAAAAAAAAAAD/fwAA/38AAAAAAAAJAAAABAAAAAAAAAAeAAAAaAAAAAAAAAAAAAAAAAAAAAAAAAAAAAAAECcAABAnAAAAAAAAAAAAAAAAAAAAAAAAAAAAAAAAAAAAAAAAAAAAABQAAAAAAAAAwMD/AAAAAABkAAAAMgAAAAAAAABkAAAAAAAAAH9/fwAKAAAAIgAAABgAAAAAAAAAAAAAAAAAAAAAAAAAAAAAAAAAAAAkAAAAJAAAAAAAAAAHAAAAAAAAAAAAAAAAAAAAAAAAAAAAAAAAAAAAf39/ACUAAABYAAAAAAAAAAAAAAAAAAAAAAAAAAAAAAAAAAAAAAAAAAAAAAAAAAAAAAAAAAAAAAA/AAAAAAAAAKCGAQAAAAAAAAAAAAAAAAAMAAAAAQAAAAAAAAAAAAAAAAAAAB8AAABUAAAAAAAABQAAAAEAAAAAAAAAAAAAAAAAAAAAAAAAAAAAAAAAAAAAAAAAAAAAAAJ/f38AAAAAA8zMzADAwP8Af39/AAAAAAAAAAAAAAAAAAAAAAAAAAAAIQAAABgAAAAUAAAAwAMAABsnAAA/FQAAWSkAABAAAAAmAAAACAAAAAAAAAAAAAAA"/>
               </a:ext>
             </a:extLst>
           </p:cNvSpPr>
@@ -2404,7 +2404,7 @@
           <a:lstStyle/>
           <a:p>
             <a:pPr/>
-            <a:fld id="{5FD72428-66B2-82D2-FC6F-90876A210AC5}" type="datetime1">
+            <a:fld id="{40F03639-77AD-A5C0-E348-8195780615D4}" type="datetime1">
               <a:t/>
             </a:fld>
           </a:p>
@@ -2417,7 +2417,7 @@
             <a:spLocks noGrp="1" noChangeArrowheads="1"/>
             <a:extLst>
               <a:ext uri="smNativeData">
-                <pr:smNativeData xmlns:pr="smNativeData" xmlns="smNativeData" val="SMDATA_15_ZqHWaRMAAAAlAAAAZAAAAA8BAAAAkAAAAEgAAACQAAAASAAAAAAAAAABAAAAAAAAAAEAAABQAAAAAAAAAAAA4D8AAAAAAADgPwAAAAAAAOA/AAAAAAAA4D8AAAAAAADgPwAAAAAAAOA/AAAAAAAA4D8AAAAAAADgPwAAAAAAAOA/AAAAAAAA4D8CAAAAjAAAAAAAAAAAAAAAu+DjDP///wgAAAAAAAAAAAAAAAAAAAAAAAAAAAAAAAAAAAAAZAAAAAEAAABAAAAAAAAAAAAAAAAAAAAAAAAAAAAAAAAAAAAAAAAAAAAAAAAAAAAAAAAAAAAAAAAAAAAAAAAAAAAAAAAAAAAAAAAAAAAAAAAAAAAAAAAAAAAAAAAAAAAAFAAAADwAAAAAAAAAAAAAAAAAAAkUAAAAAQAAABQAAAAUAAAAFAAAAAEAAAAAAAAAZAAAAGQAAAAAAAAAZAAAAGQAAAAVAAAAYAAAAAAAAAAAAAAADwAAACADAAAAAAAAAAAAAAEAAACgMgAAVgcAAKr4//8BAAAAf39/AAEAAABkAAAAAAAAABQAAABAHwAAAAAAACYAAAAAAAAAwOD//wAAAAAmAAAAZAAAABYAAABMAAAAAAAAAAAAAAAEAAAAAAAAAAEAAACAgIAKAAAAACgAAAAoAAAAZAAAAGQAAAAAAAAAzMzMAAAAAABQAAAAUAAAAGQAAABkAAAAAAAAABcAAAAUAAAAAAAAAAAAAAD/fwAA/38AAAAAAAAJAAAABAAAAHNwY0IeAAAAaAAAAAAAAAAAAAAAAAAAAAAAAAAAAAAAECcAABAnAAAAAAAAAAAAAAAAAAAAAAAAAAAAAAAAAAAAAAAAAAAAABQAAAAAAAAAwMD/AAAAAABkAAAAMgAAAAAAAABkAAAAAAAAAH9/fwAKAAAAIgAAABgAAAAAAAAAAAAAAAAAAAAAAAAAAAAAAAAAAAAkAAAAJAAAAAAAAAAHAAAAAAAAAAAAAAAAAAAAAAAAAAAAAAAAAAAAf39/ACUAAABYAAAAAAAAAAAAAAAAAAAAAAAAAAAAAAAAAAAAAAAAAAAAAAAAAAAAAAAAAAAAAAA/AAAAAAAAAKCGAQAAAAAAAAAAAAAAAAAMAAAAAQAAAAAAAAAAAAAAAAAAAB8AAABUAAAAAAAABQAAAAEAAAAAAAAAAAAAAAAAAAAAAAAAAAAAAAAAAAAAAAAAAAAAAAJ/f38AAAAAA8zMzADAwP8Af39/AAAAAAAAAAAAAAAAAAAAAAAAAAAAIQAAABgAAAAUAAAAoRkAABsnAABfMQAAWSkAABAAAAAmAAAACAAAAAAAAAAAAAAA"/>
+                <pr:smNativeData xmlns:pr="smNativeData" xmlns="smNativeData" val="SMDATA_15_MvzhaRMAAAAlAAAAZAAAAA8BAAAAkAAAAEgAAACQAAAASAAAAAAAAAABAAAAAAAAAAEAAABQAAAAAAAAAAAA4D8AAAAAAADgPwAAAAAAAOA/AAAAAAAA4D8AAAAAAADgPwAAAAAAAOA/AAAAAAAA4D8AAAAAAADgPwAAAAAAAOA/AAAAAAAA4D8CAAAAjAAAAAAAAAAAAAAAu+DjDP///wgAAAAAAAAAAAAAAAAAAAAAAAAAAAAAAAAAAAAAZAAAAAEAAABAAAAAAAAAAAAAAAAAAAAAAAAAAAAAAAAAAAAAAAAAAAAAAAAAAAAAAAAAAAAAAAAAAAAAAAAAAAAAAAAAAAAAAAAAAAAAAAAAAAAAAAAAAAAAAAAAAAAAFAAAADwAAAAAAAAAAAAAAAAAAAkUAAAAAQAAABQAAAAUAAAAFAAAAAEAAAAAAAAAZAAAAGQAAAAAAAAAZAAAAGQAAAAVAAAAYAAAAAAAAAAAAAAADwAAACADAAAAAAAAAAAAAAEAAACgMgAAVgcAAKr4//8BAAAAf39/AAEAAABkAAAAAAAAABQAAABAHwAAAAAAACYAAAAAAAAAwOD//wAAAAAmAAAAZAAAABYAAABMAAAAAAAAAAAAAAAEAAAAAAAAAAEAAACAgIAKAAAAACgAAAAoAAAAZAAAAGQAAAAAAAAAzMzMAAAAAABQAAAAUAAAAGQAAABkAAAAAAAAABcAAAAUAAAAAAAAAAAAAAD/fwAA/38AAAAAAAAJAAAABAAAAHNwY0IeAAAAaAAAAAAAAAAAAAAAAAAAAAAAAAAAAAAAECcAABAnAAAAAAAAAAAAAAAAAAAAAAAAAAAAAAAAAAAAAAAAAAAAABQAAAAAAAAAwMD/AAAAAABkAAAAMgAAAAAAAABkAAAAAAAAAH9/fwAKAAAAIgAAABgAAAAAAAAAAAAAAAAAAAAAAAAAAAAAAAAAAAAkAAAAJAAAAAAAAAAHAAAAAAAAAAAAAAAAAAAAAAAAAAAAAAAAAAAAf39/ACUAAABYAAAAAAAAAAAAAAAAAAAAAAAAAAAAAAAAAAAAAAAAAAAAAAAAAAAAAAAAAAAAAAA/AAAAAAAAAKCGAQAAAAAAAAAAAAAAAAAMAAAAAQAAAAAAAAAAAAAAAAAAAB8AAABUAAAAAAAABQAAAAEAAAAAAAAAAAAAAAAAAAAAAAAAAAAAAAAAAAAAAAAAAAAAAAJ/f38AAAAAA8zMzADAwP8Af39/AAAAAAAAAAAAAAAAAAAAAAAAAAAAIQAAABgAAAAUAAAAoRkAABsnAABfMQAAWSkAABAAAAAmAAAACAAAAAAAAAAAAAAA"/>
               </a:ext>
             </a:extLst>
           </p:cNvSpPr>
@@ -2441,7 +2441,7 @@
             <a:spLocks noGrp="1" noChangeArrowheads="1"/>
             <a:extLst>
               <a:ext uri="smNativeData">
-                <pr:smNativeData xmlns:pr="smNativeData" xmlns="smNativeData" val="SMDATA_15_ZqHWaRMAAAAlAAAAZAAAAA8BAAAAkAAAAEgAAACQAAAASAAAAAAAAAABAAAAAAAAAAEAAABQAAAAAAAAAAAA4D8AAAAAAADgPwAAAAAAAOA/AAAAAAAA4D8AAAAAAADgPwAAAAAAAOA/AAAAAAAA4D8AAAAAAADgPwAAAAAAAOA/AAAAAAAA4D8CAAAAjAAAAAAAAAAAAAAAu+DjDP///wgAAAAAAAAAAAAAAAAAAAAAAAAAAAAAAAAAAAAAZAAAAAEAAABAAAAAAAAAAAAAAAAAAAAAAAAAAAAAAAAAAAAAAAAAAAAAAAAAAAAAAAAAAAAAAAAAAAAAAAAAAAAAAAAAAAAAAAAAAAAAAAAAAAAAAAAAAAAAAAAAAAAAFAAAADwAAAAAAAAAAAAAAAAAAAkUAAAAAQAAABQAAAAUAAAAFAAAAAEAAAAAAAAAZAAAAGQAAAAAAAAAZAAAAGQAAAAVAAAAYAAAAAAAAAAAAAAADwAAACADAAAAAAAAAAAAAAEAAACgMgAAVgcAAKr4//8BAAAAf39/AAEAAABkAAAAAAAAABQAAABAHwAAAAAAACYAAAAAAAAAwOD//wAAAAAmAAAAZAAAABYAAABMAAAAAAAAAAAAAAAEAAAAAAAAAAEAAACAgIAKAAAAACgAAAAoAAAAZAAAAGQAAAAAAAAAzMzMAAAAAABQAAAAUAAAAGQAAABkAAAAAAAAABcAAAAUAAAAAAAAAAAAAAD/fwAA/38AAAAAAAAJAAAABAAAAAAAAAAeAAAAaAAAAAAAAAAAAAAAAAAAAAAAAAAAAAAAECcAABAnAAAAAAAAAAAAAAAAAAAAAAAAAAAAAAAAAAAAAAAAAAAAABQAAAAAAAAAwMD/AAAAAABkAAAAMgAAAAAAAABkAAAAAAAAAH9/fwAKAAAAIgAAABgAAAAAAAAAAAAAAAAAAAAAAAAAAAAAAAAAAAAkAAAAJAAAAAAAAAAHAAAAAAAAAAAAAAAAAAAAAAAAAAAAAAAAAAAAf39/ACUAAABYAAAAAAAAAAAAAAAAAAAAAAAAAAAAAAAAAAAAAAAAAAAAAAAAAAAAAAAAAAAAAAA/AAAAAAAAAKCGAQAAAAAAAAAAAAAAAAAMAAAAAQAAAAAAAAAAAAAAAAAAAB8AAABUAAAAAAAABQAAAAEAAAAAAAAAAAAAAAAAAAAAAAAAAAAAAAAAAAAAAAAAAAAAAAJ/f38AAAAAA8zMzADAwP8Af39/AAAAAAAAAAAAAAAAAAAAAAAAAAAAIQAAABgAAAAUAAAAwTUAABsnAABARwAAWSkAABAAAAAmAAAACAAAAAAAAAAAAAAA"/>
+                <pr:smNativeData xmlns:pr="smNativeData" xmlns="smNativeData" val="SMDATA_15_MvzhaRMAAAAlAAAAZAAAAA8BAAAAkAAAAEgAAACQAAAASAAAAAAAAAABAAAAAAAAAAEAAABQAAAAAAAAAAAA4D8AAAAAAADgPwAAAAAAAOA/AAAAAAAA4D8AAAAAAADgPwAAAAAAAOA/AAAAAAAA4D8AAAAAAADgPwAAAAAAAOA/AAAAAAAA4D8CAAAAjAAAAAAAAAAAAAAAu+DjDP///wgAAAAAAAAAAAAAAAAAAAAAAAAAAAAAAAAAAAAAZAAAAAEAAABAAAAAAAAAAAAAAAAAAAAAAAAAAAAAAAAAAAAAAAAAAAAAAAAAAAAAAAAAAAAAAAAAAAAAAAAAAAAAAAAAAAAAAAAAAAAAAAAAAAAAAAAAAAAAAAAAAAAAFAAAADwAAAAAAAAAAAAAAAAAAAkUAAAAAQAAABQAAAAUAAAAFAAAAAEAAAAAAAAAZAAAAGQAAAAAAAAAZAAAAGQAAAAVAAAAYAAAAAAAAAAAAAAADwAAACADAAAAAAAAAAAAAAEAAACgMgAAVgcAAKr4//8BAAAAf39/AAEAAABkAAAAAAAAABQAAABAHwAAAAAAACYAAAAAAAAAwOD//wAAAAAmAAAAZAAAABYAAABMAAAAAAAAAAAAAAAEAAAAAAAAAAEAAACAgIAKAAAAACgAAAAoAAAAZAAAAGQAAAAAAAAAzMzMAAAAAABQAAAAUAAAAGQAAABkAAAAAAAAABcAAAAUAAAAAAAAAAAAAAD/fwAA/38AAAAAAAAJAAAABAAAAAAAAAAeAAAAaAAAAAAAAAAAAAAAAAAAAAAAAAAAAAAAECcAABAnAAAAAAAAAAAAAAAAAAAAAAAAAAAAAAAAAAAAAAAAAAAAABQAAAAAAAAAwMD/AAAAAABkAAAAMgAAAAAAAABkAAAAAAAAAH9/fwAKAAAAIgAAABgAAAAAAAAAAAAAAAAAAAAAAAAAAAAAAAAAAAAkAAAAJAAAAAAAAAAHAAAAAAAAAAAAAAAAAAAAAAAAAAAAAAAAAAAAf39/ACUAAABYAAAAAAAAAAAAAAAAAAAAAAAAAAAAAAAAAAAAAAAAAAAAAAAAAAAAAAAAAAAAAAA/AAAAAAAAAKCGAQAAAAAAAAAAAAAAAAAMAAAAAQAAAAAAAAAAAAAAAAAAAB8AAABUAAAAAAAABQAAAAEAAAAAAAAAAAAAAAAAAAAAAAAAAAAAAAAAAAAAAAAAAAAAAAJ/f38AAAAAA8zMzADAwP8Af39/AAAAAAAAAAAAAAAAAAAAAAAAAAAAIQAAABgAAAAUAAAAwTUAABsnAABARwAAWSkAABAAAAAmAAAACAAAAAAAAAAAAAAA"/>
               </a:ext>
             </a:extLst>
           </p:cNvSpPr>
@@ -2455,7 +2455,7 @@
           <a:lstStyle/>
           <a:p>
             <a:pPr/>
-            <a:fld id="{118205C8-86FC-D7F3-B23A-70A64B744425}" type="slidenum">
+            <a:fld id="{179AA0A4-EAFA-CF56-B422-1C03EE6C4249}" type="slidenum">
               <a:t/>
             </a:fld>
           </a:p>
@@ -2494,7 +2494,7 @@
             <a:spLocks noGrp="1" noChangeArrowheads="1"/>
             <a:extLst>
               <a:ext uri="smNativeData">
-                <pr:smNativeData xmlns:pr="smNativeData" xmlns="smNativeData" val="SMDATA_15_ZqHWaRMAAAAlAAAAZAAAAA8BAAAAkAAAAEgAAACQAAAASAAAAAAAAAACAAAAAAAAAAEAAABQAAAAAAAAAAAA4D8AAAAAAADgPwAAAAAAAOA/AAAAAAAA4D8AAAAAAADgPwAAAAAAAOA/AAAAAAAA4D8AAAAAAADgPwAAAAAAAOA/AAAAAAAA4D8CAAAAjAAAAAAAAAAAAAAAu+DjDP///wgAAAAAAAAAAAAAAAAAAAAAAAAAAAAAAAAAAAAAZAAAAAEAAABAAAAAAAAAAAAAAAAAAAAAAAAAAAAAAAAAAAAAAAAAAAAAAAAAAAAAAAAAAAAAAAAAAAAAAAAAAAAAAAAAAAAAAAAAAAAAAAAAAAAAAAAAAAAAAAAAAAAAFAAAADwAAAAAAAAAAAAAAAAAAAkUAAAAAQAAABQAAAAUAAAAFAAAAAEAAAAAAAAAZAAAAGQAAAAAAAAAZAAAAGQAAAAVAAAAYAAAAAAAAAAAAAAADwAAACADAAAAAAAAAAAAAAEAAACgMgAAVgcAAKr4//8BAAAAf39/AAEAAABkAAAAAAAAABQAAABAHwAAAAAAACYAAAAAAAAAwOD//wAAAAAmAAAAZAAAABYAAABMAAAAAAAAAAAAAAAEAAAAAAAAAAEAAACAgIAKAAAAACgAAAAoAAAAZAAAAGQAAAAAAAAAzMzMAAAAAABQAAAAUAAAAGQAAABkAAAAAAAAABcAAAAUAAAAAAAAAAAAAAD/fwAA/38AAAAAAAAJAAAABAAAAAAAAAAeAAAAaAAAAAAAAAAAAAAAAAAAAAAAAAAAAAAAECcAABAnAAAAAAAAAAAAAAAAAAAAAAAAAAAAAAAAAAAAAAAAAAAAABQAAAAAAAAAwMD/AAAAAABkAAAAMgAAAAAAAABkAAAAAAAAAH9/fwAKAAAAIgAAABgAAAAAAAAAAAAAAAAAAAAAAAAAAAAAAAAAAAAkAAAAJAAAAAAAAAAHAAAAAAAAAAAAAAAAAAAAAAAAAAAAAAAAAAAAf39/ACUAAABYAAAAAAAAAAAAAAAAAAAAAAAAAAAAAAAAAAAAAAAAAAAAAAAAAAAAAAAAAAAAAAA/AAAAAAAAAKCGAQAAAAAAAAAAAAAAAAAMAAAAAQAAAAAAAAAAAAAAAAAAAB8AAABUAAAAAAAABQAAAAEAAAAAAAAAAAAAAAAAAAAAAAAAAAAAAAAAAAAAAAAAAAAAAAJ/f38AAAAAA8zMzADAwP8Af39/AAAAAAAAAAAAAAAAAAAAAAAAAAAAIQAAABgAAAAUAAAAsw4AAIgdAACzOwAABCEAABAAAAAmAAAACAAAAIGAAAAAAAAA"/>
+                <pr:smNativeData xmlns:pr="smNativeData" xmlns="smNativeData" val="SMDATA_15_MvzhaRMAAAAlAAAAZAAAAA8BAAAAkAAAAEgAAACQAAAASAAAAAAAAAACAAAAAAAAAAEAAABQAAAAAAAAAAAA4D8AAAAAAADgPwAAAAAAAOA/AAAAAAAA4D8AAAAAAADgPwAAAAAAAOA/AAAAAAAA4D8AAAAAAADgPwAAAAAAAOA/AAAAAAAA4D8CAAAAjAAAAAAAAAAAAAAAu+DjDP///wgAAAAAAAAAAAAAAAAAAAAAAAAAAAAAAAAAAAAAZAAAAAEAAABAAAAAAAAAAAAAAAAAAAAAAAAAAAAAAAAAAAAAAAAAAAAAAAAAAAAAAAAAAAAAAAAAAAAAAAAAAAAAAAAAAAAAAAAAAAAAAAAAAAAAAAAAAAAAAAAAAAAAFAAAADwAAAAAAAAAAAAAAAAAAAkUAAAAAQAAABQAAAAUAAAAFAAAAAEAAAAAAAAAZAAAAGQAAAAAAAAAZAAAAGQAAAAVAAAAYAAAAAAAAAAAAAAADwAAACADAAAAAAAAAAAAAAEAAACgMgAAVgcAAKr4//8BAAAAf39/AAEAAABkAAAAAAAAABQAAABAHwAAAAAAACYAAAAAAAAAwOD//wAAAAAmAAAAZAAAABYAAABMAAAAAAAAAAAAAAAEAAAAAAAAAAEAAACAgIAKAAAAACgAAAAoAAAAZAAAAGQAAAAAAAAAzMzMAAAAAABQAAAAUAAAAGQAAABkAAAAAAAAABcAAAAUAAAAAAAAAAAAAAD/fwAA/38AAAAAAAAJAAAABAAAAAAAAAAeAAAAaAAAAAAAAAAAAAAAAAAAAAAAAAAAAAAAECcAABAnAAAAAAAAAAAAAAAAAAAAAAAAAAAAAAAAAAAAAAAAAAAAABQAAAAAAAAAwMD/AAAAAABkAAAAMgAAAAAAAABkAAAAAAAAAH9/fwAKAAAAIgAAABgAAAAAAAAAAAAAAAAAAAAAAAAAAAAAAAAAAAAkAAAAJAAAAAAAAAAHAAAAAAAAAAAAAAAAAAAAAAAAAAAAAAAAAAAAf39/ACUAAABYAAAAAAAAAAAAAAAAAAAAAAAAAAAAAAAAAAAAAAAAAAAAAAAAAAAAAAAAAAAAAAA/AAAAAAAAAKCGAQAAAAAAAAAAAAAAAAAMAAAAAQAAAAAAAAAAAAAAAAAAAB8AAABUAAAAAAAABQAAAAEAAAAAAAAAAAAAAAAAAAAAAAAAAAAAAAAAAAAAAAAAAAAAAAJ/f38AAAAAA8zMzADAwP8Af39/AAAAAAAAAAAAAAAAAAAAAAAAAAAAIQAAABgAAAAUAAAAsw4AAIgdAACzOwAABCEAABAAAAAmAAAACAAAAIGAAAAAAAAA"/>
               </a:ext>
             </a:extLst>
           </p:cNvSpPr>
@@ -2534,7 +2534,7 @@
             <a:spLocks noGrp="1" noChangeArrowheads="1"/>
             <a:extLst>
               <a:ext uri="smNativeData">
-                <pr:smNativeData xmlns:pr="smNativeData" xmlns="smNativeData" val="SMDATA_15_ZqHWaRMAAAAlAAAAZAAAAA8BAAAAkAAAAEgAAACQAAAASAAAAAAAAAAAAAAAAAAAAAEAAABQAAAAAAAAAAAA4D8AAAAAAADgPwAAAAAAAOA/AAAAAAAA4D8AAAAAAADgPwAAAAAAAOA/AAAAAAAA4D8AAAAAAADgPwAAAAAAAOA/AAAAAAAA4D8CAAAAjAAAAAAAAAAAAAAAu+DjDP///wgAAAAAAAAAAAAAAAAAAAAAAAAAAAAAAAAAAAAAZAAAAAEAAABAAAAAAAAAAAAAAAAAAAAAAAAAAAAAAAAAAAAAAAAAAAAAAAAAAAAAAAAAAAAAAAAAAAAAAAAAAAAAAAAAAAAAAAAAAAAAAAAAAAAAAAAAAAAAAAAAAAAAFAAAADwAAAAAAAAAAAAAAAAAAAkUAAAAAQAAABQAAAAUAAAAFAAAAAEAAAAAAAAAZAAAAGQAAAAAAAAAZAAAAGQAAAAVAAAAYAAAAAAAAAAAAAAADwAAACADAAAAAAAAAAAAAAEAAACgMgAAVgcAAKr4//8BAAAAf39/AAEAAABkAAAAAAAAABQAAABAHwAAAAAAACYAAAAAAAAAwOD//wAAAAAmAAAAZAAAABYAAABMAAAAAAAAAAAAAAAEAAAAAAAAAAEAAACAgIAKAAAAACgAAAAoAAAAZAAAAGQAAAAAAAAAzMzMAAAAAABQAAAAUAAAAGQAAABkAAAAAAAAABcAAAAUAAAAAAAAAAAAAAD/fwAA/38AAAAAAAAJAAAABAAAAAAAAAAeAAAAaAAAAAAAAAAAAAAAAAAAAAAAAAAAAAAAECcAABAnAAAAAAAAAAAAAAAAAAAAAAAAAAAAAAAAAAAAAAAAAAAAABQAAAAAAAAAwMD/AAAAAABkAAAAMgAAAAAAAABkAAAAAAAAAH9/fwAKAAAAIgAAABgAAAAAAAAAAAAAAAAAAAAAAAAAAAAAAAAAAAAkAAAAJAAAAAAAAAAHAAAAAAAAAAAAAAAAAAAAAAAAAAAAAAAAAAAAf39/ACUAAABYAAAAAAAAAAAAAAAAAAAAAAAAAAAAAAAAAAAAAAAAAAAAAAAAAAAAAAAAAAAAAAA/AAAAAAAAAKCGAQAAAAAAAAAAAAAAAAAMAAAAAQAAAAAAAAAAAAAAAAAAAB8AAABUAAAAAAAABQAAAAEAAAAAAAAAAAAAAAAAAAAAAAAAAAAAAAAAAAAAAAAAAAAAAAJ/f38AAAAAA8zMzADAwP8Af39/AAAAAAAAAAAAAAAAAAAAAAAAAAAAIQAAABgAAAAUAAAAsw4AAMYDAACzOwAAFh0AABAAAAAmAAAACAAAAAGAAAAAAAAA"/>
+                <pr:smNativeData xmlns:pr="smNativeData" xmlns="smNativeData" val="SMDATA_15_MvzhaRMAAAAlAAAAZAAAAA8BAAAAkAAAAEgAAACQAAAASAAAAAAAAAAAAAAAAAAAAAEAAABQAAAAAAAAAAAA4D8AAAAAAADgPwAAAAAAAOA/AAAAAAAA4D8AAAAAAADgPwAAAAAAAOA/AAAAAAAA4D8AAAAAAADgPwAAAAAAAOA/AAAAAAAA4D8CAAAAjAAAAAAAAAAAAAAAu+DjDP///wgAAAAAAAAAAAAAAAAAAAAAAAAAAAAAAAAAAAAAZAAAAAEAAABAAAAAAAAAAAAAAAAAAAAAAAAAAAAAAAAAAAAAAAAAAAAAAAAAAAAAAAAAAAAAAAAAAAAAAAAAAAAAAAAAAAAAAAAAAAAAAAAAAAAAAAAAAAAAAAAAAAAAFAAAADwAAAAAAAAAAAAAAAAAAAkUAAAAAQAAABQAAAAUAAAAFAAAAAEAAAAAAAAAZAAAAGQAAAAAAAAAZAAAAGQAAAAVAAAAYAAAAAAAAAAAAAAADwAAACADAAAAAAAAAAAAAAEAAACgMgAAVgcAAKr4//8BAAAAf39/AAEAAABkAAAAAAAAABQAAABAHwAAAAAAACYAAAAAAAAAwOD//wAAAAAmAAAAZAAAABYAAABMAAAAAAAAAAAAAAAEAAAAAAAAAAEAAACAgIAKAAAAACgAAAAoAAAAZAAAAGQAAAAAAAAAzMzMAAAAAABQAAAAUAAAAGQAAABkAAAAAAAAABcAAAAUAAAAAAAAAAAAAAD/fwAA/38AAAAAAAAJAAAABAAAAAAAAAAeAAAAaAAAAAAAAAAAAAAAAAAAAAAAAAAAAAAAECcAABAnAAAAAAAAAAAAAAAAAAAAAAAAAAAAAAAAAAAAAAAAAAAAABQAAAAAAAAAwMD/AAAAAABkAAAAMgAAAAAAAABkAAAAAAAAAH9/fwAKAAAAIgAAABgAAAAAAAAAAAAAAAAAAAAAAAAAAAAAAAAAAAAkAAAAJAAAAAAAAAAHAAAAAAAAAAAAAAAAAAAAAAAAAAAAAAAAAAAAf39/ACUAAABYAAAAAAAAAAAAAAAAAAAAAAAAAAAAAAAAAAAAAAAAAAAAAAAAAAAAAAAAAAAAAAA/AAAAAAAAAKCGAQAAAAAAAAAAAAAAAAAMAAAAAQAAAAAAAAAAAAAAAAAAAB8AAABUAAAAAAAABQAAAAEAAAAAAAAAAAAAAAAAAAAAAAAAAAAAAAAAAAAAAAAAAAAAAAJ/f38AAAAAA8zMzADAwP8Af39/AAAAAAAAAAAAAAAAAAAAAAAAAAAAIQAAABgAAAAUAAAAsw4AAMYDAACzOwAAFh0AABAAAAAmAAAACAAAAAGAAAAAAAAA"/>
               </a:ext>
             </a:extLst>
           </p:cNvSpPr>
@@ -2603,7 +2603,7 @@
             <a:spLocks noGrp="1" noChangeArrowheads="1"/>
             <a:extLst>
               <a:ext uri="smNativeData">
-                <pr:smNativeData xmlns:pr="smNativeData" xmlns="smNativeData" val="SMDATA_15_ZqHWaRMAAAAlAAAAZAAAAA8BAAAAkAAAAEgAAACQAAAASAAAAAAAAAAAAAAAAAAAAAEAAABQAAAAAAAAAAAA4D8AAAAAAADgPwAAAAAAAOA/AAAAAAAA4D8AAAAAAADgPwAAAAAAAOA/AAAAAAAA4D8AAAAAAADgPwAAAAAAAOA/AAAAAAAA4D8CAAAAjAAAAAAAAAAAAAAAu+DjDP///wgAAAAAAAAAAAAAAAAAAAAAAAAAAAAAAAAAAAAAZAAAAAEAAABAAAAAAAAAAAAAAAAAAAAAAAAAAAAAAAAAAAAAAAAAAAAAAAAAAAAAAAAAAAAAAAAAAAAAAAAAAAAAAAAAAAAAAAAAAAAAAAAAAAAAAAAAAAAAAAAAAAAAFAAAADwAAAAAAAAAAAAAAAAAAAkUAAAAAQAAABQAAAAUAAAAFAAAAAEAAAAAAAAAZAAAAGQAAAAAAAAAZAAAAGQAAAAVAAAAYAAAAAAAAAAAAAAADwAAACADAAAAAAAAAAAAAAEAAACgMgAAVgcAAKr4//8BAAAAf39/AAEAAABkAAAAAAAAABQAAABAHwAAAAAAACYAAAAAAAAAwOD//wAAAAAmAAAAZAAAABYAAABMAAAAAAAAAAAAAAAEAAAAAAAAAAEAAACAgIAKAAAAACgAAAAoAAAAZAAAAGQAAAAAAAAAzMzMAAAAAABQAAAAUAAAAGQAAABkAAAAAAAAABcAAAAUAAAAAAAAAAAAAAD/fwAA/38AAAAAAAAJAAAABAAAAAAAAAAeAAAAaAAAAAAAAAAAAAAAAAAAAAAAAAAAAAAAECcAABAnAAAAAAAAAAAAAAAAAAAAAAAAAAAAAAAAAAAAAAAAAAAAABQAAAAAAAAAwMD/AAAAAABkAAAAMgAAAAAAAABkAAAAAAAAAH9/fwAKAAAAIgAAABgAAAAAAAAAAAAAAAAAAAAAAAAAAAAAAAAAAAAkAAAAJAAAAAAAAAAHAAAAAAAAAAAAAAAAAAAAAAAAAAAAAAAAAAAAf39/ACUAAABYAAAAAAAAAAAAAAAAAAAAAAAAAAAAAAAAAAAAAAAAAAAAAAAAAAAAAAAAAAAAAAA/AAAAAAAAAKCGAQAAAAAAAAAAAAAAAAAMAAAAAQAAAAAAAAAAAAAAAAAAAB8AAABUAAAAAAAABQAAAAEAAAAAAAAAAAAAAAAAAAAAAAAAAAAAAAAAAAAAAAAAAAAAAAJ/f38AAAAAA8zMzADAwP8Af39/AAAAAAAAAAAAAAAAAAAAAAAAAAAAIQAAABgAAAAUAAAAsw4AAAQhAACzOwAA+CUAABAAAAAmAAAACAAAAAGAAAAAAAAA"/>
+                <pr:smNativeData xmlns:pr="smNativeData" xmlns="smNativeData" val="SMDATA_15_MvzhaRMAAAAlAAAAZAAAAA8BAAAAkAAAAEgAAACQAAAASAAAAAAAAAAAAAAAAAAAAAEAAABQAAAAAAAAAAAA4D8AAAAAAADgPwAAAAAAAOA/AAAAAAAA4D8AAAAAAADgPwAAAAAAAOA/AAAAAAAA4D8AAAAAAADgPwAAAAAAAOA/AAAAAAAA4D8CAAAAjAAAAAAAAAAAAAAAu+DjDP///wgAAAAAAAAAAAAAAAAAAAAAAAAAAAAAAAAAAAAAZAAAAAEAAABAAAAAAAAAAAAAAAAAAAAAAAAAAAAAAAAAAAAAAAAAAAAAAAAAAAAAAAAAAAAAAAAAAAAAAAAAAAAAAAAAAAAAAAAAAAAAAAAAAAAAAAAAAAAAAAAAAAAAFAAAADwAAAAAAAAAAAAAAAAAAAkUAAAAAQAAABQAAAAUAAAAFAAAAAEAAAAAAAAAZAAAAGQAAAAAAAAAZAAAAGQAAAAVAAAAYAAAAAAAAAAAAAAADwAAACADAAAAAAAAAAAAAAEAAACgMgAAVgcAAKr4//8BAAAAf39/AAEAAABkAAAAAAAAABQAAABAHwAAAAAAACYAAAAAAAAAwOD//wAAAAAmAAAAZAAAABYAAABMAAAAAAAAAAAAAAAEAAAAAAAAAAEAAACAgIAKAAAAACgAAAAoAAAAZAAAAGQAAAAAAAAAzMzMAAAAAABQAAAAUAAAAGQAAABkAAAAAAAAABcAAAAUAAAAAAAAAAAAAAD/fwAA/38AAAAAAAAJAAAABAAAAAAAAAAeAAAAaAAAAAAAAAAAAAAAAAAAAAAAAAAAAAAAECcAABAnAAAAAAAAAAAAAAAAAAAAAAAAAAAAAAAAAAAAAAAAAAAAABQAAAAAAAAAwMD/AAAAAABkAAAAMgAAAAAAAABkAAAAAAAAAH9/fwAKAAAAIgAAABgAAAAAAAAAAAAAAAAAAAAAAAAAAAAAAAAAAAAkAAAAJAAAAAAAAAAHAAAAAAAAAAAAAAAAAAAAAAAAAAAAAAAAAAAAf39/ACUAAABYAAAAAAAAAAAAAAAAAAAAAAAAAAAAAAAAAAAAAAAAAAAAAAAAAAAAAAAAAAAAAAA/AAAAAAAAAKCGAQAAAAAAAAAAAAAAAAAMAAAAAQAAAAAAAAAAAAAAAAAAAB8AAABUAAAAAAAABQAAAAEAAAAAAAAAAAAAAAAAAAAAAAAAAAAAAAAAAAAAAAAAAAAAAAJ/f38AAAAAA8zMzADAwP8Af39/AAAAAAAAAAAAAAAAAAAAAAAAAAAAIQAAABgAAAAUAAAAsw4AAAQhAACzOwAA+CUAABAAAAAmAAAACAAAAAGAAAAAAAAA"/>
               </a:ext>
             </a:extLst>
           </p:cNvSpPr>
@@ -2672,7 +2672,7 @@
             <a:spLocks noGrp="1" noChangeArrowheads="1"/>
             <a:extLst>
               <a:ext uri="smNativeData">
-                <pr:smNativeData xmlns:pr="smNativeData" xmlns="smNativeData" val="SMDATA_15_ZqHWaRMAAAAlAAAAZAAAAA8BAAAAkAAAAEgAAACQAAAASAAAAAAAAAABAAAAAAAAAAEAAABQAAAAAAAAAAAA4D8AAAAAAADgPwAAAAAAAOA/AAAAAAAA4D8AAAAAAADgPwAAAAAAAOA/AAAAAAAA4D8AAAAAAADgPwAAAAAAAOA/AAAAAAAA4D8CAAAAjAAAAAAAAAAAAAAAu+DjDP///wgAAAAAAAAAAAAAAAAAAAAAAAAAAAAAAAAAAAAAZAAAAAEAAABAAAAAAAAAAAAAAAAAAAAAAAAAAAAAAAAAAAAAAAAAAAAAAAAAAAAAAAAAAAAAAAAAAAAAAAAAAAAAAAAAAAAAAAAAAAAAAAAAAAAAAAAAAAAAAAAAAAAAFAAAADwAAAAAAAAAAAAAAAAAAAkUAAAAAQAAABQAAAAUAAAAFAAAAAEAAAAAAAAAZAAAAGQAAAAAAAAAZAAAAGQAAAAVAAAAYAAAAAAAAAAAAAAADwAAACADAAAAAAAAAAAAAAEAAACgMgAAVgcAAKr4//8BAAAAf39/AAEAAABkAAAAAAAAABQAAABAHwAAAAAAACYAAAAAAAAAwOD//wAAAAAmAAAAZAAAABYAAABMAAAAAAAAAAAAAAAEAAAAAAAAAAEAAACAgIAKAAAAACgAAAAoAAAAZAAAAGQAAAAAAAAAzMzMAAAAAABQAAAAUAAAAGQAAABkAAAAAAAAABcAAAAUAAAAAAAAAAAAAAD/fwAA/38AAAAAAAAJAAAABAAAAAAAAAAeAAAAaAAAAAAAAAAAAAAAAAAAAAAAAAAAAAAAECcAABAnAAAAAAAAAAAAAAAAAAAAAAAAAAAAAAAAAAAAAAAAAAAAABQAAAAAAAAAwMD/AAAAAABkAAAAMgAAAAAAAABkAAAAAAAAAH9/fwAKAAAAIgAAABgAAAAAAAAAAAAAAAAAAAAAAAAAAAAAAAAAAAAkAAAAJAAAAAAAAAAHAAAAAAAAAAAAAAAAAAAAAAAAAAAAAAAAAAAAf39/ACUAAABYAAAAAAAAAAAAAAAAAAAAAAAAAAAAAAAAAAAAAAAAAAAAAAAAAAAAAAAAAAAAAAA/AAAAAAAAAKCGAQAAAAAAAAAAAAAAAAAMAAAAAQAAAAAAAAAAAAAAAAAAAB8AAABUAAAAAAAABQAAAAEAAAAAAAAAAAAAAAAAAAAAAAAAAAAAAAAAAAAAAAAAAAAAAAJ/f38AAAAAA8zMzADAwP8Af39/AAAAAAAAAAAAAAAAAAAAAAAAAAAAIQAAABgAAAAUAAAAwAMAABsnAAA/FQAAWSkAABAAAAAmAAAACAAAAAAAAAAAAAAA"/>
+                <pr:smNativeData xmlns:pr="smNativeData" xmlns="smNativeData" val="SMDATA_15_MvzhaRMAAAAlAAAAZAAAAA8BAAAAkAAAAEgAAACQAAAASAAAAAAAAAABAAAAAAAAAAEAAABQAAAAAAAAAAAA4D8AAAAAAADgPwAAAAAAAOA/AAAAAAAA4D8AAAAAAADgPwAAAAAAAOA/AAAAAAAA4D8AAAAAAADgPwAAAAAAAOA/AAAAAAAA4D8CAAAAjAAAAAAAAAAAAAAAu+DjDP///wgAAAAAAAAAAAAAAAAAAAAAAAAAAAAAAAAAAAAAZAAAAAEAAABAAAAAAAAAAAAAAAAAAAAAAAAAAAAAAAAAAAAAAAAAAAAAAAAAAAAAAAAAAAAAAAAAAAAAAAAAAAAAAAAAAAAAAAAAAAAAAAAAAAAAAAAAAAAAAAAAAAAAFAAAADwAAAAAAAAAAAAAAAAAAAkUAAAAAQAAABQAAAAUAAAAFAAAAAEAAAAAAAAAZAAAAGQAAAAAAAAAZAAAAGQAAAAVAAAAYAAAAAAAAAAAAAAADwAAACADAAAAAAAAAAAAAAEAAACgMgAAVgcAAKr4//8BAAAAf39/AAEAAABkAAAAAAAAABQAAABAHwAAAAAAACYAAAAAAAAAwOD//wAAAAAmAAAAZAAAABYAAABMAAAAAAAAAAAAAAAEAAAAAAAAAAEAAACAgIAKAAAAACgAAAAoAAAAZAAAAGQAAAAAAAAAzMzMAAAAAABQAAAAUAAAAGQAAABkAAAAAAAAABcAAAAUAAAAAAAAAAAAAAD/fwAA/38AAAAAAAAJAAAABAAAAAAAAAAeAAAAaAAAAAAAAAAAAAAAAAAAAAAAAAAAAAAAECcAABAnAAAAAAAAAAAAAAAAAAAAAAAAAAAAAAAAAAAAAAAAAAAAABQAAAAAAAAAwMD/AAAAAABkAAAAMgAAAAAAAABkAAAAAAAAAH9/fwAKAAAAIgAAABgAAAAAAAAAAAAAAAAAAAAAAAAAAAAAAAAAAAAkAAAAJAAAAAAAAAAHAAAAAAAAAAAAAAAAAAAAAAAAAAAAAAAAAAAAf39/ACUAAABYAAAAAAAAAAAAAAAAAAAAAAAAAAAAAAAAAAAAAAAAAAAAAAAAAAAAAAAAAAAAAAA/AAAAAAAAAKCGAQAAAAAAAAAAAAAAAAAMAAAAAQAAAAAAAAAAAAAAAAAAAB8AAABUAAAAAAAABQAAAAEAAAAAAAAAAAAAAAAAAAAAAAAAAAAAAAAAAAAAAAAAAAAAAAJ/f38AAAAAA8zMzADAwP8Af39/AAAAAAAAAAAAAAAAAAAAAAAAAAAAIQAAABgAAAAUAAAAwAMAABsnAAA/FQAAWSkAABAAAAAmAAAACAAAAAAAAAAAAAAA"/>
               </a:ext>
             </a:extLst>
           </p:cNvSpPr>
@@ -2686,7 +2686,7 @@
           <a:lstStyle/>
           <a:p>
             <a:pPr/>
-            <a:fld id="{0DD7AE41-0FE0-8258-AE6F-F90DE02158AC}" type="datetime1">
+            <a:fld id="{58F202F3-BDB5-A7F4-FB4A-4BA14C040D1E}" type="datetime1">
               <a:t/>
             </a:fld>
           </a:p>
@@ -2699,7 +2699,7 @@
             <a:spLocks noGrp="1" noChangeArrowheads="1"/>
             <a:extLst>
               <a:ext uri="smNativeData">
-                <pr:smNativeData xmlns:pr="smNativeData" xmlns="smNativeData" val="SMDATA_15_ZqHWaRMAAAAlAAAAZAAAAA8BAAAAkAAAAEgAAACQAAAASAAAAAAAAAABAAAAAAAAAAEAAABQAAAAAAAAAAAA4D8AAAAAAADgPwAAAAAAAOA/AAAAAAAA4D8AAAAAAADgPwAAAAAAAOA/AAAAAAAA4D8AAAAAAADgPwAAAAAAAOA/AAAAAAAA4D8CAAAAjAAAAAAAAAAAAAAAu+DjDP///wgAAAAAAAAAAAAAAAAAAAAAAAAAAAAAAAAAAAAAZAAAAAEAAABAAAAAAAAAAAAAAAAAAAAAAAAAAAAAAAAAAAAAAAAAAAAAAAAAAAAAAAAAAAAAAAAAAAAAAAAAAAAAAAAAAAAAAAAAAAAAAAAAAAAAAAAAAAAAAAAAAAAAFAAAADwAAAAAAAAAAAAAAAAAAAkUAAAAAQAAABQAAAAUAAAAFAAAAAEAAAAAAAAAZAAAAGQAAAAAAAAAZAAAAGQAAAAVAAAAYAAAAAAAAAAAAAAADwAAACADAAAAAAAAAAAAAAEAAACgMgAAVgcAAKr4//8BAAAAf39/AAEAAABkAAAAAAAAABQAAABAHwAAAAAAACYAAAAAAAAAwOD//wAAAAAmAAAAZAAAABYAAABMAAAAAAAAAAAAAAAEAAAAAAAAAAEAAACAgIAKAAAAACgAAAAoAAAAZAAAAGQAAAAAAAAAzMzMAAAAAABQAAAAUAAAAGQAAABkAAAAAAAAABcAAAAUAAAAAAAAAAAAAAD/fwAA/38AAAAAAAAJAAAABAAAAAAAAAAeAAAAaAAAAAAAAAAAAAAAAAAAAAAAAAAAAAAAECcAABAnAAAAAAAAAAAAAAAAAAAAAAAAAAAAAAAAAAAAAAAAAAAAABQAAAAAAAAAwMD/AAAAAABkAAAAMgAAAAAAAABkAAAAAAAAAH9/fwAKAAAAIgAAABgAAAAAAAAAAAAAAAAAAAAAAAAAAAAAAAAAAAAkAAAAJAAAAAAAAAAHAAAAAAAAAAAAAAAAAAAAAAAAAAAAAAAAAAAAf39/ACUAAABYAAAAAAAAAAAAAAAAAAAAAAAAAAAAAAAAAAAAAAAAAAAAAAAAAAAAAAAAAAAAAAA/AAAAAAAAAKCGAQAAAAAAAAAAAAAAAAAMAAAAAQAAAAAAAAAAAAAAAAAAAB8AAABUAAAAAAAABQAAAAEAAAAAAAAAAAAAAAAAAAAAAAAAAAAAAAAAAAAAAAAAAAAAAAJ/f38AAAAAA8zMzADAwP8Af39/AAAAAAAAAAAAAAAAAAAAAAAAAAAAIQAAABgAAAAUAAAAoRkAABsnAABfMQAAWSkAABAAAAAmAAAACAAAAAAAAAAAAAAA"/>
+                <pr:smNativeData xmlns:pr="smNativeData" xmlns="smNativeData" val="SMDATA_15_MvzhaRMAAAAlAAAAZAAAAA8BAAAAkAAAAEgAAACQAAAASAAAAAAAAAABAAAAAAAAAAEAAABQAAAAAAAAAAAA4D8AAAAAAADgPwAAAAAAAOA/AAAAAAAA4D8AAAAAAADgPwAAAAAAAOA/AAAAAAAA4D8AAAAAAADgPwAAAAAAAOA/AAAAAAAA4D8CAAAAjAAAAAAAAAAAAAAAu+DjDP///wgAAAAAAAAAAAAAAAAAAAAAAAAAAAAAAAAAAAAAZAAAAAEAAABAAAAAAAAAAAAAAAAAAAAAAAAAAAAAAAAAAAAAAAAAAAAAAAAAAAAAAAAAAAAAAAAAAAAAAAAAAAAAAAAAAAAAAAAAAAAAAAAAAAAAAAAAAAAAAAAAAAAAFAAAADwAAAAAAAAAAAAAAAAAAAkUAAAAAQAAABQAAAAUAAAAFAAAAAEAAAAAAAAAZAAAAGQAAAAAAAAAZAAAAGQAAAAVAAAAYAAAAAAAAAAAAAAADwAAACADAAAAAAAAAAAAAAEAAACgMgAAVgcAAKr4//8BAAAAf39/AAEAAABkAAAAAAAAABQAAABAHwAAAAAAACYAAAAAAAAAwOD//wAAAAAmAAAAZAAAABYAAABMAAAAAAAAAAAAAAAEAAAAAAAAAAEAAACAgIAKAAAAACgAAAAoAAAAZAAAAGQAAAAAAAAAzMzMAAAAAABQAAAAUAAAAGQAAABkAAAAAAAAABcAAAAUAAAAAAAAAAAAAAD/fwAA/38AAAAAAAAJAAAABAAAAAAAAAAeAAAAaAAAAAAAAAAAAAAAAAAAAAAAAAAAAAAAECcAABAnAAAAAAAAAAAAAAAAAAAAAAAAAAAAAAAAAAAAAAAAAAAAABQAAAAAAAAAwMD/AAAAAABkAAAAMgAAAAAAAABkAAAAAAAAAH9/fwAKAAAAIgAAABgAAAAAAAAAAAAAAAAAAAAAAAAAAAAAAAAAAAAkAAAAJAAAAAAAAAAHAAAAAAAAAAAAAAAAAAAAAAAAAAAAAAAAAAAAf39/ACUAAABYAAAAAAAAAAAAAAAAAAAAAAAAAAAAAAAAAAAAAAAAAAAAAAAAAAAAAAAAAAAAAAA/AAAAAAAAAKCGAQAAAAAAAAAAAAAAAAAMAAAAAQAAAAAAAAAAAAAAAAAAAB8AAABUAAAAAAAABQAAAAEAAAAAAAAAAAAAAAAAAAAAAAAAAAAAAAAAAAAAAAAAAAAAAAJ/f38AAAAAA8zMzADAwP8Af39/AAAAAAAAAAAAAAAAAAAAAAAAAAAAIQAAABgAAAAUAAAAoRkAABsnAABfMQAAWSkAABAAAAAmAAAACAAAAAAAAAAAAAAA"/>
               </a:ext>
             </a:extLst>
           </p:cNvSpPr>
@@ -2723,7 +2723,7 @@
             <a:spLocks noGrp="1" noChangeArrowheads="1"/>
             <a:extLst>
               <a:ext uri="smNativeData">
-                <pr:smNativeData xmlns:pr="smNativeData" xmlns="smNativeData" val="SMDATA_15_ZqHWaRMAAAAlAAAAZAAAAA8BAAAAkAAAAEgAAACQAAAASAAAAAAAAAABAAAAAAAAAAEAAABQAAAAAAAAAAAA4D8AAAAAAADgPwAAAAAAAOA/AAAAAAAA4D8AAAAAAADgPwAAAAAAAOA/AAAAAAAA4D8AAAAAAADgPwAAAAAAAOA/AAAAAAAA4D8CAAAAjAAAAAAAAAAAAAAAu+DjDP///wgAAAAAAAAAAAAAAAAAAAAAAAAAAAAAAAAAAAAAZAAAAAEAAABAAAAAAAAAAAAAAAAAAAAAAAAAAAAAAAAAAAAAAAAAAAAAAAAAAAAAAAAAAAAAAAAAAAAAAAAAAAAAAAAAAAAAAAAAAAAAAAAAAAAAAAAAAAAAAAAAAAAAFAAAADwAAAAAAAAAAAAAAAAAAAkUAAAAAQAAABQAAAAUAAAAFAAAAAEAAAAAAAAAZAAAAGQAAAAAAAAAZAAAAGQAAAAVAAAAYAAAAAAAAAAAAAAADwAAACADAAAAAAAAAAAAAAEAAACgMgAAVgcAAKr4//8BAAAAf39/AAEAAABkAAAAAAAAABQAAABAHwAAAAAAACYAAAAAAAAAwOD//wAAAAAmAAAAZAAAABYAAABMAAAAAAAAAAAAAAAEAAAAAAAAAAEAAACAgIAKAAAAACgAAAAoAAAAZAAAAGQAAAAAAAAAzMzMAAAAAABQAAAAUAAAAGQAAABkAAAAAAAAABcAAAAUAAAAAAAAAAAAAAD/fwAA/38AAAAAAAAJAAAABAAAAAAAAAAeAAAAaAAAAAAAAAAAAAAAAAAAAAAAAAAAAAAAECcAABAnAAAAAAAAAAAAAAAAAAAAAAAAAAAAAAAAAAAAAAAAAAAAABQAAAAAAAAAwMD/AAAAAABkAAAAMgAAAAAAAABkAAAAAAAAAH9/fwAKAAAAIgAAABgAAAAAAAAAAAAAAAAAAAAAAAAAAAAAAAAAAAAkAAAAJAAAAAAAAAAHAAAAAAAAAAAAAAAAAAAAAAAAAAAAAAAAAAAAf39/ACUAAABYAAAAAAAAAAAAAAAAAAAAAAAAAAAAAAAAAAAAAAAAAAAAAAAAAAAAAAAAAAAAAAA/AAAAAAAAAKCGAQAAAAAAAAAAAAAAAAAMAAAAAQAAAAAAAAAAAAAAAAAAAB8AAABUAAAAAAAABQAAAAEAAAAAAAAAAAAAAAAAAAAAAAAAAAAAAAAAAAAAAAAAAAAAAAJ/f38AAAAAA8zMzADAwP8Af39/AAAAAAAAAAAAAAAAAAAAAAAAAAAAIQAAABgAAAAUAAAAwTUAABsnAABARwAAWSkAABAAAAAmAAAACAAAAAAAAAAAAAAA"/>
+                <pr:smNativeData xmlns:pr="smNativeData" xmlns="smNativeData" val="SMDATA_15_MvzhaRMAAAAlAAAAZAAAAA8BAAAAkAAAAEgAAACQAAAASAAAAAAAAAABAAAAAAAAAAEAAABQAAAAAAAAAAAA4D8AAAAAAADgPwAAAAAAAOA/AAAAAAAA4D8AAAAAAADgPwAAAAAAAOA/AAAAAAAA4D8AAAAAAADgPwAAAAAAAOA/AAAAAAAA4D8CAAAAjAAAAAAAAAAAAAAAu+DjDP///wgAAAAAAAAAAAAAAAAAAAAAAAAAAAAAAAAAAAAAZAAAAAEAAABAAAAAAAAAAAAAAAAAAAAAAAAAAAAAAAAAAAAAAAAAAAAAAAAAAAAAAAAAAAAAAAAAAAAAAAAAAAAAAAAAAAAAAAAAAAAAAAAAAAAAAAAAAAAAAAAAAAAAFAAAADwAAAAAAAAAAAAAAAAAAAkUAAAAAQAAABQAAAAUAAAAFAAAAAEAAAAAAAAAZAAAAGQAAAAAAAAAZAAAAGQAAAAVAAAAYAAAAAAAAAAAAAAADwAAACADAAAAAAAAAAAAAAEAAACgMgAAVgcAAKr4//8BAAAAf39/AAEAAABkAAAAAAAAABQAAABAHwAAAAAAACYAAAAAAAAAwOD//wAAAAAmAAAAZAAAABYAAABMAAAAAAAAAAAAAAAEAAAAAAAAAAEAAACAgIAKAAAAACgAAAAoAAAAZAAAAGQAAAAAAAAAzMzMAAAAAABQAAAAUAAAAGQAAABkAAAAAAAAABcAAAAUAAAAAAAAAAAAAAD/fwAA/38AAAAAAAAJAAAABAAAAAAAAAAeAAAAaAAAAAAAAAAAAAAAAAAAAAAAAAAAAAAAECcAABAnAAAAAAAAAAAAAAAAAAAAAAAAAAAAAAAAAAAAAAAAAAAAABQAAAAAAAAAwMD/AAAAAABkAAAAMgAAAAAAAABkAAAAAAAAAH9/fwAKAAAAIgAAABgAAAAAAAAAAAAAAAAAAAAAAAAAAAAAAAAAAAAkAAAAJAAAAAAAAAAHAAAAAAAAAAAAAAAAAAAAAAAAAAAAAAAAAAAAf39/ACUAAABYAAAAAAAAAAAAAAAAAAAAAAAAAAAAAAAAAAAAAAAAAAAAAAAAAAAAAAAAAAAAAAA/AAAAAAAAAKCGAQAAAAAAAAAAAAAAAAAMAAAAAQAAAAAAAAAAAAAAAAAAAB8AAABUAAAAAAAABQAAAAEAAAAAAAAAAAAAAAAAAAAAAAAAAAAAAAAAAAAAAAAAAAAAAAJ/f38AAAAAA8zMzADAwP8Af39/AAAAAAAAAAAAAAAAAAAAAAAAAAAAIQAAABgAAAAUAAAAwTUAABsnAABARwAAWSkAABAAAAAmAAAACAAAAAAAAAAAAAAA"/>
               </a:ext>
             </a:extLst>
           </p:cNvSpPr>
@@ -2737,7 +2737,7 @@
           <a:lstStyle/>
           <a:p>
             <a:pPr/>
-            <a:fld id="{12CA112A-64FF-9FE7-B172-92B25F3C47C7}" type="slidenum">
+            <a:fld id="{5B8DDC85-CBB6-D82A-F835-3D7F927B0E68}" type="slidenum">
               <a:t/>
             </a:fld>
           </a:p>
@@ -2784,7 +2784,7 @@
             <a:spLocks noGrp="1" noChangeArrowheads="1"/>
             <a:extLst>
               <a:ext uri="smNativeData">
-                <pr:smNativeData xmlns:pr="smNativeData" xmlns="smNativeData" val="SMDATA_15_ZqHWaRMAAAAlAAAAZAAAAA8BAAAAkAAAAEgAAACQAAAASAAAAAAAAAABAAAAAAAAAAEAAABQAAAAAAAAAAAA4D8AAAAAAADgPwAAAAAAAOA/AAAAAAAA4D8AAAAAAADgPwAAAAAAAOA/AAAAAAAA4D8AAAAAAADgPwAAAAAAAOA/AAAAAAAA4D8CAAAAjAAAAAAAAAAAAAAAu+DjDP///wgAAAAAAAAAAAAAAAAAAAAAAAAAAAAAAAAAAAAAZAAAAAEAAABAAAAAAAAAAAAAAAAAAAAAAAAAAAAAAAAAAAAAAAAAAAAAAAAAAAAAAAAAAAAAAAAAAAAAAAAAAAAAAAAAAAAAAAAAAAAAAAAAAAAAAAAAAAAAAAAAAAAAFAAAADwAAAAAAAAAAAAAAAAAAAkUAAAAAQAAABQAAAAUAAAAFAAAAAEAAAAAAAAAZAAAAGQAAAAAAAAAZAAAAGQAAAAVAAAAYAAAAAAAAAAAAAAADwAAACADAAAAAAAAAAAAAAEAAACgMgAAVgcAAKr4//8BAAAAf39/AAEAAABkAAAAAAAAABQAAABAHwAAAAAAACYAAAAAAAAAwOD//wAAAAAmAAAAZAAAABYAAABMAAAAAAAAAAAAAAAEAAAAAAAAAAEAAACAgIAKAAAAACgAAAAoAAAAZAAAAGQAAAAAAAAAzMzMAAAAAABQAAAAUAAAAGQAAABkAAAAAAAAABcAAAAUAAAAAAAAAAAAAAD/fwAA/38AAAAAAAAJAAAABAAAAHsAfAAeAAAAaAAAAAAAAAAAAAAAAAAAAAAAAAAAAAAAECcAABAnAAAAAAAAAAAAAAAAAAAAAAAAAAAAAAAAAAAAAAAAAAAAABQAAAAAAAAAwMD/AAAAAABkAAAAMgAAAAAAAABkAAAAAAAAAH9/fwAKAAAAIgAAABgAAAAAAAAAAAAAAAAAAAAAAAAAAAAAAAAAAAAkAAAAJAAAAAAAAAAHAAAAAAAAAAAAAAAAAAAAAAAAAAAAAAAAAAAAf39/ACUAAABYAAAAAAAAAAAAAAAAAAAAAAAAAAAAAAAAAAAAAAAAAAAAAAAAAAAAAAAAAAAAAAA/AAAAAAAAAKCGAQAAAAAAAAAAAAAAAAAMAAAAAQAAAAAAAAAAAAAAAAAAAB8AAABUAAAAAAAABQAAAAEAAAAAAAAAAAAAAAAAAAAAAAAAAAAAAAAAAAAAAAAAAAAAAAJ/f38AAAAAA8zMzADAwP8Af39/AAAAAAAAAAAAAAAAAAAAAAAAAAAAIQAAABgAAAAUAAAAwAMAALABAABARwAAuAgAABAAAAAmAAAACAAAAP//////////"/>
+                <pr:smNativeData xmlns:pr="smNativeData" xmlns="smNativeData" val="SMDATA_15_MvzhaRMAAAAlAAAAZAAAAA8BAAAAkAAAAEgAAACQAAAASAAAAAAAAAABAAAAAAAAAAEAAABQAAAAAAAAAAAA4D8AAAAAAADgPwAAAAAAAOA/AAAAAAAA4D8AAAAAAADgPwAAAAAAAOA/AAAAAAAA4D8AAAAAAADgPwAAAAAAAOA/AAAAAAAA4D8CAAAAjAAAAAAAAAAAAAAAu+DjDP///wgAAAAAAAAAAAAAAAAAAAAAAAAAAAAAAAAAAAAAZAAAAAEAAABAAAAAAAAAAAAAAAAAAAAAAAAAAAAAAAAAAAAAAAAAAAAAAAAAAAAAAAAAAAAAAAAAAAAAAAAAAAAAAAAAAAAAAAAAAAAAAAAAAAAAAAAAAAAAAAAAAAAAFAAAADwAAAAAAAAAAAAAAAAAAAkUAAAAAQAAABQAAAAUAAAAFAAAAAEAAAAAAAAAZAAAAGQAAAAAAAAAZAAAAGQAAAAVAAAAYAAAAAAAAAAAAAAADwAAACADAAAAAAAAAAAAAAEAAACgMgAAVgcAAKr4//8BAAAAf39/AAEAAABkAAAAAAAAABQAAABAHwAAAAAAACYAAAAAAAAAwOD//wAAAAAmAAAAZAAAABYAAABMAAAAAAAAAAAAAAAEAAAAAAAAAAEAAACAgIAKAAAAACgAAAAoAAAAZAAAAGQAAAAAAAAAzMzMAAAAAABQAAAAUAAAAGQAAABkAAAAAAAAABcAAAAUAAAAAAAAAAAAAAD/fwAA/38AAAAAAAAJAAAABAAAAHsAfAAeAAAAaAAAAAAAAAAAAAAAAAAAAAAAAAAAAAAAECcAABAnAAAAAAAAAAAAAAAAAAAAAAAAAAAAAAAAAAAAAAAAAAAAABQAAAAAAAAAwMD/AAAAAABkAAAAMgAAAAAAAABkAAAAAAAAAH9/fwAKAAAAIgAAABgAAAAAAAAAAAAAAAAAAAAAAAAAAAAAAAAAAAAkAAAAJAAAAAAAAAAHAAAAAAAAAAAAAAAAAAAAAAAAAAAAAAAAAAAAf39/ACUAAABYAAAAAAAAAAAAAAAAAAAAAAAAAAAAAAAAAAAAAAAAAAAAAAAAAAAAAAAAAAAAAAA/AAAAAAAAAKCGAQAAAAAAAAAAAAAAAAAMAAAAAQAAAAAAAAAAAAAAAAAAAB8AAABUAAAAAAAABQAAAAEAAAAAAAAAAAAAAAAAAAAAAAAAAAAAAAAAAAAAAAAAAAAAAAJ/f38AAAAAA8zMzADAwP8Af39/AAAAAAAAAAAAAAAAAAAAAAAAAAAAIQAAABgAAAAUAAAAwAMAALABAABARwAAuAgAABAAAAAmAAAACAAAAP//////////"/>
               </a:ext>
             </a:extLst>
           </p:cNvSpPr>
@@ -2828,7 +2828,7 @@
             <a:spLocks noGrp="1" noChangeArrowheads="1"/>
             <a:extLst>
               <a:ext uri="smNativeData">
-                <pr:smNativeData xmlns:pr="smNativeData" xmlns="smNativeData" val="SMDATA_15_ZqHWaRMAAAAlAAAAZAAAAA8BAAAAkAAAAEgAAACQAAAASAAAAAAAAAAAAAAAAAAAAAEAAABQAAAAAAAAAAAA4D8AAAAAAADgPwAAAAAAAOA/AAAAAAAA4D8AAAAAAADgPwAAAAAAAOA/AAAAAAAA4D8AAAAAAADgPwAAAAAAAOA/AAAAAAAA4D8CAAAAjAAAAAAAAAAAAAAAu+DjDP///wgAAAAAAAAAAAAAAAAAAAAAAAAAAAAAAAAAAAAAZAAAAAEAAABAAAAAAAAAAAAAAAAAAAAAAAAAAAAAAAAAAAAAAAAAAAAAAAAAAAAAAAAAAAAAAAAAAAAAAAAAAAAAAAAAAAAAAAAAAAAAAAAAAAAAAAAAAAAAAAAAAAAAFAAAADwAAAAAAAAAAAAAAAAAAAkUAAAAAQAAABQAAAAUAAAAFAAAAAEAAAAAAAAAZAAAAGQAAAAAAAAAZAAAAGQAAAAVAAAAYAAAAAAAAAAAAAAADwAAACADAAAAAAAAAAAAAAEAAACgMgAAVgcAAKr4//8BAAAAf39/AAEAAABkAAAAAAAAABQAAABAHwAAAAAAACYAAAAAAAAAwOD//wAAAAAmAAAAZAAAABYAAABMAAAAAAAAAAAAAAAEAAAAAAAAAAEAAACAgIAKAAAAACgAAAAoAAAAZAAAAGQAAAAAAAAAzMzMAAAAAABQAAAAUAAAAGQAAABkAAAAAAAAABcAAAAUAAAAAAAAAAAAAAD/fwAA/38AAAAAAAAJAAAABAAAAHsAfAAeAAAAaAAAAAAAAAAAAAAAAAAAAAAAAAAAAAAAECcAABAnAAAAAAAAAAAAAAAAAAAAAAAAAAAAAAAAAAAAAAAAAAAAABQAAAAAAAAAwMD/AAAAAABkAAAAMgAAAAAAAABkAAAAAAAAAH9/fwAKAAAAIgAAABgAAAAAAAAAAAAAAAAAAAAAAAAAAAAAAAAAAAAkAAAAJAAAAAAAAAAHAAAAAAAAAAAAAAAAAAAAAAAAAAAAAAAAAAAAf39/ACUAAABYAAAAAAAAAAAAAAAAAAAAAAAAAAAAAAAAAAAAAAAAAAAAAAAAAAAAAAAAAAAAAAA/AAAAAAAAAKCGAQAAAAAAAAAAAAAAAAAMAAAAAQAAAAAAAAAAAAAAAAAAAB8AAABUAAAAAAAABQAAAAEAAAAAAAAAAAAAAAAAAAAAAAAAAAAAAAAAAAAAAAAAAAAAAAJ/f38AAAAAA8zMzADAwP8Af39/AAAAAAAAAAAAAAAAAAAAAAAAAAAAIQAAABgAAAAUAAAAwAMAANgJAABARwAAsCUAABAAAAAmAAAACAAAAP//////////"/>
+                <pr:smNativeData xmlns:pr="smNativeData" xmlns="smNativeData" val="SMDATA_15_MvzhaRMAAAAlAAAAZAAAAA8BAAAAkAAAAEgAAACQAAAASAAAAAAAAAAAAAAAAAAAAAEAAABQAAAAAAAAAAAA4D8AAAAAAADgPwAAAAAAAOA/AAAAAAAA4D8AAAAAAADgPwAAAAAAAOA/AAAAAAAA4D8AAAAAAADgPwAAAAAAAOA/AAAAAAAA4D8CAAAAjAAAAAAAAAAAAAAAu+DjDP///wgAAAAAAAAAAAAAAAAAAAAAAAAAAAAAAAAAAAAAZAAAAAEAAABAAAAAAAAAAAAAAAAAAAAAAAAAAAAAAAAAAAAAAAAAAAAAAAAAAAAAAAAAAAAAAAAAAAAAAAAAAAAAAAAAAAAAAAAAAAAAAAAAAAAAAAAAAAAAAAAAAAAAFAAAADwAAAAAAAAAAAAAAAAAAAkUAAAAAQAAABQAAAAUAAAAFAAAAAEAAAAAAAAAZAAAAGQAAAAAAAAAZAAAAGQAAAAVAAAAYAAAAAAAAAAAAAAADwAAACADAAAAAAAAAAAAAAEAAACgMgAAVgcAAKr4//8BAAAAf39/AAEAAABkAAAAAAAAABQAAABAHwAAAAAAACYAAAAAAAAAwOD//wAAAAAmAAAAZAAAABYAAABMAAAAAAAAAAAAAAAEAAAAAAAAAAEAAACAgIAKAAAAACgAAAAoAAAAZAAAAGQAAAAAAAAAzMzMAAAAAABQAAAAUAAAAGQAAABkAAAAAAAAABcAAAAUAAAAAAAAAAAAAAD/fwAA/38AAAAAAAAJAAAABAAAAHsAfAAeAAAAaAAAAAAAAAAAAAAAAAAAAAAAAAAAAAAAECcAABAnAAAAAAAAAAAAAAAAAAAAAAAAAAAAAAAAAAAAAAAAAAAAABQAAAAAAAAAwMD/AAAAAABkAAAAMgAAAAAAAABkAAAAAAAAAH9/fwAKAAAAIgAAABgAAAAAAAAAAAAAAAAAAAAAAAAAAAAAAAAAAAAkAAAAJAAAAAAAAAAHAAAAAAAAAAAAAAAAAAAAAAAAAAAAAAAAAAAAf39/ACUAAABYAAAAAAAAAAAAAAAAAAAAAAAAAAAAAAAAAAAAAAAAAAAAAAAAAAAAAAAAAAAAAAA/AAAAAAAAAKCGAQAAAAAAAAAAAAAAAAAMAAAAAQAAAAAAAAAAAAAAAAAAAB8AAABUAAAAAAAABQAAAAEAAAAAAAAAAAAAAAAAAAAAAAAAAAAAAAAAAAAAAAAAAAAAAAJ/f38AAAAAA8zMzADAwP8Af39/AAAAAAAAAAAAAAAAAAAAAAAAAAAAIQAAABgAAAAUAAAAwAMAANgJAABARwAAsCUAABAAAAAmAAAACAAAAP//////////"/>
               </a:ext>
             </a:extLst>
           </p:cNvSpPr>
@@ -2896,7 +2896,7 @@
             <a:spLocks noGrp="1" noChangeArrowheads="1"/>
             <a:extLst>
               <a:ext uri="smNativeData">
-                <pr:smNativeData xmlns:pr="smNativeData" xmlns="smNativeData" val="SMDATA_15_ZqHWaRMAAAAlAAAAZAAAAA8BAAAAkAAAAEgAAACQAAAASAAAAAAAAAABAAAAAAAAAAEAAABQAAAAAAAAAAAA4D8AAAAAAADgPwAAAAAAAOA/AAAAAAAA4D8AAAAAAADgPwAAAAAAAOA/AAAAAAAA4D8AAAAAAADgPwAAAAAAAOA/AAAAAAAA4D8CAAAAjAAAAAAAAAAAAAAAu+DjDP///wgAAAAAAAAAAAAAAAAAAAAAAAAAAAAAAAAAAAAAZAAAAAEAAABAAAAAAAAAAAAAAAAAAAAAAAAAAAAAAAAAAAAAAAAAAAAAAAAAAAAAAAAAAAAAAAAAAAAAAAAAAAAAAAAAAAAAAAAAAAAAAAAAAAAAAAAAAAAAAAAAAAAAFAAAADwAAAAAAAAAAAAAAAAAAAkUAAAAAQAAABQAAAAUAAAAFAAAAAEAAAAAAAAAZAAAAGQAAAAAAAAAZAAAAGQAAAAVAAAAYAAAAAAAAAAAAAAADwAAACADAAAAAAAAAAAAAAEAAACgMgAAVgcAAKr4//8BAAAAf39/AAEAAABkAAAAAAAAABQAAABAHwAAAAAAACYAAAAAAAAAwOD//wAAAAAmAAAAZAAAABYAAABMAAAAAAAAAAAAAAAEAAAAAAAAAAEAAACAgIAKAAAAACgAAAAoAAAAZAAAAGQAAAAAAAAAzMzMAAAAAABQAAAAUAAAAGQAAABkAAAAAAAAABcAAAAUAAAAAAAAAAAAAAD/fwAA/38AAAAAAAAJAAAABAAAAHsAfAAeAAAAaAAAAAAAAAAAAAAAAAAAAAAAAAAAAAAAECcAABAnAAAAAAAAAAAAAAAAAAAAAAAAAAAAAAAAAAAAAAAAAAAAABQAAAAAAAAAwMD/AAAAAABkAAAAMgAAAAAAAABkAAAAAAAAAH9/fwAKAAAAIgAAABgAAAAAAAAAAAAAAAAAAAAAAAAAAAAAAAAAAAAkAAAAJAAAAAAAAAAHAAAAAAAAAAAAAAAAAAAAAAAAAAAAAAAAAAAAf39/ACUAAABYAAAAAAAAAAAAAAAAAAAAAAAAAAAAAAAAAAAAAAAAAAAAAAAAAAAAAAAAAAAAAAA/AAAAAAAAAKCGAQAAAAAAAAAAAAAAAAAMAAAAAQAAAAAAAAAAAAAAAAAAAB8AAABUAAAAAAAABQAAAAEAAAAAAAAAAAAAAAAAAAAAAAAAAAAAAAAAAAAAAAAAAAAAAAJ/f38AAAAAA8zMzADAwP8Af39/AAAAAAAAAAAAAAAAAAAAAAAAAAAAIQAAABgAAAAUAAAAwAMAABsnAAA/FQAAWSkAABAAAAAmAAAACAAAAP//////////"/>
+                <pr:smNativeData xmlns:pr="smNativeData" xmlns="smNativeData" val="SMDATA_15_MvzhaRMAAAAlAAAAZAAAAA8BAAAAkAAAAEgAAACQAAAASAAAAAAAAAABAAAAAAAAAAEAAABQAAAAAAAAAAAA4D8AAAAAAADgPwAAAAAAAOA/AAAAAAAA4D8AAAAAAADgPwAAAAAAAOA/AAAAAAAA4D8AAAAAAADgPwAAAAAAAOA/AAAAAAAA4D8CAAAAjAAAAAAAAAAAAAAAu+DjDP///wgAAAAAAAAAAAAAAAAAAAAAAAAAAAAAAAAAAAAAZAAAAAEAAABAAAAAAAAAAAAAAAAAAAAAAAAAAAAAAAAAAAAAAAAAAAAAAAAAAAAAAAAAAAAAAAAAAAAAAAAAAAAAAAAAAAAAAAAAAAAAAAAAAAAAAAAAAAAAAAAAAAAAFAAAADwAAAAAAAAAAAAAAAAAAAkUAAAAAQAAABQAAAAUAAAAFAAAAAEAAAAAAAAAZAAAAGQAAAAAAAAAZAAAAGQAAAAVAAAAYAAAAAAAAAAAAAAADwAAACADAAAAAAAAAAAAAAEAAACgMgAAVgcAAKr4//8BAAAAf39/AAEAAABkAAAAAAAAABQAAABAHwAAAAAAACYAAAAAAAAAwOD//wAAAAAmAAAAZAAAABYAAABMAAAAAAAAAAAAAAAEAAAAAAAAAAEAAACAgIAKAAAAACgAAAAoAAAAZAAAAGQAAAAAAAAAzMzMAAAAAABQAAAAUAAAAGQAAABkAAAAAAAAABcAAAAUAAAAAAAAAAAAAAD/fwAA/38AAAAAAAAJAAAABAAAAHsAfAAeAAAAaAAAAAAAAAAAAAAAAAAAAAAAAAAAAAAAECcAABAnAAAAAAAAAAAAAAAAAAAAAAAAAAAAAAAAAAAAAAAAAAAAABQAAAAAAAAAwMD/AAAAAABkAAAAMgAAAAAAAABkAAAAAAAAAH9/fwAKAAAAIgAAABgAAAAAAAAAAAAAAAAAAAAAAAAAAAAAAAAAAAAkAAAAJAAAAAAAAAAHAAAAAAAAAAAAAAAAAAAAAAAAAAAAAAAAAAAAf39/ACUAAABYAAAAAAAAAAAAAAAAAAAAAAAAAAAAAAAAAAAAAAAAAAAAAAAAAAAAAAAAAAAAAAA/AAAAAAAAAKCGAQAAAAAAAAAAAAAAAAAMAAAAAQAAAAAAAAAAAAAAAAAAAB8AAABUAAAAAAAABQAAAAEAAAAAAAAAAAAAAAAAAAAAAAAAAAAAAAAAAAAAAAAAAAAAAAJ/f38AAAAAA8zMzADAwP8Af39/AAAAAAAAAAAAAAAAAAAAAAAAAAAAIQAAABgAAAAUAAAAwAMAABsnAAA/FQAAWSkAABAAAAAmAAAACAAAAP//////////"/>
               </a:ext>
             </a:extLst>
           </p:cNvSpPr>
@@ -2931,7 +2931,7 @@
           </a:lstStyle>
           <a:p>
             <a:pPr/>
-            <a:fld id="{0F85D4D5-9BE2-D022-AC3D-6D779A735A38}" type="datetime1">
+            <a:fld id="{76FB7B4A-049B-AE8D-D543-F2D8350D23A7}" type="datetime1">
               <a:t/>
             </a:fld>
           </a:p>
@@ -2944,7 +2944,7 @@
             <a:spLocks noGrp="1" noChangeArrowheads="1"/>
             <a:extLst>
               <a:ext uri="smNativeData">
-                <pr:smNativeData xmlns:pr="smNativeData" xmlns="smNativeData" val="SMDATA_15_ZqHWaRMAAAAlAAAAZAAAAA8BAAAAkAAAAEgAAACQAAAASAAAAAAAAAABAAAAAAAAAAEAAABQAAAAAAAAAAAA4D8AAAAAAADgPwAAAAAAAOA/AAAAAAAA4D8AAAAAAADgPwAAAAAAAOA/AAAAAAAA4D8AAAAAAADgPwAAAAAAAOA/AAAAAAAA4D8CAAAAjAAAAAAAAAAAAAAAu+DjDP///wgAAAAAAAAAAAAAAAAAAAAAAAAAAAAAAAAAAAAAZAAAAAEAAABAAAAAAAAAAAAAAAAAAAAAAAAAAAAAAAAAAAAAAAAAAAAAAAAAAAAAAAAAAAAAAAAAAAAAAAAAAAAAAAAAAAAAAAAAAAAAAAAAAAAAAAAAAAAAAAAAAAAAFAAAADwAAAAAAAAAAAAAAAAAAAkUAAAAAQAAABQAAAAUAAAAFAAAAAEAAAAAAAAAZAAAAGQAAAAAAAAAZAAAAGQAAAAVAAAAYAAAAAAAAAAAAAAADwAAACADAAAAAAAAAAAAAAEAAACgMgAAVgcAAKr4//8BAAAAf39/AAEAAABkAAAAAAAAABQAAABAHwAAAAAAACYAAAAAAAAAwOD//wAAAAAmAAAAZAAAABYAAABMAAAAAAAAAAAAAAAEAAAAAAAAAAEAAACAgIAKAAAAACgAAAAoAAAAZAAAAGQAAAAAAAAAzMzMAAAAAABQAAAAUAAAAGQAAABkAAAAAAAAABcAAAAUAAAAAAAAAAAAAAD/fwAA/38AAAAAAAAJAAAABAAAAAAAAAAeAAAAaAAAAAAAAAAAAAAAAAAAAAAAAAAAAAAAECcAABAnAAAAAAAAAAAAAAAAAAAAAAAAAAAAAAAAAAAAAAAAAAAAABQAAAAAAAAAwMD/AAAAAABkAAAAMgAAAAAAAABkAAAAAAAAAH9/fwAKAAAAIgAAABgAAAAAAAAAAAAAAAAAAAAAAAAAAAAAAAAAAAAkAAAAJAAAAAAAAAAHAAAAAAAAAAAAAAAAAAAAAAAAAAAAAAAAAAAAf39/ACUAAABYAAAAAAAAAAAAAAAAAAAAAAAAAAAAAAAAAAAAAAAAAAAAAAAAAAAAAAAAAAAAAAA/AAAAAAAAAKCGAQAAAAAAAAAAAAAAAAAMAAAAAQAAAAAAAAAAAAAAAAAAAB8AAABUAAAAAAAABQAAAAEAAAAAAAAAAAAAAAAAAAAAAAAAAAAAAAAAAAAAAAAAAAAAAAJ/f38AAAAAA8zMzADAwP8Af39/AAAAAAAAAAAAAAAAAAAAAAAAAAAAIQAAABgAAAAUAAAAoRkAABsnAABfMQAAWSkAABAAAAAmAAAACAAAAP//////////"/>
+                <pr:smNativeData xmlns:pr="smNativeData" xmlns="smNativeData" val="SMDATA_15_MvzhaRMAAAAlAAAAZAAAAA8BAAAAkAAAAEgAAACQAAAASAAAAAAAAAABAAAAAAAAAAEAAABQAAAAAAAAAAAA4D8AAAAAAADgPwAAAAAAAOA/AAAAAAAA4D8AAAAAAADgPwAAAAAAAOA/AAAAAAAA4D8AAAAAAADgPwAAAAAAAOA/AAAAAAAA4D8CAAAAjAAAAAAAAAAAAAAAu+DjDP///wgAAAAAAAAAAAAAAAAAAAAAAAAAAAAAAAAAAAAAZAAAAAEAAABAAAAAAAAAAAAAAAAAAAAAAAAAAAAAAAAAAAAAAAAAAAAAAAAAAAAAAAAAAAAAAAAAAAAAAAAAAAAAAAAAAAAAAAAAAAAAAAAAAAAAAAAAAAAAAAAAAAAAFAAAADwAAAAAAAAAAAAAAAAAAAkUAAAAAQAAABQAAAAUAAAAFAAAAAEAAAAAAAAAZAAAAGQAAAAAAAAAZAAAAGQAAAAVAAAAYAAAAAAAAAAAAAAADwAAACADAAAAAAAAAAAAAAEAAACgMgAAVgcAAKr4//8BAAAAf39/AAEAAABkAAAAAAAAABQAAABAHwAAAAAAACYAAAAAAAAAwOD//wAAAAAmAAAAZAAAABYAAABMAAAAAAAAAAAAAAAEAAAAAAAAAAEAAACAgIAKAAAAACgAAAAoAAAAZAAAAGQAAAAAAAAAzMzMAAAAAABQAAAAUAAAAGQAAABkAAAAAAAAABcAAAAUAAAAAAAAAAAAAAD/fwAA/38AAAAAAAAJAAAABAAAAAAAAAAeAAAAaAAAAAAAAAAAAAAAAAAAAAAAAAAAAAAAECcAABAnAAAAAAAAAAAAAAAAAAAAAAAAAAAAAAAAAAAAAAAAAAAAABQAAAAAAAAAwMD/AAAAAABkAAAAMgAAAAAAAABkAAAAAAAAAH9/fwAKAAAAIgAAABgAAAAAAAAAAAAAAAAAAAAAAAAAAAAAAAAAAAAkAAAAJAAAAAAAAAAHAAAAAAAAAAAAAAAAAAAAAAAAAAAAAAAAAAAAf39/ACUAAABYAAAAAAAAAAAAAAAAAAAAAAAAAAAAAAAAAAAAAAAAAAAAAAAAAAAAAAAAAAAAAAA/AAAAAAAAAKCGAQAAAAAAAAAAAAAAAAAMAAAAAQAAAAAAAAAAAAAAAAAAAB8AAABUAAAAAAAABQAAAAEAAAAAAAAAAAAAAAAAAAAAAAAAAAAAAAAAAAAAAAAAAAAAAAJ/f38AAAAAA8zMzADAwP8Af39/AAAAAAAAAAAAAAAAAAAAAAAAAAAAIQAAABgAAAAUAAAAoRkAABsnAABfMQAAWSkAABAAAAAmAAAACAAAAP//////////"/>
               </a:ext>
             </a:extLst>
           </p:cNvSpPr>
@@ -2989,7 +2989,7 @@
             <a:spLocks noGrp="1" noChangeArrowheads="1"/>
             <a:extLst>
               <a:ext uri="smNativeData">
-                <pr:smNativeData xmlns:pr="smNativeData" xmlns="smNativeData" val="SMDATA_15_ZqHWaRMAAAAlAAAAZAAAAA8BAAAAkAAAAEgAAACQAAAASAAAAAAAAAABAAAAAAAAAAEAAABQAAAAAAAAAAAA4D8AAAAAAADgPwAAAAAAAOA/AAAAAAAA4D8AAAAAAADgPwAAAAAAAOA/AAAAAAAA4D8AAAAAAADgPwAAAAAAAOA/AAAAAAAA4D8CAAAAjAAAAAAAAAAAAAAAu+DjDP///wgAAAAAAAAAAAAAAAAAAAAAAAAAAAAAAAAAAAAAZAAAAAEAAABAAAAAAAAAAAAAAAAAAAAAAAAAAAAAAAAAAAAAAAAAAAAAAAAAAAAAAAAAAAAAAAAAAAAAAAAAAAAAAAAAAAAAAAAAAAAAAAAAAAAAAAAAAAAAAAAAAAAAFAAAADwAAAAAAAAAAAAAAAAAAAkUAAAAAQAAABQAAAAUAAAAFAAAAAEAAAAAAAAAZAAAAGQAAAAAAAAAZAAAAGQAAAAVAAAAYAAAAAAAAAAAAAAADwAAACADAAAAAAAAAAAAAAEAAACgMgAAVgcAAKr4//8BAAAAf39/AAEAAABkAAAAAAAAABQAAABAHwAAAAAAACYAAAAAAAAAwOD//wAAAAAmAAAAZAAAABYAAABMAAAAAAAAAAAAAAAEAAAAAAAAAAEAAACAgIAKAAAAACgAAAAoAAAAZAAAAGQAAAAAAAAAzMzMAAAAAABQAAAAUAAAAGQAAABkAAAAAAAAABcAAAAUAAAAAAAAAAAAAAD/fwAA/38AAAAAAAAJAAAABAAAAP////8eAAAAaAAAAAAAAAAAAAAAAAAAAAAAAAAAAAAAECcAABAnAAAAAAAAAAAAAAAAAAAAAAAAAAAAAAAAAAAAAAAAAAAAABQAAAAAAAAAwMD/AAAAAABkAAAAMgAAAAAAAABkAAAAAAAAAH9/fwAKAAAAIgAAABgAAAAAAAAAAAAAAAAAAAAAAAAAAAAAAAAAAAAkAAAAJAAAAAAAAAAHAAAAAAAAAAAAAAAAAAAAAAAAAAAAAAAAAAAAf39/ACUAAABYAAAAAAAAAAAAAAAAAAAAAAAAAAAAAAAAAAAAAAAAAAAAAAAAAAAAAAAAAAAAAAA/AAAAAAAAAKCGAQAAAAAAAAAAAAAAAAAMAAAAAQAAAAAAAAAAAAAAAAAAAB8AAABUAAAAAAAABQAAAAEAAAAAAAAAAAAAAAAAAAAAAAAAAAAAAAAAAAAAAAAAAAAAAAJ/f38AAAAAA8zMzADAwP8Af39/AAAAAAAAAAAAAAAAAAAAAAAAAAAAIQAAABgAAAAUAAAAwTUAABsnAABARwAAWSkAABAAAAAmAAAACAAAAP//////////"/>
+                <pr:smNativeData xmlns:pr="smNativeData" xmlns="smNativeData" val="SMDATA_15_MvzhaRMAAAAlAAAAZAAAAA8BAAAAkAAAAEgAAACQAAAASAAAAAAAAAABAAAAAAAAAAEAAABQAAAAAAAAAAAA4D8AAAAAAADgPwAAAAAAAOA/AAAAAAAA4D8AAAAAAADgPwAAAAAAAOA/AAAAAAAA4D8AAAAAAADgPwAAAAAAAOA/AAAAAAAA4D8CAAAAjAAAAAAAAAAAAAAAu+DjDP///wgAAAAAAAAAAAAAAAAAAAAAAAAAAAAAAAAAAAAAZAAAAAEAAABAAAAAAAAAAAAAAAAAAAAAAAAAAAAAAAAAAAAAAAAAAAAAAAAAAAAAAAAAAAAAAAAAAAAAAAAAAAAAAAAAAAAAAAAAAAAAAAAAAAAAAAAAAAAAAAAAAAAAFAAAADwAAAAAAAAAAAAAAAAAAAkUAAAAAQAAABQAAAAUAAAAFAAAAAEAAAAAAAAAZAAAAGQAAAAAAAAAZAAAAGQAAAAVAAAAYAAAAAAAAAAAAAAADwAAACADAAAAAAAAAAAAAAEAAACgMgAAVgcAAKr4//8BAAAAf39/AAEAAABkAAAAAAAAABQAAABAHwAAAAAAACYAAAAAAAAAwOD//wAAAAAmAAAAZAAAABYAAABMAAAAAAAAAAAAAAAEAAAAAAAAAAEAAACAgIAKAAAAACgAAAAoAAAAZAAAAGQAAAAAAAAAzMzMAAAAAABQAAAAUAAAAGQAAABkAAAAAAAAABcAAAAUAAAAAAAAAAAAAAD/fwAA/38AAAAAAAAJAAAABAAAAP////8eAAAAaAAAAAAAAAAAAAAAAAAAAAAAAAAAAAAAECcAABAnAAAAAAAAAAAAAAAAAAAAAAAAAAAAAAAAAAAAAAAAAAAAABQAAAAAAAAAwMD/AAAAAABkAAAAMgAAAAAAAABkAAAAAAAAAH9/fwAKAAAAIgAAABgAAAAAAAAAAAAAAAAAAAAAAAAAAAAAAAAAAAAkAAAAJAAAAAAAAAAHAAAAAAAAAAAAAAAAAAAAAAAAAAAAAAAAAAAAf39/ACUAAABYAAAAAAAAAAAAAAAAAAAAAAAAAAAAAAAAAAAAAAAAAAAAAAAAAAAAAAAAAAAAAAA/AAAAAAAAAKCGAQAAAAAAAAAAAAAAAAAMAAAAAQAAAAAAAAAAAAAAAAAAAB8AAABUAAAAAAAABQAAAAEAAAAAAAAAAAAAAAAAAAAAAAAAAAAAAAAAAAAAAAAAAAAAAAJ/f38AAAAAA8zMzADAwP8Af39/AAAAAAAAAAAAAAAAAAAAAAAAAAAAIQAAABgAAAAUAAAAwTUAABsnAABARwAAWSkAABAAAAAmAAAACAAAAP//////////"/>
               </a:ext>
             </a:extLst>
           </p:cNvSpPr>
@@ -3024,7 +3024,7 @@
           </a:lstStyle>
           <a:p>
             <a:pPr/>
-            <a:fld id="{01B672B6-F8EC-E384-A20E-0ED13C40545B}" type="slidenum">
+            <a:fld id="{55B1AB28-66B8-E45D-F609-9008E54700C5}" type="slidenum">
               <a:t/>
             </a:fld>
           </a:p>
@@ -3702,7 +3702,7 @@
           <p:cNvSpPr txBox="1">
             <a:extLst>
               <a:ext uri="smNativeData">
-                <pr:smNativeData xmlns:pr="smNativeData" xmlns="smNativeData" val="SMDATA_15_ZqHWaRMAAAAlAAAAEgAAAE8BAAAAkAAAAEgAAACQAAAASAAAAAAAAAAAAAAAAAAAAAEAAABQAAAAAAAAAAAA4D8AAAAAAADgPwAAAAAAAOA/AAAAAAAA4D8AAAAAAADgPwAAAAAAAOA/AAAAAAAA4D8AAAAAAADgPwAAAAAAAOA/AAAAAAAA4D8CAAAAjAAAAAAAAAAAAAAAu+DjDP///wgAAAAAAAAAAAAAAAAAAAAAAAAAAAAAAAAAAAAAZAAAAAEAAABAAAAAAAAAAAAAAAAAAAAAAAAAAAAAAAAAAAAAAAAAAAAAAAAAAAAAAAAAAAAAAAAAAAAAAAAAAAAAAAAAAAAAAAAAAAAAAAAAAAAAAAAAAAAAAAAAAAAAFAAAADwAAAAAAAAAAAAAAAAAAAkUAAAAAQAAABQAAAAUAAAAFAAAAAEAAAAAAAAAZAAAAGQAAAAAAAAAZAAAAGQAAAAVAAAAYAAAAAAAAAAAAAAADwAAACADAAAAAAAAAAAAAAEAAACgMgAAVgcAAKr4//8BAAAAf39/AAEAAABkAAAAAAAAABQAAABAHwAAAAAAACYAAAAAAAAAwOD//wAAAAAmAAAAZAAAABYAAABMAAAAAAAAAAAAAAAEAAAAAAAAAAEAAACAgIAKAAAAACgAAAAoAAAAZAAAAGQAAAAAAAAAzMzMAAAAAABQAAAAUAAAAGQAAABkAAAAAAAAABcAAAAUAAAAAAAAANwIAAD/fwAA/38AAAAAAAAJAAAABAAAACMAAAAeAAAAaAAAAAAAAAAAAAAAAAAAAAAAAAAAAAAAECcAABAnAAAAAAAAAAAAAAAAAAAAAAAAAAAAAAAAAAAAAAAAAAAAABQAAAAAAAAAwMD/AAAAAABkAAAAMgAAAAAAAABkAAAAAAAAAH9/fwAKAAAAIgAAABgAAAAAAAAAAAAAAAAAAAAAAAAAAAAAAAAAAAAkAAAAJAAAAAAAAAAHAAAAAAAAAAAAAAAAAAAAAAAAAAAAAAAAAAAAf39/ACUAAABYAAAAAAAAAAAAAAAAAAAAAAAAAAAAAAAAAAAAAAAAAAAAAAAAAAAAAAAAAAAAAAA/AAAAAAAAAKCGAQAAAAAAAAAAAAAAAAAMAAAAAQAAAAAAAAAAAAAAAAAAAB8AAABUAAAAu+DjBf///wEAAAAAAAAAAAAAAAAAAAAAAAAAAAAAAAAAAAAAAAAAAAAAAAJ/f38AgICAA8zMzADAwP8Af39/AAAAAAAAAAAAAAAAAAAAAAAAAAAAIQAAABgAAAAUAAAA3yIAADUNAABpNQAAdQ8AAAAgAAAmAAAACAAAAP//////////"/>
+                <pr:smNativeData xmlns:pr="smNativeData" xmlns="smNativeData" val="SMDATA_15_MvzhaRMAAAAlAAAAEgAAAE8BAAAAkAAAAEgAAACQAAAASAAAAAAAAAAAAAAAAAAAAAEAAABQAAAAAAAAAAAA4D8AAAAAAADgPwAAAAAAAOA/AAAAAAAA4D8AAAAAAADgPwAAAAAAAOA/AAAAAAAA4D8AAAAAAADgPwAAAAAAAOA/AAAAAAAA4D8CAAAAjAAAAAAAAAAAAAAAu+DjDP///wgAAAAAAAAAAAAAAAAAAAAAAAAAAAAAAAAAAAAAZAAAAAEAAABAAAAAAAAAAAAAAAAAAAAAAAAAAAAAAAAAAAAAAAAAAAAAAAAAAAAAAAAAAAAAAAAAAAAAAAAAAAAAAAAAAAAAAAAAAAAAAAAAAAAAAAAAAAAAAAAAAAAAFAAAADwAAAAAAAAAAAAAAAAAAAkUAAAAAQAAABQAAAAUAAAAFAAAAAEAAAAAAAAAZAAAAGQAAAAAAAAAZAAAAGQAAAAVAAAAYAAAAAAAAAAAAAAADwAAACADAAAAAAAAAAAAAAEAAACgMgAAVgcAAKr4//8BAAAAf39/AAEAAABkAAAAAAAAABQAAABAHwAAAAAAACYAAAAAAAAAwOD//wAAAAAmAAAAZAAAABYAAABMAAAAAAAAAAAAAAAEAAAAAAAAAAEAAACAgIAKAAAAACgAAAAoAAAAZAAAAGQAAAAAAAAAzMzMAAAAAABQAAAAUAAAAGQAAABkAAAAAAAAABcAAAAUAAAAAAAAANwIAAD/fwAA/38AAAAAAAAJAAAABAAAACMAAAAeAAAAaAAAAAAAAAAAAAAAAAAAAAAAAAAAAAAAECcAABAnAAAAAAAAAAAAAAAAAAAAAAAAAAAAAAAAAAAAAAAAAAAAABQAAAAAAAAAwMD/AAAAAABkAAAAMgAAAAAAAABkAAAAAAAAAH9/fwAKAAAAIgAAABgAAAAAAAAAAAAAAAAAAAAAAAAAAAAAAAAAAAAkAAAAJAAAAAAAAAAHAAAAAAAAAAAAAAAAAAAAAAAAAAAAAAAAAAAAf39/ACUAAABYAAAAAAAAAAAAAAAAAAAAAAAAAAAAAAAAAAAAAAAAAAAAAAAAAAAAAAAAAAAAAAA/AAAAAAAAAKCGAQAAAAAAAAAAAAAAAAAMAAAAAQAAAAAAAAAAAAAAAAAAAB8AAABUAAAAu+DjBf///wEAAAAAAAAAAAAAAAAAAAAAAAAAAAAAAAAAAAAAAAAAAAAAAAJ/f38AgICAA8zMzADAwP8Af39/AAAAAAAAAAAAAAAAAAAAAAAAAAAAIQAAABgAAAAUAAAA3yIAADUNAABpNQAAdQ8AABAgAAAmAAAACAAAAP//////////"/>
               </a:ext>
             </a:extLst>
           </p:cNvSpPr>
@@ -3739,7 +3739,7 @@
           <p:cNvSpPr txBox="1">
             <a:extLst>
               <a:ext uri="smNativeData">
-                <pr:smNativeData xmlns:pr="smNativeData" xmlns="smNativeData" val="SMDATA_15_ZqHWaRMAAAAlAAAAEgAAAE8BAAAAkAAAAEgAAACQAAAASAAAAAAAAAAAAAAAAAAAAAEAAABQAAAAAAAAAAAA4D8AAAAAAADgPwAAAAAAAOA/AAAAAAAA4D8AAAAAAADgPwAAAAAAAOA/AAAAAAAA4D8AAAAAAADgPwAAAAAAAOA/AAAAAAAA4D8CAAAAjAAAAAAAAAAAAAAAu+DjDP///wgAAAAAAAAAAAAAAAAAAAAAAAAAAAAAAAAAAAAAZAAAAAEAAABAAAAAAAAAAAAAAAAAAAAAAAAAAAAAAAAAAAAAAAAAAAAAAAAAAAAAAAAAAAAAAAAAAAAAAAAAAAAAAAAAAAAAAAAAAAAAAAAAAAAAAAAAAAAAAAAAAAAAFAAAADwAAAAAAAAAAAAAAAAAAAkUAAAAAQAAABQAAAAUAAAAFAAAAAEAAAAAAAAAZAAAAGQAAAAAAAAAZAAAAGQAAAAVAAAAYAAAAAAAAAAAAAAADwAAACADAAAAAAAAAAAAAAEAAACgMgAAVgcAAKr4//8BAAAAf39/AAEAAABkAAAAAAAAABQAAABAHwAAAAAAACYAAAAAAAAAwOD//wAAAAAmAAAAZAAAABYAAABMAAAAAAAAAAAAAAAEAAAAAAAAAAEAAACAgIAKAAAAACgAAAAoAAAAZAAAAGQAAAAAAAAAzMzMAAAAAABQAAAAUAAAAGQAAABkAAAAAAAAABcAAAAUAAAAAAAAANwIAAD/fwAA/38AAAAAAAAJAAAABAAAAEkAAAAeAAAAaAAAAAAAAAAAAAAAAAAAAAAAAAAAAAAAECcAABAnAAAAAAAAAAAAAAAAAAAAAAAAAAAAAAAAAAAAAAAAAAAAABQAAAAAAAAAwMD/AAAAAABkAAAAMgAAAAAAAABkAAAAAAAAAH9/fwAKAAAAIgAAABgAAAAAAAAAAAAAAAAAAAAAAAAAAAAAAAAAAAAkAAAAJAAAAAAAAAAHAAAAAAAAAAAAAAAAAAAAAAAAAAAAAAAAAAAAf39/ACUAAABYAAAAAAAAAAAAAAAAAAAAAAAAAAAAAAAAAAAAAAAAAAAAAAAAAAAAAAAAAAAAAAA/AAAAAAAAAKCGAQAAAAAAAAAAAAAAAAAMAAAAAQAAAAAAAAAAAAAAAAAAAB8AAABUAAAAu+DjBf///wEAAAAAAAAAAAAAAAAAAAAAAAAAAAAAAAAAAAAAAAAAAAAAAAJ/f38AgICAA8zMzADAwP8Af39/AAAAAAAAAAAAAAAAAAAAAAAAAAAAIQAAABgAAAAUAAAA3yIAAO4QAABpNQAALhMAAAAgAAAmAAAACAAAAP//////////"/>
+                <pr:smNativeData xmlns:pr="smNativeData" xmlns="smNativeData" val="SMDATA_15_MvzhaRMAAAAlAAAAEgAAAE8BAAAAkAAAAEgAAACQAAAASAAAAAAAAAAAAAAAAAAAAAEAAABQAAAAAAAAAAAA4D8AAAAAAADgPwAAAAAAAOA/AAAAAAAA4D8AAAAAAADgPwAAAAAAAOA/AAAAAAAA4D8AAAAAAADgPwAAAAAAAOA/AAAAAAAA4D8CAAAAjAAAAAAAAAAAAAAAu+DjDP///wgAAAAAAAAAAAAAAAAAAAAAAAAAAAAAAAAAAAAAZAAAAAEAAABAAAAAAAAAAAAAAAAAAAAAAAAAAAAAAAAAAAAAAAAAAAAAAAAAAAAAAAAAAAAAAAAAAAAAAAAAAAAAAAAAAAAAAAAAAAAAAAAAAAAAAAAAAAAAAAAAAAAAFAAAADwAAAAAAAAAAAAAAAAAAAkUAAAAAQAAABQAAAAUAAAAFAAAAAEAAAAAAAAAZAAAAGQAAAAAAAAAZAAAAGQAAAAVAAAAYAAAAAAAAAAAAAAADwAAACADAAAAAAAAAAAAAAEAAACgMgAAVgcAAKr4//8BAAAAf39/AAEAAABkAAAAAAAAABQAAABAHwAAAAAAACYAAAAAAAAAwOD//wAAAAAmAAAAZAAAABYAAABMAAAAAAAAAAAAAAAEAAAAAAAAAAEAAACAgIAKAAAAACgAAAAoAAAAZAAAAGQAAAAAAAAAzMzMAAAAAABQAAAAUAAAAGQAAABkAAAAAAAAABcAAAAUAAAAAAAAANwIAAD/fwAA/38AAAAAAAAJAAAABAAAAEkAAAAeAAAAaAAAAAAAAAAAAAAAAAAAAAAAAAAAAAAAECcAABAnAAAAAAAAAAAAAAAAAAAAAAAAAAAAAAAAAAAAAAAAAAAAABQAAAAAAAAAwMD/AAAAAABkAAAAMgAAAAAAAABkAAAAAAAAAH9/fwAKAAAAIgAAABgAAAAAAAAAAAAAAAAAAAAAAAAAAAAAAAAAAAAkAAAAJAAAAAAAAAAHAAAAAAAAAAAAAAAAAAAAAAAAAAAAAAAAAAAAf39/ACUAAABYAAAAAAAAAAAAAAAAAAAAAAAAAAAAAAAAAAAAAAAAAAAAAAAAAAAAAAAAAAAAAAA/AAAAAAAAAKCGAQAAAAAAAAAAAAAAAAAMAAAAAQAAAAAAAAAAAAAAAAAAAB8AAABUAAAAu+DjBf///wEAAAAAAAAAAAAAAAAAAAAAAAAAAAAAAAAAAAAAAAAAAAAAAAJ/f38AgICAA8zMzADAwP8Af39/AAAAAAAAAAAAAAAAAAAAAAAAAAAAIQAAABgAAAAUAAAA3yIAAO4QAABpNQAALhMAABAgAAAmAAAACAAAAP//////////"/>
               </a:ext>
             </a:extLst>
           </p:cNvSpPr>
@@ -3776,7 +3776,7 @@
           <p:cNvSpPr txBox="1">
             <a:extLst>
               <a:ext uri="smNativeData">
-                <pr:smNativeData xmlns:pr="smNativeData" xmlns="smNativeData" val="SMDATA_15_ZqHWaRMAAAAlAAAAEgAAAE8BAAAAkAAAAEgAAACQAAAASAAAAAAAAAAAAAAAAAAAAAEAAABQAAAAAAAAAAAA4D8AAAAAAADgPwAAAAAAAOA/AAAAAAAA4D8AAAAAAADgPwAAAAAAAOA/AAAAAAAA4D8AAAAAAADgPwAAAAAAAOA/AAAAAAAA4D8CAAAAjAAAAAAAAAAAAAAAu+DjDP///wgAAAAAAAAAAAAAAAAAAAAAAAAAAAAAAAAAAAAAZAAAAAEAAABAAAAAAAAAAAAAAAAAAAAAAAAAAAAAAAAAAAAAAAAAAAAAAAAAAAAAAAAAAAAAAAAAAAAAAAAAAAAAAAAAAAAAAAAAAAAAAAAAAAAAAAAAAAAAAAAAAAAAFAAAADwAAAAAAAAAAAAAAAAAAAkUAAAAAQAAABQAAAAUAAAAFAAAAAEAAAAAAAAAZAAAAGQAAAAAAAAAZAAAAGQAAAAVAAAAYAAAAAAAAAAAAAAADwAAACADAAAAAAAAAAAAAAEAAACgMgAAVgcAAKr4//8BAAAAf39/AAEAAABkAAAAAAAAABQAAABAHwAAAAAAACYAAAAAAAAAwOD//wAAAAAmAAAAZAAAABYAAABMAAAAAAAAAAAAAAAEAAAAAAAAAAEAAACAgIAKAAAAACgAAAAoAAAAZAAAAGQAAAAAAAAAzMzMAAAAAABQAAAAUAAAAGQAAABkAAAAAAAAABcAAAAUAAAAAAAAANwIAAD/fwAA/38AAAAAAAAJAAAABAAAAAAAAQAeAAAAaAAAAAAAAAAAAAAAAAAAAAAAAAAAAAAAECcAABAnAAAAAAAAAAAAAAAAAAAAAAAAAAAAAAAAAAAAAAAAAAAAABQAAAAAAAAAwMD/AAAAAABkAAAAMgAAAAAAAABkAAAAAAAAAH9/fwAKAAAAIgAAABgAAAAAAAAAAAAAAAAAAAAAAAAAAAAAAAAAAAAkAAAAJAAAAAAAAAAHAAAAAAAAAAAAAAAAAAAAAAAAAAAAAAAAAAAAf39/ACUAAABYAAAAAAAAAAAAAAAAAAAAAAAAAAAAAAAAAAAAAAAAAAAAAAAAAAAAAAAAAAAAAAA/AAAAAAAAAKCGAQAAAAAAAAAAAAAAAAAMAAAAAQAAAAAAAAAAAAAAAAAAAB8AAABUAAAAu+DjBf///wEAAAAAAAAAAAAAAAAAAAAAAAAAAAAAAAAAAAAAAAAAAAAAAAJ/f38AgICAA8zMzADAwP8Af39/AAAAAAAAAAAAAAAAAAAAAAAAAAAAIQAAABgAAAAUAAAA3yIAAKcUAABpNQAA5xYAAAAgAAAmAAAACAAAAP//////////"/>
+                <pr:smNativeData xmlns:pr="smNativeData" xmlns="smNativeData" val="SMDATA_15_MvzhaRMAAAAlAAAAEgAAAE8BAAAAkAAAAEgAAACQAAAASAAAAAAAAAAAAAAAAAAAAAEAAABQAAAAAAAAAAAA4D8AAAAAAADgPwAAAAAAAOA/AAAAAAAA4D8AAAAAAADgPwAAAAAAAOA/AAAAAAAA4D8AAAAAAADgPwAAAAAAAOA/AAAAAAAA4D8CAAAAjAAAAAAAAAAAAAAAu+DjDP///wgAAAAAAAAAAAAAAAAAAAAAAAAAAAAAAAAAAAAAZAAAAAEAAABAAAAAAAAAAAAAAAAAAAAAAAAAAAAAAAAAAAAAAAAAAAAAAAAAAAAAAAAAAAAAAAAAAAAAAAAAAAAAAAAAAAAAAAAAAAAAAAAAAAAAAAAAAAAAAAAAAAAAFAAAADwAAAAAAAAAAAAAAAAAAAkUAAAAAQAAABQAAAAUAAAAFAAAAAEAAAAAAAAAZAAAAGQAAAAAAAAAZAAAAGQAAAAVAAAAYAAAAAAAAAAAAAAADwAAACADAAAAAAAAAAAAAAEAAACgMgAAVgcAAKr4//8BAAAAf39/AAEAAABkAAAAAAAAABQAAABAHwAAAAAAACYAAAAAAAAAwOD//wAAAAAmAAAAZAAAABYAAABMAAAAAAAAAAAAAAAEAAAAAAAAAAEAAACAgIAKAAAAACgAAAAoAAAAZAAAAGQAAAAAAAAAzMzMAAAAAABQAAAAUAAAAGQAAABkAAAAAAAAABcAAAAUAAAAAAAAANwIAAD/fwAA/38AAAAAAAAJAAAABAAAAAAAAQAeAAAAaAAAAAAAAAAAAAAAAAAAAAAAAAAAAAAAECcAABAnAAAAAAAAAAAAAAAAAAAAAAAAAAAAAAAAAAAAAAAAAAAAABQAAAAAAAAAwMD/AAAAAABkAAAAMgAAAAAAAABkAAAAAAAAAH9/fwAKAAAAIgAAABgAAAAAAAAAAAAAAAAAAAAAAAAAAAAAAAAAAAAkAAAAJAAAAAAAAAAHAAAAAAAAAAAAAAAAAAAAAAAAAAAAAAAAAAAAf39/ACUAAABYAAAAAAAAAAAAAAAAAAAAAAAAAAAAAAAAAAAAAAAAAAAAAAAAAAAAAAAAAAAAAAA/AAAAAAAAAKCGAQAAAAAAAAAAAAAAAAAMAAAAAQAAAAAAAAAAAAAAAAAAAB8AAABUAAAAu+DjBf///wEAAAAAAAAAAAAAAAAAAAAAAAAAAAAAAAAAAAAAAAAAAAAAAAJ/f38AgICAA8zMzADAwP8Af39/AAAAAAAAAAAAAAAAAAAAAAAAAAAAIQAAABgAAAAUAAAA3yIAAKcUAABpNQAA5xYAABAgAAAmAAAACAAAAP//////////"/>
               </a:ext>
             </a:extLst>
           </p:cNvSpPr>
@@ -3813,7 +3813,7 @@
           <p:cNvSpPr>
             <a:extLst>
               <a:ext uri="smNativeData">
-                <pr:smNativeData xmlns:pr="smNativeData" xmlns="smNativeData" val="SMDATA_15_ZqHWaRMAAAAlAAAACgAAAA8BAAAAkAAAAEgAAACQAAAASAAAAAAAAAAAAAAAAAAAAAEAAABQAAAAAAAAAAAA4D8AAAAAAADgPwAAAAAAAOA/AAAAAAAA4D8AAAAAAADgPwAAAAAAAOA/AAAAAAAA4D8AAAAAAADgPwAAAAAAAOA/AAAAAAAA4D8CAAAAjAAAAAAAAAAAAAAAu+DjDP///wgAAAAAAAAAAAAAAAAAAAAAAAAAAAAAAAAAAAAAZAAAAAEAAABAAAAAAAAAAAAAAAAAAAAAAAAAAAAAAAAAAAAAAAAAAAAAAAAAAAAAAAAAAAAAAAAAAAAAAAAAAAAAAAAAAAAAAAAAAAAAAAAAAAAAAAAAAAAAAAAAAAAAFAAAADwAAAABAAAAAAAAAAAAAAlkAAAAAQAAABQAAAAUAAAAFAAAAAEAAAAAAAAAZAAAAGQAAAABAAAAlgAAAJYAAAAVAAAAYAAAAAAAAAAAAAAADwAAACADAAAAAAAAAAAAAAEAAACgMgAAVgcAAKr4//8BAAAAf39/AAEAAABkAAAAAAAAABQAAABAHwAAAAAAACYAAAAAAAAAwOD//wAAAAAmAAAAZAAAABYAAABMAAAAAAAAAAAAAAAEAAAAAAAAAAEAAACAgIAKAAAAACgAAAAoAAAAZAAAAGQAAAAAAAAAzMzMAAAAAABQAAAAUAAAAGQAAABkAAAAAAAAABcAAAAUAAAAAAAAAAAAAAD/fwAA/38AAAAAAAAJAAAABAAAAAAAAAAeAAAAaAAAAAAAAAAAAAAAAAAAAAAAAAAAAAAAECcAABAnAAAAAAAAAAAAAAAAAAAAAAAAAAAAAAAAAAAAAAAAAAAAABQAAAAAAAAAwMD/AAAAAABkAAAAMgAAAAAAAABkAAAAAAAAAH9/fwAKAAAAIgAAABgAAAAAAAAAAAAAAAAAAAAAAAAAAAAAAAAAAAAkAAAAJAAAAAAAAAAHAAAAAAAAAAAAAAAAAAAAAAAAAAAAAAAAAAAAf39/ACUAAABYAAAAAAAAAAAAAAAAAAAAAAAAAAAAAAAAAAAAAAAAAAAAAAAAAAAAAAAAAAAAAAA/AAAAAAAAAKCGAQAAAAAAAAAAAAAAAAAMAAAAAQAAAAAAAAAAAAAAAAAAAB8AAABUAAAAu+DjBf///wEAAAAAAAAAAAAAAAAAAAAAAAAAAAAAAAAAAAAAAAAAAAAAAAJ/f38AgICAA8zMzADAwP8Af39/AAAAAAAAAAAAAAAAAAAAAAAAAAAAIQAAABgAAAAUAAAAMBUAAI8OAACqIAAAkQ4AAAAAAAAmAAAACAAAAP//////////"/>
+                <pr:smNativeData xmlns:pr="smNativeData" xmlns="smNativeData" val="SMDATA_15_MvzhaRMAAAAlAAAACgAAAA8BAAAAkAAAAEgAAACQAAAASAAAAAAAAAAAAAAAAAAAAAEAAABQAAAAAAAAAAAA4D8AAAAAAADgPwAAAAAAAOA/AAAAAAAA4D8AAAAAAADgPwAAAAAAAOA/AAAAAAAA4D8AAAAAAADgPwAAAAAAAOA/AAAAAAAA4D8CAAAAjAAAAAAAAAAAAAAAu+DjDP///wgAAAAAAAAAAAAAAAAAAAAAAAAAAAAAAAAAAAAAZAAAAAEAAABAAAAAAAAAAAAAAAAAAAAAAAAAAAAAAAAAAAAAAAAAAAAAAAAAAAAAAAAAAAAAAAAAAAAAAAAAAAAAAAAAAAAAAAAAAAAAAAAAAAAAAAAAAAAAAAAAAAAAFAAAADwAAAABAAAAAAAAAAAAAAlkAAAAAQAAABQAAAAUAAAAFAAAAAEAAAAAAAAAZAAAAGQAAAABAAAAlgAAAJYAAAAVAAAAYAAAAAAAAAAAAAAADwAAACADAAAAAAAAAAAAAAEAAACgMgAAVgcAAKr4//8BAAAAf39/AAEAAABkAAAAAAAAABQAAABAHwAAAAAAACYAAAAAAAAAwOD//wAAAAAmAAAAZAAAABYAAABMAAAAAAAAAAAAAAAEAAAAAAAAAAEAAACAgIAKAAAAACgAAAAoAAAAZAAAAGQAAAAAAAAAzMzMAAAAAABQAAAAUAAAAGQAAABkAAAAAAAAABcAAAAUAAAAAAAAAAAAAAD/fwAA/38AAAAAAAAJAAAABAAAAAAAAAAeAAAAaAAAAAAAAAAAAAAAAAAAAAAAAAAAAAAAECcAABAnAAAAAAAAAAAAAAAAAAAAAAAAAAAAAAAAAAAAAAAAAAAAABQAAAAAAAAAwMD/AAAAAABkAAAAMgAAAAAAAABkAAAAAAAAAH9/fwAKAAAAIgAAABgAAAAAAAAAAAAAAAAAAAAAAAAAAAAAAAAAAAAkAAAAJAAAAAAAAAAHAAAAAAAAAAAAAAAAAAAAAAAAAAAAAAAAAAAAf39/ACUAAABYAAAAAAAAAAAAAAAAAAAAAAAAAAAAAAAAAAAAAAAAAAAAAAAAAAAAAAAAAAAAAAA/AAAAAAAAAKCGAQAAAAAAAAAAAAAAAAAMAAAAAQAAAAAAAAAAAAAAAAAAAB8AAABUAAAAu+DjBf///wEAAAAAAAAAAAAAAAAAAAAAAAAAAAAAAAAAAAAAAAAAAAAAAAJ/f38AgICAA8zMzADAwP8Af39/AAAAAAAAAAAAAAAAAAAAAAAAAAAAIQAAABgAAAAUAAAAMBUAAI8OAACqIAAAkQ4AABAAAAAmAAAACAAAAP//////////"/>
               </a:ext>
             </a:extLst>
           </p:cNvSpPr>
@@ -3845,7 +3845,7 @@
           <p:cNvSpPr>
             <a:extLst>
               <a:ext uri="smNativeData">
-                <pr:smNativeData xmlns:pr="smNativeData" xmlns="smNativeData" val="SMDATA_15_ZqHWaRMAAAAlAAAACgAAAA8BAAAAkAAAAEgAAACQAAAASAAAAAAAAAAAAAAAAAAAAAEAAABQAAAAAAAAAAAA4D8AAAAAAADgPwAAAAAAAOA/AAAAAAAA4D8AAAAAAADgPwAAAAAAAOA/AAAAAAAA4D8AAAAAAADgPwAAAAAAAOA/AAAAAAAA4D8CAAAAjAAAAAAAAAAAAAAAu+DjDP///wgAAAAAAAAAAAAAAAAAAAAAAAAAAAAAAAAAAAAAZAAAAAEAAABAAAAAAAAAAAAAAAAAAAAAAAAAAAAAAAAAAAAAAAAAAAAAAAAAAAAAAAAAAAAAAAAAAAAAAAAAAAAAAAAAAAAAAAAAAAAAAAAAAAAAAAAAAAAAAAAAAAAAFAAAADwAAAABAAAAAQAAAAAAAAlkAAAAAQAAABQAAAAUAAAAFAAAAAEAAAAAAAAAZAAAAGQAAAABAAAAlgAAAJYAAAAVAAAAYAAAAAAAAAAAAAAADwAAACADAAAAAAAAAAAAAAEAAACgMgAAVgcAAKr4//8BAAAAf39/AAEAAABkAAAAAAAAABQAAABAHwAAAAAAACYAAAAAAAAAwOD//wAAAAAmAAAAZAAAABYAAABMAAAAAAAAAAAAAAAEAAAAAAAAAAEAAACAgIAKAAAAACgAAAAoAAAAZAAAAGQAAAAAAAAAzMzMAAAAAABQAAAAUAAAAGQAAABkAAAAAAAAABcAAAAUAAAAAAAAAAAAAAD/fwAA/38AAAAAAAAJAAAABAAAAEC5/SQeAAAAaAAAAAAAAAAAAAAAAAAAAAAAAAAAAAAAECcAABAnAAAAAAAAAAAAAAAAAAAAAAAAAAAAAAAAAAAAAAAAAAAAABQAAAAAAAAAwMD/AAAAAABkAAAAMgAAAAAAAABkAAAAAAAAAH9/fwAKAAAAIgAAABgAAAAAAAAAAAAAAAAAAAAAAAAAAAAAAAAAAAAkAAAAJAAAAAAAAAAHAAAAAAAAAAAAAAAAAAAAAAAAAAAAAAAAAAAAf39/ACUAAABYAAAAAAAAAAAAAAAAAAAAAAAAAAAAAAAAAAAAAAAAAAAAAAAAAAAAAAAAAAAAAAA/AAAAAAAAAKCGAQAAAAAAAAAAAAAAAAAMAAAAAQAAAAAAAAAAAAAAAAAAAB8AAABUAAAAu+DjBf///wEAAAAAAAAAAAAAAAAAAAAAAAAAAAAAAAAAAAAAAAAAAAAAAAJ/f38AgICAA8zMzADAwP8Af39/AAAAAAAAAAAAAAAAAAAAAAAAAAAAIQAAABgAAAAUAAAAMBUAABkSAACqIAAAGxIAAAAAAAAmAAAACAAAAP//////////"/>
+                <pr:smNativeData xmlns:pr="smNativeData" xmlns="smNativeData" val="SMDATA_15_MvzhaRMAAAAlAAAACgAAAA8BAAAAkAAAAEgAAACQAAAASAAAAAAAAAAAAAAAAAAAAAEAAABQAAAAAAAAAAAA4D8AAAAAAADgPwAAAAAAAOA/AAAAAAAA4D8AAAAAAADgPwAAAAAAAOA/AAAAAAAA4D8AAAAAAADgPwAAAAAAAOA/AAAAAAAA4D8CAAAAjAAAAAAAAAAAAAAAu+DjDP///wgAAAAAAAAAAAAAAAAAAAAAAAAAAAAAAAAAAAAAZAAAAAEAAABAAAAAAAAAAAAAAAAAAAAAAAAAAAAAAAAAAAAAAAAAAAAAAAAAAAAAAAAAAAAAAAAAAAAAAAAAAAAAAAAAAAAAAAAAAAAAAAAAAAAAAAAAAAAAAAAAAAAAFAAAADwAAAABAAAAAQAAAAAAAAlkAAAAAQAAABQAAAAUAAAAFAAAAAEAAAAAAAAAZAAAAGQAAAABAAAAlgAAAJYAAAAVAAAAYAAAAAAAAAAAAAAADwAAACADAAAAAAAAAAAAAAEAAACgMgAAVgcAAKr4//8BAAAAf39/AAEAAABkAAAAAAAAABQAAABAHwAAAAAAACYAAAAAAAAAwOD//wAAAAAmAAAAZAAAABYAAABMAAAAAAAAAAAAAAAEAAAAAAAAAAEAAACAgIAKAAAAACgAAAAoAAAAZAAAAGQAAAAAAAAAzMzMAAAAAABQAAAAUAAAAGQAAABkAAAAAAAAABcAAAAUAAAAAAAAAAAAAAD/fwAA/38AAAAAAAAJAAAABAAAAEC5/SQeAAAAaAAAAAAAAAAAAAAAAAAAAAAAAAAAAAAAECcAABAnAAAAAAAAAAAAAAAAAAAAAAAAAAAAAAAAAAAAAAAAAAAAABQAAAAAAAAAwMD/AAAAAABkAAAAMgAAAAAAAABkAAAAAAAAAH9/fwAKAAAAIgAAABgAAAAAAAAAAAAAAAAAAAAAAAAAAAAAAAAAAAAkAAAAJAAAAAAAAAAHAAAAAAAAAAAAAAAAAAAAAAAAAAAAAAAAAAAAf39/ACUAAABYAAAAAAAAAAAAAAAAAAAAAAAAAAAAAAAAAAAAAAAAAAAAAAAAAAAAAAAAAAAAAAA/AAAAAAAAAKCGAQAAAAAAAAAAAAAAAAAMAAAAAQAAAAAAAAAAAAAAAAAAAB8AAABUAAAAu+DjBf///wEAAAAAAAAAAAAAAAAAAAAAAAAAAAAAAAAAAAAAAAAAAAAAAAJ/f38AgICAA8zMzADAwP8Af39/AAAAAAAAAAAAAAAAAAAAAAAAAAAAIQAAABgAAAAUAAAAMBUAABkSAACqIAAAGxIAABAAAAAmAAAACAAAAP//////////"/>
               </a:ext>
             </a:extLst>
           </p:cNvSpPr>
@@ -3877,7 +3877,7 @@
           <p:cNvSpPr>
             <a:extLst>
               <a:ext uri="smNativeData">
-                <pr:smNativeData xmlns:pr="smNativeData" xmlns="smNativeData" val="SMDATA_15_ZqHWaRMAAAAlAAAACgAAAA8BAAAAkAAAAEgAAACQAAAASAAAAAAAAAAAAAAAAAAAAAEAAABQAAAAAAAAAAAA4D8AAAAAAADgPwAAAAAAAOA/AAAAAAAA4D8AAAAAAADgPwAAAAAAAOA/AAAAAAAA4D8AAAAAAADgPwAAAAAAAOA/AAAAAAAA4D8CAAAAjAAAAAAAAAAAAAAAu+DjDP///wgAAAAAAAAAAAAAAAAAAAAAAAAAAAAAAAAAAAAAZAAAAAEAAABAAAAAAAAAAAAAAAAAAAAAAAAAAAAAAAAAAAAAAAAAAAAAAAAAAAAAAAAAAAAAAAAAAAAAAAAAAAAAAAAAAAAAAAAAAAAAAAAAAAAAAAAAAAAAAAAAAAAAFAAAADwAAAABAAAAAgAAAAAAAAlkAAAAAQAAABQAAAAUAAAAFAAAAAEAAAAAAAAAZAAAAGQAAAABAAAAlgAAAJYAAAAVAAAAYAAAAAAAAAAAAAAADwAAACADAAAAAAAAAAAAAAEAAACgMgAAVgcAAKr4//8BAAAAf39/AAEAAABkAAAAAAAAABQAAABAHwAAAAAAACYAAAAAAAAAwOD//wAAAAAmAAAAZAAAABYAAABMAAAAAAAAAAAAAAAEAAAAAAAAAAEAAACAgIAKAAAAACgAAAAoAAAAZAAAAGQAAAAAAAAAzMzMAAAAAABQAAAAUAAAAGQAAABkAAAAAAAAABcAAAAUAAAAAAAAAAAAAAD/fwAA/38AAAAAAAAJAAAABAAAAADB/SQeAAAAaAAAAAAAAAAAAAAAAAAAAAAAAAAAAAAAECcAABAnAAAAAAAAAAAAAAAAAAAAAAAAAAAAAAAAAAAAAAAAAAAAABQAAAAAAAAAwMD/AAAAAABkAAAAMgAAAAAAAABkAAAAAAAAAH9/fwAKAAAAIgAAABgAAAAAAAAAAAAAAAAAAAAAAAAAAAAAAAAAAAAkAAAAJAAAAAAAAAAHAAAAAAAAAAAAAAAAAAAAAAAAAAAAAAAAAAAAf39/ACUAAABYAAAAAAAAAAAAAAAAAAAAAAAAAAAAAAAAAAAAAAAAAAAAAAAAAAAAAAAAAAAAAAA/AAAAAAAAAKCGAQAAAAAAAAAAAAAAAAAMAAAAAQAAAAAAAAAAAAAAAAAAAB8AAABUAAAAu+DjBf///wEAAAAAAAAAAAAAAAAAAAAAAAAAAAAAAAAAAAAAAAAAAAAAAAJ/f38AgICAA8zMzADAwP8Af39/AAAAAAAAAAAAAAAAAAAAAAAAAAAAIQAAABgAAAAUAAAAMBUAABAWAACqIAAAEhYAAAAAAAAmAAAACAAAAP//////////"/>
+                <pr:smNativeData xmlns:pr="smNativeData" xmlns="smNativeData" val="SMDATA_15_MvzhaRMAAAAlAAAACgAAAA8BAAAAkAAAAEgAAACQAAAASAAAAAAAAAAAAAAAAAAAAAEAAABQAAAAAAAAAAAA4D8AAAAAAADgPwAAAAAAAOA/AAAAAAAA4D8AAAAAAADgPwAAAAAAAOA/AAAAAAAA4D8AAAAAAADgPwAAAAAAAOA/AAAAAAAA4D8CAAAAjAAAAAAAAAAAAAAAu+DjDP///wgAAAAAAAAAAAAAAAAAAAAAAAAAAAAAAAAAAAAAZAAAAAEAAABAAAAAAAAAAAAAAAAAAAAAAAAAAAAAAAAAAAAAAAAAAAAAAAAAAAAAAAAAAAAAAAAAAAAAAAAAAAAAAAAAAAAAAAAAAAAAAAAAAAAAAAAAAAAAAAAAAAAAFAAAADwAAAABAAAAAgAAAAAAAAlkAAAAAQAAABQAAAAUAAAAFAAAAAEAAAAAAAAAZAAAAGQAAAABAAAAlgAAAJYAAAAVAAAAYAAAAAAAAAAAAAAADwAAACADAAAAAAAAAAAAAAEAAACgMgAAVgcAAKr4//8BAAAAf39/AAEAAABkAAAAAAAAABQAAABAHwAAAAAAACYAAAAAAAAAwOD//wAAAAAmAAAAZAAAABYAAABMAAAAAAAAAAAAAAAEAAAAAAAAAAEAAACAgIAKAAAAACgAAAAoAAAAZAAAAGQAAAAAAAAAzMzMAAAAAABQAAAAUAAAAGQAAABkAAAAAAAAABcAAAAUAAAAAAAAAAAAAAD/fwAA/38AAAAAAAAJAAAABAAAAADB/SQeAAAAaAAAAAAAAAAAAAAAAAAAAAAAAAAAAAAAECcAABAnAAAAAAAAAAAAAAAAAAAAAAAAAAAAAAAAAAAAAAAAAAAAABQAAAAAAAAAwMD/AAAAAABkAAAAMgAAAAAAAABkAAAAAAAAAH9/fwAKAAAAIgAAABgAAAAAAAAAAAAAAAAAAAAAAAAAAAAAAAAAAAAkAAAAJAAAAAAAAAAHAAAAAAAAAAAAAAAAAAAAAAAAAAAAAAAAAAAAf39/ACUAAABYAAAAAAAAAAAAAAAAAAAAAAAAAAAAAAAAAAAAAAAAAAAAAAAAAAAAAAAAAAAAAAA/AAAAAAAAAKCGAQAAAAAAAAAAAAAAAAAMAAAAAQAAAAAAAAAAAAAAAAAAAB8AAABUAAAAu+DjBf///wEAAAAAAAAAAAAAAAAAAAAAAAAAAAAAAAAAAAAAAAAAAAAAAAJ/f38AgICAA8zMzADAwP8Af39/AAAAAAAAAAAAAAAAAAAAAAAAAAAAIQAAABgAAAAUAAAAMBUAABAWAACqIAAAEhYAABAAAAAmAAAACAAAAP//////////"/>
               </a:ext>
             </a:extLst>
           </p:cNvSpPr>
@@ -3941,7 +3941,7 @@
           <p:cNvSpPr txBox="1">
             <a:extLst>
               <a:ext uri="smNativeData">
-                <pr:smNativeData xmlns:pr="smNativeData" xmlns="smNativeData" val="SMDATA_15_ZqHWaRMAAAAlAAAAEgAAAA8BAAAAkAAAAEgAAACQAAAASAAAAAAAAAABAAAAAAAAAAEAAABQAAAAAAAAAAAA4D8AAAAAAADgPwAAAAAAAOA/AAAAAAAA4D8AAAAAAADgPwAAAAAAAOA/AAAAAAAA4D8AAAAAAADgPwAAAAAAAOA/AAAAAAAA4D8CAAAAjAAAAAEAAAAAAAAAAP8AAP///wgAAAAAAAAAAAAAAAAAAAAAAAAAAAAAAAAAAAAAZAAAAAEAAABAAAAAAAAAAAAAAAAAAAAAAAAAAAAAAAAAAAAAAAAAAAAAAAAAAAAAAAAAAAAAAAAAAAAAAAAAAAAAAAAAAAAAAAAAAAAAAAAAAAAAAAAAAAAAAAAAAAAAFAAAADwAAAABAAAAAAAAAAAAAAkUAAAAAQAAABQAAAAUAAAAFAAAAAEAAAAAAAAAZAAAAGQAAAAAAAAAZAAAAGQAAAAVAAAAYAAAAAAAAAAAAAAADwAAACADAAAAAAAAAAAAAAEAAACgMgAAVgcAAKr4//8BAAAAf39/AAEAAABkAAAAAAAAABQAAABAHwAAAAAAACYAAAAAAAAAwOD//wAAAAAmAAAAZAAAABYAAABMAAAAAAAAAAAAAAAEAAAAAAAAAAEAAACAgIAKAAAAACgAAAAoAAAAZAAAAGQAAAAAAAAAzMzMAAAAAABQAAAAUAAAAGQAAABkAAAAAAAAABcAAAAUAAAAAAAAAIEHAAD/fwAA/38AAAAAAAAJAAAABAAAAAsAAAAeAAAAaAAAAAAAAAAAAAAAAAAAAAAAAAAAAAAAECcAABAnAAAAAAAAAAAAAAAAAAAAAAAAAAAAAAAAAAAAAAAAAAAAABQAAAAAAAAAwMD/AAAAAABkAAAAMgAAAAAAAABkAAAAAAAAAH9/fwAKAAAAIgAAABgAAAAAAAAAAAAAAAAAAAAAAAAAAAAAAAAAAAAkAAAAJAAAAAAAAAAHAAAAAAAAAAAAAAAAAAAAAAAAAAAAAAAAAAAAf39/ACUAAABYAAAAAAAAAAAAAAAAAAAAAAAAAAAAAAAAAAAAAAAAAAAAAAAAAAAAAAAAAAAAAAA/AAAAAAAAAKCGAQAAAAAAAAAAAAAAAAAMAAAAAQAAAAAAAAAAAAAAAAAAAB8AAABUAAAAAP8AAP///wEAAAAAAAAAAAAAAAAAAAAAAAAAAAAAAAAAAAAAAAAAAAAAAAJ/f38AgICAA8zMzADAwP8Af39/AAAAAAAAAAAAAAAAAAAAAAAAAAAAIQAAABgAAAAUAAAADyAAAP0MAAD6KwAA9hAAABAAAAAmAAAACAAAAP//////////"/>
+                <pr:smNativeData xmlns:pr="smNativeData" xmlns="smNativeData" val="SMDATA_15_MvzhaRMAAAAlAAAAEgAAAA8BAAAAkAAAAEgAAACQAAAASAAAAAAAAAABAAAAAAAAAAEAAABQAAAAAAAAAAAA4D8AAAAAAADgPwAAAAAAAOA/AAAAAAAA4D8AAAAAAADgPwAAAAAAAOA/AAAAAAAA4D8AAAAAAADgPwAAAAAAAOA/AAAAAAAA4D8CAAAAjAAAAAEAAAAAAAAAAP8AAP///wgAAAAAAAAAAAAAAAAAAAAAAAAAAAAAAAAAAAAAZAAAAAEAAABAAAAAAAAAAAAAAAAAAAAAAAAAAAAAAAAAAAAAAAAAAAAAAAAAAAAAAAAAAAAAAAAAAAAAAAAAAAAAAAAAAAAAAAAAAAAAAAAAAAAAAAAAAAAAAAAAAAAAFAAAADwAAAABAAAAAAAAAAAAAAkUAAAAAQAAABQAAAAUAAAAFAAAAAEAAAAAAAAAZAAAAGQAAAAAAAAAZAAAAGQAAAAVAAAAYAAAAAAAAAAAAAAADwAAACADAAAAAAAAAAAAAAEAAACgMgAAVgcAAKr4//8BAAAAf39/AAEAAABkAAAAAAAAABQAAABAHwAAAAAAACYAAAAAAAAAwOD//wAAAAAmAAAAZAAAABYAAABMAAAAAAAAAAAAAAAEAAAAAAAAAAEAAACAgIAKAAAAACgAAAAoAAAAZAAAAGQAAAAAAAAAzMzMAAAAAABQAAAAUAAAAGQAAABkAAAAAAAAABcAAAAUAAAAAAAAAIEHAAD/fwAA/38AAAAAAAAJAAAABAAAAAsAAAAeAAAAaAAAAAAAAAAAAAAAAAAAAAAAAAAAAAAAECcAABAnAAAAAAAAAAAAAAAAAAAAAAAAAAAAAAAAAAAAAAAAAAAAABQAAAAAAAAAwMD/AAAAAABkAAAAMgAAAAAAAABkAAAAAAAAAH9/fwAKAAAAIgAAABgAAAAAAAAAAAAAAAAAAAAAAAAAAAAAAAAAAAAkAAAAJAAAAAAAAAAHAAAAAAAAAAAAAAAAAAAAAAAAAAAAAAAAAAAAf39/ACUAAABYAAAAAAAAAAAAAAAAAAAAAAAAAAAAAAAAAAAAAAAAAAAAAAAAAAAAAAAAAAAAAAA/AAAAAAAAAKCGAQAAAAAAAAAAAAAAAAAMAAAAAQAAAAAAAAAAAAAAAAAAAB8AAABUAAAAAP8AAP///wEAAAAAAAAAAAAAAAAAAAAAAAAAAAAAAAAAAAAAAAAAAAAAAAJ/f38AgICAA8zMzADAwP8Af39/AAAAAAAAAAAAAAAAAAAAAAAAAAAAIQAAABgAAAAUAAAADyAAAP0MAAD6KwAA9hAAABAAAAAmAAAACAAAAP//////////"/>
               </a:ext>
             </a:extLst>
           </p:cNvSpPr>
@@ -3993,7 +3993,7 @@
           <p:cNvSpPr txBox="1">
             <a:extLst>
               <a:ext uri="smNativeData">
-                <pr:smNativeData xmlns:pr="smNativeData" xmlns="smNativeData" val="SMDATA_15_ZqHWaRMAAAAlAAAAEgAAAA8BAAAAkAAAAEgAAACQAAAASAAAAAAAAAABAAAAAAAAAAEAAABQAAAAAAAAAAAA4D8AAAAAAADgPwAAAAAAAOA/AAAAAAAA4D8AAAAAAADgPwAAAAAAAOA/AAAAAAAA4D8AAAAAAADgPwAAAAAAAOA/AAAAAAAA4D8CAAAAjAAAAAEAAAAAAAAAAP8AAP///wgAAAAAAAAAAAAAAAAAAAAAAAAAAAAAAAAAAAAAZAAAAAEAAABAAAAAAAAAAAAAAAAAAAAAAAAAAAAAAAAAAAAAAAAAAAAAAAAAAAAAAAAAAAAAAAAAAAAAAAAAAAAAAAAAAAAAAAAAAAAAAAAAAAAAAAAAAAAAAAAAAAAAFAAAADwAAAABAAAAAAAAAAAAAAkUAAAAAQAAABQAAAAUAAAAFAAAAAEAAAAAAAAAZAAAAGQAAAAAAAAAZAAAAGQAAAAVAAAAYAAAAAAAAAAAAAAADwAAACADAAAAAAAAAAAAAAEAAACgMgAAVgcAAKr4//8BAAAAf39/AAEAAABkAAAAAAAAABQAAABAHwAAAAAAACYAAAAAAAAAwOD//wAAAAAmAAAAZAAAABYAAABMAAAAAAAAAAAAAAAEAAAAAAAAAAEAAACAgIAKAAAAACgAAAAoAAAAZAAAAGQAAAAAAAAAzMzMAAAAAABQAAAAUAAAAGQAAABkAAAAAAAAABcAAAAUAAAAAAAAAIgDAAD/fwAA/38AAAAAAAAJAAAABAAAAA4AAAAeAAAAaAAAAAAAAAAAAAAAAAAAAAAAAAAAAAAAECcAABAnAAAAAAAAAAAAAAAAAAAAAAAAAAAAAAAAAAAAAAAAAAAAABQAAAAAAAAAwMD/AAAAAABkAAAAMgAAAAAAAABkAAAAAAAAAH9/fwAKAAAAIgAAABgAAAAAAAAAAAAAAAAAAAAAAAAAAAAAAAAAAAAkAAAAJAAAAAAAAAAHAAAAAAAAAAAAAAAAAAAAAAAAAAAAAAAAAAAAf39/ACUAAABYAAAAAAAAAAAAAAAAAAAAAAAAAAAAAAAAAAAAAAAAAAAAAAAAAAAAAAAAAAAAAAA/AAAAAAAAAKCGAQAAAAAAAAAAAAAAAAAMAAAAAQAAAAAAAAAAAAAAAAAAAB8AAABUAAAAAP8AAP///wEAAAAAAAAAAAAAAAAAAAAAAAAAAAAAAAAAAAAAAAAAAAAAAAJ/f38AgICAA8zMzADAwP8Af39/AAAAAAAAAAAAAAAAAAAAAAAAAAAAIQAAABgAAAAUAAAAJBQAAAENAACHHAAA+hAAABAAAAAmAAAACAAAAP//////////"/>
+                <pr:smNativeData xmlns:pr="smNativeData" xmlns="smNativeData" val="SMDATA_15_MvzhaRMAAAAlAAAAEgAAAA8BAAAAkAAAAEgAAACQAAAASAAAAAAAAAABAAAAAAAAAAEAAABQAAAAAAAAAAAA4D8AAAAAAADgPwAAAAAAAOA/AAAAAAAA4D8AAAAAAADgPwAAAAAAAOA/AAAAAAAA4D8AAAAAAADgPwAAAAAAAOA/AAAAAAAA4D8CAAAAjAAAAAEAAAAAAAAAAP8AAP///wgAAAAAAAAAAAAAAAAAAAAAAAAAAAAAAAAAAAAAZAAAAAEAAABAAAAAAAAAAAAAAAAAAAAAAAAAAAAAAAAAAAAAAAAAAAAAAAAAAAAAAAAAAAAAAAAAAAAAAAAAAAAAAAAAAAAAAAAAAAAAAAAAAAAAAAAAAAAAAAAAAAAAFAAAADwAAAABAAAAAAAAAAAAAAkUAAAAAQAAABQAAAAUAAAAFAAAAAEAAAAAAAAAZAAAAGQAAAAAAAAAZAAAAGQAAAAVAAAAYAAAAAAAAAAAAAAADwAAACADAAAAAAAAAAAAAAEAAACgMgAAVgcAAKr4//8BAAAAf39/AAEAAABkAAAAAAAAABQAAABAHwAAAAAAACYAAAAAAAAAwOD//wAAAAAmAAAAZAAAABYAAABMAAAAAAAAAAAAAAAEAAAAAAAAAAEAAACAgIAKAAAAACgAAAAoAAAAZAAAAGQAAAAAAAAAzMzMAAAAAABQAAAAUAAAAGQAAABkAAAAAAAAABcAAAAUAAAAAAAAAIgDAAD/fwAA/38AAAAAAAAJAAAABAAAAA4AAAAeAAAAaAAAAAAAAAAAAAAAAAAAAAAAAAAAAAAAECcAABAnAAAAAAAAAAAAAAAAAAAAAAAAAAAAAAAAAAAAAAAAAAAAABQAAAAAAAAAwMD/AAAAAABkAAAAMgAAAAAAAABkAAAAAAAAAH9/fwAKAAAAIgAAABgAAAAAAAAAAAAAAAAAAAAAAAAAAAAAAAAAAAAkAAAAJAAAAAAAAAAHAAAAAAAAAAAAAAAAAAAAAAAAAAAAAAAAAAAAf39/ACUAAABYAAAAAAAAAAAAAAAAAAAAAAAAAAAAAAAAAAAAAAAAAAAAAAAAAAAAAAAAAAAAAAA/AAAAAAAAAKCGAQAAAAAAAAAAAAAAAAAMAAAAAQAAAAAAAAAAAAAAAAAAAB8AAABUAAAAAP8AAP///wEAAAAAAAAAAAAAAAAAAAAAAAAAAAAAAAAAAAAAAAAAAAAAAAJ/f38AgICAA8zMzADAwP8Af39/AAAAAAAAAAAAAAAAAAAAAAAAAAAAIQAAABgAAAAUAAAAJBQAAAENAACHHAAA+hAAABAAAAAmAAAACAAAAP//////////"/>
               </a:ext>
             </a:extLst>
           </p:cNvSpPr>
@@ -4045,7 +4045,7 @@
           <p:cNvSpPr txBox="1">
             <a:extLst>
               <a:ext uri="smNativeData">
-                <pr:smNativeData xmlns:pr="smNativeData" xmlns="smNativeData" val="SMDATA_15_ZqHWaRMAAAAlAAAAEgAAAA8BAAAAkAAAAEgAAACQAAAASAAAAAAAAAABAAAAAAAAAAEAAABQAAAAAAAAAAAA4D8AAAAAAADgPwAAAAAAAOA/AAAAAAAA4D8AAAAAAADgPwAAAAAAAOA/AAAAAAAA4D8AAAAAAADgPwAAAAAAAOA/AAAAAAAA4D8CAAAAjAAAAAEAAAAAAAAAAP8AAP///wgAAAAAAAAAAAAAAAAAAAAAAAAAAAAAAAAAAAAAZAAAAAEAAABAAAAAAAAAAAAAAAAAAAAAAAAAAAAAAAAAAAAAAAAAAAAAAAAAAAAAAAAAAAAAAAAAAAAAAAAAAAAAAAAAAAAAAAAAAAAAAAAAAAAAAAAAAAAAAAAAAAAAFAAAADwAAAABAAAAAAAAAAAAAAkUAAAAAQAAABQAAAAUAAAAFAAAAAEAAAAAAAAAZAAAAGQAAAAAAAAAZAAAAGQAAAAVAAAAYAAAAAAAAAAAAAAADwAAACADAAAAAAAAAAAAAAEAAACgMgAAVgcAAKr4//8BAAAAf39/AAEAAABkAAAAAAAAABQAAABAHwAAAAAAACYAAAAAAAAAwOD//wAAAAAmAAAAZAAAABYAAABMAAAAAAAAAAAAAAAEAAAAAAAAAAEAAACAgIAKAAAAACgAAAAoAAAAZAAAAGQAAAAAAAAAzMzMAAAAAABQAAAAUAAAAGQAAABkAAAAAAAAABcAAAAUAAAAAAAAAIgDAAD/fwAA/38AAAAAAAAJAAAABAAAACMAAAAeAAAAaAAAAAAAAAAAAAAAAAAAAAAAAAAAAAAAECcAABAnAAAAAAAAAAAAAAAAAAAAAAAAAAAAAAAAAAAAAAAAAAAAABQAAAAAAAAAwMD/AAAAAABkAAAAMgAAAAAAAABkAAAAAAAAAH9/fwAKAAAAIgAAABgAAAAAAAAAAAAAAAAAAAAAAAAAAAAAAAAAAAAkAAAAJAAAAAAAAAAHAAAAAAAAAAAAAAAAAAAAAAAAAAAAAAAAAAAAf39/ACUAAABYAAAAAAAAAAAAAAAAAAAAAAAAAAAAAAAAAAAAAAAAAAAAAAAAAAAAAAAAAAAAAAA/AAAAAAAAAKCGAQAAAAAAAAAAAAAAAAAMAAAAAQAAAAAAAAAAAAAAAAAAAB8AAABUAAAAAP8AAP///wEAAAAAAAAAAAAAAAAAAAAAAAAAAAAAAAAAAAAAAAAAAAAAAAJ/f38AgICAA8zMzADAwP8Af39/AAAAAAAAAAAAAAAAAAAAAAAAAAAAIQAAABgAAAAUAAAAOxUAAJIGAABpGwAAiwoAABAAAAAmAAAACAAAAP//////////"/>
+                <pr:smNativeData xmlns:pr="smNativeData" xmlns="smNativeData" val="SMDATA_15_MvzhaRMAAAAlAAAAEgAAAA8BAAAAkAAAAEgAAACQAAAASAAAAAAAAAABAAAAAAAAAAEAAABQAAAAAAAAAAAA4D8AAAAAAADgPwAAAAAAAOA/AAAAAAAA4D8AAAAAAADgPwAAAAAAAOA/AAAAAAAA4D8AAAAAAADgPwAAAAAAAOA/AAAAAAAA4D8CAAAAjAAAAAEAAAAAAAAAAP8AAP///wgAAAAAAAAAAAAAAAAAAAAAAAAAAAAAAAAAAAAAZAAAAAEAAABAAAAAAAAAAAAAAAAAAAAAAAAAAAAAAAAAAAAAAAAAAAAAAAAAAAAAAAAAAAAAAAAAAAAAAAAAAAAAAAAAAAAAAAAAAAAAAAAAAAAAAAAAAAAAAAAAAAAAFAAAADwAAAABAAAAAAAAAAAAAAkUAAAAAQAAABQAAAAUAAAAFAAAAAEAAAAAAAAAZAAAAGQAAAAAAAAAZAAAAGQAAAAVAAAAYAAAAAAAAAAAAAAADwAAACADAAAAAAAAAAAAAAEAAACgMgAAVgcAAKr4//8BAAAAf39/AAEAAABkAAAAAAAAABQAAABAHwAAAAAAACYAAAAAAAAAwOD//wAAAAAmAAAAZAAAABYAAABMAAAAAAAAAAAAAAAEAAAAAAAAAAEAAACAgIAKAAAAACgAAAAoAAAAZAAAAGQAAAAAAAAAzMzMAAAAAABQAAAAUAAAAGQAAABkAAAAAAAAABcAAAAUAAAAAAAAAIgDAAD/fwAA/38AAAAAAAAJAAAABAAAACMAAAAeAAAAaAAAAAAAAAAAAAAAAAAAAAAAAAAAAAAAECcAABAnAAAAAAAAAAAAAAAAAAAAAAAAAAAAAAAAAAAAAAAAAAAAABQAAAAAAAAAwMD/AAAAAABkAAAAMgAAAAAAAABkAAAAAAAAAH9/fwAKAAAAIgAAABgAAAAAAAAAAAAAAAAAAAAAAAAAAAAAAAAAAAAkAAAAJAAAAAAAAAAHAAAAAAAAAAAAAAAAAAAAAAAAAAAAAAAAAAAAf39/ACUAAABYAAAAAAAAAAAAAAAAAAAAAAAAAAAAAAAAAAAAAAAAAAAAAAAAAAAAAAAAAAAAAAA/AAAAAAAAAKCGAQAAAAAAAAAAAAAAAAAMAAAAAQAAAAAAAAAAAAAAAAAAAB8AAABUAAAAAP8AAP///wEAAAAAAAAAAAAAAAAAAAAAAAAAAAAAAAAAAAAAAAAAAAAAAAJ/f38AgICAA8zMzADAwP8Af39/AAAAAAAAAAAAAAAAAAAAAAAAAAAAIQAAABgAAAAUAAAAOxUAAJIGAABpGwAAiwoAABAAAAAmAAAACAAAAP//////////"/>
               </a:ext>
             </a:extLst>
           </p:cNvSpPr>
@@ -4097,7 +4097,7 @@
           <p:cNvSpPr txBox="1">
             <a:extLst>
               <a:ext uri="smNativeData">
-                <pr:smNativeData xmlns:pr="smNativeData" xmlns="smNativeData" val="SMDATA_15_ZqHWaRMAAAAlAAAAEgAAAA8BAAAAkAAAAEgAAACQAAAASAAAAAAAAAABAAAAAAAAAAEAAABQAAAAAAAAAAAA4D8AAAAAAADgPwAAAAAAAOA/AAAAAAAA4D8AAAAAAADgPwAAAAAAAOA/AAAAAAAA4D8AAAAAAADgPwAAAAAAAOA/AAAAAAAA4D8CAAAAjAAAAAEAAAAAAAAA//8AAP///wgAAAAAAAAAAAAAAAAAAAAAAAAAAAAAAAAAAAAAZAAAAAEAAABAAAAAAAAAAAAAAAAAAAAAAAAAAAAAAAAAAAAAAAAAAAAAAAAAAAAAAAAAAAAAAAAAAAAAAAAAAAAAAAAAAAAAAAAAAAAAAAAAAAAAAAAAAAAAAAAAAAAAFAAAADwAAAABAAAAAAAAAAAAAAkUAAAAAQAAABQAAAAUAAAAFAAAAAEAAAAAAAAAZAAAAGQAAAAAAAAAZAAAAGQAAAAVAAAAYAAAAAAAAAAAAAAADwAAACADAAAAAAAAAAAAAAEAAACgMgAAVgcAAKr4//8BAAAAf39/AAEAAABkAAAAAAAAABQAAABAHwAAAAAAACYAAAAAAAAAwOD//wAAAAAmAAAAZAAAABYAAABMAAAAAAAAAAAAAAAEAAAAAAAAAAEAAACAgIAKAAAAACgAAAAoAAAAZAAAAGQAAAAAAAAAzMzMAAAAAABQAAAAUAAAAGQAAABkAAAAAAAAABcAAAAUAAAAAAAAAIgDAAD/fwAA/38AAAAAAAAJAAAABAAAAAEBAQEeAAAAaAAAAAAAAAAAAAAAAAAAAAAAAAAAAAAAECcAABAnAAAAAAAAAAAAAAAAAAAAAAAAAAAAAAAAAAAAAAAAAAAAABQAAAAAAAAAwMD/AAAAAABkAAAAMgAAAAAAAABkAAAAAAAAAH9/fwAKAAAAIgAAABgAAAAAAAAAAAAAAAAAAAAAAAAAAAAAAAAAAAAkAAAAJAAAAAAAAAAHAAAAAAAAAAAAAAAAAAAAAAAAAAAAAAAAAAAAf39/ACUAAABYAAAAAAAAAAAAAAAAAAAAAAAAAAAAAAAAAAAAAAAAAAAAAAAAAAAAAAAAAAAAAAA/AAAAAAAAAKCGAQAAAAAAAAAAAAAAAAAMAAAAAQAAAAAAAAAAAAAAAAAAAB8AAABUAAAA//8AAP///wEAAAAAAAAAAAAAAAAAAAAAAAAAAAAAAAAAAAAAAAAAAAAAAAJ/f38AgICAA8zMzADAwP8Af39/AAAAAAAAAAAAAAAAAAAAAAAAAAAAIQAAABgAAAAUAAAAwQsAAIgNAADvEQAAehAAABAAAAAmAAAACAAAAP//////////"/>
+                <pr:smNativeData xmlns:pr="smNativeData" xmlns="smNativeData" val="SMDATA_15_MvzhaRMAAAAlAAAAEgAAAA8BAAAAkAAAAEgAAACQAAAASAAAAAAAAAABAAAAAAAAAAEAAABQAAAAAAAAAAAA4D8AAAAAAADgPwAAAAAAAOA/AAAAAAAA4D8AAAAAAADgPwAAAAAAAOA/AAAAAAAA4D8AAAAAAADgPwAAAAAAAOA/AAAAAAAA4D8CAAAAjAAAAAEAAAAAAAAA//8AAP///wgAAAAAAAAAAAAAAAAAAAAAAAAAAAAAAAAAAAAAZAAAAAEAAABAAAAAAAAAAAAAAAAAAAAAAAAAAAAAAAAAAAAAAAAAAAAAAAAAAAAAAAAAAAAAAAAAAAAAAAAAAAAAAAAAAAAAAAAAAAAAAAAAAAAAAAAAAAAAAAAAAAAAFAAAADwAAAABAAAAAAAAAAAAAAkUAAAAAQAAABQAAAAUAAAAFAAAAAEAAAAAAAAAZAAAAGQAAAAAAAAAZAAAAGQAAAAVAAAAYAAAAAAAAAAAAAAADwAAACADAAAAAAAAAAAAAAEAAACgMgAAVgcAAKr4//8BAAAAf39/AAEAAABkAAAAAAAAABQAAABAHwAAAAAAACYAAAAAAAAAwOD//wAAAAAmAAAAZAAAABYAAABMAAAAAAAAAAAAAAAEAAAAAAAAAAEAAACAgIAKAAAAACgAAAAoAAAAZAAAAGQAAAAAAAAAzMzMAAAAAABQAAAAUAAAAGQAAABkAAAAAAAAABcAAAAUAAAAAAAAAIgDAAD/fwAA/38AAAAAAAAJAAAABAAAAAEBAQEeAAAAaAAAAAAAAAAAAAAAAAAAAAAAAAAAAAAAECcAABAnAAAAAAAAAAAAAAAAAAAAAAAAAAAAAAAAAAAAAAAAAAAAABQAAAAAAAAAwMD/AAAAAABkAAAAMgAAAAAAAABkAAAAAAAAAH9/fwAKAAAAIgAAABgAAAAAAAAAAAAAAAAAAAAAAAAAAAAAAAAAAAAkAAAAJAAAAAAAAAAHAAAAAAAAAAAAAAAAAAAAAAAAAAAAAAAAAAAAf39/ACUAAABYAAAAAAAAAAAAAAAAAAAAAAAAAAAAAAAAAAAAAAAAAAAAAAAAAAAAAAAAAAAAAAA/AAAAAAAAAKCGAQAAAAAAAAAAAAAAAAAMAAAAAQAAAAAAAAAAAAAAAAAAAB8AAABUAAAA//8AAP///wEAAAAAAAAAAAAAAAAAAAAAAAAAAAAAAAAAAAAAAAAAAAAAAAJ/f38AgICAA8zMzADAwP8Af39/AAAAAAAAAAAAAAAAAAAAAAAAAAAAIQAAABgAAAAUAAAAwQsAAIgNAADvEQAAehAAABAAAAAmAAAACAAAAP//////////"/>
               </a:ext>
             </a:extLst>
           </p:cNvSpPr>
@@ -4137,11 +4137,11 @@
       </p:sp>
       <p:sp>
         <p:nvSpPr>
-          <p:cNvPr id="6" name="Textbox5"/>
+          <p:cNvPr id="6" name="Textbox6"/>
           <p:cNvSpPr txBox="1">
             <a:extLst>
               <a:ext uri="smNativeData">
-                <pr:smNativeData xmlns:pr="smNativeData" xmlns="smNativeData" val="SMDATA_15_ZqHWaRMAAAAlAAAAEgAAAA8BAAAAkAAAAEgAAACQAAAASAAAAAAAAAABAAAAAAAAAAEAAABQAAAAAAAAAAAA4D8AAAAAAADgPwAAAAAAAOA/AAAAAAAA4D8AAAAAAADgPwAAAAAAAOA/AAAAAAAA4D8AAAAAAADgPwAAAAAAAOA/AAAAAAAA4D8CAAAAjAAAAAEAAAAAAAAAAP8AAP///wgAAAAAAAAAAAAAAAAAAAAAAAAAAAAAAAAAAAAAZAAAAAEAAABAAAAAAAAAAAAAAAAAAAAAAAAAAAAAAAAAAAAAAAAAAAAAAAAAAAAAAAAAAAAAAAAAAAAAAAAAAAAAAAAAAAAAAAAAAAAAAAAAAAAAAAAAAAAAAAAAAAAAFAAAADwAAAABAAAAAAAAAAAAAAkUAAAAAQAAABQAAAAUAAAAFAAAAAEAAAAAAAAAZAAAAGQAAAAAAAAAZAAAAGQAAAAVAAAAYAAAAAAAAAAAAAAADwAAACADAAAAAAAAAAAAAAEAAACgMgAAVgcAAKr4//8BAAAAf39/AAEAAABkAAAAAAAAABQAAABAHwAAAAAAACYAAAAAAAAAwOD//wAAAAAmAAAAZAAAABYAAABMAAAAAAAAAAAAAAAEAAAAAAAAAAEAAACAgIAKAAAAACgAAAAoAAAAZAAAAGQAAAAAAAAAzMzMAAAAAABQAAAAUAAAAGQAAABkAAAAAAAAABcAAAAUAAAAAAAAAIgDAAD/fwAA/38AAAAAAAAJAAAABAAAACMAAAAeAAAAaAAAAAAAAAAAAAAAAAAAAAAAAAAAAAAAECcAABAnAAAAAAAAAAAAAAAAAAAAAAAAAAAAAAAAAAAAAAAAAAAAABQAAAAAAAAAwMD/AAAAAABkAAAAMgAAAAAAAABkAAAAAAAAAH9/fwAKAAAAIgAAABgAAAAAAAAAAAAAAAAAAAAAAAAAAAAAAAAAAAAkAAAAJAAAAAAAAAAHAAAAAAAAAAAAAAAAAAAAAAAAAAAAAAAAAAAAf39/ACUAAABYAAAAAAAAAAAAAAAAAAAAAAAAAAAAAAAAAAAAAAAAAAAAAAAAAAAAAAAAAAAAAAA/AAAAAAAAAKCGAQAAAAAAAAAAAAAAAAAMAAAAAQAAAAAAAAAAAAAAAAAAAB8AAABUAAAAAP8AAP///wEAAAAAAAAAAAAAAAAAAAAAAAAAAAAAAAAAAAAAAAAAAAAAAAJ/f38AgICAA8zMzADAwP8Af39/AAAAAAAAAAAAAAAAAAAAAAAAAAAAIQAAABgAAAAUAAAAfiIAAHgGAACOKQAAcQoAABAAAAAmAAAACAAAAP//////////"/>
+                <pr:smNativeData xmlns:pr="smNativeData" xmlns="smNativeData" val="SMDATA_15_MvzhaRMAAAAlAAAAEgAAAA8BAAAAkAAAAEgAAACQAAAASAAAAAAAAAABAAAAAAAAAAEAAABQAAAAAAAAAAAA4D8AAAAAAADgPwAAAAAAAOA/AAAAAAAA4D8AAAAAAADgPwAAAAAAAOA/AAAAAAAA4D8AAAAAAADgPwAAAAAAAOA/AAAAAAAA4D8CAAAAjAAAAAEAAAAAAAAA//8AAP///wgAAAAAAAAAAAAAAAAAAAAAAAAAAAAAAAAAAAAAZAAAAAEAAABAAAAAAAAAAAAAAAAAAAAAAAAAAAAAAAAAAAAAAAAAAAAAAAAAAAAAAAAAAAAAAAAAAAAAAAAAAAAAAAAAAAAAAAAAAAAAAAAAAAAAAAAAAAAAAAAAAAAAFAAAADwAAAABAAAAAAAAAAAAAAkUAAAAAQAAABQAAAAUAAAAFAAAAAEAAAAAAAAAZAAAAGQAAAAAAAAAZAAAAGQAAAAVAAAAYAAAAAAAAAAAAAAADwAAACADAAAAAAAAAAAAAAEAAACgMgAAVgcAAKr4//8BAAAAf39/AAEAAABkAAAAAAAAABQAAABAHwAAAAAAACYAAAAAAAAAwOD//wAAAAAmAAAAZAAAABYAAABMAAAAAAAAAAAAAAAEAAAAAAAAAAEAAACAgIAKAAAAACgAAAAoAAAAZAAAAGQAAAAAAAAAzMzMAAAAAABQAAAAUAAAAGQAAABkAAAAAAAAABcAAAAUAAAAAAAAAIEHAAD/fwAA/38AAAAAAAAJAAAABAAAACMAAAAeAAAAaAAAAAAAAAAAAAAAAAAAAAAAAAAAAAAAECcAABAnAAAAAAAAAAAAAAAAAAAAAAAAAAAAAAAAAAAAAAAAAAAAABQAAAAAAAAAwMD/AAAAAABkAAAAMgAAAAAAAABkAAAAAAAAAH9/fwAKAAAAIgAAABgAAAAAAAAAAAAAAAAAAAAAAAAAAAAAAAAAAAAkAAAAJAAAAAAAAAAHAAAAAAAAAAAAAAAAAAAAAAAAAAAAAAAAAAAAf39/ACUAAABYAAAAAAAAAAAAAAAAAAAAAAAAAAAAAAAAAAAAAAAAAAAAAAAAAAAAAAAAAAAAAAA/AAAAAAAAAKCGAQAAAAAAAAAAAAAAAAAMAAAAAQAAAAAAAAAAAAAAAAAAAB8AAABUAAAA//8AAP///wEAAAAAAAAAAAAAAAAAAAAAAAAAAAAAAAAAAAAAAAAAAAAAAAJ/f38AgICAA8zMzADAwP8Af39/AAAAAAAAAAAAAAAAAAAAAAAAAAAAIQAAABgAAAAUAAAA8SAAAFsUAAAYKwAAVBgAABAAAAAmAAAACAAAAP//////////"/>
               </a:ext>
             </a:extLst>
           </p:cNvSpPr>
@@ -4149,8 +4149,104 @@
         </p:nvSpPr>
         <p:spPr>
           <a:xfrm>
-            <a:off x="5607050" y="1051560"/>
-            <a:ext cx="1148080" cy="645795"/>
+            <a:off x="5354955" y="3308985"/>
+            <a:ext cx="1650365" cy="645795"/>
+          </a:xfrm>
+          <a:prstGeom prst="rect">
+            <a:avLst/>
+          </a:prstGeom>
+          <a:solidFill>
+            <a:srgbClr val="FFFF00"/>
+          </a:solidFill>
+          <a:ln w="12700" cap="flat" cmpd="sng" algn="ctr">
+            <a:solidFill>
+              <a:schemeClr val="tx1"/>
+            </a:solidFill>
+            <a:prstDash val="solid"/>
+            <a:headEnd type="none"/>
+            <a:tailEnd type="none"/>
+          </a:ln>
+          <a:effectLst/>
+        </p:spPr>
+        <p:txBody>
+          <a:bodyPr vert="horz" wrap="square" numCol="1" spcCol="215900" anchor="ctr"/>
+          <a:lstStyle/>
+          <a:p>
+            <a:pPr algn="ctr"/>
+            <a:r>
+              <a:t>ZigClassEntry</a:t>
+            </a:r>
+          </a:p>
+          <a:p>
+            <a:pPr algn="ctr">
+              <a:defRPr sz="1200" cap="none"/>
+            </a:pPr>
+            <a:r>
+              <a:t>class entry</a:t>
+            </a:r>
+          </a:p>
+        </p:txBody>
+      </p:sp>
+      <p:sp>
+        <p:nvSpPr>
+          <p:cNvPr id="7" name="Textbox7"/>
+          <p:cNvSpPr txBox="1">
+            <a:extLst>
+              <a:ext uri="smNativeData">
+                <pr:smNativeData xmlns:pr="smNativeData" xmlns="smNativeData" val="SMDATA_15_MvzhaRMAAAAlAAAAEgAAAA8BAAAAkAAAAEgAAACQAAAASAAAAAAAAAABAAAAAAAAAAEAAABQAAAAAAAAAAAA4D8AAAAAAADgPwAAAAAAAOA/AAAAAAAA4D8AAAAAAADgPwAAAAAAAOA/AAAAAAAA4D8AAAAAAADgPwAAAAAAAOA/AAAAAAAA4D8CAAAAjAAAAAEAAAAAAAAA//8AAP///wgAAAAAAAAAAAAAAAAAAAAAAAAAAAAAAAAAAAAAZAAAAAEAAABAAAAAAAAAAAAAAAAAAAAAAAAAAAAAAAAAAAAAAAAAAAAAAAAAAAAAAAAAAAAAAAAAAAAAAAAAAAAAAAAAAAAAAAAAAAAAAAAAAAAAAAAAAAAAAAAAAAAAFAAAADwAAAABAAAAAAAAAAAAAAkUAAAAAQAAABQAAAAUAAAAFAAAAAEAAAAAAAAAZAAAAGQAAAAAAAAAZAAAAGQAAAAVAAAAYAAAAAAAAAAAAAAADwAAACADAAAAAAAAAAAAAAEAAACgMgAAVgcAAKr4//8BAAAAf39/AAEAAABkAAAAAAAAABQAAABAHwAAAAAAACYAAAAAAAAAwOD//wAAAAAmAAAAZAAAABYAAABMAAAAAAAAAAAAAAAEAAAAAAAAAAEAAACAgIAKAAAAACgAAAAoAAAAZAAAAGQAAAAAAAAAzMzMAAAAAABQAAAAUAAAAGQAAABkAAAAAAAAABcAAAAUAAAAAAAAAIgDAAD/fwAA/38AAAAAAAAJAAAABAAAACMAAAAeAAAAaAAAAAAAAAAAAAAAAAAAAAAAAAAAAAAAECcAABAnAAAAAAAAAAAAAAAAAAAAAAAAAAAAAAAAAAAAAAAAAAAAABQAAAAAAAAAwMD/AAAAAABkAAAAMgAAAAAAAABkAAAAAAAAAH9/fwAKAAAAIgAAABgAAAAAAAAAAAAAAAAAAAAAAAAAAAAAAAAAAAAkAAAAJAAAAAAAAAAHAAAAAAAAAAAAAAAAAAAAAAAAAAAAAAAAAAAAf39/ACUAAABYAAAAAAAAAAAAAAAAAAAAAAAAAAAAAAAAAAAAAAAAAAAAAAAAAAAAAAAAAAAAAAA/AAAAAAAAAKCGAQAAAAAAAAAAAAAAAAAMAAAAAQAAAAAAAAAAAAAAAAAAAB8AAABUAAAA//8AAP///wEAAAAAAAAAAAAAAAAAAAAAAAAAAAAAAAAAAAAAAAAAAAAAAAJ/f38AgICAA8zMzADAwP8Af39/AAAAAAAAAAAAAAAAAAAAAAAAAAAAIQAAABgAAAAUAAAAgTIAAOUHAADkOgAA/AoAABAAAAAmAAAACAAAAP//////////"/>
+              </a:ext>
+            </a:extLst>
+          </p:cNvSpPr>
+          <p:nvPr/>
+        </p:nvSpPr>
+        <p:spPr>
+          <a:xfrm>
+            <a:off x="8209915" y="1283335"/>
+            <a:ext cx="1363345" cy="502285"/>
+          </a:xfrm>
+          <a:prstGeom prst="rect">
+            <a:avLst/>
+          </a:prstGeom>
+          <a:solidFill>
+            <a:srgbClr val="FFFF00"/>
+          </a:solidFill>
+          <a:ln w="12700" cap="flat" cmpd="sng" algn="ctr">
+            <a:solidFill>
+              <a:schemeClr val="tx1"/>
+            </a:solidFill>
+            <a:prstDash val="solid"/>
+            <a:headEnd type="none"/>
+            <a:tailEnd type="none"/>
+          </a:ln>
+          <a:effectLst/>
+        </p:spPr>
+        <p:txBody>
+          <a:bodyPr vert="horz" wrap="square" numCol="1" spcCol="215900" anchor="ctr"/>
+          <a:lstStyle/>
+          <a:p>
+            <a:pPr algn="ctr"/>
+            <a:r>
+              <a:t>ModuleHost</a:t>
+            </a:r>
+          </a:p>
+        </p:txBody>
+      </p:sp>
+      <p:sp>
+        <p:nvSpPr>
+          <p:cNvPr id="8" name="Textbox8"/>
+          <p:cNvSpPr txBox="1">
+            <a:extLst>
+              <a:ext uri="smNativeData">
+                <pr:smNativeData xmlns:pr="smNativeData" xmlns="smNativeData" val="SMDATA_15_MvzhaRMAAAAlAAAAEgAAAA8BAAAAkAAAAEgAAACQAAAASAAAAAAAAAABAAAAAAAAAAEAAABQAAAAAAAAAAAA4D8AAAAAAADgPwAAAAAAAOA/AAAAAAAA4D8AAAAAAADgPwAAAAAAAOA/AAAAAAAA4D8AAAAAAADgPwAAAAAAAOA/AAAAAAAA4D8CAAAAjAAAAAEAAAAAAAAAAP8AAP///wgAAAAAAAAAAAAAAAAAAAAAAAAAAAAAAAAAAAAAZAAAAAEAAABAAAAAAAAAAAAAAAAAAAAAAAAAAAAAAAAAAAAAAAAAAAAAAAAAAAAAAAAAAAAAAAAAAAAAAAAAAAAAAAAAAAAAAAAAAAAAAAAAAAAAAAAAAAAAAAAAAAAAFAAAADwAAAABAAAAAAAAAAAAAAkUAAAAAQAAABQAAAAUAAAAFAAAAAEAAAAAAAAAZAAAAGQAAAAAAAAAZAAAAGQAAAAVAAAAYAAAAAAAAAAAAAAADwAAACADAAAAAAAAAAAAAAEAAACgMgAAVgcAAKr4//8BAAAAf39/AAEAAABkAAAAAAAAABQAAABAHwAAAAAAACYAAAAAAAAAwOD//wAAAAAmAAAAZAAAABYAAABMAAAAAAAAAAAAAAAEAAAAAAAAAAEAAACAgIAKAAAAACgAAAAoAAAAZAAAAGQAAAAAAAAAzMzMAAAAAABQAAAAUAAAAGQAAABkAAAAAAAAABcAAAAUAAAAAAAAAIgDAAD/fwAA/38AAAAAAAAJAAAABAAAACMAAAAeAAAAaAAAAAAAAAAAAAAAAAAAAAAAAAAAAAAAECcAABAnAAAAAAAAAAAAAAAAAAAAAAAAAAAAAAAAAAAAAAAAAAAAABQAAAAAAAAAwMD/AAAAAABkAAAAMgAAAAAAAABkAAAAAAAAAH9/fwAKAAAAIgAAABgAAAAAAAAAAAAAAAAAAAAAAAAAAAAAAAAAAAAkAAAAJAAAAAAAAAAHAAAAAAAAAAAAAAAAAAAAAAAAAAAAAAAAAAAAf39/ACUAAABYAAAAAAAAAAAAAAAAAAAAAAAAAAAAAAAAAAAAAAAAAAAAAAAAAAAAAAAAAAAAAAA/AAAAAAAAAKCGAQAAAAAAAAAAAAAAAAAMAAAAAQAAAAAAAAAAAAAAAAAAAB8AAABUAAAAAP8AAP///wEAAAAAAAAAAAAAAAAAAAAAAAAAAAAAAAAAAAAAAAAAAAAAAAJ/f38AgICAA8zMzADAwP8Af39/AAAAAAAAAAAAAAAAAAAAAAAAAAAAIQAAABgAAAAUAAAALDEAAH8CAAA1PAAAlgUAABAAAAAmAAAACAAAAP//////////"/>
+              </a:ext>
+            </a:extLst>
+          </p:cNvSpPr>
+          <p:nvPr/>
+        </p:nvSpPr>
+        <p:spPr>
+          <a:xfrm>
+            <a:off x="7993380" y="405765"/>
+            <a:ext cx="1793875" cy="502285"/>
           </a:xfrm>
           <a:prstGeom prst="rect">
             <a:avLst/>
@@ -4174,26 +4270,18 @@
           <a:p>
             <a:pPr algn="ctr"/>
             <a:r>
-              <a:t>table</a:t>
-            </a:r>
-          </a:p>
-          <a:p>
-            <a:pPr algn="ctr">
-              <a:defRPr sz="1200" cap="none"/>
-            </a:pPr>
-            <a:r>
-              <a:t>static variables</a:t>
-            </a:r>
-          </a:p>
-        </p:txBody>
-      </p:sp>
-      <p:sp>
-        <p:nvSpPr>
-          <p:cNvPr id="7" name="Textbox6"/>
+              <a:t>global error set</a:t>
+            </a:r>
+          </a:p>
+        </p:txBody>
+      </p:sp>
+      <p:sp>
+        <p:nvSpPr>
+          <p:cNvPr id="9" name="Textbox9"/>
           <p:cNvSpPr txBox="1">
             <a:extLst>
               <a:ext uri="smNativeData">
-                <pr:smNativeData xmlns:pr="smNativeData" xmlns="smNativeData" val="SMDATA_15_ZqHWaRMAAAAlAAAAEgAAAA8BAAAAkAAAAEgAAACQAAAASAAAAAAAAAABAAAAAAAAAAEAAABQAAAAAAAAAAAA4D8AAAAAAADgPwAAAAAAAOA/AAAAAAAA4D8AAAAAAADgPwAAAAAAAOA/AAAAAAAA4D8AAAAAAADgPwAAAAAAAOA/AAAAAAAA4D8CAAAAjAAAAAEAAAAAAAAA//8AAP///wgAAAAAAAAAAAAAAAAAAAAAAAAAAAAAAAAAAAAAZAAAAAEAAABAAAAAAAAAAAAAAAAAAAAAAAAAAAAAAAAAAAAAAAAAAAAAAAAAAAAAAAAAAAAAAAAAAAAAAAAAAAAAAAAAAAAAAAAAAAAAAAAAAAAAAAAAAAAAAAAAAAAAFAAAADwAAAABAAAAAAAAAAAAAAkUAAAAAQAAABQAAAAUAAAAFAAAAAEAAAAAAAAAZAAAAGQAAAAAAAAAZAAAAGQAAAAVAAAAYAAAAAAAAAAAAAAADwAAACADAAAAAAAAAAAAAAEAAACgMgAAVgcAAKr4//8BAAAAf39/AAEAAABkAAAAAAAAABQAAABAHwAAAAAAACYAAAAAAAAAwOD//wAAAAAmAAAAZAAAABYAAABMAAAAAAAAAAAAAAAEAAAAAAAAAAEAAACAgIAKAAAAACgAAAAoAAAAZAAAAGQAAAAAAAAAzMzMAAAAAABQAAAAUAAAAGQAAABkAAAAAAAAABcAAAAUAAAAAAAAAIEHAAD/fwAA/38AAAAAAAAJAAAABAAAACMAAAAeAAAAaAAAAAAAAAAAAAAAAAAAAAAAAAAAAAAAECcAABAnAAAAAAAAAAAAAAAAAAAAAAAAAAAAAAAAAAAAAAAAAAAAABQAAAAAAAAAwMD/AAAAAABkAAAAMgAAAAAAAABkAAAAAAAAAH9/fwAKAAAAIgAAABgAAAAAAAAAAAAAAAAAAAAAAAAAAAAAAAAAAAAkAAAAJAAAAAAAAAAHAAAAAAAAAAAAAAAAAAAAAAAAAAAAAAAAAAAAf39/ACUAAABYAAAAAAAAAAAAAAAAAAAAAAAAAAAAAAAAAAAAAAAAAAAAAAAAAAAAAAAAAAAAAAA/AAAAAAAAAKCGAQAAAAAAAAAAAAAAAAAMAAAAAQAAAAAAAAAAAAAAAAAAAB8AAABUAAAA//8AAP///wEAAAAAAAAAAAAAAAAAAAAAAAAAAAAAAAAAAAAAAAAAAAAAAAJ/f38AgICAA8zMzADAwP8Af39/AAAAAAAAAAAAAAAAAAAAAAAAAAAAIQAAABgAAAAUAAAA8SAAAFsUAAAYKwAAVBgAABAAAAAmAAAACAAAAP//////////"/>
+                <pr:smNativeData xmlns:pr="smNativeData" xmlns="smNativeData" val="SMDATA_15_MvzhaRMAAAAlAAAAEgAAAA8BAAAAkAAAAEgAAACQAAAASAAAAAAAAAABAAAAAAAAAAEAAABQAAAAAAAAAAAA4D8AAAAAAADgPwAAAAAAAOA/AAAAAAAA4D8AAAAAAADgPwAAAAAAAOA/AAAAAAAA4D8AAAAAAADgPwAAAAAAAOA/AAAAAAAA4D8CAAAAjAAAAAEAAAAAAAAA//8AAP///wgAAAAAAAAAAAAAAAAAAAAAAAAAAAAAAAAAAAAAZAAAAAEAAABAAAAAAAAAAAAAAAAAAAAAAAAAAAAAAAAAAAAAAAAAAAAAAAAAAAAAAAAAAAAAAAAAAAAAAAAAAAAAAAAAAAAAAAAAAAAAAAAAAAAAAAAAAAAAAAAAAAAAFAAAADwAAAABAAAAAAAAAAAAAAkUAAAAAQAAABQAAAAUAAAAFAAAAAEAAAAAAAAAZAAAAGQAAAAAAAAAZAAAAGQAAAAVAAAAYAAAAAAAAAAAAAAADwAAACADAAAAAAAAAAAAAAEAAACgMgAAVgcAAKr4//8BAAAAf39/AAEAAABkAAAAAAAAABQAAABAHwAAAAAAACYAAAAAAAAAwOD//wAAAAAmAAAAZAAAABYAAABMAAAAAAAAAAAAAAAEAAAAAAAAAAEAAACAgIAKAAAAACgAAAAoAAAAZAAAAGQAAAAAAAAAzMzMAAAAAABQAAAAUAAAAGQAAABkAAAAAAAAABcAAAAUAAAAAAAAAIEHAAD/fwAA/38AAAAAAAAJAAAABAAAACMAAAAeAAAAaAAAAAAAAAAAAAAAAAAAAAAAAAAAAAAAECcAABAnAAAAAAAAAAAAAAAAAAAAAAAAAAAAAAAAAAAAAAAAAAAAABQAAAAAAAAAwMD/AAAAAABkAAAAMgAAAAAAAABkAAAAAAAAAH9/fwAKAAAAIgAAABgAAAAAAAAAAAAAAAAAAAAAAAAAAAAAAAAAAAAkAAAAJAAAAAAAAAAHAAAAAAAAAAAAAAAAAAAAAAAAAAAAAAAAAAAAf39/ACUAAABYAAAAAAAAAAAAAAAAAAAAAAAAAAAAAAAAAAAAAAAAAAAAAAAAAAAAAAAAAAAAAAA/AAAAAAAAAKCGAQAAAAAAAAAAAAAAAAAMAAAAAQAAAAAAAAAAAAAAAAAAAB8AAABUAAAA//8AAP///wEAAAAAAAAAAAAAAAAAAAAAAAAAAAAAAAAAAAAAAAAAAAAAAAJ/f38AgICAA8zMzADAwP8Af39/AAAAAAAAAAAAAAAAAAAAAAAAAAAAIQAAABgAAAAUAAAAgDIAABMOAACnPAAADBIAABAAAAAmAAAACAAAAP//////////"/>
               </a:ext>
             </a:extLst>
           </p:cNvSpPr>
@@ -4201,7 +4289,7 @@
         </p:nvSpPr>
         <p:spPr>
           <a:xfrm>
-            <a:off x="5354955" y="3308985"/>
+            <a:off x="8209280" y="2287905"/>
             <a:ext cx="1650365" cy="645795"/>
           </a:xfrm>
           <a:prstGeom prst="rect">
@@ -4226,7 +4314,7 @@
           <a:p>
             <a:pPr algn="ctr"/>
             <a:r>
-              <a:t>ZigClassEntry</a:t>
+              <a:t>S.Static</a:t>
             </a:r>
           </a:p>
           <a:p>
@@ -4234,18 +4322,18 @@
               <a:defRPr sz="1200" cap="none"/>
             </a:pPr>
             <a:r>
-              <a:t>class entry</a:t>
-            </a:r>
-          </a:p>
-        </p:txBody>
-      </p:sp>
-      <p:sp>
-        <p:nvSpPr>
-          <p:cNvPr id="8" name="Textbox7"/>
+              <a:t>structure static data</a:t>
+            </a:r>
+          </a:p>
+        </p:txBody>
+      </p:sp>
+      <p:sp>
+        <p:nvSpPr>
+          <p:cNvPr id="10" name="Textbox10"/>
           <p:cNvSpPr txBox="1">
             <a:extLst>
               <a:ext uri="smNativeData">
-                <pr:smNativeData xmlns:pr="smNativeData" xmlns="smNativeData" val="SMDATA_15_ZqHWaRMAAAAlAAAAEgAAAA8BAAAAkAAAAEgAAACQAAAASAAAAAAAAAABAAAAAAAAAAEAAABQAAAAAAAAAAAA4D8AAAAAAADgPwAAAAAAAOA/AAAAAAAA4D8AAAAAAADgPwAAAAAAAOA/AAAAAAAA4D8AAAAAAADgPwAAAAAAAOA/AAAAAAAA4D8CAAAAjAAAAAEAAAAAAAAA//8AAP///wgAAAAAAAAAAAAAAAAAAAAAAAAAAAAAAAAAAAAAZAAAAAEAAABAAAAAAAAAAAAAAAAAAAAAAAAAAAAAAAAAAAAAAAAAAAAAAAAAAAAAAAAAAAAAAAAAAAAAAAAAAAAAAAAAAAAAAAAAAAAAAAAAAAAAAAAAAAAAAAAAAAAAFAAAADwAAAABAAAAAAAAAAAAAAkUAAAAAQAAABQAAAAUAAAAFAAAAAEAAAAAAAAAZAAAAGQAAAAAAAAAZAAAAGQAAAAVAAAAYAAAAAAAAAAAAAAADwAAACADAAAAAAAAAAAAAAEAAACgMgAAVgcAAKr4//8BAAAAf39/AAEAAABkAAAAAAAAABQAAABAHwAAAAAAACYAAAAAAAAAwOD//wAAAAAmAAAAZAAAABYAAABMAAAAAAAAAAAAAAAEAAAAAAAAAAEAAACAgIAKAAAAACgAAAAoAAAAZAAAAGQAAAAAAAAAzMzMAAAAAABQAAAAUAAAAGQAAABkAAAAAAAAABcAAAAUAAAAAAAAAIgDAAD/fwAA/38AAAAAAAAJAAAABAAAACMAAAAeAAAAaAAAAAAAAAAAAAAAAAAAAAAAAAAAAAAAECcAABAnAAAAAAAAAAAAAAAAAAAAAAAAAAAAAAAAAAAAAAAAAAAAABQAAAAAAAAAwMD/AAAAAABkAAAAMgAAAAAAAABkAAAAAAAAAH9/fwAKAAAAIgAAABgAAAAAAAAAAAAAAAAAAAAAAAAAAAAAAAAAAAAkAAAAJAAAAAAAAAAHAAAAAAAAAAAAAAAAAAAAAAAAAAAAAAAAAAAAf39/ACUAAABYAAAAAAAAAAAAAAAAAAAAAAAAAAAAAAAAAAAAAAAAAAAAAAAAAAAAAAAAAAAAAAA/AAAAAAAAAKCGAQAAAAAAAAAAAAAAAAAMAAAAAQAAAAAAAAAAAAAAAAAAAB8AAABUAAAA//8AAP///wEAAAAAAAAAAAAAAAAAAAAAAAAAAAAAAAAAAAAAAAAAAAAAAAJ/f38AgICAA8zMzADAwP8Af39/AAAAAAAAAAAAAAAAAAAAAAAAAAAAIQAAABgAAAAUAAAAgTIAAOUHAADkOgAA/AoAABAAAAAmAAAACAAAAP//////////"/>
+                <pr:smNativeData xmlns:pr="smNativeData" xmlns="smNativeData" val="SMDATA_15_MvzhaRMAAAAlAAAAEgAAAA8BAAAAkAAAAEgAAACQAAAASAAAAAAAAAABAAAAAAAAAAEAAABQAAAAAAAAAAAA4D8AAAAAAADgPwAAAAAAAOA/AAAAAAAA4D8AAAAAAADgPwAAAAAAAOA/AAAAAAAA4D8AAAAAAADgPwAAAAAAAOA/AAAAAAAA4D8CAAAAjAAAAAEAAAAAAAAA//8AAP///wgAAAAAAAAAAAAAAAAAAAAAAAAAAAAAAAAAAAAAZAAAAAEAAABAAAAAAAAAAAAAAAAAAAAAAAAAAAAAAAAAAAAAAAAAAAAAAAAAAAAAAAAAAAAAAAAAAAAAAAAAAAAAAAAAAAAAAAAAAAAAAAAAAAAAAAAAAAAAAAAAAAAAFAAAADwAAAABAAAAAAAAAAAAAAkUAAAAAQAAABQAAAAUAAAAFAAAAAEAAAAAAAAAZAAAAGQAAAAAAAAAZAAAAGQAAAAVAAAAYAAAAAAAAAAAAAAADwAAACADAAAAAAAAAAAAAAEAAACgMgAAVgcAAKr4//8BAAAAf39/AAEAAABkAAAAAAAAABQAAABAHwAAAAAAACYAAAAAAAAAwOD//wAAAAAmAAAAZAAAABYAAABMAAAAAAAAAAAAAAAEAAAAAAAAAAEAAACAgIAKAAAAACgAAAAoAAAAZAAAAGQAAAAAAAAAzMzMAAAAAABQAAAAUAAAAGQAAABkAAAAAAAAABcAAAAUAAAAAAAAAIEHAAD/fwAA/38AAAAAAAAJAAAABAAAAJCbpzEeAAAAaAAAAAAAAAAAAAAAAAAAAAAAAAAAAAAAECcAABAnAAAAAAAAAAAAAAAAAAAAAAAAAAAAAAAAAAAAAAAAAAAAABQAAAAAAAAAwMD/AAAAAABkAAAAMgAAAAAAAABkAAAAAAAAAH9/fwAKAAAAIgAAABgAAAAAAAAAAAAAAAAAAAAAAAAAAAAAAAAAAAAkAAAAJAAAAAAAAAAHAAAAAAAAAAAAAAAAAAAAAAAAAAAAAAAAAAAAf39/ACUAAABYAAAAAAAAAAAAAAAAAAAAAAAAAAAAAAAAAAAAAAAAAAAAAAAAAAAAAAAAAAAAAAA/AAAAAAAAAKCGAQAAAAAAAAAAAAAAAAAMAAAAAQAAAAAAAAAAAAAAAAAAAB8AAABUAAAA//8AAP///wEAAAAAAAAAAAAAAAAAAAAAAAAAAAAAAAAAAAAAAAAAAAAAAAJ/f38AgICAA8zMzADAwP8Af39/AAAAAAAAAAAAAAAAAAAAAAAAAAAAIQAAABgAAAAUAAAARjEAAFsUAACSNgAAVBgAABAAAAAmAAAACAAAAP//////////"/>
               </a:ext>
             </a:extLst>
           </p:cNvSpPr>
@@ -4253,8 +4341,8 @@
         </p:nvSpPr>
         <p:spPr>
           <a:xfrm>
-            <a:off x="8209915" y="1283335"/>
-            <a:ext cx="1363345" cy="502285"/>
+            <a:off x="8009890" y="3308985"/>
+            <a:ext cx="861060" cy="645795"/>
           </a:xfrm>
           <a:prstGeom prst="rect">
             <a:avLst/>
@@ -4278,95 +4366,7 @@
           <a:p>
             <a:pPr algn="ctr"/>
             <a:r>
-              <a:t>ModuleHost</a:t>
-            </a:r>
-          </a:p>
-        </p:txBody>
-      </p:sp>
-      <p:sp>
-        <p:nvSpPr>
-          <p:cNvPr id="9" name="Textbox8"/>
-          <p:cNvSpPr txBox="1">
-            <a:extLst>
-              <a:ext uri="smNativeData">
-                <pr:smNativeData xmlns:pr="smNativeData" xmlns="smNativeData" val="SMDATA_15_ZqHWaRMAAAAlAAAAEgAAAA8BAAAAkAAAAEgAAACQAAAASAAAAAAAAAABAAAAAAAAAAEAAABQAAAAAAAAAAAA4D8AAAAAAADgPwAAAAAAAOA/AAAAAAAA4D8AAAAAAADgPwAAAAAAAOA/AAAAAAAA4D8AAAAAAADgPwAAAAAAAOA/AAAAAAAA4D8CAAAAjAAAAAEAAAAAAAAAAP8AAP///wgAAAAAAAAAAAAAAAAAAAAAAAAAAAAAAAAAAAAAZAAAAAEAAABAAAAAAAAAAAAAAAAAAAAAAAAAAAAAAAAAAAAAAAAAAAAAAAAAAAAAAAAAAAAAAAAAAAAAAAAAAAAAAAAAAAAAAAAAAAAAAAAAAAAAAAAAAAAAAAAAAAAAFAAAADwAAAABAAAAAAAAAAAAAAkUAAAAAQAAABQAAAAUAAAAFAAAAAEAAAAAAAAAZAAAAGQAAAAAAAAAZAAAAGQAAAAVAAAAYAAAAAAAAAAAAAAADwAAACADAAAAAAAAAAAAAAEAAACgMgAAVgcAAKr4//8BAAAAf39/AAEAAABkAAAAAAAAABQAAABAHwAAAAAAACYAAAAAAAAAwOD//wAAAAAmAAAAZAAAABYAAABMAAAAAAAAAAAAAAAEAAAAAAAAAAEAAACAgIAKAAAAACgAAAAoAAAAZAAAAGQAAAAAAAAAzMzMAAAAAABQAAAAUAAAAGQAAABkAAAAAAAAABcAAAAUAAAAAAAAAIgDAAD/fwAA/38AAAAAAAAJAAAABAAAACMAAAAeAAAAaAAAAAAAAAAAAAAAAAAAAAAAAAAAAAAAECcAABAnAAAAAAAAAAAAAAAAAAAAAAAAAAAAAAAAAAAAAAAAAAAAABQAAAAAAAAAwMD/AAAAAABkAAAAMgAAAAAAAABkAAAAAAAAAH9/fwAKAAAAIgAAABgAAAAAAAAAAAAAAAAAAAAAAAAAAAAAAAAAAAAkAAAAJAAAAAAAAAAHAAAAAAAAAAAAAAAAAAAAAAAAAAAAAAAAAAAAf39/ACUAAABYAAAAAAAAAAAAAAAAAAAAAAAAAAAAAAAAAAAAAAAAAAAAAAAAAAAAAAAAAAAAAAA/AAAAAAAAAKCGAQAAAAAAAAAAAAAAAAAMAAAAAQAAAAAAAAAAAAAAAAAAAB8AAABUAAAAAP8AAP///wEAAAAAAAAAAAAAAAAAAAAAAAAAAAAAAAAAAAAAAAAAAAAAAAJ/f38AgICAA8zMzADAwP8Af39/AAAAAAAAAAAAAAAAAAAAAAAAAAAAIQAAABgAAAAUAAAALDEAAH8CAAA1PAAAlgUAABAAAAAmAAAACAAAAP//////////"/>
-              </a:ext>
-            </a:extLst>
-          </p:cNvSpPr>
-          <p:nvPr/>
-        </p:nvSpPr>
-        <p:spPr>
-          <a:xfrm>
-            <a:off x="7993380" y="405765"/>
-            <a:ext cx="1793875" cy="502285"/>
-          </a:xfrm>
-          <a:prstGeom prst="rect">
-            <a:avLst/>
-          </a:prstGeom>
-          <a:solidFill>
-            <a:srgbClr val="00FF00"/>
-          </a:solidFill>
-          <a:ln w="12700" cap="flat" cmpd="sng" algn="ctr">
-            <a:solidFill>
-              <a:schemeClr val="tx1"/>
-            </a:solidFill>
-            <a:prstDash val="solid"/>
-            <a:headEnd type="none"/>
-            <a:tailEnd type="none"/>
-          </a:ln>
-          <a:effectLst/>
-        </p:spPr>
-        <p:txBody>
-          <a:bodyPr vert="horz" wrap="square" numCol="1" spcCol="215900" anchor="ctr"/>
-          <a:lstStyle/>
-          <a:p>
-            <a:pPr algn="ctr"/>
-            <a:r>
-              <a:t>global error set</a:t>
-            </a:r>
-          </a:p>
-        </p:txBody>
-      </p:sp>
-      <p:sp>
-        <p:nvSpPr>
-          <p:cNvPr id="10" name="Textbox9"/>
-          <p:cNvSpPr txBox="1">
-            <a:extLst>
-              <a:ext uri="smNativeData">
-                <pr:smNativeData xmlns:pr="smNativeData" xmlns="smNativeData" val="SMDATA_15_ZqHWaRMAAAAlAAAAEgAAAA8BAAAAkAAAAEgAAACQAAAASAAAAAAAAAABAAAAAAAAAAEAAABQAAAAAAAAAAAA4D8AAAAAAADgPwAAAAAAAOA/AAAAAAAA4D8AAAAAAADgPwAAAAAAAOA/AAAAAAAA4D8AAAAAAADgPwAAAAAAAOA/AAAAAAAA4D8CAAAAjAAAAAEAAAAAAAAA//8AAP///wgAAAAAAAAAAAAAAAAAAAAAAAAAAAAAAAAAAAAAZAAAAAEAAABAAAAAAAAAAAAAAAAAAAAAAAAAAAAAAAAAAAAAAAAAAAAAAAAAAAAAAAAAAAAAAAAAAAAAAAAAAAAAAAAAAAAAAAAAAAAAAAAAAAAAAAAAAAAAAAAAAAAAFAAAADwAAAABAAAAAAAAAAAAAAkUAAAAAQAAABQAAAAUAAAAFAAAAAEAAAAAAAAAZAAAAGQAAAAAAAAAZAAAAGQAAAAVAAAAYAAAAAAAAAAAAAAADwAAACADAAAAAAAAAAAAAAEAAACgMgAAVgcAAKr4//8BAAAAf39/AAEAAABkAAAAAAAAABQAAABAHwAAAAAAACYAAAAAAAAAwOD//wAAAAAmAAAAZAAAABYAAABMAAAAAAAAAAAAAAAEAAAAAAAAAAEAAACAgIAKAAAAACgAAAAoAAAAZAAAAGQAAAAAAAAAzMzMAAAAAABQAAAAUAAAAGQAAABkAAAAAAAAABcAAAAUAAAAAAAAAIEHAAD/fwAA/38AAAAAAAAJAAAABAAAACMAAAAeAAAAaAAAAAAAAAAAAAAAAAAAAAAAAAAAAAAAECcAABAnAAAAAAAAAAAAAAAAAAAAAAAAAAAAAAAAAAAAAAAAAAAAABQAAAAAAAAAwMD/AAAAAABkAAAAMgAAAAAAAABkAAAAAAAAAH9/fwAKAAAAIgAAABgAAAAAAAAAAAAAAAAAAAAAAAAAAAAAAAAAAAAkAAAAJAAAAAAAAAAHAAAAAAAAAAAAAAAAAAAAAAAAAAAAAAAAAAAAf39/ACUAAABYAAAAAAAAAAAAAAAAAAAAAAAAAAAAAAAAAAAAAAAAAAAAAAAAAAAAAAAAAAAAAAA/AAAAAAAAAKCGAQAAAAAAAAAAAAAAAAAMAAAAAQAAAAAAAAAAAAAAAAAAAB8AAABUAAAA//8AAP///wEAAAAAAAAAAAAAAAAAAAAAAAAAAAAAAAAAAAAAAAAAAAAAAAJ/f38AgICAA8zMzADAwP8Af39/AAAAAAAAAAAAAAAAAAAAAAAAAAAAIQAAABgAAAAUAAAAgDIAABMOAACnPAAADBIAABAAAAAmAAAACAAAAP//////////"/>
-              </a:ext>
-            </a:extLst>
-          </p:cNvSpPr>
-          <p:nvPr/>
-        </p:nvSpPr>
-        <p:spPr>
-          <a:xfrm>
-            <a:off x="8209280" y="2287905"/>
-            <a:ext cx="1650365" cy="645795"/>
-          </a:xfrm>
-          <a:prstGeom prst="rect">
-            <a:avLst/>
-          </a:prstGeom>
-          <a:solidFill>
-            <a:srgbClr val="FFFF00"/>
-          </a:solidFill>
-          <a:ln w="12700" cap="flat" cmpd="sng" algn="ctr">
-            <a:solidFill>
-              <a:schemeClr val="tx1"/>
-            </a:solidFill>
-            <a:prstDash val="solid"/>
-            <a:headEnd type="none"/>
-            <a:tailEnd type="none"/>
-          </a:ln>
-          <a:effectLst/>
-        </p:spPr>
-        <p:txBody>
-          <a:bodyPr vert="horz" wrap="square" numCol="1" spcCol="215900" anchor="ctr"/>
-          <a:lstStyle/>
-          <a:p>
-            <a:pPr algn="ctr"/>
-            <a:r>
-              <a:t>S.Static</a:t>
+              <a:t>Scope</a:t>
             </a:r>
           </a:p>
           <a:p>
@@ -4374,58 +4374,6 @@
               <a:defRPr sz="1200" cap="none"/>
             </a:pPr>
             <a:r>
-              <a:t>structure static data</a:t>
-            </a:r>
-          </a:p>
-        </p:txBody>
-      </p:sp>
-      <p:sp>
-        <p:nvSpPr>
-          <p:cNvPr id="11" name="Textbox10"/>
-          <p:cNvSpPr txBox="1">
-            <a:extLst>
-              <a:ext uri="smNativeData">
-                <pr:smNativeData xmlns:pr="smNativeData" xmlns="smNativeData" val="SMDATA_15_ZqHWaRMAAAAlAAAAEgAAAA8BAAAAkAAAAEgAAACQAAAASAAAAAAAAAABAAAAAAAAAAEAAABQAAAAAAAAAAAA4D8AAAAAAADgPwAAAAAAAOA/AAAAAAAA4D8AAAAAAADgPwAAAAAAAOA/AAAAAAAA4D8AAAAAAADgPwAAAAAAAOA/AAAAAAAA4D8CAAAAjAAAAAEAAAAAAAAA//8AAP///wgAAAAAAAAAAAAAAAAAAAAAAAAAAAAAAAAAAAAAZAAAAAEAAABAAAAAAAAAAAAAAAAAAAAAAAAAAAAAAAAAAAAAAAAAAAAAAAAAAAAAAAAAAAAAAAAAAAAAAAAAAAAAAAAAAAAAAAAAAAAAAAAAAAAAAAAAAAAAAAAAAAAAFAAAADwAAAABAAAAAAAAAAAAAAkUAAAAAQAAABQAAAAUAAAAFAAAAAEAAAAAAAAAZAAAAGQAAAAAAAAAZAAAAGQAAAAVAAAAYAAAAAAAAAAAAAAADwAAACADAAAAAAAAAAAAAAEAAACgMgAAVgcAAKr4//8BAAAAf39/AAEAAABkAAAAAAAAABQAAABAHwAAAAAAACYAAAAAAAAAwOD//wAAAAAmAAAAZAAAABYAAABMAAAAAAAAAAAAAAAEAAAAAAAAAAEAAACAgIAKAAAAACgAAAAoAAAAZAAAAGQAAAAAAAAAzMzMAAAAAABQAAAAUAAAAGQAAABkAAAAAAAAABcAAAAUAAAAAAAAAIEHAAD/fwAA/38AAAAAAAAJAAAABAAAAJCbpzEeAAAAaAAAAAAAAAAAAAAAAAAAAAAAAAAAAAAAECcAABAnAAAAAAAAAAAAAAAAAAAAAAAAAAAAAAAAAAAAAAAAAAAAABQAAAAAAAAAwMD/AAAAAABkAAAAMgAAAAAAAABkAAAAAAAAAH9/fwAKAAAAIgAAABgAAAAAAAAAAAAAAAAAAAAAAAAAAAAAAAAAAAAkAAAAJAAAAAAAAAAHAAAAAAAAAAAAAAAAAAAAAAAAAAAAAAAAAAAAf39/ACUAAABYAAAAAAAAAAAAAAAAAAAAAAAAAAAAAAAAAAAAAAAAAAAAAAAAAAAAAAAAAAAAAAA/AAAAAAAAAKCGAQAAAAAAAAAAAAAAAAAMAAAAAQAAAAAAAAAAAAAAAAAAAB8AAABUAAAA//8AAP///wEAAAAAAAAAAAAAAAAAAAAAAAAAAAAAAAAAAAAAAAAAAAAAAAJ/f38AgICAA8zMzADAwP8Af39/AAAAAAAAAAAAAAAAAAAAAAAAAAAAIQAAABgAAAAUAAAARjEAAFsUAACSNgAAVBgAABAAAAAmAAAACAAAAP//////////"/>
-              </a:ext>
-            </a:extLst>
-          </p:cNvSpPr>
-          <p:nvPr/>
-        </p:nvSpPr>
-        <p:spPr>
-          <a:xfrm>
-            <a:off x="8009890" y="3308985"/>
-            <a:ext cx="861060" cy="645795"/>
-          </a:xfrm>
-          <a:prstGeom prst="rect">
-            <a:avLst/>
-          </a:prstGeom>
-          <a:solidFill>
-            <a:srgbClr val="FFFF00"/>
-          </a:solidFill>
-          <a:ln w="12700" cap="flat" cmpd="sng" algn="ctr">
-            <a:solidFill>
-              <a:schemeClr val="tx1"/>
-            </a:solidFill>
-            <a:prstDash val="solid"/>
-            <a:headEnd type="none"/>
-            <a:tailEnd type="none"/>
-          </a:ln>
-          <a:effectLst/>
-        </p:spPr>
-        <p:txBody>
-          <a:bodyPr vert="horz" wrap="square" numCol="1" spcCol="215900" anchor="ctr"/>
-          <a:lstStyle/>
-          <a:p>
-            <a:pPr algn="ctr"/>
-            <a:r>
-              <a:t>Scope</a:t>
-            </a:r>
-          </a:p>
-          <a:p>
-            <a:pPr algn="ctr">
-              <a:defRPr sz="1200" cap="none"/>
-            </a:pPr>
-            <a:r>
               <a:t>static</a:t>
             </a:r>
           </a:p>
@@ -4433,11 +4381,11 @@
       </p:sp>
       <p:grpSp>
         <p:nvGrpSpPr>
-          <p:cNvPr id="12" name="Group1"/>
+          <p:cNvPr id="11" name="Group1"/>
           <p:cNvGrpSpPr>
             <a:extLst>
               <a:ext uri="smNativeData">
-                <pr:smNativeData xmlns:pr="smNativeData" xmlns="smNativeData" val="SMDATA_6_ZqHWaRMAAAAlAAAAAQAAAA8BAAAAkAAAAEgAAACQAAAASAAAAAAAAAAAAAAAAAAAABcAAAAUAAAAAAAAAAAAAAD/fwAA/38AAAAAAAAJAAAABAAAAN4aAAAfAAAAVAAAAAAAAAAAAAAAAAAAAAAAAAAAAAAAAAAAAAAAAAAAAAAAAAAAAAAAAAAAAAAAAAAAAAAAAAAAAAAAAAAAAAAAAAAAAAAAAAAAAAAAAAAAAAAAAAAAACEAAAAYAAAAFAAAAKkoAADFGwAATDAAAP4eAAAQAAAAJgAAAAgAAAD/////AAAAAA=="/>
+                <pr:smNativeData xmlns:pr="smNativeData" xmlns="smNativeData" val="SMDATA_6_MvzhaRMAAAAlAAAAAQAAAA8BAAAAkAAAAEgAAACQAAAASAAAAAAAAAAAAAAAAAAAABcAAAAUAAAAAAAAAAAAAAD/fwAA/38AAAAAAAAJAAAABAAAAD4AAAAfAAAAVAAAAAAAAAAAAAAAAAAAAAAAAAAAAAAAAAAAAAAAAAAAAAAAAAAAAAAAAAAAAAAAAAAAAAAAAAAAAAAAAAAAAAAAAAAAAAAAAAAAAAAAAAAAAAAAAAAAACEAAAAYAAAAFAAAAKkoAADFGwAATDAAAP4eAAAQAAAAJgAAAAgAAAD/////AAAAAA=="/>
               </a:ext>
             </a:extLst>
           </p:cNvGrpSpPr>
@@ -4453,11 +4401,11 @@
         </p:grpSpPr>
         <p:sp>
           <p:nvSpPr>
-            <p:cNvPr id="14" name="Textbox13"/>
+            <p:cNvPr id="13" name="Textbox13"/>
             <p:cNvSpPr txBox="1">
               <a:extLst>
                 <a:ext uri="smNativeData">
-                  <pr:smNativeData xmlns:pr="smNativeData" xmlns="smNativeData" val="SMDATA_15_ZqHWaRMAAAAlAAAAEgAAAA8BAAAAkAAAAEgAAACQAAAASAAAAAAAAAABAAAAAAAAAAEAAABQAAAAAAAAAAAA4D8AAAAAAADgPwAAAAAAAOA/AAAAAAAA4D8AAAAAAADgPwAAAAAAAOA/AAAAAAAA4D8AAAAAAADgPwAAAAAAAOA/AAAAAAAA4D8CAAAAjAAAAAEAAAAAAAAA//8AAP///wgAAAAAAAAAAAAAAAAAAAAAAAAAAAAAAAAAAAAAZAAAAAEAAABAAAAAAAAAAAAAAAAAAAAAAAAAAAAAAAAAAAAAAAAAAAAAAAAAAAAAAAAAAAAAAAAAAAAAAAAAAAAAAAAAAAAAAAAAAAAAAAAAAAAAAAAAAAAAAAAAAAAAFAAAADwAAAABAAAAAAAAAAAAAAkUAAAAAQAAABQAAAAUAAAAFAAAAAEAAAAAAAAAZAAAAGQAAAAAAAAAZAAAAGQAAAAVAAAAYAAAAAAAAAAAAAAADwAAACADAAAAAAAAAAAAAAEAAACgMgAAVgcAAKr4//8BAAAAf39/AAEAAABkAAAAAAAAABQAAABAHwAAAAAAACYAAAAAAAAAwOD//wAAAAAmAAAAZAAAABYAAABMAAAAAAAAAAAAAAAEAAAAAAAAAAEAAACAgIAKAAAAACgAAAAoAAAAZAAAAGQAAAAAAAAAzMzMAAAAAABQAAAAUAAAAGQAAABkAAAAAAAAABcAAAAUAAAAAAAAAIgDAAD/fwAA/38AAAAAAAAJAAAABAAAACMAAAAeAAAAaAAAAAAAAAAAAAAAAAAAAAAAAAAAAAAAECcAABAnAAAAAAAAAAAAAAAAAAAAAAAAAAAAAAAAAAAAAAAAAAAAABQAAAAAAAAAwMD/AAAAAABkAAAAMgAAAAAAAABkAAAAAAAAAH9/fwAKAAAAIgAAABgAAAAAAAAAAAAAAAAAAAAAAAAAAAAAAAAAAAAkAAAAJAAAAAAAAAAHAAAAAAAAAAAAAAAAAAAAAAAAAAAAAAAAAAAAf39/ACUAAABYAAAAAAAAAAAAAAAAAAAAAAAAAAAAAAAAAAAAAAAAAAAAAAAAAAAAAAAAAAAAAAA/AAAAAAAAAKCGAQAAAAAAAAAAAAAAAAAMAAAAAQAAAAAAAAAAAAAAAAAAAB8AAABUAAAA//8AAP///wEAAAAAAAAAAAAAAAAAAAAAAAAAAAAAAAAAAAAAAAAAAAAAAAJ/f38AgICAA8zMzADAwP8Af39/AAAAAAAAAAAAAAAAAAAAAAAAAAAAIQAAABgAAAAUAAAADSkAACkcAABMMAAA/h4AAAAAAAAmAAAACAAAAP//////////"/>
+                  <pr:smNativeData xmlns:pr="smNativeData" xmlns="smNativeData" val="SMDATA_15_MvzhaRMAAAAlAAAAEgAAAA8BAAAAkAAAAEgAAACQAAAASAAAAAAAAAABAAAAAAAAAAEAAABQAAAAAAAAAAAA4D8AAAAAAADgPwAAAAAAAOA/AAAAAAAA4D8AAAAAAADgPwAAAAAAAOA/AAAAAAAA4D8AAAAAAADgPwAAAAAAAOA/AAAAAAAA4D8CAAAAjAAAAAEAAAAAAAAA//8AAP///wgAAAAAAAAAAAAAAAAAAAAAAAAAAAAAAAAAAAAAZAAAAAEAAABAAAAAAAAAAAAAAAAAAAAAAAAAAAAAAAAAAAAAAAAAAAAAAAAAAAAAAAAAAAAAAAAAAAAAAAAAAAAAAAAAAAAAAAAAAAAAAAAAAAAAAAAAAAAAAAAAAAAAFAAAADwAAAABAAAAAAAAAAAAAAkUAAAAAQAAABQAAAAUAAAAFAAAAAEAAAAAAAAAZAAAAGQAAAAAAAAAZAAAAGQAAAAVAAAAYAAAAAAAAAAAAAAADwAAACADAAAAAAAAAAAAAAEAAACgMgAAVgcAAKr4//8BAAAAf39/AAEAAABkAAAAAAAAABQAAABAHwAAAAAAACYAAAAAAAAAwOD//wAAAAAmAAAAZAAAABYAAABMAAAAAAAAAAAAAAAEAAAAAAAAAAEAAACAgIAKAAAAACgAAAAoAAAAZAAAAGQAAAAAAAAAzMzMAAAAAABQAAAAUAAAAGQAAABkAAAAAAAAABcAAAAUAAAAAAAAAIgDAAD/fwAA/38AAAAAAAAJAAAABAAAACMAAAAeAAAAaAAAAAAAAAAAAAAAAAAAAAAAAAAAAAAAECcAABAnAAAAAAAAAAAAAAAAAAAAAAAAAAAAAAAAAAAAAAAAAAAAABQAAAAAAAAAwMD/AAAAAABkAAAAMgAAAAAAAABkAAAAAAAAAH9/fwAKAAAAIgAAABgAAAAAAAAAAAAAAAAAAAAAAAAAAAAAAAAAAAAkAAAAJAAAAAAAAAAHAAAAAAAAAAAAAAAAAAAAAAAAAAAAAAAAAAAAf39/ACUAAABYAAAAAAAAAAAAAAAAAAAAAAAAAAAAAAAAAAAAAAAAAAAAAAAAAAAAAAAAAAAAAAA/AAAAAAAAAKCGAQAAAAAAAAAAAAAAAAAMAAAAAQAAAAAAAAAAAAAAAAAAAB8AAABUAAAA//8AAP///wEAAAAAAAAAAAAAAAAAAAAAAAAAAAAAAAAAAAAAAAAAAAAAAAJ/f38AgICAA8zMzADAwP8Af39/AAAAAAAAAAAAAAAAAAAAAAAAAAAAIQAAABgAAAAUAAAADSkAACkcAABMMAAA/h4AAAAAAAAmAAAACAAAAP//////////"/>
                 </a:ext>
               </a:extLst>
             </p:cNvSpPr>
@@ -4497,11 +4445,11 @@
         </p:sp>
         <p:sp>
           <p:nvSpPr>
-            <p:cNvPr id="13" name="Textbox11"/>
+            <p:cNvPr id="12" name="Textbox11"/>
             <p:cNvSpPr txBox="1">
               <a:extLst>
                 <a:ext uri="smNativeData">
-                  <pr:smNativeData xmlns:pr="smNativeData" xmlns="smNativeData" val="SMDATA_15_ZqHWaRMAAAAlAAAAEgAAAA8BAAAAkAAAAEgAAACQAAAASAAAAAAAAAABAAAAAAAAAAEAAABQAAAAAAAAAAAA4D8AAAAAAADgPwAAAAAAAOA/AAAAAAAA4D8AAAAAAADgPwAAAAAAAOA/AAAAAAAA4D8AAAAAAADgPwAAAAAAAOA/AAAAAAAA4D8CAAAAjAAAAAEAAAAAAAAA//8AAP///wgAAAAAAAAAAAAAAAAAAAAAAAAAAAAAAAAAAAAAZAAAAAEAAABAAAAAAAAAAAAAAAAAAAAAAAAAAAAAAAAAAAAAAAAAAAAAAAAAAAAAAAAAAAAAAAAAAAAAAAAAAAAAAAAAAAAAAAAAAAAAAAAAAAAAAAAAAAAAAAAAAAAAFAAAADwAAAABAAAAAAAAAAAAAAkUAAAAAQAAABQAAAAUAAAAFAAAAAEAAAAAAAAAZAAAAGQAAAAAAAAAZAAAAGQAAAAVAAAAYAAAAAAAAAAAAAAADwAAACADAAAAAAAAAAAAAAEAAACgMgAAVgcAAKr4//8BAAAAf39/AAEAAABkAAAAAAAAABQAAABAHwAAAAAAACYAAAAAAAAAwOD//wAAAAAmAAAAZAAAABYAAABMAAAAAAAAAAAAAAAEAAAAAAAAAAEAAACAgIAKAAAAACgAAAAoAAAAZAAAAGQAAAAAAAAAzMzMAAAAAABQAAAAUAAAAGQAAABkAAAAAAAAABcAAAAUAAAAAAAAAIgDAAD/fwAA/38AAAAAAAAJAAAABAAAAID8+zAeAAAAaAAAAAAAAAAAAAAAAAAAAAAAAAAAAAAAECcAABAnAAAAAAAAAAAAAAAAAAAAAAAAAAAAAAAAAAAAAAAAAAAAABQAAAAAAAAAwMD/AAAAAABkAAAAMgAAAAAAAABkAAAAAAAAAH9/fwAKAAAAIgAAABgAAAAAAAAAAAAAAAAAAAAAAAAAAAAAAAAAAAAkAAAAJAAAAAAAAAAHAAAAAAAAAAAAAAAAAAAAAAAAAAAAAAAAAAAAf39/ACUAAABYAAAAAAAAAAAAAAAAAAAAAAAAAAAAAAAAAAAAAAAAAAAAAAAAAAAAAAAAAAAAAAA/AAAAAAAAAKCGAQAAAAAAAAAAAAAAAAAMAAAAAQAAAAAAAAAAAAAAAAAAAB8AAABUAAAA//8AAP///wEAAAAAAAAAAAAAAAAAAAAAAAAAAAAAAAAAAAAAAAAAAAAAAAJ/f38AgICAA8zMzADAwP8Af39/AAAAAAAAAAAAAAAAAAAAAAAAAAAAIQAAABgAAAAUAAAAqSgAAMUbAADoLwAAmh4AAAAAAAAmAAAACAAAAP//////////"/>
+                  <pr:smNativeData xmlns:pr="smNativeData" xmlns="smNativeData" val="SMDATA_15_MvzhaRMAAAAlAAAAEgAAAA8BAAAAkAAAAEgAAACQAAAASAAAAAAAAAABAAAAAAAAAAEAAABQAAAAAAAAAAAA4D8AAAAAAADgPwAAAAAAAOA/AAAAAAAA4D8AAAAAAADgPwAAAAAAAOA/AAAAAAAA4D8AAAAAAADgPwAAAAAAAOA/AAAAAAAA4D8CAAAAjAAAAAEAAAAAAAAA//8AAP///wgAAAAAAAAAAAAAAAAAAAAAAAAAAAAAAAAAAAAAZAAAAAEAAABAAAAAAAAAAAAAAAAAAAAAAAAAAAAAAAAAAAAAAAAAAAAAAAAAAAAAAAAAAAAAAAAAAAAAAAAAAAAAAAAAAAAAAAAAAAAAAAAAAAAAAAAAAAAAAAAAAAAAFAAAADwAAAABAAAAAAAAAAAAAAkUAAAAAQAAABQAAAAUAAAAFAAAAAEAAAAAAAAAZAAAAGQAAAAAAAAAZAAAAGQAAAAVAAAAYAAAAAAAAAAAAAAADwAAACADAAAAAAAAAAAAAAEAAACgMgAAVgcAAKr4//8BAAAAf39/AAEAAABkAAAAAAAAABQAAABAHwAAAAAAACYAAAAAAAAAwOD//wAAAAAmAAAAZAAAABYAAABMAAAAAAAAAAAAAAAEAAAAAAAAAAEAAACAgIAKAAAAACgAAAAoAAAAZAAAAGQAAAAAAAAAzMzMAAAAAABQAAAAUAAAAGQAAABkAAAAAAAAABcAAAAUAAAAAAAAAIgDAAD/fwAA/38AAAAAAAAJAAAABAAAAID8+zAeAAAAaAAAAAAAAAAAAAAAAAAAAAAAAAAAAAAAECcAABAnAAAAAAAAAAAAAAAAAAAAAAAAAAAAAAAAAAAAAAAAAAAAABQAAAAAAAAAwMD/AAAAAABkAAAAMgAAAAAAAABkAAAAAAAAAH9/fwAKAAAAIgAAABgAAAAAAAAAAAAAAAAAAAAAAAAAAAAAAAAAAAAkAAAAJAAAAAAAAAAHAAAAAAAAAAAAAAAAAAAAAAAAAAAAAAAAAAAAf39/ACUAAABYAAAAAAAAAAAAAAAAAAAAAAAAAAAAAAAAAAAAAAAAAAAAAAAAAAAAAAAAAAAAAAA/AAAAAAAAAKCGAQAAAAAAAAAAAAAAAAAMAAAAAQAAAAAAAAAAAAAAAAAAAB8AAABUAAAA//8AAP///wEAAAAAAAAAAAAAAAAAAAAAAAAAAAAAAAAAAAAAAAAAAAAAAAJ/f38AgICAA8zMzADAwP8Af39/AAAAAAAAAAAAAAAAAAAAAAAAAAAAIQAAABgAAAAUAAAAqSgAAMUbAADoLwAAmh4AAAAAAAAmAAAACAAAAP//////////"/>
                 </a:ext>
               </a:extLst>
             </p:cNvSpPr>
@@ -4542,11 +4490,11 @@
       </p:grpSp>
       <p:sp>
         <p:nvSpPr>
-          <p:cNvPr id="15" name="Textbox12"/>
+          <p:cNvPr id="14" name="Textbox12"/>
           <p:cNvSpPr txBox="1">
             <a:extLst>
               <a:ext uri="smNativeData">
-                <pr:smNativeData xmlns:pr="smNativeData" xmlns="smNativeData" val="SMDATA_15_ZqHWaRMAAAAlAAAAEgAAAA8BAAAAkAAAAEgAAACQAAAASAAAAAAAAAABAAAAAAAAAAEAAABQAAAAAAAAAAAA4D8AAAAAAADgPwAAAAAAAOA/AAAAAAAA4D8AAAAAAADgPwAAAAAAAOA/AAAAAAAA4D8AAAAAAADgPwAAAAAAAOA/AAAAAAAA4D8CAAAAjAAAAAEAAAAAAAAA//8AAP///wgAAAAAAAAAAAAAAAAAAAAAAAAAAAAAAAAAAAAAZAAAAAEAAABAAAAAAAAAAAAAAAAAAAAAAAAAAAAAAAAAAAAAAAAAAAAAAAAAAAAAAAAAAAAAAAAAAAAAAAAAAAAAAAAAAAAAAAAAAAAAAAAAAAAAAAAAAAAAAAAAAAAAFAAAADwAAAABAAAAAAAAAAAAAAkUAAAAAQAAABQAAAAUAAAAFAAAAAEAAAAAAAAAZAAAAGQAAAAAAAAAZAAAAGQAAAAVAAAAYAAAAAAAAAAAAAAADwAAACADAAAAAAAAAAAAAAEAAACgMgAAVgcAAKr4//8BAAAAf39/AAEAAABkAAAAAAAAABQAAABAHwAAAAAAACYAAAAAAAAAwOD//wAAAAAmAAAAZAAAABYAAABMAAAAAAAAAAAAAAAEAAAAAAAAAAEAAACAgIAKAAAAACgAAAAoAAAAZAAAAGQAAAAAAAAAzMzMAAAAAABQAAAAUAAAAGQAAABkAAAAAAAAABcAAAAUAAAAAAAAAIgDAAD/fwAA/38AAAAAAAAJAAAABAAAACMAAAAeAAAAaAAAAAAAAAAAAAAAAAAAAAAAAAAAAAAAECcAABAnAAAAAAAAAAAAAAAAAAAAAAAAAAAAAAAAAAAAAAAAAAAAABQAAAAAAAAAwMD/AAAAAABkAAAAMgAAAAAAAABkAAAAAAAAAH9/fwAKAAAAIgAAABgAAAAAAAAAAAAAAAAAAAAAAAAAAAAAAAAAAAAkAAAAJAAAAAAAAAAHAAAAAAAAAAAAAAAAAAAAAAAAAAAAAAAAAAAAf39/ACUAAABYAAAAAAAAAAAAAAAAAAAAAAAAAAAAAAAAAAAAAAAAAAAAAAAAAAAAAAAAAAAAAAA/AAAAAAAAAKCGAQAAAAAAAAAAAAAAAAAMAAAAAQAAAAAAAAAAAAAAAAAAAB8AAABUAAAA//8AAP///wEAAAAAAAAAAAAAAAAAAAAAAAAAAAAAAAAAAAAAAAAAAAAAAAJ/f38AgICAA8zMzADAwP8Af39/AAAAAAAAAAAAAAAAAAAAAAAAAAAAIQAAABgAAAAUAAAAAzgAANEbAABCPwAAph4AABAAAAAmAAAACAAAAP//////////"/>
+                <pr:smNativeData xmlns:pr="smNativeData" xmlns="smNativeData" val="SMDATA_15_MvzhaRMAAAAlAAAAEgAAAA8BAAAAkAAAAEgAAACQAAAASAAAAAAAAAABAAAAAAAAAAEAAABQAAAAAAAAAAAA4D8AAAAAAADgPwAAAAAAAOA/AAAAAAAA4D8AAAAAAADgPwAAAAAAAOA/AAAAAAAA4D8AAAAAAADgPwAAAAAAAOA/AAAAAAAA4D8CAAAAjAAAAAEAAAAAAAAA//8AAP///wgAAAAAAAAAAAAAAAAAAAAAAAAAAAAAAAAAAAAAZAAAAAEAAABAAAAAAAAAAAAAAAAAAAAAAAAAAAAAAAAAAAAAAAAAAAAAAAAAAAAAAAAAAAAAAAAAAAAAAAAAAAAAAAAAAAAAAAAAAAAAAAAAAAAAAAAAAAAAAAAAAAAAFAAAADwAAAABAAAAAAAAAAAAAAkUAAAAAQAAABQAAAAUAAAAFAAAAAEAAAAAAAAAZAAAAGQAAAAAAAAAZAAAAGQAAAAVAAAAYAAAAAAAAAAAAAAADwAAACADAAAAAAAAAAAAAAEAAACgMgAAVgcAAKr4//8BAAAAf39/AAEAAABkAAAAAAAAABQAAABAHwAAAAAAACYAAAAAAAAAwOD//wAAAAAmAAAAZAAAABYAAABMAAAAAAAAAAAAAAAEAAAAAAAAAAEAAACAgIAKAAAAACgAAAAoAAAAZAAAAGQAAAAAAAAAzMzMAAAAAABQAAAAUAAAAGQAAABkAAAAAAAAABcAAAAUAAAAAAAAAIgDAAD/fwAA/38AAAAAAAAJAAAABAAAACMAAAAeAAAAaAAAAAAAAAAAAAAAAAAAAAAAAAAAAAAAECcAABAnAAAAAAAAAAAAAAAAAAAAAAAAAAAAAAAAAAAAAAAAAAAAABQAAAAAAAAAwMD/AAAAAABkAAAAMgAAAAAAAABkAAAAAAAAAH9/fwAKAAAAIgAAABgAAAAAAAAAAAAAAAAAAAAAAAAAAAAAAAAAAAAkAAAAJAAAAAAAAAAHAAAAAAAAAAAAAAAAAAAAAAAAAAAAAAAAAAAAf39/ACUAAABYAAAAAAAAAAAAAAAAAAAAAAAAAAAAAAAAAAAAAAAAAAAAAAAAAAAAAAAAAAAAAAA/AAAAAAAAAKCGAQAAAAAAAAAAAAAAAAAMAAAAAQAAAAAAAAAAAAAAAAAAAB8AAABUAAAA//8AAP///wEAAAAAAAAAAAAAAAAAAAAAAAAAAAAAAAAAAAAAAAAAAAAAAAJ/f38AgICAA8zMzADAwP8Af39/AAAAAAAAAAAAAAAAAAAAAAAAAAAAIQAAABgAAAAUAAAAAzgAANEbAABCPwAAph4AABAAAAAmAAAACAAAAP//////////"/>
               </a:ext>
             </a:extLst>
           </p:cNvSpPr>
@@ -4586,11 +4534,11 @@
       </p:sp>
       <p:sp>
         <p:nvSpPr>
-          <p:cNvPr id="16" name="Textbox15"/>
+          <p:cNvPr id="15" name="Textbox15"/>
           <p:cNvSpPr txBox="1">
             <a:extLst>
               <a:ext uri="smNativeData">
-                <pr:smNativeData xmlns:pr="smNativeData" xmlns="smNativeData" val="SMDATA_15_ZqHWaRMAAAAlAAAAEgAAAA8BAAAAkAAAAEgAAACQAAAASAAAAAAAAAABAAAAAAAAAAEAAABQAAAAAAAAAAAA4D8AAAAAAADgPwAAAAAAAOA/AAAAAAAA4D8AAAAAAADgPwAAAAAAAOA/AAAAAAAA4D8AAAAAAADgPwAAAAAAAOA/AAAAAAAA4D8CAAAAjAAAAAEAAAAAAAAAAP8AAP///wgAAAAAAAAAAAAAAAAAAAAAAAAAAAAAAAAAAAAAZAAAAAEAAABAAAAAAAAAAAAAAAAAAAAAAAAAAAAAAAAAAAAAAAAAAAAAAAAAAAAAAAAAAAAAAAAAAAAAAAAAAAAAAAAAAAAAAAAAAAAAAAAAAAAAAAAAAAAAAAAAAAAAFAAAADwAAAABAAAAAAAAAAAAAAkUAAAAAQAAABQAAAAUAAAAFAAAAAEAAAAAAAAAZAAAAGQAAAAAAAAAZAAAAGQAAAAVAAAAYAAAAAAAAAAAAAAADwAAACADAAAAAAAAAAAAAAEAAACgMgAAVgcAAKr4//8BAAAAf39/AAEAAABkAAAAAAAAABQAAABAHwAAAAAAACYAAAAAAAAAwOD//wAAAAAmAAAAZAAAABYAAABMAAAAAAAAAAAAAAAEAAAAAAAAAAEAAACAgIAKAAAAACgAAAAoAAAAZAAAAGQAAAAAAAAAzMzMAAAAAABQAAAAUAAAAGQAAABkAAAAAAAAABcAAAAUAAAAAAAAAIgDAAD/fwAA/38AAAAAAAAJAAAABAAAACMAAAAeAAAAaAAAAAAAAAAAAAAAAAAAAAAAAAAAAAAAECcAABAnAAAAAAAAAAAAAAAAAAAAAAAAAAAAAAAAAAAAAAAAAAAAABQAAAAAAAAAwMD/AAAAAABkAAAAMgAAAAAAAABkAAAAAAAAAH9/fwAKAAAAIgAAABgAAAAAAAAAAAAAAAAAAAAAAAAAAAAAAAAAAAAkAAAAJAAAAAAAAAAHAAAAAAAAAAAAAAAAAAAAAAAAAAAAAAAAAAAAf39/ACUAAABYAAAAAAAAAAAAAAAAAAAAAAAAAAAAAAAAAAAAAAAAAAAAAAAAAAAAAAAAAAAAAAA/AAAAAAAAAKCGAQAAAAAAAAAAAAAAAAAMAAAAAQAAAAAAAAAAAAAAAAAAAB8AAABUAAAAAP8AAP///wEAAAAAAAAAAAAAAAAAAAAAAAAAAAAAAAAAAAAAAAAAAAAAAAJ/f38AgICAA8zMzADAwP8Af39/AAAAAAAAAAAAAAAAAAAAAAAAAAAAIQAAABgAAAAUAAAANTkAAHwgAAAQPgAAUSMAABAAAAAmAAAACAAAAP//////////"/>
+                <pr:smNativeData xmlns:pr="smNativeData" xmlns="smNativeData" val="SMDATA_15_MvzhaRMAAAAlAAAAEgAAAA8BAAAAkAAAAEgAAACQAAAASAAAAAAAAAABAAAAAAAAAAEAAABQAAAAAAAAAAAA4D8AAAAAAADgPwAAAAAAAOA/AAAAAAAA4D8AAAAAAADgPwAAAAAAAOA/AAAAAAAA4D8AAAAAAADgPwAAAAAAAOA/AAAAAAAA4D8CAAAAjAAAAAEAAAAAAAAAAP8AAP///wgAAAAAAAAAAAAAAAAAAAAAAAAAAAAAAAAAAAAAZAAAAAEAAABAAAAAAAAAAAAAAAAAAAAAAAAAAAAAAAAAAAAAAAAAAAAAAAAAAAAAAAAAAAAAAAAAAAAAAAAAAAAAAAAAAAAAAAAAAAAAAAAAAAAAAAAAAAAAAAAAAAAAFAAAADwAAAABAAAAAAAAAAAAAAkUAAAAAQAAABQAAAAUAAAAFAAAAAEAAAAAAAAAZAAAAGQAAAAAAAAAZAAAAGQAAAAVAAAAYAAAAAAAAAAAAAAADwAAACADAAAAAAAAAAAAAAEAAACgMgAAVgcAAKr4//8BAAAAf39/AAEAAABkAAAAAAAAABQAAABAHwAAAAAAACYAAAAAAAAAwOD//wAAAAAmAAAAZAAAABYAAABMAAAAAAAAAAAAAAAEAAAAAAAAAAEAAACAgIAKAAAAACgAAAAoAAAAZAAAAGQAAAAAAAAAzMzMAAAAAABQAAAAUAAAAGQAAABkAAAAAAAAABcAAAAUAAAAAAAAAIgDAAD/fwAA/38AAAAAAAAJAAAABAAAACMAAAAeAAAAaAAAAAAAAAAAAAAAAAAAAAAAAAAAAAAAECcAABAnAAAAAAAAAAAAAAAAAAAAAAAAAAAAAAAAAAAAAAAAAAAAABQAAAAAAAAAwMD/AAAAAABkAAAAMgAAAAAAAABkAAAAAAAAAH9/fwAKAAAAIgAAABgAAAAAAAAAAAAAAAAAAAAAAAAAAAAAAAAAAAAkAAAAJAAAAAAAAAAHAAAAAAAAAAAAAAAAAAAAAAAAAAAAAAAAAAAAf39/ACUAAABYAAAAAAAAAAAAAAAAAAAAAAAAAAAAAAAAAAAAAAAAAAAAAAAAAAAAAAAAAAAAAAA/AAAAAAAAAKCGAQAAAAAAAAAAAAAAAAAMAAAAAQAAAAAAAAAAAAAAAAAAAB8AAABUAAAAAP8AAP///wEAAAAAAAAAAAAAAAAAAAAAAAAAAAAAAAAAAAAAAAAAAAAAAAJ/f38AgICAA8zMzADAwP8Af39/AAAAAAAAAAAAAAAAAAAAAAAAAAAAIQAAABgAAAAUAAAANTkAAHwgAAAQPgAAUSMAABAAAAAmAAAACAAAAP//////////"/>
               </a:ext>
             </a:extLst>
           </p:cNvSpPr>
@@ -4630,11 +4578,11 @@
       </p:sp>
       <p:sp>
         <p:nvSpPr>
-          <p:cNvPr id="17" name="Textbox17"/>
+          <p:cNvPr id="16" name="Textbox17"/>
           <p:cNvSpPr txBox="1">
             <a:extLst>
               <a:ext uri="smNativeData">
-                <pr:smNativeData xmlns:pr="smNativeData" xmlns="smNativeData" val="SMDATA_15_ZqHWaRMAAAAlAAAAEgAAAA8BAAAAkAAAAEgAAACQAAAASAAAAAAAAAABAAAAAAAAAAEAAABQAAAAAAAAAAAA4D8AAAAAAADgPwAAAAAAAOA/AAAAAAAA4D8AAAAAAADgPwAAAAAAAOA/AAAAAAAA4D8AAAAAAADgPwAAAAAAAOA/AAAAAAAA4D8CAAAAjAAAAAEAAAAAAAAA//8AAP///wgAAAAAAAAAAAAAAAAAAAAAAAAAAAAAAAAAAAAAZAAAAAEAAABAAAAAAAAAAAAAAAAAAAAAAAAAAAAAAAAAAAAAAAAAAAAAAAAAAAAAAAAAAAAAAAAAAAAAAAAAAAAAAAAAAAAAAAAAAAAAAAAAAAAAAAAAAAAAAAAAAAAAFAAAADwAAAABAAAAAAAAAAAAAAkUAAAAAQAAABQAAAAUAAAAFAAAAAEAAAAAAAAAZAAAAGQAAAAAAAAAZAAAAGQAAAAVAAAAYAAAAAAAAAAAAAAADwAAACADAAAAAAAAAAAAAAEAAACgMgAAVgcAAKr4//8BAAAAf39/AAEAAABkAAAAAAAAABQAAABAHwAAAAAAACYAAAAAAAAAwOD//wAAAAAmAAAAZAAAABYAAABMAAAAAAAAAAAAAAAEAAAAAAAAAAEAAACAgIAKAAAAACgAAAAoAAAAZAAAAGQAAAAAAAAAzMzMAAAAAABQAAAAUAAAAGQAAABkAAAAAAAAABcAAAAUAAAAAAAAAIEHAAD/fwAA/38AAAAAAAAJAAAABAAAACJIYW4eAAAAaAAAAAAAAAAAAAAAAAAAAAAAAAAAAAAAECcAABAnAAAAAAAAAAAAAAAAAAAAAAAAAAAAAAAAAAAAAAAAAAAAABQAAAAAAAAAwMD/AAAAAABkAAAAMgAAAAAAAABkAAAAAAAAAH9/fwAKAAAAIgAAABgAAAAAAAAAAAAAAAAAAAAAAAAAAAAAAAAAAAAkAAAAJAAAAAAAAAAHAAAAAAAAAAAAAAAAAAAAAAAAAAAAAAAAAAAAf39/ACUAAABYAAAAAAAAAAAAAAAAAAAAAAAAAAAAAAAAAAAAAAAAAAAAAAAAAAAAAAAAAAAAAAA/AAAAAAAAAKCGAQAAAAAAAAAAAAAAAAAMAAAAAQAAAAAAAAAAAAAAAAAAAB8AAABUAAAA//8AAP///wEAAAAAAAAAAAAAAAAAAAAAAAAAAAAAAAAAAAAAAAAAAAAAAAJ/f38AgICAA8zMzADAwP8Af39/AAAAAAAAAAAAAAAAAAAAAAAAAAAAIQAAABgAAAAUAAAAahQAAFsUAAC2GQAAVBgAABAAAAAmAAAACAAAAP//////////"/>
+                <pr:smNativeData xmlns:pr="smNativeData" xmlns="smNativeData" val="SMDATA_15_MvzhaRMAAAAlAAAAEgAAAA8BAAAAkAAAAEgAAACQAAAASAAAAAAAAAABAAAAAAAAAAEAAABQAAAAAAAAAAAA4D8AAAAAAADgPwAAAAAAAOA/AAAAAAAA4D8AAAAAAADgPwAAAAAAAOA/AAAAAAAA4D8AAAAAAADgPwAAAAAAAOA/AAAAAAAA4D8CAAAAjAAAAAEAAAAAAAAA//8AAP///wgAAAAAAAAAAAAAAAAAAAAAAAAAAAAAAAAAAAAAZAAAAAEAAABAAAAAAAAAAAAAAAAAAAAAAAAAAAAAAAAAAAAAAAAAAAAAAAAAAAAAAAAAAAAAAAAAAAAAAAAAAAAAAAAAAAAAAAAAAAAAAAAAAAAAAAAAAAAAAAAAAAAAFAAAADwAAAABAAAAAAAAAAAAAAkUAAAAAQAAABQAAAAUAAAAFAAAAAEAAAAAAAAAZAAAAGQAAAAAAAAAZAAAAGQAAAAVAAAAYAAAAAAAAAAAAAAADwAAACADAAAAAAAAAAAAAAEAAACgMgAAVgcAAKr4//8BAAAAf39/AAEAAABkAAAAAAAAABQAAABAHwAAAAAAACYAAAAAAAAAwOD//wAAAAAmAAAAZAAAABYAAABMAAAAAAAAAAAAAAAEAAAAAAAAAAEAAACAgIAKAAAAACgAAAAoAAAAZAAAAGQAAAAAAAAAzMzMAAAAAABQAAAAUAAAAGQAAABkAAAAAAAAABcAAAAUAAAAAAAAAIEHAAD/fwAA/38AAAAAAAAJAAAABAAAACJIYW4eAAAAaAAAAAAAAAAAAAAAAAAAAAAAAAAAAAAAECcAABAnAAAAAAAAAAAAAAAAAAAAAAAAAAAAAAAAAAAAAAAAAAAAABQAAAAAAAAAwMD/AAAAAABkAAAAMgAAAAAAAABkAAAAAAAAAH9/fwAKAAAAIgAAABgAAAAAAAAAAAAAAAAAAAAAAAAAAAAAAAAAAAAkAAAAJAAAAAAAAAAHAAAAAAAAAAAAAAAAAAAAAAAAAAAAAAAAAAAAf39/ACUAAABYAAAAAAAAAAAAAAAAAAAAAAAAAAAAAAAAAAAAAAAAAAAAAAAAAAAAAAAAAAAAAAA/AAAAAAAAAKCGAQAAAAAAAAAAAAAAAAAMAAAAAQAAAAAAAAAAAAAAAAAAAB8AAABUAAAA//8AAP///wEAAAAAAAAAAAAAAAAAAAAAAAAAAAAAAAAAAAAAAAAAAAAAAAJ/f38AgICAA8zMzADAwP8Af39/AAAAAAAAAAAAAAAAAAAAAAAAAAAAIQAAABgAAAAUAAAAahQAAFsUAAC2GQAAVBgAABAAAAAmAAAACAAAAP//////////"/>
               </a:ext>
             </a:extLst>
           </p:cNvSpPr>
@@ -4682,11 +4630,11 @@
       </p:sp>
       <p:sp>
         <p:nvSpPr>
-          <p:cNvPr id="18" name="Textbox18"/>
+          <p:cNvPr id="17" name="Textbox18"/>
           <p:cNvSpPr txBox="1">
             <a:extLst>
               <a:ext uri="smNativeData">
-                <pr:smNativeData xmlns:pr="smNativeData" xmlns="smNativeData" val="SMDATA_15_ZqHWaRMAAAAlAAAAEgAAAA8BAAAAkAAAAEgAAACQAAAASAAAAAAAAAABAAAAAAAAAAEAAABQAAAAAAAAAAAA4D8AAAAAAADgPwAAAAAAAOA/AAAAAAAA4D8AAAAAAADgPwAAAAAAAOA/AAAAAAAA4D8AAAAAAADgPwAAAAAAAOA/AAAAAAAA4D8CAAAAjAAAAAEAAAAAAAAA//8AAP///wgAAAAAAAAAAAAAAAAAAAAAAAAAAAAAAAAAAAAAZAAAAAEAAABAAAAAAAAAAAAAAAAAAAAAAAAAAAAAAAAAAAAAAAAAAAAAAAAAAAAAAAAAAAAAAAAAAAAAAAAAAAAAAAAAAAAAAAAAAAAAAAAAAAAAAAAAAAAAAAAAAAAAFAAAADwAAAABAAAAAAAAAAAAAAkUAAAAAQAAABQAAAAUAAAAFAAAAAEAAAAAAAAAZAAAAGQAAAAAAAAAZAAAAGQAAAAVAAAAYAAAAAAAAAAAAAAADwAAACADAAAAAAAAAAAAAAEAAACgMgAAVgcAAKr4//8BAAAAf39/AAEAAABkAAAAAAAAABQAAABAHwAAAAAAACYAAAAAAAAAwOD//wAAAAAmAAAAZAAAABYAAABMAAAAAAAAAAAAAAAEAAAAAAAAAAEAAACAgIAKAAAAACgAAAAoAAAAZAAAAGQAAAAAAAAAzMzMAAAAAABQAAAAUAAAAGQAAABkAAAAAAAAABcAAAAUAAAAAAAAAIgDAAD/fwAA/38AAAAAAAAJAAAABAAAACMAAAAeAAAAaAAAAAAAAAAAAAAAAAAAAAAAAAAAAAAAECcAABAnAAAAAAAAAAAAAAAAAAAAAAAAAAAAAAAAAAAAAAAAAAAAABQAAAAAAAAAwMD/AAAAAABkAAAAMgAAAAAAAABkAAAAAAAAAH9/fwAKAAAAIgAAABgAAAAAAAAAAAAAAAAAAAAAAAAAAAAAAAAAAAAkAAAAJAAAAAAAAAAHAAAAAAAAAAAAAAAAAAAAAAAAAAAAAAAAAAAAf39/ACUAAABYAAAAAAAAAAAAAAAAAAAAAAAAAAAAAAAAAAAAAAAAAAAAAAAAAAAAAAAAAAAAAAA/AAAAAAAAAKCGAQAAAAAAAAAAAAAAAAAMAAAAAQAAAAAAAAAAAAAAAAAAAB8AAABUAAAA//8AAP///wEAAAAAAAAAAAAAAAAAAAAAAAAAAAAAAAAAAAAAAAAAAAAAAAJ/f38AgICAA8zMzADAwP8Af39/AAAAAAAAAAAAAAAAAAAAAAAAAAAAIQAAABgAAAAUAAAAsRsAAJAbAADwIgAAZR4AABAAAAAmAAAACAAAAP//////////"/>
+                <pr:smNativeData xmlns:pr="smNativeData" xmlns="smNativeData" val="SMDATA_15_MvzhaRMAAAAlAAAAEgAAAA8BAAAAkAAAAEgAAACQAAAASAAAAAAAAAABAAAAAAAAAAEAAABQAAAAAAAAAAAA4D8AAAAAAADgPwAAAAAAAOA/AAAAAAAA4D8AAAAAAADgPwAAAAAAAOA/AAAAAAAA4D8AAAAAAADgPwAAAAAAAOA/AAAAAAAA4D8CAAAAjAAAAAEAAAAAAAAA//8AAP///wgAAAAAAAAAAAAAAAAAAAAAAAAAAAAAAAAAAAAAZAAAAAEAAABAAAAAAAAAAAAAAAAAAAAAAAAAAAAAAAAAAAAAAAAAAAAAAAAAAAAAAAAAAAAAAAAAAAAAAAAAAAAAAAAAAAAAAAAAAAAAAAAAAAAAAAAAAAAAAAAAAAAAFAAAADwAAAABAAAAAAAAAAAAAAkUAAAAAQAAABQAAAAUAAAAFAAAAAEAAAAAAAAAZAAAAGQAAAAAAAAAZAAAAGQAAAAVAAAAYAAAAAAAAAAAAAAADwAAACADAAAAAAAAAAAAAAEAAACgMgAAVgcAAKr4//8BAAAAf39/AAEAAABkAAAAAAAAABQAAABAHwAAAAAAACYAAAAAAAAAwOD//wAAAAAmAAAAZAAAABYAAABMAAAAAAAAAAAAAAAEAAAAAAAAAAEAAACAgIAKAAAAACgAAAAoAAAAZAAAAGQAAAAAAAAAzMzMAAAAAABQAAAAUAAAAGQAAABkAAAAAAAAABcAAAAUAAAAAAAAAIgDAAD/fwAA/38AAAAAAAAJAAAABAAAACMAAAAeAAAAaAAAAAAAAAAAAAAAAAAAAAAAAAAAAAAAECcAABAnAAAAAAAAAAAAAAAAAAAAAAAAAAAAAAAAAAAAAAAAAAAAABQAAAAAAAAAwMD/AAAAAABkAAAAMgAAAAAAAABkAAAAAAAAAH9/fwAKAAAAIgAAABgAAAAAAAAAAAAAAAAAAAAAAAAAAAAAAAAAAAAkAAAAJAAAAAAAAAAHAAAAAAAAAAAAAAAAAAAAAAAAAAAAAAAAAAAAf39/ACUAAABYAAAAAAAAAAAAAAAAAAAAAAAAAAAAAAAAAAAAAAAAAAAAAAAAAAAAAAAAAAAAAAA/AAAAAAAAAKCGAQAAAAAAAAAAAAAAAAAMAAAAAQAAAAAAAAAAAAAAAAAAAB8AAABUAAAA//8AAP///wEAAAAAAAAAAAAAAAAAAAAAAAAAAAAAAAAAAAAAAAAAAAAAAAJ/f38AgICAA8zMzADAwP8Af39/AAAAAAAAAAAAAAAAAAAAAAAAAAAAIQAAABgAAAAUAAAAsRsAAJAbAADwIgAAZR4AABAAAAAmAAAACAAAAP//////////"/>
               </a:ext>
             </a:extLst>
           </p:cNvSpPr>
@@ -4726,11 +4674,11 @@
       </p:sp>
       <p:sp>
         <p:nvSpPr>
-          <p:cNvPr id="19" name="Textbox19"/>
+          <p:cNvPr id="18" name="Textbox19"/>
           <p:cNvSpPr txBox="1">
             <a:extLst>
               <a:ext uri="smNativeData">
-                <pr:smNativeData xmlns:pr="smNativeData" xmlns="smNativeData" val="SMDATA_15_ZqHWaRMAAAAlAAAAEgAAAA8BAAAAkAAAAEgAAACQAAAASAAAAAAAAAABAAAAAAAAAAEAAABQAAAAAAAAAAAA4D8AAAAAAADgPwAAAAAAAOA/AAAAAAAA4D8AAAAAAADgPwAAAAAAAOA/AAAAAAAA4D8AAAAAAADgPwAAAAAAAOA/AAAAAAAA4D8CAAAAjAAAAAEAAAAAAAAAAP8AAP///wgAAAAAAAAAAAAAAAAAAAAAAAAAAAAAAAAAAAAAZAAAAAEAAABAAAAAAAAAAAAAAAAAAAAAAAAAAAAAAAAAAAAAAAAAAAAAAAAAAAAAAAAAAAAAAAAAAAAAAAAAAAAAAAAAAAAAAAAAAAAAAAAAAAAAAAAAAAAAAAAAAAAAFAAAADwAAAABAAAAAAAAAAAAAAkUAAAAAQAAABQAAAAUAAAAFAAAAAEAAAAAAAAAZAAAAGQAAAAAAAAAZAAAAGQAAAAVAAAAYAAAAAAAAAAAAAAADwAAACADAAAAAAAAAAAAAAEAAACgMgAAVgcAAKr4//8BAAAAf39/AAEAAABkAAAAAAAAABQAAABAHwAAAAAAACYAAAAAAAAAwOD//wAAAAAmAAAAZAAAABYAAABMAAAAAAAAAAAAAAAEAAAAAAAAAAEAAACAgIAKAAAAACgAAAAoAAAAZAAAAGQAAAAAAAAAzMzMAAAAAABQAAAAUAAAAGQAAABkAAAAAAAAABcAAAAUAAAAAAAAAIgDAAD/fwAA/38AAAAAAAAJAAAABAAAAAAAAAAeAAAAaAAAAAAAAAAAAAAAAAAAAAAAAAAAAAAAECcAABAnAAAAAAAAAAAAAAAAAAAAAAAAAAAAAAAAAAAAAAAAAAAAABQAAAAAAAAAwMD/AAAAAABkAAAAMgAAAAAAAABkAAAAAAAAAH9/fwAKAAAAIgAAABgAAAAAAAAAAAAAAAAAAAAAAAAAAAAAAAAAAAAkAAAAJAAAAAAAAAAHAAAAAAAAAAAAAAAAAAAAAAAAAAAAAAAAAAAAf39/ACUAAABYAAAAAAAAAAAAAAAAAAAAAAAAAAAAAAAAAAAAAAAAAAAAAAAAAAAAAAAAAAAAAAA/AAAAAAAAAKCGAQAAAAAAAAAAAAAAAAAMAAAAAQAAAAAAAAAAAAAAAAAAAB8AAABUAAAAAP8AAP///wEAAAAAAAAAAAAAAAAAAAAAAAAAAAAAAAAAAAAAAAAAAAAAAAJ/f38AgICAA8zMzADAwP8Af39/AAAAAAAAAAAAAAAAAAAAAAAAAAAAIQAAABgAAAAUAAAA4xwAAGsgAAC+IQAAQCMAABAAAAAmAAAACAAAAP//////////"/>
+                <pr:smNativeData xmlns:pr="smNativeData" xmlns="smNativeData" val="SMDATA_15_MvzhaRMAAAAlAAAAEgAAAA8BAAAAkAAAAEgAAACQAAAASAAAAAAAAAABAAAAAAAAAAEAAABQAAAAAAAAAAAA4D8AAAAAAADgPwAAAAAAAOA/AAAAAAAA4D8AAAAAAADgPwAAAAAAAOA/AAAAAAAA4D8AAAAAAADgPwAAAAAAAOA/AAAAAAAA4D8CAAAAjAAAAAEAAAAAAAAAAP8AAP///wgAAAAAAAAAAAAAAAAAAAAAAAAAAAAAAAAAAAAAZAAAAAEAAABAAAAAAAAAAAAAAAAAAAAAAAAAAAAAAAAAAAAAAAAAAAAAAAAAAAAAAAAAAAAAAAAAAAAAAAAAAAAAAAAAAAAAAAAAAAAAAAAAAAAAAAAAAAAAAAAAAAAAFAAAADwAAAABAAAAAAAAAAAAAAkUAAAAAQAAABQAAAAUAAAAFAAAAAEAAAAAAAAAZAAAAGQAAAAAAAAAZAAAAGQAAAAVAAAAYAAAAAAAAAAAAAAADwAAACADAAAAAAAAAAAAAAEAAACgMgAAVgcAAKr4//8BAAAAf39/AAEAAABkAAAAAAAAABQAAABAHwAAAAAAACYAAAAAAAAAwOD//wAAAAAmAAAAZAAAABYAAABMAAAAAAAAAAAAAAAEAAAAAAAAAAEAAACAgIAKAAAAACgAAAAoAAAAZAAAAGQAAAAAAAAAzMzMAAAAAABQAAAAUAAAAGQAAABkAAAAAAAAABcAAAAUAAAAAAAAAIgDAAD/fwAA/38AAAAAAAAJAAAABAAAAAAAAAAeAAAAaAAAAAAAAAAAAAAAAAAAAAAAAAAAAAAAECcAABAnAAAAAAAAAAAAAAAAAAAAAAAAAAAAAAAAAAAAAAAAAAAAABQAAAAAAAAAwMD/AAAAAABkAAAAMgAAAAAAAABkAAAAAAAAAH9/fwAKAAAAIgAAABgAAAAAAAAAAAAAAAAAAAAAAAAAAAAAAAAAAAAkAAAAJAAAAAAAAAAHAAAAAAAAAAAAAAAAAAAAAAAAAAAAAAAAAAAAf39/ACUAAABYAAAAAAAAAAAAAAAAAAAAAAAAAAAAAAAAAAAAAAAAAAAAAAAAAAAAAAAAAAAAAAA/AAAAAAAAAKCGAQAAAAAAAAAAAAAAAAAMAAAAAQAAAAAAAAAAAAAAAAAAAB8AAABUAAAAAP8AAP///wEAAAAAAAAAAAAAAAAAAAAAAAAAAAAAAAAAAAAAAAAAAAAAAAJ/f38AgICAA8zMzADAwP8Af39/AAAAAAAAAAAAAAAAAAAAAAAAAAAAIQAAABgAAAAUAAAA4xwAAGsgAAC+IQAAQCMAABAAAAAmAAAACAAAAP//////////"/>
               </a:ext>
             </a:extLst>
           </p:cNvSpPr>
@@ -4770,11 +4718,11 @@
       </p:sp>
       <p:grpSp>
         <p:nvGrpSpPr>
-          <p:cNvPr id="20" name="Group3"/>
+          <p:cNvPr id="19" name="Group3"/>
           <p:cNvGrpSpPr>
             <a:extLst>
               <a:ext uri="smNativeData">
-                <pr:smNativeData xmlns:pr="smNativeData" xmlns="smNativeData" val="SMDATA_6_ZqHWaRMAAAAlAAAAAQAAAA8BAAAAkAAAAEgAAACQAAAASAAAAAAAAAAAAAAAAAAAABcAAAAUAAAAAAAAAAAAAAD/fwAA/38AAAAAAAAJAAAABAAAAF0AAAAfAAAAVAAAAAAAAAAAAAAAAAAAAAAAAAAAAAAAAAAAAAAAAAAAAAAAAAAAAAAAAAAAAAAAAAAAAAAAAAAAAAAAAAAAAAAAAAAAAAAAAAAAAAAAAAAAAAAAAAAAACEAAAAYAAAAFAAAAAgOAACcGwAAqxUAANUeAAAQAAAAJgAAAAgAAAD/////AAAAAA=="/>
+                <pr:smNativeData xmlns:pr="smNativeData" xmlns="smNativeData" val="SMDATA_6_MvzhaRMAAAAlAAAAAQAAAA8BAAAAkAAAAEgAAACQAAAASAAAAAAAAAAAAAAAAAAAABcAAAAUAAAAAAAAAAAAAAD/fwAA/38AAAAAAAAJAAAABAAAANFSgjUfAAAAVAAAAAAAAAAAAAAAAAAAAAAAAAAAAAAAAAAAAAAAAAAAAAAAAAAAAAAAAAAAAAAAAAAAAAAAAAAAAAAAAAAAAAAAAAAAAAAAAAAAAAAAAAAAAAAAAAAAACEAAAAYAAAAFAAAAAgOAACcGwAAqxUAANUeAAAQAAAAJgAAAAgAAAD/////AAAAAA=="/>
               </a:ext>
             </a:extLst>
           </p:cNvGrpSpPr>
@@ -4790,11 +4738,11 @@
         </p:grpSpPr>
         <p:sp>
           <p:nvSpPr>
-            <p:cNvPr id="22" name="Textbox21"/>
+            <p:cNvPr id="21" name="Textbox21"/>
             <p:cNvSpPr txBox="1">
               <a:extLst>
                 <a:ext uri="smNativeData">
-                  <pr:smNativeData xmlns:pr="smNativeData" xmlns="smNativeData" val="SMDATA_15_ZqHWaRMAAAAlAAAAEgAAAA8BAAAAkAAAAEgAAACQAAAASAAAAAAAAAABAAAAAAAAAAEAAABQAAAAAAAAAAAA4D8AAAAAAADgPwAAAAAAAOA/AAAAAAAA4D8AAAAAAADgPwAAAAAAAOA/AAAAAAAA4D8AAAAAAADgPwAAAAAAAOA/AAAAAAAA4D8CAAAAjAAAAAEAAAAAAAAA//8AAP///wgAAAAAAAAAAAAAAAAAAAAAAAAAAAAAAAAAAAAAZAAAAAEAAABAAAAAAAAAAAAAAAAAAAAAAAAAAAAAAAAAAAAAAAAAAAAAAAAAAAAAAAAAAAAAAAAAAAAAAAAAAAAAAAAAAAAAAAAAAAAAAAAAAAAAAAAAAAAAAAAAAAAAFAAAADwAAAABAAAAAAAAAAAAAAkUAAAAAQAAABQAAAAUAAAAFAAAAAEAAAAAAAAAZAAAAGQAAAAAAAAAZAAAAGQAAAAVAAAAYAAAAAAAAAAAAAAADwAAACADAAAAAAAAAAAAAAEAAACgMgAAVgcAAKr4//8BAAAAf39/AAEAAABkAAAAAAAAABQAAABAHwAAAAAAACYAAAAAAAAAwOD//wAAAAAmAAAAZAAAABYAAABMAAAAAAAAAAAAAAAEAAAAAAAAAAEAAACAgIAKAAAAACgAAAAoAAAAZAAAAGQAAAAAAAAAzMzMAAAAAABQAAAAUAAAAGQAAABkAAAAAAAAABcAAAAUAAAAAAAAAIgDAAD/fwAA/38AAAAAAAAJAAAABAAAAJD3rDEeAAAAaAAAAAAAAAAAAAAAAAAAAAAAAAAAAAAAECcAABAnAAAAAAAAAAAAAAAAAAAAAAAAAAAAAAAAAAAAAAAAAAAAABQAAAAAAAAAwMD/AAAAAABkAAAAMgAAAAAAAABkAAAAAAAAAH9/fwAKAAAAIgAAABgAAAAAAAAAAAAAAAAAAAAAAAAAAAAAAAAAAAAkAAAAJAAAAAAAAAAHAAAAAAAAAAAAAAAAAAAAAAAAAAAAAAAAAAAAf39/ACUAAABYAAAAAAAAAAAAAAAAAAAAAAAAAAAAAAAAAAAAAAAAAAAAAAAAAAAAAAAAAAAAAAA/AAAAAAAAAKCGAQAAAAAAAAAAAAAAAAAMAAAAAQAAAAAAAAAAAAAAAAAAAB8AAABUAAAA//8AAP///wEAAAAAAAAAAAAAAAAAAAAAAAAAAAAAAAAAAAAAAAAAAAAAAAJ/f38AgICAA8zMzADAwP8Af39/AAAAAAAAAAAAAAAAAAAAAAAAAAAAIQAAABgAAAAUAAAAbA4AAAAcAACrFQAA1R4AAAAAAAAmAAAACAAAAP//////////"/>
+                  <pr:smNativeData xmlns:pr="smNativeData" xmlns="smNativeData" val="SMDATA_15_MvzhaRMAAAAlAAAAEgAAAA8BAAAAkAAAAEgAAACQAAAASAAAAAAAAAABAAAAAAAAAAEAAABQAAAAAAAAAAAA4D8AAAAAAADgPwAAAAAAAOA/AAAAAAAA4D8AAAAAAADgPwAAAAAAAOA/AAAAAAAA4D8AAAAAAADgPwAAAAAAAOA/AAAAAAAA4D8CAAAAjAAAAAEAAAAAAAAA//8AAP///wgAAAAAAAAAAAAAAAAAAAAAAAAAAAAAAAAAAAAAZAAAAAEAAABAAAAAAAAAAAAAAAAAAAAAAAAAAAAAAAAAAAAAAAAAAAAAAAAAAAAAAAAAAAAAAAAAAAAAAAAAAAAAAAAAAAAAAAAAAAAAAAAAAAAAAAAAAAAAAAAAAAAAFAAAADwAAAABAAAAAAAAAAAAAAkUAAAAAQAAABQAAAAUAAAAFAAAAAEAAAAAAAAAZAAAAGQAAAAAAAAAZAAAAGQAAAAVAAAAYAAAAAAAAAAAAAAADwAAACADAAAAAAAAAAAAAAEAAACgMgAAVgcAAKr4//8BAAAAf39/AAEAAABkAAAAAAAAABQAAABAHwAAAAAAACYAAAAAAAAAwOD//wAAAAAmAAAAZAAAABYAAABMAAAAAAAAAAAAAAAEAAAAAAAAAAEAAACAgIAKAAAAACgAAAAoAAAAZAAAAGQAAAAAAAAAzMzMAAAAAABQAAAAUAAAAGQAAABkAAAAAAAAABcAAAAUAAAAAAAAAIgDAAD/fwAA/38AAAAAAAAJAAAABAAAAJD3rDEeAAAAaAAAAAAAAAAAAAAAAAAAAAAAAAAAAAAAECcAABAnAAAAAAAAAAAAAAAAAAAAAAAAAAAAAAAAAAAAAAAAAAAAABQAAAAAAAAAwMD/AAAAAABkAAAAMgAAAAAAAABkAAAAAAAAAH9/fwAKAAAAIgAAABgAAAAAAAAAAAAAAAAAAAAAAAAAAAAAAAAAAAAkAAAAJAAAAAAAAAAHAAAAAAAAAAAAAAAAAAAAAAAAAAAAAAAAAAAAf39/ACUAAABYAAAAAAAAAAAAAAAAAAAAAAAAAAAAAAAAAAAAAAAAAAAAAAAAAAAAAAAAAAAAAAA/AAAAAAAAAKCGAQAAAAAAAAAAAAAAAAAMAAAAAQAAAAAAAAAAAAAAAAAAAB8AAABUAAAA//8AAP///wEAAAAAAAAAAAAAAAAAAAAAAAAAAAAAAAAAAAAAAAAAAAAAAAJ/f38AgICAA8zMzADAwP8Af39/AAAAAAAAAAAAAAAAAAAAAAAAAAAAIQAAABgAAAAUAAAAbA4AAAAcAACrFQAA1R4AAAAAAAAmAAAACAAAAP//////////"/>
                 </a:ext>
               </a:extLst>
             </p:cNvSpPr>
@@ -4834,11 +4782,11 @@
         </p:sp>
         <p:sp>
           <p:nvSpPr>
-            <p:cNvPr id="21" name="Textbox20"/>
+            <p:cNvPr id="20" name="Textbox20"/>
             <p:cNvSpPr txBox="1">
               <a:extLst>
                 <a:ext uri="smNativeData">
-                  <pr:smNativeData xmlns:pr="smNativeData" xmlns="smNativeData" val="SMDATA_15_ZqHWaRMAAAAlAAAAEgAAAA8BAAAAkAAAAEgAAACQAAAASAAAAAAAAAABAAAAAAAAAAEAAABQAAAAAAAAAAAA4D8AAAAAAADgPwAAAAAAAOA/AAAAAAAA4D8AAAAAAADgPwAAAAAAAOA/AAAAAAAA4D8AAAAAAADgPwAAAAAAAOA/AAAAAAAA4D8CAAAAjAAAAAEAAAAAAAAA//8AAP///wgAAAAAAAAAAAAAAAAAAAAAAAAAAAAAAAAAAAAAZAAAAAEAAABAAAAAAAAAAAAAAAAAAAAAAAAAAAAAAAAAAAAAAAAAAAAAAAAAAAAAAAAAAAAAAAAAAAAAAAAAAAAAAAAAAAAAAAAAAAAAAAAAAAAAAAAAAAAAAAAAAAAAFAAAADwAAAABAAAAAAAAAAAAAAkUAAAAAQAAABQAAAAUAAAAFAAAAAEAAAAAAAAAZAAAAGQAAAAAAAAAZAAAAGQAAAAVAAAAYAAAAAAAAAAAAAAADwAAACADAAAAAAAAAAAAAAEAAACgMgAAVgcAAKr4//8BAAAAf39/AAEAAABkAAAAAAAAABQAAABAHwAAAAAAACYAAAAAAAAAwOD//wAAAAAmAAAAZAAAABYAAABMAAAAAAAAAAAAAAAEAAAAAAAAAAEAAACAgIAKAAAAACgAAAAoAAAAZAAAAGQAAAAAAAAAzMzMAAAAAABQAAAAUAAAAGQAAABkAAAAAAAAABcAAAAUAAAAAAAAAIgDAAD/fwAA/38AAAAAAAAJAAAABAAAACMAAAAeAAAAaAAAAAAAAAAAAAAAAAAAAAAAAAAAAAAAECcAABAnAAAAAAAAAAAAAAAAAAAAAAAAAAAAAAAAAAAAAAAAAAAAABQAAAAAAAAAwMD/AAAAAABkAAAAMgAAAAAAAABkAAAAAAAAAH9/fwAKAAAAIgAAABgAAAAAAAAAAAAAAAAAAAAAAAAAAAAAAAAAAAAkAAAAJAAAAAAAAAAHAAAAAAAAAAAAAAAAAAAAAAAAAAAAAAAAAAAAf39/ACUAAABYAAAAAAAAAAAAAAAAAAAAAAAAAAAAAAAAAAAAAAAAAAAAAAAAAAAAAAAAAAAAAAA/AAAAAAAAAKCGAQAAAAAAAAAAAAAAAAAMAAAAAQAAAAAAAAAAAAAAAAAAAB8AAABUAAAA//8AAP///wEAAAAAAAAAAAAAAAAAAAAAAAAAAAAAAAAAAAAAAAAAAAAAAAJ/f38AgICAA8zMzADAwP8Af39/AAAAAAAAAAAAAAAAAAAAAAAAAAAAIQAAABgAAAAUAAAACA4AAJwbAABHFQAAcR4AAAAAAAAmAAAACAAAAP//////////"/>
+                  <pr:smNativeData xmlns:pr="smNativeData" xmlns="smNativeData" val="SMDATA_15_MvzhaRMAAAAlAAAAEgAAAA8BAAAAkAAAAEgAAACQAAAASAAAAAAAAAABAAAAAAAAAAEAAABQAAAAAAAAAAAA4D8AAAAAAADgPwAAAAAAAOA/AAAAAAAA4D8AAAAAAADgPwAAAAAAAOA/AAAAAAAA4D8AAAAAAADgPwAAAAAAAOA/AAAAAAAA4D8CAAAAjAAAAAEAAAAAAAAA//8AAP///wgAAAAAAAAAAAAAAAAAAAAAAAAAAAAAAAAAAAAAZAAAAAEAAABAAAAAAAAAAAAAAAAAAAAAAAAAAAAAAAAAAAAAAAAAAAAAAAAAAAAAAAAAAAAAAAAAAAAAAAAAAAAAAAAAAAAAAAAAAAAAAAAAAAAAAAAAAAAAAAAAAAAAFAAAADwAAAABAAAAAAAAAAAAAAkUAAAAAQAAABQAAAAUAAAAFAAAAAEAAAAAAAAAZAAAAGQAAAAAAAAAZAAAAGQAAAAVAAAAYAAAAAAAAAAAAAAADwAAACADAAAAAAAAAAAAAAEAAACgMgAAVgcAAKr4//8BAAAAf39/AAEAAABkAAAAAAAAABQAAABAHwAAAAAAACYAAAAAAAAAwOD//wAAAAAmAAAAZAAAABYAAABMAAAAAAAAAAAAAAAEAAAAAAAAAAEAAACAgIAKAAAAACgAAAAoAAAAZAAAAGQAAAAAAAAAzMzMAAAAAABQAAAAUAAAAGQAAABkAAAAAAAAABcAAAAUAAAAAAAAAIgDAAD/fwAA/38AAAAAAAAJAAAABAAAACMAAAAeAAAAaAAAAAAAAAAAAAAAAAAAAAAAAAAAAAAAECcAABAnAAAAAAAAAAAAAAAAAAAAAAAAAAAAAAAAAAAAAAAAAAAAABQAAAAAAAAAwMD/AAAAAABkAAAAMgAAAAAAAABkAAAAAAAAAH9/fwAKAAAAIgAAABgAAAAAAAAAAAAAAAAAAAAAAAAAAAAAAAAAAAAkAAAAJAAAAAAAAAAHAAAAAAAAAAAAAAAAAAAAAAAAAAAAAAAAAAAAf39/ACUAAABYAAAAAAAAAAAAAAAAAAAAAAAAAAAAAAAAAAAAAAAAAAAAAAAAAAAAAAAAAAAAAAA/AAAAAAAAAKCGAQAAAAAAAAAAAAAAAAAMAAAAAQAAAAAAAAAAAAAAAAAAAB8AAABUAAAA//8AAP///wEAAAAAAAAAAAAAAAAAAAAAAAAAAAAAAAAAAAAAAAAAAAAAAAJ/f38AgICAA8zMzADAwP8Af39/AAAAAAAAAAAAAAAAAAAAAAAAAAAAIQAAABgAAAAUAAAACA4AAJwbAABHFQAAcR4AAAAAAAAmAAAACAAAAP//////////"/>
                 </a:ext>
               </a:extLst>
             </p:cNvSpPr>
@@ -4879,120 +4827,11 @@
       </p:grpSp>
       <p:grpSp>
         <p:nvGrpSpPr>
-          <p:cNvPr id="23" name="Group2"/>
+          <p:cNvPr id="22" name="Group5"/>
           <p:cNvGrpSpPr>
             <a:extLst>
               <a:ext uri="smNativeData">
-                <pr:smNativeData xmlns:pr="smNativeData" xmlns="smNativeData" val="SMDATA_6_ZqHWaRMAAAAlAAAAAQAAAA8BAAAAkAAAAEgAAACQAAAASAAAAAAAAAAAAAAAAAAAABcAAAAUAAAAAAAAAAAAAAD/fwAA/38AAAAAAAAJAAAABAAAABQeAjMfAAAAVAAAAAAAAAAAAAAAAAAAAAAAAAAAAAAAAAAAAAAAAAAAAAAAAAAAAAAAAAAAAAAAAAAAAAAAAAAAAAAAAAAAAAAAAAAAAAAAAAAAAAAAAAAAAAAAAAAAACEAAAAYAAAAFAAAADMNAACoJAAAaBYAAN4nAAAQAAAAJgAAAAgAAAD/////AAAAAA=="/>
-              </a:ext>
-            </a:extLst>
-          </p:cNvGrpSpPr>
-          <p:nvPr/>
-        </p:nvGrpSpPr>
-        <p:grpSpPr>
-          <a:xfrm>
-            <a:off x="2145665" y="5958840"/>
-            <a:ext cx="1496695" cy="521970"/>
-            <a:chOff x="2145665" y="5958840"/>
-            <a:chExt cx="1496695" cy="521970"/>
-          </a:xfrm>
-        </p:grpSpPr>
-        <p:sp>
-          <p:nvSpPr>
-            <p:cNvPr id="25" name="Textbox14"/>
-            <p:cNvSpPr txBox="1">
-              <a:extLst>
-                <a:ext uri="smNativeData">
-                  <pr:smNativeData xmlns:pr="smNativeData" xmlns="smNativeData" val="SMDATA_15_ZqHWaRMAAAAlAAAAEgAAAA8BAAAAkAAAAEgAAACQAAAASAAAAAAAAAABAAAAAAAAAAEAAABQAAAAAAAAAAAA4D8AAAAAAADgPwAAAAAAAOA/AAAAAAAA4D8AAAAAAADgPwAAAAAAAOA/AAAAAAAA4D8AAAAAAADgPwAAAAAAAOA/AAAAAAAA4D8CAAAAjAAAAAEAAAAAAAAA//8AAP///wgAAAAAAAAAAAAAAAAAAAAAAAAAAAAAAAAAAAAAZAAAAAEAAABAAAAAAAAAAAAAAAAAAAAAAAAAAAAAAAAAAAAAAAAAAAAAAAAAAAAAAAAAAAAAAAAAAAAAAAAAAAAAAAAAAAAAAAAAAAAAAAAAAAAAAAAAAAAAAAAAAAAAFAAAADwAAAABAAAAAAAAAAAAAAkUAAAAAQAAABQAAAAUAAAAFAAAAAEAAAAAAAAAZAAAAGQAAAAAAAAAZAAAAGQAAAAVAAAAYAAAAAAAAAAAAAAADwAAACADAAAAAAAAAAAAAAEAAACgMgAAVgcAAKr4//8BAAAAf39/AAEAAABkAAAAAAAAABQAAABAHwAAAAAAACYAAAAAAAAAwOD//wAAAAAmAAAAZAAAABYAAABMAAAAAAAAAAAAAAAEAAAAAAAAAAEAAACAgIAKAAAAACgAAAAoAAAAZAAAAGQAAAAAAAAAzMzMAAAAAABQAAAAUAAAAGQAAABkAAAAAAAAABcAAAAUAAAAAAAAAIgDAAD/fwAA/38AAAAAAAAJAAAABAAAAAAAAAAeAAAAaAAAAAAAAAAAAAAAAAAAAAAAAAAAAAAAECcAABAnAAAAAAAAAAAAAAAAAAAAAAAAAAAAAAAAAAAAAAAAAAAAABQAAAAAAAAAwMD/AAAAAABkAAAAMgAAAAAAAABkAAAAAAAAAH9/fwAKAAAAIgAAABgAAAAAAAAAAAAAAAAAAAAAAAAAAAAAAAAAAAAkAAAAJAAAAAAAAAAHAAAAAAAAAAAAAAAAAAAAAAAAAAAAAAAAAAAAf39/ACUAAABYAAAAAAAAAAAAAAAAAAAAAAAAAAAAAAAAAAAAAAAAAAAAAAAAAAAAAAAAAAAAAAA/AAAAAAAAAKCGAQAAAAAAAAAAAAAAAAAMAAAAAQAAAAAAAAAAAAAAAAAAAB8AAABUAAAA//8AAP///wEAAAAAAAAAAAAAAAAAAAAAAAAAAAAAAAAAAAAAAAAAAAAAAAJ/f38AgICAA8zMzADAwP8Af39/AAAAAAAAAAAAAAAAAAAAAAAAAAAAIQAAABgAAAAUAAAAlA0AAAklAABoFgAA3icAAAAAAAAmAAAACAAAAP//////////"/>
-                </a:ext>
-              </a:extLst>
-            </p:cNvSpPr>
-            <p:nvPr/>
-          </p:nvSpPr>
-          <p:spPr>
-            <a:xfrm>
-              <a:off x="2207260" y="6020435"/>
-              <a:ext cx="1435100" cy="460375"/>
-            </a:xfrm>
-            <a:prstGeom prst="rect">
-              <a:avLst/>
-            </a:prstGeom>
-            <a:solidFill>
-              <a:srgbClr val="FFFF00"/>
-            </a:solidFill>
-            <a:ln w="12700" cap="flat" cmpd="sng" algn="ctr">
-              <a:solidFill>
-                <a:schemeClr val="tx1"/>
-              </a:solidFill>
-              <a:prstDash val="solid"/>
-              <a:headEnd type="none"/>
-              <a:tailEnd type="none"/>
-            </a:ln>
-            <a:effectLst/>
-          </p:spPr>
-          <p:txBody>
-            <a:bodyPr vert="horz" wrap="square" numCol="1" spcCol="215900" anchor="ctr"/>
-            <a:lstStyle/>
-            <a:p>
-              <a:pPr algn="ctr"/>
-              <a:r>
-                <a:t>class entries</a:t>
-              </a:r>
-            </a:p>
-          </p:txBody>
-        </p:sp>
-        <p:sp>
-          <p:nvSpPr>
-            <p:cNvPr id="24" name="Textbox16"/>
-            <p:cNvSpPr txBox="1">
-              <a:extLst>
-                <a:ext uri="smNativeData">
-                  <pr:smNativeData xmlns:pr="smNativeData" xmlns="smNativeData" val="SMDATA_15_ZqHWaRMAAAAlAAAAEgAAAA8BAAAAkAAAAEgAAACQAAAASAAAAAAAAAABAAAAAAAAAAEAAABQAAAAAAAAAAAA4D8AAAAAAADgPwAAAAAAAOA/AAAAAAAA4D8AAAAAAADgPwAAAAAAAOA/AAAAAAAA4D8AAAAAAADgPwAAAAAAAOA/AAAAAAAA4D8CAAAAjAAAAAEAAAAAAAAA//8AAP///wgAAAAAAAAAAAAAAAAAAAAAAAAAAAAAAAAAAAAAZAAAAAEAAABAAAAAAAAAAAAAAAAAAAAAAAAAAAAAAAAAAAAAAAAAAAAAAAAAAAAAAAAAAAAAAAAAAAAAAAAAAAAAAAAAAAAAAAAAAAAAAAAAAAAAAAAAAAAAAAAAAAAAFAAAADwAAAABAAAAAAAAAAAAAAkUAAAAAQAAABQAAAAUAAAAFAAAAAEAAAAAAAAAZAAAAGQAAAAAAAAAZAAAAGQAAAAVAAAAYAAAAAAAAAAAAAAADwAAACADAAAAAAAAAAAAAAEAAACgMgAAVgcAAKr4//8BAAAAf39/AAEAAABkAAAAAAAAABQAAABAHwAAAAAAACYAAAAAAAAAwOD//wAAAAAmAAAAZAAAABYAAABMAAAAAAAAAAAAAAAEAAAAAAAAAAEAAACAgIAKAAAAACgAAAAoAAAAZAAAAGQAAAAAAAAAzMzMAAAAAABQAAAAUAAAAGQAAABkAAAAAAAAABcAAAAUAAAAAAAAAIgDAAD/fwAA/38AAAAAAAAJAAAABAAAAA+Qx/8eAAAAaAAAAAAAAAAAAAAAAAAAAAAAAAAAAAAAECcAABAnAAAAAAAAAAAAAAAAAAAAAAAAAAAAAAAAAAAAAAAAAAAAABQAAAAAAAAAwMD/AAAAAABkAAAAMgAAAAAAAABkAAAAAAAAAH9/fwAKAAAAIgAAABgAAAAAAAAAAAAAAAAAAAAAAAAAAAAAAAAAAAAkAAAAJAAAAAAAAAAHAAAAAAAAAAAAAAAAAAAAAAAAAAAAAAAAAAAAf39/ACUAAABYAAAAAAAAAAAAAAAAAAAAAAAAAAAAAAAAAAAAAAAAAAAAAAAAAAAAAAAAAAAAAAA/AAAAAAAAAKCGAQAAAAAAAAAAAAAAAAAMAAAAAQAAAAAAAAAAAAAAAAAAAB8AAABUAAAA//8AAP///wEAAAAAAAAAAAAAAAAAAAAAAAAAAAAAAAAAAAAAAAAAAAAAAAJ/f38AgICAA8zMzADAwP8Af39/AAAAAAAAAAAAAAAAAAAAAAAAAAAAIQAAABgAAAAUAAAAMw0AAKgkAAAHFgAAfScAAAAAAAAmAAAACAAAAP//////////"/>
-                </a:ext>
-              </a:extLst>
-            </p:cNvSpPr>
-            <p:nvPr/>
-          </p:nvSpPr>
-          <p:spPr>
-            <a:xfrm>
-              <a:off x="2145665" y="5958840"/>
-              <a:ext cx="1435100" cy="460375"/>
-            </a:xfrm>
-            <a:prstGeom prst="rect">
-              <a:avLst/>
-            </a:prstGeom>
-            <a:solidFill>
-              <a:srgbClr val="FFFF00"/>
-            </a:solidFill>
-            <a:ln w="12700" cap="flat" cmpd="sng" algn="ctr">
-              <a:solidFill>
-                <a:schemeClr val="tx1"/>
-              </a:solidFill>
-              <a:prstDash val="solid"/>
-              <a:headEnd type="none"/>
-              <a:tailEnd type="none"/>
-            </a:ln>
-            <a:effectLst/>
-          </p:spPr>
-          <p:txBody>
-            <a:bodyPr vert="horz" wrap="square" numCol="1" spcCol="215900" anchor="ctr"/>
-            <a:lstStyle/>
-            <a:p>
-              <a:pPr algn="ctr"/>
-              <a:r>
-                <a:t>class entries</a:t>
-              </a:r>
-            </a:p>
-          </p:txBody>
-        </p:sp>
-      </p:grpSp>
-      <p:grpSp>
-        <p:nvGrpSpPr>
-          <p:cNvPr id="26" name="Group5"/>
-          <p:cNvGrpSpPr>
-            <a:extLst>
-              <a:ext uri="smNativeData">
-                <pr:smNativeData xmlns:pr="smNativeData" xmlns="smNativeData" val="SMDATA_6_ZqHWaRMAAAAlAAAAAQAAAA8BAAAAkAAAAEgAAACQAAAASAAAAAAAAAAAAAAAAAAAABcAAAAUAAAAAAAAAAAAAAD/fwAA/38AAAAAAAAJAAAABAAAAHIGAAAfAAAAVAAAAAAAAAAAAAAAAAAAAAAAAAAAAAAAAAAAAAAAAAAAAAAAAAAAAAAAAAAAAAAAAAAAAAAAAAAAAAAAAAAAAAAAAAAAAAAAAAAAAAAAAAAAAAAAAAAAACEAAAAYAAAAFAAAAGoNAABqIAAAMRYAAHQjAAAQAAAAJgAAAAgAAAD/////AAAAAA=="/>
+                <pr:smNativeData xmlns:pr="smNativeData" xmlns="smNativeData" val="SMDATA_6_MvzhaRMAAAAlAAAAAQAAAA8BAAAAkAAAAEgAAACQAAAASAAAAAAAAAAAAAAAAAAAABcAAAAUAAAAAAAAAAAAAAD/fwAA/38AAAAAAAAJAAAABAAAAJgIAAAfAAAAVAAAAAAAAAAAAAAAAAAAAAAAAAAAAAAAAAAAAAAAAAAAAAAAAAAAAAAAAAAAAAAAAAAAAAAAAAAAAAAAAAAAAAAAAAAAAAAAAAAAAAAAAAAAAAAAAAAAACEAAAAYAAAAFAAAAGoNAABqIAAAMRYAAHQjAAAQAAAAJgAAAAgAAAD/////AAAAAA=="/>
               </a:ext>
             </a:extLst>
           </p:cNvGrpSpPr>
@@ -5008,11 +4847,11 @@
         </p:grpSpPr>
         <p:sp>
           <p:nvSpPr>
-            <p:cNvPr id="28" name="Textbox26"/>
+            <p:cNvPr id="24" name="Textbox26"/>
             <p:cNvSpPr txBox="1">
               <a:extLst>
                 <a:ext uri="smNativeData">
-                  <pr:smNativeData xmlns:pr="smNativeData" xmlns="smNativeData" val="SMDATA_15_ZqHWaRMAAAAlAAAAEgAAAA8BAAAAkAAAAEgAAACQAAAASAAAAAAAAAABAAAAAAAAAAEAAABQAAAAAAAAAAAA4D8AAAAAAADgPwAAAAAAAOA/AAAAAAAA4D8AAAAAAADgPwAAAAAAAOA/AAAAAAAA4D8AAAAAAADgPwAAAAAAAOA/AAAAAAAA4D8CAAAAjAAAAAEAAAAAAAAAAP8AAP///wgAAAAAAAAAAAAAAAAAAAAAAAAAAAAAAAAAAAAAZAAAAAEAAABAAAAAAAAAAAAAAAAAAAAAAAAAAAAAAAAAAAAAAAAAAAAAAAAAAAAAAAAAAAAAAAAAAAAAAAAAAAAAAAAAAAAAAAAAAAAAAAAAAAAAAAAAAAAAAAAAAAAAFAAAADwAAAABAAAAAAAAAAAAAAkUAAAAAQAAABQAAAAUAAAAFAAAAAEAAAAAAAAAZAAAAGQAAAAAAAAAZAAAAGQAAAAVAAAAYAAAAAAAAAAAAAAADwAAACADAAAAAAAAAAAAAAEAAACgMgAAVgcAAKr4//8BAAAAf39/AAEAAABkAAAAAAAAABQAAABAHwAAAAAAACYAAAAAAAAAwOD//wAAAAAmAAAAZAAAABYAAABMAAAAAAAAAAAAAAAEAAAAAAAAAAEAAACAgIAKAAAAACgAAAAoAAAAZAAAAGQAAAAAAAAAzMzMAAAAAABQAAAAUAAAAGQAAABkAAAAAAAAABcAAAAUAAAAAAAAAIgDAAD/fwAA/38AAAAAAAAJAAAABAAAACMAAAAeAAAAaAAAAAAAAAAAAAAAAAAAAAAAAAAAAAAAECcAABAnAAAAAAAAAAAAAAAAAAAAAAAAAAAAAAAAAAAAAAAAAAAAABQAAAAAAAAAwMD/AAAAAABkAAAAMgAAAAAAAABkAAAAAAAAAH9/fwAKAAAAIgAAABgAAAAAAAAAAAAAAAAAAAAAAAAAAAAAAAAAAAAkAAAAJAAAAAAAAAAHAAAAAAAAAAAAAAAAAAAAAAAAAAAAAAAAAAAAf39/ACUAAABYAAAAAAAAAAAAAAAAAAAAAAAAAAAAAAAAAAAAAAAAAAAAAAAAAAAAAAAAAAAAAAA/AAAAAAAAAKCGAQAAAAAAAAAAAAAAAAAMAAAAAQAAAAAAAAAAAAAAAAAAAB8AAABUAAAAAP8AAP///wEAAAAAAAAAAAAAAAAAAAAAAAAAAAAAAAAAAAAAAAAAAAAAAAJ/f38AgICAA8zMzADAwP8Af39/AAAAAAAAAAAAAAAAAAAAAAAAAAAAIQAAABgAAAAUAAAAzg0AAM4gAAAxFgAAdCMAAAAAAAAmAAAACAAAAP//////////"/>
+                  <pr:smNativeData xmlns:pr="smNativeData" xmlns="smNativeData" val="SMDATA_15_MvzhaRMAAAAlAAAAEgAAAA8BAAAAkAAAAEgAAACQAAAASAAAAAAAAAABAAAAAAAAAAEAAABQAAAAAAAAAAAA4D8AAAAAAADgPwAAAAAAAOA/AAAAAAAA4D8AAAAAAADgPwAAAAAAAOA/AAAAAAAA4D8AAAAAAADgPwAAAAAAAOA/AAAAAAAA4D8CAAAAjAAAAAEAAAAAAAAAAP8AAP///wgAAAAAAAAAAAAAAAAAAAAAAAAAAAAAAAAAAAAAZAAAAAEAAABAAAAAAAAAAAAAAAAAAAAAAAAAAAAAAAAAAAAAAAAAAAAAAAAAAAAAAAAAAAAAAAAAAAAAAAAAAAAAAAAAAAAAAAAAAAAAAAAAAAAAAAAAAAAAAAAAAAAAFAAAADwAAAABAAAAAAAAAAAAAAkUAAAAAQAAABQAAAAUAAAAFAAAAAEAAAAAAAAAZAAAAGQAAAAAAAAAZAAAAGQAAAAVAAAAYAAAAAAAAAAAAAAADwAAACADAAAAAAAAAAAAAAEAAACgMgAAVgcAAKr4//8BAAAAf39/AAEAAABkAAAAAAAAABQAAABAHwAAAAAAACYAAAAAAAAAwOD//wAAAAAmAAAAZAAAABYAAABMAAAAAAAAAAAAAAAEAAAAAAAAAAEAAACAgIAKAAAAACgAAAAoAAAAZAAAAGQAAAAAAAAAzMzMAAAAAABQAAAAUAAAAGQAAABkAAAAAAAAABcAAAAUAAAAAAAAAIgDAAD/fwAA/38AAAAAAAAJAAAABAAAACMAAAAeAAAAaAAAAAAAAAAAAAAAAAAAAAAAAAAAAAAAECcAABAnAAAAAAAAAAAAAAAAAAAAAAAAAAAAAAAAAAAAAAAAAAAAABQAAAAAAAAAwMD/AAAAAABkAAAAMgAAAAAAAABkAAAAAAAAAH9/fwAKAAAAIgAAABgAAAAAAAAAAAAAAAAAAAAAAAAAAAAAAAAAAAAkAAAAJAAAAAAAAAAHAAAAAAAAAAAAAAAAAAAAAAAAAAAAAAAAAAAAf39/ACUAAABYAAAAAAAAAAAAAAAAAAAAAAAAAAAAAAAAAAAAAAAAAAAAAAAAAAAAAAAAAAAAAAA/AAAAAAAAAKCGAQAAAAAAAAAAAAAAAAAMAAAAAQAAAAAAAAAAAAAAAAAAAB8AAABUAAAAAP8AAP///wEAAAAAAAAAAAAAAAAAAAAAAAAAAAAAAAAAAAAAAAAAAAAAAAJ/f38AgICAA8zMzADAwP8Af39/AAAAAAAAAAAAAAAAAAAAAAAAAAAAIQAAABgAAAAUAAAAzg0AAM4gAAAxFgAAdCMAAAAAAAAmAAAACAAAAP//////////"/>
                 </a:ext>
               </a:extLst>
             </p:cNvSpPr>
@@ -5052,11 +4891,11 @@
         </p:sp>
         <p:sp>
           <p:nvSpPr>
-            <p:cNvPr id="27" name="Textbox27"/>
+            <p:cNvPr id="23" name="Textbox27"/>
             <p:cNvSpPr txBox="1">
               <a:extLst>
                 <a:ext uri="smNativeData">
-                  <pr:smNativeData xmlns:pr="smNativeData" xmlns="smNativeData" val="SMDATA_15_ZqHWaRMAAAAlAAAAEgAAAA8BAAAAkAAAAEgAAACQAAAASAAAAAAAAAABAAAAAAAAAAEAAABQAAAAAAAAAAAA4D8AAAAAAADgPwAAAAAAAOA/AAAAAAAA4D8AAAAAAADgPwAAAAAAAOA/AAAAAAAA4D8AAAAAAADgPwAAAAAAAOA/AAAAAAAA4D8CAAAAjAAAAAEAAAAAAAAAAP8AAP///wgAAAAAAAAAAAAAAAAAAAAAAAAAAAAAAAAAAAAAZAAAAAEAAABAAAAAAAAAAAAAAAAAAAAAAAAAAAAAAAAAAAAAAAAAAAAAAAAAAAAAAAAAAAAAAAAAAAAAAAAAAAAAAAAAAAAAAAAAAAAAAAAAAAAAAAAAAAAAAAAAAAAAFAAAADwAAAABAAAAAAAAAAAAAAkUAAAAAQAAABQAAAAUAAAAFAAAAAEAAAAAAAAAZAAAAGQAAAAAAAAAZAAAAGQAAAAVAAAAYAAAAAAAAAAAAAAADwAAACADAAAAAAAAAAAAAAEAAACgMgAAVgcAAKr4//8BAAAAf39/AAEAAABkAAAAAAAAABQAAABAHwAAAAAAACYAAAAAAAAAwOD//wAAAAAmAAAAZAAAABYAAABMAAAAAAAAAAAAAAAEAAAAAAAAAAEAAACAgIAKAAAAACgAAAAoAAAAZAAAAGQAAAAAAAAAzMzMAAAAAABQAAAAUAAAAGQAAABkAAAAAAAAABcAAAAUAAAAAAAAAIgDAAD/fwAA/38AAAAAAAAJAAAABAAAACMAAAAeAAAAaAAAAAAAAAAAAAAAAAAAAAAAAAAAAAAAECcAABAnAAAAAAAAAAAAAAAAAAAAAAAAAAAAAAAAAAAAAAAAAAAAABQAAAAAAAAAwMD/AAAAAABkAAAAMgAAAAAAAABkAAAAAAAAAH9/fwAKAAAAIgAAABgAAAAAAAAAAAAAAAAAAAAAAAAAAAAAAAAAAAAkAAAAJAAAAAAAAAAHAAAAAAAAAAAAAAAAAAAAAAAAAAAAAAAAAAAAf39/ACUAAABYAAAAAAAAAAAAAAAAAAAAAAAAAAAAAAAAAAAAAAAAAAAAAAAAAAAAAAAAAAAAAAA/AAAAAAAAAKCGAQAAAAAAAAAAAAAAAAAMAAAAAQAAAAAAAAAAAAAAAAAAAB8AAABUAAAAAP8AAP///wEAAAAAAAAAAAAAAAAAAAAAAAAAAAAAAAAAAAAAAAAAAAAAAAJ/f38AgICAA8zMzADAwP8Af39/AAAAAAAAAAAAAAAAAAAAAAAAAAAAIQAAABgAAAAUAAAAag0AAGogAADNFQAAECMAAAAAAAAmAAAACAAAAP//////////"/>
+                  <pr:smNativeData xmlns:pr="smNativeData" xmlns="smNativeData" val="SMDATA_15_MvzhaRMAAAAlAAAAEgAAAA8BAAAAkAAAAEgAAACQAAAASAAAAAAAAAABAAAAAAAAAAEAAABQAAAAAAAAAAAA4D8AAAAAAADgPwAAAAAAAOA/AAAAAAAA4D8AAAAAAADgPwAAAAAAAOA/AAAAAAAA4D8AAAAAAADgPwAAAAAAAOA/AAAAAAAA4D8CAAAAjAAAAAEAAAAAAAAAAP8AAP///wgAAAAAAAAAAAAAAAAAAAAAAAAAAAAAAAAAAAAAZAAAAAEAAABAAAAAAAAAAAAAAAAAAAAAAAAAAAAAAAAAAAAAAAAAAAAAAAAAAAAAAAAAAAAAAAAAAAAAAAAAAAAAAAAAAAAAAAAAAAAAAAAAAAAAAAAAAAAAAAAAAAAAFAAAADwAAAABAAAAAAAAAAAAAAkUAAAAAQAAABQAAAAUAAAAFAAAAAEAAAAAAAAAZAAAAGQAAAAAAAAAZAAAAGQAAAAVAAAAYAAAAAAAAAAAAAAADwAAACADAAAAAAAAAAAAAAEAAACgMgAAVgcAAKr4//8BAAAAf39/AAEAAABkAAAAAAAAABQAAABAHwAAAAAAACYAAAAAAAAAwOD//wAAAAAmAAAAZAAAABYAAABMAAAAAAAAAAAAAAAEAAAAAAAAAAEAAACAgIAKAAAAACgAAAAoAAAAZAAAAGQAAAAAAAAAzMzMAAAAAABQAAAAUAAAAGQAAABkAAAAAAAAABcAAAAUAAAAAAAAAIgDAAD/fwAA/38AAAAAAAAJAAAABAAAACMAAAAeAAAAaAAAAAAAAAAAAAAAAAAAAAAAAAAAAAAAECcAABAnAAAAAAAAAAAAAAAAAAAAAAAAAAAAAAAAAAAAAAAAAAAAABQAAAAAAAAAwMD/AAAAAABkAAAAMgAAAAAAAABkAAAAAAAAAH9/fwAKAAAAIgAAABgAAAAAAAAAAAAAAAAAAAAAAAAAAAAAAAAAAAAkAAAAJAAAAAAAAAAHAAAAAAAAAAAAAAAAAAAAAAAAAAAAAAAAAAAAf39/ACUAAABYAAAAAAAAAAAAAAAAAAAAAAAAAAAAAAAAAAAAAAAAAAAAAAAAAAAAAAAAAAAAAAA/AAAAAAAAAKCGAQAAAAAAAAAAAAAAAAAMAAAAAQAAAAAAAAAAAAAAAAAAAB8AAABUAAAAAP8AAP///wEAAAAAAAAAAAAAAAAAAAAAAAAAAAAAAAAAAAAAAAAAAAAAAAJ/f38AgICAA8zMzADAwP8Af39/AAAAAAAAAAAAAAAAAAAAAAAAAAAAIQAAABgAAAAUAAAAag0AAGogAADNFQAAECMAAAAAAAAmAAAACAAAAP//////////"/>
                 </a:ext>
               </a:extLst>
             </p:cNvSpPr>
@@ -5097,13 +4936,13 @@
       </p:grpSp>
       <p:cxnSp>
         <p:nvCxnSpPr>
-          <p:cNvPr id="29" name="Connector3"/>
+          <p:cNvPr id="25" name="Connector3"/>
           <p:cNvCxnSpPr>
-            <a:stCxn id="18" idx="2"/>
-            <a:endCxn id="19" idx="0"/>
-            <a:extLst>
-              <a:ext uri="smNativeData">
-                <pr:smNativeData xmlns:pr="smNativeData" xmlns="smNativeData" val="SMDATA_15_ZqHWaRMAAAAlAAAADgAAAA8BAAAAkAAAAEgAAACQAAAASAAAAAAAAAAAAAAAAAAAAAEAAABQAAAAVObRwNBxAbwAAAAAAADgPwAAAAAAAOA/AAAAAAAA4D8AAAAAAADgPwAAAAAAAOA/AAAAAAAA4D8AAAAAAADgPwAAAAAAAOA/AAAAAAAA4D8CAAAAjAAAAAAAAAAAAAAAu+DjDP///wgAAAAAAAAAAAAAAAAAAAAAAAAAAAAAAAAAAAAAZAAAAAEAAABAAAAAAAAAAAAAAAAAAAAAAAAAAAAAAAAAAAAAAAAAAAAAAAAAAAAAAAAAAAAAAAAAAAAAAAAAAAAAAAAAAAAAAAAAAAAAAAAAAAAAAAAAAAAAAAAAAAAAFAAAADwAAAABAAAAAAAAAAAAAAkUAAAAAQAAABQAAAAUAAAAFAAAAAEAAAAAAAAAZAAAAGQAAAABAAAAlgAAAJYAAAAVAAAAYAAAAAAAAAAAAAAADwAAACADAAAAAAAAAAAAAAEAAACgMgAAVgcAAKr4//8BAAAAf39/AAEAAABkAAAAAAAAABQAAABAHwAAAAAAACYAAAAAAAAAwOD//wAAAAAmAAAAZAAAABYAAABMAAAAAAAAAAAAAAAEAAAAAAAAAAEAAACAgIAKAAAAACgAAAAoAAAAZAAAAGQAAAAAAAAAzMzMAAAAAABQAAAAUAAAAGQAAABkAAAAAAAAABcAAAAUAAAAAAAAAAAAAAD/fwAA/38AAAAAAAAJAAAABAAAAAIAAAAeAAAAaAAAAAAAAAAAAAAAAAAAAAAAAAAAAAAAECcAABAnAAAAAAAAAAAAAAAAAAAAAAAAAAAAAAAAAAAAAAAAAAAAABQAAAAAAAAAwMD/AAAAAABkAAAAMgAAAAAAAABkAAAAAAAAAH9/fwAKAAAAIgAAABgAAAAAAAAAAAAAAAAAAAAAAAAAAAAAAAAAAAAkAAAAJAAAAAAAAAAHAAAAAAAAAAAAAAAAAAAAAAAAAAAAAAAAAAAAf39/ACUAAABYAAAAAAAAAAAAAAAAAAAAAAAAAAAAAAAAAAAAAAAAAAAAAAAAAAAAAAAAAAAAAAA/AAAAAAAAAKCGAQAAAAAAAAAAAAAAAAAMAAAAAQAAAAAAAAAAAAAAAAAAAB8AAABUAAAAu+DjBf///wEAAAAAAAAAAAAAAAAAAAAAAAAAAAAAAAAAAAAAAAAAAAAAAAJ/f38AgICAA8zMzADAwP8Af39/AAAAAAAAAAAAAAAAAAAAAAAAAAAAIQAAABgAAAAUAAAAUR8AAGUeAABRHwAAayAAABAAAAAmAAAACAAAAP//////////"/>
+            <a:stCxn id="17" idx="2"/>
+            <a:endCxn id="18" idx="0"/>
+            <a:extLst>
+              <a:ext uri="smNativeData">
+                <pr:smNativeData xmlns:pr="smNativeData" xmlns="smNativeData" val="SMDATA_15_MvzhaRMAAAAlAAAADgAAAA8BAAAAkAAAAEgAAACQAAAASAAAAAAAAAAAAAAAAAAAAAEAAABQAAAAVObRwNBxAbwAAAAAAADgPwAAAAAAAOA/AAAAAAAA4D8AAAAAAADgPwAAAAAAAOA/AAAAAAAA4D8AAAAAAADgPwAAAAAAAOA/AAAAAAAA4D8CAAAAjAAAAAAAAAAAAAAAu+DjDP///wgAAAAAAAAAAAAAAAAAAAAAAAAAAAAAAAAAAAAAZAAAAAEAAABAAAAAAAAAAAAAAAAAAAAAAAAAAAAAAAAAAAAAAAAAAAAAAAAAAAAAAAAAAAAAAAAAAAAAAAAAAAAAAAAAAAAAAAAAAAAAAAAAAAAAAAAAAAAAAAAAAAAAFAAAADwAAAABAAAAAAAAAAAAAAkUAAAAAQAAABQAAAAUAAAAFAAAAAEAAAAAAAAAZAAAAGQAAAABAAAAlgAAAJYAAAAVAAAAYAAAAAAAAAAAAAAADwAAACADAAAAAAAAAAAAAAEAAACgMgAAVgcAAKr4//8BAAAAf39/AAEAAABkAAAAAAAAABQAAABAHwAAAAAAACYAAAAAAAAAwOD//wAAAAAmAAAAZAAAABYAAABMAAAAAAAAAAAAAAAEAAAAAAAAAAEAAACAgIAKAAAAACgAAAAoAAAAZAAAAGQAAAAAAAAAzMzMAAAAAABQAAAAUAAAAGQAAABkAAAAAAAAABcAAAAUAAAAAAAAAAAAAAD/fwAA/38AAAAAAAAJAAAABAAAAAIAAAAeAAAAaAAAAAAAAAAAAAAAAAAAAAAAAAAAAAAAECcAABAnAAAAAAAAAAAAAAAAAAAAAAAAAAAAAAAAAAAAAAAAAAAAABQAAAAAAAAAwMD/AAAAAABkAAAAMgAAAAAAAABkAAAAAAAAAH9/fwAKAAAAIgAAABgAAAAAAAAAAAAAAAAAAAAAAAAAAAAAAAAAAAAkAAAAJAAAAAAAAAAHAAAAAAAAAAAAAAAAAAAAAAAAAAAAAAAAAAAAf39/ACUAAABYAAAAAAAAAAAAAAAAAAAAAAAAAAAAAAAAAAAAAAAAAAAAAAAAAAAAAAAAAAAAAAA/AAAAAAAAAKCGAQAAAAAAAAAAAAAAAAAMAAAAAQAAAAAAAAAAAAAAAAAAAB8AAABUAAAAu+DjBf///wEAAAAAAAAAAAAAAAAAAAAAAAAAAAAAAAAAAAAAAAAAAAAAAAJ/f38AgICAA8zMzADAwP8Af39/AAAAAAAAAAAAAAAAAAAAAAAAAAAAIQAAABgAAAAUAAAAUR8AAGUeAABRHwAAayAAABAAAAAmAAAACAAAAP//////////"/>
               </a:ext>
             </a:extLst>
           </p:cNvCxnSpPr>
@@ -5131,12 +4970,12 @@
       </p:cxnSp>
       <p:cxnSp>
         <p:nvCxnSpPr>
-          <p:cNvPr id="30" name="Connector4"/>
+          <p:cNvPr id="26" name="Connector4"/>
           <p:cNvCxnSpPr>
-            <a:stCxn id="17" idx="2"/>
-            <a:extLst>
-              <a:ext uri="smNativeData">
-                <pr:smNativeData xmlns:pr="smNativeData" xmlns="smNativeData" val="SMDATA_15_ZqHWaRMAAAAlAAAADgAAAA8BAAAAkAAAAEgAAACQAAAASAAAAAAAAAAAAAAAAAAAAAEAAABQAAAAAAAAAAAAAAAAAAAAAADgPwAAAAAAAOA/AAAAAAAA4D8AAAAAAADgPwAAAAAAAOA/AAAAAAAA4D8AAAAAAADgPwAAAAAAAOA/AAAAAAAA4D8CAAAAjAAAAAAAAAAAAAAAu+DjDP///wgAAAAAAAAAAAAAAAAAAAAAAAAAAAAAAAAAAAAAZAAAAAEAAABAAAAAAAAAAAAAAAAAAAAAAAAAAAAAAAAAAAAAAAAAAAAAAAAAAAAAAAAAAAAAAAAAAAAAAAAAAAAAAAAAAAAAAAAAAAAAAAAAAAAAAAAAAAAAAAAAAAAAFAAAADwAAAABAAAAAAAAAAAAAAkUAAAAAQAAABQAAAAUAAAAFAAAAAEAAAAAAAAAZAAAAGQAAAABAAAAlgAAAJYAAAAVAAAAYAAAAAAAAAAAAAAADwAAACADAAAAAAAAAAAAAAEAAACgMgAAVgcAAKr4//8BAAAAf39/AAEAAABkAAAAAAAAABQAAABAHwAAAAAAACYAAAAAAAAAwOD//wAAAAAmAAAAZAAAABYAAABMAAAAAAAAAAAAAAAEAAAAAAAAAAEAAACAgIAKAAAAACgAAAAoAAAAZAAAAGQAAAAAAAAAzMzMAAAAAABQAAAAUAAAAGQAAABkAAAAAAAAABcAAAAUAAAAAAAAAAAAAAD/fwAA/38AAAAAAAAJAAAABAAAAAAAAAAeAAAAaAAAAAAAAAAAAAAAAAAAAAAAAAAAAAAAECcAABAnAAAAAAAAAAAAAAAAAAAAAAAAAAAAAAAAAAAAAAAAAAAAABQAAAAAAAAAwMD/AAAAAABkAAAAMgAAAAAAAABkAAAAAAAAAH9/fwAKAAAAIgAAABgAAAAAAAAAAAAAAAAAAAAAAAAAAAAAAAAAAAAkAAAAJAAAAAAAAAAHAAAAAAAAAAAAAAAAAAAAAAAAAAAAAAAAAAAAf39/ACUAAABYAAAAAAAAAAAAAAAAAAAAAAAAAAAAAAAAAAAAAAAAAAAAAAAAAAAAAAAAAAAAAAA/AAAAAAAAAKCGAQAAAAAAAAAAAAAAAAAMAAAAAQAAAAAAAAAAAAAAAAAAAB8AAABUAAAAu+DjBf///wEAAAAAAAAAAAAAAAAAAAAAAAAAAAAAAAAAAAAAAAAAAAAAAAJ/f38AgICAA8zMzADAwP8Af39/AAAAAAAAAAAAAAAAAAAAAAAAAAAAIQAAABgAAAAUAAAA1hEAAFQYAAAQFwAAkBsAABAAAAAmAAAACAAAAP//////////"/>
+            <a:stCxn id="16" idx="2"/>
+            <a:extLst>
+              <a:ext uri="smNativeData">
+                <pr:smNativeData xmlns:pr="smNativeData" xmlns="smNativeData" val="SMDATA_15_MvzhaRMAAAAlAAAADgAAAA8BAAAAkAAAAEgAAACQAAAASAAAAAAAAAAAAAAAAAAAAAEAAABQAAAAAAAAAAAAAAAAAAAAAADgPwAAAAAAAOA/AAAAAAAA4D8AAAAAAADgPwAAAAAAAOA/AAAAAAAA4D8AAAAAAADgPwAAAAAAAOA/AAAAAAAA4D8CAAAAjAAAAAAAAAAAAAAAu+DjDP///wgAAAAAAAAAAAAAAAAAAAAAAAAAAAAAAAAAAAAAZAAAAAEAAABAAAAAAAAAAAAAAAAAAAAAAAAAAAAAAAAAAAAAAAAAAAAAAAAAAAAAAAAAAAAAAAAAAAAAAAAAAAAAAAAAAAAAAAAAAAAAAAAAAAAAAAAAAAAAAAAAAAAAFAAAADwAAAABAAAAAAAAAAAAAAkUAAAAAQAAABQAAAAUAAAAFAAAAAEAAAAAAAAAZAAAAGQAAAABAAAAlgAAAJYAAAAVAAAAYAAAAAAAAAAAAAAADwAAACADAAAAAAAAAAAAAAEAAACgMgAAVgcAAKr4//8BAAAAf39/AAEAAABkAAAAAAAAABQAAABAHwAAAAAAACYAAAAAAAAAwOD//wAAAAAmAAAAZAAAABYAAABMAAAAAAAAAAAAAAAEAAAAAAAAAAEAAACAgIAKAAAAACgAAAAoAAAAZAAAAGQAAAAAAAAAzMzMAAAAAABQAAAAUAAAAGQAAABkAAAAAAAAABcAAAAUAAAAAAAAAAAAAAD/fwAA/38AAAAAAAAJAAAABAAAAAAAAAAeAAAAaAAAAAAAAAAAAAAAAAAAAAAAAAAAAAAAECcAABAnAAAAAAAAAAAAAAAAAAAAAAAAAAAAAAAAAAAAAAAAAAAAABQAAAAAAAAAwMD/AAAAAABkAAAAMgAAAAAAAABkAAAAAAAAAH9/fwAKAAAAIgAAABgAAAAAAAAAAAAAAAAAAAAAAAAAAAAAAAAAAAAkAAAAJAAAAAAAAAAHAAAAAAAAAAAAAAAAAAAAAAAAAAAAAAAAAAAAf39/ACUAAABYAAAAAAAAAAAAAAAAAAAAAAAAAAAAAAAAAAAAAAAAAAAAAAAAAAAAAAAAAAAAAAA/AAAAAAAAAKCGAQAAAAAAAAAAAAAAAAAMAAAAAQAAAAAAAAAAAAAAAAAAAB8AAABUAAAAu+DjBf///wEAAAAAAAAAAAAAAAAAAAAAAAAAAAAAAAAAAAAAAAAAAAAAAAJ/f38AgICAA8zMzADAwP8Af39/AAAAAAAAAAAAAAAAAAAAAAAAAAAAIQAAABgAAAAUAAAA1hEAAFQYAAAQFwAAkBsAABAAAAAmAAAACAAAAP//////////"/>
               </a:ext>
             </a:extLst>
           </p:cNvCxnSpPr>
@@ -5166,13 +5005,13 @@
       </p:cxnSp>
       <p:cxnSp>
         <p:nvCxnSpPr>
-          <p:cNvPr id="31" name="Connector5"/>
+          <p:cNvPr id="27" name="Connector5"/>
           <p:cNvCxnSpPr>
-            <a:stCxn id="17" idx="2"/>
-            <a:endCxn id="18" idx="0"/>
-            <a:extLst>
-              <a:ext uri="smNativeData">
-                <pr:smNativeData xmlns:pr="smNativeData" xmlns="smNativeData" val="SMDATA_15_ZqHWaRMAAAAlAAAADgAAAA8BAAAAkAAAAEgAAACQAAAASAAAAAAAAAAAAAAAAAAAAAEAAABQAAAAKgs9ranT9TsAAAAAAADgPwAAAAAAAOA/AAAAAAAA4D8AAAAAAADgPwAAAAAAAOA/AAAAAAAA4D8AAAAAAADgPwAAAAAAAOA/AAAAAAAA4D8CAAAAjAAAAAAAAAAAAAAAu+DjDP///wgAAAAAAAAAAAAAAAAAAAAAAAAAAAAAAAAAAAAAZAAAAAEAAABAAAAAAAAAAAAAAAAAAAAAAAAAAAAAAAAAAAAAAAAAAAAAAAAAAAAAAAAAAAAAAAAAAAAAAAAAAAAAAAAAAAAAAAAAAAAAAAAAAAAAAAAAAAAAAAAAAAAAFAAAADwAAAABAAAAAAAAAAAAAAkUAAAAAQAAABQAAAAUAAAAFAAAAAEAAAAAAAAAZAAAAGQAAAABAAAAlgAAAJYAAAAVAAAAYAAAAAAAAAAAAAAADwAAACADAAAAAAAAAAAAAAEAAACgMgAAVgcAAKr4//8BAAAAf39/AAEAAABkAAAAAAAAABQAAABAHwAAAAAAACYAAAAAAAAAwOD//wAAAAAmAAAAZAAAABYAAABMAAAAAAAAAAAAAAAEAAAAAAAAAAEAAACAgIAKAAAAACgAAAAoAAAAZAAAAGQAAAAAAAAAzMzMAAAAAABQAAAAUAAAAGQAAABkAAAAAAAAABcAAAAUAAAAAAAAAAAAAAD/fwAA/38AAAAAAAAJAAAABAAAAAAAAAAeAAAAaAAAAAAAAAAAAAAAAAAAAAAAAAAAAAAAECcAABAnAAAAAAAAAAAAAAAAAAAAAAAAAAAAAAAAAAAAAAAAAAAAABQAAAAAAAAAwMD/AAAAAABkAAAAMgAAAAAAAABkAAAAAAAAAH9/fwAKAAAAIgAAABgAAAAAAAAAAAAAAAAAAAAAAAAAAAAAAAAAAAAkAAAAJAAAAAAAAAAHAAAAAAAAAAAAAAAAAAAAAAAAAAAAAAAAAAAAf39/ACUAAABYAAAAAAAAAAAAAAAAAAAAAAAAAAAAAAAAAAAAAAAAAAAAAAAAAAAAAAAAAAAAAAA/AAAAAAAAAKCGAQAAAAAAAAAAAAAAAAAMAAAAAQAAAAAAAAAAAAAAAAAAAB8AAABUAAAAu+DjBf///wEAAAAAAAAAAAAAAAAAAAAAAAAAAAAAAAAAAAAAAAAAAAAAAAJ/f38AgICAA8zMzADAwP8Af39/AAAAAAAAAAAAAAAAAAAAAAAAAAAAIQAAABgAAAAUAAAAEBcAAFQYAABRHwAAkBsAABAAAAAmAAAACAAAAP//////////"/>
+            <a:stCxn id="16" idx="2"/>
+            <a:endCxn id="17" idx="0"/>
+            <a:extLst>
+              <a:ext uri="smNativeData">
+                <pr:smNativeData xmlns:pr="smNativeData" xmlns="smNativeData" val="SMDATA_15_MvzhaRMAAAAlAAAADgAAAA8BAAAAkAAAAEgAAACQAAAASAAAAAAAAAAAAAAAAAAAAAEAAABQAAAAKgs9ranT9TsAAAAAAADgPwAAAAAAAOA/AAAAAAAA4D8AAAAAAADgPwAAAAAAAOA/AAAAAAAA4D8AAAAAAADgPwAAAAAAAOA/AAAAAAAA4D8CAAAAjAAAAAAAAAAAAAAAu+DjDP///wgAAAAAAAAAAAAAAAAAAAAAAAAAAAAAAAAAAAAAZAAAAAEAAABAAAAAAAAAAAAAAAAAAAAAAAAAAAAAAAAAAAAAAAAAAAAAAAAAAAAAAAAAAAAAAAAAAAAAAAAAAAAAAAAAAAAAAAAAAAAAAAAAAAAAAAAAAAAAAAAAAAAAFAAAADwAAAABAAAAAAAAAAAAAAkUAAAAAQAAABQAAAAUAAAAFAAAAAEAAAAAAAAAZAAAAGQAAAABAAAAlgAAAJYAAAAVAAAAYAAAAAAAAAAAAAAADwAAACADAAAAAAAAAAAAAAEAAACgMgAAVgcAAKr4//8BAAAAf39/AAEAAABkAAAAAAAAABQAAABAHwAAAAAAACYAAAAAAAAAwOD//wAAAAAmAAAAZAAAABYAAABMAAAAAAAAAAAAAAAEAAAAAAAAAAEAAACAgIAKAAAAACgAAAAoAAAAZAAAAGQAAAAAAAAAzMzMAAAAAABQAAAAUAAAAGQAAABkAAAAAAAAABcAAAAUAAAAAAAAAAAAAAD/fwAA/38AAAAAAAAJAAAABAAAAAAAAAAeAAAAaAAAAAAAAAAAAAAAAAAAAAAAAAAAAAAAECcAABAnAAAAAAAAAAAAAAAAAAAAAAAAAAAAAAAAAAAAAAAAAAAAABQAAAAAAAAAwMD/AAAAAABkAAAAMgAAAAAAAABkAAAAAAAAAH9/fwAKAAAAIgAAABgAAAAAAAAAAAAAAAAAAAAAAAAAAAAAAAAAAAAkAAAAJAAAAAAAAAAHAAAAAAAAAAAAAAAAAAAAAAAAAAAAAAAAAAAAf39/ACUAAABYAAAAAAAAAAAAAAAAAAAAAAAAAAAAAAAAAAAAAAAAAAAAAAAAAAAAAAAAAAAAAAA/AAAAAAAAAKCGAQAAAAAAAAAAAAAAAAAMAAAAAQAAAAAAAAAAAAAAAAAAAB8AAABUAAAAu+DjBf///wEAAAAAAAAAAAAAAAAAAAAAAAAAAAAAAAAAAAAAAAAAAAAAAAJ/f38AgICAA8zMzADAwP8Af39/AAAAAAAAAAAAAAAAAAAAAAAAAAAAIQAAABgAAAAUAAAAEBcAAFQYAABRHwAAkBsAABAAAAAmAAAACAAAAP//////////"/>
               </a:ext>
             </a:extLst>
           </p:cNvCxnSpPr>
@@ -5202,13 +5041,13 @@
       </p:cxnSp>
       <p:cxnSp>
         <p:nvCxnSpPr>
-          <p:cNvPr id="32" name="Connector6"/>
+          <p:cNvPr id="28" name="Connector6"/>
           <p:cNvCxnSpPr>
-            <a:stCxn id="7" idx="1"/>
-            <a:endCxn id="17" idx="3"/>
-            <a:extLst>
-              <a:ext uri="smNativeData">
-                <pr:smNativeData xmlns:pr="smNativeData" xmlns="smNativeData" val="SMDATA_15_ZqHWaRMAAAAlAAAADQAAAA8BAAAAkAAAAEgAAACQAAAASAAAAAAAAAAAAAAAAAAAAAEAAABQAAAAAAAAAAAA4D8AAAAAAADgPwAAAAAAAOA/AAAAAAAA4D8AAAAAAADgPwAAAAAAAOA/AAAAAAAA4D8AAAAAAADgPwAAAAAAAOA/AAAAAAAA4D8CAAAAjAAAAAAAAAAAAAAAu+DjDP///wgAAAAAAAAAAAAAAAAAAAAAAAAAAAAAAAAAAAAAZAAAAAEAAABAAAAAAAAAAAAAAAAAAAAAAAAAAAAAAAAAAAAAAAAAAAAAAAAAAAAAAAAAAAAAAAAAAAAAAAAAAAAAAAAAAAAAAAAAAAAAAAAAAAAAAAAAAAAAAAAAAAAAFAAAADwAAAABAAAAAAAAAAAAAAkUAAAAAQAAABQAAAAUAAAAFAAAAAEAAAAAAAAAZAAAAGQAAAABAAAAlgAAAJYAAAAVAAAAYAAAAAAAAAAAAAAADwAAACADAAAAAAAAAAAAAAEAAACgMgAAVgcAAKr4//8BAAAAf39/AAEAAABkAAAAAAAAABQAAABAHwAAAAAAACYAAAAAAAAAwOD//wAAAAAmAAAAZAAAABYAAABMAAAAAAAAAAAAAAAEAAAAAAAAAAEAAACAgIAKAAAAACgAAAAoAAAAZAAAAGQAAAAAAAAAzMzMAAAAAABQAAAAUAAAAGQAAABkAAAAAAAAABcAAAAUAAAAAAAAAAAAAAD/fwAA/38AAAAAAAAJAAAABAAAAAAAAAAeAAAAaAAAAAAAAAAAAAAAAAAAAAAAAAAAAAAAECcAABAnAAAAAAAAAAAAAAAAAAAAAAAAAAAAAAAAAAAAAAAAAAAAABQAAAAAAAAAwMD/AAAAAABkAAAAMgAAAAAAAABkAAAAAAAAAH9/fwAKAAAAIgAAABgAAAAAAAAAAAAAAAAAAAAAAAAAAAAAAAAAAAAkAAAAJAAAAAAAAAAHAAAAAAAAAAAAAAAAAAAAAAAAAAAAAAAAAAAAf39/ACUAAABYAAAAAAAAAAAAAAAAAAAAAAAAAAAAAAAAAAAAAAAAAAAAAAAAAAAAAAAAAAAAAAA/AAAAAAAAAKCGAQAAAAAAAAAAAAAAAAAMAAAAAQAAAAAAAAAAAAAAAAAAAB8AAABUAAAAu+DjBf///wEAAAAAAAAAAAAAAAAAAAAAAAAAAAAAAAAAAAAAAAAAAAAAAAJ/f38AgICAA8zMzADAwP8Af39/AAAAAAAAAAAAAAAAAAAAAAAAAAAAIQAAABgAAAAUAAAAthkAAFgWAADxIAAAWBYAABAAAAAmAAAACAAAAP//////////"/>
+            <a:stCxn id="6" idx="1"/>
+            <a:endCxn id="16" idx="3"/>
+            <a:extLst>
+              <a:ext uri="smNativeData">
+                <pr:smNativeData xmlns:pr="smNativeData" xmlns="smNativeData" val="SMDATA_15_MvzhaRMAAAAlAAAADQAAAA8BAAAAkAAAAEgAAACQAAAASAAAAAAAAAAAAAAAAAAAAAEAAABQAAAAAAAAAAAA4D8AAAAAAADgPwAAAAAAAOA/AAAAAAAA4D8AAAAAAADgPwAAAAAAAOA/AAAAAAAA4D8AAAAAAADgPwAAAAAAAOA/AAAAAAAA4D8CAAAAjAAAAAAAAAAAAAAAu+DjDP///wgAAAAAAAAAAAAAAAAAAAAAAAAAAAAAAAAAAAAAZAAAAAEAAABAAAAAAAAAAAAAAAAAAAAAAAAAAAAAAAAAAAAAAAAAAAAAAAAAAAAAAAAAAAAAAAAAAAAAAAAAAAAAAAAAAAAAAAAAAAAAAAAAAAAAAAAAAAAAAAAAAAAAFAAAADwAAAABAAAAAAAAAAAAAAkUAAAAAQAAABQAAAAUAAAAFAAAAAEAAAAAAAAAZAAAAGQAAAABAAAAlgAAAJYAAAAVAAAAYAAAAAAAAAAAAAAADwAAACADAAAAAAAAAAAAAAEAAACgMgAAVgcAAKr4//8BAAAAf39/AAEAAABkAAAAAAAAABQAAABAHwAAAAAAACYAAAAAAAAAwOD//wAAAAAmAAAAZAAAABYAAABMAAAAAAAAAAAAAAAEAAAAAAAAAAEAAACAgIAKAAAAACgAAAAoAAAAZAAAAGQAAAAAAAAAzMzMAAAAAABQAAAAUAAAAGQAAABkAAAAAAAAABcAAAAUAAAAAAAAAAAAAAD/fwAA/38AAAAAAAAJAAAABAAAAAAAAAAeAAAAaAAAAAAAAAAAAAAAAAAAAAAAAAAAAAAAECcAABAnAAAAAAAAAAAAAAAAAAAAAAAAAAAAAAAAAAAAAAAAAAAAABQAAAAAAAAAwMD/AAAAAABkAAAAMgAAAAAAAABkAAAAAAAAAH9/fwAKAAAAIgAAABgAAAAAAAAAAAAAAAAAAAAAAAAAAAAAAAAAAAAkAAAAJAAAAAAAAAAHAAAAAAAAAAAAAAAAAAAAAAAAAAAAAAAAAAAAf39/ACUAAABYAAAAAAAAAAAAAAAAAAAAAAAAAAAAAAAAAAAAAAAAAAAAAAAAAAAAAAAAAAAAAAA/AAAAAAAAAKCGAQAAAAAAAAAAAAAAAAAMAAAAAQAAAAAAAAAAAAAAAAAAAB8AAABUAAAAu+DjBf///wEAAAAAAAAAAAAAAAAAAAAAAAAAAAAAAAAAAAAAAAAAAAAAAAJ/f38AgICAA8zMzADAwP8Af39/AAAAAAAAAAAAAAAAAAAAAAAAAAAAIQAAABgAAAAUAAAAthkAAFgWAADxIAAAWBYAABAAAAAmAAAACAAAAP//////////"/>
               </a:ext>
             </a:extLst>
           </p:cNvCxnSpPr>
@@ -5236,13 +5075,13 @@
       </p:cxnSp>
       <p:cxnSp>
         <p:nvCxnSpPr>
-          <p:cNvPr id="33" name="Connector7"/>
+          <p:cNvPr id="29" name="Connector7"/>
           <p:cNvCxnSpPr>
-            <a:stCxn id="7" idx="3"/>
-            <a:endCxn id="11" idx="1"/>
-            <a:extLst>
-              <a:ext uri="smNativeData">
-                <pr:smNativeData xmlns:pr="smNativeData" xmlns="smNativeData" val="SMDATA_15_ZqHWaRMAAAAlAAAADQAAAA8BAAAAkAAAAEgAAACQAAAASAAAAAAAAAAAAAAAAAAAAAEAAABQAAAAAAAAAAAA4D8AAAAAAADgPwAAAAAAAOA/AAAAAAAA4D8AAAAAAADgPwAAAAAAAOA/AAAAAAAA4D8AAAAAAADgPwAAAAAAAOA/AAAAAAAA4D8CAAAAjAAAAAAAAAAAAAAAu+DjDP///wgAAAAAAAAAAAAAAAAAAAAAAAAAAAAAAAAAAAAAZAAAAAEAAABAAAAAAAAAAAAAAAAAAAAAAAAAAAAAAAAAAAAAAAAAAAAAAAAAAAAAAAAAAAAAAAAAAAAAAAAAAAAAAAAAAAAAAAAAAAAAAAAAAAAAAAAAAAAAAAAAAAAAFAAAADwAAAABAAAAAAAAAAAAAAkUAAAAAQAAABQAAAAUAAAAFAAAAAEAAAAAAAAAZAAAAGQAAAABAAAAlgAAAJYAAAAVAAAAYAAAAAAAAAAAAAAADwAAACADAAAAAAAAAAAAAAEAAACgMgAAVgcAAKr4//8BAAAAf39/AAEAAABkAAAAAAAAABQAAABAHwAAAAAAACYAAAAAAAAAwOD//wAAAAAmAAAAZAAAABYAAABMAAAAAAAAAAAAAAAEAAAAAAAAAAEAAACAgIAKAAAAACgAAAAoAAAAZAAAAGQAAAAAAAAAzMzMAAAAAABQAAAAUAAAAGQAAABkAAAAAAAAABcAAAAUAAAAAAAAAAAAAAD/fwAA/38AAAAAAAAJAAAABAAAAAAAAAAeAAAAaAAAAAAAAAAAAAAAAAAAAAAAAAAAAAAAECcAABAnAAAAAAAAAAAAAAAAAAAAAAAAAAAAAAAAAAAAAAAAAAAAABQAAAAAAAAAwMD/AAAAAABkAAAAMgAAAAAAAABkAAAAAAAAAH9/fwAKAAAAIgAAABgAAAAAAAAAAAAAAAAAAAAAAAAAAAAAAAAAAAAkAAAAJAAAAAAAAAAHAAAAAAAAAAAAAAAAAAAAAAAAAAAAAAAAAAAAf39/ACUAAABYAAAAAAAAAAAAAAAAAAAAAAAAAAAAAAAAAAAAAAAAAAAAAAAAAAAAAAAAAAAAAAA/AAAAAAAAAKCGAQAAAAAAAAAAAAAAAAAMAAAAAQAAAAAAAAAAAAAAAAAAAB8AAABUAAAAu+DjBf///wEAAAAAAAAAAAAAAAAAAAAAAAAAAAAAAAAAAAAAAAAAAAAAAAJ/f38AgICAA8zMzADAwP8Af39/AAAAAAAAAAAAAAAAAAAAAAAAAAAAIQAAABgAAAAUAAAAGCsAAFgWAABGMQAAWBYAABAAAAAmAAAACAAAAP//////////"/>
+            <a:stCxn id="6" idx="3"/>
+            <a:endCxn id="10" idx="1"/>
+            <a:extLst>
+              <a:ext uri="smNativeData">
+                <pr:smNativeData xmlns:pr="smNativeData" xmlns="smNativeData" val="SMDATA_15_MvzhaRMAAAAlAAAADQAAAA8BAAAAkAAAAEgAAACQAAAASAAAAAAAAAAAAAAAAAAAAAEAAABQAAAAAAAAAAAA4D8AAAAAAADgPwAAAAAAAOA/AAAAAAAA4D8AAAAAAADgPwAAAAAAAOA/AAAAAAAA4D8AAAAAAADgPwAAAAAAAOA/AAAAAAAA4D8CAAAAjAAAAAAAAAAAAAAAu+DjDP///wgAAAAAAAAAAAAAAAAAAAAAAAAAAAAAAAAAAAAAZAAAAAEAAABAAAAAAAAAAAAAAAAAAAAAAAAAAAAAAAAAAAAAAAAAAAAAAAAAAAAAAAAAAAAAAAAAAAAAAAAAAAAAAAAAAAAAAAAAAAAAAAAAAAAAAAAAAAAAAAAAAAAAFAAAADwAAAABAAAAAAAAAAAAAAkUAAAAAQAAABQAAAAUAAAAFAAAAAEAAAAAAAAAZAAAAGQAAAABAAAAlgAAAJYAAAAVAAAAYAAAAAAAAAAAAAAADwAAACADAAAAAAAAAAAAAAEAAACgMgAAVgcAAKr4//8BAAAAf39/AAEAAABkAAAAAAAAABQAAABAHwAAAAAAACYAAAAAAAAAwOD//wAAAAAmAAAAZAAAABYAAABMAAAAAAAAAAAAAAAEAAAAAAAAAAEAAACAgIAKAAAAACgAAAAoAAAAZAAAAGQAAAAAAAAAzMzMAAAAAABQAAAAUAAAAGQAAABkAAAAAAAAABcAAAAUAAAAAAAAAAAAAAD/fwAA/38AAAAAAAAJAAAABAAAAAAAAAAeAAAAaAAAAAAAAAAAAAAAAAAAAAAAAAAAAAAAECcAABAnAAAAAAAAAAAAAAAAAAAAAAAAAAAAAAAAAAAAAAAAAAAAABQAAAAAAAAAwMD/AAAAAABkAAAAMgAAAAAAAABkAAAAAAAAAH9/fwAKAAAAIgAAABgAAAAAAAAAAAAAAAAAAAAAAAAAAAAAAAAAAAAkAAAAJAAAAAAAAAAHAAAAAAAAAAAAAAAAAAAAAAAAAAAAAAAAAAAAf39/ACUAAABYAAAAAAAAAAAAAAAAAAAAAAAAAAAAAAAAAAAAAAAAAAAAAAAAAAAAAAAAAAAAAAA/AAAAAAAAAKCGAQAAAAAAAAAAAAAAAAAMAAAAAQAAAAAAAAAAAAAAAAAAAB8AAABUAAAAu+DjBf///wEAAAAAAAAAAAAAAAAAAAAAAAAAAAAAAAAAAAAAAAAAAAAAAAJ/f38AgICAA8zMzADAwP8Af39/AAAAAAAAAAAAAAAAAAAAAAAAAAAAIQAAABgAAAAUAAAAGCsAAFgWAABGMQAAWBYAABAAAAAmAAAACAAAAP//////////"/>
               </a:ext>
             </a:extLst>
           </p:cNvCxnSpPr>
@@ -5270,12 +5109,12 @@
       </p:cxnSp>
       <p:cxnSp>
         <p:nvCxnSpPr>
-          <p:cNvPr id="34" name="Connector8"/>
+          <p:cNvPr id="30" name="Connector8"/>
           <p:cNvCxnSpPr>
-            <a:stCxn id="11" idx="2"/>
-            <a:extLst>
-              <a:ext uri="smNativeData">
-                <pr:smNativeData xmlns:pr="smNativeData" xmlns="smNativeData" val="SMDATA_15_ZqHWaRMAAAAlAAAADgAAAA8BAAAAkAAAAEgAAACQAAAASAAAAAAAAAAAAAAAAAAAAAEAAABQAAAAIlGJdd5YUr8AAAAAAADgPwAAAAAAAOA/AAAAAAAA4D8AAAAAAADgPwAAAAAAAOA/AAAAAAAA4D8AAAAAAADgPwAAAAAAAOA/AAAAAAAA4D8CAAAAjAAAAAAAAAAAAAAAu+DjDP///wgAAAAAAAAAAAAAAAAAAAAAAAAAAAAAAAAAAAAAZAAAAAEAAABAAAAAAAAAAAAAAAAAAAAAAAAAAAAAAAAAAAAAAAAAAAAAAAAAAAAAAAAAAAAAAAAAAAAAAAAAAAAAAAAAAAAAAAAAAAAAAAAAAAAAAAAAAAAAAAAAAAAAFAAAADwAAAABAAAAAAAAAAAAAAkUAAAAAQAAABQAAAAUAAAAFAAAAAEAAAAAAAAAZAAAAGQAAAABAAAAlgAAAJYAAAAVAAAAYAAAAAAAAAAAAAAADwAAACADAAAAAAAAAAAAAAEAAACgMgAAVgcAAKr4//8BAAAAf39/AAEAAABkAAAAAAAAABQAAABAHwAAAAAAACYAAAAAAAAAwOD//wAAAAAmAAAAZAAAABYAAABMAAAAAAAAAAAAAAAEAAAAAAAAAAEAAACAgIAKAAAAACgAAAAoAAAAZAAAAGQAAAAAAAAAzMzMAAAAAABQAAAAUAAAAGQAAABkAAAAAAAAABcAAAAUAAAAAAAAAAAAAAD/fwAA/38AAAAAAAAJAAAABAAAAAAAAAAeAAAAaAAAAAAAAAAAAAAAAAAAAAAAAAAAAAAAECcAABAnAAAAAAAAAAAAAAAAAAAAAAAAAAAAAAAAAAAAAAAAAAAAABQAAAAAAAAAwMD/AAAAAABkAAAAMgAAAAAAAABkAAAAAAAAAH9/fwAKAAAAIgAAABgAAAAAAAAAAAAAAAAAAAAAAAAAAAAAAAAAAAAkAAAAJAAAAAAAAAAHAAAAAAAAAAAAAAAAAAAAAAAAAAAAAAAAAAAAf39/ACUAAABYAAAAAAAAAAAAAAAAAAAAAAAAAAAAAAAAAAAAAAAAAAAAAAAAAAAAAAAAAAAAAAA/AAAAAAAAAKCGAQAAAAAAAAAAAAAAAAAMAAAAAQAAAAAAAAAAAAAAAAAAAB8AAABUAAAAu+DjBf///wEAAAAAAAAAAAAAAAAAAAAAAAAAAAAAAAAAAAAAAAAAAAAAAAJ/f38AgICAA8zMzADAwP8Af39/AAAAAAAAAAAAAAAAAAAAAAAAAAAAIQAAABgAAAAUAAAASSwAAFQYAADsMwAA0RsAABAAAAAmAAAACAAAAP//////////"/>
+            <a:stCxn id="10" idx="2"/>
+            <a:extLst>
+              <a:ext uri="smNativeData">
+                <pr:smNativeData xmlns:pr="smNativeData" xmlns="smNativeData" val="SMDATA_15_MvzhaRMAAAAlAAAADgAAAA8BAAAAkAAAAEgAAACQAAAASAAAAAAAAAAAAAAAAAAAAAEAAABQAAAAIlGJdd5YUr8AAAAAAADgPwAAAAAAAOA/AAAAAAAA4D8AAAAAAADgPwAAAAAAAOA/AAAAAAAA4D8AAAAAAADgPwAAAAAAAOA/AAAAAAAA4D8CAAAAjAAAAAAAAAAAAAAAu+DjDP///wgAAAAAAAAAAAAAAAAAAAAAAAAAAAAAAAAAAAAAZAAAAAEAAABAAAAAAAAAAAAAAAAAAAAAAAAAAAAAAAAAAAAAAAAAAAAAAAAAAAAAAAAAAAAAAAAAAAAAAAAAAAAAAAAAAAAAAAAAAAAAAAAAAAAAAAAAAAAAAAAAAAAAFAAAADwAAAABAAAAAAAAAAAAAAkUAAAAAQAAABQAAAAUAAAAFAAAAAEAAAAAAAAAZAAAAGQAAAABAAAAlgAAAJYAAAAVAAAAYAAAAAAAAAAAAAAADwAAACADAAAAAAAAAAAAAAEAAACgMgAAVgcAAKr4//8BAAAAf39/AAEAAABkAAAAAAAAABQAAABAHwAAAAAAACYAAAAAAAAAwOD//wAAAAAmAAAAZAAAABYAAABMAAAAAAAAAAAAAAAEAAAAAAAAAAEAAACAgIAKAAAAACgAAAAoAAAAZAAAAGQAAAAAAAAAzMzMAAAAAABQAAAAUAAAAGQAAABkAAAAAAAAABcAAAAUAAAAAAAAAAAAAAD/fwAA/38AAAAAAAAJAAAABAAAAAAAAAAeAAAAaAAAAAAAAAAAAAAAAAAAAAAAAAAAAAAAECcAABAnAAAAAAAAAAAAAAAAAAAAAAAAAAAAAAAAAAAAAAAAAAAAABQAAAAAAAAAwMD/AAAAAABkAAAAMgAAAAAAAABkAAAAAAAAAH9/fwAKAAAAIgAAABgAAAAAAAAAAAAAAAAAAAAAAAAAAAAAAAAAAAAkAAAAJAAAAAAAAAAHAAAAAAAAAAAAAAAAAAAAAAAAAAAAAAAAAAAAf39/ACUAAABYAAAAAAAAAAAAAAAAAAAAAAAAAAAAAAAAAAAAAAAAAAAAAAAAAAAAAAAAAAAAAAA/AAAAAAAAAKCGAQAAAAAAAAAAAAAAAAAMAAAAAQAAAAAAAAAAAAAAAAAAAB8AAABUAAAAu+DjBf///wEAAAAAAAAAAAAAAAAAAAAAAAAAAAAAAAAAAAAAAAAAAAAAAAJ/f38AgICAA8zMzADAwP8Af39/AAAAAAAAAAAAAAAAAAAAAAAAAAAAIQAAABgAAAAUAAAASSwAAFQYAADsMwAA0RsAABAAAAAmAAAACAAAAP//////////"/>
               </a:ext>
             </a:extLst>
           </p:cNvCxnSpPr>
@@ -5305,13 +5144,13 @@
       </p:cxnSp>
       <p:cxnSp>
         <p:nvCxnSpPr>
-          <p:cNvPr id="35" name="Connector9"/>
+          <p:cNvPr id="31" name="Connector9"/>
           <p:cNvCxnSpPr>
-            <a:stCxn id="11" idx="2"/>
-            <a:endCxn id="15" idx="0"/>
-            <a:extLst>
-              <a:ext uri="smNativeData">
-                <pr:smNativeData xmlns:pr="smNativeData" xmlns="smNativeData" val="SMDATA_15_ZqHWaRMAAAAlAAAADgAAAA8BAAAAkAAAAEgAAACQAAAASAAAAAAAAAAAAAAAAAAAAAEAAABQAAAAIFGJdd5YUr8AAAAAAADgPwAAAAAAAOA/AAAAAAAA4D8AAAAAAADgPwAAAAAAAOA/AAAAAAAA4D8AAAAAAADgPwAAAAAAAOA/AAAAAAAA4D8CAAAAjAAAAAAAAAAAAAAAu+DjDP///wgAAAAAAAAAAAAAAAAAAAAAAAAAAAAAAAAAAAAAZAAAAAEAAABAAAAAAAAAAAAAAAAAAAAAAAAAAAAAAAAAAAAAAAAAAAAAAAAAAAAAAAAAAAAAAAAAAAAAAAAAAAAAAAAAAAAAAAAAAAAAAAAAAAAAAAAAAAAAAAAAAAAAFAAAADwAAAABAAAAAAAAAAAAAAkUAAAAAQAAABQAAAAUAAAAFAAAAAEAAAAAAAAAZAAAAGQAAAABAAAAlgAAAJYAAAAVAAAAYAAAAAAAAAAAAAAADwAAACADAAAAAAAAAAAAAAEAAACgMgAAVgcAAKr4//8BAAAAf39/AAEAAABkAAAAAAAAABQAAABAHwAAAAAAACYAAAAAAAAAwOD//wAAAAAmAAAAZAAAABYAAABMAAAAAAAAAAAAAAAEAAAAAAAAAAEAAACAgIAKAAAAACgAAAAoAAAAZAAAAGQAAAAAAAAAzMzMAAAAAABQAAAAUAAAAGQAAABkAAAAAAAAABcAAAAUAAAAAAAAAAAAAAD/fwAA/38AAAAAAAAJAAAABAAAAAAAAAAeAAAAaAAAAAAAAAAAAAAAAAAAAAAAAAAAAAAAECcAABAnAAAAAAAAAAAAAAAAAAAAAAAAAAAAAAAAAAAAAAAAAAAAABQAAAAAAAAAwMD/AAAAAABkAAAAMgAAAAAAAABkAAAAAAAAAH9/fwAKAAAAIgAAABgAAAAAAAAAAAAAAAAAAAAAAAAAAAAAAAAAAAAkAAAAJAAAAAAAAAAHAAAAAAAAAAAAAAAAAAAAAAAAAAAAAAAAAAAAf39/ACUAAABYAAAAAAAAAAAAAAAAAAAAAAAAAAAAAAAAAAAAAAAAAAAAAAAAAAAAAAAAAAAAAAA/AAAAAAAAAKCGAQAAAAAAAAAAAAAAAAAMAAAAAQAAAAAAAAAAAAAAAAAAAB8AAABUAAAAu+DjBf///wEAAAAAAAAAAAAAAAAAAAAAAAAAAAAAAAAAAAAAAAAAAAAAAAJ/f38AgICAA8zMzADAwP8Af39/AAAAAAAAAAAAAAAAAAAAAAAAAAAAIQAAABgAAAAUAAAA7DMAAFQYAACjOwAA0RsAABAAAAAmAAAACAAAAP//////////"/>
+            <a:stCxn id="10" idx="2"/>
+            <a:endCxn id="14" idx="0"/>
+            <a:extLst>
+              <a:ext uri="smNativeData">
+                <pr:smNativeData xmlns:pr="smNativeData" xmlns="smNativeData" val="SMDATA_15_MvzhaRMAAAAlAAAADgAAAA8BAAAAkAAAAEgAAACQAAAASAAAAAAAAAAAAAAAAAAAAAEAAABQAAAAIFGJdd5YUr8AAAAAAADgPwAAAAAAAOA/AAAAAAAA4D8AAAAAAADgPwAAAAAAAOA/AAAAAAAA4D8AAAAAAADgPwAAAAAAAOA/AAAAAAAA4D8CAAAAjAAAAAAAAAAAAAAAu+DjDP///wgAAAAAAAAAAAAAAAAAAAAAAAAAAAAAAAAAAAAAZAAAAAEAAABAAAAAAAAAAAAAAAAAAAAAAAAAAAAAAAAAAAAAAAAAAAAAAAAAAAAAAAAAAAAAAAAAAAAAAAAAAAAAAAAAAAAAAAAAAAAAAAAAAAAAAAAAAAAAAAAAAAAAFAAAADwAAAABAAAAAAAAAAAAAAkUAAAAAQAAABQAAAAUAAAAFAAAAAEAAAAAAAAAZAAAAGQAAAABAAAAlgAAAJYAAAAVAAAAYAAAAAAAAAAAAAAADwAAACADAAAAAAAAAAAAAAEAAACgMgAAVgcAAKr4//8BAAAAf39/AAEAAABkAAAAAAAAABQAAABAHwAAAAAAACYAAAAAAAAAwOD//wAAAAAmAAAAZAAAABYAAABMAAAAAAAAAAAAAAAEAAAAAAAAAAEAAACAgIAKAAAAACgAAAAoAAAAZAAAAGQAAAAAAAAAzMzMAAAAAABQAAAAUAAAAGQAAABkAAAAAAAAABcAAAAUAAAAAAAAAAAAAAD/fwAA/38AAAAAAAAJAAAABAAAAAAAAAAeAAAAaAAAAAAAAAAAAAAAAAAAAAAAAAAAAAAAECcAABAnAAAAAAAAAAAAAAAAAAAAAAAAAAAAAAAAAAAAAAAAAAAAABQAAAAAAAAAwMD/AAAAAABkAAAAMgAAAAAAAABkAAAAAAAAAH9/fwAKAAAAIgAAABgAAAAAAAAAAAAAAAAAAAAAAAAAAAAAAAAAAAAkAAAAJAAAAAAAAAAHAAAAAAAAAAAAAAAAAAAAAAAAAAAAAAAAAAAAf39/ACUAAABYAAAAAAAAAAAAAAAAAAAAAAAAAAAAAAAAAAAAAAAAAAAAAAAAAAAAAAAAAAAAAAA/AAAAAAAAAKCGAQAAAAAAAAAAAAAAAAAMAAAAAQAAAAAAAAAAAAAAAAAAAB8AAABUAAAAu+DjBf///wEAAAAAAAAAAAAAAAAAAAAAAAAAAAAAAAAAAAAAAAAAAAAAAAJ/f38AgICAA8zMzADAwP8Af39/AAAAAAAAAAAAAAAAAAAAAAAAAAAAIQAAABgAAAAUAAAA7DMAAFQYAACjOwAA0RsAABAAAAAmAAAACAAAAP//////////"/>
               </a:ext>
             </a:extLst>
           </p:cNvCxnSpPr>
@@ -5341,13 +5180,13 @@
       </p:cxnSp>
       <p:cxnSp>
         <p:nvCxnSpPr>
-          <p:cNvPr id="36" name="Connector11"/>
+          <p:cNvPr id="32" name="Connector11"/>
           <p:cNvCxnSpPr>
-            <a:stCxn id="15" idx="2"/>
-            <a:endCxn id="16" idx="0"/>
-            <a:extLst>
-              <a:ext uri="smNativeData">
-                <pr:smNativeData xmlns:pr="smNativeData" xmlns="smNativeData" val="SMDATA_15_ZqHWaRMAAAAlAAAADQAAAA8BAAAAkAAAAEgAAACQAAAASAAAAAAAAAAAAAAAAAAAAAEAAABQAAAAU01UIIFqDDwAAAAAAADgPwAAAAAAAOA/AAAAAAAA4D8AAAAAAADgPwAAAAAAAOA/AAAAAAAA4D8AAAAAAADgPwAAAAAAAOA/AAAAAAAA4D8CAAAAjAAAAAAAAAAAAAAAu+DjDP///wgAAAAAAAAAAAAAAAAAAAAAAAAAAAAAAAAAAAAAZAAAAAEAAABAAAAAAAAAAAAAAAAAAAAAAAAAAAAAAAAAAAAAAAAAAAAAAAAAAAAAAAAAAAAAAAAAAAAAAAAAAAAAAAAAAAAAAAAAAAAAAAAAAAAAAAAAAAAAAAAAAAAAFAAAADwAAAABAAAAAAAAAAAAAAkUAAAAAQAAABQAAAAUAAAAFAAAAAEAAAAAAAAAZAAAAGQAAAABAAAAlgAAAJYAAAAVAAAAYAAAAAAAAAAAAAAADwAAACADAAAAAAAAAAAAAAEAAACgMgAAVgcAAKr4//8BAAAAf39/AAEAAABkAAAAAAAAABQAAABAHwAAAAAAACYAAAAAAAAAwOD//wAAAAAmAAAAZAAAABYAAABMAAAAAAAAAAAAAAAEAAAAAAAAAAEAAACAgIAKAAAAACgAAAAoAAAAZAAAAGQAAAAAAAAAzMzMAAAAAABQAAAAUAAAAGQAAABkAAAAAAAAABcAAAAUAAAAAAAAAAAAAAD/fwAA/38AAAAAAAAJAAAABAAAAAAAAAAeAAAAaAAAAAAAAAAAAAAAAAAAAAAAAAAAAAAAECcAABAnAAAAAAAAAAAAAAAAAAAAAAAAAAAAAAAAAAAAAAAAAAAAABQAAAAAAAAAwMD/AAAAAABkAAAAMgAAAAAAAABkAAAAAAAAAH9/fwAKAAAAIgAAABgAAAAAAAAAAAAAAAAAAAAAAAAAAAAAAAAAAAAkAAAAJAAAAAAAAAAHAAAAAAAAAAAAAAAAAAAAAAAAAAAAAAAAAAAAf39/ACUAAABYAAAAAAAAAAAAAAAAAAAAAAAAAAAAAAAAAAAAAAAAAAAAAAAAAAAAAAAAAAAAAAA/AAAAAAAAAKCGAQAAAAAAAAAAAAAAAAAMAAAAAQAAAAAAAAAAAAAAAAAAAB8AAABUAAAAu+DjBf///wEAAAAAAAAAAAAAAAAAAAAAAAAAAAAAAAAAAAAAAAAAAAAAAAJ/f38AgICAA8zMzADAwP8Af39/AAAAAAAAAAAAAAAAAAAAAAAAAAAAIQAAABgAAAAUAAAAozsAAKYeAACjOwAAfCAAABAAAAAmAAAACAAAAP//////////"/>
+            <a:stCxn id="14" idx="2"/>
+            <a:endCxn id="15" idx="0"/>
+            <a:extLst>
+              <a:ext uri="smNativeData">
+                <pr:smNativeData xmlns:pr="smNativeData" xmlns="smNativeData" val="SMDATA_15_MvzhaRMAAAAlAAAADQAAAA8BAAAAkAAAAEgAAACQAAAASAAAAAAAAAAAAAAAAAAAAAEAAABQAAAAU01UIIFqDDwAAAAAAADgPwAAAAAAAOA/AAAAAAAA4D8AAAAAAADgPwAAAAAAAOA/AAAAAAAA4D8AAAAAAADgPwAAAAAAAOA/AAAAAAAA4D8CAAAAjAAAAAAAAAAAAAAAu+DjDP///wgAAAAAAAAAAAAAAAAAAAAAAAAAAAAAAAAAAAAAZAAAAAEAAABAAAAAAAAAAAAAAAAAAAAAAAAAAAAAAAAAAAAAAAAAAAAAAAAAAAAAAAAAAAAAAAAAAAAAAAAAAAAAAAAAAAAAAAAAAAAAAAAAAAAAAAAAAAAAAAAAAAAAFAAAADwAAAABAAAAAAAAAAAAAAkUAAAAAQAAABQAAAAUAAAAFAAAAAEAAAAAAAAAZAAAAGQAAAABAAAAlgAAAJYAAAAVAAAAYAAAAAAAAAAAAAAADwAAACADAAAAAAAAAAAAAAEAAACgMgAAVgcAAKr4//8BAAAAf39/AAEAAABkAAAAAAAAABQAAABAHwAAAAAAACYAAAAAAAAAwOD//wAAAAAmAAAAZAAAABYAAABMAAAAAAAAAAAAAAAEAAAAAAAAAAEAAACAgIAKAAAAACgAAAAoAAAAZAAAAGQAAAAAAAAAzMzMAAAAAABQAAAAUAAAAGQAAABkAAAAAAAAABcAAAAUAAAAAAAAAAAAAAD/fwAA/38AAAAAAAAJAAAABAAAAAAAAAAeAAAAaAAAAAAAAAAAAAAAAAAAAAAAAAAAAAAAECcAABAnAAAAAAAAAAAAAAAAAAAAAAAAAAAAAAAAAAAAAAAAAAAAABQAAAAAAAAAwMD/AAAAAABkAAAAMgAAAAAAAABkAAAAAAAAAH9/fwAKAAAAIgAAABgAAAAAAAAAAAAAAAAAAAAAAAAAAAAAAAAAAAAkAAAAJAAAAAAAAAAHAAAAAAAAAAAAAAAAAAAAAAAAAAAAAAAAAAAAf39/ACUAAABYAAAAAAAAAAAAAAAAAAAAAAAAAAAAAAAAAAAAAAAAAAAAAAAAAAAAAAAAAAAAAAA/AAAAAAAAAKCGAQAAAAAAAAAAAAAAAAAMAAAAAQAAAAAAAAAAAAAAAAAAAB8AAABUAAAAu+DjBf///wEAAAAAAAAAAAAAAAAAAAAAAAAAAAAAAAAAAAAAAAAAAAAAAAJ/f38AgICAA8zMzADAwP8Af39/AAAAAAAAAAAAAAAAAAAAAAAAAAAAIQAAABgAAAAUAAAAozsAAKYeAACjOwAAfCAAABAAAAAmAAAACAAAAP//////////"/>
               </a:ext>
             </a:extLst>
           </p:cNvCxnSpPr>
@@ -5375,13 +5214,13 @@
       </p:cxnSp>
       <p:cxnSp>
         <p:nvCxnSpPr>
-          <p:cNvPr id="37" name="Connector12"/>
+          <p:cNvPr id="33" name="Connector12"/>
           <p:cNvCxnSpPr>
             <a:stCxn id="2" idx="2"/>
-            <a:endCxn id="7" idx="0"/>
-            <a:extLst>
-              <a:ext uri="smNativeData">
-                <pr:smNativeData xmlns:pr="smNativeData" xmlns="smNativeData" val="SMDATA_15_ZqHWaRMAAAAlAAAADgAAAA8BAAAAkAAAAEgAAACQAAAASAAAAAAAAAAAAAAAAAAAAAEAAABQAAAA9uN+f2jSSb8AAAAAAADgPwAAAAAAAOA/AAAAAAAA4D8AAAAAAADgPwAAAAAAAOA/AAAAAAAA4D8AAAAAAADgPwAAAAAAAOA/AAAAAAAA4D8CAAAAjAAAAAAAAAAAAAAAu+DjDP///wgAAAAAAAAAAAAAAAAAAAAAAAAAAAAAAAAAAAAAZAAAAAEAAABAAAAAAAAAAAAAAAAAAAAAAAAAAAAAAAAAAAAAAAAAAAAAAAAAAAAAAAAAAAAAAAAAAAAAAAAAAAAAAAAAAAAAAAAAAAAAAAAAAAAAAAAAAAAAAAAAAAAAFAAAADwAAAABAAAAAAAAAAAAAAkUAAAAAQAAABQAAAAUAAAAFAAAAAEAAAAAAAAAZAAAAGQAAAABAAAAlgAAAJYAAAAVAAAAYAAAAAAAAAAAAAAADwAAACADAAAAAAAAAAAAAAEAAACgMgAAVgcAAKr4//8BAAAAf39/AAEAAABkAAAAAAAAABQAAABAHwAAAAAAACYAAAAAAAAAwOD//wAAAAAmAAAAZAAAABYAAABMAAAAAAAAAAAAAAAEAAAAAAAAAAEAAACAgIAKAAAAACgAAAAoAAAAZAAAAGQAAAAAAAAAzMzMAAAAAABQAAAAUAAAAGQAAABkAAAAAAAAABcAAAAUAAAAAAAAAAAAAAD/fwAA/38AAAAAAAAJAAAABAAAAAIAAAAeAAAAaAAAAAAAAAAAAAAAAAAAAAAAAAAAAAAAECcAABAnAAAAAAAAAAAAAAAAAAAAAAAAAAAAAAAAAAAAAAAAAAAAABQAAAAAAAAAwMD/AAAAAABkAAAAMgAAAAAAAABkAAAAAAAAAH9/fwAKAAAAIgAAABgAAAAAAAAAAAAAAAAAAAAAAAAAAAAAAAAAAAAkAAAAJAAAAAAAAAAHAAAAAAAAAAAAAAAAAAAAAAAAAAAAAAAAAAAAf39/ACUAAABYAAAAAAAAAAAAAAAAAAAAAAAAAAAAAAAAAAAAAAAAAAAAAAAAAAAAAAAAAAAAAAA/AAAAAAAAAKCGAQAAAAAAAAAAAAAAAAAMAAAAAQAAAAAAAAAAAAAAAAAAAB8AAABUAAAAu+DjBf///wEAAAAAAAAAAAAAAAAAAAAAAAAAAAAAAAAAAAAAAAAAAAAAAAJ/f38AgICAA8zMzADAwP8Af39/AAAAAAAAAAAAAAAAAAAAAAAAAAAAIQAAABgAAAAUAAAABCYAAPYQAAAEJgAAWxQAABAAAAAmAAAACAAAAP//////////"/>
+            <a:endCxn id="6" idx="0"/>
+            <a:extLst>
+              <a:ext uri="smNativeData">
+                <pr:smNativeData xmlns:pr="smNativeData" xmlns="smNativeData" val="SMDATA_15_MvzhaRMAAAAlAAAADgAAAA8BAAAAkAAAAEgAAACQAAAASAAAAAAAAAAAAAAAAAAAAAEAAABQAAAA9uN+f2jSSb8AAAAAAADgPwAAAAAAAOA/AAAAAAAA4D8AAAAAAADgPwAAAAAAAOA/AAAAAAAA4D8AAAAAAADgPwAAAAAAAOA/AAAAAAAA4D8CAAAAjAAAAAAAAAAAAAAAu+DjDP///wgAAAAAAAAAAAAAAAAAAAAAAAAAAAAAAAAAAAAAZAAAAAEAAABAAAAAAAAAAAAAAAAAAAAAAAAAAAAAAAAAAAAAAAAAAAAAAAAAAAAAAAAAAAAAAAAAAAAAAAAAAAAAAAAAAAAAAAAAAAAAAAAAAAAAAAAAAAAAAAAAAAAAFAAAADwAAAABAAAAAAAAAAAAAAkUAAAAAQAAABQAAAAUAAAAFAAAAAEAAAAAAAAAZAAAAGQAAAABAAAAlgAAAJYAAAAVAAAAYAAAAAAAAAAAAAAADwAAACADAAAAAAAAAAAAAAEAAACgMgAAVgcAAKr4//8BAAAAf39/AAEAAABkAAAAAAAAABQAAABAHwAAAAAAACYAAAAAAAAAwOD//wAAAAAmAAAAZAAAABYAAABMAAAAAAAAAAAAAAAEAAAAAAAAAAEAAACAgIAKAAAAACgAAAAoAAAAZAAAAGQAAAAAAAAAzMzMAAAAAABQAAAAUAAAAGQAAABkAAAAAAAAABcAAAAUAAAAAAAAAAAAAAD/fwAA/38AAAAAAAAJAAAABAAAAAIAAAAeAAAAaAAAAAAAAAAAAAAAAAAAAAAAAAAAAAAAECcAABAnAAAAAAAAAAAAAAAAAAAAAAAAAAAAAAAAAAAAAAAAAAAAABQAAAAAAAAAwMD/AAAAAABkAAAAMgAAAAAAAABkAAAAAAAAAH9/fwAKAAAAIgAAABgAAAAAAAAAAAAAAAAAAAAAAAAAAAAAAAAAAAAkAAAAJAAAAAAAAAAHAAAAAAAAAAAAAAAAAAAAAAAAAAAAAAAAAAAAf39/ACUAAABYAAAAAAAAAAAAAAAAAAAAAAAAAAAAAAAAAAAAAAAAAAAAAAAAAAAAAAAAAAAAAAA/AAAAAAAAAKCGAQAAAAAAAAAAAAAAAAAMAAAAAQAAAAAAAAAAAAAAAAAAAB8AAABUAAAAu+DjBf///wEAAAAAAAAAAAAAAAAAAAAAAAAAAAAAAAAAAAAAAAAAAAAAAAJ/f38AgICAA8zMzADAwP8Af39/AAAAAAAAAAAAAAAAAAAAAAAAAAAAIQAAABgAAAAUAAAABCYAAPYQAAAEJgAAWxQAABAAAAAmAAAACAAAAP//////////"/>
               </a:ext>
             </a:extLst>
           </p:cNvCxnSpPr>
@@ -5409,13 +5248,13 @@
       </p:cxnSp>
       <p:cxnSp>
         <p:nvCxnSpPr>
-          <p:cNvPr id="38" name="Connector13"/>
+          <p:cNvPr id="34" name="Connector13"/>
           <p:cNvCxnSpPr>
-            <a:stCxn id="7" idx="3"/>
-            <a:endCxn id="10" idx="1"/>
-            <a:extLst>
-              <a:ext uri="smNativeData">
-                <pr:smNativeData xmlns:pr="smNativeData" xmlns="smNativeData" val="SMDATA_15_ZqHWaRMAAAAlAAAADgAAAA8BAAAAkAAAAEgAAACQAAAASAAAAAAAAAAAAAAAAAAAAAEAAABQAAAAAAAAAAAAAAAAAAAAAADgPwAAAAAAAOA/AAAAAAAA4D8AAAAAAADgPwAAAAAAAOA/AAAAAAAA4D8AAAAAAADgPwAAAAAAAOA/AAAAAAAA4D8CAAAAjAAAAAAAAAAAAAAAu+DjDP///wgAAAAAAAAAAAAAAAAAAAAAAAAAAAAAAAAAAAAAZAAAAAEAAABAAAAAAAAAAAAAAAAAAAAAAAAAAAAAAAAAAAAAAAAAAAAAAAAAAAAAAAAAAAAAAAAAAAAAAAAAAAAAAAAAAAAAAAAAAAAAAAAAAAAAAAAAAAAAAAAAAAAAFAAAADwAAAABAAAAAAAAAAAAAAkUAAAAAQAAABQAAAAUAAAAFAAAAAEAAAAAAAAAZAAAAGQAAAABAAAAlgAAAJYAAAAVAAAAYAAAAAAAAAAAAAAADwAAACADAAAAAAAAAAAAAAEAAACgMgAAVgcAAKr4//8BAAAAf39/AAEAAABkAAAAAAAAABQAAABAHwAAAAAAACYAAAAAAAAAwOD//wAAAAAmAAAAZAAAABYAAABMAAAAAAAAAAAAAAAEAAAAAAAAAAEAAACAgIAKAAAAACgAAAAoAAAAZAAAAGQAAAAAAAAAzMzMAAAAAABQAAAAUAAAAGQAAABkAAAAAAAAABcAAAAUAAAAAAAAAAAAAAD/fwAA/38AAAAAAAAJAAAABAAAAAsAAAAeAAAAaAAAAAAAAAAAAAAAAAAAAAAAAAAAAAAAECcAABAnAAAAAAAAAAAAAAAAAAAAAAAAAAAAAAAAAAAAAAAAAAAAABQAAAAAAAAAwMD/AAAAAABkAAAAMgAAAAAAAABkAAAAAAAAAH9/fwAKAAAAIgAAABgAAAAAAAAAAAAAAAAAAAAAAAAAAAAAAAAAAAAkAAAAJAAAAAAAAAAHAAAAAAAAAAAAAAAAAAAAAAAAAAAAAAAAAAAAf39/ACUAAABYAAAAAAAAAAAAAAAAAAAAAAAAAAAAAAAAAAAAAAAAAAAAAAAAAAAAAAAAAAAAAAA/AAAAAAAAAKCGAQAAAAAAAAAAAAAAAAAMAAAAAQAAAAAAAAAAAAAAAAAAAB8AAABUAAAAu+DjBf///wEAAAAAAAAAAAAAAAAAAAAAAAAAAAAAAAAAAAAAAAAAAAAAAAJ/f38AgICAA8zMzADAwP8Af39/AAAAAAAAAAAAAAAAAAAAAAAAAAAAIQAAABgAAAAUAAAAGCsAABAQAACAMgAAWBYAABAAAAAmAAAACAAAAP//////////"/>
+            <a:stCxn id="6" idx="3"/>
+            <a:endCxn id="9" idx="1"/>
+            <a:extLst>
+              <a:ext uri="smNativeData">
+                <pr:smNativeData xmlns:pr="smNativeData" xmlns="smNativeData" val="SMDATA_15_MvzhaRMAAAAlAAAADgAAAA8BAAAAkAAAAEgAAACQAAAASAAAAAAAAAAAAAAAAAAAAAEAAABQAAAAAAAAAAAAAAAAAAAAAADgPwAAAAAAAOA/AAAAAAAA4D8AAAAAAADgPwAAAAAAAOA/AAAAAAAA4D8AAAAAAADgPwAAAAAAAOA/AAAAAAAA4D8CAAAAjAAAAAAAAAAAAAAAu+DjDP///wgAAAAAAAAAAAAAAAAAAAAAAAAAAAAAAAAAAAAAZAAAAAEAAABAAAAAAAAAAAAAAAAAAAAAAAAAAAAAAAAAAAAAAAAAAAAAAAAAAAAAAAAAAAAAAAAAAAAAAAAAAAAAAAAAAAAAAAAAAAAAAAAAAAAAAAAAAAAAAAAAAAAAFAAAADwAAAABAAAAAAAAAAAAAAkUAAAAAQAAABQAAAAUAAAAFAAAAAEAAAAAAAAAZAAAAGQAAAABAAAAlgAAAJYAAAAVAAAAYAAAAAAAAAAAAAAADwAAACADAAAAAAAAAAAAAAEAAACgMgAAVgcAAKr4//8BAAAAf39/AAEAAABkAAAAAAAAABQAAABAHwAAAAAAACYAAAAAAAAAwOD//wAAAAAmAAAAZAAAABYAAABMAAAAAAAAAAAAAAAEAAAAAAAAAAEAAACAgIAKAAAAACgAAAAoAAAAZAAAAGQAAAAAAAAAzMzMAAAAAABQAAAAUAAAAGQAAABkAAAAAAAAABcAAAAUAAAAAAAAAAAAAAD/fwAA/38AAAAAAAAJAAAABAAAAAsAAAAeAAAAaAAAAAAAAAAAAAAAAAAAAAAAAAAAAAAAECcAABAnAAAAAAAAAAAAAAAAAAAAAAAAAAAAAAAAAAAAAAAAAAAAABQAAAAAAAAAwMD/AAAAAABkAAAAMgAAAAAAAABkAAAAAAAAAH9/fwAKAAAAIgAAABgAAAAAAAAAAAAAAAAAAAAAAAAAAAAAAAAAAAAkAAAAJAAAAAAAAAAHAAAAAAAAAAAAAAAAAAAAAAAAAAAAAAAAAAAAf39/ACUAAABYAAAAAAAAAAAAAAAAAAAAAAAAAAAAAAAAAAAAAAAAAAAAAAAAAAAAAAAAAAAAAAA/AAAAAAAAAKCGAQAAAAAAAAAAAAAAAAAMAAAAAQAAAAAAAAAAAAAAAAAAAB8AAABUAAAAu+DjBf///wEAAAAAAAAAAAAAAAAAAAAAAAAAAAAAAAAAAAAAAAAAAAAAAAJ/f38AgICAA8zMzADAwP8Af39/AAAAAAAAAAAAAAAAAAAAAAAAAAAAIQAAABgAAAAUAAAAGCsAABAQAACAMgAAWBYAABAAAAAmAAAACAAAAP//////////"/>
               </a:ext>
             </a:extLst>
           </p:cNvCxnSpPr>
@@ -5445,13 +5284,13 @@
       </p:cxnSp>
       <p:cxnSp>
         <p:nvCxnSpPr>
-          <p:cNvPr id="39" name="Connector14"/>
+          <p:cNvPr id="35" name="Connector14"/>
           <p:cNvCxnSpPr>
-            <a:stCxn id="7" idx="3"/>
-            <a:endCxn id="8" idx="1"/>
-            <a:extLst>
-              <a:ext uri="smNativeData">
-                <pr:smNativeData xmlns:pr="smNativeData" xmlns="smNativeData" val="SMDATA_15_ZqHWaRMAAAAlAAAADgAAAA8BAAAAkAAAAEgAAACQAAAASAAAAAAAAAAAAAAAAAAAAAEAAABQAAAA+cV9/AlGQb8AAAAAAADgPwAAAAAAAOA/AAAAAAAA4D8AAAAAAADgPwAAAAAAAOA/AAAAAAAA4D8AAAAAAADgPwAAAAAAAOA/AAAAAAAA4D8CAAAAjAAAAAAAAAAAAAAAu+DjDP///wgAAAAAAAAAAAAAAAAAAAAAAAAAAAAAAAAAAAAAZAAAAAEAAABAAAAAAAAAAAAAAAAAAAAAAAAAAAAAAAAAAAAAAAAAAAAAAAAAAAAAAAAAAAAAAAAAAAAAAAAAAAAAAAAAAAAAAAAAAAAAAAAAAAAAAAAAAAAAAAAAAAAAFAAAADwAAAABAAAAAAAAAAAAAAkUAAAAAQAAABQAAAAUAAAAFAAAAAEAAAAAAAAAZAAAAGQAAAABAAAAlgAAAJYAAAAVAAAAYAAAAAAAAAAAAAAADwAAACADAAAAAAAAAAAAAAEAAACgMgAAVgcAAKr4//8BAAAAf39/AAEAAABkAAAAAAAAABQAAABAHwAAAAAAACYAAAAAAAAAwOD//wAAAAAmAAAAZAAAABYAAABMAAAAAAAAAAAAAAAEAAAAAAAAAAEAAACAgIAKAAAAACgAAAAoAAAAZAAAAGQAAAAAAAAAzMzMAAAAAABQAAAAUAAAAGQAAABkAAAAAAAAABcAAAAUAAAAAAAAAAAAAAD/fwAA/38AAAAAAAAJAAAABAAAAAAAAAAeAAAAaAAAAAAAAAAAAAAAAAAAAAAAAAAAAAAAECcAABAnAAAAAAAAAAAAAAAAAAAAAAAAAAAAAAAAAAAAAAAAAAAAABQAAAAAAAAAwMD/AAAAAABkAAAAMgAAAAAAAABkAAAAAAAAAH9/fwAKAAAAIgAAABgAAAAAAAAAAAAAAAAAAAAAAAAAAAAAAAAAAAAkAAAAJAAAAAAAAAAHAAAAAAAAAAAAAAAAAAAAAAAAAAAAAAAAAAAAf39/ACUAAABYAAAAAAAAAAAAAAAAAAAAAAAAAAAAAAAAAAAAAAAAAAAAAAAAAAAAAAAAAAAAAAA/AAAAAAAAAKCGAQAAAAAAAAAAAAAAAAAMAAAAAQAAAAAAAAAAAAAAAAAAAB8AAABUAAAAu+DjBf///wEAAAAAAAAAAAAAAAAAAAAAAAAAAAAAAAAAAAAAAAAAAAAAAAJ/f38AgICAA8zMzADAwP8Af39/AAAAAAAAAAAAAAAAAAAAAAAAAAAAIQAAABgAAAAUAAAAGCsAAHEJAACBMgAAWBYAABAAAAAmAAAACAAAAP//////////"/>
+            <a:stCxn id="6" idx="3"/>
+            <a:endCxn id="7" idx="1"/>
+            <a:extLst>
+              <a:ext uri="smNativeData">
+                <pr:smNativeData xmlns:pr="smNativeData" xmlns="smNativeData" val="SMDATA_15_MvzhaRMAAAAlAAAADgAAAA8BAAAAkAAAAEgAAACQAAAASAAAAAAAAAAAAAAAAAAAAAEAAABQAAAA+cV9/AlGQb8AAAAAAADgPwAAAAAAAOA/AAAAAAAA4D8AAAAAAADgPwAAAAAAAOA/AAAAAAAA4D8AAAAAAADgPwAAAAAAAOA/AAAAAAAA4D8CAAAAjAAAAAAAAAAAAAAAu+DjDP///wgAAAAAAAAAAAAAAAAAAAAAAAAAAAAAAAAAAAAAZAAAAAEAAABAAAAAAAAAAAAAAAAAAAAAAAAAAAAAAAAAAAAAAAAAAAAAAAAAAAAAAAAAAAAAAAAAAAAAAAAAAAAAAAAAAAAAAAAAAAAAAAAAAAAAAAAAAAAAAAAAAAAAFAAAADwAAAABAAAAAAAAAAAAAAkUAAAAAQAAABQAAAAUAAAAFAAAAAEAAAAAAAAAZAAAAGQAAAABAAAAlgAAAJYAAAAVAAAAYAAAAAAAAAAAAAAADwAAACADAAAAAAAAAAAAAAEAAACgMgAAVgcAAKr4//8BAAAAf39/AAEAAABkAAAAAAAAABQAAABAHwAAAAAAACYAAAAAAAAAwOD//wAAAAAmAAAAZAAAABYAAABMAAAAAAAAAAAAAAAEAAAAAAAAAAEAAACAgIAKAAAAACgAAAAoAAAAZAAAAGQAAAAAAAAAzMzMAAAAAABQAAAAUAAAAGQAAABkAAAAAAAAABcAAAAUAAAAAAAAAAAAAAD/fwAA/38AAAAAAAAJAAAABAAAAAAAAAAeAAAAaAAAAAAAAAAAAAAAAAAAAAAAAAAAAAAAECcAABAnAAAAAAAAAAAAAAAAAAAAAAAAAAAAAAAAAAAAAAAAAAAAABQAAAAAAAAAwMD/AAAAAABkAAAAMgAAAAAAAABkAAAAAAAAAH9/fwAKAAAAIgAAABgAAAAAAAAAAAAAAAAAAAAAAAAAAAAAAAAAAAAkAAAAJAAAAAAAAAAHAAAAAAAAAAAAAAAAAAAAAAAAAAAAAAAAAAAAf39/ACUAAABYAAAAAAAAAAAAAAAAAAAAAAAAAAAAAAAAAAAAAAAAAAAAAAAAAAAAAAAAAAAAAAA/AAAAAAAAAKCGAQAAAAAAAAAAAAAAAAAMAAAAAQAAAAAAAAAAAAAAAAAAAB8AAABUAAAAu+DjBf///wEAAAAAAAAAAAAAAAAAAAAAAAAAAAAAAAAAAAAAAAAAAAAAAAJ/f38AgICAA8zMzADAwP8Af39/AAAAAAAAAAAAAAAAAAAAAAAAAAAAIQAAABgAAAAUAAAAGCsAAHEJAACBMgAAWBYAABAAAAAmAAAACAAAAP//////////"/>
               </a:ext>
             </a:extLst>
           </p:cNvCxnSpPr>
@@ -5481,13 +5320,13 @@
       </p:cxnSp>
       <p:cxnSp>
         <p:nvCxnSpPr>
-          <p:cNvPr id="40" name="Connector15"/>
+          <p:cNvPr id="36" name="Connector15"/>
           <p:cNvCxnSpPr>
-            <a:stCxn id="8" idx="0"/>
-            <a:endCxn id="9" idx="2"/>
-            <a:extLst>
-              <a:ext uri="smNativeData">
-                <pr:smNativeData xmlns:pr="smNativeData" xmlns="smNativeData" val="SMDATA_15_ZqHWaRMAAAAlAAAADgAAAA8BAAAAkAAAAEgAAACQAAAASAAAAAAAAAAAAAAAAAAAAAEAAABQAAAAk5SHCfa4Wz8AAAAAAADgPwAAAAAAAOA/AAAAAAAA4D8AAAAAAADgPwAAAAAAAOA/AAAAAAAA4D8AAAAAAADgPwAAAAAAAOA/AAAAAAAA4D8CAAAAjAAAAAAAAAAAAAAAu+DjDP///wgAAAAAAAAAAAAAAAAAAAAAAAAAAAAAAAAAAAAAZAAAAAEAAABAAAAAAAAAAAAAAAAAAAAAAAAAAAAAAAAAAAAAAAAAAAAAAAAAAAAAAAAAAAAAAAAAAAAAAAAAAAAAAAAAAAAAAAAAAAAAAAAAAAAAAAAAAAAAAAAAAAAAFAAAADwAAAABAAAAAAAAAAAAAAkUAAAAAQAAABQAAAAUAAAAFAAAAAEAAAAAAAAAZAAAAGQAAAABAAAAlgAAAJYAAAAVAAAAYAAAAAAAAAAAAAAADwAAACADAAAAAAAAAAAAAAEAAACgMgAAVgcAAKr4//8BAAAAf39/AAEAAABkAAAAAAAAABQAAABAHwAAAAAAACYAAAAAAAAAwOD//wAAAAAmAAAAZAAAABYAAABMAAAAAAAAAAAAAAAEAAAAAAAAAAEAAACAgIAKAAAAACgAAAAoAAAAZAAAAGQAAAAAAAAAzMzMAAAAAABQAAAAUAAAAGQAAABkAAAAAAAAABcAAAAUAAAAAAAAAAAAAAD/fwAA/38AAAAAAAAJAAAABAAAAAAAAAAeAAAAaAAAAAAAAAAAAAAAAAAAAAAAAAAAAAAAECcAABAnAAAAAAAAAAAAAAAAAAAAAAAAAAAAAAAAAAAAAAAAAAAAABQAAAAAAAAAwMD/AAAAAABkAAAAMgAAAAAAAABkAAAAAAAAAH9/fwAKAAAAIgAAABgAAAAAAAAAAAAAAAAAAAAAAAAAAAAAAAAAAAAkAAAAJAAAAAAAAAAHAAAAAAAAAAAAAAAAAAAAAAAAAAAAAAAAAAAAf39/ACUAAABYAAAAAAAAAAAAAAAAAAAAAAAAAAAAAAAAAAAAAAAAAAAAAAAAAAAAAAAAAAAAAAA/AAAAAAAAAKCGAQAAAAAAAAAAAAAAAAAMAAAAAQAAAAAAAAAAAAAAAAAAAB8AAABUAAAAu+DjBf///wEAAAAAAAAAAAAAAAAAAAAAAAAAAAAAAAAAAAAAAAAAAAAAAAJ/f38AgICAA8zMzADAwP8Af39/AAAAAAAAAAAAAAAAAAAAAAAAAAAAIQAAABgAAAAUAAAAsTYAAJYFAACzNgAA5QcAABAAAAAmAAAACAAAAP//////////"/>
+            <a:stCxn id="7" idx="0"/>
+            <a:endCxn id="8" idx="2"/>
+            <a:extLst>
+              <a:ext uri="smNativeData">
+                <pr:smNativeData xmlns:pr="smNativeData" xmlns="smNativeData" val="SMDATA_15_MvzhaRMAAAAlAAAADgAAAA8BAAAAkAAAAEgAAACQAAAASAAAAAAAAAAAAAAAAAAAAAEAAABQAAAAk5SHCfa4Wz8AAAAAAADgPwAAAAAAAOA/AAAAAAAA4D8AAAAAAADgPwAAAAAAAOA/AAAAAAAA4D8AAAAAAADgPwAAAAAAAOA/AAAAAAAA4D8CAAAAjAAAAAAAAAAAAAAAu+DjDP///wgAAAAAAAAAAAAAAAAAAAAAAAAAAAAAAAAAAAAAZAAAAAEAAABAAAAAAAAAAAAAAAAAAAAAAAAAAAAAAAAAAAAAAAAAAAAAAAAAAAAAAAAAAAAAAAAAAAAAAAAAAAAAAAAAAAAAAAAAAAAAAAAAAAAAAAAAAAAAAAAAAAAAFAAAADwAAAABAAAAAAAAAAAAAAkUAAAAAQAAABQAAAAUAAAAFAAAAAEAAAAAAAAAZAAAAGQAAAABAAAAlgAAAJYAAAAVAAAAYAAAAAAAAAAAAAAADwAAACADAAAAAAAAAAAAAAEAAACgMgAAVgcAAKr4//8BAAAAf39/AAEAAABkAAAAAAAAABQAAABAHwAAAAAAACYAAAAAAAAAwOD//wAAAAAmAAAAZAAAABYAAABMAAAAAAAAAAAAAAAEAAAAAAAAAAEAAACAgIAKAAAAACgAAAAoAAAAZAAAAGQAAAAAAAAAzMzMAAAAAABQAAAAUAAAAGQAAABkAAAAAAAAABcAAAAUAAAAAAAAAAAAAAD/fwAA/38AAAAAAAAJAAAABAAAAAAAAAAeAAAAaAAAAAAAAAAAAAAAAAAAAAAAAAAAAAAAECcAABAnAAAAAAAAAAAAAAAAAAAAAAAAAAAAAAAAAAAAAAAAAAAAABQAAAAAAAAAwMD/AAAAAABkAAAAMgAAAAAAAABkAAAAAAAAAH9/fwAKAAAAIgAAABgAAAAAAAAAAAAAAAAAAAAAAAAAAAAAAAAAAAAkAAAAJAAAAAAAAAAHAAAAAAAAAAAAAAAAAAAAAAAAAAAAAAAAAAAAf39/ACUAAABYAAAAAAAAAAAAAAAAAAAAAAAAAAAAAAAAAAAAAAAAAAAAAAAAAAAAAAAAAAAAAAA/AAAAAAAAAKCGAQAAAAAAAAAAAAAAAAAMAAAAAQAAAAAAAAAAAAAAAAAAAB8AAABUAAAAu+DjBf///wEAAAAAAAAAAAAAAAAAAAAAAAAAAAAAAAAAAAAAAAAAAAAAAAJ/f38AgICAA8zMzADAwP8Af39/AAAAAAAAAAAAAAAAAAAAAAAAAAAAIQAAABgAAAAUAAAAsTYAAJYFAACzNgAA5QcAABAAAAAmAAAACAAAAP//////////"/>
               </a:ext>
             </a:extLst>
           </p:cNvCxnSpPr>
@@ -5517,49 +5356,13 @@
       </p:cxnSp>
       <p:cxnSp>
         <p:nvCxnSpPr>
-          <p:cNvPr id="41" name="Connector16"/>
-          <p:cNvCxnSpPr>
-            <a:stCxn id="2" idx="0"/>
-            <a:endCxn id="6" idx="2"/>
-            <a:extLst>
-              <a:ext uri="smNativeData">
-                <pr:smNativeData xmlns:pr="smNativeData" xmlns="smNativeData" val="SMDATA_15_ZqHWaRMAAAAlAAAADgAAAA8BAAAAkAAAAEgAAACQAAAASAAAAAAAAAAAAAAAAAAAAAEAAABQAAAAhLEZLP23+7sAAAAAAADgPwAAAAAAAOA/AAAAAAAA4D8AAAAAAADgPwAAAAAAAOA/AAAAAAAA4D8AAAAAAADgPwAAAAAAAOA/AAAAAAAA4D8CAAAAjAAAAAAAAAAAAAAAu+DjDP///wgAAAAAAAAAAAAAAAAAAAAAAAAAAAAAAAAAAAAAZAAAAAEAAABAAAAAAAAAAAAAAAAAAAAAAAAAAAAAAAAAAAAAAAAAAAAAAAAAAAAAAAAAAAAAAAAAAAAAAAAAAAAAAAAAAAAAAAAAAAAAAAAAAAAAAAAAAAAAAAAAAAAAFAAAADwAAAABAAAAAAAAAAAAAAkUAAAAAQAAABQAAAAUAAAAFAAAAAEAAAAAAAAAZAAAAGQAAAABAAAAlgAAAJYAAAAVAAAAYAAAAAAAAAAAAAAADwAAACADAAAAAAAAAAAAAAEAAACgMgAAVgcAAKr4//8BAAAAf39/AAEAAABkAAAAAAAAABQAAABAHwAAAAAAACYAAAAAAAAAwOD//wAAAAAmAAAAZAAAABYAAABMAAAAAAAAAAAAAAAEAAAAAAAAAAEAAACAgIAKAAAAACgAAAAoAAAAZAAAAGQAAAAAAAAAzMzMAAAAAABQAAAAUAAAAGQAAABkAAAAAAAAABcAAAAUAAAAAAAAAAAAAAD/fwAA/38AAAAAAAAJAAAABAAAAJYAAAAeAAAAaAAAAAAAAAAAAAAAAAAAAAAAAAAAAAAAECcAABAnAAAAAAAAAAAAAAAAAAAAAAAAAAAAAAAAAAAAAAAAAAAAABQAAAAAAAAAwMD/AAAAAABkAAAAMgAAAAAAAABkAAAAAAAAAH9/fwAKAAAAIgAAABgAAAAAAAAAAAAAAAAAAAAAAAAAAAAAAAAAAAAkAAAAJAAAAAAAAAAHAAAAAAAAAAAAAAAAAAAAAAAAAAAAAAAAAAAAf39/ACUAAABYAAAAAAAAAAAAAAAAAAAAAAAAAAAAAAAAAAAAAAAAAAAAAAAAAAAAAAAAAAAAAAA/AAAAAAAAAKCGAQAAAAAAAAAAAAAAAAAMAAAAAQAAAAAAAAAAAAAAAAAAAB8AAABUAAAAu+DjBf///wEAAAAAAAAAAAAAAAAAAAAAAAAAAAAAAAAAAAAAAAAAAAAAAAJ/f38AgICAA8zMzADAwP8Af39/AAAAAAAAAAAAAAAAAAAAAAAAAAAAIQAAABgAAAAUAAAABCYAAHEKAAAGJgAA/QwAABAAAAAmAAAACAAAAP//////////"/>
-              </a:ext>
-            </a:extLst>
-          </p:cNvCxnSpPr>
-          <p:nvPr/>
-        </p:nvCxnSpPr>
-        <p:spPr>
-          <a:xfrm rot="16200000">
-            <a:off x="5973445" y="1903730"/>
-            <a:ext cx="414020" cy="1270"/>
-          </a:xfrm>
-          <a:prstGeom prst="bentConnector3">
-            <a:avLst>
-              <a:gd name="adj1" fmla="val 50000"/>
-            </a:avLst>
-          </a:prstGeom>
-          <a:noFill/>
-          <a:ln w="12700" cap="flat" cmpd="sng" algn="ctr">
-            <a:solidFill>
-              <a:schemeClr val="tx1"/>
-            </a:solidFill>
-            <a:prstDash val="solid"/>
-            <a:headEnd type="none"/>
-            <a:tailEnd type="stealth" w="lg" len="lg"/>
-          </a:ln>
-          <a:effectLst/>
-        </p:spPr>
-      </p:cxnSp>
-      <p:cxnSp>
-        <p:nvCxnSpPr>
-          <p:cNvPr id="42" name="Connector23"/>
+          <p:cNvPr id="37" name="Connector23"/>
           <p:cNvCxnSpPr>
             <a:stCxn id="3" idx="0"/>
             <a:endCxn id="4" idx="3"/>
             <a:extLst>
               <a:ext uri="smNativeData">
-                <pr:smNativeData xmlns:pr="smNativeData" xmlns="smNativeData" val="SMDATA_15_ZqHWaRMAAAAlAAAADwAAAA8BAAAAkAAAAEgAAACQAAAASAAAAAAAAAAAAAAAAAAAAAEAAABQAAAAXqfsgsWR3L8rL7VBsjQCQAAAAAAAAOA/AAAAAAAA4D8AAAAAAADgPwAAAAAAAOA/AAAAAAAA4D8AAAAAAADgPwAAAAAAAOA/AAAAAAAA4D8CAAAAjAAAAAAAAAAAAAAAu+DjDP///wgAAAAAAAAAAAAAAAAAAAAAAAAAAAAAAAAAAAAAZAAAAAEAAABAAAAAAAAAAAAAAAAAAAAAAAAAAAAAAAAAAAAAAAAAAAAAAAAAAAAAAAAAAAAAAAAAAAAAAAAAAAAAAAAAAAAAAAAAAAAAAAAAAAAAAAAAAAAAAAAAAAAAFAAAADwAAAABAAAAAgAAAAAAAAkUAAAAAQAAABQAAAAUAAAAFAAAAAEAAAAAAAAAZAAAAGQAAAABAAAAlgAAAJYAAAAVAAAAYAAAAAAAAAAAAAAADwAAACADAAAAAAAAAAAAAAEAAACgMgAAVgcAAKr4//8BAAAAf39/AAEAAABkAAAAAAAAABQAAABAHwAAAAAAACYAAAAAAAAAwOD//wAAAAAmAAAAZAAAABYAAABMAAAAAAAAAAAAAAAEAAAAAAAAAAEAAACAgIAKAAAAACgAAAAoAAAAZAAAAGQAAAAAAAAAzMzMAAAAAABQAAAAUAAAAGQAAABkAAAAAAAAABcAAAAUAAAAAAAAAAAAAAD/fwAA/38AAAAAAAAJAAAABAAAAAsAAAAeAAAAaAAAAAAAAAAAAAAAAAAAAAAAAAAAAAAAECcAABAnAAAAAAAAAAAAAAAAAAAAAAAAAAAAAAAAAAAAAAAAAAAAABQAAAAAAAAAwMD/AAAAAABkAAAAMgAAAAAAAABkAAAAAAAAAH9/fwAKAAAAIgAAABgAAAAAAAAAAAAAAAAAAAAAAAAAAAAAAAAAAAAkAAAAJAAAAAAAAAAHAAAAAAAAAAAAAAAAAAAAAAAAAAAAAAAAAAAAf39/ACUAAABYAAAAAAAAAAAAAAAAAAAAAAAAAAAAAAAAAAAAAAAAAAAAAAAAAAAAAAAAAAAAAAA/AAAAAAAAAKCGAQAAAAAAAAAAAAAAAAAMAAAAAQAAAAAAAAAAAAAAAAAAAB8AAABUAAAAu+DjBf///wEAAAAAAAAAAAAAAAAAAAAAAAAAAAAAAAAAAAAAAAAAAAAAAAJ/f38AgICAA8zMzADAwP8Af39/AAAAAAAAAAAAAAAAAAAAAAAAAAAAIQAAABgAAAAUAAAAVhgAAI8IAABpGwAAAQ0AABAAAAAmAAAACAAAAP//////////"/>
+                <pr:smNativeData xmlns:pr="smNativeData" xmlns="smNativeData" val="SMDATA_15_MvzhaRMAAAAlAAAADwAAAA8BAAAAkAAAAEgAAACQAAAASAAAAAAAAAAAAAAAAAAAAAEAAABQAAAAXqfsgsWR3L8rL7VBsjQCQAAAAAAAAOA/AAAAAAAA4D8AAAAAAADgPwAAAAAAAOA/AAAAAAAA4D8AAAAAAADgPwAAAAAAAOA/AAAAAAAA4D8CAAAAjAAAAAAAAAAAAAAAu+DjDP///wgAAAAAAAAAAAAAAAAAAAAAAAAAAAAAAAAAAAAAZAAAAAEAAABAAAAAAAAAAAAAAAAAAAAAAAAAAAAAAAAAAAAAAAAAAAAAAAAAAAAAAAAAAAAAAAAAAAAAAAAAAAAAAAAAAAAAAAAAAAAAAAAAAAAAAAAAAAAAAAAAAAAAFAAAADwAAAABAAAAAgAAAAAAAAkUAAAAAQAAABQAAAAUAAAAFAAAAAEAAAAAAAAAZAAAAGQAAAABAAAAlgAAAJYAAAAVAAAAYAAAAAAAAAAAAAAADwAAACADAAAAAAAAAAAAAAEAAACgMgAAVgcAAKr4//8BAAAAf39/AAEAAABkAAAAAAAAABQAAABAHwAAAAAAACYAAAAAAAAAwOD//wAAAAAmAAAAZAAAABYAAABMAAAAAAAAAAAAAAAEAAAAAAAAAAEAAACAgIAKAAAAACgAAAAoAAAAZAAAAGQAAAAAAAAAzMzMAAAAAABQAAAAUAAAAGQAAABkAAAAAAAAABcAAAAUAAAAAAAAAAAAAAD/fwAA/38AAAAAAAAJAAAABAAAAAsAAAAeAAAAaAAAAAAAAAAAAAAAAAAAAAAAAAAAAAAAECcAABAnAAAAAAAAAAAAAAAAAAAAAAAAAAAAAAAAAAAAAAAAAAAAABQAAAAAAAAAwMD/AAAAAABkAAAAMgAAAAAAAABkAAAAAAAAAH9/fwAKAAAAIgAAABgAAAAAAAAAAAAAAAAAAAAAAAAAAAAAAAAAAAAkAAAAJAAAAAAAAAAHAAAAAAAAAAAAAAAAAAAAAAAAAAAAAAAAAAAAf39/ACUAAABYAAAAAAAAAAAAAAAAAAAAAAAAAAAAAAAAAAAAAAAAAAAAAAAAAAAAAAAAAAAAAAA/AAAAAAAAAKCGAQAAAAAAAAAAAAAAAAAMAAAAAQAAAAAAAAAAAAAAAAAAAB8AAABUAAAAu+DjBf///wEAAAAAAAAAAAAAAAAAAAAAAAAAAAAAAAAAAAAAAAAAAAAAAAJ/f38AgICAA8zMzADAwP8Af39/AAAAAAAAAAAAAAAAAAAAAAAAAAAAIQAAABgAAAAUAAAAVhgAAI8IAABpGwAAAQ0AABAAAAAmAAAACAAAAP//////////"/>
               </a:ext>
             </a:extLst>
           </p:cNvCxnSpPr>
@@ -5590,13 +5393,13 @@
       </p:cxnSp>
       <p:cxnSp>
         <p:nvCxnSpPr>
-          <p:cNvPr id="43" name="Connector22"/>
+          <p:cNvPr id="38" name="Connector22"/>
           <p:cNvCxnSpPr>
             <a:stCxn id="2" idx="2"/>
-            <a:endCxn id="16" idx="3"/>
-            <a:extLst>
-              <a:ext uri="smNativeData">
-                <pr:smNativeData xmlns:pr="smNativeData" xmlns="smNativeData" val="SMDATA_15_ZqHWaRMAAAAlAAAADwAAAA8BAAAAkAAAAEgAAACQAAAASAAAAAAAAAAAAAAAAAAAAAEAAABQAAAAbeCGQwi05r9vsApdqUj3PwAAAAAAAOA/AAAAAAAA4D8AAAAAAADgPwAAAAAAAOA/AAAAAAAA4D8AAAAAAADgPwAAAAAAAOA/AAAAAAAA4D8CAAAAjAAAAAAAAAAAAAAAu+DjDP///wgAAAAAAAAAAAAAAAAAAAAAAAAAAAAAAAAAAAAAZAAAAAEAAABAAAAAAAAAAAAAAAAAAAAAAAAAAAAAAAAAAAAAAAAAAAAAAAAAAAAAAAAAAAAAAAAAAAAAAAAAAAAAAAAAAAAAAAAAAAAAAAAAAAAAAAAAAAAAAAAAAAAAFAAAADwAAAABAAAAAgAAAAAAAAkUAAAAAQAAABQAAAAUAAAAFAAAAAEAAAAAAAAAZAAAAGQAAAABAAAAlgAAAJYAAAAVAAAAYAAAAAAAAAAAAAAADwAAACADAAAAAAAAAAAAAAEAAACgMgAAVgcAAKr4//8BAAAAf39/AAEAAABkAAAAAAAAABQAAABAHwAAAAAAACYAAAAAAAAAwOD//wAAAAAmAAAAZAAAABYAAABMAAAAAAAAAAAAAAAEAAAAAAAAAAEAAACAgIAKAAAAACgAAAAoAAAAZAAAAGQAAAAAAAAAzMzMAAAAAABQAAAAUAAAAGQAAABkAAAAAAAAABcAAAAUAAAAAAAAAAAAAAD/fwAA/38AAAAAAAAJAAAABAAAAAAAAAAeAAAAaAAAAAAAAAAAAAAAAAAAAAAAAAAAAAAAECcAABAnAAAAAAAAAAAAAAAAAAAAAAAAAAAAAAAAAAAAAAAAAAAAABQAAAAAAAAAwMD/AAAAAABkAAAAMgAAAAAAAABkAAAAAAAAAH9/fwAKAAAAIgAAABgAAAAAAAAAAAAAAAAAAAAAAAAAAAAAAAAAAAAkAAAAJAAAAAAAAAAHAAAAAAAAAAAAAAAAAAAAAAAAAAAAAAAAAAAAf39/ACUAAABYAAAAAAAAAAAAAAAAAAAAAAAAAAAAAAAAAAAAAAAAAAAAAAAAAAAAAAAAAAAAAAA/AAAAAAAAAKCGAQAAAAAAAAAAAAAAAAAMAAAAAQAAAAAAAAAAAAAAAAAAAB8AAABUAAAAu+DjBf///wEAAAAAAAAAAAAAAAAAAAAAAAAAAAAAAAAAAAAAAAAAAAAAAAJ/f38AgICAA8zMzADAwP8Af39/AAAAAAAAAAAAAAAAAAAAAAAAAAAAIQAAABgAAAAUAAAABSYAAPYQAAAQPgAA5yEAABAAAAAmAAAACAAAAP//////////"/>
+            <a:endCxn id="15" idx="3"/>
+            <a:extLst>
+              <a:ext uri="smNativeData">
+                <pr:smNativeData xmlns:pr="smNativeData" xmlns="smNativeData" val="SMDATA_15_MvzhaRMAAAAlAAAADwAAAA8BAAAAkAAAAEgAAACQAAAASAAAAAAAAAAAAAAAAAAAAAEAAABQAAAAbeCGQwi05r9vsApdqUj3PwAAAAAAAOA/AAAAAAAA4D8AAAAAAADgPwAAAAAAAOA/AAAAAAAA4D8AAAAAAADgPwAAAAAAAOA/AAAAAAAA4D8CAAAAjAAAAAAAAAAAAAAAu+DjDP///wgAAAAAAAAAAAAAAAAAAAAAAAAAAAAAAAAAAAAAZAAAAAEAAABAAAAAAAAAAAAAAAAAAAAAAAAAAAAAAAAAAAAAAAAAAAAAAAAAAAAAAAAAAAAAAAAAAAAAAAAAAAAAAAAAAAAAAAAAAAAAAAAAAAAAAAAAAAAAAAAAAAAAFAAAADwAAAABAAAAAgAAAAAAAAkUAAAAAQAAABQAAAAUAAAAFAAAAAEAAAAAAAAAZAAAAGQAAAABAAAAlgAAAJYAAAAVAAAAYAAAAAAAAAAAAAAADwAAACADAAAAAAAAAAAAAAEAAACgMgAAVgcAAKr4//8BAAAAf39/AAEAAABkAAAAAAAAABQAAABAHwAAAAAAACYAAAAAAAAAwOD//wAAAAAmAAAAZAAAABYAAABMAAAAAAAAAAAAAAAEAAAAAAAAAAEAAACAgIAKAAAAACgAAAAoAAAAZAAAAGQAAAAAAAAAzMzMAAAAAABQAAAAUAAAAGQAAABkAAAAAAAAABcAAAAUAAAAAAAAAAAAAAD/fwAA/38AAAAAAAAJAAAABAAAAAAAAAAeAAAAaAAAAAAAAAAAAAAAAAAAAAAAAAAAAAAAECcAABAnAAAAAAAAAAAAAAAAAAAAAAAAAAAAAAAAAAAAAAAAAAAAABQAAAAAAAAAwMD/AAAAAABkAAAAMgAAAAAAAABkAAAAAAAAAH9/fwAKAAAAIgAAABgAAAAAAAAAAAAAAAAAAAAAAAAAAAAAAAAAAAAkAAAAJAAAAAAAAAAHAAAAAAAAAAAAAAAAAAAAAAAAAAAAAAAAAAAAf39/ACUAAABYAAAAAAAAAAAAAAAAAAAAAAAAAAAAAAAAAAAAAAAAAAAAAAAAAAAAAAAAAAAAAAA/AAAAAAAAAKCGAQAAAAAAAAAAAAAAAAAMAAAAAQAAAAAAAAAAAAAAAAAAAB8AAABUAAAAu+DjBf///wEAAAAAAAAAAAAAAAAAAAAAAAAAAAAAAAAAAAAAAAAAAAAAAAJ/f38AgICAA8zMzADAwP8Af39/AAAAAAAAAAAAAAAAAAAAAAAAAAAAIQAAABgAAAAUAAAABCYAAPYQAAAQPgAA5yEAABAAAAAmAAAACAAAAP//////////"/>
               </a:ext>
             </a:extLst>
           </p:cNvCxnSpPr>
@@ -5604,8 +5407,8 @@
         </p:nvCxnSpPr>
         <p:spPr>
           <a:xfrm rot="16200000" flipH="1">
-            <a:off x="6757670" y="2179955"/>
-            <a:ext cx="2753995" cy="3908425"/>
+            <a:off x="6757035" y="2179955"/>
+            <a:ext cx="2753995" cy="3909060"/>
           </a:xfrm>
           <a:prstGeom prst="curvedConnector4">
             <a:avLst>
@@ -5627,13 +5430,13 @@
       </p:cxnSp>
       <p:cxnSp>
         <p:nvCxnSpPr>
-          <p:cNvPr id="44" name="Connector20"/>
+          <p:cNvPr id="39" name="Connector20"/>
           <p:cNvCxnSpPr>
             <a:stCxn id="2" idx="2"/>
-            <a:endCxn id="19" idx="1"/>
-            <a:extLst>
-              <a:ext uri="smNativeData">
-                <pr:smNativeData xmlns:pr="smNativeData" xmlns="smNativeData" val="SMDATA_15_ZqHWaRMAAAAlAAAADwAAAA8BAAAAkAAAAEgAAACQAAAASAAAAAAAAAAAAAAAAAAAAAEAAABQAAAA4m9TjBr+5L+ev8Vpzfb5PwAAAAAAAOA/AAAAAAAA4D8AAAAAAADgPwAAAAAAAOA/AAAAAAAA4D8AAAAAAADgPwAAAAAAAOA/AAAAAAAA4D8CAAAAjAAAAAAAAAAAAAAAu+DjDP///wgAAAAAAAAAAAAAAAAAAAAAAAAAAAAAAAAAAAAAZAAAAAEAAABAAAAAAAAAAAAAAAAAAAAAAAAAAAAAAAAAAAAAAAAAAAAAAAAAAAAAAAAAAAAAAAAAAAAAAAAAAAAAAAAAAAAAAAAAAAAAAAAAAAAAAAAAAAAAAAAAAAAAFAAAADwAAAABAAAAAgAAAAAAAAkUAAAAAQAAABQAAAAUAAAAFAAAAAEAAAAAAAAAZAAAAGQAAAABAAAAlgAAAJYAAAAVAAAAYAAAAAAAAAAAAAAADwAAACADAAAAAAAAAAAAAAEAAACgMgAAVgcAAKr4//8BAAAAf39/AAEAAABkAAAAAAAAABQAAABAHwAAAAAAACYAAAAAAAAAwOD//wAAAAAmAAAAZAAAABYAAABMAAAAAAAAAAAAAAAEAAAAAAAAAAEAAACAgIAKAAAAACgAAAAoAAAAZAAAAGQAAAAAAAAAzMzMAAAAAABQAAAAUAAAAGQAAABkAAAAAAAAABcAAAAUAAAAAAAAAAAAAAD/fwAA/38AAAAAAAAJAAAABAAAAAAAAAAeAAAAaAAAAAAAAAAAAAAAAAAAAAAAAAAAAAAAECcAABAnAAAAAAAAAAAAAAAAAAAAAAAAAAAAAAAAAAAAAAAAAAAAABQAAAAAAAAAwMD/AAAAAABkAAAAMgAAAAAAAABkAAAAAAAAAH9/fwAKAAAAIgAAABgAAAAAAAAAAAAAAAAAAAAAAAAAAAAAAAAAAAAkAAAAJAAAAAAAAAAHAAAAAAAAAAAAAAAAAAAAAAAAAAAAAAAAAAAAf39/ACUAAABYAAAAAAAAAAAAAAAAAAAAAAAAAAAAAAAAAAAAAAAAAAAAAAAAAAAAAAAAAAAAAAA/AAAAAAAAAKCGAQAAAAAAAAAAAAAAAAAMAAAAAQAAAAAAAAAAAAAAAAAAAB8AAABUAAAAu+DjBf///wEAAAAAAAAAAAAAAAAAAAAAAAAAAAAAAAAAAAAAAAAAAAAAAAJ/f38AgICAA8zMzADAwP8Af39/AAAAAAAAAAAAAAAAAAAAAAAAAAAAIQAAABgAAAAUAAAA4xwAAPYQAAAEJgAA1iEAABAAAAAmAAAACAAAAP//////////"/>
+            <a:endCxn id="18" idx="1"/>
+            <a:extLst>
+              <a:ext uri="smNativeData">
+                <pr:smNativeData xmlns:pr="smNativeData" xmlns="smNativeData" val="SMDATA_15_MvzhaRMAAAAlAAAADwAAAA8BAAAAkAAAAEgAAACQAAAASAAAAAAAAAAAAAAAAAAAAAEAAABQAAAA4m9TjBr+5L+ev8Vpzfb5PwAAAAAAAOA/AAAAAAAA4D8AAAAAAADgPwAAAAAAAOA/AAAAAAAA4D8AAAAAAADgPwAAAAAAAOA/AAAAAAAA4D8CAAAAjAAAAAAAAAAAAAAAu+DjDP///wgAAAAAAAAAAAAAAAAAAAAAAAAAAAAAAAAAAAAAZAAAAAEAAABAAAAAAAAAAAAAAAAAAAAAAAAAAAAAAAAAAAAAAAAAAAAAAAAAAAAAAAAAAAAAAAAAAAAAAAAAAAAAAAAAAAAAAAAAAAAAAAAAAAAAAAAAAAAAAAAAAAAAFAAAADwAAAABAAAAAgAAAAAAAAkUAAAAAQAAABQAAAAUAAAAFAAAAAEAAAAAAAAAZAAAAGQAAAABAAAAlgAAAJYAAAAVAAAAYAAAAAAAAAAAAAAADwAAACADAAAAAAAAAAAAAAEAAACgMgAAVgcAAKr4//8BAAAAf39/AAEAAABkAAAAAAAAABQAAABAHwAAAAAAACYAAAAAAAAAwOD//wAAAAAmAAAAZAAAABYAAABMAAAAAAAAAAAAAAAEAAAAAAAAAAEAAACAgIAKAAAAACgAAAAoAAAAZAAAAGQAAAAAAAAAzMzMAAAAAABQAAAAUAAAAGQAAABkAAAAAAAAABcAAAAUAAAAAAAAAAAAAAD/fwAA/38AAAAAAAAJAAAABAAAAAAAAAAeAAAAaAAAAAAAAAAAAAAAAAAAAAAAAAAAAAAAECcAABAnAAAAAAAAAAAAAAAAAAAAAAAAAAAAAAAAAAAAAAAAAAAAABQAAAAAAAAAwMD/AAAAAABkAAAAMgAAAAAAAABkAAAAAAAAAH9/fwAKAAAAIgAAABgAAAAAAAAAAAAAAAAAAAAAAAAAAAAAAAAAAAAkAAAAJAAAAAAAAAAHAAAAAAAAAAAAAAAAAAAAAAAAAAAAAAAAAAAAf39/ACUAAABYAAAAAAAAAAAAAAAAAAAAAAAAAAAAAAAAAAAAAAAAAAAAAAAAAAAAAAAAAAAAAAA/AAAAAAAAAKCGAQAAAAAAAAAAAAAAAAAMAAAAAQAAAAAAAAAAAAAAAAAAAB8AAABUAAAAu+DjBf///wEAAAAAAAAAAAAAAAAAAAAAAAAAAAAAAAAAAAAAAAAAAAAAAAJ/f38AgICAA8zMzADAwP8Af39/AAAAAAAAAAAAAAAAAAAAAAAAAAAAIQAAABgAAAAUAAAA4xwAAPYQAAAEJgAA1iEAABAAAAAmAAAACAAAAP//////////"/>
               </a:ext>
             </a:extLst>
           </p:cNvCxnSpPr>
@@ -5664,12 +5467,12 @@
       </p:cxnSp>
       <p:cxnSp>
         <p:nvCxnSpPr>
-          <p:cNvPr id="45" name="Connector24"/>
+          <p:cNvPr id="40" name="Connector24"/>
           <p:cNvCxnSpPr>
             <a:stCxn id="2" idx="2"/>
             <a:extLst>
               <a:ext uri="smNativeData">
-                <pr:smNativeData xmlns:pr="smNativeData" xmlns="smNativeData" val="SMDATA_15_ZqHWaRMAAAAlAAAADwAAAA8BAAAAkAAAAEgAAACQAAAASAAAAAAAAAAAAAAAAAAAAAEAAABQAAAAQtr79nGI5r8qniQtlC/2PwAAAAAAAOA/AAAAAAAA4D8AAAAAAADgPwAAAAAAAOA/AAAAAAAA4D8AAAAAAADgPwAAAAAAAOA/AAAAAAAA4D8CAAAAjAAAAAAAAAAAAAAAu+DjDP///wgAAAAAAAAAAAAAAAAAAAAAAAAAAAAAAAAAAAAAZAAAAAEAAABAAAAAAAAAAAAAAAAAAAAAAAAAAAAAAAAAAAAAAAAAAAAAAAAAAAAAAAAAAAAAAAAAAAAAAAAAAAAAAAAAAAAAAAAAAAAAAAAAAAAAAAAAAAAAAAAAAAAAFAAAADwAAAABAAAAAgAAAAAAAAkUAAAAAQAAABQAAAAUAAAAFAAAAAEAAAAAAAAAZAAAAGQAAAABAAAAlgAAAJYAAAAVAAAAYAAAAAAAAAAAAAAADwAAACADAAAAAAAAAAAAAAEAAACgMgAAVgcAAKr4//8BAAAAf39/AAEAAABkAAAAAAAAABQAAABAHwAAAAAAACYAAAAAAAAAwOD//wAAAAAmAAAAZAAAABYAAABMAAAAAAAAAAAAAAAEAAAAAAAAAAEAAACAgIAKAAAAACgAAAAoAAAAZAAAAGQAAAAAAAAAzMzMAAAAAABQAAAAUAAAAGQAAABkAAAAAAAAABcAAAAUAAAAAAAAAAAAAAD/fwAA/38AAAAAAAAJAAAABAAAAAAAAAAeAAAAaAAAAAAAAAAAAAAAAAAAAAAAAAAAAAAAECcAABAnAAAAAAAAAAAAAAAAAAAAAAAAAAAAAAAAAAAAAAAAAAAAABQAAAAAAAAAwMD/AAAAAABkAAAAMgAAAAAAAABkAAAAAAAAAH9/fwAKAAAAIgAAABgAAAAAAAAAAAAAAAAAAAAAAAAAAAAAAAAAAAAkAAAAJAAAAAAAAAAHAAAAAAAAAAAAAAAAAAAAAAAAAAAAAAAAAAAAf39/ACUAAABYAAAAAAAAAAAAAAAAAAAAAAAAAAAAAAAAAAAAAAAAAAAAAAAAAAAAAAAAAAAAAAA/AAAAAAAAAKCGAQAAAAAAAAAAAAAAAAAMAAAAAQAAAAAAAAAAAAAAAAAAAB8AAABUAAAAu+DjBf///wEAAAAAAAAAAAAAAAAAAAAAAAAAAAAAAAAAAAAAAAAAAAAAAAJ/f38AgICAA8zMzADAwP8Af39/AAAAAAAAAAAAAAAAAAAAAAAAAAAAIQAAABgAAAAUAAAAYw0AAPYQAAAFJgAAmSEAABAAAAAmAAAACAAAAP//////////"/>
+                <pr:smNativeData xmlns:pr="smNativeData" xmlns="smNativeData" val="SMDATA_15_MvzhaRMAAAAlAAAADwAAAA8BAAAAkAAAAEgAAACQAAAASAAAAAAAAAAAAAAAAAAAAAEAAABQAAAAQtr79nGI5r8qniQtlC/2PwAAAAAAAOA/AAAAAAAA4D8AAAAAAADgPwAAAAAAAOA/AAAAAAAA4D8AAAAAAADgPwAAAAAAAOA/AAAAAAAA4D8CAAAAjAAAAAAAAAAAAAAAu+DjDP///wgAAAAAAAAAAAAAAAAAAAAAAAAAAAAAAAAAAAAAZAAAAAEAAABAAAAAAAAAAAAAAAAAAAAAAAAAAAAAAAAAAAAAAAAAAAAAAAAAAAAAAAAAAAAAAAAAAAAAAAAAAAAAAAAAAAAAAAAAAAAAAAAAAAAAAAAAAAAAAAAAAAAAFAAAADwAAAABAAAAAgAAAAAAAAkUAAAAAQAAABQAAAAUAAAAFAAAAAEAAAAAAAAAZAAAAGQAAAABAAAAlgAAAJYAAAAVAAAAYAAAAAAAAAAAAAAADwAAACADAAAAAAAAAAAAAAEAAACgMgAAVgcAAKr4//8BAAAAf39/AAEAAABkAAAAAAAAABQAAABAHwAAAAAAACYAAAAAAAAAwOD//wAAAAAmAAAAZAAAABYAAABMAAAAAAAAAAAAAAAEAAAAAAAAAAEAAACAgIAKAAAAACgAAAAoAAAAZAAAAGQAAAAAAAAAzMzMAAAAAABQAAAAUAAAAGQAAABkAAAAAAAAABcAAAAUAAAAAAAAAAAAAAD/fwAA/38AAAAAAAAJAAAABAAAAAAAAAAeAAAAaAAAAAAAAAAAAAAAAAAAAAAAAAAAAAAAECcAABAnAAAAAAAAAAAAAAAAAAAAAAAAAAAAAAAAAAAAAAAAAAAAABQAAAAAAAAAwMD/AAAAAABkAAAAMgAAAAAAAABkAAAAAAAAAH9/fwAKAAAAIgAAABgAAAAAAAAAAAAAAAAAAAAAAAAAAAAAAAAAAAAkAAAAJAAAAAAAAAAHAAAAAAAAAAAAAAAAAAAAAAAAAAAAAAAAAAAAf39/ACUAAABYAAAAAAAAAAAAAAAAAAAAAAAAAAAAAAAAAAAAAAAAAAAAAAAAAAAAAAAAAAAAAAA/AAAAAAAAAKCGAQAAAAAAAAAAAAAAAAAMAAAAAQAAAAAAAAAAAAAAAAAAAB8AAABUAAAAu+DjBf///wEAAAAAAAAAAAAAAAAAAAAAAAAAAAAAAAAAAAAAAAAAAAAAAAJ/f38AgICAA8zMzADAwP8Af39/AAAAAAAAAAAAAAAAAAAAAAAAAAAAIQAAABgAAAAUAAAAYw0AAPYQAAAFJgAAmSEAABAAAAAmAAAACAAAAP//////////"/>
               </a:ext>
             </a:extLst>
           </p:cNvCxnSpPr>
@@ -5700,13 +5503,13 @@
       </p:cxnSp>
       <p:cxnSp>
         <p:nvCxnSpPr>
-          <p:cNvPr id="46" name="Connector21"/>
+          <p:cNvPr id="41" name="Connector21"/>
           <p:cNvCxnSpPr>
-            <a:stCxn id="7" idx="3"/>
+            <a:stCxn id="6" idx="3"/>
             <a:endCxn id="2" idx="3"/>
             <a:extLst>
               <a:ext uri="smNativeData">
-                <pr:smNativeData xmlns:pr="smNativeData" xmlns="smNativeData" val="SMDATA_15_ZqHWaRMAAAAlAAAADwAAAA8BAAAAkAAAAEgAAACQAAAASAAAAAAAAAAAAAAAAAAAAAEAAABQAAAAAAAAAAAAFEAAAAAAAADgPwAAAAAAAOA/AAAAAAAA4D8AAAAAAADgPwAAAAAAAOA/AAAAAAAA4D8AAAAAAADgPwAAAAAAAOA/AAAAAAAA4D8CAAAAjAAAAAAAAAAAAAAAu+DjDP///wgAAAAAAAAAAAAAAAAAAAAAAAAAAAAAAAAAAAAAZAAAAAEAAABAAAAAAAAAAAAAAAAAAAAAAAAAAAAAAAAAAAAAAAAAAAAAAAAAAAAAAAAAAAAAAAAAAAAAAAAAAAAAAAAAAAAAAAAAAAAAAAAAAAAAAAAAAAAAAAAAAAAAFAAAADwAAAABAAAAAQAAAAAAAAkUAAAAAQAAABQAAAAUAAAAFAAAAAEAAAAAAAAAZAAAAGQAAAABAAAAlgAAAJYAAAAVAAAAYAAAAAAAAAAAAAAADwAAACADAAAAAAAAAAAAAAEAAACgMgAAVgcAAKr4//8BAAAAf39/AAEAAABkAAAAAAAAABQAAABAHwAAAAAAACYAAAAAAAAAwOD//wAAAAAmAAAAZAAAABYAAABMAAAAAAAAAAAAAAAEAAAAAAAAAAEAAACAgIAKAAAAACgAAAAoAAAAZAAAAGQAAAAAAAAAzMzMAAAAAABQAAAAUAAAAGQAAABkAAAAAAAAABcAAAAUAAAAAAAAAAAAAAD/fwAA/38AAAAAAAAJAAAABAAAAAAAAAAeAAAAaAAAAAAAAAAAAAAAAAAAAAAAAAAAAAAAECcAABAnAAAAAAAAAAAAAAAAAAAAAAAAAAAAAAAAAAAAAAAAAAAAABQAAAAAAAAAwMD/AAAAAABkAAAAMgAAAAAAAABkAAAAAAAAAH9/fwAKAAAAIgAAABgAAAAAAAAAAAAAAAAAAAAAAAAAAAAAAAAAAAAkAAAAJAAAAAAAAAAHAAAAAAAAAAAAAAAAAAAAAAAAAAAAAAAAAAAAf39/ACUAAABYAAAAAAAAAAAAAAAAAAAAAAAAAAAAAAAAAAAAAAAAAAAAAAAAAAAAAAAAAAAAAAA/AAAAAAAAAKCGAQAAAAAAAAAAAAAAAAAMAAAAAQAAAAAAAAAAAAAAAAAAAB8AAABUAAAAu+DjBf///wEAAAAAAAAAAAAAAAAAAAAAAAAAAAAAAAAAAAAAAAAAAAAAAAJ/f38AgICAA8zMzADAwP8Af39/AAAAAAAAAAAAAAAAAAAAAAAAAAAAIQAAABgAAAAUAAAAGCsAAPoOAAD6KwAAWBYAABAAAAAmAAAACAAAAP//////////"/>
+                <pr:smNativeData xmlns:pr="smNativeData" xmlns="smNativeData" val="SMDATA_15_MvzhaRMAAAAlAAAADwAAAA8BAAAAkAAAAEgAAACQAAAASAAAAAAAAAAAAAAAAAAAAAEAAABQAAAAAAAAAAAAFEAAAAAAAADgPwAAAAAAAOA/AAAAAAAA4D8AAAAAAADgPwAAAAAAAOA/AAAAAAAA4D8AAAAAAADgPwAAAAAAAOA/AAAAAAAA4D8CAAAAjAAAAAAAAAAAAAAAu+DjDP///wgAAAAAAAAAAAAAAAAAAAAAAAAAAAAAAAAAAAAAZAAAAAEAAABAAAAAAAAAAAAAAAAAAAAAAAAAAAAAAAAAAAAAAAAAAAAAAAAAAAAAAAAAAAAAAAAAAAAAAAAAAAAAAAAAAAAAAAAAAAAAAAAAAAAAAAAAAAAAAAAAAAAAFAAAADwAAAABAAAAAQAAAAAAAAkUAAAAAQAAABQAAAAUAAAAFAAAAAEAAAAAAAAAZAAAAGQAAAABAAAAlgAAAJYAAAAVAAAAYAAAAAAAAAAAAAAADwAAACADAAAAAAAAAAAAAAEAAACgMgAAVgcAAKr4//8BAAAAf39/AAEAAABkAAAAAAAAABQAAABAHwAAAAAAACYAAAAAAAAAwOD//wAAAAAmAAAAZAAAABYAAABMAAAAAAAAAAAAAAAEAAAAAAAAAAEAAACAgIAKAAAAACgAAAAoAAAAZAAAAGQAAAAAAAAAzMzMAAAAAABQAAAAUAAAAGQAAABkAAAAAAAAABcAAAAUAAAAAAAAAAAAAAD/fwAA/38AAAAAAAAJAAAABAAAAAAAAAAeAAAAaAAAAAAAAAAAAAAAAAAAAAAAAAAAAAAAECcAABAnAAAAAAAAAAAAAAAAAAAAAAAAAAAAAAAAAAAAAAAAAAAAABQAAAAAAAAAwMD/AAAAAABkAAAAMgAAAAAAAABkAAAAAAAAAH9/fwAKAAAAIgAAABgAAAAAAAAAAAAAAAAAAAAAAAAAAAAAAAAAAAAkAAAAJAAAAAAAAAAHAAAAAAAAAAAAAAAAAAAAAAAAAAAAAAAAAAAAf39/ACUAAABYAAAAAAAAAAAAAAAAAAAAAAAAAAAAAAAAAAAAAAAAAAAAAAAAAAAAAAAAAAAAAAA/AAAAAAAAAKCGAQAAAAAAAAAAAAAAAAAMAAAAAQAAAAAAAAAAAAAAAAAAAB8AAABUAAAAu+DjBf///wEAAAAAAAAAAAAAAAAAAAAAAAAAAAAAAAAAAAAAAAAAAAAAAAJ/f38AgICAA8zMzADAwP8Af39/AAAAAAAAAAAAAAAAAAAAAAAAAAAAIQAAABgAAAAUAAAAGCsAAPoOAAD6KwAAWBYAABAAAAAmAAAACAAAAP//////////"/>
               </a:ext>
             </a:extLst>
           </p:cNvCxnSpPr>
@@ -5736,13 +5539,13 @@
       </p:cxnSp>
       <p:cxnSp>
         <p:nvCxnSpPr>
-          <p:cNvPr id="47" name="Connector19"/>
+          <p:cNvPr id="42" name="Connector19"/>
           <p:cNvCxnSpPr>
             <a:stCxn id="3" idx="2"/>
             <a:endCxn id="2" idx="1"/>
             <a:extLst>
               <a:ext uri="smNativeData">
-                <pr:smNativeData xmlns:pr="smNativeData" xmlns="smNativeData" val="SMDATA_15_ZqHWaRMAAAAlAAAADwAAAA8BAAAAkAAAAEgAAACQAAAASAAAAAAAAAAAAAAAAAAAAAEAAABQAAAAAAAAAACABMA3jx60mcXaPwAAAAAAAOA/AAAAAAAA4D8AAAAAAADgPwAAAAAAAOA/AAAAAAAA4D8AAAAAAADgPwAAAAAAAOA/AAAAAAAA4D8CAAAAjAAAAAAAAAAAAAAAu+DjDP///wgAAAAAAAAAAAAAAAAAAAAAAAAAAAAAAAAAAAAAZAAAAAEAAABAAAAAAAAAAAAAAAAAAAAAAAAAAAAAAAAAAAAAAAAAAAAAAAAAAAAAAAAAAAAAAAAAAAAAAAAAAAAAAAAAAAAAAAAAAAAAAAAAAAAAAAAAAAAAAAAAAAAAFAAAADwAAAABAAAAAgAAAAAAAAkUAAAAAQAAABQAAAAUAAAAFAAAAAEAAAAAAAAAZAAAAGQAAAABAAAAlgAAAJYAAAAVAAAAYAAAAAAAAAAAAAAADwAAACADAAAAAAAAAAAAAAEAAACgMgAAVgcAAKr4//8BAAAAf39/AAEAAABkAAAAAAAAABQAAABAHwAAAAAAACYAAAAAAAAAwOD//wAAAAAmAAAAZAAAABYAAABMAAAAAAAAAAAAAAAEAAAAAAAAAAEAAACAgIAKAAAAACgAAAAoAAAAZAAAAGQAAAAAAAAAzMzMAAAAAABQAAAAUAAAAGQAAABkAAAAAAAAABcAAAAUAAAAAAAAAAAAAAD/fwAA/38AAAAAAAAJAAAABAAAAAAAAAAeAAAAaAAAAAAAAAAAAAAAAAAAAAAAAAAAAAAAECcAABAnAAAAAAAAAAAAAAAAAAAAAAAAAAAAAAAAAAAAAAAAAAAAABQAAAAAAAAAwMD/AAAAAABkAAAAMgAAAAAAAABkAAAAAAAAAH9/fwAKAAAAIgAAABgAAAAAAAAAAAAAAAAAAAAAAAAAAAAAAAAAAAAkAAAAJAAAAAAAAAAHAAAAAAAAAAAAAAAAAAAAAAAAAAAAAAAAAAAAf39/ACUAAABYAAAAAAAAAAAAAAAAAAAAAAAAAAAAAAAAAAAAAAAAAAAAAAAAAAAAAAAAAAAAAAA/AAAAAAAAAKCGAQAAAAAAAAAAAAAAAAAMAAAAAQAAAAAAAAAAAAAAAAAAAB8AAABUAAAAu+DjBf///wEAAAAAAAAAAAAAAAAAAAAAAAAAAAAAAAAAAAAAAAAAAAAAAAJ/f38AgICAA8zMzADAwP8Af39/AAAAAAAAAAAAAAAAAAAAAAAAAAAAIQAAABgAAAAUAAAAVhgAAPoOAAAPIAAA+hAAABAAAAAmAAAACAAAAP//////////"/>
+                <pr:smNativeData xmlns:pr="smNativeData" xmlns="smNativeData" val="SMDATA_15_MvzhaRMAAAAlAAAADwAAAA8BAAAAkAAAAEgAAACQAAAASAAAAAAAAAAAAAAAAAAAAAEAAABQAAAAAAAAAACABMA3jx60mcXaPwAAAAAAAOA/AAAAAAAA4D8AAAAAAADgPwAAAAAAAOA/AAAAAAAA4D8AAAAAAADgPwAAAAAAAOA/AAAAAAAA4D8CAAAAjAAAAAAAAAAAAAAAu+DjDP///wgAAAAAAAAAAAAAAAAAAAAAAAAAAAAAAAAAAAAAZAAAAAEAAABAAAAAAAAAAAAAAAAAAAAAAAAAAAAAAAAAAAAAAAAAAAAAAAAAAAAAAAAAAAAAAAAAAAAAAAAAAAAAAAAAAAAAAAAAAAAAAAAAAAAAAAAAAAAAAAAAAAAAFAAAADwAAAABAAAAAgAAAAAAAAkUAAAAAQAAABQAAAAUAAAAFAAAAAEAAAAAAAAAZAAAAGQAAAABAAAAlgAAAJYAAAAVAAAAYAAAAAAAAAAAAAAADwAAACADAAAAAAAAAAAAAAEAAACgMgAAVgcAAKr4//8BAAAAf39/AAEAAABkAAAAAAAAABQAAABAHwAAAAAAACYAAAAAAAAAwOD//wAAAAAmAAAAZAAAABYAAABMAAAAAAAAAAAAAAAEAAAAAAAAAAEAAACAgIAKAAAAACgAAAAoAAAAZAAAAGQAAAAAAAAAzMzMAAAAAABQAAAAUAAAAGQAAABkAAAAAAAAABcAAAAUAAAAAAAAAAAAAAD/fwAA/38AAAAAAAAJAAAABAAAAAAAAAAeAAAAaAAAAAAAAAAAAAAAAAAAAAAAAAAAAAAAECcAABAnAAAAAAAAAAAAAAAAAAAAAAAAAAAAAAAAAAAAAAAAAAAAABQAAAAAAAAAwMD/AAAAAABkAAAAMgAAAAAAAABkAAAAAAAAAH9/fwAKAAAAIgAAABgAAAAAAAAAAAAAAAAAAAAAAAAAAAAAAAAAAAAkAAAAJAAAAAAAAAAHAAAAAAAAAAAAAAAAAAAAAAAAAAAAAAAAAAAAf39/ACUAAABYAAAAAAAAAAAAAAAAAAAAAAAAAAAAAAAAAAAAAAAAAAAAAAAAAAAAAAAAAAAAAAA/AAAAAAAAAKCGAQAAAAAAAAAAAAAAAAAMAAAAAQAAAAAAAAAAAAAAAAAAAB8AAABUAAAAu+DjBf///wEAAAAAAAAAAAAAAAAAAAAAAAAAAAAAAAAAAAAAAAAAAAAAAAJ/f38AgICAA8zMzADAwP8Af39/AAAAAAAAAAAAAAAAAAAAAAAAAAAAIQAAABgAAAAUAAAAVhgAAPoOAAAPIAAA+hAAABAAAAAmAAAACAAAAP//////////"/>
               </a:ext>
             </a:extLst>
           </p:cNvCxnSpPr>
@@ -5773,13 +5576,13 @@
       </p:cxnSp>
       <p:cxnSp>
         <p:nvCxnSpPr>
-          <p:cNvPr id="48" name="Connector25"/>
+          <p:cNvPr id="43" name="Connector25"/>
           <p:cNvCxnSpPr>
             <a:stCxn id="3" idx="3"/>
             <a:endCxn id="2" idx="1"/>
             <a:extLst>
               <a:ext uri="smNativeData">
-                <pr:smNativeData xmlns:pr="smNativeData" xmlns="smNativeData" val="SMDATA_15_ZqHWaRMAAAAlAAAADQAAAA8BAAAAkAAAAEgAAACQAAAASAAAAAAAAAAAAAAAAAAAAAEAAABQAAAAAAAAAAAA4D8AAAAAAADgPwAAAAAAAOA/AAAAAAAA4D8AAAAAAADgPwAAAAAAAOA/AAAAAAAA4D8AAAAAAADgPwAAAAAAAOA/AAAAAAAA4D8CAAAAjAAAAAAAAAAAAAAAu+DjDP///wgAAAAAAAAAAAAAAAAAAAAAAAAAAAAAAAAAAAAAZAAAAAEAAABAAAAAAAAAAAAAAAAAAAAAAAAAAAAAAAAAAAAAAAAAAAAAAAAAAAAAAAAAAAAAAAAAAAAAAAAAAAAAAAAAAAAAAAAAAAAAAAAAAAAAAAAAAAAAAAAAAAAAFAAAADwAAAABAAAAAAAAAAAAAAkUAAAAAQAAABQAAAAUAAAAFAAAAAEAAAAAAAAAZAAAAGQAAAABAAAAlgAAAJYAAAAVAAAAYAAAAAAAAAAAAAAADwAAACADAAAAAAAAAAAAAAEAAACgMgAAVgcAAKr4//8BAAAAf39/AAEAAABkAAAAAAAAABQAAABAHwAAAAAAACYAAAAAAAAAwOD//wAAAAAmAAAAZAAAABYAAABMAAAAAAAAAAAAAAAEAAAAAAAAAAEAAACAgIAKAAAAACgAAAAoAAAAZAAAAGQAAAAAAAAAzMzMAAAAAABQAAAAUAAAAGQAAABkAAAAAAAAABcAAAAUAAAAAAAAAAAAAAD/fwAA/38AAAAAAAAJAAAABAAAAAAAAAAeAAAAaAAAAAAAAAAAAAAAAAAAAAAAAAAAAAAAECcAABAnAAAAAAAAAAAAAAAAAAAAAAAAAAAAAAAAAAAAAAAAAAAAABQAAAAAAAAAwMD/AAAAAABkAAAAMgAAAAAAAABkAAAAAAAAAH9/fwAKAAAAIgAAABgAAAAAAAAAAAAAAAAAAAAAAAAAAAAAAAAAAAAkAAAAJAAAAAAAAAAHAAAAAAAAAAAAAAAAAAAAAAAAAAAAAAAAAAAAf39/ACUAAABYAAAAAAAAAAAAAAAAAAAAAAAAAAAAAAAAAAAAAAAAAAAAAAAAAAAAAAAAAAAAAAA/AAAAAAAAAKCGAQAAAAAAAAAAAAAAAAAMAAAAAQAAAAAAAAAAAAAAAAAAAB8AAABUAAAAu+DjBf///wEAAAAAAAAAAAAAAAAAAAAAAAAAAAAAAAAAAAAAAAAAAAAAAAJ/f38AgICAA8zMzADAwP8Af39/AAAAAAAAAAAAAAAAAAAAAAAAAAAAIQAAABgAAAAUAAAAhxwAAPoOAAAPIAAA/g4AABAAAAAmAAAACAAAAP//////////"/>
+                <pr:smNativeData xmlns:pr="smNativeData" xmlns="smNativeData" val="SMDATA_15_MvzhaRMAAAAlAAAADQAAAA8BAAAAkAAAAEgAAACQAAAASAAAAAAAAAAAAAAAAAAAAAEAAABQAAAAAAAAAAAA4D8AAAAAAADgPwAAAAAAAOA/AAAAAAAA4D8AAAAAAADgPwAAAAAAAOA/AAAAAAAA4D8AAAAAAADgPwAAAAAAAOA/AAAAAAAA4D8CAAAAjAAAAAAAAAAAAAAAu+DjDP///wgAAAAAAAAAAAAAAAAAAAAAAAAAAAAAAAAAAAAAZAAAAAEAAABAAAAAAAAAAAAAAAAAAAAAAAAAAAAAAAAAAAAAAAAAAAAAAAAAAAAAAAAAAAAAAAAAAAAAAAAAAAAAAAAAAAAAAAAAAAAAAAAAAAAAAAAAAAAAAAAAAAAAFAAAADwAAAABAAAAAAAAAAAAAAkUAAAAAQAAABQAAAAUAAAAFAAAAAEAAAAAAAAAZAAAAGQAAAABAAAAlgAAAJYAAAAVAAAAYAAAAAAAAAAAAAAADwAAACADAAAAAAAAAAAAAAEAAACgMgAAVgcAAKr4//8BAAAAf39/AAEAAABkAAAAAAAAABQAAABAHwAAAAAAACYAAAAAAAAAwOD//wAAAAAmAAAAZAAAABYAAABMAAAAAAAAAAAAAAAEAAAAAAAAAAEAAACAgIAKAAAAACgAAAAoAAAAZAAAAGQAAAAAAAAAzMzMAAAAAABQAAAAUAAAAGQAAABkAAAAAAAAABcAAAAUAAAAAAAAAAAAAAD/fwAA/38AAAAAAAAJAAAABAAAAAAAAAAeAAAAaAAAAAAAAAAAAAAAAAAAAAAAAAAAAAAAECcAABAnAAAAAAAAAAAAAAAAAAAAAAAAAAAAAAAAAAAAAAAAAAAAABQAAAAAAAAAwMD/AAAAAABkAAAAMgAAAAAAAABkAAAAAAAAAH9/fwAKAAAAIgAAABgAAAAAAAAAAAAAAAAAAAAAAAAAAAAAAAAAAAAkAAAAJAAAAAAAAAAHAAAAAAAAAAAAAAAAAAAAAAAAAAAAAAAAAAAAf39/ACUAAABYAAAAAAAAAAAAAAAAAAAAAAAAAAAAAAAAAAAAAAAAAAAAAAAAAAAAAAAAAAAAAAA/AAAAAAAAAKCGAQAAAAAAAAAAAAAAAAAMAAAAAQAAAAAAAAAAAAAAAAAAAB8AAABUAAAAu+DjBf///wEAAAAAAAAAAAAAAAAAAAAAAAAAAAAAAAAAAAAAAAAAAAAAAAJ/f38AgICAA8zMzADAwP8Af39/AAAAAAAAAAAAAAAAAAAAAAAAAAAAIQAAABgAAAAUAAAAhxwAAPoOAAAPIAAA/g4AABAAAAAmAAAACAAAAP//////////"/>
               </a:ext>
             </a:extLst>
           </p:cNvCxnSpPr>
@@ -5807,13 +5610,13 @@
       </p:cxnSp>
       <p:cxnSp>
         <p:nvCxnSpPr>
-          <p:cNvPr id="49" name="Connector17"/>
+          <p:cNvPr id="44" name="Connector17"/>
           <p:cNvCxnSpPr>
             <a:stCxn id="3" idx="1"/>
             <a:endCxn id="5" idx="3"/>
             <a:extLst>
               <a:ext uri="smNativeData">
-                <pr:smNativeData xmlns:pr="smNativeData" xmlns="smNativeData" val="SMDATA_15_ZqHWaRMAAAAlAAAADQAAAA8BAAAAkAAAAEgAAACQAAAASAAAAAAAAAAAAAAAAAAAAAEAAABQAAAAAAAAAAAA4D8AAAAAAADgPwAAAAAAAOA/AAAAAAAA4D8AAAAAAADgPwAAAAAAAOA/AAAAAAAA4D8AAAAAAADgPwAAAAAAAOA/AAAAAAAA4D8CAAAAjAAAAAAAAAAAAAAAu+DjDP///wgAAAAAAAAAAAAAAAAAAAAAAAAAAAAAAAAAAAAAZAAAAAEAAABAAAAAAAAAAAAAAAAAAAAAAAAAAAAAAAAAAAAAAAAAAAAAAAAAAAAAAAAAAAAAAAAAAAAAAAAAAAAAAAAAAAAAAAAAAAAAAAAAAAAAAAAAAAAAAAAAAAAAFAAAADwAAAABAAAAAAAAAAAAAAkUAAAAAQAAABQAAAAUAAAAFAAAAAEAAAAAAAAAZAAAAGQAAAABAAAAlgAAAJYAAAAVAAAAYAAAAAAAAAAAAAAADwAAACADAAAAAAAAAAAAAAEAAACgMgAAVgcAAKr4//8BAAAAf39/AAEAAABkAAAAAAAAABQAAABAHwAAAAAAACYAAAAAAAAAwOD//wAAAAAmAAAAZAAAABYAAABMAAAAAAAAAAAAAAAEAAAAAAAAAAEAAACAgIAKAAAAACgAAAAoAAAAZAAAAGQAAAAAAAAAzMzMAAAAAABQAAAAUAAAAGQAAABkAAAAAAAAABcAAAAUAAAAAAAAAAAAAAD/fwAA/38AAAAAAAAJAAAABAAAAAAAAQAeAAAAaAAAAAAAAAAAAAAAAAAAAAAAAAAAAAAAECcAABAnAAAAAAAAAAAAAAAAAAAAAAAAAAAAAAAAAAAAAAAAAAAAABQAAAAAAAAAwMD/AAAAAABkAAAAMgAAAAAAAABkAAAAAAAAAH9/fwAKAAAAIgAAABgAAAAAAAAAAAAAAAAAAAAAAAAAAAAAAAAAAAAkAAAAJAAAAAAAAAAHAAAAAAAAAAAAAAAAAAAAAAAAAAAAAAAAAAAAf39/ACUAAABYAAAAAAAAAAAAAAAAAAAAAAAAAAAAAAAAAAAAAAAAAAAAAAAAAAAAAAAAAAAAAAA/AAAAAAAAAKCGAQAAAAAAAAAAAAAAAAAMAAAAAQAAAAAAAAAAAAAAAAAAAB8AAABUAAAAu+DjBf///wEAAAAAAAAAAAAAAAAAAAAAAAAAAAAAAAAAAAAAAAAAAAAAAAJ/f38AgICAA8zMzADAwP8Af39/AAAAAAAAAAAAAAAAAAAAAAAAAAAAIQAAABgAAAAUAAAA7xEAAP4OAAAkFAAAAQ8AABAAAAAmAAAACAAAAP//////////"/>
+                <pr:smNativeData xmlns:pr="smNativeData" xmlns="smNativeData" val="SMDATA_15_MvzhaRMAAAAlAAAADQAAAA8BAAAAkAAAAEgAAACQAAAASAAAAAAAAAAAAAAAAAAAAAEAAABQAAAAAAAAAAAA4D8AAAAAAADgPwAAAAAAAOA/AAAAAAAA4D8AAAAAAADgPwAAAAAAAOA/AAAAAAAA4D8AAAAAAADgPwAAAAAAAOA/AAAAAAAA4D8CAAAAjAAAAAAAAAAAAAAAu+DjDP///wgAAAAAAAAAAAAAAAAAAAAAAAAAAAAAAAAAAAAAZAAAAAEAAABAAAAAAAAAAAAAAAAAAAAAAAAAAAAAAAAAAAAAAAAAAAAAAAAAAAAAAAAAAAAAAAAAAAAAAAAAAAAAAAAAAAAAAAAAAAAAAAAAAAAAAAAAAAAAAAAAAAAAFAAAADwAAAABAAAAAAAAAAAAAAkUAAAAAQAAABQAAAAUAAAAFAAAAAEAAAAAAAAAZAAAAGQAAAABAAAAlgAAAJYAAAAVAAAAYAAAAAAAAAAAAAAADwAAACADAAAAAAAAAAAAAAEAAACgMgAAVgcAAKr4//8BAAAAf39/AAEAAABkAAAAAAAAABQAAABAHwAAAAAAACYAAAAAAAAAwOD//wAAAAAmAAAAZAAAABYAAABMAAAAAAAAAAAAAAAEAAAAAAAAAAEAAACAgIAKAAAAACgAAAAoAAAAZAAAAGQAAAAAAAAAzMzMAAAAAABQAAAAUAAAAGQAAABkAAAAAAAAABcAAAAUAAAAAAAAAAAAAAD/fwAA/38AAAAAAAAJAAAABAAAAAAAAQAeAAAAaAAAAAAAAAAAAAAAAAAAAAAAAAAAAAAAECcAABAnAAAAAAAAAAAAAAAAAAAAAAAAAAAAAAAAAAAAAAAAAAAAABQAAAAAAAAAwMD/AAAAAABkAAAAMgAAAAAAAABkAAAAAAAAAH9/fwAKAAAAIgAAABgAAAAAAAAAAAAAAAAAAAAAAAAAAAAAAAAAAAAkAAAAJAAAAAAAAAAHAAAAAAAAAAAAAAAAAAAAAAAAAAAAAAAAAAAAf39/ACUAAABYAAAAAAAAAAAAAAAAAAAAAAAAAAAAAAAAAAAAAAAAAAAAAAAAAAAAAAAAAAAAAAA/AAAAAAAAAKCGAQAAAAAAAAAAAAAAAAAMAAAAAQAAAAAAAAAAAAAAAAAAAB8AAABUAAAAu+DjBf///wEAAAAAAAAAAAAAAAAAAAAAAAAAAAAAAAAAAAAAAAAAAAAAAAJ/f38AgICAA8zMzADAwP8Af39/AAAAAAAAAAAAAAAAAAAAAAAAAAAAIQAAABgAAAAUAAAA7xEAAP4OAAAkFAAAAQ8AABAAAAAmAAAACAAAAP//////////"/>
               </a:ext>
             </a:extLst>
           </p:cNvCxnSpPr>
@@ -5841,13 +5644,13 @@
       </p:cxnSp>
       <p:cxnSp>
         <p:nvCxnSpPr>
-          <p:cNvPr id="50" name="Connector18"/>
+          <p:cNvPr id="45" name="Connector18"/>
           <p:cNvCxnSpPr>
             <a:stCxn id="3" idx="0"/>
             <a:endCxn id="4" idx="2"/>
             <a:extLst>
               <a:ext uri="smNativeData">
-                <pr:smNativeData xmlns:pr="smNativeData" xmlns="smNativeData" val="SMDATA_15_ZqHWaRMAAAAlAAAADQAAAA8BAAAAkAAAAEgAAACQAAAASAAAAAAAAAAAAAAAAAAAAAEAAABQAAAAAAAAAAAA4D8AAAAAAADgPwAAAAAAAOA/AAAAAAAA4D8AAAAAAADgPwAAAAAAAOA/AAAAAAAA4D8AAAAAAADgPwAAAAAAAOA/AAAAAAAA4D8CAAAAjAAAAAAAAAAAAAAAu+DjDP///wgAAAAAAAAAAAAAAAAAAAAAAAAAAAAAAAAAAAAAZAAAAAEAAABAAAAAAAAAAAAAAAAAAAAAAAAAAAAAAAAAAAAAAAAAAAAAAAAAAAAAAAAAAAAAAAAAAAAAAAAAAAAAAAAAAAAAAAAAAAAAAAAAAAAAAAAAAAAAAAAAAAAAFAAAADwAAAABAAAAAAAAAAAAAAkUAAAAAQAAABQAAAAUAAAAFAAAAAEAAAAAAAAAZAAAAGQAAAABAAAAlgAAAJYAAAAVAAAAYAAAAAAAAAAAAAAADwAAACADAAAAAAAAAAAAAAEAAACgMgAAVgcAAKr4//8BAAAAf39/AAEAAABkAAAAAAAAABQAAABAHwAAAAAAACYAAAAAAAAAwOD//wAAAAAmAAAAZAAAABYAAABMAAAAAAAAAAAAAAAEAAAAAAAAAAEAAACAgIAKAAAAACgAAAAoAAAAZAAAAGQAAAAAAAAAzMzMAAAAAABQAAAAUAAAAGQAAABkAAAAAAAAABcAAAAUAAAAAAAAAAAAAAD/fwAA/38AAAAAAAAJAAAABAAAAAsAAAAeAAAAaAAAAAAAAAAAAAAAAAAAAAAAAAAAAAAAECcAABAnAAAAAAAAAAAAAAAAAAAAAAAAAAAAAAAAAAAAAAAAAAAAABQAAAAAAAAAwMD/AAAAAABkAAAAMgAAAAAAAABkAAAAAAAAAH9/fwAKAAAAIgAAABgAAAAAAAAAAAAAAAAAAAAAAAAAAAAAAAAAAAAkAAAAJAAAAAAAAAAHAAAAAAAAAAAAAAAAAAAAAAAAAAAAAAAAAAAAf39/ACUAAABYAAAAAAAAAAAAAAAAAAAAAAAAAAAAAAAAAAAAAAAAAAAAAAAAAAAAAAAAAAAAAAA/AAAAAAAAAKCGAQAAAAAAAAAAAAAAAAAMAAAAAQAAAAAAAAAAAAAAAAAAAB8AAABUAAAAu+DjBf///wEAAAAAAAAAAAAAAAAAAAAAAAAAAAAAAAAAAAAAAAAAAAAAAAJ/f38AgICAA8zMzADAwP8Af39/AAAAAAAAAAAAAAAAAAAAAAAAAAAAIQAAABgAAAAUAAAAUhgAAIsKAABWGAAAAQ0AABAAAAAmAAAACAAAAP//////////"/>
+                <pr:smNativeData xmlns:pr="smNativeData" xmlns="smNativeData" val="SMDATA_15_MvzhaRMAAAAlAAAADQAAAA8BAAAAkAAAAEgAAACQAAAASAAAAAAAAAAAAAAAAAAAAAEAAABQAAAAAAAAAAAA4D8AAAAAAADgPwAAAAAAAOA/AAAAAAAA4D8AAAAAAADgPwAAAAAAAOA/AAAAAAAA4D8AAAAAAADgPwAAAAAAAOA/AAAAAAAA4D8CAAAAjAAAAAAAAAAAAAAAu+DjDP///wgAAAAAAAAAAAAAAAAAAAAAAAAAAAAAAAAAAAAAZAAAAAEAAABAAAAAAAAAAAAAAAAAAAAAAAAAAAAAAAAAAAAAAAAAAAAAAAAAAAAAAAAAAAAAAAAAAAAAAAAAAAAAAAAAAAAAAAAAAAAAAAAAAAAAAAAAAAAAAAAAAAAAFAAAADwAAAABAAAAAAAAAAAAAAkUAAAAAQAAABQAAAAUAAAAFAAAAAEAAAAAAAAAZAAAAGQAAAABAAAAlgAAAJYAAAAVAAAAYAAAAAAAAAAAAAAADwAAACADAAAAAAAAAAAAAAEAAACgMgAAVgcAAKr4//8BAAAAf39/AAEAAABkAAAAAAAAABQAAABAHwAAAAAAACYAAAAAAAAAwOD//wAAAAAmAAAAZAAAABYAAABMAAAAAAAAAAAAAAAEAAAAAAAAAAEAAACAgIAKAAAAACgAAAAoAAAAZAAAAGQAAAAAAAAAzMzMAAAAAABQAAAAUAAAAGQAAABkAAAAAAAAABcAAAAUAAAAAAAAAAAAAAD/fwAA/38AAAAAAAAJAAAABAAAAAsAAAAeAAAAaAAAAAAAAAAAAAAAAAAAAAAAAAAAAAAAECcAABAnAAAAAAAAAAAAAAAAAAAAAAAAAAAAAAAAAAAAAAAAAAAAABQAAAAAAAAAwMD/AAAAAABkAAAAMgAAAAAAAABkAAAAAAAAAH9/fwAKAAAAIgAAABgAAAAAAAAAAAAAAAAAAAAAAAAAAAAAAAAAAAAkAAAAJAAAAAAAAAAHAAAAAAAAAAAAAAAAAAAAAAAAAAAAAAAAAAAAf39/ACUAAABYAAAAAAAAAAAAAAAAAAAAAAAAAAAAAAAAAAAAAAAAAAAAAAAAAAAAAAAAAAAAAAA/AAAAAAAAAKCGAQAAAAAAAAAAAAAAAAAMAAAAAQAAAAAAAAAAAAAAAAAAAB8AAABUAAAAu+DjBf///wEAAAAAAAAAAAAAAAAAAAAAAAAAAAAAAAAAAAAAAAAAAAAAAAJ/f38AgICAA8zMzADAwP8Af39/AAAAAAAAAAAAAAAAAAAAAAAAAAAAIQAAABgAAAAUAAAAUhgAAIsKAABWGAAAAQ0AABAAAAAmAAAACAAAAP//////////"/>
               </a:ext>
             </a:extLst>
           </p:cNvCxnSpPr>
@@ -5875,11 +5678,11 @@
       </p:cxnSp>
       <p:grpSp>
         <p:nvGrpSpPr>
-          <p:cNvPr id="51" name="Group6"/>
+          <p:cNvPr id="46" name="Group6"/>
           <p:cNvGrpSpPr>
             <a:extLst>
               <a:ext uri="smNativeData">
-                <pr:smNativeData xmlns:pr="smNativeData" xmlns="smNativeData" val="SMDATA_6_ZqHWaRMAAAAlAAAAAQAAAA8BAAAAkAAAAEgAAACQAAAASAAAAAAAAAAAAAAAAAAAABcAAAAUAAAAAAAAAAAAAAD/fwAA/38AAAAAAAAJAAAABAAAAA8AAAAfAAAAVAAAAAAAAAAAAAAAAAAAAAAAAAAAAAAAAAAAAAAAAAAAAAAAAAAAAAAAAAAAAAAAAAAAAAAAAAAAAAAAAAAAAAAAAAAAAAAAAAAAAAAAAAAAAAAAAAAAACEAAAAYAAAAFAAAABooAACqIAAA4TAAALQjAAAQAAAAJgAAAAgAAAD/////AAAAAA=="/>
+                <pr:smNativeData xmlns:pr="smNativeData" xmlns="smNativeData" val="SMDATA_6_MvzhaRMAAAAlAAAAAQAAAA8BAAAAkAAAAEgAAACQAAAASAAAAAAAAAAAAAAAAAAAABcAAAAUAAAAAAAAAAAAAAD/fwAA/38AAAAAAAAJAAAABAAAAA8AAAAfAAAAVAAAAAAAAAAAAAAAAAAAAAAAAAAAAAAAAAAAAAAAAAAAAAAAAAAAAAAAAAAAAAAAAAAAAAAAAAAAAAAAAAAAAAAAAAAAAAAAAAAAAAAAAAAAAAAAAAAAACEAAAAYAAAAFAAAABooAACqIAAA4TAAALQjAAAQAAAAJgAAAAgAAAD/////AAAAAA=="/>
               </a:ext>
             </a:extLst>
           </p:cNvGrpSpPr>
@@ -5895,11 +5698,11 @@
         </p:grpSpPr>
         <p:sp>
           <p:nvSpPr>
-            <p:cNvPr id="53" name="Textbox24"/>
+            <p:cNvPr id="48" name="Textbox24"/>
             <p:cNvSpPr txBox="1">
               <a:extLst>
                 <a:ext uri="smNativeData">
-                  <pr:smNativeData xmlns:pr="smNativeData" xmlns="smNativeData" val="SMDATA_15_ZqHWaRMAAAAlAAAAEgAAAA8BAAAAkAAAAEgAAACQAAAASAAAAAAAAAABAAAAAAAAAAEAAABQAAAAAAAAAAAA4D8AAAAAAADgPwAAAAAAAOA/AAAAAAAA4D8AAAAAAADgPwAAAAAAAOA/AAAAAAAA4D8AAAAAAADgPwAAAAAAAOA/AAAAAAAA4D8CAAAAjAAAAAEAAAAAAAAAAP8AAP///wgAAAAAAAAAAAAAAAAAAAAAAAAAAAAAAAAAAAAAZAAAAAEAAABAAAAAAAAAAAAAAAAAAAAAAAAAAAAAAAAAAAAAAAAAAAAAAAAAAAAAAAAAAAAAAAAAAAAAAAAAAAAAAAAAAAAAAAAAAAAAAAAAAAAAAAAAAAAAAAAAAAAAFAAAADwAAAABAAAAAAAAAAAAAAkUAAAAAQAAABQAAAAUAAAAFAAAAAEAAAAAAAAAZAAAAGQAAAAAAAAAZAAAAGQAAAAVAAAAYAAAAAAAAAAAAAAADwAAACADAAAAAAAAAAAAAAEAAACgMgAAVgcAAKr4//8BAAAAf39/AAEAAABkAAAAAAAAABQAAABAHwAAAAAAACYAAAAAAAAAwOD//wAAAAAmAAAAZAAAABYAAABMAAAAAAAAAAAAAAAEAAAAAAAAAAEAAACAgIAKAAAAACgAAAAoAAAAZAAAAGQAAAAAAAAAzMzMAAAAAABQAAAAUAAAAGQAAABkAAAAAAAAABcAAAAUAAAAAAAAAIgDAAD/fwAA/38AAAAAAAAJAAAABAAAACMAAAAeAAAAaAAAAAAAAAAAAAAAAAAAAAAAAAAAAAAAECcAABAnAAAAAAAAAAAAAAAAAAAAAAAAAAAAAAAAAAAAAAAAAAAAABQAAAAAAAAAwMD/AAAAAABkAAAAMgAAAAAAAABkAAAAAAAAAH9/fwAKAAAAIgAAABgAAAAAAAAAAAAAAAAAAAAAAAAAAAAAAAAAAAAkAAAAJAAAAAAAAAAHAAAAAAAAAAAAAAAAAAAAAAAAAAAAAAAAAAAAf39/ACUAAABYAAAAAAAAAAAAAAAAAAAAAAAAAAAAAAAAAAAAAAAAAAAAAAAAAAAAAAAAAAAAAAA/AAAAAAAAAKCGAQAAAAAAAAAAAAAAAAAMAAAAAQAAAAAAAAAAAAAAAAAAAB8AAABUAAAAAP8AAP///wEAAAAAAAAAAAAAAAAAAAAAAAAAAAAAAAAAAAAAAAAAAAAAAAJ/f38AgICAA8zMzADAwP8Af39/AAAAAAAAAAAAAAAAAAAAAAAAAAAAIQAAABgAAAAUAAAAfigAAA4hAADhMAAAtCMAAAAAAAAmAAAACAAAAP//////////"/>
+                  <pr:smNativeData xmlns:pr="smNativeData" xmlns="smNativeData" val="SMDATA_15_MvzhaRMAAAAlAAAAEgAAAA8BAAAAkAAAAEgAAACQAAAASAAAAAAAAAABAAAAAAAAAAEAAABQAAAAAAAAAAAA4D8AAAAAAADgPwAAAAAAAOA/AAAAAAAA4D8AAAAAAADgPwAAAAAAAOA/AAAAAAAA4D8AAAAAAADgPwAAAAAAAOA/AAAAAAAA4D8CAAAAjAAAAAEAAAAAAAAAAP8AAP///wgAAAAAAAAAAAAAAAAAAAAAAAAAAAAAAAAAAAAAZAAAAAEAAABAAAAAAAAAAAAAAAAAAAAAAAAAAAAAAAAAAAAAAAAAAAAAAAAAAAAAAAAAAAAAAAAAAAAAAAAAAAAAAAAAAAAAAAAAAAAAAAAAAAAAAAAAAAAAAAAAAAAAFAAAADwAAAABAAAAAAAAAAAAAAkUAAAAAQAAABQAAAAUAAAAFAAAAAEAAAAAAAAAZAAAAGQAAAAAAAAAZAAAAGQAAAAVAAAAYAAAAAAAAAAAAAAADwAAACADAAAAAAAAAAAAAAEAAACgMgAAVgcAAKr4//8BAAAAf39/AAEAAABkAAAAAAAAABQAAABAHwAAAAAAACYAAAAAAAAAwOD//wAAAAAmAAAAZAAAABYAAABMAAAAAAAAAAAAAAAEAAAAAAAAAAEAAACAgIAKAAAAACgAAAAoAAAAZAAAAGQAAAAAAAAAzMzMAAAAAABQAAAAUAAAAGQAAABkAAAAAAAAABcAAAAUAAAAAAAAAIgDAAD/fwAA/38AAAAAAAAJAAAABAAAACMAAAAeAAAAaAAAAAAAAAAAAAAAAAAAAAAAAAAAAAAAECcAABAnAAAAAAAAAAAAAAAAAAAAAAAAAAAAAAAAAAAAAAAAAAAAABQAAAAAAAAAwMD/AAAAAABkAAAAMgAAAAAAAABkAAAAAAAAAH9/fwAKAAAAIgAAABgAAAAAAAAAAAAAAAAAAAAAAAAAAAAAAAAAAAAkAAAAJAAAAAAAAAAHAAAAAAAAAAAAAAAAAAAAAAAAAAAAAAAAAAAAf39/ACUAAABYAAAAAAAAAAAAAAAAAAAAAAAAAAAAAAAAAAAAAAAAAAAAAAAAAAAAAAAAAAAAAAA/AAAAAAAAAKCGAQAAAAAAAAAAAAAAAAAMAAAAAQAAAAAAAAAAAAAAAAAAAB8AAABUAAAAAP8AAP///wEAAAAAAAAAAAAAAAAAAAAAAAAAAAAAAAAAAAAAAAAAAAAAAAJ/f38AgICAA8zMzADAwP8Af39/AAAAAAAAAAAAAAAAAAAAAAAAAAAAIQAAABgAAAAUAAAAfigAAA4hAADhMAAAtCMAAAAAAAAmAAAACAAAAP//////////"/>
                 </a:ext>
               </a:extLst>
             </p:cNvSpPr>
@@ -5939,11 +5742,11 @@
         </p:sp>
         <p:sp>
           <p:nvSpPr>
-            <p:cNvPr id="52" name="Textbox25"/>
+            <p:cNvPr id="47" name="Textbox25"/>
             <p:cNvSpPr txBox="1">
               <a:extLst>
                 <a:ext uri="smNativeData">
-                  <pr:smNativeData xmlns:pr="smNativeData" xmlns="smNativeData" val="SMDATA_15_ZqHWaRMAAAAlAAAAEgAAAA8BAAAAkAAAAEgAAACQAAAASAAAAAAAAAABAAAAAAAAAAEAAABQAAAAAAAAAAAA4D8AAAAAAADgPwAAAAAAAOA/AAAAAAAA4D8AAAAAAADgPwAAAAAAAOA/AAAAAAAA4D8AAAAAAADgPwAAAAAAAOA/AAAAAAAA4D8CAAAAjAAAAAEAAAAAAAAAAP8AAP///wgAAAAAAAAAAAAAAAAAAAAAAAAAAAAAAAAAAAAAZAAAAAEAAABAAAAAAAAAAAAAAAAAAAAAAAAAAAAAAAAAAAAAAAAAAAAAAAAAAAAAAAAAAAAAAAAAAAAAAAAAAAAAAAAAAAAAAAAAAAAAAAAAAAAAAAAAAAAAAAAAAAAAFAAAADwAAAABAAAAAAAAAAAAAAkUAAAAAQAAABQAAAAUAAAAFAAAAAEAAAAAAAAAZAAAAGQAAAAAAAAAZAAAAGQAAAAVAAAAYAAAAAAAAAAAAAAADwAAACADAAAAAAAAAAAAAAEAAACgMgAAVgcAAKr4//8BAAAAf39/AAEAAABkAAAAAAAAABQAAABAHwAAAAAAACYAAAAAAAAAwOD//wAAAAAmAAAAZAAAABYAAABMAAAAAAAAAAAAAAAEAAAAAAAAAAEAAACAgIAKAAAAACgAAAAoAAAAZAAAAGQAAAAAAAAAzMzMAAAAAABQAAAAUAAAAGQAAABkAAAAAAAAABcAAAAUAAAAAAAAAIgDAAD/fwAA/38AAAAAAAAJAAAABAAAAAAAAAAeAAAAaAAAAAAAAAAAAAAAAAAAAAAAAAAAAAAAECcAABAnAAAAAAAAAAAAAAAAAAAAAAAAAAAAAAAAAAAAAAAAAAAAABQAAAAAAAAAwMD/AAAAAABkAAAAMgAAAAAAAABkAAAAAAAAAH9/fwAKAAAAIgAAABgAAAAAAAAAAAAAAAAAAAAAAAAAAAAAAAAAAAAkAAAAJAAAAAAAAAAHAAAAAAAAAAAAAAAAAAAAAAAAAAAAAAAAAAAAf39/ACUAAABYAAAAAAAAAAAAAAAAAAAAAAAAAAAAAAAAAAAAAAAAAAAAAAAAAAAAAAAAAAAAAAA/AAAAAAAAAKCGAQAAAAAAAAAAAAAAAAAMAAAAAQAAAAAAAAAAAAAAAAAAAB8AAABUAAAAAP8AAP///wEAAAAAAAAAAAAAAAAAAAAAAAAAAAAAAAAAAAAAAAAAAAAAAAJ/f38AgICAA8zMzADAwP8Af39/AAAAAAAAAAAAAAAAAAAAAAAAAAAAIQAAABgAAAAUAAAAGigAAKogAAB9MAAAUCMAAAAAAAAmAAAACAAAAP//////////"/>
+                  <pr:smNativeData xmlns:pr="smNativeData" xmlns="smNativeData" val="SMDATA_15_MvzhaRMAAAAlAAAAEgAAAA8BAAAAkAAAAEgAAACQAAAASAAAAAAAAAABAAAAAAAAAAEAAABQAAAAAAAAAAAA4D8AAAAAAADgPwAAAAAAAOA/AAAAAAAA4D8AAAAAAADgPwAAAAAAAOA/AAAAAAAA4D8AAAAAAADgPwAAAAAAAOA/AAAAAAAA4D8CAAAAjAAAAAEAAAAAAAAAAP8AAP///wgAAAAAAAAAAAAAAAAAAAAAAAAAAAAAAAAAAAAAZAAAAAEAAABAAAAAAAAAAAAAAAAAAAAAAAAAAAAAAAAAAAAAAAAAAAAAAAAAAAAAAAAAAAAAAAAAAAAAAAAAAAAAAAAAAAAAAAAAAAAAAAAAAAAAAAAAAAAAAAAAAAAAFAAAADwAAAABAAAAAAAAAAAAAAkUAAAAAQAAABQAAAAUAAAAFAAAAAEAAAAAAAAAZAAAAGQAAAAAAAAAZAAAAGQAAAAVAAAAYAAAAAAAAAAAAAAADwAAACADAAAAAAAAAAAAAAEAAACgMgAAVgcAAKr4//8BAAAAf39/AAEAAABkAAAAAAAAABQAAABAHwAAAAAAACYAAAAAAAAAwOD//wAAAAAmAAAAZAAAABYAAABMAAAAAAAAAAAAAAAEAAAAAAAAAAEAAACAgIAKAAAAACgAAAAoAAAAZAAAAGQAAAAAAAAAzMzMAAAAAABQAAAAUAAAAGQAAABkAAAAAAAAABcAAAAUAAAAAAAAAIgDAAD/fwAA/38AAAAAAAAJAAAABAAAAAAAAAAeAAAAaAAAAAAAAAAAAAAAAAAAAAAAAAAAAAAAECcAABAnAAAAAAAAAAAAAAAAAAAAAAAAAAAAAAAAAAAAAAAAAAAAABQAAAAAAAAAwMD/AAAAAABkAAAAMgAAAAAAAABkAAAAAAAAAH9/fwAKAAAAIgAAABgAAAAAAAAAAAAAAAAAAAAAAAAAAAAAAAAAAAAkAAAAJAAAAAAAAAAHAAAAAAAAAAAAAAAAAAAAAAAAAAAAAAAAAAAAf39/ACUAAABYAAAAAAAAAAAAAAAAAAAAAAAAAAAAAAAAAAAAAAAAAAAAAAAAAAAAAAAAAAAAAAA/AAAAAAAAAKCGAQAAAAAAAAAAAAAAAAAMAAAAAQAAAAAAAAAAAAAAAAAAAB8AAABUAAAAAP8AAP///wEAAAAAAAAAAAAAAAAAAAAAAAAAAAAAAAAAAAAAAAAAAAAAAAJ/f38AgICAA8zMzADAwP8Af39/AAAAAAAAAAAAAAAAAAAAAAAAAAAAIQAAABgAAAAUAAAAGigAAKogAAB9MAAAUCMAAAAAAAAmAAAACAAAAP//////////"/>
                 </a:ext>
               </a:extLst>
             </p:cNvSpPr>
@@ -5984,11 +5787,11 @@
       </p:grpSp>
       <p:cxnSp>
         <p:nvCxnSpPr>
-          <p:cNvPr id="54" name="Connector1"/>
+          <p:cNvPr id="49" name="Connector1"/>
           <p:cNvCxnSpPr>
             <a:extLst>
               <a:ext uri="smNativeData">
-                <pr:smNativeData xmlns:pr="smNativeData" xmlns="smNativeData" val="SMDATA_15_ZqHWaRMAAAAlAAAADQAAAA8BAAAAkAAAAEgAAACQAAAASAAAAAAAAAAAAAAAAAAAAAEAAABQAAAAAAAAAAAA4D8AAAAAAADgPwAAAAAAAOA/AAAAAAAA4D8AAAAAAADgPwAAAAAAAOA/AAAAAAAA4D8AAAAAAADgPwAAAAAAAOA/AAAAAAAA4D8CAAAAjAAAAAAAAAAAAAAAu+DjDP///wgAAAAAAAAAAAAAAAAAAAAAAAAAAAAAAAAAAAAAZAAAAAEAAABAAAAAAAAAAAAAAAAAAAAAAAAAAAAAAAAAAAAAAAAAAAAAAAAAAAAAAAAAAAAAAAAAAAAAAAAAAAAAAAAAAAAAAAAAAAAAAAAAAAAAAAAAAAAAAAAAAAAAFAAAADwAAAABAAAAAAAAAAAAAAkUAAAAAQAAABQAAAAUAAAAFAAAAAEAAAAAAAAAZAAAAGQAAAABAAAAlgAAAJYAAAAVAAAAYAAAAAAAAAAAAAAADwAAACADAAAAAAAAAAAAAAEAAACgMgAAVgcAAKr4//8BAAAAf39/AAEAAABkAAAAAAAAABQAAABAHwAAAAAAACYAAAAAAAAAwOD//wAAAAAmAAAAZAAAABYAAABMAAAAAAAAAAAAAAAEAAAAAAAAAAEAAACAgIAKAAAAACgAAAAoAAAAZAAAAGQAAAAAAAAAzMzMAAAAAABQAAAAUAAAAGQAAABkAAAAAAAAABcAAAAUAAAAAAAAAAAAAAD/fwAA/38AAAAAAAAJAAAABAAAAAAAED4eAAAAaAAAAAAAAAAAAAAAAAAAAAAAAAAAAAAAECcAABAnAAAAAAAAAAAAAAAAAAAAAAAAAAAAAAAAAAAAAAAAAAAAABQAAAAAAAAAwMD/AAAAAABkAAAAMgAAAAAAAABkAAAAAAAAAH9/fwAKAAAAIgAAABgAAAAAAAAAAAAAAAAAAAAAAAAAAAAAAAAAAAAkAAAAJAAAAAAAAAAHAAAAAAAAAAAAAAAAAAAAAAAAAAAAAAAAAAAAf39/ACUAAABYAAAAAAAAAAAAAAAAAAAAAAAAAAAAAAAAAAAAAAAAAAAAAAAAAAAAAAAAAAAAAAA/AAAAAAAAAKCGAQAAAAAAAAAAAAAAAAAMAAAAAQAAAAAAAAAAAAAAAAAAAB8AAABUAAAAu+DjBf///wEAAAAAAAAAAAAAAAAAAAAAAAAAAAAAAAAAAAAAAAAAAAAAAAJ/f38AgICAA8zMzADAwP8Af39/AAAAAAAAAAAAAAAAAAAAAAAAAAAAIQAAABgAAAAUAAAAgSsAAJoeAACEKwAAqiAAABAAAAAmAAAACAAAAP//////////"/>
+                <pr:smNativeData xmlns:pr="smNativeData" xmlns="smNativeData" val="SMDATA_15_MvzhaRMAAAAlAAAADQAAAA8BAAAAkAAAAEgAAACQAAAASAAAAAAAAAAAAAAAAAAAAAEAAABQAAAAAAAAAAAA4D8AAAAAAADgPwAAAAAAAOA/AAAAAAAA4D8AAAAAAADgPwAAAAAAAOA/AAAAAAAA4D8AAAAAAADgPwAAAAAAAOA/AAAAAAAA4D8CAAAAjAAAAAAAAAAAAAAAu+DjDP///wgAAAAAAAAAAAAAAAAAAAAAAAAAAAAAAAAAAAAAZAAAAAEAAABAAAAAAAAAAAAAAAAAAAAAAAAAAAAAAAAAAAAAAAAAAAAAAAAAAAAAAAAAAAAAAAAAAAAAAAAAAAAAAAAAAAAAAAAAAAAAAAAAAAAAAAAAAAAAAAAAAAAAFAAAADwAAAABAAAAAQAAAAAAAAkUAAAAAQAAABQAAAAUAAAAFAAAAAEAAAAAAAAAZAAAAGQAAAABAAAAlgAAAJYAAAAVAAAAYAAAAAAAAAAAAAAADwAAACADAAAAAAAAAAAAAAEAAACgMgAAVgcAAKr4//8BAAAAf39/AAEAAABkAAAAAAAAABQAAABAHwAAAAAAACYAAAAAAAAAwOD//wAAAAAmAAAAZAAAABYAAABMAAAAAAAAAAAAAAAEAAAAAAAAAAEAAACAgIAKAAAAACgAAAAoAAAAZAAAAGQAAAAAAAAAzMzMAAAAAABQAAAAUAAAAGQAAABkAAAAAAAAABcAAAAUAAAAAAAAAAAAAAD/fwAA/38AAAAAAAAJAAAABAAAAAAAED4eAAAAaAAAAAAAAAAAAAAAAAAAAAAAAAAAAAAAECcAABAnAAAAAAAAAAAAAAAAAAAAAAAAAAAAAAAAAAAAAAAAAAAAABQAAAAAAAAAwMD/AAAAAABkAAAAMgAAAAAAAABkAAAAAAAAAH9/fwAKAAAAIgAAABgAAAAAAAAAAAAAAAAAAAAAAAAAAAAAAAAAAAAkAAAAJAAAAAAAAAAHAAAAAAAAAAAAAAAAAAAAAAAAAAAAAAAAAAAAf39/ACUAAABYAAAAAAAAAAAAAAAAAAAAAAAAAAAAAAAAAAAAAAAAAAAAAAAAAAAAAAAAAAAAAAA/AAAAAAAAAKCGAQAAAAAAAAAAAAAAAAAMAAAAAQAAAAAAAAAAAAAAAAAAAB8AAABUAAAAu+DjBf///wEAAAAAAAAAAAAAAAAAAAAAAAAAAAAAAAAAAAAAAAAAAAAAAAJ/f38AgICAA8zMzADAwP8Af39/AAAAAAAAAAAAAAAAAAAAAAAAAAAAIQAAABgAAAAUAAAAgSsAAJoeAACEKwAAqiAAABAAAAAmAAAACAAAAP//////////"/>
               </a:ext>
             </a:extLst>
           </p:cNvCxnSpPr>
@@ -5998,6 +5801,39 @@
           <a:xfrm rot="16200000" flipH="1">
             <a:off x="6905625" y="5140960"/>
             <a:ext cx="335280" cy="1905"/>
+          </a:xfrm>
+          <a:prstGeom prst="straightConnector1">
+            <a:avLst/>
+          </a:prstGeom>
+          <a:noFill/>
+          <a:ln w="12700" cap="flat" cmpd="sng" algn="ctr">
+            <a:solidFill>
+              <a:schemeClr val="tx1"/>
+            </a:solidFill>
+            <a:prstDash val="sysDot"/>
+            <a:headEnd type="none"/>
+            <a:tailEnd type="stealth" w="lg" len="lg"/>
+          </a:ln>
+          <a:effectLst/>
+        </p:spPr>
+      </p:cxnSp>
+      <p:cxnSp>
+        <p:nvCxnSpPr>
+          <p:cNvPr id="50" name="Connector2"/>
+          <p:cNvCxnSpPr>
+            <a:stCxn id="20" idx="2"/>
+            <a:extLst>
+              <a:ext uri="smNativeData">
+                <pr:smNativeData xmlns:pr="smNativeData" xmlns="smNativeData" val="SMDATA_15_MvzhaRMAAAAlAAAADQAAAA8BAAAAkAAAAEgAAACQAAAASAAAAAAAAAAAAAAAAAAAAAEAAABQAAAAAAAAAAAA4D8AAAAAAADgPwAAAAAAAOA/AAAAAAAA4D8AAAAAAADgPwAAAAAAAOA/AAAAAAAA4D8AAAAAAADgPwAAAAAAAOA/AAAAAAAA4D8CAAAAjAAAAAAAAAAAAAAAu+DjDP///wgAAAAAAAAAAAAAAAAAAAAAAAAAAAAAAAAAAAAAZAAAAAEAAABAAAAAAAAAAAAAAAAAAAAAAAAAAAAAAAAAAAAAAAAAAAAAAAAAAAAAAAAAAAAAAAAAAAAAAAAAAAAAAAAAAAAAAAAAAAAAAAAAAAAAAAAAAAAAAAAAAAAAFAAAADwAAAABAAAAAAAAAAAAAAkUAAAAAQAAABQAAAAUAAAAFAAAAAEAAAAAAAAAZAAAAGQAAAABAAAAlgAAAJYAAAAVAAAAYAAAAAAAAAAAAAAADwAAACADAAAAAAAAAAAAAAEAAACgMgAAVgcAAKr4//8BAAAAf39/AAEAAABkAAAAAAAAABQAAABAHwAAAAAAACYAAAAAAAAAwOD//wAAAAAmAAAAZAAAABYAAABMAAAAAAAAAAAAAAAEAAAAAAAAAAEAAACAgIAKAAAAACgAAAAoAAAAZAAAAGQAAAAAAAAAzMzMAAAAAABQAAAAUAAAAGQAAABkAAAAAAAAABcAAAAUAAAAAAAAAAAAAAD/fwAA/38AAAAAAAAJAAAABAAAAAAAAAAeAAAAaAAAAAAAAAAAAAAAAAAAAAAAAAAAAAAAECcAABAnAAAAAAAAAAAAAAAAAAAAAAAAAAAAAAAAAAAAAAAAAAAAABQAAAAAAAAAwMD/AAAAAABkAAAAMgAAAAAAAABkAAAAAAAAAH9/fwAKAAAAIgAAABgAAAAAAAAAAAAAAAAAAAAAAAAAAAAAAAAAAAAkAAAAJAAAAAAAAAAHAAAAAAAAAAAAAAAAAAAAAAAAAAAAAAAAAAAAf39/ACUAAABYAAAAAAAAAAAAAAAAAAAAAAAAAAAAAAAAAAAAAAAAAAAAAAAAAAAAAAAAAAAAAAA/AAAAAAAAAKCGAQAAAAAAAAAAAAAAAAAMAAAAAQAAAAAAAAAAAAAAAAAAAB8AAABUAAAAu+DjBf///wEAAAAAAAAAAAAAAAAAAAAAAAAAAAAAAAAAAAAAAAAAAAAAAAJ/f38AgICAA8zMzADAwP8Af39/AAAAAAAAAAAAAAAAAAAAAAAAAAAAIQAAABgAAAAUAAAAqBEAAHEeAACpEQAAaiAAABAAAAAmAAAACAAAAP//////////"/>
+              </a:ext>
+            </a:extLst>
+          </p:cNvCxnSpPr>
+          <p:nvPr/>
+        </p:nvCxnSpPr>
+        <p:spPr>
+          <a:xfrm rot="16200000" flipH="1">
+            <a:off x="2710180" y="5108575"/>
+            <a:ext cx="320675" cy="635"/>
           </a:xfrm>
           <a:prstGeom prst="straightConnector1">
             <a:avLst/>
@@ -6014,87 +5850,22 @@
           <a:effectLst/>
         </p:spPr>
       </p:cxnSp>
-      <p:cxnSp>
-        <p:nvCxnSpPr>
-          <p:cNvPr id="55" name="Connector2"/>
-          <p:cNvCxnSpPr>
-            <a:stCxn id="21" idx="2"/>
-            <a:extLst>
-              <a:ext uri="smNativeData">
-                <pr:smNativeData xmlns:pr="smNativeData" xmlns="smNativeData" val="SMDATA_15_ZqHWaRMAAAAlAAAADQAAAA8BAAAAkAAAAEgAAACQAAAASAAAAAAAAAAAAAAAAAAAAAEAAABQAAAAAAAAAAAA4D8AAAAAAADgPwAAAAAAAOA/AAAAAAAA4D8AAAAAAADgPwAAAAAAAOA/AAAAAAAA4D8AAAAAAADgPwAAAAAAAOA/AAAAAAAA4D8CAAAAjAAAAAAAAAAAAAAAu+DjDP///wgAAAAAAAAAAAAAAAAAAAAAAAAAAAAAAAAAAAAAZAAAAAEAAABAAAAAAAAAAAAAAAAAAAAAAAAAAAAAAAAAAAAAAAAAAAAAAAAAAAAAAAAAAAAAAAAAAAAAAAAAAAAAAAAAAAAAAAAAAAAAAAAAAAAAAAAAAAAAAAAAAAAAFAAAADwAAAABAAAAAAAAAAAAAAkUAAAAAQAAABQAAAAUAAAAFAAAAAEAAAAAAAAAZAAAAGQAAAABAAAAlgAAAJYAAAAVAAAAYAAAAAAAAAAAAAAADwAAACADAAAAAAAAAAAAAAEAAACgMgAAVgcAAKr4//8BAAAAf39/AAEAAABkAAAAAAAAABQAAABAHwAAAAAAACYAAAAAAAAAwOD//wAAAAAmAAAAZAAAABYAAABMAAAAAAAAAAAAAAAEAAAAAAAAAAEAAACAgIAKAAAAACgAAAAoAAAAZAAAAGQAAAAAAAAAzMzMAAAAAABQAAAAUAAAAGQAAABkAAAAAAAAABcAAAAUAAAAAAAAAAAAAAD/fwAA/38AAAAAAAAJAAAABAAAAAAAAAAeAAAAaAAAAAAAAAAAAAAAAAAAAAAAAAAAAAAAECcAABAnAAAAAAAAAAAAAAAAAAAAAAAAAAAAAAAAAAAAAAAAAAAAABQAAAAAAAAAwMD/AAAAAABkAAAAMgAAAAAAAABkAAAAAAAAAH9/fwAKAAAAIgAAABgAAAAAAAAAAAAAAAAAAAAAAAAAAAAAAAAAAAAkAAAAJAAAAAAAAAAHAAAAAAAAAAAAAAAAAAAAAAAAAAAAAAAAAAAAf39/ACUAAABYAAAAAAAAAAAAAAAAAAAAAAAAAAAAAAAAAAAAAAAAAAAAAAAAAAAAAAAAAAAAAAA/AAAAAAAAAKCGAQAAAAAAAAAAAAAAAAAMAAAAAQAAAAAAAAAAAAAAAAAAAB8AAABUAAAAu+DjBf///wEAAAAAAAAAAAAAAAAAAAAAAAAAAAAAAAAAAAAAAAAAAAAAAAJ/f38AgICAA8zMzADAwP8Af39/AAAAAAAAAAAAAAAAAAAAAAAAAAAAIQAAABgAAAAUAAAAqBEAAHEeAACpEQAAaiAAABAAAAAmAAAACAAAAP//////////"/>
-              </a:ext>
-            </a:extLst>
-          </p:cNvCxnSpPr>
+      <p:sp>
+        <p:nvSpPr>
+          <p:cNvPr id="51" name="Textbox23"/>
+          <p:cNvSpPr txBox="1">
+            <a:extLst>
+              <a:ext uri="smNativeData">
+                <pr:smNativeData xmlns:pr="smNativeData" xmlns="smNativeData" val="SMDATA_15_MvzhaRMAAAAlAAAAEgAAAE8BAAAAkAAAAEgAAACQAAAASAAAAAAAAAAAAAAAAAAAAAEAAABQAAAAAAAAAAAA4D8AAAAAAADgPwAAAAAAAOA/AAAAAAAA4D8AAAAAAADgPwAAAAAAAOA/AAAAAAAA4D8AAAAAAADgPwAAAAAAAOA/AAAAAAAA4D8CAAAAjAAAAAAAAAAAAAAAu+DjDP///wgAAAAAAAAAAAAAAAAAAAAAAAAAAAAAAAAAAAAAZAAAAAEAAABAAAAAAAAAAAAAAAAAAAAAAAAAAAAAAAAAAAAAAAAAAAAAAAAAAAAAAAAAAAAAAAAAAAAAAAAAAAAAAAAAAAAAAAAAAAAAAAAAAAAAAAAAAAAAAAAAAAAAFAAAADwAAAAAAAAAAAAAAAAAAAkUAAAAAQAAABQAAAAUAAAAFAAAAAEAAAAAAAAAZAAAAGQAAAAAAAAAZAAAAGQAAAAVAAAAYAAAAAAAAAAAAAAADwAAACADAAAAAAAAAAAAAAEAAACgMgAAVgcAAKr4//8BAAAAf39/AAEAAABkAAAAAAAAABQAAABAHwAAAAAAACYAAAAAAAAAwOD//wAAAAAmAAAAZAAAABYAAABMAAAAAAAAAAAAAAAEAAAAAAAAAAEAAACAgIAKAAAAACgAAAAoAAAAZAAAAGQAAAAAAAAAzMzMAAAAAABQAAAAUAAAAGQAAABkAAAAAAAAABcAAAAUAAAAAAAAANwIAAD/fwAA/38AAAAAAAAJAAAABAAAAAAAAAAeAAAAaAAAAAAAAAAAAAAAAAAAAAAAAAAAAAAAECcAABAnAAAAAAAAAAAAAAAAAAAAAAAAAAAAAAAAAAAAAAAAAAAAABQAAAAAAAAAwMD/AAAAAABkAAAAMgAAAAAAAABkAAAAAAAAAH9/fwAKAAAAIgAAABgAAAAAAAAAAAAAAAAAAAAAAAAAAAAAAAAAAAAkAAAAJAAAAAAAAAAHAAAAAAAAAAAAAAAAAAAAAAAAAAAAAAAAAAAAf39/ACUAAABYAAAAAAAAAAAAAAAAAAAAAAAAAAAAAAAAAAAAAAAAAAAAAAAAAAAAAAAAAAAAAAA/AAAAAAAAAKCGAQAAAAAAAAAAAAAAAAAMAAAAAQAAAAAAAAAAAAAAAAAAAB8AAABUAAAAu+DjBf///wEAAAAAAAAAAAAAAAAAAAAAAAAAAAAAAAAAAAAAAAAAAAAAAAJ/f38AgICAA8zMzADAwP8Af39/AAAAAAAAAAAAAAAAAAAAAAAAAAAAIQAAABgAAAAUAAAAakAAAOgiAABGSQAA2CYAAAAgAAAmAAAACAAAAP//////////"/>
+              </a:ext>
+            </a:extLst>
+          </p:cNvSpPr>
           <p:nvPr/>
-        </p:nvCxnSpPr>
-        <p:spPr>
-          <a:xfrm rot="16200000" flipH="1">
-            <a:off x="2710180" y="5108575"/>
-            <a:ext cx="320675" cy="635"/>
-          </a:xfrm>
-          <a:prstGeom prst="straightConnector1">
-            <a:avLst/>
-          </a:prstGeom>
-          <a:noFill/>
-          <a:ln w="12700" cap="flat" cmpd="sng" algn="ctr">
-            <a:solidFill>
-              <a:schemeClr val="tx1"/>
-            </a:solidFill>
-            <a:prstDash val="solid"/>
-            <a:headEnd type="none"/>
-            <a:tailEnd type="stealth" w="lg" len="lg"/>
-          </a:ln>
-          <a:effectLst/>
-        </p:spPr>
-      </p:cxnSp>
-      <p:cxnSp>
-        <p:nvCxnSpPr>
-          <p:cNvPr id="56" name="Connector10"/>
-          <p:cNvCxnSpPr>
-            <a:extLst>
-              <a:ext uri="smNativeData">
-                <pr:smNativeData xmlns:pr="smNativeData" xmlns="smNativeData" val="SMDATA_15_ZqHWaRMAAAAlAAAADQAAAA8BAAAAkAAAAEgAAACQAAAASAAAAAAAAAAAAAAAAAAAAAEAAABQAAAAAAAAAAAA4D8AAAAAAADgPwAAAAAAAOA/AAAAAAAA4D8AAAAAAADgPwAAAAAAAOA/AAAAAAAA4D8AAAAAAADgPwAAAAAAAOA/AAAAAAAA4D8CAAAAjAAAAAAAAAAAAAAAu+DjDP///wgAAAAAAAAAAAAAAAAAAAAAAAAAAAAAAAAAAAAAZAAAAAEAAABAAAAAAAAAAAAAAAAAAAAAAAAAAAAAAAAAAAAAAAAAAAAAAAAAAAAAAAAAAAAAAAAAAAAAAAAAAAAAAAAAAAAAAAAAAAAAAAAAAAAAAAAAAAAAAAAAAAAAFAAAADwAAAABAAAAAAAAAAAAAAkUAAAAAQAAABQAAAAUAAAAFAAAAAEAAAAAAAAAZAAAAGQAAAABAAAAlgAAAJYAAAAVAAAAYAAAAAAAAAAAAAAADwAAACADAAAAAAAAAAAAAAEAAACgMgAAVgcAAKr4//8BAAAAf39/AAEAAABkAAAAAAAAABQAAABAHwAAAAAAACYAAAAAAAAAwOD//wAAAAAmAAAAZAAAABYAAABMAAAAAAAAAAAAAAAEAAAAAAAAAAEAAACAgIAKAAAAACgAAAAoAAAAZAAAAGQAAAAAAAAAzMzMAAAAAABQAAAAUAAAAGQAAABkAAAAAAAAABcAAAAUAAAAAAAAAAAAAAD/fwAA/38AAAAAAAAJAAAABAAAAAAAAAAeAAAAaAAAAAAAAAAAAAAAAAAAAAAAAAAAAAAAECcAABAnAAAAAAAAAAAAAAAAAAAAAAAAAAAAAAAAAAAAAAAAAAAAABQAAAAAAAAAwMD/AAAAAABkAAAAMgAAAAAAAABkAAAAAAAAAH9/fwAKAAAAIgAAABgAAAAAAAAAAAAAAAAAAAAAAAAAAAAAAAAAAAAkAAAAJAAAAAAAAAAHAAAAAAAAAAAAAAAAAAAAAAAAAAAAAAAAAAAAf39/ACUAAABYAAAAAAAAAAAAAAAAAAAAAAAAAAAAAAAAAAAAAAAAAAAAAAAAAAAAAAAAAAAAAAA/AAAAAAAAAKCGAQAAAAAAAAAAAAAAAAAMAAAAAQAAAAAAAAAAAAAAAAAAAB8AAABUAAAAu+DjBf///wEAAAAAAAAAAAAAAAAAAAAAAAAAAAAAAAAAAAAAAAAAAAAAAAJ/f38AgICAA8zMzADAwP8Af39/AAAAAAAAAAAAAAAAAAAAAAAAAAAAIQAAABgAAAAUAAAAqBEAABAjAACpEQAAqCQAABAAAAAmAAAACAAAAP//////////"/>
-              </a:ext>
-            </a:extLst>
-          </p:cNvCxnSpPr>
-          <p:nvPr/>
-        </p:nvCxnSpPr>
-        <p:spPr>
-          <a:xfrm rot="16200000" flipH="1">
-            <a:off x="2741295" y="5828665"/>
-            <a:ext cx="259080" cy="635"/>
-          </a:xfrm>
-          <a:prstGeom prst="straightConnector1">
-            <a:avLst/>
-          </a:prstGeom>
-          <a:noFill/>
-          <a:ln w="12700" cap="flat" cmpd="sng" algn="ctr">
-            <a:solidFill>
-              <a:schemeClr val="tx1"/>
-            </a:solidFill>
-            <a:prstDash val="solid"/>
-            <a:headEnd type="none"/>
-            <a:tailEnd type="stealth" w="lg" len="lg"/>
-          </a:ln>
-          <a:effectLst/>
-        </p:spPr>
-      </p:cxnSp>
-      <p:sp>
-        <p:nvSpPr>
-          <p:cNvPr id="57" name="Textbox23"/>
-          <p:cNvSpPr txBox="1">
-            <a:extLst>
-              <a:ext uri="smNativeData">
-                <pr:smNativeData xmlns:pr="smNativeData" xmlns="smNativeData" val="SMDATA_15_ZqHWaRMAAAAlAAAAEgAAAE8BAAAAkAAAAEgAAACQAAAASAAAAAAAAAAAAAAAAAAAAAEAAABQAAAAAAAAAAAA4D8AAAAAAADgPwAAAAAAAOA/AAAAAAAA4D8AAAAAAADgPwAAAAAAAOA/AAAAAAAA4D8AAAAAAADgPwAAAAAAAOA/AAAAAAAA4D8CAAAAjAAAAAAAAAAAAAAAu+DjDP///wgAAAAAAAAAAAAAAAAAAAAAAAAAAAAAAAAAAAAAZAAAAAEAAABAAAAAAAAAAAAAAAAAAAAAAAAAAAAAAAAAAAAAAAAAAAAAAAAAAAAAAAAAAAAAAAAAAAAAAAAAAAAAAAAAAAAAAAAAAAAAAAAAAAAAAAAAAAAAAAAAAAAAFAAAADwAAAAAAAAAAAAAAAAAAAkUAAAAAQAAABQAAAAUAAAAFAAAAAEAAAAAAAAAZAAAAGQAAAAAAAAAZAAAAGQAAAAVAAAAYAAAAAAAAAAAAAAADwAAACADAAAAAAAAAAAAAAEAAACgMgAAVgcAAKr4//8BAAAAf39/AAEAAABkAAAAAAAAABQAAABAHwAAAAAAACYAAAAAAAAAwOD//wAAAAAmAAAAZAAAABYAAABMAAAAAAAAAAAAAAAEAAAAAAAAAAEAAACAgIAKAAAAACgAAAAoAAAAZAAAAGQAAAAAAAAAzMzMAAAAAABQAAAAUAAAAGQAAABkAAAAAAAAABcAAAAUAAAAAAAAANwIAAD/fwAA/38AAAAAAAAJAAAABAAAAAAAAAAeAAAAaAAAAAAAAAAAAAAAAAAAAAAAAAAAAAAAECcAABAnAAAAAAAAAAAAAAAAAAAAAAAAAAAAAAAAAAAAAAAAAAAAABQAAAAAAAAAwMD/AAAAAABkAAAAMgAAAAAAAABkAAAAAAAAAH9/fwAKAAAAIgAAABgAAAAAAAAAAAAAAAAAAAAAAAAAAAAAAAAAAAAkAAAAJAAAAAAAAAAHAAAAAAAAAAAAAAAAAAAAAAAAAAAAAAAAAAAAf39/ACUAAABYAAAAAAAAAAAAAAAAAAAAAAAAAAAAAAAAAAAAAAAAAAAAAAAAAAAAAAAAAAAAAAA/AAAAAAAAAKCGAQAAAAAAAAAAAAAAAAAMAAAAAQAAAAAAAAAAAAAAAAAAAB8AAABUAAAAu+DjBf///wEAAAAAAAAAAAAAAAAAAAAAAAAAAAAAAAAAAAAAAAAAAAAAAAJ/f38AgICAA8zMzADAwP8Af39/AAAAAAAAAAAAAAAAAAAAAAAAAAAAIQAAABgAAAAUAAAAXD8AAFQiAAA4SAAAZCcAABAgAAAmAAAACAAAAP//////////"/>
-              </a:ext>
-            </a:extLst>
-          </p:cNvSpPr>
-          <p:nvPr/>
         </p:nvSpPr>
         <p:spPr>
           <a:xfrm>
-            <a:off x="10299700" y="5580380"/>
-            <a:ext cx="1440180" cy="822960"/>
+            <a:off x="10471150" y="5674360"/>
+            <a:ext cx="1440180" cy="640080"/>
           </a:xfrm>
           <a:prstGeom prst="rect">
             <a:avLst/>
@@ -6113,18 +5884,18 @@
               <a:defRPr sz="1200" cap="none"/>
             </a:pPr>
             <a:r>
-              <a:t>This table holds the same objects as the one used for static variables</a:t>
-            </a:r>
-          </a:p>
-        </p:txBody>
-      </p:sp>
-      <p:sp>
-        <p:nvSpPr>
-          <p:cNvPr id="58" name="Textbox28"/>
+              <a:t>This table is the used for static variables</a:t>
+            </a:r>
+          </a:p>
+        </p:txBody>
+      </p:sp>
+      <p:sp>
+        <p:nvSpPr>
+          <p:cNvPr id="52" name="Textbox28"/>
           <p:cNvSpPr txBox="1">
             <a:extLst>
               <a:ext uri="smNativeData">
-                <pr:smNativeData xmlns:pr="smNativeData" xmlns="smNativeData" val="SMDATA_15_ZqHWaRMAAAAlAAAAEgAAAE8BAAAAkAAAAEgAAACQAAAASAAAAAAAAAAAAAAAAAAAAAEAAABQAAAAAAAAAAAA4D8AAAAAAADgPwAAAAAAAOA/AAAAAAAA4D8AAAAAAADgPwAAAAAAAOA/AAAAAAAA4D8AAAAAAADgPwAAAAAAAOA/AAAAAAAA4D8CAAAAjAAAAAAAAAAAAAAAu+DjDP///wgAAAAAAAAAAAAAAAAAAAAAAAAAAAAAAAAAAAAAZAAAAAEAAABAAAAAAAAAAAAAAAAAAAAAAAAAAAAAAAAAAAAAAAAAAAAAAAAAAAAAAAAAAAAAAAAAAAAAAAAAAAAAAAAAAAAAAAAAAAAAAAAAAAAAAAAAAAAAAAAAAAAAFAAAADwAAAAAAAAAAAAAAAAAAAkUAAAAAQAAABQAAAAUAAAAFAAAAAEAAAAAAAAAZAAAAGQAAAAAAAAAZAAAAGQAAAAVAAAAYAAAAAAAAAAAAAAADwAAACADAAAAAAAAAAAAAAEAAACgMgAAVgcAAKr4//8BAAAAf39/AAEAAABkAAAAAAAAABQAAABAHwAAAAAAACYAAAAAAAAAwOD//wAAAAAmAAAAZAAAABYAAABMAAAAAAAAAAAAAAAEAAAAAAAAAAEAAACAgIAKAAAAACgAAAAoAAAAZAAAAGQAAAAAAAAAzMzMAAAAAABQAAAAUAAAAGQAAABkAAAAAAAAABcAAAAUAAAAAAAAANwIAAD/fwAA/38AAAAAAAAJAAAABAAAACMAAAAeAAAAaAAAAAAAAAAAAAAAAAAAAAAAAAAAAAAAECcAABAnAAAAAAAAAAAAAAAAAAAAAAAAAAAAAAAAAAAAAAAAAAAAABQAAAAAAAAAwMD/AAAAAABkAAAAMgAAAAAAAABkAAAAAAAAAH9/fwAKAAAAIgAAABgAAAAAAAAAAAAAAAAAAAAAAAAAAAAAAAAAAAAkAAAAJAAAAAAAAAAHAAAAAAAAAAAAAAAAAAAAAAAAAAAAAAAAAAAAf39/ACUAAABYAAAAAAAAAAAAAAAAAAAAAAAAAAAAAAAAAAAAAAAAAAAAAAAAAAAAAAAAAAAAAAA/AAAAAAAAAKCGAQAAAAAAAAAAAAAAAAAMAAAAAQAAAAAAAAAAAAAAAAAAAB8AAABUAAAAu+DjBf///wEAAAAAAAAAAAAAAAAAAAAAAAAAAAAAAAAAAAAAAAAAAAAAAAJ/f38AgICAA8zMzADAwP8Af39/AAAAAAAAAAAAAAAAAAAAAAAAAAAAIQAAABgAAAAUAAAAOQEAAM4iAADRCwAA3icAABAgAAAmAAAACAAAAP//////////"/>
+                <pr:smNativeData xmlns:pr="smNativeData" xmlns="smNativeData" val="SMDATA_15_MvzhaRMAAAAlAAAAEgAAAE8BAAAAkAAAAEgAAACQAAAASAAAAAAAAAAAAAAAAAAAAAEAAABQAAAAAAAAAAAA4D8AAAAAAADgPwAAAAAAAOA/AAAAAAAA4D8AAAAAAADgPwAAAAAAAOA/AAAAAAAA4D8AAAAAAADgPwAAAAAAAOA/AAAAAAAA4D8CAAAAjAAAAAAAAAAAAAAAu+DjDP///wgAAAAAAAAAAAAAAAAAAAAAAAAAAAAAAAAAAAAAZAAAAAEAAABAAAAAAAAAAAAAAAAAAAAAAAAAAAAAAAAAAAAAAAAAAAAAAAAAAAAAAAAAAAAAAAAAAAAAAAAAAAAAAAAAAAAAAAAAAAAAAAAAAAAAAAAAAAAAAAAAAAAAFAAAADwAAAAAAAAAAAAAAAAAAAkUAAAAAQAAABQAAAAUAAAAFAAAAAEAAAAAAAAAZAAAAGQAAAAAAAAAZAAAAGQAAAAVAAAAYAAAAAAAAAAAAAAADwAAACADAAAAAAAAAAAAAAEAAACgMgAAVgcAAKr4//8BAAAAf39/AAEAAABkAAAAAAAAABQAAABAHwAAAAAAACYAAAAAAAAAwOD//wAAAAAmAAAAZAAAABYAAABMAAAAAAAAAAAAAAAEAAAAAAAAAAEAAACAgIAKAAAAACgAAAAoAAAAZAAAAGQAAAAAAAAAzMzMAAAAAABQAAAAUAAAAGQAAABkAAAAAAAAABcAAAAUAAAAAAAAANwIAAD/fwAA/38AAAAAAAAJAAAABAAAACMAAAAeAAAAaAAAAAAAAAAAAAAAAAAAAAAAAAAAAAAAECcAABAnAAAAAAAAAAAAAAAAAAAAAAAAAAAAAAAAAAAAAAAAAAAAABQAAAAAAAAAwMD/AAAAAABkAAAAMgAAAAAAAABkAAAAAAAAAH9/fwAKAAAAIgAAABgAAAAAAAAAAAAAAAAAAAAAAAAAAAAAAAAAAAAkAAAAJAAAAAAAAAAHAAAAAAAAAAAAAAAAAAAAAAAAAAAAAAAAAAAAf39/ACUAAABYAAAAAAAAAAAAAAAAAAAAAAAAAAAAAAAAAAAAAAAAAAAAAAAAAAAAAAAAAAAAAAA/AAAAAAAAAKCGAQAAAAAAAAAAAAAAAAAMAAAAAQAAAAAAAAAAAAAAAAAAAB8AAABUAAAAu+DjBf///wEAAAAAAAAAAAAAAAAAAAAAAAAAAAAAAAAAAAAAAAAAAAAAAAJ/f38AgICAA8zMzADAwP8Af39/AAAAAAAAAAAAAAAAAAAAAAAAAAAAIQAAABgAAAAUAAAAOQEAAM4iAADRCwAAviYAAAAgAAAmAAAACAAAAP//////////"/>
               </a:ext>
             </a:extLst>
           </p:cNvSpPr>
@@ -6133,7 +5904,7 @@
         <p:spPr>
           <a:xfrm>
             <a:off x="198755" y="5657850"/>
-            <a:ext cx="1722120" cy="822960"/>
+            <a:ext cx="1722120" cy="640080"/>
           </a:xfrm>
           <a:prstGeom prst="rect">
             <a:avLst/>
@@ -6152,18 +5923,18 @@
               <a:defRPr sz="1200" cap="none"/>
             </a:pPr>
             <a:r>
-              <a:t>A member holds an explicit reference to the class entry, but has ownership of the object </a:t>
+              <a:t>Instance members have strong references to the class object</a:t>
             </a:r>
           </a:p>
         </p:txBody>
       </p:sp>
       <p:cxnSp>
         <p:nvCxnSpPr>
-          <p:cNvPr id="59" name="Connector26"/>
+          <p:cNvPr id="53" name="Connector26"/>
           <p:cNvCxnSpPr>
             <a:extLst>
               <a:ext uri="smNativeData">
-                <pr:smNativeData xmlns:pr="smNativeData" xmlns="smNativeData" val="SMDATA_15_ZqHWaRMAAAAlAAAADwAAAA8BAAAAkAAAAEgAAACQAAAASAAAAAAAAAAAAAAAAAAAAAEAAABQAAAAa6211lprGcAAAAAAAADgPwAAAAAAAOA/AAAAAAAA4D8AAAAAAADgPwAAAAAAAOA/AAAAAAAA4D8AAAAAAADgPwAAAAAAAOA/AAAAAAAA4D8CAAAAjAAAAAAAAAAAAAAAu+DjDP///wgAAAAAAAAAAAAAAAAAAAAAAAAAAAAAAAAAAAAAZAAAAAEAAABAAAAAAAAAAAAAAAAAAAAAAAAAAAAAAAAAAAAAAAAAAAAAAAAAAAAAAAAAAAAAAAAAAAAAAAAAAAAAAAAAAAAAAAAAAAAAAAAAAAAAAAAAAAAAAAAAAAAAFAAAADwAAAABAAAAAQAAAAAAAAkUAAAAAQAAABQAAAAUAAAAFAAAAAEAAAAAAAAAZAAAAGQAAAABAAAAlgAAAJYAAAAVAAAAYAAAAAAAAAAAAAAADwAAACADAAAAAAAAAAAAAAEAAACgMgAAVgcAAKr4//8BAAAAf39/AAEAAABkAAAAAAAAABQAAABAHwAAAAAAACYAAAAAAAAAwOD//wAAAAAmAAAAZAAAABYAAABMAAAAAAAAAAAAAAAEAAAAAAAAAAEAAACAgIAKAAAAACgAAAAoAAAAZAAAAGQAAAAAAAAAzMzMAAAAAABQAAAAUAAAAGQAAABkAAAAAAAAABcAAAAUAAAAAAAAAAAAAAD/fwAA/38AAAAAAAAJAAAABAAAAAAAAAAeAAAAaAAAAAAAAAAAAAAAAAAAAAAAAAAAAAAAECcAABAnAAAAAAAAAAAAAAAAAAAAAAAAAAAAAAAAAAAAAAAAAAAAABQAAAAAAAAAwMD/AAAAAABkAAAAMgAAAAAAAABkAAAAAAAAAH9/fwAKAAAAIgAAABgAAAAAAAAAAAAAAAAAAAAAAAAAAAAAAAAAAAAkAAAAJAAAAAAAAAAHAAAAAAAAAAAAAAAAAAAAAAAAAAAAAAAAAAAAf39/ACUAAABYAAAAAAAAAAAAAAAAAAAAAAAAAAAAAAAAAAAAAAAAAAAAAAAAAAAAAAAAAAAAAAA/AAAAAAAAAKCGAQAAAAAAAAAAAAAAAAAMAAAAAQAAAAAAAAAAAAAAAAAAAB8AAABUAAAAu+DjBf///wEAAAAAAAAAAAAAAAAAAAAAAAAAAAAAAAAAAAAAAAAAAAAAAAJ/f38AgICAA8zMzADAwP8Af39/AAAAAAAAAAAAAAAAAAAAAAAAAAAAIQAAABgAAAAUAAAA2RUAAL0hAAB0FgAAdCYAABAAAAAmAAAACAAAAP//////////"/>
+                <pr:smNativeData xmlns:pr="smNativeData" xmlns="smNativeData" val="SMDATA_15_MvzhaRMAAAAlAAAADwAAAA8BAAAAkAAAAEgAAACQAAAASAAAAAAAAAAAAAAAAAAAAAEAAABQAAAAa6211lprGcAAAAAAAADgPwAAAAAAAOA/AAAAAAAA4D8AAAAAAADgPwAAAAAAAOA/AAAAAAAA4D8AAAAAAADgPwAAAAAAAOA/AAAAAAAA4D8CAAAAjAAAAAAAAAAAAAAAu+DjDP///wgAAAAAAAAAAAAAAAAAAAAAAAAAAAAAAAAAAAAAZAAAAAEAAABAAAAAAAAAAAAAAAAAAAAAAAAAAAAAAAAAAAAAAAAAAAAAAAAAAAAAAAAAAAAAAAAAAAAAAAAAAAAAAAAAAAAAAAAAAAAAAAAAAAAAAAAAAAAAAAAAAAAAFAAAADwAAAABAAAAAQAAAAAAAAkUAAAAAQAAABQAAAAUAAAAFAAAAAEAAAAAAAAAZAAAAGQAAAABAAAAlgAAAJYAAAAVAAAAYAAAAAAAAAAAAAAADwAAACADAAAAAAAAAAAAAAEAAACgMgAAVgcAAKr4//8BAAAAf39/AAEAAABkAAAAAAAAABQAAABAHwAAAAAAACYAAAAAAAAAwOD//wAAAAAmAAAAZAAAABYAAABMAAAAAAAAAAAAAAAEAAAAAAAAAAEAAACAgIAKAAAAACgAAAAoAAAAZAAAAGQAAAAAAAAAzMzMAAAAAABQAAAAUAAAAGQAAABkAAAAAAAAABcAAAAUAAAAAAAAAAAAAAD/fwAA/38AAAAAAAAJAAAABAAAAAAAAAAeAAAAaAAAAAAAAAAAAAAAAAAAAAAAAAAAAAAAECcAABAnAAAAAAAAAAAAAAAAAAAAAAAAAAAAAAAAAAAAAAAAAAAAABQAAAAAAAAAwMD/AAAAAABkAAAAMgAAAAAAAABkAAAAAAAAAH9/fwAKAAAAIgAAABgAAAAAAAAAAAAAAAAAAAAAAAAAAAAAAAAAAAAkAAAAJAAAAAAAAAAHAAAAAAAAAAAAAAAAAAAAAAAAAAAAAAAAAAAAf39/ACUAAABYAAAAAAAAAAAAAAAAAAAAAAAAAAAAAAAAAAAAAAAAAAAAAAAAAAAAAAAAAAAAAAA/AAAAAAAAAKCGAQAAAAAAAAAAAAAAAAAMAAAAAQAAAAAAAAAAAAAAAAAAAB8AAABUAAAAu+DjBf///wEAAAAAAAAAAAAAAAAAAAAAAAAAAAAAAAAAAAAAAAAAAAAAAAJ/f38AgICAA8zMzADAwP8Af39/AAAAAAAAAAAAAAAAAAAAAAAAAAAAIQAAABgAAAAUAAAA2RUAAL0hAAB0FgAAdCYAABAAAAAmAAAACAAAAP//////////"/>
               </a:ext>
             </a:extLst>
           </p:cNvCxnSpPr>
@@ -6191,6 +5962,45 @@
           <a:effectLst/>
         </p:spPr>
       </p:cxnSp>
+      <p:sp>
+        <p:nvSpPr>
+          <p:cNvPr id="54" name="Textbox5"/>
+          <p:cNvSpPr txBox="1">
+            <a:extLst>
+              <a:ext uri="smNativeData">
+                <pr:smNativeData xmlns:pr="smNativeData" xmlns="smNativeData" val="SMDATA_15_MvzhaRMAAAAlAAAAEgAAAE8BAAAAkAAAAEgAAACQAAAASAAAAAAAAAAAAAAAAAAAAAEAAABQAAAAAAAAAAAA4D8AAAAAAADgPwAAAAAAAOA/AAAAAAAA4D8AAAAAAADgPwAAAAAAAOA/AAAAAAAA4D8AAAAAAADgPwAAAAAAAOA/AAAAAAAA4D8CAAAAjAAAAAAAAAAAAAAAu+DjDP///wgAAAAAAAAAAAAAAAAAAAAAAAAAAAAAAAAAAAAAZAAAAAEAAABAAAAAAAAAAAAAAAAAAAAAAAAAAAAAAAAAAAAAAAAAAAAAAAAAAAAAAAAAAAAAAAAAAAAAAAAAAAAAAAAAAAAAAAAAAAAAAAAAAAAAAAAAAAAAAAAAAAAAFAAAADwAAAAAAAAAAAAAAAAAAAkUAAAAAQAAABQAAAAUAAAAFAAAAAEAAAAAAAAAZAAAAGQAAAAAAAAAZAAAAGQAAAAVAAAAYAAAAAAAAAAAAAAADwAAACADAAAAAAAAAAAAAAEAAACgMgAAVgcAAKr4//8BAAAAf39/AAEAAABkAAAAAAAAABQAAABAHwAAAAAAACYAAAAAAAAAwOD//wAAAAAmAAAAZAAAABYAAABMAAAAAAAAAAAAAAAEAAAAAAAAAAEAAACAgIAKAAAAACgAAAAoAAAAZAAAAGQAAAAAAAAAzMzMAAAAAABQAAAAUAAAAGQAAABkAAAAAAAAABcAAAAUAAAAAAAAANwIAAD/fwAA/38AAAAAAAAJAAAABAAAAAAAAAAeAAAAaAAAAAAAAAAAAAAAAAAAAAAAAAAAAAAAECcAABAnAAAAAAAAAAAAAAAAAAAAAAAAAAAAAAAAAAAAAAAAAAAAABQAAAAAAAAAwMD/AAAAAABkAAAAMgAAAAAAAABkAAAAAAAAAH9/fwAKAAAAIgAAABgAAAAAAAAAAAAAAAAAAAAAAAAAAAAAAAAAAAAkAAAAJAAAAAAAAAAHAAAAAAAAAAAAAAAAAAAAAAAAAAAAAAAAAAAAf39/ACUAAABYAAAAAAAAAAAAAAAAAAAAAAAAAAAAAAAAAAAAAAAAAAAAAAAAAAAAAAAAAAAAAAA/AAAAAAAAAKCGAQAAAAAAAAAAAAAAAAAMAAAAAQAAAAAAAAAAAAAAAAAAAB8AAABUAAAAu+DjBf///wEAAAAAAAAAAAAAAAAAAAAAAAAAAAAAAAAAAAAAAAAAAAAAAAJ/f38AgICAA8zMzADAwP8Af39/AAAAAAAAAAAAAAAAAAAAAAAAAAAAIQAAABgAAAAUAAAAXhsAAKMkAACAJQAAkygAAAAgAAAmAAAACAAAAP//////////"/>
+              </a:ext>
+            </a:extLst>
+          </p:cNvSpPr>
+          <p:nvPr/>
+        </p:nvSpPr>
+        <p:spPr>
+          <a:xfrm>
+            <a:off x="4448810" y="5955665"/>
+            <a:ext cx="1647190" cy="640080"/>
+          </a:xfrm>
+          <a:prstGeom prst="rect">
+            <a:avLst/>
+          </a:prstGeom>
+          <a:noFill/>
+          <a:ln>
+            <a:noFill/>
+          </a:ln>
+          <a:effectLst/>
+        </p:spPr>
+        <p:txBody>
+          <a:bodyPr vert="horz" wrap="square" numCol="1" spcCol="215900" anchor="t"/>
+          <a:lstStyle/>
+          <a:p>
+            <a:pPr>
+              <a:defRPr sz="1200" cap="none"/>
+            </a:pPr>
+            <a:r>
+              <a:t>This table holds objects representing comptime fields</a:t>
+            </a:r>
+          </a:p>
+        </p:txBody>
+      </p:sp>
     </p:spTree>
   </p:cSld>
   <p:clrMapOvr>
@@ -7031,6 +6841,47 @@
       </a:clrScheme>
       <a:clrMap bg1="lt1" tx1="dk1" bg2="lt2" tx2="dk2" accent1="accent1" accent2="accent2" accent3="accent3" accent4="accent4" accent5="accent5" accent6="accent6" hlink="hlink" folHlink="folHlink"/>
     </a:extraClrScheme>
+    <a:extraClrScheme>
+      <a:clrScheme name="Presentation 15">
+        <a:dk1>
+          <a:srgbClr val="000000"/>
+        </a:dk1>
+        <a:lt1>
+          <a:srgbClr val="FFFFFF"/>
+        </a:lt1>
+        <a:dk2>
+          <a:srgbClr val="000000"/>
+        </a:dk2>
+        <a:lt2>
+          <a:srgbClr val="808080"/>
+        </a:lt2>
+        <a:accent1>
+          <a:srgbClr val="BBE0E3"/>
+        </a:accent1>
+        <a:accent2>
+          <a:srgbClr val="333399"/>
+        </a:accent2>
+        <a:accent3>
+          <a:srgbClr val="535379"/>
+        </a:accent3>
+        <a:accent4>
+          <a:srgbClr val="737359"/>
+        </a:accent4>
+        <a:accent5>
+          <a:srgbClr val="939339"/>
+        </a:accent5>
+        <a:accent6>
+          <a:srgbClr val="B3B319"/>
+        </a:accent6>
+        <a:hlink>
+          <a:srgbClr val="009999"/>
+        </a:hlink>
+        <a:folHlink>
+          <a:srgbClr val="99CC00"/>
+        </a:folHlink>
+      </a:clrScheme>
+      <a:clrMap bg1="lt1" tx1="dk1" bg2="lt2" tx2="dk2" accent1="accent1" accent2="accent2" accent3="accent3" accent4="accent4" accent5="accent5" accent6="accent6" hlink="hlink" folHlink="folHlink"/>
+    </a:extraClrScheme>
   </a:extraClrSchemeLst>
 </a:theme>
 </file>
</xml_diff>